<commit_message>
docs: synchronize r6 implementation evidence and delivery artifacts
</commit_message>
<xml_diff>
--- a/Inertia-Architecture.pptx
+++ b/Inertia-Architecture.pptx
@@ -2,19 +2,20 @@
 <file path=ppt/presentation.xml><?xml version="1.0" encoding="utf-8"?>
 <p:presentation xmlns:p="http://schemas.openxmlformats.org/presentationml/2006/main">
   <p:sldMasterIdLst>
-    <p:sldMasterId xmlns:r="http://schemas.openxmlformats.org/officeDocument/2006/relationships" id="2147483648" r:id="R7522085dea574879"/>
+    <p:sldMasterId xmlns:r="http://schemas.openxmlformats.org/officeDocument/2006/relationships" id="2147483648" r:id="R273b139f7c044ff7"/>
   </p:sldMasterIdLst>
   <p:notesMasterIdLst>
-    <p:notesMasterId xmlns:r="http://schemas.openxmlformats.org/officeDocument/2006/relationships" r:id="R85a23800730c45d9"/>
+    <p:notesMasterId xmlns:r="http://schemas.openxmlformats.org/officeDocument/2006/relationships" r:id="Rbaa4f659cae2406d"/>
   </p:notesMasterIdLst>
   <p:sldIdLst>
-    <p:sldId xmlns:r="http://schemas.openxmlformats.org/officeDocument/2006/relationships" id="256" r:id="Rf1fed21ed4354fc8"/>
-    <p:sldId xmlns:r="http://schemas.openxmlformats.org/officeDocument/2006/relationships" id="257" r:id="Rddf49720d4544dd2"/>
-    <p:sldId xmlns:r="http://schemas.openxmlformats.org/officeDocument/2006/relationships" id="258" r:id="R1095a1afbde74181"/>
-    <p:sldId xmlns:r="http://schemas.openxmlformats.org/officeDocument/2006/relationships" id="259" r:id="R47b2dd4ced1b4c3e"/>
-    <p:sldId xmlns:r="http://schemas.openxmlformats.org/officeDocument/2006/relationships" id="260" r:id="R37bcb76b39084b56"/>
-    <p:sldId xmlns:r="http://schemas.openxmlformats.org/officeDocument/2006/relationships" id="261" r:id="R37960745e2e04e7e"/>
-    <p:sldId xmlns:r="http://schemas.openxmlformats.org/officeDocument/2006/relationships" id="262" r:id="R418cf28906d64387"/>
+    <p:sldId xmlns:r="http://schemas.openxmlformats.org/officeDocument/2006/relationships" id="256" r:id="Rb2428aaf842a4875"/>
+    <p:sldId xmlns:r="http://schemas.openxmlformats.org/officeDocument/2006/relationships" id="257" r:id="R59276d759b26441c"/>
+    <p:sldId xmlns:r="http://schemas.openxmlformats.org/officeDocument/2006/relationships" id="258" r:id="R025705acd4d7429f"/>
+    <p:sldId xmlns:r="http://schemas.openxmlformats.org/officeDocument/2006/relationships" id="259" r:id="R7fefb3c3e2714bbc"/>
+    <p:sldId xmlns:r="http://schemas.openxmlformats.org/officeDocument/2006/relationships" id="260" r:id="Rdbc8884b250e4fd9"/>
+    <p:sldId xmlns:r="http://schemas.openxmlformats.org/officeDocument/2006/relationships" id="261" r:id="R380d774362574d86"/>
+    <p:sldId xmlns:r="http://schemas.openxmlformats.org/officeDocument/2006/relationships" id="262" r:id="Rbd70252bac4442fe"/>
+    <p:sldId xmlns:r="http://schemas.openxmlformats.org/officeDocument/2006/relationships" id="263" r:id="R2d339179cb0b4cd0"/>
   </p:sldIdLst>
   <p:sldSz cx="15240000" cy="8572500"/>
   <p:notesSz cx="6858000" cy="9144000"/>
@@ -448,7 +449,7 @@
           <a:lstStyle xmlns:a="http://schemas.openxmlformats.org/drawingml/2006/main"/>
           <a:p xmlns:a="http://schemas.openxmlformats.org/drawingml/2006/main">
             <a:r>
-              <a:t>INERTIA-2026-10-22-r5. Design refinement. See spec.md, testing.md, decisions.md and plan.md. Paperclip source 341b622604b639b056fc58b10e2dd3312d40385c; Buzz source dc25198d530acc6237a0320b697365f29daf0ea6. Source review established native capability surfaces; selected runtime qualification and detailed design review precede implementation. Original overview remains unchanged. Public repo https://github.com/NetRxn/Inertia .</a:t>
+              <a:t>INERTIA-2026-10-22-r6. Sources: spec.md, testing.md, decisions.md, plan.md. Merged baseline https://github.com/NetRxn/Inertia/commit/1d41eeb70b02275a488a7f7583c116c8d2c77f3c; PR 2 https://github.com/NetRxn/Inertia/pull/2; PR 3 https://github.com/NetRxn/Inertia/pull/3. Paperclip selected public release v2026.1012.0, bba6a45f0d364cfd962ac59b3bdf2426a8222adb. Buzz dc25198d530acc6237a0320b697365f29daf0ea6. PR 4 https://github.com/NetRxn/Inertia/pull/4 and PR 5 https://github.com/NetRxn/Inertia/pull/5 merged. Combined 108 tests, typecheck, build and synthetic demo passed. No private execution-provider source included.</a:t>
             </a:r>
           </a:p>
         </p:txBody>
@@ -518,7 +519,7 @@
           <a:lstStyle xmlns:a="http://schemas.openxmlformats.org/drawingml/2006/main"/>
           <a:p xmlns:a="http://schemas.openxmlformats.org/drawingml/2006/main">
             <a:r>
-              <a:t>INERTIA-2026-10-22-r5. Design refinement. See spec.md, testing.md, decisions.md and plan.md. Paperclip source 341b622604b639b056fc58b10e2dd3312d40385c; Buzz source dc25198d530acc6237a0320b697365f29daf0ea6. Source review established native capability surfaces; selected runtime qualification and detailed design review precede implementation. Original overview remains unchanged. Public repo https://github.com/NetRxn/Inertia .</a:t>
+              <a:t>INERTIA-2026-10-22-r6. Sources: spec.md, testing.md, decisions.md, plan.md. Merged baseline https://github.com/NetRxn/Inertia/commit/1d41eeb70b02275a488a7f7583c116c8d2c77f3c; PR 2 https://github.com/NetRxn/Inertia/pull/2; PR 3 https://github.com/NetRxn/Inertia/pull/3. Paperclip selected public release v2026.1012.0, bba6a45f0d364cfd962ac59b3bdf2426a8222adb. Buzz dc25198d530acc6237a0320b697365f29daf0ea6. PR 4 https://github.com/NetRxn/Inertia/pull/4 and PR 5 https://github.com/NetRxn/Inertia/pull/5 merged. Combined 108 tests, typecheck, build and synthetic demo passed. No private execution-provider source included.</a:t>
             </a:r>
           </a:p>
         </p:txBody>
@@ -588,7 +589,7 @@
           <a:lstStyle xmlns:a="http://schemas.openxmlformats.org/drawingml/2006/main"/>
           <a:p xmlns:a="http://schemas.openxmlformats.org/drawingml/2006/main">
             <a:r>
-              <a:t>INERTIA-2026-10-22-r5. Design refinement. See spec.md, testing.md, decisions.md and plan.md. Paperclip source 341b622604b639b056fc58b10e2dd3312d40385c; Buzz source dc25198d530acc6237a0320b697365f29daf0ea6. Source review established native capability surfaces; selected runtime qualification and detailed design review precede implementation. Original overview remains unchanged. Public repo https://github.com/NetRxn/Inertia .</a:t>
+              <a:t>INERTIA-2026-10-22-r6. Sources: spec.md, testing.md, decisions.md, plan.md. Merged baseline https://github.com/NetRxn/Inertia/commit/1d41eeb70b02275a488a7f7583c116c8d2c77f3c; PR 2 https://github.com/NetRxn/Inertia/pull/2; PR 3 https://github.com/NetRxn/Inertia/pull/3. Paperclip selected public release v2026.1012.0, bba6a45f0d364cfd962ac59b3bdf2426a8222adb. Buzz dc25198d530acc6237a0320b697365f29daf0ea6. PR 4 https://github.com/NetRxn/Inertia/pull/4 and PR 5 https://github.com/NetRxn/Inertia/pull/5 merged. Combined 108 tests, typecheck, build and synthetic demo passed. No private execution-provider source included.</a:t>
             </a:r>
           </a:p>
         </p:txBody>
@@ -658,7 +659,7 @@
           <a:lstStyle xmlns:a="http://schemas.openxmlformats.org/drawingml/2006/main"/>
           <a:p xmlns:a="http://schemas.openxmlformats.org/drawingml/2006/main">
             <a:r>
-              <a:t>INERTIA-2026-10-22-r5. Design refinement. See spec.md, testing.md, decisions.md and plan.md. Paperclip source 341b622604b639b056fc58b10e2dd3312d40385c; Buzz source dc25198d530acc6237a0320b697365f29daf0ea6. Source review established native capability surfaces; selected runtime qualification and detailed design review precede implementation. Original overview remains unchanged. Public repo https://github.com/NetRxn/Inertia .</a:t>
+              <a:t>INERTIA-2026-10-22-r6. Sources: spec.md, testing.md, decisions.md, plan.md. Merged baseline https://github.com/NetRxn/Inertia/commit/1d41eeb70b02275a488a7f7583c116c8d2c77f3c; PR 2 https://github.com/NetRxn/Inertia/pull/2; PR 3 https://github.com/NetRxn/Inertia/pull/3. Paperclip selected public release v2026.1012.0, bba6a45f0d364cfd962ac59b3bdf2426a8222adb. Buzz dc25198d530acc6237a0320b697365f29daf0ea6. PR 4 https://github.com/NetRxn/Inertia/pull/4 and PR 5 https://github.com/NetRxn/Inertia/pull/5 merged. Combined 108 tests, typecheck, build and synthetic demo passed. No private execution-provider source included.</a:t>
             </a:r>
           </a:p>
         </p:txBody>
@@ -728,7 +729,7 @@
           <a:lstStyle xmlns:a="http://schemas.openxmlformats.org/drawingml/2006/main"/>
           <a:p xmlns:a="http://schemas.openxmlformats.org/drawingml/2006/main">
             <a:r>
-              <a:t>INERTIA-2026-10-22-r5. Design refinement. See spec.md, testing.md, decisions.md and plan.md. Paperclip source 341b622604b639b056fc58b10e2dd3312d40385c; Buzz source dc25198d530acc6237a0320b697365f29daf0ea6. Source review established native capability surfaces; selected runtime qualification and detailed design review precede implementation. Original overview remains unchanged. Public repo https://github.com/NetRxn/Inertia .</a:t>
+              <a:t>INERTIA-2026-10-22-r6. Sources: spec.md, testing.md, decisions.md, plan.md. Merged baseline https://github.com/NetRxn/Inertia/commit/1d41eeb70b02275a488a7f7583c116c8d2c77f3c; PR 2 https://github.com/NetRxn/Inertia/pull/2; PR 3 https://github.com/NetRxn/Inertia/pull/3. Paperclip selected public release v2026.1012.0, bba6a45f0d364cfd962ac59b3bdf2426a8222adb. Buzz dc25198d530acc6237a0320b697365f29daf0ea6. PR 4 https://github.com/NetRxn/Inertia/pull/4 and PR 5 https://github.com/NetRxn/Inertia/pull/5 merged. Combined 108 tests, typecheck, build and synthetic demo passed. No private execution-provider source included.</a:t>
             </a:r>
           </a:p>
         </p:txBody>
@@ -798,7 +799,7 @@
           <a:lstStyle xmlns:a="http://schemas.openxmlformats.org/drawingml/2006/main"/>
           <a:p xmlns:a="http://schemas.openxmlformats.org/drawingml/2006/main">
             <a:r>
-              <a:t>INERTIA-2026-10-22-r5. Design refinement. See spec.md, testing.md, decisions.md and plan.md. Paperclip source 341b622604b639b056fc58b10e2dd3312d40385c; Buzz source dc25198d530acc6237a0320b697365f29daf0ea6. Source review established native capability surfaces; selected runtime qualification and detailed design review precede implementation. Original overview remains unchanged. Public repo https://github.com/NetRxn/Inertia .</a:t>
+              <a:t>INERTIA-2026-10-22-r6. Sources: spec.md, testing.md, decisions.md, plan.md. Merged baseline https://github.com/NetRxn/Inertia/commit/1d41eeb70b02275a488a7f7583c116c8d2c77f3c; PR 2 https://github.com/NetRxn/Inertia/pull/2; PR 3 https://github.com/NetRxn/Inertia/pull/3. Paperclip selected public release v2026.1012.0, bba6a45f0d364cfd962ac59b3bdf2426a8222adb. Buzz dc25198d530acc6237a0320b697365f29daf0ea6. PR 4 https://github.com/NetRxn/Inertia/pull/4 and PR 5 https://github.com/NetRxn/Inertia/pull/5 merged. Combined 108 tests, typecheck, build and synthetic demo passed. No private execution-provider source included.</a:t>
             </a:r>
           </a:p>
         </p:txBody>
@@ -868,7 +869,77 @@
           <a:lstStyle xmlns:a="http://schemas.openxmlformats.org/drawingml/2006/main"/>
           <a:p xmlns:a="http://schemas.openxmlformats.org/drawingml/2006/main">
             <a:r>
-              <a:t>INERTIA-2026-10-22-r5. Design refinement. See spec.md, testing.md, decisions.md and plan.md. Paperclip source 341b622604b639b056fc58b10e2dd3312d40385c; Buzz source dc25198d530acc6237a0320b697365f29daf0ea6. Source review established native capability surfaces; selected runtime qualification and detailed design review precede implementation. Original overview remains unchanged. Public repo https://github.com/NetRxn/Inertia .</a:t>
+              <a:t>INERTIA-2026-10-22-r6. Sources: spec.md, testing.md, decisions.md, plan.md. Merged baseline https://github.com/NetRxn/Inertia/commit/1d41eeb70b02275a488a7f7583c116c8d2c77f3c; PR 2 https://github.com/NetRxn/Inertia/pull/2; PR 3 https://github.com/NetRxn/Inertia/pull/3. Paperclip selected public release v2026.1012.0, bba6a45f0d364cfd962ac59b3bdf2426a8222adb. Buzz dc25198d530acc6237a0320b697365f29daf0ea6. PR 4 https://github.com/NetRxn/Inertia/pull/4 and PR 5 https://github.com/NetRxn/Inertia/pull/5 merged. Combined 108 tests, typecheck, build and synthetic demo passed. No private execution-provider source included.</a:t>
+            </a:r>
+          </a:p>
+        </p:txBody>
+      </p:sp>
+      <p:sp>
+        <p:nvSpPr>
+          <p:cNvPr id="4" name="Slide Number Placeholder 3"/>
+          <p:cNvSpPr>
+            <a:spLocks xmlns:a="http://schemas.openxmlformats.org/drawingml/2006/main" noGrp="1"/>
+          </p:cNvSpPr>
+          <p:nvPr>
+            <p:ph type="sldNum" idx="5"/>
+          </p:nvPr>
+        </p:nvSpPr>
+        <p:spPr/>
+        <p:txBody>
+          <a:bodyPr xmlns:a="http://schemas.openxmlformats.org/drawingml/2006/main"/>
+          <a:lstStyle xmlns:a="http://schemas.openxmlformats.org/drawingml/2006/main"/>
+          <a:p xmlns:a="http://schemas.openxmlformats.org/drawingml/2006/main"/>
+        </p:txBody>
+      </p:sp>
+    </p:spTree>
+  </p:cSld>
+  <p:clrMapOvr>
+    <a:masterClrMapping xmlns:a="http://schemas.openxmlformats.org/drawingml/2006/main"/>
+  </p:clrMapOvr>
+</p:notes>
+</file>
+
+<file path=ppt/notesSlides/notesSlide8.xml><?xml version="1.0" encoding="utf-8"?>
+<p:notes xmlns:p="http://schemas.openxmlformats.org/presentationml/2006/main">
+  <p:cSld>
+    <p:spTree>
+      <p:nvGrpSpPr>
+        <p:cNvPr id="1" name=""/>
+        <p:cNvGrpSpPr/>
+        <p:nvPr/>
+      </p:nvGrpSpPr>
+      <p:grpSpPr>
+        <a:xfrm xmlns:a="http://schemas.openxmlformats.org/drawingml/2006/main"/>
+      </p:grpSpPr>
+      <p:sp>
+        <p:nvSpPr>
+          <p:cNvPr id="2" name="Slide Image Placeholder 1"/>
+          <p:cNvSpPr>
+            <a:spLocks xmlns:a="http://schemas.openxmlformats.org/drawingml/2006/main" noGrp="1"/>
+          </p:cNvSpPr>
+          <p:nvPr>
+            <p:ph type="sldImg" idx="0"/>
+          </p:nvPr>
+        </p:nvSpPr>
+        <p:spPr/>
+      </p:sp>
+      <p:sp>
+        <p:nvSpPr>
+          <p:cNvPr id="3" name="Notes Placeholder 2"/>
+          <p:cNvSpPr>
+            <a:spLocks xmlns:a="http://schemas.openxmlformats.org/drawingml/2006/main" noGrp="1"/>
+          </p:cNvSpPr>
+          <p:nvPr>
+            <p:ph type="body" idx="1"/>
+          </p:nvPr>
+        </p:nvSpPr>
+        <p:spPr/>
+        <p:txBody>
+          <a:bodyPr xmlns:a="http://schemas.openxmlformats.org/drawingml/2006/main"/>
+          <a:lstStyle xmlns:a="http://schemas.openxmlformats.org/drawingml/2006/main"/>
+          <a:p xmlns:a="http://schemas.openxmlformats.org/drawingml/2006/main">
+            <a:r>
+              <a:t>INERTIA-2026-10-22-r6. Sources: spec.md, testing.md, decisions.md, plan.md. Merged baseline https://github.com/NetRxn/Inertia/commit/1d41eeb70b02275a488a7f7583c116c8d2c77f3c; PR 2 https://github.com/NetRxn/Inertia/pull/2; PR 3 https://github.com/NetRxn/Inertia/pull/3. Paperclip selected public release v2026.1012.0, bba6a45f0d364cfd962ac59b3bdf2426a8222adb. Buzz dc25198d530acc6237a0320b697365f29daf0ea6. PR 4 https://github.com/NetRxn/Inertia/pull/4 and PR 5 https://github.com/NetRxn/Inertia/pull/5 merged. Combined 108 tests, typecheck, build and synthetic demo passed. No private execution-provider source included.</a:t>
             </a:r>
           </a:p>
         </p:txBody>
@@ -915,7 +986,7 @@
           <p:cNvPr id="3" name="Title">
             <a:extLst xmlns:a="http://schemas.openxmlformats.org/drawingml/2006/main">
               <a:ext uri="{FF2B5EF4-FFF2-40B4-BE49-F238E27FC236}">
-                <a16:creationId xmlns:a16="http://schemas.microsoft.com/office/drawing/2014/main" id="{7296E375-8DAF-49D1-B9B8-4D497B8E2C31}"/>
+                <a16:creationId xmlns:a16="http://schemas.microsoft.com/office/drawing/2014/main" id="{BDF0810F-6050-4674-AAA8-ECA143DEEC4D}"/>
               </a:ext>
             </a:extLst>
           </p:cNvPr>
@@ -1072,7 +1143,7 @@
           <p:cNvPr id="2" name="Subtitle">
             <a:extLst xmlns:a="http://schemas.openxmlformats.org/drawingml/2006/main">
               <a:ext uri="{FF2B5EF4-FFF2-40B4-BE49-F238E27FC236}">
-                <a16:creationId xmlns:a16="http://schemas.microsoft.com/office/drawing/2014/main" id="{652AB539-0D1A-4CAD-B305-70F08784E45F}"/>
+                <a16:creationId xmlns:a16="http://schemas.microsoft.com/office/drawing/2014/main" id="{EA6B8F91-5509-4B4B-9C3C-ED80D6C5251B}"/>
               </a:ext>
             </a:extLst>
           </p:cNvPr>
@@ -1246,7 +1317,7 @@
           <p:cNvPr id="2" name="Section title">
             <a:extLst xmlns:a="http://schemas.openxmlformats.org/drawingml/2006/main">
               <a:ext uri="{FF2B5EF4-FFF2-40B4-BE49-F238E27FC236}">
-                <a16:creationId xmlns:a16="http://schemas.microsoft.com/office/drawing/2014/main" id="{5B86BD6A-B536-4CC4-8C31-CACCB918698D}"/>
+                <a16:creationId xmlns:a16="http://schemas.microsoft.com/office/drawing/2014/main" id="{21A9519E-FBF9-43FA-93B2-B31DDA0C141D}"/>
               </a:ext>
             </a:extLst>
           </p:cNvPr>
@@ -1420,7 +1491,7 @@
           <p:cNvPr id="3" name="Title">
             <a:extLst xmlns:a="http://schemas.openxmlformats.org/drawingml/2006/main">
               <a:ext uri="{FF2B5EF4-FFF2-40B4-BE49-F238E27FC236}">
-                <a16:creationId xmlns:a16="http://schemas.microsoft.com/office/drawing/2014/main" id="{57121D69-91E0-4F8C-A577-9E331BFD15C5}"/>
+                <a16:creationId xmlns:a16="http://schemas.microsoft.com/office/drawing/2014/main" id="{EA6BA450-EE2D-498A-B8C5-5E9E63F6AE3B}"/>
               </a:ext>
             </a:extLst>
           </p:cNvPr>
@@ -1577,7 +1648,7 @@
           <p:cNvPr id="2" name="Body">
             <a:extLst xmlns:a="http://schemas.openxmlformats.org/drawingml/2006/main">
               <a:ext uri="{FF2B5EF4-FFF2-40B4-BE49-F238E27FC236}">
-                <a16:creationId xmlns:a16="http://schemas.microsoft.com/office/drawing/2014/main" id="{C6CED398-DBC2-4AE9-B16F-B805668D8822}"/>
+                <a16:creationId xmlns:a16="http://schemas.microsoft.com/office/drawing/2014/main" id="{F1F6EC7A-3BCB-494E-BDF6-A407637FBE5D}"/>
               </a:ext>
             </a:extLst>
           </p:cNvPr>
@@ -1751,7 +1822,7 @@
           <p:cNvPr id="4" name="Title">
             <a:extLst xmlns:a="http://schemas.openxmlformats.org/drawingml/2006/main">
               <a:ext uri="{FF2B5EF4-FFF2-40B4-BE49-F238E27FC236}">
-                <a16:creationId xmlns:a16="http://schemas.microsoft.com/office/drawing/2014/main" id="{C05DE1DC-5B02-4BC9-870C-7990ACEAB626}"/>
+                <a16:creationId xmlns:a16="http://schemas.microsoft.com/office/drawing/2014/main" id="{D8072316-C6BD-4433-8CB6-8ED38FFF9D72}"/>
               </a:ext>
             </a:extLst>
           </p:cNvPr>
@@ -1908,7 +1979,7 @@
           <p:cNvPr id="2" name="Left column">
             <a:extLst xmlns:a="http://schemas.openxmlformats.org/drawingml/2006/main">
               <a:ext uri="{FF2B5EF4-FFF2-40B4-BE49-F238E27FC236}">
-                <a16:creationId xmlns:a16="http://schemas.microsoft.com/office/drawing/2014/main" id="{AE6C1047-B568-43DD-82A9-87C43A65FF20}"/>
+                <a16:creationId xmlns:a16="http://schemas.microsoft.com/office/drawing/2014/main" id="{8365BC37-D593-4BE1-B8B4-A612C93CFD8E}"/>
               </a:ext>
             </a:extLst>
           </p:cNvPr>
@@ -2065,7 +2136,7 @@
           <p:cNvPr id="3" name="Right column">
             <a:extLst xmlns:a="http://schemas.openxmlformats.org/drawingml/2006/main">
               <a:ext uri="{FF2B5EF4-FFF2-40B4-BE49-F238E27FC236}">
-                <a16:creationId xmlns:a16="http://schemas.microsoft.com/office/drawing/2014/main" id="{56E3E9C7-2112-469E-BC77-56D947FE140A}"/>
+                <a16:creationId xmlns:a16="http://schemas.microsoft.com/office/drawing/2014/main" id="{979E7B16-753E-4015-8000-450742DCD271}"/>
               </a:ext>
             </a:extLst>
           </p:cNvPr>
@@ -2239,7 +2310,7 @@
           <p:cNvPr id="3" name="Title">
             <a:extLst xmlns:a="http://schemas.openxmlformats.org/drawingml/2006/main">
               <a:ext uri="{FF2B5EF4-FFF2-40B4-BE49-F238E27FC236}">
-                <a16:creationId xmlns:a16="http://schemas.microsoft.com/office/drawing/2014/main" id="{3DED7CBB-3927-4608-B3FD-395C26DD1670}"/>
+                <a16:creationId xmlns:a16="http://schemas.microsoft.com/office/drawing/2014/main" id="{6443D337-3BC4-4995-A4E6-5F85B907D525}"/>
               </a:ext>
             </a:extLst>
           </p:cNvPr>
@@ -2396,7 +2467,7 @@
           <p:cNvPr id="2" name="Left column">
             <a:extLst xmlns:a="http://schemas.openxmlformats.org/drawingml/2006/main">
               <a:ext uri="{FF2B5EF4-FFF2-40B4-BE49-F238E27FC236}">
-                <a16:creationId xmlns:a16="http://schemas.microsoft.com/office/drawing/2014/main" id="{43652C21-222F-45C1-92D2-E4E5C9EB3863}"/>
+                <a16:creationId xmlns:a16="http://schemas.microsoft.com/office/drawing/2014/main" id="{B4349902-5219-49E5-9EF2-5FD7115225ED}"/>
               </a:ext>
             </a:extLst>
           </p:cNvPr>
@@ -2591,12 +2662,12 @@
   </p:cSld>
   <p:clrMap bg1="lt1" tx1="dk1" bg2="lt2" tx2="dk2" accent1="accent1" accent2="accent2" accent3="accent3" accent4="accent4" accent5="accent5" accent6="accent6" hlink="hlink" folHlink="folHlink"/>
   <p:sldLayoutIdLst>
-    <p:sldLayoutId xmlns:r="http://schemas.openxmlformats.org/officeDocument/2006/relationships" id="2147483649" r:id="R6e1d382a9f844b7c"/>
-    <p:sldLayoutId xmlns:r="http://schemas.openxmlformats.org/officeDocument/2006/relationships" id="2147483650" r:id="R80faeb746418477c"/>
-    <p:sldLayoutId xmlns:r="http://schemas.openxmlformats.org/officeDocument/2006/relationships" id="2147483651" r:id="Rcec9c4c97530455a"/>
-    <p:sldLayoutId xmlns:r="http://schemas.openxmlformats.org/officeDocument/2006/relationships" id="2147483652" r:id="R72f278bcceab47f9"/>
-    <p:sldLayoutId xmlns:r="http://schemas.openxmlformats.org/officeDocument/2006/relationships" id="2147483653" r:id="Rea35dcf0d8a64f00"/>
-    <p:sldLayoutId xmlns:r="http://schemas.openxmlformats.org/officeDocument/2006/relationships" id="2147483654" r:id="R1eb39f78f78f4c9d"/>
+    <p:sldLayoutId xmlns:r="http://schemas.openxmlformats.org/officeDocument/2006/relationships" id="2147483649" r:id="R8c57d72e0bc3468b"/>
+    <p:sldLayoutId xmlns:r="http://schemas.openxmlformats.org/officeDocument/2006/relationships" id="2147483650" r:id="R0293d6e23782453b"/>
+    <p:sldLayoutId xmlns:r="http://schemas.openxmlformats.org/officeDocument/2006/relationships" id="2147483651" r:id="Rf00b4e3903384bd5"/>
+    <p:sldLayoutId xmlns:r="http://schemas.openxmlformats.org/officeDocument/2006/relationships" id="2147483652" r:id="Rb962b177267a48d7"/>
+    <p:sldLayoutId xmlns:r="http://schemas.openxmlformats.org/officeDocument/2006/relationships" id="2147483653" r:id="R3057f58f9b084090"/>
+    <p:sldLayoutId xmlns:r="http://schemas.openxmlformats.org/officeDocument/2006/relationships" id="2147483654" r:id="Rcd59f86f3a4d47b2"/>
   </p:sldLayoutIdLst>
   <p:txStyles>
     <p:titleStyle>
@@ -3147,7 +3218,7 @@
           <p:cNvPr id="17" name="">
             <a:extLst xmlns:a="http://schemas.openxmlformats.org/drawingml/2006/main">
               <a:ext uri="{FF2B5EF4-FFF2-40B4-BE49-F238E27FC236}">
-                <a16:creationId xmlns:a16="http://schemas.microsoft.com/office/drawing/2014/main" id="{1A6643E8-4A51-44FF-96C5-984E3B8768E3}"/>
+                <a16:creationId xmlns:a16="http://schemas.microsoft.com/office/drawing/2014/main" id="{18F0D5F2-C12D-4E15-A331-126E9EC351DF}"/>
               </a:ext>
             </a:extLst>
           </p:cNvPr>
@@ -3214,7 +3285,7 @@
           <p:cNvPr id="2" name="">
             <a:extLst xmlns:a="http://schemas.openxmlformats.org/drawingml/2006/main">
               <a:ext uri="{FF2B5EF4-FFF2-40B4-BE49-F238E27FC236}">
-                <a16:creationId xmlns:a16="http://schemas.microsoft.com/office/drawing/2014/main" id="{55DAEA9F-5337-4E4B-BDE6-1A7387D93D3F}"/>
+                <a16:creationId xmlns:a16="http://schemas.microsoft.com/office/drawing/2014/main" id="{9CB2C3C6-B61A-430B-8269-DCA1A8055E42}"/>
               </a:ext>
             </a:extLst>
           </p:cNvPr>
@@ -3271,7 +3342,7 @@
                 <a:ea typeface="Aptos"/>
                 <a:cs typeface="Aptos"/>
               </a:rPr>
-              <a:t>One operating platform, two interfaces</a:t>
+              <a:t>Inertia makes DAO work easier</a:t>
             </a:r>
           </a:p>
         </p:txBody>
@@ -3281,7 +3352,7 @@
           <p:cNvPr id="3" name="">
             <a:extLst xmlns:a="http://schemas.openxmlformats.org/drawingml/2006/main">
               <a:ext uri="{FF2B5EF4-FFF2-40B4-BE49-F238E27FC236}">
-                <a16:creationId xmlns:a16="http://schemas.microsoft.com/office/drawing/2014/main" id="{CB76819D-1D9F-4E1B-B252-AEFD74D96CF7}"/>
+                <a16:creationId xmlns:a16="http://schemas.microsoft.com/office/drawing/2014/main" id="{D954B08E-70D2-48D4-BD99-32420D842391}"/>
               </a:ext>
             </a:extLst>
           </p:cNvPr>
@@ -3338,7 +3409,7 @@
                 <a:ea typeface="Aptos"/>
                 <a:cs typeface="Aptos"/>
               </a:rPr>
-              <a:t>Paperclip owns the work. Buzz and the dashboard present the same tasks, hierarchy and decisions.</a:t>
+              <a:t>One shared work system, with Buzz and the Paperclip dashboard as equal entry points.</a:t>
             </a:r>
           </a:p>
         </p:txBody>
@@ -3348,7 +3419,7 @@
           <p:cNvPr id="4" name="">
             <a:extLst xmlns:a="http://schemas.openxmlformats.org/drawingml/2006/main">
               <a:ext uri="{FF2B5EF4-FFF2-40B4-BE49-F238E27FC236}">
-                <a16:creationId xmlns:a16="http://schemas.microsoft.com/office/drawing/2014/main" id="{736E4F01-69B6-42F2-9C9F-B71E671D34CE}"/>
+                <a16:creationId xmlns:a16="http://schemas.microsoft.com/office/drawing/2014/main" id="{8CAD2439-400F-47B7-BC8B-1B191BA7BD9C}"/>
               </a:ext>
             </a:extLst>
           </p:cNvPr>
@@ -3379,7 +3450,7 @@
           <p:cNvPr id="5" name="">
             <a:extLst xmlns:a="http://schemas.openxmlformats.org/drawingml/2006/main">
               <a:ext uri="{FF2B5EF4-FFF2-40B4-BE49-F238E27FC236}">
-                <a16:creationId xmlns:a16="http://schemas.microsoft.com/office/drawing/2014/main" id="{C97B2F2F-AEFD-4A06-A67F-20F6C003455F}"/>
+                <a16:creationId xmlns:a16="http://schemas.microsoft.com/office/drawing/2014/main" id="{E6203AED-F4B7-4FAC-8669-B1DE88056755}"/>
               </a:ext>
             </a:extLst>
           </p:cNvPr>
@@ -3436,7 +3507,7 @@
                 <a:ea typeface="Aptos"/>
                 <a:cs typeface="Aptos"/>
               </a:rPr>
-              <a:t>INERTIA-2026-10-22-r5 · 22 October 2026 · Design refinement · Compatibility first</a:t>
+              <a:t>INERTIA-2026-10-22-r6 · 22 October 2026 · Autonomous build</a:t>
             </a:r>
           </a:p>
         </p:txBody>
@@ -3446,7 +3517,7 @@
           <p:cNvPr id="6" name="">
             <a:extLst xmlns:a="http://schemas.openxmlformats.org/drawingml/2006/main">
               <a:ext uri="{FF2B5EF4-FFF2-40B4-BE49-F238E27FC236}">
-                <a16:creationId xmlns:a16="http://schemas.microsoft.com/office/drawing/2014/main" id="{A8FBA034-4D2C-4B83-A1C8-101533A13A70}"/>
+                <a16:creationId xmlns:a16="http://schemas.microsoft.com/office/drawing/2014/main" id="{AE2EC293-047E-4D0D-9C76-830648911ED9}"/>
               </a:ext>
             </a:extLst>
           </p:cNvPr>
@@ -3513,7 +3584,7 @@
           <p:cNvPr id="7" name="">
             <a:extLst xmlns:a="http://schemas.openxmlformats.org/drawingml/2006/main">
               <a:ext uri="{FF2B5EF4-FFF2-40B4-BE49-F238E27FC236}">
-                <a16:creationId xmlns:a16="http://schemas.microsoft.com/office/drawing/2014/main" id="{3AB2933E-4012-4530-99E1-4548AC116B37}"/>
+                <a16:creationId xmlns:a16="http://schemas.microsoft.com/office/drawing/2014/main" id="{43EBA0A8-A765-42A6-BFC7-70FD9067A607}"/>
               </a:ext>
             </a:extLst>
           </p:cNvPr>
@@ -3546,7 +3617,7 @@
           <p:cNvPr id="8" name="">
             <a:extLst xmlns:a="http://schemas.openxmlformats.org/drawingml/2006/main">
               <a:ext uri="{FF2B5EF4-FFF2-40B4-BE49-F238E27FC236}">
-                <a16:creationId xmlns:a16="http://schemas.microsoft.com/office/drawing/2014/main" id="{5CE5D347-45B9-4800-A344-607494CB0D59}"/>
+                <a16:creationId xmlns:a16="http://schemas.microsoft.com/office/drawing/2014/main" id="{5B315368-6FA2-4C94-BE4C-90CC68B031EF}"/>
               </a:ext>
             </a:extLst>
           </p:cNvPr>
@@ -3603,7 +3674,7 @@
                 <a:ea typeface="Aptos"/>
                 <a:cs typeface="Aptos"/>
               </a:rPr>
-              <a:t>Paperclip operations</a:t>
+              <a:t>Automatic meetings</a:t>
             </a:r>
           </a:p>
         </p:txBody>
@@ -3613,7 +3684,7 @@
           <p:cNvPr id="9" name="">
             <a:extLst xmlns:a="http://schemas.openxmlformats.org/drawingml/2006/main">
               <a:ext uri="{FF2B5EF4-FFF2-40B4-BE49-F238E27FC236}">
-                <a16:creationId xmlns:a16="http://schemas.microsoft.com/office/drawing/2014/main" id="{52944F71-DB82-426A-ADE6-E2252C955CB7}"/>
+                <a16:creationId xmlns:a16="http://schemas.microsoft.com/office/drawing/2014/main" id="{1979C0B7-880F-4130-8A84-708C4C367E41}"/>
               </a:ext>
             </a:extLst>
           </p:cNvPr>
@@ -3670,7 +3741,7 @@
                 <a:ea typeface="Aptos"/>
                 <a:cs typeface="Aptos"/>
               </a:rPr>
-              <a:t>CEO and hiring</a:t>
+              <a:t>Gemini output in Drive</a:t>
             </a:r>
           </a:p>
           <a:p xmlns:a="http://schemas.openxmlformats.org/drawingml/2006/main">
@@ -3693,7 +3764,7 @@
                 <a:ea typeface="Aptos"/>
                 <a:cs typeface="Aptos"/>
               </a:rPr>
-              <a:t>Goals, issues and dependencies</a:t>
+              <a:t>Clean transcript and notes</a:t>
             </a:r>
           </a:p>
           <a:p xmlns:a="http://schemas.openxmlformats.org/drawingml/2006/main">
@@ -3716,7 +3787,7 @@
                 <a:ea typeface="Aptos"/>
                 <a:cs typeface="Aptos"/>
               </a:rPr>
-              <a:t>Native checkout and routines</a:t>
+              <a:t>Verified website publication</a:t>
             </a:r>
           </a:p>
           <a:p xmlns:a="http://schemas.openxmlformats.org/drawingml/2006/main">
@@ -3739,7 +3810,7 @@
                 <a:ea typeface="Aptos"/>
                 <a:cs typeface="Aptos"/>
               </a:rPr>
-              <a:t>Decisions, documents and budgets</a:t>
+              <a:t>Links back to the conversation</a:t>
             </a:r>
           </a:p>
         </p:txBody>
@@ -3749,7 +3820,7 @@
           <p:cNvPr id="10" name="">
             <a:extLst xmlns:a="http://schemas.openxmlformats.org/drawingml/2006/main">
               <a:ext uri="{FF2B5EF4-FFF2-40B4-BE49-F238E27FC236}">
-                <a16:creationId xmlns:a16="http://schemas.microsoft.com/office/drawing/2014/main" id="{0178DA48-5590-45CE-BF05-1F4E8F7D03BC}"/>
+                <a16:creationId xmlns:a16="http://schemas.microsoft.com/office/drawing/2014/main" id="{9DAF82BC-8350-4090-B196-DFE9144D3C03}"/>
               </a:ext>
             </a:extLst>
           </p:cNvPr>
@@ -3782,7 +3853,7 @@
           <p:cNvPr id="11" name="">
             <a:extLst xmlns:a="http://schemas.openxmlformats.org/drawingml/2006/main">
               <a:ext uri="{FF2B5EF4-FFF2-40B4-BE49-F238E27FC236}">
-                <a16:creationId xmlns:a16="http://schemas.microsoft.com/office/drawing/2014/main" id="{7FF019C3-174B-4453-9A5D-2E6A21950F9F}"/>
+                <a16:creationId xmlns:a16="http://schemas.microsoft.com/office/drawing/2014/main" id="{FB37A1F1-3FD0-4275-BCC6-12F1BA5DF000}"/>
               </a:ext>
             </a:extLst>
           </p:cNvPr>
@@ -3839,7 +3910,7 @@
                 <a:ea typeface="Aptos"/>
                 <a:cs typeface="Aptos"/>
               </a:rPr>
-              <a:t>Buzz + dashboard</a:t>
+              <a:t>Current grant packet</a:t>
             </a:r>
           </a:p>
         </p:txBody>
@@ -3849,7 +3920,7 @@
           <p:cNvPr id="12" name="">
             <a:extLst xmlns:a="http://schemas.openxmlformats.org/drawingml/2006/main">
               <a:ext uri="{FF2B5EF4-FFF2-40B4-BE49-F238E27FC236}">
-                <a16:creationId xmlns:a16="http://schemas.microsoft.com/office/drawing/2014/main" id="{F265AD85-E06A-4221-9FBE-CB232796A3E2}"/>
+                <a16:creationId xmlns:a16="http://schemas.microsoft.com/office/drawing/2014/main" id="{88C78972-E46C-4B6F-BC16-BE2DAAC57BE9}"/>
               </a:ext>
             </a:extLst>
           </p:cNvPr>
@@ -3906,7 +3977,7 @@
                 <a:ea typeface="Aptos"/>
                 <a:cs typeface="Aptos"/>
               </a:rPr>
-              <a:t>Shared task and interaction IDs</a:t>
+              <a:t>Existing scanner discovers</a:t>
             </a:r>
           </a:p>
           <a:p xmlns:a="http://schemas.openxmlformats.org/drawingml/2006/main">
@@ -3929,7 +4000,7 @@
                 <a:ea typeface="Aptos"/>
                 <a:cs typeface="Aptos"/>
               </a:rPr>
-              <a:t>Explicit human / agent pairing</a:t>
+              <a:t>Team reviews the application</a:t>
             </a:r>
           </a:p>
           <a:p xmlns:a="http://schemas.openxmlformats.org/drawingml/2006/main">
@@ -3952,7 +4023,7 @@
                 <a:ea typeface="Aptos"/>
                 <a:cs typeface="Aptos"/>
               </a:rPr>
-              <a:t>Bidirectional results and decisions</a:t>
+              <a:t>Blockchain vote binds the packet</a:t>
             </a:r>
           </a:p>
           <a:p xmlns:a="http://schemas.openxmlformats.org/drawingml/2006/main">
@@ -3975,7 +4046,7 @@
                 <a:ea typeface="Aptos"/>
                 <a:cs typeface="Aptos"/>
               </a:rPr>
-              <a:t>One execution owner</a:t>
+              <a:t>Y2 keeps interests current</a:t>
             </a:r>
           </a:p>
         </p:txBody>
@@ -3985,7 +4056,7 @@
           <p:cNvPr id="13" name="">
             <a:extLst xmlns:a="http://schemas.openxmlformats.org/drawingml/2006/main">
               <a:ext uri="{FF2B5EF4-FFF2-40B4-BE49-F238E27FC236}">
-                <a16:creationId xmlns:a16="http://schemas.microsoft.com/office/drawing/2014/main" id="{0625D2DD-B817-4FBB-ABD9-5780838688BD}"/>
+                <a16:creationId xmlns:a16="http://schemas.microsoft.com/office/drawing/2014/main" id="{BE83E02F-EDCA-455C-B07A-662C6CD036C9}"/>
               </a:ext>
             </a:extLst>
           </p:cNvPr>
@@ -4018,7 +4089,7 @@
           <p:cNvPr id="14" name="">
             <a:extLst xmlns:a="http://schemas.openxmlformats.org/drawingml/2006/main">
               <a:ext uri="{FF2B5EF4-FFF2-40B4-BE49-F238E27FC236}">
-                <a16:creationId xmlns:a16="http://schemas.microsoft.com/office/drawing/2014/main" id="{9603F2C3-A3A5-4F4D-A8C2-39C668F1CAF2}"/>
+                <a16:creationId xmlns:a16="http://schemas.microsoft.com/office/drawing/2014/main" id="{88EFBBB1-2A79-4490-84C5-A53A01473DEE}"/>
               </a:ext>
             </a:extLst>
           </p:cNvPr>
@@ -4075,7 +4146,7 @@
                 <a:ea typeface="Aptos"/>
                 <a:cs typeface="Aptos"/>
               </a:rPr>
-              <a:t>Domain integrations</a:t>
+              <a:t>Member spare capacity</a:t>
             </a:r>
           </a:p>
         </p:txBody>
@@ -4085,7 +4156,7 @@
           <p:cNvPr id="15" name="">
             <a:extLst xmlns:a="http://schemas.openxmlformats.org/drawingml/2006/main">
               <a:ext uri="{FF2B5EF4-FFF2-40B4-BE49-F238E27FC236}">
-                <a16:creationId xmlns:a16="http://schemas.microsoft.com/office/drawing/2014/main" id="{B0940CE0-147C-472D-BAC6-039E39242DE1}"/>
+                <a16:creationId xmlns:a16="http://schemas.microsoft.com/office/drawing/2014/main" id="{ED9D4108-5BBB-4249-9AC9-1CE09E26B5E4}"/>
               </a:ext>
             </a:extLst>
           </p:cNvPr>
@@ -4142,7 +4213,7 @@
                 <a:ea typeface="Aptos"/>
                 <a:cs typeface="Aptos"/>
               </a:rPr>
-              <a:t>Meetings → DAO publication</a:t>
+              <a:t>Connect an authorized agent</a:t>
             </a:r>
           </a:p>
           <a:p xmlns:a="http://schemas.openxmlformats.org/drawingml/2006/main">
@@ -4165,7 +4236,7 @@
                 <a:ea typeface="Aptos"/>
                 <a:cs typeface="Aptos"/>
               </a:rPr>
-              <a:t>Scanner → packet-bound vote</a:t>
+              <a:t>Acquire eligible work eagerly</a:t>
             </a:r>
           </a:p>
           <a:p xmlns:a="http://schemas.openxmlformats.org/drawingml/2006/main">
@@ -4188,7 +4259,7 @@
                 <a:ea typeface="Aptos"/>
                 <a:cs typeface="Aptos"/>
               </a:rPr>
-              <a:t>Member agents → contributions</a:t>
+              <a:t>Return a validated contribution</a:t>
             </a:r>
           </a:p>
           <a:p xmlns:a="http://schemas.openxmlformats.org/drawingml/2006/main">
@@ -4211,7 +4282,7 @@
                 <a:ea typeface="Aptos"/>
                 <a:cs typeface="Aptos"/>
               </a:rPr>
-              <a:t>Y2 updates → linked work</a:t>
+              <a:t>Continue useful follow-ups</a:t>
             </a:r>
           </a:p>
         </p:txBody>
@@ -4221,7 +4292,7 @@
           <p:cNvPr id="16" name="">
             <a:extLst xmlns:a="http://schemas.openxmlformats.org/drawingml/2006/main">
               <a:ext uri="{FF2B5EF4-FFF2-40B4-BE49-F238E27FC236}">
-                <a16:creationId xmlns:a16="http://schemas.microsoft.com/office/drawing/2014/main" id="{FA75D7A4-C2AF-4551-88A8-D86CB47239C3}"/>
+                <a16:creationId xmlns:a16="http://schemas.microsoft.com/office/drawing/2014/main" id="{46AD2712-6E4F-481F-8740-D011F03C8708}"/>
               </a:ext>
             </a:extLst>
           </p:cNvPr>
@@ -4278,7 +4349,7 @@
                 <a:ea typeface="Aptos"/>
                 <a:cs typeface="Aptos"/>
               </a:rPr>
-              <a:t>Design rule: reuse native capabilities and existing execution hardening before adding custom infrastructure.</a:t>
+              <a:t>Required demo outcomes: meeting publication, a packet-bound vote and a second member’s contribution.</a:t>
             </a:r>
           </a:p>
         </p:txBody>
@@ -4286,7 +4357,7 @@
     </p:spTree>
     <p:extLst>
       <p:ext uri="{BB962C8B-B14F-4D97-AF65-F5344CB8AC3E}">
-        <p14:creationId xmlns:p14="http://schemas.microsoft.com/office/powerpoint/2010/main" val="1300162236"/>
+        <p14:creationId xmlns:p14="http://schemas.microsoft.com/office/powerpoint/2010/main" val="210611669"/>
       </p:ext>
     </p:extLst>
   </p:cSld>
@@ -4317,7 +4388,7 @@
           <p:cNvPr id="17" name="">
             <a:extLst xmlns:a="http://schemas.openxmlformats.org/drawingml/2006/main">
               <a:ext uri="{FF2B5EF4-FFF2-40B4-BE49-F238E27FC236}">
-                <a16:creationId xmlns:a16="http://schemas.microsoft.com/office/drawing/2014/main" id="{2374D608-470A-4F36-9D2B-C16B31545796}"/>
+                <a16:creationId xmlns:a16="http://schemas.microsoft.com/office/drawing/2014/main" id="{7FDB1E3D-14E6-4B82-BA03-F8C55EC22F4A}"/>
               </a:ext>
             </a:extLst>
           </p:cNvPr>
@@ -4384,7 +4455,7 @@
           <p:cNvPr id="2" name="">
             <a:extLst xmlns:a="http://schemas.openxmlformats.org/drawingml/2006/main">
               <a:ext uri="{FF2B5EF4-FFF2-40B4-BE49-F238E27FC236}">
-                <a16:creationId xmlns:a16="http://schemas.microsoft.com/office/drawing/2014/main" id="{77652950-3C07-406E-A543-F35860EDEBC8}"/>
+                <a16:creationId xmlns:a16="http://schemas.microsoft.com/office/drawing/2014/main" id="{447186F9-1F90-452E-B2CC-2B9C61F25805}"/>
               </a:ext>
             </a:extLst>
           </p:cNvPr>
@@ -4441,7 +4512,7 @@
                 <a:ea typeface="Aptos"/>
                 <a:cs typeface="Aptos"/>
               </a:rPr>
-              <a:t>Automatic Roundtable publication</a:t>
+              <a:t>Paperclip owns the operating model</a:t>
             </a:r>
           </a:p>
         </p:txBody>
@@ -4451,7 +4522,7 @@
           <p:cNvPr id="3" name="">
             <a:extLst xmlns:a="http://schemas.openxmlformats.org/drawingml/2006/main">
               <a:ext uri="{FF2B5EF4-FFF2-40B4-BE49-F238E27FC236}">
-                <a16:creationId xmlns:a16="http://schemas.microsoft.com/office/drawing/2014/main" id="{7A740A9A-3817-4C6B-9E44-A9FA5F78C887}"/>
+                <a16:creationId xmlns:a16="http://schemas.microsoft.com/office/drawing/2014/main" id="{892CFB54-6CB7-4E30-B7A0-879E1B639ED8}"/>
               </a:ext>
             </a:extLst>
           </p:cNvPr>
@@ -4508,7 +4579,7 @@
                 <a:ea typeface="Aptos"/>
                 <a:cs typeface="Aptos"/>
               </a:rPr>
-              <a:t>Meet video → Gemini → organization Drive → cleaned transcript and separate notes → DAO website.</a:t>
+              <a:t>Reuse the platform’s CEO, hiring, hierarchy and execution primitives.</a:t>
             </a:r>
           </a:p>
         </p:txBody>
@@ -4518,7 +4589,7 @@
           <p:cNvPr id="4" name="">
             <a:extLst xmlns:a="http://schemas.openxmlformats.org/drawingml/2006/main">
               <a:ext uri="{FF2B5EF4-FFF2-40B4-BE49-F238E27FC236}">
-                <a16:creationId xmlns:a16="http://schemas.microsoft.com/office/drawing/2014/main" id="{4CBA3F52-B7F9-4DD3-AEEE-DD6D4E611EE4}"/>
+                <a16:creationId xmlns:a16="http://schemas.microsoft.com/office/drawing/2014/main" id="{79822DEE-9BDB-4B9F-95D2-08D03800DC42}"/>
               </a:ext>
             </a:extLst>
           </p:cNvPr>
@@ -4549,7 +4620,7 @@
           <p:cNvPr id="5" name="">
             <a:extLst xmlns:a="http://schemas.openxmlformats.org/drawingml/2006/main">
               <a:ext uri="{FF2B5EF4-FFF2-40B4-BE49-F238E27FC236}">
-                <a16:creationId xmlns:a16="http://schemas.microsoft.com/office/drawing/2014/main" id="{80B010E9-6791-418F-8641-F34D3924342A}"/>
+                <a16:creationId xmlns:a16="http://schemas.microsoft.com/office/drawing/2014/main" id="{87B22CF7-2F37-4043-A998-159758858DE7}"/>
               </a:ext>
             </a:extLst>
           </p:cNvPr>
@@ -4606,7 +4677,7 @@
                 <a:ea typeface="Aptos"/>
                 <a:cs typeface="Aptos"/>
               </a:rPr>
-              <a:t>INERTIA-2026-10-22-r5 · 22 October 2026 · Design refinement · Compatibility first</a:t>
+              <a:t>INERTIA-2026-10-22-r6 · 22 October 2026 · Autonomous build</a:t>
             </a:r>
           </a:p>
         </p:txBody>
@@ -4616,7 +4687,7 @@
           <p:cNvPr id="6" name="">
             <a:extLst xmlns:a="http://schemas.openxmlformats.org/drawingml/2006/main">
               <a:ext uri="{FF2B5EF4-FFF2-40B4-BE49-F238E27FC236}">
-                <a16:creationId xmlns:a16="http://schemas.microsoft.com/office/drawing/2014/main" id="{D090FA42-C48D-4CD7-A1EA-68E9FF5EB2BF}"/>
+                <a16:creationId xmlns:a16="http://schemas.microsoft.com/office/drawing/2014/main" id="{9670D08E-CA51-4233-B455-D689C0422AF0}"/>
               </a:ext>
             </a:extLst>
           </p:cNvPr>
@@ -4683,7 +4754,7 @@
           <p:cNvPr id="7" name="">
             <a:extLst xmlns:a="http://schemas.openxmlformats.org/drawingml/2006/main">
               <a:ext uri="{FF2B5EF4-FFF2-40B4-BE49-F238E27FC236}">
-                <a16:creationId xmlns:a16="http://schemas.microsoft.com/office/drawing/2014/main" id="{DA81D690-10BE-4A88-93D8-A06C4B62E112}"/>
+                <a16:creationId xmlns:a16="http://schemas.microsoft.com/office/drawing/2014/main" id="{1E44DB16-86B0-4A3A-B776-408D486ABCC7}"/>
               </a:ext>
             </a:extLst>
           </p:cNvPr>
@@ -4716,7 +4787,7 @@
           <p:cNvPr id="8" name="">
             <a:extLst xmlns:a="http://schemas.openxmlformats.org/drawingml/2006/main">
               <a:ext uri="{FF2B5EF4-FFF2-40B4-BE49-F238E27FC236}">
-                <a16:creationId xmlns:a16="http://schemas.microsoft.com/office/drawing/2014/main" id="{4A06A3F9-262F-404A-A441-6E18E7EC691B}"/>
+                <a16:creationId xmlns:a16="http://schemas.microsoft.com/office/drawing/2014/main" id="{CAB656FB-4476-44A8-9041-21949A6D60B1}"/>
               </a:ext>
             </a:extLst>
           </p:cNvPr>
@@ -4773,7 +4844,7 @@
                 <a:ea typeface="Aptos"/>
                 <a:cs typeface="Aptos"/>
               </a:rPr>
-              <a:t>Observe + preserve</a:t>
+              <a:t>Native platform</a:t>
             </a:r>
           </a:p>
         </p:txBody>
@@ -4783,7 +4854,7 @@
           <p:cNvPr id="9" name="">
             <a:extLst xmlns:a="http://schemas.openxmlformats.org/drawingml/2006/main">
               <a:ext uri="{FF2B5EF4-FFF2-40B4-BE49-F238E27FC236}">
-                <a16:creationId xmlns:a16="http://schemas.microsoft.com/office/drawing/2014/main" id="{72312766-2657-48C8-B0E0-5B788AF61E1F}"/>
+                <a16:creationId xmlns:a16="http://schemas.microsoft.com/office/drawing/2014/main" id="{06EA6574-CEA2-48F0-8CE6-A9322B137457}"/>
               </a:ext>
             </a:extLst>
           </p:cNvPr>
@@ -4840,7 +4911,7 @@
                 <a:ea typeface="Aptos"/>
                 <a:cs typeface="Aptos"/>
               </a:rPr>
-              <a:t>Authorized ready source</a:t>
+              <a:t>Goals, issues and dependencies</a:t>
             </a:r>
           </a:p>
           <a:p xmlns:a="http://schemas.openxmlformats.org/drawingml/2006/main">
@@ -4863,7 +4934,7 @@
                 <a:ea typeface="Aptos"/>
                 <a:cs typeface="Aptos"/>
               </a:rPr>
-              <a:t>Meeting ID, revision and hash</a:t>
+              <a:t>Hiring and policy permissions</a:t>
             </a:r>
           </a:p>
           <a:p xmlns:a="http://schemas.openxmlformats.org/drawingml/2006/main">
@@ -4886,7 +4957,7 @@
                 <a:ea typeface="Aptos"/>
                 <a:cs typeface="Aptos"/>
               </a:rPr>
-              <a:t>Original retained</a:t>
+              <a:t>Checkout, runs and budgets</a:t>
             </a:r>
           </a:p>
           <a:p xmlns:a="http://schemas.openxmlformats.org/drawingml/2006/main">
@@ -4909,7 +4980,7 @@
                 <a:ea typeface="Aptos"/>
                 <a:cs typeface="Aptos"/>
               </a:rPr>
-              <a:t>Summary-only exception</a:t>
+              <a:t>Documents and human decisions</a:t>
             </a:r>
           </a:p>
         </p:txBody>
@@ -4919,7 +4990,7 @@
           <p:cNvPr id="10" name="">
             <a:extLst xmlns:a="http://schemas.openxmlformats.org/drawingml/2006/main">
               <a:ext uri="{FF2B5EF4-FFF2-40B4-BE49-F238E27FC236}">
-                <a16:creationId xmlns:a16="http://schemas.microsoft.com/office/drawing/2014/main" id="{172D4A56-340B-4307-A853-D85B16CD34FE}"/>
+                <a16:creationId xmlns:a16="http://schemas.microsoft.com/office/drawing/2014/main" id="{2309BDC6-461C-45CA-B060-03EEB742AB3D}"/>
               </a:ext>
             </a:extLst>
           </p:cNvPr>
@@ -4952,7 +5023,7 @@
           <p:cNvPr id="11" name="">
             <a:extLst xmlns:a="http://schemas.openxmlformats.org/drawingml/2006/main">
               <a:ext uri="{FF2B5EF4-FFF2-40B4-BE49-F238E27FC236}">
-                <a16:creationId xmlns:a16="http://schemas.microsoft.com/office/drawing/2014/main" id="{4BF90455-1471-467C-BDFF-4A3E774CC8B8}"/>
+                <a16:creationId xmlns:a16="http://schemas.microsoft.com/office/drawing/2014/main" id="{C8968B24-F8F6-446A-801A-08FDEFAE1C68}"/>
               </a:ext>
             </a:extLst>
           </p:cNvPr>
@@ -5009,7 +5080,7 @@
                 <a:ea typeface="Aptos"/>
                 <a:cs typeface="Aptos"/>
               </a:rPr>
-              <a:t>Transform + publish</a:t>
+              <a:t>Thin Buzz bridge</a:t>
             </a:r>
           </a:p>
         </p:txBody>
@@ -5019,7 +5090,7 @@
           <p:cNvPr id="12" name="">
             <a:extLst xmlns:a="http://schemas.openxmlformats.org/drawingml/2006/main">
               <a:ext uri="{FF2B5EF4-FFF2-40B4-BE49-F238E27FC236}">
-                <a16:creationId xmlns:a16="http://schemas.microsoft.com/office/drawing/2014/main" id="{C4FAA448-2019-4765-971E-0A11690272A7}"/>
+                <a16:creationId xmlns:a16="http://schemas.microsoft.com/office/drawing/2014/main" id="{58A10BD4-424D-4F69-877C-BCB1DF973486}"/>
               </a:ext>
             </a:extLst>
           </p:cNvPr>
@@ -5076,7 +5147,7 @@
                 <a:ea typeface="Aptos"/>
                 <a:cs typeface="Aptos"/>
               </a:rPr>
-              <a:t>Faithful cleaned transcript</a:t>
+              <a:t>Signed requests and identity</a:t>
             </a:r>
           </a:p>
           <a:p xmlns:a="http://schemas.openxmlformats.org/drawingml/2006/main">
@@ -5099,7 +5170,7 @@
                 <a:ea typeface="Aptos"/>
                 <a:cs typeface="Aptos"/>
               </a:rPr>
-              <a:t>Source-linked notes and actions</a:t>
+              <a:t>Existing native task IDs</a:t>
             </a:r>
           </a:p>
           <a:p xmlns:a="http://schemas.openxmlformats.org/drawingml/2006/main">
@@ -5122,7 +5193,7 @@
                 <a:ea typeface="Aptos"/>
                 <a:cs typeface="Aptos"/>
               </a:rPr>
-              <a:t>Fixed audience and policy</a:t>
+              <a:t>Shared decisions and receipts</a:t>
             </a:r>
           </a:p>
           <a:p xmlns:a="http://schemas.openxmlformats.org/drawingml/2006/main">
@@ -5145,7 +5216,7 @@
                 <a:ea typeface="Aptos"/>
                 <a:cs typeface="Aptos"/>
               </a:rPr>
-              <a:t>Automatic in-policy upsert</a:t>
+              <a:t>Durable delivery recovery</a:t>
             </a:r>
           </a:p>
         </p:txBody>
@@ -5155,7 +5226,7 @@
           <p:cNvPr id="13" name="">
             <a:extLst xmlns:a="http://schemas.openxmlformats.org/drawingml/2006/main">
               <a:ext uri="{FF2B5EF4-FFF2-40B4-BE49-F238E27FC236}">
-                <a16:creationId xmlns:a16="http://schemas.microsoft.com/office/drawing/2014/main" id="{1F2C7741-A4DE-4B3F-AAAC-1CBA38BBBADF}"/>
+                <a16:creationId xmlns:a16="http://schemas.microsoft.com/office/drawing/2014/main" id="{9AB4E859-0FAF-4674-AB2F-3EDE7D329C90}"/>
               </a:ext>
             </a:extLst>
           </p:cNvPr>
@@ -5188,7 +5259,7 @@
           <p:cNvPr id="14" name="">
             <a:extLst xmlns:a="http://schemas.openxmlformats.org/drawingml/2006/main">
               <a:ext uri="{FF2B5EF4-FFF2-40B4-BE49-F238E27FC236}">
-                <a16:creationId xmlns:a16="http://schemas.microsoft.com/office/drawing/2014/main" id="{8B5F0496-2AB9-4634-A7A8-A22A6D95F7EC}"/>
+                <a16:creationId xmlns:a16="http://schemas.microsoft.com/office/drawing/2014/main" id="{A56A4B57-50B5-4EDB-9D4A-DAEB97B403D5}"/>
               </a:ext>
             </a:extLst>
           </p:cNvPr>
@@ -5245,7 +5316,7 @@
                 <a:ea typeface="Aptos"/>
                 <a:cs typeface="Aptos"/>
               </a:rPr>
-              <a:t>Verify + recover</a:t>
+              <a:t>Existing infrastructure</a:t>
             </a:r>
           </a:p>
         </p:txBody>
@@ -5255,7 +5326,7 @@
           <p:cNvPr id="15" name="">
             <a:extLst xmlns:a="http://schemas.openxmlformats.org/drawingml/2006/main">
               <a:ext uri="{FF2B5EF4-FFF2-40B4-BE49-F238E27FC236}">
-                <a16:creationId xmlns:a16="http://schemas.microsoft.com/office/drawing/2014/main" id="{EFE531EA-E7AD-4124-AEDB-65ABC0362BA8}"/>
+                <a16:creationId xmlns:a16="http://schemas.microsoft.com/office/drawing/2014/main" id="{039A0B8E-E7B4-4CDA-A507-50859BBBA647}"/>
               </a:ext>
             </a:extLst>
           </p:cNvPr>
@@ -5312,7 +5383,7 @@
                 <a:ea typeface="Aptos"/>
                 <a:cs typeface="Aptos"/>
               </a:rPr>
-              <a:t>Read back content and audience</a:t>
+              <a:t>Qualified hardened provider</a:t>
             </a:r>
           </a:p>
           <a:p xmlns:a="http://schemas.openxmlformats.org/drawingml/2006/main">
@@ -5335,7 +5406,7 @@
                 <a:ea typeface="Aptos"/>
                 <a:cs typeface="Aptos"/>
               </a:rPr>
-              <a:t>Return verified URLs</a:t>
+              <a:t>Client-side task isolation</a:t>
             </a:r>
           </a:p>
           <a:p xmlns:a="http://schemas.openxmlformats.org/drawingml/2006/main">
@@ -5358,7 +5429,7 @@
                 <a:ea typeface="Aptos"/>
                 <a:cs typeface="Aptos"/>
               </a:rPr>
-              <a:t>Reconcile uncertain writes</a:t>
+              <a:t>PlanetScale DAO database</a:t>
             </a:r>
           </a:p>
           <a:p xmlns:a="http://schemas.openxmlformats.org/drawingml/2006/main">
@@ -5381,7 +5452,7 @@
                 <a:ea typeface="Aptos"/>
                 <a:cs typeface="Aptos"/>
               </a:rPr>
-              <a:t>Version corrected outputs</a:t>
+              <a:t>Cloudflare available as needed</a:t>
             </a:r>
           </a:p>
         </p:txBody>
@@ -5391,7 +5462,7 @@
           <p:cNvPr id="16" name="">
             <a:extLst xmlns:a="http://schemas.openxmlformats.org/drawingml/2006/main">
               <a:ext uri="{FF2B5EF4-FFF2-40B4-BE49-F238E27FC236}">
-                <a16:creationId xmlns:a16="http://schemas.microsoft.com/office/drawing/2014/main" id="{BFF06EF6-B0DA-496F-8B3A-AC52D6488000}"/>
+                <a16:creationId xmlns:a16="http://schemas.microsoft.com/office/drawing/2014/main" id="{7D1BEF74-5AF5-4DF4-880A-ADC2EDE4E752}"/>
               </a:ext>
             </a:extLst>
           </p:cNvPr>
@@ -5448,7 +5519,7 @@
                 <a:ea typeface="Aptos"/>
                 <a:cs typeface="Aptos"/>
               </a:rPr>
-              <a:t>Publication uses a trusted domain adapter; source text cannot choose new destinations or permissions.</a:t>
+              <a:t>A narrow plugin fits the selected Paperclip release. Shared records keep the two interfaces coherent.</a:t>
             </a:r>
           </a:p>
         </p:txBody>
@@ -5456,7 +5527,7 @@
     </p:spTree>
     <p:extLst>
       <p:ext uri="{BB962C8B-B14F-4D97-AF65-F5344CB8AC3E}">
-        <p14:creationId xmlns:p14="http://schemas.microsoft.com/office/powerpoint/2010/main" val="742430007"/>
+        <p14:creationId xmlns:p14="http://schemas.microsoft.com/office/powerpoint/2010/main" val="559018357"/>
       </p:ext>
     </p:extLst>
   </p:cSld>
@@ -5487,7 +5558,7 @@
           <p:cNvPr id="17" name="">
             <a:extLst xmlns:a="http://schemas.openxmlformats.org/drawingml/2006/main">
               <a:ext uri="{FF2B5EF4-FFF2-40B4-BE49-F238E27FC236}">
-                <a16:creationId xmlns:a16="http://schemas.microsoft.com/office/drawing/2014/main" id="{CE45C6AD-A984-4057-9566-8542FDFE75F3}"/>
+                <a16:creationId xmlns:a16="http://schemas.microsoft.com/office/drawing/2014/main" id="{319E6743-03AF-46EE-A123-BC5277600AC1}"/>
               </a:ext>
             </a:extLst>
           </p:cNvPr>
@@ -5554,7 +5625,7 @@
           <p:cNvPr id="2" name="">
             <a:extLst xmlns:a="http://schemas.openxmlformats.org/drawingml/2006/main">
               <a:ext uri="{FF2B5EF4-FFF2-40B4-BE49-F238E27FC236}">
-                <a16:creationId xmlns:a16="http://schemas.microsoft.com/office/drawing/2014/main" id="{7F56EC6F-AE16-48E6-ADEA-699705798ED2}"/>
+                <a16:creationId xmlns:a16="http://schemas.microsoft.com/office/drawing/2014/main" id="{0E5E0A98-4101-4121-B59A-D41F47249808}"/>
               </a:ext>
             </a:extLst>
           </p:cNvPr>
@@ -5611,7 +5682,7 @@
                 <a:ea typeface="Aptos"/>
                 <a:cs typeface="Aptos"/>
               </a:rPr>
-              <a:t>Current grant → reviewed packet → vote</a:t>
+              <a:t>Automatic Roundtable publication</a:t>
             </a:r>
           </a:p>
         </p:txBody>
@@ -5621,7 +5692,7 @@
           <p:cNvPr id="3" name="">
             <a:extLst xmlns:a="http://schemas.openxmlformats.org/drawingml/2006/main">
               <a:ext uri="{FF2B5EF4-FFF2-40B4-BE49-F238E27FC236}">
-                <a16:creationId xmlns:a16="http://schemas.microsoft.com/office/drawing/2014/main" id="{D5D63B03-8C3F-46C7-9904-5AB4229D0FF0}"/>
+                <a16:creationId xmlns:a16="http://schemas.microsoft.com/office/drawing/2014/main" id="{A9A296B7-3458-4C32-A4AA-B18835F01475}"/>
               </a:ext>
             </a:extLst>
           </p:cNvPr>
@@ -5678,7 +5749,7 @@
                 <a:ea typeface="Aptos"/>
                 <a:cs typeface="Aptos"/>
               </a:rPr>
-              <a:t>Reuse the existing scanner and review workflow. Bind voted authority to an immutable application packet.</a:t>
+              <a:t>Meet recording and Gemini processing feed the organization’s Drive folder.</a:t>
             </a:r>
           </a:p>
         </p:txBody>
@@ -5688,7 +5759,7 @@
           <p:cNvPr id="4" name="">
             <a:extLst xmlns:a="http://schemas.openxmlformats.org/drawingml/2006/main">
               <a:ext uri="{FF2B5EF4-FFF2-40B4-BE49-F238E27FC236}">
-                <a16:creationId xmlns:a16="http://schemas.microsoft.com/office/drawing/2014/main" id="{72AAB282-21E4-466B-9CEB-D809B4A2CDE0}"/>
+                <a16:creationId xmlns:a16="http://schemas.microsoft.com/office/drawing/2014/main" id="{F1013BEB-9F03-4C4B-8E9B-783A5CCEEB6B}"/>
               </a:ext>
             </a:extLst>
           </p:cNvPr>
@@ -5719,7 +5790,7 @@
           <p:cNvPr id="5" name="">
             <a:extLst xmlns:a="http://schemas.openxmlformats.org/drawingml/2006/main">
               <a:ext uri="{FF2B5EF4-FFF2-40B4-BE49-F238E27FC236}">
-                <a16:creationId xmlns:a16="http://schemas.microsoft.com/office/drawing/2014/main" id="{52A3687A-47FC-472D-891E-9825A8EFDA5E}"/>
+                <a16:creationId xmlns:a16="http://schemas.microsoft.com/office/drawing/2014/main" id="{1E6CEA3E-86F4-47E3-935A-39DF16D29EE8}"/>
               </a:ext>
             </a:extLst>
           </p:cNvPr>
@@ -5776,7 +5847,7 @@
                 <a:ea typeface="Aptos"/>
                 <a:cs typeface="Aptos"/>
               </a:rPr>
-              <a:t>INERTIA-2026-10-22-r5 · 22 October 2026 · Design refinement · Compatibility first</a:t>
+              <a:t>INERTIA-2026-10-22-r6 · 22 October 2026 · Autonomous build</a:t>
             </a:r>
           </a:p>
         </p:txBody>
@@ -5786,7 +5857,7 @@
           <p:cNvPr id="6" name="">
             <a:extLst xmlns:a="http://schemas.openxmlformats.org/drawingml/2006/main">
               <a:ext uri="{FF2B5EF4-FFF2-40B4-BE49-F238E27FC236}">
-                <a16:creationId xmlns:a16="http://schemas.microsoft.com/office/drawing/2014/main" id="{4AD6D167-DDA4-4D86-9E17-17590E706C43}"/>
+                <a16:creationId xmlns:a16="http://schemas.microsoft.com/office/drawing/2014/main" id="{9B07308A-CE4F-4AC5-9B17-2DB64AEAD30B}"/>
               </a:ext>
             </a:extLst>
           </p:cNvPr>
@@ -5853,7 +5924,7 @@
           <p:cNvPr id="7" name="">
             <a:extLst xmlns:a="http://schemas.openxmlformats.org/drawingml/2006/main">
               <a:ext uri="{FF2B5EF4-FFF2-40B4-BE49-F238E27FC236}">
-                <a16:creationId xmlns:a16="http://schemas.microsoft.com/office/drawing/2014/main" id="{5366AE13-C2A4-43C9-B282-3583691BE349}"/>
+                <a16:creationId xmlns:a16="http://schemas.microsoft.com/office/drawing/2014/main" id="{38D3E445-5CDC-4B45-A494-8A1E92FEABCF}"/>
               </a:ext>
             </a:extLst>
           </p:cNvPr>
@@ -5886,7 +5957,7 @@
           <p:cNvPr id="8" name="">
             <a:extLst xmlns:a="http://schemas.openxmlformats.org/drawingml/2006/main">
               <a:ext uri="{FF2B5EF4-FFF2-40B4-BE49-F238E27FC236}">
-                <a16:creationId xmlns:a16="http://schemas.microsoft.com/office/drawing/2014/main" id="{C1C84069-B9F1-4938-800C-4111ED3E1241}"/>
+                <a16:creationId xmlns:a16="http://schemas.microsoft.com/office/drawing/2014/main" id="{6D4DD690-7815-45AC-9050-77846EBBD068}"/>
               </a:ext>
             </a:extLst>
           </p:cNvPr>
@@ -5943,7 +6014,7 @@
                 <a:ea typeface="Aptos"/>
                 <a:cs typeface="Aptos"/>
               </a:rPr>
-              <a:t>Find + draft</a:t>
+              <a:t>Ready source</a:t>
             </a:r>
           </a:p>
         </p:txBody>
@@ -5953,7 +6024,7 @@
           <p:cNvPr id="9" name="">
             <a:extLst xmlns:a="http://schemas.openxmlformats.org/drawingml/2006/main">
               <a:ext uri="{FF2B5EF4-FFF2-40B4-BE49-F238E27FC236}">
-                <a16:creationId xmlns:a16="http://schemas.microsoft.com/office/drawing/2014/main" id="{FA28254B-DB4A-4D20-9ABF-83E58C3DD43C}"/>
+                <a16:creationId xmlns:a16="http://schemas.microsoft.com/office/drawing/2014/main" id="{4E5587FC-D2CE-4C8A-AB54-900FC19A45D0}"/>
               </a:ext>
             </a:extLst>
           </p:cNvPr>
@@ -6010,7 +6081,7 @@
                 <a:ea typeface="Aptos"/>
                 <a:cs typeface="Aptos"/>
               </a:rPr>
-              <a:t>Fresh sources and deadlines</a:t>
+              <a:t>Identify meeting and revision</a:t>
             </a:r>
           </a:p>
           <a:p xmlns:a="http://schemas.openxmlformats.org/drawingml/2006/main">
@@ -6033,7 +6104,7 @@
                 <a:ea typeface="Aptos"/>
                 <a:cs typeface="Aptos"/>
               </a:rPr>
-              <a:t>Eligibility and applicant route</a:t>
+              <a:t>Retain original source</a:t>
             </a:r>
           </a:p>
           <a:p xmlns:a="http://schemas.openxmlformats.org/drawingml/2006/main">
@@ -6056,7 +6127,7 @@
                 <a:ea typeface="Aptos"/>
                 <a:cs typeface="Aptos"/>
               </a:rPr>
-              <a:t>Template-based cited draft</a:t>
+              <a:t>Preserve uncertain wording</a:t>
             </a:r>
           </a:p>
           <a:p xmlns:a="http://schemas.openxmlformats.org/drawingml/2006/main">
@@ -6079,7 +6150,7 @@
                 <a:ea typeface="Aptos"/>
                 <a:cs typeface="Aptos"/>
               </a:rPr>
-              <a:t>Existing review and signoffs</a:t>
+              <a:t>Handle notes-only input honestly</a:t>
             </a:r>
           </a:p>
         </p:txBody>
@@ -6089,7 +6160,7 @@
           <p:cNvPr id="10" name="">
             <a:extLst xmlns:a="http://schemas.openxmlformats.org/drawingml/2006/main">
               <a:ext uri="{FF2B5EF4-FFF2-40B4-BE49-F238E27FC236}">
-                <a16:creationId xmlns:a16="http://schemas.microsoft.com/office/drawing/2014/main" id="{FDCD0A01-A777-413A-8204-046FEB19D146}"/>
+                <a16:creationId xmlns:a16="http://schemas.microsoft.com/office/drawing/2014/main" id="{680E04DA-B97B-4FCB-A922-EDB04BE4B8F8}"/>
               </a:ext>
             </a:extLst>
           </p:cNvPr>
@@ -6122,7 +6193,7 @@
           <p:cNvPr id="11" name="">
             <a:extLst xmlns:a="http://schemas.openxmlformats.org/drawingml/2006/main">
               <a:ext uri="{FF2B5EF4-FFF2-40B4-BE49-F238E27FC236}">
-                <a16:creationId xmlns:a16="http://schemas.microsoft.com/office/drawing/2014/main" id="{224398F4-7623-440C-B013-75BA81A0EC99}"/>
+                <a16:creationId xmlns:a16="http://schemas.microsoft.com/office/drawing/2014/main" id="{542D52CC-DEE8-483A-ABCC-CF7591802FEF}"/>
               </a:ext>
             </a:extLst>
           </p:cNvPr>
@@ -6179,7 +6250,7 @@
                 <a:ea typeface="Aptos"/>
                 <a:cs typeface="Aptos"/>
               </a:rPr>
-              <a:t>Freeze + decide</a:t>
+              <a:t>Faithful transformation</a:t>
             </a:r>
           </a:p>
         </p:txBody>
@@ -6189,7 +6260,7 @@
           <p:cNvPr id="12" name="">
             <a:extLst xmlns:a="http://schemas.openxmlformats.org/drawingml/2006/main">
               <a:ext uri="{FF2B5EF4-FFF2-40B4-BE49-F238E27FC236}">
-                <a16:creationId xmlns:a16="http://schemas.microsoft.com/office/drawing/2014/main" id="{A69C82A9-92F5-48E0-846E-79A5F89032BB}"/>
+                <a16:creationId xmlns:a16="http://schemas.microsoft.com/office/drawing/2014/main" id="{AAAE2A79-0B08-464E-94C2-934ED636ABF7}"/>
               </a:ext>
             </a:extLst>
           </p:cNvPr>
@@ -6246,7 +6317,7 @@
                 <a:ea typeface="Aptos"/>
                 <a:cs typeface="Aptos"/>
               </a:rPr>
-              <a:t>Packet ID, version and hash</a:t>
+              <a:t>Separate transcript and notes</a:t>
             </a:r>
           </a:p>
           <a:p xmlns:a="http://schemas.openxmlformats.org/drawingml/2006/main">
@@ -6269,7 +6340,7 @@
                 <a:ea typeface="Aptos"/>
                 <a:cs typeface="Aptos"/>
               </a:rPr>
-              <a:t>Blockchain proposal binding</a:t>
+              <a:t>Cite source for action items</a:t>
             </a:r>
           </a:p>
           <a:p xmlns:a="http://schemas.openxmlformats.org/drawingml/2006/main">
@@ -6292,7 +6363,7 @@
                 <a:ea typeface="Aptos"/>
                 <a:cs typeface="Aptos"/>
               </a:rPr>
-              <a:t>Finality and result validation</a:t>
+              <a:t>Keep names and claims grounded</a:t>
             </a:r>
           </a:p>
           <a:p xmlns:a="http://schemas.openxmlformats.org/drawingml/2006/main">
@@ -6315,7 +6386,7 @@
                 <a:ea typeface="Aptos"/>
                 <a:cs typeface="Aptos"/>
               </a:rPr>
-              <a:t>Changed packet needs new vote</a:t>
+              <a:t>Apply the configured audience</a:t>
             </a:r>
           </a:p>
         </p:txBody>
@@ -6325,7 +6396,7 @@
           <p:cNvPr id="13" name="">
             <a:extLst xmlns:a="http://schemas.openxmlformats.org/drawingml/2006/main">
               <a:ext uri="{FF2B5EF4-FFF2-40B4-BE49-F238E27FC236}">
-                <a16:creationId xmlns:a16="http://schemas.microsoft.com/office/drawing/2014/main" id="{95B9DFC5-F393-418E-8E66-3999BB7BCB6D}"/>
+                <a16:creationId xmlns:a16="http://schemas.microsoft.com/office/drawing/2014/main" id="{1C019A24-69A3-416A-907D-87F0F7460D76}"/>
               </a:ext>
             </a:extLst>
           </p:cNvPr>
@@ -6358,7 +6429,7 @@
           <p:cNvPr id="14" name="">
             <a:extLst xmlns:a="http://schemas.openxmlformats.org/drawingml/2006/main">
               <a:ext uri="{FF2B5EF4-FFF2-40B4-BE49-F238E27FC236}">
-                <a16:creationId xmlns:a16="http://schemas.microsoft.com/office/drawing/2014/main" id="{714C03D3-11F5-412E-B789-96DD0EA56CCE}"/>
+                <a16:creationId xmlns:a16="http://schemas.microsoft.com/office/drawing/2014/main" id="{92B17FEF-C16B-4B76-9439-AC8CAD19F4CB}"/>
               </a:ext>
             </a:extLst>
           </p:cNvPr>
@@ -6415,7 +6486,7 @@
                 <a:ea typeface="Aptos"/>
                 <a:cs typeface="Aptos"/>
               </a:rPr>
-              <a:t>Watch + advance</a:t>
+              <a:t>Trusted publication</a:t>
             </a:r>
           </a:p>
         </p:txBody>
@@ -6425,7 +6496,7 @@
           <p:cNvPr id="15" name="">
             <a:extLst xmlns:a="http://schemas.openxmlformats.org/drawingml/2006/main">
               <a:ext uri="{FF2B5EF4-FFF2-40B4-BE49-F238E27FC236}">
-                <a16:creationId xmlns:a16="http://schemas.microsoft.com/office/drawing/2014/main" id="{ADACCE6B-4340-4F75-A668-307C3586CAF7}"/>
+                <a16:creationId xmlns:a16="http://schemas.microsoft.com/office/drawing/2014/main" id="{DC91D38A-A662-46F7-83F6-E54B15781712}"/>
               </a:ext>
             </a:extLst>
           </p:cNvPr>
@@ -6482,7 +6553,7 @@
                 <a:ea typeface="Aptos"/>
                 <a:cs typeface="Aptos"/>
               </a:rPr>
-              <a:t>Y2 registered interests</a:t>
+              <a:t>Upsert the website record</a:t>
             </a:r>
           </a:p>
           <a:p xmlns:a="http://schemas.openxmlformats.org/drawingml/2006/main">
@@ -6505,7 +6576,7 @@
                 <a:ea typeface="Aptos"/>
                 <a:cs typeface="Aptos"/>
               </a:rPr>
-              <a:t>Updates linked to existing work</a:t>
+              <a:t>Verify content and audience</a:t>
             </a:r>
           </a:p>
           <a:p xmlns:a="http://schemas.openxmlformats.org/drawingml/2006/main">
@@ -6528,7 +6599,7 @@
                 <a:ea typeface="Aptos"/>
                 <a:cs typeface="Aptos"/>
               </a:rPr>
-              <a:t>Ordinary tasks need no vote</a:t>
+              <a:t>Return the published URLs</a:t>
             </a:r>
           </a:p>
           <a:p xmlns:a="http://schemas.openxmlformats.org/drawingml/2006/main">
@@ -6551,7 +6622,7 @@
                 <a:ea typeface="Aptos"/>
                 <a:cs typeface="Aptos"/>
               </a:rPr>
-              <a:t>990 enrichment remains stretch</a:t>
+              <a:t>Reconcile corrections and retries</a:t>
             </a:r>
           </a:p>
         </p:txBody>
@@ -6561,7 +6632,7 @@
           <p:cNvPr id="16" name="">
             <a:extLst xmlns:a="http://schemas.openxmlformats.org/drawingml/2006/main">
               <a:ext uri="{FF2B5EF4-FFF2-40B4-BE49-F238E27FC236}">
-                <a16:creationId xmlns:a16="http://schemas.microsoft.com/office/drawing/2014/main" id="{B68FDFFE-29F1-437B-B4FD-0C9F8B933698}"/>
+                <a16:creationId xmlns:a16="http://schemas.microsoft.com/office/drawing/2014/main" id="{B5B2587C-D93F-449E-86C7-87C9C2922318}"/>
               </a:ext>
             </a:extLst>
           </p:cNvPr>
@@ -6618,7 +6689,7 @@
                 <a:ea typeface="Aptos"/>
                 <a:cs typeface="Aptos"/>
               </a:rPr>
-              <a:t>Required demo: verified packet-bound decision. Actual funder submission is a separately controlled step.</a:t>
+              <a:t>After one-time setup, routine publication runs automatically. Exceptions name the precise action needed.</a:t>
             </a:r>
           </a:p>
         </p:txBody>
@@ -6626,7 +6697,7 @@
     </p:spTree>
     <p:extLst>
       <p:ext uri="{BB962C8B-B14F-4D97-AF65-F5344CB8AC3E}">
-        <p14:creationId xmlns:p14="http://schemas.microsoft.com/office/powerpoint/2010/main" val="1999123243"/>
+        <p14:creationId xmlns:p14="http://schemas.microsoft.com/office/powerpoint/2010/main" val="2074361515"/>
       </p:ext>
     </p:extLst>
   </p:cSld>
@@ -6657,7 +6728,7 @@
           <p:cNvPr id="17" name="">
             <a:extLst xmlns:a="http://schemas.openxmlformats.org/drawingml/2006/main">
               <a:ext uri="{FF2B5EF4-FFF2-40B4-BE49-F238E27FC236}">
-                <a16:creationId xmlns:a16="http://schemas.microsoft.com/office/drawing/2014/main" id="{43F8A8D8-EDCA-442A-9022-3F847DF766BF}"/>
+                <a16:creationId xmlns:a16="http://schemas.microsoft.com/office/drawing/2014/main" id="{FC4E56A8-E93D-4BF6-91D3-307368775853}"/>
               </a:ext>
             </a:extLst>
           </p:cNvPr>
@@ -6724,7 +6795,7 @@
           <p:cNvPr id="2" name="">
             <a:extLst xmlns:a="http://schemas.openxmlformats.org/drawingml/2006/main">
               <a:ext uri="{FF2B5EF4-FFF2-40B4-BE49-F238E27FC236}">
-                <a16:creationId xmlns:a16="http://schemas.microsoft.com/office/drawing/2014/main" id="{9F3E0806-B5C9-4309-85F5-A59B35AA90E5}"/>
+                <a16:creationId xmlns:a16="http://schemas.microsoft.com/office/drawing/2014/main" id="{48FBF5F0-28E8-4CB1-9871-8468B4979FFF}"/>
               </a:ext>
             </a:extLst>
           </p:cNvPr>
@@ -6781,7 +6852,7 @@
                 <a:ea typeface="Aptos"/>
                 <a:cs typeface="Aptos"/>
               </a:rPr>
-              <a:t>Eager agents, native execution</a:t>
+              <a:t>Grant decisions and Y2 updates</a:t>
             </a:r>
           </a:p>
         </p:txBody>
@@ -6791,7 +6862,7 @@
           <p:cNvPr id="3" name="">
             <a:extLst xmlns:a="http://schemas.openxmlformats.org/drawingml/2006/main">
               <a:ext uri="{FF2B5EF4-FFF2-40B4-BE49-F238E27FC236}">
-                <a16:creationId xmlns:a16="http://schemas.microsoft.com/office/drawing/2014/main" id="{33AD090A-EECF-43B9-A823-AE1746A9C4EA}"/>
+                <a16:creationId xmlns:a16="http://schemas.microsoft.com/office/drawing/2014/main" id="{647085AC-D644-425E-A57D-0D58449A4281}"/>
               </a:ext>
             </a:extLst>
           </p:cNvPr>
@@ -6848,7 +6919,7 @@
                 <a:ea typeface="Aptos"/>
                 <a:cs typeface="Aptos"/>
               </a:rPr>
-              <a:t>Member-owned capacity contributes through Paperclip’s qualified runner and execution interfaces.</a:t>
+              <a:t>Reuse the grant scanner and preserve review before freezing the application.</a:t>
             </a:r>
           </a:p>
         </p:txBody>
@@ -6858,7 +6929,7 @@
           <p:cNvPr id="4" name="">
             <a:extLst xmlns:a="http://schemas.openxmlformats.org/drawingml/2006/main">
               <a:ext uri="{FF2B5EF4-FFF2-40B4-BE49-F238E27FC236}">
-                <a16:creationId xmlns:a16="http://schemas.microsoft.com/office/drawing/2014/main" id="{1D669476-A46D-48C7-A765-C68839D3D3AF}"/>
+                <a16:creationId xmlns:a16="http://schemas.microsoft.com/office/drawing/2014/main" id="{7302BBE7-D64F-42D4-AB77-AB310598A6F3}"/>
               </a:ext>
             </a:extLst>
           </p:cNvPr>
@@ -6889,7 +6960,7 @@
           <p:cNvPr id="5" name="">
             <a:extLst xmlns:a="http://schemas.openxmlformats.org/drawingml/2006/main">
               <a:ext uri="{FF2B5EF4-FFF2-40B4-BE49-F238E27FC236}">
-                <a16:creationId xmlns:a16="http://schemas.microsoft.com/office/drawing/2014/main" id="{1A755172-D817-4636-A0F4-B10FEC7901CB}"/>
+                <a16:creationId xmlns:a16="http://schemas.microsoft.com/office/drawing/2014/main" id="{37EA21DC-01D7-4BAB-A59D-12DE4B2AEB9A}"/>
               </a:ext>
             </a:extLst>
           </p:cNvPr>
@@ -6946,7 +7017,7 @@
                 <a:ea typeface="Aptos"/>
                 <a:cs typeface="Aptos"/>
               </a:rPr>
-              <a:t>INERTIA-2026-10-22-r5 · 22 October 2026 · Design refinement · Compatibility first</a:t>
+              <a:t>INERTIA-2026-10-22-r6 · 22 October 2026 · Autonomous build</a:t>
             </a:r>
           </a:p>
         </p:txBody>
@@ -6956,7 +7027,7 @@
           <p:cNvPr id="6" name="">
             <a:extLst xmlns:a="http://schemas.openxmlformats.org/drawingml/2006/main">
               <a:ext uri="{FF2B5EF4-FFF2-40B4-BE49-F238E27FC236}">
-                <a16:creationId xmlns:a16="http://schemas.microsoft.com/office/drawing/2014/main" id="{5AD9E2E7-2817-44CF-BA5E-7D562504F22D}"/>
+                <a16:creationId xmlns:a16="http://schemas.microsoft.com/office/drawing/2014/main" id="{6E8372E9-7FE1-47FF-8D84-627DB2AE462E}"/>
               </a:ext>
             </a:extLst>
           </p:cNvPr>
@@ -7023,7 +7094,7 @@
           <p:cNvPr id="7" name="">
             <a:extLst xmlns:a="http://schemas.openxmlformats.org/drawingml/2006/main">
               <a:ext uri="{FF2B5EF4-FFF2-40B4-BE49-F238E27FC236}">
-                <a16:creationId xmlns:a16="http://schemas.microsoft.com/office/drawing/2014/main" id="{2BF11F28-569F-423D-8C86-10CBBF4E1FE2}"/>
+                <a16:creationId xmlns:a16="http://schemas.microsoft.com/office/drawing/2014/main" id="{61D71157-418A-4879-AD0A-2DCEFBCA6EE5}"/>
               </a:ext>
             </a:extLst>
           </p:cNvPr>
@@ -7056,7 +7127,7 @@
           <p:cNvPr id="8" name="">
             <a:extLst xmlns:a="http://schemas.openxmlformats.org/drawingml/2006/main">
               <a:ext uri="{FF2B5EF4-FFF2-40B4-BE49-F238E27FC236}">
-                <a16:creationId xmlns:a16="http://schemas.microsoft.com/office/drawing/2014/main" id="{3A6A17EA-762A-47EC-A1D5-4D25F6033EB7}"/>
+                <a16:creationId xmlns:a16="http://schemas.microsoft.com/office/drawing/2014/main" id="{37C46F52-B48E-41BA-9C5D-0A7A16DF257E}"/>
               </a:ext>
             </a:extLst>
           </p:cNvPr>
@@ -7113,7 +7184,7 @@
                 <a:ea typeface="Aptos"/>
                 <a:cs typeface="Aptos"/>
               </a:rPr>
-              <a:t>Native coordination</a:t>
+              <a:t>Find and prepare</a:t>
             </a:r>
           </a:p>
         </p:txBody>
@@ -7123,7 +7194,7 @@
           <p:cNvPr id="9" name="">
             <a:extLst xmlns:a="http://schemas.openxmlformats.org/drawingml/2006/main">
               <a:ext uri="{FF2B5EF4-FFF2-40B4-BE49-F238E27FC236}">
-                <a16:creationId xmlns:a16="http://schemas.microsoft.com/office/drawing/2014/main" id="{CFCB8415-54B5-4E97-8378-6BEB46A237FA}"/>
+                <a16:creationId xmlns:a16="http://schemas.microsoft.com/office/drawing/2014/main" id="{7A33A761-3DFA-4BB5-8F6C-B2059421A66B}"/>
               </a:ext>
             </a:extLst>
           </p:cNvPr>
@@ -7180,7 +7251,7 @@
                 <a:ea typeface="Aptos"/>
                 <a:cs typeface="Aptos"/>
               </a:rPr>
-              <a:t>CEO delegates and unblocks</a:t>
+              <a:t>Refresh opportunities</a:t>
             </a:r>
           </a:p>
           <a:p xmlns:a="http://schemas.openxmlformats.org/drawingml/2006/main">
@@ -7203,7 +7274,7 @@
                 <a:ea typeface="Aptos"/>
                 <a:cs typeface="Aptos"/>
               </a:rPr>
-              <a:t>Eligible work acquired eagerly</a:t>
+              <a:t>Check deadline and eligibility</a:t>
             </a:r>
           </a:p>
           <a:p xmlns:a="http://schemas.openxmlformats.org/drawingml/2006/main">
@@ -7226,7 +7297,7 @@
                 <a:ea typeface="Aptos"/>
                 <a:cs typeface="Aptos"/>
               </a:rPr>
-              <a:t>Atomic checkout ownership</a:t>
+              <a:t>Build a cited draft packet</a:t>
             </a:r>
           </a:p>
           <a:p xmlns:a="http://schemas.openxmlformats.org/drawingml/2006/main">
@@ -7249,7 +7320,7 @@
                 <a:ea typeface="Aptos"/>
                 <a:cs typeface="Aptos"/>
               </a:rPr>
-              <a:t>Hiring and budget policy</a:t>
+              <a:t>Preserve reviewer signoffs</a:t>
             </a:r>
           </a:p>
         </p:txBody>
@@ -7259,7 +7330,7 @@
           <p:cNvPr id="10" name="">
             <a:extLst xmlns:a="http://schemas.openxmlformats.org/drawingml/2006/main">
               <a:ext uri="{FF2B5EF4-FFF2-40B4-BE49-F238E27FC236}">
-                <a16:creationId xmlns:a16="http://schemas.microsoft.com/office/drawing/2014/main" id="{8656ABAF-3F4C-469B-B565-D54E68ED7CE3}"/>
+                <a16:creationId xmlns:a16="http://schemas.microsoft.com/office/drawing/2014/main" id="{1A78F3C7-4E5E-4CEE-AE48-F92FA04D6398}"/>
               </a:ext>
             </a:extLst>
           </p:cNvPr>
@@ -7292,7 +7363,7 @@
           <p:cNvPr id="11" name="">
             <a:extLst xmlns:a="http://schemas.openxmlformats.org/drawingml/2006/main">
               <a:ext uri="{FF2B5EF4-FFF2-40B4-BE49-F238E27FC236}">
-                <a16:creationId xmlns:a16="http://schemas.microsoft.com/office/drawing/2014/main" id="{3E9F14A6-6E7D-4710-AE15-23428B9CECB7}"/>
+                <a16:creationId xmlns:a16="http://schemas.microsoft.com/office/drawing/2014/main" id="{23174286-6403-46E8-B0CE-D480B04AF43C}"/>
               </a:ext>
             </a:extLst>
           </p:cNvPr>
@@ -7349,7 +7420,7 @@
                 <a:ea typeface="Aptos"/>
                 <a:cs typeface="Aptos"/>
               </a:rPr>
-              <a:t>Qualified execution</a:t>
+              <a:t>Bind the vote</a:t>
             </a:r>
           </a:p>
         </p:txBody>
@@ -7359,7 +7430,7 @@
           <p:cNvPr id="12" name="">
             <a:extLst xmlns:a="http://schemas.openxmlformats.org/drawingml/2006/main">
               <a:ext uri="{FF2B5EF4-FFF2-40B4-BE49-F238E27FC236}">
-                <a16:creationId xmlns:a16="http://schemas.microsoft.com/office/drawing/2014/main" id="{8E8CE0F0-15D9-4BA8-A137-5667C83A4CAA}"/>
+                <a16:creationId xmlns:a16="http://schemas.microsoft.com/office/drawing/2014/main" id="{2623B582-C87C-4427-B28D-C6416FA4E166}"/>
               </a:ext>
             </a:extLst>
           </p:cNvPr>
@@ -7416,7 +7487,7 @@
                 <a:ea typeface="Aptos"/>
                 <a:cs typeface="Aptos"/>
               </a:rPr>
-              <a:t>Client-side sandbox</a:t>
+              <a:t>Freeze packet version and hash</a:t>
             </a:r>
           </a:p>
           <a:p xmlns:a="http://schemas.openxmlformats.org/drawingml/2006/main">
@@ -7439,7 +7510,7 @@
                 <a:ea typeface="Aptos"/>
                 <a:cs typeface="Aptos"/>
               </a:rPr>
-              <a:t>Isolated task workspace</a:t>
+              <a:t>Verify network and finality</a:t>
             </a:r>
           </a:p>
           <a:p xmlns:a="http://schemas.openxmlformats.org/drawingml/2006/main">
@@ -7462,7 +7533,7 @@
                 <a:ea typeface="Aptos"/>
                 <a:cs typeface="Aptos"/>
               </a:rPr>
-              <a:t>Narrow data and tool scopes</a:t>
+              <a:t>Match the authorized action</a:t>
             </a:r>
           </a:p>
           <a:p xmlns:a="http://schemas.openxmlformats.org/drawingml/2006/main">
@@ -7485,7 +7556,7 @@
                 <a:ea typeface="Aptos"/>
                 <a:cs typeface="Aptos"/>
               </a:rPr>
-              <a:t>Native lifecycle and recovery</a:t>
+              <a:t>Apply the result once</a:t>
             </a:r>
           </a:p>
         </p:txBody>
@@ -7495,7 +7566,7 @@
           <p:cNvPr id="13" name="">
             <a:extLst xmlns:a="http://schemas.openxmlformats.org/drawingml/2006/main">
               <a:ext uri="{FF2B5EF4-FFF2-40B4-BE49-F238E27FC236}">
-                <a16:creationId xmlns:a16="http://schemas.microsoft.com/office/drawing/2014/main" id="{3DE0F909-2EB6-41F3-872E-4D654DB61ECB}"/>
+                <a16:creationId xmlns:a16="http://schemas.microsoft.com/office/drawing/2014/main" id="{EECDE4C2-8AA6-40DB-B988-7CF7DCBB1242}"/>
               </a:ext>
             </a:extLst>
           </p:cNvPr>
@@ -7528,7 +7599,7 @@
           <p:cNvPr id="14" name="">
             <a:extLst xmlns:a="http://schemas.openxmlformats.org/drawingml/2006/main">
               <a:ext uri="{FF2B5EF4-FFF2-40B4-BE49-F238E27FC236}">
-                <a16:creationId xmlns:a16="http://schemas.microsoft.com/office/drawing/2014/main" id="{B672AD8B-F944-4D7F-A9F0-91F48C00A317}"/>
+                <a16:creationId xmlns:a16="http://schemas.microsoft.com/office/drawing/2014/main" id="{57B3BFD3-5B6A-45B8-A51E-B0CE4B3A5C79}"/>
               </a:ext>
             </a:extLst>
           </p:cNvPr>
@@ -7585,7 +7656,7 @@
                 <a:ea typeface="Aptos"/>
                 <a:cs typeface="Aptos"/>
               </a:rPr>
-              <a:t>Validated contribution</a:t>
+              <a:t>Continue the work</a:t>
             </a:r>
           </a:p>
         </p:txBody>
@@ -7595,7 +7666,7 @@
           <p:cNvPr id="15" name="">
             <a:extLst xmlns:a="http://schemas.openxmlformats.org/drawingml/2006/main">
               <a:ext uri="{FF2B5EF4-FFF2-40B4-BE49-F238E27FC236}">
-                <a16:creationId xmlns:a16="http://schemas.microsoft.com/office/drawing/2014/main" id="{B0B069C1-E350-4034-8C47-44E7F7EE3D48}"/>
+                <a16:creationId xmlns:a16="http://schemas.microsoft.com/office/drawing/2014/main" id="{AA83E20B-5C82-4BE8-B9E5-C4F9F6EB5B1D}"/>
               </a:ext>
             </a:extLst>
           </p:cNvPr>
@@ -7652,7 +7723,7 @@
                 <a:ea typeface="Aptos"/>
                 <a:cs typeface="Aptos"/>
               </a:rPr>
-              <a:t>Server-side artifact validation</a:t>
+              <a:t>Y2 registered interests</a:t>
             </a:r>
           </a:p>
           <a:p xmlns:a="http://schemas.openxmlformats.org/drawingml/2006/main">
@@ -7675,7 +7746,7 @@
                 <a:ea typeface="Aptos"/>
                 <a:cs typeface="Aptos"/>
               </a:rPr>
-              <a:t>Trusted publication adapter</a:t>
+              <a:t>Updates attach to existing work</a:t>
             </a:r>
           </a:p>
           <a:p xmlns:a="http://schemas.openxmlformats.org/drawingml/2006/main">
@@ -7698,7 +7769,7 @@
                 <a:ea typeface="Aptos"/>
                 <a:cs typeface="Aptos"/>
               </a:rPr>
-              <a:t>Follow-ups with reason + parent</a:t>
+              <a:t>Ordinary work proceeds normally</a:t>
             </a:r>
           </a:p>
           <a:p xmlns:a="http://schemas.openxmlformats.org/drawingml/2006/main">
@@ -7721,7 +7792,7 @@
                 <a:ea typeface="Aptos"/>
                 <a:cs typeface="Aptos"/>
               </a:rPr>
-              <a:t>Deduplication and bounded depth</a:t>
+              <a:t>990 enrichment remains stretch</a:t>
             </a:r>
           </a:p>
         </p:txBody>
@@ -7731,7 +7802,7 @@
           <p:cNvPr id="16" name="">
             <a:extLst xmlns:a="http://schemas.openxmlformats.org/drawingml/2006/main">
               <a:ext uri="{FF2B5EF4-FFF2-40B4-BE49-F238E27FC236}">
-                <a16:creationId xmlns:a16="http://schemas.microsoft.com/office/drawing/2014/main" id="{17E20610-18AE-4734-AE85-849243E9FD5D}"/>
+                <a16:creationId xmlns:a16="http://schemas.microsoft.com/office/drawing/2014/main" id="{B42FF771-3120-4382-863F-6D88BFDCA3EE}"/>
               </a:ext>
             </a:extLst>
           </p:cNvPr>
@@ -7788,7 +7859,7 @@
                 <a:ea typeface="Aptos"/>
                 <a:cs typeface="Aptos"/>
               </a:rPr>
-              <a:t>Reuse existing execution hardening against the selected Paperclip release; verify SDK support and serving admission.</a:t>
+              <a:t>The demo demonstrates the ratified packet. Actual funder submission remains a separately authorized action.</a:t>
             </a:r>
           </a:p>
         </p:txBody>
@@ -7796,7 +7867,7 @@
     </p:spTree>
     <p:extLst>
       <p:ext uri="{BB962C8B-B14F-4D97-AF65-F5344CB8AC3E}">
-        <p14:creationId xmlns:p14="http://schemas.microsoft.com/office/powerpoint/2010/main" val="979537345"/>
+        <p14:creationId xmlns:p14="http://schemas.microsoft.com/office/powerpoint/2010/main" val="1242149921"/>
       </p:ext>
     </p:extLst>
   </p:cSld>
@@ -7827,7 +7898,7 @@
           <p:cNvPr id="17" name="">
             <a:extLst xmlns:a="http://schemas.openxmlformats.org/drawingml/2006/main">
               <a:ext uri="{FF2B5EF4-FFF2-40B4-BE49-F238E27FC236}">
-                <a16:creationId xmlns:a16="http://schemas.microsoft.com/office/drawing/2014/main" id="{796A641C-D281-409C-8535-1D50B3619795}"/>
+                <a16:creationId xmlns:a16="http://schemas.microsoft.com/office/drawing/2014/main" id="{536211E4-D234-458A-B578-6151D91E2371}"/>
               </a:ext>
             </a:extLst>
           </p:cNvPr>
@@ -7894,7 +7965,7 @@
           <p:cNvPr id="2" name="">
             <a:extLst xmlns:a="http://schemas.openxmlformats.org/drawingml/2006/main">
               <a:ext uri="{FF2B5EF4-FFF2-40B4-BE49-F238E27FC236}">
-                <a16:creationId xmlns:a16="http://schemas.microsoft.com/office/drawing/2014/main" id="{59078E90-E384-48FB-9828-A2833E0DBFC4}"/>
+                <a16:creationId xmlns:a16="http://schemas.microsoft.com/office/drawing/2014/main" id="{12FB7133-0C95-4B40-A558-1916441DF763}"/>
               </a:ext>
             </a:extLst>
           </p:cNvPr>
@@ -7951,7 +8022,7 @@
                 <a:ea typeface="Aptos"/>
                 <a:cs typeface="Aptos"/>
               </a:rPr>
-              <a:t>Bridge contract: shared identity and state</a:t>
+              <a:t>Secure member contribution</a:t>
             </a:r>
           </a:p>
         </p:txBody>
@@ -7961,7 +8032,7 @@
           <p:cNvPr id="3" name="">
             <a:extLst xmlns:a="http://schemas.openxmlformats.org/drawingml/2006/main">
               <a:ext uri="{FF2B5EF4-FFF2-40B4-BE49-F238E27FC236}">
-                <a16:creationId xmlns:a16="http://schemas.microsoft.com/office/drawing/2014/main" id="{06E29C0D-9781-438E-83F5-3AD4E08DDD62}"/>
+                <a16:creationId xmlns:a16="http://schemas.microsoft.com/office/drawing/2014/main" id="{725CA979-ACCF-4D4D-BDA9-2D9208745412}"/>
               </a:ext>
             </a:extLst>
           </p:cNvPr>
@@ -8018,7 +8089,7 @@
                 <a:ea typeface="Aptos"/>
                 <a:cs typeface="Aptos"/>
               </a:rPr>
-              <a:t>Choose a native Buzz provider or bounded plugin bridge after compatibility qualification.</a:t>
+              <a:t>An enrolled member’s agent contributes from its own isolated execution environment.</a:t>
             </a:r>
           </a:p>
         </p:txBody>
@@ -8028,7 +8099,7 @@
           <p:cNvPr id="4" name="">
             <a:extLst xmlns:a="http://schemas.openxmlformats.org/drawingml/2006/main">
               <a:ext uri="{FF2B5EF4-FFF2-40B4-BE49-F238E27FC236}">
-                <a16:creationId xmlns:a16="http://schemas.microsoft.com/office/drawing/2014/main" id="{62916EEB-B82C-4A3F-B47D-D9D27AF79AD1}"/>
+                <a16:creationId xmlns:a16="http://schemas.microsoft.com/office/drawing/2014/main" id="{E6198B50-92B1-41C2-BF0F-E134EECB77C4}"/>
               </a:ext>
             </a:extLst>
           </p:cNvPr>
@@ -8059,7 +8130,7 @@
           <p:cNvPr id="5" name="">
             <a:extLst xmlns:a="http://schemas.openxmlformats.org/drawingml/2006/main">
               <a:ext uri="{FF2B5EF4-FFF2-40B4-BE49-F238E27FC236}">
-                <a16:creationId xmlns:a16="http://schemas.microsoft.com/office/drawing/2014/main" id="{F5F01EA0-C2CC-4F61-8DB3-761B141501AB}"/>
+                <a16:creationId xmlns:a16="http://schemas.microsoft.com/office/drawing/2014/main" id="{5C5D66A7-A791-47FC-AADD-968044D0F32C}"/>
               </a:ext>
             </a:extLst>
           </p:cNvPr>
@@ -8116,7 +8187,7 @@
                 <a:ea typeface="Aptos"/>
                 <a:cs typeface="Aptos"/>
               </a:rPr>
-              <a:t>INERTIA-2026-10-22-r5 · 22 October 2026 · Design refinement · Compatibility first</a:t>
+              <a:t>INERTIA-2026-10-22-r6 · 22 October 2026 · Autonomous build</a:t>
             </a:r>
           </a:p>
         </p:txBody>
@@ -8126,7 +8197,7 @@
           <p:cNvPr id="6" name="">
             <a:extLst xmlns:a="http://schemas.openxmlformats.org/drawingml/2006/main">
               <a:ext uri="{FF2B5EF4-FFF2-40B4-BE49-F238E27FC236}">
-                <a16:creationId xmlns:a16="http://schemas.microsoft.com/office/drawing/2014/main" id="{C37CB3E7-2BEF-4C59-A679-991B4A403378}"/>
+                <a16:creationId xmlns:a16="http://schemas.microsoft.com/office/drawing/2014/main" id="{1A48AE7C-4502-41EC-A036-EBB8C1EFF160}"/>
               </a:ext>
             </a:extLst>
           </p:cNvPr>
@@ -8193,7 +8264,7 @@
           <p:cNvPr id="7" name="">
             <a:extLst xmlns:a="http://schemas.openxmlformats.org/drawingml/2006/main">
               <a:ext uri="{FF2B5EF4-FFF2-40B4-BE49-F238E27FC236}">
-                <a16:creationId xmlns:a16="http://schemas.microsoft.com/office/drawing/2014/main" id="{859A76CD-56EE-45C5-B880-78B6E3EF56B6}"/>
+                <a16:creationId xmlns:a16="http://schemas.microsoft.com/office/drawing/2014/main" id="{46AEB412-1793-4D76-8880-420EAE6B4C4A}"/>
               </a:ext>
             </a:extLst>
           </p:cNvPr>
@@ -8226,7 +8297,7 @@
           <p:cNvPr id="8" name="">
             <a:extLst xmlns:a="http://schemas.openxmlformats.org/drawingml/2006/main">
               <a:ext uri="{FF2B5EF4-FFF2-40B4-BE49-F238E27FC236}">
-                <a16:creationId xmlns:a16="http://schemas.microsoft.com/office/drawing/2014/main" id="{714302E0-A19B-45C4-8690-E9B6E74A3632}"/>
+                <a16:creationId xmlns:a16="http://schemas.microsoft.com/office/drawing/2014/main" id="{AB915837-2254-47DA-8A79-0B276DF698AF}"/>
               </a:ext>
             </a:extLst>
           </p:cNvPr>
@@ -8283,7 +8354,7 @@
                 <a:ea typeface="Aptos"/>
                 <a:cs typeface="Aptos"/>
               </a:rPr>
-              <a:t>Ingress</a:t>
+              <a:t>Eager acquisition</a:t>
             </a:r>
           </a:p>
         </p:txBody>
@@ -8293,7 +8364,7 @@
           <p:cNvPr id="9" name="">
             <a:extLst xmlns:a="http://schemas.openxmlformats.org/drawingml/2006/main">
               <a:ext uri="{FF2B5EF4-FFF2-40B4-BE49-F238E27FC236}">
-                <a16:creationId xmlns:a16="http://schemas.microsoft.com/office/drawing/2014/main" id="{560842E7-CA6D-4BA1-8573-8794B8066B3F}"/>
+                <a16:creationId xmlns:a16="http://schemas.microsoft.com/office/drawing/2014/main" id="{CB7F8E25-211A-4D1A-9D69-13414168C874}"/>
               </a:ext>
             </a:extLst>
           </p:cNvPr>
@@ -8350,7 +8421,7 @@
                 <a:ea typeface="Aptos"/>
                 <a:cs typeface="Aptos"/>
               </a:rPr>
-              <a:t>Relay/channel/thread mapping</a:t>
+              <a:t>Native CEO delegates work</a:t>
             </a:r>
           </a:p>
           <a:p xmlns:a="http://schemas.openxmlformats.org/drawingml/2006/main">
@@ -8373,7 +8444,7 @@
                 <a:ea typeface="Aptos"/>
                 <a:cs typeface="Aptos"/>
               </a:rPr>
-              <a:t>Paired human or agent identity</a:t>
+              <a:t>Agent selects eligible tasks</a:t>
             </a:r>
           </a:p>
           <a:p xmlns:a="http://schemas.openxmlformats.org/drawingml/2006/main">
@@ -8396,7 +8467,7 @@
                 <a:ea typeface="Aptos"/>
                 <a:cs typeface="Aptos"/>
               </a:rPr>
-              <a:t>Durable event deduplication</a:t>
+              <a:t>Atomic checkout wins ownership</a:t>
             </a:r>
           </a:p>
           <a:p xmlns:a="http://schemas.openxmlformats.org/drawingml/2006/main">
@@ -8419,7 +8490,7 @@
                 <a:ea typeface="Aptos"/>
                 <a:cs typeface="Aptos"/>
               </a:rPr>
-              <a:t>Origin marker prevents echoes</a:t>
+              <a:t>Budgets bound activity</a:t>
             </a:r>
           </a:p>
         </p:txBody>
@@ -8429,7 +8500,7 @@
           <p:cNvPr id="10" name="">
             <a:extLst xmlns:a="http://schemas.openxmlformats.org/drawingml/2006/main">
               <a:ext uri="{FF2B5EF4-FFF2-40B4-BE49-F238E27FC236}">
-                <a16:creationId xmlns:a16="http://schemas.microsoft.com/office/drawing/2014/main" id="{D1093884-3572-4106-9365-426876EFAD4D}"/>
+                <a16:creationId xmlns:a16="http://schemas.microsoft.com/office/drawing/2014/main" id="{41083009-1B2E-4505-B370-7E58503D615F}"/>
               </a:ext>
             </a:extLst>
           </p:cNvPr>
@@ -8462,7 +8533,7 @@
           <p:cNvPr id="11" name="">
             <a:extLst xmlns:a="http://schemas.openxmlformats.org/drawingml/2006/main">
               <a:ext uri="{FF2B5EF4-FFF2-40B4-BE49-F238E27FC236}">
-                <a16:creationId xmlns:a16="http://schemas.microsoft.com/office/drawing/2014/main" id="{90B46EDF-1986-4F2C-8BCC-67A5D174B5A8}"/>
+                <a16:creationId xmlns:a16="http://schemas.microsoft.com/office/drawing/2014/main" id="{7D2B6383-E041-412D-8AB2-70E73D0CDEBA}"/>
               </a:ext>
             </a:extLst>
           </p:cNvPr>
@@ -8519,7 +8590,7 @@
                 <a:ea typeface="Aptos"/>
                 <a:cs typeface="Aptos"/>
               </a:rPr>
-              <a:t>Decisions</a:t>
+              <a:t>Scoped execution</a:t>
             </a:r>
           </a:p>
         </p:txBody>
@@ -8529,7 +8600,7 @@
           <p:cNvPr id="12" name="">
             <a:extLst xmlns:a="http://schemas.openxmlformats.org/drawingml/2006/main">
               <a:ext uri="{FF2B5EF4-FFF2-40B4-BE49-F238E27FC236}">
-                <a16:creationId xmlns:a16="http://schemas.microsoft.com/office/drawing/2014/main" id="{06AC444E-7833-4BFE-B15D-9AF3BE4F448F}"/>
+                <a16:creationId xmlns:a16="http://schemas.microsoft.com/office/drawing/2014/main" id="{424591E1-06DB-4383-A7FB-0097C6C08745}"/>
               </a:ext>
             </a:extLst>
           </p:cNvPr>
@@ -8586,7 +8657,7 @@
                 <a:ea typeface="Aptos"/>
                 <a:cs typeface="Aptos"/>
               </a:rPr>
-              <a:t>Native interaction ID + revision</a:t>
+              <a:t>Task-specific inputs</a:t>
             </a:r>
           </a:p>
           <a:p xmlns:a="http://schemas.openxmlformats.org/drawingml/2006/main">
@@ -8609,7 +8680,7 @@
                 <a:ea typeface="Aptos"/>
                 <a:cs typeface="Aptos"/>
               </a:rPr>
-              <a:t>Current authorization at apply</a:t>
+              <a:t>Sandbox and isolated worktree</a:t>
             </a:r>
           </a:p>
           <a:p xmlns:a="http://schemas.openxmlformats.org/drawingml/2006/main">
@@ -8632,7 +8703,7 @@
                 <a:ea typeface="Aptos"/>
                 <a:cs typeface="Aptos"/>
               </a:rPr>
-              <a:t>Stale/conflicting answer handling</a:t>
+              <a:t>Existing provider lifecycle</a:t>
             </a:r>
           </a:p>
           <a:p xmlns:a="http://schemas.openxmlformats.org/drawingml/2006/main">
@@ -8655,7 +8726,7 @@
                 <a:ea typeface="Aptos"/>
                 <a:cs typeface="Aptos"/>
               </a:rPr>
-              <a:t>Agent ≠ human approval</a:t>
+              <a:t>No shared publisher credentials</a:t>
             </a:r>
           </a:p>
         </p:txBody>
@@ -8665,7 +8736,7 @@
           <p:cNvPr id="13" name="">
             <a:extLst xmlns:a="http://schemas.openxmlformats.org/drawingml/2006/main">
               <a:ext uri="{FF2B5EF4-FFF2-40B4-BE49-F238E27FC236}">
-                <a16:creationId xmlns:a16="http://schemas.microsoft.com/office/drawing/2014/main" id="{9E409CEF-4B5D-416E-B84A-9888DB2E62F0}"/>
+                <a16:creationId xmlns:a16="http://schemas.microsoft.com/office/drawing/2014/main" id="{CBAF23CF-14FD-40C7-BEE2-1B0894CA12DD}"/>
               </a:ext>
             </a:extLst>
           </p:cNvPr>
@@ -8698,7 +8769,7 @@
           <p:cNvPr id="14" name="">
             <a:extLst xmlns:a="http://schemas.openxmlformats.org/drawingml/2006/main">
               <a:ext uri="{FF2B5EF4-FFF2-40B4-BE49-F238E27FC236}">
-                <a16:creationId xmlns:a16="http://schemas.microsoft.com/office/drawing/2014/main" id="{852249FF-515C-457F-BC9B-E8BD8A419DF5}"/>
+                <a16:creationId xmlns:a16="http://schemas.microsoft.com/office/drawing/2014/main" id="{0EF6E3C3-8538-407D-8323-0B92B83E7700}"/>
               </a:ext>
             </a:extLst>
           </p:cNvPr>
@@ -8755,7 +8826,7 @@
                 <a:ea typeface="Aptos"/>
                 <a:cs typeface="Aptos"/>
               </a:rPr>
-              <a:t>Recovery + audience</a:t>
+              <a:t>Useful result</a:t>
             </a:r>
           </a:p>
         </p:txBody>
@@ -8765,7 +8836,7 @@
           <p:cNvPr id="15" name="">
             <a:extLst xmlns:a="http://schemas.openxmlformats.org/drawingml/2006/main">
               <a:ext uri="{FF2B5EF4-FFF2-40B4-BE49-F238E27FC236}">
-                <a16:creationId xmlns:a16="http://schemas.microsoft.com/office/drawing/2014/main" id="{710B54A4-31E8-4BB5-B111-B6329E8FB691}"/>
+                <a16:creationId xmlns:a16="http://schemas.microsoft.com/office/drawing/2014/main" id="{7472C7BA-02D4-41A2-AD17-667D5D2DDB05}"/>
               </a:ext>
             </a:extLst>
           </p:cNvPr>
@@ -8822,7 +8893,7 @@
                 <a:ea typeface="Aptos"/>
                 <a:cs typeface="Aptos"/>
               </a:rPr>
-              <a:t>Persisted cursor and receipts</a:t>
+              <a:t>Server validates the artifact</a:t>
             </a:r>
           </a:p>
           <a:p xmlns:a="http://schemas.openxmlformats.org/drawingml/2006/main">
@@ -8845,7 +8916,7 @@
                 <a:ea typeface="Aptos"/>
                 <a:cs typeface="Aptos"/>
               </a:rPr>
-              <a:t>Reconcile edits and disconnects</a:t>
+              <a:t>Native review accepts evidence</a:t>
             </a:r>
           </a:p>
           <a:p xmlns:a="http://schemas.openxmlformats.org/drawingml/2006/main">
@@ -8868,7 +8939,7 @@
                 <a:ea typeface="Aptos"/>
                 <a:cs typeface="Aptos"/>
               </a:rPr>
-              <a:t>Same-thread result presentation</a:t>
+              <a:t>Trusted adapter publishes</a:t>
             </a:r>
           </a:p>
           <a:p xmlns:a="http://schemas.openxmlformats.org/drawingml/2006/main">
@@ -8891,7 +8962,7 @@
                 <a:ea typeface="Aptos"/>
                 <a:cs typeface="Aptos"/>
               </a:rPr>
-              <a:t>No cross-company data leakage</a:t>
+              <a:t>Bounded follow-ups preserve context</a:t>
             </a:r>
           </a:p>
         </p:txBody>
@@ -8901,7 +8972,7 @@
           <p:cNvPr id="16" name="">
             <a:extLst xmlns:a="http://schemas.openxmlformats.org/drawingml/2006/main">
               <a:ext uri="{FF2B5EF4-FFF2-40B4-BE49-F238E27FC236}">
-                <a16:creationId xmlns:a16="http://schemas.microsoft.com/office/drawing/2014/main" id="{5191D1A3-FF01-49CA-A27E-E64DC44FBF6D}"/>
+                <a16:creationId xmlns:a16="http://schemas.microsoft.com/office/drawing/2014/main" id="{3B3E80F0-9A88-48A2-A43F-ABA3D488D308}"/>
               </a:ext>
             </a:extLst>
           </p:cNvPr>
@@ -8958,7 +9029,7 @@
                 <a:ea typeface="Aptos"/>
                 <a:cs typeface="Aptos"/>
               </a:rPr>
-              <a:t>A Buzz trigger and native routine must never create two schedulers for the same admitted work.</a:t>
+              <a:t>Integrate through existing public execution contracts. Qualify runtime isolation and enrollment before live participation.</a:t>
             </a:r>
           </a:p>
         </p:txBody>
@@ -8966,7 +9037,7 @@
     </p:spTree>
     <p:extLst>
       <p:ext uri="{BB962C8B-B14F-4D97-AF65-F5344CB8AC3E}">
-        <p14:creationId xmlns:p14="http://schemas.microsoft.com/office/powerpoint/2010/main" val="788778692"/>
+        <p14:creationId xmlns:p14="http://schemas.microsoft.com/office/powerpoint/2010/main" val="1143166186"/>
       </p:ext>
     </p:extLst>
   </p:cSld>
@@ -8997,7 +9068,7 @@
           <p:cNvPr id="17" name="">
             <a:extLst xmlns:a="http://schemas.openxmlformats.org/drawingml/2006/main">
               <a:ext uri="{FF2B5EF4-FFF2-40B4-BE49-F238E27FC236}">
-                <a16:creationId xmlns:a16="http://schemas.microsoft.com/office/drawing/2014/main" id="{EDAE1D18-6CD2-4E5D-9269-E8B44CADFBF6}"/>
+                <a16:creationId xmlns:a16="http://schemas.microsoft.com/office/drawing/2014/main" id="{E8BFF74A-1AD1-4C6B-BD01-419D45C73820}"/>
               </a:ext>
             </a:extLst>
           </p:cNvPr>
@@ -9064,7 +9135,7 @@
           <p:cNvPr id="2" name="">
             <a:extLst xmlns:a="http://schemas.openxmlformats.org/drawingml/2006/main">
               <a:ext uri="{FF2B5EF4-FFF2-40B4-BE49-F238E27FC236}">
-                <a16:creationId xmlns:a16="http://schemas.microsoft.com/office/drawing/2014/main" id="{DBA3FB14-B136-4215-BFFD-14D05040CF1E}"/>
+                <a16:creationId xmlns:a16="http://schemas.microsoft.com/office/drawing/2014/main" id="{230A7959-6D24-4DD6-B1B5-C19B68B9EB8D}"/>
               </a:ext>
             </a:extLst>
           </p:cNvPr>
@@ -9121,7 +9192,7 @@
                 <a:ea typeface="Aptos"/>
                 <a:cs typeface="Aptos"/>
               </a:rPr>
-              <a:t>Tests that establish the connected loop</a:t>
+              <a:t>Reliable operation without babysitting</a:t>
             </a:r>
           </a:p>
         </p:txBody>
@@ -9131,7 +9202,7 @@
           <p:cNvPr id="3" name="">
             <a:extLst xmlns:a="http://schemas.openxmlformats.org/drawingml/2006/main">
               <a:ext uri="{FF2B5EF4-FFF2-40B4-BE49-F238E27FC236}">
-                <a16:creationId xmlns:a16="http://schemas.microsoft.com/office/drawing/2014/main" id="{00F9A190-9750-456D-AC46-04A9BD913C4C}"/>
+                <a16:creationId xmlns:a16="http://schemas.microsoft.com/office/drawing/2014/main" id="{EFF4F7FF-0C2A-4EC3-BCF8-F41024202C2B}"/>
               </a:ext>
             </a:extLst>
           </p:cNvPr>
@@ -9188,7 +9259,7 @@
                 <a:ea typeface="Aptos"/>
                 <a:cs typeface="Aptos"/>
               </a:rPr>
-              <a:t>Define fixtures first; retain exact code/config versions, expected outcomes and readback receipts.</a:t>
+              <a:t>One-time pairing and configuration support automatic normal work and recovery.</a:t>
             </a:r>
           </a:p>
         </p:txBody>
@@ -9198,7 +9269,7 @@
           <p:cNvPr id="4" name="">
             <a:extLst xmlns:a="http://schemas.openxmlformats.org/drawingml/2006/main">
               <a:ext uri="{FF2B5EF4-FFF2-40B4-BE49-F238E27FC236}">
-                <a16:creationId xmlns:a16="http://schemas.microsoft.com/office/drawing/2014/main" id="{A7A92A80-8B78-4F76-AB52-C70FA6E24A94}"/>
+                <a16:creationId xmlns:a16="http://schemas.microsoft.com/office/drawing/2014/main" id="{C2793082-B249-4DC4-8471-1FAF88E7F6B0}"/>
               </a:ext>
             </a:extLst>
           </p:cNvPr>
@@ -9229,7 +9300,7 @@
           <p:cNvPr id="5" name="">
             <a:extLst xmlns:a="http://schemas.openxmlformats.org/drawingml/2006/main">
               <a:ext uri="{FF2B5EF4-FFF2-40B4-BE49-F238E27FC236}">
-                <a16:creationId xmlns:a16="http://schemas.microsoft.com/office/drawing/2014/main" id="{9C5D642A-3B63-4889-B24D-D89B18BFB3BF}"/>
+                <a16:creationId xmlns:a16="http://schemas.microsoft.com/office/drawing/2014/main" id="{9170EF64-F932-411E-8306-4801C24BF409}"/>
               </a:ext>
             </a:extLst>
           </p:cNvPr>
@@ -9286,7 +9357,7 @@
                 <a:ea typeface="Aptos"/>
                 <a:cs typeface="Aptos"/>
               </a:rPr>
-              <a:t>INERTIA-2026-10-22-r5 · 22 October 2026 · Design refinement · Compatibility first</a:t>
+              <a:t>INERTIA-2026-10-22-r6 · 22 October 2026 · Autonomous build</a:t>
             </a:r>
           </a:p>
         </p:txBody>
@@ -9296,7 +9367,7 @@
           <p:cNvPr id="6" name="">
             <a:extLst xmlns:a="http://schemas.openxmlformats.org/drawingml/2006/main">
               <a:ext uri="{FF2B5EF4-FFF2-40B4-BE49-F238E27FC236}">
-                <a16:creationId xmlns:a16="http://schemas.microsoft.com/office/drawing/2014/main" id="{AF7546A4-25BA-46E8-A584-C9DA42E9D643}"/>
+                <a16:creationId xmlns:a16="http://schemas.microsoft.com/office/drawing/2014/main" id="{B9B040D9-DFD2-43A0-B283-F6C92C8B651E}"/>
               </a:ext>
             </a:extLst>
           </p:cNvPr>
@@ -9363,7 +9434,7 @@
           <p:cNvPr id="7" name="">
             <a:extLst xmlns:a="http://schemas.openxmlformats.org/drawingml/2006/main">
               <a:ext uri="{FF2B5EF4-FFF2-40B4-BE49-F238E27FC236}">
-                <a16:creationId xmlns:a16="http://schemas.microsoft.com/office/drawing/2014/main" id="{6AB94246-0EE4-4527-B38D-0D68B579D3D4}"/>
+                <a16:creationId xmlns:a16="http://schemas.microsoft.com/office/drawing/2014/main" id="{9ED3A75D-EB6A-4B80-B076-2247FB90597E}"/>
               </a:ext>
             </a:extLst>
           </p:cNvPr>
@@ -9396,7 +9467,7 @@
           <p:cNvPr id="8" name="">
             <a:extLst xmlns:a="http://schemas.openxmlformats.org/drawingml/2006/main">
               <a:ext uri="{FF2B5EF4-FFF2-40B4-BE49-F238E27FC236}">
-                <a16:creationId xmlns:a16="http://schemas.microsoft.com/office/drawing/2014/main" id="{A46DA315-9578-41AE-BB7D-99027E8A7DEC}"/>
+                <a16:creationId xmlns:a16="http://schemas.microsoft.com/office/drawing/2014/main" id="{B4FF6F3B-F4F9-4584-B905-4DE2B777090D}"/>
               </a:ext>
             </a:extLst>
           </p:cNvPr>
@@ -9453,7 +9524,7 @@
                 <a:ea typeface="Aptos"/>
                 <a:cs typeface="Aptos"/>
               </a:rPr>
-              <a:t>Bridge contracts</a:t>
+              <a:t>Configure once</a:t>
             </a:r>
           </a:p>
         </p:txBody>
@@ -9463,7 +9534,7 @@
           <p:cNvPr id="9" name="">
             <a:extLst xmlns:a="http://schemas.openxmlformats.org/drawingml/2006/main">
               <a:ext uri="{FF2B5EF4-FFF2-40B4-BE49-F238E27FC236}">
-                <a16:creationId xmlns:a16="http://schemas.microsoft.com/office/drawing/2014/main" id="{2B77AE1D-82A2-4B26-918E-D6794834A077}"/>
+                <a16:creationId xmlns:a16="http://schemas.microsoft.com/office/drawing/2014/main" id="{6B1382C3-5A6C-4D06-9556-6809EE8439CF}"/>
               </a:ext>
             </a:extLst>
           </p:cNvPr>
@@ -9520,7 +9591,7 @@
                 <a:ea typeface="Aptos"/>
                 <a:cs typeface="Aptos"/>
               </a:rPr>
-              <a:t>Pairing and revocation</a:t>
+              <a:t>Admit the plugin and provider</a:t>
             </a:r>
           </a:p>
           <a:p xmlns:a="http://schemas.openxmlformats.org/drawingml/2006/main">
@@ -9543,7 +9614,7 @@
                 <a:ea typeface="Aptos"/>
                 <a:cs typeface="Aptos"/>
               </a:rPr>
-              <a:t>Duplicate event and echo loop</a:t>
+              <a:t>Bind company, channel and task</a:t>
             </a:r>
           </a:p>
           <a:p xmlns:a="http://schemas.openxmlformats.org/drawingml/2006/main">
@@ -9566,7 +9637,7 @@
                 <a:ea typeface="Aptos"/>
                 <a:cs typeface="Aptos"/>
               </a:rPr>
-              <a:t>Stale/conflicting decisions</a:t>
+              <a:t>Pair authorized identities</a:t>
             </a:r>
           </a:p>
           <a:p xmlns:a="http://schemas.openxmlformats.org/drawingml/2006/main">
@@ -9589,7 +9660,7 @@
                 <a:ea typeface="Aptos"/>
                 <a:cs typeface="Aptos"/>
               </a:rPr>
-              <a:t>Reconnect and one scheduler</a:t>
+              <a:t>Choose source and publication policy</a:t>
             </a:r>
           </a:p>
         </p:txBody>
@@ -9599,7 +9670,7 @@
           <p:cNvPr id="10" name="">
             <a:extLst xmlns:a="http://schemas.openxmlformats.org/drawingml/2006/main">
               <a:ext uri="{FF2B5EF4-FFF2-40B4-BE49-F238E27FC236}">
-                <a16:creationId xmlns:a16="http://schemas.microsoft.com/office/drawing/2014/main" id="{6EC4F03D-DD9D-4E29-AD60-38000924B8CB}"/>
+                <a16:creationId xmlns:a16="http://schemas.microsoft.com/office/drawing/2014/main" id="{2F41B63E-9811-45C2-B0C2-D454743A724F}"/>
               </a:ext>
             </a:extLst>
           </p:cNvPr>
@@ -9632,7 +9703,7 @@
           <p:cNvPr id="11" name="">
             <a:extLst xmlns:a="http://schemas.openxmlformats.org/drawingml/2006/main">
               <a:ext uri="{FF2B5EF4-FFF2-40B4-BE49-F238E27FC236}">
-                <a16:creationId xmlns:a16="http://schemas.microsoft.com/office/drawing/2014/main" id="{84E7D5B2-DC0C-470A-8F4A-CF08AB229A73}"/>
+                <a16:creationId xmlns:a16="http://schemas.microsoft.com/office/drawing/2014/main" id="{72656AD3-8B73-4D89-ADF5-37D3C63785BF}"/>
               </a:ext>
             </a:extLst>
           </p:cNvPr>
@@ -9689,7 +9760,7 @@
                 <a:ea typeface="Aptos"/>
                 <a:cs typeface="Aptos"/>
               </a:rPr>
-              <a:t>Domain acceptance</a:t>
+              <a:t>Recover automatically</a:t>
             </a:r>
           </a:p>
         </p:txBody>
@@ -9699,7 +9770,7 @@
           <p:cNvPr id="12" name="">
             <a:extLst xmlns:a="http://schemas.openxmlformats.org/drawingml/2006/main">
               <a:ext uri="{FF2B5EF4-FFF2-40B4-BE49-F238E27FC236}">
-                <a16:creationId xmlns:a16="http://schemas.microsoft.com/office/drawing/2014/main" id="{61611C16-55CC-4C3E-B88F-583F197C205E}"/>
+                <a16:creationId xmlns:a16="http://schemas.microsoft.com/office/drawing/2014/main" id="{244F498A-6FFD-4234-A00E-64B2C10C5AAD}"/>
               </a:ext>
             </a:extLst>
           </p:cNvPr>
@@ -9756,7 +9827,7 @@
                 <a:ea typeface="Aptos"/>
                 <a:cs typeface="Aptos"/>
               </a:rPr>
-              <a:t>Faithful meeting publication</a:t>
+              <a:t>Persist receipts and checkpoints</a:t>
             </a:r>
           </a:p>
           <a:p xmlns:a="http://schemas.openxmlformats.org/drawingml/2006/main">
@@ -9779,7 +9850,7 @@
                 <a:ea typeface="Aptos"/>
                 <a:cs typeface="Aptos"/>
               </a:rPr>
-              <a:t>Audience and upsert readback</a:t>
+              <a:t>Retry the same signed event</a:t>
             </a:r>
           </a:p>
           <a:p xmlns:a="http://schemas.openxmlformats.org/drawingml/2006/main">
@@ -9802,7 +9873,7 @@
                 <a:ea typeface="Aptos"/>
                 <a:cs typeface="Aptos"/>
               </a:rPr>
-              <a:t>Current grant + immutable packet</a:t>
+              <a:t>Respect server retry timing</a:t>
             </a:r>
           </a:p>
           <a:p xmlns:a="http://schemas.openxmlformats.org/drawingml/2006/main">
@@ -9825,7 +9896,7 @@
                 <a:ea typeface="Aptos"/>
                 <a:cs typeface="Aptos"/>
               </a:rPr>
-              <a:t>Vote hash/network/finality</a:t>
+              <a:t>Reconcile uncertain writes first</a:t>
             </a:r>
           </a:p>
         </p:txBody>
@@ -9835,7 +9906,7 @@
           <p:cNvPr id="13" name="">
             <a:extLst xmlns:a="http://schemas.openxmlformats.org/drawingml/2006/main">
               <a:ext uri="{FF2B5EF4-FFF2-40B4-BE49-F238E27FC236}">
-                <a16:creationId xmlns:a16="http://schemas.microsoft.com/office/drawing/2014/main" id="{E6023EF8-110A-43EF-A098-D9ABFF43CA16}"/>
+                <a16:creationId xmlns:a16="http://schemas.microsoft.com/office/drawing/2014/main" id="{397EE58A-D433-4144-8B73-EDB41BE1F84E}"/>
               </a:ext>
             </a:extLst>
           </p:cNvPr>
@@ -9868,7 +9939,7 @@
           <p:cNvPr id="14" name="">
             <a:extLst xmlns:a="http://schemas.openxmlformats.org/drawingml/2006/main">
               <a:ext uri="{FF2B5EF4-FFF2-40B4-BE49-F238E27FC236}">
-                <a16:creationId xmlns:a16="http://schemas.microsoft.com/office/drawing/2014/main" id="{C90498A9-0FEA-4EC3-9075-9E2ADB1C2018}"/>
+                <a16:creationId xmlns:a16="http://schemas.microsoft.com/office/drawing/2014/main" id="{E07624BE-028A-40D7-AF2A-29F9DD5E200D}"/>
               </a:ext>
             </a:extLst>
           </p:cNvPr>
@@ -9925,7 +9996,7 @@
                 <a:ea typeface="Aptos"/>
                 <a:cs typeface="Aptos"/>
               </a:rPr>
-              <a:t>Member boundaries</a:t>
+              <a:t>Show what matters</a:t>
             </a:r>
           </a:p>
         </p:txBody>
@@ -9935,7 +10006,7 @@
           <p:cNvPr id="15" name="">
             <a:extLst xmlns:a="http://schemas.openxmlformats.org/drawingml/2006/main">
               <a:ext uri="{FF2B5EF4-FFF2-40B4-BE49-F238E27FC236}">
-                <a16:creationId xmlns:a16="http://schemas.microsoft.com/office/drawing/2014/main" id="{72D2CD91-4760-4A7D-8302-5090D711B663}"/>
+                <a16:creationId xmlns:a16="http://schemas.microsoft.com/office/drawing/2014/main" id="{E3D4E954-651E-496F-8F4E-1115F08B1959}"/>
               </a:ext>
             </a:extLst>
           </p:cNvPr>
@@ -9992,7 +10063,7 @@
                 <a:ea typeface="Aptos"/>
                 <a:cs typeface="Aptos"/>
               </a:rPr>
-              <a:t>Second member contribution</a:t>
+              <a:t>Useful same-thread results</a:t>
             </a:r>
           </a:p>
           <a:p xmlns:a="http://schemas.openxmlformats.org/drawingml/2006/main">
@@ -10015,7 +10086,7 @@
                 <a:ea typeface="Aptos"/>
                 <a:cs typeface="Aptos"/>
               </a:rPr>
-              <a:t>Cross-task access denial</a:t>
+              <a:t>Backlog and last successful sync</a:t>
             </a:r>
           </a:p>
           <a:p xmlns:a="http://schemas.openxmlformats.org/drawingml/2006/main">
@@ -10038,7 +10109,7 @@
                 <a:ea typeface="Aptos"/>
                 <a:cs typeface="Aptos"/>
               </a:rPr>
-              <a:t>Sandbox and artifact validation</a:t>
+              <a:t>Clear permanent setup errors</a:t>
             </a:r>
           </a:p>
           <a:p xmlns:a="http://schemas.openxmlformats.org/drawingml/2006/main">
@@ -10061,7 +10132,7 @@
                 <a:ea typeface="Aptos"/>
                 <a:cs typeface="Aptos"/>
               </a:rPr>
-              <a:t>Follow-up limits and recovery</a:t>
+              <a:t>Native UI for complex decisions</a:t>
             </a:r>
           </a:p>
         </p:txBody>
@@ -10071,7 +10142,7 @@
           <p:cNvPr id="16" name="">
             <a:extLst xmlns:a="http://schemas.openxmlformats.org/drawingml/2006/main">
               <a:ext uri="{FF2B5EF4-FFF2-40B4-BE49-F238E27FC236}">
-                <a16:creationId xmlns:a16="http://schemas.microsoft.com/office/drawing/2014/main" id="{E53890B4-F980-4243-ACEC-EA3034B317BC}"/>
+                <a16:creationId xmlns:a16="http://schemas.microsoft.com/office/drawing/2014/main" id="{26AAD5B6-0DB4-4A3C-8838-782ACA834860}"/>
               </a:ext>
             </a:extLst>
           </p:cNvPr>
@@ -10128,7 +10199,7 @@
                 <a:ea typeface="Aptos"/>
                 <a:cs typeface="Aptos"/>
               </a:rPr>
-              <a:t>G1 compatibility → G2 reviewed design → G3 contract acceptance → G4 end-to-end demo evidence.</a:t>
+              <a:t>Source text cannot grant authority. Current host permissions govern every human-attributed native action.</a:t>
             </a:r>
           </a:p>
         </p:txBody>
@@ -10136,7 +10207,7 @@
     </p:spTree>
     <p:extLst>
       <p:ext uri="{BB962C8B-B14F-4D97-AF65-F5344CB8AC3E}">
-        <p14:creationId xmlns:p14="http://schemas.microsoft.com/office/powerpoint/2010/main" val="1663250411"/>
+        <p14:creationId xmlns:p14="http://schemas.microsoft.com/office/powerpoint/2010/main" val="1796107977"/>
       </p:ext>
     </p:extLst>
   </p:cSld>
@@ -10167,7 +10238,7 @@
           <p:cNvPr id="17" name="">
             <a:extLst xmlns:a="http://schemas.openxmlformats.org/drawingml/2006/main">
               <a:ext uri="{FF2B5EF4-FFF2-40B4-BE49-F238E27FC236}">
-                <a16:creationId xmlns:a16="http://schemas.microsoft.com/office/drawing/2014/main" id="{B3DD369A-0929-47EB-AE6A-007377F2A85C}"/>
+                <a16:creationId xmlns:a16="http://schemas.microsoft.com/office/drawing/2014/main" id="{B2493966-7999-40A3-83FF-AB2B04D81A0D}"/>
               </a:ext>
             </a:extLst>
           </p:cNvPr>
@@ -10234,7 +10305,7 @@
           <p:cNvPr id="2" name="">
             <a:extLst xmlns:a="http://schemas.openxmlformats.org/drawingml/2006/main">
               <a:ext uri="{FF2B5EF4-FFF2-40B4-BE49-F238E27FC236}">
-                <a16:creationId xmlns:a16="http://schemas.microsoft.com/office/drawing/2014/main" id="{FA9C625F-9237-482B-91AC-7D3F03CBEECB}"/>
+                <a16:creationId xmlns:a16="http://schemas.microsoft.com/office/drawing/2014/main" id="{C8B52D4F-9531-4529-B538-197B671F0AD1}"/>
               </a:ext>
             </a:extLst>
           </p:cNvPr>
@@ -10291,7 +10362,7 @@
                 <a:ea typeface="Aptos"/>
                 <a:cs typeface="Aptos"/>
               </a:rPr>
-              <a:t>Compatibility first, then concrete design</a:t>
+              <a:t>Build evidence on 22 October</a:t>
             </a:r>
           </a:p>
         </p:txBody>
@@ -10301,7 +10372,7 @@
           <p:cNvPr id="3" name="">
             <a:extLst xmlns:a="http://schemas.openxmlformats.org/drawingml/2006/main">
               <a:ext uri="{FF2B5EF4-FFF2-40B4-BE49-F238E27FC236}">
-                <a16:creationId xmlns:a16="http://schemas.microsoft.com/office/drawing/2014/main" id="{A0EF6768-4815-46D9-912A-D16D3034D249}"/>
+                <a16:creationId xmlns:a16="http://schemas.microsoft.com/office/drawing/2014/main" id="{A6EF57FD-C9F4-4EC6-B9EB-88FFEFCB32F0}"/>
               </a:ext>
             </a:extLst>
           </p:cNvPr>
@@ -10358,7 +10429,7 @@
                 <a:ea typeface="Aptos"/>
                 <a:cs typeface="Aptos"/>
               </a:rPr>
-              <a:t>Three required outcomes remain the target. The next review selects supported interfaces and deployment topology.</a:t>
+              <a:t>Connected bridge and Roundtable core are merged into develop.</a:t>
             </a:r>
           </a:p>
         </p:txBody>
@@ -10368,7 +10439,7 @@
           <p:cNvPr id="4" name="">
             <a:extLst xmlns:a="http://schemas.openxmlformats.org/drawingml/2006/main">
               <a:ext uri="{FF2B5EF4-FFF2-40B4-BE49-F238E27FC236}">
-                <a16:creationId xmlns:a16="http://schemas.microsoft.com/office/drawing/2014/main" id="{256044AF-BE43-4CDD-A043-3E574B8C717A}"/>
+                <a16:creationId xmlns:a16="http://schemas.microsoft.com/office/drawing/2014/main" id="{5616D756-27A0-4527-9667-A16925328996}"/>
               </a:ext>
             </a:extLst>
           </p:cNvPr>
@@ -10399,7 +10470,7 @@
           <p:cNvPr id="5" name="">
             <a:extLst xmlns:a="http://schemas.openxmlformats.org/drawingml/2006/main">
               <a:ext uri="{FF2B5EF4-FFF2-40B4-BE49-F238E27FC236}">
-                <a16:creationId xmlns:a16="http://schemas.microsoft.com/office/drawing/2014/main" id="{853CACAF-275D-4EF3-8FC3-4E0AF3BFA612}"/>
+                <a16:creationId xmlns:a16="http://schemas.microsoft.com/office/drawing/2014/main" id="{C7F36929-593B-48E1-B7F8-53BE82B0D754}"/>
               </a:ext>
             </a:extLst>
           </p:cNvPr>
@@ -10456,7 +10527,7 @@
                 <a:ea typeface="Aptos"/>
                 <a:cs typeface="Aptos"/>
               </a:rPr>
-              <a:t>INERTIA-2026-10-22-r5 · 22 October 2026 · Design refinement · Compatibility first</a:t>
+              <a:t>INERTIA-2026-10-22-r6 · 22 October 2026 · Autonomous build</a:t>
             </a:r>
           </a:p>
         </p:txBody>
@@ -10466,7 +10537,7 @@
           <p:cNvPr id="6" name="">
             <a:extLst xmlns:a="http://schemas.openxmlformats.org/drawingml/2006/main">
               <a:ext uri="{FF2B5EF4-FFF2-40B4-BE49-F238E27FC236}">
-                <a16:creationId xmlns:a16="http://schemas.microsoft.com/office/drawing/2014/main" id="{D53C9AEC-253D-403E-9B1A-6C4F6206C376}"/>
+                <a16:creationId xmlns:a16="http://schemas.microsoft.com/office/drawing/2014/main" id="{1D7FF4B2-2E49-4723-8518-73C80825B92A}"/>
               </a:ext>
             </a:extLst>
           </p:cNvPr>
@@ -10533,7 +10604,7 @@
           <p:cNvPr id="7" name="">
             <a:extLst xmlns:a="http://schemas.openxmlformats.org/drawingml/2006/main">
               <a:ext uri="{FF2B5EF4-FFF2-40B4-BE49-F238E27FC236}">
-                <a16:creationId xmlns:a16="http://schemas.microsoft.com/office/drawing/2014/main" id="{A3E4C447-32FF-4521-935D-2D681E74CC07}"/>
+                <a16:creationId xmlns:a16="http://schemas.microsoft.com/office/drawing/2014/main" id="{42B87E8A-366F-4EA9-BA12-2F34D9CD8C0C}"/>
               </a:ext>
             </a:extLst>
           </p:cNvPr>
@@ -10566,7 +10637,7 @@
           <p:cNvPr id="8" name="">
             <a:extLst xmlns:a="http://schemas.openxmlformats.org/drawingml/2006/main">
               <a:ext uri="{FF2B5EF4-FFF2-40B4-BE49-F238E27FC236}">
-                <a16:creationId xmlns:a16="http://schemas.microsoft.com/office/drawing/2014/main" id="{5A9B8ED6-81F4-4300-B98F-8846CDFAD7E9}"/>
+                <a16:creationId xmlns:a16="http://schemas.microsoft.com/office/drawing/2014/main" id="{049B2ABF-5E1E-44D2-BBCA-26EAEA7ED08B}"/>
               </a:ext>
             </a:extLst>
           </p:cNvPr>
@@ -10623,7 +10694,7 @@
                 <a:ea typeface="Aptos"/>
                 <a:cs typeface="Aptos"/>
               </a:rPr>
-              <a:t>22–23 OCT</a:t>
+              <a:t>Merged foundation</a:t>
             </a:r>
           </a:p>
         </p:txBody>
@@ -10633,7 +10704,7 @@
           <p:cNvPr id="9" name="">
             <a:extLst xmlns:a="http://schemas.openxmlformats.org/drawingml/2006/main">
               <a:ext uri="{FF2B5EF4-FFF2-40B4-BE49-F238E27FC236}">
-                <a16:creationId xmlns:a16="http://schemas.microsoft.com/office/drawing/2014/main" id="{A84519E0-C3C8-44E1-A338-394258AA8F3C}"/>
+                <a16:creationId xmlns:a16="http://schemas.microsoft.com/office/drawing/2014/main" id="{AB45F3C5-0478-4887-A909-6C9123996D0D}"/>
               </a:ext>
             </a:extLst>
           </p:cNvPr>
@@ -10690,7 +10761,7 @@
                 <a:ea typeface="Aptos"/>
                 <a:cs typeface="Aptos"/>
               </a:rPr>
-              <a:t>Pin versions and serving routes</a:t>
+              <a:t>PR 2: 36 transport tests</a:t>
             </a:r>
           </a:p>
           <a:p xmlns:a="http://schemas.openxmlformats.org/drawingml/2006/main">
@@ -10713,7 +10784,7 @@
                 <a:ea typeface="Aptos"/>
                 <a:cs typeface="Aptos"/>
               </a:rPr>
-              <a:t>Qualify execution integration</a:t>
+              <a:t>PR 3: combined 60 tests</a:t>
             </a:r>
           </a:p>
           <a:p xmlns:a="http://schemas.openxmlformats.org/drawingml/2006/main">
@@ -10736,7 +10807,7 @@
                 <a:ea typeface="Aptos"/>
                 <a:cs typeface="Aptos"/>
               </a:rPr>
-              <a:t>Resolve identity and policies</a:t>
+              <a:t>Real signatures and SQL</a:t>
             </a:r>
           </a:p>
           <a:p xmlns:a="http://schemas.openxmlformats.org/drawingml/2006/main">
@@ -10759,7 +10830,7 @@
                 <a:ea typeface="Aptos"/>
                 <a:cs typeface="Aptos"/>
               </a:rPr>
-              <a:t>Review exact bridge contracts</a:t>
+              <a:t>Typecheck, build and fixture demo</a:t>
             </a:r>
           </a:p>
         </p:txBody>
@@ -10769,7 +10840,7 @@
           <p:cNvPr id="10" name="">
             <a:extLst xmlns:a="http://schemas.openxmlformats.org/drawingml/2006/main">
               <a:ext uri="{FF2B5EF4-FFF2-40B4-BE49-F238E27FC236}">
-                <a16:creationId xmlns:a16="http://schemas.microsoft.com/office/drawing/2014/main" id="{A46F59DE-F0BD-469B-9BB3-91D97D641B92}"/>
+                <a16:creationId xmlns:a16="http://schemas.microsoft.com/office/drawing/2014/main" id="{1CA97F40-E346-4BDC-9132-7BEED9E2D73A}"/>
               </a:ext>
             </a:extLst>
           </p:cNvPr>
@@ -10802,7 +10873,7 @@
           <p:cNvPr id="11" name="">
             <a:extLst xmlns:a="http://schemas.openxmlformats.org/drawingml/2006/main">
               <a:ext uri="{FF2B5EF4-FFF2-40B4-BE49-F238E27FC236}">
-                <a16:creationId xmlns:a16="http://schemas.microsoft.com/office/drawing/2014/main" id="{9E7AF292-1641-4CC4-A216-4273FF19CC5B}"/>
+                <a16:creationId xmlns:a16="http://schemas.microsoft.com/office/drawing/2014/main" id="{F58C2A2F-813A-4942-8559-A14A91E62C96}"/>
               </a:ext>
             </a:extLst>
           </p:cNvPr>
@@ -10859,7 +10930,7 @@
                 <a:ea typeface="Aptos"/>
                 <a:cs typeface="Aptos"/>
               </a:rPr>
-              <a:t>23–27 OCT</a:t>
+              <a:t>Connected plugin</a:t>
             </a:r>
           </a:p>
         </p:txBody>
@@ -10869,7 +10940,7 @@
           <p:cNvPr id="12" name="">
             <a:extLst xmlns:a="http://schemas.openxmlformats.org/drawingml/2006/main">
               <a:ext uri="{FF2B5EF4-FFF2-40B4-BE49-F238E27FC236}">
-                <a16:creationId xmlns:a16="http://schemas.microsoft.com/office/drawing/2014/main" id="{AC29E812-4497-418E-B5BF-2A15D81656E4}"/>
+                <a16:creationId xmlns:a16="http://schemas.microsoft.com/office/drawing/2014/main" id="{43C2D438-195B-4E88-8B61-DA5CEDCB5C21}"/>
               </a:ext>
             </a:extLst>
           </p:cNvPr>
@@ -10926,7 +10997,7 @@
                 <a:ea typeface="Aptos"/>
                 <a:cs typeface="Aptos"/>
               </a:rPr>
-              <a:t>Automatic meetings</a:t>
+              <a:t>PR 4 merged: 85 tests</a:t>
             </a:r>
           </a:p>
           <a:p xmlns:a="http://schemas.openxmlformats.org/drawingml/2006/main">
@@ -10949,7 +11020,7 @@
                 <a:ea typeface="Aptos"/>
                 <a:cs typeface="Aptos"/>
               </a:rPr>
-              <a:t>Grant packet vote and Y2</a:t>
+              <a:t>Durable retry and backfill</a:t>
             </a:r>
           </a:p>
           <a:p xmlns:a="http://schemas.openxmlformats.org/drawingml/2006/main">
@@ -10972,7 +11043,7 @@
                 <a:ea typeface="Aptos"/>
                 <a:cs typeface="Aptos"/>
               </a:rPr>
-              <a:t>Member eager contribution</a:t>
+              <a:t>Company-scoped health</a:t>
             </a:r>
           </a:p>
           <a:p xmlns:a="http://schemas.openxmlformats.org/drawingml/2006/main">
@@ -10995,7 +11066,7 @@
                 <a:ea typeface="Aptos"/>
                 <a:cs typeface="Aptos"/>
               </a:rPr>
-              <a:t>Shared Buzz/dashboard state</a:t>
+              <a:t>Addressed-card privacy</a:t>
             </a:r>
           </a:p>
         </p:txBody>
@@ -11005,7 +11076,7 @@
           <p:cNvPr id="13" name="">
             <a:extLst xmlns:a="http://schemas.openxmlformats.org/drawingml/2006/main">
               <a:ext uri="{FF2B5EF4-FFF2-40B4-BE49-F238E27FC236}">
-                <a16:creationId xmlns:a16="http://schemas.microsoft.com/office/drawing/2014/main" id="{25D9261A-17B1-471E-8F79-95CE17810A02}"/>
+                <a16:creationId xmlns:a16="http://schemas.microsoft.com/office/drawing/2014/main" id="{0A9E9C16-C0B5-4EA7-93EB-B9B634082DAB}"/>
               </a:ext>
             </a:extLst>
           </p:cNvPr>
@@ -11038,7 +11109,7 @@
           <p:cNvPr id="14" name="">
             <a:extLst xmlns:a="http://schemas.openxmlformats.org/drawingml/2006/main">
               <a:ext uri="{FF2B5EF4-FFF2-40B4-BE49-F238E27FC236}">
-                <a16:creationId xmlns:a16="http://schemas.microsoft.com/office/drawing/2014/main" id="{F6C29B88-2A05-47D0-8A24-044EBFB49D14}"/>
+                <a16:creationId xmlns:a16="http://schemas.microsoft.com/office/drawing/2014/main" id="{5FACB03B-8C2C-4AE9-829F-FBBD7F80DDC9}"/>
               </a:ext>
             </a:extLst>
           </p:cNvPr>
@@ -11095,7 +11166,7 @@
                 <a:ea typeface="Aptos"/>
                 <a:cs typeface="Aptos"/>
               </a:rPr>
-              <a:t>28–30 OCT</a:t>
+              <a:t>Next product slices</a:t>
             </a:r>
           </a:p>
         </p:txBody>
@@ -11105,7 +11176,7 @@
           <p:cNvPr id="15" name="">
             <a:extLst xmlns:a="http://schemas.openxmlformats.org/drawingml/2006/main">
               <a:ext uri="{FF2B5EF4-FFF2-40B4-BE49-F238E27FC236}">
-                <a16:creationId xmlns:a16="http://schemas.microsoft.com/office/drawing/2014/main" id="{F4E16340-2053-4EEE-9B2D-4BB03B90797A}"/>
+                <a16:creationId xmlns:a16="http://schemas.microsoft.com/office/drawing/2014/main" id="{B07EEB5C-4180-4597-AA18-E563072A6866}"/>
               </a:ext>
             </a:extLst>
           </p:cNvPr>
@@ -11162,7 +11233,7 @@
                 <a:ea typeface="Aptos"/>
                 <a:cs typeface="Aptos"/>
               </a:rPr>
-              <a:t>Adversarial and recovery tests</a:t>
+              <a:t>PR 5: 23 Roundtable tests</a:t>
             </a:r>
           </a:p>
           <a:p xmlns:a="http://schemas.openxmlformats.org/drawingml/2006/main">
@@ -11185,7 +11256,7 @@
                 <a:ea typeface="Aptos"/>
                 <a:cs typeface="Aptos"/>
               </a:rPr>
-              <a:t>Three-flow rehearsal by Oct 29</a:t>
+              <a:t>108 combined tests passing</a:t>
             </a:r>
           </a:p>
           <a:p xmlns:a="http://schemas.openxmlformats.org/drawingml/2006/main">
@@ -11208,7 +11279,7 @@
                 <a:ea typeface="Aptos"/>
                 <a:cs typeface="Aptos"/>
               </a:rPr>
-              <a:t>Synchronized docs and deck</a:t>
+              <a:t>Website publisher still pending</a:t>
             </a:r>
           </a:p>
           <a:p xmlns:a="http://schemas.openxmlformats.org/drawingml/2006/main">
@@ -11231,7 +11302,7 @@
                 <a:ea typeface="Aptos"/>
                 <a:cs typeface="Aptos"/>
               </a:rPr>
-              <a:t>Submission window Oct 30</a:t>
+              <a:t>Grant and member adapters next</a:t>
             </a:r>
           </a:p>
         </p:txBody>
@@ -11241,7 +11312,7 @@
           <p:cNvPr id="16" name="">
             <a:extLst xmlns:a="http://schemas.openxmlformats.org/drawingml/2006/main">
               <a:ext uri="{FF2B5EF4-FFF2-40B4-BE49-F238E27FC236}">
-                <a16:creationId xmlns:a16="http://schemas.microsoft.com/office/drawing/2014/main" id="{8DAEE01F-AC1D-46AE-8041-F73A1BEEF8BA}"/>
+                <a16:creationId xmlns:a16="http://schemas.microsoft.com/office/drawing/2014/main" id="{863246D1-918B-4CE3-859E-EE9ADEC03E3C}"/>
               </a:ext>
             </a:extLst>
           </p:cNvPr>
@@ -11298,7 +11369,7 @@
                 <a:ea typeface="Aptos"/>
                 <a:cs typeface="Aptos"/>
               </a:rPr>
-              <a:t>Configuration questions live in decisions.md. PlanetScale stays; Cloudflare is available; Helix is de-prioritized.</a:t>
+              <a:t>Fixture evidence uses real bridge code with substituted external I/O. Deployment and live rehearsal are still ahead.</a:t>
             </a:r>
           </a:p>
         </p:txBody>
@@ -11306,7 +11377,1177 @@
     </p:spTree>
     <p:extLst>
       <p:ext uri="{BB962C8B-B14F-4D97-AF65-F5344CB8AC3E}">
-        <p14:creationId xmlns:p14="http://schemas.microsoft.com/office/powerpoint/2010/main" val="1562188321"/>
+        <p14:creationId xmlns:p14="http://schemas.microsoft.com/office/powerpoint/2010/main" val="1719125137"/>
+      </p:ext>
+    </p:extLst>
+  </p:cSld>
+</p:sld>
+</file>
+
+<file path=ppt/slides/slide8.xml><?xml version="1.0" encoding="utf-8"?>
+<p:sld xmlns:p="http://schemas.openxmlformats.org/presentationml/2006/main">
+  <p:cSld>
+    <p:bg>
+      <p:bgPr>
+        <a:solidFill xmlns:a="http://schemas.openxmlformats.org/drawingml/2006/main">
+          <a:srgbClr val="F6F5F0"/>
+        </a:solidFill>
+      </p:bgPr>
+    </p:bg>
+    <p:spTree>
+      <p:nvGrpSpPr>
+        <p:cNvPr id="1" name=""/>
+        <p:cNvGrpSpPr/>
+        <p:nvPr/>
+      </p:nvGrpSpPr>
+      <p:grpSpPr>
+        <a:xfrm xmlns:a="http://schemas.openxmlformats.org/drawingml/2006/main"/>
+      </p:grpSpPr>
+      <p:sp>
+        <p:nvSpPr>
+          <p:cNvPr id="17" name="">
+            <a:extLst xmlns:a="http://schemas.openxmlformats.org/drawingml/2006/main">
+              <a:ext uri="{FF2B5EF4-FFF2-40B4-BE49-F238E27FC236}">
+                <a16:creationId xmlns:a16="http://schemas.microsoft.com/office/drawing/2014/main" id="{A7F36360-C342-4961-B6BB-833D725C142D}"/>
+              </a:ext>
+            </a:extLst>
+          </p:cNvPr>
+          <p:cNvSpPr>
+            <a:spLocks xmlns:a="http://schemas.openxmlformats.org/drawingml/2006/main" noGrp="1"/>
+          </p:cNvSpPr>
+          <p:nvPr/>
+        </p:nvSpPr>
+        <p:spPr>
+          <a:xfrm xmlns:a="http://schemas.openxmlformats.org/drawingml/2006/main">
+            <a:off x="571500" y="295275"/>
+            <a:ext cx="9525000" cy="238125"/>
+          </a:xfrm>
+          <a:prstGeom xmlns:a="http://schemas.openxmlformats.org/drawingml/2006/main" prst="rect">
+            <a:avLst/>
+          </a:prstGeom>
+          <a:noFill xmlns:a="http://schemas.openxmlformats.org/drawingml/2006/main"/>
+          <a:ln xmlns:a="http://schemas.openxmlformats.org/drawingml/2006/main" w="0">
+            <a:noFill/>
+            <a:prstDash val="solid"/>
+          </a:ln>
+        </p:spPr>
+        <p:txBody>
+          <a:bodyPr xmlns:a="http://schemas.openxmlformats.org/drawingml/2006/main" lIns="0" tIns="0" rIns="0" bIns="0" anchor="t"/>
+          <a:lstStyle xmlns:a="http://schemas.openxmlformats.org/drawingml/2006/main">
+            <a:defPPr>
+              <a:defRPr sz="1350" b="1">
+                <a:solidFill>
+                  <a:srgbClr val="157D80"/>
+                </a:solidFill>
+                <a:latin typeface="Aptos"/>
+                <a:ea typeface="Aptos"/>
+                <a:cs typeface="Aptos"/>
+              </a:defRPr>
+            </a:defPPr>
+          </a:lstStyle>
+          <a:p xmlns:a="http://schemas.openxmlformats.org/drawingml/2006/main">
+            <a:pPr>
+              <a:defRPr sz="1350" b="1">
+                <a:solidFill>
+                  <a:srgbClr val="157D80"/>
+                </a:solidFill>
+                <a:latin typeface="Aptos"/>
+                <a:ea typeface="Aptos"/>
+                <a:cs typeface="Aptos"/>
+              </a:defRPr>
+            </a:pPr>
+            <a:r>
+              <a:rPr sz="1350" b="1">
+                <a:solidFill>
+                  <a:srgbClr val="157D80"/>
+                </a:solidFill>
+                <a:latin typeface="Aptos"/>
+                <a:ea typeface="Aptos"/>
+                <a:cs typeface="Aptos"/>
+              </a:rPr>
+              <a:t>INERTIA / FORT WORTH DAO</a:t>
+            </a:r>
+          </a:p>
+        </p:txBody>
+      </p:sp>
+      <p:sp>
+        <p:nvSpPr>
+          <p:cNvPr id="2" name="">
+            <a:extLst xmlns:a="http://schemas.openxmlformats.org/drawingml/2006/main">
+              <a:ext uri="{FF2B5EF4-FFF2-40B4-BE49-F238E27FC236}">
+                <a16:creationId xmlns:a16="http://schemas.microsoft.com/office/drawing/2014/main" id="{7800FAFB-FC91-4239-9015-A95D85B1BF6F}"/>
+              </a:ext>
+            </a:extLst>
+          </p:cNvPr>
+          <p:cNvSpPr>
+            <a:spLocks xmlns:a="http://schemas.openxmlformats.org/drawingml/2006/main" noGrp="1"/>
+          </p:cNvSpPr>
+          <p:nvPr/>
+        </p:nvSpPr>
+        <p:spPr>
+          <a:xfrm xmlns:a="http://schemas.openxmlformats.org/drawingml/2006/main">
+            <a:off x="571500" y="723900"/>
+            <a:ext cx="14097000" cy="619125"/>
+          </a:xfrm>
+          <a:prstGeom xmlns:a="http://schemas.openxmlformats.org/drawingml/2006/main" prst="rect">
+            <a:avLst/>
+          </a:prstGeom>
+          <a:noFill xmlns:a="http://schemas.openxmlformats.org/drawingml/2006/main"/>
+          <a:ln xmlns:a="http://schemas.openxmlformats.org/drawingml/2006/main" w="0">
+            <a:noFill/>
+            <a:prstDash val="solid"/>
+          </a:ln>
+        </p:spPr>
+        <p:txBody>
+          <a:bodyPr xmlns:a="http://schemas.openxmlformats.org/drawingml/2006/main" lIns="0" tIns="0" rIns="0" bIns="0" anchor="t"/>
+          <a:lstStyle xmlns:a="http://schemas.openxmlformats.org/drawingml/2006/main">
+            <a:defPPr>
+              <a:defRPr sz="3450" b="1">
+                <a:solidFill>
+                  <a:srgbClr val="132E38"/>
+                </a:solidFill>
+                <a:latin typeface="Aptos"/>
+                <a:ea typeface="Aptos"/>
+                <a:cs typeface="Aptos"/>
+              </a:defRPr>
+            </a:defPPr>
+          </a:lstStyle>
+          <a:p xmlns:a="http://schemas.openxmlformats.org/drawingml/2006/main">
+            <a:pPr>
+              <a:defRPr sz="3450" b="1">
+                <a:solidFill>
+                  <a:srgbClr val="132E38"/>
+                </a:solidFill>
+                <a:latin typeface="Aptos"/>
+                <a:ea typeface="Aptos"/>
+                <a:cs typeface="Aptos"/>
+              </a:defRPr>
+            </a:pPr>
+            <a:r>
+              <a:rPr sz="3450" b="1">
+                <a:solidFill>
+                  <a:srgbClr val="132E38"/>
+                </a:solidFill>
+                <a:latin typeface="Aptos"/>
+                <a:ea typeface="Aptos"/>
+                <a:cs typeface="Aptos"/>
+              </a:rPr>
+              <a:t>Delivery focused on working outcomes</a:t>
+            </a:r>
+          </a:p>
+        </p:txBody>
+      </p:sp>
+      <p:sp>
+        <p:nvSpPr>
+          <p:cNvPr id="3" name="">
+            <a:extLst xmlns:a="http://schemas.openxmlformats.org/drawingml/2006/main">
+              <a:ext uri="{FF2B5EF4-FFF2-40B4-BE49-F238E27FC236}">
+                <a16:creationId xmlns:a16="http://schemas.microsoft.com/office/drawing/2014/main" id="{18FBB0F3-049A-4480-90E3-C75A3E6300F2}"/>
+              </a:ext>
+            </a:extLst>
+          </p:cNvPr>
+          <p:cNvSpPr>
+            <a:spLocks xmlns:a="http://schemas.openxmlformats.org/drawingml/2006/main" noGrp="1"/>
+          </p:cNvSpPr>
+          <p:nvPr/>
+        </p:nvSpPr>
+        <p:spPr>
+          <a:xfrm xmlns:a="http://schemas.openxmlformats.org/drawingml/2006/main">
+            <a:off x="571500" y="1362075"/>
+            <a:ext cx="14097000" cy="523875"/>
+          </a:xfrm>
+          <a:prstGeom xmlns:a="http://schemas.openxmlformats.org/drawingml/2006/main" prst="rect">
+            <a:avLst/>
+          </a:prstGeom>
+          <a:noFill xmlns:a="http://schemas.openxmlformats.org/drawingml/2006/main"/>
+          <a:ln xmlns:a="http://schemas.openxmlformats.org/drawingml/2006/main" w="0">
+            <a:noFill/>
+            <a:prstDash val="solid"/>
+          </a:ln>
+        </p:spPr>
+        <p:txBody>
+          <a:bodyPr xmlns:a="http://schemas.openxmlformats.org/drawingml/2006/main" lIns="0" tIns="0" rIns="0" bIns="0" anchor="t"/>
+          <a:lstStyle xmlns:a="http://schemas.openxmlformats.org/drawingml/2006/main">
+            <a:defPPr>
+              <a:defRPr sz="1800" b="0">
+                <a:solidFill>
+                  <a:srgbClr val="49616A"/>
+                </a:solidFill>
+                <a:latin typeface="Aptos"/>
+                <a:ea typeface="Aptos"/>
+                <a:cs typeface="Aptos"/>
+              </a:defRPr>
+            </a:defPPr>
+          </a:lstStyle>
+          <a:p xmlns:a="http://schemas.openxmlformats.org/drawingml/2006/main">
+            <a:pPr>
+              <a:defRPr sz="1800" b="0">
+                <a:solidFill>
+                  <a:srgbClr val="49616A"/>
+                </a:solidFill>
+                <a:latin typeface="Aptos"/>
+                <a:ea typeface="Aptos"/>
+                <a:cs typeface="Aptos"/>
+              </a:defRPr>
+            </a:pPr>
+            <a:r>
+              <a:rPr sz="1800" b="0">
+                <a:solidFill>
+                  <a:srgbClr val="49616A"/>
+                </a:solidFill>
+                <a:latin typeface="Aptos"/>
+                <a:ea typeface="Aptos"/>
+                <a:cs typeface="Aptos"/>
+              </a:rPr>
+              <a:t>Proposed delivery sequence. Tested and reviewed feature branches merge into develop.</a:t>
+            </a:r>
+          </a:p>
+        </p:txBody>
+      </p:sp>
+      <p:sp>
+        <p:nvSpPr>
+          <p:cNvPr id="4" name="">
+            <a:extLst xmlns:a="http://schemas.openxmlformats.org/drawingml/2006/main">
+              <a:ext uri="{FF2B5EF4-FFF2-40B4-BE49-F238E27FC236}">
+                <a16:creationId xmlns:a16="http://schemas.microsoft.com/office/drawing/2014/main" id="{2EC8A4F3-0E50-44E9-9A25-06979A479A58}"/>
+              </a:ext>
+            </a:extLst>
+          </p:cNvPr>
+          <p:cNvSpPr>
+            <a:spLocks xmlns:a="http://schemas.openxmlformats.org/drawingml/2006/main" noGrp="1"/>
+          </p:cNvSpPr>
+          <p:nvPr/>
+        </p:nvSpPr>
+        <p:spPr>
+          <a:xfrm xmlns:a="http://schemas.openxmlformats.org/drawingml/2006/main">
+            <a:off x="571500" y="7962900"/>
+            <a:ext cx="14097000" cy="9525"/>
+          </a:xfrm>
+          <a:prstGeom xmlns:a="http://schemas.openxmlformats.org/drawingml/2006/main" prst="rect">
+            <a:avLst/>
+          </a:prstGeom>
+          <a:solidFill xmlns:a="http://schemas.openxmlformats.org/drawingml/2006/main">
+            <a:srgbClr val="B9C9C7"/>
+          </a:solidFill>
+          <a:ln xmlns:a="http://schemas.openxmlformats.org/drawingml/2006/main" w="0">
+            <a:noFill/>
+            <a:prstDash val="solid"/>
+          </a:ln>
+        </p:spPr>
+      </p:sp>
+      <p:sp>
+        <p:nvSpPr>
+          <p:cNvPr id="5" name="">
+            <a:extLst xmlns:a="http://schemas.openxmlformats.org/drawingml/2006/main">
+              <a:ext uri="{FF2B5EF4-FFF2-40B4-BE49-F238E27FC236}">
+                <a16:creationId xmlns:a16="http://schemas.microsoft.com/office/drawing/2014/main" id="{7681E94F-2EB8-4076-AFB3-0324B76F029C}"/>
+              </a:ext>
+            </a:extLst>
+          </p:cNvPr>
+          <p:cNvSpPr>
+            <a:spLocks xmlns:a="http://schemas.openxmlformats.org/drawingml/2006/main" noGrp="1"/>
+          </p:cNvSpPr>
+          <p:nvPr/>
+        </p:nvSpPr>
+        <p:spPr>
+          <a:xfrm xmlns:a="http://schemas.openxmlformats.org/drawingml/2006/main">
+            <a:off x="571500" y="8105775"/>
+            <a:ext cx="13144500" cy="238125"/>
+          </a:xfrm>
+          <a:prstGeom xmlns:a="http://schemas.openxmlformats.org/drawingml/2006/main" prst="rect">
+            <a:avLst/>
+          </a:prstGeom>
+          <a:noFill xmlns:a="http://schemas.openxmlformats.org/drawingml/2006/main"/>
+          <a:ln xmlns:a="http://schemas.openxmlformats.org/drawingml/2006/main" w="0">
+            <a:noFill/>
+            <a:prstDash val="solid"/>
+          </a:ln>
+        </p:spPr>
+        <p:txBody>
+          <a:bodyPr xmlns:a="http://schemas.openxmlformats.org/drawingml/2006/main" lIns="0" tIns="0" rIns="0" bIns="0" anchor="t"/>
+          <a:lstStyle xmlns:a="http://schemas.openxmlformats.org/drawingml/2006/main">
+            <a:defPPr>
+              <a:defRPr sz="1275" b="0">
+                <a:solidFill>
+                  <a:srgbClr val="49616A"/>
+                </a:solidFill>
+                <a:latin typeface="Aptos"/>
+                <a:ea typeface="Aptos"/>
+                <a:cs typeface="Aptos"/>
+              </a:defRPr>
+            </a:defPPr>
+          </a:lstStyle>
+          <a:p xmlns:a="http://schemas.openxmlformats.org/drawingml/2006/main">
+            <a:pPr>
+              <a:defRPr sz="1275" b="0">
+                <a:solidFill>
+                  <a:srgbClr val="49616A"/>
+                </a:solidFill>
+                <a:latin typeface="Aptos"/>
+                <a:ea typeface="Aptos"/>
+                <a:cs typeface="Aptos"/>
+              </a:defRPr>
+            </a:pPr>
+            <a:r>
+              <a:rPr sz="1275" b="0">
+                <a:solidFill>
+                  <a:srgbClr val="49616A"/>
+                </a:solidFill>
+                <a:latin typeface="Aptos"/>
+                <a:ea typeface="Aptos"/>
+                <a:cs typeface="Aptos"/>
+              </a:rPr>
+              <a:t>INERTIA-2026-10-22-r6 · 22 October 2026 · Autonomous build</a:t>
+            </a:r>
+          </a:p>
+        </p:txBody>
+      </p:sp>
+      <p:sp>
+        <p:nvSpPr>
+          <p:cNvPr id="6" name="">
+            <a:extLst xmlns:a="http://schemas.openxmlformats.org/drawingml/2006/main">
+              <a:ext uri="{FF2B5EF4-FFF2-40B4-BE49-F238E27FC236}">
+                <a16:creationId xmlns:a16="http://schemas.microsoft.com/office/drawing/2014/main" id="{0F34DE2E-A6A4-446E-AC81-0F455F233699}"/>
+              </a:ext>
+            </a:extLst>
+          </p:cNvPr>
+          <p:cNvSpPr>
+            <a:spLocks xmlns:a="http://schemas.openxmlformats.org/drawingml/2006/main" noGrp="1"/>
+          </p:cNvSpPr>
+          <p:nvPr/>
+        </p:nvSpPr>
+        <p:spPr>
+          <a:xfrm xmlns:a="http://schemas.openxmlformats.org/drawingml/2006/main">
+            <a:off x="14001750" y="8067675"/>
+            <a:ext cx="666750" cy="304800"/>
+          </a:xfrm>
+          <a:prstGeom xmlns:a="http://schemas.openxmlformats.org/drawingml/2006/main" prst="rect">
+            <a:avLst/>
+          </a:prstGeom>
+          <a:noFill xmlns:a="http://schemas.openxmlformats.org/drawingml/2006/main"/>
+          <a:ln xmlns:a="http://schemas.openxmlformats.org/drawingml/2006/main" w="0">
+            <a:noFill/>
+            <a:prstDash val="solid"/>
+          </a:ln>
+        </p:spPr>
+        <p:txBody>
+          <a:bodyPr xmlns:a="http://schemas.openxmlformats.org/drawingml/2006/main" lIns="0" tIns="0" rIns="0" bIns="0" anchor="t"/>
+          <a:lstStyle xmlns:a="http://schemas.openxmlformats.org/drawingml/2006/main">
+            <a:defPPr>
+              <a:defRPr sz="1800" b="1">
+                <a:solidFill>
+                  <a:srgbClr val="157D80"/>
+                </a:solidFill>
+                <a:latin typeface="Aptos"/>
+                <a:ea typeface="Aptos"/>
+                <a:cs typeface="Aptos"/>
+              </a:defRPr>
+            </a:defPPr>
+          </a:lstStyle>
+          <a:p xmlns:a="http://schemas.openxmlformats.org/drawingml/2006/main">
+            <a:pPr>
+              <a:defRPr sz="1800" b="1">
+                <a:solidFill>
+                  <a:srgbClr val="157D80"/>
+                </a:solidFill>
+                <a:latin typeface="Aptos"/>
+                <a:ea typeface="Aptos"/>
+                <a:cs typeface="Aptos"/>
+              </a:defRPr>
+            </a:pPr>
+            <a:r>
+              <a:rPr sz="1800" b="1">
+                <a:solidFill>
+                  <a:srgbClr val="157D80"/>
+                </a:solidFill>
+                <a:latin typeface="Aptos"/>
+                <a:ea typeface="Aptos"/>
+                <a:cs typeface="Aptos"/>
+              </a:rPr>
+              <a:t>08</a:t>
+            </a:r>
+          </a:p>
+        </p:txBody>
+      </p:sp>
+      <p:sp>
+        <p:nvSpPr>
+          <p:cNvPr id="7" name="">
+            <a:extLst xmlns:a="http://schemas.openxmlformats.org/drawingml/2006/main">
+              <a:ext uri="{FF2B5EF4-FFF2-40B4-BE49-F238E27FC236}">
+                <a16:creationId xmlns:a16="http://schemas.microsoft.com/office/drawing/2014/main" id="{49BE7E97-517E-42DB-9A82-F072C4130C03}"/>
+              </a:ext>
+            </a:extLst>
+          </p:cNvPr>
+          <p:cNvSpPr>
+            <a:spLocks xmlns:a="http://schemas.openxmlformats.org/drawingml/2006/main" noGrp="1"/>
+          </p:cNvSpPr>
+          <p:nvPr/>
+        </p:nvSpPr>
+        <p:spPr>
+          <a:xfrm xmlns:a="http://schemas.openxmlformats.org/drawingml/2006/main">
+            <a:off x="571500" y="2381250"/>
+            <a:ext cx="4476750" cy="3619500"/>
+          </a:xfrm>
+          <a:prstGeom xmlns:a="http://schemas.openxmlformats.org/drawingml/2006/main" prst="rect">
+            <a:avLst/>
+          </a:prstGeom>
+          <a:solidFill xmlns:a="http://schemas.openxmlformats.org/drawingml/2006/main">
+            <a:srgbClr val="FFFFFF"/>
+          </a:solidFill>
+          <a:ln xmlns:a="http://schemas.openxmlformats.org/drawingml/2006/main" w="19050">
+            <a:solidFill>
+              <a:srgbClr val="157D80"/>
+            </a:solidFill>
+            <a:prstDash val="dash"/>
+          </a:ln>
+        </p:spPr>
+      </p:sp>
+      <p:sp>
+        <p:nvSpPr>
+          <p:cNvPr id="8" name="">
+            <a:extLst xmlns:a="http://schemas.openxmlformats.org/drawingml/2006/main">
+              <a:ext uri="{FF2B5EF4-FFF2-40B4-BE49-F238E27FC236}">
+                <a16:creationId xmlns:a16="http://schemas.microsoft.com/office/drawing/2014/main" id="{36E7074E-E5B4-4F3A-AEE7-CD3E3BCF96C5}"/>
+              </a:ext>
+            </a:extLst>
+          </p:cNvPr>
+          <p:cNvSpPr>
+            <a:spLocks xmlns:a="http://schemas.openxmlformats.org/drawingml/2006/main" noGrp="1"/>
+          </p:cNvSpPr>
+          <p:nvPr/>
+        </p:nvSpPr>
+        <p:spPr>
+          <a:xfrm xmlns:a="http://schemas.openxmlformats.org/drawingml/2006/main">
+            <a:off x="742950" y="2514600"/>
+            <a:ext cx="4133850" cy="552450"/>
+          </a:xfrm>
+          <a:prstGeom xmlns:a="http://schemas.openxmlformats.org/drawingml/2006/main" prst="rect">
+            <a:avLst/>
+          </a:prstGeom>
+          <a:noFill xmlns:a="http://schemas.openxmlformats.org/drawingml/2006/main"/>
+          <a:ln xmlns:a="http://schemas.openxmlformats.org/drawingml/2006/main" w="0">
+            <a:noFill/>
+            <a:prstDash val="solid"/>
+          </a:ln>
+        </p:spPr>
+        <p:txBody>
+          <a:bodyPr xmlns:a="http://schemas.openxmlformats.org/drawingml/2006/main" lIns="0" tIns="0" rIns="0" bIns="0" anchor="t"/>
+          <a:lstStyle xmlns:a="http://schemas.openxmlformats.org/drawingml/2006/main">
+            <a:defPPr>
+              <a:defRPr sz="1875" b="1">
+                <a:solidFill>
+                  <a:srgbClr val="157D80"/>
+                </a:solidFill>
+                <a:latin typeface="Aptos"/>
+                <a:ea typeface="Aptos"/>
+                <a:cs typeface="Aptos"/>
+              </a:defRPr>
+            </a:defPPr>
+          </a:lstStyle>
+          <a:p xmlns:a="http://schemas.openxmlformats.org/drawingml/2006/main">
+            <a:pPr>
+              <a:defRPr sz="1875" b="1">
+                <a:solidFill>
+                  <a:srgbClr val="157D80"/>
+                </a:solidFill>
+                <a:latin typeface="Aptos"/>
+                <a:ea typeface="Aptos"/>
+                <a:cs typeface="Aptos"/>
+              </a:defRPr>
+            </a:pPr>
+            <a:r>
+              <a:rPr sz="1875" b="1">
+                <a:solidFill>
+                  <a:srgbClr val="157D80"/>
+                </a:solidFill>
+                <a:latin typeface="Aptos"/>
+                <a:ea typeface="Aptos"/>
+                <a:cs typeface="Aptos"/>
+              </a:rPr>
+              <a:t>22–23 OCT</a:t>
+            </a:r>
+          </a:p>
+        </p:txBody>
+      </p:sp>
+      <p:sp>
+        <p:nvSpPr>
+          <p:cNvPr id="9" name="">
+            <a:extLst xmlns:a="http://schemas.openxmlformats.org/drawingml/2006/main">
+              <a:ext uri="{FF2B5EF4-FFF2-40B4-BE49-F238E27FC236}">
+                <a16:creationId xmlns:a16="http://schemas.microsoft.com/office/drawing/2014/main" id="{41EE5B33-E5A6-491B-AED2-645B84F2620F}"/>
+              </a:ext>
+            </a:extLst>
+          </p:cNvPr>
+          <p:cNvSpPr>
+            <a:spLocks xmlns:a="http://schemas.openxmlformats.org/drawingml/2006/main" noGrp="1"/>
+          </p:cNvSpPr>
+          <p:nvPr/>
+        </p:nvSpPr>
+        <p:spPr>
+          <a:xfrm xmlns:a="http://schemas.openxmlformats.org/drawingml/2006/main">
+            <a:off x="742950" y="3048000"/>
+            <a:ext cx="4133850" cy="2876550"/>
+          </a:xfrm>
+          <a:prstGeom xmlns:a="http://schemas.openxmlformats.org/drawingml/2006/main" prst="rect">
+            <a:avLst/>
+          </a:prstGeom>
+          <a:noFill xmlns:a="http://schemas.openxmlformats.org/drawingml/2006/main"/>
+          <a:ln xmlns:a="http://schemas.openxmlformats.org/drawingml/2006/main" w="0">
+            <a:noFill/>
+            <a:prstDash val="solid"/>
+          </a:ln>
+        </p:spPr>
+        <p:txBody>
+          <a:bodyPr xmlns:a="http://schemas.openxmlformats.org/drawingml/2006/main" lIns="0" tIns="0" rIns="0" bIns="0" anchor="t"/>
+          <a:lstStyle xmlns:a="http://schemas.openxmlformats.org/drawingml/2006/main">
+            <a:defPPr>
+              <a:defRPr sz="2250" b="0">
+                <a:solidFill>
+                  <a:srgbClr val="49616A"/>
+                </a:solidFill>
+                <a:latin typeface="Aptos"/>
+                <a:ea typeface="Aptos"/>
+                <a:cs typeface="Aptos"/>
+              </a:defRPr>
+            </a:defPPr>
+          </a:lstStyle>
+          <a:p xmlns:a="http://schemas.openxmlformats.org/drawingml/2006/main">
+            <a:pPr>
+              <a:defRPr sz="2250" b="0">
+                <a:solidFill>
+                  <a:srgbClr val="49616A"/>
+                </a:solidFill>
+                <a:latin typeface="Aptos"/>
+                <a:ea typeface="Aptos"/>
+                <a:cs typeface="Aptos"/>
+              </a:defRPr>
+            </a:pPr>
+            <a:r>
+              <a:rPr sz="2250" b="0">
+                <a:solidFill>
+                  <a:srgbClr val="49616A"/>
+                </a:solidFill>
+                <a:latin typeface="Aptos"/>
+                <a:ea typeface="Aptos"/>
+                <a:cs typeface="Aptos"/>
+              </a:rPr>
+              <a:t>Bridge and core merged</a:t>
+            </a:r>
+          </a:p>
+          <a:p xmlns:a="http://schemas.openxmlformats.org/drawingml/2006/main">
+            <a:pPr>
+              <a:defRPr sz="2250" b="0">
+                <a:solidFill>
+                  <a:srgbClr val="49616A"/>
+                </a:solidFill>
+                <a:latin typeface="Aptos"/>
+                <a:ea typeface="Aptos"/>
+                <a:cs typeface="Aptos"/>
+              </a:defRPr>
+            </a:pPr>
+            <a:r>
+              <a:rPr sz="2250" b="0">
+                <a:solidFill>
+                  <a:srgbClr val="49616A"/>
+                </a:solidFill>
+                <a:latin typeface="Aptos"/>
+                <a:ea typeface="Aptos"/>
+                <a:cs typeface="Aptos"/>
+              </a:rPr>
+              <a:t>Continue website publisher</a:t>
+            </a:r>
+          </a:p>
+          <a:p xmlns:a="http://schemas.openxmlformats.org/drawingml/2006/main">
+            <a:pPr>
+              <a:defRPr sz="2250" b="0">
+                <a:solidFill>
+                  <a:srgbClr val="49616A"/>
+                </a:solidFill>
+                <a:latin typeface="Aptos"/>
+                <a:ea typeface="Aptos"/>
+                <a:cs typeface="Aptos"/>
+              </a:defRPr>
+            </a:pPr>
+            <a:r>
+              <a:rPr sz="2250" b="0">
+                <a:solidFill>
+                  <a:srgbClr val="49616A"/>
+                </a:solidFill>
+                <a:latin typeface="Aptos"/>
+                <a:ea typeface="Aptos"/>
+                <a:cs typeface="Aptos"/>
+              </a:rPr>
+              <a:t>Grant slice now active</a:t>
+            </a:r>
+          </a:p>
+          <a:p xmlns:a="http://schemas.openxmlformats.org/drawingml/2006/main">
+            <a:pPr>
+              <a:defRPr sz="2250" b="0">
+                <a:solidFill>
+                  <a:srgbClr val="49616A"/>
+                </a:solidFill>
+                <a:latin typeface="Aptos"/>
+                <a:ea typeface="Aptos"/>
+                <a:cs typeface="Aptos"/>
+              </a:defRPr>
+            </a:pPr>
+            <a:r>
+              <a:rPr sz="2250" b="0">
+                <a:solidFill>
+                  <a:srgbClr val="49616A"/>
+                </a:solidFill>
+                <a:latin typeface="Aptos"/>
+                <a:ea typeface="Aptos"/>
+                <a:cs typeface="Aptos"/>
+              </a:rPr>
+              <a:t>Keep artifacts aligned</a:t>
+            </a:r>
+          </a:p>
+        </p:txBody>
+      </p:sp>
+      <p:sp>
+        <p:nvSpPr>
+          <p:cNvPr id="10" name="">
+            <a:extLst xmlns:a="http://schemas.openxmlformats.org/drawingml/2006/main">
+              <a:ext uri="{FF2B5EF4-FFF2-40B4-BE49-F238E27FC236}">
+                <a16:creationId xmlns:a16="http://schemas.microsoft.com/office/drawing/2014/main" id="{6DCF7EC8-8239-4E90-B2BD-E87B6944589B}"/>
+              </a:ext>
+            </a:extLst>
+          </p:cNvPr>
+          <p:cNvSpPr>
+            <a:spLocks xmlns:a="http://schemas.openxmlformats.org/drawingml/2006/main" noGrp="1"/>
+          </p:cNvSpPr>
+          <p:nvPr/>
+        </p:nvSpPr>
+        <p:spPr>
+          <a:xfrm xmlns:a="http://schemas.openxmlformats.org/drawingml/2006/main">
+            <a:off x="5381625" y="2381250"/>
+            <a:ext cx="4476750" cy="3619500"/>
+          </a:xfrm>
+          <a:prstGeom xmlns:a="http://schemas.openxmlformats.org/drawingml/2006/main" prst="rect">
+            <a:avLst/>
+          </a:prstGeom>
+          <a:solidFill xmlns:a="http://schemas.openxmlformats.org/drawingml/2006/main">
+            <a:srgbClr val="FFFFFF"/>
+          </a:solidFill>
+          <a:ln xmlns:a="http://schemas.openxmlformats.org/drawingml/2006/main" w="19050">
+            <a:solidFill>
+              <a:srgbClr val="157D80"/>
+            </a:solidFill>
+            <a:prstDash val="dash"/>
+          </a:ln>
+        </p:spPr>
+      </p:sp>
+      <p:sp>
+        <p:nvSpPr>
+          <p:cNvPr id="11" name="">
+            <a:extLst xmlns:a="http://schemas.openxmlformats.org/drawingml/2006/main">
+              <a:ext uri="{FF2B5EF4-FFF2-40B4-BE49-F238E27FC236}">
+                <a16:creationId xmlns:a16="http://schemas.microsoft.com/office/drawing/2014/main" id="{580FAE3F-48DD-4E6D-A5A4-04715DDE9CA1}"/>
+              </a:ext>
+            </a:extLst>
+          </p:cNvPr>
+          <p:cNvSpPr>
+            <a:spLocks xmlns:a="http://schemas.openxmlformats.org/drawingml/2006/main" noGrp="1"/>
+          </p:cNvSpPr>
+          <p:nvPr/>
+        </p:nvSpPr>
+        <p:spPr>
+          <a:xfrm xmlns:a="http://schemas.openxmlformats.org/drawingml/2006/main">
+            <a:off x="5553075" y="2514600"/>
+            <a:ext cx="4133850" cy="552450"/>
+          </a:xfrm>
+          <a:prstGeom xmlns:a="http://schemas.openxmlformats.org/drawingml/2006/main" prst="rect">
+            <a:avLst/>
+          </a:prstGeom>
+          <a:noFill xmlns:a="http://schemas.openxmlformats.org/drawingml/2006/main"/>
+          <a:ln xmlns:a="http://schemas.openxmlformats.org/drawingml/2006/main" w="0">
+            <a:noFill/>
+            <a:prstDash val="solid"/>
+          </a:ln>
+        </p:spPr>
+        <p:txBody>
+          <a:bodyPr xmlns:a="http://schemas.openxmlformats.org/drawingml/2006/main" lIns="0" tIns="0" rIns="0" bIns="0" anchor="t"/>
+          <a:lstStyle xmlns:a="http://schemas.openxmlformats.org/drawingml/2006/main">
+            <a:defPPr>
+              <a:defRPr sz="1875" b="1">
+                <a:solidFill>
+                  <a:srgbClr val="157D80"/>
+                </a:solidFill>
+                <a:latin typeface="Aptos"/>
+                <a:ea typeface="Aptos"/>
+                <a:cs typeface="Aptos"/>
+              </a:defRPr>
+            </a:defPPr>
+          </a:lstStyle>
+          <a:p xmlns:a="http://schemas.openxmlformats.org/drawingml/2006/main">
+            <a:pPr>
+              <a:defRPr sz="1875" b="1">
+                <a:solidFill>
+                  <a:srgbClr val="157D80"/>
+                </a:solidFill>
+                <a:latin typeface="Aptos"/>
+                <a:ea typeface="Aptos"/>
+                <a:cs typeface="Aptos"/>
+              </a:defRPr>
+            </a:pPr>
+            <a:r>
+              <a:rPr sz="1875" b="1">
+                <a:solidFill>
+                  <a:srgbClr val="157D80"/>
+                </a:solidFill>
+                <a:latin typeface="Aptos"/>
+                <a:ea typeface="Aptos"/>
+                <a:cs typeface="Aptos"/>
+              </a:rPr>
+              <a:t>23–27 OCT</a:t>
+            </a:r>
+          </a:p>
+        </p:txBody>
+      </p:sp>
+      <p:sp>
+        <p:nvSpPr>
+          <p:cNvPr id="12" name="">
+            <a:extLst xmlns:a="http://schemas.openxmlformats.org/drawingml/2006/main">
+              <a:ext uri="{FF2B5EF4-FFF2-40B4-BE49-F238E27FC236}">
+                <a16:creationId xmlns:a16="http://schemas.microsoft.com/office/drawing/2014/main" id="{64513E19-DC8F-4038-9D60-2C703B484CBF}"/>
+              </a:ext>
+            </a:extLst>
+          </p:cNvPr>
+          <p:cNvSpPr>
+            <a:spLocks xmlns:a="http://schemas.openxmlformats.org/drawingml/2006/main" noGrp="1"/>
+          </p:cNvSpPr>
+          <p:nvPr/>
+        </p:nvSpPr>
+        <p:spPr>
+          <a:xfrm xmlns:a="http://schemas.openxmlformats.org/drawingml/2006/main">
+            <a:off x="5553075" y="3048000"/>
+            <a:ext cx="4133850" cy="2876550"/>
+          </a:xfrm>
+          <a:prstGeom xmlns:a="http://schemas.openxmlformats.org/drawingml/2006/main" prst="rect">
+            <a:avLst/>
+          </a:prstGeom>
+          <a:noFill xmlns:a="http://schemas.openxmlformats.org/drawingml/2006/main"/>
+          <a:ln xmlns:a="http://schemas.openxmlformats.org/drawingml/2006/main" w="0">
+            <a:noFill/>
+            <a:prstDash val="solid"/>
+          </a:ln>
+        </p:spPr>
+        <p:txBody>
+          <a:bodyPr xmlns:a="http://schemas.openxmlformats.org/drawingml/2006/main" lIns="0" tIns="0" rIns="0" bIns="0" anchor="t"/>
+          <a:lstStyle xmlns:a="http://schemas.openxmlformats.org/drawingml/2006/main">
+            <a:defPPr>
+              <a:defRPr sz="2250" b="0">
+                <a:solidFill>
+                  <a:srgbClr val="49616A"/>
+                </a:solidFill>
+                <a:latin typeface="Aptos"/>
+                <a:ea typeface="Aptos"/>
+                <a:cs typeface="Aptos"/>
+              </a:defRPr>
+            </a:defPPr>
+          </a:lstStyle>
+          <a:p xmlns:a="http://schemas.openxmlformats.org/drawingml/2006/main">
+            <a:pPr>
+              <a:defRPr sz="2250" b="0">
+                <a:solidFill>
+                  <a:srgbClr val="49616A"/>
+                </a:solidFill>
+                <a:latin typeface="Aptos"/>
+                <a:ea typeface="Aptos"/>
+                <a:cs typeface="Aptos"/>
+              </a:defRPr>
+            </a:pPr>
+            <a:r>
+              <a:rPr sz="2250" b="0">
+                <a:solidFill>
+                  <a:srgbClr val="49616A"/>
+                </a:solidFill>
+                <a:latin typeface="Aptos"/>
+                <a:ea typeface="Aptos"/>
+                <a:cs typeface="Aptos"/>
+              </a:rPr>
+              <a:t>Complete domain adapters</a:t>
+            </a:r>
+          </a:p>
+          <a:p xmlns:a="http://schemas.openxmlformats.org/drawingml/2006/main">
+            <a:pPr>
+              <a:defRPr sz="2250" b="0">
+                <a:solidFill>
+                  <a:srgbClr val="49616A"/>
+                </a:solidFill>
+                <a:latin typeface="Aptos"/>
+                <a:ea typeface="Aptos"/>
+                <a:cs typeface="Aptos"/>
+              </a:defRPr>
+            </a:pPr>
+            <a:r>
+              <a:rPr sz="2250" b="0">
+                <a:solidFill>
+                  <a:srgbClr val="49616A"/>
+                </a:solidFill>
+                <a:latin typeface="Aptos"/>
+                <a:ea typeface="Aptos"/>
+                <a:cs typeface="Aptos"/>
+              </a:rPr>
+              <a:t>Integrate approved targets</a:t>
+            </a:r>
+          </a:p>
+          <a:p xmlns:a="http://schemas.openxmlformats.org/drawingml/2006/main">
+            <a:pPr>
+              <a:defRPr sz="2250" b="0">
+                <a:solidFill>
+                  <a:srgbClr val="49616A"/>
+                </a:solidFill>
+                <a:latin typeface="Aptos"/>
+                <a:ea typeface="Aptos"/>
+                <a:cs typeface="Aptos"/>
+              </a:defRPr>
+            </a:pPr>
+            <a:r>
+              <a:rPr sz="2250" b="0">
+                <a:solidFill>
+                  <a:srgbClr val="49616A"/>
+                </a:solidFill>
+                <a:latin typeface="Aptos"/>
+                <a:ea typeface="Aptos"/>
+                <a:cs typeface="Aptos"/>
+              </a:rPr>
+              <a:t>Exercise member contribution</a:t>
+            </a:r>
+          </a:p>
+          <a:p xmlns:a="http://schemas.openxmlformats.org/drawingml/2006/main">
+            <a:pPr>
+              <a:defRPr sz="2250" b="0">
+                <a:solidFill>
+                  <a:srgbClr val="49616A"/>
+                </a:solidFill>
+                <a:latin typeface="Aptos"/>
+                <a:ea typeface="Aptos"/>
+                <a:cs typeface="Aptos"/>
+              </a:defRPr>
+            </a:pPr>
+            <a:r>
+              <a:rPr sz="2250" b="0">
+                <a:solidFill>
+                  <a:srgbClr val="49616A"/>
+                </a:solidFill>
+                <a:latin typeface="Aptos"/>
+                <a:ea typeface="Aptos"/>
+                <a:cs typeface="Aptos"/>
+              </a:rPr>
+              <a:t>Verify normal automatic recovery</a:t>
+            </a:r>
+          </a:p>
+        </p:txBody>
+      </p:sp>
+      <p:sp>
+        <p:nvSpPr>
+          <p:cNvPr id="13" name="">
+            <a:extLst xmlns:a="http://schemas.openxmlformats.org/drawingml/2006/main">
+              <a:ext uri="{FF2B5EF4-FFF2-40B4-BE49-F238E27FC236}">
+                <a16:creationId xmlns:a16="http://schemas.microsoft.com/office/drawing/2014/main" id="{7D0894CB-2A24-4773-B711-3DBB03AD9814}"/>
+              </a:ext>
+            </a:extLst>
+          </p:cNvPr>
+          <p:cNvSpPr>
+            <a:spLocks xmlns:a="http://schemas.openxmlformats.org/drawingml/2006/main" noGrp="1"/>
+          </p:cNvSpPr>
+          <p:nvPr/>
+        </p:nvSpPr>
+        <p:spPr>
+          <a:xfrm xmlns:a="http://schemas.openxmlformats.org/drawingml/2006/main">
+            <a:off x="10191750" y="2381250"/>
+            <a:ext cx="4476750" cy="3619500"/>
+          </a:xfrm>
+          <a:prstGeom xmlns:a="http://schemas.openxmlformats.org/drawingml/2006/main" prst="rect">
+            <a:avLst/>
+          </a:prstGeom>
+          <a:solidFill xmlns:a="http://schemas.openxmlformats.org/drawingml/2006/main">
+            <a:srgbClr val="FFFFFF"/>
+          </a:solidFill>
+          <a:ln xmlns:a="http://schemas.openxmlformats.org/drawingml/2006/main" w="19050">
+            <a:solidFill>
+              <a:srgbClr val="157D80"/>
+            </a:solidFill>
+            <a:prstDash val="dash"/>
+          </a:ln>
+        </p:spPr>
+      </p:sp>
+      <p:sp>
+        <p:nvSpPr>
+          <p:cNvPr id="14" name="">
+            <a:extLst xmlns:a="http://schemas.openxmlformats.org/drawingml/2006/main">
+              <a:ext uri="{FF2B5EF4-FFF2-40B4-BE49-F238E27FC236}">
+                <a16:creationId xmlns:a16="http://schemas.microsoft.com/office/drawing/2014/main" id="{50D29861-A92C-43B0-87FE-E7557E1579C4}"/>
+              </a:ext>
+            </a:extLst>
+          </p:cNvPr>
+          <p:cNvSpPr>
+            <a:spLocks xmlns:a="http://schemas.openxmlformats.org/drawingml/2006/main" noGrp="1"/>
+          </p:cNvSpPr>
+          <p:nvPr/>
+        </p:nvSpPr>
+        <p:spPr>
+          <a:xfrm xmlns:a="http://schemas.openxmlformats.org/drawingml/2006/main">
+            <a:off x="10363200" y="2514600"/>
+            <a:ext cx="4133850" cy="552450"/>
+          </a:xfrm>
+          <a:prstGeom xmlns:a="http://schemas.openxmlformats.org/drawingml/2006/main" prst="rect">
+            <a:avLst/>
+          </a:prstGeom>
+          <a:noFill xmlns:a="http://schemas.openxmlformats.org/drawingml/2006/main"/>
+          <a:ln xmlns:a="http://schemas.openxmlformats.org/drawingml/2006/main" w="0">
+            <a:noFill/>
+            <a:prstDash val="solid"/>
+          </a:ln>
+        </p:spPr>
+        <p:txBody>
+          <a:bodyPr xmlns:a="http://schemas.openxmlformats.org/drawingml/2006/main" lIns="0" tIns="0" rIns="0" bIns="0" anchor="t"/>
+          <a:lstStyle xmlns:a="http://schemas.openxmlformats.org/drawingml/2006/main">
+            <a:defPPr>
+              <a:defRPr sz="1875" b="1">
+                <a:solidFill>
+                  <a:srgbClr val="157D80"/>
+                </a:solidFill>
+                <a:latin typeface="Aptos"/>
+                <a:ea typeface="Aptos"/>
+                <a:cs typeface="Aptos"/>
+              </a:defRPr>
+            </a:defPPr>
+          </a:lstStyle>
+          <a:p xmlns:a="http://schemas.openxmlformats.org/drawingml/2006/main">
+            <a:pPr>
+              <a:defRPr sz="1875" b="1">
+                <a:solidFill>
+                  <a:srgbClr val="157D80"/>
+                </a:solidFill>
+                <a:latin typeface="Aptos"/>
+                <a:ea typeface="Aptos"/>
+                <a:cs typeface="Aptos"/>
+              </a:defRPr>
+            </a:pPr>
+            <a:r>
+              <a:rPr sz="1875" b="1">
+                <a:solidFill>
+                  <a:srgbClr val="157D80"/>
+                </a:solidFill>
+                <a:latin typeface="Aptos"/>
+                <a:ea typeface="Aptos"/>
+                <a:cs typeface="Aptos"/>
+              </a:rPr>
+              <a:t>28–30 OCT</a:t>
+            </a:r>
+          </a:p>
+        </p:txBody>
+      </p:sp>
+      <p:sp>
+        <p:nvSpPr>
+          <p:cNvPr id="15" name="">
+            <a:extLst xmlns:a="http://schemas.openxmlformats.org/drawingml/2006/main">
+              <a:ext uri="{FF2B5EF4-FFF2-40B4-BE49-F238E27FC236}">
+                <a16:creationId xmlns:a16="http://schemas.microsoft.com/office/drawing/2014/main" id="{5829169D-E3DB-4D23-8915-953CE26B069D}"/>
+              </a:ext>
+            </a:extLst>
+          </p:cNvPr>
+          <p:cNvSpPr>
+            <a:spLocks xmlns:a="http://schemas.openxmlformats.org/drawingml/2006/main" noGrp="1"/>
+          </p:cNvSpPr>
+          <p:nvPr/>
+        </p:nvSpPr>
+        <p:spPr>
+          <a:xfrm xmlns:a="http://schemas.openxmlformats.org/drawingml/2006/main">
+            <a:off x="10363200" y="3048000"/>
+            <a:ext cx="4133850" cy="2876550"/>
+          </a:xfrm>
+          <a:prstGeom xmlns:a="http://schemas.openxmlformats.org/drawingml/2006/main" prst="rect">
+            <a:avLst/>
+          </a:prstGeom>
+          <a:noFill xmlns:a="http://schemas.openxmlformats.org/drawingml/2006/main"/>
+          <a:ln xmlns:a="http://schemas.openxmlformats.org/drawingml/2006/main" w="0">
+            <a:noFill/>
+            <a:prstDash val="solid"/>
+          </a:ln>
+        </p:spPr>
+        <p:txBody>
+          <a:bodyPr xmlns:a="http://schemas.openxmlformats.org/drawingml/2006/main" lIns="0" tIns="0" rIns="0" bIns="0" anchor="t"/>
+          <a:lstStyle xmlns:a="http://schemas.openxmlformats.org/drawingml/2006/main">
+            <a:defPPr>
+              <a:defRPr sz="2250" b="0">
+                <a:solidFill>
+                  <a:srgbClr val="49616A"/>
+                </a:solidFill>
+                <a:latin typeface="Aptos"/>
+                <a:ea typeface="Aptos"/>
+                <a:cs typeface="Aptos"/>
+              </a:defRPr>
+            </a:defPPr>
+          </a:lstStyle>
+          <a:p xmlns:a="http://schemas.openxmlformats.org/drawingml/2006/main">
+            <a:pPr>
+              <a:defRPr sz="2250" b="0">
+                <a:solidFill>
+                  <a:srgbClr val="49616A"/>
+                </a:solidFill>
+                <a:latin typeface="Aptos"/>
+                <a:ea typeface="Aptos"/>
+                <a:cs typeface="Aptos"/>
+              </a:defRPr>
+            </a:pPr>
+            <a:r>
+              <a:rPr sz="2250" b="0">
+                <a:solidFill>
+                  <a:srgbClr val="49616A"/>
+                </a:solidFill>
+                <a:latin typeface="Aptos"/>
+                <a:ea typeface="Aptos"/>
+                <a:cs typeface="Aptos"/>
+              </a:rPr>
+              <a:t>Recovery and isolation tests</a:t>
+            </a:r>
+          </a:p>
+          <a:p xmlns:a="http://schemas.openxmlformats.org/drawingml/2006/main">
+            <a:pPr>
+              <a:defRPr sz="2250" b="0">
+                <a:solidFill>
+                  <a:srgbClr val="49616A"/>
+                </a:solidFill>
+                <a:latin typeface="Aptos"/>
+                <a:ea typeface="Aptos"/>
+                <a:cs typeface="Aptos"/>
+              </a:defRPr>
+            </a:pPr>
+            <a:r>
+              <a:rPr sz="2250" b="0">
+                <a:solidFill>
+                  <a:srgbClr val="49616A"/>
+                </a:solidFill>
+                <a:latin typeface="Aptos"/>
+                <a:ea typeface="Aptos"/>
+                <a:cs typeface="Aptos"/>
+              </a:rPr>
+              <a:t>Proposed Oct 29 rehearsal buffer</a:t>
+            </a:r>
+          </a:p>
+          <a:p xmlns:a="http://schemas.openxmlformats.org/drawingml/2006/main">
+            <a:pPr>
+              <a:defRPr sz="2250" b="0">
+                <a:solidFill>
+                  <a:srgbClr val="49616A"/>
+                </a:solidFill>
+                <a:latin typeface="Aptos"/>
+                <a:ea typeface="Aptos"/>
+                <a:cs typeface="Aptos"/>
+              </a:defRPr>
+            </a:pPr>
+            <a:r>
+              <a:rPr sz="2250" b="0">
+                <a:solidFill>
+                  <a:srgbClr val="49616A"/>
+                </a:solidFill>
+                <a:latin typeface="Aptos"/>
+                <a:ea typeface="Aptos"/>
+                <a:cs typeface="Aptos"/>
+              </a:rPr>
+              <a:t>Deck and reproducible evidence</a:t>
+            </a:r>
+          </a:p>
+          <a:p xmlns:a="http://schemas.openxmlformats.org/drawingml/2006/main">
+            <a:pPr>
+              <a:defRPr sz="2250" b="0">
+                <a:solidFill>
+                  <a:srgbClr val="49616A"/>
+                </a:solidFill>
+                <a:latin typeface="Aptos"/>
+                <a:ea typeface="Aptos"/>
+                <a:cs typeface="Aptos"/>
+              </a:defRPr>
+            </a:pPr>
+            <a:r>
+              <a:rPr sz="2250" b="0">
+                <a:solidFill>
+                  <a:srgbClr val="49616A"/>
+                </a:solidFill>
+                <a:latin typeface="Aptos"/>
+                <a:ea typeface="Aptos"/>
+                <a:cs typeface="Aptos"/>
+              </a:rPr>
+              <a:t>Oct 30 owner submission handoff</a:t>
+            </a:r>
+          </a:p>
+        </p:txBody>
+      </p:sp>
+      <p:sp>
+        <p:nvSpPr>
+          <p:cNvPr id="16" name="">
+            <a:extLst xmlns:a="http://schemas.openxmlformats.org/drawingml/2006/main">
+              <a:ext uri="{FF2B5EF4-FFF2-40B4-BE49-F238E27FC236}">
+                <a16:creationId xmlns:a16="http://schemas.microsoft.com/office/drawing/2014/main" id="{AA8ECAB8-73DF-4DFF-8904-5D3F99F4E5F5}"/>
+              </a:ext>
+            </a:extLst>
+          </p:cNvPr>
+          <p:cNvSpPr>
+            <a:spLocks xmlns:a="http://schemas.openxmlformats.org/drawingml/2006/main" noGrp="1"/>
+          </p:cNvSpPr>
+          <p:nvPr/>
+        </p:nvSpPr>
+        <p:spPr>
+          <a:xfrm xmlns:a="http://schemas.openxmlformats.org/drawingml/2006/main">
+            <a:off x="571500" y="6572250"/>
+            <a:ext cx="14097000" cy="1000125"/>
+          </a:xfrm>
+          <a:prstGeom xmlns:a="http://schemas.openxmlformats.org/drawingml/2006/main" prst="rect">
+            <a:avLst/>
+          </a:prstGeom>
+          <a:noFill xmlns:a="http://schemas.openxmlformats.org/drawingml/2006/main"/>
+          <a:ln xmlns:a="http://schemas.openxmlformats.org/drawingml/2006/main" w="0">
+            <a:noFill/>
+            <a:prstDash val="solid"/>
+          </a:ln>
+        </p:spPr>
+        <p:txBody>
+          <a:bodyPr xmlns:a="http://schemas.openxmlformats.org/drawingml/2006/main" lIns="0" tIns="0" rIns="0" bIns="0" anchor="t"/>
+          <a:lstStyle xmlns:a="http://schemas.openxmlformats.org/drawingml/2006/main">
+            <a:defPPr>
+              <a:defRPr sz="2100" b="0">
+                <a:solidFill>
+                  <a:srgbClr val="132E38"/>
+                </a:solidFill>
+                <a:latin typeface="Aptos"/>
+                <a:ea typeface="Aptos"/>
+                <a:cs typeface="Aptos"/>
+              </a:defRPr>
+            </a:defPPr>
+          </a:lstStyle>
+          <a:p xmlns:a="http://schemas.openxmlformats.org/drawingml/2006/main">
+            <a:pPr>
+              <a:defRPr sz="2100" b="0">
+                <a:solidFill>
+                  <a:srgbClr val="132E38"/>
+                </a:solidFill>
+                <a:latin typeface="Aptos"/>
+                <a:ea typeface="Aptos"/>
+                <a:cs typeface="Aptos"/>
+              </a:defRPr>
+            </a:pPr>
+            <a:r>
+              <a:rPr sz="2100" b="0">
+                <a:solidFill>
+                  <a:srgbClr val="132E38"/>
+                </a:solidFill>
+                <a:latin typeface="Aptos"/>
+                <a:ea typeface="Aptos"/>
+                <a:cs typeface="Aptos"/>
+              </a:rPr>
+              <a:t>Main stays untouched. Helix is de-prioritized. Configuration details stay in one decision register.</a:t>
+            </a:r>
+          </a:p>
+        </p:txBody>
+      </p:sp>
+    </p:spTree>
+    <p:extLst>
+      <p:ext uri="{BB962C8B-B14F-4D97-AF65-F5344CB8AC3E}">
+        <p14:creationId xmlns:p14="http://schemas.microsoft.com/office/powerpoint/2010/main" val="298920761"/>
       </p:ext>
     </p:extLst>
   </p:cSld>

</xml_diff>

<commit_message>
docs: synchronize r6 implementation evidence and delivery artifacts (#6)
</commit_message>
<xml_diff>
--- a/Inertia-Architecture.pptx
+++ b/Inertia-Architecture.pptx
@@ -2,19 +2,20 @@
 <file path=ppt/presentation.xml><?xml version="1.0" encoding="utf-8"?>
 <p:presentation xmlns:p="http://schemas.openxmlformats.org/presentationml/2006/main">
   <p:sldMasterIdLst>
-    <p:sldMasterId xmlns:r="http://schemas.openxmlformats.org/officeDocument/2006/relationships" id="2147483648" r:id="R7522085dea574879"/>
+    <p:sldMasterId xmlns:r="http://schemas.openxmlformats.org/officeDocument/2006/relationships" id="2147483648" r:id="R273b139f7c044ff7"/>
   </p:sldMasterIdLst>
   <p:notesMasterIdLst>
-    <p:notesMasterId xmlns:r="http://schemas.openxmlformats.org/officeDocument/2006/relationships" r:id="R85a23800730c45d9"/>
+    <p:notesMasterId xmlns:r="http://schemas.openxmlformats.org/officeDocument/2006/relationships" r:id="Rbaa4f659cae2406d"/>
   </p:notesMasterIdLst>
   <p:sldIdLst>
-    <p:sldId xmlns:r="http://schemas.openxmlformats.org/officeDocument/2006/relationships" id="256" r:id="Rf1fed21ed4354fc8"/>
-    <p:sldId xmlns:r="http://schemas.openxmlformats.org/officeDocument/2006/relationships" id="257" r:id="Rddf49720d4544dd2"/>
-    <p:sldId xmlns:r="http://schemas.openxmlformats.org/officeDocument/2006/relationships" id="258" r:id="R1095a1afbde74181"/>
-    <p:sldId xmlns:r="http://schemas.openxmlformats.org/officeDocument/2006/relationships" id="259" r:id="R47b2dd4ced1b4c3e"/>
-    <p:sldId xmlns:r="http://schemas.openxmlformats.org/officeDocument/2006/relationships" id="260" r:id="R37bcb76b39084b56"/>
-    <p:sldId xmlns:r="http://schemas.openxmlformats.org/officeDocument/2006/relationships" id="261" r:id="R37960745e2e04e7e"/>
-    <p:sldId xmlns:r="http://schemas.openxmlformats.org/officeDocument/2006/relationships" id="262" r:id="R418cf28906d64387"/>
+    <p:sldId xmlns:r="http://schemas.openxmlformats.org/officeDocument/2006/relationships" id="256" r:id="Rb2428aaf842a4875"/>
+    <p:sldId xmlns:r="http://schemas.openxmlformats.org/officeDocument/2006/relationships" id="257" r:id="R59276d759b26441c"/>
+    <p:sldId xmlns:r="http://schemas.openxmlformats.org/officeDocument/2006/relationships" id="258" r:id="R025705acd4d7429f"/>
+    <p:sldId xmlns:r="http://schemas.openxmlformats.org/officeDocument/2006/relationships" id="259" r:id="R7fefb3c3e2714bbc"/>
+    <p:sldId xmlns:r="http://schemas.openxmlformats.org/officeDocument/2006/relationships" id="260" r:id="Rdbc8884b250e4fd9"/>
+    <p:sldId xmlns:r="http://schemas.openxmlformats.org/officeDocument/2006/relationships" id="261" r:id="R380d774362574d86"/>
+    <p:sldId xmlns:r="http://schemas.openxmlformats.org/officeDocument/2006/relationships" id="262" r:id="Rbd70252bac4442fe"/>
+    <p:sldId xmlns:r="http://schemas.openxmlformats.org/officeDocument/2006/relationships" id="263" r:id="R2d339179cb0b4cd0"/>
   </p:sldIdLst>
   <p:sldSz cx="15240000" cy="8572500"/>
   <p:notesSz cx="6858000" cy="9144000"/>
@@ -448,7 +449,7 @@
           <a:lstStyle xmlns:a="http://schemas.openxmlformats.org/drawingml/2006/main"/>
           <a:p xmlns:a="http://schemas.openxmlformats.org/drawingml/2006/main">
             <a:r>
-              <a:t>INERTIA-2026-10-22-r5. Design refinement. See spec.md, testing.md, decisions.md and plan.md. Paperclip source 341b622604b639b056fc58b10e2dd3312d40385c; Buzz source dc25198d530acc6237a0320b697365f29daf0ea6. Source review established native capability surfaces; selected runtime qualification and detailed design review precede implementation. Original overview remains unchanged. Public repo https://github.com/NetRxn/Inertia .</a:t>
+              <a:t>INERTIA-2026-10-22-r6. Sources: spec.md, testing.md, decisions.md, plan.md. Merged baseline https://github.com/NetRxn/Inertia/commit/1d41eeb70b02275a488a7f7583c116c8d2c77f3c; PR 2 https://github.com/NetRxn/Inertia/pull/2; PR 3 https://github.com/NetRxn/Inertia/pull/3. Paperclip selected public release v2026.1012.0, bba6a45f0d364cfd962ac59b3bdf2426a8222adb. Buzz dc25198d530acc6237a0320b697365f29daf0ea6. PR 4 https://github.com/NetRxn/Inertia/pull/4 and PR 5 https://github.com/NetRxn/Inertia/pull/5 merged. Combined 108 tests, typecheck, build and synthetic demo passed. No private execution-provider source included.</a:t>
             </a:r>
           </a:p>
         </p:txBody>
@@ -518,7 +519,7 @@
           <a:lstStyle xmlns:a="http://schemas.openxmlformats.org/drawingml/2006/main"/>
           <a:p xmlns:a="http://schemas.openxmlformats.org/drawingml/2006/main">
             <a:r>
-              <a:t>INERTIA-2026-10-22-r5. Design refinement. See spec.md, testing.md, decisions.md and plan.md. Paperclip source 341b622604b639b056fc58b10e2dd3312d40385c; Buzz source dc25198d530acc6237a0320b697365f29daf0ea6. Source review established native capability surfaces; selected runtime qualification and detailed design review precede implementation. Original overview remains unchanged. Public repo https://github.com/NetRxn/Inertia .</a:t>
+              <a:t>INERTIA-2026-10-22-r6. Sources: spec.md, testing.md, decisions.md, plan.md. Merged baseline https://github.com/NetRxn/Inertia/commit/1d41eeb70b02275a488a7f7583c116c8d2c77f3c; PR 2 https://github.com/NetRxn/Inertia/pull/2; PR 3 https://github.com/NetRxn/Inertia/pull/3. Paperclip selected public release v2026.1012.0, bba6a45f0d364cfd962ac59b3bdf2426a8222adb. Buzz dc25198d530acc6237a0320b697365f29daf0ea6. PR 4 https://github.com/NetRxn/Inertia/pull/4 and PR 5 https://github.com/NetRxn/Inertia/pull/5 merged. Combined 108 tests, typecheck, build and synthetic demo passed. No private execution-provider source included.</a:t>
             </a:r>
           </a:p>
         </p:txBody>
@@ -588,7 +589,7 @@
           <a:lstStyle xmlns:a="http://schemas.openxmlformats.org/drawingml/2006/main"/>
           <a:p xmlns:a="http://schemas.openxmlformats.org/drawingml/2006/main">
             <a:r>
-              <a:t>INERTIA-2026-10-22-r5. Design refinement. See spec.md, testing.md, decisions.md and plan.md. Paperclip source 341b622604b639b056fc58b10e2dd3312d40385c; Buzz source dc25198d530acc6237a0320b697365f29daf0ea6. Source review established native capability surfaces; selected runtime qualification and detailed design review precede implementation. Original overview remains unchanged. Public repo https://github.com/NetRxn/Inertia .</a:t>
+              <a:t>INERTIA-2026-10-22-r6. Sources: spec.md, testing.md, decisions.md, plan.md. Merged baseline https://github.com/NetRxn/Inertia/commit/1d41eeb70b02275a488a7f7583c116c8d2c77f3c; PR 2 https://github.com/NetRxn/Inertia/pull/2; PR 3 https://github.com/NetRxn/Inertia/pull/3. Paperclip selected public release v2026.1012.0, bba6a45f0d364cfd962ac59b3bdf2426a8222adb. Buzz dc25198d530acc6237a0320b697365f29daf0ea6. PR 4 https://github.com/NetRxn/Inertia/pull/4 and PR 5 https://github.com/NetRxn/Inertia/pull/5 merged. Combined 108 tests, typecheck, build and synthetic demo passed. No private execution-provider source included.</a:t>
             </a:r>
           </a:p>
         </p:txBody>
@@ -658,7 +659,7 @@
           <a:lstStyle xmlns:a="http://schemas.openxmlformats.org/drawingml/2006/main"/>
           <a:p xmlns:a="http://schemas.openxmlformats.org/drawingml/2006/main">
             <a:r>
-              <a:t>INERTIA-2026-10-22-r5. Design refinement. See spec.md, testing.md, decisions.md and plan.md. Paperclip source 341b622604b639b056fc58b10e2dd3312d40385c; Buzz source dc25198d530acc6237a0320b697365f29daf0ea6. Source review established native capability surfaces; selected runtime qualification and detailed design review precede implementation. Original overview remains unchanged. Public repo https://github.com/NetRxn/Inertia .</a:t>
+              <a:t>INERTIA-2026-10-22-r6. Sources: spec.md, testing.md, decisions.md, plan.md. Merged baseline https://github.com/NetRxn/Inertia/commit/1d41eeb70b02275a488a7f7583c116c8d2c77f3c; PR 2 https://github.com/NetRxn/Inertia/pull/2; PR 3 https://github.com/NetRxn/Inertia/pull/3. Paperclip selected public release v2026.1012.0, bba6a45f0d364cfd962ac59b3bdf2426a8222adb. Buzz dc25198d530acc6237a0320b697365f29daf0ea6. PR 4 https://github.com/NetRxn/Inertia/pull/4 and PR 5 https://github.com/NetRxn/Inertia/pull/5 merged. Combined 108 tests, typecheck, build and synthetic demo passed. No private execution-provider source included.</a:t>
             </a:r>
           </a:p>
         </p:txBody>
@@ -728,7 +729,7 @@
           <a:lstStyle xmlns:a="http://schemas.openxmlformats.org/drawingml/2006/main"/>
           <a:p xmlns:a="http://schemas.openxmlformats.org/drawingml/2006/main">
             <a:r>
-              <a:t>INERTIA-2026-10-22-r5. Design refinement. See spec.md, testing.md, decisions.md and plan.md. Paperclip source 341b622604b639b056fc58b10e2dd3312d40385c; Buzz source dc25198d530acc6237a0320b697365f29daf0ea6. Source review established native capability surfaces; selected runtime qualification and detailed design review precede implementation. Original overview remains unchanged. Public repo https://github.com/NetRxn/Inertia .</a:t>
+              <a:t>INERTIA-2026-10-22-r6. Sources: spec.md, testing.md, decisions.md, plan.md. Merged baseline https://github.com/NetRxn/Inertia/commit/1d41eeb70b02275a488a7f7583c116c8d2c77f3c; PR 2 https://github.com/NetRxn/Inertia/pull/2; PR 3 https://github.com/NetRxn/Inertia/pull/3. Paperclip selected public release v2026.1012.0, bba6a45f0d364cfd962ac59b3bdf2426a8222adb. Buzz dc25198d530acc6237a0320b697365f29daf0ea6. PR 4 https://github.com/NetRxn/Inertia/pull/4 and PR 5 https://github.com/NetRxn/Inertia/pull/5 merged. Combined 108 tests, typecheck, build and synthetic demo passed. No private execution-provider source included.</a:t>
             </a:r>
           </a:p>
         </p:txBody>
@@ -798,7 +799,7 @@
           <a:lstStyle xmlns:a="http://schemas.openxmlformats.org/drawingml/2006/main"/>
           <a:p xmlns:a="http://schemas.openxmlformats.org/drawingml/2006/main">
             <a:r>
-              <a:t>INERTIA-2026-10-22-r5. Design refinement. See spec.md, testing.md, decisions.md and plan.md. Paperclip source 341b622604b639b056fc58b10e2dd3312d40385c; Buzz source dc25198d530acc6237a0320b697365f29daf0ea6. Source review established native capability surfaces; selected runtime qualification and detailed design review precede implementation. Original overview remains unchanged. Public repo https://github.com/NetRxn/Inertia .</a:t>
+              <a:t>INERTIA-2026-10-22-r6. Sources: spec.md, testing.md, decisions.md, plan.md. Merged baseline https://github.com/NetRxn/Inertia/commit/1d41eeb70b02275a488a7f7583c116c8d2c77f3c; PR 2 https://github.com/NetRxn/Inertia/pull/2; PR 3 https://github.com/NetRxn/Inertia/pull/3. Paperclip selected public release v2026.1012.0, bba6a45f0d364cfd962ac59b3bdf2426a8222adb. Buzz dc25198d530acc6237a0320b697365f29daf0ea6. PR 4 https://github.com/NetRxn/Inertia/pull/4 and PR 5 https://github.com/NetRxn/Inertia/pull/5 merged. Combined 108 tests, typecheck, build and synthetic demo passed. No private execution-provider source included.</a:t>
             </a:r>
           </a:p>
         </p:txBody>
@@ -868,7 +869,77 @@
           <a:lstStyle xmlns:a="http://schemas.openxmlformats.org/drawingml/2006/main"/>
           <a:p xmlns:a="http://schemas.openxmlformats.org/drawingml/2006/main">
             <a:r>
-              <a:t>INERTIA-2026-10-22-r5. Design refinement. See spec.md, testing.md, decisions.md and plan.md. Paperclip source 341b622604b639b056fc58b10e2dd3312d40385c; Buzz source dc25198d530acc6237a0320b697365f29daf0ea6. Source review established native capability surfaces; selected runtime qualification and detailed design review precede implementation. Original overview remains unchanged. Public repo https://github.com/NetRxn/Inertia .</a:t>
+              <a:t>INERTIA-2026-10-22-r6. Sources: spec.md, testing.md, decisions.md, plan.md. Merged baseline https://github.com/NetRxn/Inertia/commit/1d41eeb70b02275a488a7f7583c116c8d2c77f3c; PR 2 https://github.com/NetRxn/Inertia/pull/2; PR 3 https://github.com/NetRxn/Inertia/pull/3. Paperclip selected public release v2026.1012.0, bba6a45f0d364cfd962ac59b3bdf2426a8222adb. Buzz dc25198d530acc6237a0320b697365f29daf0ea6. PR 4 https://github.com/NetRxn/Inertia/pull/4 and PR 5 https://github.com/NetRxn/Inertia/pull/5 merged. Combined 108 tests, typecheck, build and synthetic demo passed. No private execution-provider source included.</a:t>
+            </a:r>
+          </a:p>
+        </p:txBody>
+      </p:sp>
+      <p:sp>
+        <p:nvSpPr>
+          <p:cNvPr id="4" name="Slide Number Placeholder 3"/>
+          <p:cNvSpPr>
+            <a:spLocks xmlns:a="http://schemas.openxmlformats.org/drawingml/2006/main" noGrp="1"/>
+          </p:cNvSpPr>
+          <p:nvPr>
+            <p:ph type="sldNum" idx="5"/>
+          </p:nvPr>
+        </p:nvSpPr>
+        <p:spPr/>
+        <p:txBody>
+          <a:bodyPr xmlns:a="http://schemas.openxmlformats.org/drawingml/2006/main"/>
+          <a:lstStyle xmlns:a="http://schemas.openxmlformats.org/drawingml/2006/main"/>
+          <a:p xmlns:a="http://schemas.openxmlformats.org/drawingml/2006/main"/>
+        </p:txBody>
+      </p:sp>
+    </p:spTree>
+  </p:cSld>
+  <p:clrMapOvr>
+    <a:masterClrMapping xmlns:a="http://schemas.openxmlformats.org/drawingml/2006/main"/>
+  </p:clrMapOvr>
+</p:notes>
+</file>
+
+<file path=ppt/notesSlides/notesSlide8.xml><?xml version="1.0" encoding="utf-8"?>
+<p:notes xmlns:p="http://schemas.openxmlformats.org/presentationml/2006/main">
+  <p:cSld>
+    <p:spTree>
+      <p:nvGrpSpPr>
+        <p:cNvPr id="1" name=""/>
+        <p:cNvGrpSpPr/>
+        <p:nvPr/>
+      </p:nvGrpSpPr>
+      <p:grpSpPr>
+        <a:xfrm xmlns:a="http://schemas.openxmlformats.org/drawingml/2006/main"/>
+      </p:grpSpPr>
+      <p:sp>
+        <p:nvSpPr>
+          <p:cNvPr id="2" name="Slide Image Placeholder 1"/>
+          <p:cNvSpPr>
+            <a:spLocks xmlns:a="http://schemas.openxmlformats.org/drawingml/2006/main" noGrp="1"/>
+          </p:cNvSpPr>
+          <p:nvPr>
+            <p:ph type="sldImg" idx="0"/>
+          </p:nvPr>
+        </p:nvSpPr>
+        <p:spPr/>
+      </p:sp>
+      <p:sp>
+        <p:nvSpPr>
+          <p:cNvPr id="3" name="Notes Placeholder 2"/>
+          <p:cNvSpPr>
+            <a:spLocks xmlns:a="http://schemas.openxmlformats.org/drawingml/2006/main" noGrp="1"/>
+          </p:cNvSpPr>
+          <p:nvPr>
+            <p:ph type="body" idx="1"/>
+          </p:nvPr>
+        </p:nvSpPr>
+        <p:spPr/>
+        <p:txBody>
+          <a:bodyPr xmlns:a="http://schemas.openxmlformats.org/drawingml/2006/main"/>
+          <a:lstStyle xmlns:a="http://schemas.openxmlformats.org/drawingml/2006/main"/>
+          <a:p xmlns:a="http://schemas.openxmlformats.org/drawingml/2006/main">
+            <a:r>
+              <a:t>INERTIA-2026-10-22-r6. Sources: spec.md, testing.md, decisions.md, plan.md. Merged baseline https://github.com/NetRxn/Inertia/commit/1d41eeb70b02275a488a7f7583c116c8d2c77f3c; PR 2 https://github.com/NetRxn/Inertia/pull/2; PR 3 https://github.com/NetRxn/Inertia/pull/3. Paperclip selected public release v2026.1012.0, bba6a45f0d364cfd962ac59b3bdf2426a8222adb. Buzz dc25198d530acc6237a0320b697365f29daf0ea6. PR 4 https://github.com/NetRxn/Inertia/pull/4 and PR 5 https://github.com/NetRxn/Inertia/pull/5 merged. Combined 108 tests, typecheck, build and synthetic demo passed. No private execution-provider source included.</a:t>
             </a:r>
           </a:p>
         </p:txBody>
@@ -915,7 +986,7 @@
           <p:cNvPr id="3" name="Title">
             <a:extLst xmlns:a="http://schemas.openxmlformats.org/drawingml/2006/main">
               <a:ext uri="{FF2B5EF4-FFF2-40B4-BE49-F238E27FC236}">
-                <a16:creationId xmlns:a16="http://schemas.microsoft.com/office/drawing/2014/main" id="{7296E375-8DAF-49D1-B9B8-4D497B8E2C31}"/>
+                <a16:creationId xmlns:a16="http://schemas.microsoft.com/office/drawing/2014/main" id="{BDF0810F-6050-4674-AAA8-ECA143DEEC4D}"/>
               </a:ext>
             </a:extLst>
           </p:cNvPr>
@@ -1072,7 +1143,7 @@
           <p:cNvPr id="2" name="Subtitle">
             <a:extLst xmlns:a="http://schemas.openxmlformats.org/drawingml/2006/main">
               <a:ext uri="{FF2B5EF4-FFF2-40B4-BE49-F238E27FC236}">
-                <a16:creationId xmlns:a16="http://schemas.microsoft.com/office/drawing/2014/main" id="{652AB539-0D1A-4CAD-B305-70F08784E45F}"/>
+                <a16:creationId xmlns:a16="http://schemas.microsoft.com/office/drawing/2014/main" id="{EA6B8F91-5509-4B4B-9C3C-ED80D6C5251B}"/>
               </a:ext>
             </a:extLst>
           </p:cNvPr>
@@ -1246,7 +1317,7 @@
           <p:cNvPr id="2" name="Section title">
             <a:extLst xmlns:a="http://schemas.openxmlformats.org/drawingml/2006/main">
               <a:ext uri="{FF2B5EF4-FFF2-40B4-BE49-F238E27FC236}">
-                <a16:creationId xmlns:a16="http://schemas.microsoft.com/office/drawing/2014/main" id="{5B86BD6A-B536-4CC4-8C31-CACCB918698D}"/>
+                <a16:creationId xmlns:a16="http://schemas.microsoft.com/office/drawing/2014/main" id="{21A9519E-FBF9-43FA-93B2-B31DDA0C141D}"/>
               </a:ext>
             </a:extLst>
           </p:cNvPr>
@@ -1420,7 +1491,7 @@
           <p:cNvPr id="3" name="Title">
             <a:extLst xmlns:a="http://schemas.openxmlformats.org/drawingml/2006/main">
               <a:ext uri="{FF2B5EF4-FFF2-40B4-BE49-F238E27FC236}">
-                <a16:creationId xmlns:a16="http://schemas.microsoft.com/office/drawing/2014/main" id="{57121D69-91E0-4F8C-A577-9E331BFD15C5}"/>
+                <a16:creationId xmlns:a16="http://schemas.microsoft.com/office/drawing/2014/main" id="{EA6BA450-EE2D-498A-B8C5-5E9E63F6AE3B}"/>
               </a:ext>
             </a:extLst>
           </p:cNvPr>
@@ -1577,7 +1648,7 @@
           <p:cNvPr id="2" name="Body">
             <a:extLst xmlns:a="http://schemas.openxmlformats.org/drawingml/2006/main">
               <a:ext uri="{FF2B5EF4-FFF2-40B4-BE49-F238E27FC236}">
-                <a16:creationId xmlns:a16="http://schemas.microsoft.com/office/drawing/2014/main" id="{C6CED398-DBC2-4AE9-B16F-B805668D8822}"/>
+                <a16:creationId xmlns:a16="http://schemas.microsoft.com/office/drawing/2014/main" id="{F1F6EC7A-3BCB-494E-BDF6-A407637FBE5D}"/>
               </a:ext>
             </a:extLst>
           </p:cNvPr>
@@ -1751,7 +1822,7 @@
           <p:cNvPr id="4" name="Title">
             <a:extLst xmlns:a="http://schemas.openxmlformats.org/drawingml/2006/main">
               <a:ext uri="{FF2B5EF4-FFF2-40B4-BE49-F238E27FC236}">
-                <a16:creationId xmlns:a16="http://schemas.microsoft.com/office/drawing/2014/main" id="{C05DE1DC-5B02-4BC9-870C-7990ACEAB626}"/>
+                <a16:creationId xmlns:a16="http://schemas.microsoft.com/office/drawing/2014/main" id="{D8072316-C6BD-4433-8CB6-8ED38FFF9D72}"/>
               </a:ext>
             </a:extLst>
           </p:cNvPr>
@@ -1908,7 +1979,7 @@
           <p:cNvPr id="2" name="Left column">
             <a:extLst xmlns:a="http://schemas.openxmlformats.org/drawingml/2006/main">
               <a:ext uri="{FF2B5EF4-FFF2-40B4-BE49-F238E27FC236}">
-                <a16:creationId xmlns:a16="http://schemas.microsoft.com/office/drawing/2014/main" id="{AE6C1047-B568-43DD-82A9-87C43A65FF20}"/>
+                <a16:creationId xmlns:a16="http://schemas.microsoft.com/office/drawing/2014/main" id="{8365BC37-D593-4BE1-B8B4-A612C93CFD8E}"/>
               </a:ext>
             </a:extLst>
           </p:cNvPr>
@@ -2065,7 +2136,7 @@
           <p:cNvPr id="3" name="Right column">
             <a:extLst xmlns:a="http://schemas.openxmlformats.org/drawingml/2006/main">
               <a:ext uri="{FF2B5EF4-FFF2-40B4-BE49-F238E27FC236}">
-                <a16:creationId xmlns:a16="http://schemas.microsoft.com/office/drawing/2014/main" id="{56E3E9C7-2112-469E-BC77-56D947FE140A}"/>
+                <a16:creationId xmlns:a16="http://schemas.microsoft.com/office/drawing/2014/main" id="{979E7B16-753E-4015-8000-450742DCD271}"/>
               </a:ext>
             </a:extLst>
           </p:cNvPr>
@@ -2239,7 +2310,7 @@
           <p:cNvPr id="3" name="Title">
             <a:extLst xmlns:a="http://schemas.openxmlformats.org/drawingml/2006/main">
               <a:ext uri="{FF2B5EF4-FFF2-40B4-BE49-F238E27FC236}">
-                <a16:creationId xmlns:a16="http://schemas.microsoft.com/office/drawing/2014/main" id="{3DED7CBB-3927-4608-B3FD-395C26DD1670}"/>
+                <a16:creationId xmlns:a16="http://schemas.microsoft.com/office/drawing/2014/main" id="{6443D337-3BC4-4995-A4E6-5F85B907D525}"/>
               </a:ext>
             </a:extLst>
           </p:cNvPr>
@@ -2396,7 +2467,7 @@
           <p:cNvPr id="2" name="Left column">
             <a:extLst xmlns:a="http://schemas.openxmlformats.org/drawingml/2006/main">
               <a:ext uri="{FF2B5EF4-FFF2-40B4-BE49-F238E27FC236}">
-                <a16:creationId xmlns:a16="http://schemas.microsoft.com/office/drawing/2014/main" id="{43652C21-222F-45C1-92D2-E4E5C9EB3863}"/>
+                <a16:creationId xmlns:a16="http://schemas.microsoft.com/office/drawing/2014/main" id="{B4349902-5219-49E5-9EF2-5FD7115225ED}"/>
               </a:ext>
             </a:extLst>
           </p:cNvPr>
@@ -2591,12 +2662,12 @@
   </p:cSld>
   <p:clrMap bg1="lt1" tx1="dk1" bg2="lt2" tx2="dk2" accent1="accent1" accent2="accent2" accent3="accent3" accent4="accent4" accent5="accent5" accent6="accent6" hlink="hlink" folHlink="folHlink"/>
   <p:sldLayoutIdLst>
-    <p:sldLayoutId xmlns:r="http://schemas.openxmlformats.org/officeDocument/2006/relationships" id="2147483649" r:id="R6e1d382a9f844b7c"/>
-    <p:sldLayoutId xmlns:r="http://schemas.openxmlformats.org/officeDocument/2006/relationships" id="2147483650" r:id="R80faeb746418477c"/>
-    <p:sldLayoutId xmlns:r="http://schemas.openxmlformats.org/officeDocument/2006/relationships" id="2147483651" r:id="Rcec9c4c97530455a"/>
-    <p:sldLayoutId xmlns:r="http://schemas.openxmlformats.org/officeDocument/2006/relationships" id="2147483652" r:id="R72f278bcceab47f9"/>
-    <p:sldLayoutId xmlns:r="http://schemas.openxmlformats.org/officeDocument/2006/relationships" id="2147483653" r:id="Rea35dcf0d8a64f00"/>
-    <p:sldLayoutId xmlns:r="http://schemas.openxmlformats.org/officeDocument/2006/relationships" id="2147483654" r:id="R1eb39f78f78f4c9d"/>
+    <p:sldLayoutId xmlns:r="http://schemas.openxmlformats.org/officeDocument/2006/relationships" id="2147483649" r:id="R8c57d72e0bc3468b"/>
+    <p:sldLayoutId xmlns:r="http://schemas.openxmlformats.org/officeDocument/2006/relationships" id="2147483650" r:id="R0293d6e23782453b"/>
+    <p:sldLayoutId xmlns:r="http://schemas.openxmlformats.org/officeDocument/2006/relationships" id="2147483651" r:id="Rf00b4e3903384bd5"/>
+    <p:sldLayoutId xmlns:r="http://schemas.openxmlformats.org/officeDocument/2006/relationships" id="2147483652" r:id="Rb962b177267a48d7"/>
+    <p:sldLayoutId xmlns:r="http://schemas.openxmlformats.org/officeDocument/2006/relationships" id="2147483653" r:id="R3057f58f9b084090"/>
+    <p:sldLayoutId xmlns:r="http://schemas.openxmlformats.org/officeDocument/2006/relationships" id="2147483654" r:id="Rcd59f86f3a4d47b2"/>
   </p:sldLayoutIdLst>
   <p:txStyles>
     <p:titleStyle>
@@ -3147,7 +3218,7 @@
           <p:cNvPr id="17" name="">
             <a:extLst xmlns:a="http://schemas.openxmlformats.org/drawingml/2006/main">
               <a:ext uri="{FF2B5EF4-FFF2-40B4-BE49-F238E27FC236}">
-                <a16:creationId xmlns:a16="http://schemas.microsoft.com/office/drawing/2014/main" id="{1A6643E8-4A51-44FF-96C5-984E3B8768E3}"/>
+                <a16:creationId xmlns:a16="http://schemas.microsoft.com/office/drawing/2014/main" id="{18F0D5F2-C12D-4E15-A331-126E9EC351DF}"/>
               </a:ext>
             </a:extLst>
           </p:cNvPr>
@@ -3214,7 +3285,7 @@
           <p:cNvPr id="2" name="">
             <a:extLst xmlns:a="http://schemas.openxmlformats.org/drawingml/2006/main">
               <a:ext uri="{FF2B5EF4-FFF2-40B4-BE49-F238E27FC236}">
-                <a16:creationId xmlns:a16="http://schemas.microsoft.com/office/drawing/2014/main" id="{55DAEA9F-5337-4E4B-BDE6-1A7387D93D3F}"/>
+                <a16:creationId xmlns:a16="http://schemas.microsoft.com/office/drawing/2014/main" id="{9CB2C3C6-B61A-430B-8269-DCA1A8055E42}"/>
               </a:ext>
             </a:extLst>
           </p:cNvPr>
@@ -3271,7 +3342,7 @@
                 <a:ea typeface="Aptos"/>
                 <a:cs typeface="Aptos"/>
               </a:rPr>
-              <a:t>One operating platform, two interfaces</a:t>
+              <a:t>Inertia makes DAO work easier</a:t>
             </a:r>
           </a:p>
         </p:txBody>
@@ -3281,7 +3352,7 @@
           <p:cNvPr id="3" name="">
             <a:extLst xmlns:a="http://schemas.openxmlformats.org/drawingml/2006/main">
               <a:ext uri="{FF2B5EF4-FFF2-40B4-BE49-F238E27FC236}">
-                <a16:creationId xmlns:a16="http://schemas.microsoft.com/office/drawing/2014/main" id="{CB76819D-1D9F-4E1B-B252-AEFD74D96CF7}"/>
+                <a16:creationId xmlns:a16="http://schemas.microsoft.com/office/drawing/2014/main" id="{D954B08E-70D2-48D4-BD99-32420D842391}"/>
               </a:ext>
             </a:extLst>
           </p:cNvPr>
@@ -3338,7 +3409,7 @@
                 <a:ea typeface="Aptos"/>
                 <a:cs typeface="Aptos"/>
               </a:rPr>
-              <a:t>Paperclip owns the work. Buzz and the dashboard present the same tasks, hierarchy and decisions.</a:t>
+              <a:t>One shared work system, with Buzz and the Paperclip dashboard as equal entry points.</a:t>
             </a:r>
           </a:p>
         </p:txBody>
@@ -3348,7 +3419,7 @@
           <p:cNvPr id="4" name="">
             <a:extLst xmlns:a="http://schemas.openxmlformats.org/drawingml/2006/main">
               <a:ext uri="{FF2B5EF4-FFF2-40B4-BE49-F238E27FC236}">
-                <a16:creationId xmlns:a16="http://schemas.microsoft.com/office/drawing/2014/main" id="{736E4F01-69B6-42F2-9C9F-B71E671D34CE}"/>
+                <a16:creationId xmlns:a16="http://schemas.microsoft.com/office/drawing/2014/main" id="{8CAD2439-400F-47B7-BC8B-1B191BA7BD9C}"/>
               </a:ext>
             </a:extLst>
           </p:cNvPr>
@@ -3379,7 +3450,7 @@
           <p:cNvPr id="5" name="">
             <a:extLst xmlns:a="http://schemas.openxmlformats.org/drawingml/2006/main">
               <a:ext uri="{FF2B5EF4-FFF2-40B4-BE49-F238E27FC236}">
-                <a16:creationId xmlns:a16="http://schemas.microsoft.com/office/drawing/2014/main" id="{C97B2F2F-AEFD-4A06-A67F-20F6C003455F}"/>
+                <a16:creationId xmlns:a16="http://schemas.microsoft.com/office/drawing/2014/main" id="{E6203AED-F4B7-4FAC-8669-B1DE88056755}"/>
               </a:ext>
             </a:extLst>
           </p:cNvPr>
@@ -3436,7 +3507,7 @@
                 <a:ea typeface="Aptos"/>
                 <a:cs typeface="Aptos"/>
               </a:rPr>
-              <a:t>INERTIA-2026-10-22-r5 · 22 October 2026 · Design refinement · Compatibility first</a:t>
+              <a:t>INERTIA-2026-10-22-r6 · 22 October 2026 · Autonomous build</a:t>
             </a:r>
           </a:p>
         </p:txBody>
@@ -3446,7 +3517,7 @@
           <p:cNvPr id="6" name="">
             <a:extLst xmlns:a="http://schemas.openxmlformats.org/drawingml/2006/main">
               <a:ext uri="{FF2B5EF4-FFF2-40B4-BE49-F238E27FC236}">
-                <a16:creationId xmlns:a16="http://schemas.microsoft.com/office/drawing/2014/main" id="{A8FBA034-4D2C-4B83-A1C8-101533A13A70}"/>
+                <a16:creationId xmlns:a16="http://schemas.microsoft.com/office/drawing/2014/main" id="{AE2EC293-047E-4D0D-9C76-830648911ED9}"/>
               </a:ext>
             </a:extLst>
           </p:cNvPr>
@@ -3513,7 +3584,7 @@
           <p:cNvPr id="7" name="">
             <a:extLst xmlns:a="http://schemas.openxmlformats.org/drawingml/2006/main">
               <a:ext uri="{FF2B5EF4-FFF2-40B4-BE49-F238E27FC236}">
-                <a16:creationId xmlns:a16="http://schemas.microsoft.com/office/drawing/2014/main" id="{3AB2933E-4012-4530-99E1-4548AC116B37}"/>
+                <a16:creationId xmlns:a16="http://schemas.microsoft.com/office/drawing/2014/main" id="{43EBA0A8-A765-42A6-BFC7-70FD9067A607}"/>
               </a:ext>
             </a:extLst>
           </p:cNvPr>
@@ -3546,7 +3617,7 @@
           <p:cNvPr id="8" name="">
             <a:extLst xmlns:a="http://schemas.openxmlformats.org/drawingml/2006/main">
               <a:ext uri="{FF2B5EF4-FFF2-40B4-BE49-F238E27FC236}">
-                <a16:creationId xmlns:a16="http://schemas.microsoft.com/office/drawing/2014/main" id="{5CE5D347-45B9-4800-A344-607494CB0D59}"/>
+                <a16:creationId xmlns:a16="http://schemas.microsoft.com/office/drawing/2014/main" id="{5B315368-6FA2-4C94-BE4C-90CC68B031EF}"/>
               </a:ext>
             </a:extLst>
           </p:cNvPr>
@@ -3603,7 +3674,7 @@
                 <a:ea typeface="Aptos"/>
                 <a:cs typeface="Aptos"/>
               </a:rPr>
-              <a:t>Paperclip operations</a:t>
+              <a:t>Automatic meetings</a:t>
             </a:r>
           </a:p>
         </p:txBody>
@@ -3613,7 +3684,7 @@
           <p:cNvPr id="9" name="">
             <a:extLst xmlns:a="http://schemas.openxmlformats.org/drawingml/2006/main">
               <a:ext uri="{FF2B5EF4-FFF2-40B4-BE49-F238E27FC236}">
-                <a16:creationId xmlns:a16="http://schemas.microsoft.com/office/drawing/2014/main" id="{52944F71-DB82-426A-ADE6-E2252C955CB7}"/>
+                <a16:creationId xmlns:a16="http://schemas.microsoft.com/office/drawing/2014/main" id="{1979C0B7-880F-4130-8A84-708C4C367E41}"/>
               </a:ext>
             </a:extLst>
           </p:cNvPr>
@@ -3670,7 +3741,7 @@
                 <a:ea typeface="Aptos"/>
                 <a:cs typeface="Aptos"/>
               </a:rPr>
-              <a:t>CEO and hiring</a:t>
+              <a:t>Gemini output in Drive</a:t>
             </a:r>
           </a:p>
           <a:p xmlns:a="http://schemas.openxmlformats.org/drawingml/2006/main">
@@ -3693,7 +3764,7 @@
                 <a:ea typeface="Aptos"/>
                 <a:cs typeface="Aptos"/>
               </a:rPr>
-              <a:t>Goals, issues and dependencies</a:t>
+              <a:t>Clean transcript and notes</a:t>
             </a:r>
           </a:p>
           <a:p xmlns:a="http://schemas.openxmlformats.org/drawingml/2006/main">
@@ -3716,7 +3787,7 @@
                 <a:ea typeface="Aptos"/>
                 <a:cs typeface="Aptos"/>
               </a:rPr>
-              <a:t>Native checkout and routines</a:t>
+              <a:t>Verified website publication</a:t>
             </a:r>
           </a:p>
           <a:p xmlns:a="http://schemas.openxmlformats.org/drawingml/2006/main">
@@ -3739,7 +3810,7 @@
                 <a:ea typeface="Aptos"/>
                 <a:cs typeface="Aptos"/>
               </a:rPr>
-              <a:t>Decisions, documents and budgets</a:t>
+              <a:t>Links back to the conversation</a:t>
             </a:r>
           </a:p>
         </p:txBody>
@@ -3749,7 +3820,7 @@
           <p:cNvPr id="10" name="">
             <a:extLst xmlns:a="http://schemas.openxmlformats.org/drawingml/2006/main">
               <a:ext uri="{FF2B5EF4-FFF2-40B4-BE49-F238E27FC236}">
-                <a16:creationId xmlns:a16="http://schemas.microsoft.com/office/drawing/2014/main" id="{0178DA48-5590-45CE-BF05-1F4E8F7D03BC}"/>
+                <a16:creationId xmlns:a16="http://schemas.microsoft.com/office/drawing/2014/main" id="{9DAF82BC-8350-4090-B196-DFE9144D3C03}"/>
               </a:ext>
             </a:extLst>
           </p:cNvPr>
@@ -3782,7 +3853,7 @@
           <p:cNvPr id="11" name="">
             <a:extLst xmlns:a="http://schemas.openxmlformats.org/drawingml/2006/main">
               <a:ext uri="{FF2B5EF4-FFF2-40B4-BE49-F238E27FC236}">
-                <a16:creationId xmlns:a16="http://schemas.microsoft.com/office/drawing/2014/main" id="{7FF019C3-174B-4453-9A5D-2E6A21950F9F}"/>
+                <a16:creationId xmlns:a16="http://schemas.microsoft.com/office/drawing/2014/main" id="{FB37A1F1-3FD0-4275-BCC6-12F1BA5DF000}"/>
               </a:ext>
             </a:extLst>
           </p:cNvPr>
@@ -3839,7 +3910,7 @@
                 <a:ea typeface="Aptos"/>
                 <a:cs typeface="Aptos"/>
               </a:rPr>
-              <a:t>Buzz + dashboard</a:t>
+              <a:t>Current grant packet</a:t>
             </a:r>
           </a:p>
         </p:txBody>
@@ -3849,7 +3920,7 @@
           <p:cNvPr id="12" name="">
             <a:extLst xmlns:a="http://schemas.openxmlformats.org/drawingml/2006/main">
               <a:ext uri="{FF2B5EF4-FFF2-40B4-BE49-F238E27FC236}">
-                <a16:creationId xmlns:a16="http://schemas.microsoft.com/office/drawing/2014/main" id="{F265AD85-E06A-4221-9FBE-CB232796A3E2}"/>
+                <a16:creationId xmlns:a16="http://schemas.microsoft.com/office/drawing/2014/main" id="{88C78972-E46C-4B6F-BC16-BE2DAAC57BE9}"/>
               </a:ext>
             </a:extLst>
           </p:cNvPr>
@@ -3906,7 +3977,7 @@
                 <a:ea typeface="Aptos"/>
                 <a:cs typeface="Aptos"/>
               </a:rPr>
-              <a:t>Shared task and interaction IDs</a:t>
+              <a:t>Existing scanner discovers</a:t>
             </a:r>
           </a:p>
           <a:p xmlns:a="http://schemas.openxmlformats.org/drawingml/2006/main">
@@ -3929,7 +4000,7 @@
                 <a:ea typeface="Aptos"/>
                 <a:cs typeface="Aptos"/>
               </a:rPr>
-              <a:t>Explicit human / agent pairing</a:t>
+              <a:t>Team reviews the application</a:t>
             </a:r>
           </a:p>
           <a:p xmlns:a="http://schemas.openxmlformats.org/drawingml/2006/main">
@@ -3952,7 +4023,7 @@
                 <a:ea typeface="Aptos"/>
                 <a:cs typeface="Aptos"/>
               </a:rPr>
-              <a:t>Bidirectional results and decisions</a:t>
+              <a:t>Blockchain vote binds the packet</a:t>
             </a:r>
           </a:p>
           <a:p xmlns:a="http://schemas.openxmlformats.org/drawingml/2006/main">
@@ -3975,7 +4046,7 @@
                 <a:ea typeface="Aptos"/>
                 <a:cs typeface="Aptos"/>
               </a:rPr>
-              <a:t>One execution owner</a:t>
+              <a:t>Y2 keeps interests current</a:t>
             </a:r>
           </a:p>
         </p:txBody>
@@ -3985,7 +4056,7 @@
           <p:cNvPr id="13" name="">
             <a:extLst xmlns:a="http://schemas.openxmlformats.org/drawingml/2006/main">
               <a:ext uri="{FF2B5EF4-FFF2-40B4-BE49-F238E27FC236}">
-                <a16:creationId xmlns:a16="http://schemas.microsoft.com/office/drawing/2014/main" id="{0625D2DD-B817-4FBB-ABD9-5780838688BD}"/>
+                <a16:creationId xmlns:a16="http://schemas.microsoft.com/office/drawing/2014/main" id="{BE83E02F-EDCA-455C-B07A-662C6CD036C9}"/>
               </a:ext>
             </a:extLst>
           </p:cNvPr>
@@ -4018,7 +4089,7 @@
           <p:cNvPr id="14" name="">
             <a:extLst xmlns:a="http://schemas.openxmlformats.org/drawingml/2006/main">
               <a:ext uri="{FF2B5EF4-FFF2-40B4-BE49-F238E27FC236}">
-                <a16:creationId xmlns:a16="http://schemas.microsoft.com/office/drawing/2014/main" id="{9603F2C3-A3A5-4F4D-A8C2-39C668F1CAF2}"/>
+                <a16:creationId xmlns:a16="http://schemas.microsoft.com/office/drawing/2014/main" id="{88EFBBB1-2A79-4490-84C5-A53A01473DEE}"/>
               </a:ext>
             </a:extLst>
           </p:cNvPr>
@@ -4075,7 +4146,7 @@
                 <a:ea typeface="Aptos"/>
                 <a:cs typeface="Aptos"/>
               </a:rPr>
-              <a:t>Domain integrations</a:t>
+              <a:t>Member spare capacity</a:t>
             </a:r>
           </a:p>
         </p:txBody>
@@ -4085,7 +4156,7 @@
           <p:cNvPr id="15" name="">
             <a:extLst xmlns:a="http://schemas.openxmlformats.org/drawingml/2006/main">
               <a:ext uri="{FF2B5EF4-FFF2-40B4-BE49-F238E27FC236}">
-                <a16:creationId xmlns:a16="http://schemas.microsoft.com/office/drawing/2014/main" id="{B0940CE0-147C-472D-BAC6-039E39242DE1}"/>
+                <a16:creationId xmlns:a16="http://schemas.microsoft.com/office/drawing/2014/main" id="{ED9D4108-5BBB-4249-9AC9-1CE09E26B5E4}"/>
               </a:ext>
             </a:extLst>
           </p:cNvPr>
@@ -4142,7 +4213,7 @@
                 <a:ea typeface="Aptos"/>
                 <a:cs typeface="Aptos"/>
               </a:rPr>
-              <a:t>Meetings → DAO publication</a:t>
+              <a:t>Connect an authorized agent</a:t>
             </a:r>
           </a:p>
           <a:p xmlns:a="http://schemas.openxmlformats.org/drawingml/2006/main">
@@ -4165,7 +4236,7 @@
                 <a:ea typeface="Aptos"/>
                 <a:cs typeface="Aptos"/>
               </a:rPr>
-              <a:t>Scanner → packet-bound vote</a:t>
+              <a:t>Acquire eligible work eagerly</a:t>
             </a:r>
           </a:p>
           <a:p xmlns:a="http://schemas.openxmlformats.org/drawingml/2006/main">
@@ -4188,7 +4259,7 @@
                 <a:ea typeface="Aptos"/>
                 <a:cs typeface="Aptos"/>
               </a:rPr>
-              <a:t>Member agents → contributions</a:t>
+              <a:t>Return a validated contribution</a:t>
             </a:r>
           </a:p>
           <a:p xmlns:a="http://schemas.openxmlformats.org/drawingml/2006/main">
@@ -4211,7 +4282,7 @@
                 <a:ea typeface="Aptos"/>
                 <a:cs typeface="Aptos"/>
               </a:rPr>
-              <a:t>Y2 updates → linked work</a:t>
+              <a:t>Continue useful follow-ups</a:t>
             </a:r>
           </a:p>
         </p:txBody>
@@ -4221,7 +4292,7 @@
           <p:cNvPr id="16" name="">
             <a:extLst xmlns:a="http://schemas.openxmlformats.org/drawingml/2006/main">
               <a:ext uri="{FF2B5EF4-FFF2-40B4-BE49-F238E27FC236}">
-                <a16:creationId xmlns:a16="http://schemas.microsoft.com/office/drawing/2014/main" id="{FA75D7A4-C2AF-4551-88A8-D86CB47239C3}"/>
+                <a16:creationId xmlns:a16="http://schemas.microsoft.com/office/drawing/2014/main" id="{46AD2712-6E4F-481F-8740-D011F03C8708}"/>
               </a:ext>
             </a:extLst>
           </p:cNvPr>
@@ -4278,7 +4349,7 @@
                 <a:ea typeface="Aptos"/>
                 <a:cs typeface="Aptos"/>
               </a:rPr>
-              <a:t>Design rule: reuse native capabilities and existing execution hardening before adding custom infrastructure.</a:t>
+              <a:t>Required demo outcomes: meeting publication, a packet-bound vote and a second member’s contribution.</a:t>
             </a:r>
           </a:p>
         </p:txBody>
@@ -4286,7 +4357,7 @@
     </p:spTree>
     <p:extLst>
       <p:ext uri="{BB962C8B-B14F-4D97-AF65-F5344CB8AC3E}">
-        <p14:creationId xmlns:p14="http://schemas.microsoft.com/office/powerpoint/2010/main" val="1300162236"/>
+        <p14:creationId xmlns:p14="http://schemas.microsoft.com/office/powerpoint/2010/main" val="210611669"/>
       </p:ext>
     </p:extLst>
   </p:cSld>
@@ -4317,7 +4388,7 @@
           <p:cNvPr id="17" name="">
             <a:extLst xmlns:a="http://schemas.openxmlformats.org/drawingml/2006/main">
               <a:ext uri="{FF2B5EF4-FFF2-40B4-BE49-F238E27FC236}">
-                <a16:creationId xmlns:a16="http://schemas.microsoft.com/office/drawing/2014/main" id="{2374D608-470A-4F36-9D2B-C16B31545796}"/>
+                <a16:creationId xmlns:a16="http://schemas.microsoft.com/office/drawing/2014/main" id="{7FDB1E3D-14E6-4B82-BA03-F8C55EC22F4A}"/>
               </a:ext>
             </a:extLst>
           </p:cNvPr>
@@ -4384,7 +4455,7 @@
           <p:cNvPr id="2" name="">
             <a:extLst xmlns:a="http://schemas.openxmlformats.org/drawingml/2006/main">
               <a:ext uri="{FF2B5EF4-FFF2-40B4-BE49-F238E27FC236}">
-                <a16:creationId xmlns:a16="http://schemas.microsoft.com/office/drawing/2014/main" id="{77652950-3C07-406E-A543-F35860EDEBC8}"/>
+                <a16:creationId xmlns:a16="http://schemas.microsoft.com/office/drawing/2014/main" id="{447186F9-1F90-452E-B2CC-2B9C61F25805}"/>
               </a:ext>
             </a:extLst>
           </p:cNvPr>
@@ -4441,7 +4512,7 @@
                 <a:ea typeface="Aptos"/>
                 <a:cs typeface="Aptos"/>
               </a:rPr>
-              <a:t>Automatic Roundtable publication</a:t>
+              <a:t>Paperclip owns the operating model</a:t>
             </a:r>
           </a:p>
         </p:txBody>
@@ -4451,7 +4522,7 @@
           <p:cNvPr id="3" name="">
             <a:extLst xmlns:a="http://schemas.openxmlformats.org/drawingml/2006/main">
               <a:ext uri="{FF2B5EF4-FFF2-40B4-BE49-F238E27FC236}">
-                <a16:creationId xmlns:a16="http://schemas.microsoft.com/office/drawing/2014/main" id="{7A740A9A-3817-4C6B-9E44-A9FA5F78C887}"/>
+                <a16:creationId xmlns:a16="http://schemas.microsoft.com/office/drawing/2014/main" id="{892CFB54-6CB7-4E30-B7A0-879E1B639ED8}"/>
               </a:ext>
             </a:extLst>
           </p:cNvPr>
@@ -4508,7 +4579,7 @@
                 <a:ea typeface="Aptos"/>
                 <a:cs typeface="Aptos"/>
               </a:rPr>
-              <a:t>Meet video → Gemini → organization Drive → cleaned transcript and separate notes → DAO website.</a:t>
+              <a:t>Reuse the platform’s CEO, hiring, hierarchy and execution primitives.</a:t>
             </a:r>
           </a:p>
         </p:txBody>
@@ -4518,7 +4589,7 @@
           <p:cNvPr id="4" name="">
             <a:extLst xmlns:a="http://schemas.openxmlformats.org/drawingml/2006/main">
               <a:ext uri="{FF2B5EF4-FFF2-40B4-BE49-F238E27FC236}">
-                <a16:creationId xmlns:a16="http://schemas.microsoft.com/office/drawing/2014/main" id="{4CBA3F52-B7F9-4DD3-AEEE-DD6D4E611EE4}"/>
+                <a16:creationId xmlns:a16="http://schemas.microsoft.com/office/drawing/2014/main" id="{79822DEE-9BDB-4B9F-95D2-08D03800DC42}"/>
               </a:ext>
             </a:extLst>
           </p:cNvPr>
@@ -4549,7 +4620,7 @@
           <p:cNvPr id="5" name="">
             <a:extLst xmlns:a="http://schemas.openxmlformats.org/drawingml/2006/main">
               <a:ext uri="{FF2B5EF4-FFF2-40B4-BE49-F238E27FC236}">
-                <a16:creationId xmlns:a16="http://schemas.microsoft.com/office/drawing/2014/main" id="{80B010E9-6791-418F-8641-F34D3924342A}"/>
+                <a16:creationId xmlns:a16="http://schemas.microsoft.com/office/drawing/2014/main" id="{87B22CF7-2F37-4043-A998-159758858DE7}"/>
               </a:ext>
             </a:extLst>
           </p:cNvPr>
@@ -4606,7 +4677,7 @@
                 <a:ea typeface="Aptos"/>
                 <a:cs typeface="Aptos"/>
               </a:rPr>
-              <a:t>INERTIA-2026-10-22-r5 · 22 October 2026 · Design refinement · Compatibility first</a:t>
+              <a:t>INERTIA-2026-10-22-r6 · 22 October 2026 · Autonomous build</a:t>
             </a:r>
           </a:p>
         </p:txBody>
@@ -4616,7 +4687,7 @@
           <p:cNvPr id="6" name="">
             <a:extLst xmlns:a="http://schemas.openxmlformats.org/drawingml/2006/main">
               <a:ext uri="{FF2B5EF4-FFF2-40B4-BE49-F238E27FC236}">
-                <a16:creationId xmlns:a16="http://schemas.microsoft.com/office/drawing/2014/main" id="{D090FA42-C48D-4CD7-A1EA-68E9FF5EB2BF}"/>
+                <a16:creationId xmlns:a16="http://schemas.microsoft.com/office/drawing/2014/main" id="{9670D08E-CA51-4233-B455-D689C0422AF0}"/>
               </a:ext>
             </a:extLst>
           </p:cNvPr>
@@ -4683,7 +4754,7 @@
           <p:cNvPr id="7" name="">
             <a:extLst xmlns:a="http://schemas.openxmlformats.org/drawingml/2006/main">
               <a:ext uri="{FF2B5EF4-FFF2-40B4-BE49-F238E27FC236}">
-                <a16:creationId xmlns:a16="http://schemas.microsoft.com/office/drawing/2014/main" id="{DA81D690-10BE-4A88-93D8-A06C4B62E112}"/>
+                <a16:creationId xmlns:a16="http://schemas.microsoft.com/office/drawing/2014/main" id="{1E44DB16-86B0-4A3A-B776-408D486ABCC7}"/>
               </a:ext>
             </a:extLst>
           </p:cNvPr>
@@ -4716,7 +4787,7 @@
           <p:cNvPr id="8" name="">
             <a:extLst xmlns:a="http://schemas.openxmlformats.org/drawingml/2006/main">
               <a:ext uri="{FF2B5EF4-FFF2-40B4-BE49-F238E27FC236}">
-                <a16:creationId xmlns:a16="http://schemas.microsoft.com/office/drawing/2014/main" id="{4A06A3F9-262F-404A-A441-6E18E7EC691B}"/>
+                <a16:creationId xmlns:a16="http://schemas.microsoft.com/office/drawing/2014/main" id="{CAB656FB-4476-44A8-9041-21949A6D60B1}"/>
               </a:ext>
             </a:extLst>
           </p:cNvPr>
@@ -4773,7 +4844,7 @@
                 <a:ea typeface="Aptos"/>
                 <a:cs typeface="Aptos"/>
               </a:rPr>
-              <a:t>Observe + preserve</a:t>
+              <a:t>Native platform</a:t>
             </a:r>
           </a:p>
         </p:txBody>
@@ -4783,7 +4854,7 @@
           <p:cNvPr id="9" name="">
             <a:extLst xmlns:a="http://schemas.openxmlformats.org/drawingml/2006/main">
               <a:ext uri="{FF2B5EF4-FFF2-40B4-BE49-F238E27FC236}">
-                <a16:creationId xmlns:a16="http://schemas.microsoft.com/office/drawing/2014/main" id="{72312766-2657-48C8-B0E0-5B788AF61E1F}"/>
+                <a16:creationId xmlns:a16="http://schemas.microsoft.com/office/drawing/2014/main" id="{06EA6574-CEA2-48F0-8CE6-A9322B137457}"/>
               </a:ext>
             </a:extLst>
           </p:cNvPr>
@@ -4840,7 +4911,7 @@
                 <a:ea typeface="Aptos"/>
                 <a:cs typeface="Aptos"/>
               </a:rPr>
-              <a:t>Authorized ready source</a:t>
+              <a:t>Goals, issues and dependencies</a:t>
             </a:r>
           </a:p>
           <a:p xmlns:a="http://schemas.openxmlformats.org/drawingml/2006/main">
@@ -4863,7 +4934,7 @@
                 <a:ea typeface="Aptos"/>
                 <a:cs typeface="Aptos"/>
               </a:rPr>
-              <a:t>Meeting ID, revision and hash</a:t>
+              <a:t>Hiring and policy permissions</a:t>
             </a:r>
           </a:p>
           <a:p xmlns:a="http://schemas.openxmlformats.org/drawingml/2006/main">
@@ -4886,7 +4957,7 @@
                 <a:ea typeface="Aptos"/>
                 <a:cs typeface="Aptos"/>
               </a:rPr>
-              <a:t>Original retained</a:t>
+              <a:t>Checkout, runs and budgets</a:t>
             </a:r>
           </a:p>
           <a:p xmlns:a="http://schemas.openxmlformats.org/drawingml/2006/main">
@@ -4909,7 +4980,7 @@
                 <a:ea typeface="Aptos"/>
                 <a:cs typeface="Aptos"/>
               </a:rPr>
-              <a:t>Summary-only exception</a:t>
+              <a:t>Documents and human decisions</a:t>
             </a:r>
           </a:p>
         </p:txBody>
@@ -4919,7 +4990,7 @@
           <p:cNvPr id="10" name="">
             <a:extLst xmlns:a="http://schemas.openxmlformats.org/drawingml/2006/main">
               <a:ext uri="{FF2B5EF4-FFF2-40B4-BE49-F238E27FC236}">
-                <a16:creationId xmlns:a16="http://schemas.microsoft.com/office/drawing/2014/main" id="{172D4A56-340B-4307-A853-D85B16CD34FE}"/>
+                <a16:creationId xmlns:a16="http://schemas.microsoft.com/office/drawing/2014/main" id="{2309BDC6-461C-45CA-B060-03EEB742AB3D}"/>
               </a:ext>
             </a:extLst>
           </p:cNvPr>
@@ -4952,7 +5023,7 @@
           <p:cNvPr id="11" name="">
             <a:extLst xmlns:a="http://schemas.openxmlformats.org/drawingml/2006/main">
               <a:ext uri="{FF2B5EF4-FFF2-40B4-BE49-F238E27FC236}">
-                <a16:creationId xmlns:a16="http://schemas.microsoft.com/office/drawing/2014/main" id="{4BF90455-1471-467C-BDFF-4A3E774CC8B8}"/>
+                <a16:creationId xmlns:a16="http://schemas.microsoft.com/office/drawing/2014/main" id="{C8968B24-F8F6-446A-801A-08FDEFAE1C68}"/>
               </a:ext>
             </a:extLst>
           </p:cNvPr>
@@ -5009,7 +5080,7 @@
                 <a:ea typeface="Aptos"/>
                 <a:cs typeface="Aptos"/>
               </a:rPr>
-              <a:t>Transform + publish</a:t>
+              <a:t>Thin Buzz bridge</a:t>
             </a:r>
           </a:p>
         </p:txBody>
@@ -5019,7 +5090,7 @@
           <p:cNvPr id="12" name="">
             <a:extLst xmlns:a="http://schemas.openxmlformats.org/drawingml/2006/main">
               <a:ext uri="{FF2B5EF4-FFF2-40B4-BE49-F238E27FC236}">
-                <a16:creationId xmlns:a16="http://schemas.microsoft.com/office/drawing/2014/main" id="{C4FAA448-2019-4765-971E-0A11690272A7}"/>
+                <a16:creationId xmlns:a16="http://schemas.microsoft.com/office/drawing/2014/main" id="{58A10BD4-424D-4F69-877C-BCB1DF973486}"/>
               </a:ext>
             </a:extLst>
           </p:cNvPr>
@@ -5076,7 +5147,7 @@
                 <a:ea typeface="Aptos"/>
                 <a:cs typeface="Aptos"/>
               </a:rPr>
-              <a:t>Faithful cleaned transcript</a:t>
+              <a:t>Signed requests and identity</a:t>
             </a:r>
           </a:p>
           <a:p xmlns:a="http://schemas.openxmlformats.org/drawingml/2006/main">
@@ -5099,7 +5170,7 @@
                 <a:ea typeface="Aptos"/>
                 <a:cs typeface="Aptos"/>
               </a:rPr>
-              <a:t>Source-linked notes and actions</a:t>
+              <a:t>Existing native task IDs</a:t>
             </a:r>
           </a:p>
           <a:p xmlns:a="http://schemas.openxmlformats.org/drawingml/2006/main">
@@ -5122,7 +5193,7 @@
                 <a:ea typeface="Aptos"/>
                 <a:cs typeface="Aptos"/>
               </a:rPr>
-              <a:t>Fixed audience and policy</a:t>
+              <a:t>Shared decisions and receipts</a:t>
             </a:r>
           </a:p>
           <a:p xmlns:a="http://schemas.openxmlformats.org/drawingml/2006/main">
@@ -5145,7 +5216,7 @@
                 <a:ea typeface="Aptos"/>
                 <a:cs typeface="Aptos"/>
               </a:rPr>
-              <a:t>Automatic in-policy upsert</a:t>
+              <a:t>Durable delivery recovery</a:t>
             </a:r>
           </a:p>
         </p:txBody>
@@ -5155,7 +5226,7 @@
           <p:cNvPr id="13" name="">
             <a:extLst xmlns:a="http://schemas.openxmlformats.org/drawingml/2006/main">
               <a:ext uri="{FF2B5EF4-FFF2-40B4-BE49-F238E27FC236}">
-                <a16:creationId xmlns:a16="http://schemas.microsoft.com/office/drawing/2014/main" id="{1F2C7741-A4DE-4B3F-AAAC-1CBA38BBBADF}"/>
+                <a16:creationId xmlns:a16="http://schemas.microsoft.com/office/drawing/2014/main" id="{9AB4E859-0FAF-4674-AB2F-3EDE7D329C90}"/>
               </a:ext>
             </a:extLst>
           </p:cNvPr>
@@ -5188,7 +5259,7 @@
           <p:cNvPr id="14" name="">
             <a:extLst xmlns:a="http://schemas.openxmlformats.org/drawingml/2006/main">
               <a:ext uri="{FF2B5EF4-FFF2-40B4-BE49-F238E27FC236}">
-                <a16:creationId xmlns:a16="http://schemas.microsoft.com/office/drawing/2014/main" id="{8B5F0496-2AB9-4634-A7A8-A22A6D95F7EC}"/>
+                <a16:creationId xmlns:a16="http://schemas.microsoft.com/office/drawing/2014/main" id="{A56A4B57-50B5-4EDB-9D4A-DAEB97B403D5}"/>
               </a:ext>
             </a:extLst>
           </p:cNvPr>
@@ -5245,7 +5316,7 @@
                 <a:ea typeface="Aptos"/>
                 <a:cs typeface="Aptos"/>
               </a:rPr>
-              <a:t>Verify + recover</a:t>
+              <a:t>Existing infrastructure</a:t>
             </a:r>
           </a:p>
         </p:txBody>
@@ -5255,7 +5326,7 @@
           <p:cNvPr id="15" name="">
             <a:extLst xmlns:a="http://schemas.openxmlformats.org/drawingml/2006/main">
               <a:ext uri="{FF2B5EF4-FFF2-40B4-BE49-F238E27FC236}">
-                <a16:creationId xmlns:a16="http://schemas.microsoft.com/office/drawing/2014/main" id="{EFE531EA-E7AD-4124-AEDB-65ABC0362BA8}"/>
+                <a16:creationId xmlns:a16="http://schemas.microsoft.com/office/drawing/2014/main" id="{039A0B8E-E7B4-4CDA-A507-50859BBBA647}"/>
               </a:ext>
             </a:extLst>
           </p:cNvPr>
@@ -5312,7 +5383,7 @@
                 <a:ea typeface="Aptos"/>
                 <a:cs typeface="Aptos"/>
               </a:rPr>
-              <a:t>Read back content and audience</a:t>
+              <a:t>Qualified hardened provider</a:t>
             </a:r>
           </a:p>
           <a:p xmlns:a="http://schemas.openxmlformats.org/drawingml/2006/main">
@@ -5335,7 +5406,7 @@
                 <a:ea typeface="Aptos"/>
                 <a:cs typeface="Aptos"/>
               </a:rPr>
-              <a:t>Return verified URLs</a:t>
+              <a:t>Client-side task isolation</a:t>
             </a:r>
           </a:p>
           <a:p xmlns:a="http://schemas.openxmlformats.org/drawingml/2006/main">
@@ -5358,7 +5429,7 @@
                 <a:ea typeface="Aptos"/>
                 <a:cs typeface="Aptos"/>
               </a:rPr>
-              <a:t>Reconcile uncertain writes</a:t>
+              <a:t>PlanetScale DAO database</a:t>
             </a:r>
           </a:p>
           <a:p xmlns:a="http://schemas.openxmlformats.org/drawingml/2006/main">
@@ -5381,7 +5452,7 @@
                 <a:ea typeface="Aptos"/>
                 <a:cs typeface="Aptos"/>
               </a:rPr>
-              <a:t>Version corrected outputs</a:t>
+              <a:t>Cloudflare available as needed</a:t>
             </a:r>
           </a:p>
         </p:txBody>
@@ -5391,7 +5462,7 @@
           <p:cNvPr id="16" name="">
             <a:extLst xmlns:a="http://schemas.openxmlformats.org/drawingml/2006/main">
               <a:ext uri="{FF2B5EF4-FFF2-40B4-BE49-F238E27FC236}">
-                <a16:creationId xmlns:a16="http://schemas.microsoft.com/office/drawing/2014/main" id="{BFF06EF6-B0DA-496F-8B3A-AC52D6488000}"/>
+                <a16:creationId xmlns:a16="http://schemas.microsoft.com/office/drawing/2014/main" id="{7D1BEF74-5AF5-4DF4-880A-ADC2EDE4E752}"/>
               </a:ext>
             </a:extLst>
           </p:cNvPr>
@@ -5448,7 +5519,7 @@
                 <a:ea typeface="Aptos"/>
                 <a:cs typeface="Aptos"/>
               </a:rPr>
-              <a:t>Publication uses a trusted domain adapter; source text cannot choose new destinations or permissions.</a:t>
+              <a:t>A narrow plugin fits the selected Paperclip release. Shared records keep the two interfaces coherent.</a:t>
             </a:r>
           </a:p>
         </p:txBody>
@@ -5456,7 +5527,7 @@
     </p:spTree>
     <p:extLst>
       <p:ext uri="{BB962C8B-B14F-4D97-AF65-F5344CB8AC3E}">
-        <p14:creationId xmlns:p14="http://schemas.microsoft.com/office/powerpoint/2010/main" val="742430007"/>
+        <p14:creationId xmlns:p14="http://schemas.microsoft.com/office/powerpoint/2010/main" val="559018357"/>
       </p:ext>
     </p:extLst>
   </p:cSld>
@@ -5487,7 +5558,7 @@
           <p:cNvPr id="17" name="">
             <a:extLst xmlns:a="http://schemas.openxmlformats.org/drawingml/2006/main">
               <a:ext uri="{FF2B5EF4-FFF2-40B4-BE49-F238E27FC236}">
-                <a16:creationId xmlns:a16="http://schemas.microsoft.com/office/drawing/2014/main" id="{CE45C6AD-A984-4057-9566-8542FDFE75F3}"/>
+                <a16:creationId xmlns:a16="http://schemas.microsoft.com/office/drawing/2014/main" id="{319E6743-03AF-46EE-A123-BC5277600AC1}"/>
               </a:ext>
             </a:extLst>
           </p:cNvPr>
@@ -5554,7 +5625,7 @@
           <p:cNvPr id="2" name="">
             <a:extLst xmlns:a="http://schemas.openxmlformats.org/drawingml/2006/main">
               <a:ext uri="{FF2B5EF4-FFF2-40B4-BE49-F238E27FC236}">
-                <a16:creationId xmlns:a16="http://schemas.microsoft.com/office/drawing/2014/main" id="{7F56EC6F-AE16-48E6-ADEA-699705798ED2}"/>
+                <a16:creationId xmlns:a16="http://schemas.microsoft.com/office/drawing/2014/main" id="{0E5E0A98-4101-4121-B59A-D41F47249808}"/>
               </a:ext>
             </a:extLst>
           </p:cNvPr>
@@ -5611,7 +5682,7 @@
                 <a:ea typeface="Aptos"/>
                 <a:cs typeface="Aptos"/>
               </a:rPr>
-              <a:t>Current grant → reviewed packet → vote</a:t>
+              <a:t>Automatic Roundtable publication</a:t>
             </a:r>
           </a:p>
         </p:txBody>
@@ -5621,7 +5692,7 @@
           <p:cNvPr id="3" name="">
             <a:extLst xmlns:a="http://schemas.openxmlformats.org/drawingml/2006/main">
               <a:ext uri="{FF2B5EF4-FFF2-40B4-BE49-F238E27FC236}">
-                <a16:creationId xmlns:a16="http://schemas.microsoft.com/office/drawing/2014/main" id="{D5D63B03-8C3F-46C7-9904-5AB4229D0FF0}"/>
+                <a16:creationId xmlns:a16="http://schemas.microsoft.com/office/drawing/2014/main" id="{A9A296B7-3458-4C32-A4AA-B18835F01475}"/>
               </a:ext>
             </a:extLst>
           </p:cNvPr>
@@ -5678,7 +5749,7 @@
                 <a:ea typeface="Aptos"/>
                 <a:cs typeface="Aptos"/>
               </a:rPr>
-              <a:t>Reuse the existing scanner and review workflow. Bind voted authority to an immutable application packet.</a:t>
+              <a:t>Meet recording and Gemini processing feed the organization’s Drive folder.</a:t>
             </a:r>
           </a:p>
         </p:txBody>
@@ -5688,7 +5759,7 @@
           <p:cNvPr id="4" name="">
             <a:extLst xmlns:a="http://schemas.openxmlformats.org/drawingml/2006/main">
               <a:ext uri="{FF2B5EF4-FFF2-40B4-BE49-F238E27FC236}">
-                <a16:creationId xmlns:a16="http://schemas.microsoft.com/office/drawing/2014/main" id="{72AAB282-21E4-466B-9CEB-D809B4A2CDE0}"/>
+                <a16:creationId xmlns:a16="http://schemas.microsoft.com/office/drawing/2014/main" id="{F1013BEB-9F03-4C4B-8E9B-783A5CCEEB6B}"/>
               </a:ext>
             </a:extLst>
           </p:cNvPr>
@@ -5719,7 +5790,7 @@
           <p:cNvPr id="5" name="">
             <a:extLst xmlns:a="http://schemas.openxmlformats.org/drawingml/2006/main">
               <a:ext uri="{FF2B5EF4-FFF2-40B4-BE49-F238E27FC236}">
-                <a16:creationId xmlns:a16="http://schemas.microsoft.com/office/drawing/2014/main" id="{52A3687A-47FC-472D-891E-9825A8EFDA5E}"/>
+                <a16:creationId xmlns:a16="http://schemas.microsoft.com/office/drawing/2014/main" id="{1E6CEA3E-86F4-47E3-935A-39DF16D29EE8}"/>
               </a:ext>
             </a:extLst>
           </p:cNvPr>
@@ -5776,7 +5847,7 @@
                 <a:ea typeface="Aptos"/>
                 <a:cs typeface="Aptos"/>
               </a:rPr>
-              <a:t>INERTIA-2026-10-22-r5 · 22 October 2026 · Design refinement · Compatibility first</a:t>
+              <a:t>INERTIA-2026-10-22-r6 · 22 October 2026 · Autonomous build</a:t>
             </a:r>
           </a:p>
         </p:txBody>
@@ -5786,7 +5857,7 @@
           <p:cNvPr id="6" name="">
             <a:extLst xmlns:a="http://schemas.openxmlformats.org/drawingml/2006/main">
               <a:ext uri="{FF2B5EF4-FFF2-40B4-BE49-F238E27FC236}">
-                <a16:creationId xmlns:a16="http://schemas.microsoft.com/office/drawing/2014/main" id="{4AD6D167-DDA4-4D86-9E17-17590E706C43}"/>
+                <a16:creationId xmlns:a16="http://schemas.microsoft.com/office/drawing/2014/main" id="{9B07308A-CE4F-4AC5-9B17-2DB64AEAD30B}"/>
               </a:ext>
             </a:extLst>
           </p:cNvPr>
@@ -5853,7 +5924,7 @@
           <p:cNvPr id="7" name="">
             <a:extLst xmlns:a="http://schemas.openxmlformats.org/drawingml/2006/main">
               <a:ext uri="{FF2B5EF4-FFF2-40B4-BE49-F238E27FC236}">
-                <a16:creationId xmlns:a16="http://schemas.microsoft.com/office/drawing/2014/main" id="{5366AE13-C2A4-43C9-B282-3583691BE349}"/>
+                <a16:creationId xmlns:a16="http://schemas.microsoft.com/office/drawing/2014/main" id="{38D3E445-5CDC-4B45-A494-8A1E92FEABCF}"/>
               </a:ext>
             </a:extLst>
           </p:cNvPr>
@@ -5886,7 +5957,7 @@
           <p:cNvPr id="8" name="">
             <a:extLst xmlns:a="http://schemas.openxmlformats.org/drawingml/2006/main">
               <a:ext uri="{FF2B5EF4-FFF2-40B4-BE49-F238E27FC236}">
-                <a16:creationId xmlns:a16="http://schemas.microsoft.com/office/drawing/2014/main" id="{C1C84069-B9F1-4938-800C-4111ED3E1241}"/>
+                <a16:creationId xmlns:a16="http://schemas.microsoft.com/office/drawing/2014/main" id="{6D4DD690-7815-45AC-9050-77846EBBD068}"/>
               </a:ext>
             </a:extLst>
           </p:cNvPr>
@@ -5943,7 +6014,7 @@
                 <a:ea typeface="Aptos"/>
                 <a:cs typeface="Aptos"/>
               </a:rPr>
-              <a:t>Find + draft</a:t>
+              <a:t>Ready source</a:t>
             </a:r>
           </a:p>
         </p:txBody>
@@ -5953,7 +6024,7 @@
           <p:cNvPr id="9" name="">
             <a:extLst xmlns:a="http://schemas.openxmlformats.org/drawingml/2006/main">
               <a:ext uri="{FF2B5EF4-FFF2-40B4-BE49-F238E27FC236}">
-                <a16:creationId xmlns:a16="http://schemas.microsoft.com/office/drawing/2014/main" id="{FA28254B-DB4A-4D20-9ABF-83E58C3DD43C}"/>
+                <a16:creationId xmlns:a16="http://schemas.microsoft.com/office/drawing/2014/main" id="{4E5587FC-D2CE-4C8A-AB54-900FC19A45D0}"/>
               </a:ext>
             </a:extLst>
           </p:cNvPr>
@@ -6010,7 +6081,7 @@
                 <a:ea typeface="Aptos"/>
                 <a:cs typeface="Aptos"/>
               </a:rPr>
-              <a:t>Fresh sources and deadlines</a:t>
+              <a:t>Identify meeting and revision</a:t>
             </a:r>
           </a:p>
           <a:p xmlns:a="http://schemas.openxmlformats.org/drawingml/2006/main">
@@ -6033,7 +6104,7 @@
                 <a:ea typeface="Aptos"/>
                 <a:cs typeface="Aptos"/>
               </a:rPr>
-              <a:t>Eligibility and applicant route</a:t>
+              <a:t>Retain original source</a:t>
             </a:r>
           </a:p>
           <a:p xmlns:a="http://schemas.openxmlformats.org/drawingml/2006/main">
@@ -6056,7 +6127,7 @@
                 <a:ea typeface="Aptos"/>
                 <a:cs typeface="Aptos"/>
               </a:rPr>
-              <a:t>Template-based cited draft</a:t>
+              <a:t>Preserve uncertain wording</a:t>
             </a:r>
           </a:p>
           <a:p xmlns:a="http://schemas.openxmlformats.org/drawingml/2006/main">
@@ -6079,7 +6150,7 @@
                 <a:ea typeface="Aptos"/>
                 <a:cs typeface="Aptos"/>
               </a:rPr>
-              <a:t>Existing review and signoffs</a:t>
+              <a:t>Handle notes-only input honestly</a:t>
             </a:r>
           </a:p>
         </p:txBody>
@@ -6089,7 +6160,7 @@
           <p:cNvPr id="10" name="">
             <a:extLst xmlns:a="http://schemas.openxmlformats.org/drawingml/2006/main">
               <a:ext uri="{FF2B5EF4-FFF2-40B4-BE49-F238E27FC236}">
-                <a16:creationId xmlns:a16="http://schemas.microsoft.com/office/drawing/2014/main" id="{FDCD0A01-A777-413A-8204-046FEB19D146}"/>
+                <a16:creationId xmlns:a16="http://schemas.microsoft.com/office/drawing/2014/main" id="{680E04DA-B97B-4FCB-A922-EDB04BE4B8F8}"/>
               </a:ext>
             </a:extLst>
           </p:cNvPr>
@@ -6122,7 +6193,7 @@
           <p:cNvPr id="11" name="">
             <a:extLst xmlns:a="http://schemas.openxmlformats.org/drawingml/2006/main">
               <a:ext uri="{FF2B5EF4-FFF2-40B4-BE49-F238E27FC236}">
-                <a16:creationId xmlns:a16="http://schemas.microsoft.com/office/drawing/2014/main" id="{224398F4-7623-440C-B013-75BA81A0EC99}"/>
+                <a16:creationId xmlns:a16="http://schemas.microsoft.com/office/drawing/2014/main" id="{542D52CC-DEE8-483A-ABCC-CF7591802FEF}"/>
               </a:ext>
             </a:extLst>
           </p:cNvPr>
@@ -6179,7 +6250,7 @@
                 <a:ea typeface="Aptos"/>
                 <a:cs typeface="Aptos"/>
               </a:rPr>
-              <a:t>Freeze + decide</a:t>
+              <a:t>Faithful transformation</a:t>
             </a:r>
           </a:p>
         </p:txBody>
@@ -6189,7 +6260,7 @@
           <p:cNvPr id="12" name="">
             <a:extLst xmlns:a="http://schemas.openxmlformats.org/drawingml/2006/main">
               <a:ext uri="{FF2B5EF4-FFF2-40B4-BE49-F238E27FC236}">
-                <a16:creationId xmlns:a16="http://schemas.microsoft.com/office/drawing/2014/main" id="{A69C82A9-92F5-48E0-846E-79A5F89032BB}"/>
+                <a16:creationId xmlns:a16="http://schemas.microsoft.com/office/drawing/2014/main" id="{AAAE2A79-0B08-464E-94C2-934ED636ABF7}"/>
               </a:ext>
             </a:extLst>
           </p:cNvPr>
@@ -6246,7 +6317,7 @@
                 <a:ea typeface="Aptos"/>
                 <a:cs typeface="Aptos"/>
               </a:rPr>
-              <a:t>Packet ID, version and hash</a:t>
+              <a:t>Separate transcript and notes</a:t>
             </a:r>
           </a:p>
           <a:p xmlns:a="http://schemas.openxmlformats.org/drawingml/2006/main">
@@ -6269,7 +6340,7 @@
                 <a:ea typeface="Aptos"/>
                 <a:cs typeface="Aptos"/>
               </a:rPr>
-              <a:t>Blockchain proposal binding</a:t>
+              <a:t>Cite source for action items</a:t>
             </a:r>
           </a:p>
           <a:p xmlns:a="http://schemas.openxmlformats.org/drawingml/2006/main">
@@ -6292,7 +6363,7 @@
                 <a:ea typeface="Aptos"/>
                 <a:cs typeface="Aptos"/>
               </a:rPr>
-              <a:t>Finality and result validation</a:t>
+              <a:t>Keep names and claims grounded</a:t>
             </a:r>
           </a:p>
           <a:p xmlns:a="http://schemas.openxmlformats.org/drawingml/2006/main">
@@ -6315,7 +6386,7 @@
                 <a:ea typeface="Aptos"/>
                 <a:cs typeface="Aptos"/>
               </a:rPr>
-              <a:t>Changed packet needs new vote</a:t>
+              <a:t>Apply the configured audience</a:t>
             </a:r>
           </a:p>
         </p:txBody>
@@ -6325,7 +6396,7 @@
           <p:cNvPr id="13" name="">
             <a:extLst xmlns:a="http://schemas.openxmlformats.org/drawingml/2006/main">
               <a:ext uri="{FF2B5EF4-FFF2-40B4-BE49-F238E27FC236}">
-                <a16:creationId xmlns:a16="http://schemas.microsoft.com/office/drawing/2014/main" id="{95B9DFC5-F393-418E-8E66-3999BB7BCB6D}"/>
+                <a16:creationId xmlns:a16="http://schemas.microsoft.com/office/drawing/2014/main" id="{1C019A24-69A3-416A-907D-87F0F7460D76}"/>
               </a:ext>
             </a:extLst>
           </p:cNvPr>
@@ -6358,7 +6429,7 @@
           <p:cNvPr id="14" name="">
             <a:extLst xmlns:a="http://schemas.openxmlformats.org/drawingml/2006/main">
               <a:ext uri="{FF2B5EF4-FFF2-40B4-BE49-F238E27FC236}">
-                <a16:creationId xmlns:a16="http://schemas.microsoft.com/office/drawing/2014/main" id="{714C03D3-11F5-412E-B789-96DD0EA56CCE}"/>
+                <a16:creationId xmlns:a16="http://schemas.microsoft.com/office/drawing/2014/main" id="{92B17FEF-C16B-4B76-9439-AC8CAD19F4CB}"/>
               </a:ext>
             </a:extLst>
           </p:cNvPr>
@@ -6415,7 +6486,7 @@
                 <a:ea typeface="Aptos"/>
                 <a:cs typeface="Aptos"/>
               </a:rPr>
-              <a:t>Watch + advance</a:t>
+              <a:t>Trusted publication</a:t>
             </a:r>
           </a:p>
         </p:txBody>
@@ -6425,7 +6496,7 @@
           <p:cNvPr id="15" name="">
             <a:extLst xmlns:a="http://schemas.openxmlformats.org/drawingml/2006/main">
               <a:ext uri="{FF2B5EF4-FFF2-40B4-BE49-F238E27FC236}">
-                <a16:creationId xmlns:a16="http://schemas.microsoft.com/office/drawing/2014/main" id="{ADACCE6B-4340-4F75-A668-307C3586CAF7}"/>
+                <a16:creationId xmlns:a16="http://schemas.microsoft.com/office/drawing/2014/main" id="{DC91D38A-A662-46F7-83F6-E54B15781712}"/>
               </a:ext>
             </a:extLst>
           </p:cNvPr>
@@ -6482,7 +6553,7 @@
                 <a:ea typeface="Aptos"/>
                 <a:cs typeface="Aptos"/>
               </a:rPr>
-              <a:t>Y2 registered interests</a:t>
+              <a:t>Upsert the website record</a:t>
             </a:r>
           </a:p>
           <a:p xmlns:a="http://schemas.openxmlformats.org/drawingml/2006/main">
@@ -6505,7 +6576,7 @@
                 <a:ea typeface="Aptos"/>
                 <a:cs typeface="Aptos"/>
               </a:rPr>
-              <a:t>Updates linked to existing work</a:t>
+              <a:t>Verify content and audience</a:t>
             </a:r>
           </a:p>
           <a:p xmlns:a="http://schemas.openxmlformats.org/drawingml/2006/main">
@@ -6528,7 +6599,7 @@
                 <a:ea typeface="Aptos"/>
                 <a:cs typeface="Aptos"/>
               </a:rPr>
-              <a:t>Ordinary tasks need no vote</a:t>
+              <a:t>Return the published URLs</a:t>
             </a:r>
           </a:p>
           <a:p xmlns:a="http://schemas.openxmlformats.org/drawingml/2006/main">
@@ -6551,7 +6622,7 @@
                 <a:ea typeface="Aptos"/>
                 <a:cs typeface="Aptos"/>
               </a:rPr>
-              <a:t>990 enrichment remains stretch</a:t>
+              <a:t>Reconcile corrections and retries</a:t>
             </a:r>
           </a:p>
         </p:txBody>
@@ -6561,7 +6632,7 @@
           <p:cNvPr id="16" name="">
             <a:extLst xmlns:a="http://schemas.openxmlformats.org/drawingml/2006/main">
               <a:ext uri="{FF2B5EF4-FFF2-40B4-BE49-F238E27FC236}">
-                <a16:creationId xmlns:a16="http://schemas.microsoft.com/office/drawing/2014/main" id="{B68FDFFE-29F1-437B-B4FD-0C9F8B933698}"/>
+                <a16:creationId xmlns:a16="http://schemas.microsoft.com/office/drawing/2014/main" id="{B5B2587C-D93F-449E-86C7-87C9C2922318}"/>
               </a:ext>
             </a:extLst>
           </p:cNvPr>
@@ -6618,7 +6689,7 @@
                 <a:ea typeface="Aptos"/>
                 <a:cs typeface="Aptos"/>
               </a:rPr>
-              <a:t>Required demo: verified packet-bound decision. Actual funder submission is a separately controlled step.</a:t>
+              <a:t>After one-time setup, routine publication runs automatically. Exceptions name the precise action needed.</a:t>
             </a:r>
           </a:p>
         </p:txBody>
@@ -6626,7 +6697,7 @@
     </p:spTree>
     <p:extLst>
       <p:ext uri="{BB962C8B-B14F-4D97-AF65-F5344CB8AC3E}">
-        <p14:creationId xmlns:p14="http://schemas.microsoft.com/office/powerpoint/2010/main" val="1999123243"/>
+        <p14:creationId xmlns:p14="http://schemas.microsoft.com/office/powerpoint/2010/main" val="2074361515"/>
       </p:ext>
     </p:extLst>
   </p:cSld>
@@ -6657,7 +6728,7 @@
           <p:cNvPr id="17" name="">
             <a:extLst xmlns:a="http://schemas.openxmlformats.org/drawingml/2006/main">
               <a:ext uri="{FF2B5EF4-FFF2-40B4-BE49-F238E27FC236}">
-                <a16:creationId xmlns:a16="http://schemas.microsoft.com/office/drawing/2014/main" id="{43F8A8D8-EDCA-442A-9022-3F847DF766BF}"/>
+                <a16:creationId xmlns:a16="http://schemas.microsoft.com/office/drawing/2014/main" id="{FC4E56A8-E93D-4BF6-91D3-307368775853}"/>
               </a:ext>
             </a:extLst>
           </p:cNvPr>
@@ -6724,7 +6795,7 @@
           <p:cNvPr id="2" name="">
             <a:extLst xmlns:a="http://schemas.openxmlformats.org/drawingml/2006/main">
               <a:ext uri="{FF2B5EF4-FFF2-40B4-BE49-F238E27FC236}">
-                <a16:creationId xmlns:a16="http://schemas.microsoft.com/office/drawing/2014/main" id="{9F3E0806-B5C9-4309-85F5-A59B35AA90E5}"/>
+                <a16:creationId xmlns:a16="http://schemas.microsoft.com/office/drawing/2014/main" id="{48FBF5F0-28E8-4CB1-9871-8468B4979FFF}"/>
               </a:ext>
             </a:extLst>
           </p:cNvPr>
@@ -6781,7 +6852,7 @@
                 <a:ea typeface="Aptos"/>
                 <a:cs typeface="Aptos"/>
               </a:rPr>
-              <a:t>Eager agents, native execution</a:t>
+              <a:t>Grant decisions and Y2 updates</a:t>
             </a:r>
           </a:p>
         </p:txBody>
@@ -6791,7 +6862,7 @@
           <p:cNvPr id="3" name="">
             <a:extLst xmlns:a="http://schemas.openxmlformats.org/drawingml/2006/main">
               <a:ext uri="{FF2B5EF4-FFF2-40B4-BE49-F238E27FC236}">
-                <a16:creationId xmlns:a16="http://schemas.microsoft.com/office/drawing/2014/main" id="{33AD090A-EECF-43B9-A823-AE1746A9C4EA}"/>
+                <a16:creationId xmlns:a16="http://schemas.microsoft.com/office/drawing/2014/main" id="{647085AC-D644-425E-A57D-0D58449A4281}"/>
               </a:ext>
             </a:extLst>
           </p:cNvPr>
@@ -6848,7 +6919,7 @@
                 <a:ea typeface="Aptos"/>
                 <a:cs typeface="Aptos"/>
               </a:rPr>
-              <a:t>Member-owned capacity contributes through Paperclip’s qualified runner and execution interfaces.</a:t>
+              <a:t>Reuse the grant scanner and preserve review before freezing the application.</a:t>
             </a:r>
           </a:p>
         </p:txBody>
@@ -6858,7 +6929,7 @@
           <p:cNvPr id="4" name="">
             <a:extLst xmlns:a="http://schemas.openxmlformats.org/drawingml/2006/main">
               <a:ext uri="{FF2B5EF4-FFF2-40B4-BE49-F238E27FC236}">
-                <a16:creationId xmlns:a16="http://schemas.microsoft.com/office/drawing/2014/main" id="{1D669476-A46D-48C7-A765-C68839D3D3AF}"/>
+                <a16:creationId xmlns:a16="http://schemas.microsoft.com/office/drawing/2014/main" id="{7302BBE7-D64F-42D4-AB77-AB310598A6F3}"/>
               </a:ext>
             </a:extLst>
           </p:cNvPr>
@@ -6889,7 +6960,7 @@
           <p:cNvPr id="5" name="">
             <a:extLst xmlns:a="http://schemas.openxmlformats.org/drawingml/2006/main">
               <a:ext uri="{FF2B5EF4-FFF2-40B4-BE49-F238E27FC236}">
-                <a16:creationId xmlns:a16="http://schemas.microsoft.com/office/drawing/2014/main" id="{1A755172-D817-4636-A0F4-B10FEC7901CB}"/>
+                <a16:creationId xmlns:a16="http://schemas.microsoft.com/office/drawing/2014/main" id="{37EA21DC-01D7-4BAB-A59D-12DE4B2AEB9A}"/>
               </a:ext>
             </a:extLst>
           </p:cNvPr>
@@ -6946,7 +7017,7 @@
                 <a:ea typeface="Aptos"/>
                 <a:cs typeface="Aptos"/>
               </a:rPr>
-              <a:t>INERTIA-2026-10-22-r5 · 22 October 2026 · Design refinement · Compatibility first</a:t>
+              <a:t>INERTIA-2026-10-22-r6 · 22 October 2026 · Autonomous build</a:t>
             </a:r>
           </a:p>
         </p:txBody>
@@ -6956,7 +7027,7 @@
           <p:cNvPr id="6" name="">
             <a:extLst xmlns:a="http://schemas.openxmlformats.org/drawingml/2006/main">
               <a:ext uri="{FF2B5EF4-FFF2-40B4-BE49-F238E27FC236}">
-                <a16:creationId xmlns:a16="http://schemas.microsoft.com/office/drawing/2014/main" id="{5AD9E2E7-2817-44CF-BA5E-7D562504F22D}"/>
+                <a16:creationId xmlns:a16="http://schemas.microsoft.com/office/drawing/2014/main" id="{6E8372E9-7FE1-47FF-8D84-627DB2AE462E}"/>
               </a:ext>
             </a:extLst>
           </p:cNvPr>
@@ -7023,7 +7094,7 @@
           <p:cNvPr id="7" name="">
             <a:extLst xmlns:a="http://schemas.openxmlformats.org/drawingml/2006/main">
               <a:ext uri="{FF2B5EF4-FFF2-40B4-BE49-F238E27FC236}">
-                <a16:creationId xmlns:a16="http://schemas.microsoft.com/office/drawing/2014/main" id="{2BF11F28-569F-423D-8C86-10CBBF4E1FE2}"/>
+                <a16:creationId xmlns:a16="http://schemas.microsoft.com/office/drawing/2014/main" id="{61D71157-418A-4879-AD0A-2DCEFBCA6EE5}"/>
               </a:ext>
             </a:extLst>
           </p:cNvPr>
@@ -7056,7 +7127,7 @@
           <p:cNvPr id="8" name="">
             <a:extLst xmlns:a="http://schemas.openxmlformats.org/drawingml/2006/main">
               <a:ext uri="{FF2B5EF4-FFF2-40B4-BE49-F238E27FC236}">
-                <a16:creationId xmlns:a16="http://schemas.microsoft.com/office/drawing/2014/main" id="{3A6A17EA-762A-47EC-A1D5-4D25F6033EB7}"/>
+                <a16:creationId xmlns:a16="http://schemas.microsoft.com/office/drawing/2014/main" id="{37C46F52-B48E-41BA-9C5D-0A7A16DF257E}"/>
               </a:ext>
             </a:extLst>
           </p:cNvPr>
@@ -7113,7 +7184,7 @@
                 <a:ea typeface="Aptos"/>
                 <a:cs typeface="Aptos"/>
               </a:rPr>
-              <a:t>Native coordination</a:t>
+              <a:t>Find and prepare</a:t>
             </a:r>
           </a:p>
         </p:txBody>
@@ -7123,7 +7194,7 @@
           <p:cNvPr id="9" name="">
             <a:extLst xmlns:a="http://schemas.openxmlformats.org/drawingml/2006/main">
               <a:ext uri="{FF2B5EF4-FFF2-40B4-BE49-F238E27FC236}">
-                <a16:creationId xmlns:a16="http://schemas.microsoft.com/office/drawing/2014/main" id="{CFCB8415-54B5-4E97-8378-6BEB46A237FA}"/>
+                <a16:creationId xmlns:a16="http://schemas.microsoft.com/office/drawing/2014/main" id="{7A33A761-3DFA-4BB5-8F6C-B2059421A66B}"/>
               </a:ext>
             </a:extLst>
           </p:cNvPr>
@@ -7180,7 +7251,7 @@
                 <a:ea typeface="Aptos"/>
                 <a:cs typeface="Aptos"/>
               </a:rPr>
-              <a:t>CEO delegates and unblocks</a:t>
+              <a:t>Refresh opportunities</a:t>
             </a:r>
           </a:p>
           <a:p xmlns:a="http://schemas.openxmlformats.org/drawingml/2006/main">
@@ -7203,7 +7274,7 @@
                 <a:ea typeface="Aptos"/>
                 <a:cs typeface="Aptos"/>
               </a:rPr>
-              <a:t>Eligible work acquired eagerly</a:t>
+              <a:t>Check deadline and eligibility</a:t>
             </a:r>
           </a:p>
           <a:p xmlns:a="http://schemas.openxmlformats.org/drawingml/2006/main">
@@ -7226,7 +7297,7 @@
                 <a:ea typeface="Aptos"/>
                 <a:cs typeface="Aptos"/>
               </a:rPr>
-              <a:t>Atomic checkout ownership</a:t>
+              <a:t>Build a cited draft packet</a:t>
             </a:r>
           </a:p>
           <a:p xmlns:a="http://schemas.openxmlformats.org/drawingml/2006/main">
@@ -7249,7 +7320,7 @@
                 <a:ea typeface="Aptos"/>
                 <a:cs typeface="Aptos"/>
               </a:rPr>
-              <a:t>Hiring and budget policy</a:t>
+              <a:t>Preserve reviewer signoffs</a:t>
             </a:r>
           </a:p>
         </p:txBody>
@@ -7259,7 +7330,7 @@
           <p:cNvPr id="10" name="">
             <a:extLst xmlns:a="http://schemas.openxmlformats.org/drawingml/2006/main">
               <a:ext uri="{FF2B5EF4-FFF2-40B4-BE49-F238E27FC236}">
-                <a16:creationId xmlns:a16="http://schemas.microsoft.com/office/drawing/2014/main" id="{8656ABAF-3F4C-469B-B565-D54E68ED7CE3}"/>
+                <a16:creationId xmlns:a16="http://schemas.microsoft.com/office/drawing/2014/main" id="{1A78F3C7-4E5E-4CEE-AE48-F92FA04D6398}"/>
               </a:ext>
             </a:extLst>
           </p:cNvPr>
@@ -7292,7 +7363,7 @@
           <p:cNvPr id="11" name="">
             <a:extLst xmlns:a="http://schemas.openxmlformats.org/drawingml/2006/main">
               <a:ext uri="{FF2B5EF4-FFF2-40B4-BE49-F238E27FC236}">
-                <a16:creationId xmlns:a16="http://schemas.microsoft.com/office/drawing/2014/main" id="{3E9F14A6-6E7D-4710-AE15-23428B9CECB7}"/>
+                <a16:creationId xmlns:a16="http://schemas.microsoft.com/office/drawing/2014/main" id="{23174286-6403-46E8-B0CE-D480B04AF43C}"/>
               </a:ext>
             </a:extLst>
           </p:cNvPr>
@@ -7349,7 +7420,7 @@
                 <a:ea typeface="Aptos"/>
                 <a:cs typeface="Aptos"/>
               </a:rPr>
-              <a:t>Qualified execution</a:t>
+              <a:t>Bind the vote</a:t>
             </a:r>
           </a:p>
         </p:txBody>
@@ -7359,7 +7430,7 @@
           <p:cNvPr id="12" name="">
             <a:extLst xmlns:a="http://schemas.openxmlformats.org/drawingml/2006/main">
               <a:ext uri="{FF2B5EF4-FFF2-40B4-BE49-F238E27FC236}">
-                <a16:creationId xmlns:a16="http://schemas.microsoft.com/office/drawing/2014/main" id="{8E8CE0F0-15D9-4BA8-A137-5667C83A4CAA}"/>
+                <a16:creationId xmlns:a16="http://schemas.microsoft.com/office/drawing/2014/main" id="{2623B582-C87C-4427-B28D-C6416FA4E166}"/>
               </a:ext>
             </a:extLst>
           </p:cNvPr>
@@ -7416,7 +7487,7 @@
                 <a:ea typeface="Aptos"/>
                 <a:cs typeface="Aptos"/>
               </a:rPr>
-              <a:t>Client-side sandbox</a:t>
+              <a:t>Freeze packet version and hash</a:t>
             </a:r>
           </a:p>
           <a:p xmlns:a="http://schemas.openxmlformats.org/drawingml/2006/main">
@@ -7439,7 +7510,7 @@
                 <a:ea typeface="Aptos"/>
                 <a:cs typeface="Aptos"/>
               </a:rPr>
-              <a:t>Isolated task workspace</a:t>
+              <a:t>Verify network and finality</a:t>
             </a:r>
           </a:p>
           <a:p xmlns:a="http://schemas.openxmlformats.org/drawingml/2006/main">
@@ -7462,7 +7533,7 @@
                 <a:ea typeface="Aptos"/>
                 <a:cs typeface="Aptos"/>
               </a:rPr>
-              <a:t>Narrow data and tool scopes</a:t>
+              <a:t>Match the authorized action</a:t>
             </a:r>
           </a:p>
           <a:p xmlns:a="http://schemas.openxmlformats.org/drawingml/2006/main">
@@ -7485,7 +7556,7 @@
                 <a:ea typeface="Aptos"/>
                 <a:cs typeface="Aptos"/>
               </a:rPr>
-              <a:t>Native lifecycle and recovery</a:t>
+              <a:t>Apply the result once</a:t>
             </a:r>
           </a:p>
         </p:txBody>
@@ -7495,7 +7566,7 @@
           <p:cNvPr id="13" name="">
             <a:extLst xmlns:a="http://schemas.openxmlformats.org/drawingml/2006/main">
               <a:ext uri="{FF2B5EF4-FFF2-40B4-BE49-F238E27FC236}">
-                <a16:creationId xmlns:a16="http://schemas.microsoft.com/office/drawing/2014/main" id="{3DE0F909-2EB6-41F3-872E-4D654DB61ECB}"/>
+                <a16:creationId xmlns:a16="http://schemas.microsoft.com/office/drawing/2014/main" id="{EECDE4C2-8AA6-40DB-B988-7CF7DCBB1242}"/>
               </a:ext>
             </a:extLst>
           </p:cNvPr>
@@ -7528,7 +7599,7 @@
           <p:cNvPr id="14" name="">
             <a:extLst xmlns:a="http://schemas.openxmlformats.org/drawingml/2006/main">
               <a:ext uri="{FF2B5EF4-FFF2-40B4-BE49-F238E27FC236}">
-                <a16:creationId xmlns:a16="http://schemas.microsoft.com/office/drawing/2014/main" id="{B672AD8B-F944-4D7F-A9F0-91F48C00A317}"/>
+                <a16:creationId xmlns:a16="http://schemas.microsoft.com/office/drawing/2014/main" id="{57B3BFD3-5B6A-45B8-A51E-B0CE4B3A5C79}"/>
               </a:ext>
             </a:extLst>
           </p:cNvPr>
@@ -7585,7 +7656,7 @@
                 <a:ea typeface="Aptos"/>
                 <a:cs typeface="Aptos"/>
               </a:rPr>
-              <a:t>Validated contribution</a:t>
+              <a:t>Continue the work</a:t>
             </a:r>
           </a:p>
         </p:txBody>
@@ -7595,7 +7666,7 @@
           <p:cNvPr id="15" name="">
             <a:extLst xmlns:a="http://schemas.openxmlformats.org/drawingml/2006/main">
               <a:ext uri="{FF2B5EF4-FFF2-40B4-BE49-F238E27FC236}">
-                <a16:creationId xmlns:a16="http://schemas.microsoft.com/office/drawing/2014/main" id="{B0B069C1-E350-4034-8C47-44E7F7EE3D48}"/>
+                <a16:creationId xmlns:a16="http://schemas.microsoft.com/office/drawing/2014/main" id="{AA83E20B-5C82-4BE8-B9E5-C4F9F6EB5B1D}"/>
               </a:ext>
             </a:extLst>
           </p:cNvPr>
@@ -7652,7 +7723,7 @@
                 <a:ea typeface="Aptos"/>
                 <a:cs typeface="Aptos"/>
               </a:rPr>
-              <a:t>Server-side artifact validation</a:t>
+              <a:t>Y2 registered interests</a:t>
             </a:r>
           </a:p>
           <a:p xmlns:a="http://schemas.openxmlformats.org/drawingml/2006/main">
@@ -7675,7 +7746,7 @@
                 <a:ea typeface="Aptos"/>
                 <a:cs typeface="Aptos"/>
               </a:rPr>
-              <a:t>Trusted publication adapter</a:t>
+              <a:t>Updates attach to existing work</a:t>
             </a:r>
           </a:p>
           <a:p xmlns:a="http://schemas.openxmlformats.org/drawingml/2006/main">
@@ -7698,7 +7769,7 @@
                 <a:ea typeface="Aptos"/>
                 <a:cs typeface="Aptos"/>
               </a:rPr>
-              <a:t>Follow-ups with reason + parent</a:t>
+              <a:t>Ordinary work proceeds normally</a:t>
             </a:r>
           </a:p>
           <a:p xmlns:a="http://schemas.openxmlformats.org/drawingml/2006/main">
@@ -7721,7 +7792,7 @@
                 <a:ea typeface="Aptos"/>
                 <a:cs typeface="Aptos"/>
               </a:rPr>
-              <a:t>Deduplication and bounded depth</a:t>
+              <a:t>990 enrichment remains stretch</a:t>
             </a:r>
           </a:p>
         </p:txBody>
@@ -7731,7 +7802,7 @@
           <p:cNvPr id="16" name="">
             <a:extLst xmlns:a="http://schemas.openxmlformats.org/drawingml/2006/main">
               <a:ext uri="{FF2B5EF4-FFF2-40B4-BE49-F238E27FC236}">
-                <a16:creationId xmlns:a16="http://schemas.microsoft.com/office/drawing/2014/main" id="{17E20610-18AE-4734-AE85-849243E9FD5D}"/>
+                <a16:creationId xmlns:a16="http://schemas.microsoft.com/office/drawing/2014/main" id="{B42FF771-3120-4382-863F-6D88BFDCA3EE}"/>
               </a:ext>
             </a:extLst>
           </p:cNvPr>
@@ -7788,7 +7859,7 @@
                 <a:ea typeface="Aptos"/>
                 <a:cs typeface="Aptos"/>
               </a:rPr>
-              <a:t>Reuse existing execution hardening against the selected Paperclip release; verify SDK support and serving admission.</a:t>
+              <a:t>The demo demonstrates the ratified packet. Actual funder submission remains a separately authorized action.</a:t>
             </a:r>
           </a:p>
         </p:txBody>
@@ -7796,7 +7867,7 @@
     </p:spTree>
     <p:extLst>
       <p:ext uri="{BB962C8B-B14F-4D97-AF65-F5344CB8AC3E}">
-        <p14:creationId xmlns:p14="http://schemas.microsoft.com/office/powerpoint/2010/main" val="979537345"/>
+        <p14:creationId xmlns:p14="http://schemas.microsoft.com/office/powerpoint/2010/main" val="1242149921"/>
       </p:ext>
     </p:extLst>
   </p:cSld>
@@ -7827,7 +7898,7 @@
           <p:cNvPr id="17" name="">
             <a:extLst xmlns:a="http://schemas.openxmlformats.org/drawingml/2006/main">
               <a:ext uri="{FF2B5EF4-FFF2-40B4-BE49-F238E27FC236}">
-                <a16:creationId xmlns:a16="http://schemas.microsoft.com/office/drawing/2014/main" id="{796A641C-D281-409C-8535-1D50B3619795}"/>
+                <a16:creationId xmlns:a16="http://schemas.microsoft.com/office/drawing/2014/main" id="{536211E4-D234-458A-B578-6151D91E2371}"/>
               </a:ext>
             </a:extLst>
           </p:cNvPr>
@@ -7894,7 +7965,7 @@
           <p:cNvPr id="2" name="">
             <a:extLst xmlns:a="http://schemas.openxmlformats.org/drawingml/2006/main">
               <a:ext uri="{FF2B5EF4-FFF2-40B4-BE49-F238E27FC236}">
-                <a16:creationId xmlns:a16="http://schemas.microsoft.com/office/drawing/2014/main" id="{59078E90-E384-48FB-9828-A2833E0DBFC4}"/>
+                <a16:creationId xmlns:a16="http://schemas.microsoft.com/office/drawing/2014/main" id="{12FB7133-0C95-4B40-A558-1916441DF763}"/>
               </a:ext>
             </a:extLst>
           </p:cNvPr>
@@ -7951,7 +8022,7 @@
                 <a:ea typeface="Aptos"/>
                 <a:cs typeface="Aptos"/>
               </a:rPr>
-              <a:t>Bridge contract: shared identity and state</a:t>
+              <a:t>Secure member contribution</a:t>
             </a:r>
           </a:p>
         </p:txBody>
@@ -7961,7 +8032,7 @@
           <p:cNvPr id="3" name="">
             <a:extLst xmlns:a="http://schemas.openxmlformats.org/drawingml/2006/main">
               <a:ext uri="{FF2B5EF4-FFF2-40B4-BE49-F238E27FC236}">
-                <a16:creationId xmlns:a16="http://schemas.microsoft.com/office/drawing/2014/main" id="{06E29C0D-9781-438E-83F5-3AD4E08DDD62}"/>
+                <a16:creationId xmlns:a16="http://schemas.microsoft.com/office/drawing/2014/main" id="{725CA979-ACCF-4D4D-BDA9-2D9208745412}"/>
               </a:ext>
             </a:extLst>
           </p:cNvPr>
@@ -8018,7 +8089,7 @@
                 <a:ea typeface="Aptos"/>
                 <a:cs typeface="Aptos"/>
               </a:rPr>
-              <a:t>Choose a native Buzz provider or bounded plugin bridge after compatibility qualification.</a:t>
+              <a:t>An enrolled member’s agent contributes from its own isolated execution environment.</a:t>
             </a:r>
           </a:p>
         </p:txBody>
@@ -8028,7 +8099,7 @@
           <p:cNvPr id="4" name="">
             <a:extLst xmlns:a="http://schemas.openxmlformats.org/drawingml/2006/main">
               <a:ext uri="{FF2B5EF4-FFF2-40B4-BE49-F238E27FC236}">
-                <a16:creationId xmlns:a16="http://schemas.microsoft.com/office/drawing/2014/main" id="{62916EEB-B82C-4A3F-B47D-D9D27AF79AD1}"/>
+                <a16:creationId xmlns:a16="http://schemas.microsoft.com/office/drawing/2014/main" id="{E6198B50-92B1-41C2-BF0F-E134EECB77C4}"/>
               </a:ext>
             </a:extLst>
           </p:cNvPr>
@@ -8059,7 +8130,7 @@
           <p:cNvPr id="5" name="">
             <a:extLst xmlns:a="http://schemas.openxmlformats.org/drawingml/2006/main">
               <a:ext uri="{FF2B5EF4-FFF2-40B4-BE49-F238E27FC236}">
-                <a16:creationId xmlns:a16="http://schemas.microsoft.com/office/drawing/2014/main" id="{F5F01EA0-C2CC-4F61-8DB3-761B141501AB}"/>
+                <a16:creationId xmlns:a16="http://schemas.microsoft.com/office/drawing/2014/main" id="{5C5D66A7-A791-47FC-AADD-968044D0F32C}"/>
               </a:ext>
             </a:extLst>
           </p:cNvPr>
@@ -8116,7 +8187,7 @@
                 <a:ea typeface="Aptos"/>
                 <a:cs typeface="Aptos"/>
               </a:rPr>
-              <a:t>INERTIA-2026-10-22-r5 · 22 October 2026 · Design refinement · Compatibility first</a:t>
+              <a:t>INERTIA-2026-10-22-r6 · 22 October 2026 · Autonomous build</a:t>
             </a:r>
           </a:p>
         </p:txBody>
@@ -8126,7 +8197,7 @@
           <p:cNvPr id="6" name="">
             <a:extLst xmlns:a="http://schemas.openxmlformats.org/drawingml/2006/main">
               <a:ext uri="{FF2B5EF4-FFF2-40B4-BE49-F238E27FC236}">
-                <a16:creationId xmlns:a16="http://schemas.microsoft.com/office/drawing/2014/main" id="{C37CB3E7-2BEF-4C59-A679-991B4A403378}"/>
+                <a16:creationId xmlns:a16="http://schemas.microsoft.com/office/drawing/2014/main" id="{1A48AE7C-4502-41EC-A036-EBB8C1EFF160}"/>
               </a:ext>
             </a:extLst>
           </p:cNvPr>
@@ -8193,7 +8264,7 @@
           <p:cNvPr id="7" name="">
             <a:extLst xmlns:a="http://schemas.openxmlformats.org/drawingml/2006/main">
               <a:ext uri="{FF2B5EF4-FFF2-40B4-BE49-F238E27FC236}">
-                <a16:creationId xmlns:a16="http://schemas.microsoft.com/office/drawing/2014/main" id="{859A76CD-56EE-45C5-B880-78B6E3EF56B6}"/>
+                <a16:creationId xmlns:a16="http://schemas.microsoft.com/office/drawing/2014/main" id="{46AEB412-1793-4D76-8880-420EAE6B4C4A}"/>
               </a:ext>
             </a:extLst>
           </p:cNvPr>
@@ -8226,7 +8297,7 @@
           <p:cNvPr id="8" name="">
             <a:extLst xmlns:a="http://schemas.openxmlformats.org/drawingml/2006/main">
               <a:ext uri="{FF2B5EF4-FFF2-40B4-BE49-F238E27FC236}">
-                <a16:creationId xmlns:a16="http://schemas.microsoft.com/office/drawing/2014/main" id="{714302E0-A19B-45C4-8690-E9B6E74A3632}"/>
+                <a16:creationId xmlns:a16="http://schemas.microsoft.com/office/drawing/2014/main" id="{AB915837-2254-47DA-8A79-0B276DF698AF}"/>
               </a:ext>
             </a:extLst>
           </p:cNvPr>
@@ -8283,7 +8354,7 @@
                 <a:ea typeface="Aptos"/>
                 <a:cs typeface="Aptos"/>
               </a:rPr>
-              <a:t>Ingress</a:t>
+              <a:t>Eager acquisition</a:t>
             </a:r>
           </a:p>
         </p:txBody>
@@ -8293,7 +8364,7 @@
           <p:cNvPr id="9" name="">
             <a:extLst xmlns:a="http://schemas.openxmlformats.org/drawingml/2006/main">
               <a:ext uri="{FF2B5EF4-FFF2-40B4-BE49-F238E27FC236}">
-                <a16:creationId xmlns:a16="http://schemas.microsoft.com/office/drawing/2014/main" id="{560842E7-CA6D-4BA1-8573-8794B8066B3F}"/>
+                <a16:creationId xmlns:a16="http://schemas.microsoft.com/office/drawing/2014/main" id="{CB7F8E25-211A-4D1A-9D69-13414168C874}"/>
               </a:ext>
             </a:extLst>
           </p:cNvPr>
@@ -8350,7 +8421,7 @@
                 <a:ea typeface="Aptos"/>
                 <a:cs typeface="Aptos"/>
               </a:rPr>
-              <a:t>Relay/channel/thread mapping</a:t>
+              <a:t>Native CEO delegates work</a:t>
             </a:r>
           </a:p>
           <a:p xmlns:a="http://schemas.openxmlformats.org/drawingml/2006/main">
@@ -8373,7 +8444,7 @@
                 <a:ea typeface="Aptos"/>
                 <a:cs typeface="Aptos"/>
               </a:rPr>
-              <a:t>Paired human or agent identity</a:t>
+              <a:t>Agent selects eligible tasks</a:t>
             </a:r>
           </a:p>
           <a:p xmlns:a="http://schemas.openxmlformats.org/drawingml/2006/main">
@@ -8396,7 +8467,7 @@
                 <a:ea typeface="Aptos"/>
                 <a:cs typeface="Aptos"/>
               </a:rPr>
-              <a:t>Durable event deduplication</a:t>
+              <a:t>Atomic checkout wins ownership</a:t>
             </a:r>
           </a:p>
           <a:p xmlns:a="http://schemas.openxmlformats.org/drawingml/2006/main">
@@ -8419,7 +8490,7 @@
                 <a:ea typeface="Aptos"/>
                 <a:cs typeface="Aptos"/>
               </a:rPr>
-              <a:t>Origin marker prevents echoes</a:t>
+              <a:t>Budgets bound activity</a:t>
             </a:r>
           </a:p>
         </p:txBody>
@@ -8429,7 +8500,7 @@
           <p:cNvPr id="10" name="">
             <a:extLst xmlns:a="http://schemas.openxmlformats.org/drawingml/2006/main">
               <a:ext uri="{FF2B5EF4-FFF2-40B4-BE49-F238E27FC236}">
-                <a16:creationId xmlns:a16="http://schemas.microsoft.com/office/drawing/2014/main" id="{D1093884-3572-4106-9365-426876EFAD4D}"/>
+                <a16:creationId xmlns:a16="http://schemas.microsoft.com/office/drawing/2014/main" id="{41083009-1B2E-4505-B370-7E58503D615F}"/>
               </a:ext>
             </a:extLst>
           </p:cNvPr>
@@ -8462,7 +8533,7 @@
           <p:cNvPr id="11" name="">
             <a:extLst xmlns:a="http://schemas.openxmlformats.org/drawingml/2006/main">
               <a:ext uri="{FF2B5EF4-FFF2-40B4-BE49-F238E27FC236}">
-                <a16:creationId xmlns:a16="http://schemas.microsoft.com/office/drawing/2014/main" id="{90B46EDF-1986-4F2C-8BCC-67A5D174B5A8}"/>
+                <a16:creationId xmlns:a16="http://schemas.microsoft.com/office/drawing/2014/main" id="{7D2B6383-E041-412D-8AB2-70E73D0CDEBA}"/>
               </a:ext>
             </a:extLst>
           </p:cNvPr>
@@ -8519,7 +8590,7 @@
                 <a:ea typeface="Aptos"/>
                 <a:cs typeface="Aptos"/>
               </a:rPr>
-              <a:t>Decisions</a:t>
+              <a:t>Scoped execution</a:t>
             </a:r>
           </a:p>
         </p:txBody>
@@ -8529,7 +8600,7 @@
           <p:cNvPr id="12" name="">
             <a:extLst xmlns:a="http://schemas.openxmlformats.org/drawingml/2006/main">
               <a:ext uri="{FF2B5EF4-FFF2-40B4-BE49-F238E27FC236}">
-                <a16:creationId xmlns:a16="http://schemas.microsoft.com/office/drawing/2014/main" id="{06AC444E-7833-4BFE-B15D-9AF3BE4F448F}"/>
+                <a16:creationId xmlns:a16="http://schemas.microsoft.com/office/drawing/2014/main" id="{424591E1-06DB-4383-A7FB-0097C6C08745}"/>
               </a:ext>
             </a:extLst>
           </p:cNvPr>
@@ -8586,7 +8657,7 @@
                 <a:ea typeface="Aptos"/>
                 <a:cs typeface="Aptos"/>
               </a:rPr>
-              <a:t>Native interaction ID + revision</a:t>
+              <a:t>Task-specific inputs</a:t>
             </a:r>
           </a:p>
           <a:p xmlns:a="http://schemas.openxmlformats.org/drawingml/2006/main">
@@ -8609,7 +8680,7 @@
                 <a:ea typeface="Aptos"/>
                 <a:cs typeface="Aptos"/>
               </a:rPr>
-              <a:t>Current authorization at apply</a:t>
+              <a:t>Sandbox and isolated worktree</a:t>
             </a:r>
           </a:p>
           <a:p xmlns:a="http://schemas.openxmlformats.org/drawingml/2006/main">
@@ -8632,7 +8703,7 @@
                 <a:ea typeface="Aptos"/>
                 <a:cs typeface="Aptos"/>
               </a:rPr>
-              <a:t>Stale/conflicting answer handling</a:t>
+              <a:t>Existing provider lifecycle</a:t>
             </a:r>
           </a:p>
           <a:p xmlns:a="http://schemas.openxmlformats.org/drawingml/2006/main">
@@ -8655,7 +8726,7 @@
                 <a:ea typeface="Aptos"/>
                 <a:cs typeface="Aptos"/>
               </a:rPr>
-              <a:t>Agent ≠ human approval</a:t>
+              <a:t>No shared publisher credentials</a:t>
             </a:r>
           </a:p>
         </p:txBody>
@@ -8665,7 +8736,7 @@
           <p:cNvPr id="13" name="">
             <a:extLst xmlns:a="http://schemas.openxmlformats.org/drawingml/2006/main">
               <a:ext uri="{FF2B5EF4-FFF2-40B4-BE49-F238E27FC236}">
-                <a16:creationId xmlns:a16="http://schemas.microsoft.com/office/drawing/2014/main" id="{9E409CEF-4B5D-416E-B84A-9888DB2E62F0}"/>
+                <a16:creationId xmlns:a16="http://schemas.microsoft.com/office/drawing/2014/main" id="{CBAF23CF-14FD-40C7-BEE2-1B0894CA12DD}"/>
               </a:ext>
             </a:extLst>
           </p:cNvPr>
@@ -8698,7 +8769,7 @@
           <p:cNvPr id="14" name="">
             <a:extLst xmlns:a="http://schemas.openxmlformats.org/drawingml/2006/main">
               <a:ext uri="{FF2B5EF4-FFF2-40B4-BE49-F238E27FC236}">
-                <a16:creationId xmlns:a16="http://schemas.microsoft.com/office/drawing/2014/main" id="{852249FF-515C-457F-BC9B-E8BD8A419DF5}"/>
+                <a16:creationId xmlns:a16="http://schemas.microsoft.com/office/drawing/2014/main" id="{0EF6E3C3-8538-407D-8323-0B92B83E7700}"/>
               </a:ext>
             </a:extLst>
           </p:cNvPr>
@@ -8755,7 +8826,7 @@
                 <a:ea typeface="Aptos"/>
                 <a:cs typeface="Aptos"/>
               </a:rPr>
-              <a:t>Recovery + audience</a:t>
+              <a:t>Useful result</a:t>
             </a:r>
           </a:p>
         </p:txBody>
@@ -8765,7 +8836,7 @@
           <p:cNvPr id="15" name="">
             <a:extLst xmlns:a="http://schemas.openxmlformats.org/drawingml/2006/main">
               <a:ext uri="{FF2B5EF4-FFF2-40B4-BE49-F238E27FC236}">
-                <a16:creationId xmlns:a16="http://schemas.microsoft.com/office/drawing/2014/main" id="{710B54A4-31E8-4BB5-B111-B6329E8FB691}"/>
+                <a16:creationId xmlns:a16="http://schemas.microsoft.com/office/drawing/2014/main" id="{7472C7BA-02D4-41A2-AD17-667D5D2DDB05}"/>
               </a:ext>
             </a:extLst>
           </p:cNvPr>
@@ -8822,7 +8893,7 @@
                 <a:ea typeface="Aptos"/>
                 <a:cs typeface="Aptos"/>
               </a:rPr>
-              <a:t>Persisted cursor and receipts</a:t>
+              <a:t>Server validates the artifact</a:t>
             </a:r>
           </a:p>
           <a:p xmlns:a="http://schemas.openxmlformats.org/drawingml/2006/main">
@@ -8845,7 +8916,7 @@
                 <a:ea typeface="Aptos"/>
                 <a:cs typeface="Aptos"/>
               </a:rPr>
-              <a:t>Reconcile edits and disconnects</a:t>
+              <a:t>Native review accepts evidence</a:t>
             </a:r>
           </a:p>
           <a:p xmlns:a="http://schemas.openxmlformats.org/drawingml/2006/main">
@@ -8868,7 +8939,7 @@
                 <a:ea typeface="Aptos"/>
                 <a:cs typeface="Aptos"/>
               </a:rPr>
-              <a:t>Same-thread result presentation</a:t>
+              <a:t>Trusted adapter publishes</a:t>
             </a:r>
           </a:p>
           <a:p xmlns:a="http://schemas.openxmlformats.org/drawingml/2006/main">
@@ -8891,7 +8962,7 @@
                 <a:ea typeface="Aptos"/>
                 <a:cs typeface="Aptos"/>
               </a:rPr>
-              <a:t>No cross-company data leakage</a:t>
+              <a:t>Bounded follow-ups preserve context</a:t>
             </a:r>
           </a:p>
         </p:txBody>
@@ -8901,7 +8972,7 @@
           <p:cNvPr id="16" name="">
             <a:extLst xmlns:a="http://schemas.openxmlformats.org/drawingml/2006/main">
               <a:ext uri="{FF2B5EF4-FFF2-40B4-BE49-F238E27FC236}">
-                <a16:creationId xmlns:a16="http://schemas.microsoft.com/office/drawing/2014/main" id="{5191D1A3-FF01-49CA-A27E-E64DC44FBF6D}"/>
+                <a16:creationId xmlns:a16="http://schemas.microsoft.com/office/drawing/2014/main" id="{3B3E80F0-9A88-48A2-A43F-ABA3D488D308}"/>
               </a:ext>
             </a:extLst>
           </p:cNvPr>
@@ -8958,7 +9029,7 @@
                 <a:ea typeface="Aptos"/>
                 <a:cs typeface="Aptos"/>
               </a:rPr>
-              <a:t>A Buzz trigger and native routine must never create two schedulers for the same admitted work.</a:t>
+              <a:t>Integrate through existing public execution contracts. Qualify runtime isolation and enrollment before live participation.</a:t>
             </a:r>
           </a:p>
         </p:txBody>
@@ -8966,7 +9037,7 @@
     </p:spTree>
     <p:extLst>
       <p:ext uri="{BB962C8B-B14F-4D97-AF65-F5344CB8AC3E}">
-        <p14:creationId xmlns:p14="http://schemas.microsoft.com/office/powerpoint/2010/main" val="788778692"/>
+        <p14:creationId xmlns:p14="http://schemas.microsoft.com/office/powerpoint/2010/main" val="1143166186"/>
       </p:ext>
     </p:extLst>
   </p:cSld>
@@ -8997,7 +9068,7 @@
           <p:cNvPr id="17" name="">
             <a:extLst xmlns:a="http://schemas.openxmlformats.org/drawingml/2006/main">
               <a:ext uri="{FF2B5EF4-FFF2-40B4-BE49-F238E27FC236}">
-                <a16:creationId xmlns:a16="http://schemas.microsoft.com/office/drawing/2014/main" id="{EDAE1D18-6CD2-4E5D-9269-E8B44CADFBF6}"/>
+                <a16:creationId xmlns:a16="http://schemas.microsoft.com/office/drawing/2014/main" id="{E8BFF74A-1AD1-4C6B-BD01-419D45C73820}"/>
               </a:ext>
             </a:extLst>
           </p:cNvPr>
@@ -9064,7 +9135,7 @@
           <p:cNvPr id="2" name="">
             <a:extLst xmlns:a="http://schemas.openxmlformats.org/drawingml/2006/main">
               <a:ext uri="{FF2B5EF4-FFF2-40B4-BE49-F238E27FC236}">
-                <a16:creationId xmlns:a16="http://schemas.microsoft.com/office/drawing/2014/main" id="{DBA3FB14-B136-4215-BFFD-14D05040CF1E}"/>
+                <a16:creationId xmlns:a16="http://schemas.microsoft.com/office/drawing/2014/main" id="{230A7959-6D24-4DD6-B1B5-C19B68B9EB8D}"/>
               </a:ext>
             </a:extLst>
           </p:cNvPr>
@@ -9121,7 +9192,7 @@
                 <a:ea typeface="Aptos"/>
                 <a:cs typeface="Aptos"/>
               </a:rPr>
-              <a:t>Tests that establish the connected loop</a:t>
+              <a:t>Reliable operation without babysitting</a:t>
             </a:r>
           </a:p>
         </p:txBody>
@@ -9131,7 +9202,7 @@
           <p:cNvPr id="3" name="">
             <a:extLst xmlns:a="http://schemas.openxmlformats.org/drawingml/2006/main">
               <a:ext uri="{FF2B5EF4-FFF2-40B4-BE49-F238E27FC236}">
-                <a16:creationId xmlns:a16="http://schemas.microsoft.com/office/drawing/2014/main" id="{00F9A190-9750-456D-AC46-04A9BD913C4C}"/>
+                <a16:creationId xmlns:a16="http://schemas.microsoft.com/office/drawing/2014/main" id="{EFF4F7FF-0C2A-4EC3-BCF8-F41024202C2B}"/>
               </a:ext>
             </a:extLst>
           </p:cNvPr>
@@ -9188,7 +9259,7 @@
                 <a:ea typeface="Aptos"/>
                 <a:cs typeface="Aptos"/>
               </a:rPr>
-              <a:t>Define fixtures first; retain exact code/config versions, expected outcomes and readback receipts.</a:t>
+              <a:t>One-time pairing and configuration support automatic normal work and recovery.</a:t>
             </a:r>
           </a:p>
         </p:txBody>
@@ -9198,7 +9269,7 @@
           <p:cNvPr id="4" name="">
             <a:extLst xmlns:a="http://schemas.openxmlformats.org/drawingml/2006/main">
               <a:ext uri="{FF2B5EF4-FFF2-40B4-BE49-F238E27FC236}">
-                <a16:creationId xmlns:a16="http://schemas.microsoft.com/office/drawing/2014/main" id="{A7A92A80-8B78-4F76-AB52-C70FA6E24A94}"/>
+                <a16:creationId xmlns:a16="http://schemas.microsoft.com/office/drawing/2014/main" id="{C2793082-B249-4DC4-8471-1FAF88E7F6B0}"/>
               </a:ext>
             </a:extLst>
           </p:cNvPr>
@@ -9229,7 +9300,7 @@
           <p:cNvPr id="5" name="">
             <a:extLst xmlns:a="http://schemas.openxmlformats.org/drawingml/2006/main">
               <a:ext uri="{FF2B5EF4-FFF2-40B4-BE49-F238E27FC236}">
-                <a16:creationId xmlns:a16="http://schemas.microsoft.com/office/drawing/2014/main" id="{9C5D642A-3B63-4889-B24D-D89B18BFB3BF}"/>
+                <a16:creationId xmlns:a16="http://schemas.microsoft.com/office/drawing/2014/main" id="{9170EF64-F932-411E-8306-4801C24BF409}"/>
               </a:ext>
             </a:extLst>
           </p:cNvPr>
@@ -9286,7 +9357,7 @@
                 <a:ea typeface="Aptos"/>
                 <a:cs typeface="Aptos"/>
               </a:rPr>
-              <a:t>INERTIA-2026-10-22-r5 · 22 October 2026 · Design refinement · Compatibility first</a:t>
+              <a:t>INERTIA-2026-10-22-r6 · 22 October 2026 · Autonomous build</a:t>
             </a:r>
           </a:p>
         </p:txBody>
@@ -9296,7 +9367,7 @@
           <p:cNvPr id="6" name="">
             <a:extLst xmlns:a="http://schemas.openxmlformats.org/drawingml/2006/main">
               <a:ext uri="{FF2B5EF4-FFF2-40B4-BE49-F238E27FC236}">
-                <a16:creationId xmlns:a16="http://schemas.microsoft.com/office/drawing/2014/main" id="{AF7546A4-25BA-46E8-A584-C9DA42E9D643}"/>
+                <a16:creationId xmlns:a16="http://schemas.microsoft.com/office/drawing/2014/main" id="{B9B040D9-DFD2-43A0-B283-F6C92C8B651E}"/>
               </a:ext>
             </a:extLst>
           </p:cNvPr>
@@ -9363,7 +9434,7 @@
           <p:cNvPr id="7" name="">
             <a:extLst xmlns:a="http://schemas.openxmlformats.org/drawingml/2006/main">
               <a:ext uri="{FF2B5EF4-FFF2-40B4-BE49-F238E27FC236}">
-                <a16:creationId xmlns:a16="http://schemas.microsoft.com/office/drawing/2014/main" id="{6AB94246-0EE4-4527-B38D-0D68B579D3D4}"/>
+                <a16:creationId xmlns:a16="http://schemas.microsoft.com/office/drawing/2014/main" id="{9ED3A75D-EB6A-4B80-B076-2247FB90597E}"/>
               </a:ext>
             </a:extLst>
           </p:cNvPr>
@@ -9396,7 +9467,7 @@
           <p:cNvPr id="8" name="">
             <a:extLst xmlns:a="http://schemas.openxmlformats.org/drawingml/2006/main">
               <a:ext uri="{FF2B5EF4-FFF2-40B4-BE49-F238E27FC236}">
-                <a16:creationId xmlns:a16="http://schemas.microsoft.com/office/drawing/2014/main" id="{A46DA315-9578-41AE-BB7D-99027E8A7DEC}"/>
+                <a16:creationId xmlns:a16="http://schemas.microsoft.com/office/drawing/2014/main" id="{B4FF6F3B-F4F9-4584-B905-4DE2B777090D}"/>
               </a:ext>
             </a:extLst>
           </p:cNvPr>
@@ -9453,7 +9524,7 @@
                 <a:ea typeface="Aptos"/>
                 <a:cs typeface="Aptos"/>
               </a:rPr>
-              <a:t>Bridge contracts</a:t>
+              <a:t>Configure once</a:t>
             </a:r>
           </a:p>
         </p:txBody>
@@ -9463,7 +9534,7 @@
           <p:cNvPr id="9" name="">
             <a:extLst xmlns:a="http://schemas.openxmlformats.org/drawingml/2006/main">
               <a:ext uri="{FF2B5EF4-FFF2-40B4-BE49-F238E27FC236}">
-                <a16:creationId xmlns:a16="http://schemas.microsoft.com/office/drawing/2014/main" id="{2B77AE1D-82A2-4B26-918E-D6794834A077}"/>
+                <a16:creationId xmlns:a16="http://schemas.microsoft.com/office/drawing/2014/main" id="{6B1382C3-5A6C-4D06-9556-6809EE8439CF}"/>
               </a:ext>
             </a:extLst>
           </p:cNvPr>
@@ -9520,7 +9591,7 @@
                 <a:ea typeface="Aptos"/>
                 <a:cs typeface="Aptos"/>
               </a:rPr>
-              <a:t>Pairing and revocation</a:t>
+              <a:t>Admit the plugin and provider</a:t>
             </a:r>
           </a:p>
           <a:p xmlns:a="http://schemas.openxmlformats.org/drawingml/2006/main">
@@ -9543,7 +9614,7 @@
                 <a:ea typeface="Aptos"/>
                 <a:cs typeface="Aptos"/>
               </a:rPr>
-              <a:t>Duplicate event and echo loop</a:t>
+              <a:t>Bind company, channel and task</a:t>
             </a:r>
           </a:p>
           <a:p xmlns:a="http://schemas.openxmlformats.org/drawingml/2006/main">
@@ -9566,7 +9637,7 @@
                 <a:ea typeface="Aptos"/>
                 <a:cs typeface="Aptos"/>
               </a:rPr>
-              <a:t>Stale/conflicting decisions</a:t>
+              <a:t>Pair authorized identities</a:t>
             </a:r>
           </a:p>
           <a:p xmlns:a="http://schemas.openxmlformats.org/drawingml/2006/main">
@@ -9589,7 +9660,7 @@
                 <a:ea typeface="Aptos"/>
                 <a:cs typeface="Aptos"/>
               </a:rPr>
-              <a:t>Reconnect and one scheduler</a:t>
+              <a:t>Choose source and publication policy</a:t>
             </a:r>
           </a:p>
         </p:txBody>
@@ -9599,7 +9670,7 @@
           <p:cNvPr id="10" name="">
             <a:extLst xmlns:a="http://schemas.openxmlformats.org/drawingml/2006/main">
               <a:ext uri="{FF2B5EF4-FFF2-40B4-BE49-F238E27FC236}">
-                <a16:creationId xmlns:a16="http://schemas.microsoft.com/office/drawing/2014/main" id="{6EC4F03D-DD9D-4E29-AD60-38000924B8CB}"/>
+                <a16:creationId xmlns:a16="http://schemas.microsoft.com/office/drawing/2014/main" id="{2F41B63E-9811-45C2-B0C2-D454743A724F}"/>
               </a:ext>
             </a:extLst>
           </p:cNvPr>
@@ -9632,7 +9703,7 @@
           <p:cNvPr id="11" name="">
             <a:extLst xmlns:a="http://schemas.openxmlformats.org/drawingml/2006/main">
               <a:ext uri="{FF2B5EF4-FFF2-40B4-BE49-F238E27FC236}">
-                <a16:creationId xmlns:a16="http://schemas.microsoft.com/office/drawing/2014/main" id="{84E7D5B2-DC0C-470A-8F4A-CF08AB229A73}"/>
+                <a16:creationId xmlns:a16="http://schemas.microsoft.com/office/drawing/2014/main" id="{72656AD3-8B73-4D89-ADF5-37D3C63785BF}"/>
               </a:ext>
             </a:extLst>
           </p:cNvPr>
@@ -9689,7 +9760,7 @@
                 <a:ea typeface="Aptos"/>
                 <a:cs typeface="Aptos"/>
               </a:rPr>
-              <a:t>Domain acceptance</a:t>
+              <a:t>Recover automatically</a:t>
             </a:r>
           </a:p>
         </p:txBody>
@@ -9699,7 +9770,7 @@
           <p:cNvPr id="12" name="">
             <a:extLst xmlns:a="http://schemas.openxmlformats.org/drawingml/2006/main">
               <a:ext uri="{FF2B5EF4-FFF2-40B4-BE49-F238E27FC236}">
-                <a16:creationId xmlns:a16="http://schemas.microsoft.com/office/drawing/2014/main" id="{61611C16-55CC-4C3E-B88F-583F197C205E}"/>
+                <a16:creationId xmlns:a16="http://schemas.microsoft.com/office/drawing/2014/main" id="{244F498A-6FFD-4234-A00E-64B2C10C5AAD}"/>
               </a:ext>
             </a:extLst>
           </p:cNvPr>
@@ -9756,7 +9827,7 @@
                 <a:ea typeface="Aptos"/>
                 <a:cs typeface="Aptos"/>
               </a:rPr>
-              <a:t>Faithful meeting publication</a:t>
+              <a:t>Persist receipts and checkpoints</a:t>
             </a:r>
           </a:p>
           <a:p xmlns:a="http://schemas.openxmlformats.org/drawingml/2006/main">
@@ -9779,7 +9850,7 @@
                 <a:ea typeface="Aptos"/>
                 <a:cs typeface="Aptos"/>
               </a:rPr>
-              <a:t>Audience and upsert readback</a:t>
+              <a:t>Retry the same signed event</a:t>
             </a:r>
           </a:p>
           <a:p xmlns:a="http://schemas.openxmlformats.org/drawingml/2006/main">
@@ -9802,7 +9873,7 @@
                 <a:ea typeface="Aptos"/>
                 <a:cs typeface="Aptos"/>
               </a:rPr>
-              <a:t>Current grant + immutable packet</a:t>
+              <a:t>Respect server retry timing</a:t>
             </a:r>
           </a:p>
           <a:p xmlns:a="http://schemas.openxmlformats.org/drawingml/2006/main">
@@ -9825,7 +9896,7 @@
                 <a:ea typeface="Aptos"/>
                 <a:cs typeface="Aptos"/>
               </a:rPr>
-              <a:t>Vote hash/network/finality</a:t>
+              <a:t>Reconcile uncertain writes first</a:t>
             </a:r>
           </a:p>
         </p:txBody>
@@ -9835,7 +9906,7 @@
           <p:cNvPr id="13" name="">
             <a:extLst xmlns:a="http://schemas.openxmlformats.org/drawingml/2006/main">
               <a:ext uri="{FF2B5EF4-FFF2-40B4-BE49-F238E27FC236}">
-                <a16:creationId xmlns:a16="http://schemas.microsoft.com/office/drawing/2014/main" id="{E6023EF8-110A-43EF-A098-D9ABFF43CA16}"/>
+                <a16:creationId xmlns:a16="http://schemas.microsoft.com/office/drawing/2014/main" id="{397EE58A-D433-4144-8B73-EDB41BE1F84E}"/>
               </a:ext>
             </a:extLst>
           </p:cNvPr>
@@ -9868,7 +9939,7 @@
           <p:cNvPr id="14" name="">
             <a:extLst xmlns:a="http://schemas.openxmlformats.org/drawingml/2006/main">
               <a:ext uri="{FF2B5EF4-FFF2-40B4-BE49-F238E27FC236}">
-                <a16:creationId xmlns:a16="http://schemas.microsoft.com/office/drawing/2014/main" id="{C90498A9-0FEA-4EC3-9075-9E2ADB1C2018}"/>
+                <a16:creationId xmlns:a16="http://schemas.microsoft.com/office/drawing/2014/main" id="{E07624BE-028A-40D7-AF2A-29F9DD5E200D}"/>
               </a:ext>
             </a:extLst>
           </p:cNvPr>
@@ -9925,7 +9996,7 @@
                 <a:ea typeface="Aptos"/>
                 <a:cs typeface="Aptos"/>
               </a:rPr>
-              <a:t>Member boundaries</a:t>
+              <a:t>Show what matters</a:t>
             </a:r>
           </a:p>
         </p:txBody>
@@ -9935,7 +10006,7 @@
           <p:cNvPr id="15" name="">
             <a:extLst xmlns:a="http://schemas.openxmlformats.org/drawingml/2006/main">
               <a:ext uri="{FF2B5EF4-FFF2-40B4-BE49-F238E27FC236}">
-                <a16:creationId xmlns:a16="http://schemas.microsoft.com/office/drawing/2014/main" id="{72D2CD91-4760-4A7D-8302-5090D711B663}"/>
+                <a16:creationId xmlns:a16="http://schemas.microsoft.com/office/drawing/2014/main" id="{E3D4E954-651E-496F-8F4E-1115F08B1959}"/>
               </a:ext>
             </a:extLst>
           </p:cNvPr>
@@ -9992,7 +10063,7 @@
                 <a:ea typeface="Aptos"/>
                 <a:cs typeface="Aptos"/>
               </a:rPr>
-              <a:t>Second member contribution</a:t>
+              <a:t>Useful same-thread results</a:t>
             </a:r>
           </a:p>
           <a:p xmlns:a="http://schemas.openxmlformats.org/drawingml/2006/main">
@@ -10015,7 +10086,7 @@
                 <a:ea typeface="Aptos"/>
                 <a:cs typeface="Aptos"/>
               </a:rPr>
-              <a:t>Cross-task access denial</a:t>
+              <a:t>Backlog and last successful sync</a:t>
             </a:r>
           </a:p>
           <a:p xmlns:a="http://schemas.openxmlformats.org/drawingml/2006/main">
@@ -10038,7 +10109,7 @@
                 <a:ea typeface="Aptos"/>
                 <a:cs typeface="Aptos"/>
               </a:rPr>
-              <a:t>Sandbox and artifact validation</a:t>
+              <a:t>Clear permanent setup errors</a:t>
             </a:r>
           </a:p>
           <a:p xmlns:a="http://schemas.openxmlformats.org/drawingml/2006/main">
@@ -10061,7 +10132,7 @@
                 <a:ea typeface="Aptos"/>
                 <a:cs typeface="Aptos"/>
               </a:rPr>
-              <a:t>Follow-up limits and recovery</a:t>
+              <a:t>Native UI for complex decisions</a:t>
             </a:r>
           </a:p>
         </p:txBody>
@@ -10071,7 +10142,7 @@
           <p:cNvPr id="16" name="">
             <a:extLst xmlns:a="http://schemas.openxmlformats.org/drawingml/2006/main">
               <a:ext uri="{FF2B5EF4-FFF2-40B4-BE49-F238E27FC236}">
-                <a16:creationId xmlns:a16="http://schemas.microsoft.com/office/drawing/2014/main" id="{E53890B4-F980-4243-ACEC-EA3034B317BC}"/>
+                <a16:creationId xmlns:a16="http://schemas.microsoft.com/office/drawing/2014/main" id="{26AAD5B6-0DB4-4A3C-8838-782ACA834860}"/>
               </a:ext>
             </a:extLst>
           </p:cNvPr>
@@ -10128,7 +10199,7 @@
                 <a:ea typeface="Aptos"/>
                 <a:cs typeface="Aptos"/>
               </a:rPr>
-              <a:t>G1 compatibility → G2 reviewed design → G3 contract acceptance → G4 end-to-end demo evidence.</a:t>
+              <a:t>Source text cannot grant authority. Current host permissions govern every human-attributed native action.</a:t>
             </a:r>
           </a:p>
         </p:txBody>
@@ -10136,7 +10207,7 @@
     </p:spTree>
     <p:extLst>
       <p:ext uri="{BB962C8B-B14F-4D97-AF65-F5344CB8AC3E}">
-        <p14:creationId xmlns:p14="http://schemas.microsoft.com/office/powerpoint/2010/main" val="1663250411"/>
+        <p14:creationId xmlns:p14="http://schemas.microsoft.com/office/powerpoint/2010/main" val="1796107977"/>
       </p:ext>
     </p:extLst>
   </p:cSld>
@@ -10167,7 +10238,7 @@
           <p:cNvPr id="17" name="">
             <a:extLst xmlns:a="http://schemas.openxmlformats.org/drawingml/2006/main">
               <a:ext uri="{FF2B5EF4-FFF2-40B4-BE49-F238E27FC236}">
-                <a16:creationId xmlns:a16="http://schemas.microsoft.com/office/drawing/2014/main" id="{B3DD369A-0929-47EB-AE6A-007377F2A85C}"/>
+                <a16:creationId xmlns:a16="http://schemas.microsoft.com/office/drawing/2014/main" id="{B2493966-7999-40A3-83FF-AB2B04D81A0D}"/>
               </a:ext>
             </a:extLst>
           </p:cNvPr>
@@ -10234,7 +10305,7 @@
           <p:cNvPr id="2" name="">
             <a:extLst xmlns:a="http://schemas.openxmlformats.org/drawingml/2006/main">
               <a:ext uri="{FF2B5EF4-FFF2-40B4-BE49-F238E27FC236}">
-                <a16:creationId xmlns:a16="http://schemas.microsoft.com/office/drawing/2014/main" id="{FA9C625F-9237-482B-91AC-7D3F03CBEECB}"/>
+                <a16:creationId xmlns:a16="http://schemas.microsoft.com/office/drawing/2014/main" id="{C8B52D4F-9531-4529-B538-197B671F0AD1}"/>
               </a:ext>
             </a:extLst>
           </p:cNvPr>
@@ -10291,7 +10362,7 @@
                 <a:ea typeface="Aptos"/>
                 <a:cs typeface="Aptos"/>
               </a:rPr>
-              <a:t>Compatibility first, then concrete design</a:t>
+              <a:t>Build evidence on 22 October</a:t>
             </a:r>
           </a:p>
         </p:txBody>
@@ -10301,7 +10372,7 @@
           <p:cNvPr id="3" name="">
             <a:extLst xmlns:a="http://schemas.openxmlformats.org/drawingml/2006/main">
               <a:ext uri="{FF2B5EF4-FFF2-40B4-BE49-F238E27FC236}">
-                <a16:creationId xmlns:a16="http://schemas.microsoft.com/office/drawing/2014/main" id="{A0EF6768-4815-46D9-912A-D16D3034D249}"/>
+                <a16:creationId xmlns:a16="http://schemas.microsoft.com/office/drawing/2014/main" id="{A6EF57FD-C9F4-4EC6-B9EB-88FFEFCB32F0}"/>
               </a:ext>
             </a:extLst>
           </p:cNvPr>
@@ -10358,7 +10429,7 @@
                 <a:ea typeface="Aptos"/>
                 <a:cs typeface="Aptos"/>
               </a:rPr>
-              <a:t>Three required outcomes remain the target. The next review selects supported interfaces and deployment topology.</a:t>
+              <a:t>Connected bridge and Roundtable core are merged into develop.</a:t>
             </a:r>
           </a:p>
         </p:txBody>
@@ -10368,7 +10439,7 @@
           <p:cNvPr id="4" name="">
             <a:extLst xmlns:a="http://schemas.openxmlformats.org/drawingml/2006/main">
               <a:ext uri="{FF2B5EF4-FFF2-40B4-BE49-F238E27FC236}">
-                <a16:creationId xmlns:a16="http://schemas.microsoft.com/office/drawing/2014/main" id="{256044AF-BE43-4CDD-A043-3E574B8C717A}"/>
+                <a16:creationId xmlns:a16="http://schemas.microsoft.com/office/drawing/2014/main" id="{5616D756-27A0-4527-9667-A16925328996}"/>
               </a:ext>
             </a:extLst>
           </p:cNvPr>
@@ -10399,7 +10470,7 @@
           <p:cNvPr id="5" name="">
             <a:extLst xmlns:a="http://schemas.openxmlformats.org/drawingml/2006/main">
               <a:ext uri="{FF2B5EF4-FFF2-40B4-BE49-F238E27FC236}">
-                <a16:creationId xmlns:a16="http://schemas.microsoft.com/office/drawing/2014/main" id="{853CACAF-275D-4EF3-8FC3-4E0AF3BFA612}"/>
+                <a16:creationId xmlns:a16="http://schemas.microsoft.com/office/drawing/2014/main" id="{C7F36929-593B-48E1-B7F8-53BE82B0D754}"/>
               </a:ext>
             </a:extLst>
           </p:cNvPr>
@@ -10456,7 +10527,7 @@
                 <a:ea typeface="Aptos"/>
                 <a:cs typeface="Aptos"/>
               </a:rPr>
-              <a:t>INERTIA-2026-10-22-r5 · 22 October 2026 · Design refinement · Compatibility first</a:t>
+              <a:t>INERTIA-2026-10-22-r6 · 22 October 2026 · Autonomous build</a:t>
             </a:r>
           </a:p>
         </p:txBody>
@@ -10466,7 +10537,7 @@
           <p:cNvPr id="6" name="">
             <a:extLst xmlns:a="http://schemas.openxmlformats.org/drawingml/2006/main">
               <a:ext uri="{FF2B5EF4-FFF2-40B4-BE49-F238E27FC236}">
-                <a16:creationId xmlns:a16="http://schemas.microsoft.com/office/drawing/2014/main" id="{D53C9AEC-253D-403E-9B1A-6C4F6206C376}"/>
+                <a16:creationId xmlns:a16="http://schemas.microsoft.com/office/drawing/2014/main" id="{1D7FF4B2-2E49-4723-8518-73C80825B92A}"/>
               </a:ext>
             </a:extLst>
           </p:cNvPr>
@@ -10533,7 +10604,7 @@
           <p:cNvPr id="7" name="">
             <a:extLst xmlns:a="http://schemas.openxmlformats.org/drawingml/2006/main">
               <a:ext uri="{FF2B5EF4-FFF2-40B4-BE49-F238E27FC236}">
-                <a16:creationId xmlns:a16="http://schemas.microsoft.com/office/drawing/2014/main" id="{A3E4C447-32FF-4521-935D-2D681E74CC07}"/>
+                <a16:creationId xmlns:a16="http://schemas.microsoft.com/office/drawing/2014/main" id="{42B87E8A-366F-4EA9-BA12-2F34D9CD8C0C}"/>
               </a:ext>
             </a:extLst>
           </p:cNvPr>
@@ -10566,7 +10637,7 @@
           <p:cNvPr id="8" name="">
             <a:extLst xmlns:a="http://schemas.openxmlformats.org/drawingml/2006/main">
               <a:ext uri="{FF2B5EF4-FFF2-40B4-BE49-F238E27FC236}">
-                <a16:creationId xmlns:a16="http://schemas.microsoft.com/office/drawing/2014/main" id="{5A9B8ED6-81F4-4300-B98F-8846CDFAD7E9}"/>
+                <a16:creationId xmlns:a16="http://schemas.microsoft.com/office/drawing/2014/main" id="{049B2ABF-5E1E-44D2-BBCA-26EAEA7ED08B}"/>
               </a:ext>
             </a:extLst>
           </p:cNvPr>
@@ -10623,7 +10694,7 @@
                 <a:ea typeface="Aptos"/>
                 <a:cs typeface="Aptos"/>
               </a:rPr>
-              <a:t>22–23 OCT</a:t>
+              <a:t>Merged foundation</a:t>
             </a:r>
           </a:p>
         </p:txBody>
@@ -10633,7 +10704,7 @@
           <p:cNvPr id="9" name="">
             <a:extLst xmlns:a="http://schemas.openxmlformats.org/drawingml/2006/main">
               <a:ext uri="{FF2B5EF4-FFF2-40B4-BE49-F238E27FC236}">
-                <a16:creationId xmlns:a16="http://schemas.microsoft.com/office/drawing/2014/main" id="{A84519E0-C3C8-44E1-A338-394258AA8F3C}"/>
+                <a16:creationId xmlns:a16="http://schemas.microsoft.com/office/drawing/2014/main" id="{AB45F3C5-0478-4887-A909-6C9123996D0D}"/>
               </a:ext>
             </a:extLst>
           </p:cNvPr>
@@ -10690,7 +10761,7 @@
                 <a:ea typeface="Aptos"/>
                 <a:cs typeface="Aptos"/>
               </a:rPr>
-              <a:t>Pin versions and serving routes</a:t>
+              <a:t>PR 2: 36 transport tests</a:t>
             </a:r>
           </a:p>
           <a:p xmlns:a="http://schemas.openxmlformats.org/drawingml/2006/main">
@@ -10713,7 +10784,7 @@
                 <a:ea typeface="Aptos"/>
                 <a:cs typeface="Aptos"/>
               </a:rPr>
-              <a:t>Qualify execution integration</a:t>
+              <a:t>PR 3: combined 60 tests</a:t>
             </a:r>
           </a:p>
           <a:p xmlns:a="http://schemas.openxmlformats.org/drawingml/2006/main">
@@ -10736,7 +10807,7 @@
                 <a:ea typeface="Aptos"/>
                 <a:cs typeface="Aptos"/>
               </a:rPr>
-              <a:t>Resolve identity and policies</a:t>
+              <a:t>Real signatures and SQL</a:t>
             </a:r>
           </a:p>
           <a:p xmlns:a="http://schemas.openxmlformats.org/drawingml/2006/main">
@@ -10759,7 +10830,7 @@
                 <a:ea typeface="Aptos"/>
                 <a:cs typeface="Aptos"/>
               </a:rPr>
-              <a:t>Review exact bridge contracts</a:t>
+              <a:t>Typecheck, build and fixture demo</a:t>
             </a:r>
           </a:p>
         </p:txBody>
@@ -10769,7 +10840,7 @@
           <p:cNvPr id="10" name="">
             <a:extLst xmlns:a="http://schemas.openxmlformats.org/drawingml/2006/main">
               <a:ext uri="{FF2B5EF4-FFF2-40B4-BE49-F238E27FC236}">
-                <a16:creationId xmlns:a16="http://schemas.microsoft.com/office/drawing/2014/main" id="{A46F59DE-F0BD-469B-9BB3-91D97D641B92}"/>
+                <a16:creationId xmlns:a16="http://schemas.microsoft.com/office/drawing/2014/main" id="{1CA97F40-E346-4BDC-9132-7BEED9E2D73A}"/>
               </a:ext>
             </a:extLst>
           </p:cNvPr>
@@ -10802,7 +10873,7 @@
           <p:cNvPr id="11" name="">
             <a:extLst xmlns:a="http://schemas.openxmlformats.org/drawingml/2006/main">
               <a:ext uri="{FF2B5EF4-FFF2-40B4-BE49-F238E27FC236}">
-                <a16:creationId xmlns:a16="http://schemas.microsoft.com/office/drawing/2014/main" id="{9E7AF292-1641-4CC4-A216-4273FF19CC5B}"/>
+                <a16:creationId xmlns:a16="http://schemas.microsoft.com/office/drawing/2014/main" id="{F58C2A2F-813A-4942-8559-A14A91E62C96}"/>
               </a:ext>
             </a:extLst>
           </p:cNvPr>
@@ -10859,7 +10930,7 @@
                 <a:ea typeface="Aptos"/>
                 <a:cs typeface="Aptos"/>
               </a:rPr>
-              <a:t>23–27 OCT</a:t>
+              <a:t>Connected plugin</a:t>
             </a:r>
           </a:p>
         </p:txBody>
@@ -10869,7 +10940,7 @@
           <p:cNvPr id="12" name="">
             <a:extLst xmlns:a="http://schemas.openxmlformats.org/drawingml/2006/main">
               <a:ext uri="{FF2B5EF4-FFF2-40B4-BE49-F238E27FC236}">
-                <a16:creationId xmlns:a16="http://schemas.microsoft.com/office/drawing/2014/main" id="{AC29E812-4497-418E-B5BF-2A15D81656E4}"/>
+                <a16:creationId xmlns:a16="http://schemas.microsoft.com/office/drawing/2014/main" id="{43C2D438-195B-4E88-8B61-DA5CEDCB5C21}"/>
               </a:ext>
             </a:extLst>
           </p:cNvPr>
@@ -10926,7 +10997,7 @@
                 <a:ea typeface="Aptos"/>
                 <a:cs typeface="Aptos"/>
               </a:rPr>
-              <a:t>Automatic meetings</a:t>
+              <a:t>PR 4 merged: 85 tests</a:t>
             </a:r>
           </a:p>
           <a:p xmlns:a="http://schemas.openxmlformats.org/drawingml/2006/main">
@@ -10949,7 +11020,7 @@
                 <a:ea typeface="Aptos"/>
                 <a:cs typeface="Aptos"/>
               </a:rPr>
-              <a:t>Grant packet vote and Y2</a:t>
+              <a:t>Durable retry and backfill</a:t>
             </a:r>
           </a:p>
           <a:p xmlns:a="http://schemas.openxmlformats.org/drawingml/2006/main">
@@ -10972,7 +11043,7 @@
                 <a:ea typeface="Aptos"/>
                 <a:cs typeface="Aptos"/>
               </a:rPr>
-              <a:t>Member eager contribution</a:t>
+              <a:t>Company-scoped health</a:t>
             </a:r>
           </a:p>
           <a:p xmlns:a="http://schemas.openxmlformats.org/drawingml/2006/main">
@@ -10995,7 +11066,7 @@
                 <a:ea typeface="Aptos"/>
                 <a:cs typeface="Aptos"/>
               </a:rPr>
-              <a:t>Shared Buzz/dashboard state</a:t>
+              <a:t>Addressed-card privacy</a:t>
             </a:r>
           </a:p>
         </p:txBody>
@@ -11005,7 +11076,7 @@
           <p:cNvPr id="13" name="">
             <a:extLst xmlns:a="http://schemas.openxmlformats.org/drawingml/2006/main">
               <a:ext uri="{FF2B5EF4-FFF2-40B4-BE49-F238E27FC236}">
-                <a16:creationId xmlns:a16="http://schemas.microsoft.com/office/drawing/2014/main" id="{25D9261A-17B1-471E-8F79-95CE17810A02}"/>
+                <a16:creationId xmlns:a16="http://schemas.microsoft.com/office/drawing/2014/main" id="{0A9E9C16-C0B5-4EA7-93EB-B9B634082DAB}"/>
               </a:ext>
             </a:extLst>
           </p:cNvPr>
@@ -11038,7 +11109,7 @@
           <p:cNvPr id="14" name="">
             <a:extLst xmlns:a="http://schemas.openxmlformats.org/drawingml/2006/main">
               <a:ext uri="{FF2B5EF4-FFF2-40B4-BE49-F238E27FC236}">
-                <a16:creationId xmlns:a16="http://schemas.microsoft.com/office/drawing/2014/main" id="{F6C29B88-2A05-47D0-8A24-044EBFB49D14}"/>
+                <a16:creationId xmlns:a16="http://schemas.microsoft.com/office/drawing/2014/main" id="{5FACB03B-8C2C-4AE9-829F-FBBD7F80DDC9}"/>
               </a:ext>
             </a:extLst>
           </p:cNvPr>
@@ -11095,7 +11166,7 @@
                 <a:ea typeface="Aptos"/>
                 <a:cs typeface="Aptos"/>
               </a:rPr>
-              <a:t>28–30 OCT</a:t>
+              <a:t>Next product slices</a:t>
             </a:r>
           </a:p>
         </p:txBody>
@@ -11105,7 +11176,7 @@
           <p:cNvPr id="15" name="">
             <a:extLst xmlns:a="http://schemas.openxmlformats.org/drawingml/2006/main">
               <a:ext uri="{FF2B5EF4-FFF2-40B4-BE49-F238E27FC236}">
-                <a16:creationId xmlns:a16="http://schemas.microsoft.com/office/drawing/2014/main" id="{F4E16340-2053-4EEE-9B2D-4BB03B90797A}"/>
+                <a16:creationId xmlns:a16="http://schemas.microsoft.com/office/drawing/2014/main" id="{B07EEB5C-4180-4597-AA18-E563072A6866}"/>
               </a:ext>
             </a:extLst>
           </p:cNvPr>
@@ -11162,7 +11233,7 @@
                 <a:ea typeface="Aptos"/>
                 <a:cs typeface="Aptos"/>
               </a:rPr>
-              <a:t>Adversarial and recovery tests</a:t>
+              <a:t>PR 5: 23 Roundtable tests</a:t>
             </a:r>
           </a:p>
           <a:p xmlns:a="http://schemas.openxmlformats.org/drawingml/2006/main">
@@ -11185,7 +11256,7 @@
                 <a:ea typeface="Aptos"/>
                 <a:cs typeface="Aptos"/>
               </a:rPr>
-              <a:t>Three-flow rehearsal by Oct 29</a:t>
+              <a:t>108 combined tests passing</a:t>
             </a:r>
           </a:p>
           <a:p xmlns:a="http://schemas.openxmlformats.org/drawingml/2006/main">
@@ -11208,7 +11279,7 @@
                 <a:ea typeface="Aptos"/>
                 <a:cs typeface="Aptos"/>
               </a:rPr>
-              <a:t>Synchronized docs and deck</a:t>
+              <a:t>Website publisher still pending</a:t>
             </a:r>
           </a:p>
           <a:p xmlns:a="http://schemas.openxmlformats.org/drawingml/2006/main">
@@ -11231,7 +11302,7 @@
                 <a:ea typeface="Aptos"/>
                 <a:cs typeface="Aptos"/>
               </a:rPr>
-              <a:t>Submission window Oct 30</a:t>
+              <a:t>Grant and member adapters next</a:t>
             </a:r>
           </a:p>
         </p:txBody>
@@ -11241,7 +11312,7 @@
           <p:cNvPr id="16" name="">
             <a:extLst xmlns:a="http://schemas.openxmlformats.org/drawingml/2006/main">
               <a:ext uri="{FF2B5EF4-FFF2-40B4-BE49-F238E27FC236}">
-                <a16:creationId xmlns:a16="http://schemas.microsoft.com/office/drawing/2014/main" id="{8DAEE01F-AC1D-46AE-8041-F73A1BEEF8BA}"/>
+                <a16:creationId xmlns:a16="http://schemas.microsoft.com/office/drawing/2014/main" id="{863246D1-918B-4CE3-859E-EE9ADEC03E3C}"/>
               </a:ext>
             </a:extLst>
           </p:cNvPr>
@@ -11298,7 +11369,7 @@
                 <a:ea typeface="Aptos"/>
                 <a:cs typeface="Aptos"/>
               </a:rPr>
-              <a:t>Configuration questions live in decisions.md. PlanetScale stays; Cloudflare is available; Helix is de-prioritized.</a:t>
+              <a:t>Fixture evidence uses real bridge code with substituted external I/O. Deployment and live rehearsal are still ahead.</a:t>
             </a:r>
           </a:p>
         </p:txBody>
@@ -11306,7 +11377,1177 @@
     </p:spTree>
     <p:extLst>
       <p:ext uri="{BB962C8B-B14F-4D97-AF65-F5344CB8AC3E}">
-        <p14:creationId xmlns:p14="http://schemas.microsoft.com/office/powerpoint/2010/main" val="1562188321"/>
+        <p14:creationId xmlns:p14="http://schemas.microsoft.com/office/powerpoint/2010/main" val="1719125137"/>
+      </p:ext>
+    </p:extLst>
+  </p:cSld>
+</p:sld>
+</file>
+
+<file path=ppt/slides/slide8.xml><?xml version="1.0" encoding="utf-8"?>
+<p:sld xmlns:p="http://schemas.openxmlformats.org/presentationml/2006/main">
+  <p:cSld>
+    <p:bg>
+      <p:bgPr>
+        <a:solidFill xmlns:a="http://schemas.openxmlformats.org/drawingml/2006/main">
+          <a:srgbClr val="F6F5F0"/>
+        </a:solidFill>
+      </p:bgPr>
+    </p:bg>
+    <p:spTree>
+      <p:nvGrpSpPr>
+        <p:cNvPr id="1" name=""/>
+        <p:cNvGrpSpPr/>
+        <p:nvPr/>
+      </p:nvGrpSpPr>
+      <p:grpSpPr>
+        <a:xfrm xmlns:a="http://schemas.openxmlformats.org/drawingml/2006/main"/>
+      </p:grpSpPr>
+      <p:sp>
+        <p:nvSpPr>
+          <p:cNvPr id="17" name="">
+            <a:extLst xmlns:a="http://schemas.openxmlformats.org/drawingml/2006/main">
+              <a:ext uri="{FF2B5EF4-FFF2-40B4-BE49-F238E27FC236}">
+                <a16:creationId xmlns:a16="http://schemas.microsoft.com/office/drawing/2014/main" id="{A7F36360-C342-4961-B6BB-833D725C142D}"/>
+              </a:ext>
+            </a:extLst>
+          </p:cNvPr>
+          <p:cNvSpPr>
+            <a:spLocks xmlns:a="http://schemas.openxmlformats.org/drawingml/2006/main" noGrp="1"/>
+          </p:cNvSpPr>
+          <p:nvPr/>
+        </p:nvSpPr>
+        <p:spPr>
+          <a:xfrm xmlns:a="http://schemas.openxmlformats.org/drawingml/2006/main">
+            <a:off x="571500" y="295275"/>
+            <a:ext cx="9525000" cy="238125"/>
+          </a:xfrm>
+          <a:prstGeom xmlns:a="http://schemas.openxmlformats.org/drawingml/2006/main" prst="rect">
+            <a:avLst/>
+          </a:prstGeom>
+          <a:noFill xmlns:a="http://schemas.openxmlformats.org/drawingml/2006/main"/>
+          <a:ln xmlns:a="http://schemas.openxmlformats.org/drawingml/2006/main" w="0">
+            <a:noFill/>
+            <a:prstDash val="solid"/>
+          </a:ln>
+        </p:spPr>
+        <p:txBody>
+          <a:bodyPr xmlns:a="http://schemas.openxmlformats.org/drawingml/2006/main" lIns="0" tIns="0" rIns="0" bIns="0" anchor="t"/>
+          <a:lstStyle xmlns:a="http://schemas.openxmlformats.org/drawingml/2006/main">
+            <a:defPPr>
+              <a:defRPr sz="1350" b="1">
+                <a:solidFill>
+                  <a:srgbClr val="157D80"/>
+                </a:solidFill>
+                <a:latin typeface="Aptos"/>
+                <a:ea typeface="Aptos"/>
+                <a:cs typeface="Aptos"/>
+              </a:defRPr>
+            </a:defPPr>
+          </a:lstStyle>
+          <a:p xmlns:a="http://schemas.openxmlformats.org/drawingml/2006/main">
+            <a:pPr>
+              <a:defRPr sz="1350" b="1">
+                <a:solidFill>
+                  <a:srgbClr val="157D80"/>
+                </a:solidFill>
+                <a:latin typeface="Aptos"/>
+                <a:ea typeface="Aptos"/>
+                <a:cs typeface="Aptos"/>
+              </a:defRPr>
+            </a:pPr>
+            <a:r>
+              <a:rPr sz="1350" b="1">
+                <a:solidFill>
+                  <a:srgbClr val="157D80"/>
+                </a:solidFill>
+                <a:latin typeface="Aptos"/>
+                <a:ea typeface="Aptos"/>
+                <a:cs typeface="Aptos"/>
+              </a:rPr>
+              <a:t>INERTIA / FORT WORTH DAO</a:t>
+            </a:r>
+          </a:p>
+        </p:txBody>
+      </p:sp>
+      <p:sp>
+        <p:nvSpPr>
+          <p:cNvPr id="2" name="">
+            <a:extLst xmlns:a="http://schemas.openxmlformats.org/drawingml/2006/main">
+              <a:ext uri="{FF2B5EF4-FFF2-40B4-BE49-F238E27FC236}">
+                <a16:creationId xmlns:a16="http://schemas.microsoft.com/office/drawing/2014/main" id="{7800FAFB-FC91-4239-9015-A95D85B1BF6F}"/>
+              </a:ext>
+            </a:extLst>
+          </p:cNvPr>
+          <p:cNvSpPr>
+            <a:spLocks xmlns:a="http://schemas.openxmlformats.org/drawingml/2006/main" noGrp="1"/>
+          </p:cNvSpPr>
+          <p:nvPr/>
+        </p:nvSpPr>
+        <p:spPr>
+          <a:xfrm xmlns:a="http://schemas.openxmlformats.org/drawingml/2006/main">
+            <a:off x="571500" y="723900"/>
+            <a:ext cx="14097000" cy="619125"/>
+          </a:xfrm>
+          <a:prstGeom xmlns:a="http://schemas.openxmlformats.org/drawingml/2006/main" prst="rect">
+            <a:avLst/>
+          </a:prstGeom>
+          <a:noFill xmlns:a="http://schemas.openxmlformats.org/drawingml/2006/main"/>
+          <a:ln xmlns:a="http://schemas.openxmlformats.org/drawingml/2006/main" w="0">
+            <a:noFill/>
+            <a:prstDash val="solid"/>
+          </a:ln>
+        </p:spPr>
+        <p:txBody>
+          <a:bodyPr xmlns:a="http://schemas.openxmlformats.org/drawingml/2006/main" lIns="0" tIns="0" rIns="0" bIns="0" anchor="t"/>
+          <a:lstStyle xmlns:a="http://schemas.openxmlformats.org/drawingml/2006/main">
+            <a:defPPr>
+              <a:defRPr sz="3450" b="1">
+                <a:solidFill>
+                  <a:srgbClr val="132E38"/>
+                </a:solidFill>
+                <a:latin typeface="Aptos"/>
+                <a:ea typeface="Aptos"/>
+                <a:cs typeface="Aptos"/>
+              </a:defRPr>
+            </a:defPPr>
+          </a:lstStyle>
+          <a:p xmlns:a="http://schemas.openxmlformats.org/drawingml/2006/main">
+            <a:pPr>
+              <a:defRPr sz="3450" b="1">
+                <a:solidFill>
+                  <a:srgbClr val="132E38"/>
+                </a:solidFill>
+                <a:latin typeface="Aptos"/>
+                <a:ea typeface="Aptos"/>
+                <a:cs typeface="Aptos"/>
+              </a:defRPr>
+            </a:pPr>
+            <a:r>
+              <a:rPr sz="3450" b="1">
+                <a:solidFill>
+                  <a:srgbClr val="132E38"/>
+                </a:solidFill>
+                <a:latin typeface="Aptos"/>
+                <a:ea typeface="Aptos"/>
+                <a:cs typeface="Aptos"/>
+              </a:rPr>
+              <a:t>Delivery focused on working outcomes</a:t>
+            </a:r>
+          </a:p>
+        </p:txBody>
+      </p:sp>
+      <p:sp>
+        <p:nvSpPr>
+          <p:cNvPr id="3" name="">
+            <a:extLst xmlns:a="http://schemas.openxmlformats.org/drawingml/2006/main">
+              <a:ext uri="{FF2B5EF4-FFF2-40B4-BE49-F238E27FC236}">
+                <a16:creationId xmlns:a16="http://schemas.microsoft.com/office/drawing/2014/main" id="{18FBB0F3-049A-4480-90E3-C75A3E6300F2}"/>
+              </a:ext>
+            </a:extLst>
+          </p:cNvPr>
+          <p:cNvSpPr>
+            <a:spLocks xmlns:a="http://schemas.openxmlformats.org/drawingml/2006/main" noGrp="1"/>
+          </p:cNvSpPr>
+          <p:nvPr/>
+        </p:nvSpPr>
+        <p:spPr>
+          <a:xfrm xmlns:a="http://schemas.openxmlformats.org/drawingml/2006/main">
+            <a:off x="571500" y="1362075"/>
+            <a:ext cx="14097000" cy="523875"/>
+          </a:xfrm>
+          <a:prstGeom xmlns:a="http://schemas.openxmlformats.org/drawingml/2006/main" prst="rect">
+            <a:avLst/>
+          </a:prstGeom>
+          <a:noFill xmlns:a="http://schemas.openxmlformats.org/drawingml/2006/main"/>
+          <a:ln xmlns:a="http://schemas.openxmlformats.org/drawingml/2006/main" w="0">
+            <a:noFill/>
+            <a:prstDash val="solid"/>
+          </a:ln>
+        </p:spPr>
+        <p:txBody>
+          <a:bodyPr xmlns:a="http://schemas.openxmlformats.org/drawingml/2006/main" lIns="0" tIns="0" rIns="0" bIns="0" anchor="t"/>
+          <a:lstStyle xmlns:a="http://schemas.openxmlformats.org/drawingml/2006/main">
+            <a:defPPr>
+              <a:defRPr sz="1800" b="0">
+                <a:solidFill>
+                  <a:srgbClr val="49616A"/>
+                </a:solidFill>
+                <a:latin typeface="Aptos"/>
+                <a:ea typeface="Aptos"/>
+                <a:cs typeface="Aptos"/>
+              </a:defRPr>
+            </a:defPPr>
+          </a:lstStyle>
+          <a:p xmlns:a="http://schemas.openxmlformats.org/drawingml/2006/main">
+            <a:pPr>
+              <a:defRPr sz="1800" b="0">
+                <a:solidFill>
+                  <a:srgbClr val="49616A"/>
+                </a:solidFill>
+                <a:latin typeface="Aptos"/>
+                <a:ea typeface="Aptos"/>
+                <a:cs typeface="Aptos"/>
+              </a:defRPr>
+            </a:pPr>
+            <a:r>
+              <a:rPr sz="1800" b="0">
+                <a:solidFill>
+                  <a:srgbClr val="49616A"/>
+                </a:solidFill>
+                <a:latin typeface="Aptos"/>
+                <a:ea typeface="Aptos"/>
+                <a:cs typeface="Aptos"/>
+              </a:rPr>
+              <a:t>Proposed delivery sequence. Tested and reviewed feature branches merge into develop.</a:t>
+            </a:r>
+          </a:p>
+        </p:txBody>
+      </p:sp>
+      <p:sp>
+        <p:nvSpPr>
+          <p:cNvPr id="4" name="">
+            <a:extLst xmlns:a="http://schemas.openxmlformats.org/drawingml/2006/main">
+              <a:ext uri="{FF2B5EF4-FFF2-40B4-BE49-F238E27FC236}">
+                <a16:creationId xmlns:a16="http://schemas.microsoft.com/office/drawing/2014/main" id="{2EC8A4F3-0E50-44E9-9A25-06979A479A58}"/>
+              </a:ext>
+            </a:extLst>
+          </p:cNvPr>
+          <p:cNvSpPr>
+            <a:spLocks xmlns:a="http://schemas.openxmlformats.org/drawingml/2006/main" noGrp="1"/>
+          </p:cNvSpPr>
+          <p:nvPr/>
+        </p:nvSpPr>
+        <p:spPr>
+          <a:xfrm xmlns:a="http://schemas.openxmlformats.org/drawingml/2006/main">
+            <a:off x="571500" y="7962900"/>
+            <a:ext cx="14097000" cy="9525"/>
+          </a:xfrm>
+          <a:prstGeom xmlns:a="http://schemas.openxmlformats.org/drawingml/2006/main" prst="rect">
+            <a:avLst/>
+          </a:prstGeom>
+          <a:solidFill xmlns:a="http://schemas.openxmlformats.org/drawingml/2006/main">
+            <a:srgbClr val="B9C9C7"/>
+          </a:solidFill>
+          <a:ln xmlns:a="http://schemas.openxmlformats.org/drawingml/2006/main" w="0">
+            <a:noFill/>
+            <a:prstDash val="solid"/>
+          </a:ln>
+        </p:spPr>
+      </p:sp>
+      <p:sp>
+        <p:nvSpPr>
+          <p:cNvPr id="5" name="">
+            <a:extLst xmlns:a="http://schemas.openxmlformats.org/drawingml/2006/main">
+              <a:ext uri="{FF2B5EF4-FFF2-40B4-BE49-F238E27FC236}">
+                <a16:creationId xmlns:a16="http://schemas.microsoft.com/office/drawing/2014/main" id="{7681E94F-2EB8-4076-AFB3-0324B76F029C}"/>
+              </a:ext>
+            </a:extLst>
+          </p:cNvPr>
+          <p:cNvSpPr>
+            <a:spLocks xmlns:a="http://schemas.openxmlformats.org/drawingml/2006/main" noGrp="1"/>
+          </p:cNvSpPr>
+          <p:nvPr/>
+        </p:nvSpPr>
+        <p:spPr>
+          <a:xfrm xmlns:a="http://schemas.openxmlformats.org/drawingml/2006/main">
+            <a:off x="571500" y="8105775"/>
+            <a:ext cx="13144500" cy="238125"/>
+          </a:xfrm>
+          <a:prstGeom xmlns:a="http://schemas.openxmlformats.org/drawingml/2006/main" prst="rect">
+            <a:avLst/>
+          </a:prstGeom>
+          <a:noFill xmlns:a="http://schemas.openxmlformats.org/drawingml/2006/main"/>
+          <a:ln xmlns:a="http://schemas.openxmlformats.org/drawingml/2006/main" w="0">
+            <a:noFill/>
+            <a:prstDash val="solid"/>
+          </a:ln>
+        </p:spPr>
+        <p:txBody>
+          <a:bodyPr xmlns:a="http://schemas.openxmlformats.org/drawingml/2006/main" lIns="0" tIns="0" rIns="0" bIns="0" anchor="t"/>
+          <a:lstStyle xmlns:a="http://schemas.openxmlformats.org/drawingml/2006/main">
+            <a:defPPr>
+              <a:defRPr sz="1275" b="0">
+                <a:solidFill>
+                  <a:srgbClr val="49616A"/>
+                </a:solidFill>
+                <a:latin typeface="Aptos"/>
+                <a:ea typeface="Aptos"/>
+                <a:cs typeface="Aptos"/>
+              </a:defRPr>
+            </a:defPPr>
+          </a:lstStyle>
+          <a:p xmlns:a="http://schemas.openxmlformats.org/drawingml/2006/main">
+            <a:pPr>
+              <a:defRPr sz="1275" b="0">
+                <a:solidFill>
+                  <a:srgbClr val="49616A"/>
+                </a:solidFill>
+                <a:latin typeface="Aptos"/>
+                <a:ea typeface="Aptos"/>
+                <a:cs typeface="Aptos"/>
+              </a:defRPr>
+            </a:pPr>
+            <a:r>
+              <a:rPr sz="1275" b="0">
+                <a:solidFill>
+                  <a:srgbClr val="49616A"/>
+                </a:solidFill>
+                <a:latin typeface="Aptos"/>
+                <a:ea typeface="Aptos"/>
+                <a:cs typeface="Aptos"/>
+              </a:rPr>
+              <a:t>INERTIA-2026-10-22-r6 · 22 October 2026 · Autonomous build</a:t>
+            </a:r>
+          </a:p>
+        </p:txBody>
+      </p:sp>
+      <p:sp>
+        <p:nvSpPr>
+          <p:cNvPr id="6" name="">
+            <a:extLst xmlns:a="http://schemas.openxmlformats.org/drawingml/2006/main">
+              <a:ext uri="{FF2B5EF4-FFF2-40B4-BE49-F238E27FC236}">
+                <a16:creationId xmlns:a16="http://schemas.microsoft.com/office/drawing/2014/main" id="{0F34DE2E-A6A4-446E-AC81-0F455F233699}"/>
+              </a:ext>
+            </a:extLst>
+          </p:cNvPr>
+          <p:cNvSpPr>
+            <a:spLocks xmlns:a="http://schemas.openxmlformats.org/drawingml/2006/main" noGrp="1"/>
+          </p:cNvSpPr>
+          <p:nvPr/>
+        </p:nvSpPr>
+        <p:spPr>
+          <a:xfrm xmlns:a="http://schemas.openxmlformats.org/drawingml/2006/main">
+            <a:off x="14001750" y="8067675"/>
+            <a:ext cx="666750" cy="304800"/>
+          </a:xfrm>
+          <a:prstGeom xmlns:a="http://schemas.openxmlformats.org/drawingml/2006/main" prst="rect">
+            <a:avLst/>
+          </a:prstGeom>
+          <a:noFill xmlns:a="http://schemas.openxmlformats.org/drawingml/2006/main"/>
+          <a:ln xmlns:a="http://schemas.openxmlformats.org/drawingml/2006/main" w="0">
+            <a:noFill/>
+            <a:prstDash val="solid"/>
+          </a:ln>
+        </p:spPr>
+        <p:txBody>
+          <a:bodyPr xmlns:a="http://schemas.openxmlformats.org/drawingml/2006/main" lIns="0" tIns="0" rIns="0" bIns="0" anchor="t"/>
+          <a:lstStyle xmlns:a="http://schemas.openxmlformats.org/drawingml/2006/main">
+            <a:defPPr>
+              <a:defRPr sz="1800" b="1">
+                <a:solidFill>
+                  <a:srgbClr val="157D80"/>
+                </a:solidFill>
+                <a:latin typeface="Aptos"/>
+                <a:ea typeface="Aptos"/>
+                <a:cs typeface="Aptos"/>
+              </a:defRPr>
+            </a:defPPr>
+          </a:lstStyle>
+          <a:p xmlns:a="http://schemas.openxmlformats.org/drawingml/2006/main">
+            <a:pPr>
+              <a:defRPr sz="1800" b="1">
+                <a:solidFill>
+                  <a:srgbClr val="157D80"/>
+                </a:solidFill>
+                <a:latin typeface="Aptos"/>
+                <a:ea typeface="Aptos"/>
+                <a:cs typeface="Aptos"/>
+              </a:defRPr>
+            </a:pPr>
+            <a:r>
+              <a:rPr sz="1800" b="1">
+                <a:solidFill>
+                  <a:srgbClr val="157D80"/>
+                </a:solidFill>
+                <a:latin typeface="Aptos"/>
+                <a:ea typeface="Aptos"/>
+                <a:cs typeface="Aptos"/>
+              </a:rPr>
+              <a:t>08</a:t>
+            </a:r>
+          </a:p>
+        </p:txBody>
+      </p:sp>
+      <p:sp>
+        <p:nvSpPr>
+          <p:cNvPr id="7" name="">
+            <a:extLst xmlns:a="http://schemas.openxmlformats.org/drawingml/2006/main">
+              <a:ext uri="{FF2B5EF4-FFF2-40B4-BE49-F238E27FC236}">
+                <a16:creationId xmlns:a16="http://schemas.microsoft.com/office/drawing/2014/main" id="{49BE7E97-517E-42DB-9A82-F072C4130C03}"/>
+              </a:ext>
+            </a:extLst>
+          </p:cNvPr>
+          <p:cNvSpPr>
+            <a:spLocks xmlns:a="http://schemas.openxmlformats.org/drawingml/2006/main" noGrp="1"/>
+          </p:cNvSpPr>
+          <p:nvPr/>
+        </p:nvSpPr>
+        <p:spPr>
+          <a:xfrm xmlns:a="http://schemas.openxmlformats.org/drawingml/2006/main">
+            <a:off x="571500" y="2381250"/>
+            <a:ext cx="4476750" cy="3619500"/>
+          </a:xfrm>
+          <a:prstGeom xmlns:a="http://schemas.openxmlformats.org/drawingml/2006/main" prst="rect">
+            <a:avLst/>
+          </a:prstGeom>
+          <a:solidFill xmlns:a="http://schemas.openxmlformats.org/drawingml/2006/main">
+            <a:srgbClr val="FFFFFF"/>
+          </a:solidFill>
+          <a:ln xmlns:a="http://schemas.openxmlformats.org/drawingml/2006/main" w="19050">
+            <a:solidFill>
+              <a:srgbClr val="157D80"/>
+            </a:solidFill>
+            <a:prstDash val="dash"/>
+          </a:ln>
+        </p:spPr>
+      </p:sp>
+      <p:sp>
+        <p:nvSpPr>
+          <p:cNvPr id="8" name="">
+            <a:extLst xmlns:a="http://schemas.openxmlformats.org/drawingml/2006/main">
+              <a:ext uri="{FF2B5EF4-FFF2-40B4-BE49-F238E27FC236}">
+                <a16:creationId xmlns:a16="http://schemas.microsoft.com/office/drawing/2014/main" id="{36E7074E-E5B4-4F3A-AEE7-CD3E3BCF96C5}"/>
+              </a:ext>
+            </a:extLst>
+          </p:cNvPr>
+          <p:cNvSpPr>
+            <a:spLocks xmlns:a="http://schemas.openxmlformats.org/drawingml/2006/main" noGrp="1"/>
+          </p:cNvSpPr>
+          <p:nvPr/>
+        </p:nvSpPr>
+        <p:spPr>
+          <a:xfrm xmlns:a="http://schemas.openxmlformats.org/drawingml/2006/main">
+            <a:off x="742950" y="2514600"/>
+            <a:ext cx="4133850" cy="552450"/>
+          </a:xfrm>
+          <a:prstGeom xmlns:a="http://schemas.openxmlformats.org/drawingml/2006/main" prst="rect">
+            <a:avLst/>
+          </a:prstGeom>
+          <a:noFill xmlns:a="http://schemas.openxmlformats.org/drawingml/2006/main"/>
+          <a:ln xmlns:a="http://schemas.openxmlformats.org/drawingml/2006/main" w="0">
+            <a:noFill/>
+            <a:prstDash val="solid"/>
+          </a:ln>
+        </p:spPr>
+        <p:txBody>
+          <a:bodyPr xmlns:a="http://schemas.openxmlformats.org/drawingml/2006/main" lIns="0" tIns="0" rIns="0" bIns="0" anchor="t"/>
+          <a:lstStyle xmlns:a="http://schemas.openxmlformats.org/drawingml/2006/main">
+            <a:defPPr>
+              <a:defRPr sz="1875" b="1">
+                <a:solidFill>
+                  <a:srgbClr val="157D80"/>
+                </a:solidFill>
+                <a:latin typeface="Aptos"/>
+                <a:ea typeface="Aptos"/>
+                <a:cs typeface="Aptos"/>
+              </a:defRPr>
+            </a:defPPr>
+          </a:lstStyle>
+          <a:p xmlns:a="http://schemas.openxmlformats.org/drawingml/2006/main">
+            <a:pPr>
+              <a:defRPr sz="1875" b="1">
+                <a:solidFill>
+                  <a:srgbClr val="157D80"/>
+                </a:solidFill>
+                <a:latin typeface="Aptos"/>
+                <a:ea typeface="Aptos"/>
+                <a:cs typeface="Aptos"/>
+              </a:defRPr>
+            </a:pPr>
+            <a:r>
+              <a:rPr sz="1875" b="1">
+                <a:solidFill>
+                  <a:srgbClr val="157D80"/>
+                </a:solidFill>
+                <a:latin typeface="Aptos"/>
+                <a:ea typeface="Aptos"/>
+                <a:cs typeface="Aptos"/>
+              </a:rPr>
+              <a:t>22–23 OCT</a:t>
+            </a:r>
+          </a:p>
+        </p:txBody>
+      </p:sp>
+      <p:sp>
+        <p:nvSpPr>
+          <p:cNvPr id="9" name="">
+            <a:extLst xmlns:a="http://schemas.openxmlformats.org/drawingml/2006/main">
+              <a:ext uri="{FF2B5EF4-FFF2-40B4-BE49-F238E27FC236}">
+                <a16:creationId xmlns:a16="http://schemas.microsoft.com/office/drawing/2014/main" id="{41EE5B33-E5A6-491B-AED2-645B84F2620F}"/>
+              </a:ext>
+            </a:extLst>
+          </p:cNvPr>
+          <p:cNvSpPr>
+            <a:spLocks xmlns:a="http://schemas.openxmlformats.org/drawingml/2006/main" noGrp="1"/>
+          </p:cNvSpPr>
+          <p:nvPr/>
+        </p:nvSpPr>
+        <p:spPr>
+          <a:xfrm xmlns:a="http://schemas.openxmlformats.org/drawingml/2006/main">
+            <a:off x="742950" y="3048000"/>
+            <a:ext cx="4133850" cy="2876550"/>
+          </a:xfrm>
+          <a:prstGeom xmlns:a="http://schemas.openxmlformats.org/drawingml/2006/main" prst="rect">
+            <a:avLst/>
+          </a:prstGeom>
+          <a:noFill xmlns:a="http://schemas.openxmlformats.org/drawingml/2006/main"/>
+          <a:ln xmlns:a="http://schemas.openxmlformats.org/drawingml/2006/main" w="0">
+            <a:noFill/>
+            <a:prstDash val="solid"/>
+          </a:ln>
+        </p:spPr>
+        <p:txBody>
+          <a:bodyPr xmlns:a="http://schemas.openxmlformats.org/drawingml/2006/main" lIns="0" tIns="0" rIns="0" bIns="0" anchor="t"/>
+          <a:lstStyle xmlns:a="http://schemas.openxmlformats.org/drawingml/2006/main">
+            <a:defPPr>
+              <a:defRPr sz="2250" b="0">
+                <a:solidFill>
+                  <a:srgbClr val="49616A"/>
+                </a:solidFill>
+                <a:latin typeface="Aptos"/>
+                <a:ea typeface="Aptos"/>
+                <a:cs typeface="Aptos"/>
+              </a:defRPr>
+            </a:defPPr>
+          </a:lstStyle>
+          <a:p xmlns:a="http://schemas.openxmlformats.org/drawingml/2006/main">
+            <a:pPr>
+              <a:defRPr sz="2250" b="0">
+                <a:solidFill>
+                  <a:srgbClr val="49616A"/>
+                </a:solidFill>
+                <a:latin typeface="Aptos"/>
+                <a:ea typeface="Aptos"/>
+                <a:cs typeface="Aptos"/>
+              </a:defRPr>
+            </a:pPr>
+            <a:r>
+              <a:rPr sz="2250" b="0">
+                <a:solidFill>
+                  <a:srgbClr val="49616A"/>
+                </a:solidFill>
+                <a:latin typeface="Aptos"/>
+                <a:ea typeface="Aptos"/>
+                <a:cs typeface="Aptos"/>
+              </a:rPr>
+              <a:t>Bridge and core merged</a:t>
+            </a:r>
+          </a:p>
+          <a:p xmlns:a="http://schemas.openxmlformats.org/drawingml/2006/main">
+            <a:pPr>
+              <a:defRPr sz="2250" b="0">
+                <a:solidFill>
+                  <a:srgbClr val="49616A"/>
+                </a:solidFill>
+                <a:latin typeface="Aptos"/>
+                <a:ea typeface="Aptos"/>
+                <a:cs typeface="Aptos"/>
+              </a:defRPr>
+            </a:pPr>
+            <a:r>
+              <a:rPr sz="2250" b="0">
+                <a:solidFill>
+                  <a:srgbClr val="49616A"/>
+                </a:solidFill>
+                <a:latin typeface="Aptos"/>
+                <a:ea typeface="Aptos"/>
+                <a:cs typeface="Aptos"/>
+              </a:rPr>
+              <a:t>Continue website publisher</a:t>
+            </a:r>
+          </a:p>
+          <a:p xmlns:a="http://schemas.openxmlformats.org/drawingml/2006/main">
+            <a:pPr>
+              <a:defRPr sz="2250" b="0">
+                <a:solidFill>
+                  <a:srgbClr val="49616A"/>
+                </a:solidFill>
+                <a:latin typeface="Aptos"/>
+                <a:ea typeface="Aptos"/>
+                <a:cs typeface="Aptos"/>
+              </a:defRPr>
+            </a:pPr>
+            <a:r>
+              <a:rPr sz="2250" b="0">
+                <a:solidFill>
+                  <a:srgbClr val="49616A"/>
+                </a:solidFill>
+                <a:latin typeface="Aptos"/>
+                <a:ea typeface="Aptos"/>
+                <a:cs typeface="Aptos"/>
+              </a:rPr>
+              <a:t>Grant slice now active</a:t>
+            </a:r>
+          </a:p>
+          <a:p xmlns:a="http://schemas.openxmlformats.org/drawingml/2006/main">
+            <a:pPr>
+              <a:defRPr sz="2250" b="0">
+                <a:solidFill>
+                  <a:srgbClr val="49616A"/>
+                </a:solidFill>
+                <a:latin typeface="Aptos"/>
+                <a:ea typeface="Aptos"/>
+                <a:cs typeface="Aptos"/>
+              </a:defRPr>
+            </a:pPr>
+            <a:r>
+              <a:rPr sz="2250" b="0">
+                <a:solidFill>
+                  <a:srgbClr val="49616A"/>
+                </a:solidFill>
+                <a:latin typeface="Aptos"/>
+                <a:ea typeface="Aptos"/>
+                <a:cs typeface="Aptos"/>
+              </a:rPr>
+              <a:t>Keep artifacts aligned</a:t>
+            </a:r>
+          </a:p>
+        </p:txBody>
+      </p:sp>
+      <p:sp>
+        <p:nvSpPr>
+          <p:cNvPr id="10" name="">
+            <a:extLst xmlns:a="http://schemas.openxmlformats.org/drawingml/2006/main">
+              <a:ext uri="{FF2B5EF4-FFF2-40B4-BE49-F238E27FC236}">
+                <a16:creationId xmlns:a16="http://schemas.microsoft.com/office/drawing/2014/main" id="{6DCF7EC8-8239-4E90-B2BD-E87B6944589B}"/>
+              </a:ext>
+            </a:extLst>
+          </p:cNvPr>
+          <p:cNvSpPr>
+            <a:spLocks xmlns:a="http://schemas.openxmlformats.org/drawingml/2006/main" noGrp="1"/>
+          </p:cNvSpPr>
+          <p:nvPr/>
+        </p:nvSpPr>
+        <p:spPr>
+          <a:xfrm xmlns:a="http://schemas.openxmlformats.org/drawingml/2006/main">
+            <a:off x="5381625" y="2381250"/>
+            <a:ext cx="4476750" cy="3619500"/>
+          </a:xfrm>
+          <a:prstGeom xmlns:a="http://schemas.openxmlformats.org/drawingml/2006/main" prst="rect">
+            <a:avLst/>
+          </a:prstGeom>
+          <a:solidFill xmlns:a="http://schemas.openxmlformats.org/drawingml/2006/main">
+            <a:srgbClr val="FFFFFF"/>
+          </a:solidFill>
+          <a:ln xmlns:a="http://schemas.openxmlformats.org/drawingml/2006/main" w="19050">
+            <a:solidFill>
+              <a:srgbClr val="157D80"/>
+            </a:solidFill>
+            <a:prstDash val="dash"/>
+          </a:ln>
+        </p:spPr>
+      </p:sp>
+      <p:sp>
+        <p:nvSpPr>
+          <p:cNvPr id="11" name="">
+            <a:extLst xmlns:a="http://schemas.openxmlformats.org/drawingml/2006/main">
+              <a:ext uri="{FF2B5EF4-FFF2-40B4-BE49-F238E27FC236}">
+                <a16:creationId xmlns:a16="http://schemas.microsoft.com/office/drawing/2014/main" id="{580FAE3F-48DD-4E6D-A5A4-04715DDE9CA1}"/>
+              </a:ext>
+            </a:extLst>
+          </p:cNvPr>
+          <p:cNvSpPr>
+            <a:spLocks xmlns:a="http://schemas.openxmlformats.org/drawingml/2006/main" noGrp="1"/>
+          </p:cNvSpPr>
+          <p:nvPr/>
+        </p:nvSpPr>
+        <p:spPr>
+          <a:xfrm xmlns:a="http://schemas.openxmlformats.org/drawingml/2006/main">
+            <a:off x="5553075" y="2514600"/>
+            <a:ext cx="4133850" cy="552450"/>
+          </a:xfrm>
+          <a:prstGeom xmlns:a="http://schemas.openxmlformats.org/drawingml/2006/main" prst="rect">
+            <a:avLst/>
+          </a:prstGeom>
+          <a:noFill xmlns:a="http://schemas.openxmlformats.org/drawingml/2006/main"/>
+          <a:ln xmlns:a="http://schemas.openxmlformats.org/drawingml/2006/main" w="0">
+            <a:noFill/>
+            <a:prstDash val="solid"/>
+          </a:ln>
+        </p:spPr>
+        <p:txBody>
+          <a:bodyPr xmlns:a="http://schemas.openxmlformats.org/drawingml/2006/main" lIns="0" tIns="0" rIns="0" bIns="0" anchor="t"/>
+          <a:lstStyle xmlns:a="http://schemas.openxmlformats.org/drawingml/2006/main">
+            <a:defPPr>
+              <a:defRPr sz="1875" b="1">
+                <a:solidFill>
+                  <a:srgbClr val="157D80"/>
+                </a:solidFill>
+                <a:latin typeface="Aptos"/>
+                <a:ea typeface="Aptos"/>
+                <a:cs typeface="Aptos"/>
+              </a:defRPr>
+            </a:defPPr>
+          </a:lstStyle>
+          <a:p xmlns:a="http://schemas.openxmlformats.org/drawingml/2006/main">
+            <a:pPr>
+              <a:defRPr sz="1875" b="1">
+                <a:solidFill>
+                  <a:srgbClr val="157D80"/>
+                </a:solidFill>
+                <a:latin typeface="Aptos"/>
+                <a:ea typeface="Aptos"/>
+                <a:cs typeface="Aptos"/>
+              </a:defRPr>
+            </a:pPr>
+            <a:r>
+              <a:rPr sz="1875" b="1">
+                <a:solidFill>
+                  <a:srgbClr val="157D80"/>
+                </a:solidFill>
+                <a:latin typeface="Aptos"/>
+                <a:ea typeface="Aptos"/>
+                <a:cs typeface="Aptos"/>
+              </a:rPr>
+              <a:t>23–27 OCT</a:t>
+            </a:r>
+          </a:p>
+        </p:txBody>
+      </p:sp>
+      <p:sp>
+        <p:nvSpPr>
+          <p:cNvPr id="12" name="">
+            <a:extLst xmlns:a="http://schemas.openxmlformats.org/drawingml/2006/main">
+              <a:ext uri="{FF2B5EF4-FFF2-40B4-BE49-F238E27FC236}">
+                <a16:creationId xmlns:a16="http://schemas.microsoft.com/office/drawing/2014/main" id="{64513E19-DC8F-4038-9D60-2C703B484CBF}"/>
+              </a:ext>
+            </a:extLst>
+          </p:cNvPr>
+          <p:cNvSpPr>
+            <a:spLocks xmlns:a="http://schemas.openxmlformats.org/drawingml/2006/main" noGrp="1"/>
+          </p:cNvSpPr>
+          <p:nvPr/>
+        </p:nvSpPr>
+        <p:spPr>
+          <a:xfrm xmlns:a="http://schemas.openxmlformats.org/drawingml/2006/main">
+            <a:off x="5553075" y="3048000"/>
+            <a:ext cx="4133850" cy="2876550"/>
+          </a:xfrm>
+          <a:prstGeom xmlns:a="http://schemas.openxmlformats.org/drawingml/2006/main" prst="rect">
+            <a:avLst/>
+          </a:prstGeom>
+          <a:noFill xmlns:a="http://schemas.openxmlformats.org/drawingml/2006/main"/>
+          <a:ln xmlns:a="http://schemas.openxmlformats.org/drawingml/2006/main" w="0">
+            <a:noFill/>
+            <a:prstDash val="solid"/>
+          </a:ln>
+        </p:spPr>
+        <p:txBody>
+          <a:bodyPr xmlns:a="http://schemas.openxmlformats.org/drawingml/2006/main" lIns="0" tIns="0" rIns="0" bIns="0" anchor="t"/>
+          <a:lstStyle xmlns:a="http://schemas.openxmlformats.org/drawingml/2006/main">
+            <a:defPPr>
+              <a:defRPr sz="2250" b="0">
+                <a:solidFill>
+                  <a:srgbClr val="49616A"/>
+                </a:solidFill>
+                <a:latin typeface="Aptos"/>
+                <a:ea typeface="Aptos"/>
+                <a:cs typeface="Aptos"/>
+              </a:defRPr>
+            </a:defPPr>
+          </a:lstStyle>
+          <a:p xmlns:a="http://schemas.openxmlformats.org/drawingml/2006/main">
+            <a:pPr>
+              <a:defRPr sz="2250" b="0">
+                <a:solidFill>
+                  <a:srgbClr val="49616A"/>
+                </a:solidFill>
+                <a:latin typeface="Aptos"/>
+                <a:ea typeface="Aptos"/>
+                <a:cs typeface="Aptos"/>
+              </a:defRPr>
+            </a:pPr>
+            <a:r>
+              <a:rPr sz="2250" b="0">
+                <a:solidFill>
+                  <a:srgbClr val="49616A"/>
+                </a:solidFill>
+                <a:latin typeface="Aptos"/>
+                <a:ea typeface="Aptos"/>
+                <a:cs typeface="Aptos"/>
+              </a:rPr>
+              <a:t>Complete domain adapters</a:t>
+            </a:r>
+          </a:p>
+          <a:p xmlns:a="http://schemas.openxmlformats.org/drawingml/2006/main">
+            <a:pPr>
+              <a:defRPr sz="2250" b="0">
+                <a:solidFill>
+                  <a:srgbClr val="49616A"/>
+                </a:solidFill>
+                <a:latin typeface="Aptos"/>
+                <a:ea typeface="Aptos"/>
+                <a:cs typeface="Aptos"/>
+              </a:defRPr>
+            </a:pPr>
+            <a:r>
+              <a:rPr sz="2250" b="0">
+                <a:solidFill>
+                  <a:srgbClr val="49616A"/>
+                </a:solidFill>
+                <a:latin typeface="Aptos"/>
+                <a:ea typeface="Aptos"/>
+                <a:cs typeface="Aptos"/>
+              </a:rPr>
+              <a:t>Integrate approved targets</a:t>
+            </a:r>
+          </a:p>
+          <a:p xmlns:a="http://schemas.openxmlformats.org/drawingml/2006/main">
+            <a:pPr>
+              <a:defRPr sz="2250" b="0">
+                <a:solidFill>
+                  <a:srgbClr val="49616A"/>
+                </a:solidFill>
+                <a:latin typeface="Aptos"/>
+                <a:ea typeface="Aptos"/>
+                <a:cs typeface="Aptos"/>
+              </a:defRPr>
+            </a:pPr>
+            <a:r>
+              <a:rPr sz="2250" b="0">
+                <a:solidFill>
+                  <a:srgbClr val="49616A"/>
+                </a:solidFill>
+                <a:latin typeface="Aptos"/>
+                <a:ea typeface="Aptos"/>
+                <a:cs typeface="Aptos"/>
+              </a:rPr>
+              <a:t>Exercise member contribution</a:t>
+            </a:r>
+          </a:p>
+          <a:p xmlns:a="http://schemas.openxmlformats.org/drawingml/2006/main">
+            <a:pPr>
+              <a:defRPr sz="2250" b="0">
+                <a:solidFill>
+                  <a:srgbClr val="49616A"/>
+                </a:solidFill>
+                <a:latin typeface="Aptos"/>
+                <a:ea typeface="Aptos"/>
+                <a:cs typeface="Aptos"/>
+              </a:defRPr>
+            </a:pPr>
+            <a:r>
+              <a:rPr sz="2250" b="0">
+                <a:solidFill>
+                  <a:srgbClr val="49616A"/>
+                </a:solidFill>
+                <a:latin typeface="Aptos"/>
+                <a:ea typeface="Aptos"/>
+                <a:cs typeface="Aptos"/>
+              </a:rPr>
+              <a:t>Verify normal automatic recovery</a:t>
+            </a:r>
+          </a:p>
+        </p:txBody>
+      </p:sp>
+      <p:sp>
+        <p:nvSpPr>
+          <p:cNvPr id="13" name="">
+            <a:extLst xmlns:a="http://schemas.openxmlformats.org/drawingml/2006/main">
+              <a:ext uri="{FF2B5EF4-FFF2-40B4-BE49-F238E27FC236}">
+                <a16:creationId xmlns:a16="http://schemas.microsoft.com/office/drawing/2014/main" id="{7D0894CB-2A24-4773-B711-3DBB03AD9814}"/>
+              </a:ext>
+            </a:extLst>
+          </p:cNvPr>
+          <p:cNvSpPr>
+            <a:spLocks xmlns:a="http://schemas.openxmlformats.org/drawingml/2006/main" noGrp="1"/>
+          </p:cNvSpPr>
+          <p:nvPr/>
+        </p:nvSpPr>
+        <p:spPr>
+          <a:xfrm xmlns:a="http://schemas.openxmlformats.org/drawingml/2006/main">
+            <a:off x="10191750" y="2381250"/>
+            <a:ext cx="4476750" cy="3619500"/>
+          </a:xfrm>
+          <a:prstGeom xmlns:a="http://schemas.openxmlformats.org/drawingml/2006/main" prst="rect">
+            <a:avLst/>
+          </a:prstGeom>
+          <a:solidFill xmlns:a="http://schemas.openxmlformats.org/drawingml/2006/main">
+            <a:srgbClr val="FFFFFF"/>
+          </a:solidFill>
+          <a:ln xmlns:a="http://schemas.openxmlformats.org/drawingml/2006/main" w="19050">
+            <a:solidFill>
+              <a:srgbClr val="157D80"/>
+            </a:solidFill>
+            <a:prstDash val="dash"/>
+          </a:ln>
+        </p:spPr>
+      </p:sp>
+      <p:sp>
+        <p:nvSpPr>
+          <p:cNvPr id="14" name="">
+            <a:extLst xmlns:a="http://schemas.openxmlformats.org/drawingml/2006/main">
+              <a:ext uri="{FF2B5EF4-FFF2-40B4-BE49-F238E27FC236}">
+                <a16:creationId xmlns:a16="http://schemas.microsoft.com/office/drawing/2014/main" id="{50D29861-A92C-43B0-87FE-E7557E1579C4}"/>
+              </a:ext>
+            </a:extLst>
+          </p:cNvPr>
+          <p:cNvSpPr>
+            <a:spLocks xmlns:a="http://schemas.openxmlformats.org/drawingml/2006/main" noGrp="1"/>
+          </p:cNvSpPr>
+          <p:nvPr/>
+        </p:nvSpPr>
+        <p:spPr>
+          <a:xfrm xmlns:a="http://schemas.openxmlformats.org/drawingml/2006/main">
+            <a:off x="10363200" y="2514600"/>
+            <a:ext cx="4133850" cy="552450"/>
+          </a:xfrm>
+          <a:prstGeom xmlns:a="http://schemas.openxmlformats.org/drawingml/2006/main" prst="rect">
+            <a:avLst/>
+          </a:prstGeom>
+          <a:noFill xmlns:a="http://schemas.openxmlformats.org/drawingml/2006/main"/>
+          <a:ln xmlns:a="http://schemas.openxmlformats.org/drawingml/2006/main" w="0">
+            <a:noFill/>
+            <a:prstDash val="solid"/>
+          </a:ln>
+        </p:spPr>
+        <p:txBody>
+          <a:bodyPr xmlns:a="http://schemas.openxmlformats.org/drawingml/2006/main" lIns="0" tIns="0" rIns="0" bIns="0" anchor="t"/>
+          <a:lstStyle xmlns:a="http://schemas.openxmlformats.org/drawingml/2006/main">
+            <a:defPPr>
+              <a:defRPr sz="1875" b="1">
+                <a:solidFill>
+                  <a:srgbClr val="157D80"/>
+                </a:solidFill>
+                <a:latin typeface="Aptos"/>
+                <a:ea typeface="Aptos"/>
+                <a:cs typeface="Aptos"/>
+              </a:defRPr>
+            </a:defPPr>
+          </a:lstStyle>
+          <a:p xmlns:a="http://schemas.openxmlformats.org/drawingml/2006/main">
+            <a:pPr>
+              <a:defRPr sz="1875" b="1">
+                <a:solidFill>
+                  <a:srgbClr val="157D80"/>
+                </a:solidFill>
+                <a:latin typeface="Aptos"/>
+                <a:ea typeface="Aptos"/>
+                <a:cs typeface="Aptos"/>
+              </a:defRPr>
+            </a:pPr>
+            <a:r>
+              <a:rPr sz="1875" b="1">
+                <a:solidFill>
+                  <a:srgbClr val="157D80"/>
+                </a:solidFill>
+                <a:latin typeface="Aptos"/>
+                <a:ea typeface="Aptos"/>
+                <a:cs typeface="Aptos"/>
+              </a:rPr>
+              <a:t>28–30 OCT</a:t>
+            </a:r>
+          </a:p>
+        </p:txBody>
+      </p:sp>
+      <p:sp>
+        <p:nvSpPr>
+          <p:cNvPr id="15" name="">
+            <a:extLst xmlns:a="http://schemas.openxmlformats.org/drawingml/2006/main">
+              <a:ext uri="{FF2B5EF4-FFF2-40B4-BE49-F238E27FC236}">
+                <a16:creationId xmlns:a16="http://schemas.microsoft.com/office/drawing/2014/main" id="{5829169D-E3DB-4D23-8915-953CE26B069D}"/>
+              </a:ext>
+            </a:extLst>
+          </p:cNvPr>
+          <p:cNvSpPr>
+            <a:spLocks xmlns:a="http://schemas.openxmlformats.org/drawingml/2006/main" noGrp="1"/>
+          </p:cNvSpPr>
+          <p:nvPr/>
+        </p:nvSpPr>
+        <p:spPr>
+          <a:xfrm xmlns:a="http://schemas.openxmlformats.org/drawingml/2006/main">
+            <a:off x="10363200" y="3048000"/>
+            <a:ext cx="4133850" cy="2876550"/>
+          </a:xfrm>
+          <a:prstGeom xmlns:a="http://schemas.openxmlformats.org/drawingml/2006/main" prst="rect">
+            <a:avLst/>
+          </a:prstGeom>
+          <a:noFill xmlns:a="http://schemas.openxmlformats.org/drawingml/2006/main"/>
+          <a:ln xmlns:a="http://schemas.openxmlformats.org/drawingml/2006/main" w="0">
+            <a:noFill/>
+            <a:prstDash val="solid"/>
+          </a:ln>
+        </p:spPr>
+        <p:txBody>
+          <a:bodyPr xmlns:a="http://schemas.openxmlformats.org/drawingml/2006/main" lIns="0" tIns="0" rIns="0" bIns="0" anchor="t"/>
+          <a:lstStyle xmlns:a="http://schemas.openxmlformats.org/drawingml/2006/main">
+            <a:defPPr>
+              <a:defRPr sz="2250" b="0">
+                <a:solidFill>
+                  <a:srgbClr val="49616A"/>
+                </a:solidFill>
+                <a:latin typeface="Aptos"/>
+                <a:ea typeface="Aptos"/>
+                <a:cs typeface="Aptos"/>
+              </a:defRPr>
+            </a:defPPr>
+          </a:lstStyle>
+          <a:p xmlns:a="http://schemas.openxmlformats.org/drawingml/2006/main">
+            <a:pPr>
+              <a:defRPr sz="2250" b="0">
+                <a:solidFill>
+                  <a:srgbClr val="49616A"/>
+                </a:solidFill>
+                <a:latin typeface="Aptos"/>
+                <a:ea typeface="Aptos"/>
+                <a:cs typeface="Aptos"/>
+              </a:defRPr>
+            </a:pPr>
+            <a:r>
+              <a:rPr sz="2250" b="0">
+                <a:solidFill>
+                  <a:srgbClr val="49616A"/>
+                </a:solidFill>
+                <a:latin typeface="Aptos"/>
+                <a:ea typeface="Aptos"/>
+                <a:cs typeface="Aptos"/>
+              </a:rPr>
+              <a:t>Recovery and isolation tests</a:t>
+            </a:r>
+          </a:p>
+          <a:p xmlns:a="http://schemas.openxmlformats.org/drawingml/2006/main">
+            <a:pPr>
+              <a:defRPr sz="2250" b="0">
+                <a:solidFill>
+                  <a:srgbClr val="49616A"/>
+                </a:solidFill>
+                <a:latin typeface="Aptos"/>
+                <a:ea typeface="Aptos"/>
+                <a:cs typeface="Aptos"/>
+              </a:defRPr>
+            </a:pPr>
+            <a:r>
+              <a:rPr sz="2250" b="0">
+                <a:solidFill>
+                  <a:srgbClr val="49616A"/>
+                </a:solidFill>
+                <a:latin typeface="Aptos"/>
+                <a:ea typeface="Aptos"/>
+                <a:cs typeface="Aptos"/>
+              </a:rPr>
+              <a:t>Proposed Oct 29 rehearsal buffer</a:t>
+            </a:r>
+          </a:p>
+          <a:p xmlns:a="http://schemas.openxmlformats.org/drawingml/2006/main">
+            <a:pPr>
+              <a:defRPr sz="2250" b="0">
+                <a:solidFill>
+                  <a:srgbClr val="49616A"/>
+                </a:solidFill>
+                <a:latin typeface="Aptos"/>
+                <a:ea typeface="Aptos"/>
+                <a:cs typeface="Aptos"/>
+              </a:defRPr>
+            </a:pPr>
+            <a:r>
+              <a:rPr sz="2250" b="0">
+                <a:solidFill>
+                  <a:srgbClr val="49616A"/>
+                </a:solidFill>
+                <a:latin typeface="Aptos"/>
+                <a:ea typeface="Aptos"/>
+                <a:cs typeface="Aptos"/>
+              </a:rPr>
+              <a:t>Deck and reproducible evidence</a:t>
+            </a:r>
+          </a:p>
+          <a:p xmlns:a="http://schemas.openxmlformats.org/drawingml/2006/main">
+            <a:pPr>
+              <a:defRPr sz="2250" b="0">
+                <a:solidFill>
+                  <a:srgbClr val="49616A"/>
+                </a:solidFill>
+                <a:latin typeface="Aptos"/>
+                <a:ea typeface="Aptos"/>
+                <a:cs typeface="Aptos"/>
+              </a:defRPr>
+            </a:pPr>
+            <a:r>
+              <a:rPr sz="2250" b="0">
+                <a:solidFill>
+                  <a:srgbClr val="49616A"/>
+                </a:solidFill>
+                <a:latin typeface="Aptos"/>
+                <a:ea typeface="Aptos"/>
+                <a:cs typeface="Aptos"/>
+              </a:rPr>
+              <a:t>Oct 30 owner submission handoff</a:t>
+            </a:r>
+          </a:p>
+        </p:txBody>
+      </p:sp>
+      <p:sp>
+        <p:nvSpPr>
+          <p:cNvPr id="16" name="">
+            <a:extLst xmlns:a="http://schemas.openxmlformats.org/drawingml/2006/main">
+              <a:ext uri="{FF2B5EF4-FFF2-40B4-BE49-F238E27FC236}">
+                <a16:creationId xmlns:a16="http://schemas.microsoft.com/office/drawing/2014/main" id="{AA8ECAB8-73DF-4DFF-8904-5D3F99F4E5F5}"/>
+              </a:ext>
+            </a:extLst>
+          </p:cNvPr>
+          <p:cNvSpPr>
+            <a:spLocks xmlns:a="http://schemas.openxmlformats.org/drawingml/2006/main" noGrp="1"/>
+          </p:cNvSpPr>
+          <p:nvPr/>
+        </p:nvSpPr>
+        <p:spPr>
+          <a:xfrm xmlns:a="http://schemas.openxmlformats.org/drawingml/2006/main">
+            <a:off x="571500" y="6572250"/>
+            <a:ext cx="14097000" cy="1000125"/>
+          </a:xfrm>
+          <a:prstGeom xmlns:a="http://schemas.openxmlformats.org/drawingml/2006/main" prst="rect">
+            <a:avLst/>
+          </a:prstGeom>
+          <a:noFill xmlns:a="http://schemas.openxmlformats.org/drawingml/2006/main"/>
+          <a:ln xmlns:a="http://schemas.openxmlformats.org/drawingml/2006/main" w="0">
+            <a:noFill/>
+            <a:prstDash val="solid"/>
+          </a:ln>
+        </p:spPr>
+        <p:txBody>
+          <a:bodyPr xmlns:a="http://schemas.openxmlformats.org/drawingml/2006/main" lIns="0" tIns="0" rIns="0" bIns="0" anchor="t"/>
+          <a:lstStyle xmlns:a="http://schemas.openxmlformats.org/drawingml/2006/main">
+            <a:defPPr>
+              <a:defRPr sz="2100" b="0">
+                <a:solidFill>
+                  <a:srgbClr val="132E38"/>
+                </a:solidFill>
+                <a:latin typeface="Aptos"/>
+                <a:ea typeface="Aptos"/>
+                <a:cs typeface="Aptos"/>
+              </a:defRPr>
+            </a:defPPr>
+          </a:lstStyle>
+          <a:p xmlns:a="http://schemas.openxmlformats.org/drawingml/2006/main">
+            <a:pPr>
+              <a:defRPr sz="2100" b="0">
+                <a:solidFill>
+                  <a:srgbClr val="132E38"/>
+                </a:solidFill>
+                <a:latin typeface="Aptos"/>
+                <a:ea typeface="Aptos"/>
+                <a:cs typeface="Aptos"/>
+              </a:defRPr>
+            </a:pPr>
+            <a:r>
+              <a:rPr sz="2100" b="0">
+                <a:solidFill>
+                  <a:srgbClr val="132E38"/>
+                </a:solidFill>
+                <a:latin typeface="Aptos"/>
+                <a:ea typeface="Aptos"/>
+                <a:cs typeface="Aptos"/>
+              </a:rPr>
+              <a:t>Main stays untouched. Helix is de-prioritized. Configuration details stay in one decision register.</a:t>
+            </a:r>
+          </a:p>
+        </p:txBody>
+      </p:sp>
+    </p:spTree>
+    <p:extLst>
+      <p:ext uri="{BB962C8B-B14F-4D97-AF65-F5344CB8AC3E}">
+        <p14:creationId xmlns:p14="http://schemas.microsoft.com/office/powerpoint/2010/main" val="298920761"/>
       </p:ext>
     </p:extLst>
   </p:cSld>

</xml_diff>

<commit_message>
docs: synchronize r7 grant and installable plugin evidence
</commit_message>
<xml_diff>
--- a/Inertia-Architecture.pptx
+++ b/Inertia-Architecture.pptx
@@ -2,20 +2,20 @@
 <file path=ppt/presentation.xml><?xml version="1.0" encoding="utf-8"?>
 <p:presentation xmlns:p="http://schemas.openxmlformats.org/presentationml/2006/main">
   <p:sldMasterIdLst>
-    <p:sldMasterId xmlns:r="http://schemas.openxmlformats.org/officeDocument/2006/relationships" id="2147483648" r:id="R273b139f7c044ff7"/>
+    <p:sldMasterId xmlns:r="http://schemas.openxmlformats.org/officeDocument/2006/relationships" id="2147483648" r:id="R3be3756c8c8e4d06"/>
   </p:sldMasterIdLst>
   <p:notesMasterIdLst>
-    <p:notesMasterId xmlns:r="http://schemas.openxmlformats.org/officeDocument/2006/relationships" r:id="Rbaa4f659cae2406d"/>
+    <p:notesMasterId xmlns:r="http://schemas.openxmlformats.org/officeDocument/2006/relationships" r:id="R919ed80d140d4fc7"/>
   </p:notesMasterIdLst>
   <p:sldIdLst>
-    <p:sldId xmlns:r="http://schemas.openxmlformats.org/officeDocument/2006/relationships" id="256" r:id="Rb2428aaf842a4875"/>
-    <p:sldId xmlns:r="http://schemas.openxmlformats.org/officeDocument/2006/relationships" id="257" r:id="R59276d759b26441c"/>
-    <p:sldId xmlns:r="http://schemas.openxmlformats.org/officeDocument/2006/relationships" id="258" r:id="R025705acd4d7429f"/>
-    <p:sldId xmlns:r="http://schemas.openxmlformats.org/officeDocument/2006/relationships" id="259" r:id="R7fefb3c3e2714bbc"/>
-    <p:sldId xmlns:r="http://schemas.openxmlformats.org/officeDocument/2006/relationships" id="260" r:id="Rdbc8884b250e4fd9"/>
-    <p:sldId xmlns:r="http://schemas.openxmlformats.org/officeDocument/2006/relationships" id="261" r:id="R380d774362574d86"/>
-    <p:sldId xmlns:r="http://schemas.openxmlformats.org/officeDocument/2006/relationships" id="262" r:id="Rbd70252bac4442fe"/>
-    <p:sldId xmlns:r="http://schemas.openxmlformats.org/officeDocument/2006/relationships" id="263" r:id="R2d339179cb0b4cd0"/>
+    <p:sldId xmlns:r="http://schemas.openxmlformats.org/officeDocument/2006/relationships" id="256" r:id="Re58f4a1192c74eb7"/>
+    <p:sldId xmlns:r="http://schemas.openxmlformats.org/officeDocument/2006/relationships" id="257" r:id="Rb1ef7f9abbed4c2f"/>
+    <p:sldId xmlns:r="http://schemas.openxmlformats.org/officeDocument/2006/relationships" id="258" r:id="R5d83b06a76334ccd"/>
+    <p:sldId xmlns:r="http://schemas.openxmlformats.org/officeDocument/2006/relationships" id="259" r:id="R766df985260e44a9"/>
+    <p:sldId xmlns:r="http://schemas.openxmlformats.org/officeDocument/2006/relationships" id="260" r:id="Rb41a4fe761d7431d"/>
+    <p:sldId xmlns:r="http://schemas.openxmlformats.org/officeDocument/2006/relationships" id="261" r:id="R6d062e6c2d2d4a16"/>
+    <p:sldId xmlns:r="http://schemas.openxmlformats.org/officeDocument/2006/relationships" id="262" r:id="R4bc29f4189db4bbe"/>
+    <p:sldId xmlns:r="http://schemas.openxmlformats.org/officeDocument/2006/relationships" id="263" r:id="Ref3549c8c3f04046"/>
   </p:sldIdLst>
   <p:sldSz cx="15240000" cy="8572500"/>
   <p:notesSz cx="6858000" cy="9144000"/>
@@ -449,7 +449,7 @@
           <a:lstStyle xmlns:a="http://schemas.openxmlformats.org/drawingml/2006/main"/>
           <a:p xmlns:a="http://schemas.openxmlformats.org/drawingml/2006/main">
             <a:r>
-              <a:t>INERTIA-2026-10-22-r6. Sources: spec.md, testing.md, decisions.md, plan.md. Merged baseline https://github.com/NetRxn/Inertia/commit/1d41eeb70b02275a488a7f7583c116c8d2c77f3c; PR 2 https://github.com/NetRxn/Inertia/pull/2; PR 3 https://github.com/NetRxn/Inertia/pull/3. Paperclip selected public release v2026.1012.0, bba6a45f0d364cfd962ac59b3bdf2426a8222adb. Buzz dc25198d530acc6237a0320b697365f29daf0ea6. PR 4 https://github.com/NetRxn/Inertia/pull/4 and PR 5 https://github.com/NetRxn/Inertia/pull/5 merged. Combined 108 tests, typecheck, build and synthetic demo passed. No private execution-provider source included.</a:t>
+              <a:t>INERTIA-2026-10-23-r7. Sources: spec.md, testing.md, decisions.md, plan.md. Merged baseline https://github.com/NetRxn/Inertia/commit/53d0f2eedf62778f8af6cc92da6fc7b84f3f0435; PR 2 https://github.com/NetRxn/Inertia/pull/2; PR 3 https://github.com/NetRxn/Inertia/pull/3. Paperclip selected public release v2026.1012.0, bba6a45f0d364cfd962ac59b3bdf2426a8222adb. Buzz dc25198d530acc6237a0320b697365f29daf0ea6. PR 4 https://github.com/NetRxn/Inertia/pull/4 and PR 5 https://github.com/NetRxn/Inertia/pull/5 merged. PR 7 https://github.com/NetRxn/Inertia/pull/7 merged with 37 grant tests. PR 8 https://github.com/NetRxn/Inertia/pull/8 merged with packaging f68e8bb98df0bb05f9a946340d885e0bcfc6e188 independently reviewed; 149 combined tests, typecheck, build, fresh production install and native JSON-RPC worker handshake passed. No private execution-provider source included.</a:t>
             </a:r>
           </a:p>
         </p:txBody>
@@ -519,7 +519,7 @@
           <a:lstStyle xmlns:a="http://schemas.openxmlformats.org/drawingml/2006/main"/>
           <a:p xmlns:a="http://schemas.openxmlformats.org/drawingml/2006/main">
             <a:r>
-              <a:t>INERTIA-2026-10-22-r6. Sources: spec.md, testing.md, decisions.md, plan.md. Merged baseline https://github.com/NetRxn/Inertia/commit/1d41eeb70b02275a488a7f7583c116c8d2c77f3c; PR 2 https://github.com/NetRxn/Inertia/pull/2; PR 3 https://github.com/NetRxn/Inertia/pull/3. Paperclip selected public release v2026.1012.0, bba6a45f0d364cfd962ac59b3bdf2426a8222adb. Buzz dc25198d530acc6237a0320b697365f29daf0ea6. PR 4 https://github.com/NetRxn/Inertia/pull/4 and PR 5 https://github.com/NetRxn/Inertia/pull/5 merged. Combined 108 tests, typecheck, build and synthetic demo passed. No private execution-provider source included.</a:t>
+              <a:t>INERTIA-2026-10-23-r7. Sources: spec.md, testing.md, decisions.md, plan.md. Merged baseline https://github.com/NetRxn/Inertia/commit/53d0f2eedf62778f8af6cc92da6fc7b84f3f0435; PR 2 https://github.com/NetRxn/Inertia/pull/2; PR 3 https://github.com/NetRxn/Inertia/pull/3. Paperclip selected public release v2026.1012.0, bba6a45f0d364cfd962ac59b3bdf2426a8222adb. Buzz dc25198d530acc6237a0320b697365f29daf0ea6. PR 4 https://github.com/NetRxn/Inertia/pull/4 and PR 5 https://github.com/NetRxn/Inertia/pull/5 merged. PR 7 https://github.com/NetRxn/Inertia/pull/7 merged with 37 grant tests. PR 8 https://github.com/NetRxn/Inertia/pull/8 merged with packaging f68e8bb98df0bb05f9a946340d885e0bcfc6e188 independently reviewed; 149 combined tests, typecheck, build, fresh production install and native JSON-RPC worker handshake passed. No private execution-provider source included.</a:t>
             </a:r>
           </a:p>
         </p:txBody>
@@ -589,7 +589,7 @@
           <a:lstStyle xmlns:a="http://schemas.openxmlformats.org/drawingml/2006/main"/>
           <a:p xmlns:a="http://schemas.openxmlformats.org/drawingml/2006/main">
             <a:r>
-              <a:t>INERTIA-2026-10-22-r6. Sources: spec.md, testing.md, decisions.md, plan.md. Merged baseline https://github.com/NetRxn/Inertia/commit/1d41eeb70b02275a488a7f7583c116c8d2c77f3c; PR 2 https://github.com/NetRxn/Inertia/pull/2; PR 3 https://github.com/NetRxn/Inertia/pull/3. Paperclip selected public release v2026.1012.0, bba6a45f0d364cfd962ac59b3bdf2426a8222adb. Buzz dc25198d530acc6237a0320b697365f29daf0ea6. PR 4 https://github.com/NetRxn/Inertia/pull/4 and PR 5 https://github.com/NetRxn/Inertia/pull/5 merged. Combined 108 tests, typecheck, build and synthetic demo passed. No private execution-provider source included.</a:t>
+              <a:t>INERTIA-2026-10-23-r7. Sources: spec.md, testing.md, decisions.md, plan.md. Merged baseline https://github.com/NetRxn/Inertia/commit/53d0f2eedf62778f8af6cc92da6fc7b84f3f0435; PR 2 https://github.com/NetRxn/Inertia/pull/2; PR 3 https://github.com/NetRxn/Inertia/pull/3. Paperclip selected public release v2026.1012.0, bba6a45f0d364cfd962ac59b3bdf2426a8222adb. Buzz dc25198d530acc6237a0320b697365f29daf0ea6. PR 4 https://github.com/NetRxn/Inertia/pull/4 and PR 5 https://github.com/NetRxn/Inertia/pull/5 merged. PR 7 https://github.com/NetRxn/Inertia/pull/7 merged with 37 grant tests. PR 8 https://github.com/NetRxn/Inertia/pull/8 merged with packaging f68e8bb98df0bb05f9a946340d885e0bcfc6e188 independently reviewed; 149 combined tests, typecheck, build, fresh production install and native JSON-RPC worker handshake passed. No private execution-provider source included.</a:t>
             </a:r>
           </a:p>
         </p:txBody>
@@ -659,7 +659,7 @@
           <a:lstStyle xmlns:a="http://schemas.openxmlformats.org/drawingml/2006/main"/>
           <a:p xmlns:a="http://schemas.openxmlformats.org/drawingml/2006/main">
             <a:r>
-              <a:t>INERTIA-2026-10-22-r6. Sources: spec.md, testing.md, decisions.md, plan.md. Merged baseline https://github.com/NetRxn/Inertia/commit/1d41eeb70b02275a488a7f7583c116c8d2c77f3c; PR 2 https://github.com/NetRxn/Inertia/pull/2; PR 3 https://github.com/NetRxn/Inertia/pull/3. Paperclip selected public release v2026.1012.0, bba6a45f0d364cfd962ac59b3bdf2426a8222adb. Buzz dc25198d530acc6237a0320b697365f29daf0ea6. PR 4 https://github.com/NetRxn/Inertia/pull/4 and PR 5 https://github.com/NetRxn/Inertia/pull/5 merged. Combined 108 tests, typecheck, build and synthetic demo passed. No private execution-provider source included.</a:t>
+              <a:t>INERTIA-2026-10-23-r7. Sources: spec.md, testing.md, decisions.md, plan.md. Merged baseline https://github.com/NetRxn/Inertia/commit/53d0f2eedf62778f8af6cc92da6fc7b84f3f0435; PR 2 https://github.com/NetRxn/Inertia/pull/2; PR 3 https://github.com/NetRxn/Inertia/pull/3. Paperclip selected public release v2026.1012.0, bba6a45f0d364cfd962ac59b3bdf2426a8222adb. Buzz dc25198d530acc6237a0320b697365f29daf0ea6. PR 4 https://github.com/NetRxn/Inertia/pull/4 and PR 5 https://github.com/NetRxn/Inertia/pull/5 merged. PR 7 https://github.com/NetRxn/Inertia/pull/7 merged with 37 grant tests. PR 8 https://github.com/NetRxn/Inertia/pull/8 merged with packaging f68e8bb98df0bb05f9a946340d885e0bcfc6e188 independently reviewed; 149 combined tests, typecheck, build, fresh production install and native JSON-RPC worker handshake passed. No private execution-provider source included.</a:t>
             </a:r>
           </a:p>
         </p:txBody>
@@ -729,7 +729,7 @@
           <a:lstStyle xmlns:a="http://schemas.openxmlformats.org/drawingml/2006/main"/>
           <a:p xmlns:a="http://schemas.openxmlformats.org/drawingml/2006/main">
             <a:r>
-              <a:t>INERTIA-2026-10-22-r6. Sources: spec.md, testing.md, decisions.md, plan.md. Merged baseline https://github.com/NetRxn/Inertia/commit/1d41eeb70b02275a488a7f7583c116c8d2c77f3c; PR 2 https://github.com/NetRxn/Inertia/pull/2; PR 3 https://github.com/NetRxn/Inertia/pull/3. Paperclip selected public release v2026.1012.0, bba6a45f0d364cfd962ac59b3bdf2426a8222adb. Buzz dc25198d530acc6237a0320b697365f29daf0ea6. PR 4 https://github.com/NetRxn/Inertia/pull/4 and PR 5 https://github.com/NetRxn/Inertia/pull/5 merged. Combined 108 tests, typecheck, build and synthetic demo passed. No private execution-provider source included.</a:t>
+              <a:t>INERTIA-2026-10-23-r7. Sources: spec.md, testing.md, decisions.md, plan.md. Merged baseline https://github.com/NetRxn/Inertia/commit/53d0f2eedf62778f8af6cc92da6fc7b84f3f0435; PR 2 https://github.com/NetRxn/Inertia/pull/2; PR 3 https://github.com/NetRxn/Inertia/pull/3. Paperclip selected public release v2026.1012.0, bba6a45f0d364cfd962ac59b3bdf2426a8222adb. Buzz dc25198d530acc6237a0320b697365f29daf0ea6. PR 4 https://github.com/NetRxn/Inertia/pull/4 and PR 5 https://github.com/NetRxn/Inertia/pull/5 merged. PR 7 https://github.com/NetRxn/Inertia/pull/7 merged with 37 grant tests. PR 8 https://github.com/NetRxn/Inertia/pull/8 merged with packaging f68e8bb98df0bb05f9a946340d885e0bcfc6e188 independently reviewed; 149 combined tests, typecheck, build, fresh production install and native JSON-RPC worker handshake passed. No private execution-provider source included.</a:t>
             </a:r>
           </a:p>
         </p:txBody>
@@ -799,7 +799,7 @@
           <a:lstStyle xmlns:a="http://schemas.openxmlformats.org/drawingml/2006/main"/>
           <a:p xmlns:a="http://schemas.openxmlformats.org/drawingml/2006/main">
             <a:r>
-              <a:t>INERTIA-2026-10-22-r6. Sources: spec.md, testing.md, decisions.md, plan.md. Merged baseline https://github.com/NetRxn/Inertia/commit/1d41eeb70b02275a488a7f7583c116c8d2c77f3c; PR 2 https://github.com/NetRxn/Inertia/pull/2; PR 3 https://github.com/NetRxn/Inertia/pull/3. Paperclip selected public release v2026.1012.0, bba6a45f0d364cfd962ac59b3bdf2426a8222adb. Buzz dc25198d530acc6237a0320b697365f29daf0ea6. PR 4 https://github.com/NetRxn/Inertia/pull/4 and PR 5 https://github.com/NetRxn/Inertia/pull/5 merged. Combined 108 tests, typecheck, build and synthetic demo passed. No private execution-provider source included.</a:t>
+              <a:t>INERTIA-2026-10-23-r7. Sources: spec.md, testing.md, decisions.md, plan.md. Merged baseline https://github.com/NetRxn/Inertia/commit/53d0f2eedf62778f8af6cc92da6fc7b84f3f0435; PR 2 https://github.com/NetRxn/Inertia/pull/2; PR 3 https://github.com/NetRxn/Inertia/pull/3. Paperclip selected public release v2026.1012.0, bba6a45f0d364cfd962ac59b3bdf2426a8222adb. Buzz dc25198d530acc6237a0320b697365f29daf0ea6. PR 4 https://github.com/NetRxn/Inertia/pull/4 and PR 5 https://github.com/NetRxn/Inertia/pull/5 merged. PR 7 https://github.com/NetRxn/Inertia/pull/7 merged with 37 grant tests. PR 8 https://github.com/NetRxn/Inertia/pull/8 merged with packaging f68e8bb98df0bb05f9a946340d885e0bcfc6e188 independently reviewed; 149 combined tests, typecheck, build, fresh production install and native JSON-RPC worker handshake passed. No private execution-provider source included.</a:t>
             </a:r>
           </a:p>
         </p:txBody>
@@ -869,7 +869,7 @@
           <a:lstStyle xmlns:a="http://schemas.openxmlformats.org/drawingml/2006/main"/>
           <a:p xmlns:a="http://schemas.openxmlformats.org/drawingml/2006/main">
             <a:r>
-              <a:t>INERTIA-2026-10-22-r6. Sources: spec.md, testing.md, decisions.md, plan.md. Merged baseline https://github.com/NetRxn/Inertia/commit/1d41eeb70b02275a488a7f7583c116c8d2c77f3c; PR 2 https://github.com/NetRxn/Inertia/pull/2; PR 3 https://github.com/NetRxn/Inertia/pull/3. Paperclip selected public release v2026.1012.0, bba6a45f0d364cfd962ac59b3bdf2426a8222adb. Buzz dc25198d530acc6237a0320b697365f29daf0ea6. PR 4 https://github.com/NetRxn/Inertia/pull/4 and PR 5 https://github.com/NetRxn/Inertia/pull/5 merged. Combined 108 tests, typecheck, build and synthetic demo passed. No private execution-provider source included.</a:t>
+              <a:t>INERTIA-2026-10-23-r7. Sources: spec.md, testing.md, decisions.md, plan.md. Merged baseline https://github.com/NetRxn/Inertia/commit/53d0f2eedf62778f8af6cc92da6fc7b84f3f0435; PR 2 https://github.com/NetRxn/Inertia/pull/2; PR 3 https://github.com/NetRxn/Inertia/pull/3. Paperclip selected public release v2026.1012.0, bba6a45f0d364cfd962ac59b3bdf2426a8222adb. Buzz dc25198d530acc6237a0320b697365f29daf0ea6. PR 4 https://github.com/NetRxn/Inertia/pull/4 and PR 5 https://github.com/NetRxn/Inertia/pull/5 merged. PR 7 https://github.com/NetRxn/Inertia/pull/7 merged with 37 grant tests. PR 8 https://github.com/NetRxn/Inertia/pull/8 merged with packaging f68e8bb98df0bb05f9a946340d885e0bcfc6e188 independently reviewed; 149 combined tests, typecheck, build, fresh production install and native JSON-RPC worker handshake passed. No private execution-provider source included.</a:t>
             </a:r>
           </a:p>
         </p:txBody>
@@ -939,7 +939,7 @@
           <a:lstStyle xmlns:a="http://schemas.openxmlformats.org/drawingml/2006/main"/>
           <a:p xmlns:a="http://schemas.openxmlformats.org/drawingml/2006/main">
             <a:r>
-              <a:t>INERTIA-2026-10-22-r6. Sources: spec.md, testing.md, decisions.md, plan.md. Merged baseline https://github.com/NetRxn/Inertia/commit/1d41eeb70b02275a488a7f7583c116c8d2c77f3c; PR 2 https://github.com/NetRxn/Inertia/pull/2; PR 3 https://github.com/NetRxn/Inertia/pull/3. Paperclip selected public release v2026.1012.0, bba6a45f0d364cfd962ac59b3bdf2426a8222adb. Buzz dc25198d530acc6237a0320b697365f29daf0ea6. PR 4 https://github.com/NetRxn/Inertia/pull/4 and PR 5 https://github.com/NetRxn/Inertia/pull/5 merged. Combined 108 tests, typecheck, build and synthetic demo passed. No private execution-provider source included.</a:t>
+              <a:t>INERTIA-2026-10-23-r7. Sources: spec.md, testing.md, decisions.md, plan.md. Merged baseline https://github.com/NetRxn/Inertia/commit/53d0f2eedf62778f8af6cc92da6fc7b84f3f0435; PR 2 https://github.com/NetRxn/Inertia/pull/2; PR 3 https://github.com/NetRxn/Inertia/pull/3. Paperclip selected public release v2026.1012.0, bba6a45f0d364cfd962ac59b3bdf2426a8222adb. Buzz dc25198d530acc6237a0320b697365f29daf0ea6. PR 4 https://github.com/NetRxn/Inertia/pull/4 and PR 5 https://github.com/NetRxn/Inertia/pull/5 merged. PR 7 https://github.com/NetRxn/Inertia/pull/7 merged with 37 grant tests. PR 8 https://github.com/NetRxn/Inertia/pull/8 merged with packaging f68e8bb98df0bb05f9a946340d885e0bcfc6e188 independently reviewed; 149 combined tests, typecheck, build, fresh production install and native JSON-RPC worker handshake passed. No private execution-provider source included.</a:t>
             </a:r>
           </a:p>
         </p:txBody>
@@ -986,7 +986,7 @@
           <p:cNvPr id="3" name="Title">
             <a:extLst xmlns:a="http://schemas.openxmlformats.org/drawingml/2006/main">
               <a:ext uri="{FF2B5EF4-FFF2-40B4-BE49-F238E27FC236}">
-                <a16:creationId xmlns:a16="http://schemas.microsoft.com/office/drawing/2014/main" id="{BDF0810F-6050-4674-AAA8-ECA143DEEC4D}"/>
+                <a16:creationId xmlns:a16="http://schemas.microsoft.com/office/drawing/2014/main" id="{95D1E57F-B585-48FA-B271-4C568F5362D9}"/>
               </a:ext>
             </a:extLst>
           </p:cNvPr>
@@ -1143,7 +1143,7 @@
           <p:cNvPr id="2" name="Subtitle">
             <a:extLst xmlns:a="http://schemas.openxmlformats.org/drawingml/2006/main">
               <a:ext uri="{FF2B5EF4-FFF2-40B4-BE49-F238E27FC236}">
-                <a16:creationId xmlns:a16="http://schemas.microsoft.com/office/drawing/2014/main" id="{EA6B8F91-5509-4B4B-9C3C-ED80D6C5251B}"/>
+                <a16:creationId xmlns:a16="http://schemas.microsoft.com/office/drawing/2014/main" id="{ADCBF4C5-38CE-4382-ADFF-8D349780FF13}"/>
               </a:ext>
             </a:extLst>
           </p:cNvPr>
@@ -1317,7 +1317,7 @@
           <p:cNvPr id="2" name="Section title">
             <a:extLst xmlns:a="http://schemas.openxmlformats.org/drawingml/2006/main">
               <a:ext uri="{FF2B5EF4-FFF2-40B4-BE49-F238E27FC236}">
-                <a16:creationId xmlns:a16="http://schemas.microsoft.com/office/drawing/2014/main" id="{21A9519E-FBF9-43FA-93B2-B31DDA0C141D}"/>
+                <a16:creationId xmlns:a16="http://schemas.microsoft.com/office/drawing/2014/main" id="{91B867D4-3DA0-47B2-9D01-3112A1B2E3BD}"/>
               </a:ext>
             </a:extLst>
           </p:cNvPr>
@@ -1491,7 +1491,7 @@
           <p:cNvPr id="3" name="Title">
             <a:extLst xmlns:a="http://schemas.openxmlformats.org/drawingml/2006/main">
               <a:ext uri="{FF2B5EF4-FFF2-40B4-BE49-F238E27FC236}">
-                <a16:creationId xmlns:a16="http://schemas.microsoft.com/office/drawing/2014/main" id="{EA6BA450-EE2D-498A-B8C5-5E9E63F6AE3B}"/>
+                <a16:creationId xmlns:a16="http://schemas.microsoft.com/office/drawing/2014/main" id="{3E0D570B-6EBC-43AC-B476-FB076AF1E7A7}"/>
               </a:ext>
             </a:extLst>
           </p:cNvPr>
@@ -1648,7 +1648,7 @@
           <p:cNvPr id="2" name="Body">
             <a:extLst xmlns:a="http://schemas.openxmlformats.org/drawingml/2006/main">
               <a:ext uri="{FF2B5EF4-FFF2-40B4-BE49-F238E27FC236}">
-                <a16:creationId xmlns:a16="http://schemas.microsoft.com/office/drawing/2014/main" id="{F1F6EC7A-3BCB-494E-BDF6-A407637FBE5D}"/>
+                <a16:creationId xmlns:a16="http://schemas.microsoft.com/office/drawing/2014/main" id="{8BD6B71A-F54F-42C7-A877-7354E411401C}"/>
               </a:ext>
             </a:extLst>
           </p:cNvPr>
@@ -1822,7 +1822,7 @@
           <p:cNvPr id="4" name="Title">
             <a:extLst xmlns:a="http://schemas.openxmlformats.org/drawingml/2006/main">
               <a:ext uri="{FF2B5EF4-FFF2-40B4-BE49-F238E27FC236}">
-                <a16:creationId xmlns:a16="http://schemas.microsoft.com/office/drawing/2014/main" id="{D8072316-C6BD-4433-8CB6-8ED38FFF9D72}"/>
+                <a16:creationId xmlns:a16="http://schemas.microsoft.com/office/drawing/2014/main" id="{68C2C14D-F684-4909-88F4-3F250CAAB786}"/>
               </a:ext>
             </a:extLst>
           </p:cNvPr>
@@ -1979,7 +1979,7 @@
           <p:cNvPr id="2" name="Left column">
             <a:extLst xmlns:a="http://schemas.openxmlformats.org/drawingml/2006/main">
               <a:ext uri="{FF2B5EF4-FFF2-40B4-BE49-F238E27FC236}">
-                <a16:creationId xmlns:a16="http://schemas.microsoft.com/office/drawing/2014/main" id="{8365BC37-D593-4BE1-B8B4-A612C93CFD8E}"/>
+                <a16:creationId xmlns:a16="http://schemas.microsoft.com/office/drawing/2014/main" id="{FCDF51D0-11A0-4E3D-A341-7B7B2CE8E009}"/>
               </a:ext>
             </a:extLst>
           </p:cNvPr>
@@ -2136,7 +2136,7 @@
           <p:cNvPr id="3" name="Right column">
             <a:extLst xmlns:a="http://schemas.openxmlformats.org/drawingml/2006/main">
               <a:ext uri="{FF2B5EF4-FFF2-40B4-BE49-F238E27FC236}">
-                <a16:creationId xmlns:a16="http://schemas.microsoft.com/office/drawing/2014/main" id="{979E7B16-753E-4015-8000-450742DCD271}"/>
+                <a16:creationId xmlns:a16="http://schemas.microsoft.com/office/drawing/2014/main" id="{5FD43888-3962-41C3-8D69-C94503E9CB1E}"/>
               </a:ext>
             </a:extLst>
           </p:cNvPr>
@@ -2310,7 +2310,7 @@
           <p:cNvPr id="3" name="Title">
             <a:extLst xmlns:a="http://schemas.openxmlformats.org/drawingml/2006/main">
               <a:ext uri="{FF2B5EF4-FFF2-40B4-BE49-F238E27FC236}">
-                <a16:creationId xmlns:a16="http://schemas.microsoft.com/office/drawing/2014/main" id="{6443D337-3BC4-4995-A4E6-5F85B907D525}"/>
+                <a16:creationId xmlns:a16="http://schemas.microsoft.com/office/drawing/2014/main" id="{5C7F9286-8D75-4BA5-A753-5F902D8904BD}"/>
               </a:ext>
             </a:extLst>
           </p:cNvPr>
@@ -2467,7 +2467,7 @@
           <p:cNvPr id="2" name="Left column">
             <a:extLst xmlns:a="http://schemas.openxmlformats.org/drawingml/2006/main">
               <a:ext uri="{FF2B5EF4-FFF2-40B4-BE49-F238E27FC236}">
-                <a16:creationId xmlns:a16="http://schemas.microsoft.com/office/drawing/2014/main" id="{B4349902-5219-49E5-9EF2-5FD7115225ED}"/>
+                <a16:creationId xmlns:a16="http://schemas.microsoft.com/office/drawing/2014/main" id="{6E137C6C-C699-4A3B-9DF9-6DA18ED53DB5}"/>
               </a:ext>
             </a:extLst>
           </p:cNvPr>
@@ -2662,12 +2662,12 @@
   </p:cSld>
   <p:clrMap bg1="lt1" tx1="dk1" bg2="lt2" tx2="dk2" accent1="accent1" accent2="accent2" accent3="accent3" accent4="accent4" accent5="accent5" accent6="accent6" hlink="hlink" folHlink="folHlink"/>
   <p:sldLayoutIdLst>
-    <p:sldLayoutId xmlns:r="http://schemas.openxmlformats.org/officeDocument/2006/relationships" id="2147483649" r:id="R8c57d72e0bc3468b"/>
-    <p:sldLayoutId xmlns:r="http://schemas.openxmlformats.org/officeDocument/2006/relationships" id="2147483650" r:id="R0293d6e23782453b"/>
-    <p:sldLayoutId xmlns:r="http://schemas.openxmlformats.org/officeDocument/2006/relationships" id="2147483651" r:id="Rf00b4e3903384bd5"/>
-    <p:sldLayoutId xmlns:r="http://schemas.openxmlformats.org/officeDocument/2006/relationships" id="2147483652" r:id="Rb962b177267a48d7"/>
-    <p:sldLayoutId xmlns:r="http://schemas.openxmlformats.org/officeDocument/2006/relationships" id="2147483653" r:id="R3057f58f9b084090"/>
-    <p:sldLayoutId xmlns:r="http://schemas.openxmlformats.org/officeDocument/2006/relationships" id="2147483654" r:id="Rcd59f86f3a4d47b2"/>
+    <p:sldLayoutId xmlns:r="http://schemas.openxmlformats.org/officeDocument/2006/relationships" id="2147483649" r:id="R233f2e708c214e04"/>
+    <p:sldLayoutId xmlns:r="http://schemas.openxmlformats.org/officeDocument/2006/relationships" id="2147483650" r:id="R16173458a66b442b"/>
+    <p:sldLayoutId xmlns:r="http://schemas.openxmlformats.org/officeDocument/2006/relationships" id="2147483651" r:id="Rb005901e47b247ed"/>
+    <p:sldLayoutId xmlns:r="http://schemas.openxmlformats.org/officeDocument/2006/relationships" id="2147483652" r:id="Rb8747a1593ac46e5"/>
+    <p:sldLayoutId xmlns:r="http://schemas.openxmlformats.org/officeDocument/2006/relationships" id="2147483653" r:id="R48da9b55596e4ba5"/>
+    <p:sldLayoutId xmlns:r="http://schemas.openxmlformats.org/officeDocument/2006/relationships" id="2147483654" r:id="Re252940858574bd5"/>
   </p:sldLayoutIdLst>
   <p:txStyles>
     <p:titleStyle>
@@ -3218,7 +3218,7 @@
           <p:cNvPr id="17" name="">
             <a:extLst xmlns:a="http://schemas.openxmlformats.org/drawingml/2006/main">
               <a:ext uri="{FF2B5EF4-FFF2-40B4-BE49-F238E27FC236}">
-                <a16:creationId xmlns:a16="http://schemas.microsoft.com/office/drawing/2014/main" id="{18F0D5F2-C12D-4E15-A331-126E9EC351DF}"/>
+                <a16:creationId xmlns:a16="http://schemas.microsoft.com/office/drawing/2014/main" id="{75A17CB0-39A8-4057-8703-88DC0F47DA44}"/>
               </a:ext>
             </a:extLst>
           </p:cNvPr>
@@ -3285,7 +3285,7 @@
           <p:cNvPr id="2" name="">
             <a:extLst xmlns:a="http://schemas.openxmlformats.org/drawingml/2006/main">
               <a:ext uri="{FF2B5EF4-FFF2-40B4-BE49-F238E27FC236}">
-                <a16:creationId xmlns:a16="http://schemas.microsoft.com/office/drawing/2014/main" id="{9CB2C3C6-B61A-430B-8269-DCA1A8055E42}"/>
+                <a16:creationId xmlns:a16="http://schemas.microsoft.com/office/drawing/2014/main" id="{8E7AA5AE-3884-4754-BB21-036316BC93B7}"/>
               </a:ext>
             </a:extLst>
           </p:cNvPr>
@@ -3352,7 +3352,7 @@
           <p:cNvPr id="3" name="">
             <a:extLst xmlns:a="http://schemas.openxmlformats.org/drawingml/2006/main">
               <a:ext uri="{FF2B5EF4-FFF2-40B4-BE49-F238E27FC236}">
-                <a16:creationId xmlns:a16="http://schemas.microsoft.com/office/drawing/2014/main" id="{D954B08E-70D2-48D4-BD99-32420D842391}"/>
+                <a16:creationId xmlns:a16="http://schemas.microsoft.com/office/drawing/2014/main" id="{C52E8E11-3AAB-4161-BA43-A873C284EE78}"/>
               </a:ext>
             </a:extLst>
           </p:cNvPr>
@@ -3419,7 +3419,7 @@
           <p:cNvPr id="4" name="">
             <a:extLst xmlns:a="http://schemas.openxmlformats.org/drawingml/2006/main">
               <a:ext uri="{FF2B5EF4-FFF2-40B4-BE49-F238E27FC236}">
-                <a16:creationId xmlns:a16="http://schemas.microsoft.com/office/drawing/2014/main" id="{8CAD2439-400F-47B7-BC8B-1B191BA7BD9C}"/>
+                <a16:creationId xmlns:a16="http://schemas.microsoft.com/office/drawing/2014/main" id="{B79EDA0C-5311-4F7A-B0E4-BC61B4DD2BBA}"/>
               </a:ext>
             </a:extLst>
           </p:cNvPr>
@@ -3450,7 +3450,7 @@
           <p:cNvPr id="5" name="">
             <a:extLst xmlns:a="http://schemas.openxmlformats.org/drawingml/2006/main">
               <a:ext uri="{FF2B5EF4-FFF2-40B4-BE49-F238E27FC236}">
-                <a16:creationId xmlns:a16="http://schemas.microsoft.com/office/drawing/2014/main" id="{E6203AED-F4B7-4FAC-8669-B1DE88056755}"/>
+                <a16:creationId xmlns:a16="http://schemas.microsoft.com/office/drawing/2014/main" id="{A997853C-D0FA-442D-B83B-10E243559DD1}"/>
               </a:ext>
             </a:extLst>
           </p:cNvPr>
@@ -3507,7 +3507,7 @@
                 <a:ea typeface="Aptos"/>
                 <a:cs typeface="Aptos"/>
               </a:rPr>
-              <a:t>INERTIA-2026-10-22-r6 · 22 October 2026 · Autonomous build</a:t>
+              <a:t>INERTIA-2026-10-23-r7 · 23 October 2026 · Autonomous build</a:t>
             </a:r>
           </a:p>
         </p:txBody>
@@ -3517,7 +3517,7 @@
           <p:cNvPr id="6" name="">
             <a:extLst xmlns:a="http://schemas.openxmlformats.org/drawingml/2006/main">
               <a:ext uri="{FF2B5EF4-FFF2-40B4-BE49-F238E27FC236}">
-                <a16:creationId xmlns:a16="http://schemas.microsoft.com/office/drawing/2014/main" id="{AE2EC293-047E-4D0D-9C76-830648911ED9}"/>
+                <a16:creationId xmlns:a16="http://schemas.microsoft.com/office/drawing/2014/main" id="{E1AAD32A-738A-4B4D-AF3B-E1039F8B2359}"/>
               </a:ext>
             </a:extLst>
           </p:cNvPr>
@@ -3584,7 +3584,7 @@
           <p:cNvPr id="7" name="">
             <a:extLst xmlns:a="http://schemas.openxmlformats.org/drawingml/2006/main">
               <a:ext uri="{FF2B5EF4-FFF2-40B4-BE49-F238E27FC236}">
-                <a16:creationId xmlns:a16="http://schemas.microsoft.com/office/drawing/2014/main" id="{43EBA0A8-A765-42A6-BFC7-70FD9067A607}"/>
+                <a16:creationId xmlns:a16="http://schemas.microsoft.com/office/drawing/2014/main" id="{895CD7D3-4E64-4D64-95EC-AE898156BC0D}"/>
               </a:ext>
             </a:extLst>
           </p:cNvPr>
@@ -3617,7 +3617,7 @@
           <p:cNvPr id="8" name="">
             <a:extLst xmlns:a="http://schemas.openxmlformats.org/drawingml/2006/main">
               <a:ext uri="{FF2B5EF4-FFF2-40B4-BE49-F238E27FC236}">
-                <a16:creationId xmlns:a16="http://schemas.microsoft.com/office/drawing/2014/main" id="{5B315368-6FA2-4C94-BE4C-90CC68B031EF}"/>
+                <a16:creationId xmlns:a16="http://schemas.microsoft.com/office/drawing/2014/main" id="{0822820E-389C-4386-ABF5-8F3E89F88428}"/>
               </a:ext>
             </a:extLst>
           </p:cNvPr>
@@ -3684,7 +3684,7 @@
           <p:cNvPr id="9" name="">
             <a:extLst xmlns:a="http://schemas.openxmlformats.org/drawingml/2006/main">
               <a:ext uri="{FF2B5EF4-FFF2-40B4-BE49-F238E27FC236}">
-                <a16:creationId xmlns:a16="http://schemas.microsoft.com/office/drawing/2014/main" id="{1979C0B7-880F-4130-8A84-708C4C367E41}"/>
+                <a16:creationId xmlns:a16="http://schemas.microsoft.com/office/drawing/2014/main" id="{4DF2FB39-8503-4F7F-A20E-D799FFC3CB8D}"/>
               </a:ext>
             </a:extLst>
           </p:cNvPr>
@@ -3820,7 +3820,7 @@
           <p:cNvPr id="10" name="">
             <a:extLst xmlns:a="http://schemas.openxmlformats.org/drawingml/2006/main">
               <a:ext uri="{FF2B5EF4-FFF2-40B4-BE49-F238E27FC236}">
-                <a16:creationId xmlns:a16="http://schemas.microsoft.com/office/drawing/2014/main" id="{9DAF82BC-8350-4090-B196-DFE9144D3C03}"/>
+                <a16:creationId xmlns:a16="http://schemas.microsoft.com/office/drawing/2014/main" id="{4394AFB3-3884-4B91-84F9-D9DBD29A978D}"/>
               </a:ext>
             </a:extLst>
           </p:cNvPr>
@@ -3853,7 +3853,7 @@
           <p:cNvPr id="11" name="">
             <a:extLst xmlns:a="http://schemas.openxmlformats.org/drawingml/2006/main">
               <a:ext uri="{FF2B5EF4-FFF2-40B4-BE49-F238E27FC236}">
-                <a16:creationId xmlns:a16="http://schemas.microsoft.com/office/drawing/2014/main" id="{FB37A1F1-3FD0-4275-BCC6-12F1BA5DF000}"/>
+                <a16:creationId xmlns:a16="http://schemas.microsoft.com/office/drawing/2014/main" id="{D6201A74-09B1-4889-AF4F-41F9C25DA6FA}"/>
               </a:ext>
             </a:extLst>
           </p:cNvPr>
@@ -3920,7 +3920,7 @@
           <p:cNvPr id="12" name="">
             <a:extLst xmlns:a="http://schemas.openxmlformats.org/drawingml/2006/main">
               <a:ext uri="{FF2B5EF4-FFF2-40B4-BE49-F238E27FC236}">
-                <a16:creationId xmlns:a16="http://schemas.microsoft.com/office/drawing/2014/main" id="{88C78972-E46C-4B6F-BC16-BE2DAAC57BE9}"/>
+                <a16:creationId xmlns:a16="http://schemas.microsoft.com/office/drawing/2014/main" id="{71961843-971E-4E58-A870-49045C7CBA83}"/>
               </a:ext>
             </a:extLst>
           </p:cNvPr>
@@ -4056,7 +4056,7 @@
           <p:cNvPr id="13" name="">
             <a:extLst xmlns:a="http://schemas.openxmlformats.org/drawingml/2006/main">
               <a:ext uri="{FF2B5EF4-FFF2-40B4-BE49-F238E27FC236}">
-                <a16:creationId xmlns:a16="http://schemas.microsoft.com/office/drawing/2014/main" id="{BE83E02F-EDCA-455C-B07A-662C6CD036C9}"/>
+                <a16:creationId xmlns:a16="http://schemas.microsoft.com/office/drawing/2014/main" id="{42A6583E-D56A-43F0-97A0-A8C7DC6F55E2}"/>
               </a:ext>
             </a:extLst>
           </p:cNvPr>
@@ -4089,7 +4089,7 @@
           <p:cNvPr id="14" name="">
             <a:extLst xmlns:a="http://schemas.openxmlformats.org/drawingml/2006/main">
               <a:ext uri="{FF2B5EF4-FFF2-40B4-BE49-F238E27FC236}">
-                <a16:creationId xmlns:a16="http://schemas.microsoft.com/office/drawing/2014/main" id="{88EFBBB1-2A79-4490-84C5-A53A01473DEE}"/>
+                <a16:creationId xmlns:a16="http://schemas.microsoft.com/office/drawing/2014/main" id="{07AD5DAD-5402-4ACA-B83A-9A0DD58443A8}"/>
               </a:ext>
             </a:extLst>
           </p:cNvPr>
@@ -4156,7 +4156,7 @@
           <p:cNvPr id="15" name="">
             <a:extLst xmlns:a="http://schemas.openxmlformats.org/drawingml/2006/main">
               <a:ext uri="{FF2B5EF4-FFF2-40B4-BE49-F238E27FC236}">
-                <a16:creationId xmlns:a16="http://schemas.microsoft.com/office/drawing/2014/main" id="{ED9D4108-5BBB-4249-9AC9-1CE09E26B5E4}"/>
+                <a16:creationId xmlns:a16="http://schemas.microsoft.com/office/drawing/2014/main" id="{BC00549C-210B-4AA3-B9A5-A2121A074DE9}"/>
               </a:ext>
             </a:extLst>
           </p:cNvPr>
@@ -4292,7 +4292,7 @@
           <p:cNvPr id="16" name="">
             <a:extLst xmlns:a="http://schemas.openxmlformats.org/drawingml/2006/main">
               <a:ext uri="{FF2B5EF4-FFF2-40B4-BE49-F238E27FC236}">
-                <a16:creationId xmlns:a16="http://schemas.microsoft.com/office/drawing/2014/main" id="{46AD2712-6E4F-481F-8740-D011F03C8708}"/>
+                <a16:creationId xmlns:a16="http://schemas.microsoft.com/office/drawing/2014/main" id="{E07F0EA3-9DEE-4358-9B37-79AC719B0BDB}"/>
               </a:ext>
             </a:extLst>
           </p:cNvPr>
@@ -4357,7 +4357,7 @@
     </p:spTree>
     <p:extLst>
       <p:ext uri="{BB962C8B-B14F-4D97-AF65-F5344CB8AC3E}">
-        <p14:creationId xmlns:p14="http://schemas.microsoft.com/office/powerpoint/2010/main" val="210611669"/>
+        <p14:creationId xmlns:p14="http://schemas.microsoft.com/office/powerpoint/2010/main" val="1968587660"/>
       </p:ext>
     </p:extLst>
   </p:cSld>
@@ -4388,7 +4388,7 @@
           <p:cNvPr id="17" name="">
             <a:extLst xmlns:a="http://schemas.openxmlformats.org/drawingml/2006/main">
               <a:ext uri="{FF2B5EF4-FFF2-40B4-BE49-F238E27FC236}">
-                <a16:creationId xmlns:a16="http://schemas.microsoft.com/office/drawing/2014/main" id="{7FDB1E3D-14E6-4B82-BA03-F8C55EC22F4A}"/>
+                <a16:creationId xmlns:a16="http://schemas.microsoft.com/office/drawing/2014/main" id="{EE06281D-7DA2-4A51-9FB6-D45B89B30533}"/>
               </a:ext>
             </a:extLst>
           </p:cNvPr>
@@ -4455,7 +4455,7 @@
           <p:cNvPr id="2" name="">
             <a:extLst xmlns:a="http://schemas.openxmlformats.org/drawingml/2006/main">
               <a:ext uri="{FF2B5EF4-FFF2-40B4-BE49-F238E27FC236}">
-                <a16:creationId xmlns:a16="http://schemas.microsoft.com/office/drawing/2014/main" id="{447186F9-1F90-452E-B2CC-2B9C61F25805}"/>
+                <a16:creationId xmlns:a16="http://schemas.microsoft.com/office/drawing/2014/main" id="{53C260F7-D566-4389-8653-E77D369EAE33}"/>
               </a:ext>
             </a:extLst>
           </p:cNvPr>
@@ -4522,7 +4522,7 @@
           <p:cNvPr id="3" name="">
             <a:extLst xmlns:a="http://schemas.openxmlformats.org/drawingml/2006/main">
               <a:ext uri="{FF2B5EF4-FFF2-40B4-BE49-F238E27FC236}">
-                <a16:creationId xmlns:a16="http://schemas.microsoft.com/office/drawing/2014/main" id="{892CFB54-6CB7-4E30-B7A0-879E1B639ED8}"/>
+                <a16:creationId xmlns:a16="http://schemas.microsoft.com/office/drawing/2014/main" id="{B06AB686-7526-49D9-BFF9-E1FDC2B46EF9}"/>
               </a:ext>
             </a:extLst>
           </p:cNvPr>
@@ -4589,7 +4589,7 @@
           <p:cNvPr id="4" name="">
             <a:extLst xmlns:a="http://schemas.openxmlformats.org/drawingml/2006/main">
               <a:ext uri="{FF2B5EF4-FFF2-40B4-BE49-F238E27FC236}">
-                <a16:creationId xmlns:a16="http://schemas.microsoft.com/office/drawing/2014/main" id="{79822DEE-9BDB-4B9F-95D2-08D03800DC42}"/>
+                <a16:creationId xmlns:a16="http://schemas.microsoft.com/office/drawing/2014/main" id="{C659046B-B47F-4269-8A3F-B410C60F3E1D}"/>
               </a:ext>
             </a:extLst>
           </p:cNvPr>
@@ -4620,7 +4620,7 @@
           <p:cNvPr id="5" name="">
             <a:extLst xmlns:a="http://schemas.openxmlformats.org/drawingml/2006/main">
               <a:ext uri="{FF2B5EF4-FFF2-40B4-BE49-F238E27FC236}">
-                <a16:creationId xmlns:a16="http://schemas.microsoft.com/office/drawing/2014/main" id="{87B22CF7-2F37-4043-A998-159758858DE7}"/>
+                <a16:creationId xmlns:a16="http://schemas.microsoft.com/office/drawing/2014/main" id="{E734B095-112B-43C9-B8C3-FED820A4522A}"/>
               </a:ext>
             </a:extLst>
           </p:cNvPr>
@@ -4677,7 +4677,7 @@
                 <a:ea typeface="Aptos"/>
                 <a:cs typeface="Aptos"/>
               </a:rPr>
-              <a:t>INERTIA-2026-10-22-r6 · 22 October 2026 · Autonomous build</a:t>
+              <a:t>INERTIA-2026-10-23-r7 · 23 October 2026 · Autonomous build</a:t>
             </a:r>
           </a:p>
         </p:txBody>
@@ -4687,7 +4687,7 @@
           <p:cNvPr id="6" name="">
             <a:extLst xmlns:a="http://schemas.openxmlformats.org/drawingml/2006/main">
               <a:ext uri="{FF2B5EF4-FFF2-40B4-BE49-F238E27FC236}">
-                <a16:creationId xmlns:a16="http://schemas.microsoft.com/office/drawing/2014/main" id="{9670D08E-CA51-4233-B455-D689C0422AF0}"/>
+                <a16:creationId xmlns:a16="http://schemas.microsoft.com/office/drawing/2014/main" id="{C14636F2-19A8-4444-9E5C-EAC575F842E8}"/>
               </a:ext>
             </a:extLst>
           </p:cNvPr>
@@ -4754,7 +4754,7 @@
           <p:cNvPr id="7" name="">
             <a:extLst xmlns:a="http://schemas.openxmlformats.org/drawingml/2006/main">
               <a:ext uri="{FF2B5EF4-FFF2-40B4-BE49-F238E27FC236}">
-                <a16:creationId xmlns:a16="http://schemas.microsoft.com/office/drawing/2014/main" id="{1E44DB16-86B0-4A3A-B776-408D486ABCC7}"/>
+                <a16:creationId xmlns:a16="http://schemas.microsoft.com/office/drawing/2014/main" id="{00F6D0B6-C34F-4F11-95B4-E702EE3C5D89}"/>
               </a:ext>
             </a:extLst>
           </p:cNvPr>
@@ -4787,7 +4787,7 @@
           <p:cNvPr id="8" name="">
             <a:extLst xmlns:a="http://schemas.openxmlformats.org/drawingml/2006/main">
               <a:ext uri="{FF2B5EF4-FFF2-40B4-BE49-F238E27FC236}">
-                <a16:creationId xmlns:a16="http://schemas.microsoft.com/office/drawing/2014/main" id="{CAB656FB-4476-44A8-9041-21949A6D60B1}"/>
+                <a16:creationId xmlns:a16="http://schemas.microsoft.com/office/drawing/2014/main" id="{41AA1ADC-CCFE-4008-9E98-BF3BBF7DF52A}"/>
               </a:ext>
             </a:extLst>
           </p:cNvPr>
@@ -4854,7 +4854,7 @@
           <p:cNvPr id="9" name="">
             <a:extLst xmlns:a="http://schemas.openxmlformats.org/drawingml/2006/main">
               <a:ext uri="{FF2B5EF4-FFF2-40B4-BE49-F238E27FC236}">
-                <a16:creationId xmlns:a16="http://schemas.microsoft.com/office/drawing/2014/main" id="{06EA6574-CEA2-48F0-8CE6-A9322B137457}"/>
+                <a16:creationId xmlns:a16="http://schemas.microsoft.com/office/drawing/2014/main" id="{95F2B8EF-39D5-412B-8A7B-24B0745D6BAE}"/>
               </a:ext>
             </a:extLst>
           </p:cNvPr>
@@ -4990,7 +4990,7 @@
           <p:cNvPr id="10" name="">
             <a:extLst xmlns:a="http://schemas.openxmlformats.org/drawingml/2006/main">
               <a:ext uri="{FF2B5EF4-FFF2-40B4-BE49-F238E27FC236}">
-                <a16:creationId xmlns:a16="http://schemas.microsoft.com/office/drawing/2014/main" id="{2309BDC6-461C-45CA-B060-03EEB742AB3D}"/>
+                <a16:creationId xmlns:a16="http://schemas.microsoft.com/office/drawing/2014/main" id="{104C8D86-6522-47BF-A332-D13A05656B5D}"/>
               </a:ext>
             </a:extLst>
           </p:cNvPr>
@@ -5023,7 +5023,7 @@
           <p:cNvPr id="11" name="">
             <a:extLst xmlns:a="http://schemas.openxmlformats.org/drawingml/2006/main">
               <a:ext uri="{FF2B5EF4-FFF2-40B4-BE49-F238E27FC236}">
-                <a16:creationId xmlns:a16="http://schemas.microsoft.com/office/drawing/2014/main" id="{C8968B24-F8F6-446A-801A-08FDEFAE1C68}"/>
+                <a16:creationId xmlns:a16="http://schemas.microsoft.com/office/drawing/2014/main" id="{8E2D9FF4-17E6-413C-9349-22137D1EC7E0}"/>
               </a:ext>
             </a:extLst>
           </p:cNvPr>
@@ -5090,7 +5090,7 @@
           <p:cNvPr id="12" name="">
             <a:extLst xmlns:a="http://schemas.openxmlformats.org/drawingml/2006/main">
               <a:ext uri="{FF2B5EF4-FFF2-40B4-BE49-F238E27FC236}">
-                <a16:creationId xmlns:a16="http://schemas.microsoft.com/office/drawing/2014/main" id="{58A10BD4-424D-4F69-877C-BCB1DF973486}"/>
+                <a16:creationId xmlns:a16="http://schemas.microsoft.com/office/drawing/2014/main" id="{51029DB9-D370-43DB-8A01-DCC57E26F78B}"/>
               </a:ext>
             </a:extLst>
           </p:cNvPr>
@@ -5226,7 +5226,7 @@
           <p:cNvPr id="13" name="">
             <a:extLst xmlns:a="http://schemas.openxmlformats.org/drawingml/2006/main">
               <a:ext uri="{FF2B5EF4-FFF2-40B4-BE49-F238E27FC236}">
-                <a16:creationId xmlns:a16="http://schemas.microsoft.com/office/drawing/2014/main" id="{9AB4E859-0FAF-4674-AB2F-3EDE7D329C90}"/>
+                <a16:creationId xmlns:a16="http://schemas.microsoft.com/office/drawing/2014/main" id="{2995EA0B-045D-491F-80B4-C54E28EFA07C}"/>
               </a:ext>
             </a:extLst>
           </p:cNvPr>
@@ -5259,7 +5259,7 @@
           <p:cNvPr id="14" name="">
             <a:extLst xmlns:a="http://schemas.openxmlformats.org/drawingml/2006/main">
               <a:ext uri="{FF2B5EF4-FFF2-40B4-BE49-F238E27FC236}">
-                <a16:creationId xmlns:a16="http://schemas.microsoft.com/office/drawing/2014/main" id="{A56A4B57-50B5-4EDB-9D4A-DAEB97B403D5}"/>
+                <a16:creationId xmlns:a16="http://schemas.microsoft.com/office/drawing/2014/main" id="{A89751F6-B7D3-4B44-8391-576F0F93809D}"/>
               </a:ext>
             </a:extLst>
           </p:cNvPr>
@@ -5326,7 +5326,7 @@
           <p:cNvPr id="15" name="">
             <a:extLst xmlns:a="http://schemas.openxmlformats.org/drawingml/2006/main">
               <a:ext uri="{FF2B5EF4-FFF2-40B4-BE49-F238E27FC236}">
-                <a16:creationId xmlns:a16="http://schemas.microsoft.com/office/drawing/2014/main" id="{039A0B8E-E7B4-4CDA-A507-50859BBBA647}"/>
+                <a16:creationId xmlns:a16="http://schemas.microsoft.com/office/drawing/2014/main" id="{F2747B70-629C-4D99-BD56-6DA417CFD4E2}"/>
               </a:ext>
             </a:extLst>
           </p:cNvPr>
@@ -5462,7 +5462,7 @@
           <p:cNvPr id="16" name="">
             <a:extLst xmlns:a="http://schemas.openxmlformats.org/drawingml/2006/main">
               <a:ext uri="{FF2B5EF4-FFF2-40B4-BE49-F238E27FC236}">
-                <a16:creationId xmlns:a16="http://schemas.microsoft.com/office/drawing/2014/main" id="{7D1BEF74-5AF5-4DF4-880A-ADC2EDE4E752}"/>
+                <a16:creationId xmlns:a16="http://schemas.microsoft.com/office/drawing/2014/main" id="{B450F4DE-8F17-40A3-AA49-4DD93E986894}"/>
               </a:ext>
             </a:extLst>
           </p:cNvPr>
@@ -5527,7 +5527,7 @@
     </p:spTree>
     <p:extLst>
       <p:ext uri="{BB962C8B-B14F-4D97-AF65-F5344CB8AC3E}">
-        <p14:creationId xmlns:p14="http://schemas.microsoft.com/office/powerpoint/2010/main" val="559018357"/>
+        <p14:creationId xmlns:p14="http://schemas.microsoft.com/office/powerpoint/2010/main" val="733959173"/>
       </p:ext>
     </p:extLst>
   </p:cSld>
@@ -5558,7 +5558,7 @@
           <p:cNvPr id="17" name="">
             <a:extLst xmlns:a="http://schemas.openxmlformats.org/drawingml/2006/main">
               <a:ext uri="{FF2B5EF4-FFF2-40B4-BE49-F238E27FC236}">
-                <a16:creationId xmlns:a16="http://schemas.microsoft.com/office/drawing/2014/main" id="{319E6743-03AF-46EE-A123-BC5277600AC1}"/>
+                <a16:creationId xmlns:a16="http://schemas.microsoft.com/office/drawing/2014/main" id="{8CF80F0F-375A-4B24-A0C5-A8CBDDE1ED60}"/>
               </a:ext>
             </a:extLst>
           </p:cNvPr>
@@ -5625,7 +5625,7 @@
           <p:cNvPr id="2" name="">
             <a:extLst xmlns:a="http://schemas.openxmlformats.org/drawingml/2006/main">
               <a:ext uri="{FF2B5EF4-FFF2-40B4-BE49-F238E27FC236}">
-                <a16:creationId xmlns:a16="http://schemas.microsoft.com/office/drawing/2014/main" id="{0E5E0A98-4101-4121-B59A-D41F47249808}"/>
+                <a16:creationId xmlns:a16="http://schemas.microsoft.com/office/drawing/2014/main" id="{95F88023-8372-4D9F-AE47-A9345B2F0AF8}"/>
               </a:ext>
             </a:extLst>
           </p:cNvPr>
@@ -5692,7 +5692,7 @@
           <p:cNvPr id="3" name="">
             <a:extLst xmlns:a="http://schemas.openxmlformats.org/drawingml/2006/main">
               <a:ext uri="{FF2B5EF4-FFF2-40B4-BE49-F238E27FC236}">
-                <a16:creationId xmlns:a16="http://schemas.microsoft.com/office/drawing/2014/main" id="{A9A296B7-3458-4C32-A4AA-B18835F01475}"/>
+                <a16:creationId xmlns:a16="http://schemas.microsoft.com/office/drawing/2014/main" id="{1AFD17F5-A822-4FC5-83B8-7A3C435B8022}"/>
               </a:ext>
             </a:extLst>
           </p:cNvPr>
@@ -5759,7 +5759,7 @@
           <p:cNvPr id="4" name="">
             <a:extLst xmlns:a="http://schemas.openxmlformats.org/drawingml/2006/main">
               <a:ext uri="{FF2B5EF4-FFF2-40B4-BE49-F238E27FC236}">
-                <a16:creationId xmlns:a16="http://schemas.microsoft.com/office/drawing/2014/main" id="{F1013BEB-9F03-4C4B-8E9B-783A5CCEEB6B}"/>
+                <a16:creationId xmlns:a16="http://schemas.microsoft.com/office/drawing/2014/main" id="{F7802C5E-0670-40F2-997D-DA582BC5F085}"/>
               </a:ext>
             </a:extLst>
           </p:cNvPr>
@@ -5790,7 +5790,7 @@
           <p:cNvPr id="5" name="">
             <a:extLst xmlns:a="http://schemas.openxmlformats.org/drawingml/2006/main">
               <a:ext uri="{FF2B5EF4-FFF2-40B4-BE49-F238E27FC236}">
-                <a16:creationId xmlns:a16="http://schemas.microsoft.com/office/drawing/2014/main" id="{1E6CEA3E-86F4-47E3-935A-39DF16D29EE8}"/>
+                <a16:creationId xmlns:a16="http://schemas.microsoft.com/office/drawing/2014/main" id="{5D677A4C-05D8-406A-9A87-EBD6B2AFAC4E}"/>
               </a:ext>
             </a:extLst>
           </p:cNvPr>
@@ -5847,7 +5847,7 @@
                 <a:ea typeface="Aptos"/>
                 <a:cs typeface="Aptos"/>
               </a:rPr>
-              <a:t>INERTIA-2026-10-22-r6 · 22 October 2026 · Autonomous build</a:t>
+              <a:t>INERTIA-2026-10-23-r7 · 23 October 2026 · Autonomous build</a:t>
             </a:r>
           </a:p>
         </p:txBody>
@@ -5857,7 +5857,7 @@
           <p:cNvPr id="6" name="">
             <a:extLst xmlns:a="http://schemas.openxmlformats.org/drawingml/2006/main">
               <a:ext uri="{FF2B5EF4-FFF2-40B4-BE49-F238E27FC236}">
-                <a16:creationId xmlns:a16="http://schemas.microsoft.com/office/drawing/2014/main" id="{9B07308A-CE4F-4AC5-9B17-2DB64AEAD30B}"/>
+                <a16:creationId xmlns:a16="http://schemas.microsoft.com/office/drawing/2014/main" id="{D264DAEF-B56A-4E10-94A2-06346AE44A35}"/>
               </a:ext>
             </a:extLst>
           </p:cNvPr>
@@ -5924,7 +5924,7 @@
           <p:cNvPr id="7" name="">
             <a:extLst xmlns:a="http://schemas.openxmlformats.org/drawingml/2006/main">
               <a:ext uri="{FF2B5EF4-FFF2-40B4-BE49-F238E27FC236}">
-                <a16:creationId xmlns:a16="http://schemas.microsoft.com/office/drawing/2014/main" id="{38D3E445-5CDC-4B45-A494-8A1E92FEABCF}"/>
+                <a16:creationId xmlns:a16="http://schemas.microsoft.com/office/drawing/2014/main" id="{1DA0AE12-E67A-47B6-848C-EFBF3557132E}"/>
               </a:ext>
             </a:extLst>
           </p:cNvPr>
@@ -5957,7 +5957,7 @@
           <p:cNvPr id="8" name="">
             <a:extLst xmlns:a="http://schemas.openxmlformats.org/drawingml/2006/main">
               <a:ext uri="{FF2B5EF4-FFF2-40B4-BE49-F238E27FC236}">
-                <a16:creationId xmlns:a16="http://schemas.microsoft.com/office/drawing/2014/main" id="{6D4DD690-7815-45AC-9050-77846EBBD068}"/>
+                <a16:creationId xmlns:a16="http://schemas.microsoft.com/office/drawing/2014/main" id="{7CB359B6-55AA-467E-A1E0-849449F2DDA2}"/>
               </a:ext>
             </a:extLst>
           </p:cNvPr>
@@ -6024,7 +6024,7 @@
           <p:cNvPr id="9" name="">
             <a:extLst xmlns:a="http://schemas.openxmlformats.org/drawingml/2006/main">
               <a:ext uri="{FF2B5EF4-FFF2-40B4-BE49-F238E27FC236}">
-                <a16:creationId xmlns:a16="http://schemas.microsoft.com/office/drawing/2014/main" id="{4E5587FC-D2CE-4C8A-AB54-900FC19A45D0}"/>
+                <a16:creationId xmlns:a16="http://schemas.microsoft.com/office/drawing/2014/main" id="{35525060-F203-465B-804A-C4F0859369D1}"/>
               </a:ext>
             </a:extLst>
           </p:cNvPr>
@@ -6160,7 +6160,7 @@
           <p:cNvPr id="10" name="">
             <a:extLst xmlns:a="http://schemas.openxmlformats.org/drawingml/2006/main">
               <a:ext uri="{FF2B5EF4-FFF2-40B4-BE49-F238E27FC236}">
-                <a16:creationId xmlns:a16="http://schemas.microsoft.com/office/drawing/2014/main" id="{680E04DA-B97B-4FCB-A922-EDB04BE4B8F8}"/>
+                <a16:creationId xmlns:a16="http://schemas.microsoft.com/office/drawing/2014/main" id="{E2A8BDE7-EB9F-484E-B8C4-5C7DD6286A49}"/>
               </a:ext>
             </a:extLst>
           </p:cNvPr>
@@ -6193,7 +6193,7 @@
           <p:cNvPr id="11" name="">
             <a:extLst xmlns:a="http://schemas.openxmlformats.org/drawingml/2006/main">
               <a:ext uri="{FF2B5EF4-FFF2-40B4-BE49-F238E27FC236}">
-                <a16:creationId xmlns:a16="http://schemas.microsoft.com/office/drawing/2014/main" id="{542D52CC-DEE8-483A-ABCC-CF7591802FEF}"/>
+                <a16:creationId xmlns:a16="http://schemas.microsoft.com/office/drawing/2014/main" id="{EEE638D8-CD51-41FA-B258-DD582E92B9C7}"/>
               </a:ext>
             </a:extLst>
           </p:cNvPr>
@@ -6260,7 +6260,7 @@
           <p:cNvPr id="12" name="">
             <a:extLst xmlns:a="http://schemas.openxmlformats.org/drawingml/2006/main">
               <a:ext uri="{FF2B5EF4-FFF2-40B4-BE49-F238E27FC236}">
-                <a16:creationId xmlns:a16="http://schemas.microsoft.com/office/drawing/2014/main" id="{AAAE2A79-0B08-464E-94C2-934ED636ABF7}"/>
+                <a16:creationId xmlns:a16="http://schemas.microsoft.com/office/drawing/2014/main" id="{BC9D344B-EE5B-4FE6-961D-BBCE8E8F592F}"/>
               </a:ext>
             </a:extLst>
           </p:cNvPr>
@@ -6396,7 +6396,7 @@
           <p:cNvPr id="13" name="">
             <a:extLst xmlns:a="http://schemas.openxmlformats.org/drawingml/2006/main">
               <a:ext uri="{FF2B5EF4-FFF2-40B4-BE49-F238E27FC236}">
-                <a16:creationId xmlns:a16="http://schemas.microsoft.com/office/drawing/2014/main" id="{1C019A24-69A3-416A-907D-87F0F7460D76}"/>
+                <a16:creationId xmlns:a16="http://schemas.microsoft.com/office/drawing/2014/main" id="{39675A13-9C7C-400A-9B51-0C8CE7965117}"/>
               </a:ext>
             </a:extLst>
           </p:cNvPr>
@@ -6429,7 +6429,7 @@
           <p:cNvPr id="14" name="">
             <a:extLst xmlns:a="http://schemas.openxmlformats.org/drawingml/2006/main">
               <a:ext uri="{FF2B5EF4-FFF2-40B4-BE49-F238E27FC236}">
-                <a16:creationId xmlns:a16="http://schemas.microsoft.com/office/drawing/2014/main" id="{92B17FEF-C16B-4B76-9439-AC8CAD19F4CB}"/>
+                <a16:creationId xmlns:a16="http://schemas.microsoft.com/office/drawing/2014/main" id="{36561293-C6F2-470F-85CC-5CE76B44E89D}"/>
               </a:ext>
             </a:extLst>
           </p:cNvPr>
@@ -6496,7 +6496,7 @@
           <p:cNvPr id="15" name="">
             <a:extLst xmlns:a="http://schemas.openxmlformats.org/drawingml/2006/main">
               <a:ext uri="{FF2B5EF4-FFF2-40B4-BE49-F238E27FC236}">
-                <a16:creationId xmlns:a16="http://schemas.microsoft.com/office/drawing/2014/main" id="{DC91D38A-A662-46F7-83F6-E54B15781712}"/>
+                <a16:creationId xmlns:a16="http://schemas.microsoft.com/office/drawing/2014/main" id="{E03254B7-D753-4857-8759-D4058038D82C}"/>
               </a:ext>
             </a:extLst>
           </p:cNvPr>
@@ -6632,7 +6632,7 @@
           <p:cNvPr id="16" name="">
             <a:extLst xmlns:a="http://schemas.openxmlformats.org/drawingml/2006/main">
               <a:ext uri="{FF2B5EF4-FFF2-40B4-BE49-F238E27FC236}">
-                <a16:creationId xmlns:a16="http://schemas.microsoft.com/office/drawing/2014/main" id="{B5B2587C-D93F-449E-86C7-87C9C2922318}"/>
+                <a16:creationId xmlns:a16="http://schemas.microsoft.com/office/drawing/2014/main" id="{49CF7F52-762A-48D1-B7F9-0D46C2049BF9}"/>
               </a:ext>
             </a:extLst>
           </p:cNvPr>
@@ -6697,7 +6697,7 @@
     </p:spTree>
     <p:extLst>
       <p:ext uri="{BB962C8B-B14F-4D97-AF65-F5344CB8AC3E}">
-        <p14:creationId xmlns:p14="http://schemas.microsoft.com/office/powerpoint/2010/main" val="2074361515"/>
+        <p14:creationId xmlns:p14="http://schemas.microsoft.com/office/powerpoint/2010/main" val="324729755"/>
       </p:ext>
     </p:extLst>
   </p:cSld>
@@ -6728,7 +6728,7 @@
           <p:cNvPr id="17" name="">
             <a:extLst xmlns:a="http://schemas.openxmlformats.org/drawingml/2006/main">
               <a:ext uri="{FF2B5EF4-FFF2-40B4-BE49-F238E27FC236}">
-                <a16:creationId xmlns:a16="http://schemas.microsoft.com/office/drawing/2014/main" id="{FC4E56A8-E93D-4BF6-91D3-307368775853}"/>
+                <a16:creationId xmlns:a16="http://schemas.microsoft.com/office/drawing/2014/main" id="{01DC6921-6E3D-49C1-B77F-EBE2BB3AFB24}"/>
               </a:ext>
             </a:extLst>
           </p:cNvPr>
@@ -6795,7 +6795,7 @@
           <p:cNvPr id="2" name="">
             <a:extLst xmlns:a="http://schemas.openxmlformats.org/drawingml/2006/main">
               <a:ext uri="{FF2B5EF4-FFF2-40B4-BE49-F238E27FC236}">
-                <a16:creationId xmlns:a16="http://schemas.microsoft.com/office/drawing/2014/main" id="{48FBF5F0-28E8-4CB1-9871-8468B4979FFF}"/>
+                <a16:creationId xmlns:a16="http://schemas.microsoft.com/office/drawing/2014/main" id="{5DE53B3B-1E11-495E-98FC-DE65910F8C64}"/>
               </a:ext>
             </a:extLst>
           </p:cNvPr>
@@ -6862,7 +6862,7 @@
           <p:cNvPr id="3" name="">
             <a:extLst xmlns:a="http://schemas.openxmlformats.org/drawingml/2006/main">
               <a:ext uri="{FF2B5EF4-FFF2-40B4-BE49-F238E27FC236}">
-                <a16:creationId xmlns:a16="http://schemas.microsoft.com/office/drawing/2014/main" id="{647085AC-D644-425E-A57D-0D58449A4281}"/>
+                <a16:creationId xmlns:a16="http://schemas.microsoft.com/office/drawing/2014/main" id="{59C4734B-514E-419D-B2F6-3847209B9083}"/>
               </a:ext>
             </a:extLst>
           </p:cNvPr>
@@ -6929,7 +6929,7 @@
           <p:cNvPr id="4" name="">
             <a:extLst xmlns:a="http://schemas.openxmlformats.org/drawingml/2006/main">
               <a:ext uri="{FF2B5EF4-FFF2-40B4-BE49-F238E27FC236}">
-                <a16:creationId xmlns:a16="http://schemas.microsoft.com/office/drawing/2014/main" id="{7302BBE7-D64F-42D4-AB77-AB310598A6F3}"/>
+                <a16:creationId xmlns:a16="http://schemas.microsoft.com/office/drawing/2014/main" id="{4513E10F-7FD3-4729-9EE8-9302C9B66AFA}"/>
               </a:ext>
             </a:extLst>
           </p:cNvPr>
@@ -6960,7 +6960,7 @@
           <p:cNvPr id="5" name="">
             <a:extLst xmlns:a="http://schemas.openxmlformats.org/drawingml/2006/main">
               <a:ext uri="{FF2B5EF4-FFF2-40B4-BE49-F238E27FC236}">
-                <a16:creationId xmlns:a16="http://schemas.microsoft.com/office/drawing/2014/main" id="{37EA21DC-01D7-4BAB-A59D-12DE4B2AEB9A}"/>
+                <a16:creationId xmlns:a16="http://schemas.microsoft.com/office/drawing/2014/main" id="{03124CB6-7559-4A83-AB54-CCD1EA6215AC}"/>
               </a:ext>
             </a:extLst>
           </p:cNvPr>
@@ -7017,7 +7017,7 @@
                 <a:ea typeface="Aptos"/>
                 <a:cs typeface="Aptos"/>
               </a:rPr>
-              <a:t>INERTIA-2026-10-22-r6 · 22 October 2026 · Autonomous build</a:t>
+              <a:t>INERTIA-2026-10-23-r7 · 23 October 2026 · Autonomous build</a:t>
             </a:r>
           </a:p>
         </p:txBody>
@@ -7027,7 +7027,7 @@
           <p:cNvPr id="6" name="">
             <a:extLst xmlns:a="http://schemas.openxmlformats.org/drawingml/2006/main">
               <a:ext uri="{FF2B5EF4-FFF2-40B4-BE49-F238E27FC236}">
-                <a16:creationId xmlns:a16="http://schemas.microsoft.com/office/drawing/2014/main" id="{6E8372E9-7FE1-47FF-8D84-627DB2AE462E}"/>
+                <a16:creationId xmlns:a16="http://schemas.microsoft.com/office/drawing/2014/main" id="{9F55A98B-27B7-4926-82D6-0B633EC78C76}"/>
               </a:ext>
             </a:extLst>
           </p:cNvPr>
@@ -7094,7 +7094,7 @@
           <p:cNvPr id="7" name="">
             <a:extLst xmlns:a="http://schemas.openxmlformats.org/drawingml/2006/main">
               <a:ext uri="{FF2B5EF4-FFF2-40B4-BE49-F238E27FC236}">
-                <a16:creationId xmlns:a16="http://schemas.microsoft.com/office/drawing/2014/main" id="{61D71157-418A-4879-AD0A-2DCEFBCA6EE5}"/>
+                <a16:creationId xmlns:a16="http://schemas.microsoft.com/office/drawing/2014/main" id="{C989028D-C5A1-44AC-98B9-F522566AB8F3}"/>
               </a:ext>
             </a:extLst>
           </p:cNvPr>
@@ -7127,7 +7127,7 @@
           <p:cNvPr id="8" name="">
             <a:extLst xmlns:a="http://schemas.openxmlformats.org/drawingml/2006/main">
               <a:ext uri="{FF2B5EF4-FFF2-40B4-BE49-F238E27FC236}">
-                <a16:creationId xmlns:a16="http://schemas.microsoft.com/office/drawing/2014/main" id="{37C46F52-B48E-41BA-9C5D-0A7A16DF257E}"/>
+                <a16:creationId xmlns:a16="http://schemas.microsoft.com/office/drawing/2014/main" id="{06929054-E808-44A2-BA67-FD4F1878760E}"/>
               </a:ext>
             </a:extLst>
           </p:cNvPr>
@@ -7194,7 +7194,7 @@
           <p:cNvPr id="9" name="">
             <a:extLst xmlns:a="http://schemas.openxmlformats.org/drawingml/2006/main">
               <a:ext uri="{FF2B5EF4-FFF2-40B4-BE49-F238E27FC236}">
-                <a16:creationId xmlns:a16="http://schemas.microsoft.com/office/drawing/2014/main" id="{7A33A761-3DFA-4BB5-8F6C-B2059421A66B}"/>
+                <a16:creationId xmlns:a16="http://schemas.microsoft.com/office/drawing/2014/main" id="{99361BDF-B9DB-47A2-BDBE-C6CBEC1C22C3}"/>
               </a:ext>
             </a:extLst>
           </p:cNvPr>
@@ -7330,7 +7330,7 @@
           <p:cNvPr id="10" name="">
             <a:extLst xmlns:a="http://schemas.openxmlformats.org/drawingml/2006/main">
               <a:ext uri="{FF2B5EF4-FFF2-40B4-BE49-F238E27FC236}">
-                <a16:creationId xmlns:a16="http://schemas.microsoft.com/office/drawing/2014/main" id="{1A78F3C7-4E5E-4CEE-AE48-F92FA04D6398}"/>
+                <a16:creationId xmlns:a16="http://schemas.microsoft.com/office/drawing/2014/main" id="{B14E1725-29FC-492E-9F4D-3E5CEFAE2B58}"/>
               </a:ext>
             </a:extLst>
           </p:cNvPr>
@@ -7363,7 +7363,7 @@
           <p:cNvPr id="11" name="">
             <a:extLst xmlns:a="http://schemas.openxmlformats.org/drawingml/2006/main">
               <a:ext uri="{FF2B5EF4-FFF2-40B4-BE49-F238E27FC236}">
-                <a16:creationId xmlns:a16="http://schemas.microsoft.com/office/drawing/2014/main" id="{23174286-6403-46E8-B0CE-D480B04AF43C}"/>
+                <a16:creationId xmlns:a16="http://schemas.microsoft.com/office/drawing/2014/main" id="{F5B617B6-2AAB-454B-933E-8788E506B26A}"/>
               </a:ext>
             </a:extLst>
           </p:cNvPr>
@@ -7430,7 +7430,7 @@
           <p:cNvPr id="12" name="">
             <a:extLst xmlns:a="http://schemas.openxmlformats.org/drawingml/2006/main">
               <a:ext uri="{FF2B5EF4-FFF2-40B4-BE49-F238E27FC236}">
-                <a16:creationId xmlns:a16="http://schemas.microsoft.com/office/drawing/2014/main" id="{2623B582-C87C-4427-B28D-C6416FA4E166}"/>
+                <a16:creationId xmlns:a16="http://schemas.microsoft.com/office/drawing/2014/main" id="{E7680E9C-7E60-44E0-8F0F-585CC9AE416D}"/>
               </a:ext>
             </a:extLst>
           </p:cNvPr>
@@ -7566,7 +7566,7 @@
           <p:cNvPr id="13" name="">
             <a:extLst xmlns:a="http://schemas.openxmlformats.org/drawingml/2006/main">
               <a:ext uri="{FF2B5EF4-FFF2-40B4-BE49-F238E27FC236}">
-                <a16:creationId xmlns:a16="http://schemas.microsoft.com/office/drawing/2014/main" id="{EECDE4C2-8AA6-40DB-B988-7CF7DCBB1242}"/>
+                <a16:creationId xmlns:a16="http://schemas.microsoft.com/office/drawing/2014/main" id="{442DE98C-7B7F-4898-B100-6BF8B9074F78}"/>
               </a:ext>
             </a:extLst>
           </p:cNvPr>
@@ -7599,7 +7599,7 @@
           <p:cNvPr id="14" name="">
             <a:extLst xmlns:a="http://schemas.openxmlformats.org/drawingml/2006/main">
               <a:ext uri="{FF2B5EF4-FFF2-40B4-BE49-F238E27FC236}">
-                <a16:creationId xmlns:a16="http://schemas.microsoft.com/office/drawing/2014/main" id="{57B3BFD3-5B6A-45B8-A51E-B0CE4B3A5C79}"/>
+                <a16:creationId xmlns:a16="http://schemas.microsoft.com/office/drawing/2014/main" id="{100CDD26-91C4-46B0-9C01-515EB159A4CC}"/>
               </a:ext>
             </a:extLst>
           </p:cNvPr>
@@ -7666,7 +7666,7 @@
           <p:cNvPr id="15" name="">
             <a:extLst xmlns:a="http://schemas.openxmlformats.org/drawingml/2006/main">
               <a:ext uri="{FF2B5EF4-FFF2-40B4-BE49-F238E27FC236}">
-                <a16:creationId xmlns:a16="http://schemas.microsoft.com/office/drawing/2014/main" id="{AA83E20B-5C82-4BE8-B9E5-C4F9F6EB5B1D}"/>
+                <a16:creationId xmlns:a16="http://schemas.microsoft.com/office/drawing/2014/main" id="{D0D245FA-627E-4331-B5DF-B8E13DC0CD8A}"/>
               </a:ext>
             </a:extLst>
           </p:cNvPr>
@@ -7802,7 +7802,7 @@
           <p:cNvPr id="16" name="">
             <a:extLst xmlns:a="http://schemas.openxmlformats.org/drawingml/2006/main">
               <a:ext uri="{FF2B5EF4-FFF2-40B4-BE49-F238E27FC236}">
-                <a16:creationId xmlns:a16="http://schemas.microsoft.com/office/drawing/2014/main" id="{B42FF771-3120-4382-863F-6D88BFDCA3EE}"/>
+                <a16:creationId xmlns:a16="http://schemas.microsoft.com/office/drawing/2014/main" id="{8C918133-2949-4E57-B0E4-632E9309C7C9}"/>
               </a:ext>
             </a:extLst>
           </p:cNvPr>
@@ -7867,7 +7867,7 @@
     </p:spTree>
     <p:extLst>
       <p:ext uri="{BB962C8B-B14F-4D97-AF65-F5344CB8AC3E}">
-        <p14:creationId xmlns:p14="http://schemas.microsoft.com/office/powerpoint/2010/main" val="1242149921"/>
+        <p14:creationId xmlns:p14="http://schemas.microsoft.com/office/powerpoint/2010/main" val="321599319"/>
       </p:ext>
     </p:extLst>
   </p:cSld>
@@ -7898,7 +7898,7 @@
           <p:cNvPr id="17" name="">
             <a:extLst xmlns:a="http://schemas.openxmlformats.org/drawingml/2006/main">
               <a:ext uri="{FF2B5EF4-FFF2-40B4-BE49-F238E27FC236}">
-                <a16:creationId xmlns:a16="http://schemas.microsoft.com/office/drawing/2014/main" id="{536211E4-D234-458A-B578-6151D91E2371}"/>
+                <a16:creationId xmlns:a16="http://schemas.microsoft.com/office/drawing/2014/main" id="{ED2DC141-D254-4DE5-BD71-76EF407D31E2}"/>
               </a:ext>
             </a:extLst>
           </p:cNvPr>
@@ -7965,7 +7965,7 @@
           <p:cNvPr id="2" name="">
             <a:extLst xmlns:a="http://schemas.openxmlformats.org/drawingml/2006/main">
               <a:ext uri="{FF2B5EF4-FFF2-40B4-BE49-F238E27FC236}">
-                <a16:creationId xmlns:a16="http://schemas.microsoft.com/office/drawing/2014/main" id="{12FB7133-0C95-4B40-A558-1916441DF763}"/>
+                <a16:creationId xmlns:a16="http://schemas.microsoft.com/office/drawing/2014/main" id="{D9D038F5-85DB-4E70-BD88-0E1621BEE5A8}"/>
               </a:ext>
             </a:extLst>
           </p:cNvPr>
@@ -8032,7 +8032,7 @@
           <p:cNvPr id="3" name="">
             <a:extLst xmlns:a="http://schemas.openxmlformats.org/drawingml/2006/main">
               <a:ext uri="{FF2B5EF4-FFF2-40B4-BE49-F238E27FC236}">
-                <a16:creationId xmlns:a16="http://schemas.microsoft.com/office/drawing/2014/main" id="{725CA979-ACCF-4D4D-BDA9-2D9208745412}"/>
+                <a16:creationId xmlns:a16="http://schemas.microsoft.com/office/drawing/2014/main" id="{BC184259-C62C-402F-B013-77FA9FEE6B7B}"/>
               </a:ext>
             </a:extLst>
           </p:cNvPr>
@@ -8099,7 +8099,7 @@
           <p:cNvPr id="4" name="">
             <a:extLst xmlns:a="http://schemas.openxmlformats.org/drawingml/2006/main">
               <a:ext uri="{FF2B5EF4-FFF2-40B4-BE49-F238E27FC236}">
-                <a16:creationId xmlns:a16="http://schemas.microsoft.com/office/drawing/2014/main" id="{E6198B50-92B1-41C2-BF0F-E134EECB77C4}"/>
+                <a16:creationId xmlns:a16="http://schemas.microsoft.com/office/drawing/2014/main" id="{F990F645-E639-4397-8E4F-03F21AAC0720}"/>
               </a:ext>
             </a:extLst>
           </p:cNvPr>
@@ -8130,7 +8130,7 @@
           <p:cNvPr id="5" name="">
             <a:extLst xmlns:a="http://schemas.openxmlformats.org/drawingml/2006/main">
               <a:ext uri="{FF2B5EF4-FFF2-40B4-BE49-F238E27FC236}">
-                <a16:creationId xmlns:a16="http://schemas.microsoft.com/office/drawing/2014/main" id="{5C5D66A7-A791-47FC-AADD-968044D0F32C}"/>
+                <a16:creationId xmlns:a16="http://schemas.microsoft.com/office/drawing/2014/main" id="{2CC7AEBB-DCFB-45C7-85E3-8FD384A7CDFF}"/>
               </a:ext>
             </a:extLst>
           </p:cNvPr>
@@ -8187,7 +8187,7 @@
                 <a:ea typeface="Aptos"/>
                 <a:cs typeface="Aptos"/>
               </a:rPr>
-              <a:t>INERTIA-2026-10-22-r6 · 22 October 2026 · Autonomous build</a:t>
+              <a:t>INERTIA-2026-10-23-r7 · 23 October 2026 · Autonomous build</a:t>
             </a:r>
           </a:p>
         </p:txBody>
@@ -8197,7 +8197,7 @@
           <p:cNvPr id="6" name="">
             <a:extLst xmlns:a="http://schemas.openxmlformats.org/drawingml/2006/main">
               <a:ext uri="{FF2B5EF4-FFF2-40B4-BE49-F238E27FC236}">
-                <a16:creationId xmlns:a16="http://schemas.microsoft.com/office/drawing/2014/main" id="{1A48AE7C-4502-41EC-A036-EBB8C1EFF160}"/>
+                <a16:creationId xmlns:a16="http://schemas.microsoft.com/office/drawing/2014/main" id="{BB1CBF1F-B28A-49CC-8A5C-0435571F040E}"/>
               </a:ext>
             </a:extLst>
           </p:cNvPr>
@@ -8264,7 +8264,7 @@
           <p:cNvPr id="7" name="">
             <a:extLst xmlns:a="http://schemas.openxmlformats.org/drawingml/2006/main">
               <a:ext uri="{FF2B5EF4-FFF2-40B4-BE49-F238E27FC236}">
-                <a16:creationId xmlns:a16="http://schemas.microsoft.com/office/drawing/2014/main" id="{46AEB412-1793-4D76-8880-420EAE6B4C4A}"/>
+                <a16:creationId xmlns:a16="http://schemas.microsoft.com/office/drawing/2014/main" id="{E3486E29-1A85-4932-A63A-EF2E664E9016}"/>
               </a:ext>
             </a:extLst>
           </p:cNvPr>
@@ -8297,7 +8297,7 @@
           <p:cNvPr id="8" name="">
             <a:extLst xmlns:a="http://schemas.openxmlformats.org/drawingml/2006/main">
               <a:ext uri="{FF2B5EF4-FFF2-40B4-BE49-F238E27FC236}">
-                <a16:creationId xmlns:a16="http://schemas.microsoft.com/office/drawing/2014/main" id="{AB915837-2254-47DA-8A79-0B276DF698AF}"/>
+                <a16:creationId xmlns:a16="http://schemas.microsoft.com/office/drawing/2014/main" id="{BD91FFC3-388A-4CC5-AC05-690B1E24E1BE}"/>
               </a:ext>
             </a:extLst>
           </p:cNvPr>
@@ -8364,7 +8364,7 @@
           <p:cNvPr id="9" name="">
             <a:extLst xmlns:a="http://schemas.openxmlformats.org/drawingml/2006/main">
               <a:ext uri="{FF2B5EF4-FFF2-40B4-BE49-F238E27FC236}">
-                <a16:creationId xmlns:a16="http://schemas.microsoft.com/office/drawing/2014/main" id="{CB7F8E25-211A-4D1A-9D69-13414168C874}"/>
+                <a16:creationId xmlns:a16="http://schemas.microsoft.com/office/drawing/2014/main" id="{1D9C9603-C241-411B-AEE8-D90AB526881E}"/>
               </a:ext>
             </a:extLst>
           </p:cNvPr>
@@ -8500,7 +8500,7 @@
           <p:cNvPr id="10" name="">
             <a:extLst xmlns:a="http://schemas.openxmlformats.org/drawingml/2006/main">
               <a:ext uri="{FF2B5EF4-FFF2-40B4-BE49-F238E27FC236}">
-                <a16:creationId xmlns:a16="http://schemas.microsoft.com/office/drawing/2014/main" id="{41083009-1B2E-4505-B370-7E58503D615F}"/>
+                <a16:creationId xmlns:a16="http://schemas.microsoft.com/office/drawing/2014/main" id="{B450DD4D-0C59-4A75-BA62-4B2317A1EC59}"/>
               </a:ext>
             </a:extLst>
           </p:cNvPr>
@@ -8533,7 +8533,7 @@
           <p:cNvPr id="11" name="">
             <a:extLst xmlns:a="http://schemas.openxmlformats.org/drawingml/2006/main">
               <a:ext uri="{FF2B5EF4-FFF2-40B4-BE49-F238E27FC236}">
-                <a16:creationId xmlns:a16="http://schemas.microsoft.com/office/drawing/2014/main" id="{7D2B6383-E041-412D-8AB2-70E73D0CDEBA}"/>
+                <a16:creationId xmlns:a16="http://schemas.microsoft.com/office/drawing/2014/main" id="{47920630-DC1C-44FD-A160-DA26F896F7DF}"/>
               </a:ext>
             </a:extLst>
           </p:cNvPr>
@@ -8600,7 +8600,7 @@
           <p:cNvPr id="12" name="">
             <a:extLst xmlns:a="http://schemas.openxmlformats.org/drawingml/2006/main">
               <a:ext uri="{FF2B5EF4-FFF2-40B4-BE49-F238E27FC236}">
-                <a16:creationId xmlns:a16="http://schemas.microsoft.com/office/drawing/2014/main" id="{424591E1-06DB-4383-A7FB-0097C6C08745}"/>
+                <a16:creationId xmlns:a16="http://schemas.microsoft.com/office/drawing/2014/main" id="{7BB76621-66CA-4E7C-8B68-2BBADF10107C}"/>
               </a:ext>
             </a:extLst>
           </p:cNvPr>
@@ -8736,7 +8736,7 @@
           <p:cNvPr id="13" name="">
             <a:extLst xmlns:a="http://schemas.openxmlformats.org/drawingml/2006/main">
               <a:ext uri="{FF2B5EF4-FFF2-40B4-BE49-F238E27FC236}">
-                <a16:creationId xmlns:a16="http://schemas.microsoft.com/office/drawing/2014/main" id="{CBAF23CF-14FD-40C7-BEE2-1B0894CA12DD}"/>
+                <a16:creationId xmlns:a16="http://schemas.microsoft.com/office/drawing/2014/main" id="{7537C6E8-5FDC-4695-A315-C5F042ABBD8B}"/>
               </a:ext>
             </a:extLst>
           </p:cNvPr>
@@ -8769,7 +8769,7 @@
           <p:cNvPr id="14" name="">
             <a:extLst xmlns:a="http://schemas.openxmlformats.org/drawingml/2006/main">
               <a:ext uri="{FF2B5EF4-FFF2-40B4-BE49-F238E27FC236}">
-                <a16:creationId xmlns:a16="http://schemas.microsoft.com/office/drawing/2014/main" id="{0EF6E3C3-8538-407D-8323-0B92B83E7700}"/>
+                <a16:creationId xmlns:a16="http://schemas.microsoft.com/office/drawing/2014/main" id="{99B727E6-9693-45B3-A114-23FF70516691}"/>
               </a:ext>
             </a:extLst>
           </p:cNvPr>
@@ -8836,7 +8836,7 @@
           <p:cNvPr id="15" name="">
             <a:extLst xmlns:a="http://schemas.openxmlformats.org/drawingml/2006/main">
               <a:ext uri="{FF2B5EF4-FFF2-40B4-BE49-F238E27FC236}">
-                <a16:creationId xmlns:a16="http://schemas.microsoft.com/office/drawing/2014/main" id="{7472C7BA-02D4-41A2-AD17-667D5D2DDB05}"/>
+                <a16:creationId xmlns:a16="http://schemas.microsoft.com/office/drawing/2014/main" id="{CA1D98ED-45D6-476F-A6A0-17312C98205F}"/>
               </a:ext>
             </a:extLst>
           </p:cNvPr>
@@ -8972,7 +8972,7 @@
           <p:cNvPr id="16" name="">
             <a:extLst xmlns:a="http://schemas.openxmlformats.org/drawingml/2006/main">
               <a:ext uri="{FF2B5EF4-FFF2-40B4-BE49-F238E27FC236}">
-                <a16:creationId xmlns:a16="http://schemas.microsoft.com/office/drawing/2014/main" id="{3B3E80F0-9A88-48A2-A43F-ABA3D488D308}"/>
+                <a16:creationId xmlns:a16="http://schemas.microsoft.com/office/drawing/2014/main" id="{7C3EEFB9-D08E-4A71-8ACE-A5F9A402742C}"/>
               </a:ext>
             </a:extLst>
           </p:cNvPr>
@@ -9037,7 +9037,7 @@
     </p:spTree>
     <p:extLst>
       <p:ext uri="{BB962C8B-B14F-4D97-AF65-F5344CB8AC3E}">
-        <p14:creationId xmlns:p14="http://schemas.microsoft.com/office/powerpoint/2010/main" val="1143166186"/>
+        <p14:creationId xmlns:p14="http://schemas.microsoft.com/office/powerpoint/2010/main" val="2123739644"/>
       </p:ext>
     </p:extLst>
   </p:cSld>
@@ -9068,7 +9068,7 @@
           <p:cNvPr id="17" name="">
             <a:extLst xmlns:a="http://schemas.openxmlformats.org/drawingml/2006/main">
               <a:ext uri="{FF2B5EF4-FFF2-40B4-BE49-F238E27FC236}">
-                <a16:creationId xmlns:a16="http://schemas.microsoft.com/office/drawing/2014/main" id="{E8BFF74A-1AD1-4C6B-BD01-419D45C73820}"/>
+                <a16:creationId xmlns:a16="http://schemas.microsoft.com/office/drawing/2014/main" id="{B3B4703C-6380-4DB5-9C85-7BF843F514F7}"/>
               </a:ext>
             </a:extLst>
           </p:cNvPr>
@@ -9135,7 +9135,7 @@
           <p:cNvPr id="2" name="">
             <a:extLst xmlns:a="http://schemas.openxmlformats.org/drawingml/2006/main">
               <a:ext uri="{FF2B5EF4-FFF2-40B4-BE49-F238E27FC236}">
-                <a16:creationId xmlns:a16="http://schemas.microsoft.com/office/drawing/2014/main" id="{230A7959-6D24-4DD6-B1B5-C19B68B9EB8D}"/>
+                <a16:creationId xmlns:a16="http://schemas.microsoft.com/office/drawing/2014/main" id="{A471F36B-5B6B-47F9-A74C-9F87BE678B7C}"/>
               </a:ext>
             </a:extLst>
           </p:cNvPr>
@@ -9202,7 +9202,7 @@
           <p:cNvPr id="3" name="">
             <a:extLst xmlns:a="http://schemas.openxmlformats.org/drawingml/2006/main">
               <a:ext uri="{FF2B5EF4-FFF2-40B4-BE49-F238E27FC236}">
-                <a16:creationId xmlns:a16="http://schemas.microsoft.com/office/drawing/2014/main" id="{EFF4F7FF-0C2A-4EC3-BCF8-F41024202C2B}"/>
+                <a16:creationId xmlns:a16="http://schemas.microsoft.com/office/drawing/2014/main" id="{9AF09CB2-CCE7-43D8-B3F9-7B85C37BBD84}"/>
               </a:ext>
             </a:extLst>
           </p:cNvPr>
@@ -9269,7 +9269,7 @@
           <p:cNvPr id="4" name="">
             <a:extLst xmlns:a="http://schemas.openxmlformats.org/drawingml/2006/main">
               <a:ext uri="{FF2B5EF4-FFF2-40B4-BE49-F238E27FC236}">
-                <a16:creationId xmlns:a16="http://schemas.microsoft.com/office/drawing/2014/main" id="{C2793082-B249-4DC4-8471-1FAF88E7F6B0}"/>
+                <a16:creationId xmlns:a16="http://schemas.microsoft.com/office/drawing/2014/main" id="{CE780204-1B19-43AA-9A69-460FA2652455}"/>
               </a:ext>
             </a:extLst>
           </p:cNvPr>
@@ -9300,7 +9300,7 @@
           <p:cNvPr id="5" name="">
             <a:extLst xmlns:a="http://schemas.openxmlformats.org/drawingml/2006/main">
               <a:ext uri="{FF2B5EF4-FFF2-40B4-BE49-F238E27FC236}">
-                <a16:creationId xmlns:a16="http://schemas.microsoft.com/office/drawing/2014/main" id="{9170EF64-F932-411E-8306-4801C24BF409}"/>
+                <a16:creationId xmlns:a16="http://schemas.microsoft.com/office/drawing/2014/main" id="{0235216B-9D63-4B73-BB56-B68EBBBFACC0}"/>
               </a:ext>
             </a:extLst>
           </p:cNvPr>
@@ -9357,7 +9357,7 @@
                 <a:ea typeface="Aptos"/>
                 <a:cs typeface="Aptos"/>
               </a:rPr>
-              <a:t>INERTIA-2026-10-22-r6 · 22 October 2026 · Autonomous build</a:t>
+              <a:t>INERTIA-2026-10-23-r7 · 23 October 2026 · Autonomous build</a:t>
             </a:r>
           </a:p>
         </p:txBody>
@@ -9367,7 +9367,7 @@
           <p:cNvPr id="6" name="">
             <a:extLst xmlns:a="http://schemas.openxmlformats.org/drawingml/2006/main">
               <a:ext uri="{FF2B5EF4-FFF2-40B4-BE49-F238E27FC236}">
-                <a16:creationId xmlns:a16="http://schemas.microsoft.com/office/drawing/2014/main" id="{B9B040D9-DFD2-43A0-B283-F6C92C8B651E}"/>
+                <a16:creationId xmlns:a16="http://schemas.microsoft.com/office/drawing/2014/main" id="{1859E5AC-3CE7-4068-86F1-41FE801FCB43}"/>
               </a:ext>
             </a:extLst>
           </p:cNvPr>
@@ -9434,7 +9434,7 @@
           <p:cNvPr id="7" name="">
             <a:extLst xmlns:a="http://schemas.openxmlformats.org/drawingml/2006/main">
               <a:ext uri="{FF2B5EF4-FFF2-40B4-BE49-F238E27FC236}">
-                <a16:creationId xmlns:a16="http://schemas.microsoft.com/office/drawing/2014/main" id="{9ED3A75D-EB6A-4B80-B076-2247FB90597E}"/>
+                <a16:creationId xmlns:a16="http://schemas.microsoft.com/office/drawing/2014/main" id="{D4C981A4-6F99-47F3-A096-2CD9D2DA7B57}"/>
               </a:ext>
             </a:extLst>
           </p:cNvPr>
@@ -9467,7 +9467,7 @@
           <p:cNvPr id="8" name="">
             <a:extLst xmlns:a="http://schemas.openxmlformats.org/drawingml/2006/main">
               <a:ext uri="{FF2B5EF4-FFF2-40B4-BE49-F238E27FC236}">
-                <a16:creationId xmlns:a16="http://schemas.microsoft.com/office/drawing/2014/main" id="{B4FF6F3B-F4F9-4584-B905-4DE2B777090D}"/>
+                <a16:creationId xmlns:a16="http://schemas.microsoft.com/office/drawing/2014/main" id="{58CD9F90-2BB7-493A-A78A-12BBC740E41D}"/>
               </a:ext>
             </a:extLst>
           </p:cNvPr>
@@ -9534,7 +9534,7 @@
           <p:cNvPr id="9" name="">
             <a:extLst xmlns:a="http://schemas.openxmlformats.org/drawingml/2006/main">
               <a:ext uri="{FF2B5EF4-FFF2-40B4-BE49-F238E27FC236}">
-                <a16:creationId xmlns:a16="http://schemas.microsoft.com/office/drawing/2014/main" id="{6B1382C3-5A6C-4D06-9556-6809EE8439CF}"/>
+                <a16:creationId xmlns:a16="http://schemas.microsoft.com/office/drawing/2014/main" id="{EFF0F005-C273-4DA2-8A52-7200348FA2B3}"/>
               </a:ext>
             </a:extLst>
           </p:cNvPr>
@@ -9591,7 +9591,7 @@
                 <a:ea typeface="Aptos"/>
                 <a:cs typeface="Aptos"/>
               </a:rPr>
-              <a:t>Admit the plugin and provider</a:t>
+              <a:t>Install verified archive</a:t>
             </a:r>
           </a:p>
           <a:p xmlns:a="http://schemas.openxmlformats.org/drawingml/2006/main">
@@ -9614,7 +9614,7 @@
                 <a:ea typeface="Aptos"/>
                 <a:cs typeface="Aptos"/>
               </a:rPr>
-              <a:t>Bind company, channel and task</a:t>
+              <a:t>Use Node 24.11 or newer</a:t>
             </a:r>
           </a:p>
           <a:p xmlns:a="http://schemas.openxmlformats.org/drawingml/2006/main">
@@ -9637,7 +9637,7 @@
                 <a:ea typeface="Aptos"/>
                 <a:cs typeface="Aptos"/>
               </a:rPr>
-              <a:t>Pair authorized identities</a:t>
+              <a:t>Fill disabled configuration</a:t>
             </a:r>
           </a:p>
           <a:p xmlns:a="http://schemas.openxmlformats.org/drawingml/2006/main">
@@ -9660,7 +9660,7 @@
                 <a:ea typeface="Aptos"/>
                 <a:cs typeface="Aptos"/>
               </a:rPr>
-              <a:t>Choose source and publication policy</a:t>
+              <a:t>Validate, pair and enable</a:t>
             </a:r>
           </a:p>
         </p:txBody>
@@ -9670,7 +9670,7 @@
           <p:cNvPr id="10" name="">
             <a:extLst xmlns:a="http://schemas.openxmlformats.org/drawingml/2006/main">
               <a:ext uri="{FF2B5EF4-FFF2-40B4-BE49-F238E27FC236}">
-                <a16:creationId xmlns:a16="http://schemas.microsoft.com/office/drawing/2014/main" id="{2F41B63E-9811-45C2-B0C2-D454743A724F}"/>
+                <a16:creationId xmlns:a16="http://schemas.microsoft.com/office/drawing/2014/main" id="{2EE7951A-2B99-420A-925A-0F37A4D128AF}"/>
               </a:ext>
             </a:extLst>
           </p:cNvPr>
@@ -9703,7 +9703,7 @@
           <p:cNvPr id="11" name="">
             <a:extLst xmlns:a="http://schemas.openxmlformats.org/drawingml/2006/main">
               <a:ext uri="{FF2B5EF4-FFF2-40B4-BE49-F238E27FC236}">
-                <a16:creationId xmlns:a16="http://schemas.microsoft.com/office/drawing/2014/main" id="{72656AD3-8B73-4D89-ADF5-37D3C63785BF}"/>
+                <a16:creationId xmlns:a16="http://schemas.microsoft.com/office/drawing/2014/main" id="{9362A06D-DD7C-4EB7-993D-1C9F1C422298}"/>
               </a:ext>
             </a:extLst>
           </p:cNvPr>
@@ -9770,7 +9770,7 @@
           <p:cNvPr id="12" name="">
             <a:extLst xmlns:a="http://schemas.openxmlformats.org/drawingml/2006/main">
               <a:ext uri="{FF2B5EF4-FFF2-40B4-BE49-F238E27FC236}">
-                <a16:creationId xmlns:a16="http://schemas.microsoft.com/office/drawing/2014/main" id="{244F498A-6FFD-4234-A00E-64B2C10C5AAD}"/>
+                <a16:creationId xmlns:a16="http://schemas.microsoft.com/office/drawing/2014/main" id="{5EDD8827-F4E9-4C22-B40E-FEF00E895B01}"/>
               </a:ext>
             </a:extLst>
           </p:cNvPr>
@@ -9906,7 +9906,7 @@
           <p:cNvPr id="13" name="">
             <a:extLst xmlns:a="http://schemas.openxmlformats.org/drawingml/2006/main">
               <a:ext uri="{FF2B5EF4-FFF2-40B4-BE49-F238E27FC236}">
-                <a16:creationId xmlns:a16="http://schemas.microsoft.com/office/drawing/2014/main" id="{397EE58A-D433-4144-8B73-EDB41BE1F84E}"/>
+                <a16:creationId xmlns:a16="http://schemas.microsoft.com/office/drawing/2014/main" id="{ADE00A3D-7A7E-46BB-8400-3C94B843FD0C}"/>
               </a:ext>
             </a:extLst>
           </p:cNvPr>
@@ -9939,7 +9939,7 @@
           <p:cNvPr id="14" name="">
             <a:extLst xmlns:a="http://schemas.openxmlformats.org/drawingml/2006/main">
               <a:ext uri="{FF2B5EF4-FFF2-40B4-BE49-F238E27FC236}">
-                <a16:creationId xmlns:a16="http://schemas.microsoft.com/office/drawing/2014/main" id="{E07624BE-028A-40D7-AF2A-29F9DD5E200D}"/>
+                <a16:creationId xmlns:a16="http://schemas.microsoft.com/office/drawing/2014/main" id="{0C78BD01-8E6C-496A-86B1-8587DA887D68}"/>
               </a:ext>
             </a:extLst>
           </p:cNvPr>
@@ -10006,7 +10006,7 @@
           <p:cNvPr id="15" name="">
             <a:extLst xmlns:a="http://schemas.openxmlformats.org/drawingml/2006/main">
               <a:ext uri="{FF2B5EF4-FFF2-40B4-BE49-F238E27FC236}">
-                <a16:creationId xmlns:a16="http://schemas.microsoft.com/office/drawing/2014/main" id="{E3D4E954-651E-496F-8F4E-1115F08B1959}"/>
+                <a16:creationId xmlns:a16="http://schemas.microsoft.com/office/drawing/2014/main" id="{3F701368-6612-47BA-A09E-DF5B0B7294D9}"/>
               </a:ext>
             </a:extLst>
           </p:cNvPr>
@@ -10142,7 +10142,7 @@
           <p:cNvPr id="16" name="">
             <a:extLst xmlns:a="http://schemas.openxmlformats.org/drawingml/2006/main">
               <a:ext uri="{FF2B5EF4-FFF2-40B4-BE49-F238E27FC236}">
-                <a16:creationId xmlns:a16="http://schemas.microsoft.com/office/drawing/2014/main" id="{26AAD5B6-0DB4-4A3C-8838-782ACA834860}"/>
+                <a16:creationId xmlns:a16="http://schemas.microsoft.com/office/drawing/2014/main" id="{95F268FE-615B-4B0E-B778-926E0D57BA5B}"/>
               </a:ext>
             </a:extLst>
           </p:cNvPr>
@@ -10207,7 +10207,7 @@
     </p:spTree>
     <p:extLst>
       <p:ext uri="{BB962C8B-B14F-4D97-AF65-F5344CB8AC3E}">
-        <p14:creationId xmlns:p14="http://schemas.microsoft.com/office/powerpoint/2010/main" val="1796107977"/>
+        <p14:creationId xmlns:p14="http://schemas.microsoft.com/office/powerpoint/2010/main" val="1265001805"/>
       </p:ext>
     </p:extLst>
   </p:cSld>
@@ -10238,7 +10238,7 @@
           <p:cNvPr id="17" name="">
             <a:extLst xmlns:a="http://schemas.openxmlformats.org/drawingml/2006/main">
               <a:ext uri="{FF2B5EF4-FFF2-40B4-BE49-F238E27FC236}">
-                <a16:creationId xmlns:a16="http://schemas.microsoft.com/office/drawing/2014/main" id="{B2493966-7999-40A3-83FF-AB2B04D81A0D}"/>
+                <a16:creationId xmlns:a16="http://schemas.microsoft.com/office/drawing/2014/main" id="{663A0F38-B73F-4B71-AD7B-292F0DFA67E0}"/>
               </a:ext>
             </a:extLst>
           </p:cNvPr>
@@ -10305,7 +10305,7 @@
           <p:cNvPr id="2" name="">
             <a:extLst xmlns:a="http://schemas.openxmlformats.org/drawingml/2006/main">
               <a:ext uri="{FF2B5EF4-FFF2-40B4-BE49-F238E27FC236}">
-                <a16:creationId xmlns:a16="http://schemas.microsoft.com/office/drawing/2014/main" id="{C8B52D4F-9531-4529-B538-197B671F0AD1}"/>
+                <a16:creationId xmlns:a16="http://schemas.microsoft.com/office/drawing/2014/main" id="{5137B871-C8CB-4528-A968-63C3B3AE9E7B}"/>
               </a:ext>
             </a:extLst>
           </p:cNvPr>
@@ -10362,7 +10362,7 @@
                 <a:ea typeface="Aptos"/>
                 <a:cs typeface="Aptos"/>
               </a:rPr>
-              <a:t>Build evidence on 22 October</a:t>
+              <a:t>Build evidence on 23 October</a:t>
             </a:r>
           </a:p>
         </p:txBody>
@@ -10372,7 +10372,7 @@
           <p:cNvPr id="3" name="">
             <a:extLst xmlns:a="http://schemas.openxmlformats.org/drawingml/2006/main">
               <a:ext uri="{FF2B5EF4-FFF2-40B4-BE49-F238E27FC236}">
-                <a16:creationId xmlns:a16="http://schemas.microsoft.com/office/drawing/2014/main" id="{A6EF57FD-C9F4-4EC6-B9EB-88FFEFCB32F0}"/>
+                <a16:creationId xmlns:a16="http://schemas.microsoft.com/office/drawing/2014/main" id="{EC123BF2-95A5-4DF3-8145-D32045B3FA84}"/>
               </a:ext>
             </a:extLst>
           </p:cNvPr>
@@ -10429,7 +10429,7 @@
                 <a:ea typeface="Aptos"/>
                 <a:cs typeface="Aptos"/>
               </a:rPr>
-              <a:t>Connected bridge and Roundtable core are merged into develop.</a:t>
+              <a:t>Grant packet binding and installable-package qualification extend the connected loop.</a:t>
             </a:r>
           </a:p>
         </p:txBody>
@@ -10439,7 +10439,7 @@
           <p:cNvPr id="4" name="">
             <a:extLst xmlns:a="http://schemas.openxmlformats.org/drawingml/2006/main">
               <a:ext uri="{FF2B5EF4-FFF2-40B4-BE49-F238E27FC236}">
-                <a16:creationId xmlns:a16="http://schemas.microsoft.com/office/drawing/2014/main" id="{5616D756-27A0-4527-9667-A16925328996}"/>
+                <a16:creationId xmlns:a16="http://schemas.microsoft.com/office/drawing/2014/main" id="{55F576AF-4BD2-4AA1-AF73-C9F378045DF9}"/>
               </a:ext>
             </a:extLst>
           </p:cNvPr>
@@ -10470,7 +10470,7 @@
           <p:cNvPr id="5" name="">
             <a:extLst xmlns:a="http://schemas.openxmlformats.org/drawingml/2006/main">
               <a:ext uri="{FF2B5EF4-FFF2-40B4-BE49-F238E27FC236}">
-                <a16:creationId xmlns:a16="http://schemas.microsoft.com/office/drawing/2014/main" id="{C7F36929-593B-48E1-B7F8-53BE82B0D754}"/>
+                <a16:creationId xmlns:a16="http://schemas.microsoft.com/office/drawing/2014/main" id="{25D9C22E-FC38-4A89-9D73-681B6C592327}"/>
               </a:ext>
             </a:extLst>
           </p:cNvPr>
@@ -10527,7 +10527,7 @@
                 <a:ea typeface="Aptos"/>
                 <a:cs typeface="Aptos"/>
               </a:rPr>
-              <a:t>INERTIA-2026-10-22-r6 · 22 October 2026 · Autonomous build</a:t>
+              <a:t>INERTIA-2026-10-23-r7 · 23 October 2026 · Autonomous build</a:t>
             </a:r>
           </a:p>
         </p:txBody>
@@ -10537,7 +10537,7 @@
           <p:cNvPr id="6" name="">
             <a:extLst xmlns:a="http://schemas.openxmlformats.org/drawingml/2006/main">
               <a:ext uri="{FF2B5EF4-FFF2-40B4-BE49-F238E27FC236}">
-                <a16:creationId xmlns:a16="http://schemas.microsoft.com/office/drawing/2014/main" id="{1D7FF4B2-2E49-4723-8518-73C80825B92A}"/>
+                <a16:creationId xmlns:a16="http://schemas.microsoft.com/office/drawing/2014/main" id="{094CDB74-4903-4445-8C21-C7C714DC88AD}"/>
               </a:ext>
             </a:extLst>
           </p:cNvPr>
@@ -10604,7 +10604,7 @@
           <p:cNvPr id="7" name="">
             <a:extLst xmlns:a="http://schemas.openxmlformats.org/drawingml/2006/main">
               <a:ext uri="{FF2B5EF4-FFF2-40B4-BE49-F238E27FC236}">
-                <a16:creationId xmlns:a16="http://schemas.microsoft.com/office/drawing/2014/main" id="{42B87E8A-366F-4EA9-BA12-2F34D9CD8C0C}"/>
+                <a16:creationId xmlns:a16="http://schemas.microsoft.com/office/drawing/2014/main" id="{29117874-9FF5-4915-8CA6-B7D4ABD8CE04}"/>
               </a:ext>
             </a:extLst>
           </p:cNvPr>
@@ -10637,7 +10637,7 @@
           <p:cNvPr id="8" name="">
             <a:extLst xmlns:a="http://schemas.openxmlformats.org/drawingml/2006/main">
               <a:ext uri="{FF2B5EF4-FFF2-40B4-BE49-F238E27FC236}">
-                <a16:creationId xmlns:a16="http://schemas.microsoft.com/office/drawing/2014/main" id="{049B2ABF-5E1E-44D2-BBCA-26EAEA7ED08B}"/>
+                <a16:creationId xmlns:a16="http://schemas.microsoft.com/office/drawing/2014/main" id="{ADD6E2AF-1EB3-4582-9DF4-1BE9F8295F55}"/>
               </a:ext>
             </a:extLst>
           </p:cNvPr>
@@ -10704,7 +10704,7 @@
           <p:cNvPr id="9" name="">
             <a:extLst xmlns:a="http://schemas.openxmlformats.org/drawingml/2006/main">
               <a:ext uri="{FF2B5EF4-FFF2-40B4-BE49-F238E27FC236}">
-                <a16:creationId xmlns:a16="http://schemas.microsoft.com/office/drawing/2014/main" id="{AB45F3C5-0478-4887-A909-6C9123996D0D}"/>
+                <a16:creationId xmlns:a16="http://schemas.microsoft.com/office/drawing/2014/main" id="{A36F21E8-DB54-4991-B8EC-E9387EBA9DF6}"/>
               </a:ext>
             </a:extLst>
           </p:cNvPr>
@@ -10761,7 +10761,7 @@
                 <a:ea typeface="Aptos"/>
                 <a:cs typeface="Aptos"/>
               </a:rPr>
-              <a:t>PR 2: 36 transport tests</a:t>
+              <a:t>Signed transport and native core</a:t>
             </a:r>
           </a:p>
           <a:p xmlns:a="http://schemas.openxmlformats.org/drawingml/2006/main">
@@ -10784,7 +10784,7 @@
                 <a:ea typeface="Aptos"/>
                 <a:cs typeface="Aptos"/>
               </a:rPr>
-              <a:t>PR 3: combined 60 tests</a:t>
+              <a:t>Connected bridge: 85 tests</a:t>
             </a:r>
           </a:p>
           <a:p xmlns:a="http://schemas.openxmlformats.org/drawingml/2006/main">
@@ -10807,7 +10807,7 @@
                 <a:ea typeface="Aptos"/>
                 <a:cs typeface="Aptos"/>
               </a:rPr>
-              <a:t>Real signatures and SQL</a:t>
+              <a:t>Roundtable core: 23 tests</a:t>
             </a:r>
           </a:p>
           <a:p xmlns:a="http://schemas.openxmlformats.org/drawingml/2006/main">
@@ -10830,7 +10830,7 @@
                 <a:ea typeface="Aptos"/>
                 <a:cs typeface="Aptos"/>
               </a:rPr>
-              <a:t>Typecheck, build and fixture demo</a:t>
+              <a:t>Actual website publisher pending</a:t>
             </a:r>
           </a:p>
         </p:txBody>
@@ -10840,7 +10840,7 @@
           <p:cNvPr id="10" name="">
             <a:extLst xmlns:a="http://schemas.openxmlformats.org/drawingml/2006/main">
               <a:ext uri="{FF2B5EF4-FFF2-40B4-BE49-F238E27FC236}">
-                <a16:creationId xmlns:a16="http://schemas.microsoft.com/office/drawing/2014/main" id="{1CA97F40-E346-4BDC-9132-7BEED9E2D73A}"/>
+                <a16:creationId xmlns:a16="http://schemas.microsoft.com/office/drawing/2014/main" id="{55B89C6C-D208-47EA-8F33-9D667AB734B9}"/>
               </a:ext>
             </a:extLst>
           </p:cNvPr>
@@ -10873,7 +10873,7 @@
           <p:cNvPr id="11" name="">
             <a:extLst xmlns:a="http://schemas.openxmlformats.org/drawingml/2006/main">
               <a:ext uri="{FF2B5EF4-FFF2-40B4-BE49-F238E27FC236}">
-                <a16:creationId xmlns:a16="http://schemas.microsoft.com/office/drawing/2014/main" id="{F58C2A2F-813A-4942-8559-A14A91E62C96}"/>
+                <a16:creationId xmlns:a16="http://schemas.microsoft.com/office/drawing/2014/main" id="{46FE38AA-64E5-4EA1-9BD0-A77BDF030101}"/>
               </a:ext>
             </a:extLst>
           </p:cNvPr>
@@ -10930,7 +10930,7 @@
                 <a:ea typeface="Aptos"/>
                 <a:cs typeface="Aptos"/>
               </a:rPr>
-              <a:t>Connected plugin</a:t>
+              <a:t>Grant packet binding</a:t>
             </a:r>
           </a:p>
         </p:txBody>
@@ -10940,7 +10940,7 @@
           <p:cNvPr id="12" name="">
             <a:extLst xmlns:a="http://schemas.openxmlformats.org/drawingml/2006/main">
               <a:ext uri="{FF2B5EF4-FFF2-40B4-BE49-F238E27FC236}">
-                <a16:creationId xmlns:a16="http://schemas.microsoft.com/office/drawing/2014/main" id="{43C2D438-195B-4E88-8B61-DA5CEDCB5C21}"/>
+                <a16:creationId xmlns:a16="http://schemas.microsoft.com/office/drawing/2014/main" id="{D19F5B84-AAD2-45F1-A9B3-13C8AA43F34E}"/>
               </a:ext>
             </a:extLst>
           </p:cNvPr>
@@ -10997,7 +10997,7 @@
                 <a:ea typeface="Aptos"/>
                 <a:cs typeface="Aptos"/>
               </a:rPr>
-              <a:t>PR 4 merged: 85 tests</a:t>
+              <a:t>PR 7 grant core: 37 tests</a:t>
             </a:r>
           </a:p>
           <a:p xmlns:a="http://schemas.openxmlformats.org/drawingml/2006/main">
@@ -11020,7 +11020,7 @@
                 <a:ea typeface="Aptos"/>
                 <a:cs typeface="Aptos"/>
               </a:rPr>
-              <a:t>Durable retry and backfill</a:t>
+              <a:t>Packet, review and vote binding</a:t>
             </a:r>
           </a:p>
           <a:p xmlns:a="http://schemas.openxmlformats.org/drawingml/2006/main">
@@ -11043,7 +11043,7 @@
                 <a:ea typeface="Aptos"/>
                 <a:cs typeface="Aptos"/>
               </a:rPr>
-              <a:t>Company-scoped health</a:t>
+              <a:t>Source freshness and replay</a:t>
             </a:r>
           </a:p>
           <a:p xmlns:a="http://schemas.openxmlformats.org/drawingml/2006/main">
@@ -11066,7 +11066,7 @@
                 <a:ea typeface="Aptos"/>
                 <a:cs typeface="Aptos"/>
               </a:rPr>
-              <a:t>Addressed-card privacy</a:t>
+              <a:t>Production adapters next</a:t>
             </a:r>
           </a:p>
         </p:txBody>
@@ -11076,7 +11076,7 @@
           <p:cNvPr id="13" name="">
             <a:extLst xmlns:a="http://schemas.openxmlformats.org/drawingml/2006/main">
               <a:ext uri="{FF2B5EF4-FFF2-40B4-BE49-F238E27FC236}">
-                <a16:creationId xmlns:a16="http://schemas.microsoft.com/office/drawing/2014/main" id="{0A9E9C16-C0B5-4EA7-93EB-B9B634082DAB}"/>
+                <a16:creationId xmlns:a16="http://schemas.microsoft.com/office/drawing/2014/main" id="{46275AFE-4AE2-4691-9FA0-A458C7E8D68B}"/>
               </a:ext>
             </a:extLst>
           </p:cNvPr>
@@ -11109,7 +11109,7 @@
           <p:cNvPr id="14" name="">
             <a:extLst xmlns:a="http://schemas.openxmlformats.org/drawingml/2006/main">
               <a:ext uri="{FF2B5EF4-FFF2-40B4-BE49-F238E27FC236}">
-                <a16:creationId xmlns:a16="http://schemas.microsoft.com/office/drawing/2014/main" id="{5FACB03B-8C2C-4AE9-829F-FBBD7F80DDC9}"/>
+                <a16:creationId xmlns:a16="http://schemas.microsoft.com/office/drawing/2014/main" id="{DC6CF57D-258D-4AFF-846A-C46A43A44081}"/>
               </a:ext>
             </a:extLst>
           </p:cNvPr>
@@ -11166,7 +11166,7 @@
                 <a:ea typeface="Aptos"/>
                 <a:cs typeface="Aptos"/>
               </a:rPr>
-              <a:t>Next product slices</a:t>
+              <a:t>Installable delivery</a:t>
             </a:r>
           </a:p>
         </p:txBody>
@@ -11176,7 +11176,7 @@
           <p:cNvPr id="15" name="">
             <a:extLst xmlns:a="http://schemas.openxmlformats.org/drawingml/2006/main">
               <a:ext uri="{FF2B5EF4-FFF2-40B4-BE49-F238E27FC236}">
-                <a16:creationId xmlns:a16="http://schemas.microsoft.com/office/drawing/2014/main" id="{B07EEB5C-4180-4597-AA18-E563072A6866}"/>
+                <a16:creationId xmlns:a16="http://schemas.microsoft.com/office/drawing/2014/main" id="{A04A5A5D-AA08-4A57-A275-AA0DE9303DD5}"/>
               </a:ext>
             </a:extLst>
           </p:cNvPr>
@@ -11233,7 +11233,7 @@
                 <a:ea typeface="Aptos"/>
                 <a:cs typeface="Aptos"/>
               </a:rPr>
-              <a:t>PR 5: 23 Roundtable tests</a:t>
+              <a:t>149 combined tests passing</a:t>
             </a:r>
           </a:p>
           <a:p xmlns:a="http://schemas.openxmlformats.org/drawingml/2006/main">
@@ -11256,7 +11256,7 @@
                 <a:ea typeface="Aptos"/>
                 <a:cs typeface="Aptos"/>
               </a:rPr>
-              <a:t>108 combined tests passing</a:t>
+              <a:t>Fresh production installation</a:t>
             </a:r>
           </a:p>
           <a:p xmlns:a="http://schemas.openxmlformats.org/drawingml/2006/main">
@@ -11279,7 +11279,7 @@
                 <a:ea typeface="Aptos"/>
                 <a:cs typeface="Aptos"/>
               </a:rPr>
-              <a:t>Website publisher still pending</a:t>
+              <a:t>Native worker RPC handshake</a:t>
             </a:r>
           </a:p>
           <a:p xmlns:a="http://schemas.openxmlformats.org/drawingml/2006/main">
@@ -11302,7 +11302,7 @@
                 <a:ea typeface="Aptos"/>
                 <a:cs typeface="Aptos"/>
               </a:rPr>
-              <a:t>Grant and member adapters next</a:t>
+              <a:t>Guided configuration validation</a:t>
             </a:r>
           </a:p>
         </p:txBody>
@@ -11312,7 +11312,7 @@
           <p:cNvPr id="16" name="">
             <a:extLst xmlns:a="http://schemas.openxmlformats.org/drawingml/2006/main">
               <a:ext uri="{FF2B5EF4-FFF2-40B4-BE49-F238E27FC236}">
-                <a16:creationId xmlns:a16="http://schemas.microsoft.com/office/drawing/2014/main" id="{863246D1-918B-4CE3-859E-EE9ADEC03E3C}"/>
+                <a16:creationId xmlns:a16="http://schemas.microsoft.com/office/drawing/2014/main" id="{B49B2408-1C1E-4D89-8275-A0662A08CF9A}"/>
               </a:ext>
             </a:extLst>
           </p:cNvPr>
@@ -11377,7 +11377,7 @@
     </p:spTree>
     <p:extLst>
       <p:ext uri="{BB962C8B-B14F-4D97-AF65-F5344CB8AC3E}">
-        <p14:creationId xmlns:p14="http://schemas.microsoft.com/office/powerpoint/2010/main" val="1719125137"/>
+        <p14:creationId xmlns:p14="http://schemas.microsoft.com/office/powerpoint/2010/main" val="829709320"/>
       </p:ext>
     </p:extLst>
   </p:cSld>
@@ -11408,7 +11408,7 @@
           <p:cNvPr id="17" name="">
             <a:extLst xmlns:a="http://schemas.openxmlformats.org/drawingml/2006/main">
               <a:ext uri="{FF2B5EF4-FFF2-40B4-BE49-F238E27FC236}">
-                <a16:creationId xmlns:a16="http://schemas.microsoft.com/office/drawing/2014/main" id="{A7F36360-C342-4961-B6BB-833D725C142D}"/>
+                <a16:creationId xmlns:a16="http://schemas.microsoft.com/office/drawing/2014/main" id="{0173441E-F063-4E8A-BF1A-3FE90B8F955D}"/>
               </a:ext>
             </a:extLst>
           </p:cNvPr>
@@ -11475,7 +11475,7 @@
           <p:cNvPr id="2" name="">
             <a:extLst xmlns:a="http://schemas.openxmlformats.org/drawingml/2006/main">
               <a:ext uri="{FF2B5EF4-FFF2-40B4-BE49-F238E27FC236}">
-                <a16:creationId xmlns:a16="http://schemas.microsoft.com/office/drawing/2014/main" id="{7800FAFB-FC91-4239-9015-A95D85B1BF6F}"/>
+                <a16:creationId xmlns:a16="http://schemas.microsoft.com/office/drawing/2014/main" id="{F5C871FE-F01B-488E-9C0A-CAF465CA5DB1}"/>
               </a:ext>
             </a:extLst>
           </p:cNvPr>
@@ -11542,7 +11542,7 @@
           <p:cNvPr id="3" name="">
             <a:extLst xmlns:a="http://schemas.openxmlformats.org/drawingml/2006/main">
               <a:ext uri="{FF2B5EF4-FFF2-40B4-BE49-F238E27FC236}">
-                <a16:creationId xmlns:a16="http://schemas.microsoft.com/office/drawing/2014/main" id="{18FBB0F3-049A-4480-90E3-C75A3E6300F2}"/>
+                <a16:creationId xmlns:a16="http://schemas.microsoft.com/office/drawing/2014/main" id="{2B1A65F4-3C73-462B-8F26-C26536AC782E}"/>
               </a:ext>
             </a:extLst>
           </p:cNvPr>
@@ -11609,7 +11609,7 @@
           <p:cNvPr id="4" name="">
             <a:extLst xmlns:a="http://schemas.openxmlformats.org/drawingml/2006/main">
               <a:ext uri="{FF2B5EF4-FFF2-40B4-BE49-F238E27FC236}">
-                <a16:creationId xmlns:a16="http://schemas.microsoft.com/office/drawing/2014/main" id="{2EC8A4F3-0E50-44E9-9A25-06979A479A58}"/>
+                <a16:creationId xmlns:a16="http://schemas.microsoft.com/office/drawing/2014/main" id="{EF2C142C-5C03-4D47-BFD4-3D6B04CEC89B}"/>
               </a:ext>
             </a:extLst>
           </p:cNvPr>
@@ -11640,7 +11640,7 @@
           <p:cNvPr id="5" name="">
             <a:extLst xmlns:a="http://schemas.openxmlformats.org/drawingml/2006/main">
               <a:ext uri="{FF2B5EF4-FFF2-40B4-BE49-F238E27FC236}">
-                <a16:creationId xmlns:a16="http://schemas.microsoft.com/office/drawing/2014/main" id="{7681E94F-2EB8-4076-AFB3-0324B76F029C}"/>
+                <a16:creationId xmlns:a16="http://schemas.microsoft.com/office/drawing/2014/main" id="{A3B4C865-930F-462E-96D0-8847246307CA}"/>
               </a:ext>
             </a:extLst>
           </p:cNvPr>
@@ -11697,7 +11697,7 @@
                 <a:ea typeface="Aptos"/>
                 <a:cs typeface="Aptos"/>
               </a:rPr>
-              <a:t>INERTIA-2026-10-22-r6 · 22 October 2026 · Autonomous build</a:t>
+              <a:t>INERTIA-2026-10-23-r7 · 23 October 2026 · Autonomous build</a:t>
             </a:r>
           </a:p>
         </p:txBody>
@@ -11707,7 +11707,7 @@
           <p:cNvPr id="6" name="">
             <a:extLst xmlns:a="http://schemas.openxmlformats.org/drawingml/2006/main">
               <a:ext uri="{FF2B5EF4-FFF2-40B4-BE49-F238E27FC236}">
-                <a16:creationId xmlns:a16="http://schemas.microsoft.com/office/drawing/2014/main" id="{0F34DE2E-A6A4-446E-AC81-0F455F233699}"/>
+                <a16:creationId xmlns:a16="http://schemas.microsoft.com/office/drawing/2014/main" id="{88373A89-E773-4F3B-9E34-A682312AA7E1}"/>
               </a:ext>
             </a:extLst>
           </p:cNvPr>
@@ -11774,7 +11774,7 @@
           <p:cNvPr id="7" name="">
             <a:extLst xmlns:a="http://schemas.openxmlformats.org/drawingml/2006/main">
               <a:ext uri="{FF2B5EF4-FFF2-40B4-BE49-F238E27FC236}">
-                <a16:creationId xmlns:a16="http://schemas.microsoft.com/office/drawing/2014/main" id="{49BE7E97-517E-42DB-9A82-F072C4130C03}"/>
+                <a16:creationId xmlns:a16="http://schemas.microsoft.com/office/drawing/2014/main" id="{929FF0A0-B33A-4487-BFDB-6835B1732A0B}"/>
               </a:ext>
             </a:extLst>
           </p:cNvPr>
@@ -11807,7 +11807,7 @@
           <p:cNvPr id="8" name="">
             <a:extLst xmlns:a="http://schemas.openxmlformats.org/drawingml/2006/main">
               <a:ext uri="{FF2B5EF4-FFF2-40B4-BE49-F238E27FC236}">
-                <a16:creationId xmlns:a16="http://schemas.microsoft.com/office/drawing/2014/main" id="{36E7074E-E5B4-4F3A-AEE7-CD3E3BCF96C5}"/>
+                <a16:creationId xmlns:a16="http://schemas.microsoft.com/office/drawing/2014/main" id="{639AE9B0-2039-47D3-9C4F-6A4CBFAA7575}"/>
               </a:ext>
             </a:extLst>
           </p:cNvPr>
@@ -11874,7 +11874,7 @@
           <p:cNvPr id="9" name="">
             <a:extLst xmlns:a="http://schemas.openxmlformats.org/drawingml/2006/main">
               <a:ext uri="{FF2B5EF4-FFF2-40B4-BE49-F238E27FC236}">
-                <a16:creationId xmlns:a16="http://schemas.microsoft.com/office/drawing/2014/main" id="{41EE5B33-E5A6-491B-AED2-645B84F2620F}"/>
+                <a16:creationId xmlns:a16="http://schemas.microsoft.com/office/drawing/2014/main" id="{D800D6A5-1A4D-4994-85B3-97D9159DEA6F}"/>
               </a:ext>
             </a:extLst>
           </p:cNvPr>
@@ -11931,7 +11931,7 @@
                 <a:ea typeface="Aptos"/>
                 <a:cs typeface="Aptos"/>
               </a:rPr>
-              <a:t>Bridge and core merged</a:t>
+              <a:t>Bridge and domain cores merged</a:t>
             </a:r>
           </a:p>
           <a:p xmlns:a="http://schemas.openxmlformats.org/drawingml/2006/main">
@@ -11954,7 +11954,7 @@
                 <a:ea typeface="Aptos"/>
                 <a:cs typeface="Aptos"/>
               </a:rPr>
-              <a:t>Continue website publisher</a:t>
+              <a:t>Plugin archive qualified</a:t>
             </a:r>
           </a:p>
           <a:p xmlns:a="http://schemas.openxmlformats.org/drawingml/2006/main">
@@ -11977,7 +11977,7 @@
                 <a:ea typeface="Aptos"/>
                 <a:cs typeface="Aptos"/>
               </a:rPr>
-              <a:t>Grant slice now active</a:t>
+              <a:t>Website publisher pending</a:t>
             </a:r>
           </a:p>
           <a:p xmlns:a="http://schemas.openxmlformats.org/drawingml/2006/main">
@@ -12010,7 +12010,7 @@
           <p:cNvPr id="10" name="">
             <a:extLst xmlns:a="http://schemas.openxmlformats.org/drawingml/2006/main">
               <a:ext uri="{FF2B5EF4-FFF2-40B4-BE49-F238E27FC236}">
-                <a16:creationId xmlns:a16="http://schemas.microsoft.com/office/drawing/2014/main" id="{6DCF7EC8-8239-4E90-B2BD-E87B6944589B}"/>
+                <a16:creationId xmlns:a16="http://schemas.microsoft.com/office/drawing/2014/main" id="{6B941325-326B-4F86-8450-C7509CC5DDE5}"/>
               </a:ext>
             </a:extLst>
           </p:cNvPr>
@@ -12043,7 +12043,7 @@
           <p:cNvPr id="11" name="">
             <a:extLst xmlns:a="http://schemas.openxmlformats.org/drawingml/2006/main">
               <a:ext uri="{FF2B5EF4-FFF2-40B4-BE49-F238E27FC236}">
-                <a16:creationId xmlns:a16="http://schemas.microsoft.com/office/drawing/2014/main" id="{580FAE3F-48DD-4E6D-A5A4-04715DDE9CA1}"/>
+                <a16:creationId xmlns:a16="http://schemas.microsoft.com/office/drawing/2014/main" id="{34DD5DE3-0E52-4993-A7C2-FA7308C23B11}"/>
               </a:ext>
             </a:extLst>
           </p:cNvPr>
@@ -12110,7 +12110,7 @@
           <p:cNvPr id="12" name="">
             <a:extLst xmlns:a="http://schemas.openxmlformats.org/drawingml/2006/main">
               <a:ext uri="{FF2B5EF4-FFF2-40B4-BE49-F238E27FC236}">
-                <a16:creationId xmlns:a16="http://schemas.microsoft.com/office/drawing/2014/main" id="{64513E19-DC8F-4038-9D60-2C703B484CBF}"/>
+                <a16:creationId xmlns:a16="http://schemas.microsoft.com/office/drawing/2014/main" id="{DF341400-E46A-4547-A3B9-6E2DCF4F4229}"/>
               </a:ext>
             </a:extLst>
           </p:cNvPr>
@@ -12246,7 +12246,7 @@
           <p:cNvPr id="13" name="">
             <a:extLst xmlns:a="http://schemas.openxmlformats.org/drawingml/2006/main">
               <a:ext uri="{FF2B5EF4-FFF2-40B4-BE49-F238E27FC236}">
-                <a16:creationId xmlns:a16="http://schemas.microsoft.com/office/drawing/2014/main" id="{7D0894CB-2A24-4773-B711-3DBB03AD9814}"/>
+                <a16:creationId xmlns:a16="http://schemas.microsoft.com/office/drawing/2014/main" id="{A2D50665-ABDE-434C-BCE8-FC777D1F21CB}"/>
               </a:ext>
             </a:extLst>
           </p:cNvPr>
@@ -12279,7 +12279,7 @@
           <p:cNvPr id="14" name="">
             <a:extLst xmlns:a="http://schemas.openxmlformats.org/drawingml/2006/main">
               <a:ext uri="{FF2B5EF4-FFF2-40B4-BE49-F238E27FC236}">
-                <a16:creationId xmlns:a16="http://schemas.microsoft.com/office/drawing/2014/main" id="{50D29861-A92C-43B0-87FE-E7557E1579C4}"/>
+                <a16:creationId xmlns:a16="http://schemas.microsoft.com/office/drawing/2014/main" id="{C0EE3AEA-04D6-4FCE-A14B-5FE39DB833C1}"/>
               </a:ext>
             </a:extLst>
           </p:cNvPr>
@@ -12346,7 +12346,7 @@
           <p:cNvPr id="15" name="">
             <a:extLst xmlns:a="http://schemas.openxmlformats.org/drawingml/2006/main">
               <a:ext uri="{FF2B5EF4-FFF2-40B4-BE49-F238E27FC236}">
-                <a16:creationId xmlns:a16="http://schemas.microsoft.com/office/drawing/2014/main" id="{5829169D-E3DB-4D23-8915-953CE26B069D}"/>
+                <a16:creationId xmlns:a16="http://schemas.microsoft.com/office/drawing/2014/main" id="{93DED335-5776-42AC-BBC1-81BD8EC9BCBA}"/>
               </a:ext>
             </a:extLst>
           </p:cNvPr>
@@ -12482,7 +12482,7 @@
           <p:cNvPr id="16" name="">
             <a:extLst xmlns:a="http://schemas.openxmlformats.org/drawingml/2006/main">
               <a:ext uri="{FF2B5EF4-FFF2-40B4-BE49-F238E27FC236}">
-                <a16:creationId xmlns:a16="http://schemas.microsoft.com/office/drawing/2014/main" id="{AA8ECAB8-73DF-4DFF-8904-5D3F99F4E5F5}"/>
+                <a16:creationId xmlns:a16="http://schemas.microsoft.com/office/drawing/2014/main" id="{0691ACA3-223A-4D47-BBE2-A8593645D206}"/>
               </a:ext>
             </a:extLst>
           </p:cNvPr>
@@ -12547,7 +12547,7 @@
     </p:spTree>
     <p:extLst>
       <p:ext uri="{BB962C8B-B14F-4D97-AF65-F5344CB8AC3E}">
-        <p14:creationId xmlns:p14="http://schemas.microsoft.com/office/powerpoint/2010/main" val="298920761"/>
+        <p14:creationId xmlns:p14="http://schemas.microsoft.com/office/powerpoint/2010/main" val="485357773"/>
       </p:ext>
     </p:extLst>
   </p:cSld>

</xml_diff>

<commit_message>
docs: synchronize r7 grant and installable plugin evidence (#9)
</commit_message>
<xml_diff>
--- a/Inertia-Architecture.pptx
+++ b/Inertia-Architecture.pptx
@@ -2,20 +2,20 @@
 <file path=ppt/presentation.xml><?xml version="1.0" encoding="utf-8"?>
 <p:presentation xmlns:p="http://schemas.openxmlformats.org/presentationml/2006/main">
   <p:sldMasterIdLst>
-    <p:sldMasterId xmlns:r="http://schemas.openxmlformats.org/officeDocument/2006/relationships" id="2147483648" r:id="R273b139f7c044ff7"/>
+    <p:sldMasterId xmlns:r="http://schemas.openxmlformats.org/officeDocument/2006/relationships" id="2147483648" r:id="R3be3756c8c8e4d06"/>
   </p:sldMasterIdLst>
   <p:notesMasterIdLst>
-    <p:notesMasterId xmlns:r="http://schemas.openxmlformats.org/officeDocument/2006/relationships" r:id="Rbaa4f659cae2406d"/>
+    <p:notesMasterId xmlns:r="http://schemas.openxmlformats.org/officeDocument/2006/relationships" r:id="R919ed80d140d4fc7"/>
   </p:notesMasterIdLst>
   <p:sldIdLst>
-    <p:sldId xmlns:r="http://schemas.openxmlformats.org/officeDocument/2006/relationships" id="256" r:id="Rb2428aaf842a4875"/>
-    <p:sldId xmlns:r="http://schemas.openxmlformats.org/officeDocument/2006/relationships" id="257" r:id="R59276d759b26441c"/>
-    <p:sldId xmlns:r="http://schemas.openxmlformats.org/officeDocument/2006/relationships" id="258" r:id="R025705acd4d7429f"/>
-    <p:sldId xmlns:r="http://schemas.openxmlformats.org/officeDocument/2006/relationships" id="259" r:id="R7fefb3c3e2714bbc"/>
-    <p:sldId xmlns:r="http://schemas.openxmlformats.org/officeDocument/2006/relationships" id="260" r:id="Rdbc8884b250e4fd9"/>
-    <p:sldId xmlns:r="http://schemas.openxmlformats.org/officeDocument/2006/relationships" id="261" r:id="R380d774362574d86"/>
-    <p:sldId xmlns:r="http://schemas.openxmlformats.org/officeDocument/2006/relationships" id="262" r:id="Rbd70252bac4442fe"/>
-    <p:sldId xmlns:r="http://schemas.openxmlformats.org/officeDocument/2006/relationships" id="263" r:id="R2d339179cb0b4cd0"/>
+    <p:sldId xmlns:r="http://schemas.openxmlformats.org/officeDocument/2006/relationships" id="256" r:id="Re58f4a1192c74eb7"/>
+    <p:sldId xmlns:r="http://schemas.openxmlformats.org/officeDocument/2006/relationships" id="257" r:id="Rb1ef7f9abbed4c2f"/>
+    <p:sldId xmlns:r="http://schemas.openxmlformats.org/officeDocument/2006/relationships" id="258" r:id="R5d83b06a76334ccd"/>
+    <p:sldId xmlns:r="http://schemas.openxmlformats.org/officeDocument/2006/relationships" id="259" r:id="R766df985260e44a9"/>
+    <p:sldId xmlns:r="http://schemas.openxmlformats.org/officeDocument/2006/relationships" id="260" r:id="Rb41a4fe761d7431d"/>
+    <p:sldId xmlns:r="http://schemas.openxmlformats.org/officeDocument/2006/relationships" id="261" r:id="R6d062e6c2d2d4a16"/>
+    <p:sldId xmlns:r="http://schemas.openxmlformats.org/officeDocument/2006/relationships" id="262" r:id="R4bc29f4189db4bbe"/>
+    <p:sldId xmlns:r="http://schemas.openxmlformats.org/officeDocument/2006/relationships" id="263" r:id="Ref3549c8c3f04046"/>
   </p:sldIdLst>
   <p:sldSz cx="15240000" cy="8572500"/>
   <p:notesSz cx="6858000" cy="9144000"/>
@@ -449,7 +449,7 @@
           <a:lstStyle xmlns:a="http://schemas.openxmlformats.org/drawingml/2006/main"/>
           <a:p xmlns:a="http://schemas.openxmlformats.org/drawingml/2006/main">
             <a:r>
-              <a:t>INERTIA-2026-10-22-r6. Sources: spec.md, testing.md, decisions.md, plan.md. Merged baseline https://github.com/NetRxn/Inertia/commit/1d41eeb70b02275a488a7f7583c116c8d2c77f3c; PR 2 https://github.com/NetRxn/Inertia/pull/2; PR 3 https://github.com/NetRxn/Inertia/pull/3. Paperclip selected public release v2026.1012.0, bba6a45f0d364cfd962ac59b3bdf2426a8222adb. Buzz dc25198d530acc6237a0320b697365f29daf0ea6. PR 4 https://github.com/NetRxn/Inertia/pull/4 and PR 5 https://github.com/NetRxn/Inertia/pull/5 merged. Combined 108 tests, typecheck, build and synthetic demo passed. No private execution-provider source included.</a:t>
+              <a:t>INERTIA-2026-10-23-r7. Sources: spec.md, testing.md, decisions.md, plan.md. Merged baseline https://github.com/NetRxn/Inertia/commit/53d0f2eedf62778f8af6cc92da6fc7b84f3f0435; PR 2 https://github.com/NetRxn/Inertia/pull/2; PR 3 https://github.com/NetRxn/Inertia/pull/3. Paperclip selected public release v2026.1012.0, bba6a45f0d364cfd962ac59b3bdf2426a8222adb. Buzz dc25198d530acc6237a0320b697365f29daf0ea6. PR 4 https://github.com/NetRxn/Inertia/pull/4 and PR 5 https://github.com/NetRxn/Inertia/pull/5 merged. PR 7 https://github.com/NetRxn/Inertia/pull/7 merged with 37 grant tests. PR 8 https://github.com/NetRxn/Inertia/pull/8 merged with packaging f68e8bb98df0bb05f9a946340d885e0bcfc6e188 independently reviewed; 149 combined tests, typecheck, build, fresh production install and native JSON-RPC worker handshake passed. No private execution-provider source included.</a:t>
             </a:r>
           </a:p>
         </p:txBody>
@@ -519,7 +519,7 @@
           <a:lstStyle xmlns:a="http://schemas.openxmlformats.org/drawingml/2006/main"/>
           <a:p xmlns:a="http://schemas.openxmlformats.org/drawingml/2006/main">
             <a:r>
-              <a:t>INERTIA-2026-10-22-r6. Sources: spec.md, testing.md, decisions.md, plan.md. Merged baseline https://github.com/NetRxn/Inertia/commit/1d41eeb70b02275a488a7f7583c116c8d2c77f3c; PR 2 https://github.com/NetRxn/Inertia/pull/2; PR 3 https://github.com/NetRxn/Inertia/pull/3. Paperclip selected public release v2026.1012.0, bba6a45f0d364cfd962ac59b3bdf2426a8222adb. Buzz dc25198d530acc6237a0320b697365f29daf0ea6. PR 4 https://github.com/NetRxn/Inertia/pull/4 and PR 5 https://github.com/NetRxn/Inertia/pull/5 merged. Combined 108 tests, typecheck, build and synthetic demo passed. No private execution-provider source included.</a:t>
+              <a:t>INERTIA-2026-10-23-r7. Sources: spec.md, testing.md, decisions.md, plan.md. Merged baseline https://github.com/NetRxn/Inertia/commit/53d0f2eedf62778f8af6cc92da6fc7b84f3f0435; PR 2 https://github.com/NetRxn/Inertia/pull/2; PR 3 https://github.com/NetRxn/Inertia/pull/3. Paperclip selected public release v2026.1012.0, bba6a45f0d364cfd962ac59b3bdf2426a8222adb. Buzz dc25198d530acc6237a0320b697365f29daf0ea6. PR 4 https://github.com/NetRxn/Inertia/pull/4 and PR 5 https://github.com/NetRxn/Inertia/pull/5 merged. PR 7 https://github.com/NetRxn/Inertia/pull/7 merged with 37 grant tests. PR 8 https://github.com/NetRxn/Inertia/pull/8 merged with packaging f68e8bb98df0bb05f9a946340d885e0bcfc6e188 independently reviewed; 149 combined tests, typecheck, build, fresh production install and native JSON-RPC worker handshake passed. No private execution-provider source included.</a:t>
             </a:r>
           </a:p>
         </p:txBody>
@@ -589,7 +589,7 @@
           <a:lstStyle xmlns:a="http://schemas.openxmlformats.org/drawingml/2006/main"/>
           <a:p xmlns:a="http://schemas.openxmlformats.org/drawingml/2006/main">
             <a:r>
-              <a:t>INERTIA-2026-10-22-r6. Sources: spec.md, testing.md, decisions.md, plan.md. Merged baseline https://github.com/NetRxn/Inertia/commit/1d41eeb70b02275a488a7f7583c116c8d2c77f3c; PR 2 https://github.com/NetRxn/Inertia/pull/2; PR 3 https://github.com/NetRxn/Inertia/pull/3. Paperclip selected public release v2026.1012.0, bba6a45f0d364cfd962ac59b3bdf2426a8222adb. Buzz dc25198d530acc6237a0320b697365f29daf0ea6. PR 4 https://github.com/NetRxn/Inertia/pull/4 and PR 5 https://github.com/NetRxn/Inertia/pull/5 merged. Combined 108 tests, typecheck, build and synthetic demo passed. No private execution-provider source included.</a:t>
+              <a:t>INERTIA-2026-10-23-r7. Sources: spec.md, testing.md, decisions.md, plan.md. Merged baseline https://github.com/NetRxn/Inertia/commit/53d0f2eedf62778f8af6cc92da6fc7b84f3f0435; PR 2 https://github.com/NetRxn/Inertia/pull/2; PR 3 https://github.com/NetRxn/Inertia/pull/3. Paperclip selected public release v2026.1012.0, bba6a45f0d364cfd962ac59b3bdf2426a8222adb. Buzz dc25198d530acc6237a0320b697365f29daf0ea6. PR 4 https://github.com/NetRxn/Inertia/pull/4 and PR 5 https://github.com/NetRxn/Inertia/pull/5 merged. PR 7 https://github.com/NetRxn/Inertia/pull/7 merged with 37 grant tests. PR 8 https://github.com/NetRxn/Inertia/pull/8 merged with packaging f68e8bb98df0bb05f9a946340d885e0bcfc6e188 independently reviewed; 149 combined tests, typecheck, build, fresh production install and native JSON-RPC worker handshake passed. No private execution-provider source included.</a:t>
             </a:r>
           </a:p>
         </p:txBody>
@@ -659,7 +659,7 @@
           <a:lstStyle xmlns:a="http://schemas.openxmlformats.org/drawingml/2006/main"/>
           <a:p xmlns:a="http://schemas.openxmlformats.org/drawingml/2006/main">
             <a:r>
-              <a:t>INERTIA-2026-10-22-r6. Sources: spec.md, testing.md, decisions.md, plan.md. Merged baseline https://github.com/NetRxn/Inertia/commit/1d41eeb70b02275a488a7f7583c116c8d2c77f3c; PR 2 https://github.com/NetRxn/Inertia/pull/2; PR 3 https://github.com/NetRxn/Inertia/pull/3. Paperclip selected public release v2026.1012.0, bba6a45f0d364cfd962ac59b3bdf2426a8222adb. Buzz dc25198d530acc6237a0320b697365f29daf0ea6. PR 4 https://github.com/NetRxn/Inertia/pull/4 and PR 5 https://github.com/NetRxn/Inertia/pull/5 merged. Combined 108 tests, typecheck, build and synthetic demo passed. No private execution-provider source included.</a:t>
+              <a:t>INERTIA-2026-10-23-r7. Sources: spec.md, testing.md, decisions.md, plan.md. Merged baseline https://github.com/NetRxn/Inertia/commit/53d0f2eedf62778f8af6cc92da6fc7b84f3f0435; PR 2 https://github.com/NetRxn/Inertia/pull/2; PR 3 https://github.com/NetRxn/Inertia/pull/3. Paperclip selected public release v2026.1012.0, bba6a45f0d364cfd962ac59b3bdf2426a8222adb. Buzz dc25198d530acc6237a0320b697365f29daf0ea6. PR 4 https://github.com/NetRxn/Inertia/pull/4 and PR 5 https://github.com/NetRxn/Inertia/pull/5 merged. PR 7 https://github.com/NetRxn/Inertia/pull/7 merged with 37 grant tests. PR 8 https://github.com/NetRxn/Inertia/pull/8 merged with packaging f68e8bb98df0bb05f9a946340d885e0bcfc6e188 independently reviewed; 149 combined tests, typecheck, build, fresh production install and native JSON-RPC worker handshake passed. No private execution-provider source included.</a:t>
             </a:r>
           </a:p>
         </p:txBody>
@@ -729,7 +729,7 @@
           <a:lstStyle xmlns:a="http://schemas.openxmlformats.org/drawingml/2006/main"/>
           <a:p xmlns:a="http://schemas.openxmlformats.org/drawingml/2006/main">
             <a:r>
-              <a:t>INERTIA-2026-10-22-r6. Sources: spec.md, testing.md, decisions.md, plan.md. Merged baseline https://github.com/NetRxn/Inertia/commit/1d41eeb70b02275a488a7f7583c116c8d2c77f3c; PR 2 https://github.com/NetRxn/Inertia/pull/2; PR 3 https://github.com/NetRxn/Inertia/pull/3. Paperclip selected public release v2026.1012.0, bba6a45f0d364cfd962ac59b3bdf2426a8222adb. Buzz dc25198d530acc6237a0320b697365f29daf0ea6. PR 4 https://github.com/NetRxn/Inertia/pull/4 and PR 5 https://github.com/NetRxn/Inertia/pull/5 merged. Combined 108 tests, typecheck, build and synthetic demo passed. No private execution-provider source included.</a:t>
+              <a:t>INERTIA-2026-10-23-r7. Sources: spec.md, testing.md, decisions.md, plan.md. Merged baseline https://github.com/NetRxn/Inertia/commit/53d0f2eedf62778f8af6cc92da6fc7b84f3f0435; PR 2 https://github.com/NetRxn/Inertia/pull/2; PR 3 https://github.com/NetRxn/Inertia/pull/3. Paperclip selected public release v2026.1012.0, bba6a45f0d364cfd962ac59b3bdf2426a8222adb. Buzz dc25198d530acc6237a0320b697365f29daf0ea6. PR 4 https://github.com/NetRxn/Inertia/pull/4 and PR 5 https://github.com/NetRxn/Inertia/pull/5 merged. PR 7 https://github.com/NetRxn/Inertia/pull/7 merged with 37 grant tests. PR 8 https://github.com/NetRxn/Inertia/pull/8 merged with packaging f68e8bb98df0bb05f9a946340d885e0bcfc6e188 independently reviewed; 149 combined tests, typecheck, build, fresh production install and native JSON-RPC worker handshake passed. No private execution-provider source included.</a:t>
             </a:r>
           </a:p>
         </p:txBody>
@@ -799,7 +799,7 @@
           <a:lstStyle xmlns:a="http://schemas.openxmlformats.org/drawingml/2006/main"/>
           <a:p xmlns:a="http://schemas.openxmlformats.org/drawingml/2006/main">
             <a:r>
-              <a:t>INERTIA-2026-10-22-r6. Sources: spec.md, testing.md, decisions.md, plan.md. Merged baseline https://github.com/NetRxn/Inertia/commit/1d41eeb70b02275a488a7f7583c116c8d2c77f3c; PR 2 https://github.com/NetRxn/Inertia/pull/2; PR 3 https://github.com/NetRxn/Inertia/pull/3. Paperclip selected public release v2026.1012.0, bba6a45f0d364cfd962ac59b3bdf2426a8222adb. Buzz dc25198d530acc6237a0320b697365f29daf0ea6. PR 4 https://github.com/NetRxn/Inertia/pull/4 and PR 5 https://github.com/NetRxn/Inertia/pull/5 merged. Combined 108 tests, typecheck, build and synthetic demo passed. No private execution-provider source included.</a:t>
+              <a:t>INERTIA-2026-10-23-r7. Sources: spec.md, testing.md, decisions.md, plan.md. Merged baseline https://github.com/NetRxn/Inertia/commit/53d0f2eedf62778f8af6cc92da6fc7b84f3f0435; PR 2 https://github.com/NetRxn/Inertia/pull/2; PR 3 https://github.com/NetRxn/Inertia/pull/3. Paperclip selected public release v2026.1012.0, bba6a45f0d364cfd962ac59b3bdf2426a8222adb. Buzz dc25198d530acc6237a0320b697365f29daf0ea6. PR 4 https://github.com/NetRxn/Inertia/pull/4 and PR 5 https://github.com/NetRxn/Inertia/pull/5 merged. PR 7 https://github.com/NetRxn/Inertia/pull/7 merged with 37 grant tests. PR 8 https://github.com/NetRxn/Inertia/pull/8 merged with packaging f68e8bb98df0bb05f9a946340d885e0bcfc6e188 independently reviewed; 149 combined tests, typecheck, build, fresh production install and native JSON-RPC worker handshake passed. No private execution-provider source included.</a:t>
             </a:r>
           </a:p>
         </p:txBody>
@@ -869,7 +869,7 @@
           <a:lstStyle xmlns:a="http://schemas.openxmlformats.org/drawingml/2006/main"/>
           <a:p xmlns:a="http://schemas.openxmlformats.org/drawingml/2006/main">
             <a:r>
-              <a:t>INERTIA-2026-10-22-r6. Sources: spec.md, testing.md, decisions.md, plan.md. Merged baseline https://github.com/NetRxn/Inertia/commit/1d41eeb70b02275a488a7f7583c116c8d2c77f3c; PR 2 https://github.com/NetRxn/Inertia/pull/2; PR 3 https://github.com/NetRxn/Inertia/pull/3. Paperclip selected public release v2026.1012.0, bba6a45f0d364cfd962ac59b3bdf2426a8222adb. Buzz dc25198d530acc6237a0320b697365f29daf0ea6. PR 4 https://github.com/NetRxn/Inertia/pull/4 and PR 5 https://github.com/NetRxn/Inertia/pull/5 merged. Combined 108 tests, typecheck, build and synthetic demo passed. No private execution-provider source included.</a:t>
+              <a:t>INERTIA-2026-10-23-r7. Sources: spec.md, testing.md, decisions.md, plan.md. Merged baseline https://github.com/NetRxn/Inertia/commit/53d0f2eedf62778f8af6cc92da6fc7b84f3f0435; PR 2 https://github.com/NetRxn/Inertia/pull/2; PR 3 https://github.com/NetRxn/Inertia/pull/3. Paperclip selected public release v2026.1012.0, bba6a45f0d364cfd962ac59b3bdf2426a8222adb. Buzz dc25198d530acc6237a0320b697365f29daf0ea6. PR 4 https://github.com/NetRxn/Inertia/pull/4 and PR 5 https://github.com/NetRxn/Inertia/pull/5 merged. PR 7 https://github.com/NetRxn/Inertia/pull/7 merged with 37 grant tests. PR 8 https://github.com/NetRxn/Inertia/pull/8 merged with packaging f68e8bb98df0bb05f9a946340d885e0bcfc6e188 independently reviewed; 149 combined tests, typecheck, build, fresh production install and native JSON-RPC worker handshake passed. No private execution-provider source included.</a:t>
             </a:r>
           </a:p>
         </p:txBody>
@@ -939,7 +939,7 @@
           <a:lstStyle xmlns:a="http://schemas.openxmlformats.org/drawingml/2006/main"/>
           <a:p xmlns:a="http://schemas.openxmlformats.org/drawingml/2006/main">
             <a:r>
-              <a:t>INERTIA-2026-10-22-r6. Sources: spec.md, testing.md, decisions.md, plan.md. Merged baseline https://github.com/NetRxn/Inertia/commit/1d41eeb70b02275a488a7f7583c116c8d2c77f3c; PR 2 https://github.com/NetRxn/Inertia/pull/2; PR 3 https://github.com/NetRxn/Inertia/pull/3. Paperclip selected public release v2026.1012.0, bba6a45f0d364cfd962ac59b3bdf2426a8222adb. Buzz dc25198d530acc6237a0320b697365f29daf0ea6. PR 4 https://github.com/NetRxn/Inertia/pull/4 and PR 5 https://github.com/NetRxn/Inertia/pull/5 merged. Combined 108 tests, typecheck, build and synthetic demo passed. No private execution-provider source included.</a:t>
+              <a:t>INERTIA-2026-10-23-r7. Sources: spec.md, testing.md, decisions.md, plan.md. Merged baseline https://github.com/NetRxn/Inertia/commit/53d0f2eedf62778f8af6cc92da6fc7b84f3f0435; PR 2 https://github.com/NetRxn/Inertia/pull/2; PR 3 https://github.com/NetRxn/Inertia/pull/3. Paperclip selected public release v2026.1012.0, bba6a45f0d364cfd962ac59b3bdf2426a8222adb. Buzz dc25198d530acc6237a0320b697365f29daf0ea6. PR 4 https://github.com/NetRxn/Inertia/pull/4 and PR 5 https://github.com/NetRxn/Inertia/pull/5 merged. PR 7 https://github.com/NetRxn/Inertia/pull/7 merged with 37 grant tests. PR 8 https://github.com/NetRxn/Inertia/pull/8 merged with packaging f68e8bb98df0bb05f9a946340d885e0bcfc6e188 independently reviewed; 149 combined tests, typecheck, build, fresh production install and native JSON-RPC worker handshake passed. No private execution-provider source included.</a:t>
             </a:r>
           </a:p>
         </p:txBody>
@@ -986,7 +986,7 @@
           <p:cNvPr id="3" name="Title">
             <a:extLst xmlns:a="http://schemas.openxmlformats.org/drawingml/2006/main">
               <a:ext uri="{FF2B5EF4-FFF2-40B4-BE49-F238E27FC236}">
-                <a16:creationId xmlns:a16="http://schemas.microsoft.com/office/drawing/2014/main" id="{BDF0810F-6050-4674-AAA8-ECA143DEEC4D}"/>
+                <a16:creationId xmlns:a16="http://schemas.microsoft.com/office/drawing/2014/main" id="{95D1E57F-B585-48FA-B271-4C568F5362D9}"/>
               </a:ext>
             </a:extLst>
           </p:cNvPr>
@@ -1143,7 +1143,7 @@
           <p:cNvPr id="2" name="Subtitle">
             <a:extLst xmlns:a="http://schemas.openxmlformats.org/drawingml/2006/main">
               <a:ext uri="{FF2B5EF4-FFF2-40B4-BE49-F238E27FC236}">
-                <a16:creationId xmlns:a16="http://schemas.microsoft.com/office/drawing/2014/main" id="{EA6B8F91-5509-4B4B-9C3C-ED80D6C5251B}"/>
+                <a16:creationId xmlns:a16="http://schemas.microsoft.com/office/drawing/2014/main" id="{ADCBF4C5-38CE-4382-ADFF-8D349780FF13}"/>
               </a:ext>
             </a:extLst>
           </p:cNvPr>
@@ -1317,7 +1317,7 @@
           <p:cNvPr id="2" name="Section title">
             <a:extLst xmlns:a="http://schemas.openxmlformats.org/drawingml/2006/main">
               <a:ext uri="{FF2B5EF4-FFF2-40B4-BE49-F238E27FC236}">
-                <a16:creationId xmlns:a16="http://schemas.microsoft.com/office/drawing/2014/main" id="{21A9519E-FBF9-43FA-93B2-B31DDA0C141D}"/>
+                <a16:creationId xmlns:a16="http://schemas.microsoft.com/office/drawing/2014/main" id="{91B867D4-3DA0-47B2-9D01-3112A1B2E3BD}"/>
               </a:ext>
             </a:extLst>
           </p:cNvPr>
@@ -1491,7 +1491,7 @@
           <p:cNvPr id="3" name="Title">
             <a:extLst xmlns:a="http://schemas.openxmlformats.org/drawingml/2006/main">
               <a:ext uri="{FF2B5EF4-FFF2-40B4-BE49-F238E27FC236}">
-                <a16:creationId xmlns:a16="http://schemas.microsoft.com/office/drawing/2014/main" id="{EA6BA450-EE2D-498A-B8C5-5E9E63F6AE3B}"/>
+                <a16:creationId xmlns:a16="http://schemas.microsoft.com/office/drawing/2014/main" id="{3E0D570B-6EBC-43AC-B476-FB076AF1E7A7}"/>
               </a:ext>
             </a:extLst>
           </p:cNvPr>
@@ -1648,7 +1648,7 @@
           <p:cNvPr id="2" name="Body">
             <a:extLst xmlns:a="http://schemas.openxmlformats.org/drawingml/2006/main">
               <a:ext uri="{FF2B5EF4-FFF2-40B4-BE49-F238E27FC236}">
-                <a16:creationId xmlns:a16="http://schemas.microsoft.com/office/drawing/2014/main" id="{F1F6EC7A-3BCB-494E-BDF6-A407637FBE5D}"/>
+                <a16:creationId xmlns:a16="http://schemas.microsoft.com/office/drawing/2014/main" id="{8BD6B71A-F54F-42C7-A877-7354E411401C}"/>
               </a:ext>
             </a:extLst>
           </p:cNvPr>
@@ -1822,7 +1822,7 @@
           <p:cNvPr id="4" name="Title">
             <a:extLst xmlns:a="http://schemas.openxmlformats.org/drawingml/2006/main">
               <a:ext uri="{FF2B5EF4-FFF2-40B4-BE49-F238E27FC236}">
-                <a16:creationId xmlns:a16="http://schemas.microsoft.com/office/drawing/2014/main" id="{D8072316-C6BD-4433-8CB6-8ED38FFF9D72}"/>
+                <a16:creationId xmlns:a16="http://schemas.microsoft.com/office/drawing/2014/main" id="{68C2C14D-F684-4909-88F4-3F250CAAB786}"/>
               </a:ext>
             </a:extLst>
           </p:cNvPr>
@@ -1979,7 +1979,7 @@
           <p:cNvPr id="2" name="Left column">
             <a:extLst xmlns:a="http://schemas.openxmlformats.org/drawingml/2006/main">
               <a:ext uri="{FF2B5EF4-FFF2-40B4-BE49-F238E27FC236}">
-                <a16:creationId xmlns:a16="http://schemas.microsoft.com/office/drawing/2014/main" id="{8365BC37-D593-4BE1-B8B4-A612C93CFD8E}"/>
+                <a16:creationId xmlns:a16="http://schemas.microsoft.com/office/drawing/2014/main" id="{FCDF51D0-11A0-4E3D-A341-7B7B2CE8E009}"/>
               </a:ext>
             </a:extLst>
           </p:cNvPr>
@@ -2136,7 +2136,7 @@
           <p:cNvPr id="3" name="Right column">
             <a:extLst xmlns:a="http://schemas.openxmlformats.org/drawingml/2006/main">
               <a:ext uri="{FF2B5EF4-FFF2-40B4-BE49-F238E27FC236}">
-                <a16:creationId xmlns:a16="http://schemas.microsoft.com/office/drawing/2014/main" id="{979E7B16-753E-4015-8000-450742DCD271}"/>
+                <a16:creationId xmlns:a16="http://schemas.microsoft.com/office/drawing/2014/main" id="{5FD43888-3962-41C3-8D69-C94503E9CB1E}"/>
               </a:ext>
             </a:extLst>
           </p:cNvPr>
@@ -2310,7 +2310,7 @@
           <p:cNvPr id="3" name="Title">
             <a:extLst xmlns:a="http://schemas.openxmlformats.org/drawingml/2006/main">
               <a:ext uri="{FF2B5EF4-FFF2-40B4-BE49-F238E27FC236}">
-                <a16:creationId xmlns:a16="http://schemas.microsoft.com/office/drawing/2014/main" id="{6443D337-3BC4-4995-A4E6-5F85B907D525}"/>
+                <a16:creationId xmlns:a16="http://schemas.microsoft.com/office/drawing/2014/main" id="{5C7F9286-8D75-4BA5-A753-5F902D8904BD}"/>
               </a:ext>
             </a:extLst>
           </p:cNvPr>
@@ -2467,7 +2467,7 @@
           <p:cNvPr id="2" name="Left column">
             <a:extLst xmlns:a="http://schemas.openxmlformats.org/drawingml/2006/main">
               <a:ext uri="{FF2B5EF4-FFF2-40B4-BE49-F238E27FC236}">
-                <a16:creationId xmlns:a16="http://schemas.microsoft.com/office/drawing/2014/main" id="{B4349902-5219-49E5-9EF2-5FD7115225ED}"/>
+                <a16:creationId xmlns:a16="http://schemas.microsoft.com/office/drawing/2014/main" id="{6E137C6C-C699-4A3B-9DF9-6DA18ED53DB5}"/>
               </a:ext>
             </a:extLst>
           </p:cNvPr>
@@ -2662,12 +2662,12 @@
   </p:cSld>
   <p:clrMap bg1="lt1" tx1="dk1" bg2="lt2" tx2="dk2" accent1="accent1" accent2="accent2" accent3="accent3" accent4="accent4" accent5="accent5" accent6="accent6" hlink="hlink" folHlink="folHlink"/>
   <p:sldLayoutIdLst>
-    <p:sldLayoutId xmlns:r="http://schemas.openxmlformats.org/officeDocument/2006/relationships" id="2147483649" r:id="R8c57d72e0bc3468b"/>
-    <p:sldLayoutId xmlns:r="http://schemas.openxmlformats.org/officeDocument/2006/relationships" id="2147483650" r:id="R0293d6e23782453b"/>
-    <p:sldLayoutId xmlns:r="http://schemas.openxmlformats.org/officeDocument/2006/relationships" id="2147483651" r:id="Rf00b4e3903384bd5"/>
-    <p:sldLayoutId xmlns:r="http://schemas.openxmlformats.org/officeDocument/2006/relationships" id="2147483652" r:id="Rb962b177267a48d7"/>
-    <p:sldLayoutId xmlns:r="http://schemas.openxmlformats.org/officeDocument/2006/relationships" id="2147483653" r:id="R3057f58f9b084090"/>
-    <p:sldLayoutId xmlns:r="http://schemas.openxmlformats.org/officeDocument/2006/relationships" id="2147483654" r:id="Rcd59f86f3a4d47b2"/>
+    <p:sldLayoutId xmlns:r="http://schemas.openxmlformats.org/officeDocument/2006/relationships" id="2147483649" r:id="R233f2e708c214e04"/>
+    <p:sldLayoutId xmlns:r="http://schemas.openxmlformats.org/officeDocument/2006/relationships" id="2147483650" r:id="R16173458a66b442b"/>
+    <p:sldLayoutId xmlns:r="http://schemas.openxmlformats.org/officeDocument/2006/relationships" id="2147483651" r:id="Rb005901e47b247ed"/>
+    <p:sldLayoutId xmlns:r="http://schemas.openxmlformats.org/officeDocument/2006/relationships" id="2147483652" r:id="Rb8747a1593ac46e5"/>
+    <p:sldLayoutId xmlns:r="http://schemas.openxmlformats.org/officeDocument/2006/relationships" id="2147483653" r:id="R48da9b55596e4ba5"/>
+    <p:sldLayoutId xmlns:r="http://schemas.openxmlformats.org/officeDocument/2006/relationships" id="2147483654" r:id="Re252940858574bd5"/>
   </p:sldLayoutIdLst>
   <p:txStyles>
     <p:titleStyle>
@@ -3218,7 +3218,7 @@
           <p:cNvPr id="17" name="">
             <a:extLst xmlns:a="http://schemas.openxmlformats.org/drawingml/2006/main">
               <a:ext uri="{FF2B5EF4-FFF2-40B4-BE49-F238E27FC236}">
-                <a16:creationId xmlns:a16="http://schemas.microsoft.com/office/drawing/2014/main" id="{18F0D5F2-C12D-4E15-A331-126E9EC351DF}"/>
+                <a16:creationId xmlns:a16="http://schemas.microsoft.com/office/drawing/2014/main" id="{75A17CB0-39A8-4057-8703-88DC0F47DA44}"/>
               </a:ext>
             </a:extLst>
           </p:cNvPr>
@@ -3285,7 +3285,7 @@
           <p:cNvPr id="2" name="">
             <a:extLst xmlns:a="http://schemas.openxmlformats.org/drawingml/2006/main">
               <a:ext uri="{FF2B5EF4-FFF2-40B4-BE49-F238E27FC236}">
-                <a16:creationId xmlns:a16="http://schemas.microsoft.com/office/drawing/2014/main" id="{9CB2C3C6-B61A-430B-8269-DCA1A8055E42}"/>
+                <a16:creationId xmlns:a16="http://schemas.microsoft.com/office/drawing/2014/main" id="{8E7AA5AE-3884-4754-BB21-036316BC93B7}"/>
               </a:ext>
             </a:extLst>
           </p:cNvPr>
@@ -3352,7 +3352,7 @@
           <p:cNvPr id="3" name="">
             <a:extLst xmlns:a="http://schemas.openxmlformats.org/drawingml/2006/main">
               <a:ext uri="{FF2B5EF4-FFF2-40B4-BE49-F238E27FC236}">
-                <a16:creationId xmlns:a16="http://schemas.microsoft.com/office/drawing/2014/main" id="{D954B08E-70D2-48D4-BD99-32420D842391}"/>
+                <a16:creationId xmlns:a16="http://schemas.microsoft.com/office/drawing/2014/main" id="{C52E8E11-3AAB-4161-BA43-A873C284EE78}"/>
               </a:ext>
             </a:extLst>
           </p:cNvPr>
@@ -3419,7 +3419,7 @@
           <p:cNvPr id="4" name="">
             <a:extLst xmlns:a="http://schemas.openxmlformats.org/drawingml/2006/main">
               <a:ext uri="{FF2B5EF4-FFF2-40B4-BE49-F238E27FC236}">
-                <a16:creationId xmlns:a16="http://schemas.microsoft.com/office/drawing/2014/main" id="{8CAD2439-400F-47B7-BC8B-1B191BA7BD9C}"/>
+                <a16:creationId xmlns:a16="http://schemas.microsoft.com/office/drawing/2014/main" id="{B79EDA0C-5311-4F7A-B0E4-BC61B4DD2BBA}"/>
               </a:ext>
             </a:extLst>
           </p:cNvPr>
@@ -3450,7 +3450,7 @@
           <p:cNvPr id="5" name="">
             <a:extLst xmlns:a="http://schemas.openxmlformats.org/drawingml/2006/main">
               <a:ext uri="{FF2B5EF4-FFF2-40B4-BE49-F238E27FC236}">
-                <a16:creationId xmlns:a16="http://schemas.microsoft.com/office/drawing/2014/main" id="{E6203AED-F4B7-4FAC-8669-B1DE88056755}"/>
+                <a16:creationId xmlns:a16="http://schemas.microsoft.com/office/drawing/2014/main" id="{A997853C-D0FA-442D-B83B-10E243559DD1}"/>
               </a:ext>
             </a:extLst>
           </p:cNvPr>
@@ -3507,7 +3507,7 @@
                 <a:ea typeface="Aptos"/>
                 <a:cs typeface="Aptos"/>
               </a:rPr>
-              <a:t>INERTIA-2026-10-22-r6 · 22 October 2026 · Autonomous build</a:t>
+              <a:t>INERTIA-2026-10-23-r7 · 23 October 2026 · Autonomous build</a:t>
             </a:r>
           </a:p>
         </p:txBody>
@@ -3517,7 +3517,7 @@
           <p:cNvPr id="6" name="">
             <a:extLst xmlns:a="http://schemas.openxmlformats.org/drawingml/2006/main">
               <a:ext uri="{FF2B5EF4-FFF2-40B4-BE49-F238E27FC236}">
-                <a16:creationId xmlns:a16="http://schemas.microsoft.com/office/drawing/2014/main" id="{AE2EC293-047E-4D0D-9C76-830648911ED9}"/>
+                <a16:creationId xmlns:a16="http://schemas.microsoft.com/office/drawing/2014/main" id="{E1AAD32A-738A-4B4D-AF3B-E1039F8B2359}"/>
               </a:ext>
             </a:extLst>
           </p:cNvPr>
@@ -3584,7 +3584,7 @@
           <p:cNvPr id="7" name="">
             <a:extLst xmlns:a="http://schemas.openxmlformats.org/drawingml/2006/main">
               <a:ext uri="{FF2B5EF4-FFF2-40B4-BE49-F238E27FC236}">
-                <a16:creationId xmlns:a16="http://schemas.microsoft.com/office/drawing/2014/main" id="{43EBA0A8-A765-42A6-BFC7-70FD9067A607}"/>
+                <a16:creationId xmlns:a16="http://schemas.microsoft.com/office/drawing/2014/main" id="{895CD7D3-4E64-4D64-95EC-AE898156BC0D}"/>
               </a:ext>
             </a:extLst>
           </p:cNvPr>
@@ -3617,7 +3617,7 @@
           <p:cNvPr id="8" name="">
             <a:extLst xmlns:a="http://schemas.openxmlformats.org/drawingml/2006/main">
               <a:ext uri="{FF2B5EF4-FFF2-40B4-BE49-F238E27FC236}">
-                <a16:creationId xmlns:a16="http://schemas.microsoft.com/office/drawing/2014/main" id="{5B315368-6FA2-4C94-BE4C-90CC68B031EF}"/>
+                <a16:creationId xmlns:a16="http://schemas.microsoft.com/office/drawing/2014/main" id="{0822820E-389C-4386-ABF5-8F3E89F88428}"/>
               </a:ext>
             </a:extLst>
           </p:cNvPr>
@@ -3684,7 +3684,7 @@
           <p:cNvPr id="9" name="">
             <a:extLst xmlns:a="http://schemas.openxmlformats.org/drawingml/2006/main">
               <a:ext uri="{FF2B5EF4-FFF2-40B4-BE49-F238E27FC236}">
-                <a16:creationId xmlns:a16="http://schemas.microsoft.com/office/drawing/2014/main" id="{1979C0B7-880F-4130-8A84-708C4C367E41}"/>
+                <a16:creationId xmlns:a16="http://schemas.microsoft.com/office/drawing/2014/main" id="{4DF2FB39-8503-4F7F-A20E-D799FFC3CB8D}"/>
               </a:ext>
             </a:extLst>
           </p:cNvPr>
@@ -3820,7 +3820,7 @@
           <p:cNvPr id="10" name="">
             <a:extLst xmlns:a="http://schemas.openxmlformats.org/drawingml/2006/main">
               <a:ext uri="{FF2B5EF4-FFF2-40B4-BE49-F238E27FC236}">
-                <a16:creationId xmlns:a16="http://schemas.microsoft.com/office/drawing/2014/main" id="{9DAF82BC-8350-4090-B196-DFE9144D3C03}"/>
+                <a16:creationId xmlns:a16="http://schemas.microsoft.com/office/drawing/2014/main" id="{4394AFB3-3884-4B91-84F9-D9DBD29A978D}"/>
               </a:ext>
             </a:extLst>
           </p:cNvPr>
@@ -3853,7 +3853,7 @@
           <p:cNvPr id="11" name="">
             <a:extLst xmlns:a="http://schemas.openxmlformats.org/drawingml/2006/main">
               <a:ext uri="{FF2B5EF4-FFF2-40B4-BE49-F238E27FC236}">
-                <a16:creationId xmlns:a16="http://schemas.microsoft.com/office/drawing/2014/main" id="{FB37A1F1-3FD0-4275-BCC6-12F1BA5DF000}"/>
+                <a16:creationId xmlns:a16="http://schemas.microsoft.com/office/drawing/2014/main" id="{D6201A74-09B1-4889-AF4F-41F9C25DA6FA}"/>
               </a:ext>
             </a:extLst>
           </p:cNvPr>
@@ -3920,7 +3920,7 @@
           <p:cNvPr id="12" name="">
             <a:extLst xmlns:a="http://schemas.openxmlformats.org/drawingml/2006/main">
               <a:ext uri="{FF2B5EF4-FFF2-40B4-BE49-F238E27FC236}">
-                <a16:creationId xmlns:a16="http://schemas.microsoft.com/office/drawing/2014/main" id="{88C78972-E46C-4B6F-BC16-BE2DAAC57BE9}"/>
+                <a16:creationId xmlns:a16="http://schemas.microsoft.com/office/drawing/2014/main" id="{71961843-971E-4E58-A870-49045C7CBA83}"/>
               </a:ext>
             </a:extLst>
           </p:cNvPr>
@@ -4056,7 +4056,7 @@
           <p:cNvPr id="13" name="">
             <a:extLst xmlns:a="http://schemas.openxmlformats.org/drawingml/2006/main">
               <a:ext uri="{FF2B5EF4-FFF2-40B4-BE49-F238E27FC236}">
-                <a16:creationId xmlns:a16="http://schemas.microsoft.com/office/drawing/2014/main" id="{BE83E02F-EDCA-455C-B07A-662C6CD036C9}"/>
+                <a16:creationId xmlns:a16="http://schemas.microsoft.com/office/drawing/2014/main" id="{42A6583E-D56A-43F0-97A0-A8C7DC6F55E2}"/>
               </a:ext>
             </a:extLst>
           </p:cNvPr>
@@ -4089,7 +4089,7 @@
           <p:cNvPr id="14" name="">
             <a:extLst xmlns:a="http://schemas.openxmlformats.org/drawingml/2006/main">
               <a:ext uri="{FF2B5EF4-FFF2-40B4-BE49-F238E27FC236}">
-                <a16:creationId xmlns:a16="http://schemas.microsoft.com/office/drawing/2014/main" id="{88EFBBB1-2A79-4490-84C5-A53A01473DEE}"/>
+                <a16:creationId xmlns:a16="http://schemas.microsoft.com/office/drawing/2014/main" id="{07AD5DAD-5402-4ACA-B83A-9A0DD58443A8}"/>
               </a:ext>
             </a:extLst>
           </p:cNvPr>
@@ -4156,7 +4156,7 @@
           <p:cNvPr id="15" name="">
             <a:extLst xmlns:a="http://schemas.openxmlformats.org/drawingml/2006/main">
               <a:ext uri="{FF2B5EF4-FFF2-40B4-BE49-F238E27FC236}">
-                <a16:creationId xmlns:a16="http://schemas.microsoft.com/office/drawing/2014/main" id="{ED9D4108-5BBB-4249-9AC9-1CE09E26B5E4}"/>
+                <a16:creationId xmlns:a16="http://schemas.microsoft.com/office/drawing/2014/main" id="{BC00549C-210B-4AA3-B9A5-A2121A074DE9}"/>
               </a:ext>
             </a:extLst>
           </p:cNvPr>
@@ -4292,7 +4292,7 @@
           <p:cNvPr id="16" name="">
             <a:extLst xmlns:a="http://schemas.openxmlformats.org/drawingml/2006/main">
               <a:ext uri="{FF2B5EF4-FFF2-40B4-BE49-F238E27FC236}">
-                <a16:creationId xmlns:a16="http://schemas.microsoft.com/office/drawing/2014/main" id="{46AD2712-6E4F-481F-8740-D011F03C8708}"/>
+                <a16:creationId xmlns:a16="http://schemas.microsoft.com/office/drawing/2014/main" id="{E07F0EA3-9DEE-4358-9B37-79AC719B0BDB}"/>
               </a:ext>
             </a:extLst>
           </p:cNvPr>
@@ -4357,7 +4357,7 @@
     </p:spTree>
     <p:extLst>
       <p:ext uri="{BB962C8B-B14F-4D97-AF65-F5344CB8AC3E}">
-        <p14:creationId xmlns:p14="http://schemas.microsoft.com/office/powerpoint/2010/main" val="210611669"/>
+        <p14:creationId xmlns:p14="http://schemas.microsoft.com/office/powerpoint/2010/main" val="1968587660"/>
       </p:ext>
     </p:extLst>
   </p:cSld>
@@ -4388,7 +4388,7 @@
           <p:cNvPr id="17" name="">
             <a:extLst xmlns:a="http://schemas.openxmlformats.org/drawingml/2006/main">
               <a:ext uri="{FF2B5EF4-FFF2-40B4-BE49-F238E27FC236}">
-                <a16:creationId xmlns:a16="http://schemas.microsoft.com/office/drawing/2014/main" id="{7FDB1E3D-14E6-4B82-BA03-F8C55EC22F4A}"/>
+                <a16:creationId xmlns:a16="http://schemas.microsoft.com/office/drawing/2014/main" id="{EE06281D-7DA2-4A51-9FB6-D45B89B30533}"/>
               </a:ext>
             </a:extLst>
           </p:cNvPr>
@@ -4455,7 +4455,7 @@
           <p:cNvPr id="2" name="">
             <a:extLst xmlns:a="http://schemas.openxmlformats.org/drawingml/2006/main">
               <a:ext uri="{FF2B5EF4-FFF2-40B4-BE49-F238E27FC236}">
-                <a16:creationId xmlns:a16="http://schemas.microsoft.com/office/drawing/2014/main" id="{447186F9-1F90-452E-B2CC-2B9C61F25805}"/>
+                <a16:creationId xmlns:a16="http://schemas.microsoft.com/office/drawing/2014/main" id="{53C260F7-D566-4389-8653-E77D369EAE33}"/>
               </a:ext>
             </a:extLst>
           </p:cNvPr>
@@ -4522,7 +4522,7 @@
           <p:cNvPr id="3" name="">
             <a:extLst xmlns:a="http://schemas.openxmlformats.org/drawingml/2006/main">
               <a:ext uri="{FF2B5EF4-FFF2-40B4-BE49-F238E27FC236}">
-                <a16:creationId xmlns:a16="http://schemas.microsoft.com/office/drawing/2014/main" id="{892CFB54-6CB7-4E30-B7A0-879E1B639ED8}"/>
+                <a16:creationId xmlns:a16="http://schemas.microsoft.com/office/drawing/2014/main" id="{B06AB686-7526-49D9-BFF9-E1FDC2B46EF9}"/>
               </a:ext>
             </a:extLst>
           </p:cNvPr>
@@ -4589,7 +4589,7 @@
           <p:cNvPr id="4" name="">
             <a:extLst xmlns:a="http://schemas.openxmlformats.org/drawingml/2006/main">
               <a:ext uri="{FF2B5EF4-FFF2-40B4-BE49-F238E27FC236}">
-                <a16:creationId xmlns:a16="http://schemas.microsoft.com/office/drawing/2014/main" id="{79822DEE-9BDB-4B9F-95D2-08D03800DC42}"/>
+                <a16:creationId xmlns:a16="http://schemas.microsoft.com/office/drawing/2014/main" id="{C659046B-B47F-4269-8A3F-B410C60F3E1D}"/>
               </a:ext>
             </a:extLst>
           </p:cNvPr>
@@ -4620,7 +4620,7 @@
           <p:cNvPr id="5" name="">
             <a:extLst xmlns:a="http://schemas.openxmlformats.org/drawingml/2006/main">
               <a:ext uri="{FF2B5EF4-FFF2-40B4-BE49-F238E27FC236}">
-                <a16:creationId xmlns:a16="http://schemas.microsoft.com/office/drawing/2014/main" id="{87B22CF7-2F37-4043-A998-159758858DE7}"/>
+                <a16:creationId xmlns:a16="http://schemas.microsoft.com/office/drawing/2014/main" id="{E734B095-112B-43C9-B8C3-FED820A4522A}"/>
               </a:ext>
             </a:extLst>
           </p:cNvPr>
@@ -4677,7 +4677,7 @@
                 <a:ea typeface="Aptos"/>
                 <a:cs typeface="Aptos"/>
               </a:rPr>
-              <a:t>INERTIA-2026-10-22-r6 · 22 October 2026 · Autonomous build</a:t>
+              <a:t>INERTIA-2026-10-23-r7 · 23 October 2026 · Autonomous build</a:t>
             </a:r>
           </a:p>
         </p:txBody>
@@ -4687,7 +4687,7 @@
           <p:cNvPr id="6" name="">
             <a:extLst xmlns:a="http://schemas.openxmlformats.org/drawingml/2006/main">
               <a:ext uri="{FF2B5EF4-FFF2-40B4-BE49-F238E27FC236}">
-                <a16:creationId xmlns:a16="http://schemas.microsoft.com/office/drawing/2014/main" id="{9670D08E-CA51-4233-B455-D689C0422AF0}"/>
+                <a16:creationId xmlns:a16="http://schemas.microsoft.com/office/drawing/2014/main" id="{C14636F2-19A8-4444-9E5C-EAC575F842E8}"/>
               </a:ext>
             </a:extLst>
           </p:cNvPr>
@@ -4754,7 +4754,7 @@
           <p:cNvPr id="7" name="">
             <a:extLst xmlns:a="http://schemas.openxmlformats.org/drawingml/2006/main">
               <a:ext uri="{FF2B5EF4-FFF2-40B4-BE49-F238E27FC236}">
-                <a16:creationId xmlns:a16="http://schemas.microsoft.com/office/drawing/2014/main" id="{1E44DB16-86B0-4A3A-B776-408D486ABCC7}"/>
+                <a16:creationId xmlns:a16="http://schemas.microsoft.com/office/drawing/2014/main" id="{00F6D0B6-C34F-4F11-95B4-E702EE3C5D89}"/>
               </a:ext>
             </a:extLst>
           </p:cNvPr>
@@ -4787,7 +4787,7 @@
           <p:cNvPr id="8" name="">
             <a:extLst xmlns:a="http://schemas.openxmlformats.org/drawingml/2006/main">
               <a:ext uri="{FF2B5EF4-FFF2-40B4-BE49-F238E27FC236}">
-                <a16:creationId xmlns:a16="http://schemas.microsoft.com/office/drawing/2014/main" id="{CAB656FB-4476-44A8-9041-21949A6D60B1}"/>
+                <a16:creationId xmlns:a16="http://schemas.microsoft.com/office/drawing/2014/main" id="{41AA1ADC-CCFE-4008-9E98-BF3BBF7DF52A}"/>
               </a:ext>
             </a:extLst>
           </p:cNvPr>
@@ -4854,7 +4854,7 @@
           <p:cNvPr id="9" name="">
             <a:extLst xmlns:a="http://schemas.openxmlformats.org/drawingml/2006/main">
               <a:ext uri="{FF2B5EF4-FFF2-40B4-BE49-F238E27FC236}">
-                <a16:creationId xmlns:a16="http://schemas.microsoft.com/office/drawing/2014/main" id="{06EA6574-CEA2-48F0-8CE6-A9322B137457}"/>
+                <a16:creationId xmlns:a16="http://schemas.microsoft.com/office/drawing/2014/main" id="{95F2B8EF-39D5-412B-8A7B-24B0745D6BAE}"/>
               </a:ext>
             </a:extLst>
           </p:cNvPr>
@@ -4990,7 +4990,7 @@
           <p:cNvPr id="10" name="">
             <a:extLst xmlns:a="http://schemas.openxmlformats.org/drawingml/2006/main">
               <a:ext uri="{FF2B5EF4-FFF2-40B4-BE49-F238E27FC236}">
-                <a16:creationId xmlns:a16="http://schemas.microsoft.com/office/drawing/2014/main" id="{2309BDC6-461C-45CA-B060-03EEB742AB3D}"/>
+                <a16:creationId xmlns:a16="http://schemas.microsoft.com/office/drawing/2014/main" id="{104C8D86-6522-47BF-A332-D13A05656B5D}"/>
               </a:ext>
             </a:extLst>
           </p:cNvPr>
@@ -5023,7 +5023,7 @@
           <p:cNvPr id="11" name="">
             <a:extLst xmlns:a="http://schemas.openxmlformats.org/drawingml/2006/main">
               <a:ext uri="{FF2B5EF4-FFF2-40B4-BE49-F238E27FC236}">
-                <a16:creationId xmlns:a16="http://schemas.microsoft.com/office/drawing/2014/main" id="{C8968B24-F8F6-446A-801A-08FDEFAE1C68}"/>
+                <a16:creationId xmlns:a16="http://schemas.microsoft.com/office/drawing/2014/main" id="{8E2D9FF4-17E6-413C-9349-22137D1EC7E0}"/>
               </a:ext>
             </a:extLst>
           </p:cNvPr>
@@ -5090,7 +5090,7 @@
           <p:cNvPr id="12" name="">
             <a:extLst xmlns:a="http://schemas.openxmlformats.org/drawingml/2006/main">
               <a:ext uri="{FF2B5EF4-FFF2-40B4-BE49-F238E27FC236}">
-                <a16:creationId xmlns:a16="http://schemas.microsoft.com/office/drawing/2014/main" id="{58A10BD4-424D-4F69-877C-BCB1DF973486}"/>
+                <a16:creationId xmlns:a16="http://schemas.microsoft.com/office/drawing/2014/main" id="{51029DB9-D370-43DB-8A01-DCC57E26F78B}"/>
               </a:ext>
             </a:extLst>
           </p:cNvPr>
@@ -5226,7 +5226,7 @@
           <p:cNvPr id="13" name="">
             <a:extLst xmlns:a="http://schemas.openxmlformats.org/drawingml/2006/main">
               <a:ext uri="{FF2B5EF4-FFF2-40B4-BE49-F238E27FC236}">
-                <a16:creationId xmlns:a16="http://schemas.microsoft.com/office/drawing/2014/main" id="{9AB4E859-0FAF-4674-AB2F-3EDE7D329C90}"/>
+                <a16:creationId xmlns:a16="http://schemas.microsoft.com/office/drawing/2014/main" id="{2995EA0B-045D-491F-80B4-C54E28EFA07C}"/>
               </a:ext>
             </a:extLst>
           </p:cNvPr>
@@ -5259,7 +5259,7 @@
           <p:cNvPr id="14" name="">
             <a:extLst xmlns:a="http://schemas.openxmlformats.org/drawingml/2006/main">
               <a:ext uri="{FF2B5EF4-FFF2-40B4-BE49-F238E27FC236}">
-                <a16:creationId xmlns:a16="http://schemas.microsoft.com/office/drawing/2014/main" id="{A56A4B57-50B5-4EDB-9D4A-DAEB97B403D5}"/>
+                <a16:creationId xmlns:a16="http://schemas.microsoft.com/office/drawing/2014/main" id="{A89751F6-B7D3-4B44-8391-576F0F93809D}"/>
               </a:ext>
             </a:extLst>
           </p:cNvPr>
@@ -5326,7 +5326,7 @@
           <p:cNvPr id="15" name="">
             <a:extLst xmlns:a="http://schemas.openxmlformats.org/drawingml/2006/main">
               <a:ext uri="{FF2B5EF4-FFF2-40B4-BE49-F238E27FC236}">
-                <a16:creationId xmlns:a16="http://schemas.microsoft.com/office/drawing/2014/main" id="{039A0B8E-E7B4-4CDA-A507-50859BBBA647}"/>
+                <a16:creationId xmlns:a16="http://schemas.microsoft.com/office/drawing/2014/main" id="{F2747B70-629C-4D99-BD56-6DA417CFD4E2}"/>
               </a:ext>
             </a:extLst>
           </p:cNvPr>
@@ -5462,7 +5462,7 @@
           <p:cNvPr id="16" name="">
             <a:extLst xmlns:a="http://schemas.openxmlformats.org/drawingml/2006/main">
               <a:ext uri="{FF2B5EF4-FFF2-40B4-BE49-F238E27FC236}">
-                <a16:creationId xmlns:a16="http://schemas.microsoft.com/office/drawing/2014/main" id="{7D1BEF74-5AF5-4DF4-880A-ADC2EDE4E752}"/>
+                <a16:creationId xmlns:a16="http://schemas.microsoft.com/office/drawing/2014/main" id="{B450F4DE-8F17-40A3-AA49-4DD93E986894}"/>
               </a:ext>
             </a:extLst>
           </p:cNvPr>
@@ -5527,7 +5527,7 @@
     </p:spTree>
     <p:extLst>
       <p:ext uri="{BB962C8B-B14F-4D97-AF65-F5344CB8AC3E}">
-        <p14:creationId xmlns:p14="http://schemas.microsoft.com/office/powerpoint/2010/main" val="559018357"/>
+        <p14:creationId xmlns:p14="http://schemas.microsoft.com/office/powerpoint/2010/main" val="733959173"/>
       </p:ext>
     </p:extLst>
   </p:cSld>
@@ -5558,7 +5558,7 @@
           <p:cNvPr id="17" name="">
             <a:extLst xmlns:a="http://schemas.openxmlformats.org/drawingml/2006/main">
               <a:ext uri="{FF2B5EF4-FFF2-40B4-BE49-F238E27FC236}">
-                <a16:creationId xmlns:a16="http://schemas.microsoft.com/office/drawing/2014/main" id="{319E6743-03AF-46EE-A123-BC5277600AC1}"/>
+                <a16:creationId xmlns:a16="http://schemas.microsoft.com/office/drawing/2014/main" id="{8CF80F0F-375A-4B24-A0C5-A8CBDDE1ED60}"/>
               </a:ext>
             </a:extLst>
           </p:cNvPr>
@@ -5625,7 +5625,7 @@
           <p:cNvPr id="2" name="">
             <a:extLst xmlns:a="http://schemas.openxmlformats.org/drawingml/2006/main">
               <a:ext uri="{FF2B5EF4-FFF2-40B4-BE49-F238E27FC236}">
-                <a16:creationId xmlns:a16="http://schemas.microsoft.com/office/drawing/2014/main" id="{0E5E0A98-4101-4121-B59A-D41F47249808}"/>
+                <a16:creationId xmlns:a16="http://schemas.microsoft.com/office/drawing/2014/main" id="{95F88023-8372-4D9F-AE47-A9345B2F0AF8}"/>
               </a:ext>
             </a:extLst>
           </p:cNvPr>
@@ -5692,7 +5692,7 @@
           <p:cNvPr id="3" name="">
             <a:extLst xmlns:a="http://schemas.openxmlformats.org/drawingml/2006/main">
               <a:ext uri="{FF2B5EF4-FFF2-40B4-BE49-F238E27FC236}">
-                <a16:creationId xmlns:a16="http://schemas.microsoft.com/office/drawing/2014/main" id="{A9A296B7-3458-4C32-A4AA-B18835F01475}"/>
+                <a16:creationId xmlns:a16="http://schemas.microsoft.com/office/drawing/2014/main" id="{1AFD17F5-A822-4FC5-83B8-7A3C435B8022}"/>
               </a:ext>
             </a:extLst>
           </p:cNvPr>
@@ -5759,7 +5759,7 @@
           <p:cNvPr id="4" name="">
             <a:extLst xmlns:a="http://schemas.openxmlformats.org/drawingml/2006/main">
               <a:ext uri="{FF2B5EF4-FFF2-40B4-BE49-F238E27FC236}">
-                <a16:creationId xmlns:a16="http://schemas.microsoft.com/office/drawing/2014/main" id="{F1013BEB-9F03-4C4B-8E9B-783A5CCEEB6B}"/>
+                <a16:creationId xmlns:a16="http://schemas.microsoft.com/office/drawing/2014/main" id="{F7802C5E-0670-40F2-997D-DA582BC5F085}"/>
               </a:ext>
             </a:extLst>
           </p:cNvPr>
@@ -5790,7 +5790,7 @@
           <p:cNvPr id="5" name="">
             <a:extLst xmlns:a="http://schemas.openxmlformats.org/drawingml/2006/main">
               <a:ext uri="{FF2B5EF4-FFF2-40B4-BE49-F238E27FC236}">
-                <a16:creationId xmlns:a16="http://schemas.microsoft.com/office/drawing/2014/main" id="{1E6CEA3E-86F4-47E3-935A-39DF16D29EE8}"/>
+                <a16:creationId xmlns:a16="http://schemas.microsoft.com/office/drawing/2014/main" id="{5D677A4C-05D8-406A-9A87-EBD6B2AFAC4E}"/>
               </a:ext>
             </a:extLst>
           </p:cNvPr>
@@ -5847,7 +5847,7 @@
                 <a:ea typeface="Aptos"/>
                 <a:cs typeface="Aptos"/>
               </a:rPr>
-              <a:t>INERTIA-2026-10-22-r6 · 22 October 2026 · Autonomous build</a:t>
+              <a:t>INERTIA-2026-10-23-r7 · 23 October 2026 · Autonomous build</a:t>
             </a:r>
           </a:p>
         </p:txBody>
@@ -5857,7 +5857,7 @@
           <p:cNvPr id="6" name="">
             <a:extLst xmlns:a="http://schemas.openxmlformats.org/drawingml/2006/main">
               <a:ext uri="{FF2B5EF4-FFF2-40B4-BE49-F238E27FC236}">
-                <a16:creationId xmlns:a16="http://schemas.microsoft.com/office/drawing/2014/main" id="{9B07308A-CE4F-4AC5-9B17-2DB64AEAD30B}"/>
+                <a16:creationId xmlns:a16="http://schemas.microsoft.com/office/drawing/2014/main" id="{D264DAEF-B56A-4E10-94A2-06346AE44A35}"/>
               </a:ext>
             </a:extLst>
           </p:cNvPr>
@@ -5924,7 +5924,7 @@
           <p:cNvPr id="7" name="">
             <a:extLst xmlns:a="http://schemas.openxmlformats.org/drawingml/2006/main">
               <a:ext uri="{FF2B5EF4-FFF2-40B4-BE49-F238E27FC236}">
-                <a16:creationId xmlns:a16="http://schemas.microsoft.com/office/drawing/2014/main" id="{38D3E445-5CDC-4B45-A494-8A1E92FEABCF}"/>
+                <a16:creationId xmlns:a16="http://schemas.microsoft.com/office/drawing/2014/main" id="{1DA0AE12-E67A-47B6-848C-EFBF3557132E}"/>
               </a:ext>
             </a:extLst>
           </p:cNvPr>
@@ -5957,7 +5957,7 @@
           <p:cNvPr id="8" name="">
             <a:extLst xmlns:a="http://schemas.openxmlformats.org/drawingml/2006/main">
               <a:ext uri="{FF2B5EF4-FFF2-40B4-BE49-F238E27FC236}">
-                <a16:creationId xmlns:a16="http://schemas.microsoft.com/office/drawing/2014/main" id="{6D4DD690-7815-45AC-9050-77846EBBD068}"/>
+                <a16:creationId xmlns:a16="http://schemas.microsoft.com/office/drawing/2014/main" id="{7CB359B6-55AA-467E-A1E0-849449F2DDA2}"/>
               </a:ext>
             </a:extLst>
           </p:cNvPr>
@@ -6024,7 +6024,7 @@
           <p:cNvPr id="9" name="">
             <a:extLst xmlns:a="http://schemas.openxmlformats.org/drawingml/2006/main">
               <a:ext uri="{FF2B5EF4-FFF2-40B4-BE49-F238E27FC236}">
-                <a16:creationId xmlns:a16="http://schemas.microsoft.com/office/drawing/2014/main" id="{4E5587FC-D2CE-4C8A-AB54-900FC19A45D0}"/>
+                <a16:creationId xmlns:a16="http://schemas.microsoft.com/office/drawing/2014/main" id="{35525060-F203-465B-804A-C4F0859369D1}"/>
               </a:ext>
             </a:extLst>
           </p:cNvPr>
@@ -6160,7 +6160,7 @@
           <p:cNvPr id="10" name="">
             <a:extLst xmlns:a="http://schemas.openxmlformats.org/drawingml/2006/main">
               <a:ext uri="{FF2B5EF4-FFF2-40B4-BE49-F238E27FC236}">
-                <a16:creationId xmlns:a16="http://schemas.microsoft.com/office/drawing/2014/main" id="{680E04DA-B97B-4FCB-A922-EDB04BE4B8F8}"/>
+                <a16:creationId xmlns:a16="http://schemas.microsoft.com/office/drawing/2014/main" id="{E2A8BDE7-EB9F-484E-B8C4-5C7DD6286A49}"/>
               </a:ext>
             </a:extLst>
           </p:cNvPr>
@@ -6193,7 +6193,7 @@
           <p:cNvPr id="11" name="">
             <a:extLst xmlns:a="http://schemas.openxmlformats.org/drawingml/2006/main">
               <a:ext uri="{FF2B5EF4-FFF2-40B4-BE49-F238E27FC236}">
-                <a16:creationId xmlns:a16="http://schemas.microsoft.com/office/drawing/2014/main" id="{542D52CC-DEE8-483A-ABCC-CF7591802FEF}"/>
+                <a16:creationId xmlns:a16="http://schemas.microsoft.com/office/drawing/2014/main" id="{EEE638D8-CD51-41FA-B258-DD582E92B9C7}"/>
               </a:ext>
             </a:extLst>
           </p:cNvPr>
@@ -6260,7 +6260,7 @@
           <p:cNvPr id="12" name="">
             <a:extLst xmlns:a="http://schemas.openxmlformats.org/drawingml/2006/main">
               <a:ext uri="{FF2B5EF4-FFF2-40B4-BE49-F238E27FC236}">
-                <a16:creationId xmlns:a16="http://schemas.microsoft.com/office/drawing/2014/main" id="{AAAE2A79-0B08-464E-94C2-934ED636ABF7}"/>
+                <a16:creationId xmlns:a16="http://schemas.microsoft.com/office/drawing/2014/main" id="{BC9D344B-EE5B-4FE6-961D-BBCE8E8F592F}"/>
               </a:ext>
             </a:extLst>
           </p:cNvPr>
@@ -6396,7 +6396,7 @@
           <p:cNvPr id="13" name="">
             <a:extLst xmlns:a="http://schemas.openxmlformats.org/drawingml/2006/main">
               <a:ext uri="{FF2B5EF4-FFF2-40B4-BE49-F238E27FC236}">
-                <a16:creationId xmlns:a16="http://schemas.microsoft.com/office/drawing/2014/main" id="{1C019A24-69A3-416A-907D-87F0F7460D76}"/>
+                <a16:creationId xmlns:a16="http://schemas.microsoft.com/office/drawing/2014/main" id="{39675A13-9C7C-400A-9B51-0C8CE7965117}"/>
               </a:ext>
             </a:extLst>
           </p:cNvPr>
@@ -6429,7 +6429,7 @@
           <p:cNvPr id="14" name="">
             <a:extLst xmlns:a="http://schemas.openxmlformats.org/drawingml/2006/main">
               <a:ext uri="{FF2B5EF4-FFF2-40B4-BE49-F238E27FC236}">
-                <a16:creationId xmlns:a16="http://schemas.microsoft.com/office/drawing/2014/main" id="{92B17FEF-C16B-4B76-9439-AC8CAD19F4CB}"/>
+                <a16:creationId xmlns:a16="http://schemas.microsoft.com/office/drawing/2014/main" id="{36561293-C6F2-470F-85CC-5CE76B44E89D}"/>
               </a:ext>
             </a:extLst>
           </p:cNvPr>
@@ -6496,7 +6496,7 @@
           <p:cNvPr id="15" name="">
             <a:extLst xmlns:a="http://schemas.openxmlformats.org/drawingml/2006/main">
               <a:ext uri="{FF2B5EF4-FFF2-40B4-BE49-F238E27FC236}">
-                <a16:creationId xmlns:a16="http://schemas.microsoft.com/office/drawing/2014/main" id="{DC91D38A-A662-46F7-83F6-E54B15781712}"/>
+                <a16:creationId xmlns:a16="http://schemas.microsoft.com/office/drawing/2014/main" id="{E03254B7-D753-4857-8759-D4058038D82C}"/>
               </a:ext>
             </a:extLst>
           </p:cNvPr>
@@ -6632,7 +6632,7 @@
           <p:cNvPr id="16" name="">
             <a:extLst xmlns:a="http://schemas.openxmlformats.org/drawingml/2006/main">
               <a:ext uri="{FF2B5EF4-FFF2-40B4-BE49-F238E27FC236}">
-                <a16:creationId xmlns:a16="http://schemas.microsoft.com/office/drawing/2014/main" id="{B5B2587C-D93F-449E-86C7-87C9C2922318}"/>
+                <a16:creationId xmlns:a16="http://schemas.microsoft.com/office/drawing/2014/main" id="{49CF7F52-762A-48D1-B7F9-0D46C2049BF9}"/>
               </a:ext>
             </a:extLst>
           </p:cNvPr>
@@ -6697,7 +6697,7 @@
     </p:spTree>
     <p:extLst>
       <p:ext uri="{BB962C8B-B14F-4D97-AF65-F5344CB8AC3E}">
-        <p14:creationId xmlns:p14="http://schemas.microsoft.com/office/powerpoint/2010/main" val="2074361515"/>
+        <p14:creationId xmlns:p14="http://schemas.microsoft.com/office/powerpoint/2010/main" val="324729755"/>
       </p:ext>
     </p:extLst>
   </p:cSld>
@@ -6728,7 +6728,7 @@
           <p:cNvPr id="17" name="">
             <a:extLst xmlns:a="http://schemas.openxmlformats.org/drawingml/2006/main">
               <a:ext uri="{FF2B5EF4-FFF2-40B4-BE49-F238E27FC236}">
-                <a16:creationId xmlns:a16="http://schemas.microsoft.com/office/drawing/2014/main" id="{FC4E56A8-E93D-4BF6-91D3-307368775853}"/>
+                <a16:creationId xmlns:a16="http://schemas.microsoft.com/office/drawing/2014/main" id="{01DC6921-6E3D-49C1-B77F-EBE2BB3AFB24}"/>
               </a:ext>
             </a:extLst>
           </p:cNvPr>
@@ -6795,7 +6795,7 @@
           <p:cNvPr id="2" name="">
             <a:extLst xmlns:a="http://schemas.openxmlformats.org/drawingml/2006/main">
               <a:ext uri="{FF2B5EF4-FFF2-40B4-BE49-F238E27FC236}">
-                <a16:creationId xmlns:a16="http://schemas.microsoft.com/office/drawing/2014/main" id="{48FBF5F0-28E8-4CB1-9871-8468B4979FFF}"/>
+                <a16:creationId xmlns:a16="http://schemas.microsoft.com/office/drawing/2014/main" id="{5DE53B3B-1E11-495E-98FC-DE65910F8C64}"/>
               </a:ext>
             </a:extLst>
           </p:cNvPr>
@@ -6862,7 +6862,7 @@
           <p:cNvPr id="3" name="">
             <a:extLst xmlns:a="http://schemas.openxmlformats.org/drawingml/2006/main">
               <a:ext uri="{FF2B5EF4-FFF2-40B4-BE49-F238E27FC236}">
-                <a16:creationId xmlns:a16="http://schemas.microsoft.com/office/drawing/2014/main" id="{647085AC-D644-425E-A57D-0D58449A4281}"/>
+                <a16:creationId xmlns:a16="http://schemas.microsoft.com/office/drawing/2014/main" id="{59C4734B-514E-419D-B2F6-3847209B9083}"/>
               </a:ext>
             </a:extLst>
           </p:cNvPr>
@@ -6929,7 +6929,7 @@
           <p:cNvPr id="4" name="">
             <a:extLst xmlns:a="http://schemas.openxmlformats.org/drawingml/2006/main">
               <a:ext uri="{FF2B5EF4-FFF2-40B4-BE49-F238E27FC236}">
-                <a16:creationId xmlns:a16="http://schemas.microsoft.com/office/drawing/2014/main" id="{7302BBE7-D64F-42D4-AB77-AB310598A6F3}"/>
+                <a16:creationId xmlns:a16="http://schemas.microsoft.com/office/drawing/2014/main" id="{4513E10F-7FD3-4729-9EE8-9302C9B66AFA}"/>
               </a:ext>
             </a:extLst>
           </p:cNvPr>
@@ -6960,7 +6960,7 @@
           <p:cNvPr id="5" name="">
             <a:extLst xmlns:a="http://schemas.openxmlformats.org/drawingml/2006/main">
               <a:ext uri="{FF2B5EF4-FFF2-40B4-BE49-F238E27FC236}">
-                <a16:creationId xmlns:a16="http://schemas.microsoft.com/office/drawing/2014/main" id="{37EA21DC-01D7-4BAB-A59D-12DE4B2AEB9A}"/>
+                <a16:creationId xmlns:a16="http://schemas.microsoft.com/office/drawing/2014/main" id="{03124CB6-7559-4A83-AB54-CCD1EA6215AC}"/>
               </a:ext>
             </a:extLst>
           </p:cNvPr>
@@ -7017,7 +7017,7 @@
                 <a:ea typeface="Aptos"/>
                 <a:cs typeface="Aptos"/>
               </a:rPr>
-              <a:t>INERTIA-2026-10-22-r6 · 22 October 2026 · Autonomous build</a:t>
+              <a:t>INERTIA-2026-10-23-r7 · 23 October 2026 · Autonomous build</a:t>
             </a:r>
           </a:p>
         </p:txBody>
@@ -7027,7 +7027,7 @@
           <p:cNvPr id="6" name="">
             <a:extLst xmlns:a="http://schemas.openxmlformats.org/drawingml/2006/main">
               <a:ext uri="{FF2B5EF4-FFF2-40B4-BE49-F238E27FC236}">
-                <a16:creationId xmlns:a16="http://schemas.microsoft.com/office/drawing/2014/main" id="{6E8372E9-7FE1-47FF-8D84-627DB2AE462E}"/>
+                <a16:creationId xmlns:a16="http://schemas.microsoft.com/office/drawing/2014/main" id="{9F55A98B-27B7-4926-82D6-0B633EC78C76}"/>
               </a:ext>
             </a:extLst>
           </p:cNvPr>
@@ -7094,7 +7094,7 @@
           <p:cNvPr id="7" name="">
             <a:extLst xmlns:a="http://schemas.openxmlformats.org/drawingml/2006/main">
               <a:ext uri="{FF2B5EF4-FFF2-40B4-BE49-F238E27FC236}">
-                <a16:creationId xmlns:a16="http://schemas.microsoft.com/office/drawing/2014/main" id="{61D71157-418A-4879-AD0A-2DCEFBCA6EE5}"/>
+                <a16:creationId xmlns:a16="http://schemas.microsoft.com/office/drawing/2014/main" id="{C989028D-C5A1-44AC-98B9-F522566AB8F3}"/>
               </a:ext>
             </a:extLst>
           </p:cNvPr>
@@ -7127,7 +7127,7 @@
           <p:cNvPr id="8" name="">
             <a:extLst xmlns:a="http://schemas.openxmlformats.org/drawingml/2006/main">
               <a:ext uri="{FF2B5EF4-FFF2-40B4-BE49-F238E27FC236}">
-                <a16:creationId xmlns:a16="http://schemas.microsoft.com/office/drawing/2014/main" id="{37C46F52-B48E-41BA-9C5D-0A7A16DF257E}"/>
+                <a16:creationId xmlns:a16="http://schemas.microsoft.com/office/drawing/2014/main" id="{06929054-E808-44A2-BA67-FD4F1878760E}"/>
               </a:ext>
             </a:extLst>
           </p:cNvPr>
@@ -7194,7 +7194,7 @@
           <p:cNvPr id="9" name="">
             <a:extLst xmlns:a="http://schemas.openxmlformats.org/drawingml/2006/main">
               <a:ext uri="{FF2B5EF4-FFF2-40B4-BE49-F238E27FC236}">
-                <a16:creationId xmlns:a16="http://schemas.microsoft.com/office/drawing/2014/main" id="{7A33A761-3DFA-4BB5-8F6C-B2059421A66B}"/>
+                <a16:creationId xmlns:a16="http://schemas.microsoft.com/office/drawing/2014/main" id="{99361BDF-B9DB-47A2-BDBE-C6CBEC1C22C3}"/>
               </a:ext>
             </a:extLst>
           </p:cNvPr>
@@ -7330,7 +7330,7 @@
           <p:cNvPr id="10" name="">
             <a:extLst xmlns:a="http://schemas.openxmlformats.org/drawingml/2006/main">
               <a:ext uri="{FF2B5EF4-FFF2-40B4-BE49-F238E27FC236}">
-                <a16:creationId xmlns:a16="http://schemas.microsoft.com/office/drawing/2014/main" id="{1A78F3C7-4E5E-4CEE-AE48-F92FA04D6398}"/>
+                <a16:creationId xmlns:a16="http://schemas.microsoft.com/office/drawing/2014/main" id="{B14E1725-29FC-492E-9F4D-3E5CEFAE2B58}"/>
               </a:ext>
             </a:extLst>
           </p:cNvPr>
@@ -7363,7 +7363,7 @@
           <p:cNvPr id="11" name="">
             <a:extLst xmlns:a="http://schemas.openxmlformats.org/drawingml/2006/main">
               <a:ext uri="{FF2B5EF4-FFF2-40B4-BE49-F238E27FC236}">
-                <a16:creationId xmlns:a16="http://schemas.microsoft.com/office/drawing/2014/main" id="{23174286-6403-46E8-B0CE-D480B04AF43C}"/>
+                <a16:creationId xmlns:a16="http://schemas.microsoft.com/office/drawing/2014/main" id="{F5B617B6-2AAB-454B-933E-8788E506B26A}"/>
               </a:ext>
             </a:extLst>
           </p:cNvPr>
@@ -7430,7 +7430,7 @@
           <p:cNvPr id="12" name="">
             <a:extLst xmlns:a="http://schemas.openxmlformats.org/drawingml/2006/main">
               <a:ext uri="{FF2B5EF4-FFF2-40B4-BE49-F238E27FC236}">
-                <a16:creationId xmlns:a16="http://schemas.microsoft.com/office/drawing/2014/main" id="{2623B582-C87C-4427-B28D-C6416FA4E166}"/>
+                <a16:creationId xmlns:a16="http://schemas.microsoft.com/office/drawing/2014/main" id="{E7680E9C-7E60-44E0-8F0F-585CC9AE416D}"/>
               </a:ext>
             </a:extLst>
           </p:cNvPr>
@@ -7566,7 +7566,7 @@
           <p:cNvPr id="13" name="">
             <a:extLst xmlns:a="http://schemas.openxmlformats.org/drawingml/2006/main">
               <a:ext uri="{FF2B5EF4-FFF2-40B4-BE49-F238E27FC236}">
-                <a16:creationId xmlns:a16="http://schemas.microsoft.com/office/drawing/2014/main" id="{EECDE4C2-8AA6-40DB-B988-7CF7DCBB1242}"/>
+                <a16:creationId xmlns:a16="http://schemas.microsoft.com/office/drawing/2014/main" id="{442DE98C-7B7F-4898-B100-6BF8B9074F78}"/>
               </a:ext>
             </a:extLst>
           </p:cNvPr>
@@ -7599,7 +7599,7 @@
           <p:cNvPr id="14" name="">
             <a:extLst xmlns:a="http://schemas.openxmlformats.org/drawingml/2006/main">
               <a:ext uri="{FF2B5EF4-FFF2-40B4-BE49-F238E27FC236}">
-                <a16:creationId xmlns:a16="http://schemas.microsoft.com/office/drawing/2014/main" id="{57B3BFD3-5B6A-45B8-A51E-B0CE4B3A5C79}"/>
+                <a16:creationId xmlns:a16="http://schemas.microsoft.com/office/drawing/2014/main" id="{100CDD26-91C4-46B0-9C01-515EB159A4CC}"/>
               </a:ext>
             </a:extLst>
           </p:cNvPr>
@@ -7666,7 +7666,7 @@
           <p:cNvPr id="15" name="">
             <a:extLst xmlns:a="http://schemas.openxmlformats.org/drawingml/2006/main">
               <a:ext uri="{FF2B5EF4-FFF2-40B4-BE49-F238E27FC236}">
-                <a16:creationId xmlns:a16="http://schemas.microsoft.com/office/drawing/2014/main" id="{AA83E20B-5C82-4BE8-B9E5-C4F9F6EB5B1D}"/>
+                <a16:creationId xmlns:a16="http://schemas.microsoft.com/office/drawing/2014/main" id="{D0D245FA-627E-4331-B5DF-B8E13DC0CD8A}"/>
               </a:ext>
             </a:extLst>
           </p:cNvPr>
@@ -7802,7 +7802,7 @@
           <p:cNvPr id="16" name="">
             <a:extLst xmlns:a="http://schemas.openxmlformats.org/drawingml/2006/main">
               <a:ext uri="{FF2B5EF4-FFF2-40B4-BE49-F238E27FC236}">
-                <a16:creationId xmlns:a16="http://schemas.microsoft.com/office/drawing/2014/main" id="{B42FF771-3120-4382-863F-6D88BFDCA3EE}"/>
+                <a16:creationId xmlns:a16="http://schemas.microsoft.com/office/drawing/2014/main" id="{8C918133-2949-4E57-B0E4-632E9309C7C9}"/>
               </a:ext>
             </a:extLst>
           </p:cNvPr>
@@ -7867,7 +7867,7 @@
     </p:spTree>
     <p:extLst>
       <p:ext uri="{BB962C8B-B14F-4D97-AF65-F5344CB8AC3E}">
-        <p14:creationId xmlns:p14="http://schemas.microsoft.com/office/powerpoint/2010/main" val="1242149921"/>
+        <p14:creationId xmlns:p14="http://schemas.microsoft.com/office/powerpoint/2010/main" val="321599319"/>
       </p:ext>
     </p:extLst>
   </p:cSld>
@@ -7898,7 +7898,7 @@
           <p:cNvPr id="17" name="">
             <a:extLst xmlns:a="http://schemas.openxmlformats.org/drawingml/2006/main">
               <a:ext uri="{FF2B5EF4-FFF2-40B4-BE49-F238E27FC236}">
-                <a16:creationId xmlns:a16="http://schemas.microsoft.com/office/drawing/2014/main" id="{536211E4-D234-458A-B578-6151D91E2371}"/>
+                <a16:creationId xmlns:a16="http://schemas.microsoft.com/office/drawing/2014/main" id="{ED2DC141-D254-4DE5-BD71-76EF407D31E2}"/>
               </a:ext>
             </a:extLst>
           </p:cNvPr>
@@ -7965,7 +7965,7 @@
           <p:cNvPr id="2" name="">
             <a:extLst xmlns:a="http://schemas.openxmlformats.org/drawingml/2006/main">
               <a:ext uri="{FF2B5EF4-FFF2-40B4-BE49-F238E27FC236}">
-                <a16:creationId xmlns:a16="http://schemas.microsoft.com/office/drawing/2014/main" id="{12FB7133-0C95-4B40-A558-1916441DF763}"/>
+                <a16:creationId xmlns:a16="http://schemas.microsoft.com/office/drawing/2014/main" id="{D9D038F5-85DB-4E70-BD88-0E1621BEE5A8}"/>
               </a:ext>
             </a:extLst>
           </p:cNvPr>
@@ -8032,7 +8032,7 @@
           <p:cNvPr id="3" name="">
             <a:extLst xmlns:a="http://schemas.openxmlformats.org/drawingml/2006/main">
               <a:ext uri="{FF2B5EF4-FFF2-40B4-BE49-F238E27FC236}">
-                <a16:creationId xmlns:a16="http://schemas.microsoft.com/office/drawing/2014/main" id="{725CA979-ACCF-4D4D-BDA9-2D9208745412}"/>
+                <a16:creationId xmlns:a16="http://schemas.microsoft.com/office/drawing/2014/main" id="{BC184259-C62C-402F-B013-77FA9FEE6B7B}"/>
               </a:ext>
             </a:extLst>
           </p:cNvPr>
@@ -8099,7 +8099,7 @@
           <p:cNvPr id="4" name="">
             <a:extLst xmlns:a="http://schemas.openxmlformats.org/drawingml/2006/main">
               <a:ext uri="{FF2B5EF4-FFF2-40B4-BE49-F238E27FC236}">
-                <a16:creationId xmlns:a16="http://schemas.microsoft.com/office/drawing/2014/main" id="{E6198B50-92B1-41C2-BF0F-E134EECB77C4}"/>
+                <a16:creationId xmlns:a16="http://schemas.microsoft.com/office/drawing/2014/main" id="{F990F645-E639-4397-8E4F-03F21AAC0720}"/>
               </a:ext>
             </a:extLst>
           </p:cNvPr>
@@ -8130,7 +8130,7 @@
           <p:cNvPr id="5" name="">
             <a:extLst xmlns:a="http://schemas.openxmlformats.org/drawingml/2006/main">
               <a:ext uri="{FF2B5EF4-FFF2-40B4-BE49-F238E27FC236}">
-                <a16:creationId xmlns:a16="http://schemas.microsoft.com/office/drawing/2014/main" id="{5C5D66A7-A791-47FC-AADD-968044D0F32C}"/>
+                <a16:creationId xmlns:a16="http://schemas.microsoft.com/office/drawing/2014/main" id="{2CC7AEBB-DCFB-45C7-85E3-8FD384A7CDFF}"/>
               </a:ext>
             </a:extLst>
           </p:cNvPr>
@@ -8187,7 +8187,7 @@
                 <a:ea typeface="Aptos"/>
                 <a:cs typeface="Aptos"/>
               </a:rPr>
-              <a:t>INERTIA-2026-10-22-r6 · 22 October 2026 · Autonomous build</a:t>
+              <a:t>INERTIA-2026-10-23-r7 · 23 October 2026 · Autonomous build</a:t>
             </a:r>
           </a:p>
         </p:txBody>
@@ -8197,7 +8197,7 @@
           <p:cNvPr id="6" name="">
             <a:extLst xmlns:a="http://schemas.openxmlformats.org/drawingml/2006/main">
               <a:ext uri="{FF2B5EF4-FFF2-40B4-BE49-F238E27FC236}">
-                <a16:creationId xmlns:a16="http://schemas.microsoft.com/office/drawing/2014/main" id="{1A48AE7C-4502-41EC-A036-EBB8C1EFF160}"/>
+                <a16:creationId xmlns:a16="http://schemas.microsoft.com/office/drawing/2014/main" id="{BB1CBF1F-B28A-49CC-8A5C-0435571F040E}"/>
               </a:ext>
             </a:extLst>
           </p:cNvPr>
@@ -8264,7 +8264,7 @@
           <p:cNvPr id="7" name="">
             <a:extLst xmlns:a="http://schemas.openxmlformats.org/drawingml/2006/main">
               <a:ext uri="{FF2B5EF4-FFF2-40B4-BE49-F238E27FC236}">
-                <a16:creationId xmlns:a16="http://schemas.microsoft.com/office/drawing/2014/main" id="{46AEB412-1793-4D76-8880-420EAE6B4C4A}"/>
+                <a16:creationId xmlns:a16="http://schemas.microsoft.com/office/drawing/2014/main" id="{E3486E29-1A85-4932-A63A-EF2E664E9016}"/>
               </a:ext>
             </a:extLst>
           </p:cNvPr>
@@ -8297,7 +8297,7 @@
           <p:cNvPr id="8" name="">
             <a:extLst xmlns:a="http://schemas.openxmlformats.org/drawingml/2006/main">
               <a:ext uri="{FF2B5EF4-FFF2-40B4-BE49-F238E27FC236}">
-                <a16:creationId xmlns:a16="http://schemas.microsoft.com/office/drawing/2014/main" id="{AB915837-2254-47DA-8A79-0B276DF698AF}"/>
+                <a16:creationId xmlns:a16="http://schemas.microsoft.com/office/drawing/2014/main" id="{BD91FFC3-388A-4CC5-AC05-690B1E24E1BE}"/>
               </a:ext>
             </a:extLst>
           </p:cNvPr>
@@ -8364,7 +8364,7 @@
           <p:cNvPr id="9" name="">
             <a:extLst xmlns:a="http://schemas.openxmlformats.org/drawingml/2006/main">
               <a:ext uri="{FF2B5EF4-FFF2-40B4-BE49-F238E27FC236}">
-                <a16:creationId xmlns:a16="http://schemas.microsoft.com/office/drawing/2014/main" id="{CB7F8E25-211A-4D1A-9D69-13414168C874}"/>
+                <a16:creationId xmlns:a16="http://schemas.microsoft.com/office/drawing/2014/main" id="{1D9C9603-C241-411B-AEE8-D90AB526881E}"/>
               </a:ext>
             </a:extLst>
           </p:cNvPr>
@@ -8500,7 +8500,7 @@
           <p:cNvPr id="10" name="">
             <a:extLst xmlns:a="http://schemas.openxmlformats.org/drawingml/2006/main">
               <a:ext uri="{FF2B5EF4-FFF2-40B4-BE49-F238E27FC236}">
-                <a16:creationId xmlns:a16="http://schemas.microsoft.com/office/drawing/2014/main" id="{41083009-1B2E-4505-B370-7E58503D615F}"/>
+                <a16:creationId xmlns:a16="http://schemas.microsoft.com/office/drawing/2014/main" id="{B450DD4D-0C59-4A75-BA62-4B2317A1EC59}"/>
               </a:ext>
             </a:extLst>
           </p:cNvPr>
@@ -8533,7 +8533,7 @@
           <p:cNvPr id="11" name="">
             <a:extLst xmlns:a="http://schemas.openxmlformats.org/drawingml/2006/main">
               <a:ext uri="{FF2B5EF4-FFF2-40B4-BE49-F238E27FC236}">
-                <a16:creationId xmlns:a16="http://schemas.microsoft.com/office/drawing/2014/main" id="{7D2B6383-E041-412D-8AB2-70E73D0CDEBA}"/>
+                <a16:creationId xmlns:a16="http://schemas.microsoft.com/office/drawing/2014/main" id="{47920630-DC1C-44FD-A160-DA26F896F7DF}"/>
               </a:ext>
             </a:extLst>
           </p:cNvPr>
@@ -8600,7 +8600,7 @@
           <p:cNvPr id="12" name="">
             <a:extLst xmlns:a="http://schemas.openxmlformats.org/drawingml/2006/main">
               <a:ext uri="{FF2B5EF4-FFF2-40B4-BE49-F238E27FC236}">
-                <a16:creationId xmlns:a16="http://schemas.microsoft.com/office/drawing/2014/main" id="{424591E1-06DB-4383-A7FB-0097C6C08745}"/>
+                <a16:creationId xmlns:a16="http://schemas.microsoft.com/office/drawing/2014/main" id="{7BB76621-66CA-4E7C-8B68-2BBADF10107C}"/>
               </a:ext>
             </a:extLst>
           </p:cNvPr>
@@ -8736,7 +8736,7 @@
           <p:cNvPr id="13" name="">
             <a:extLst xmlns:a="http://schemas.openxmlformats.org/drawingml/2006/main">
               <a:ext uri="{FF2B5EF4-FFF2-40B4-BE49-F238E27FC236}">
-                <a16:creationId xmlns:a16="http://schemas.microsoft.com/office/drawing/2014/main" id="{CBAF23CF-14FD-40C7-BEE2-1B0894CA12DD}"/>
+                <a16:creationId xmlns:a16="http://schemas.microsoft.com/office/drawing/2014/main" id="{7537C6E8-5FDC-4695-A315-C5F042ABBD8B}"/>
               </a:ext>
             </a:extLst>
           </p:cNvPr>
@@ -8769,7 +8769,7 @@
           <p:cNvPr id="14" name="">
             <a:extLst xmlns:a="http://schemas.openxmlformats.org/drawingml/2006/main">
               <a:ext uri="{FF2B5EF4-FFF2-40B4-BE49-F238E27FC236}">
-                <a16:creationId xmlns:a16="http://schemas.microsoft.com/office/drawing/2014/main" id="{0EF6E3C3-8538-407D-8323-0B92B83E7700}"/>
+                <a16:creationId xmlns:a16="http://schemas.microsoft.com/office/drawing/2014/main" id="{99B727E6-9693-45B3-A114-23FF70516691}"/>
               </a:ext>
             </a:extLst>
           </p:cNvPr>
@@ -8836,7 +8836,7 @@
           <p:cNvPr id="15" name="">
             <a:extLst xmlns:a="http://schemas.openxmlformats.org/drawingml/2006/main">
               <a:ext uri="{FF2B5EF4-FFF2-40B4-BE49-F238E27FC236}">
-                <a16:creationId xmlns:a16="http://schemas.microsoft.com/office/drawing/2014/main" id="{7472C7BA-02D4-41A2-AD17-667D5D2DDB05}"/>
+                <a16:creationId xmlns:a16="http://schemas.microsoft.com/office/drawing/2014/main" id="{CA1D98ED-45D6-476F-A6A0-17312C98205F}"/>
               </a:ext>
             </a:extLst>
           </p:cNvPr>
@@ -8972,7 +8972,7 @@
           <p:cNvPr id="16" name="">
             <a:extLst xmlns:a="http://schemas.openxmlformats.org/drawingml/2006/main">
               <a:ext uri="{FF2B5EF4-FFF2-40B4-BE49-F238E27FC236}">
-                <a16:creationId xmlns:a16="http://schemas.microsoft.com/office/drawing/2014/main" id="{3B3E80F0-9A88-48A2-A43F-ABA3D488D308}"/>
+                <a16:creationId xmlns:a16="http://schemas.microsoft.com/office/drawing/2014/main" id="{7C3EEFB9-D08E-4A71-8ACE-A5F9A402742C}"/>
               </a:ext>
             </a:extLst>
           </p:cNvPr>
@@ -9037,7 +9037,7 @@
     </p:spTree>
     <p:extLst>
       <p:ext uri="{BB962C8B-B14F-4D97-AF65-F5344CB8AC3E}">
-        <p14:creationId xmlns:p14="http://schemas.microsoft.com/office/powerpoint/2010/main" val="1143166186"/>
+        <p14:creationId xmlns:p14="http://schemas.microsoft.com/office/powerpoint/2010/main" val="2123739644"/>
       </p:ext>
     </p:extLst>
   </p:cSld>
@@ -9068,7 +9068,7 @@
           <p:cNvPr id="17" name="">
             <a:extLst xmlns:a="http://schemas.openxmlformats.org/drawingml/2006/main">
               <a:ext uri="{FF2B5EF4-FFF2-40B4-BE49-F238E27FC236}">
-                <a16:creationId xmlns:a16="http://schemas.microsoft.com/office/drawing/2014/main" id="{E8BFF74A-1AD1-4C6B-BD01-419D45C73820}"/>
+                <a16:creationId xmlns:a16="http://schemas.microsoft.com/office/drawing/2014/main" id="{B3B4703C-6380-4DB5-9C85-7BF843F514F7}"/>
               </a:ext>
             </a:extLst>
           </p:cNvPr>
@@ -9135,7 +9135,7 @@
           <p:cNvPr id="2" name="">
             <a:extLst xmlns:a="http://schemas.openxmlformats.org/drawingml/2006/main">
               <a:ext uri="{FF2B5EF4-FFF2-40B4-BE49-F238E27FC236}">
-                <a16:creationId xmlns:a16="http://schemas.microsoft.com/office/drawing/2014/main" id="{230A7959-6D24-4DD6-B1B5-C19B68B9EB8D}"/>
+                <a16:creationId xmlns:a16="http://schemas.microsoft.com/office/drawing/2014/main" id="{A471F36B-5B6B-47F9-A74C-9F87BE678B7C}"/>
               </a:ext>
             </a:extLst>
           </p:cNvPr>
@@ -9202,7 +9202,7 @@
           <p:cNvPr id="3" name="">
             <a:extLst xmlns:a="http://schemas.openxmlformats.org/drawingml/2006/main">
               <a:ext uri="{FF2B5EF4-FFF2-40B4-BE49-F238E27FC236}">
-                <a16:creationId xmlns:a16="http://schemas.microsoft.com/office/drawing/2014/main" id="{EFF4F7FF-0C2A-4EC3-BCF8-F41024202C2B}"/>
+                <a16:creationId xmlns:a16="http://schemas.microsoft.com/office/drawing/2014/main" id="{9AF09CB2-CCE7-43D8-B3F9-7B85C37BBD84}"/>
               </a:ext>
             </a:extLst>
           </p:cNvPr>
@@ -9269,7 +9269,7 @@
           <p:cNvPr id="4" name="">
             <a:extLst xmlns:a="http://schemas.openxmlformats.org/drawingml/2006/main">
               <a:ext uri="{FF2B5EF4-FFF2-40B4-BE49-F238E27FC236}">
-                <a16:creationId xmlns:a16="http://schemas.microsoft.com/office/drawing/2014/main" id="{C2793082-B249-4DC4-8471-1FAF88E7F6B0}"/>
+                <a16:creationId xmlns:a16="http://schemas.microsoft.com/office/drawing/2014/main" id="{CE780204-1B19-43AA-9A69-460FA2652455}"/>
               </a:ext>
             </a:extLst>
           </p:cNvPr>
@@ -9300,7 +9300,7 @@
           <p:cNvPr id="5" name="">
             <a:extLst xmlns:a="http://schemas.openxmlformats.org/drawingml/2006/main">
               <a:ext uri="{FF2B5EF4-FFF2-40B4-BE49-F238E27FC236}">
-                <a16:creationId xmlns:a16="http://schemas.microsoft.com/office/drawing/2014/main" id="{9170EF64-F932-411E-8306-4801C24BF409}"/>
+                <a16:creationId xmlns:a16="http://schemas.microsoft.com/office/drawing/2014/main" id="{0235216B-9D63-4B73-BB56-B68EBBBFACC0}"/>
               </a:ext>
             </a:extLst>
           </p:cNvPr>
@@ -9357,7 +9357,7 @@
                 <a:ea typeface="Aptos"/>
                 <a:cs typeface="Aptos"/>
               </a:rPr>
-              <a:t>INERTIA-2026-10-22-r6 · 22 October 2026 · Autonomous build</a:t>
+              <a:t>INERTIA-2026-10-23-r7 · 23 October 2026 · Autonomous build</a:t>
             </a:r>
           </a:p>
         </p:txBody>
@@ -9367,7 +9367,7 @@
           <p:cNvPr id="6" name="">
             <a:extLst xmlns:a="http://schemas.openxmlformats.org/drawingml/2006/main">
               <a:ext uri="{FF2B5EF4-FFF2-40B4-BE49-F238E27FC236}">
-                <a16:creationId xmlns:a16="http://schemas.microsoft.com/office/drawing/2014/main" id="{B9B040D9-DFD2-43A0-B283-F6C92C8B651E}"/>
+                <a16:creationId xmlns:a16="http://schemas.microsoft.com/office/drawing/2014/main" id="{1859E5AC-3CE7-4068-86F1-41FE801FCB43}"/>
               </a:ext>
             </a:extLst>
           </p:cNvPr>
@@ -9434,7 +9434,7 @@
           <p:cNvPr id="7" name="">
             <a:extLst xmlns:a="http://schemas.openxmlformats.org/drawingml/2006/main">
               <a:ext uri="{FF2B5EF4-FFF2-40B4-BE49-F238E27FC236}">
-                <a16:creationId xmlns:a16="http://schemas.microsoft.com/office/drawing/2014/main" id="{9ED3A75D-EB6A-4B80-B076-2247FB90597E}"/>
+                <a16:creationId xmlns:a16="http://schemas.microsoft.com/office/drawing/2014/main" id="{D4C981A4-6F99-47F3-A096-2CD9D2DA7B57}"/>
               </a:ext>
             </a:extLst>
           </p:cNvPr>
@@ -9467,7 +9467,7 @@
           <p:cNvPr id="8" name="">
             <a:extLst xmlns:a="http://schemas.openxmlformats.org/drawingml/2006/main">
               <a:ext uri="{FF2B5EF4-FFF2-40B4-BE49-F238E27FC236}">
-                <a16:creationId xmlns:a16="http://schemas.microsoft.com/office/drawing/2014/main" id="{B4FF6F3B-F4F9-4584-B905-4DE2B777090D}"/>
+                <a16:creationId xmlns:a16="http://schemas.microsoft.com/office/drawing/2014/main" id="{58CD9F90-2BB7-493A-A78A-12BBC740E41D}"/>
               </a:ext>
             </a:extLst>
           </p:cNvPr>
@@ -9534,7 +9534,7 @@
           <p:cNvPr id="9" name="">
             <a:extLst xmlns:a="http://schemas.openxmlformats.org/drawingml/2006/main">
               <a:ext uri="{FF2B5EF4-FFF2-40B4-BE49-F238E27FC236}">
-                <a16:creationId xmlns:a16="http://schemas.microsoft.com/office/drawing/2014/main" id="{6B1382C3-5A6C-4D06-9556-6809EE8439CF}"/>
+                <a16:creationId xmlns:a16="http://schemas.microsoft.com/office/drawing/2014/main" id="{EFF0F005-C273-4DA2-8A52-7200348FA2B3}"/>
               </a:ext>
             </a:extLst>
           </p:cNvPr>
@@ -9591,7 +9591,7 @@
                 <a:ea typeface="Aptos"/>
                 <a:cs typeface="Aptos"/>
               </a:rPr>
-              <a:t>Admit the plugin and provider</a:t>
+              <a:t>Install verified archive</a:t>
             </a:r>
           </a:p>
           <a:p xmlns:a="http://schemas.openxmlformats.org/drawingml/2006/main">
@@ -9614,7 +9614,7 @@
                 <a:ea typeface="Aptos"/>
                 <a:cs typeface="Aptos"/>
               </a:rPr>
-              <a:t>Bind company, channel and task</a:t>
+              <a:t>Use Node 24.11 or newer</a:t>
             </a:r>
           </a:p>
           <a:p xmlns:a="http://schemas.openxmlformats.org/drawingml/2006/main">
@@ -9637,7 +9637,7 @@
                 <a:ea typeface="Aptos"/>
                 <a:cs typeface="Aptos"/>
               </a:rPr>
-              <a:t>Pair authorized identities</a:t>
+              <a:t>Fill disabled configuration</a:t>
             </a:r>
           </a:p>
           <a:p xmlns:a="http://schemas.openxmlformats.org/drawingml/2006/main">
@@ -9660,7 +9660,7 @@
                 <a:ea typeface="Aptos"/>
                 <a:cs typeface="Aptos"/>
               </a:rPr>
-              <a:t>Choose source and publication policy</a:t>
+              <a:t>Validate, pair and enable</a:t>
             </a:r>
           </a:p>
         </p:txBody>
@@ -9670,7 +9670,7 @@
           <p:cNvPr id="10" name="">
             <a:extLst xmlns:a="http://schemas.openxmlformats.org/drawingml/2006/main">
               <a:ext uri="{FF2B5EF4-FFF2-40B4-BE49-F238E27FC236}">
-                <a16:creationId xmlns:a16="http://schemas.microsoft.com/office/drawing/2014/main" id="{2F41B63E-9811-45C2-B0C2-D454743A724F}"/>
+                <a16:creationId xmlns:a16="http://schemas.microsoft.com/office/drawing/2014/main" id="{2EE7951A-2B99-420A-925A-0F37A4D128AF}"/>
               </a:ext>
             </a:extLst>
           </p:cNvPr>
@@ -9703,7 +9703,7 @@
           <p:cNvPr id="11" name="">
             <a:extLst xmlns:a="http://schemas.openxmlformats.org/drawingml/2006/main">
               <a:ext uri="{FF2B5EF4-FFF2-40B4-BE49-F238E27FC236}">
-                <a16:creationId xmlns:a16="http://schemas.microsoft.com/office/drawing/2014/main" id="{72656AD3-8B73-4D89-ADF5-37D3C63785BF}"/>
+                <a16:creationId xmlns:a16="http://schemas.microsoft.com/office/drawing/2014/main" id="{9362A06D-DD7C-4EB7-993D-1C9F1C422298}"/>
               </a:ext>
             </a:extLst>
           </p:cNvPr>
@@ -9770,7 +9770,7 @@
           <p:cNvPr id="12" name="">
             <a:extLst xmlns:a="http://schemas.openxmlformats.org/drawingml/2006/main">
               <a:ext uri="{FF2B5EF4-FFF2-40B4-BE49-F238E27FC236}">
-                <a16:creationId xmlns:a16="http://schemas.microsoft.com/office/drawing/2014/main" id="{244F498A-6FFD-4234-A00E-64B2C10C5AAD}"/>
+                <a16:creationId xmlns:a16="http://schemas.microsoft.com/office/drawing/2014/main" id="{5EDD8827-F4E9-4C22-B40E-FEF00E895B01}"/>
               </a:ext>
             </a:extLst>
           </p:cNvPr>
@@ -9906,7 +9906,7 @@
           <p:cNvPr id="13" name="">
             <a:extLst xmlns:a="http://schemas.openxmlformats.org/drawingml/2006/main">
               <a:ext uri="{FF2B5EF4-FFF2-40B4-BE49-F238E27FC236}">
-                <a16:creationId xmlns:a16="http://schemas.microsoft.com/office/drawing/2014/main" id="{397EE58A-D433-4144-8B73-EDB41BE1F84E}"/>
+                <a16:creationId xmlns:a16="http://schemas.microsoft.com/office/drawing/2014/main" id="{ADE00A3D-7A7E-46BB-8400-3C94B843FD0C}"/>
               </a:ext>
             </a:extLst>
           </p:cNvPr>
@@ -9939,7 +9939,7 @@
           <p:cNvPr id="14" name="">
             <a:extLst xmlns:a="http://schemas.openxmlformats.org/drawingml/2006/main">
               <a:ext uri="{FF2B5EF4-FFF2-40B4-BE49-F238E27FC236}">
-                <a16:creationId xmlns:a16="http://schemas.microsoft.com/office/drawing/2014/main" id="{E07624BE-028A-40D7-AF2A-29F9DD5E200D}"/>
+                <a16:creationId xmlns:a16="http://schemas.microsoft.com/office/drawing/2014/main" id="{0C78BD01-8E6C-496A-86B1-8587DA887D68}"/>
               </a:ext>
             </a:extLst>
           </p:cNvPr>
@@ -10006,7 +10006,7 @@
           <p:cNvPr id="15" name="">
             <a:extLst xmlns:a="http://schemas.openxmlformats.org/drawingml/2006/main">
               <a:ext uri="{FF2B5EF4-FFF2-40B4-BE49-F238E27FC236}">
-                <a16:creationId xmlns:a16="http://schemas.microsoft.com/office/drawing/2014/main" id="{E3D4E954-651E-496F-8F4E-1115F08B1959}"/>
+                <a16:creationId xmlns:a16="http://schemas.microsoft.com/office/drawing/2014/main" id="{3F701368-6612-47BA-A09E-DF5B0B7294D9}"/>
               </a:ext>
             </a:extLst>
           </p:cNvPr>
@@ -10142,7 +10142,7 @@
           <p:cNvPr id="16" name="">
             <a:extLst xmlns:a="http://schemas.openxmlformats.org/drawingml/2006/main">
               <a:ext uri="{FF2B5EF4-FFF2-40B4-BE49-F238E27FC236}">
-                <a16:creationId xmlns:a16="http://schemas.microsoft.com/office/drawing/2014/main" id="{26AAD5B6-0DB4-4A3C-8838-782ACA834860}"/>
+                <a16:creationId xmlns:a16="http://schemas.microsoft.com/office/drawing/2014/main" id="{95F268FE-615B-4B0E-B778-926E0D57BA5B}"/>
               </a:ext>
             </a:extLst>
           </p:cNvPr>
@@ -10207,7 +10207,7 @@
     </p:spTree>
     <p:extLst>
       <p:ext uri="{BB962C8B-B14F-4D97-AF65-F5344CB8AC3E}">
-        <p14:creationId xmlns:p14="http://schemas.microsoft.com/office/powerpoint/2010/main" val="1796107977"/>
+        <p14:creationId xmlns:p14="http://schemas.microsoft.com/office/powerpoint/2010/main" val="1265001805"/>
       </p:ext>
     </p:extLst>
   </p:cSld>
@@ -10238,7 +10238,7 @@
           <p:cNvPr id="17" name="">
             <a:extLst xmlns:a="http://schemas.openxmlformats.org/drawingml/2006/main">
               <a:ext uri="{FF2B5EF4-FFF2-40B4-BE49-F238E27FC236}">
-                <a16:creationId xmlns:a16="http://schemas.microsoft.com/office/drawing/2014/main" id="{B2493966-7999-40A3-83FF-AB2B04D81A0D}"/>
+                <a16:creationId xmlns:a16="http://schemas.microsoft.com/office/drawing/2014/main" id="{663A0F38-B73F-4B71-AD7B-292F0DFA67E0}"/>
               </a:ext>
             </a:extLst>
           </p:cNvPr>
@@ -10305,7 +10305,7 @@
           <p:cNvPr id="2" name="">
             <a:extLst xmlns:a="http://schemas.openxmlformats.org/drawingml/2006/main">
               <a:ext uri="{FF2B5EF4-FFF2-40B4-BE49-F238E27FC236}">
-                <a16:creationId xmlns:a16="http://schemas.microsoft.com/office/drawing/2014/main" id="{C8B52D4F-9531-4529-B538-197B671F0AD1}"/>
+                <a16:creationId xmlns:a16="http://schemas.microsoft.com/office/drawing/2014/main" id="{5137B871-C8CB-4528-A968-63C3B3AE9E7B}"/>
               </a:ext>
             </a:extLst>
           </p:cNvPr>
@@ -10362,7 +10362,7 @@
                 <a:ea typeface="Aptos"/>
                 <a:cs typeface="Aptos"/>
               </a:rPr>
-              <a:t>Build evidence on 22 October</a:t>
+              <a:t>Build evidence on 23 October</a:t>
             </a:r>
           </a:p>
         </p:txBody>
@@ -10372,7 +10372,7 @@
           <p:cNvPr id="3" name="">
             <a:extLst xmlns:a="http://schemas.openxmlformats.org/drawingml/2006/main">
               <a:ext uri="{FF2B5EF4-FFF2-40B4-BE49-F238E27FC236}">
-                <a16:creationId xmlns:a16="http://schemas.microsoft.com/office/drawing/2014/main" id="{A6EF57FD-C9F4-4EC6-B9EB-88FFEFCB32F0}"/>
+                <a16:creationId xmlns:a16="http://schemas.microsoft.com/office/drawing/2014/main" id="{EC123BF2-95A5-4DF3-8145-D32045B3FA84}"/>
               </a:ext>
             </a:extLst>
           </p:cNvPr>
@@ -10429,7 +10429,7 @@
                 <a:ea typeface="Aptos"/>
                 <a:cs typeface="Aptos"/>
               </a:rPr>
-              <a:t>Connected bridge and Roundtable core are merged into develop.</a:t>
+              <a:t>Grant packet binding and installable-package qualification extend the connected loop.</a:t>
             </a:r>
           </a:p>
         </p:txBody>
@@ -10439,7 +10439,7 @@
           <p:cNvPr id="4" name="">
             <a:extLst xmlns:a="http://schemas.openxmlformats.org/drawingml/2006/main">
               <a:ext uri="{FF2B5EF4-FFF2-40B4-BE49-F238E27FC236}">
-                <a16:creationId xmlns:a16="http://schemas.microsoft.com/office/drawing/2014/main" id="{5616D756-27A0-4527-9667-A16925328996}"/>
+                <a16:creationId xmlns:a16="http://schemas.microsoft.com/office/drawing/2014/main" id="{55F576AF-4BD2-4AA1-AF73-C9F378045DF9}"/>
               </a:ext>
             </a:extLst>
           </p:cNvPr>
@@ -10470,7 +10470,7 @@
           <p:cNvPr id="5" name="">
             <a:extLst xmlns:a="http://schemas.openxmlformats.org/drawingml/2006/main">
               <a:ext uri="{FF2B5EF4-FFF2-40B4-BE49-F238E27FC236}">
-                <a16:creationId xmlns:a16="http://schemas.microsoft.com/office/drawing/2014/main" id="{C7F36929-593B-48E1-B7F8-53BE82B0D754}"/>
+                <a16:creationId xmlns:a16="http://schemas.microsoft.com/office/drawing/2014/main" id="{25D9C22E-FC38-4A89-9D73-681B6C592327}"/>
               </a:ext>
             </a:extLst>
           </p:cNvPr>
@@ -10527,7 +10527,7 @@
                 <a:ea typeface="Aptos"/>
                 <a:cs typeface="Aptos"/>
               </a:rPr>
-              <a:t>INERTIA-2026-10-22-r6 · 22 October 2026 · Autonomous build</a:t>
+              <a:t>INERTIA-2026-10-23-r7 · 23 October 2026 · Autonomous build</a:t>
             </a:r>
           </a:p>
         </p:txBody>
@@ -10537,7 +10537,7 @@
           <p:cNvPr id="6" name="">
             <a:extLst xmlns:a="http://schemas.openxmlformats.org/drawingml/2006/main">
               <a:ext uri="{FF2B5EF4-FFF2-40B4-BE49-F238E27FC236}">
-                <a16:creationId xmlns:a16="http://schemas.microsoft.com/office/drawing/2014/main" id="{1D7FF4B2-2E49-4723-8518-73C80825B92A}"/>
+                <a16:creationId xmlns:a16="http://schemas.microsoft.com/office/drawing/2014/main" id="{094CDB74-4903-4445-8C21-C7C714DC88AD}"/>
               </a:ext>
             </a:extLst>
           </p:cNvPr>
@@ -10604,7 +10604,7 @@
           <p:cNvPr id="7" name="">
             <a:extLst xmlns:a="http://schemas.openxmlformats.org/drawingml/2006/main">
               <a:ext uri="{FF2B5EF4-FFF2-40B4-BE49-F238E27FC236}">
-                <a16:creationId xmlns:a16="http://schemas.microsoft.com/office/drawing/2014/main" id="{42B87E8A-366F-4EA9-BA12-2F34D9CD8C0C}"/>
+                <a16:creationId xmlns:a16="http://schemas.microsoft.com/office/drawing/2014/main" id="{29117874-9FF5-4915-8CA6-B7D4ABD8CE04}"/>
               </a:ext>
             </a:extLst>
           </p:cNvPr>
@@ -10637,7 +10637,7 @@
           <p:cNvPr id="8" name="">
             <a:extLst xmlns:a="http://schemas.openxmlformats.org/drawingml/2006/main">
               <a:ext uri="{FF2B5EF4-FFF2-40B4-BE49-F238E27FC236}">
-                <a16:creationId xmlns:a16="http://schemas.microsoft.com/office/drawing/2014/main" id="{049B2ABF-5E1E-44D2-BBCA-26EAEA7ED08B}"/>
+                <a16:creationId xmlns:a16="http://schemas.microsoft.com/office/drawing/2014/main" id="{ADD6E2AF-1EB3-4582-9DF4-1BE9F8295F55}"/>
               </a:ext>
             </a:extLst>
           </p:cNvPr>
@@ -10704,7 +10704,7 @@
           <p:cNvPr id="9" name="">
             <a:extLst xmlns:a="http://schemas.openxmlformats.org/drawingml/2006/main">
               <a:ext uri="{FF2B5EF4-FFF2-40B4-BE49-F238E27FC236}">
-                <a16:creationId xmlns:a16="http://schemas.microsoft.com/office/drawing/2014/main" id="{AB45F3C5-0478-4887-A909-6C9123996D0D}"/>
+                <a16:creationId xmlns:a16="http://schemas.microsoft.com/office/drawing/2014/main" id="{A36F21E8-DB54-4991-B8EC-E9387EBA9DF6}"/>
               </a:ext>
             </a:extLst>
           </p:cNvPr>
@@ -10761,7 +10761,7 @@
                 <a:ea typeface="Aptos"/>
                 <a:cs typeface="Aptos"/>
               </a:rPr>
-              <a:t>PR 2: 36 transport tests</a:t>
+              <a:t>Signed transport and native core</a:t>
             </a:r>
           </a:p>
           <a:p xmlns:a="http://schemas.openxmlformats.org/drawingml/2006/main">
@@ -10784,7 +10784,7 @@
                 <a:ea typeface="Aptos"/>
                 <a:cs typeface="Aptos"/>
               </a:rPr>
-              <a:t>PR 3: combined 60 tests</a:t>
+              <a:t>Connected bridge: 85 tests</a:t>
             </a:r>
           </a:p>
           <a:p xmlns:a="http://schemas.openxmlformats.org/drawingml/2006/main">
@@ -10807,7 +10807,7 @@
                 <a:ea typeface="Aptos"/>
                 <a:cs typeface="Aptos"/>
               </a:rPr>
-              <a:t>Real signatures and SQL</a:t>
+              <a:t>Roundtable core: 23 tests</a:t>
             </a:r>
           </a:p>
           <a:p xmlns:a="http://schemas.openxmlformats.org/drawingml/2006/main">
@@ -10830,7 +10830,7 @@
                 <a:ea typeface="Aptos"/>
                 <a:cs typeface="Aptos"/>
               </a:rPr>
-              <a:t>Typecheck, build and fixture demo</a:t>
+              <a:t>Actual website publisher pending</a:t>
             </a:r>
           </a:p>
         </p:txBody>
@@ -10840,7 +10840,7 @@
           <p:cNvPr id="10" name="">
             <a:extLst xmlns:a="http://schemas.openxmlformats.org/drawingml/2006/main">
               <a:ext uri="{FF2B5EF4-FFF2-40B4-BE49-F238E27FC236}">
-                <a16:creationId xmlns:a16="http://schemas.microsoft.com/office/drawing/2014/main" id="{1CA97F40-E346-4BDC-9132-7BEED9E2D73A}"/>
+                <a16:creationId xmlns:a16="http://schemas.microsoft.com/office/drawing/2014/main" id="{55B89C6C-D208-47EA-8F33-9D667AB734B9}"/>
               </a:ext>
             </a:extLst>
           </p:cNvPr>
@@ -10873,7 +10873,7 @@
           <p:cNvPr id="11" name="">
             <a:extLst xmlns:a="http://schemas.openxmlformats.org/drawingml/2006/main">
               <a:ext uri="{FF2B5EF4-FFF2-40B4-BE49-F238E27FC236}">
-                <a16:creationId xmlns:a16="http://schemas.microsoft.com/office/drawing/2014/main" id="{F58C2A2F-813A-4942-8559-A14A91E62C96}"/>
+                <a16:creationId xmlns:a16="http://schemas.microsoft.com/office/drawing/2014/main" id="{46FE38AA-64E5-4EA1-9BD0-A77BDF030101}"/>
               </a:ext>
             </a:extLst>
           </p:cNvPr>
@@ -10930,7 +10930,7 @@
                 <a:ea typeface="Aptos"/>
                 <a:cs typeface="Aptos"/>
               </a:rPr>
-              <a:t>Connected plugin</a:t>
+              <a:t>Grant packet binding</a:t>
             </a:r>
           </a:p>
         </p:txBody>
@@ -10940,7 +10940,7 @@
           <p:cNvPr id="12" name="">
             <a:extLst xmlns:a="http://schemas.openxmlformats.org/drawingml/2006/main">
               <a:ext uri="{FF2B5EF4-FFF2-40B4-BE49-F238E27FC236}">
-                <a16:creationId xmlns:a16="http://schemas.microsoft.com/office/drawing/2014/main" id="{43C2D438-195B-4E88-8B61-DA5CEDCB5C21}"/>
+                <a16:creationId xmlns:a16="http://schemas.microsoft.com/office/drawing/2014/main" id="{D19F5B84-AAD2-45F1-A9B3-13C8AA43F34E}"/>
               </a:ext>
             </a:extLst>
           </p:cNvPr>
@@ -10997,7 +10997,7 @@
                 <a:ea typeface="Aptos"/>
                 <a:cs typeface="Aptos"/>
               </a:rPr>
-              <a:t>PR 4 merged: 85 tests</a:t>
+              <a:t>PR 7 grant core: 37 tests</a:t>
             </a:r>
           </a:p>
           <a:p xmlns:a="http://schemas.openxmlformats.org/drawingml/2006/main">
@@ -11020,7 +11020,7 @@
                 <a:ea typeface="Aptos"/>
                 <a:cs typeface="Aptos"/>
               </a:rPr>
-              <a:t>Durable retry and backfill</a:t>
+              <a:t>Packet, review and vote binding</a:t>
             </a:r>
           </a:p>
           <a:p xmlns:a="http://schemas.openxmlformats.org/drawingml/2006/main">
@@ -11043,7 +11043,7 @@
                 <a:ea typeface="Aptos"/>
                 <a:cs typeface="Aptos"/>
               </a:rPr>
-              <a:t>Company-scoped health</a:t>
+              <a:t>Source freshness and replay</a:t>
             </a:r>
           </a:p>
           <a:p xmlns:a="http://schemas.openxmlformats.org/drawingml/2006/main">
@@ -11066,7 +11066,7 @@
                 <a:ea typeface="Aptos"/>
                 <a:cs typeface="Aptos"/>
               </a:rPr>
-              <a:t>Addressed-card privacy</a:t>
+              <a:t>Production adapters next</a:t>
             </a:r>
           </a:p>
         </p:txBody>
@@ -11076,7 +11076,7 @@
           <p:cNvPr id="13" name="">
             <a:extLst xmlns:a="http://schemas.openxmlformats.org/drawingml/2006/main">
               <a:ext uri="{FF2B5EF4-FFF2-40B4-BE49-F238E27FC236}">
-                <a16:creationId xmlns:a16="http://schemas.microsoft.com/office/drawing/2014/main" id="{0A9E9C16-C0B5-4EA7-93EB-B9B634082DAB}"/>
+                <a16:creationId xmlns:a16="http://schemas.microsoft.com/office/drawing/2014/main" id="{46275AFE-4AE2-4691-9FA0-A458C7E8D68B}"/>
               </a:ext>
             </a:extLst>
           </p:cNvPr>
@@ -11109,7 +11109,7 @@
           <p:cNvPr id="14" name="">
             <a:extLst xmlns:a="http://schemas.openxmlformats.org/drawingml/2006/main">
               <a:ext uri="{FF2B5EF4-FFF2-40B4-BE49-F238E27FC236}">
-                <a16:creationId xmlns:a16="http://schemas.microsoft.com/office/drawing/2014/main" id="{5FACB03B-8C2C-4AE9-829F-FBBD7F80DDC9}"/>
+                <a16:creationId xmlns:a16="http://schemas.microsoft.com/office/drawing/2014/main" id="{DC6CF57D-258D-4AFF-846A-C46A43A44081}"/>
               </a:ext>
             </a:extLst>
           </p:cNvPr>
@@ -11166,7 +11166,7 @@
                 <a:ea typeface="Aptos"/>
                 <a:cs typeface="Aptos"/>
               </a:rPr>
-              <a:t>Next product slices</a:t>
+              <a:t>Installable delivery</a:t>
             </a:r>
           </a:p>
         </p:txBody>
@@ -11176,7 +11176,7 @@
           <p:cNvPr id="15" name="">
             <a:extLst xmlns:a="http://schemas.openxmlformats.org/drawingml/2006/main">
               <a:ext uri="{FF2B5EF4-FFF2-40B4-BE49-F238E27FC236}">
-                <a16:creationId xmlns:a16="http://schemas.microsoft.com/office/drawing/2014/main" id="{B07EEB5C-4180-4597-AA18-E563072A6866}"/>
+                <a16:creationId xmlns:a16="http://schemas.microsoft.com/office/drawing/2014/main" id="{A04A5A5D-AA08-4A57-A275-AA0DE9303DD5}"/>
               </a:ext>
             </a:extLst>
           </p:cNvPr>
@@ -11233,7 +11233,7 @@
                 <a:ea typeface="Aptos"/>
                 <a:cs typeface="Aptos"/>
               </a:rPr>
-              <a:t>PR 5: 23 Roundtable tests</a:t>
+              <a:t>149 combined tests passing</a:t>
             </a:r>
           </a:p>
           <a:p xmlns:a="http://schemas.openxmlformats.org/drawingml/2006/main">
@@ -11256,7 +11256,7 @@
                 <a:ea typeface="Aptos"/>
                 <a:cs typeface="Aptos"/>
               </a:rPr>
-              <a:t>108 combined tests passing</a:t>
+              <a:t>Fresh production installation</a:t>
             </a:r>
           </a:p>
           <a:p xmlns:a="http://schemas.openxmlformats.org/drawingml/2006/main">
@@ -11279,7 +11279,7 @@
                 <a:ea typeface="Aptos"/>
                 <a:cs typeface="Aptos"/>
               </a:rPr>
-              <a:t>Website publisher still pending</a:t>
+              <a:t>Native worker RPC handshake</a:t>
             </a:r>
           </a:p>
           <a:p xmlns:a="http://schemas.openxmlformats.org/drawingml/2006/main">
@@ -11302,7 +11302,7 @@
                 <a:ea typeface="Aptos"/>
                 <a:cs typeface="Aptos"/>
               </a:rPr>
-              <a:t>Grant and member adapters next</a:t>
+              <a:t>Guided configuration validation</a:t>
             </a:r>
           </a:p>
         </p:txBody>
@@ -11312,7 +11312,7 @@
           <p:cNvPr id="16" name="">
             <a:extLst xmlns:a="http://schemas.openxmlformats.org/drawingml/2006/main">
               <a:ext uri="{FF2B5EF4-FFF2-40B4-BE49-F238E27FC236}">
-                <a16:creationId xmlns:a16="http://schemas.microsoft.com/office/drawing/2014/main" id="{863246D1-918B-4CE3-859E-EE9ADEC03E3C}"/>
+                <a16:creationId xmlns:a16="http://schemas.microsoft.com/office/drawing/2014/main" id="{B49B2408-1C1E-4D89-8275-A0662A08CF9A}"/>
               </a:ext>
             </a:extLst>
           </p:cNvPr>
@@ -11377,7 +11377,7 @@
     </p:spTree>
     <p:extLst>
       <p:ext uri="{BB962C8B-B14F-4D97-AF65-F5344CB8AC3E}">
-        <p14:creationId xmlns:p14="http://schemas.microsoft.com/office/powerpoint/2010/main" val="1719125137"/>
+        <p14:creationId xmlns:p14="http://schemas.microsoft.com/office/powerpoint/2010/main" val="829709320"/>
       </p:ext>
     </p:extLst>
   </p:cSld>
@@ -11408,7 +11408,7 @@
           <p:cNvPr id="17" name="">
             <a:extLst xmlns:a="http://schemas.openxmlformats.org/drawingml/2006/main">
               <a:ext uri="{FF2B5EF4-FFF2-40B4-BE49-F238E27FC236}">
-                <a16:creationId xmlns:a16="http://schemas.microsoft.com/office/drawing/2014/main" id="{A7F36360-C342-4961-B6BB-833D725C142D}"/>
+                <a16:creationId xmlns:a16="http://schemas.microsoft.com/office/drawing/2014/main" id="{0173441E-F063-4E8A-BF1A-3FE90B8F955D}"/>
               </a:ext>
             </a:extLst>
           </p:cNvPr>
@@ -11475,7 +11475,7 @@
           <p:cNvPr id="2" name="">
             <a:extLst xmlns:a="http://schemas.openxmlformats.org/drawingml/2006/main">
               <a:ext uri="{FF2B5EF4-FFF2-40B4-BE49-F238E27FC236}">
-                <a16:creationId xmlns:a16="http://schemas.microsoft.com/office/drawing/2014/main" id="{7800FAFB-FC91-4239-9015-A95D85B1BF6F}"/>
+                <a16:creationId xmlns:a16="http://schemas.microsoft.com/office/drawing/2014/main" id="{F5C871FE-F01B-488E-9C0A-CAF465CA5DB1}"/>
               </a:ext>
             </a:extLst>
           </p:cNvPr>
@@ -11542,7 +11542,7 @@
           <p:cNvPr id="3" name="">
             <a:extLst xmlns:a="http://schemas.openxmlformats.org/drawingml/2006/main">
               <a:ext uri="{FF2B5EF4-FFF2-40B4-BE49-F238E27FC236}">
-                <a16:creationId xmlns:a16="http://schemas.microsoft.com/office/drawing/2014/main" id="{18FBB0F3-049A-4480-90E3-C75A3E6300F2}"/>
+                <a16:creationId xmlns:a16="http://schemas.microsoft.com/office/drawing/2014/main" id="{2B1A65F4-3C73-462B-8F26-C26536AC782E}"/>
               </a:ext>
             </a:extLst>
           </p:cNvPr>
@@ -11609,7 +11609,7 @@
           <p:cNvPr id="4" name="">
             <a:extLst xmlns:a="http://schemas.openxmlformats.org/drawingml/2006/main">
               <a:ext uri="{FF2B5EF4-FFF2-40B4-BE49-F238E27FC236}">
-                <a16:creationId xmlns:a16="http://schemas.microsoft.com/office/drawing/2014/main" id="{2EC8A4F3-0E50-44E9-9A25-06979A479A58}"/>
+                <a16:creationId xmlns:a16="http://schemas.microsoft.com/office/drawing/2014/main" id="{EF2C142C-5C03-4D47-BFD4-3D6B04CEC89B}"/>
               </a:ext>
             </a:extLst>
           </p:cNvPr>
@@ -11640,7 +11640,7 @@
           <p:cNvPr id="5" name="">
             <a:extLst xmlns:a="http://schemas.openxmlformats.org/drawingml/2006/main">
               <a:ext uri="{FF2B5EF4-FFF2-40B4-BE49-F238E27FC236}">
-                <a16:creationId xmlns:a16="http://schemas.microsoft.com/office/drawing/2014/main" id="{7681E94F-2EB8-4076-AFB3-0324B76F029C}"/>
+                <a16:creationId xmlns:a16="http://schemas.microsoft.com/office/drawing/2014/main" id="{A3B4C865-930F-462E-96D0-8847246307CA}"/>
               </a:ext>
             </a:extLst>
           </p:cNvPr>
@@ -11697,7 +11697,7 @@
                 <a:ea typeface="Aptos"/>
                 <a:cs typeface="Aptos"/>
               </a:rPr>
-              <a:t>INERTIA-2026-10-22-r6 · 22 October 2026 · Autonomous build</a:t>
+              <a:t>INERTIA-2026-10-23-r7 · 23 October 2026 · Autonomous build</a:t>
             </a:r>
           </a:p>
         </p:txBody>
@@ -11707,7 +11707,7 @@
           <p:cNvPr id="6" name="">
             <a:extLst xmlns:a="http://schemas.openxmlformats.org/drawingml/2006/main">
               <a:ext uri="{FF2B5EF4-FFF2-40B4-BE49-F238E27FC236}">
-                <a16:creationId xmlns:a16="http://schemas.microsoft.com/office/drawing/2014/main" id="{0F34DE2E-A6A4-446E-AC81-0F455F233699}"/>
+                <a16:creationId xmlns:a16="http://schemas.microsoft.com/office/drawing/2014/main" id="{88373A89-E773-4F3B-9E34-A682312AA7E1}"/>
               </a:ext>
             </a:extLst>
           </p:cNvPr>
@@ -11774,7 +11774,7 @@
           <p:cNvPr id="7" name="">
             <a:extLst xmlns:a="http://schemas.openxmlformats.org/drawingml/2006/main">
               <a:ext uri="{FF2B5EF4-FFF2-40B4-BE49-F238E27FC236}">
-                <a16:creationId xmlns:a16="http://schemas.microsoft.com/office/drawing/2014/main" id="{49BE7E97-517E-42DB-9A82-F072C4130C03}"/>
+                <a16:creationId xmlns:a16="http://schemas.microsoft.com/office/drawing/2014/main" id="{929FF0A0-B33A-4487-BFDB-6835B1732A0B}"/>
               </a:ext>
             </a:extLst>
           </p:cNvPr>
@@ -11807,7 +11807,7 @@
           <p:cNvPr id="8" name="">
             <a:extLst xmlns:a="http://schemas.openxmlformats.org/drawingml/2006/main">
               <a:ext uri="{FF2B5EF4-FFF2-40B4-BE49-F238E27FC236}">
-                <a16:creationId xmlns:a16="http://schemas.microsoft.com/office/drawing/2014/main" id="{36E7074E-E5B4-4F3A-AEE7-CD3E3BCF96C5}"/>
+                <a16:creationId xmlns:a16="http://schemas.microsoft.com/office/drawing/2014/main" id="{639AE9B0-2039-47D3-9C4F-6A4CBFAA7575}"/>
               </a:ext>
             </a:extLst>
           </p:cNvPr>
@@ -11874,7 +11874,7 @@
           <p:cNvPr id="9" name="">
             <a:extLst xmlns:a="http://schemas.openxmlformats.org/drawingml/2006/main">
               <a:ext uri="{FF2B5EF4-FFF2-40B4-BE49-F238E27FC236}">
-                <a16:creationId xmlns:a16="http://schemas.microsoft.com/office/drawing/2014/main" id="{41EE5B33-E5A6-491B-AED2-645B84F2620F}"/>
+                <a16:creationId xmlns:a16="http://schemas.microsoft.com/office/drawing/2014/main" id="{D800D6A5-1A4D-4994-85B3-97D9159DEA6F}"/>
               </a:ext>
             </a:extLst>
           </p:cNvPr>
@@ -11931,7 +11931,7 @@
                 <a:ea typeface="Aptos"/>
                 <a:cs typeface="Aptos"/>
               </a:rPr>
-              <a:t>Bridge and core merged</a:t>
+              <a:t>Bridge and domain cores merged</a:t>
             </a:r>
           </a:p>
           <a:p xmlns:a="http://schemas.openxmlformats.org/drawingml/2006/main">
@@ -11954,7 +11954,7 @@
                 <a:ea typeface="Aptos"/>
                 <a:cs typeface="Aptos"/>
               </a:rPr>
-              <a:t>Continue website publisher</a:t>
+              <a:t>Plugin archive qualified</a:t>
             </a:r>
           </a:p>
           <a:p xmlns:a="http://schemas.openxmlformats.org/drawingml/2006/main">
@@ -11977,7 +11977,7 @@
                 <a:ea typeface="Aptos"/>
                 <a:cs typeface="Aptos"/>
               </a:rPr>
-              <a:t>Grant slice now active</a:t>
+              <a:t>Website publisher pending</a:t>
             </a:r>
           </a:p>
           <a:p xmlns:a="http://schemas.openxmlformats.org/drawingml/2006/main">
@@ -12010,7 +12010,7 @@
           <p:cNvPr id="10" name="">
             <a:extLst xmlns:a="http://schemas.openxmlformats.org/drawingml/2006/main">
               <a:ext uri="{FF2B5EF4-FFF2-40B4-BE49-F238E27FC236}">
-                <a16:creationId xmlns:a16="http://schemas.microsoft.com/office/drawing/2014/main" id="{6DCF7EC8-8239-4E90-B2BD-E87B6944589B}"/>
+                <a16:creationId xmlns:a16="http://schemas.microsoft.com/office/drawing/2014/main" id="{6B941325-326B-4F86-8450-C7509CC5DDE5}"/>
               </a:ext>
             </a:extLst>
           </p:cNvPr>
@@ -12043,7 +12043,7 @@
           <p:cNvPr id="11" name="">
             <a:extLst xmlns:a="http://schemas.openxmlformats.org/drawingml/2006/main">
               <a:ext uri="{FF2B5EF4-FFF2-40B4-BE49-F238E27FC236}">
-                <a16:creationId xmlns:a16="http://schemas.microsoft.com/office/drawing/2014/main" id="{580FAE3F-48DD-4E6D-A5A4-04715DDE9CA1}"/>
+                <a16:creationId xmlns:a16="http://schemas.microsoft.com/office/drawing/2014/main" id="{34DD5DE3-0E52-4993-A7C2-FA7308C23B11}"/>
               </a:ext>
             </a:extLst>
           </p:cNvPr>
@@ -12110,7 +12110,7 @@
           <p:cNvPr id="12" name="">
             <a:extLst xmlns:a="http://schemas.openxmlformats.org/drawingml/2006/main">
               <a:ext uri="{FF2B5EF4-FFF2-40B4-BE49-F238E27FC236}">
-                <a16:creationId xmlns:a16="http://schemas.microsoft.com/office/drawing/2014/main" id="{64513E19-DC8F-4038-9D60-2C703B484CBF}"/>
+                <a16:creationId xmlns:a16="http://schemas.microsoft.com/office/drawing/2014/main" id="{DF341400-E46A-4547-A3B9-6E2DCF4F4229}"/>
               </a:ext>
             </a:extLst>
           </p:cNvPr>
@@ -12246,7 +12246,7 @@
           <p:cNvPr id="13" name="">
             <a:extLst xmlns:a="http://schemas.openxmlformats.org/drawingml/2006/main">
               <a:ext uri="{FF2B5EF4-FFF2-40B4-BE49-F238E27FC236}">
-                <a16:creationId xmlns:a16="http://schemas.microsoft.com/office/drawing/2014/main" id="{7D0894CB-2A24-4773-B711-3DBB03AD9814}"/>
+                <a16:creationId xmlns:a16="http://schemas.microsoft.com/office/drawing/2014/main" id="{A2D50665-ABDE-434C-BCE8-FC777D1F21CB}"/>
               </a:ext>
             </a:extLst>
           </p:cNvPr>
@@ -12279,7 +12279,7 @@
           <p:cNvPr id="14" name="">
             <a:extLst xmlns:a="http://schemas.openxmlformats.org/drawingml/2006/main">
               <a:ext uri="{FF2B5EF4-FFF2-40B4-BE49-F238E27FC236}">
-                <a16:creationId xmlns:a16="http://schemas.microsoft.com/office/drawing/2014/main" id="{50D29861-A92C-43B0-87FE-E7557E1579C4}"/>
+                <a16:creationId xmlns:a16="http://schemas.microsoft.com/office/drawing/2014/main" id="{C0EE3AEA-04D6-4FCE-A14B-5FE39DB833C1}"/>
               </a:ext>
             </a:extLst>
           </p:cNvPr>
@@ -12346,7 +12346,7 @@
           <p:cNvPr id="15" name="">
             <a:extLst xmlns:a="http://schemas.openxmlformats.org/drawingml/2006/main">
               <a:ext uri="{FF2B5EF4-FFF2-40B4-BE49-F238E27FC236}">
-                <a16:creationId xmlns:a16="http://schemas.microsoft.com/office/drawing/2014/main" id="{5829169D-E3DB-4D23-8915-953CE26B069D}"/>
+                <a16:creationId xmlns:a16="http://schemas.microsoft.com/office/drawing/2014/main" id="{93DED335-5776-42AC-BBC1-81BD8EC9BCBA}"/>
               </a:ext>
             </a:extLst>
           </p:cNvPr>
@@ -12482,7 +12482,7 @@
           <p:cNvPr id="16" name="">
             <a:extLst xmlns:a="http://schemas.openxmlformats.org/drawingml/2006/main">
               <a:ext uri="{FF2B5EF4-FFF2-40B4-BE49-F238E27FC236}">
-                <a16:creationId xmlns:a16="http://schemas.microsoft.com/office/drawing/2014/main" id="{AA8ECAB8-73DF-4DFF-8904-5D3F99F4E5F5}"/>
+                <a16:creationId xmlns:a16="http://schemas.microsoft.com/office/drawing/2014/main" id="{0691ACA3-223A-4D47-BBE2-A8593645D206}"/>
               </a:ext>
             </a:extLst>
           </p:cNvPr>
@@ -12547,7 +12547,7 @@
     </p:spTree>
     <p:extLst>
       <p:ext uri="{BB962C8B-B14F-4D97-AF65-F5344CB8AC3E}">
-        <p14:creationId xmlns:p14="http://schemas.microsoft.com/office/powerpoint/2010/main" val="298920761"/>
+        <p14:creationId xmlns:p14="http://schemas.microsoft.com/office/powerpoint/2010/main" val="485357773"/>
       </p:ext>
     </p:extLst>
   </p:cSld>

</xml_diff>

<commit_message>
docs: synchronize r8 architecture and qualified website handoff
</commit_message>
<xml_diff>
--- a/Inertia-Architecture.pptx
+++ b/Inertia-Architecture.pptx
@@ -2,20 +2,20 @@
 <file path=ppt/presentation.xml><?xml version="1.0" encoding="utf-8"?>
 <p:presentation xmlns:p="http://schemas.openxmlformats.org/presentationml/2006/main">
   <p:sldMasterIdLst>
-    <p:sldMasterId xmlns:r="http://schemas.openxmlformats.org/officeDocument/2006/relationships" id="2147483648" r:id="R3be3756c8c8e4d06"/>
+    <p:sldMasterId xmlns:r="http://schemas.openxmlformats.org/officeDocument/2006/relationships" id="2147483648" r:id="Re63ac91880a5454e"/>
   </p:sldMasterIdLst>
   <p:notesMasterIdLst>
-    <p:notesMasterId xmlns:r="http://schemas.openxmlformats.org/officeDocument/2006/relationships" r:id="R919ed80d140d4fc7"/>
+    <p:notesMasterId xmlns:r="http://schemas.openxmlformats.org/officeDocument/2006/relationships" r:id="R565c0f89eef14973"/>
   </p:notesMasterIdLst>
   <p:sldIdLst>
-    <p:sldId xmlns:r="http://schemas.openxmlformats.org/officeDocument/2006/relationships" id="256" r:id="Re58f4a1192c74eb7"/>
-    <p:sldId xmlns:r="http://schemas.openxmlformats.org/officeDocument/2006/relationships" id="257" r:id="Rb1ef7f9abbed4c2f"/>
-    <p:sldId xmlns:r="http://schemas.openxmlformats.org/officeDocument/2006/relationships" id="258" r:id="R5d83b06a76334ccd"/>
-    <p:sldId xmlns:r="http://schemas.openxmlformats.org/officeDocument/2006/relationships" id="259" r:id="R766df985260e44a9"/>
-    <p:sldId xmlns:r="http://schemas.openxmlformats.org/officeDocument/2006/relationships" id="260" r:id="Rb41a4fe761d7431d"/>
-    <p:sldId xmlns:r="http://schemas.openxmlformats.org/officeDocument/2006/relationships" id="261" r:id="R6d062e6c2d2d4a16"/>
-    <p:sldId xmlns:r="http://schemas.openxmlformats.org/officeDocument/2006/relationships" id="262" r:id="R4bc29f4189db4bbe"/>
-    <p:sldId xmlns:r="http://schemas.openxmlformats.org/officeDocument/2006/relationships" id="263" r:id="Ref3549c8c3f04046"/>
+    <p:sldId xmlns:r="http://schemas.openxmlformats.org/officeDocument/2006/relationships" id="256" r:id="R61af3860cbfb4f76"/>
+    <p:sldId xmlns:r="http://schemas.openxmlformats.org/officeDocument/2006/relationships" id="257" r:id="Rb9391e72b1374f46"/>
+    <p:sldId xmlns:r="http://schemas.openxmlformats.org/officeDocument/2006/relationships" id="258" r:id="R93e9e8d68d904378"/>
+    <p:sldId xmlns:r="http://schemas.openxmlformats.org/officeDocument/2006/relationships" id="259" r:id="R15d2ec525f2e449e"/>
+    <p:sldId xmlns:r="http://schemas.openxmlformats.org/officeDocument/2006/relationships" id="260" r:id="Rc7df1c9c7fd3442e"/>
+    <p:sldId xmlns:r="http://schemas.openxmlformats.org/officeDocument/2006/relationships" id="261" r:id="R24343b718bcc40f3"/>
+    <p:sldId xmlns:r="http://schemas.openxmlformats.org/officeDocument/2006/relationships" id="262" r:id="R0472f160c43c4b11"/>
+    <p:sldId xmlns:r="http://schemas.openxmlformats.org/officeDocument/2006/relationships" id="263" r:id="Rb14ba0e698bb42a9"/>
   </p:sldIdLst>
   <p:sldSz cx="15240000" cy="8572500"/>
   <p:notesSz cx="6858000" cy="9144000"/>
@@ -449,7 +449,7 @@
           <a:lstStyle xmlns:a="http://schemas.openxmlformats.org/drawingml/2006/main"/>
           <a:p xmlns:a="http://schemas.openxmlformats.org/drawingml/2006/main">
             <a:r>
-              <a:t>INERTIA-2026-10-23-r7. Sources: spec.md, testing.md, decisions.md, plan.md. Merged baseline https://github.com/NetRxn/Inertia/commit/53d0f2eedf62778f8af6cc92da6fc7b84f3f0435; PR 2 https://github.com/NetRxn/Inertia/pull/2; PR 3 https://github.com/NetRxn/Inertia/pull/3. Paperclip selected public release v2026.1012.0, bba6a45f0d364cfd962ac59b3bdf2426a8222adb. Buzz dc25198d530acc6237a0320b697365f29daf0ea6. PR 4 https://github.com/NetRxn/Inertia/pull/4 and PR 5 https://github.com/NetRxn/Inertia/pull/5 merged. PR 7 https://github.com/NetRxn/Inertia/pull/7 merged with 37 grant tests. PR 8 https://github.com/NetRxn/Inertia/pull/8 merged with packaging f68e8bb98df0bb05f9a946340d885e0bcfc6e188 independently reviewed; 149 combined tests, typecheck, build, fresh production install and native JSON-RPC worker handshake passed. No private execution-provider source included.</a:t>
+              <a:t>INERTIA-2026-10-23-r8. Sources: spec.md, testing.md, decisions.md, plan.md. Merged baseline https://github.com/NetRxn/Inertia/commit/ec26c1b850e7937a9d5b1561c1a27b43d06394de; PR 2 https://github.com/NetRxn/Inertia/pull/2; PR 3 https://github.com/NetRxn/Inertia/pull/3. Paperclip selected public release v2026.1012.0, bba6a45f0d364cfd962ac59b3bdf2426a8222adb. Buzz dc25198d530acc6237a0320b697365f29daf0ea6. PR 4 https://github.com/NetRxn/Inertia/pull/4 and PR 5 https://github.com/NetRxn/Inertia/pull/5 merged. PR 7 https://github.com/NetRxn/Inertia/pull/7 merged with 37 grant tests. PR 8 https://github.com/NetRxn/Inertia/pull/8 merged with packaging f68e8bb98df0bb05f9a946340d885e0bcfc6e188 independently reviewed; 149 combined tests, typecheck, build, fresh production install and native JSON-RPC worker handshake passed at PR8. PR10 https://github.com/NetRxn/Inertia/pull/10 adds the connected workflow: 152 total tests and five demos pass. External I/O and native work seeding are fixtures. See docs/implementation/live-handoff-checklist.md and docs/qualification/native-services.md. Actual pinned native services passed using PostgreSQL18.1; cloud HTTP startup was blocked by interface enumeration; the authorized isolated Docker fallback subsequently passed full HTTP/API qualification without shims. Latest published host/SDK remain 2026.1012.0 as of 23 October. PR11 https://github.com/NetRxn/Inertia/pull/11 upgrade workflow has 12 focused tests and isolated 152-test/package qualification. DAO organizational facts come from authorized website retrieval with citations and restricted audiences. No private execution-provider source included.</a:t>
             </a:r>
           </a:p>
         </p:txBody>
@@ -519,7 +519,7 @@
           <a:lstStyle xmlns:a="http://schemas.openxmlformats.org/drawingml/2006/main"/>
           <a:p xmlns:a="http://schemas.openxmlformats.org/drawingml/2006/main">
             <a:r>
-              <a:t>INERTIA-2026-10-23-r7. Sources: spec.md, testing.md, decisions.md, plan.md. Merged baseline https://github.com/NetRxn/Inertia/commit/53d0f2eedf62778f8af6cc92da6fc7b84f3f0435; PR 2 https://github.com/NetRxn/Inertia/pull/2; PR 3 https://github.com/NetRxn/Inertia/pull/3. Paperclip selected public release v2026.1012.0, bba6a45f0d364cfd962ac59b3bdf2426a8222adb. Buzz dc25198d530acc6237a0320b697365f29daf0ea6. PR 4 https://github.com/NetRxn/Inertia/pull/4 and PR 5 https://github.com/NetRxn/Inertia/pull/5 merged. PR 7 https://github.com/NetRxn/Inertia/pull/7 merged with 37 grant tests. PR 8 https://github.com/NetRxn/Inertia/pull/8 merged with packaging f68e8bb98df0bb05f9a946340d885e0bcfc6e188 independently reviewed; 149 combined tests, typecheck, build, fresh production install and native JSON-RPC worker handshake passed. No private execution-provider source included.</a:t>
+              <a:t>INERTIA-2026-10-23-r8. Sources: spec.md, testing.md, decisions.md, plan.md. Merged baseline https://github.com/NetRxn/Inertia/commit/ec26c1b850e7937a9d5b1561c1a27b43d06394de; PR 2 https://github.com/NetRxn/Inertia/pull/2; PR 3 https://github.com/NetRxn/Inertia/pull/3. Paperclip selected public release v2026.1012.0, bba6a45f0d364cfd962ac59b3bdf2426a8222adb. Buzz dc25198d530acc6237a0320b697365f29daf0ea6. PR 4 https://github.com/NetRxn/Inertia/pull/4 and PR 5 https://github.com/NetRxn/Inertia/pull/5 merged. PR 7 https://github.com/NetRxn/Inertia/pull/7 merged with 37 grant tests. PR 8 https://github.com/NetRxn/Inertia/pull/8 merged with packaging f68e8bb98df0bb05f9a946340d885e0bcfc6e188 independently reviewed; 149 combined tests, typecheck, build, fresh production install and native JSON-RPC worker handshake passed at PR8. PR10 https://github.com/NetRxn/Inertia/pull/10 adds the connected workflow: 152 total tests and five demos pass. External I/O and native work seeding are fixtures. See docs/implementation/live-handoff-checklist.md and docs/qualification/native-services.md. Actual pinned native services passed using PostgreSQL18.1; cloud HTTP startup was blocked by interface enumeration; the authorized isolated Docker fallback subsequently passed full HTTP/API qualification without shims. Latest published host/SDK remain 2026.1012.0 as of 23 October. PR11 https://github.com/NetRxn/Inertia/pull/11 upgrade workflow has 12 focused tests and isolated 152-test/package qualification. DAO organizational facts come from authorized website retrieval with citations and restricted audiences. No private execution-provider source included.</a:t>
             </a:r>
           </a:p>
         </p:txBody>
@@ -589,7 +589,7 @@
           <a:lstStyle xmlns:a="http://schemas.openxmlformats.org/drawingml/2006/main"/>
           <a:p xmlns:a="http://schemas.openxmlformats.org/drawingml/2006/main">
             <a:r>
-              <a:t>INERTIA-2026-10-23-r7. Sources: spec.md, testing.md, decisions.md, plan.md. Merged baseline https://github.com/NetRxn/Inertia/commit/53d0f2eedf62778f8af6cc92da6fc7b84f3f0435; PR 2 https://github.com/NetRxn/Inertia/pull/2; PR 3 https://github.com/NetRxn/Inertia/pull/3. Paperclip selected public release v2026.1012.0, bba6a45f0d364cfd962ac59b3bdf2426a8222adb. Buzz dc25198d530acc6237a0320b697365f29daf0ea6. PR 4 https://github.com/NetRxn/Inertia/pull/4 and PR 5 https://github.com/NetRxn/Inertia/pull/5 merged. PR 7 https://github.com/NetRxn/Inertia/pull/7 merged with 37 grant tests. PR 8 https://github.com/NetRxn/Inertia/pull/8 merged with packaging f68e8bb98df0bb05f9a946340d885e0bcfc6e188 independently reviewed; 149 combined tests, typecheck, build, fresh production install and native JSON-RPC worker handshake passed. No private execution-provider source included.</a:t>
+              <a:t>INERTIA-2026-10-23-r8. Sources: spec.md, testing.md, decisions.md, plan.md. Merged baseline https://github.com/NetRxn/Inertia/commit/ec26c1b850e7937a9d5b1561c1a27b43d06394de; PR 2 https://github.com/NetRxn/Inertia/pull/2; PR 3 https://github.com/NetRxn/Inertia/pull/3. Paperclip selected public release v2026.1012.0, bba6a45f0d364cfd962ac59b3bdf2426a8222adb. Buzz dc25198d530acc6237a0320b697365f29daf0ea6. PR 4 https://github.com/NetRxn/Inertia/pull/4 and PR 5 https://github.com/NetRxn/Inertia/pull/5 merged. PR 7 https://github.com/NetRxn/Inertia/pull/7 merged with 37 grant tests. PR 8 https://github.com/NetRxn/Inertia/pull/8 merged with packaging f68e8bb98df0bb05f9a946340d885e0bcfc6e188 independently reviewed; 149 combined tests, typecheck, build, fresh production install and native JSON-RPC worker handshake passed at PR8. PR10 https://github.com/NetRxn/Inertia/pull/10 adds the connected workflow: 152 total tests and five demos pass. External I/O and native work seeding are fixtures. See docs/implementation/live-handoff-checklist.md and docs/qualification/native-services.md. Actual pinned native services passed using PostgreSQL18.1; cloud HTTP startup was blocked by interface enumeration; the authorized isolated Docker fallback subsequently passed full HTTP/API qualification without shims. Latest published host/SDK remain 2026.1012.0 as of 23 October. PR11 https://github.com/NetRxn/Inertia/pull/11 upgrade workflow has 12 focused tests and isolated 152-test/package qualification. DAO organizational facts come from authorized website retrieval with citations and restricted audiences. No private execution-provider source included.</a:t>
             </a:r>
           </a:p>
         </p:txBody>
@@ -659,7 +659,7 @@
           <a:lstStyle xmlns:a="http://schemas.openxmlformats.org/drawingml/2006/main"/>
           <a:p xmlns:a="http://schemas.openxmlformats.org/drawingml/2006/main">
             <a:r>
-              <a:t>INERTIA-2026-10-23-r7. Sources: spec.md, testing.md, decisions.md, plan.md. Merged baseline https://github.com/NetRxn/Inertia/commit/53d0f2eedf62778f8af6cc92da6fc7b84f3f0435; PR 2 https://github.com/NetRxn/Inertia/pull/2; PR 3 https://github.com/NetRxn/Inertia/pull/3. Paperclip selected public release v2026.1012.0, bba6a45f0d364cfd962ac59b3bdf2426a8222adb. Buzz dc25198d530acc6237a0320b697365f29daf0ea6. PR 4 https://github.com/NetRxn/Inertia/pull/4 and PR 5 https://github.com/NetRxn/Inertia/pull/5 merged. PR 7 https://github.com/NetRxn/Inertia/pull/7 merged with 37 grant tests. PR 8 https://github.com/NetRxn/Inertia/pull/8 merged with packaging f68e8bb98df0bb05f9a946340d885e0bcfc6e188 independently reviewed; 149 combined tests, typecheck, build, fresh production install and native JSON-RPC worker handshake passed. No private execution-provider source included.</a:t>
+              <a:t>INERTIA-2026-10-23-r8. Sources: spec.md, testing.md, decisions.md, plan.md. Merged baseline https://github.com/NetRxn/Inertia/commit/ec26c1b850e7937a9d5b1561c1a27b43d06394de; PR 2 https://github.com/NetRxn/Inertia/pull/2; PR 3 https://github.com/NetRxn/Inertia/pull/3. Paperclip selected public release v2026.1012.0, bba6a45f0d364cfd962ac59b3bdf2426a8222adb. Buzz dc25198d530acc6237a0320b697365f29daf0ea6. PR 4 https://github.com/NetRxn/Inertia/pull/4 and PR 5 https://github.com/NetRxn/Inertia/pull/5 merged. PR 7 https://github.com/NetRxn/Inertia/pull/7 merged with 37 grant tests. PR 8 https://github.com/NetRxn/Inertia/pull/8 merged with packaging f68e8bb98df0bb05f9a946340d885e0bcfc6e188 independently reviewed; 149 combined tests, typecheck, build, fresh production install and native JSON-RPC worker handshake passed at PR8. PR10 https://github.com/NetRxn/Inertia/pull/10 adds the connected workflow: 152 total tests and five demos pass. External I/O and native work seeding are fixtures. See docs/implementation/live-handoff-checklist.md and docs/qualification/native-services.md. Actual pinned native services passed using PostgreSQL18.1; cloud HTTP startup was blocked by interface enumeration; the authorized isolated Docker fallback subsequently passed full HTTP/API qualification without shims. Latest published host/SDK remain 2026.1012.0 as of 23 October. PR11 https://github.com/NetRxn/Inertia/pull/11 upgrade workflow has 12 focused tests and isolated 152-test/package qualification. DAO organizational facts come from authorized website retrieval with citations and restricted audiences. No private execution-provider source included.</a:t>
             </a:r>
           </a:p>
         </p:txBody>
@@ -729,7 +729,7 @@
           <a:lstStyle xmlns:a="http://schemas.openxmlformats.org/drawingml/2006/main"/>
           <a:p xmlns:a="http://schemas.openxmlformats.org/drawingml/2006/main">
             <a:r>
-              <a:t>INERTIA-2026-10-23-r7. Sources: spec.md, testing.md, decisions.md, plan.md. Merged baseline https://github.com/NetRxn/Inertia/commit/53d0f2eedf62778f8af6cc92da6fc7b84f3f0435; PR 2 https://github.com/NetRxn/Inertia/pull/2; PR 3 https://github.com/NetRxn/Inertia/pull/3. Paperclip selected public release v2026.1012.0, bba6a45f0d364cfd962ac59b3bdf2426a8222adb. Buzz dc25198d530acc6237a0320b697365f29daf0ea6. PR 4 https://github.com/NetRxn/Inertia/pull/4 and PR 5 https://github.com/NetRxn/Inertia/pull/5 merged. PR 7 https://github.com/NetRxn/Inertia/pull/7 merged with 37 grant tests. PR 8 https://github.com/NetRxn/Inertia/pull/8 merged with packaging f68e8bb98df0bb05f9a946340d885e0bcfc6e188 independently reviewed; 149 combined tests, typecheck, build, fresh production install and native JSON-RPC worker handshake passed. No private execution-provider source included.</a:t>
+              <a:t>INERTIA-2026-10-23-r8. Sources: spec.md, testing.md, decisions.md, plan.md. Merged baseline https://github.com/NetRxn/Inertia/commit/ec26c1b850e7937a9d5b1561c1a27b43d06394de; PR 2 https://github.com/NetRxn/Inertia/pull/2; PR 3 https://github.com/NetRxn/Inertia/pull/3. Paperclip selected public release v2026.1012.0, bba6a45f0d364cfd962ac59b3bdf2426a8222adb. Buzz dc25198d530acc6237a0320b697365f29daf0ea6. PR 4 https://github.com/NetRxn/Inertia/pull/4 and PR 5 https://github.com/NetRxn/Inertia/pull/5 merged. PR 7 https://github.com/NetRxn/Inertia/pull/7 merged with 37 grant tests. PR 8 https://github.com/NetRxn/Inertia/pull/8 merged with packaging f68e8bb98df0bb05f9a946340d885e0bcfc6e188 independently reviewed; 149 combined tests, typecheck, build, fresh production install and native JSON-RPC worker handshake passed at PR8. PR10 https://github.com/NetRxn/Inertia/pull/10 adds the connected workflow: 152 total tests and five demos pass. External I/O and native work seeding are fixtures. See docs/implementation/live-handoff-checklist.md and docs/qualification/native-services.md. Actual pinned native services passed using PostgreSQL18.1; cloud HTTP startup was blocked by interface enumeration; the authorized isolated Docker fallback subsequently passed full HTTP/API qualification without shims. Latest published host/SDK remain 2026.1012.0 as of 23 October. PR11 https://github.com/NetRxn/Inertia/pull/11 upgrade workflow has 12 focused tests and isolated 152-test/package qualification. DAO organizational facts come from authorized website retrieval with citations and restricted audiences. No private execution-provider source included.</a:t>
             </a:r>
           </a:p>
         </p:txBody>
@@ -799,7 +799,7 @@
           <a:lstStyle xmlns:a="http://schemas.openxmlformats.org/drawingml/2006/main"/>
           <a:p xmlns:a="http://schemas.openxmlformats.org/drawingml/2006/main">
             <a:r>
-              <a:t>INERTIA-2026-10-23-r7. Sources: spec.md, testing.md, decisions.md, plan.md. Merged baseline https://github.com/NetRxn/Inertia/commit/53d0f2eedf62778f8af6cc92da6fc7b84f3f0435; PR 2 https://github.com/NetRxn/Inertia/pull/2; PR 3 https://github.com/NetRxn/Inertia/pull/3. Paperclip selected public release v2026.1012.0, bba6a45f0d364cfd962ac59b3bdf2426a8222adb. Buzz dc25198d530acc6237a0320b697365f29daf0ea6. PR 4 https://github.com/NetRxn/Inertia/pull/4 and PR 5 https://github.com/NetRxn/Inertia/pull/5 merged. PR 7 https://github.com/NetRxn/Inertia/pull/7 merged with 37 grant tests. PR 8 https://github.com/NetRxn/Inertia/pull/8 merged with packaging f68e8bb98df0bb05f9a946340d885e0bcfc6e188 independently reviewed; 149 combined tests, typecheck, build, fresh production install and native JSON-RPC worker handshake passed. No private execution-provider source included.</a:t>
+              <a:t>INERTIA-2026-10-23-r8. Sources: spec.md, testing.md, decisions.md, plan.md. Merged baseline https://github.com/NetRxn/Inertia/commit/ec26c1b850e7937a9d5b1561c1a27b43d06394de; PR 2 https://github.com/NetRxn/Inertia/pull/2; PR 3 https://github.com/NetRxn/Inertia/pull/3. Paperclip selected public release v2026.1012.0, bba6a45f0d364cfd962ac59b3bdf2426a8222adb. Buzz dc25198d530acc6237a0320b697365f29daf0ea6. PR 4 https://github.com/NetRxn/Inertia/pull/4 and PR 5 https://github.com/NetRxn/Inertia/pull/5 merged. PR 7 https://github.com/NetRxn/Inertia/pull/7 merged with 37 grant tests. PR 8 https://github.com/NetRxn/Inertia/pull/8 merged with packaging f68e8bb98df0bb05f9a946340d885e0bcfc6e188 independently reviewed; 149 combined tests, typecheck, build, fresh production install and native JSON-RPC worker handshake passed at PR8. PR10 https://github.com/NetRxn/Inertia/pull/10 adds the connected workflow: 152 total tests and five demos pass. External I/O and native work seeding are fixtures. See docs/implementation/live-handoff-checklist.md and docs/qualification/native-services.md. Actual pinned native services passed using PostgreSQL18.1; cloud HTTP startup was blocked by interface enumeration; the authorized isolated Docker fallback subsequently passed full HTTP/API qualification without shims. Latest published host/SDK remain 2026.1012.0 as of 23 October. PR11 https://github.com/NetRxn/Inertia/pull/11 upgrade workflow has 12 focused tests and isolated 152-test/package qualification. DAO organizational facts come from authorized website retrieval with citations and restricted audiences. No private execution-provider source included.</a:t>
             </a:r>
           </a:p>
         </p:txBody>
@@ -869,7 +869,7 @@
           <a:lstStyle xmlns:a="http://schemas.openxmlformats.org/drawingml/2006/main"/>
           <a:p xmlns:a="http://schemas.openxmlformats.org/drawingml/2006/main">
             <a:r>
-              <a:t>INERTIA-2026-10-23-r7. Sources: spec.md, testing.md, decisions.md, plan.md. Merged baseline https://github.com/NetRxn/Inertia/commit/53d0f2eedf62778f8af6cc92da6fc7b84f3f0435; PR 2 https://github.com/NetRxn/Inertia/pull/2; PR 3 https://github.com/NetRxn/Inertia/pull/3. Paperclip selected public release v2026.1012.0, bba6a45f0d364cfd962ac59b3bdf2426a8222adb. Buzz dc25198d530acc6237a0320b697365f29daf0ea6. PR 4 https://github.com/NetRxn/Inertia/pull/4 and PR 5 https://github.com/NetRxn/Inertia/pull/5 merged. PR 7 https://github.com/NetRxn/Inertia/pull/7 merged with 37 grant tests. PR 8 https://github.com/NetRxn/Inertia/pull/8 merged with packaging f68e8bb98df0bb05f9a946340d885e0bcfc6e188 independently reviewed; 149 combined tests, typecheck, build, fresh production install and native JSON-RPC worker handshake passed. No private execution-provider source included.</a:t>
+              <a:t>INERTIA-2026-10-23-r8. Sources: spec.md, testing.md, decisions.md, plan.md. Merged baseline https://github.com/NetRxn/Inertia/commit/ec26c1b850e7937a9d5b1561c1a27b43d06394de; PR 2 https://github.com/NetRxn/Inertia/pull/2; PR 3 https://github.com/NetRxn/Inertia/pull/3. Paperclip selected public release v2026.1012.0, bba6a45f0d364cfd962ac59b3bdf2426a8222adb. Buzz dc25198d530acc6237a0320b697365f29daf0ea6. PR 4 https://github.com/NetRxn/Inertia/pull/4 and PR 5 https://github.com/NetRxn/Inertia/pull/5 merged. PR 7 https://github.com/NetRxn/Inertia/pull/7 merged with 37 grant tests. PR 8 https://github.com/NetRxn/Inertia/pull/8 merged with packaging f68e8bb98df0bb05f9a946340d885e0bcfc6e188 independently reviewed; 149 combined tests, typecheck, build, fresh production install and native JSON-RPC worker handshake passed at PR8. PR10 https://github.com/NetRxn/Inertia/pull/10 adds the connected workflow: 152 total tests and five demos pass. External I/O and native work seeding are fixtures. See docs/implementation/live-handoff-checklist.md and docs/qualification/native-services.md. Actual pinned native services passed using PostgreSQL18.1; cloud HTTP startup was blocked by interface enumeration; the authorized isolated Docker fallback subsequently passed full HTTP/API qualification without shims. Latest published host/SDK remain 2026.1012.0 as of 23 October. PR11 https://github.com/NetRxn/Inertia/pull/11 upgrade workflow has 12 focused tests and isolated 152-test/package qualification. DAO organizational facts come from authorized website retrieval with citations and restricted audiences. No private execution-provider source included.</a:t>
             </a:r>
           </a:p>
         </p:txBody>
@@ -939,7 +939,7 @@
           <a:lstStyle xmlns:a="http://schemas.openxmlformats.org/drawingml/2006/main"/>
           <a:p xmlns:a="http://schemas.openxmlformats.org/drawingml/2006/main">
             <a:r>
-              <a:t>INERTIA-2026-10-23-r7. Sources: spec.md, testing.md, decisions.md, plan.md. Merged baseline https://github.com/NetRxn/Inertia/commit/53d0f2eedf62778f8af6cc92da6fc7b84f3f0435; PR 2 https://github.com/NetRxn/Inertia/pull/2; PR 3 https://github.com/NetRxn/Inertia/pull/3. Paperclip selected public release v2026.1012.0, bba6a45f0d364cfd962ac59b3bdf2426a8222adb. Buzz dc25198d530acc6237a0320b697365f29daf0ea6. PR 4 https://github.com/NetRxn/Inertia/pull/4 and PR 5 https://github.com/NetRxn/Inertia/pull/5 merged. PR 7 https://github.com/NetRxn/Inertia/pull/7 merged with 37 grant tests. PR 8 https://github.com/NetRxn/Inertia/pull/8 merged with packaging f68e8bb98df0bb05f9a946340d885e0bcfc6e188 independently reviewed; 149 combined tests, typecheck, build, fresh production install and native JSON-RPC worker handshake passed. No private execution-provider source included.</a:t>
+              <a:t>INERTIA-2026-10-23-r8. Sources: spec.md, testing.md, decisions.md, plan.md. Merged baseline https://github.com/NetRxn/Inertia/commit/ec26c1b850e7937a9d5b1561c1a27b43d06394de; PR 2 https://github.com/NetRxn/Inertia/pull/2; PR 3 https://github.com/NetRxn/Inertia/pull/3. Paperclip selected public release v2026.1012.0, bba6a45f0d364cfd962ac59b3bdf2426a8222adb. Buzz dc25198d530acc6237a0320b697365f29daf0ea6. PR 4 https://github.com/NetRxn/Inertia/pull/4 and PR 5 https://github.com/NetRxn/Inertia/pull/5 merged. PR 7 https://github.com/NetRxn/Inertia/pull/7 merged with 37 grant tests. PR 8 https://github.com/NetRxn/Inertia/pull/8 merged with packaging f68e8bb98df0bb05f9a946340d885e0bcfc6e188 independently reviewed; 149 combined tests, typecheck, build, fresh production install and native JSON-RPC worker handshake passed at PR8. PR10 https://github.com/NetRxn/Inertia/pull/10 adds the connected workflow: 152 total tests and five demos pass. External I/O and native work seeding are fixtures. See docs/implementation/live-handoff-checklist.md and docs/qualification/native-services.md. Actual pinned native services passed using PostgreSQL18.1; cloud HTTP startup was blocked by interface enumeration; the authorized isolated Docker fallback subsequently passed full HTTP/API qualification without shims. Latest published host/SDK remain 2026.1012.0 as of 23 October. PR11 https://github.com/NetRxn/Inertia/pull/11 upgrade workflow has 12 focused tests and isolated 152-test/package qualification. DAO organizational facts come from authorized website retrieval with citations and restricted audiences. No private execution-provider source included.</a:t>
             </a:r>
           </a:p>
         </p:txBody>
@@ -986,7 +986,7 @@
           <p:cNvPr id="3" name="Title">
             <a:extLst xmlns:a="http://schemas.openxmlformats.org/drawingml/2006/main">
               <a:ext uri="{FF2B5EF4-FFF2-40B4-BE49-F238E27FC236}">
-                <a16:creationId xmlns:a16="http://schemas.microsoft.com/office/drawing/2014/main" id="{95D1E57F-B585-48FA-B271-4C568F5362D9}"/>
+                <a16:creationId xmlns:a16="http://schemas.microsoft.com/office/drawing/2014/main" id="{B2BB04BB-C642-4AFE-B2AF-EA71054E0DF8}"/>
               </a:ext>
             </a:extLst>
           </p:cNvPr>
@@ -1143,7 +1143,7 @@
           <p:cNvPr id="2" name="Subtitle">
             <a:extLst xmlns:a="http://schemas.openxmlformats.org/drawingml/2006/main">
               <a:ext uri="{FF2B5EF4-FFF2-40B4-BE49-F238E27FC236}">
-                <a16:creationId xmlns:a16="http://schemas.microsoft.com/office/drawing/2014/main" id="{ADCBF4C5-38CE-4382-ADFF-8D349780FF13}"/>
+                <a16:creationId xmlns:a16="http://schemas.microsoft.com/office/drawing/2014/main" id="{60BB485D-8C21-443F-9EA8-4CFA63D31D26}"/>
               </a:ext>
             </a:extLst>
           </p:cNvPr>
@@ -1317,7 +1317,7 @@
           <p:cNvPr id="2" name="Section title">
             <a:extLst xmlns:a="http://schemas.openxmlformats.org/drawingml/2006/main">
               <a:ext uri="{FF2B5EF4-FFF2-40B4-BE49-F238E27FC236}">
-                <a16:creationId xmlns:a16="http://schemas.microsoft.com/office/drawing/2014/main" id="{91B867D4-3DA0-47B2-9D01-3112A1B2E3BD}"/>
+                <a16:creationId xmlns:a16="http://schemas.microsoft.com/office/drawing/2014/main" id="{0BED8EB3-3C72-4747-B8AF-6AA0FB6B83AA}"/>
               </a:ext>
             </a:extLst>
           </p:cNvPr>
@@ -1491,7 +1491,7 @@
           <p:cNvPr id="3" name="Title">
             <a:extLst xmlns:a="http://schemas.openxmlformats.org/drawingml/2006/main">
               <a:ext uri="{FF2B5EF4-FFF2-40B4-BE49-F238E27FC236}">
-                <a16:creationId xmlns:a16="http://schemas.microsoft.com/office/drawing/2014/main" id="{3E0D570B-6EBC-43AC-B476-FB076AF1E7A7}"/>
+                <a16:creationId xmlns:a16="http://schemas.microsoft.com/office/drawing/2014/main" id="{3860B105-9D39-465C-9FDA-541C01197993}"/>
               </a:ext>
             </a:extLst>
           </p:cNvPr>
@@ -1648,7 +1648,7 @@
           <p:cNvPr id="2" name="Body">
             <a:extLst xmlns:a="http://schemas.openxmlformats.org/drawingml/2006/main">
               <a:ext uri="{FF2B5EF4-FFF2-40B4-BE49-F238E27FC236}">
-                <a16:creationId xmlns:a16="http://schemas.microsoft.com/office/drawing/2014/main" id="{8BD6B71A-F54F-42C7-A877-7354E411401C}"/>
+                <a16:creationId xmlns:a16="http://schemas.microsoft.com/office/drawing/2014/main" id="{4612016C-7988-4E4B-AF1B-845FB0D2C4EB}"/>
               </a:ext>
             </a:extLst>
           </p:cNvPr>
@@ -1822,7 +1822,7 @@
           <p:cNvPr id="4" name="Title">
             <a:extLst xmlns:a="http://schemas.openxmlformats.org/drawingml/2006/main">
               <a:ext uri="{FF2B5EF4-FFF2-40B4-BE49-F238E27FC236}">
-                <a16:creationId xmlns:a16="http://schemas.microsoft.com/office/drawing/2014/main" id="{68C2C14D-F684-4909-88F4-3F250CAAB786}"/>
+                <a16:creationId xmlns:a16="http://schemas.microsoft.com/office/drawing/2014/main" id="{6C75AC54-C9AA-4B23-9A08-5EB093C9736F}"/>
               </a:ext>
             </a:extLst>
           </p:cNvPr>
@@ -1979,7 +1979,7 @@
           <p:cNvPr id="2" name="Left column">
             <a:extLst xmlns:a="http://schemas.openxmlformats.org/drawingml/2006/main">
               <a:ext uri="{FF2B5EF4-FFF2-40B4-BE49-F238E27FC236}">
-                <a16:creationId xmlns:a16="http://schemas.microsoft.com/office/drawing/2014/main" id="{FCDF51D0-11A0-4E3D-A341-7B7B2CE8E009}"/>
+                <a16:creationId xmlns:a16="http://schemas.microsoft.com/office/drawing/2014/main" id="{E2F28D63-9C78-4795-BC3A-CC73D8833DF6}"/>
               </a:ext>
             </a:extLst>
           </p:cNvPr>
@@ -2136,7 +2136,7 @@
           <p:cNvPr id="3" name="Right column">
             <a:extLst xmlns:a="http://schemas.openxmlformats.org/drawingml/2006/main">
               <a:ext uri="{FF2B5EF4-FFF2-40B4-BE49-F238E27FC236}">
-                <a16:creationId xmlns:a16="http://schemas.microsoft.com/office/drawing/2014/main" id="{5FD43888-3962-41C3-8D69-C94503E9CB1E}"/>
+                <a16:creationId xmlns:a16="http://schemas.microsoft.com/office/drawing/2014/main" id="{AF25E1A6-5B62-4DE3-BC6F-DAECC9F8F2B3}"/>
               </a:ext>
             </a:extLst>
           </p:cNvPr>
@@ -2310,7 +2310,7 @@
           <p:cNvPr id="3" name="Title">
             <a:extLst xmlns:a="http://schemas.openxmlformats.org/drawingml/2006/main">
               <a:ext uri="{FF2B5EF4-FFF2-40B4-BE49-F238E27FC236}">
-                <a16:creationId xmlns:a16="http://schemas.microsoft.com/office/drawing/2014/main" id="{5C7F9286-8D75-4BA5-A753-5F902D8904BD}"/>
+                <a16:creationId xmlns:a16="http://schemas.microsoft.com/office/drawing/2014/main" id="{47FC270D-D82C-4B56-A521-5FCB06B0E788}"/>
               </a:ext>
             </a:extLst>
           </p:cNvPr>
@@ -2467,7 +2467,7 @@
           <p:cNvPr id="2" name="Left column">
             <a:extLst xmlns:a="http://schemas.openxmlformats.org/drawingml/2006/main">
               <a:ext uri="{FF2B5EF4-FFF2-40B4-BE49-F238E27FC236}">
-                <a16:creationId xmlns:a16="http://schemas.microsoft.com/office/drawing/2014/main" id="{6E137C6C-C699-4A3B-9DF9-6DA18ED53DB5}"/>
+                <a16:creationId xmlns:a16="http://schemas.microsoft.com/office/drawing/2014/main" id="{9669944E-66CE-4C43-8BF8-3D6C205627F1}"/>
               </a:ext>
             </a:extLst>
           </p:cNvPr>
@@ -2662,12 +2662,12 @@
   </p:cSld>
   <p:clrMap bg1="lt1" tx1="dk1" bg2="lt2" tx2="dk2" accent1="accent1" accent2="accent2" accent3="accent3" accent4="accent4" accent5="accent5" accent6="accent6" hlink="hlink" folHlink="folHlink"/>
   <p:sldLayoutIdLst>
-    <p:sldLayoutId xmlns:r="http://schemas.openxmlformats.org/officeDocument/2006/relationships" id="2147483649" r:id="R233f2e708c214e04"/>
-    <p:sldLayoutId xmlns:r="http://schemas.openxmlformats.org/officeDocument/2006/relationships" id="2147483650" r:id="R16173458a66b442b"/>
-    <p:sldLayoutId xmlns:r="http://schemas.openxmlformats.org/officeDocument/2006/relationships" id="2147483651" r:id="Rb005901e47b247ed"/>
-    <p:sldLayoutId xmlns:r="http://schemas.openxmlformats.org/officeDocument/2006/relationships" id="2147483652" r:id="Rb8747a1593ac46e5"/>
-    <p:sldLayoutId xmlns:r="http://schemas.openxmlformats.org/officeDocument/2006/relationships" id="2147483653" r:id="R48da9b55596e4ba5"/>
-    <p:sldLayoutId xmlns:r="http://schemas.openxmlformats.org/officeDocument/2006/relationships" id="2147483654" r:id="Re252940858574bd5"/>
+    <p:sldLayoutId xmlns:r="http://schemas.openxmlformats.org/officeDocument/2006/relationships" id="2147483649" r:id="R6846bf5a52784031"/>
+    <p:sldLayoutId xmlns:r="http://schemas.openxmlformats.org/officeDocument/2006/relationships" id="2147483650" r:id="R27b90192727d4b6f"/>
+    <p:sldLayoutId xmlns:r="http://schemas.openxmlformats.org/officeDocument/2006/relationships" id="2147483651" r:id="R86f2907a34264d91"/>
+    <p:sldLayoutId xmlns:r="http://schemas.openxmlformats.org/officeDocument/2006/relationships" id="2147483652" r:id="R8696eeb5e57b422f"/>
+    <p:sldLayoutId xmlns:r="http://schemas.openxmlformats.org/officeDocument/2006/relationships" id="2147483653" r:id="Rccc8d6c9a01c44f9"/>
+    <p:sldLayoutId xmlns:r="http://schemas.openxmlformats.org/officeDocument/2006/relationships" id="2147483654" r:id="R9643191b62a84ca2"/>
   </p:sldLayoutIdLst>
   <p:txStyles>
     <p:titleStyle>
@@ -3218,7 +3218,7 @@
           <p:cNvPr id="17" name="">
             <a:extLst xmlns:a="http://schemas.openxmlformats.org/drawingml/2006/main">
               <a:ext uri="{FF2B5EF4-FFF2-40B4-BE49-F238E27FC236}">
-                <a16:creationId xmlns:a16="http://schemas.microsoft.com/office/drawing/2014/main" id="{75A17CB0-39A8-4057-8703-88DC0F47DA44}"/>
+                <a16:creationId xmlns:a16="http://schemas.microsoft.com/office/drawing/2014/main" id="{BC239CF3-AEEB-4C70-9638-598037246DD0}"/>
               </a:ext>
             </a:extLst>
           </p:cNvPr>
@@ -3285,7 +3285,7 @@
           <p:cNvPr id="2" name="">
             <a:extLst xmlns:a="http://schemas.openxmlformats.org/drawingml/2006/main">
               <a:ext uri="{FF2B5EF4-FFF2-40B4-BE49-F238E27FC236}">
-                <a16:creationId xmlns:a16="http://schemas.microsoft.com/office/drawing/2014/main" id="{8E7AA5AE-3884-4754-BB21-036316BC93B7}"/>
+                <a16:creationId xmlns:a16="http://schemas.microsoft.com/office/drawing/2014/main" id="{775A061A-BB9A-46D9-9689-1E888F612136}"/>
               </a:ext>
             </a:extLst>
           </p:cNvPr>
@@ -3352,7 +3352,7 @@
           <p:cNvPr id="3" name="">
             <a:extLst xmlns:a="http://schemas.openxmlformats.org/drawingml/2006/main">
               <a:ext uri="{FF2B5EF4-FFF2-40B4-BE49-F238E27FC236}">
-                <a16:creationId xmlns:a16="http://schemas.microsoft.com/office/drawing/2014/main" id="{C52E8E11-3AAB-4161-BA43-A873C284EE78}"/>
+                <a16:creationId xmlns:a16="http://schemas.microsoft.com/office/drawing/2014/main" id="{5D164164-343D-4C7C-B71D-8030C1CF6682}"/>
               </a:ext>
             </a:extLst>
           </p:cNvPr>
@@ -3419,7 +3419,7 @@
           <p:cNvPr id="4" name="">
             <a:extLst xmlns:a="http://schemas.openxmlformats.org/drawingml/2006/main">
               <a:ext uri="{FF2B5EF4-FFF2-40B4-BE49-F238E27FC236}">
-                <a16:creationId xmlns:a16="http://schemas.microsoft.com/office/drawing/2014/main" id="{B79EDA0C-5311-4F7A-B0E4-BC61B4DD2BBA}"/>
+                <a16:creationId xmlns:a16="http://schemas.microsoft.com/office/drawing/2014/main" id="{6423E234-E4AB-4F82-B0DF-2D097B8BABD2}"/>
               </a:ext>
             </a:extLst>
           </p:cNvPr>
@@ -3450,7 +3450,7 @@
           <p:cNvPr id="5" name="">
             <a:extLst xmlns:a="http://schemas.openxmlformats.org/drawingml/2006/main">
               <a:ext uri="{FF2B5EF4-FFF2-40B4-BE49-F238E27FC236}">
-                <a16:creationId xmlns:a16="http://schemas.microsoft.com/office/drawing/2014/main" id="{A997853C-D0FA-442D-B83B-10E243559DD1}"/>
+                <a16:creationId xmlns:a16="http://schemas.microsoft.com/office/drawing/2014/main" id="{080D05CB-D177-43A8-87B2-A8D4D710DBF6}"/>
               </a:ext>
             </a:extLst>
           </p:cNvPr>
@@ -3507,7 +3507,7 @@
                 <a:ea typeface="Aptos"/>
                 <a:cs typeface="Aptos"/>
               </a:rPr>
-              <a:t>INERTIA-2026-10-23-r7 · 23 October 2026 · Autonomous build</a:t>
+              <a:t>INERTIA-2026-10-23-r8 · 23 October 2026 · Autonomous build</a:t>
             </a:r>
           </a:p>
         </p:txBody>
@@ -3517,7 +3517,7 @@
           <p:cNvPr id="6" name="">
             <a:extLst xmlns:a="http://schemas.openxmlformats.org/drawingml/2006/main">
               <a:ext uri="{FF2B5EF4-FFF2-40B4-BE49-F238E27FC236}">
-                <a16:creationId xmlns:a16="http://schemas.microsoft.com/office/drawing/2014/main" id="{E1AAD32A-738A-4B4D-AF3B-E1039F8B2359}"/>
+                <a16:creationId xmlns:a16="http://schemas.microsoft.com/office/drawing/2014/main" id="{5DF04493-7DE5-4D72-9C1E-49BFA41D2CA5}"/>
               </a:ext>
             </a:extLst>
           </p:cNvPr>
@@ -3584,7 +3584,7 @@
           <p:cNvPr id="7" name="">
             <a:extLst xmlns:a="http://schemas.openxmlformats.org/drawingml/2006/main">
               <a:ext uri="{FF2B5EF4-FFF2-40B4-BE49-F238E27FC236}">
-                <a16:creationId xmlns:a16="http://schemas.microsoft.com/office/drawing/2014/main" id="{895CD7D3-4E64-4D64-95EC-AE898156BC0D}"/>
+                <a16:creationId xmlns:a16="http://schemas.microsoft.com/office/drawing/2014/main" id="{D2153C1E-A0B4-45F5-A34D-24706DB52EFC}"/>
               </a:ext>
             </a:extLst>
           </p:cNvPr>
@@ -3617,7 +3617,7 @@
           <p:cNvPr id="8" name="">
             <a:extLst xmlns:a="http://schemas.openxmlformats.org/drawingml/2006/main">
               <a:ext uri="{FF2B5EF4-FFF2-40B4-BE49-F238E27FC236}">
-                <a16:creationId xmlns:a16="http://schemas.microsoft.com/office/drawing/2014/main" id="{0822820E-389C-4386-ABF5-8F3E89F88428}"/>
+                <a16:creationId xmlns:a16="http://schemas.microsoft.com/office/drawing/2014/main" id="{AA48ECDB-2288-4E14-8C18-9F8332DA82D6}"/>
               </a:ext>
             </a:extLst>
           </p:cNvPr>
@@ -3684,7 +3684,7 @@
           <p:cNvPr id="9" name="">
             <a:extLst xmlns:a="http://schemas.openxmlformats.org/drawingml/2006/main">
               <a:ext uri="{FF2B5EF4-FFF2-40B4-BE49-F238E27FC236}">
-                <a16:creationId xmlns:a16="http://schemas.microsoft.com/office/drawing/2014/main" id="{4DF2FB39-8503-4F7F-A20E-D799FFC3CB8D}"/>
+                <a16:creationId xmlns:a16="http://schemas.microsoft.com/office/drawing/2014/main" id="{35B68F73-56D2-467A-95DE-6505A99DE0CD}"/>
               </a:ext>
             </a:extLst>
           </p:cNvPr>
@@ -3820,7 +3820,7 @@
           <p:cNvPr id="10" name="">
             <a:extLst xmlns:a="http://schemas.openxmlformats.org/drawingml/2006/main">
               <a:ext uri="{FF2B5EF4-FFF2-40B4-BE49-F238E27FC236}">
-                <a16:creationId xmlns:a16="http://schemas.microsoft.com/office/drawing/2014/main" id="{4394AFB3-3884-4B91-84F9-D9DBD29A978D}"/>
+                <a16:creationId xmlns:a16="http://schemas.microsoft.com/office/drawing/2014/main" id="{2E07301F-CADC-43B8-9DEC-48FBD257046F}"/>
               </a:ext>
             </a:extLst>
           </p:cNvPr>
@@ -3853,7 +3853,7 @@
           <p:cNvPr id="11" name="">
             <a:extLst xmlns:a="http://schemas.openxmlformats.org/drawingml/2006/main">
               <a:ext uri="{FF2B5EF4-FFF2-40B4-BE49-F238E27FC236}">
-                <a16:creationId xmlns:a16="http://schemas.microsoft.com/office/drawing/2014/main" id="{D6201A74-09B1-4889-AF4F-41F9C25DA6FA}"/>
+                <a16:creationId xmlns:a16="http://schemas.microsoft.com/office/drawing/2014/main" id="{3D16CEED-7B01-44E3-8A26-D63202FFE02D}"/>
               </a:ext>
             </a:extLst>
           </p:cNvPr>
@@ -3920,7 +3920,7 @@
           <p:cNvPr id="12" name="">
             <a:extLst xmlns:a="http://schemas.openxmlformats.org/drawingml/2006/main">
               <a:ext uri="{FF2B5EF4-FFF2-40B4-BE49-F238E27FC236}">
-                <a16:creationId xmlns:a16="http://schemas.microsoft.com/office/drawing/2014/main" id="{71961843-971E-4E58-A870-49045C7CBA83}"/>
+                <a16:creationId xmlns:a16="http://schemas.microsoft.com/office/drawing/2014/main" id="{69FAD8CC-CABF-460A-8D10-37945D426688}"/>
               </a:ext>
             </a:extLst>
           </p:cNvPr>
@@ -4056,7 +4056,7 @@
           <p:cNvPr id="13" name="">
             <a:extLst xmlns:a="http://schemas.openxmlformats.org/drawingml/2006/main">
               <a:ext uri="{FF2B5EF4-FFF2-40B4-BE49-F238E27FC236}">
-                <a16:creationId xmlns:a16="http://schemas.microsoft.com/office/drawing/2014/main" id="{42A6583E-D56A-43F0-97A0-A8C7DC6F55E2}"/>
+                <a16:creationId xmlns:a16="http://schemas.microsoft.com/office/drawing/2014/main" id="{CEF943F2-0F20-41AD-9B1C-CE20548E73C5}"/>
               </a:ext>
             </a:extLst>
           </p:cNvPr>
@@ -4089,7 +4089,7 @@
           <p:cNvPr id="14" name="">
             <a:extLst xmlns:a="http://schemas.openxmlformats.org/drawingml/2006/main">
               <a:ext uri="{FF2B5EF4-FFF2-40B4-BE49-F238E27FC236}">
-                <a16:creationId xmlns:a16="http://schemas.microsoft.com/office/drawing/2014/main" id="{07AD5DAD-5402-4ACA-B83A-9A0DD58443A8}"/>
+                <a16:creationId xmlns:a16="http://schemas.microsoft.com/office/drawing/2014/main" id="{B17ADE35-A4FA-44FC-89E1-5984054AE389}"/>
               </a:ext>
             </a:extLst>
           </p:cNvPr>
@@ -4156,7 +4156,7 @@
           <p:cNvPr id="15" name="">
             <a:extLst xmlns:a="http://schemas.openxmlformats.org/drawingml/2006/main">
               <a:ext uri="{FF2B5EF4-FFF2-40B4-BE49-F238E27FC236}">
-                <a16:creationId xmlns:a16="http://schemas.microsoft.com/office/drawing/2014/main" id="{BC00549C-210B-4AA3-B9A5-A2121A074DE9}"/>
+                <a16:creationId xmlns:a16="http://schemas.microsoft.com/office/drawing/2014/main" id="{D0B9CA06-3D16-4139-B9AD-07875AA91F38}"/>
               </a:ext>
             </a:extLst>
           </p:cNvPr>
@@ -4292,7 +4292,7 @@
           <p:cNvPr id="16" name="">
             <a:extLst xmlns:a="http://schemas.openxmlformats.org/drawingml/2006/main">
               <a:ext uri="{FF2B5EF4-FFF2-40B4-BE49-F238E27FC236}">
-                <a16:creationId xmlns:a16="http://schemas.microsoft.com/office/drawing/2014/main" id="{E07F0EA3-9DEE-4358-9B37-79AC719B0BDB}"/>
+                <a16:creationId xmlns:a16="http://schemas.microsoft.com/office/drawing/2014/main" id="{2E448B18-4CE1-4E33-87D1-75CE8159A33E}"/>
               </a:ext>
             </a:extLst>
           </p:cNvPr>
@@ -4349,7 +4349,7 @@
                 <a:ea typeface="Aptos"/>
                 <a:cs typeface="Aptos"/>
               </a:rPr>
-              <a:t>Required demo outcomes: meeting publication, a packet-bound vote and a second member’s contribution.</a:t>
+              <a:t>One-command synthetic walkthrough: npm run demo:workflow. Deterministic receipt links the journey and pending live handoffs.</a:t>
             </a:r>
           </a:p>
         </p:txBody>
@@ -4357,7 +4357,7 @@
     </p:spTree>
     <p:extLst>
       <p:ext uri="{BB962C8B-B14F-4D97-AF65-F5344CB8AC3E}">
-        <p14:creationId xmlns:p14="http://schemas.microsoft.com/office/powerpoint/2010/main" val="1968587660"/>
+        <p14:creationId xmlns:p14="http://schemas.microsoft.com/office/powerpoint/2010/main" val="1649333656"/>
       </p:ext>
     </p:extLst>
   </p:cSld>
@@ -4388,7 +4388,7 @@
           <p:cNvPr id="17" name="">
             <a:extLst xmlns:a="http://schemas.openxmlformats.org/drawingml/2006/main">
               <a:ext uri="{FF2B5EF4-FFF2-40B4-BE49-F238E27FC236}">
-                <a16:creationId xmlns:a16="http://schemas.microsoft.com/office/drawing/2014/main" id="{EE06281D-7DA2-4A51-9FB6-D45B89B30533}"/>
+                <a16:creationId xmlns:a16="http://schemas.microsoft.com/office/drawing/2014/main" id="{AA7E402A-3371-447D-BE62-7E56C20F8C59}"/>
               </a:ext>
             </a:extLst>
           </p:cNvPr>
@@ -4455,7 +4455,7 @@
           <p:cNvPr id="2" name="">
             <a:extLst xmlns:a="http://schemas.openxmlformats.org/drawingml/2006/main">
               <a:ext uri="{FF2B5EF4-FFF2-40B4-BE49-F238E27FC236}">
-                <a16:creationId xmlns:a16="http://schemas.microsoft.com/office/drawing/2014/main" id="{53C260F7-D566-4389-8653-E77D369EAE33}"/>
+                <a16:creationId xmlns:a16="http://schemas.microsoft.com/office/drawing/2014/main" id="{7856E497-2025-4C11-98AE-354E6125C898}"/>
               </a:ext>
             </a:extLst>
           </p:cNvPr>
@@ -4522,7 +4522,7 @@
           <p:cNvPr id="3" name="">
             <a:extLst xmlns:a="http://schemas.openxmlformats.org/drawingml/2006/main">
               <a:ext uri="{FF2B5EF4-FFF2-40B4-BE49-F238E27FC236}">
-                <a16:creationId xmlns:a16="http://schemas.microsoft.com/office/drawing/2014/main" id="{B06AB686-7526-49D9-BFF9-E1FDC2B46EF9}"/>
+                <a16:creationId xmlns:a16="http://schemas.microsoft.com/office/drawing/2014/main" id="{C9BBB0FF-4EB5-4568-B42F-9D7CDC0A2C56}"/>
               </a:ext>
             </a:extLst>
           </p:cNvPr>
@@ -4589,7 +4589,7 @@
           <p:cNvPr id="4" name="">
             <a:extLst xmlns:a="http://schemas.openxmlformats.org/drawingml/2006/main">
               <a:ext uri="{FF2B5EF4-FFF2-40B4-BE49-F238E27FC236}">
-                <a16:creationId xmlns:a16="http://schemas.microsoft.com/office/drawing/2014/main" id="{C659046B-B47F-4269-8A3F-B410C60F3E1D}"/>
+                <a16:creationId xmlns:a16="http://schemas.microsoft.com/office/drawing/2014/main" id="{F310BFE3-49C7-402D-BB80-E5A14561142F}"/>
               </a:ext>
             </a:extLst>
           </p:cNvPr>
@@ -4620,7 +4620,7 @@
           <p:cNvPr id="5" name="">
             <a:extLst xmlns:a="http://schemas.openxmlformats.org/drawingml/2006/main">
               <a:ext uri="{FF2B5EF4-FFF2-40B4-BE49-F238E27FC236}">
-                <a16:creationId xmlns:a16="http://schemas.microsoft.com/office/drawing/2014/main" id="{E734B095-112B-43C9-B8C3-FED820A4522A}"/>
+                <a16:creationId xmlns:a16="http://schemas.microsoft.com/office/drawing/2014/main" id="{6D63C75B-38AD-44DE-B2C8-8E88B008BDB1}"/>
               </a:ext>
             </a:extLst>
           </p:cNvPr>
@@ -4677,7 +4677,7 @@
                 <a:ea typeface="Aptos"/>
                 <a:cs typeface="Aptos"/>
               </a:rPr>
-              <a:t>INERTIA-2026-10-23-r7 · 23 October 2026 · Autonomous build</a:t>
+              <a:t>INERTIA-2026-10-23-r8 · 23 October 2026 · Autonomous build</a:t>
             </a:r>
           </a:p>
         </p:txBody>
@@ -4687,7 +4687,7 @@
           <p:cNvPr id="6" name="">
             <a:extLst xmlns:a="http://schemas.openxmlformats.org/drawingml/2006/main">
               <a:ext uri="{FF2B5EF4-FFF2-40B4-BE49-F238E27FC236}">
-                <a16:creationId xmlns:a16="http://schemas.microsoft.com/office/drawing/2014/main" id="{C14636F2-19A8-4444-9E5C-EAC575F842E8}"/>
+                <a16:creationId xmlns:a16="http://schemas.microsoft.com/office/drawing/2014/main" id="{AF2CB773-7879-4FB3-8C25-21C9E9DF2C6D}"/>
               </a:ext>
             </a:extLst>
           </p:cNvPr>
@@ -4754,7 +4754,7 @@
           <p:cNvPr id="7" name="">
             <a:extLst xmlns:a="http://schemas.openxmlformats.org/drawingml/2006/main">
               <a:ext uri="{FF2B5EF4-FFF2-40B4-BE49-F238E27FC236}">
-                <a16:creationId xmlns:a16="http://schemas.microsoft.com/office/drawing/2014/main" id="{00F6D0B6-C34F-4F11-95B4-E702EE3C5D89}"/>
+                <a16:creationId xmlns:a16="http://schemas.microsoft.com/office/drawing/2014/main" id="{A0500152-E36A-431D-9503-A0CB8F413815}"/>
               </a:ext>
             </a:extLst>
           </p:cNvPr>
@@ -4787,7 +4787,7 @@
           <p:cNvPr id="8" name="">
             <a:extLst xmlns:a="http://schemas.openxmlformats.org/drawingml/2006/main">
               <a:ext uri="{FF2B5EF4-FFF2-40B4-BE49-F238E27FC236}">
-                <a16:creationId xmlns:a16="http://schemas.microsoft.com/office/drawing/2014/main" id="{41AA1ADC-CCFE-4008-9E98-BF3BBF7DF52A}"/>
+                <a16:creationId xmlns:a16="http://schemas.microsoft.com/office/drawing/2014/main" id="{66709222-0339-43C4-BD8B-9C62A1D0E1E1}"/>
               </a:ext>
             </a:extLst>
           </p:cNvPr>
@@ -4854,7 +4854,7 @@
           <p:cNvPr id="9" name="">
             <a:extLst xmlns:a="http://schemas.openxmlformats.org/drawingml/2006/main">
               <a:ext uri="{FF2B5EF4-FFF2-40B4-BE49-F238E27FC236}">
-                <a16:creationId xmlns:a16="http://schemas.microsoft.com/office/drawing/2014/main" id="{95F2B8EF-39D5-412B-8A7B-24B0745D6BAE}"/>
+                <a16:creationId xmlns:a16="http://schemas.microsoft.com/office/drawing/2014/main" id="{EB7DF129-E2D4-42BF-AF3A-0A51F797F241}"/>
               </a:ext>
             </a:extLst>
           </p:cNvPr>
@@ -4990,7 +4990,7 @@
           <p:cNvPr id="10" name="">
             <a:extLst xmlns:a="http://schemas.openxmlformats.org/drawingml/2006/main">
               <a:ext uri="{FF2B5EF4-FFF2-40B4-BE49-F238E27FC236}">
-                <a16:creationId xmlns:a16="http://schemas.microsoft.com/office/drawing/2014/main" id="{104C8D86-6522-47BF-A332-D13A05656B5D}"/>
+                <a16:creationId xmlns:a16="http://schemas.microsoft.com/office/drawing/2014/main" id="{C7F4D5F2-930E-4AEA-BCAD-C642871E43BD}"/>
               </a:ext>
             </a:extLst>
           </p:cNvPr>
@@ -5023,7 +5023,7 @@
           <p:cNvPr id="11" name="">
             <a:extLst xmlns:a="http://schemas.openxmlformats.org/drawingml/2006/main">
               <a:ext uri="{FF2B5EF4-FFF2-40B4-BE49-F238E27FC236}">
-                <a16:creationId xmlns:a16="http://schemas.microsoft.com/office/drawing/2014/main" id="{8E2D9FF4-17E6-413C-9349-22137D1EC7E0}"/>
+                <a16:creationId xmlns:a16="http://schemas.microsoft.com/office/drawing/2014/main" id="{9750ECB7-DB45-4D6F-904A-A3001E33B2D4}"/>
               </a:ext>
             </a:extLst>
           </p:cNvPr>
@@ -5090,7 +5090,7 @@
           <p:cNvPr id="12" name="">
             <a:extLst xmlns:a="http://schemas.openxmlformats.org/drawingml/2006/main">
               <a:ext uri="{FF2B5EF4-FFF2-40B4-BE49-F238E27FC236}">
-                <a16:creationId xmlns:a16="http://schemas.microsoft.com/office/drawing/2014/main" id="{51029DB9-D370-43DB-8A01-DCC57E26F78B}"/>
+                <a16:creationId xmlns:a16="http://schemas.microsoft.com/office/drawing/2014/main" id="{612C9D55-35D0-4BAB-8E3D-57AB6674D958}"/>
               </a:ext>
             </a:extLst>
           </p:cNvPr>
@@ -5226,7 +5226,7 @@
           <p:cNvPr id="13" name="">
             <a:extLst xmlns:a="http://schemas.openxmlformats.org/drawingml/2006/main">
               <a:ext uri="{FF2B5EF4-FFF2-40B4-BE49-F238E27FC236}">
-                <a16:creationId xmlns:a16="http://schemas.microsoft.com/office/drawing/2014/main" id="{2995EA0B-045D-491F-80B4-C54E28EFA07C}"/>
+                <a16:creationId xmlns:a16="http://schemas.microsoft.com/office/drawing/2014/main" id="{7D6978CF-E9C4-4AFB-9744-B48389DEB42F}"/>
               </a:ext>
             </a:extLst>
           </p:cNvPr>
@@ -5259,7 +5259,7 @@
           <p:cNvPr id="14" name="">
             <a:extLst xmlns:a="http://schemas.openxmlformats.org/drawingml/2006/main">
               <a:ext uri="{FF2B5EF4-FFF2-40B4-BE49-F238E27FC236}">
-                <a16:creationId xmlns:a16="http://schemas.microsoft.com/office/drawing/2014/main" id="{A89751F6-B7D3-4B44-8391-576F0F93809D}"/>
+                <a16:creationId xmlns:a16="http://schemas.microsoft.com/office/drawing/2014/main" id="{3B0E4C0F-84D5-46C1-8AB7-B563943D2932}"/>
               </a:ext>
             </a:extLst>
           </p:cNvPr>
@@ -5326,7 +5326,7 @@
           <p:cNvPr id="15" name="">
             <a:extLst xmlns:a="http://schemas.openxmlformats.org/drawingml/2006/main">
               <a:ext uri="{FF2B5EF4-FFF2-40B4-BE49-F238E27FC236}">
-                <a16:creationId xmlns:a16="http://schemas.microsoft.com/office/drawing/2014/main" id="{F2747B70-629C-4D99-BD56-6DA417CFD4E2}"/>
+                <a16:creationId xmlns:a16="http://schemas.microsoft.com/office/drawing/2014/main" id="{B2EFF710-9337-4710-A8E0-C04D4711369E}"/>
               </a:ext>
             </a:extLst>
           </p:cNvPr>
@@ -5462,7 +5462,7 @@
           <p:cNvPr id="16" name="">
             <a:extLst xmlns:a="http://schemas.openxmlformats.org/drawingml/2006/main">
               <a:ext uri="{FF2B5EF4-FFF2-40B4-BE49-F238E27FC236}">
-                <a16:creationId xmlns:a16="http://schemas.microsoft.com/office/drawing/2014/main" id="{B450F4DE-8F17-40A3-AA49-4DD93E986894}"/>
+                <a16:creationId xmlns:a16="http://schemas.microsoft.com/office/drawing/2014/main" id="{BBA93648-BF1B-4CB2-9628-711602AA722A}"/>
               </a:ext>
             </a:extLst>
           </p:cNvPr>
@@ -5519,7 +5519,7 @@
                 <a:ea typeface="Aptos"/>
                 <a:cs typeface="Aptos"/>
               </a:rPr>
-              <a:t>A narrow plugin fits the selected Paperclip release. Shared records keep the two interfaces coherent.</a:t>
+              <a:t>Latest Paperclip releases are the target. Reproducible builds qualify compatibility and migrations before promotion.</a:t>
             </a:r>
           </a:p>
         </p:txBody>
@@ -5527,7 +5527,7 @@
     </p:spTree>
     <p:extLst>
       <p:ext uri="{BB962C8B-B14F-4D97-AF65-F5344CB8AC3E}">
-        <p14:creationId xmlns:p14="http://schemas.microsoft.com/office/powerpoint/2010/main" val="733959173"/>
+        <p14:creationId xmlns:p14="http://schemas.microsoft.com/office/powerpoint/2010/main" val="170816485"/>
       </p:ext>
     </p:extLst>
   </p:cSld>
@@ -5558,7 +5558,7 @@
           <p:cNvPr id="17" name="">
             <a:extLst xmlns:a="http://schemas.openxmlformats.org/drawingml/2006/main">
               <a:ext uri="{FF2B5EF4-FFF2-40B4-BE49-F238E27FC236}">
-                <a16:creationId xmlns:a16="http://schemas.microsoft.com/office/drawing/2014/main" id="{8CF80F0F-375A-4B24-A0C5-A8CBDDE1ED60}"/>
+                <a16:creationId xmlns:a16="http://schemas.microsoft.com/office/drawing/2014/main" id="{182BD0C8-8380-48F4-B41A-229845094366}"/>
               </a:ext>
             </a:extLst>
           </p:cNvPr>
@@ -5625,7 +5625,7 @@
           <p:cNvPr id="2" name="">
             <a:extLst xmlns:a="http://schemas.openxmlformats.org/drawingml/2006/main">
               <a:ext uri="{FF2B5EF4-FFF2-40B4-BE49-F238E27FC236}">
-                <a16:creationId xmlns:a16="http://schemas.microsoft.com/office/drawing/2014/main" id="{95F88023-8372-4D9F-AE47-A9345B2F0AF8}"/>
+                <a16:creationId xmlns:a16="http://schemas.microsoft.com/office/drawing/2014/main" id="{0CCB7C36-E25D-4D85-888E-F11279DD2CE0}"/>
               </a:ext>
             </a:extLst>
           </p:cNvPr>
@@ -5692,7 +5692,7 @@
           <p:cNvPr id="3" name="">
             <a:extLst xmlns:a="http://schemas.openxmlformats.org/drawingml/2006/main">
               <a:ext uri="{FF2B5EF4-FFF2-40B4-BE49-F238E27FC236}">
-                <a16:creationId xmlns:a16="http://schemas.microsoft.com/office/drawing/2014/main" id="{1AFD17F5-A822-4FC5-83B8-7A3C435B8022}"/>
+                <a16:creationId xmlns:a16="http://schemas.microsoft.com/office/drawing/2014/main" id="{3098477F-614C-4C0E-BDF2-15D0E0A17517}"/>
               </a:ext>
             </a:extLst>
           </p:cNvPr>
@@ -5759,7 +5759,7 @@
           <p:cNvPr id="4" name="">
             <a:extLst xmlns:a="http://schemas.openxmlformats.org/drawingml/2006/main">
               <a:ext uri="{FF2B5EF4-FFF2-40B4-BE49-F238E27FC236}">
-                <a16:creationId xmlns:a16="http://schemas.microsoft.com/office/drawing/2014/main" id="{F7802C5E-0670-40F2-997D-DA582BC5F085}"/>
+                <a16:creationId xmlns:a16="http://schemas.microsoft.com/office/drawing/2014/main" id="{78E15CD5-619F-447C-A583-3971869491F4}"/>
               </a:ext>
             </a:extLst>
           </p:cNvPr>
@@ -5790,7 +5790,7 @@
           <p:cNvPr id="5" name="">
             <a:extLst xmlns:a="http://schemas.openxmlformats.org/drawingml/2006/main">
               <a:ext uri="{FF2B5EF4-FFF2-40B4-BE49-F238E27FC236}">
-                <a16:creationId xmlns:a16="http://schemas.microsoft.com/office/drawing/2014/main" id="{5D677A4C-05D8-406A-9A87-EBD6B2AFAC4E}"/>
+                <a16:creationId xmlns:a16="http://schemas.microsoft.com/office/drawing/2014/main" id="{9F31E50D-4E53-43DB-B757-9A76A371E417}"/>
               </a:ext>
             </a:extLst>
           </p:cNvPr>
@@ -5847,7 +5847,7 @@
                 <a:ea typeface="Aptos"/>
                 <a:cs typeface="Aptos"/>
               </a:rPr>
-              <a:t>INERTIA-2026-10-23-r7 · 23 October 2026 · Autonomous build</a:t>
+              <a:t>INERTIA-2026-10-23-r8 · 23 October 2026 · Autonomous build</a:t>
             </a:r>
           </a:p>
         </p:txBody>
@@ -5857,7 +5857,7 @@
           <p:cNvPr id="6" name="">
             <a:extLst xmlns:a="http://schemas.openxmlformats.org/drawingml/2006/main">
               <a:ext uri="{FF2B5EF4-FFF2-40B4-BE49-F238E27FC236}">
-                <a16:creationId xmlns:a16="http://schemas.microsoft.com/office/drawing/2014/main" id="{D264DAEF-B56A-4E10-94A2-06346AE44A35}"/>
+                <a16:creationId xmlns:a16="http://schemas.microsoft.com/office/drawing/2014/main" id="{50252E89-1542-40E1-AA32-AC5E1A860D55}"/>
               </a:ext>
             </a:extLst>
           </p:cNvPr>
@@ -5924,7 +5924,7 @@
           <p:cNvPr id="7" name="">
             <a:extLst xmlns:a="http://schemas.openxmlformats.org/drawingml/2006/main">
               <a:ext uri="{FF2B5EF4-FFF2-40B4-BE49-F238E27FC236}">
-                <a16:creationId xmlns:a16="http://schemas.microsoft.com/office/drawing/2014/main" id="{1DA0AE12-E67A-47B6-848C-EFBF3557132E}"/>
+                <a16:creationId xmlns:a16="http://schemas.microsoft.com/office/drawing/2014/main" id="{E8E56381-D20D-49D9-9458-FD13F1C803C6}"/>
               </a:ext>
             </a:extLst>
           </p:cNvPr>
@@ -5957,7 +5957,7 @@
           <p:cNvPr id="8" name="">
             <a:extLst xmlns:a="http://schemas.openxmlformats.org/drawingml/2006/main">
               <a:ext uri="{FF2B5EF4-FFF2-40B4-BE49-F238E27FC236}">
-                <a16:creationId xmlns:a16="http://schemas.microsoft.com/office/drawing/2014/main" id="{7CB359B6-55AA-467E-A1E0-849449F2DDA2}"/>
+                <a16:creationId xmlns:a16="http://schemas.microsoft.com/office/drawing/2014/main" id="{E5E9AA49-6774-4A29-BD91-8DE661F42AB5}"/>
               </a:ext>
             </a:extLst>
           </p:cNvPr>
@@ -6024,7 +6024,7 @@
           <p:cNvPr id="9" name="">
             <a:extLst xmlns:a="http://schemas.openxmlformats.org/drawingml/2006/main">
               <a:ext uri="{FF2B5EF4-FFF2-40B4-BE49-F238E27FC236}">
-                <a16:creationId xmlns:a16="http://schemas.microsoft.com/office/drawing/2014/main" id="{35525060-F203-465B-804A-C4F0859369D1}"/>
+                <a16:creationId xmlns:a16="http://schemas.microsoft.com/office/drawing/2014/main" id="{CE60655F-0101-403F-A8D6-EF15C102A39B}"/>
               </a:ext>
             </a:extLst>
           </p:cNvPr>
@@ -6160,7 +6160,7 @@
           <p:cNvPr id="10" name="">
             <a:extLst xmlns:a="http://schemas.openxmlformats.org/drawingml/2006/main">
               <a:ext uri="{FF2B5EF4-FFF2-40B4-BE49-F238E27FC236}">
-                <a16:creationId xmlns:a16="http://schemas.microsoft.com/office/drawing/2014/main" id="{E2A8BDE7-EB9F-484E-B8C4-5C7DD6286A49}"/>
+                <a16:creationId xmlns:a16="http://schemas.microsoft.com/office/drawing/2014/main" id="{B15903F5-2A8A-4308-970B-47D068AE0062}"/>
               </a:ext>
             </a:extLst>
           </p:cNvPr>
@@ -6193,7 +6193,7 @@
           <p:cNvPr id="11" name="">
             <a:extLst xmlns:a="http://schemas.openxmlformats.org/drawingml/2006/main">
               <a:ext uri="{FF2B5EF4-FFF2-40B4-BE49-F238E27FC236}">
-                <a16:creationId xmlns:a16="http://schemas.microsoft.com/office/drawing/2014/main" id="{EEE638D8-CD51-41FA-B258-DD582E92B9C7}"/>
+                <a16:creationId xmlns:a16="http://schemas.microsoft.com/office/drawing/2014/main" id="{F350C39F-073E-4E2F-A346-00DABCFD49E3}"/>
               </a:ext>
             </a:extLst>
           </p:cNvPr>
@@ -6260,7 +6260,7 @@
           <p:cNvPr id="12" name="">
             <a:extLst xmlns:a="http://schemas.openxmlformats.org/drawingml/2006/main">
               <a:ext uri="{FF2B5EF4-FFF2-40B4-BE49-F238E27FC236}">
-                <a16:creationId xmlns:a16="http://schemas.microsoft.com/office/drawing/2014/main" id="{BC9D344B-EE5B-4FE6-961D-BBCE8E8F592F}"/>
+                <a16:creationId xmlns:a16="http://schemas.microsoft.com/office/drawing/2014/main" id="{6D3FCBDD-6038-45D5-B44F-57237FA3A733}"/>
               </a:ext>
             </a:extLst>
           </p:cNvPr>
@@ -6386,7 +6386,7 @@
                 <a:ea typeface="Aptos"/>
                 <a:cs typeface="Aptos"/>
               </a:rPr>
-              <a:t>Apply the configured audience</a:t>
+              <a:t>Members-only portal audience</a:t>
             </a:r>
           </a:p>
         </p:txBody>
@@ -6396,7 +6396,7 @@
           <p:cNvPr id="13" name="">
             <a:extLst xmlns:a="http://schemas.openxmlformats.org/drawingml/2006/main">
               <a:ext uri="{FF2B5EF4-FFF2-40B4-BE49-F238E27FC236}">
-                <a16:creationId xmlns:a16="http://schemas.microsoft.com/office/drawing/2014/main" id="{39675A13-9C7C-400A-9B51-0C8CE7965117}"/>
+                <a16:creationId xmlns:a16="http://schemas.microsoft.com/office/drawing/2014/main" id="{8282538B-46DC-42D3-B244-7DA2210A5DD9}"/>
               </a:ext>
             </a:extLst>
           </p:cNvPr>
@@ -6429,7 +6429,7 @@
           <p:cNvPr id="14" name="">
             <a:extLst xmlns:a="http://schemas.openxmlformats.org/drawingml/2006/main">
               <a:ext uri="{FF2B5EF4-FFF2-40B4-BE49-F238E27FC236}">
-                <a16:creationId xmlns:a16="http://schemas.microsoft.com/office/drawing/2014/main" id="{36561293-C6F2-470F-85CC-5CE76B44E89D}"/>
+                <a16:creationId xmlns:a16="http://schemas.microsoft.com/office/drawing/2014/main" id="{58F4BB8A-2ED4-478B-9549-54A23EF0C3DB}"/>
               </a:ext>
             </a:extLst>
           </p:cNvPr>
@@ -6496,7 +6496,7 @@
           <p:cNvPr id="15" name="">
             <a:extLst xmlns:a="http://schemas.openxmlformats.org/drawingml/2006/main">
               <a:ext uri="{FF2B5EF4-FFF2-40B4-BE49-F238E27FC236}">
-                <a16:creationId xmlns:a16="http://schemas.microsoft.com/office/drawing/2014/main" id="{E03254B7-D753-4857-8759-D4058038D82C}"/>
+                <a16:creationId xmlns:a16="http://schemas.microsoft.com/office/drawing/2014/main" id="{BB583532-EE44-401B-8727-3EF4856F4BC7}"/>
               </a:ext>
             </a:extLst>
           </p:cNvPr>
@@ -6632,7 +6632,7 @@
           <p:cNvPr id="16" name="">
             <a:extLst xmlns:a="http://schemas.openxmlformats.org/drawingml/2006/main">
               <a:ext uri="{FF2B5EF4-FFF2-40B4-BE49-F238E27FC236}">
-                <a16:creationId xmlns:a16="http://schemas.microsoft.com/office/drawing/2014/main" id="{49CF7F52-762A-48D1-B7F9-0D46C2049BF9}"/>
+                <a16:creationId xmlns:a16="http://schemas.microsoft.com/office/drawing/2014/main" id="{E2CADAA6-478D-4D2E-8BAF-DD6A233295B7}"/>
               </a:ext>
             </a:extLst>
           </p:cNvPr>
@@ -6697,7 +6697,7 @@
     </p:spTree>
     <p:extLst>
       <p:ext uri="{BB962C8B-B14F-4D97-AF65-F5344CB8AC3E}">
-        <p14:creationId xmlns:p14="http://schemas.microsoft.com/office/powerpoint/2010/main" val="324729755"/>
+        <p14:creationId xmlns:p14="http://schemas.microsoft.com/office/powerpoint/2010/main" val="1158979162"/>
       </p:ext>
     </p:extLst>
   </p:cSld>
@@ -6728,7 +6728,7 @@
           <p:cNvPr id="17" name="">
             <a:extLst xmlns:a="http://schemas.openxmlformats.org/drawingml/2006/main">
               <a:ext uri="{FF2B5EF4-FFF2-40B4-BE49-F238E27FC236}">
-                <a16:creationId xmlns:a16="http://schemas.microsoft.com/office/drawing/2014/main" id="{01DC6921-6E3D-49C1-B77F-EBE2BB3AFB24}"/>
+                <a16:creationId xmlns:a16="http://schemas.microsoft.com/office/drawing/2014/main" id="{D2FC2F97-06D6-487E-9E98-F0CF5DE466C2}"/>
               </a:ext>
             </a:extLst>
           </p:cNvPr>
@@ -6795,7 +6795,7 @@
           <p:cNvPr id="2" name="">
             <a:extLst xmlns:a="http://schemas.openxmlformats.org/drawingml/2006/main">
               <a:ext uri="{FF2B5EF4-FFF2-40B4-BE49-F238E27FC236}">
-                <a16:creationId xmlns:a16="http://schemas.microsoft.com/office/drawing/2014/main" id="{5DE53B3B-1E11-495E-98FC-DE65910F8C64}"/>
+                <a16:creationId xmlns:a16="http://schemas.microsoft.com/office/drawing/2014/main" id="{83419D17-B4D7-4165-9735-337C01851BCC}"/>
               </a:ext>
             </a:extLst>
           </p:cNvPr>
@@ -6862,7 +6862,7 @@
           <p:cNvPr id="3" name="">
             <a:extLst xmlns:a="http://schemas.openxmlformats.org/drawingml/2006/main">
               <a:ext uri="{FF2B5EF4-FFF2-40B4-BE49-F238E27FC236}">
-                <a16:creationId xmlns:a16="http://schemas.microsoft.com/office/drawing/2014/main" id="{59C4734B-514E-419D-B2F6-3847209B9083}"/>
+                <a16:creationId xmlns:a16="http://schemas.microsoft.com/office/drawing/2014/main" id="{72A1FB3E-EF37-4DB3-804E-05DC48017ACD}"/>
               </a:ext>
             </a:extLst>
           </p:cNvPr>
@@ -6929,7 +6929,7 @@
           <p:cNvPr id="4" name="">
             <a:extLst xmlns:a="http://schemas.openxmlformats.org/drawingml/2006/main">
               <a:ext uri="{FF2B5EF4-FFF2-40B4-BE49-F238E27FC236}">
-                <a16:creationId xmlns:a16="http://schemas.microsoft.com/office/drawing/2014/main" id="{4513E10F-7FD3-4729-9EE8-9302C9B66AFA}"/>
+                <a16:creationId xmlns:a16="http://schemas.microsoft.com/office/drawing/2014/main" id="{95640057-32A9-4CDE-8CAF-9C8508E5D491}"/>
               </a:ext>
             </a:extLst>
           </p:cNvPr>
@@ -6960,7 +6960,7 @@
           <p:cNvPr id="5" name="">
             <a:extLst xmlns:a="http://schemas.openxmlformats.org/drawingml/2006/main">
               <a:ext uri="{FF2B5EF4-FFF2-40B4-BE49-F238E27FC236}">
-                <a16:creationId xmlns:a16="http://schemas.microsoft.com/office/drawing/2014/main" id="{03124CB6-7559-4A83-AB54-CCD1EA6215AC}"/>
+                <a16:creationId xmlns:a16="http://schemas.microsoft.com/office/drawing/2014/main" id="{79569B78-35F0-466D-8891-22D1A755C95F}"/>
               </a:ext>
             </a:extLst>
           </p:cNvPr>
@@ -7017,7 +7017,7 @@
                 <a:ea typeface="Aptos"/>
                 <a:cs typeface="Aptos"/>
               </a:rPr>
-              <a:t>INERTIA-2026-10-23-r7 · 23 October 2026 · Autonomous build</a:t>
+              <a:t>INERTIA-2026-10-23-r8 · 23 October 2026 · Autonomous build</a:t>
             </a:r>
           </a:p>
         </p:txBody>
@@ -7027,7 +7027,7 @@
           <p:cNvPr id="6" name="">
             <a:extLst xmlns:a="http://schemas.openxmlformats.org/drawingml/2006/main">
               <a:ext uri="{FF2B5EF4-FFF2-40B4-BE49-F238E27FC236}">
-                <a16:creationId xmlns:a16="http://schemas.microsoft.com/office/drawing/2014/main" id="{9F55A98B-27B7-4926-82D6-0B633EC78C76}"/>
+                <a16:creationId xmlns:a16="http://schemas.microsoft.com/office/drawing/2014/main" id="{7DED4A85-CE34-4979-B183-F73E644DBC85}"/>
               </a:ext>
             </a:extLst>
           </p:cNvPr>
@@ -7094,7 +7094,7 @@
           <p:cNvPr id="7" name="">
             <a:extLst xmlns:a="http://schemas.openxmlformats.org/drawingml/2006/main">
               <a:ext uri="{FF2B5EF4-FFF2-40B4-BE49-F238E27FC236}">
-                <a16:creationId xmlns:a16="http://schemas.microsoft.com/office/drawing/2014/main" id="{C989028D-C5A1-44AC-98B9-F522566AB8F3}"/>
+                <a16:creationId xmlns:a16="http://schemas.microsoft.com/office/drawing/2014/main" id="{5B640562-795E-408A-B585-4034E91F00FD}"/>
               </a:ext>
             </a:extLst>
           </p:cNvPr>
@@ -7127,7 +7127,7 @@
           <p:cNvPr id="8" name="">
             <a:extLst xmlns:a="http://schemas.openxmlformats.org/drawingml/2006/main">
               <a:ext uri="{FF2B5EF4-FFF2-40B4-BE49-F238E27FC236}">
-                <a16:creationId xmlns:a16="http://schemas.microsoft.com/office/drawing/2014/main" id="{06929054-E808-44A2-BA67-FD4F1878760E}"/>
+                <a16:creationId xmlns:a16="http://schemas.microsoft.com/office/drawing/2014/main" id="{156F1506-26F9-4B61-BAEC-7F29B4E414FF}"/>
               </a:ext>
             </a:extLst>
           </p:cNvPr>
@@ -7194,7 +7194,7 @@
           <p:cNvPr id="9" name="">
             <a:extLst xmlns:a="http://schemas.openxmlformats.org/drawingml/2006/main">
               <a:ext uri="{FF2B5EF4-FFF2-40B4-BE49-F238E27FC236}">
-                <a16:creationId xmlns:a16="http://schemas.microsoft.com/office/drawing/2014/main" id="{99361BDF-B9DB-47A2-BDBE-C6CBEC1C22C3}"/>
+                <a16:creationId xmlns:a16="http://schemas.microsoft.com/office/drawing/2014/main" id="{FACA406C-30FA-4F89-B70B-44F16C2ECC0D}"/>
               </a:ext>
             </a:extLst>
           </p:cNvPr>
@@ -7274,7 +7274,7 @@
                 <a:ea typeface="Aptos"/>
                 <a:cs typeface="Aptos"/>
               </a:rPr>
-              <a:t>Check deadline and eligibility</a:t>
+              <a:t>Retrieve authorized DAO facts</a:t>
             </a:r>
           </a:p>
           <a:p xmlns:a="http://schemas.openxmlformats.org/drawingml/2006/main">
@@ -7297,7 +7297,7 @@
                 <a:ea typeface="Aptos"/>
                 <a:cs typeface="Aptos"/>
               </a:rPr>
-              <a:t>Build a cited draft packet</a:t>
+              <a:t>Build a cited, eligible packet</a:t>
             </a:r>
           </a:p>
           <a:p xmlns:a="http://schemas.openxmlformats.org/drawingml/2006/main">
@@ -7330,7 +7330,7 @@
           <p:cNvPr id="10" name="">
             <a:extLst xmlns:a="http://schemas.openxmlformats.org/drawingml/2006/main">
               <a:ext uri="{FF2B5EF4-FFF2-40B4-BE49-F238E27FC236}">
-                <a16:creationId xmlns:a16="http://schemas.microsoft.com/office/drawing/2014/main" id="{B14E1725-29FC-492E-9F4D-3E5CEFAE2B58}"/>
+                <a16:creationId xmlns:a16="http://schemas.microsoft.com/office/drawing/2014/main" id="{7A0059C5-02AF-48DA-A26B-D94D0E9553F5}"/>
               </a:ext>
             </a:extLst>
           </p:cNvPr>
@@ -7363,7 +7363,7 @@
           <p:cNvPr id="11" name="">
             <a:extLst xmlns:a="http://schemas.openxmlformats.org/drawingml/2006/main">
               <a:ext uri="{FF2B5EF4-FFF2-40B4-BE49-F238E27FC236}">
-                <a16:creationId xmlns:a16="http://schemas.microsoft.com/office/drawing/2014/main" id="{F5B617B6-2AAB-454B-933E-8788E506B26A}"/>
+                <a16:creationId xmlns:a16="http://schemas.microsoft.com/office/drawing/2014/main" id="{90A4E9AD-D135-4F46-9AF3-15DE6FE12506}"/>
               </a:ext>
             </a:extLst>
           </p:cNvPr>
@@ -7430,7 +7430,7 @@
           <p:cNvPr id="12" name="">
             <a:extLst xmlns:a="http://schemas.openxmlformats.org/drawingml/2006/main">
               <a:ext uri="{FF2B5EF4-FFF2-40B4-BE49-F238E27FC236}">
-                <a16:creationId xmlns:a16="http://schemas.microsoft.com/office/drawing/2014/main" id="{E7680E9C-7E60-44E0-8F0F-585CC9AE416D}"/>
+                <a16:creationId xmlns:a16="http://schemas.microsoft.com/office/drawing/2014/main" id="{1E8635C9-7055-41C5-BADD-A2E8D6EAB3F9}"/>
               </a:ext>
             </a:extLst>
           </p:cNvPr>
@@ -7510,7 +7510,7 @@
                 <a:ea typeface="Aptos"/>
                 <a:cs typeface="Aptos"/>
               </a:rPr>
-              <a:t>Verify network and finality</a:t>
+              <a:t>Verify required voting stages</a:t>
             </a:r>
           </a:p>
           <a:p xmlns:a="http://schemas.openxmlformats.org/drawingml/2006/main">
@@ -7533,7 +7533,7 @@
                 <a:ea typeface="Aptos"/>
                 <a:cs typeface="Aptos"/>
               </a:rPr>
-              <a:t>Match the authorized action</a:t>
+              <a:t>Match network and authorized action</a:t>
             </a:r>
           </a:p>
           <a:p xmlns:a="http://schemas.openxmlformats.org/drawingml/2006/main">
@@ -7566,7 +7566,7 @@
           <p:cNvPr id="13" name="">
             <a:extLst xmlns:a="http://schemas.openxmlformats.org/drawingml/2006/main">
               <a:ext uri="{FF2B5EF4-FFF2-40B4-BE49-F238E27FC236}">
-                <a16:creationId xmlns:a16="http://schemas.microsoft.com/office/drawing/2014/main" id="{442DE98C-7B7F-4898-B100-6BF8B9074F78}"/>
+                <a16:creationId xmlns:a16="http://schemas.microsoft.com/office/drawing/2014/main" id="{7AA7BC55-6800-4838-BD72-2B0EF7E19323}"/>
               </a:ext>
             </a:extLst>
           </p:cNvPr>
@@ -7599,7 +7599,7 @@
           <p:cNvPr id="14" name="">
             <a:extLst xmlns:a="http://schemas.openxmlformats.org/drawingml/2006/main">
               <a:ext uri="{FF2B5EF4-FFF2-40B4-BE49-F238E27FC236}">
-                <a16:creationId xmlns:a16="http://schemas.microsoft.com/office/drawing/2014/main" id="{100CDD26-91C4-46B0-9C01-515EB159A4CC}"/>
+                <a16:creationId xmlns:a16="http://schemas.microsoft.com/office/drawing/2014/main" id="{13749A35-8A2C-4117-BB77-20908F30A127}"/>
               </a:ext>
             </a:extLst>
           </p:cNvPr>
@@ -7666,7 +7666,7 @@
           <p:cNvPr id="15" name="">
             <a:extLst xmlns:a="http://schemas.openxmlformats.org/drawingml/2006/main">
               <a:ext uri="{FF2B5EF4-FFF2-40B4-BE49-F238E27FC236}">
-                <a16:creationId xmlns:a16="http://schemas.microsoft.com/office/drawing/2014/main" id="{D0D245FA-627E-4331-B5DF-B8E13DC0CD8A}"/>
+                <a16:creationId xmlns:a16="http://schemas.microsoft.com/office/drawing/2014/main" id="{0BC1D98C-E8B9-4AB4-9738-AB7F2445E98B}"/>
               </a:ext>
             </a:extLst>
           </p:cNvPr>
@@ -7802,7 +7802,7 @@
           <p:cNvPr id="16" name="">
             <a:extLst xmlns:a="http://schemas.openxmlformats.org/drawingml/2006/main">
               <a:ext uri="{FF2B5EF4-FFF2-40B4-BE49-F238E27FC236}">
-                <a16:creationId xmlns:a16="http://schemas.microsoft.com/office/drawing/2014/main" id="{8C918133-2949-4E57-B0E4-632E9309C7C9}"/>
+                <a16:creationId xmlns:a16="http://schemas.microsoft.com/office/drawing/2014/main" id="{CD148134-573F-4265-A64F-F71B77D3F8E6}"/>
               </a:ext>
             </a:extLst>
           </p:cNvPr>
@@ -7867,7 +7867,7 @@
     </p:spTree>
     <p:extLst>
       <p:ext uri="{BB962C8B-B14F-4D97-AF65-F5344CB8AC3E}">
-        <p14:creationId xmlns:p14="http://schemas.microsoft.com/office/powerpoint/2010/main" val="321599319"/>
+        <p14:creationId xmlns:p14="http://schemas.microsoft.com/office/powerpoint/2010/main" val="1111305753"/>
       </p:ext>
     </p:extLst>
   </p:cSld>
@@ -7898,7 +7898,7 @@
           <p:cNvPr id="17" name="">
             <a:extLst xmlns:a="http://schemas.openxmlformats.org/drawingml/2006/main">
               <a:ext uri="{FF2B5EF4-FFF2-40B4-BE49-F238E27FC236}">
-                <a16:creationId xmlns:a16="http://schemas.microsoft.com/office/drawing/2014/main" id="{ED2DC141-D254-4DE5-BD71-76EF407D31E2}"/>
+                <a16:creationId xmlns:a16="http://schemas.microsoft.com/office/drawing/2014/main" id="{7C7ACC79-1CF0-4DC2-8EC7-411BBF6B5B22}"/>
               </a:ext>
             </a:extLst>
           </p:cNvPr>
@@ -7965,7 +7965,7 @@
           <p:cNvPr id="2" name="">
             <a:extLst xmlns:a="http://schemas.openxmlformats.org/drawingml/2006/main">
               <a:ext uri="{FF2B5EF4-FFF2-40B4-BE49-F238E27FC236}">
-                <a16:creationId xmlns:a16="http://schemas.microsoft.com/office/drawing/2014/main" id="{D9D038F5-85DB-4E70-BD88-0E1621BEE5A8}"/>
+                <a16:creationId xmlns:a16="http://schemas.microsoft.com/office/drawing/2014/main" id="{C2E15DEA-F77A-4650-9924-2883B31F64E1}"/>
               </a:ext>
             </a:extLst>
           </p:cNvPr>
@@ -8032,7 +8032,7 @@
           <p:cNvPr id="3" name="">
             <a:extLst xmlns:a="http://schemas.openxmlformats.org/drawingml/2006/main">
               <a:ext uri="{FF2B5EF4-FFF2-40B4-BE49-F238E27FC236}">
-                <a16:creationId xmlns:a16="http://schemas.microsoft.com/office/drawing/2014/main" id="{BC184259-C62C-402F-B013-77FA9FEE6B7B}"/>
+                <a16:creationId xmlns:a16="http://schemas.microsoft.com/office/drawing/2014/main" id="{E3AD4525-7F46-4FAF-B3E9-449D65752DE1}"/>
               </a:ext>
             </a:extLst>
           </p:cNvPr>
@@ -8099,7 +8099,7 @@
           <p:cNvPr id="4" name="">
             <a:extLst xmlns:a="http://schemas.openxmlformats.org/drawingml/2006/main">
               <a:ext uri="{FF2B5EF4-FFF2-40B4-BE49-F238E27FC236}">
-                <a16:creationId xmlns:a16="http://schemas.microsoft.com/office/drawing/2014/main" id="{F990F645-E639-4397-8E4F-03F21AAC0720}"/>
+                <a16:creationId xmlns:a16="http://schemas.microsoft.com/office/drawing/2014/main" id="{961761AB-B452-4F84-99B9-FF1857A2655F}"/>
               </a:ext>
             </a:extLst>
           </p:cNvPr>
@@ -8130,7 +8130,7 @@
           <p:cNvPr id="5" name="">
             <a:extLst xmlns:a="http://schemas.openxmlformats.org/drawingml/2006/main">
               <a:ext uri="{FF2B5EF4-FFF2-40B4-BE49-F238E27FC236}">
-                <a16:creationId xmlns:a16="http://schemas.microsoft.com/office/drawing/2014/main" id="{2CC7AEBB-DCFB-45C7-85E3-8FD384A7CDFF}"/>
+                <a16:creationId xmlns:a16="http://schemas.microsoft.com/office/drawing/2014/main" id="{9AD01EC8-DCAD-4BA4-9CBC-6E48A58F990D}"/>
               </a:ext>
             </a:extLst>
           </p:cNvPr>
@@ -8187,7 +8187,7 @@
                 <a:ea typeface="Aptos"/>
                 <a:cs typeface="Aptos"/>
               </a:rPr>
-              <a:t>INERTIA-2026-10-23-r7 · 23 October 2026 · Autonomous build</a:t>
+              <a:t>INERTIA-2026-10-23-r8 · 23 October 2026 · Autonomous build</a:t>
             </a:r>
           </a:p>
         </p:txBody>
@@ -8197,7 +8197,7 @@
           <p:cNvPr id="6" name="">
             <a:extLst xmlns:a="http://schemas.openxmlformats.org/drawingml/2006/main">
               <a:ext uri="{FF2B5EF4-FFF2-40B4-BE49-F238E27FC236}">
-                <a16:creationId xmlns:a16="http://schemas.microsoft.com/office/drawing/2014/main" id="{BB1CBF1F-B28A-49CC-8A5C-0435571F040E}"/>
+                <a16:creationId xmlns:a16="http://schemas.microsoft.com/office/drawing/2014/main" id="{B13C95D2-C3B8-48D0-BE0C-145062C685E8}"/>
               </a:ext>
             </a:extLst>
           </p:cNvPr>
@@ -8264,7 +8264,7 @@
           <p:cNvPr id="7" name="">
             <a:extLst xmlns:a="http://schemas.openxmlformats.org/drawingml/2006/main">
               <a:ext uri="{FF2B5EF4-FFF2-40B4-BE49-F238E27FC236}">
-                <a16:creationId xmlns:a16="http://schemas.microsoft.com/office/drawing/2014/main" id="{E3486E29-1A85-4932-A63A-EF2E664E9016}"/>
+                <a16:creationId xmlns:a16="http://schemas.microsoft.com/office/drawing/2014/main" id="{49CC084F-3B85-481C-B48F-47A4B8C7D756}"/>
               </a:ext>
             </a:extLst>
           </p:cNvPr>
@@ -8297,7 +8297,7 @@
           <p:cNvPr id="8" name="">
             <a:extLst xmlns:a="http://schemas.openxmlformats.org/drawingml/2006/main">
               <a:ext uri="{FF2B5EF4-FFF2-40B4-BE49-F238E27FC236}">
-                <a16:creationId xmlns:a16="http://schemas.microsoft.com/office/drawing/2014/main" id="{BD91FFC3-388A-4CC5-AC05-690B1E24E1BE}"/>
+                <a16:creationId xmlns:a16="http://schemas.microsoft.com/office/drawing/2014/main" id="{B12F790B-66E3-4E62-B9F3-06E9A3503C64}"/>
               </a:ext>
             </a:extLst>
           </p:cNvPr>
@@ -8364,7 +8364,7 @@
           <p:cNvPr id="9" name="">
             <a:extLst xmlns:a="http://schemas.openxmlformats.org/drawingml/2006/main">
               <a:ext uri="{FF2B5EF4-FFF2-40B4-BE49-F238E27FC236}">
-                <a16:creationId xmlns:a16="http://schemas.microsoft.com/office/drawing/2014/main" id="{1D9C9603-C241-411B-AEE8-D90AB526881E}"/>
+                <a16:creationId xmlns:a16="http://schemas.microsoft.com/office/drawing/2014/main" id="{51A0B6D1-D035-46C2-A880-79420D738FB7}"/>
               </a:ext>
             </a:extLst>
           </p:cNvPr>
@@ -8500,7 +8500,7 @@
           <p:cNvPr id="10" name="">
             <a:extLst xmlns:a="http://schemas.openxmlformats.org/drawingml/2006/main">
               <a:ext uri="{FF2B5EF4-FFF2-40B4-BE49-F238E27FC236}">
-                <a16:creationId xmlns:a16="http://schemas.microsoft.com/office/drawing/2014/main" id="{B450DD4D-0C59-4A75-BA62-4B2317A1EC59}"/>
+                <a16:creationId xmlns:a16="http://schemas.microsoft.com/office/drawing/2014/main" id="{D2DE4B1B-1FD3-4A84-B7EF-946213685FE6}"/>
               </a:ext>
             </a:extLst>
           </p:cNvPr>
@@ -8533,7 +8533,7 @@
           <p:cNvPr id="11" name="">
             <a:extLst xmlns:a="http://schemas.openxmlformats.org/drawingml/2006/main">
               <a:ext uri="{FF2B5EF4-FFF2-40B4-BE49-F238E27FC236}">
-                <a16:creationId xmlns:a16="http://schemas.microsoft.com/office/drawing/2014/main" id="{47920630-DC1C-44FD-A160-DA26F896F7DF}"/>
+                <a16:creationId xmlns:a16="http://schemas.microsoft.com/office/drawing/2014/main" id="{C171444B-85E9-4BEC-847B-00DBA1A4B409}"/>
               </a:ext>
             </a:extLst>
           </p:cNvPr>
@@ -8600,7 +8600,7 @@
           <p:cNvPr id="12" name="">
             <a:extLst xmlns:a="http://schemas.openxmlformats.org/drawingml/2006/main">
               <a:ext uri="{FF2B5EF4-FFF2-40B4-BE49-F238E27FC236}">
-                <a16:creationId xmlns:a16="http://schemas.microsoft.com/office/drawing/2014/main" id="{7BB76621-66CA-4E7C-8B68-2BBADF10107C}"/>
+                <a16:creationId xmlns:a16="http://schemas.microsoft.com/office/drawing/2014/main" id="{ED3381AD-2A38-4B60-A263-259FC78BE451}"/>
               </a:ext>
             </a:extLst>
           </p:cNvPr>
@@ -8736,7 +8736,7 @@
           <p:cNvPr id="13" name="">
             <a:extLst xmlns:a="http://schemas.openxmlformats.org/drawingml/2006/main">
               <a:ext uri="{FF2B5EF4-FFF2-40B4-BE49-F238E27FC236}">
-                <a16:creationId xmlns:a16="http://schemas.microsoft.com/office/drawing/2014/main" id="{7537C6E8-5FDC-4695-A315-C5F042ABBD8B}"/>
+                <a16:creationId xmlns:a16="http://schemas.microsoft.com/office/drawing/2014/main" id="{2FE5E843-8E02-486A-B4AF-0BDD3BF57AFC}"/>
               </a:ext>
             </a:extLst>
           </p:cNvPr>
@@ -8769,7 +8769,7 @@
           <p:cNvPr id="14" name="">
             <a:extLst xmlns:a="http://schemas.openxmlformats.org/drawingml/2006/main">
               <a:ext uri="{FF2B5EF4-FFF2-40B4-BE49-F238E27FC236}">
-                <a16:creationId xmlns:a16="http://schemas.microsoft.com/office/drawing/2014/main" id="{99B727E6-9693-45B3-A114-23FF70516691}"/>
+                <a16:creationId xmlns:a16="http://schemas.microsoft.com/office/drawing/2014/main" id="{E6FBA71D-F0FD-4F35-9841-0EA6CD066D19}"/>
               </a:ext>
             </a:extLst>
           </p:cNvPr>
@@ -8836,7 +8836,7 @@
           <p:cNvPr id="15" name="">
             <a:extLst xmlns:a="http://schemas.openxmlformats.org/drawingml/2006/main">
               <a:ext uri="{FF2B5EF4-FFF2-40B4-BE49-F238E27FC236}">
-                <a16:creationId xmlns:a16="http://schemas.microsoft.com/office/drawing/2014/main" id="{CA1D98ED-45D6-476F-A6A0-17312C98205F}"/>
+                <a16:creationId xmlns:a16="http://schemas.microsoft.com/office/drawing/2014/main" id="{7253CC27-0E99-44C1-99B0-733914F5B148}"/>
               </a:ext>
             </a:extLst>
           </p:cNvPr>
@@ -8972,7 +8972,7 @@
           <p:cNvPr id="16" name="">
             <a:extLst xmlns:a="http://schemas.openxmlformats.org/drawingml/2006/main">
               <a:ext uri="{FF2B5EF4-FFF2-40B4-BE49-F238E27FC236}">
-                <a16:creationId xmlns:a16="http://schemas.microsoft.com/office/drawing/2014/main" id="{7C3EEFB9-D08E-4A71-8ACE-A5F9A402742C}"/>
+                <a16:creationId xmlns:a16="http://schemas.microsoft.com/office/drawing/2014/main" id="{A9ED2172-14D0-455D-A2D3-AF963514CDB2}"/>
               </a:ext>
             </a:extLst>
           </p:cNvPr>
@@ -9037,7 +9037,7 @@
     </p:spTree>
     <p:extLst>
       <p:ext uri="{BB962C8B-B14F-4D97-AF65-F5344CB8AC3E}">
-        <p14:creationId xmlns:p14="http://schemas.microsoft.com/office/powerpoint/2010/main" val="2123739644"/>
+        <p14:creationId xmlns:p14="http://schemas.microsoft.com/office/powerpoint/2010/main" val="204132117"/>
       </p:ext>
     </p:extLst>
   </p:cSld>
@@ -9068,7 +9068,7 @@
           <p:cNvPr id="17" name="">
             <a:extLst xmlns:a="http://schemas.openxmlformats.org/drawingml/2006/main">
               <a:ext uri="{FF2B5EF4-FFF2-40B4-BE49-F238E27FC236}">
-                <a16:creationId xmlns:a16="http://schemas.microsoft.com/office/drawing/2014/main" id="{B3B4703C-6380-4DB5-9C85-7BF843F514F7}"/>
+                <a16:creationId xmlns:a16="http://schemas.microsoft.com/office/drawing/2014/main" id="{4ECA6908-0C5F-494D-8E37-4F50D6B7F590}"/>
               </a:ext>
             </a:extLst>
           </p:cNvPr>
@@ -9135,7 +9135,7 @@
           <p:cNvPr id="2" name="">
             <a:extLst xmlns:a="http://schemas.openxmlformats.org/drawingml/2006/main">
               <a:ext uri="{FF2B5EF4-FFF2-40B4-BE49-F238E27FC236}">
-                <a16:creationId xmlns:a16="http://schemas.microsoft.com/office/drawing/2014/main" id="{A471F36B-5B6B-47F9-A74C-9F87BE678B7C}"/>
+                <a16:creationId xmlns:a16="http://schemas.microsoft.com/office/drawing/2014/main" id="{DA08906D-7451-4BA2-8EE7-1AFFD273B74B}"/>
               </a:ext>
             </a:extLst>
           </p:cNvPr>
@@ -9202,7 +9202,7 @@
           <p:cNvPr id="3" name="">
             <a:extLst xmlns:a="http://schemas.openxmlformats.org/drawingml/2006/main">
               <a:ext uri="{FF2B5EF4-FFF2-40B4-BE49-F238E27FC236}">
-                <a16:creationId xmlns:a16="http://schemas.microsoft.com/office/drawing/2014/main" id="{9AF09CB2-CCE7-43D8-B3F9-7B85C37BBD84}"/>
+                <a16:creationId xmlns:a16="http://schemas.microsoft.com/office/drawing/2014/main" id="{098446B2-A9A7-4DB0-BFFB-B219131CE2FC}"/>
               </a:ext>
             </a:extLst>
           </p:cNvPr>
@@ -9269,7 +9269,7 @@
           <p:cNvPr id="4" name="">
             <a:extLst xmlns:a="http://schemas.openxmlformats.org/drawingml/2006/main">
               <a:ext uri="{FF2B5EF4-FFF2-40B4-BE49-F238E27FC236}">
-                <a16:creationId xmlns:a16="http://schemas.microsoft.com/office/drawing/2014/main" id="{CE780204-1B19-43AA-9A69-460FA2652455}"/>
+                <a16:creationId xmlns:a16="http://schemas.microsoft.com/office/drawing/2014/main" id="{B28AA077-B11C-4848-A968-11FA6A0A46D4}"/>
               </a:ext>
             </a:extLst>
           </p:cNvPr>
@@ -9300,7 +9300,7 @@
           <p:cNvPr id="5" name="">
             <a:extLst xmlns:a="http://schemas.openxmlformats.org/drawingml/2006/main">
               <a:ext uri="{FF2B5EF4-FFF2-40B4-BE49-F238E27FC236}">
-                <a16:creationId xmlns:a16="http://schemas.microsoft.com/office/drawing/2014/main" id="{0235216B-9D63-4B73-BB56-B68EBBBFACC0}"/>
+                <a16:creationId xmlns:a16="http://schemas.microsoft.com/office/drawing/2014/main" id="{8B927C7B-43DD-406E-998A-30B6075D238A}"/>
               </a:ext>
             </a:extLst>
           </p:cNvPr>
@@ -9357,7 +9357,7 @@
                 <a:ea typeface="Aptos"/>
                 <a:cs typeface="Aptos"/>
               </a:rPr>
-              <a:t>INERTIA-2026-10-23-r7 · 23 October 2026 · Autonomous build</a:t>
+              <a:t>INERTIA-2026-10-23-r8 · 23 October 2026 · Autonomous build</a:t>
             </a:r>
           </a:p>
         </p:txBody>
@@ -9367,7 +9367,7 @@
           <p:cNvPr id="6" name="">
             <a:extLst xmlns:a="http://schemas.openxmlformats.org/drawingml/2006/main">
               <a:ext uri="{FF2B5EF4-FFF2-40B4-BE49-F238E27FC236}">
-                <a16:creationId xmlns:a16="http://schemas.microsoft.com/office/drawing/2014/main" id="{1859E5AC-3CE7-4068-86F1-41FE801FCB43}"/>
+                <a16:creationId xmlns:a16="http://schemas.microsoft.com/office/drawing/2014/main" id="{5BB58851-73DB-4E6F-B57A-89EA103CF554}"/>
               </a:ext>
             </a:extLst>
           </p:cNvPr>
@@ -9434,7 +9434,7 @@
           <p:cNvPr id="7" name="">
             <a:extLst xmlns:a="http://schemas.openxmlformats.org/drawingml/2006/main">
               <a:ext uri="{FF2B5EF4-FFF2-40B4-BE49-F238E27FC236}">
-                <a16:creationId xmlns:a16="http://schemas.microsoft.com/office/drawing/2014/main" id="{D4C981A4-6F99-47F3-A096-2CD9D2DA7B57}"/>
+                <a16:creationId xmlns:a16="http://schemas.microsoft.com/office/drawing/2014/main" id="{55581CA9-0659-487C-A0A4-5EC597FA957D}"/>
               </a:ext>
             </a:extLst>
           </p:cNvPr>
@@ -9467,7 +9467,7 @@
           <p:cNvPr id="8" name="">
             <a:extLst xmlns:a="http://schemas.openxmlformats.org/drawingml/2006/main">
               <a:ext uri="{FF2B5EF4-FFF2-40B4-BE49-F238E27FC236}">
-                <a16:creationId xmlns:a16="http://schemas.microsoft.com/office/drawing/2014/main" id="{58CD9F90-2BB7-493A-A78A-12BBC740E41D}"/>
+                <a16:creationId xmlns:a16="http://schemas.microsoft.com/office/drawing/2014/main" id="{07AF1F00-7C90-4503-A9CE-9436544F8EE1}"/>
               </a:ext>
             </a:extLst>
           </p:cNvPr>
@@ -9534,7 +9534,7 @@
           <p:cNvPr id="9" name="">
             <a:extLst xmlns:a="http://schemas.openxmlformats.org/drawingml/2006/main">
               <a:ext uri="{FF2B5EF4-FFF2-40B4-BE49-F238E27FC236}">
-                <a16:creationId xmlns:a16="http://schemas.microsoft.com/office/drawing/2014/main" id="{EFF0F005-C273-4DA2-8A52-7200348FA2B3}"/>
+                <a16:creationId xmlns:a16="http://schemas.microsoft.com/office/drawing/2014/main" id="{D02F411D-1D3A-4868-8541-42DE864F4EB5}"/>
               </a:ext>
             </a:extLst>
           </p:cNvPr>
@@ -9670,7 +9670,7 @@
           <p:cNvPr id="10" name="">
             <a:extLst xmlns:a="http://schemas.openxmlformats.org/drawingml/2006/main">
               <a:ext uri="{FF2B5EF4-FFF2-40B4-BE49-F238E27FC236}">
-                <a16:creationId xmlns:a16="http://schemas.microsoft.com/office/drawing/2014/main" id="{2EE7951A-2B99-420A-925A-0F37A4D128AF}"/>
+                <a16:creationId xmlns:a16="http://schemas.microsoft.com/office/drawing/2014/main" id="{1DB3F7D5-698C-41DB-88E9-9FFE9FC45EAB}"/>
               </a:ext>
             </a:extLst>
           </p:cNvPr>
@@ -9703,7 +9703,7 @@
           <p:cNvPr id="11" name="">
             <a:extLst xmlns:a="http://schemas.openxmlformats.org/drawingml/2006/main">
               <a:ext uri="{FF2B5EF4-FFF2-40B4-BE49-F238E27FC236}">
-                <a16:creationId xmlns:a16="http://schemas.microsoft.com/office/drawing/2014/main" id="{9362A06D-DD7C-4EB7-993D-1C9F1C422298}"/>
+                <a16:creationId xmlns:a16="http://schemas.microsoft.com/office/drawing/2014/main" id="{052D0783-38CD-4CCA-8286-76246F4DFFD8}"/>
               </a:ext>
             </a:extLst>
           </p:cNvPr>
@@ -9770,7 +9770,7 @@
           <p:cNvPr id="12" name="">
             <a:extLst xmlns:a="http://schemas.openxmlformats.org/drawingml/2006/main">
               <a:ext uri="{FF2B5EF4-FFF2-40B4-BE49-F238E27FC236}">
-                <a16:creationId xmlns:a16="http://schemas.microsoft.com/office/drawing/2014/main" id="{5EDD8827-F4E9-4C22-B40E-FEF00E895B01}"/>
+                <a16:creationId xmlns:a16="http://schemas.microsoft.com/office/drawing/2014/main" id="{A271BE8C-5870-434A-8438-5F2B10EE9935}"/>
               </a:ext>
             </a:extLst>
           </p:cNvPr>
@@ -9906,7 +9906,7 @@
           <p:cNvPr id="13" name="">
             <a:extLst xmlns:a="http://schemas.openxmlformats.org/drawingml/2006/main">
               <a:ext uri="{FF2B5EF4-FFF2-40B4-BE49-F238E27FC236}">
-                <a16:creationId xmlns:a16="http://schemas.microsoft.com/office/drawing/2014/main" id="{ADE00A3D-7A7E-46BB-8400-3C94B843FD0C}"/>
+                <a16:creationId xmlns:a16="http://schemas.microsoft.com/office/drawing/2014/main" id="{B698E0E1-3059-4971-9916-4D45215F8DE8}"/>
               </a:ext>
             </a:extLst>
           </p:cNvPr>
@@ -9939,7 +9939,7 @@
           <p:cNvPr id="14" name="">
             <a:extLst xmlns:a="http://schemas.openxmlformats.org/drawingml/2006/main">
               <a:ext uri="{FF2B5EF4-FFF2-40B4-BE49-F238E27FC236}">
-                <a16:creationId xmlns:a16="http://schemas.microsoft.com/office/drawing/2014/main" id="{0C78BD01-8E6C-496A-86B1-8587DA887D68}"/>
+                <a16:creationId xmlns:a16="http://schemas.microsoft.com/office/drawing/2014/main" id="{319ECE07-EEBC-4DFC-A69B-280E4BD51502}"/>
               </a:ext>
             </a:extLst>
           </p:cNvPr>
@@ -10006,7 +10006,7 @@
           <p:cNvPr id="15" name="">
             <a:extLst xmlns:a="http://schemas.openxmlformats.org/drawingml/2006/main">
               <a:ext uri="{FF2B5EF4-FFF2-40B4-BE49-F238E27FC236}">
-                <a16:creationId xmlns:a16="http://schemas.microsoft.com/office/drawing/2014/main" id="{3F701368-6612-47BA-A09E-DF5B0B7294D9}"/>
+                <a16:creationId xmlns:a16="http://schemas.microsoft.com/office/drawing/2014/main" id="{1823D53F-79D7-4286-A48B-4D0F116BA8C8}"/>
               </a:ext>
             </a:extLst>
           </p:cNvPr>
@@ -10142,7 +10142,7 @@
           <p:cNvPr id="16" name="">
             <a:extLst xmlns:a="http://schemas.openxmlformats.org/drawingml/2006/main">
               <a:ext uri="{FF2B5EF4-FFF2-40B4-BE49-F238E27FC236}">
-                <a16:creationId xmlns:a16="http://schemas.microsoft.com/office/drawing/2014/main" id="{95F268FE-615B-4B0E-B778-926E0D57BA5B}"/>
+                <a16:creationId xmlns:a16="http://schemas.microsoft.com/office/drawing/2014/main" id="{AF4115EA-0035-4234-AB15-465CC631EDCE}"/>
               </a:ext>
             </a:extLst>
           </p:cNvPr>
@@ -10207,7 +10207,7 @@
     </p:spTree>
     <p:extLst>
       <p:ext uri="{BB962C8B-B14F-4D97-AF65-F5344CB8AC3E}">
-        <p14:creationId xmlns:p14="http://schemas.microsoft.com/office/powerpoint/2010/main" val="1265001805"/>
+        <p14:creationId xmlns:p14="http://schemas.microsoft.com/office/powerpoint/2010/main" val="1558554149"/>
       </p:ext>
     </p:extLst>
   </p:cSld>
@@ -10238,7 +10238,7 @@
           <p:cNvPr id="17" name="">
             <a:extLst xmlns:a="http://schemas.openxmlformats.org/drawingml/2006/main">
               <a:ext uri="{FF2B5EF4-FFF2-40B4-BE49-F238E27FC236}">
-                <a16:creationId xmlns:a16="http://schemas.microsoft.com/office/drawing/2014/main" id="{663A0F38-B73F-4B71-AD7B-292F0DFA67E0}"/>
+                <a16:creationId xmlns:a16="http://schemas.microsoft.com/office/drawing/2014/main" id="{6BDD18E3-0173-4FF7-BCD6-06267BFFE6C7}"/>
               </a:ext>
             </a:extLst>
           </p:cNvPr>
@@ -10305,7 +10305,7 @@
           <p:cNvPr id="2" name="">
             <a:extLst xmlns:a="http://schemas.openxmlformats.org/drawingml/2006/main">
               <a:ext uri="{FF2B5EF4-FFF2-40B4-BE49-F238E27FC236}">
-                <a16:creationId xmlns:a16="http://schemas.microsoft.com/office/drawing/2014/main" id="{5137B871-C8CB-4528-A968-63C3B3AE9E7B}"/>
+                <a16:creationId xmlns:a16="http://schemas.microsoft.com/office/drawing/2014/main" id="{8D1A63DD-2F71-459B-992C-9E6690BF480F}"/>
               </a:ext>
             </a:extLst>
           </p:cNvPr>
@@ -10372,7 +10372,7 @@
           <p:cNvPr id="3" name="">
             <a:extLst xmlns:a="http://schemas.openxmlformats.org/drawingml/2006/main">
               <a:ext uri="{FF2B5EF4-FFF2-40B4-BE49-F238E27FC236}">
-                <a16:creationId xmlns:a16="http://schemas.microsoft.com/office/drawing/2014/main" id="{EC123BF2-95A5-4DF3-8145-D32045B3FA84}"/>
+                <a16:creationId xmlns:a16="http://schemas.microsoft.com/office/drawing/2014/main" id="{CD835C1E-DAA9-47C2-B935-F934F1DDBCE5}"/>
               </a:ext>
             </a:extLst>
           </p:cNvPr>
@@ -10429,7 +10429,7 @@
                 <a:ea typeface="Aptos"/>
                 <a:cs typeface="Aptos"/>
               </a:rPr>
-              <a:t>Grant packet binding and installable-package qualification extend the connected loop.</a:t>
+              <a:t>A reproducible source-checkout rehearsal joins the meeting, signed bridge and grant cores.</a:t>
             </a:r>
           </a:p>
         </p:txBody>
@@ -10439,7 +10439,7 @@
           <p:cNvPr id="4" name="">
             <a:extLst xmlns:a="http://schemas.openxmlformats.org/drawingml/2006/main">
               <a:ext uri="{FF2B5EF4-FFF2-40B4-BE49-F238E27FC236}">
-                <a16:creationId xmlns:a16="http://schemas.microsoft.com/office/drawing/2014/main" id="{55F576AF-4BD2-4AA1-AF73-C9F378045DF9}"/>
+                <a16:creationId xmlns:a16="http://schemas.microsoft.com/office/drawing/2014/main" id="{665F0A8B-8314-43E1-91FA-C50D2A9A8B03}"/>
               </a:ext>
             </a:extLst>
           </p:cNvPr>
@@ -10470,7 +10470,7 @@
           <p:cNvPr id="5" name="">
             <a:extLst xmlns:a="http://schemas.openxmlformats.org/drawingml/2006/main">
               <a:ext uri="{FF2B5EF4-FFF2-40B4-BE49-F238E27FC236}">
-                <a16:creationId xmlns:a16="http://schemas.microsoft.com/office/drawing/2014/main" id="{25D9C22E-FC38-4A89-9D73-681B6C592327}"/>
+                <a16:creationId xmlns:a16="http://schemas.microsoft.com/office/drawing/2014/main" id="{9A8A72B1-7E56-4D2D-9548-FAE08A6D5101}"/>
               </a:ext>
             </a:extLst>
           </p:cNvPr>
@@ -10527,7 +10527,7 @@
                 <a:ea typeface="Aptos"/>
                 <a:cs typeface="Aptos"/>
               </a:rPr>
-              <a:t>INERTIA-2026-10-23-r7 · 23 October 2026 · Autonomous build</a:t>
+              <a:t>INERTIA-2026-10-23-r8 · 23 October 2026 · Autonomous build</a:t>
             </a:r>
           </a:p>
         </p:txBody>
@@ -10537,7 +10537,7 @@
           <p:cNvPr id="6" name="">
             <a:extLst xmlns:a="http://schemas.openxmlformats.org/drawingml/2006/main">
               <a:ext uri="{FF2B5EF4-FFF2-40B4-BE49-F238E27FC236}">
-                <a16:creationId xmlns:a16="http://schemas.microsoft.com/office/drawing/2014/main" id="{094CDB74-4903-4445-8C21-C7C714DC88AD}"/>
+                <a16:creationId xmlns:a16="http://schemas.microsoft.com/office/drawing/2014/main" id="{4908A80E-6E1B-410B-9609-16EB5C76AB3E}"/>
               </a:ext>
             </a:extLst>
           </p:cNvPr>
@@ -10604,7 +10604,7 @@
           <p:cNvPr id="7" name="">
             <a:extLst xmlns:a="http://schemas.openxmlformats.org/drawingml/2006/main">
               <a:ext uri="{FF2B5EF4-FFF2-40B4-BE49-F238E27FC236}">
-                <a16:creationId xmlns:a16="http://schemas.microsoft.com/office/drawing/2014/main" id="{29117874-9FF5-4915-8CA6-B7D4ABD8CE04}"/>
+                <a16:creationId xmlns:a16="http://schemas.microsoft.com/office/drawing/2014/main" id="{8D6C7F50-FC46-42A5-BB38-3798375425FF}"/>
               </a:ext>
             </a:extLst>
           </p:cNvPr>
@@ -10637,7 +10637,7 @@
           <p:cNvPr id="8" name="">
             <a:extLst xmlns:a="http://schemas.openxmlformats.org/drawingml/2006/main">
               <a:ext uri="{FF2B5EF4-FFF2-40B4-BE49-F238E27FC236}">
-                <a16:creationId xmlns:a16="http://schemas.microsoft.com/office/drawing/2014/main" id="{ADD6E2AF-1EB3-4582-9DF4-1BE9F8295F55}"/>
+                <a16:creationId xmlns:a16="http://schemas.microsoft.com/office/drawing/2014/main" id="{71A41C82-6FA2-4F14-A831-52A6AA6D555E}"/>
               </a:ext>
             </a:extLst>
           </p:cNvPr>
@@ -10704,7 +10704,7 @@
           <p:cNvPr id="9" name="">
             <a:extLst xmlns:a="http://schemas.openxmlformats.org/drawingml/2006/main">
               <a:ext uri="{FF2B5EF4-FFF2-40B4-BE49-F238E27FC236}">
-                <a16:creationId xmlns:a16="http://schemas.microsoft.com/office/drawing/2014/main" id="{A36F21E8-DB54-4991-B8EC-E9387EBA9DF6}"/>
+                <a16:creationId xmlns:a16="http://schemas.microsoft.com/office/drawing/2014/main" id="{7BE1D75E-350D-4859-B2B0-AB40178F494A}"/>
               </a:ext>
             </a:extLst>
           </p:cNvPr>
@@ -10840,7 +10840,7 @@
           <p:cNvPr id="10" name="">
             <a:extLst xmlns:a="http://schemas.openxmlformats.org/drawingml/2006/main">
               <a:ext uri="{FF2B5EF4-FFF2-40B4-BE49-F238E27FC236}">
-                <a16:creationId xmlns:a16="http://schemas.microsoft.com/office/drawing/2014/main" id="{55B89C6C-D208-47EA-8F33-9D667AB734B9}"/>
+                <a16:creationId xmlns:a16="http://schemas.microsoft.com/office/drawing/2014/main" id="{123E77D0-1FD4-42F2-853C-75563BB8B74E}"/>
               </a:ext>
             </a:extLst>
           </p:cNvPr>
@@ -10873,7 +10873,7 @@
           <p:cNvPr id="11" name="">
             <a:extLst xmlns:a="http://schemas.openxmlformats.org/drawingml/2006/main">
               <a:ext uri="{FF2B5EF4-FFF2-40B4-BE49-F238E27FC236}">
-                <a16:creationId xmlns:a16="http://schemas.microsoft.com/office/drawing/2014/main" id="{46FE38AA-64E5-4EA1-9BD0-A77BDF030101}"/>
+                <a16:creationId xmlns:a16="http://schemas.microsoft.com/office/drawing/2014/main" id="{FE843C58-41F6-40C4-8E5A-B03AAB2A1463}"/>
               </a:ext>
             </a:extLst>
           </p:cNvPr>
@@ -10940,7 +10940,7 @@
           <p:cNvPr id="12" name="">
             <a:extLst xmlns:a="http://schemas.openxmlformats.org/drawingml/2006/main">
               <a:ext uri="{FF2B5EF4-FFF2-40B4-BE49-F238E27FC236}">
-                <a16:creationId xmlns:a16="http://schemas.microsoft.com/office/drawing/2014/main" id="{D19F5B84-AAD2-45F1-A9B3-13C8AA43F34E}"/>
+                <a16:creationId xmlns:a16="http://schemas.microsoft.com/office/drawing/2014/main" id="{3D4324EE-082D-4CBA-8F33-2EF64AAE9BC0}"/>
               </a:ext>
             </a:extLst>
           </p:cNvPr>
@@ -11076,7 +11076,7 @@
           <p:cNvPr id="13" name="">
             <a:extLst xmlns:a="http://schemas.openxmlformats.org/drawingml/2006/main">
               <a:ext uri="{FF2B5EF4-FFF2-40B4-BE49-F238E27FC236}">
-                <a16:creationId xmlns:a16="http://schemas.microsoft.com/office/drawing/2014/main" id="{46275AFE-4AE2-4691-9FA0-A458C7E8D68B}"/>
+                <a16:creationId xmlns:a16="http://schemas.microsoft.com/office/drawing/2014/main" id="{348D0D77-81D9-4FF9-81B8-5D4A93C15511}"/>
               </a:ext>
             </a:extLst>
           </p:cNvPr>
@@ -11109,7 +11109,7 @@
           <p:cNvPr id="14" name="">
             <a:extLst xmlns:a="http://schemas.openxmlformats.org/drawingml/2006/main">
               <a:ext uri="{FF2B5EF4-FFF2-40B4-BE49-F238E27FC236}">
-                <a16:creationId xmlns:a16="http://schemas.microsoft.com/office/drawing/2014/main" id="{DC6CF57D-258D-4AFF-846A-C46A43A44081}"/>
+                <a16:creationId xmlns:a16="http://schemas.microsoft.com/office/drawing/2014/main" id="{2D81063D-AE01-4575-82B7-B306C6391E69}"/>
               </a:ext>
             </a:extLst>
           </p:cNvPr>
@@ -11166,7 +11166,7 @@
                 <a:ea typeface="Aptos"/>
                 <a:cs typeface="Aptos"/>
               </a:rPr>
-              <a:t>Installable delivery</a:t>
+              <a:t>Connected walkthrough</a:t>
             </a:r>
           </a:p>
         </p:txBody>
@@ -11176,7 +11176,7 @@
           <p:cNvPr id="15" name="">
             <a:extLst xmlns:a="http://schemas.openxmlformats.org/drawingml/2006/main">
               <a:ext uri="{FF2B5EF4-FFF2-40B4-BE49-F238E27FC236}">
-                <a16:creationId xmlns:a16="http://schemas.microsoft.com/office/drawing/2014/main" id="{A04A5A5D-AA08-4A57-A275-AA0DE9303DD5}"/>
+                <a16:creationId xmlns:a16="http://schemas.microsoft.com/office/drawing/2014/main" id="{8B2C696F-F2EC-4437-AA34-2898C048A905}"/>
               </a:ext>
             </a:extLst>
           </p:cNvPr>
@@ -11233,7 +11233,7 @@
                 <a:ea typeface="Aptos"/>
                 <a:cs typeface="Aptos"/>
               </a:rPr>
-              <a:t>149 combined tests passing</a:t>
+              <a:t>152 tests and five demos pass</a:t>
             </a:r>
           </a:p>
           <a:p xmlns:a="http://schemas.openxmlformats.org/drawingml/2006/main">
@@ -11256,7 +11256,7 @@
                 <a:ea typeface="Aptos"/>
                 <a:cs typeface="Aptos"/>
               </a:rPr>
-              <a:t>Fresh production installation</a:t>
+              <a:t>One connected workflow command</a:t>
             </a:r>
           </a:p>
           <a:p xmlns:a="http://schemas.openxmlformats.org/drawingml/2006/main">
@@ -11279,7 +11279,7 @@
                 <a:ea typeface="Aptos"/>
                 <a:cs typeface="Aptos"/>
               </a:rPr>
-              <a:t>Native worker RPC handshake</a:t>
+              <a:t>Deterministic journey receipt</a:t>
             </a:r>
           </a:p>
           <a:p xmlns:a="http://schemas.openxmlformats.org/drawingml/2006/main">
@@ -11302,7 +11302,7 @@
                 <a:ea typeface="Aptos"/>
                 <a:cs typeface="Aptos"/>
               </a:rPr>
-              <a:t>Guided configuration validation</a:t>
+              <a:t>Native services and HTTP verified</a:t>
             </a:r>
           </a:p>
         </p:txBody>
@@ -11312,7 +11312,7 @@
           <p:cNvPr id="16" name="">
             <a:extLst xmlns:a="http://schemas.openxmlformats.org/drawingml/2006/main">
               <a:ext uri="{FF2B5EF4-FFF2-40B4-BE49-F238E27FC236}">
-                <a16:creationId xmlns:a16="http://schemas.microsoft.com/office/drawing/2014/main" id="{B49B2408-1C1E-4D89-8275-A0662A08CF9A}"/>
+                <a16:creationId xmlns:a16="http://schemas.microsoft.com/office/drawing/2014/main" id="{9D6F9082-3680-41B1-88E6-190A05E8D118}"/>
               </a:ext>
             </a:extLst>
           </p:cNvPr>
@@ -11369,7 +11369,7 @@
                 <a:ea typeface="Aptos"/>
                 <a:cs typeface="Aptos"/>
               </a:rPr>
-              <a:t>Fixture evidence uses real bridge code with substituted external I/O. Deployment and live rehearsal are still ahead.</a:t>
+              <a:t>Native services and isolated Docker HTTP/API checks passed. External integrations and live deployment remain pending.</a:t>
             </a:r>
           </a:p>
         </p:txBody>
@@ -11377,7 +11377,7 @@
     </p:spTree>
     <p:extLst>
       <p:ext uri="{BB962C8B-B14F-4D97-AF65-F5344CB8AC3E}">
-        <p14:creationId xmlns:p14="http://schemas.microsoft.com/office/powerpoint/2010/main" val="829709320"/>
+        <p14:creationId xmlns:p14="http://schemas.microsoft.com/office/powerpoint/2010/main" val="93010346"/>
       </p:ext>
     </p:extLst>
   </p:cSld>
@@ -11408,7 +11408,7 @@
           <p:cNvPr id="17" name="">
             <a:extLst xmlns:a="http://schemas.openxmlformats.org/drawingml/2006/main">
               <a:ext uri="{FF2B5EF4-FFF2-40B4-BE49-F238E27FC236}">
-                <a16:creationId xmlns:a16="http://schemas.microsoft.com/office/drawing/2014/main" id="{0173441E-F063-4E8A-BF1A-3FE90B8F955D}"/>
+                <a16:creationId xmlns:a16="http://schemas.microsoft.com/office/drawing/2014/main" id="{5E567FFF-EB96-4A56-8095-D54675D333C7}"/>
               </a:ext>
             </a:extLst>
           </p:cNvPr>
@@ -11475,7 +11475,7 @@
           <p:cNvPr id="2" name="">
             <a:extLst xmlns:a="http://schemas.openxmlformats.org/drawingml/2006/main">
               <a:ext uri="{FF2B5EF4-FFF2-40B4-BE49-F238E27FC236}">
-                <a16:creationId xmlns:a16="http://schemas.microsoft.com/office/drawing/2014/main" id="{F5C871FE-F01B-488E-9C0A-CAF465CA5DB1}"/>
+                <a16:creationId xmlns:a16="http://schemas.microsoft.com/office/drawing/2014/main" id="{45B0A5B7-447E-4220-8B45-71588DF9C790}"/>
               </a:ext>
             </a:extLst>
           </p:cNvPr>
@@ -11542,7 +11542,7 @@
           <p:cNvPr id="3" name="">
             <a:extLst xmlns:a="http://schemas.openxmlformats.org/drawingml/2006/main">
               <a:ext uri="{FF2B5EF4-FFF2-40B4-BE49-F238E27FC236}">
-                <a16:creationId xmlns:a16="http://schemas.microsoft.com/office/drawing/2014/main" id="{2B1A65F4-3C73-462B-8F26-C26536AC782E}"/>
+                <a16:creationId xmlns:a16="http://schemas.microsoft.com/office/drawing/2014/main" id="{690BC7E6-3CA6-4111-B860-790A3EA0D412}"/>
               </a:ext>
             </a:extLst>
           </p:cNvPr>
@@ -11609,7 +11609,7 @@
           <p:cNvPr id="4" name="">
             <a:extLst xmlns:a="http://schemas.openxmlformats.org/drawingml/2006/main">
               <a:ext uri="{FF2B5EF4-FFF2-40B4-BE49-F238E27FC236}">
-                <a16:creationId xmlns:a16="http://schemas.microsoft.com/office/drawing/2014/main" id="{EF2C142C-5C03-4D47-BFD4-3D6B04CEC89B}"/>
+                <a16:creationId xmlns:a16="http://schemas.microsoft.com/office/drawing/2014/main" id="{A283D3ED-12AB-4AF0-ACF1-E019983DA6AA}"/>
               </a:ext>
             </a:extLst>
           </p:cNvPr>
@@ -11640,7 +11640,7 @@
           <p:cNvPr id="5" name="">
             <a:extLst xmlns:a="http://schemas.openxmlformats.org/drawingml/2006/main">
               <a:ext uri="{FF2B5EF4-FFF2-40B4-BE49-F238E27FC236}">
-                <a16:creationId xmlns:a16="http://schemas.microsoft.com/office/drawing/2014/main" id="{A3B4C865-930F-462E-96D0-8847246307CA}"/>
+                <a16:creationId xmlns:a16="http://schemas.microsoft.com/office/drawing/2014/main" id="{50D8DC96-37BC-4084-88DA-9A431A024BDC}"/>
               </a:ext>
             </a:extLst>
           </p:cNvPr>
@@ -11697,7 +11697,7 @@
                 <a:ea typeface="Aptos"/>
                 <a:cs typeface="Aptos"/>
               </a:rPr>
-              <a:t>INERTIA-2026-10-23-r7 · 23 October 2026 · Autonomous build</a:t>
+              <a:t>INERTIA-2026-10-23-r8 · 23 October 2026 · Autonomous build</a:t>
             </a:r>
           </a:p>
         </p:txBody>
@@ -11707,7 +11707,7 @@
           <p:cNvPr id="6" name="">
             <a:extLst xmlns:a="http://schemas.openxmlformats.org/drawingml/2006/main">
               <a:ext uri="{FF2B5EF4-FFF2-40B4-BE49-F238E27FC236}">
-                <a16:creationId xmlns:a16="http://schemas.microsoft.com/office/drawing/2014/main" id="{88373A89-E773-4F3B-9E34-A682312AA7E1}"/>
+                <a16:creationId xmlns:a16="http://schemas.microsoft.com/office/drawing/2014/main" id="{6EEE5496-EAD2-4419-8C21-4EA0A4DD92DA}"/>
               </a:ext>
             </a:extLst>
           </p:cNvPr>
@@ -11774,7 +11774,7 @@
           <p:cNvPr id="7" name="">
             <a:extLst xmlns:a="http://schemas.openxmlformats.org/drawingml/2006/main">
               <a:ext uri="{FF2B5EF4-FFF2-40B4-BE49-F238E27FC236}">
-                <a16:creationId xmlns:a16="http://schemas.microsoft.com/office/drawing/2014/main" id="{929FF0A0-B33A-4487-BFDB-6835B1732A0B}"/>
+                <a16:creationId xmlns:a16="http://schemas.microsoft.com/office/drawing/2014/main" id="{4CBCEAED-129F-4A04-ADE4-ED14C78ECB0A}"/>
               </a:ext>
             </a:extLst>
           </p:cNvPr>
@@ -11807,7 +11807,7 @@
           <p:cNvPr id="8" name="">
             <a:extLst xmlns:a="http://schemas.openxmlformats.org/drawingml/2006/main">
               <a:ext uri="{FF2B5EF4-FFF2-40B4-BE49-F238E27FC236}">
-                <a16:creationId xmlns:a16="http://schemas.microsoft.com/office/drawing/2014/main" id="{639AE9B0-2039-47D3-9C4F-6A4CBFAA7575}"/>
+                <a16:creationId xmlns:a16="http://schemas.microsoft.com/office/drawing/2014/main" id="{9BAC63AA-9576-4C6C-9AAA-088C1853B07B}"/>
               </a:ext>
             </a:extLst>
           </p:cNvPr>
@@ -11874,7 +11874,7 @@
           <p:cNvPr id="9" name="">
             <a:extLst xmlns:a="http://schemas.openxmlformats.org/drawingml/2006/main">
               <a:ext uri="{FF2B5EF4-FFF2-40B4-BE49-F238E27FC236}">
-                <a16:creationId xmlns:a16="http://schemas.microsoft.com/office/drawing/2014/main" id="{D800D6A5-1A4D-4994-85B3-97D9159DEA6F}"/>
+                <a16:creationId xmlns:a16="http://schemas.microsoft.com/office/drawing/2014/main" id="{30B10408-B47D-4D49-BCBA-B19154F2962A}"/>
               </a:ext>
             </a:extLst>
           </p:cNvPr>
@@ -12010,7 +12010,7 @@
           <p:cNvPr id="10" name="">
             <a:extLst xmlns:a="http://schemas.openxmlformats.org/drawingml/2006/main">
               <a:ext uri="{FF2B5EF4-FFF2-40B4-BE49-F238E27FC236}">
-                <a16:creationId xmlns:a16="http://schemas.microsoft.com/office/drawing/2014/main" id="{6B941325-326B-4F86-8450-C7509CC5DDE5}"/>
+                <a16:creationId xmlns:a16="http://schemas.microsoft.com/office/drawing/2014/main" id="{44C87D87-17FC-4C14-B243-ABA206108EF6}"/>
               </a:ext>
             </a:extLst>
           </p:cNvPr>
@@ -12043,7 +12043,7 @@
           <p:cNvPr id="11" name="">
             <a:extLst xmlns:a="http://schemas.openxmlformats.org/drawingml/2006/main">
               <a:ext uri="{FF2B5EF4-FFF2-40B4-BE49-F238E27FC236}">
-                <a16:creationId xmlns:a16="http://schemas.microsoft.com/office/drawing/2014/main" id="{34DD5DE3-0E52-4993-A7C2-FA7308C23B11}"/>
+                <a16:creationId xmlns:a16="http://schemas.microsoft.com/office/drawing/2014/main" id="{C204AB85-AA3F-478A-98AE-1CBD71E38CD3}"/>
               </a:ext>
             </a:extLst>
           </p:cNvPr>
@@ -12110,7 +12110,7 @@
           <p:cNvPr id="12" name="">
             <a:extLst xmlns:a="http://schemas.openxmlformats.org/drawingml/2006/main">
               <a:ext uri="{FF2B5EF4-FFF2-40B4-BE49-F238E27FC236}">
-                <a16:creationId xmlns:a16="http://schemas.microsoft.com/office/drawing/2014/main" id="{DF341400-E46A-4547-A3B9-6E2DCF4F4229}"/>
+                <a16:creationId xmlns:a16="http://schemas.microsoft.com/office/drawing/2014/main" id="{F0672BBB-ED90-449A-BE6C-57BDA8427636}"/>
               </a:ext>
             </a:extLst>
           </p:cNvPr>
@@ -12190,7 +12190,7 @@
                 <a:ea typeface="Aptos"/>
                 <a:cs typeface="Aptos"/>
               </a:rPr>
-              <a:t>Integrate approved targets</a:t>
+              <a:t>Run repeatable upgrade checks</a:t>
             </a:r>
           </a:p>
           <a:p xmlns:a="http://schemas.openxmlformats.org/drawingml/2006/main">
@@ -12236,7 +12236,7 @@
                 <a:ea typeface="Aptos"/>
                 <a:cs typeface="Aptos"/>
               </a:rPr>
-              <a:t>Verify normal automatic recovery</a:t>
+              <a:t>Test backup-based recovery</a:t>
             </a:r>
           </a:p>
         </p:txBody>
@@ -12246,7 +12246,7 @@
           <p:cNvPr id="13" name="">
             <a:extLst xmlns:a="http://schemas.openxmlformats.org/drawingml/2006/main">
               <a:ext uri="{FF2B5EF4-FFF2-40B4-BE49-F238E27FC236}">
-                <a16:creationId xmlns:a16="http://schemas.microsoft.com/office/drawing/2014/main" id="{A2D50665-ABDE-434C-BCE8-FC777D1F21CB}"/>
+                <a16:creationId xmlns:a16="http://schemas.microsoft.com/office/drawing/2014/main" id="{95122083-D8F6-4998-A5DD-7F6E8DFD39A3}"/>
               </a:ext>
             </a:extLst>
           </p:cNvPr>
@@ -12279,7 +12279,7 @@
           <p:cNvPr id="14" name="">
             <a:extLst xmlns:a="http://schemas.openxmlformats.org/drawingml/2006/main">
               <a:ext uri="{FF2B5EF4-FFF2-40B4-BE49-F238E27FC236}">
-                <a16:creationId xmlns:a16="http://schemas.microsoft.com/office/drawing/2014/main" id="{C0EE3AEA-04D6-4FCE-A14B-5FE39DB833C1}"/>
+                <a16:creationId xmlns:a16="http://schemas.microsoft.com/office/drawing/2014/main" id="{CD33B486-CFD9-4B91-B987-69295E0AB051}"/>
               </a:ext>
             </a:extLst>
           </p:cNvPr>
@@ -12346,7 +12346,7 @@
           <p:cNvPr id="15" name="">
             <a:extLst xmlns:a="http://schemas.openxmlformats.org/drawingml/2006/main">
               <a:ext uri="{FF2B5EF4-FFF2-40B4-BE49-F238E27FC236}">
-                <a16:creationId xmlns:a16="http://schemas.microsoft.com/office/drawing/2014/main" id="{93DED335-5776-42AC-BBC1-81BD8EC9BCBA}"/>
+                <a16:creationId xmlns:a16="http://schemas.microsoft.com/office/drawing/2014/main" id="{4554D70B-183C-4629-8613-DBCE74744C5B}"/>
               </a:ext>
             </a:extLst>
           </p:cNvPr>
@@ -12482,7 +12482,7 @@
           <p:cNvPr id="16" name="">
             <a:extLst xmlns:a="http://schemas.openxmlformats.org/drawingml/2006/main">
               <a:ext uri="{FF2B5EF4-FFF2-40B4-BE49-F238E27FC236}">
-                <a16:creationId xmlns:a16="http://schemas.microsoft.com/office/drawing/2014/main" id="{0691ACA3-223A-4D47-BBE2-A8593645D206}"/>
+                <a16:creationId xmlns:a16="http://schemas.microsoft.com/office/drawing/2014/main" id="{660BE28A-2F62-40D0-835D-1185992D3F3E}"/>
               </a:ext>
             </a:extLst>
           </p:cNvPr>
@@ -12539,7 +12539,7 @@
                 <a:ea typeface="Aptos"/>
                 <a:cs typeface="Aptos"/>
               </a:rPr>
-              <a:t>Main stays untouched. Helix is de-prioritized. Configuration details stay in one decision register.</a:t>
+              <a:t>Cloud-first execution. Laptop fallback only for a specific blocker. Main and the runtime archive stay unchanged.</a:t>
             </a:r>
           </a:p>
         </p:txBody>
@@ -12547,7 +12547,7 @@
     </p:spTree>
     <p:extLst>
       <p:ext uri="{BB962C8B-B14F-4D97-AF65-F5344CB8AC3E}">
-        <p14:creationId xmlns:p14="http://schemas.microsoft.com/office/powerpoint/2010/main" val="485357773"/>
+        <p14:creationId xmlns:p14="http://schemas.microsoft.com/office/powerpoint/2010/main" val="301613713"/>
       </p:ext>
     </p:extLst>
   </p:cSld>

</xml_diff>

<commit_message>
docs: synchronize r8 architecture and qualified website handoff (#12)
</commit_message>
<xml_diff>
--- a/Inertia-Architecture.pptx
+++ b/Inertia-Architecture.pptx
@@ -2,20 +2,20 @@
 <file path=ppt/presentation.xml><?xml version="1.0" encoding="utf-8"?>
 <p:presentation xmlns:p="http://schemas.openxmlformats.org/presentationml/2006/main">
   <p:sldMasterIdLst>
-    <p:sldMasterId xmlns:r="http://schemas.openxmlformats.org/officeDocument/2006/relationships" id="2147483648" r:id="R3be3756c8c8e4d06"/>
+    <p:sldMasterId xmlns:r="http://schemas.openxmlformats.org/officeDocument/2006/relationships" id="2147483648" r:id="Re63ac91880a5454e"/>
   </p:sldMasterIdLst>
   <p:notesMasterIdLst>
-    <p:notesMasterId xmlns:r="http://schemas.openxmlformats.org/officeDocument/2006/relationships" r:id="R919ed80d140d4fc7"/>
+    <p:notesMasterId xmlns:r="http://schemas.openxmlformats.org/officeDocument/2006/relationships" r:id="R565c0f89eef14973"/>
   </p:notesMasterIdLst>
   <p:sldIdLst>
-    <p:sldId xmlns:r="http://schemas.openxmlformats.org/officeDocument/2006/relationships" id="256" r:id="Re58f4a1192c74eb7"/>
-    <p:sldId xmlns:r="http://schemas.openxmlformats.org/officeDocument/2006/relationships" id="257" r:id="Rb1ef7f9abbed4c2f"/>
-    <p:sldId xmlns:r="http://schemas.openxmlformats.org/officeDocument/2006/relationships" id="258" r:id="R5d83b06a76334ccd"/>
-    <p:sldId xmlns:r="http://schemas.openxmlformats.org/officeDocument/2006/relationships" id="259" r:id="R766df985260e44a9"/>
-    <p:sldId xmlns:r="http://schemas.openxmlformats.org/officeDocument/2006/relationships" id="260" r:id="Rb41a4fe761d7431d"/>
-    <p:sldId xmlns:r="http://schemas.openxmlformats.org/officeDocument/2006/relationships" id="261" r:id="R6d062e6c2d2d4a16"/>
-    <p:sldId xmlns:r="http://schemas.openxmlformats.org/officeDocument/2006/relationships" id="262" r:id="R4bc29f4189db4bbe"/>
-    <p:sldId xmlns:r="http://schemas.openxmlformats.org/officeDocument/2006/relationships" id="263" r:id="Ref3549c8c3f04046"/>
+    <p:sldId xmlns:r="http://schemas.openxmlformats.org/officeDocument/2006/relationships" id="256" r:id="R61af3860cbfb4f76"/>
+    <p:sldId xmlns:r="http://schemas.openxmlformats.org/officeDocument/2006/relationships" id="257" r:id="Rb9391e72b1374f46"/>
+    <p:sldId xmlns:r="http://schemas.openxmlformats.org/officeDocument/2006/relationships" id="258" r:id="R93e9e8d68d904378"/>
+    <p:sldId xmlns:r="http://schemas.openxmlformats.org/officeDocument/2006/relationships" id="259" r:id="R15d2ec525f2e449e"/>
+    <p:sldId xmlns:r="http://schemas.openxmlformats.org/officeDocument/2006/relationships" id="260" r:id="Rc7df1c9c7fd3442e"/>
+    <p:sldId xmlns:r="http://schemas.openxmlformats.org/officeDocument/2006/relationships" id="261" r:id="R24343b718bcc40f3"/>
+    <p:sldId xmlns:r="http://schemas.openxmlformats.org/officeDocument/2006/relationships" id="262" r:id="R0472f160c43c4b11"/>
+    <p:sldId xmlns:r="http://schemas.openxmlformats.org/officeDocument/2006/relationships" id="263" r:id="Rb14ba0e698bb42a9"/>
   </p:sldIdLst>
   <p:sldSz cx="15240000" cy="8572500"/>
   <p:notesSz cx="6858000" cy="9144000"/>
@@ -449,7 +449,7 @@
           <a:lstStyle xmlns:a="http://schemas.openxmlformats.org/drawingml/2006/main"/>
           <a:p xmlns:a="http://schemas.openxmlformats.org/drawingml/2006/main">
             <a:r>
-              <a:t>INERTIA-2026-10-23-r7. Sources: spec.md, testing.md, decisions.md, plan.md. Merged baseline https://github.com/NetRxn/Inertia/commit/53d0f2eedf62778f8af6cc92da6fc7b84f3f0435; PR 2 https://github.com/NetRxn/Inertia/pull/2; PR 3 https://github.com/NetRxn/Inertia/pull/3. Paperclip selected public release v2026.1012.0, bba6a45f0d364cfd962ac59b3bdf2426a8222adb. Buzz dc25198d530acc6237a0320b697365f29daf0ea6. PR 4 https://github.com/NetRxn/Inertia/pull/4 and PR 5 https://github.com/NetRxn/Inertia/pull/5 merged. PR 7 https://github.com/NetRxn/Inertia/pull/7 merged with 37 grant tests. PR 8 https://github.com/NetRxn/Inertia/pull/8 merged with packaging f68e8bb98df0bb05f9a946340d885e0bcfc6e188 independently reviewed; 149 combined tests, typecheck, build, fresh production install and native JSON-RPC worker handshake passed. No private execution-provider source included.</a:t>
+              <a:t>INERTIA-2026-10-23-r8. Sources: spec.md, testing.md, decisions.md, plan.md. Merged baseline https://github.com/NetRxn/Inertia/commit/ec26c1b850e7937a9d5b1561c1a27b43d06394de; PR 2 https://github.com/NetRxn/Inertia/pull/2; PR 3 https://github.com/NetRxn/Inertia/pull/3. Paperclip selected public release v2026.1012.0, bba6a45f0d364cfd962ac59b3bdf2426a8222adb. Buzz dc25198d530acc6237a0320b697365f29daf0ea6. PR 4 https://github.com/NetRxn/Inertia/pull/4 and PR 5 https://github.com/NetRxn/Inertia/pull/5 merged. PR 7 https://github.com/NetRxn/Inertia/pull/7 merged with 37 grant tests. PR 8 https://github.com/NetRxn/Inertia/pull/8 merged with packaging f68e8bb98df0bb05f9a946340d885e0bcfc6e188 independently reviewed; 149 combined tests, typecheck, build, fresh production install and native JSON-RPC worker handshake passed at PR8. PR10 https://github.com/NetRxn/Inertia/pull/10 adds the connected workflow: 152 total tests and five demos pass. External I/O and native work seeding are fixtures. See docs/implementation/live-handoff-checklist.md and docs/qualification/native-services.md. Actual pinned native services passed using PostgreSQL18.1; cloud HTTP startup was blocked by interface enumeration; the authorized isolated Docker fallback subsequently passed full HTTP/API qualification without shims. Latest published host/SDK remain 2026.1012.0 as of 23 October. PR11 https://github.com/NetRxn/Inertia/pull/11 upgrade workflow has 12 focused tests and isolated 152-test/package qualification. DAO organizational facts come from authorized website retrieval with citations and restricted audiences. No private execution-provider source included.</a:t>
             </a:r>
           </a:p>
         </p:txBody>
@@ -519,7 +519,7 @@
           <a:lstStyle xmlns:a="http://schemas.openxmlformats.org/drawingml/2006/main"/>
           <a:p xmlns:a="http://schemas.openxmlformats.org/drawingml/2006/main">
             <a:r>
-              <a:t>INERTIA-2026-10-23-r7. Sources: spec.md, testing.md, decisions.md, plan.md. Merged baseline https://github.com/NetRxn/Inertia/commit/53d0f2eedf62778f8af6cc92da6fc7b84f3f0435; PR 2 https://github.com/NetRxn/Inertia/pull/2; PR 3 https://github.com/NetRxn/Inertia/pull/3. Paperclip selected public release v2026.1012.0, bba6a45f0d364cfd962ac59b3bdf2426a8222adb. Buzz dc25198d530acc6237a0320b697365f29daf0ea6. PR 4 https://github.com/NetRxn/Inertia/pull/4 and PR 5 https://github.com/NetRxn/Inertia/pull/5 merged. PR 7 https://github.com/NetRxn/Inertia/pull/7 merged with 37 grant tests. PR 8 https://github.com/NetRxn/Inertia/pull/8 merged with packaging f68e8bb98df0bb05f9a946340d885e0bcfc6e188 independently reviewed; 149 combined tests, typecheck, build, fresh production install and native JSON-RPC worker handshake passed. No private execution-provider source included.</a:t>
+              <a:t>INERTIA-2026-10-23-r8. Sources: spec.md, testing.md, decisions.md, plan.md. Merged baseline https://github.com/NetRxn/Inertia/commit/ec26c1b850e7937a9d5b1561c1a27b43d06394de; PR 2 https://github.com/NetRxn/Inertia/pull/2; PR 3 https://github.com/NetRxn/Inertia/pull/3. Paperclip selected public release v2026.1012.0, bba6a45f0d364cfd962ac59b3bdf2426a8222adb. Buzz dc25198d530acc6237a0320b697365f29daf0ea6. PR 4 https://github.com/NetRxn/Inertia/pull/4 and PR 5 https://github.com/NetRxn/Inertia/pull/5 merged. PR 7 https://github.com/NetRxn/Inertia/pull/7 merged with 37 grant tests. PR 8 https://github.com/NetRxn/Inertia/pull/8 merged with packaging f68e8bb98df0bb05f9a946340d885e0bcfc6e188 independently reviewed; 149 combined tests, typecheck, build, fresh production install and native JSON-RPC worker handshake passed at PR8. PR10 https://github.com/NetRxn/Inertia/pull/10 adds the connected workflow: 152 total tests and five demos pass. External I/O and native work seeding are fixtures. See docs/implementation/live-handoff-checklist.md and docs/qualification/native-services.md. Actual pinned native services passed using PostgreSQL18.1; cloud HTTP startup was blocked by interface enumeration; the authorized isolated Docker fallback subsequently passed full HTTP/API qualification without shims. Latest published host/SDK remain 2026.1012.0 as of 23 October. PR11 https://github.com/NetRxn/Inertia/pull/11 upgrade workflow has 12 focused tests and isolated 152-test/package qualification. DAO organizational facts come from authorized website retrieval with citations and restricted audiences. No private execution-provider source included.</a:t>
             </a:r>
           </a:p>
         </p:txBody>
@@ -589,7 +589,7 @@
           <a:lstStyle xmlns:a="http://schemas.openxmlformats.org/drawingml/2006/main"/>
           <a:p xmlns:a="http://schemas.openxmlformats.org/drawingml/2006/main">
             <a:r>
-              <a:t>INERTIA-2026-10-23-r7. Sources: spec.md, testing.md, decisions.md, plan.md. Merged baseline https://github.com/NetRxn/Inertia/commit/53d0f2eedf62778f8af6cc92da6fc7b84f3f0435; PR 2 https://github.com/NetRxn/Inertia/pull/2; PR 3 https://github.com/NetRxn/Inertia/pull/3. Paperclip selected public release v2026.1012.0, bba6a45f0d364cfd962ac59b3bdf2426a8222adb. Buzz dc25198d530acc6237a0320b697365f29daf0ea6. PR 4 https://github.com/NetRxn/Inertia/pull/4 and PR 5 https://github.com/NetRxn/Inertia/pull/5 merged. PR 7 https://github.com/NetRxn/Inertia/pull/7 merged with 37 grant tests. PR 8 https://github.com/NetRxn/Inertia/pull/8 merged with packaging f68e8bb98df0bb05f9a946340d885e0bcfc6e188 independently reviewed; 149 combined tests, typecheck, build, fresh production install and native JSON-RPC worker handshake passed. No private execution-provider source included.</a:t>
+              <a:t>INERTIA-2026-10-23-r8. Sources: spec.md, testing.md, decisions.md, plan.md. Merged baseline https://github.com/NetRxn/Inertia/commit/ec26c1b850e7937a9d5b1561c1a27b43d06394de; PR 2 https://github.com/NetRxn/Inertia/pull/2; PR 3 https://github.com/NetRxn/Inertia/pull/3. Paperclip selected public release v2026.1012.0, bba6a45f0d364cfd962ac59b3bdf2426a8222adb. Buzz dc25198d530acc6237a0320b697365f29daf0ea6. PR 4 https://github.com/NetRxn/Inertia/pull/4 and PR 5 https://github.com/NetRxn/Inertia/pull/5 merged. PR 7 https://github.com/NetRxn/Inertia/pull/7 merged with 37 grant tests. PR 8 https://github.com/NetRxn/Inertia/pull/8 merged with packaging f68e8bb98df0bb05f9a946340d885e0bcfc6e188 independently reviewed; 149 combined tests, typecheck, build, fresh production install and native JSON-RPC worker handshake passed at PR8. PR10 https://github.com/NetRxn/Inertia/pull/10 adds the connected workflow: 152 total tests and five demos pass. External I/O and native work seeding are fixtures. See docs/implementation/live-handoff-checklist.md and docs/qualification/native-services.md. Actual pinned native services passed using PostgreSQL18.1; cloud HTTP startup was blocked by interface enumeration; the authorized isolated Docker fallback subsequently passed full HTTP/API qualification without shims. Latest published host/SDK remain 2026.1012.0 as of 23 October. PR11 https://github.com/NetRxn/Inertia/pull/11 upgrade workflow has 12 focused tests and isolated 152-test/package qualification. DAO organizational facts come from authorized website retrieval with citations and restricted audiences. No private execution-provider source included.</a:t>
             </a:r>
           </a:p>
         </p:txBody>
@@ -659,7 +659,7 @@
           <a:lstStyle xmlns:a="http://schemas.openxmlformats.org/drawingml/2006/main"/>
           <a:p xmlns:a="http://schemas.openxmlformats.org/drawingml/2006/main">
             <a:r>
-              <a:t>INERTIA-2026-10-23-r7. Sources: spec.md, testing.md, decisions.md, plan.md. Merged baseline https://github.com/NetRxn/Inertia/commit/53d0f2eedf62778f8af6cc92da6fc7b84f3f0435; PR 2 https://github.com/NetRxn/Inertia/pull/2; PR 3 https://github.com/NetRxn/Inertia/pull/3. Paperclip selected public release v2026.1012.0, bba6a45f0d364cfd962ac59b3bdf2426a8222adb. Buzz dc25198d530acc6237a0320b697365f29daf0ea6. PR 4 https://github.com/NetRxn/Inertia/pull/4 and PR 5 https://github.com/NetRxn/Inertia/pull/5 merged. PR 7 https://github.com/NetRxn/Inertia/pull/7 merged with 37 grant tests. PR 8 https://github.com/NetRxn/Inertia/pull/8 merged with packaging f68e8bb98df0bb05f9a946340d885e0bcfc6e188 independently reviewed; 149 combined tests, typecheck, build, fresh production install and native JSON-RPC worker handshake passed. No private execution-provider source included.</a:t>
+              <a:t>INERTIA-2026-10-23-r8. Sources: spec.md, testing.md, decisions.md, plan.md. Merged baseline https://github.com/NetRxn/Inertia/commit/ec26c1b850e7937a9d5b1561c1a27b43d06394de; PR 2 https://github.com/NetRxn/Inertia/pull/2; PR 3 https://github.com/NetRxn/Inertia/pull/3. Paperclip selected public release v2026.1012.0, bba6a45f0d364cfd962ac59b3bdf2426a8222adb. Buzz dc25198d530acc6237a0320b697365f29daf0ea6. PR 4 https://github.com/NetRxn/Inertia/pull/4 and PR 5 https://github.com/NetRxn/Inertia/pull/5 merged. PR 7 https://github.com/NetRxn/Inertia/pull/7 merged with 37 grant tests. PR 8 https://github.com/NetRxn/Inertia/pull/8 merged with packaging f68e8bb98df0bb05f9a946340d885e0bcfc6e188 independently reviewed; 149 combined tests, typecheck, build, fresh production install and native JSON-RPC worker handshake passed at PR8. PR10 https://github.com/NetRxn/Inertia/pull/10 adds the connected workflow: 152 total tests and five demos pass. External I/O and native work seeding are fixtures. See docs/implementation/live-handoff-checklist.md and docs/qualification/native-services.md. Actual pinned native services passed using PostgreSQL18.1; cloud HTTP startup was blocked by interface enumeration; the authorized isolated Docker fallback subsequently passed full HTTP/API qualification without shims. Latest published host/SDK remain 2026.1012.0 as of 23 October. PR11 https://github.com/NetRxn/Inertia/pull/11 upgrade workflow has 12 focused tests and isolated 152-test/package qualification. DAO organizational facts come from authorized website retrieval with citations and restricted audiences. No private execution-provider source included.</a:t>
             </a:r>
           </a:p>
         </p:txBody>
@@ -729,7 +729,7 @@
           <a:lstStyle xmlns:a="http://schemas.openxmlformats.org/drawingml/2006/main"/>
           <a:p xmlns:a="http://schemas.openxmlformats.org/drawingml/2006/main">
             <a:r>
-              <a:t>INERTIA-2026-10-23-r7. Sources: spec.md, testing.md, decisions.md, plan.md. Merged baseline https://github.com/NetRxn/Inertia/commit/53d0f2eedf62778f8af6cc92da6fc7b84f3f0435; PR 2 https://github.com/NetRxn/Inertia/pull/2; PR 3 https://github.com/NetRxn/Inertia/pull/3. Paperclip selected public release v2026.1012.0, bba6a45f0d364cfd962ac59b3bdf2426a8222adb. Buzz dc25198d530acc6237a0320b697365f29daf0ea6. PR 4 https://github.com/NetRxn/Inertia/pull/4 and PR 5 https://github.com/NetRxn/Inertia/pull/5 merged. PR 7 https://github.com/NetRxn/Inertia/pull/7 merged with 37 grant tests. PR 8 https://github.com/NetRxn/Inertia/pull/8 merged with packaging f68e8bb98df0bb05f9a946340d885e0bcfc6e188 independently reviewed; 149 combined tests, typecheck, build, fresh production install and native JSON-RPC worker handshake passed. No private execution-provider source included.</a:t>
+              <a:t>INERTIA-2026-10-23-r8. Sources: spec.md, testing.md, decisions.md, plan.md. Merged baseline https://github.com/NetRxn/Inertia/commit/ec26c1b850e7937a9d5b1561c1a27b43d06394de; PR 2 https://github.com/NetRxn/Inertia/pull/2; PR 3 https://github.com/NetRxn/Inertia/pull/3. Paperclip selected public release v2026.1012.0, bba6a45f0d364cfd962ac59b3bdf2426a8222adb. Buzz dc25198d530acc6237a0320b697365f29daf0ea6. PR 4 https://github.com/NetRxn/Inertia/pull/4 and PR 5 https://github.com/NetRxn/Inertia/pull/5 merged. PR 7 https://github.com/NetRxn/Inertia/pull/7 merged with 37 grant tests. PR 8 https://github.com/NetRxn/Inertia/pull/8 merged with packaging f68e8bb98df0bb05f9a946340d885e0bcfc6e188 independently reviewed; 149 combined tests, typecheck, build, fresh production install and native JSON-RPC worker handshake passed at PR8. PR10 https://github.com/NetRxn/Inertia/pull/10 adds the connected workflow: 152 total tests and five demos pass. External I/O and native work seeding are fixtures. See docs/implementation/live-handoff-checklist.md and docs/qualification/native-services.md. Actual pinned native services passed using PostgreSQL18.1; cloud HTTP startup was blocked by interface enumeration; the authorized isolated Docker fallback subsequently passed full HTTP/API qualification without shims. Latest published host/SDK remain 2026.1012.0 as of 23 October. PR11 https://github.com/NetRxn/Inertia/pull/11 upgrade workflow has 12 focused tests and isolated 152-test/package qualification. DAO organizational facts come from authorized website retrieval with citations and restricted audiences. No private execution-provider source included.</a:t>
             </a:r>
           </a:p>
         </p:txBody>
@@ -799,7 +799,7 @@
           <a:lstStyle xmlns:a="http://schemas.openxmlformats.org/drawingml/2006/main"/>
           <a:p xmlns:a="http://schemas.openxmlformats.org/drawingml/2006/main">
             <a:r>
-              <a:t>INERTIA-2026-10-23-r7. Sources: spec.md, testing.md, decisions.md, plan.md. Merged baseline https://github.com/NetRxn/Inertia/commit/53d0f2eedf62778f8af6cc92da6fc7b84f3f0435; PR 2 https://github.com/NetRxn/Inertia/pull/2; PR 3 https://github.com/NetRxn/Inertia/pull/3. Paperclip selected public release v2026.1012.0, bba6a45f0d364cfd962ac59b3bdf2426a8222adb. Buzz dc25198d530acc6237a0320b697365f29daf0ea6. PR 4 https://github.com/NetRxn/Inertia/pull/4 and PR 5 https://github.com/NetRxn/Inertia/pull/5 merged. PR 7 https://github.com/NetRxn/Inertia/pull/7 merged with 37 grant tests. PR 8 https://github.com/NetRxn/Inertia/pull/8 merged with packaging f68e8bb98df0bb05f9a946340d885e0bcfc6e188 independently reviewed; 149 combined tests, typecheck, build, fresh production install and native JSON-RPC worker handshake passed. No private execution-provider source included.</a:t>
+              <a:t>INERTIA-2026-10-23-r8. Sources: spec.md, testing.md, decisions.md, plan.md. Merged baseline https://github.com/NetRxn/Inertia/commit/ec26c1b850e7937a9d5b1561c1a27b43d06394de; PR 2 https://github.com/NetRxn/Inertia/pull/2; PR 3 https://github.com/NetRxn/Inertia/pull/3. Paperclip selected public release v2026.1012.0, bba6a45f0d364cfd962ac59b3bdf2426a8222adb. Buzz dc25198d530acc6237a0320b697365f29daf0ea6. PR 4 https://github.com/NetRxn/Inertia/pull/4 and PR 5 https://github.com/NetRxn/Inertia/pull/5 merged. PR 7 https://github.com/NetRxn/Inertia/pull/7 merged with 37 grant tests. PR 8 https://github.com/NetRxn/Inertia/pull/8 merged with packaging f68e8bb98df0bb05f9a946340d885e0bcfc6e188 independently reviewed; 149 combined tests, typecheck, build, fresh production install and native JSON-RPC worker handshake passed at PR8. PR10 https://github.com/NetRxn/Inertia/pull/10 adds the connected workflow: 152 total tests and five demos pass. External I/O and native work seeding are fixtures. See docs/implementation/live-handoff-checklist.md and docs/qualification/native-services.md. Actual pinned native services passed using PostgreSQL18.1; cloud HTTP startup was blocked by interface enumeration; the authorized isolated Docker fallback subsequently passed full HTTP/API qualification without shims. Latest published host/SDK remain 2026.1012.0 as of 23 October. PR11 https://github.com/NetRxn/Inertia/pull/11 upgrade workflow has 12 focused tests and isolated 152-test/package qualification. DAO organizational facts come from authorized website retrieval with citations and restricted audiences. No private execution-provider source included.</a:t>
             </a:r>
           </a:p>
         </p:txBody>
@@ -869,7 +869,7 @@
           <a:lstStyle xmlns:a="http://schemas.openxmlformats.org/drawingml/2006/main"/>
           <a:p xmlns:a="http://schemas.openxmlformats.org/drawingml/2006/main">
             <a:r>
-              <a:t>INERTIA-2026-10-23-r7. Sources: spec.md, testing.md, decisions.md, plan.md. Merged baseline https://github.com/NetRxn/Inertia/commit/53d0f2eedf62778f8af6cc92da6fc7b84f3f0435; PR 2 https://github.com/NetRxn/Inertia/pull/2; PR 3 https://github.com/NetRxn/Inertia/pull/3. Paperclip selected public release v2026.1012.0, bba6a45f0d364cfd962ac59b3bdf2426a8222adb. Buzz dc25198d530acc6237a0320b697365f29daf0ea6. PR 4 https://github.com/NetRxn/Inertia/pull/4 and PR 5 https://github.com/NetRxn/Inertia/pull/5 merged. PR 7 https://github.com/NetRxn/Inertia/pull/7 merged with 37 grant tests. PR 8 https://github.com/NetRxn/Inertia/pull/8 merged with packaging f68e8bb98df0bb05f9a946340d885e0bcfc6e188 independently reviewed; 149 combined tests, typecheck, build, fresh production install and native JSON-RPC worker handshake passed. No private execution-provider source included.</a:t>
+              <a:t>INERTIA-2026-10-23-r8. Sources: spec.md, testing.md, decisions.md, plan.md. Merged baseline https://github.com/NetRxn/Inertia/commit/ec26c1b850e7937a9d5b1561c1a27b43d06394de; PR 2 https://github.com/NetRxn/Inertia/pull/2; PR 3 https://github.com/NetRxn/Inertia/pull/3. Paperclip selected public release v2026.1012.0, bba6a45f0d364cfd962ac59b3bdf2426a8222adb. Buzz dc25198d530acc6237a0320b697365f29daf0ea6. PR 4 https://github.com/NetRxn/Inertia/pull/4 and PR 5 https://github.com/NetRxn/Inertia/pull/5 merged. PR 7 https://github.com/NetRxn/Inertia/pull/7 merged with 37 grant tests. PR 8 https://github.com/NetRxn/Inertia/pull/8 merged with packaging f68e8bb98df0bb05f9a946340d885e0bcfc6e188 independently reviewed; 149 combined tests, typecheck, build, fresh production install and native JSON-RPC worker handshake passed at PR8. PR10 https://github.com/NetRxn/Inertia/pull/10 adds the connected workflow: 152 total tests and five demos pass. External I/O and native work seeding are fixtures. See docs/implementation/live-handoff-checklist.md and docs/qualification/native-services.md. Actual pinned native services passed using PostgreSQL18.1; cloud HTTP startup was blocked by interface enumeration; the authorized isolated Docker fallback subsequently passed full HTTP/API qualification without shims. Latest published host/SDK remain 2026.1012.0 as of 23 October. PR11 https://github.com/NetRxn/Inertia/pull/11 upgrade workflow has 12 focused tests and isolated 152-test/package qualification. DAO organizational facts come from authorized website retrieval with citations and restricted audiences. No private execution-provider source included.</a:t>
             </a:r>
           </a:p>
         </p:txBody>
@@ -939,7 +939,7 @@
           <a:lstStyle xmlns:a="http://schemas.openxmlformats.org/drawingml/2006/main"/>
           <a:p xmlns:a="http://schemas.openxmlformats.org/drawingml/2006/main">
             <a:r>
-              <a:t>INERTIA-2026-10-23-r7. Sources: spec.md, testing.md, decisions.md, plan.md. Merged baseline https://github.com/NetRxn/Inertia/commit/53d0f2eedf62778f8af6cc92da6fc7b84f3f0435; PR 2 https://github.com/NetRxn/Inertia/pull/2; PR 3 https://github.com/NetRxn/Inertia/pull/3. Paperclip selected public release v2026.1012.0, bba6a45f0d364cfd962ac59b3bdf2426a8222adb. Buzz dc25198d530acc6237a0320b697365f29daf0ea6. PR 4 https://github.com/NetRxn/Inertia/pull/4 and PR 5 https://github.com/NetRxn/Inertia/pull/5 merged. PR 7 https://github.com/NetRxn/Inertia/pull/7 merged with 37 grant tests. PR 8 https://github.com/NetRxn/Inertia/pull/8 merged with packaging f68e8bb98df0bb05f9a946340d885e0bcfc6e188 independently reviewed; 149 combined tests, typecheck, build, fresh production install and native JSON-RPC worker handshake passed. No private execution-provider source included.</a:t>
+              <a:t>INERTIA-2026-10-23-r8. Sources: spec.md, testing.md, decisions.md, plan.md. Merged baseline https://github.com/NetRxn/Inertia/commit/ec26c1b850e7937a9d5b1561c1a27b43d06394de; PR 2 https://github.com/NetRxn/Inertia/pull/2; PR 3 https://github.com/NetRxn/Inertia/pull/3. Paperclip selected public release v2026.1012.0, bba6a45f0d364cfd962ac59b3bdf2426a8222adb. Buzz dc25198d530acc6237a0320b697365f29daf0ea6. PR 4 https://github.com/NetRxn/Inertia/pull/4 and PR 5 https://github.com/NetRxn/Inertia/pull/5 merged. PR 7 https://github.com/NetRxn/Inertia/pull/7 merged with 37 grant tests. PR 8 https://github.com/NetRxn/Inertia/pull/8 merged with packaging f68e8bb98df0bb05f9a946340d885e0bcfc6e188 independently reviewed; 149 combined tests, typecheck, build, fresh production install and native JSON-RPC worker handshake passed at PR8. PR10 https://github.com/NetRxn/Inertia/pull/10 adds the connected workflow: 152 total tests and five demos pass. External I/O and native work seeding are fixtures. See docs/implementation/live-handoff-checklist.md and docs/qualification/native-services.md. Actual pinned native services passed using PostgreSQL18.1; cloud HTTP startup was blocked by interface enumeration; the authorized isolated Docker fallback subsequently passed full HTTP/API qualification without shims. Latest published host/SDK remain 2026.1012.0 as of 23 October. PR11 https://github.com/NetRxn/Inertia/pull/11 upgrade workflow has 12 focused tests and isolated 152-test/package qualification. DAO organizational facts come from authorized website retrieval with citations and restricted audiences. No private execution-provider source included.</a:t>
             </a:r>
           </a:p>
         </p:txBody>
@@ -986,7 +986,7 @@
           <p:cNvPr id="3" name="Title">
             <a:extLst xmlns:a="http://schemas.openxmlformats.org/drawingml/2006/main">
               <a:ext uri="{FF2B5EF4-FFF2-40B4-BE49-F238E27FC236}">
-                <a16:creationId xmlns:a16="http://schemas.microsoft.com/office/drawing/2014/main" id="{95D1E57F-B585-48FA-B271-4C568F5362D9}"/>
+                <a16:creationId xmlns:a16="http://schemas.microsoft.com/office/drawing/2014/main" id="{B2BB04BB-C642-4AFE-B2AF-EA71054E0DF8}"/>
               </a:ext>
             </a:extLst>
           </p:cNvPr>
@@ -1143,7 +1143,7 @@
           <p:cNvPr id="2" name="Subtitle">
             <a:extLst xmlns:a="http://schemas.openxmlformats.org/drawingml/2006/main">
               <a:ext uri="{FF2B5EF4-FFF2-40B4-BE49-F238E27FC236}">
-                <a16:creationId xmlns:a16="http://schemas.microsoft.com/office/drawing/2014/main" id="{ADCBF4C5-38CE-4382-ADFF-8D349780FF13}"/>
+                <a16:creationId xmlns:a16="http://schemas.microsoft.com/office/drawing/2014/main" id="{60BB485D-8C21-443F-9EA8-4CFA63D31D26}"/>
               </a:ext>
             </a:extLst>
           </p:cNvPr>
@@ -1317,7 +1317,7 @@
           <p:cNvPr id="2" name="Section title">
             <a:extLst xmlns:a="http://schemas.openxmlformats.org/drawingml/2006/main">
               <a:ext uri="{FF2B5EF4-FFF2-40B4-BE49-F238E27FC236}">
-                <a16:creationId xmlns:a16="http://schemas.microsoft.com/office/drawing/2014/main" id="{91B867D4-3DA0-47B2-9D01-3112A1B2E3BD}"/>
+                <a16:creationId xmlns:a16="http://schemas.microsoft.com/office/drawing/2014/main" id="{0BED8EB3-3C72-4747-B8AF-6AA0FB6B83AA}"/>
               </a:ext>
             </a:extLst>
           </p:cNvPr>
@@ -1491,7 +1491,7 @@
           <p:cNvPr id="3" name="Title">
             <a:extLst xmlns:a="http://schemas.openxmlformats.org/drawingml/2006/main">
               <a:ext uri="{FF2B5EF4-FFF2-40B4-BE49-F238E27FC236}">
-                <a16:creationId xmlns:a16="http://schemas.microsoft.com/office/drawing/2014/main" id="{3E0D570B-6EBC-43AC-B476-FB076AF1E7A7}"/>
+                <a16:creationId xmlns:a16="http://schemas.microsoft.com/office/drawing/2014/main" id="{3860B105-9D39-465C-9FDA-541C01197993}"/>
               </a:ext>
             </a:extLst>
           </p:cNvPr>
@@ -1648,7 +1648,7 @@
           <p:cNvPr id="2" name="Body">
             <a:extLst xmlns:a="http://schemas.openxmlformats.org/drawingml/2006/main">
               <a:ext uri="{FF2B5EF4-FFF2-40B4-BE49-F238E27FC236}">
-                <a16:creationId xmlns:a16="http://schemas.microsoft.com/office/drawing/2014/main" id="{8BD6B71A-F54F-42C7-A877-7354E411401C}"/>
+                <a16:creationId xmlns:a16="http://schemas.microsoft.com/office/drawing/2014/main" id="{4612016C-7988-4E4B-AF1B-845FB0D2C4EB}"/>
               </a:ext>
             </a:extLst>
           </p:cNvPr>
@@ -1822,7 +1822,7 @@
           <p:cNvPr id="4" name="Title">
             <a:extLst xmlns:a="http://schemas.openxmlformats.org/drawingml/2006/main">
               <a:ext uri="{FF2B5EF4-FFF2-40B4-BE49-F238E27FC236}">
-                <a16:creationId xmlns:a16="http://schemas.microsoft.com/office/drawing/2014/main" id="{68C2C14D-F684-4909-88F4-3F250CAAB786}"/>
+                <a16:creationId xmlns:a16="http://schemas.microsoft.com/office/drawing/2014/main" id="{6C75AC54-C9AA-4B23-9A08-5EB093C9736F}"/>
               </a:ext>
             </a:extLst>
           </p:cNvPr>
@@ -1979,7 +1979,7 @@
           <p:cNvPr id="2" name="Left column">
             <a:extLst xmlns:a="http://schemas.openxmlformats.org/drawingml/2006/main">
               <a:ext uri="{FF2B5EF4-FFF2-40B4-BE49-F238E27FC236}">
-                <a16:creationId xmlns:a16="http://schemas.microsoft.com/office/drawing/2014/main" id="{FCDF51D0-11A0-4E3D-A341-7B7B2CE8E009}"/>
+                <a16:creationId xmlns:a16="http://schemas.microsoft.com/office/drawing/2014/main" id="{E2F28D63-9C78-4795-BC3A-CC73D8833DF6}"/>
               </a:ext>
             </a:extLst>
           </p:cNvPr>
@@ -2136,7 +2136,7 @@
           <p:cNvPr id="3" name="Right column">
             <a:extLst xmlns:a="http://schemas.openxmlformats.org/drawingml/2006/main">
               <a:ext uri="{FF2B5EF4-FFF2-40B4-BE49-F238E27FC236}">
-                <a16:creationId xmlns:a16="http://schemas.microsoft.com/office/drawing/2014/main" id="{5FD43888-3962-41C3-8D69-C94503E9CB1E}"/>
+                <a16:creationId xmlns:a16="http://schemas.microsoft.com/office/drawing/2014/main" id="{AF25E1A6-5B62-4DE3-BC6F-DAECC9F8F2B3}"/>
               </a:ext>
             </a:extLst>
           </p:cNvPr>
@@ -2310,7 +2310,7 @@
           <p:cNvPr id="3" name="Title">
             <a:extLst xmlns:a="http://schemas.openxmlformats.org/drawingml/2006/main">
               <a:ext uri="{FF2B5EF4-FFF2-40B4-BE49-F238E27FC236}">
-                <a16:creationId xmlns:a16="http://schemas.microsoft.com/office/drawing/2014/main" id="{5C7F9286-8D75-4BA5-A753-5F902D8904BD}"/>
+                <a16:creationId xmlns:a16="http://schemas.microsoft.com/office/drawing/2014/main" id="{47FC270D-D82C-4B56-A521-5FCB06B0E788}"/>
               </a:ext>
             </a:extLst>
           </p:cNvPr>
@@ -2467,7 +2467,7 @@
           <p:cNvPr id="2" name="Left column">
             <a:extLst xmlns:a="http://schemas.openxmlformats.org/drawingml/2006/main">
               <a:ext uri="{FF2B5EF4-FFF2-40B4-BE49-F238E27FC236}">
-                <a16:creationId xmlns:a16="http://schemas.microsoft.com/office/drawing/2014/main" id="{6E137C6C-C699-4A3B-9DF9-6DA18ED53DB5}"/>
+                <a16:creationId xmlns:a16="http://schemas.microsoft.com/office/drawing/2014/main" id="{9669944E-66CE-4C43-8BF8-3D6C205627F1}"/>
               </a:ext>
             </a:extLst>
           </p:cNvPr>
@@ -2662,12 +2662,12 @@
   </p:cSld>
   <p:clrMap bg1="lt1" tx1="dk1" bg2="lt2" tx2="dk2" accent1="accent1" accent2="accent2" accent3="accent3" accent4="accent4" accent5="accent5" accent6="accent6" hlink="hlink" folHlink="folHlink"/>
   <p:sldLayoutIdLst>
-    <p:sldLayoutId xmlns:r="http://schemas.openxmlformats.org/officeDocument/2006/relationships" id="2147483649" r:id="R233f2e708c214e04"/>
-    <p:sldLayoutId xmlns:r="http://schemas.openxmlformats.org/officeDocument/2006/relationships" id="2147483650" r:id="R16173458a66b442b"/>
-    <p:sldLayoutId xmlns:r="http://schemas.openxmlformats.org/officeDocument/2006/relationships" id="2147483651" r:id="Rb005901e47b247ed"/>
-    <p:sldLayoutId xmlns:r="http://schemas.openxmlformats.org/officeDocument/2006/relationships" id="2147483652" r:id="Rb8747a1593ac46e5"/>
-    <p:sldLayoutId xmlns:r="http://schemas.openxmlformats.org/officeDocument/2006/relationships" id="2147483653" r:id="R48da9b55596e4ba5"/>
-    <p:sldLayoutId xmlns:r="http://schemas.openxmlformats.org/officeDocument/2006/relationships" id="2147483654" r:id="Re252940858574bd5"/>
+    <p:sldLayoutId xmlns:r="http://schemas.openxmlformats.org/officeDocument/2006/relationships" id="2147483649" r:id="R6846bf5a52784031"/>
+    <p:sldLayoutId xmlns:r="http://schemas.openxmlformats.org/officeDocument/2006/relationships" id="2147483650" r:id="R27b90192727d4b6f"/>
+    <p:sldLayoutId xmlns:r="http://schemas.openxmlformats.org/officeDocument/2006/relationships" id="2147483651" r:id="R86f2907a34264d91"/>
+    <p:sldLayoutId xmlns:r="http://schemas.openxmlformats.org/officeDocument/2006/relationships" id="2147483652" r:id="R8696eeb5e57b422f"/>
+    <p:sldLayoutId xmlns:r="http://schemas.openxmlformats.org/officeDocument/2006/relationships" id="2147483653" r:id="Rccc8d6c9a01c44f9"/>
+    <p:sldLayoutId xmlns:r="http://schemas.openxmlformats.org/officeDocument/2006/relationships" id="2147483654" r:id="R9643191b62a84ca2"/>
   </p:sldLayoutIdLst>
   <p:txStyles>
     <p:titleStyle>
@@ -3218,7 +3218,7 @@
           <p:cNvPr id="17" name="">
             <a:extLst xmlns:a="http://schemas.openxmlformats.org/drawingml/2006/main">
               <a:ext uri="{FF2B5EF4-FFF2-40B4-BE49-F238E27FC236}">
-                <a16:creationId xmlns:a16="http://schemas.microsoft.com/office/drawing/2014/main" id="{75A17CB0-39A8-4057-8703-88DC0F47DA44}"/>
+                <a16:creationId xmlns:a16="http://schemas.microsoft.com/office/drawing/2014/main" id="{BC239CF3-AEEB-4C70-9638-598037246DD0}"/>
               </a:ext>
             </a:extLst>
           </p:cNvPr>
@@ -3285,7 +3285,7 @@
           <p:cNvPr id="2" name="">
             <a:extLst xmlns:a="http://schemas.openxmlformats.org/drawingml/2006/main">
               <a:ext uri="{FF2B5EF4-FFF2-40B4-BE49-F238E27FC236}">
-                <a16:creationId xmlns:a16="http://schemas.microsoft.com/office/drawing/2014/main" id="{8E7AA5AE-3884-4754-BB21-036316BC93B7}"/>
+                <a16:creationId xmlns:a16="http://schemas.microsoft.com/office/drawing/2014/main" id="{775A061A-BB9A-46D9-9689-1E888F612136}"/>
               </a:ext>
             </a:extLst>
           </p:cNvPr>
@@ -3352,7 +3352,7 @@
           <p:cNvPr id="3" name="">
             <a:extLst xmlns:a="http://schemas.openxmlformats.org/drawingml/2006/main">
               <a:ext uri="{FF2B5EF4-FFF2-40B4-BE49-F238E27FC236}">
-                <a16:creationId xmlns:a16="http://schemas.microsoft.com/office/drawing/2014/main" id="{C52E8E11-3AAB-4161-BA43-A873C284EE78}"/>
+                <a16:creationId xmlns:a16="http://schemas.microsoft.com/office/drawing/2014/main" id="{5D164164-343D-4C7C-B71D-8030C1CF6682}"/>
               </a:ext>
             </a:extLst>
           </p:cNvPr>
@@ -3419,7 +3419,7 @@
           <p:cNvPr id="4" name="">
             <a:extLst xmlns:a="http://schemas.openxmlformats.org/drawingml/2006/main">
               <a:ext uri="{FF2B5EF4-FFF2-40B4-BE49-F238E27FC236}">
-                <a16:creationId xmlns:a16="http://schemas.microsoft.com/office/drawing/2014/main" id="{B79EDA0C-5311-4F7A-B0E4-BC61B4DD2BBA}"/>
+                <a16:creationId xmlns:a16="http://schemas.microsoft.com/office/drawing/2014/main" id="{6423E234-E4AB-4F82-B0DF-2D097B8BABD2}"/>
               </a:ext>
             </a:extLst>
           </p:cNvPr>
@@ -3450,7 +3450,7 @@
           <p:cNvPr id="5" name="">
             <a:extLst xmlns:a="http://schemas.openxmlformats.org/drawingml/2006/main">
               <a:ext uri="{FF2B5EF4-FFF2-40B4-BE49-F238E27FC236}">
-                <a16:creationId xmlns:a16="http://schemas.microsoft.com/office/drawing/2014/main" id="{A997853C-D0FA-442D-B83B-10E243559DD1}"/>
+                <a16:creationId xmlns:a16="http://schemas.microsoft.com/office/drawing/2014/main" id="{080D05CB-D177-43A8-87B2-A8D4D710DBF6}"/>
               </a:ext>
             </a:extLst>
           </p:cNvPr>
@@ -3507,7 +3507,7 @@
                 <a:ea typeface="Aptos"/>
                 <a:cs typeface="Aptos"/>
               </a:rPr>
-              <a:t>INERTIA-2026-10-23-r7 · 23 October 2026 · Autonomous build</a:t>
+              <a:t>INERTIA-2026-10-23-r8 · 23 October 2026 · Autonomous build</a:t>
             </a:r>
           </a:p>
         </p:txBody>
@@ -3517,7 +3517,7 @@
           <p:cNvPr id="6" name="">
             <a:extLst xmlns:a="http://schemas.openxmlformats.org/drawingml/2006/main">
               <a:ext uri="{FF2B5EF4-FFF2-40B4-BE49-F238E27FC236}">
-                <a16:creationId xmlns:a16="http://schemas.microsoft.com/office/drawing/2014/main" id="{E1AAD32A-738A-4B4D-AF3B-E1039F8B2359}"/>
+                <a16:creationId xmlns:a16="http://schemas.microsoft.com/office/drawing/2014/main" id="{5DF04493-7DE5-4D72-9C1E-49BFA41D2CA5}"/>
               </a:ext>
             </a:extLst>
           </p:cNvPr>
@@ -3584,7 +3584,7 @@
           <p:cNvPr id="7" name="">
             <a:extLst xmlns:a="http://schemas.openxmlformats.org/drawingml/2006/main">
               <a:ext uri="{FF2B5EF4-FFF2-40B4-BE49-F238E27FC236}">
-                <a16:creationId xmlns:a16="http://schemas.microsoft.com/office/drawing/2014/main" id="{895CD7D3-4E64-4D64-95EC-AE898156BC0D}"/>
+                <a16:creationId xmlns:a16="http://schemas.microsoft.com/office/drawing/2014/main" id="{D2153C1E-A0B4-45F5-A34D-24706DB52EFC}"/>
               </a:ext>
             </a:extLst>
           </p:cNvPr>
@@ -3617,7 +3617,7 @@
           <p:cNvPr id="8" name="">
             <a:extLst xmlns:a="http://schemas.openxmlformats.org/drawingml/2006/main">
               <a:ext uri="{FF2B5EF4-FFF2-40B4-BE49-F238E27FC236}">
-                <a16:creationId xmlns:a16="http://schemas.microsoft.com/office/drawing/2014/main" id="{0822820E-389C-4386-ABF5-8F3E89F88428}"/>
+                <a16:creationId xmlns:a16="http://schemas.microsoft.com/office/drawing/2014/main" id="{AA48ECDB-2288-4E14-8C18-9F8332DA82D6}"/>
               </a:ext>
             </a:extLst>
           </p:cNvPr>
@@ -3684,7 +3684,7 @@
           <p:cNvPr id="9" name="">
             <a:extLst xmlns:a="http://schemas.openxmlformats.org/drawingml/2006/main">
               <a:ext uri="{FF2B5EF4-FFF2-40B4-BE49-F238E27FC236}">
-                <a16:creationId xmlns:a16="http://schemas.microsoft.com/office/drawing/2014/main" id="{4DF2FB39-8503-4F7F-A20E-D799FFC3CB8D}"/>
+                <a16:creationId xmlns:a16="http://schemas.microsoft.com/office/drawing/2014/main" id="{35B68F73-56D2-467A-95DE-6505A99DE0CD}"/>
               </a:ext>
             </a:extLst>
           </p:cNvPr>
@@ -3820,7 +3820,7 @@
           <p:cNvPr id="10" name="">
             <a:extLst xmlns:a="http://schemas.openxmlformats.org/drawingml/2006/main">
               <a:ext uri="{FF2B5EF4-FFF2-40B4-BE49-F238E27FC236}">
-                <a16:creationId xmlns:a16="http://schemas.microsoft.com/office/drawing/2014/main" id="{4394AFB3-3884-4B91-84F9-D9DBD29A978D}"/>
+                <a16:creationId xmlns:a16="http://schemas.microsoft.com/office/drawing/2014/main" id="{2E07301F-CADC-43B8-9DEC-48FBD257046F}"/>
               </a:ext>
             </a:extLst>
           </p:cNvPr>
@@ -3853,7 +3853,7 @@
           <p:cNvPr id="11" name="">
             <a:extLst xmlns:a="http://schemas.openxmlformats.org/drawingml/2006/main">
               <a:ext uri="{FF2B5EF4-FFF2-40B4-BE49-F238E27FC236}">
-                <a16:creationId xmlns:a16="http://schemas.microsoft.com/office/drawing/2014/main" id="{D6201A74-09B1-4889-AF4F-41F9C25DA6FA}"/>
+                <a16:creationId xmlns:a16="http://schemas.microsoft.com/office/drawing/2014/main" id="{3D16CEED-7B01-44E3-8A26-D63202FFE02D}"/>
               </a:ext>
             </a:extLst>
           </p:cNvPr>
@@ -3920,7 +3920,7 @@
           <p:cNvPr id="12" name="">
             <a:extLst xmlns:a="http://schemas.openxmlformats.org/drawingml/2006/main">
               <a:ext uri="{FF2B5EF4-FFF2-40B4-BE49-F238E27FC236}">
-                <a16:creationId xmlns:a16="http://schemas.microsoft.com/office/drawing/2014/main" id="{71961843-971E-4E58-A870-49045C7CBA83}"/>
+                <a16:creationId xmlns:a16="http://schemas.microsoft.com/office/drawing/2014/main" id="{69FAD8CC-CABF-460A-8D10-37945D426688}"/>
               </a:ext>
             </a:extLst>
           </p:cNvPr>
@@ -4056,7 +4056,7 @@
           <p:cNvPr id="13" name="">
             <a:extLst xmlns:a="http://schemas.openxmlformats.org/drawingml/2006/main">
               <a:ext uri="{FF2B5EF4-FFF2-40B4-BE49-F238E27FC236}">
-                <a16:creationId xmlns:a16="http://schemas.microsoft.com/office/drawing/2014/main" id="{42A6583E-D56A-43F0-97A0-A8C7DC6F55E2}"/>
+                <a16:creationId xmlns:a16="http://schemas.microsoft.com/office/drawing/2014/main" id="{CEF943F2-0F20-41AD-9B1C-CE20548E73C5}"/>
               </a:ext>
             </a:extLst>
           </p:cNvPr>
@@ -4089,7 +4089,7 @@
           <p:cNvPr id="14" name="">
             <a:extLst xmlns:a="http://schemas.openxmlformats.org/drawingml/2006/main">
               <a:ext uri="{FF2B5EF4-FFF2-40B4-BE49-F238E27FC236}">
-                <a16:creationId xmlns:a16="http://schemas.microsoft.com/office/drawing/2014/main" id="{07AD5DAD-5402-4ACA-B83A-9A0DD58443A8}"/>
+                <a16:creationId xmlns:a16="http://schemas.microsoft.com/office/drawing/2014/main" id="{B17ADE35-A4FA-44FC-89E1-5984054AE389}"/>
               </a:ext>
             </a:extLst>
           </p:cNvPr>
@@ -4156,7 +4156,7 @@
           <p:cNvPr id="15" name="">
             <a:extLst xmlns:a="http://schemas.openxmlformats.org/drawingml/2006/main">
               <a:ext uri="{FF2B5EF4-FFF2-40B4-BE49-F238E27FC236}">
-                <a16:creationId xmlns:a16="http://schemas.microsoft.com/office/drawing/2014/main" id="{BC00549C-210B-4AA3-B9A5-A2121A074DE9}"/>
+                <a16:creationId xmlns:a16="http://schemas.microsoft.com/office/drawing/2014/main" id="{D0B9CA06-3D16-4139-B9AD-07875AA91F38}"/>
               </a:ext>
             </a:extLst>
           </p:cNvPr>
@@ -4292,7 +4292,7 @@
           <p:cNvPr id="16" name="">
             <a:extLst xmlns:a="http://schemas.openxmlformats.org/drawingml/2006/main">
               <a:ext uri="{FF2B5EF4-FFF2-40B4-BE49-F238E27FC236}">
-                <a16:creationId xmlns:a16="http://schemas.microsoft.com/office/drawing/2014/main" id="{E07F0EA3-9DEE-4358-9B37-79AC719B0BDB}"/>
+                <a16:creationId xmlns:a16="http://schemas.microsoft.com/office/drawing/2014/main" id="{2E448B18-4CE1-4E33-87D1-75CE8159A33E}"/>
               </a:ext>
             </a:extLst>
           </p:cNvPr>
@@ -4349,7 +4349,7 @@
                 <a:ea typeface="Aptos"/>
                 <a:cs typeface="Aptos"/>
               </a:rPr>
-              <a:t>Required demo outcomes: meeting publication, a packet-bound vote and a second member’s contribution.</a:t>
+              <a:t>One-command synthetic walkthrough: npm run demo:workflow. Deterministic receipt links the journey and pending live handoffs.</a:t>
             </a:r>
           </a:p>
         </p:txBody>
@@ -4357,7 +4357,7 @@
     </p:spTree>
     <p:extLst>
       <p:ext uri="{BB962C8B-B14F-4D97-AF65-F5344CB8AC3E}">
-        <p14:creationId xmlns:p14="http://schemas.microsoft.com/office/powerpoint/2010/main" val="1968587660"/>
+        <p14:creationId xmlns:p14="http://schemas.microsoft.com/office/powerpoint/2010/main" val="1649333656"/>
       </p:ext>
     </p:extLst>
   </p:cSld>
@@ -4388,7 +4388,7 @@
           <p:cNvPr id="17" name="">
             <a:extLst xmlns:a="http://schemas.openxmlformats.org/drawingml/2006/main">
               <a:ext uri="{FF2B5EF4-FFF2-40B4-BE49-F238E27FC236}">
-                <a16:creationId xmlns:a16="http://schemas.microsoft.com/office/drawing/2014/main" id="{EE06281D-7DA2-4A51-9FB6-D45B89B30533}"/>
+                <a16:creationId xmlns:a16="http://schemas.microsoft.com/office/drawing/2014/main" id="{AA7E402A-3371-447D-BE62-7E56C20F8C59}"/>
               </a:ext>
             </a:extLst>
           </p:cNvPr>
@@ -4455,7 +4455,7 @@
           <p:cNvPr id="2" name="">
             <a:extLst xmlns:a="http://schemas.openxmlformats.org/drawingml/2006/main">
               <a:ext uri="{FF2B5EF4-FFF2-40B4-BE49-F238E27FC236}">
-                <a16:creationId xmlns:a16="http://schemas.microsoft.com/office/drawing/2014/main" id="{53C260F7-D566-4389-8653-E77D369EAE33}"/>
+                <a16:creationId xmlns:a16="http://schemas.microsoft.com/office/drawing/2014/main" id="{7856E497-2025-4C11-98AE-354E6125C898}"/>
               </a:ext>
             </a:extLst>
           </p:cNvPr>
@@ -4522,7 +4522,7 @@
           <p:cNvPr id="3" name="">
             <a:extLst xmlns:a="http://schemas.openxmlformats.org/drawingml/2006/main">
               <a:ext uri="{FF2B5EF4-FFF2-40B4-BE49-F238E27FC236}">
-                <a16:creationId xmlns:a16="http://schemas.microsoft.com/office/drawing/2014/main" id="{B06AB686-7526-49D9-BFF9-E1FDC2B46EF9}"/>
+                <a16:creationId xmlns:a16="http://schemas.microsoft.com/office/drawing/2014/main" id="{C9BBB0FF-4EB5-4568-B42F-9D7CDC0A2C56}"/>
               </a:ext>
             </a:extLst>
           </p:cNvPr>
@@ -4589,7 +4589,7 @@
           <p:cNvPr id="4" name="">
             <a:extLst xmlns:a="http://schemas.openxmlformats.org/drawingml/2006/main">
               <a:ext uri="{FF2B5EF4-FFF2-40B4-BE49-F238E27FC236}">
-                <a16:creationId xmlns:a16="http://schemas.microsoft.com/office/drawing/2014/main" id="{C659046B-B47F-4269-8A3F-B410C60F3E1D}"/>
+                <a16:creationId xmlns:a16="http://schemas.microsoft.com/office/drawing/2014/main" id="{F310BFE3-49C7-402D-BB80-E5A14561142F}"/>
               </a:ext>
             </a:extLst>
           </p:cNvPr>
@@ -4620,7 +4620,7 @@
           <p:cNvPr id="5" name="">
             <a:extLst xmlns:a="http://schemas.openxmlformats.org/drawingml/2006/main">
               <a:ext uri="{FF2B5EF4-FFF2-40B4-BE49-F238E27FC236}">
-                <a16:creationId xmlns:a16="http://schemas.microsoft.com/office/drawing/2014/main" id="{E734B095-112B-43C9-B8C3-FED820A4522A}"/>
+                <a16:creationId xmlns:a16="http://schemas.microsoft.com/office/drawing/2014/main" id="{6D63C75B-38AD-44DE-B2C8-8E88B008BDB1}"/>
               </a:ext>
             </a:extLst>
           </p:cNvPr>
@@ -4677,7 +4677,7 @@
                 <a:ea typeface="Aptos"/>
                 <a:cs typeface="Aptos"/>
               </a:rPr>
-              <a:t>INERTIA-2026-10-23-r7 · 23 October 2026 · Autonomous build</a:t>
+              <a:t>INERTIA-2026-10-23-r8 · 23 October 2026 · Autonomous build</a:t>
             </a:r>
           </a:p>
         </p:txBody>
@@ -4687,7 +4687,7 @@
           <p:cNvPr id="6" name="">
             <a:extLst xmlns:a="http://schemas.openxmlformats.org/drawingml/2006/main">
               <a:ext uri="{FF2B5EF4-FFF2-40B4-BE49-F238E27FC236}">
-                <a16:creationId xmlns:a16="http://schemas.microsoft.com/office/drawing/2014/main" id="{C14636F2-19A8-4444-9E5C-EAC575F842E8}"/>
+                <a16:creationId xmlns:a16="http://schemas.microsoft.com/office/drawing/2014/main" id="{AF2CB773-7879-4FB3-8C25-21C9E9DF2C6D}"/>
               </a:ext>
             </a:extLst>
           </p:cNvPr>
@@ -4754,7 +4754,7 @@
           <p:cNvPr id="7" name="">
             <a:extLst xmlns:a="http://schemas.openxmlformats.org/drawingml/2006/main">
               <a:ext uri="{FF2B5EF4-FFF2-40B4-BE49-F238E27FC236}">
-                <a16:creationId xmlns:a16="http://schemas.microsoft.com/office/drawing/2014/main" id="{00F6D0B6-C34F-4F11-95B4-E702EE3C5D89}"/>
+                <a16:creationId xmlns:a16="http://schemas.microsoft.com/office/drawing/2014/main" id="{A0500152-E36A-431D-9503-A0CB8F413815}"/>
               </a:ext>
             </a:extLst>
           </p:cNvPr>
@@ -4787,7 +4787,7 @@
           <p:cNvPr id="8" name="">
             <a:extLst xmlns:a="http://schemas.openxmlformats.org/drawingml/2006/main">
               <a:ext uri="{FF2B5EF4-FFF2-40B4-BE49-F238E27FC236}">
-                <a16:creationId xmlns:a16="http://schemas.microsoft.com/office/drawing/2014/main" id="{41AA1ADC-CCFE-4008-9E98-BF3BBF7DF52A}"/>
+                <a16:creationId xmlns:a16="http://schemas.microsoft.com/office/drawing/2014/main" id="{66709222-0339-43C4-BD8B-9C62A1D0E1E1}"/>
               </a:ext>
             </a:extLst>
           </p:cNvPr>
@@ -4854,7 +4854,7 @@
           <p:cNvPr id="9" name="">
             <a:extLst xmlns:a="http://schemas.openxmlformats.org/drawingml/2006/main">
               <a:ext uri="{FF2B5EF4-FFF2-40B4-BE49-F238E27FC236}">
-                <a16:creationId xmlns:a16="http://schemas.microsoft.com/office/drawing/2014/main" id="{95F2B8EF-39D5-412B-8A7B-24B0745D6BAE}"/>
+                <a16:creationId xmlns:a16="http://schemas.microsoft.com/office/drawing/2014/main" id="{EB7DF129-E2D4-42BF-AF3A-0A51F797F241}"/>
               </a:ext>
             </a:extLst>
           </p:cNvPr>
@@ -4990,7 +4990,7 @@
           <p:cNvPr id="10" name="">
             <a:extLst xmlns:a="http://schemas.openxmlformats.org/drawingml/2006/main">
               <a:ext uri="{FF2B5EF4-FFF2-40B4-BE49-F238E27FC236}">
-                <a16:creationId xmlns:a16="http://schemas.microsoft.com/office/drawing/2014/main" id="{104C8D86-6522-47BF-A332-D13A05656B5D}"/>
+                <a16:creationId xmlns:a16="http://schemas.microsoft.com/office/drawing/2014/main" id="{C7F4D5F2-930E-4AEA-BCAD-C642871E43BD}"/>
               </a:ext>
             </a:extLst>
           </p:cNvPr>
@@ -5023,7 +5023,7 @@
           <p:cNvPr id="11" name="">
             <a:extLst xmlns:a="http://schemas.openxmlformats.org/drawingml/2006/main">
               <a:ext uri="{FF2B5EF4-FFF2-40B4-BE49-F238E27FC236}">
-                <a16:creationId xmlns:a16="http://schemas.microsoft.com/office/drawing/2014/main" id="{8E2D9FF4-17E6-413C-9349-22137D1EC7E0}"/>
+                <a16:creationId xmlns:a16="http://schemas.microsoft.com/office/drawing/2014/main" id="{9750ECB7-DB45-4D6F-904A-A3001E33B2D4}"/>
               </a:ext>
             </a:extLst>
           </p:cNvPr>
@@ -5090,7 +5090,7 @@
           <p:cNvPr id="12" name="">
             <a:extLst xmlns:a="http://schemas.openxmlformats.org/drawingml/2006/main">
               <a:ext uri="{FF2B5EF4-FFF2-40B4-BE49-F238E27FC236}">
-                <a16:creationId xmlns:a16="http://schemas.microsoft.com/office/drawing/2014/main" id="{51029DB9-D370-43DB-8A01-DCC57E26F78B}"/>
+                <a16:creationId xmlns:a16="http://schemas.microsoft.com/office/drawing/2014/main" id="{612C9D55-35D0-4BAB-8E3D-57AB6674D958}"/>
               </a:ext>
             </a:extLst>
           </p:cNvPr>
@@ -5226,7 +5226,7 @@
           <p:cNvPr id="13" name="">
             <a:extLst xmlns:a="http://schemas.openxmlformats.org/drawingml/2006/main">
               <a:ext uri="{FF2B5EF4-FFF2-40B4-BE49-F238E27FC236}">
-                <a16:creationId xmlns:a16="http://schemas.microsoft.com/office/drawing/2014/main" id="{2995EA0B-045D-491F-80B4-C54E28EFA07C}"/>
+                <a16:creationId xmlns:a16="http://schemas.microsoft.com/office/drawing/2014/main" id="{7D6978CF-E9C4-4AFB-9744-B48389DEB42F}"/>
               </a:ext>
             </a:extLst>
           </p:cNvPr>
@@ -5259,7 +5259,7 @@
           <p:cNvPr id="14" name="">
             <a:extLst xmlns:a="http://schemas.openxmlformats.org/drawingml/2006/main">
               <a:ext uri="{FF2B5EF4-FFF2-40B4-BE49-F238E27FC236}">
-                <a16:creationId xmlns:a16="http://schemas.microsoft.com/office/drawing/2014/main" id="{A89751F6-B7D3-4B44-8391-576F0F93809D}"/>
+                <a16:creationId xmlns:a16="http://schemas.microsoft.com/office/drawing/2014/main" id="{3B0E4C0F-84D5-46C1-8AB7-B563943D2932}"/>
               </a:ext>
             </a:extLst>
           </p:cNvPr>
@@ -5326,7 +5326,7 @@
           <p:cNvPr id="15" name="">
             <a:extLst xmlns:a="http://schemas.openxmlformats.org/drawingml/2006/main">
               <a:ext uri="{FF2B5EF4-FFF2-40B4-BE49-F238E27FC236}">
-                <a16:creationId xmlns:a16="http://schemas.microsoft.com/office/drawing/2014/main" id="{F2747B70-629C-4D99-BD56-6DA417CFD4E2}"/>
+                <a16:creationId xmlns:a16="http://schemas.microsoft.com/office/drawing/2014/main" id="{B2EFF710-9337-4710-A8E0-C04D4711369E}"/>
               </a:ext>
             </a:extLst>
           </p:cNvPr>
@@ -5462,7 +5462,7 @@
           <p:cNvPr id="16" name="">
             <a:extLst xmlns:a="http://schemas.openxmlformats.org/drawingml/2006/main">
               <a:ext uri="{FF2B5EF4-FFF2-40B4-BE49-F238E27FC236}">
-                <a16:creationId xmlns:a16="http://schemas.microsoft.com/office/drawing/2014/main" id="{B450F4DE-8F17-40A3-AA49-4DD93E986894}"/>
+                <a16:creationId xmlns:a16="http://schemas.microsoft.com/office/drawing/2014/main" id="{BBA93648-BF1B-4CB2-9628-711602AA722A}"/>
               </a:ext>
             </a:extLst>
           </p:cNvPr>
@@ -5519,7 +5519,7 @@
                 <a:ea typeface="Aptos"/>
                 <a:cs typeface="Aptos"/>
               </a:rPr>
-              <a:t>A narrow plugin fits the selected Paperclip release. Shared records keep the two interfaces coherent.</a:t>
+              <a:t>Latest Paperclip releases are the target. Reproducible builds qualify compatibility and migrations before promotion.</a:t>
             </a:r>
           </a:p>
         </p:txBody>
@@ -5527,7 +5527,7 @@
     </p:spTree>
     <p:extLst>
       <p:ext uri="{BB962C8B-B14F-4D97-AF65-F5344CB8AC3E}">
-        <p14:creationId xmlns:p14="http://schemas.microsoft.com/office/powerpoint/2010/main" val="733959173"/>
+        <p14:creationId xmlns:p14="http://schemas.microsoft.com/office/powerpoint/2010/main" val="170816485"/>
       </p:ext>
     </p:extLst>
   </p:cSld>
@@ -5558,7 +5558,7 @@
           <p:cNvPr id="17" name="">
             <a:extLst xmlns:a="http://schemas.openxmlformats.org/drawingml/2006/main">
               <a:ext uri="{FF2B5EF4-FFF2-40B4-BE49-F238E27FC236}">
-                <a16:creationId xmlns:a16="http://schemas.microsoft.com/office/drawing/2014/main" id="{8CF80F0F-375A-4B24-A0C5-A8CBDDE1ED60}"/>
+                <a16:creationId xmlns:a16="http://schemas.microsoft.com/office/drawing/2014/main" id="{182BD0C8-8380-48F4-B41A-229845094366}"/>
               </a:ext>
             </a:extLst>
           </p:cNvPr>
@@ -5625,7 +5625,7 @@
           <p:cNvPr id="2" name="">
             <a:extLst xmlns:a="http://schemas.openxmlformats.org/drawingml/2006/main">
               <a:ext uri="{FF2B5EF4-FFF2-40B4-BE49-F238E27FC236}">
-                <a16:creationId xmlns:a16="http://schemas.microsoft.com/office/drawing/2014/main" id="{95F88023-8372-4D9F-AE47-A9345B2F0AF8}"/>
+                <a16:creationId xmlns:a16="http://schemas.microsoft.com/office/drawing/2014/main" id="{0CCB7C36-E25D-4D85-888E-F11279DD2CE0}"/>
               </a:ext>
             </a:extLst>
           </p:cNvPr>
@@ -5692,7 +5692,7 @@
           <p:cNvPr id="3" name="">
             <a:extLst xmlns:a="http://schemas.openxmlformats.org/drawingml/2006/main">
               <a:ext uri="{FF2B5EF4-FFF2-40B4-BE49-F238E27FC236}">
-                <a16:creationId xmlns:a16="http://schemas.microsoft.com/office/drawing/2014/main" id="{1AFD17F5-A822-4FC5-83B8-7A3C435B8022}"/>
+                <a16:creationId xmlns:a16="http://schemas.microsoft.com/office/drawing/2014/main" id="{3098477F-614C-4C0E-BDF2-15D0E0A17517}"/>
               </a:ext>
             </a:extLst>
           </p:cNvPr>
@@ -5759,7 +5759,7 @@
           <p:cNvPr id="4" name="">
             <a:extLst xmlns:a="http://schemas.openxmlformats.org/drawingml/2006/main">
               <a:ext uri="{FF2B5EF4-FFF2-40B4-BE49-F238E27FC236}">
-                <a16:creationId xmlns:a16="http://schemas.microsoft.com/office/drawing/2014/main" id="{F7802C5E-0670-40F2-997D-DA582BC5F085}"/>
+                <a16:creationId xmlns:a16="http://schemas.microsoft.com/office/drawing/2014/main" id="{78E15CD5-619F-447C-A583-3971869491F4}"/>
               </a:ext>
             </a:extLst>
           </p:cNvPr>
@@ -5790,7 +5790,7 @@
           <p:cNvPr id="5" name="">
             <a:extLst xmlns:a="http://schemas.openxmlformats.org/drawingml/2006/main">
               <a:ext uri="{FF2B5EF4-FFF2-40B4-BE49-F238E27FC236}">
-                <a16:creationId xmlns:a16="http://schemas.microsoft.com/office/drawing/2014/main" id="{5D677A4C-05D8-406A-9A87-EBD6B2AFAC4E}"/>
+                <a16:creationId xmlns:a16="http://schemas.microsoft.com/office/drawing/2014/main" id="{9F31E50D-4E53-43DB-B757-9A76A371E417}"/>
               </a:ext>
             </a:extLst>
           </p:cNvPr>
@@ -5847,7 +5847,7 @@
                 <a:ea typeface="Aptos"/>
                 <a:cs typeface="Aptos"/>
               </a:rPr>
-              <a:t>INERTIA-2026-10-23-r7 · 23 October 2026 · Autonomous build</a:t>
+              <a:t>INERTIA-2026-10-23-r8 · 23 October 2026 · Autonomous build</a:t>
             </a:r>
           </a:p>
         </p:txBody>
@@ -5857,7 +5857,7 @@
           <p:cNvPr id="6" name="">
             <a:extLst xmlns:a="http://schemas.openxmlformats.org/drawingml/2006/main">
               <a:ext uri="{FF2B5EF4-FFF2-40B4-BE49-F238E27FC236}">
-                <a16:creationId xmlns:a16="http://schemas.microsoft.com/office/drawing/2014/main" id="{D264DAEF-B56A-4E10-94A2-06346AE44A35}"/>
+                <a16:creationId xmlns:a16="http://schemas.microsoft.com/office/drawing/2014/main" id="{50252E89-1542-40E1-AA32-AC5E1A860D55}"/>
               </a:ext>
             </a:extLst>
           </p:cNvPr>
@@ -5924,7 +5924,7 @@
           <p:cNvPr id="7" name="">
             <a:extLst xmlns:a="http://schemas.openxmlformats.org/drawingml/2006/main">
               <a:ext uri="{FF2B5EF4-FFF2-40B4-BE49-F238E27FC236}">
-                <a16:creationId xmlns:a16="http://schemas.microsoft.com/office/drawing/2014/main" id="{1DA0AE12-E67A-47B6-848C-EFBF3557132E}"/>
+                <a16:creationId xmlns:a16="http://schemas.microsoft.com/office/drawing/2014/main" id="{E8E56381-D20D-49D9-9458-FD13F1C803C6}"/>
               </a:ext>
             </a:extLst>
           </p:cNvPr>
@@ -5957,7 +5957,7 @@
           <p:cNvPr id="8" name="">
             <a:extLst xmlns:a="http://schemas.openxmlformats.org/drawingml/2006/main">
               <a:ext uri="{FF2B5EF4-FFF2-40B4-BE49-F238E27FC236}">
-                <a16:creationId xmlns:a16="http://schemas.microsoft.com/office/drawing/2014/main" id="{7CB359B6-55AA-467E-A1E0-849449F2DDA2}"/>
+                <a16:creationId xmlns:a16="http://schemas.microsoft.com/office/drawing/2014/main" id="{E5E9AA49-6774-4A29-BD91-8DE661F42AB5}"/>
               </a:ext>
             </a:extLst>
           </p:cNvPr>
@@ -6024,7 +6024,7 @@
           <p:cNvPr id="9" name="">
             <a:extLst xmlns:a="http://schemas.openxmlformats.org/drawingml/2006/main">
               <a:ext uri="{FF2B5EF4-FFF2-40B4-BE49-F238E27FC236}">
-                <a16:creationId xmlns:a16="http://schemas.microsoft.com/office/drawing/2014/main" id="{35525060-F203-465B-804A-C4F0859369D1}"/>
+                <a16:creationId xmlns:a16="http://schemas.microsoft.com/office/drawing/2014/main" id="{CE60655F-0101-403F-A8D6-EF15C102A39B}"/>
               </a:ext>
             </a:extLst>
           </p:cNvPr>
@@ -6160,7 +6160,7 @@
           <p:cNvPr id="10" name="">
             <a:extLst xmlns:a="http://schemas.openxmlformats.org/drawingml/2006/main">
               <a:ext uri="{FF2B5EF4-FFF2-40B4-BE49-F238E27FC236}">
-                <a16:creationId xmlns:a16="http://schemas.microsoft.com/office/drawing/2014/main" id="{E2A8BDE7-EB9F-484E-B8C4-5C7DD6286A49}"/>
+                <a16:creationId xmlns:a16="http://schemas.microsoft.com/office/drawing/2014/main" id="{B15903F5-2A8A-4308-970B-47D068AE0062}"/>
               </a:ext>
             </a:extLst>
           </p:cNvPr>
@@ -6193,7 +6193,7 @@
           <p:cNvPr id="11" name="">
             <a:extLst xmlns:a="http://schemas.openxmlformats.org/drawingml/2006/main">
               <a:ext uri="{FF2B5EF4-FFF2-40B4-BE49-F238E27FC236}">
-                <a16:creationId xmlns:a16="http://schemas.microsoft.com/office/drawing/2014/main" id="{EEE638D8-CD51-41FA-B258-DD582E92B9C7}"/>
+                <a16:creationId xmlns:a16="http://schemas.microsoft.com/office/drawing/2014/main" id="{F350C39F-073E-4E2F-A346-00DABCFD49E3}"/>
               </a:ext>
             </a:extLst>
           </p:cNvPr>
@@ -6260,7 +6260,7 @@
           <p:cNvPr id="12" name="">
             <a:extLst xmlns:a="http://schemas.openxmlformats.org/drawingml/2006/main">
               <a:ext uri="{FF2B5EF4-FFF2-40B4-BE49-F238E27FC236}">
-                <a16:creationId xmlns:a16="http://schemas.microsoft.com/office/drawing/2014/main" id="{BC9D344B-EE5B-4FE6-961D-BBCE8E8F592F}"/>
+                <a16:creationId xmlns:a16="http://schemas.microsoft.com/office/drawing/2014/main" id="{6D3FCBDD-6038-45D5-B44F-57237FA3A733}"/>
               </a:ext>
             </a:extLst>
           </p:cNvPr>
@@ -6386,7 +6386,7 @@
                 <a:ea typeface="Aptos"/>
                 <a:cs typeface="Aptos"/>
               </a:rPr>
-              <a:t>Apply the configured audience</a:t>
+              <a:t>Members-only portal audience</a:t>
             </a:r>
           </a:p>
         </p:txBody>
@@ -6396,7 +6396,7 @@
           <p:cNvPr id="13" name="">
             <a:extLst xmlns:a="http://schemas.openxmlformats.org/drawingml/2006/main">
               <a:ext uri="{FF2B5EF4-FFF2-40B4-BE49-F238E27FC236}">
-                <a16:creationId xmlns:a16="http://schemas.microsoft.com/office/drawing/2014/main" id="{39675A13-9C7C-400A-9B51-0C8CE7965117}"/>
+                <a16:creationId xmlns:a16="http://schemas.microsoft.com/office/drawing/2014/main" id="{8282538B-46DC-42D3-B244-7DA2210A5DD9}"/>
               </a:ext>
             </a:extLst>
           </p:cNvPr>
@@ -6429,7 +6429,7 @@
           <p:cNvPr id="14" name="">
             <a:extLst xmlns:a="http://schemas.openxmlformats.org/drawingml/2006/main">
               <a:ext uri="{FF2B5EF4-FFF2-40B4-BE49-F238E27FC236}">
-                <a16:creationId xmlns:a16="http://schemas.microsoft.com/office/drawing/2014/main" id="{36561293-C6F2-470F-85CC-5CE76B44E89D}"/>
+                <a16:creationId xmlns:a16="http://schemas.microsoft.com/office/drawing/2014/main" id="{58F4BB8A-2ED4-478B-9549-54A23EF0C3DB}"/>
               </a:ext>
             </a:extLst>
           </p:cNvPr>
@@ -6496,7 +6496,7 @@
           <p:cNvPr id="15" name="">
             <a:extLst xmlns:a="http://schemas.openxmlformats.org/drawingml/2006/main">
               <a:ext uri="{FF2B5EF4-FFF2-40B4-BE49-F238E27FC236}">
-                <a16:creationId xmlns:a16="http://schemas.microsoft.com/office/drawing/2014/main" id="{E03254B7-D753-4857-8759-D4058038D82C}"/>
+                <a16:creationId xmlns:a16="http://schemas.microsoft.com/office/drawing/2014/main" id="{BB583532-EE44-401B-8727-3EF4856F4BC7}"/>
               </a:ext>
             </a:extLst>
           </p:cNvPr>
@@ -6632,7 +6632,7 @@
           <p:cNvPr id="16" name="">
             <a:extLst xmlns:a="http://schemas.openxmlformats.org/drawingml/2006/main">
               <a:ext uri="{FF2B5EF4-FFF2-40B4-BE49-F238E27FC236}">
-                <a16:creationId xmlns:a16="http://schemas.microsoft.com/office/drawing/2014/main" id="{49CF7F52-762A-48D1-B7F9-0D46C2049BF9}"/>
+                <a16:creationId xmlns:a16="http://schemas.microsoft.com/office/drawing/2014/main" id="{E2CADAA6-478D-4D2E-8BAF-DD6A233295B7}"/>
               </a:ext>
             </a:extLst>
           </p:cNvPr>
@@ -6697,7 +6697,7 @@
     </p:spTree>
     <p:extLst>
       <p:ext uri="{BB962C8B-B14F-4D97-AF65-F5344CB8AC3E}">
-        <p14:creationId xmlns:p14="http://schemas.microsoft.com/office/powerpoint/2010/main" val="324729755"/>
+        <p14:creationId xmlns:p14="http://schemas.microsoft.com/office/powerpoint/2010/main" val="1158979162"/>
       </p:ext>
     </p:extLst>
   </p:cSld>
@@ -6728,7 +6728,7 @@
           <p:cNvPr id="17" name="">
             <a:extLst xmlns:a="http://schemas.openxmlformats.org/drawingml/2006/main">
               <a:ext uri="{FF2B5EF4-FFF2-40B4-BE49-F238E27FC236}">
-                <a16:creationId xmlns:a16="http://schemas.microsoft.com/office/drawing/2014/main" id="{01DC6921-6E3D-49C1-B77F-EBE2BB3AFB24}"/>
+                <a16:creationId xmlns:a16="http://schemas.microsoft.com/office/drawing/2014/main" id="{D2FC2F97-06D6-487E-9E98-F0CF5DE466C2}"/>
               </a:ext>
             </a:extLst>
           </p:cNvPr>
@@ -6795,7 +6795,7 @@
           <p:cNvPr id="2" name="">
             <a:extLst xmlns:a="http://schemas.openxmlformats.org/drawingml/2006/main">
               <a:ext uri="{FF2B5EF4-FFF2-40B4-BE49-F238E27FC236}">
-                <a16:creationId xmlns:a16="http://schemas.microsoft.com/office/drawing/2014/main" id="{5DE53B3B-1E11-495E-98FC-DE65910F8C64}"/>
+                <a16:creationId xmlns:a16="http://schemas.microsoft.com/office/drawing/2014/main" id="{83419D17-B4D7-4165-9735-337C01851BCC}"/>
               </a:ext>
             </a:extLst>
           </p:cNvPr>
@@ -6862,7 +6862,7 @@
           <p:cNvPr id="3" name="">
             <a:extLst xmlns:a="http://schemas.openxmlformats.org/drawingml/2006/main">
               <a:ext uri="{FF2B5EF4-FFF2-40B4-BE49-F238E27FC236}">
-                <a16:creationId xmlns:a16="http://schemas.microsoft.com/office/drawing/2014/main" id="{59C4734B-514E-419D-B2F6-3847209B9083}"/>
+                <a16:creationId xmlns:a16="http://schemas.microsoft.com/office/drawing/2014/main" id="{72A1FB3E-EF37-4DB3-804E-05DC48017ACD}"/>
               </a:ext>
             </a:extLst>
           </p:cNvPr>
@@ -6929,7 +6929,7 @@
           <p:cNvPr id="4" name="">
             <a:extLst xmlns:a="http://schemas.openxmlformats.org/drawingml/2006/main">
               <a:ext uri="{FF2B5EF4-FFF2-40B4-BE49-F238E27FC236}">
-                <a16:creationId xmlns:a16="http://schemas.microsoft.com/office/drawing/2014/main" id="{4513E10F-7FD3-4729-9EE8-9302C9B66AFA}"/>
+                <a16:creationId xmlns:a16="http://schemas.microsoft.com/office/drawing/2014/main" id="{95640057-32A9-4CDE-8CAF-9C8508E5D491}"/>
               </a:ext>
             </a:extLst>
           </p:cNvPr>
@@ -6960,7 +6960,7 @@
           <p:cNvPr id="5" name="">
             <a:extLst xmlns:a="http://schemas.openxmlformats.org/drawingml/2006/main">
               <a:ext uri="{FF2B5EF4-FFF2-40B4-BE49-F238E27FC236}">
-                <a16:creationId xmlns:a16="http://schemas.microsoft.com/office/drawing/2014/main" id="{03124CB6-7559-4A83-AB54-CCD1EA6215AC}"/>
+                <a16:creationId xmlns:a16="http://schemas.microsoft.com/office/drawing/2014/main" id="{79569B78-35F0-466D-8891-22D1A755C95F}"/>
               </a:ext>
             </a:extLst>
           </p:cNvPr>
@@ -7017,7 +7017,7 @@
                 <a:ea typeface="Aptos"/>
                 <a:cs typeface="Aptos"/>
               </a:rPr>
-              <a:t>INERTIA-2026-10-23-r7 · 23 October 2026 · Autonomous build</a:t>
+              <a:t>INERTIA-2026-10-23-r8 · 23 October 2026 · Autonomous build</a:t>
             </a:r>
           </a:p>
         </p:txBody>
@@ -7027,7 +7027,7 @@
           <p:cNvPr id="6" name="">
             <a:extLst xmlns:a="http://schemas.openxmlformats.org/drawingml/2006/main">
               <a:ext uri="{FF2B5EF4-FFF2-40B4-BE49-F238E27FC236}">
-                <a16:creationId xmlns:a16="http://schemas.microsoft.com/office/drawing/2014/main" id="{9F55A98B-27B7-4926-82D6-0B633EC78C76}"/>
+                <a16:creationId xmlns:a16="http://schemas.microsoft.com/office/drawing/2014/main" id="{7DED4A85-CE34-4979-B183-F73E644DBC85}"/>
               </a:ext>
             </a:extLst>
           </p:cNvPr>
@@ -7094,7 +7094,7 @@
           <p:cNvPr id="7" name="">
             <a:extLst xmlns:a="http://schemas.openxmlformats.org/drawingml/2006/main">
               <a:ext uri="{FF2B5EF4-FFF2-40B4-BE49-F238E27FC236}">
-                <a16:creationId xmlns:a16="http://schemas.microsoft.com/office/drawing/2014/main" id="{C989028D-C5A1-44AC-98B9-F522566AB8F3}"/>
+                <a16:creationId xmlns:a16="http://schemas.microsoft.com/office/drawing/2014/main" id="{5B640562-795E-408A-B585-4034E91F00FD}"/>
               </a:ext>
             </a:extLst>
           </p:cNvPr>
@@ -7127,7 +7127,7 @@
           <p:cNvPr id="8" name="">
             <a:extLst xmlns:a="http://schemas.openxmlformats.org/drawingml/2006/main">
               <a:ext uri="{FF2B5EF4-FFF2-40B4-BE49-F238E27FC236}">
-                <a16:creationId xmlns:a16="http://schemas.microsoft.com/office/drawing/2014/main" id="{06929054-E808-44A2-BA67-FD4F1878760E}"/>
+                <a16:creationId xmlns:a16="http://schemas.microsoft.com/office/drawing/2014/main" id="{156F1506-26F9-4B61-BAEC-7F29B4E414FF}"/>
               </a:ext>
             </a:extLst>
           </p:cNvPr>
@@ -7194,7 +7194,7 @@
           <p:cNvPr id="9" name="">
             <a:extLst xmlns:a="http://schemas.openxmlformats.org/drawingml/2006/main">
               <a:ext uri="{FF2B5EF4-FFF2-40B4-BE49-F238E27FC236}">
-                <a16:creationId xmlns:a16="http://schemas.microsoft.com/office/drawing/2014/main" id="{99361BDF-B9DB-47A2-BDBE-C6CBEC1C22C3}"/>
+                <a16:creationId xmlns:a16="http://schemas.microsoft.com/office/drawing/2014/main" id="{FACA406C-30FA-4F89-B70B-44F16C2ECC0D}"/>
               </a:ext>
             </a:extLst>
           </p:cNvPr>
@@ -7274,7 +7274,7 @@
                 <a:ea typeface="Aptos"/>
                 <a:cs typeface="Aptos"/>
               </a:rPr>
-              <a:t>Check deadline and eligibility</a:t>
+              <a:t>Retrieve authorized DAO facts</a:t>
             </a:r>
           </a:p>
           <a:p xmlns:a="http://schemas.openxmlformats.org/drawingml/2006/main">
@@ -7297,7 +7297,7 @@
                 <a:ea typeface="Aptos"/>
                 <a:cs typeface="Aptos"/>
               </a:rPr>
-              <a:t>Build a cited draft packet</a:t>
+              <a:t>Build a cited, eligible packet</a:t>
             </a:r>
           </a:p>
           <a:p xmlns:a="http://schemas.openxmlformats.org/drawingml/2006/main">
@@ -7330,7 +7330,7 @@
           <p:cNvPr id="10" name="">
             <a:extLst xmlns:a="http://schemas.openxmlformats.org/drawingml/2006/main">
               <a:ext uri="{FF2B5EF4-FFF2-40B4-BE49-F238E27FC236}">
-                <a16:creationId xmlns:a16="http://schemas.microsoft.com/office/drawing/2014/main" id="{B14E1725-29FC-492E-9F4D-3E5CEFAE2B58}"/>
+                <a16:creationId xmlns:a16="http://schemas.microsoft.com/office/drawing/2014/main" id="{7A0059C5-02AF-48DA-A26B-D94D0E9553F5}"/>
               </a:ext>
             </a:extLst>
           </p:cNvPr>
@@ -7363,7 +7363,7 @@
           <p:cNvPr id="11" name="">
             <a:extLst xmlns:a="http://schemas.openxmlformats.org/drawingml/2006/main">
               <a:ext uri="{FF2B5EF4-FFF2-40B4-BE49-F238E27FC236}">
-                <a16:creationId xmlns:a16="http://schemas.microsoft.com/office/drawing/2014/main" id="{F5B617B6-2AAB-454B-933E-8788E506B26A}"/>
+                <a16:creationId xmlns:a16="http://schemas.microsoft.com/office/drawing/2014/main" id="{90A4E9AD-D135-4F46-9AF3-15DE6FE12506}"/>
               </a:ext>
             </a:extLst>
           </p:cNvPr>
@@ -7430,7 +7430,7 @@
           <p:cNvPr id="12" name="">
             <a:extLst xmlns:a="http://schemas.openxmlformats.org/drawingml/2006/main">
               <a:ext uri="{FF2B5EF4-FFF2-40B4-BE49-F238E27FC236}">
-                <a16:creationId xmlns:a16="http://schemas.microsoft.com/office/drawing/2014/main" id="{E7680E9C-7E60-44E0-8F0F-585CC9AE416D}"/>
+                <a16:creationId xmlns:a16="http://schemas.microsoft.com/office/drawing/2014/main" id="{1E8635C9-7055-41C5-BADD-A2E8D6EAB3F9}"/>
               </a:ext>
             </a:extLst>
           </p:cNvPr>
@@ -7510,7 +7510,7 @@
                 <a:ea typeface="Aptos"/>
                 <a:cs typeface="Aptos"/>
               </a:rPr>
-              <a:t>Verify network and finality</a:t>
+              <a:t>Verify required voting stages</a:t>
             </a:r>
           </a:p>
           <a:p xmlns:a="http://schemas.openxmlformats.org/drawingml/2006/main">
@@ -7533,7 +7533,7 @@
                 <a:ea typeface="Aptos"/>
                 <a:cs typeface="Aptos"/>
               </a:rPr>
-              <a:t>Match the authorized action</a:t>
+              <a:t>Match network and authorized action</a:t>
             </a:r>
           </a:p>
           <a:p xmlns:a="http://schemas.openxmlformats.org/drawingml/2006/main">
@@ -7566,7 +7566,7 @@
           <p:cNvPr id="13" name="">
             <a:extLst xmlns:a="http://schemas.openxmlformats.org/drawingml/2006/main">
               <a:ext uri="{FF2B5EF4-FFF2-40B4-BE49-F238E27FC236}">
-                <a16:creationId xmlns:a16="http://schemas.microsoft.com/office/drawing/2014/main" id="{442DE98C-7B7F-4898-B100-6BF8B9074F78}"/>
+                <a16:creationId xmlns:a16="http://schemas.microsoft.com/office/drawing/2014/main" id="{7AA7BC55-6800-4838-BD72-2B0EF7E19323}"/>
               </a:ext>
             </a:extLst>
           </p:cNvPr>
@@ -7599,7 +7599,7 @@
           <p:cNvPr id="14" name="">
             <a:extLst xmlns:a="http://schemas.openxmlformats.org/drawingml/2006/main">
               <a:ext uri="{FF2B5EF4-FFF2-40B4-BE49-F238E27FC236}">
-                <a16:creationId xmlns:a16="http://schemas.microsoft.com/office/drawing/2014/main" id="{100CDD26-91C4-46B0-9C01-515EB159A4CC}"/>
+                <a16:creationId xmlns:a16="http://schemas.microsoft.com/office/drawing/2014/main" id="{13749A35-8A2C-4117-BB77-20908F30A127}"/>
               </a:ext>
             </a:extLst>
           </p:cNvPr>
@@ -7666,7 +7666,7 @@
           <p:cNvPr id="15" name="">
             <a:extLst xmlns:a="http://schemas.openxmlformats.org/drawingml/2006/main">
               <a:ext uri="{FF2B5EF4-FFF2-40B4-BE49-F238E27FC236}">
-                <a16:creationId xmlns:a16="http://schemas.microsoft.com/office/drawing/2014/main" id="{D0D245FA-627E-4331-B5DF-B8E13DC0CD8A}"/>
+                <a16:creationId xmlns:a16="http://schemas.microsoft.com/office/drawing/2014/main" id="{0BC1D98C-E8B9-4AB4-9738-AB7F2445E98B}"/>
               </a:ext>
             </a:extLst>
           </p:cNvPr>
@@ -7802,7 +7802,7 @@
           <p:cNvPr id="16" name="">
             <a:extLst xmlns:a="http://schemas.openxmlformats.org/drawingml/2006/main">
               <a:ext uri="{FF2B5EF4-FFF2-40B4-BE49-F238E27FC236}">
-                <a16:creationId xmlns:a16="http://schemas.microsoft.com/office/drawing/2014/main" id="{8C918133-2949-4E57-B0E4-632E9309C7C9}"/>
+                <a16:creationId xmlns:a16="http://schemas.microsoft.com/office/drawing/2014/main" id="{CD148134-573F-4265-A64F-F71B77D3F8E6}"/>
               </a:ext>
             </a:extLst>
           </p:cNvPr>
@@ -7867,7 +7867,7 @@
     </p:spTree>
     <p:extLst>
       <p:ext uri="{BB962C8B-B14F-4D97-AF65-F5344CB8AC3E}">
-        <p14:creationId xmlns:p14="http://schemas.microsoft.com/office/powerpoint/2010/main" val="321599319"/>
+        <p14:creationId xmlns:p14="http://schemas.microsoft.com/office/powerpoint/2010/main" val="1111305753"/>
       </p:ext>
     </p:extLst>
   </p:cSld>
@@ -7898,7 +7898,7 @@
           <p:cNvPr id="17" name="">
             <a:extLst xmlns:a="http://schemas.openxmlformats.org/drawingml/2006/main">
               <a:ext uri="{FF2B5EF4-FFF2-40B4-BE49-F238E27FC236}">
-                <a16:creationId xmlns:a16="http://schemas.microsoft.com/office/drawing/2014/main" id="{ED2DC141-D254-4DE5-BD71-76EF407D31E2}"/>
+                <a16:creationId xmlns:a16="http://schemas.microsoft.com/office/drawing/2014/main" id="{7C7ACC79-1CF0-4DC2-8EC7-411BBF6B5B22}"/>
               </a:ext>
             </a:extLst>
           </p:cNvPr>
@@ -7965,7 +7965,7 @@
           <p:cNvPr id="2" name="">
             <a:extLst xmlns:a="http://schemas.openxmlformats.org/drawingml/2006/main">
               <a:ext uri="{FF2B5EF4-FFF2-40B4-BE49-F238E27FC236}">
-                <a16:creationId xmlns:a16="http://schemas.microsoft.com/office/drawing/2014/main" id="{D9D038F5-85DB-4E70-BD88-0E1621BEE5A8}"/>
+                <a16:creationId xmlns:a16="http://schemas.microsoft.com/office/drawing/2014/main" id="{C2E15DEA-F77A-4650-9924-2883B31F64E1}"/>
               </a:ext>
             </a:extLst>
           </p:cNvPr>
@@ -8032,7 +8032,7 @@
           <p:cNvPr id="3" name="">
             <a:extLst xmlns:a="http://schemas.openxmlformats.org/drawingml/2006/main">
               <a:ext uri="{FF2B5EF4-FFF2-40B4-BE49-F238E27FC236}">
-                <a16:creationId xmlns:a16="http://schemas.microsoft.com/office/drawing/2014/main" id="{BC184259-C62C-402F-B013-77FA9FEE6B7B}"/>
+                <a16:creationId xmlns:a16="http://schemas.microsoft.com/office/drawing/2014/main" id="{E3AD4525-7F46-4FAF-B3E9-449D65752DE1}"/>
               </a:ext>
             </a:extLst>
           </p:cNvPr>
@@ -8099,7 +8099,7 @@
           <p:cNvPr id="4" name="">
             <a:extLst xmlns:a="http://schemas.openxmlformats.org/drawingml/2006/main">
               <a:ext uri="{FF2B5EF4-FFF2-40B4-BE49-F238E27FC236}">
-                <a16:creationId xmlns:a16="http://schemas.microsoft.com/office/drawing/2014/main" id="{F990F645-E639-4397-8E4F-03F21AAC0720}"/>
+                <a16:creationId xmlns:a16="http://schemas.microsoft.com/office/drawing/2014/main" id="{961761AB-B452-4F84-99B9-FF1857A2655F}"/>
               </a:ext>
             </a:extLst>
           </p:cNvPr>
@@ -8130,7 +8130,7 @@
           <p:cNvPr id="5" name="">
             <a:extLst xmlns:a="http://schemas.openxmlformats.org/drawingml/2006/main">
               <a:ext uri="{FF2B5EF4-FFF2-40B4-BE49-F238E27FC236}">
-                <a16:creationId xmlns:a16="http://schemas.microsoft.com/office/drawing/2014/main" id="{2CC7AEBB-DCFB-45C7-85E3-8FD384A7CDFF}"/>
+                <a16:creationId xmlns:a16="http://schemas.microsoft.com/office/drawing/2014/main" id="{9AD01EC8-DCAD-4BA4-9CBC-6E48A58F990D}"/>
               </a:ext>
             </a:extLst>
           </p:cNvPr>
@@ -8187,7 +8187,7 @@
                 <a:ea typeface="Aptos"/>
                 <a:cs typeface="Aptos"/>
               </a:rPr>
-              <a:t>INERTIA-2026-10-23-r7 · 23 October 2026 · Autonomous build</a:t>
+              <a:t>INERTIA-2026-10-23-r8 · 23 October 2026 · Autonomous build</a:t>
             </a:r>
           </a:p>
         </p:txBody>
@@ -8197,7 +8197,7 @@
           <p:cNvPr id="6" name="">
             <a:extLst xmlns:a="http://schemas.openxmlformats.org/drawingml/2006/main">
               <a:ext uri="{FF2B5EF4-FFF2-40B4-BE49-F238E27FC236}">
-                <a16:creationId xmlns:a16="http://schemas.microsoft.com/office/drawing/2014/main" id="{BB1CBF1F-B28A-49CC-8A5C-0435571F040E}"/>
+                <a16:creationId xmlns:a16="http://schemas.microsoft.com/office/drawing/2014/main" id="{B13C95D2-C3B8-48D0-BE0C-145062C685E8}"/>
               </a:ext>
             </a:extLst>
           </p:cNvPr>
@@ -8264,7 +8264,7 @@
           <p:cNvPr id="7" name="">
             <a:extLst xmlns:a="http://schemas.openxmlformats.org/drawingml/2006/main">
               <a:ext uri="{FF2B5EF4-FFF2-40B4-BE49-F238E27FC236}">
-                <a16:creationId xmlns:a16="http://schemas.microsoft.com/office/drawing/2014/main" id="{E3486E29-1A85-4932-A63A-EF2E664E9016}"/>
+                <a16:creationId xmlns:a16="http://schemas.microsoft.com/office/drawing/2014/main" id="{49CC084F-3B85-481C-B48F-47A4B8C7D756}"/>
               </a:ext>
             </a:extLst>
           </p:cNvPr>
@@ -8297,7 +8297,7 @@
           <p:cNvPr id="8" name="">
             <a:extLst xmlns:a="http://schemas.openxmlformats.org/drawingml/2006/main">
               <a:ext uri="{FF2B5EF4-FFF2-40B4-BE49-F238E27FC236}">
-                <a16:creationId xmlns:a16="http://schemas.microsoft.com/office/drawing/2014/main" id="{BD91FFC3-388A-4CC5-AC05-690B1E24E1BE}"/>
+                <a16:creationId xmlns:a16="http://schemas.microsoft.com/office/drawing/2014/main" id="{B12F790B-66E3-4E62-B9F3-06E9A3503C64}"/>
               </a:ext>
             </a:extLst>
           </p:cNvPr>
@@ -8364,7 +8364,7 @@
           <p:cNvPr id="9" name="">
             <a:extLst xmlns:a="http://schemas.openxmlformats.org/drawingml/2006/main">
               <a:ext uri="{FF2B5EF4-FFF2-40B4-BE49-F238E27FC236}">
-                <a16:creationId xmlns:a16="http://schemas.microsoft.com/office/drawing/2014/main" id="{1D9C9603-C241-411B-AEE8-D90AB526881E}"/>
+                <a16:creationId xmlns:a16="http://schemas.microsoft.com/office/drawing/2014/main" id="{51A0B6D1-D035-46C2-A880-79420D738FB7}"/>
               </a:ext>
             </a:extLst>
           </p:cNvPr>
@@ -8500,7 +8500,7 @@
           <p:cNvPr id="10" name="">
             <a:extLst xmlns:a="http://schemas.openxmlformats.org/drawingml/2006/main">
               <a:ext uri="{FF2B5EF4-FFF2-40B4-BE49-F238E27FC236}">
-                <a16:creationId xmlns:a16="http://schemas.microsoft.com/office/drawing/2014/main" id="{B450DD4D-0C59-4A75-BA62-4B2317A1EC59}"/>
+                <a16:creationId xmlns:a16="http://schemas.microsoft.com/office/drawing/2014/main" id="{D2DE4B1B-1FD3-4A84-B7EF-946213685FE6}"/>
               </a:ext>
             </a:extLst>
           </p:cNvPr>
@@ -8533,7 +8533,7 @@
           <p:cNvPr id="11" name="">
             <a:extLst xmlns:a="http://schemas.openxmlformats.org/drawingml/2006/main">
               <a:ext uri="{FF2B5EF4-FFF2-40B4-BE49-F238E27FC236}">
-                <a16:creationId xmlns:a16="http://schemas.microsoft.com/office/drawing/2014/main" id="{47920630-DC1C-44FD-A160-DA26F896F7DF}"/>
+                <a16:creationId xmlns:a16="http://schemas.microsoft.com/office/drawing/2014/main" id="{C171444B-85E9-4BEC-847B-00DBA1A4B409}"/>
               </a:ext>
             </a:extLst>
           </p:cNvPr>
@@ -8600,7 +8600,7 @@
           <p:cNvPr id="12" name="">
             <a:extLst xmlns:a="http://schemas.openxmlformats.org/drawingml/2006/main">
               <a:ext uri="{FF2B5EF4-FFF2-40B4-BE49-F238E27FC236}">
-                <a16:creationId xmlns:a16="http://schemas.microsoft.com/office/drawing/2014/main" id="{7BB76621-66CA-4E7C-8B68-2BBADF10107C}"/>
+                <a16:creationId xmlns:a16="http://schemas.microsoft.com/office/drawing/2014/main" id="{ED3381AD-2A38-4B60-A263-259FC78BE451}"/>
               </a:ext>
             </a:extLst>
           </p:cNvPr>
@@ -8736,7 +8736,7 @@
           <p:cNvPr id="13" name="">
             <a:extLst xmlns:a="http://schemas.openxmlformats.org/drawingml/2006/main">
               <a:ext uri="{FF2B5EF4-FFF2-40B4-BE49-F238E27FC236}">
-                <a16:creationId xmlns:a16="http://schemas.microsoft.com/office/drawing/2014/main" id="{7537C6E8-5FDC-4695-A315-C5F042ABBD8B}"/>
+                <a16:creationId xmlns:a16="http://schemas.microsoft.com/office/drawing/2014/main" id="{2FE5E843-8E02-486A-B4AF-0BDD3BF57AFC}"/>
               </a:ext>
             </a:extLst>
           </p:cNvPr>
@@ -8769,7 +8769,7 @@
           <p:cNvPr id="14" name="">
             <a:extLst xmlns:a="http://schemas.openxmlformats.org/drawingml/2006/main">
               <a:ext uri="{FF2B5EF4-FFF2-40B4-BE49-F238E27FC236}">
-                <a16:creationId xmlns:a16="http://schemas.microsoft.com/office/drawing/2014/main" id="{99B727E6-9693-45B3-A114-23FF70516691}"/>
+                <a16:creationId xmlns:a16="http://schemas.microsoft.com/office/drawing/2014/main" id="{E6FBA71D-F0FD-4F35-9841-0EA6CD066D19}"/>
               </a:ext>
             </a:extLst>
           </p:cNvPr>
@@ -8836,7 +8836,7 @@
           <p:cNvPr id="15" name="">
             <a:extLst xmlns:a="http://schemas.openxmlformats.org/drawingml/2006/main">
               <a:ext uri="{FF2B5EF4-FFF2-40B4-BE49-F238E27FC236}">
-                <a16:creationId xmlns:a16="http://schemas.microsoft.com/office/drawing/2014/main" id="{CA1D98ED-45D6-476F-A6A0-17312C98205F}"/>
+                <a16:creationId xmlns:a16="http://schemas.microsoft.com/office/drawing/2014/main" id="{7253CC27-0E99-44C1-99B0-733914F5B148}"/>
               </a:ext>
             </a:extLst>
           </p:cNvPr>
@@ -8972,7 +8972,7 @@
           <p:cNvPr id="16" name="">
             <a:extLst xmlns:a="http://schemas.openxmlformats.org/drawingml/2006/main">
               <a:ext uri="{FF2B5EF4-FFF2-40B4-BE49-F238E27FC236}">
-                <a16:creationId xmlns:a16="http://schemas.microsoft.com/office/drawing/2014/main" id="{7C3EEFB9-D08E-4A71-8ACE-A5F9A402742C}"/>
+                <a16:creationId xmlns:a16="http://schemas.microsoft.com/office/drawing/2014/main" id="{A9ED2172-14D0-455D-A2D3-AF963514CDB2}"/>
               </a:ext>
             </a:extLst>
           </p:cNvPr>
@@ -9037,7 +9037,7 @@
     </p:spTree>
     <p:extLst>
       <p:ext uri="{BB962C8B-B14F-4D97-AF65-F5344CB8AC3E}">
-        <p14:creationId xmlns:p14="http://schemas.microsoft.com/office/powerpoint/2010/main" val="2123739644"/>
+        <p14:creationId xmlns:p14="http://schemas.microsoft.com/office/powerpoint/2010/main" val="204132117"/>
       </p:ext>
     </p:extLst>
   </p:cSld>
@@ -9068,7 +9068,7 @@
           <p:cNvPr id="17" name="">
             <a:extLst xmlns:a="http://schemas.openxmlformats.org/drawingml/2006/main">
               <a:ext uri="{FF2B5EF4-FFF2-40B4-BE49-F238E27FC236}">
-                <a16:creationId xmlns:a16="http://schemas.microsoft.com/office/drawing/2014/main" id="{B3B4703C-6380-4DB5-9C85-7BF843F514F7}"/>
+                <a16:creationId xmlns:a16="http://schemas.microsoft.com/office/drawing/2014/main" id="{4ECA6908-0C5F-494D-8E37-4F50D6B7F590}"/>
               </a:ext>
             </a:extLst>
           </p:cNvPr>
@@ -9135,7 +9135,7 @@
           <p:cNvPr id="2" name="">
             <a:extLst xmlns:a="http://schemas.openxmlformats.org/drawingml/2006/main">
               <a:ext uri="{FF2B5EF4-FFF2-40B4-BE49-F238E27FC236}">
-                <a16:creationId xmlns:a16="http://schemas.microsoft.com/office/drawing/2014/main" id="{A471F36B-5B6B-47F9-A74C-9F87BE678B7C}"/>
+                <a16:creationId xmlns:a16="http://schemas.microsoft.com/office/drawing/2014/main" id="{DA08906D-7451-4BA2-8EE7-1AFFD273B74B}"/>
               </a:ext>
             </a:extLst>
           </p:cNvPr>
@@ -9202,7 +9202,7 @@
           <p:cNvPr id="3" name="">
             <a:extLst xmlns:a="http://schemas.openxmlformats.org/drawingml/2006/main">
               <a:ext uri="{FF2B5EF4-FFF2-40B4-BE49-F238E27FC236}">
-                <a16:creationId xmlns:a16="http://schemas.microsoft.com/office/drawing/2014/main" id="{9AF09CB2-CCE7-43D8-B3F9-7B85C37BBD84}"/>
+                <a16:creationId xmlns:a16="http://schemas.microsoft.com/office/drawing/2014/main" id="{098446B2-A9A7-4DB0-BFFB-B219131CE2FC}"/>
               </a:ext>
             </a:extLst>
           </p:cNvPr>
@@ -9269,7 +9269,7 @@
           <p:cNvPr id="4" name="">
             <a:extLst xmlns:a="http://schemas.openxmlformats.org/drawingml/2006/main">
               <a:ext uri="{FF2B5EF4-FFF2-40B4-BE49-F238E27FC236}">
-                <a16:creationId xmlns:a16="http://schemas.microsoft.com/office/drawing/2014/main" id="{CE780204-1B19-43AA-9A69-460FA2652455}"/>
+                <a16:creationId xmlns:a16="http://schemas.microsoft.com/office/drawing/2014/main" id="{B28AA077-B11C-4848-A968-11FA6A0A46D4}"/>
               </a:ext>
             </a:extLst>
           </p:cNvPr>
@@ -9300,7 +9300,7 @@
           <p:cNvPr id="5" name="">
             <a:extLst xmlns:a="http://schemas.openxmlformats.org/drawingml/2006/main">
               <a:ext uri="{FF2B5EF4-FFF2-40B4-BE49-F238E27FC236}">
-                <a16:creationId xmlns:a16="http://schemas.microsoft.com/office/drawing/2014/main" id="{0235216B-9D63-4B73-BB56-B68EBBBFACC0}"/>
+                <a16:creationId xmlns:a16="http://schemas.microsoft.com/office/drawing/2014/main" id="{8B927C7B-43DD-406E-998A-30B6075D238A}"/>
               </a:ext>
             </a:extLst>
           </p:cNvPr>
@@ -9357,7 +9357,7 @@
                 <a:ea typeface="Aptos"/>
                 <a:cs typeface="Aptos"/>
               </a:rPr>
-              <a:t>INERTIA-2026-10-23-r7 · 23 October 2026 · Autonomous build</a:t>
+              <a:t>INERTIA-2026-10-23-r8 · 23 October 2026 · Autonomous build</a:t>
             </a:r>
           </a:p>
         </p:txBody>
@@ -9367,7 +9367,7 @@
           <p:cNvPr id="6" name="">
             <a:extLst xmlns:a="http://schemas.openxmlformats.org/drawingml/2006/main">
               <a:ext uri="{FF2B5EF4-FFF2-40B4-BE49-F238E27FC236}">
-                <a16:creationId xmlns:a16="http://schemas.microsoft.com/office/drawing/2014/main" id="{1859E5AC-3CE7-4068-86F1-41FE801FCB43}"/>
+                <a16:creationId xmlns:a16="http://schemas.microsoft.com/office/drawing/2014/main" id="{5BB58851-73DB-4E6F-B57A-89EA103CF554}"/>
               </a:ext>
             </a:extLst>
           </p:cNvPr>
@@ -9434,7 +9434,7 @@
           <p:cNvPr id="7" name="">
             <a:extLst xmlns:a="http://schemas.openxmlformats.org/drawingml/2006/main">
               <a:ext uri="{FF2B5EF4-FFF2-40B4-BE49-F238E27FC236}">
-                <a16:creationId xmlns:a16="http://schemas.microsoft.com/office/drawing/2014/main" id="{D4C981A4-6F99-47F3-A096-2CD9D2DA7B57}"/>
+                <a16:creationId xmlns:a16="http://schemas.microsoft.com/office/drawing/2014/main" id="{55581CA9-0659-487C-A0A4-5EC597FA957D}"/>
               </a:ext>
             </a:extLst>
           </p:cNvPr>
@@ -9467,7 +9467,7 @@
           <p:cNvPr id="8" name="">
             <a:extLst xmlns:a="http://schemas.openxmlformats.org/drawingml/2006/main">
               <a:ext uri="{FF2B5EF4-FFF2-40B4-BE49-F238E27FC236}">
-                <a16:creationId xmlns:a16="http://schemas.microsoft.com/office/drawing/2014/main" id="{58CD9F90-2BB7-493A-A78A-12BBC740E41D}"/>
+                <a16:creationId xmlns:a16="http://schemas.microsoft.com/office/drawing/2014/main" id="{07AF1F00-7C90-4503-A9CE-9436544F8EE1}"/>
               </a:ext>
             </a:extLst>
           </p:cNvPr>
@@ -9534,7 +9534,7 @@
           <p:cNvPr id="9" name="">
             <a:extLst xmlns:a="http://schemas.openxmlformats.org/drawingml/2006/main">
               <a:ext uri="{FF2B5EF4-FFF2-40B4-BE49-F238E27FC236}">
-                <a16:creationId xmlns:a16="http://schemas.microsoft.com/office/drawing/2014/main" id="{EFF0F005-C273-4DA2-8A52-7200348FA2B3}"/>
+                <a16:creationId xmlns:a16="http://schemas.microsoft.com/office/drawing/2014/main" id="{D02F411D-1D3A-4868-8541-42DE864F4EB5}"/>
               </a:ext>
             </a:extLst>
           </p:cNvPr>
@@ -9670,7 +9670,7 @@
           <p:cNvPr id="10" name="">
             <a:extLst xmlns:a="http://schemas.openxmlformats.org/drawingml/2006/main">
               <a:ext uri="{FF2B5EF4-FFF2-40B4-BE49-F238E27FC236}">
-                <a16:creationId xmlns:a16="http://schemas.microsoft.com/office/drawing/2014/main" id="{2EE7951A-2B99-420A-925A-0F37A4D128AF}"/>
+                <a16:creationId xmlns:a16="http://schemas.microsoft.com/office/drawing/2014/main" id="{1DB3F7D5-698C-41DB-88E9-9FFE9FC45EAB}"/>
               </a:ext>
             </a:extLst>
           </p:cNvPr>
@@ -9703,7 +9703,7 @@
           <p:cNvPr id="11" name="">
             <a:extLst xmlns:a="http://schemas.openxmlformats.org/drawingml/2006/main">
               <a:ext uri="{FF2B5EF4-FFF2-40B4-BE49-F238E27FC236}">
-                <a16:creationId xmlns:a16="http://schemas.microsoft.com/office/drawing/2014/main" id="{9362A06D-DD7C-4EB7-993D-1C9F1C422298}"/>
+                <a16:creationId xmlns:a16="http://schemas.microsoft.com/office/drawing/2014/main" id="{052D0783-38CD-4CCA-8286-76246F4DFFD8}"/>
               </a:ext>
             </a:extLst>
           </p:cNvPr>
@@ -9770,7 +9770,7 @@
           <p:cNvPr id="12" name="">
             <a:extLst xmlns:a="http://schemas.openxmlformats.org/drawingml/2006/main">
               <a:ext uri="{FF2B5EF4-FFF2-40B4-BE49-F238E27FC236}">
-                <a16:creationId xmlns:a16="http://schemas.microsoft.com/office/drawing/2014/main" id="{5EDD8827-F4E9-4C22-B40E-FEF00E895B01}"/>
+                <a16:creationId xmlns:a16="http://schemas.microsoft.com/office/drawing/2014/main" id="{A271BE8C-5870-434A-8438-5F2B10EE9935}"/>
               </a:ext>
             </a:extLst>
           </p:cNvPr>
@@ -9906,7 +9906,7 @@
           <p:cNvPr id="13" name="">
             <a:extLst xmlns:a="http://schemas.openxmlformats.org/drawingml/2006/main">
               <a:ext uri="{FF2B5EF4-FFF2-40B4-BE49-F238E27FC236}">
-                <a16:creationId xmlns:a16="http://schemas.microsoft.com/office/drawing/2014/main" id="{ADE00A3D-7A7E-46BB-8400-3C94B843FD0C}"/>
+                <a16:creationId xmlns:a16="http://schemas.microsoft.com/office/drawing/2014/main" id="{B698E0E1-3059-4971-9916-4D45215F8DE8}"/>
               </a:ext>
             </a:extLst>
           </p:cNvPr>
@@ -9939,7 +9939,7 @@
           <p:cNvPr id="14" name="">
             <a:extLst xmlns:a="http://schemas.openxmlformats.org/drawingml/2006/main">
               <a:ext uri="{FF2B5EF4-FFF2-40B4-BE49-F238E27FC236}">
-                <a16:creationId xmlns:a16="http://schemas.microsoft.com/office/drawing/2014/main" id="{0C78BD01-8E6C-496A-86B1-8587DA887D68}"/>
+                <a16:creationId xmlns:a16="http://schemas.microsoft.com/office/drawing/2014/main" id="{319ECE07-EEBC-4DFC-A69B-280E4BD51502}"/>
               </a:ext>
             </a:extLst>
           </p:cNvPr>
@@ -10006,7 +10006,7 @@
           <p:cNvPr id="15" name="">
             <a:extLst xmlns:a="http://schemas.openxmlformats.org/drawingml/2006/main">
               <a:ext uri="{FF2B5EF4-FFF2-40B4-BE49-F238E27FC236}">
-                <a16:creationId xmlns:a16="http://schemas.microsoft.com/office/drawing/2014/main" id="{3F701368-6612-47BA-A09E-DF5B0B7294D9}"/>
+                <a16:creationId xmlns:a16="http://schemas.microsoft.com/office/drawing/2014/main" id="{1823D53F-79D7-4286-A48B-4D0F116BA8C8}"/>
               </a:ext>
             </a:extLst>
           </p:cNvPr>
@@ -10142,7 +10142,7 @@
           <p:cNvPr id="16" name="">
             <a:extLst xmlns:a="http://schemas.openxmlformats.org/drawingml/2006/main">
               <a:ext uri="{FF2B5EF4-FFF2-40B4-BE49-F238E27FC236}">
-                <a16:creationId xmlns:a16="http://schemas.microsoft.com/office/drawing/2014/main" id="{95F268FE-615B-4B0E-B778-926E0D57BA5B}"/>
+                <a16:creationId xmlns:a16="http://schemas.microsoft.com/office/drawing/2014/main" id="{AF4115EA-0035-4234-AB15-465CC631EDCE}"/>
               </a:ext>
             </a:extLst>
           </p:cNvPr>
@@ -10207,7 +10207,7 @@
     </p:spTree>
     <p:extLst>
       <p:ext uri="{BB962C8B-B14F-4D97-AF65-F5344CB8AC3E}">
-        <p14:creationId xmlns:p14="http://schemas.microsoft.com/office/powerpoint/2010/main" val="1265001805"/>
+        <p14:creationId xmlns:p14="http://schemas.microsoft.com/office/powerpoint/2010/main" val="1558554149"/>
       </p:ext>
     </p:extLst>
   </p:cSld>
@@ -10238,7 +10238,7 @@
           <p:cNvPr id="17" name="">
             <a:extLst xmlns:a="http://schemas.openxmlformats.org/drawingml/2006/main">
               <a:ext uri="{FF2B5EF4-FFF2-40B4-BE49-F238E27FC236}">
-                <a16:creationId xmlns:a16="http://schemas.microsoft.com/office/drawing/2014/main" id="{663A0F38-B73F-4B71-AD7B-292F0DFA67E0}"/>
+                <a16:creationId xmlns:a16="http://schemas.microsoft.com/office/drawing/2014/main" id="{6BDD18E3-0173-4FF7-BCD6-06267BFFE6C7}"/>
               </a:ext>
             </a:extLst>
           </p:cNvPr>
@@ -10305,7 +10305,7 @@
           <p:cNvPr id="2" name="">
             <a:extLst xmlns:a="http://schemas.openxmlformats.org/drawingml/2006/main">
               <a:ext uri="{FF2B5EF4-FFF2-40B4-BE49-F238E27FC236}">
-                <a16:creationId xmlns:a16="http://schemas.microsoft.com/office/drawing/2014/main" id="{5137B871-C8CB-4528-A968-63C3B3AE9E7B}"/>
+                <a16:creationId xmlns:a16="http://schemas.microsoft.com/office/drawing/2014/main" id="{8D1A63DD-2F71-459B-992C-9E6690BF480F}"/>
               </a:ext>
             </a:extLst>
           </p:cNvPr>
@@ -10372,7 +10372,7 @@
           <p:cNvPr id="3" name="">
             <a:extLst xmlns:a="http://schemas.openxmlformats.org/drawingml/2006/main">
               <a:ext uri="{FF2B5EF4-FFF2-40B4-BE49-F238E27FC236}">
-                <a16:creationId xmlns:a16="http://schemas.microsoft.com/office/drawing/2014/main" id="{EC123BF2-95A5-4DF3-8145-D32045B3FA84}"/>
+                <a16:creationId xmlns:a16="http://schemas.microsoft.com/office/drawing/2014/main" id="{CD835C1E-DAA9-47C2-B935-F934F1DDBCE5}"/>
               </a:ext>
             </a:extLst>
           </p:cNvPr>
@@ -10429,7 +10429,7 @@
                 <a:ea typeface="Aptos"/>
                 <a:cs typeface="Aptos"/>
               </a:rPr>
-              <a:t>Grant packet binding and installable-package qualification extend the connected loop.</a:t>
+              <a:t>A reproducible source-checkout rehearsal joins the meeting, signed bridge and grant cores.</a:t>
             </a:r>
           </a:p>
         </p:txBody>
@@ -10439,7 +10439,7 @@
           <p:cNvPr id="4" name="">
             <a:extLst xmlns:a="http://schemas.openxmlformats.org/drawingml/2006/main">
               <a:ext uri="{FF2B5EF4-FFF2-40B4-BE49-F238E27FC236}">
-                <a16:creationId xmlns:a16="http://schemas.microsoft.com/office/drawing/2014/main" id="{55F576AF-4BD2-4AA1-AF73-C9F378045DF9}"/>
+                <a16:creationId xmlns:a16="http://schemas.microsoft.com/office/drawing/2014/main" id="{665F0A8B-8314-43E1-91FA-C50D2A9A8B03}"/>
               </a:ext>
             </a:extLst>
           </p:cNvPr>
@@ -10470,7 +10470,7 @@
           <p:cNvPr id="5" name="">
             <a:extLst xmlns:a="http://schemas.openxmlformats.org/drawingml/2006/main">
               <a:ext uri="{FF2B5EF4-FFF2-40B4-BE49-F238E27FC236}">
-                <a16:creationId xmlns:a16="http://schemas.microsoft.com/office/drawing/2014/main" id="{25D9C22E-FC38-4A89-9D73-681B6C592327}"/>
+                <a16:creationId xmlns:a16="http://schemas.microsoft.com/office/drawing/2014/main" id="{9A8A72B1-7E56-4D2D-9548-FAE08A6D5101}"/>
               </a:ext>
             </a:extLst>
           </p:cNvPr>
@@ -10527,7 +10527,7 @@
                 <a:ea typeface="Aptos"/>
                 <a:cs typeface="Aptos"/>
               </a:rPr>
-              <a:t>INERTIA-2026-10-23-r7 · 23 October 2026 · Autonomous build</a:t>
+              <a:t>INERTIA-2026-10-23-r8 · 23 October 2026 · Autonomous build</a:t>
             </a:r>
           </a:p>
         </p:txBody>
@@ -10537,7 +10537,7 @@
           <p:cNvPr id="6" name="">
             <a:extLst xmlns:a="http://schemas.openxmlformats.org/drawingml/2006/main">
               <a:ext uri="{FF2B5EF4-FFF2-40B4-BE49-F238E27FC236}">
-                <a16:creationId xmlns:a16="http://schemas.microsoft.com/office/drawing/2014/main" id="{094CDB74-4903-4445-8C21-C7C714DC88AD}"/>
+                <a16:creationId xmlns:a16="http://schemas.microsoft.com/office/drawing/2014/main" id="{4908A80E-6E1B-410B-9609-16EB5C76AB3E}"/>
               </a:ext>
             </a:extLst>
           </p:cNvPr>
@@ -10604,7 +10604,7 @@
           <p:cNvPr id="7" name="">
             <a:extLst xmlns:a="http://schemas.openxmlformats.org/drawingml/2006/main">
               <a:ext uri="{FF2B5EF4-FFF2-40B4-BE49-F238E27FC236}">
-                <a16:creationId xmlns:a16="http://schemas.microsoft.com/office/drawing/2014/main" id="{29117874-9FF5-4915-8CA6-B7D4ABD8CE04}"/>
+                <a16:creationId xmlns:a16="http://schemas.microsoft.com/office/drawing/2014/main" id="{8D6C7F50-FC46-42A5-BB38-3798375425FF}"/>
               </a:ext>
             </a:extLst>
           </p:cNvPr>
@@ -10637,7 +10637,7 @@
           <p:cNvPr id="8" name="">
             <a:extLst xmlns:a="http://schemas.openxmlformats.org/drawingml/2006/main">
               <a:ext uri="{FF2B5EF4-FFF2-40B4-BE49-F238E27FC236}">
-                <a16:creationId xmlns:a16="http://schemas.microsoft.com/office/drawing/2014/main" id="{ADD6E2AF-1EB3-4582-9DF4-1BE9F8295F55}"/>
+                <a16:creationId xmlns:a16="http://schemas.microsoft.com/office/drawing/2014/main" id="{71A41C82-6FA2-4F14-A831-52A6AA6D555E}"/>
               </a:ext>
             </a:extLst>
           </p:cNvPr>
@@ -10704,7 +10704,7 @@
           <p:cNvPr id="9" name="">
             <a:extLst xmlns:a="http://schemas.openxmlformats.org/drawingml/2006/main">
               <a:ext uri="{FF2B5EF4-FFF2-40B4-BE49-F238E27FC236}">
-                <a16:creationId xmlns:a16="http://schemas.microsoft.com/office/drawing/2014/main" id="{A36F21E8-DB54-4991-B8EC-E9387EBA9DF6}"/>
+                <a16:creationId xmlns:a16="http://schemas.microsoft.com/office/drawing/2014/main" id="{7BE1D75E-350D-4859-B2B0-AB40178F494A}"/>
               </a:ext>
             </a:extLst>
           </p:cNvPr>
@@ -10840,7 +10840,7 @@
           <p:cNvPr id="10" name="">
             <a:extLst xmlns:a="http://schemas.openxmlformats.org/drawingml/2006/main">
               <a:ext uri="{FF2B5EF4-FFF2-40B4-BE49-F238E27FC236}">
-                <a16:creationId xmlns:a16="http://schemas.microsoft.com/office/drawing/2014/main" id="{55B89C6C-D208-47EA-8F33-9D667AB734B9}"/>
+                <a16:creationId xmlns:a16="http://schemas.microsoft.com/office/drawing/2014/main" id="{123E77D0-1FD4-42F2-853C-75563BB8B74E}"/>
               </a:ext>
             </a:extLst>
           </p:cNvPr>
@@ -10873,7 +10873,7 @@
           <p:cNvPr id="11" name="">
             <a:extLst xmlns:a="http://schemas.openxmlformats.org/drawingml/2006/main">
               <a:ext uri="{FF2B5EF4-FFF2-40B4-BE49-F238E27FC236}">
-                <a16:creationId xmlns:a16="http://schemas.microsoft.com/office/drawing/2014/main" id="{46FE38AA-64E5-4EA1-9BD0-A77BDF030101}"/>
+                <a16:creationId xmlns:a16="http://schemas.microsoft.com/office/drawing/2014/main" id="{FE843C58-41F6-40C4-8E5A-B03AAB2A1463}"/>
               </a:ext>
             </a:extLst>
           </p:cNvPr>
@@ -10940,7 +10940,7 @@
           <p:cNvPr id="12" name="">
             <a:extLst xmlns:a="http://schemas.openxmlformats.org/drawingml/2006/main">
               <a:ext uri="{FF2B5EF4-FFF2-40B4-BE49-F238E27FC236}">
-                <a16:creationId xmlns:a16="http://schemas.microsoft.com/office/drawing/2014/main" id="{D19F5B84-AAD2-45F1-A9B3-13C8AA43F34E}"/>
+                <a16:creationId xmlns:a16="http://schemas.microsoft.com/office/drawing/2014/main" id="{3D4324EE-082D-4CBA-8F33-2EF64AAE9BC0}"/>
               </a:ext>
             </a:extLst>
           </p:cNvPr>
@@ -11076,7 +11076,7 @@
           <p:cNvPr id="13" name="">
             <a:extLst xmlns:a="http://schemas.openxmlformats.org/drawingml/2006/main">
               <a:ext uri="{FF2B5EF4-FFF2-40B4-BE49-F238E27FC236}">
-                <a16:creationId xmlns:a16="http://schemas.microsoft.com/office/drawing/2014/main" id="{46275AFE-4AE2-4691-9FA0-A458C7E8D68B}"/>
+                <a16:creationId xmlns:a16="http://schemas.microsoft.com/office/drawing/2014/main" id="{348D0D77-81D9-4FF9-81B8-5D4A93C15511}"/>
               </a:ext>
             </a:extLst>
           </p:cNvPr>
@@ -11109,7 +11109,7 @@
           <p:cNvPr id="14" name="">
             <a:extLst xmlns:a="http://schemas.openxmlformats.org/drawingml/2006/main">
               <a:ext uri="{FF2B5EF4-FFF2-40B4-BE49-F238E27FC236}">
-                <a16:creationId xmlns:a16="http://schemas.microsoft.com/office/drawing/2014/main" id="{DC6CF57D-258D-4AFF-846A-C46A43A44081}"/>
+                <a16:creationId xmlns:a16="http://schemas.microsoft.com/office/drawing/2014/main" id="{2D81063D-AE01-4575-82B7-B306C6391E69}"/>
               </a:ext>
             </a:extLst>
           </p:cNvPr>
@@ -11166,7 +11166,7 @@
                 <a:ea typeface="Aptos"/>
                 <a:cs typeface="Aptos"/>
               </a:rPr>
-              <a:t>Installable delivery</a:t>
+              <a:t>Connected walkthrough</a:t>
             </a:r>
           </a:p>
         </p:txBody>
@@ -11176,7 +11176,7 @@
           <p:cNvPr id="15" name="">
             <a:extLst xmlns:a="http://schemas.openxmlformats.org/drawingml/2006/main">
               <a:ext uri="{FF2B5EF4-FFF2-40B4-BE49-F238E27FC236}">
-                <a16:creationId xmlns:a16="http://schemas.microsoft.com/office/drawing/2014/main" id="{A04A5A5D-AA08-4A57-A275-AA0DE9303DD5}"/>
+                <a16:creationId xmlns:a16="http://schemas.microsoft.com/office/drawing/2014/main" id="{8B2C696F-F2EC-4437-AA34-2898C048A905}"/>
               </a:ext>
             </a:extLst>
           </p:cNvPr>
@@ -11233,7 +11233,7 @@
                 <a:ea typeface="Aptos"/>
                 <a:cs typeface="Aptos"/>
               </a:rPr>
-              <a:t>149 combined tests passing</a:t>
+              <a:t>152 tests and five demos pass</a:t>
             </a:r>
           </a:p>
           <a:p xmlns:a="http://schemas.openxmlformats.org/drawingml/2006/main">
@@ -11256,7 +11256,7 @@
                 <a:ea typeface="Aptos"/>
                 <a:cs typeface="Aptos"/>
               </a:rPr>
-              <a:t>Fresh production installation</a:t>
+              <a:t>One connected workflow command</a:t>
             </a:r>
           </a:p>
           <a:p xmlns:a="http://schemas.openxmlformats.org/drawingml/2006/main">
@@ -11279,7 +11279,7 @@
                 <a:ea typeface="Aptos"/>
                 <a:cs typeface="Aptos"/>
               </a:rPr>
-              <a:t>Native worker RPC handshake</a:t>
+              <a:t>Deterministic journey receipt</a:t>
             </a:r>
           </a:p>
           <a:p xmlns:a="http://schemas.openxmlformats.org/drawingml/2006/main">
@@ -11302,7 +11302,7 @@
                 <a:ea typeface="Aptos"/>
                 <a:cs typeface="Aptos"/>
               </a:rPr>
-              <a:t>Guided configuration validation</a:t>
+              <a:t>Native services and HTTP verified</a:t>
             </a:r>
           </a:p>
         </p:txBody>
@@ -11312,7 +11312,7 @@
           <p:cNvPr id="16" name="">
             <a:extLst xmlns:a="http://schemas.openxmlformats.org/drawingml/2006/main">
               <a:ext uri="{FF2B5EF4-FFF2-40B4-BE49-F238E27FC236}">
-                <a16:creationId xmlns:a16="http://schemas.microsoft.com/office/drawing/2014/main" id="{B49B2408-1C1E-4D89-8275-A0662A08CF9A}"/>
+                <a16:creationId xmlns:a16="http://schemas.microsoft.com/office/drawing/2014/main" id="{9D6F9082-3680-41B1-88E6-190A05E8D118}"/>
               </a:ext>
             </a:extLst>
           </p:cNvPr>
@@ -11369,7 +11369,7 @@
                 <a:ea typeface="Aptos"/>
                 <a:cs typeface="Aptos"/>
               </a:rPr>
-              <a:t>Fixture evidence uses real bridge code with substituted external I/O. Deployment and live rehearsal are still ahead.</a:t>
+              <a:t>Native services and isolated Docker HTTP/API checks passed. External integrations and live deployment remain pending.</a:t>
             </a:r>
           </a:p>
         </p:txBody>
@@ -11377,7 +11377,7 @@
     </p:spTree>
     <p:extLst>
       <p:ext uri="{BB962C8B-B14F-4D97-AF65-F5344CB8AC3E}">
-        <p14:creationId xmlns:p14="http://schemas.microsoft.com/office/powerpoint/2010/main" val="829709320"/>
+        <p14:creationId xmlns:p14="http://schemas.microsoft.com/office/powerpoint/2010/main" val="93010346"/>
       </p:ext>
     </p:extLst>
   </p:cSld>
@@ -11408,7 +11408,7 @@
           <p:cNvPr id="17" name="">
             <a:extLst xmlns:a="http://schemas.openxmlformats.org/drawingml/2006/main">
               <a:ext uri="{FF2B5EF4-FFF2-40B4-BE49-F238E27FC236}">
-                <a16:creationId xmlns:a16="http://schemas.microsoft.com/office/drawing/2014/main" id="{0173441E-F063-4E8A-BF1A-3FE90B8F955D}"/>
+                <a16:creationId xmlns:a16="http://schemas.microsoft.com/office/drawing/2014/main" id="{5E567FFF-EB96-4A56-8095-D54675D333C7}"/>
               </a:ext>
             </a:extLst>
           </p:cNvPr>
@@ -11475,7 +11475,7 @@
           <p:cNvPr id="2" name="">
             <a:extLst xmlns:a="http://schemas.openxmlformats.org/drawingml/2006/main">
               <a:ext uri="{FF2B5EF4-FFF2-40B4-BE49-F238E27FC236}">
-                <a16:creationId xmlns:a16="http://schemas.microsoft.com/office/drawing/2014/main" id="{F5C871FE-F01B-488E-9C0A-CAF465CA5DB1}"/>
+                <a16:creationId xmlns:a16="http://schemas.microsoft.com/office/drawing/2014/main" id="{45B0A5B7-447E-4220-8B45-71588DF9C790}"/>
               </a:ext>
             </a:extLst>
           </p:cNvPr>
@@ -11542,7 +11542,7 @@
           <p:cNvPr id="3" name="">
             <a:extLst xmlns:a="http://schemas.openxmlformats.org/drawingml/2006/main">
               <a:ext uri="{FF2B5EF4-FFF2-40B4-BE49-F238E27FC236}">
-                <a16:creationId xmlns:a16="http://schemas.microsoft.com/office/drawing/2014/main" id="{2B1A65F4-3C73-462B-8F26-C26536AC782E}"/>
+                <a16:creationId xmlns:a16="http://schemas.microsoft.com/office/drawing/2014/main" id="{690BC7E6-3CA6-4111-B860-790A3EA0D412}"/>
               </a:ext>
             </a:extLst>
           </p:cNvPr>
@@ -11609,7 +11609,7 @@
           <p:cNvPr id="4" name="">
             <a:extLst xmlns:a="http://schemas.openxmlformats.org/drawingml/2006/main">
               <a:ext uri="{FF2B5EF4-FFF2-40B4-BE49-F238E27FC236}">
-                <a16:creationId xmlns:a16="http://schemas.microsoft.com/office/drawing/2014/main" id="{EF2C142C-5C03-4D47-BFD4-3D6B04CEC89B}"/>
+                <a16:creationId xmlns:a16="http://schemas.microsoft.com/office/drawing/2014/main" id="{A283D3ED-12AB-4AF0-ACF1-E019983DA6AA}"/>
               </a:ext>
             </a:extLst>
           </p:cNvPr>
@@ -11640,7 +11640,7 @@
           <p:cNvPr id="5" name="">
             <a:extLst xmlns:a="http://schemas.openxmlformats.org/drawingml/2006/main">
               <a:ext uri="{FF2B5EF4-FFF2-40B4-BE49-F238E27FC236}">
-                <a16:creationId xmlns:a16="http://schemas.microsoft.com/office/drawing/2014/main" id="{A3B4C865-930F-462E-96D0-8847246307CA}"/>
+                <a16:creationId xmlns:a16="http://schemas.microsoft.com/office/drawing/2014/main" id="{50D8DC96-37BC-4084-88DA-9A431A024BDC}"/>
               </a:ext>
             </a:extLst>
           </p:cNvPr>
@@ -11697,7 +11697,7 @@
                 <a:ea typeface="Aptos"/>
                 <a:cs typeface="Aptos"/>
               </a:rPr>
-              <a:t>INERTIA-2026-10-23-r7 · 23 October 2026 · Autonomous build</a:t>
+              <a:t>INERTIA-2026-10-23-r8 · 23 October 2026 · Autonomous build</a:t>
             </a:r>
           </a:p>
         </p:txBody>
@@ -11707,7 +11707,7 @@
           <p:cNvPr id="6" name="">
             <a:extLst xmlns:a="http://schemas.openxmlformats.org/drawingml/2006/main">
               <a:ext uri="{FF2B5EF4-FFF2-40B4-BE49-F238E27FC236}">
-                <a16:creationId xmlns:a16="http://schemas.microsoft.com/office/drawing/2014/main" id="{88373A89-E773-4F3B-9E34-A682312AA7E1}"/>
+                <a16:creationId xmlns:a16="http://schemas.microsoft.com/office/drawing/2014/main" id="{6EEE5496-EAD2-4419-8C21-4EA0A4DD92DA}"/>
               </a:ext>
             </a:extLst>
           </p:cNvPr>
@@ -11774,7 +11774,7 @@
           <p:cNvPr id="7" name="">
             <a:extLst xmlns:a="http://schemas.openxmlformats.org/drawingml/2006/main">
               <a:ext uri="{FF2B5EF4-FFF2-40B4-BE49-F238E27FC236}">
-                <a16:creationId xmlns:a16="http://schemas.microsoft.com/office/drawing/2014/main" id="{929FF0A0-B33A-4487-BFDB-6835B1732A0B}"/>
+                <a16:creationId xmlns:a16="http://schemas.microsoft.com/office/drawing/2014/main" id="{4CBCEAED-129F-4A04-ADE4-ED14C78ECB0A}"/>
               </a:ext>
             </a:extLst>
           </p:cNvPr>
@@ -11807,7 +11807,7 @@
           <p:cNvPr id="8" name="">
             <a:extLst xmlns:a="http://schemas.openxmlformats.org/drawingml/2006/main">
               <a:ext uri="{FF2B5EF4-FFF2-40B4-BE49-F238E27FC236}">
-                <a16:creationId xmlns:a16="http://schemas.microsoft.com/office/drawing/2014/main" id="{639AE9B0-2039-47D3-9C4F-6A4CBFAA7575}"/>
+                <a16:creationId xmlns:a16="http://schemas.microsoft.com/office/drawing/2014/main" id="{9BAC63AA-9576-4C6C-9AAA-088C1853B07B}"/>
               </a:ext>
             </a:extLst>
           </p:cNvPr>
@@ -11874,7 +11874,7 @@
           <p:cNvPr id="9" name="">
             <a:extLst xmlns:a="http://schemas.openxmlformats.org/drawingml/2006/main">
               <a:ext uri="{FF2B5EF4-FFF2-40B4-BE49-F238E27FC236}">
-                <a16:creationId xmlns:a16="http://schemas.microsoft.com/office/drawing/2014/main" id="{D800D6A5-1A4D-4994-85B3-97D9159DEA6F}"/>
+                <a16:creationId xmlns:a16="http://schemas.microsoft.com/office/drawing/2014/main" id="{30B10408-B47D-4D49-BCBA-B19154F2962A}"/>
               </a:ext>
             </a:extLst>
           </p:cNvPr>
@@ -12010,7 +12010,7 @@
           <p:cNvPr id="10" name="">
             <a:extLst xmlns:a="http://schemas.openxmlformats.org/drawingml/2006/main">
               <a:ext uri="{FF2B5EF4-FFF2-40B4-BE49-F238E27FC236}">
-                <a16:creationId xmlns:a16="http://schemas.microsoft.com/office/drawing/2014/main" id="{6B941325-326B-4F86-8450-C7509CC5DDE5}"/>
+                <a16:creationId xmlns:a16="http://schemas.microsoft.com/office/drawing/2014/main" id="{44C87D87-17FC-4C14-B243-ABA206108EF6}"/>
               </a:ext>
             </a:extLst>
           </p:cNvPr>
@@ -12043,7 +12043,7 @@
           <p:cNvPr id="11" name="">
             <a:extLst xmlns:a="http://schemas.openxmlformats.org/drawingml/2006/main">
               <a:ext uri="{FF2B5EF4-FFF2-40B4-BE49-F238E27FC236}">
-                <a16:creationId xmlns:a16="http://schemas.microsoft.com/office/drawing/2014/main" id="{34DD5DE3-0E52-4993-A7C2-FA7308C23B11}"/>
+                <a16:creationId xmlns:a16="http://schemas.microsoft.com/office/drawing/2014/main" id="{C204AB85-AA3F-478A-98AE-1CBD71E38CD3}"/>
               </a:ext>
             </a:extLst>
           </p:cNvPr>
@@ -12110,7 +12110,7 @@
           <p:cNvPr id="12" name="">
             <a:extLst xmlns:a="http://schemas.openxmlformats.org/drawingml/2006/main">
               <a:ext uri="{FF2B5EF4-FFF2-40B4-BE49-F238E27FC236}">
-                <a16:creationId xmlns:a16="http://schemas.microsoft.com/office/drawing/2014/main" id="{DF341400-E46A-4547-A3B9-6E2DCF4F4229}"/>
+                <a16:creationId xmlns:a16="http://schemas.microsoft.com/office/drawing/2014/main" id="{F0672BBB-ED90-449A-BE6C-57BDA8427636}"/>
               </a:ext>
             </a:extLst>
           </p:cNvPr>
@@ -12190,7 +12190,7 @@
                 <a:ea typeface="Aptos"/>
                 <a:cs typeface="Aptos"/>
               </a:rPr>
-              <a:t>Integrate approved targets</a:t>
+              <a:t>Run repeatable upgrade checks</a:t>
             </a:r>
           </a:p>
           <a:p xmlns:a="http://schemas.openxmlformats.org/drawingml/2006/main">
@@ -12236,7 +12236,7 @@
                 <a:ea typeface="Aptos"/>
                 <a:cs typeface="Aptos"/>
               </a:rPr>
-              <a:t>Verify normal automatic recovery</a:t>
+              <a:t>Test backup-based recovery</a:t>
             </a:r>
           </a:p>
         </p:txBody>
@@ -12246,7 +12246,7 @@
           <p:cNvPr id="13" name="">
             <a:extLst xmlns:a="http://schemas.openxmlformats.org/drawingml/2006/main">
               <a:ext uri="{FF2B5EF4-FFF2-40B4-BE49-F238E27FC236}">
-                <a16:creationId xmlns:a16="http://schemas.microsoft.com/office/drawing/2014/main" id="{A2D50665-ABDE-434C-BCE8-FC777D1F21CB}"/>
+                <a16:creationId xmlns:a16="http://schemas.microsoft.com/office/drawing/2014/main" id="{95122083-D8F6-4998-A5DD-7F6E8DFD39A3}"/>
               </a:ext>
             </a:extLst>
           </p:cNvPr>
@@ -12279,7 +12279,7 @@
           <p:cNvPr id="14" name="">
             <a:extLst xmlns:a="http://schemas.openxmlformats.org/drawingml/2006/main">
               <a:ext uri="{FF2B5EF4-FFF2-40B4-BE49-F238E27FC236}">
-                <a16:creationId xmlns:a16="http://schemas.microsoft.com/office/drawing/2014/main" id="{C0EE3AEA-04D6-4FCE-A14B-5FE39DB833C1}"/>
+                <a16:creationId xmlns:a16="http://schemas.microsoft.com/office/drawing/2014/main" id="{CD33B486-CFD9-4B91-B987-69295E0AB051}"/>
               </a:ext>
             </a:extLst>
           </p:cNvPr>
@@ -12346,7 +12346,7 @@
           <p:cNvPr id="15" name="">
             <a:extLst xmlns:a="http://schemas.openxmlformats.org/drawingml/2006/main">
               <a:ext uri="{FF2B5EF4-FFF2-40B4-BE49-F238E27FC236}">
-                <a16:creationId xmlns:a16="http://schemas.microsoft.com/office/drawing/2014/main" id="{93DED335-5776-42AC-BBC1-81BD8EC9BCBA}"/>
+                <a16:creationId xmlns:a16="http://schemas.microsoft.com/office/drawing/2014/main" id="{4554D70B-183C-4629-8613-DBCE74744C5B}"/>
               </a:ext>
             </a:extLst>
           </p:cNvPr>
@@ -12482,7 +12482,7 @@
           <p:cNvPr id="16" name="">
             <a:extLst xmlns:a="http://schemas.openxmlformats.org/drawingml/2006/main">
               <a:ext uri="{FF2B5EF4-FFF2-40B4-BE49-F238E27FC236}">
-                <a16:creationId xmlns:a16="http://schemas.microsoft.com/office/drawing/2014/main" id="{0691ACA3-223A-4D47-BBE2-A8593645D206}"/>
+                <a16:creationId xmlns:a16="http://schemas.microsoft.com/office/drawing/2014/main" id="{660BE28A-2F62-40D0-835D-1185992D3F3E}"/>
               </a:ext>
             </a:extLst>
           </p:cNvPr>
@@ -12539,7 +12539,7 @@
                 <a:ea typeface="Aptos"/>
                 <a:cs typeface="Aptos"/>
               </a:rPr>
-              <a:t>Main stays untouched. Helix is de-prioritized. Configuration details stay in one decision register.</a:t>
+              <a:t>Cloud-first execution. Laptop fallback only for a specific blocker. Main and the runtime archive stay unchanged.</a:t>
             </a:r>
           </a:p>
         </p:txBody>
@@ -12547,7 +12547,7 @@
     </p:spTree>
     <p:extLst>
       <p:ext uri="{BB962C8B-B14F-4D97-AF65-F5344CB8AC3E}">
-        <p14:creationId xmlns:p14="http://schemas.microsoft.com/office/powerpoint/2010/main" val="485357773"/>
+        <p14:creationId xmlns:p14="http://schemas.microsoft.com/office/powerpoint/2010/main" val="301613713"/>
       </p:ext>
     </p:extLst>
   </p:cSld>

</xml_diff>

<commit_message>
docs: synchronize r9 artifacts and exact native qualification
</commit_message>
<xml_diff>
--- a/Inertia-Architecture.pptx
+++ b/Inertia-Architecture.pptx
@@ -2,20 +2,20 @@
 <file path=ppt/presentation.xml><?xml version="1.0" encoding="utf-8"?>
 <p:presentation xmlns:p="http://schemas.openxmlformats.org/presentationml/2006/main">
   <p:sldMasterIdLst>
-    <p:sldMasterId xmlns:r="http://schemas.openxmlformats.org/officeDocument/2006/relationships" id="2147483648" r:id="Re63ac91880a5454e"/>
+    <p:sldMasterId xmlns:r="http://schemas.openxmlformats.org/officeDocument/2006/relationships" id="2147483648" r:id="R0dd9cb7e71e0443a"/>
   </p:sldMasterIdLst>
   <p:notesMasterIdLst>
-    <p:notesMasterId xmlns:r="http://schemas.openxmlformats.org/officeDocument/2006/relationships" r:id="R565c0f89eef14973"/>
+    <p:notesMasterId xmlns:r="http://schemas.openxmlformats.org/officeDocument/2006/relationships" r:id="R30529ac607664801"/>
   </p:notesMasterIdLst>
   <p:sldIdLst>
-    <p:sldId xmlns:r="http://schemas.openxmlformats.org/officeDocument/2006/relationships" id="256" r:id="R61af3860cbfb4f76"/>
-    <p:sldId xmlns:r="http://schemas.openxmlformats.org/officeDocument/2006/relationships" id="257" r:id="Rb9391e72b1374f46"/>
-    <p:sldId xmlns:r="http://schemas.openxmlformats.org/officeDocument/2006/relationships" id="258" r:id="R93e9e8d68d904378"/>
-    <p:sldId xmlns:r="http://schemas.openxmlformats.org/officeDocument/2006/relationships" id="259" r:id="R15d2ec525f2e449e"/>
-    <p:sldId xmlns:r="http://schemas.openxmlformats.org/officeDocument/2006/relationships" id="260" r:id="Rc7df1c9c7fd3442e"/>
-    <p:sldId xmlns:r="http://schemas.openxmlformats.org/officeDocument/2006/relationships" id="261" r:id="R24343b718bcc40f3"/>
-    <p:sldId xmlns:r="http://schemas.openxmlformats.org/officeDocument/2006/relationships" id="262" r:id="R0472f160c43c4b11"/>
-    <p:sldId xmlns:r="http://schemas.openxmlformats.org/officeDocument/2006/relationships" id="263" r:id="Rb14ba0e698bb42a9"/>
+    <p:sldId xmlns:r="http://schemas.openxmlformats.org/officeDocument/2006/relationships" id="256" r:id="R07a014b80ee4408a"/>
+    <p:sldId xmlns:r="http://schemas.openxmlformats.org/officeDocument/2006/relationships" id="257" r:id="Rf7b5ddd0aa9b4179"/>
+    <p:sldId xmlns:r="http://schemas.openxmlformats.org/officeDocument/2006/relationships" id="258" r:id="Rae6958e684c04eb4"/>
+    <p:sldId xmlns:r="http://schemas.openxmlformats.org/officeDocument/2006/relationships" id="259" r:id="R7d00e6ce59aa47a4"/>
+    <p:sldId xmlns:r="http://schemas.openxmlformats.org/officeDocument/2006/relationships" id="260" r:id="Rb61e31e4dc4c417d"/>
+    <p:sldId xmlns:r="http://schemas.openxmlformats.org/officeDocument/2006/relationships" id="261" r:id="R65564fd8bbce4a04"/>
+    <p:sldId xmlns:r="http://schemas.openxmlformats.org/officeDocument/2006/relationships" id="262" r:id="R6cb958f3a90e4e84"/>
+    <p:sldId xmlns:r="http://schemas.openxmlformats.org/officeDocument/2006/relationships" id="263" r:id="R1939777d3fd44cc9"/>
   </p:sldIdLst>
   <p:sldSz cx="15240000" cy="8572500"/>
   <p:notesSz cx="6858000" cy="9144000"/>
@@ -449,7 +449,7 @@
           <a:lstStyle xmlns:a="http://schemas.openxmlformats.org/drawingml/2006/main"/>
           <a:p xmlns:a="http://schemas.openxmlformats.org/drawingml/2006/main">
             <a:r>
-              <a:t>INERTIA-2026-10-23-r8. Sources: spec.md, testing.md, decisions.md, plan.md. Merged baseline https://github.com/NetRxn/Inertia/commit/ec26c1b850e7937a9d5b1561c1a27b43d06394de; PR 2 https://github.com/NetRxn/Inertia/pull/2; PR 3 https://github.com/NetRxn/Inertia/pull/3. Paperclip selected public release v2026.1012.0, bba6a45f0d364cfd962ac59b3bdf2426a8222adb. Buzz dc25198d530acc6237a0320b697365f29daf0ea6. PR 4 https://github.com/NetRxn/Inertia/pull/4 and PR 5 https://github.com/NetRxn/Inertia/pull/5 merged. PR 7 https://github.com/NetRxn/Inertia/pull/7 merged with 37 grant tests. PR 8 https://github.com/NetRxn/Inertia/pull/8 merged with packaging f68e8bb98df0bb05f9a946340d885e0bcfc6e188 independently reviewed; 149 combined tests, typecheck, build, fresh production install and native JSON-RPC worker handshake passed at PR8. PR10 https://github.com/NetRxn/Inertia/pull/10 adds the connected workflow: 152 total tests and five demos pass. External I/O and native work seeding are fixtures. See docs/implementation/live-handoff-checklist.md and docs/qualification/native-services.md. Actual pinned native services passed using PostgreSQL18.1; cloud HTTP startup was blocked by interface enumeration; the authorized isolated Docker fallback subsequently passed full HTTP/API qualification without shims. Latest published host/SDK remain 2026.1012.0 as of 23 October. PR11 https://github.com/NetRxn/Inertia/pull/11 upgrade workflow has 12 focused tests and isolated 152-test/package qualification. DAO organizational facts come from authorized website retrieval with citations and restricted audiences. No private execution-provider source included.</a:t>
+              <a:t>INERTIA-2026-10-23-r9. Source baseline: https://github.com/NetRxn/Inertia/commit/4841f7ade1510acf93e43ce1dbd16b91ae7bcd88. Architecture target and implementation status are distinct. PR13 authenticated private cloud handoff: https://github.com/NetRxn/Inertia/pull/13. PR14 caller-side website adapter and proposed v1.1 clarification: https://github.com/NetRxn/Inertia/pull/14, final reviewed 216 tests including four concurrency regressions added after initial 212. Wire roundtable-publication-v1 and extractive-v1 unchanged. Metadata-only correction unsupported. Website server rollout, authorized Drive source and single-owner native job wiring remain pending; demos still use pendingDaoPublisher. PR15 public DAO grounding: https://github.com/NetRxn/Inertia/pull/15; public legal/tax claims remain provisional and conflicting governance needs canonical ratification evidence. PR17 https://github.com/NetRxn/Inertia/pull/17 head 2a90ce24e16a72f446a7402560bd53d22f00ca38 was independently reviewed/tested and merged at 2026-10-23T11:12:50Z as 4841f7ade1510acf93e43ce1dbd16b91ae7bcd88. The merged source bytes equal the reviewed head. This documentation tree is distinct from the exact runtime qualification hashes below. 248 combined tests in 16 files, typecheck/build and package verification: 54 files, 6 migrations. First-publication native comment mirroring only, default-off, explicit per-binding audience acknowledgment and history cutoff, existing outbox/reconciler. No edit/delete propagation or retraction. Non-expiring publication claims expose inFlightPublications; token-matched administrative recovery requires all prior workers proved stopped, never timeout/automatic expiry. Exact candidate archive SHA256 19e67c88a8de52404412e49312cebfd6db42c462de3378cf3397966250add76c, source tree 8039b3e5f54e49c302b4751445f382403381ab91, passed actual unmodified native services with PostgreSQL18.1: six migrations, eight tables, three disabled job RPCs, expected health, SQL binding/company isolation, clean lifecycle. A real host array-binding regression was fixed before this pass. No new full-HTTP qualification. See docs/qualification/combined-native-services/. PR16 native CEO operator checklist merged: https://github.com/NetRxn/Inertia/pull/16. Preparation only, no live setup or custom bootstrap engine. No automatic scan of unassigned work by default; configure an assigned intake mandate and heartbeat. General status mirroring remains future. Existing native/HTTP and package receipts qualify historical recorded baselines, not every new runtime artifact. No live deployment, credentials or member publication performed. See synchronized spec.md, testing.md, decisions.md, plan.md and public integration references.</a:t>
             </a:r>
           </a:p>
         </p:txBody>
@@ -519,7 +519,7 @@
           <a:lstStyle xmlns:a="http://schemas.openxmlformats.org/drawingml/2006/main"/>
           <a:p xmlns:a="http://schemas.openxmlformats.org/drawingml/2006/main">
             <a:r>
-              <a:t>INERTIA-2026-10-23-r8. Sources: spec.md, testing.md, decisions.md, plan.md. Merged baseline https://github.com/NetRxn/Inertia/commit/ec26c1b850e7937a9d5b1561c1a27b43d06394de; PR 2 https://github.com/NetRxn/Inertia/pull/2; PR 3 https://github.com/NetRxn/Inertia/pull/3. Paperclip selected public release v2026.1012.0, bba6a45f0d364cfd962ac59b3bdf2426a8222adb. Buzz dc25198d530acc6237a0320b697365f29daf0ea6. PR 4 https://github.com/NetRxn/Inertia/pull/4 and PR 5 https://github.com/NetRxn/Inertia/pull/5 merged. PR 7 https://github.com/NetRxn/Inertia/pull/7 merged with 37 grant tests. PR 8 https://github.com/NetRxn/Inertia/pull/8 merged with packaging f68e8bb98df0bb05f9a946340d885e0bcfc6e188 independently reviewed; 149 combined tests, typecheck, build, fresh production install and native JSON-RPC worker handshake passed at PR8. PR10 https://github.com/NetRxn/Inertia/pull/10 adds the connected workflow: 152 total tests and five demos pass. External I/O and native work seeding are fixtures. See docs/implementation/live-handoff-checklist.md and docs/qualification/native-services.md. Actual pinned native services passed using PostgreSQL18.1; cloud HTTP startup was blocked by interface enumeration; the authorized isolated Docker fallback subsequently passed full HTTP/API qualification without shims. Latest published host/SDK remain 2026.1012.0 as of 23 October. PR11 https://github.com/NetRxn/Inertia/pull/11 upgrade workflow has 12 focused tests and isolated 152-test/package qualification. DAO organizational facts come from authorized website retrieval with citations and restricted audiences. No private execution-provider source included.</a:t>
+              <a:t>INERTIA-2026-10-23-r9. Source baseline: https://github.com/NetRxn/Inertia/commit/4841f7ade1510acf93e43ce1dbd16b91ae7bcd88. Architecture target and implementation status are distinct. PR13 authenticated private cloud handoff: https://github.com/NetRxn/Inertia/pull/13. PR14 caller-side website adapter and proposed v1.1 clarification: https://github.com/NetRxn/Inertia/pull/14, final reviewed 216 tests including four concurrency regressions added after initial 212. Wire roundtable-publication-v1 and extractive-v1 unchanged. Metadata-only correction unsupported. Website server rollout, authorized Drive source and single-owner native job wiring remain pending; demos still use pendingDaoPublisher. PR15 public DAO grounding: https://github.com/NetRxn/Inertia/pull/15; public legal/tax claims remain provisional and conflicting governance needs canonical ratification evidence. PR17 https://github.com/NetRxn/Inertia/pull/17 head 2a90ce24e16a72f446a7402560bd53d22f00ca38 was independently reviewed/tested and merged at 2026-10-23T11:12:50Z as 4841f7ade1510acf93e43ce1dbd16b91ae7bcd88. The merged source bytes equal the reviewed head. This documentation tree is distinct from the exact runtime qualification hashes below. 248 combined tests in 16 files, typecheck/build and package verification: 54 files, 6 migrations. First-publication native comment mirroring only, default-off, explicit per-binding audience acknowledgment and history cutoff, existing outbox/reconciler. No edit/delete propagation or retraction. Non-expiring publication claims expose inFlightPublications; token-matched administrative recovery requires all prior workers proved stopped, never timeout/automatic expiry. Exact candidate archive SHA256 19e67c88a8de52404412e49312cebfd6db42c462de3378cf3397966250add76c, source tree 8039b3e5f54e49c302b4751445f382403381ab91, passed actual unmodified native services with PostgreSQL18.1: six migrations, eight tables, three disabled job RPCs, expected health, SQL binding/company isolation, clean lifecycle. A real host array-binding regression was fixed before this pass. No new full-HTTP qualification. See docs/qualification/combined-native-services/. PR16 native CEO operator checklist merged: https://github.com/NetRxn/Inertia/pull/16. Preparation only, no live setup or custom bootstrap engine. No automatic scan of unassigned work by default; configure an assigned intake mandate and heartbeat. General status mirroring remains future. Existing native/HTTP and package receipts qualify historical recorded baselines, not every new runtime artifact. No live deployment, credentials or member publication performed. See synchronized spec.md, testing.md, decisions.md, plan.md and public integration references.</a:t>
             </a:r>
           </a:p>
         </p:txBody>
@@ -589,7 +589,7 @@
           <a:lstStyle xmlns:a="http://schemas.openxmlformats.org/drawingml/2006/main"/>
           <a:p xmlns:a="http://schemas.openxmlformats.org/drawingml/2006/main">
             <a:r>
-              <a:t>INERTIA-2026-10-23-r8. Sources: spec.md, testing.md, decisions.md, plan.md. Merged baseline https://github.com/NetRxn/Inertia/commit/ec26c1b850e7937a9d5b1561c1a27b43d06394de; PR 2 https://github.com/NetRxn/Inertia/pull/2; PR 3 https://github.com/NetRxn/Inertia/pull/3. Paperclip selected public release v2026.1012.0, bba6a45f0d364cfd962ac59b3bdf2426a8222adb. Buzz dc25198d530acc6237a0320b697365f29daf0ea6. PR 4 https://github.com/NetRxn/Inertia/pull/4 and PR 5 https://github.com/NetRxn/Inertia/pull/5 merged. PR 7 https://github.com/NetRxn/Inertia/pull/7 merged with 37 grant tests. PR 8 https://github.com/NetRxn/Inertia/pull/8 merged with packaging f68e8bb98df0bb05f9a946340d885e0bcfc6e188 independently reviewed; 149 combined tests, typecheck, build, fresh production install and native JSON-RPC worker handshake passed at PR8. PR10 https://github.com/NetRxn/Inertia/pull/10 adds the connected workflow: 152 total tests and five demos pass. External I/O and native work seeding are fixtures. See docs/implementation/live-handoff-checklist.md and docs/qualification/native-services.md. Actual pinned native services passed using PostgreSQL18.1; cloud HTTP startup was blocked by interface enumeration; the authorized isolated Docker fallback subsequently passed full HTTP/API qualification without shims. Latest published host/SDK remain 2026.1012.0 as of 23 October. PR11 https://github.com/NetRxn/Inertia/pull/11 upgrade workflow has 12 focused tests and isolated 152-test/package qualification. DAO organizational facts come from authorized website retrieval with citations and restricted audiences. No private execution-provider source included.</a:t>
+              <a:t>INERTIA-2026-10-23-r9. Source baseline: https://github.com/NetRxn/Inertia/commit/4841f7ade1510acf93e43ce1dbd16b91ae7bcd88. Architecture target and implementation status are distinct. PR13 authenticated private cloud handoff: https://github.com/NetRxn/Inertia/pull/13. PR14 caller-side website adapter and proposed v1.1 clarification: https://github.com/NetRxn/Inertia/pull/14, final reviewed 216 tests including four concurrency regressions added after initial 212. Wire roundtable-publication-v1 and extractive-v1 unchanged. Metadata-only correction unsupported. Website server rollout, authorized Drive source and single-owner native job wiring remain pending; demos still use pendingDaoPublisher. PR15 public DAO grounding: https://github.com/NetRxn/Inertia/pull/15; public legal/tax claims remain provisional and conflicting governance needs canonical ratification evidence. PR17 https://github.com/NetRxn/Inertia/pull/17 head 2a90ce24e16a72f446a7402560bd53d22f00ca38 was independently reviewed/tested and merged at 2026-10-23T11:12:50Z as 4841f7ade1510acf93e43ce1dbd16b91ae7bcd88. The merged source bytes equal the reviewed head. This documentation tree is distinct from the exact runtime qualification hashes below. 248 combined tests in 16 files, typecheck/build and package verification: 54 files, 6 migrations. First-publication native comment mirroring only, default-off, explicit per-binding audience acknowledgment and history cutoff, existing outbox/reconciler. No edit/delete propagation or retraction. Non-expiring publication claims expose inFlightPublications; token-matched administrative recovery requires all prior workers proved stopped, never timeout/automatic expiry. Exact candidate archive SHA256 19e67c88a8de52404412e49312cebfd6db42c462de3378cf3397966250add76c, source tree 8039b3e5f54e49c302b4751445f382403381ab91, passed actual unmodified native services with PostgreSQL18.1: six migrations, eight tables, three disabled job RPCs, expected health, SQL binding/company isolation, clean lifecycle. A real host array-binding regression was fixed before this pass. No new full-HTTP qualification. See docs/qualification/combined-native-services/. PR16 native CEO operator checklist merged: https://github.com/NetRxn/Inertia/pull/16. Preparation only, no live setup or custom bootstrap engine. No automatic scan of unassigned work by default; configure an assigned intake mandate and heartbeat. General status mirroring remains future. Existing native/HTTP and package receipts qualify historical recorded baselines, not every new runtime artifact. No live deployment, credentials or member publication performed. See synchronized spec.md, testing.md, decisions.md, plan.md and public integration references.</a:t>
             </a:r>
           </a:p>
         </p:txBody>
@@ -659,7 +659,7 @@
           <a:lstStyle xmlns:a="http://schemas.openxmlformats.org/drawingml/2006/main"/>
           <a:p xmlns:a="http://schemas.openxmlformats.org/drawingml/2006/main">
             <a:r>
-              <a:t>INERTIA-2026-10-23-r8. Sources: spec.md, testing.md, decisions.md, plan.md. Merged baseline https://github.com/NetRxn/Inertia/commit/ec26c1b850e7937a9d5b1561c1a27b43d06394de; PR 2 https://github.com/NetRxn/Inertia/pull/2; PR 3 https://github.com/NetRxn/Inertia/pull/3. Paperclip selected public release v2026.1012.0, bba6a45f0d364cfd962ac59b3bdf2426a8222adb. Buzz dc25198d530acc6237a0320b697365f29daf0ea6. PR 4 https://github.com/NetRxn/Inertia/pull/4 and PR 5 https://github.com/NetRxn/Inertia/pull/5 merged. PR 7 https://github.com/NetRxn/Inertia/pull/7 merged with 37 grant tests. PR 8 https://github.com/NetRxn/Inertia/pull/8 merged with packaging f68e8bb98df0bb05f9a946340d885e0bcfc6e188 independently reviewed; 149 combined tests, typecheck, build, fresh production install and native JSON-RPC worker handshake passed at PR8. PR10 https://github.com/NetRxn/Inertia/pull/10 adds the connected workflow: 152 total tests and five demos pass. External I/O and native work seeding are fixtures. See docs/implementation/live-handoff-checklist.md and docs/qualification/native-services.md. Actual pinned native services passed using PostgreSQL18.1; cloud HTTP startup was blocked by interface enumeration; the authorized isolated Docker fallback subsequently passed full HTTP/API qualification without shims. Latest published host/SDK remain 2026.1012.0 as of 23 October. PR11 https://github.com/NetRxn/Inertia/pull/11 upgrade workflow has 12 focused tests and isolated 152-test/package qualification. DAO organizational facts come from authorized website retrieval with citations and restricted audiences. No private execution-provider source included.</a:t>
+              <a:t>INERTIA-2026-10-23-r9. Source baseline: https://github.com/NetRxn/Inertia/commit/4841f7ade1510acf93e43ce1dbd16b91ae7bcd88. Architecture target and implementation status are distinct. PR13 authenticated private cloud handoff: https://github.com/NetRxn/Inertia/pull/13. PR14 caller-side website adapter and proposed v1.1 clarification: https://github.com/NetRxn/Inertia/pull/14, final reviewed 216 tests including four concurrency regressions added after initial 212. Wire roundtable-publication-v1 and extractive-v1 unchanged. Metadata-only correction unsupported. Website server rollout, authorized Drive source and single-owner native job wiring remain pending; demos still use pendingDaoPublisher. PR15 public DAO grounding: https://github.com/NetRxn/Inertia/pull/15; public legal/tax claims remain provisional and conflicting governance needs canonical ratification evidence. PR17 https://github.com/NetRxn/Inertia/pull/17 head 2a90ce24e16a72f446a7402560bd53d22f00ca38 was independently reviewed/tested and merged at 2026-10-23T11:12:50Z as 4841f7ade1510acf93e43ce1dbd16b91ae7bcd88. The merged source bytes equal the reviewed head. This documentation tree is distinct from the exact runtime qualification hashes below. 248 combined tests in 16 files, typecheck/build and package verification: 54 files, 6 migrations. First-publication native comment mirroring only, default-off, explicit per-binding audience acknowledgment and history cutoff, existing outbox/reconciler. No edit/delete propagation or retraction. Non-expiring publication claims expose inFlightPublications; token-matched administrative recovery requires all prior workers proved stopped, never timeout/automatic expiry. Exact candidate archive SHA256 19e67c88a8de52404412e49312cebfd6db42c462de3378cf3397966250add76c, source tree 8039b3e5f54e49c302b4751445f382403381ab91, passed actual unmodified native services with PostgreSQL18.1: six migrations, eight tables, three disabled job RPCs, expected health, SQL binding/company isolation, clean lifecycle. A real host array-binding regression was fixed before this pass. No new full-HTTP qualification. See docs/qualification/combined-native-services/. PR16 native CEO operator checklist merged: https://github.com/NetRxn/Inertia/pull/16. Preparation only, no live setup or custom bootstrap engine. No automatic scan of unassigned work by default; configure an assigned intake mandate and heartbeat. General status mirroring remains future. Existing native/HTTP and package receipts qualify historical recorded baselines, not every new runtime artifact. No live deployment, credentials or member publication performed. See synchronized spec.md, testing.md, decisions.md, plan.md and public integration references.</a:t>
             </a:r>
           </a:p>
         </p:txBody>
@@ -729,7 +729,7 @@
           <a:lstStyle xmlns:a="http://schemas.openxmlformats.org/drawingml/2006/main"/>
           <a:p xmlns:a="http://schemas.openxmlformats.org/drawingml/2006/main">
             <a:r>
-              <a:t>INERTIA-2026-10-23-r8. Sources: spec.md, testing.md, decisions.md, plan.md. Merged baseline https://github.com/NetRxn/Inertia/commit/ec26c1b850e7937a9d5b1561c1a27b43d06394de; PR 2 https://github.com/NetRxn/Inertia/pull/2; PR 3 https://github.com/NetRxn/Inertia/pull/3. Paperclip selected public release v2026.1012.0, bba6a45f0d364cfd962ac59b3bdf2426a8222adb. Buzz dc25198d530acc6237a0320b697365f29daf0ea6. PR 4 https://github.com/NetRxn/Inertia/pull/4 and PR 5 https://github.com/NetRxn/Inertia/pull/5 merged. PR 7 https://github.com/NetRxn/Inertia/pull/7 merged with 37 grant tests. PR 8 https://github.com/NetRxn/Inertia/pull/8 merged with packaging f68e8bb98df0bb05f9a946340d885e0bcfc6e188 independently reviewed; 149 combined tests, typecheck, build, fresh production install and native JSON-RPC worker handshake passed at PR8. PR10 https://github.com/NetRxn/Inertia/pull/10 adds the connected workflow: 152 total tests and five demos pass. External I/O and native work seeding are fixtures. See docs/implementation/live-handoff-checklist.md and docs/qualification/native-services.md. Actual pinned native services passed using PostgreSQL18.1; cloud HTTP startup was blocked by interface enumeration; the authorized isolated Docker fallback subsequently passed full HTTP/API qualification without shims. Latest published host/SDK remain 2026.1012.0 as of 23 October. PR11 https://github.com/NetRxn/Inertia/pull/11 upgrade workflow has 12 focused tests and isolated 152-test/package qualification. DAO organizational facts come from authorized website retrieval with citations and restricted audiences. No private execution-provider source included.</a:t>
+              <a:t>INERTIA-2026-10-23-r9. Source baseline: https://github.com/NetRxn/Inertia/commit/4841f7ade1510acf93e43ce1dbd16b91ae7bcd88. Architecture target and implementation status are distinct. PR13 authenticated private cloud handoff: https://github.com/NetRxn/Inertia/pull/13. PR14 caller-side website adapter and proposed v1.1 clarification: https://github.com/NetRxn/Inertia/pull/14, final reviewed 216 tests including four concurrency regressions added after initial 212. Wire roundtable-publication-v1 and extractive-v1 unchanged. Metadata-only correction unsupported. Website server rollout, authorized Drive source and single-owner native job wiring remain pending; demos still use pendingDaoPublisher. PR15 public DAO grounding: https://github.com/NetRxn/Inertia/pull/15; public legal/tax claims remain provisional and conflicting governance needs canonical ratification evidence. PR17 https://github.com/NetRxn/Inertia/pull/17 head 2a90ce24e16a72f446a7402560bd53d22f00ca38 was independently reviewed/tested and merged at 2026-10-23T11:12:50Z as 4841f7ade1510acf93e43ce1dbd16b91ae7bcd88. The merged source bytes equal the reviewed head. This documentation tree is distinct from the exact runtime qualification hashes below. 248 combined tests in 16 files, typecheck/build and package verification: 54 files, 6 migrations. First-publication native comment mirroring only, default-off, explicit per-binding audience acknowledgment and history cutoff, existing outbox/reconciler. No edit/delete propagation or retraction. Non-expiring publication claims expose inFlightPublications; token-matched administrative recovery requires all prior workers proved stopped, never timeout/automatic expiry. Exact candidate archive SHA256 19e67c88a8de52404412e49312cebfd6db42c462de3378cf3397966250add76c, source tree 8039b3e5f54e49c302b4751445f382403381ab91, passed actual unmodified native services with PostgreSQL18.1: six migrations, eight tables, three disabled job RPCs, expected health, SQL binding/company isolation, clean lifecycle. A real host array-binding regression was fixed before this pass. No new full-HTTP qualification. See docs/qualification/combined-native-services/. PR16 native CEO operator checklist merged: https://github.com/NetRxn/Inertia/pull/16. Preparation only, no live setup or custom bootstrap engine. No automatic scan of unassigned work by default; configure an assigned intake mandate and heartbeat. General status mirroring remains future. Existing native/HTTP and package receipts qualify historical recorded baselines, not every new runtime artifact. No live deployment, credentials or member publication performed. See synchronized spec.md, testing.md, decisions.md, plan.md and public integration references.</a:t>
             </a:r>
           </a:p>
         </p:txBody>
@@ -799,7 +799,7 @@
           <a:lstStyle xmlns:a="http://schemas.openxmlformats.org/drawingml/2006/main"/>
           <a:p xmlns:a="http://schemas.openxmlformats.org/drawingml/2006/main">
             <a:r>
-              <a:t>INERTIA-2026-10-23-r8. Sources: spec.md, testing.md, decisions.md, plan.md. Merged baseline https://github.com/NetRxn/Inertia/commit/ec26c1b850e7937a9d5b1561c1a27b43d06394de; PR 2 https://github.com/NetRxn/Inertia/pull/2; PR 3 https://github.com/NetRxn/Inertia/pull/3. Paperclip selected public release v2026.1012.0, bba6a45f0d364cfd962ac59b3bdf2426a8222adb. Buzz dc25198d530acc6237a0320b697365f29daf0ea6. PR 4 https://github.com/NetRxn/Inertia/pull/4 and PR 5 https://github.com/NetRxn/Inertia/pull/5 merged. PR 7 https://github.com/NetRxn/Inertia/pull/7 merged with 37 grant tests. PR 8 https://github.com/NetRxn/Inertia/pull/8 merged with packaging f68e8bb98df0bb05f9a946340d885e0bcfc6e188 independently reviewed; 149 combined tests, typecheck, build, fresh production install and native JSON-RPC worker handshake passed at PR8. PR10 https://github.com/NetRxn/Inertia/pull/10 adds the connected workflow: 152 total tests and five demos pass. External I/O and native work seeding are fixtures. See docs/implementation/live-handoff-checklist.md and docs/qualification/native-services.md. Actual pinned native services passed using PostgreSQL18.1; cloud HTTP startup was blocked by interface enumeration; the authorized isolated Docker fallback subsequently passed full HTTP/API qualification without shims. Latest published host/SDK remain 2026.1012.0 as of 23 October. PR11 https://github.com/NetRxn/Inertia/pull/11 upgrade workflow has 12 focused tests and isolated 152-test/package qualification. DAO organizational facts come from authorized website retrieval with citations and restricted audiences. No private execution-provider source included.</a:t>
+              <a:t>INERTIA-2026-10-23-r9. Source baseline: https://github.com/NetRxn/Inertia/commit/4841f7ade1510acf93e43ce1dbd16b91ae7bcd88. Architecture target and implementation status are distinct. PR13 authenticated private cloud handoff: https://github.com/NetRxn/Inertia/pull/13. PR14 caller-side website adapter and proposed v1.1 clarification: https://github.com/NetRxn/Inertia/pull/14, final reviewed 216 tests including four concurrency regressions added after initial 212. Wire roundtable-publication-v1 and extractive-v1 unchanged. Metadata-only correction unsupported. Website server rollout, authorized Drive source and single-owner native job wiring remain pending; demos still use pendingDaoPublisher. PR15 public DAO grounding: https://github.com/NetRxn/Inertia/pull/15; public legal/tax claims remain provisional and conflicting governance needs canonical ratification evidence. PR17 https://github.com/NetRxn/Inertia/pull/17 head 2a90ce24e16a72f446a7402560bd53d22f00ca38 was independently reviewed/tested and merged at 2026-10-23T11:12:50Z as 4841f7ade1510acf93e43ce1dbd16b91ae7bcd88. The merged source bytes equal the reviewed head. This documentation tree is distinct from the exact runtime qualification hashes below. 248 combined tests in 16 files, typecheck/build and package verification: 54 files, 6 migrations. First-publication native comment mirroring only, default-off, explicit per-binding audience acknowledgment and history cutoff, existing outbox/reconciler. No edit/delete propagation or retraction. Non-expiring publication claims expose inFlightPublications; token-matched administrative recovery requires all prior workers proved stopped, never timeout/automatic expiry. Exact candidate archive SHA256 19e67c88a8de52404412e49312cebfd6db42c462de3378cf3397966250add76c, source tree 8039b3e5f54e49c302b4751445f382403381ab91, passed actual unmodified native services with PostgreSQL18.1: six migrations, eight tables, three disabled job RPCs, expected health, SQL binding/company isolation, clean lifecycle. A real host array-binding regression was fixed before this pass. No new full-HTTP qualification. See docs/qualification/combined-native-services/. PR16 native CEO operator checklist merged: https://github.com/NetRxn/Inertia/pull/16. Preparation only, no live setup or custom bootstrap engine. No automatic scan of unassigned work by default; configure an assigned intake mandate and heartbeat. General status mirroring remains future. Existing native/HTTP and package receipts qualify historical recorded baselines, not every new runtime artifact. No live deployment, credentials or member publication performed. See synchronized spec.md, testing.md, decisions.md, plan.md and public integration references.</a:t>
             </a:r>
           </a:p>
         </p:txBody>
@@ -869,7 +869,7 @@
           <a:lstStyle xmlns:a="http://schemas.openxmlformats.org/drawingml/2006/main"/>
           <a:p xmlns:a="http://schemas.openxmlformats.org/drawingml/2006/main">
             <a:r>
-              <a:t>INERTIA-2026-10-23-r8. Sources: spec.md, testing.md, decisions.md, plan.md. Merged baseline https://github.com/NetRxn/Inertia/commit/ec26c1b850e7937a9d5b1561c1a27b43d06394de; PR 2 https://github.com/NetRxn/Inertia/pull/2; PR 3 https://github.com/NetRxn/Inertia/pull/3. Paperclip selected public release v2026.1012.0, bba6a45f0d364cfd962ac59b3bdf2426a8222adb. Buzz dc25198d530acc6237a0320b697365f29daf0ea6. PR 4 https://github.com/NetRxn/Inertia/pull/4 and PR 5 https://github.com/NetRxn/Inertia/pull/5 merged. PR 7 https://github.com/NetRxn/Inertia/pull/7 merged with 37 grant tests. PR 8 https://github.com/NetRxn/Inertia/pull/8 merged with packaging f68e8bb98df0bb05f9a946340d885e0bcfc6e188 independently reviewed; 149 combined tests, typecheck, build, fresh production install and native JSON-RPC worker handshake passed at PR8. PR10 https://github.com/NetRxn/Inertia/pull/10 adds the connected workflow: 152 total tests and five demos pass. External I/O and native work seeding are fixtures. See docs/implementation/live-handoff-checklist.md and docs/qualification/native-services.md. Actual pinned native services passed using PostgreSQL18.1; cloud HTTP startup was blocked by interface enumeration; the authorized isolated Docker fallback subsequently passed full HTTP/API qualification without shims. Latest published host/SDK remain 2026.1012.0 as of 23 October. PR11 https://github.com/NetRxn/Inertia/pull/11 upgrade workflow has 12 focused tests and isolated 152-test/package qualification. DAO organizational facts come from authorized website retrieval with citations and restricted audiences. No private execution-provider source included.</a:t>
+              <a:t>INERTIA-2026-10-23-r9. Source baseline: https://github.com/NetRxn/Inertia/commit/4841f7ade1510acf93e43ce1dbd16b91ae7bcd88. Architecture target and implementation status are distinct. PR13 authenticated private cloud handoff: https://github.com/NetRxn/Inertia/pull/13. PR14 caller-side website adapter and proposed v1.1 clarification: https://github.com/NetRxn/Inertia/pull/14, final reviewed 216 tests including four concurrency regressions added after initial 212. Wire roundtable-publication-v1 and extractive-v1 unchanged. Metadata-only correction unsupported. Website server rollout, authorized Drive source and single-owner native job wiring remain pending; demos still use pendingDaoPublisher. PR15 public DAO grounding: https://github.com/NetRxn/Inertia/pull/15; public legal/tax claims remain provisional and conflicting governance needs canonical ratification evidence. PR17 https://github.com/NetRxn/Inertia/pull/17 head 2a90ce24e16a72f446a7402560bd53d22f00ca38 was independently reviewed/tested and merged at 2026-10-23T11:12:50Z as 4841f7ade1510acf93e43ce1dbd16b91ae7bcd88. The merged source bytes equal the reviewed head. This documentation tree is distinct from the exact runtime qualification hashes below. 248 combined tests in 16 files, typecheck/build and package verification: 54 files, 6 migrations. First-publication native comment mirroring only, default-off, explicit per-binding audience acknowledgment and history cutoff, existing outbox/reconciler. No edit/delete propagation or retraction. Non-expiring publication claims expose inFlightPublications; token-matched administrative recovery requires all prior workers proved stopped, never timeout/automatic expiry. Exact candidate archive SHA256 19e67c88a8de52404412e49312cebfd6db42c462de3378cf3397966250add76c, source tree 8039b3e5f54e49c302b4751445f382403381ab91, passed actual unmodified native services with PostgreSQL18.1: six migrations, eight tables, three disabled job RPCs, expected health, SQL binding/company isolation, clean lifecycle. A real host array-binding regression was fixed before this pass. No new full-HTTP qualification. See docs/qualification/combined-native-services/. PR16 native CEO operator checklist merged: https://github.com/NetRxn/Inertia/pull/16. Preparation only, no live setup or custom bootstrap engine. No automatic scan of unassigned work by default; configure an assigned intake mandate and heartbeat. General status mirroring remains future. Existing native/HTTP and package receipts qualify historical recorded baselines, not every new runtime artifact. No live deployment, credentials or member publication performed. See synchronized spec.md, testing.md, decisions.md, plan.md and public integration references.</a:t>
             </a:r>
           </a:p>
         </p:txBody>
@@ -939,7 +939,7 @@
           <a:lstStyle xmlns:a="http://schemas.openxmlformats.org/drawingml/2006/main"/>
           <a:p xmlns:a="http://schemas.openxmlformats.org/drawingml/2006/main">
             <a:r>
-              <a:t>INERTIA-2026-10-23-r8. Sources: spec.md, testing.md, decisions.md, plan.md. Merged baseline https://github.com/NetRxn/Inertia/commit/ec26c1b850e7937a9d5b1561c1a27b43d06394de; PR 2 https://github.com/NetRxn/Inertia/pull/2; PR 3 https://github.com/NetRxn/Inertia/pull/3. Paperclip selected public release v2026.1012.0, bba6a45f0d364cfd962ac59b3bdf2426a8222adb. Buzz dc25198d530acc6237a0320b697365f29daf0ea6. PR 4 https://github.com/NetRxn/Inertia/pull/4 and PR 5 https://github.com/NetRxn/Inertia/pull/5 merged. PR 7 https://github.com/NetRxn/Inertia/pull/7 merged with 37 grant tests. PR 8 https://github.com/NetRxn/Inertia/pull/8 merged with packaging f68e8bb98df0bb05f9a946340d885e0bcfc6e188 independently reviewed; 149 combined tests, typecheck, build, fresh production install and native JSON-RPC worker handshake passed at PR8. PR10 https://github.com/NetRxn/Inertia/pull/10 adds the connected workflow: 152 total tests and five demos pass. External I/O and native work seeding are fixtures. See docs/implementation/live-handoff-checklist.md and docs/qualification/native-services.md. Actual pinned native services passed using PostgreSQL18.1; cloud HTTP startup was blocked by interface enumeration; the authorized isolated Docker fallback subsequently passed full HTTP/API qualification without shims. Latest published host/SDK remain 2026.1012.0 as of 23 October. PR11 https://github.com/NetRxn/Inertia/pull/11 upgrade workflow has 12 focused tests and isolated 152-test/package qualification. DAO organizational facts come from authorized website retrieval with citations and restricted audiences. No private execution-provider source included.</a:t>
+              <a:t>INERTIA-2026-10-23-r9. Source baseline: https://github.com/NetRxn/Inertia/commit/4841f7ade1510acf93e43ce1dbd16b91ae7bcd88. Architecture target and implementation status are distinct. PR13 authenticated private cloud handoff: https://github.com/NetRxn/Inertia/pull/13. PR14 caller-side website adapter and proposed v1.1 clarification: https://github.com/NetRxn/Inertia/pull/14, final reviewed 216 tests including four concurrency regressions added after initial 212. Wire roundtable-publication-v1 and extractive-v1 unchanged. Metadata-only correction unsupported. Website server rollout, authorized Drive source and single-owner native job wiring remain pending; demos still use pendingDaoPublisher. PR15 public DAO grounding: https://github.com/NetRxn/Inertia/pull/15; public legal/tax claims remain provisional and conflicting governance needs canonical ratification evidence. PR17 https://github.com/NetRxn/Inertia/pull/17 head 2a90ce24e16a72f446a7402560bd53d22f00ca38 was independently reviewed/tested and merged at 2026-10-23T11:12:50Z as 4841f7ade1510acf93e43ce1dbd16b91ae7bcd88. The merged source bytes equal the reviewed head. This documentation tree is distinct from the exact runtime qualification hashes below. 248 combined tests in 16 files, typecheck/build and package verification: 54 files, 6 migrations. First-publication native comment mirroring only, default-off, explicit per-binding audience acknowledgment and history cutoff, existing outbox/reconciler. No edit/delete propagation or retraction. Non-expiring publication claims expose inFlightPublications; token-matched administrative recovery requires all prior workers proved stopped, never timeout/automatic expiry. Exact candidate archive SHA256 19e67c88a8de52404412e49312cebfd6db42c462de3378cf3397966250add76c, source tree 8039b3e5f54e49c302b4751445f382403381ab91, passed actual unmodified native services with PostgreSQL18.1: six migrations, eight tables, three disabled job RPCs, expected health, SQL binding/company isolation, clean lifecycle. A real host array-binding regression was fixed before this pass. No new full-HTTP qualification. See docs/qualification/combined-native-services/. PR16 native CEO operator checklist merged: https://github.com/NetRxn/Inertia/pull/16. Preparation only, no live setup or custom bootstrap engine. No automatic scan of unassigned work by default; configure an assigned intake mandate and heartbeat. General status mirroring remains future. Existing native/HTTP and package receipts qualify historical recorded baselines, not every new runtime artifact. No live deployment, credentials or member publication performed. See synchronized spec.md, testing.md, decisions.md, plan.md and public integration references.</a:t>
             </a:r>
           </a:p>
         </p:txBody>
@@ -1037,6 +1037,7 @@
                 <a:spcPts val="0"/>
               </a:spcAft>
               <a:buNone/>
+              <a:defRPr/>
             </a:lvl1pPr>
             <a:lvl2pPr marL="0" indent="0">
               <a:lnSpc>
@@ -1049,6 +1050,7 @@
                 <a:spcPts val="0"/>
               </a:spcAft>
               <a:buNone/>
+              <a:defRPr/>
             </a:lvl2pPr>
             <a:lvl3pPr marL="0" indent="0">
               <a:lnSpc>
@@ -1061,6 +1063,7 @@
                 <a:spcPts val="0"/>
               </a:spcAft>
               <a:buNone/>
+              <a:defRPr/>
             </a:lvl3pPr>
             <a:lvl4pPr marL="0" indent="0">
               <a:lnSpc>
@@ -1073,6 +1076,7 @@
                 <a:spcPts val="0"/>
               </a:spcAft>
               <a:buNone/>
+              <a:defRPr/>
             </a:lvl4pPr>
             <a:lvl5pPr marL="0" indent="0">
               <a:lnSpc>
@@ -1085,6 +1089,7 @@
                 <a:spcPts val="0"/>
               </a:spcAft>
               <a:buNone/>
+              <a:defRPr/>
             </a:lvl5pPr>
             <a:lvl6pPr marL="0" indent="0">
               <a:lnSpc>
@@ -1097,6 +1102,7 @@
                 <a:spcPts val="0"/>
               </a:spcAft>
               <a:buNone/>
+              <a:defRPr/>
             </a:lvl6pPr>
             <a:lvl7pPr marL="0" indent="0">
               <a:lnSpc>
@@ -1109,6 +1115,7 @@
                 <a:spcPts val="0"/>
               </a:spcAft>
               <a:buNone/>
+              <a:defRPr/>
             </a:lvl7pPr>
             <a:lvl8pPr marL="0" indent="0">
               <a:lnSpc>
@@ -1121,6 +1128,7 @@
                 <a:spcPts val="0"/>
               </a:spcAft>
               <a:buNone/>
+              <a:defRPr/>
             </a:lvl8pPr>
             <a:lvl9pPr marL="0" indent="0">
               <a:lnSpc>
@@ -1133,6 +1141,7 @@
                 <a:spcPts val="0"/>
               </a:spcAft>
               <a:buNone/>
+              <a:defRPr/>
             </a:lvl9pPr>
           </a:lstStyle>
           <a:p xmlns:a="http://schemas.openxmlformats.org/drawingml/2006/main"/>
@@ -1194,6 +1203,7 @@
                 <a:spcPts val="0"/>
               </a:spcAft>
               <a:buNone/>
+              <a:defRPr/>
             </a:lvl1pPr>
             <a:lvl2pPr marL="0" indent="0">
               <a:lnSpc>
@@ -1206,6 +1216,7 @@
                 <a:spcPts val="0"/>
               </a:spcAft>
               <a:buNone/>
+              <a:defRPr/>
             </a:lvl2pPr>
             <a:lvl3pPr marL="0" indent="0">
               <a:lnSpc>
@@ -1218,6 +1229,7 @@
                 <a:spcPts val="0"/>
               </a:spcAft>
               <a:buNone/>
+              <a:defRPr/>
             </a:lvl3pPr>
             <a:lvl4pPr marL="0" indent="0">
               <a:lnSpc>
@@ -1230,6 +1242,7 @@
                 <a:spcPts val="0"/>
               </a:spcAft>
               <a:buNone/>
+              <a:defRPr/>
             </a:lvl4pPr>
             <a:lvl5pPr marL="0" indent="0">
               <a:lnSpc>
@@ -1242,6 +1255,7 @@
                 <a:spcPts val="0"/>
               </a:spcAft>
               <a:buNone/>
+              <a:defRPr/>
             </a:lvl5pPr>
             <a:lvl6pPr marL="0" indent="0">
               <a:lnSpc>
@@ -1254,6 +1268,7 @@
                 <a:spcPts val="0"/>
               </a:spcAft>
               <a:buNone/>
+              <a:defRPr/>
             </a:lvl6pPr>
             <a:lvl7pPr marL="0" indent="0">
               <a:lnSpc>
@@ -1266,6 +1281,7 @@
                 <a:spcPts val="0"/>
               </a:spcAft>
               <a:buNone/>
+              <a:defRPr/>
             </a:lvl7pPr>
             <a:lvl8pPr marL="0" indent="0">
               <a:lnSpc>
@@ -1278,6 +1294,7 @@
                 <a:spcPts val="0"/>
               </a:spcAft>
               <a:buNone/>
+              <a:defRPr/>
             </a:lvl8pPr>
             <a:lvl9pPr marL="0" indent="0">
               <a:lnSpc>
@@ -1290,6 +1307,7 @@
                 <a:spcPts val="0"/>
               </a:spcAft>
               <a:buNone/>
+              <a:defRPr/>
             </a:lvl9pPr>
           </a:lstStyle>
           <a:p xmlns:a="http://schemas.openxmlformats.org/drawingml/2006/main"/>
@@ -1368,6 +1386,7 @@
                 <a:spcPts val="0"/>
               </a:spcAft>
               <a:buNone/>
+              <a:defRPr/>
             </a:lvl1pPr>
             <a:lvl2pPr marL="0" indent="0">
               <a:lnSpc>
@@ -1380,6 +1399,7 @@
                 <a:spcPts val="0"/>
               </a:spcAft>
               <a:buNone/>
+              <a:defRPr/>
             </a:lvl2pPr>
             <a:lvl3pPr marL="0" indent="0">
               <a:lnSpc>
@@ -1392,6 +1412,7 @@
                 <a:spcPts val="0"/>
               </a:spcAft>
               <a:buNone/>
+              <a:defRPr/>
             </a:lvl3pPr>
             <a:lvl4pPr marL="0" indent="0">
               <a:lnSpc>
@@ -1404,6 +1425,7 @@
                 <a:spcPts val="0"/>
               </a:spcAft>
               <a:buNone/>
+              <a:defRPr/>
             </a:lvl4pPr>
             <a:lvl5pPr marL="0" indent="0">
               <a:lnSpc>
@@ -1416,6 +1438,7 @@
                 <a:spcPts val="0"/>
               </a:spcAft>
               <a:buNone/>
+              <a:defRPr/>
             </a:lvl5pPr>
             <a:lvl6pPr marL="0" indent="0">
               <a:lnSpc>
@@ -1428,6 +1451,7 @@
                 <a:spcPts val="0"/>
               </a:spcAft>
               <a:buNone/>
+              <a:defRPr/>
             </a:lvl6pPr>
             <a:lvl7pPr marL="0" indent="0">
               <a:lnSpc>
@@ -1440,6 +1464,7 @@
                 <a:spcPts val="0"/>
               </a:spcAft>
               <a:buNone/>
+              <a:defRPr/>
             </a:lvl7pPr>
             <a:lvl8pPr marL="0" indent="0">
               <a:lnSpc>
@@ -1452,6 +1477,7 @@
                 <a:spcPts val="0"/>
               </a:spcAft>
               <a:buNone/>
+              <a:defRPr/>
             </a:lvl8pPr>
             <a:lvl9pPr marL="0" indent="0">
               <a:lnSpc>
@@ -1464,6 +1490,7 @@
                 <a:spcPts val="0"/>
               </a:spcAft>
               <a:buNone/>
+              <a:defRPr/>
             </a:lvl9pPr>
           </a:lstStyle>
           <a:p xmlns:a="http://schemas.openxmlformats.org/drawingml/2006/main"/>
@@ -1542,6 +1569,7 @@
                 <a:spcPts val="0"/>
               </a:spcAft>
               <a:buNone/>
+              <a:defRPr/>
             </a:lvl1pPr>
             <a:lvl2pPr marL="0" indent="0">
               <a:lnSpc>
@@ -1554,6 +1582,7 @@
                 <a:spcPts val="0"/>
               </a:spcAft>
               <a:buNone/>
+              <a:defRPr/>
             </a:lvl2pPr>
             <a:lvl3pPr marL="0" indent="0">
               <a:lnSpc>
@@ -1566,6 +1595,7 @@
                 <a:spcPts val="0"/>
               </a:spcAft>
               <a:buNone/>
+              <a:defRPr/>
             </a:lvl3pPr>
             <a:lvl4pPr marL="0" indent="0">
               <a:lnSpc>
@@ -1578,6 +1608,7 @@
                 <a:spcPts val="0"/>
               </a:spcAft>
               <a:buNone/>
+              <a:defRPr/>
             </a:lvl4pPr>
             <a:lvl5pPr marL="0" indent="0">
               <a:lnSpc>
@@ -1590,6 +1621,7 @@
                 <a:spcPts val="0"/>
               </a:spcAft>
               <a:buNone/>
+              <a:defRPr/>
             </a:lvl5pPr>
             <a:lvl6pPr marL="0" indent="0">
               <a:lnSpc>
@@ -1602,6 +1634,7 @@
                 <a:spcPts val="0"/>
               </a:spcAft>
               <a:buNone/>
+              <a:defRPr/>
             </a:lvl6pPr>
             <a:lvl7pPr marL="0" indent="0">
               <a:lnSpc>
@@ -1614,6 +1647,7 @@
                 <a:spcPts val="0"/>
               </a:spcAft>
               <a:buNone/>
+              <a:defRPr/>
             </a:lvl7pPr>
             <a:lvl8pPr marL="0" indent="0">
               <a:lnSpc>
@@ -1626,6 +1660,7 @@
                 <a:spcPts val="0"/>
               </a:spcAft>
               <a:buNone/>
+              <a:defRPr/>
             </a:lvl8pPr>
             <a:lvl9pPr marL="0" indent="0">
               <a:lnSpc>
@@ -1638,6 +1673,7 @@
                 <a:spcPts val="0"/>
               </a:spcAft>
               <a:buNone/>
+              <a:defRPr/>
             </a:lvl9pPr>
           </a:lstStyle>
           <a:p xmlns:a="http://schemas.openxmlformats.org/drawingml/2006/main"/>
@@ -1699,6 +1735,7 @@
                 <a:spcPts val="1500"/>
               </a:spcAft>
               <a:buChar char="•"/>
+              <a:defRPr/>
             </a:lvl1pPr>
             <a:lvl2pPr marL="666750" indent="-285750">
               <a:lnSpc>
@@ -1711,6 +1748,7 @@
                 <a:spcPts val="1500"/>
               </a:spcAft>
               <a:buChar char="•"/>
+              <a:defRPr/>
             </a:lvl2pPr>
             <a:lvl3pPr marL="1047750" indent="-285750">
               <a:lnSpc>
@@ -1723,6 +1761,7 @@
                 <a:spcPts val="1500"/>
               </a:spcAft>
               <a:buChar char="•"/>
+              <a:defRPr/>
             </a:lvl3pPr>
             <a:lvl4pPr marL="1428750" indent="-285750">
               <a:lnSpc>
@@ -1735,6 +1774,7 @@
                 <a:spcPts val="1500"/>
               </a:spcAft>
               <a:buChar char="•"/>
+              <a:defRPr/>
             </a:lvl4pPr>
             <a:lvl5pPr marL="1809750" indent="-285750">
               <a:lnSpc>
@@ -1747,6 +1787,7 @@
                 <a:spcPts val="1500"/>
               </a:spcAft>
               <a:buChar char="•"/>
+              <a:defRPr/>
             </a:lvl5pPr>
             <a:lvl6pPr marL="2190750" indent="-285750">
               <a:lnSpc>
@@ -1759,6 +1800,7 @@
                 <a:spcPts val="1500"/>
               </a:spcAft>
               <a:buChar char="•"/>
+              <a:defRPr/>
             </a:lvl6pPr>
             <a:lvl7pPr marL="2571750" indent="-285750">
               <a:lnSpc>
@@ -1771,6 +1813,7 @@
                 <a:spcPts val="1500"/>
               </a:spcAft>
               <a:buChar char="•"/>
+              <a:defRPr/>
             </a:lvl7pPr>
             <a:lvl8pPr marL="2952750" indent="-285750">
               <a:lnSpc>
@@ -1783,6 +1826,7 @@
                 <a:spcPts val="1500"/>
               </a:spcAft>
               <a:buChar char="•"/>
+              <a:defRPr/>
             </a:lvl8pPr>
             <a:lvl9pPr marL="3333750" indent="-285750">
               <a:lnSpc>
@@ -1795,6 +1839,7 @@
                 <a:spcPts val="1500"/>
               </a:spcAft>
               <a:buChar char="•"/>
+              <a:defRPr/>
             </a:lvl9pPr>
           </a:lstStyle>
           <a:p xmlns:a="http://schemas.openxmlformats.org/drawingml/2006/main"/>
@@ -1873,6 +1918,7 @@
                 <a:spcPts val="0"/>
               </a:spcAft>
               <a:buNone/>
+              <a:defRPr/>
             </a:lvl1pPr>
             <a:lvl2pPr marL="0" indent="0">
               <a:lnSpc>
@@ -1885,6 +1931,7 @@
                 <a:spcPts val="0"/>
               </a:spcAft>
               <a:buNone/>
+              <a:defRPr/>
             </a:lvl2pPr>
             <a:lvl3pPr marL="0" indent="0">
               <a:lnSpc>
@@ -1897,6 +1944,7 @@
                 <a:spcPts val="0"/>
               </a:spcAft>
               <a:buNone/>
+              <a:defRPr/>
             </a:lvl3pPr>
             <a:lvl4pPr marL="0" indent="0">
               <a:lnSpc>
@@ -1909,6 +1957,7 @@
                 <a:spcPts val="0"/>
               </a:spcAft>
               <a:buNone/>
+              <a:defRPr/>
             </a:lvl4pPr>
             <a:lvl5pPr marL="0" indent="0">
               <a:lnSpc>
@@ -1921,6 +1970,7 @@
                 <a:spcPts val="0"/>
               </a:spcAft>
               <a:buNone/>
+              <a:defRPr/>
             </a:lvl5pPr>
             <a:lvl6pPr marL="0" indent="0">
               <a:lnSpc>
@@ -1933,6 +1983,7 @@
                 <a:spcPts val="0"/>
               </a:spcAft>
               <a:buNone/>
+              <a:defRPr/>
             </a:lvl6pPr>
             <a:lvl7pPr marL="0" indent="0">
               <a:lnSpc>
@@ -1945,6 +1996,7 @@
                 <a:spcPts val="0"/>
               </a:spcAft>
               <a:buNone/>
+              <a:defRPr/>
             </a:lvl7pPr>
             <a:lvl8pPr marL="0" indent="0">
               <a:lnSpc>
@@ -1957,6 +2009,7 @@
                 <a:spcPts val="0"/>
               </a:spcAft>
               <a:buNone/>
+              <a:defRPr/>
             </a:lvl8pPr>
             <a:lvl9pPr marL="0" indent="0">
               <a:lnSpc>
@@ -1969,6 +2022,7 @@
                 <a:spcPts val="0"/>
               </a:spcAft>
               <a:buNone/>
+              <a:defRPr/>
             </a:lvl9pPr>
           </a:lstStyle>
           <a:p xmlns:a="http://schemas.openxmlformats.org/drawingml/2006/main"/>
@@ -2030,6 +2084,7 @@
                 <a:spcPts val="1500"/>
               </a:spcAft>
               <a:buChar char="•"/>
+              <a:defRPr/>
             </a:lvl1pPr>
             <a:lvl2pPr marL="666750" indent="-285750">
               <a:lnSpc>
@@ -2042,6 +2097,7 @@
                 <a:spcPts val="1500"/>
               </a:spcAft>
               <a:buChar char="•"/>
+              <a:defRPr/>
             </a:lvl2pPr>
             <a:lvl3pPr marL="1047750" indent="-285750">
               <a:lnSpc>
@@ -2054,6 +2110,7 @@
                 <a:spcPts val="1500"/>
               </a:spcAft>
               <a:buChar char="•"/>
+              <a:defRPr/>
             </a:lvl3pPr>
             <a:lvl4pPr marL="1428750" indent="-285750">
               <a:lnSpc>
@@ -2066,6 +2123,7 @@
                 <a:spcPts val="1500"/>
               </a:spcAft>
               <a:buChar char="•"/>
+              <a:defRPr/>
             </a:lvl4pPr>
             <a:lvl5pPr marL="1809750" indent="-285750">
               <a:lnSpc>
@@ -2078,6 +2136,7 @@
                 <a:spcPts val="1500"/>
               </a:spcAft>
               <a:buChar char="•"/>
+              <a:defRPr/>
             </a:lvl5pPr>
             <a:lvl6pPr marL="2190750" indent="-285750">
               <a:lnSpc>
@@ -2090,6 +2149,7 @@
                 <a:spcPts val="1500"/>
               </a:spcAft>
               <a:buChar char="•"/>
+              <a:defRPr/>
             </a:lvl6pPr>
             <a:lvl7pPr marL="2571750" indent="-285750">
               <a:lnSpc>
@@ -2102,6 +2162,7 @@
                 <a:spcPts val="1500"/>
               </a:spcAft>
               <a:buChar char="•"/>
+              <a:defRPr/>
             </a:lvl7pPr>
             <a:lvl8pPr marL="2952750" indent="-285750">
               <a:lnSpc>
@@ -2114,6 +2175,7 @@
                 <a:spcPts val="1500"/>
               </a:spcAft>
               <a:buChar char="•"/>
+              <a:defRPr/>
             </a:lvl8pPr>
             <a:lvl9pPr marL="3333750" indent="-285750">
               <a:lnSpc>
@@ -2126,6 +2188,7 @@
                 <a:spcPts val="1500"/>
               </a:spcAft>
               <a:buChar char="•"/>
+              <a:defRPr/>
             </a:lvl9pPr>
           </a:lstStyle>
           <a:p xmlns:a="http://schemas.openxmlformats.org/drawingml/2006/main"/>
@@ -2187,6 +2250,7 @@
                 <a:spcPts val="1500"/>
               </a:spcAft>
               <a:buChar char="•"/>
+              <a:defRPr/>
             </a:lvl1pPr>
             <a:lvl2pPr marL="666750" indent="-285750">
               <a:lnSpc>
@@ -2199,6 +2263,7 @@
                 <a:spcPts val="1500"/>
               </a:spcAft>
               <a:buChar char="•"/>
+              <a:defRPr/>
             </a:lvl2pPr>
             <a:lvl3pPr marL="1047750" indent="-285750">
               <a:lnSpc>
@@ -2211,6 +2276,7 @@
                 <a:spcPts val="1500"/>
               </a:spcAft>
               <a:buChar char="•"/>
+              <a:defRPr/>
             </a:lvl3pPr>
             <a:lvl4pPr marL="1428750" indent="-285750">
               <a:lnSpc>
@@ -2223,6 +2289,7 @@
                 <a:spcPts val="1500"/>
               </a:spcAft>
               <a:buChar char="•"/>
+              <a:defRPr/>
             </a:lvl4pPr>
             <a:lvl5pPr marL="1809750" indent="-285750">
               <a:lnSpc>
@@ -2235,6 +2302,7 @@
                 <a:spcPts val="1500"/>
               </a:spcAft>
               <a:buChar char="•"/>
+              <a:defRPr/>
             </a:lvl5pPr>
             <a:lvl6pPr marL="2190750" indent="-285750">
               <a:lnSpc>
@@ -2247,6 +2315,7 @@
                 <a:spcPts val="1500"/>
               </a:spcAft>
               <a:buChar char="•"/>
+              <a:defRPr/>
             </a:lvl6pPr>
             <a:lvl7pPr marL="2571750" indent="-285750">
               <a:lnSpc>
@@ -2259,6 +2328,7 @@
                 <a:spcPts val="1500"/>
               </a:spcAft>
               <a:buChar char="•"/>
+              <a:defRPr/>
             </a:lvl7pPr>
             <a:lvl8pPr marL="2952750" indent="-285750">
               <a:lnSpc>
@@ -2271,6 +2341,7 @@
                 <a:spcPts val="1500"/>
               </a:spcAft>
               <a:buChar char="•"/>
+              <a:defRPr/>
             </a:lvl8pPr>
             <a:lvl9pPr marL="3333750" indent="-285750">
               <a:lnSpc>
@@ -2283,6 +2354,7 @@
                 <a:spcPts val="1500"/>
               </a:spcAft>
               <a:buChar char="•"/>
+              <a:defRPr/>
             </a:lvl9pPr>
           </a:lstStyle>
           <a:p xmlns:a="http://schemas.openxmlformats.org/drawingml/2006/main"/>
@@ -2361,6 +2433,7 @@
                 <a:spcPts val="0"/>
               </a:spcAft>
               <a:buNone/>
+              <a:defRPr/>
             </a:lvl1pPr>
             <a:lvl2pPr marL="0" indent="0">
               <a:lnSpc>
@@ -2373,6 +2446,7 @@
                 <a:spcPts val="0"/>
               </a:spcAft>
               <a:buNone/>
+              <a:defRPr/>
             </a:lvl2pPr>
             <a:lvl3pPr marL="0" indent="0">
               <a:lnSpc>
@@ -2385,6 +2459,7 @@
                 <a:spcPts val="0"/>
               </a:spcAft>
               <a:buNone/>
+              <a:defRPr/>
             </a:lvl3pPr>
             <a:lvl4pPr marL="0" indent="0">
               <a:lnSpc>
@@ -2397,6 +2472,7 @@
                 <a:spcPts val="0"/>
               </a:spcAft>
               <a:buNone/>
+              <a:defRPr/>
             </a:lvl4pPr>
             <a:lvl5pPr marL="0" indent="0">
               <a:lnSpc>
@@ -2409,6 +2485,7 @@
                 <a:spcPts val="0"/>
               </a:spcAft>
               <a:buNone/>
+              <a:defRPr/>
             </a:lvl5pPr>
             <a:lvl6pPr marL="0" indent="0">
               <a:lnSpc>
@@ -2421,6 +2498,7 @@
                 <a:spcPts val="0"/>
               </a:spcAft>
               <a:buNone/>
+              <a:defRPr/>
             </a:lvl6pPr>
             <a:lvl7pPr marL="0" indent="0">
               <a:lnSpc>
@@ -2433,6 +2511,7 @@
                 <a:spcPts val="0"/>
               </a:spcAft>
               <a:buNone/>
+              <a:defRPr/>
             </a:lvl7pPr>
             <a:lvl8pPr marL="0" indent="0">
               <a:lnSpc>
@@ -2445,6 +2524,7 @@
                 <a:spcPts val="0"/>
               </a:spcAft>
               <a:buNone/>
+              <a:defRPr/>
             </a:lvl8pPr>
             <a:lvl9pPr marL="0" indent="0">
               <a:lnSpc>
@@ -2457,6 +2537,7 @@
                 <a:spcPts val="0"/>
               </a:spcAft>
               <a:buNone/>
+              <a:defRPr/>
             </a:lvl9pPr>
           </a:lstStyle>
           <a:p xmlns:a="http://schemas.openxmlformats.org/drawingml/2006/main"/>
@@ -2518,6 +2599,7 @@
                 <a:spcPts val="1500"/>
               </a:spcAft>
               <a:buChar char="•"/>
+              <a:defRPr/>
             </a:lvl1pPr>
             <a:lvl2pPr marL="666750" indent="-285750">
               <a:lnSpc>
@@ -2530,6 +2612,7 @@
                 <a:spcPts val="1500"/>
               </a:spcAft>
               <a:buChar char="•"/>
+              <a:defRPr/>
             </a:lvl2pPr>
             <a:lvl3pPr marL="1047750" indent="-285750">
               <a:lnSpc>
@@ -2542,6 +2625,7 @@
                 <a:spcPts val="1500"/>
               </a:spcAft>
               <a:buChar char="•"/>
+              <a:defRPr/>
             </a:lvl3pPr>
             <a:lvl4pPr marL="1428750" indent="-285750">
               <a:lnSpc>
@@ -2554,6 +2638,7 @@
                 <a:spcPts val="1500"/>
               </a:spcAft>
               <a:buChar char="•"/>
+              <a:defRPr/>
             </a:lvl4pPr>
             <a:lvl5pPr marL="1809750" indent="-285750">
               <a:lnSpc>
@@ -2566,6 +2651,7 @@
                 <a:spcPts val="1500"/>
               </a:spcAft>
               <a:buChar char="•"/>
+              <a:defRPr/>
             </a:lvl5pPr>
             <a:lvl6pPr marL="2190750" indent="-285750">
               <a:lnSpc>
@@ -2578,6 +2664,7 @@
                 <a:spcPts val="1500"/>
               </a:spcAft>
               <a:buChar char="•"/>
+              <a:defRPr/>
             </a:lvl6pPr>
             <a:lvl7pPr marL="2571750" indent="-285750">
               <a:lnSpc>
@@ -2590,6 +2677,7 @@
                 <a:spcPts val="1500"/>
               </a:spcAft>
               <a:buChar char="•"/>
+              <a:defRPr/>
             </a:lvl7pPr>
             <a:lvl8pPr marL="2952750" indent="-285750">
               <a:lnSpc>
@@ -2602,6 +2690,7 @@
                 <a:spcPts val="1500"/>
               </a:spcAft>
               <a:buChar char="•"/>
+              <a:defRPr/>
             </a:lvl8pPr>
             <a:lvl9pPr marL="3333750" indent="-285750">
               <a:lnSpc>
@@ -2614,6 +2703,7 @@
                 <a:spcPts val="1500"/>
               </a:spcAft>
               <a:buChar char="•"/>
+              <a:defRPr/>
             </a:lvl9pPr>
           </a:lstStyle>
           <a:p xmlns:a="http://schemas.openxmlformats.org/drawingml/2006/main"/>
@@ -2662,12 +2752,12 @@
   </p:cSld>
   <p:clrMap bg1="lt1" tx1="dk1" bg2="lt2" tx2="dk2" accent1="accent1" accent2="accent2" accent3="accent3" accent4="accent4" accent5="accent5" accent6="accent6" hlink="hlink" folHlink="folHlink"/>
   <p:sldLayoutIdLst>
-    <p:sldLayoutId xmlns:r="http://schemas.openxmlformats.org/officeDocument/2006/relationships" id="2147483649" r:id="R6846bf5a52784031"/>
-    <p:sldLayoutId xmlns:r="http://schemas.openxmlformats.org/officeDocument/2006/relationships" id="2147483650" r:id="R27b90192727d4b6f"/>
-    <p:sldLayoutId xmlns:r="http://schemas.openxmlformats.org/officeDocument/2006/relationships" id="2147483651" r:id="R86f2907a34264d91"/>
-    <p:sldLayoutId xmlns:r="http://schemas.openxmlformats.org/officeDocument/2006/relationships" id="2147483652" r:id="R8696eeb5e57b422f"/>
-    <p:sldLayoutId xmlns:r="http://schemas.openxmlformats.org/officeDocument/2006/relationships" id="2147483653" r:id="Rccc8d6c9a01c44f9"/>
-    <p:sldLayoutId xmlns:r="http://schemas.openxmlformats.org/officeDocument/2006/relationships" id="2147483654" r:id="R9643191b62a84ca2"/>
+    <p:sldLayoutId xmlns:r="http://schemas.openxmlformats.org/officeDocument/2006/relationships" id="2147483649" r:id="R0d3f59da63fc4a30"/>
+    <p:sldLayoutId xmlns:r="http://schemas.openxmlformats.org/officeDocument/2006/relationships" id="2147483650" r:id="Rbdb54d6e67da4e5e"/>
+    <p:sldLayoutId xmlns:r="http://schemas.openxmlformats.org/officeDocument/2006/relationships" id="2147483651" r:id="Rcf6337a96f0643ae"/>
+    <p:sldLayoutId xmlns:r="http://schemas.openxmlformats.org/officeDocument/2006/relationships" id="2147483652" r:id="R8f6e8b350d544ab5"/>
+    <p:sldLayoutId xmlns:r="http://schemas.openxmlformats.org/officeDocument/2006/relationships" id="2147483653" r:id="Rcd953509fd854bab"/>
+    <p:sldLayoutId xmlns:r="http://schemas.openxmlformats.org/officeDocument/2006/relationships" id="2147483654" r:id="R81ca42f7981f4aad"/>
   </p:sldLayoutIdLst>
   <p:txStyles>
     <p:titleStyle>
@@ -3257,6 +3347,7 @@
           </a:lstStyle>
           <a:p xmlns:a="http://schemas.openxmlformats.org/drawingml/2006/main">
             <a:pPr>
+              <a:buNone/>
               <a:defRPr sz="1350" b="1">
                 <a:solidFill>
                   <a:srgbClr val="157D80"/>
@@ -3324,6 +3415,7 @@
           </a:lstStyle>
           <a:p xmlns:a="http://schemas.openxmlformats.org/drawingml/2006/main">
             <a:pPr>
+              <a:buNone/>
               <a:defRPr sz="3450" b="1">
                 <a:solidFill>
                   <a:srgbClr val="132E38"/>
@@ -3391,6 +3483,7 @@
           </a:lstStyle>
           <a:p xmlns:a="http://schemas.openxmlformats.org/drawingml/2006/main">
             <a:pPr>
+              <a:buNone/>
               <a:defRPr sz="1800" b="0">
                 <a:solidFill>
                   <a:srgbClr val="49616A"/>
@@ -3409,7 +3502,7 @@
                 <a:ea typeface="Aptos"/>
                 <a:cs typeface="Aptos"/>
               </a:rPr>
-              <a:t>One shared work system, with Buzz and the Paperclip dashboard as equal entry points.</a:t>
+              <a:t>Target experience: one work system, with Buzz and the Paperclip dashboard as entry points.</a:t>
             </a:r>
           </a:p>
         </p:txBody>
@@ -3489,6 +3582,7 @@
           </a:lstStyle>
           <a:p xmlns:a="http://schemas.openxmlformats.org/drawingml/2006/main">
             <a:pPr>
+              <a:buNone/>
               <a:defRPr sz="1275" b="0">
                 <a:solidFill>
                   <a:srgbClr val="49616A"/>
@@ -3507,7 +3601,7 @@
                 <a:ea typeface="Aptos"/>
                 <a:cs typeface="Aptos"/>
               </a:rPr>
-              <a:t>INERTIA-2026-10-23-r8 · 23 October 2026 · Autonomous build</a:t>
+              <a:t>INERTIA-2026-10-23-r9 · 23 October 2026 · Autonomous build</a:t>
             </a:r>
           </a:p>
         </p:txBody>
@@ -3556,6 +3650,7 @@
           </a:lstStyle>
           <a:p xmlns:a="http://schemas.openxmlformats.org/drawingml/2006/main">
             <a:pPr>
+              <a:buNone/>
               <a:defRPr sz="1800" b="1">
                 <a:solidFill>
                   <a:srgbClr val="157D80"/>
@@ -3656,6 +3751,7 @@
           </a:lstStyle>
           <a:p xmlns:a="http://schemas.openxmlformats.org/drawingml/2006/main">
             <a:pPr>
+              <a:buNone/>
               <a:defRPr sz="1875" b="1">
                 <a:solidFill>
                   <a:srgbClr val="157D80"/>
@@ -3723,6 +3819,7 @@
           </a:lstStyle>
           <a:p xmlns:a="http://schemas.openxmlformats.org/drawingml/2006/main">
             <a:pPr>
+              <a:buNone/>
               <a:defRPr sz="2250" b="0">
                 <a:solidFill>
                   <a:srgbClr val="49616A"/>
@@ -3746,6 +3843,7 @@
           </a:p>
           <a:p xmlns:a="http://schemas.openxmlformats.org/drawingml/2006/main">
             <a:pPr>
+              <a:buNone/>
               <a:defRPr sz="2250" b="0">
                 <a:solidFill>
                   <a:srgbClr val="49616A"/>
@@ -3769,6 +3867,7 @@
           </a:p>
           <a:p xmlns:a="http://schemas.openxmlformats.org/drawingml/2006/main">
             <a:pPr>
+              <a:buNone/>
               <a:defRPr sz="2250" b="0">
                 <a:solidFill>
                   <a:srgbClr val="49616A"/>
@@ -3792,6 +3891,7 @@
           </a:p>
           <a:p xmlns:a="http://schemas.openxmlformats.org/drawingml/2006/main">
             <a:pPr>
+              <a:buNone/>
               <a:defRPr sz="2250" b="0">
                 <a:solidFill>
                   <a:srgbClr val="49616A"/>
@@ -3892,6 +3992,7 @@
           </a:lstStyle>
           <a:p xmlns:a="http://schemas.openxmlformats.org/drawingml/2006/main">
             <a:pPr>
+              <a:buNone/>
               <a:defRPr sz="1875" b="1">
                 <a:solidFill>
                   <a:srgbClr val="157D80"/>
@@ -3959,6 +4060,7 @@
           </a:lstStyle>
           <a:p xmlns:a="http://schemas.openxmlformats.org/drawingml/2006/main">
             <a:pPr>
+              <a:buNone/>
               <a:defRPr sz="2250" b="0">
                 <a:solidFill>
                   <a:srgbClr val="49616A"/>
@@ -3982,6 +4084,7 @@
           </a:p>
           <a:p xmlns:a="http://schemas.openxmlformats.org/drawingml/2006/main">
             <a:pPr>
+              <a:buNone/>
               <a:defRPr sz="2250" b="0">
                 <a:solidFill>
                   <a:srgbClr val="49616A"/>
@@ -4005,6 +4108,7 @@
           </a:p>
           <a:p xmlns:a="http://schemas.openxmlformats.org/drawingml/2006/main">
             <a:pPr>
+              <a:buNone/>
               <a:defRPr sz="2250" b="0">
                 <a:solidFill>
                   <a:srgbClr val="49616A"/>
@@ -4028,6 +4132,7 @@
           </a:p>
           <a:p xmlns:a="http://schemas.openxmlformats.org/drawingml/2006/main">
             <a:pPr>
+              <a:buNone/>
               <a:defRPr sz="2250" b="0">
                 <a:solidFill>
                   <a:srgbClr val="49616A"/>
@@ -4128,6 +4233,7 @@
           </a:lstStyle>
           <a:p xmlns:a="http://schemas.openxmlformats.org/drawingml/2006/main">
             <a:pPr>
+              <a:buNone/>
               <a:defRPr sz="1875" b="1">
                 <a:solidFill>
                   <a:srgbClr val="157D80"/>
@@ -4195,6 +4301,7 @@
           </a:lstStyle>
           <a:p xmlns:a="http://schemas.openxmlformats.org/drawingml/2006/main">
             <a:pPr>
+              <a:buNone/>
               <a:defRPr sz="2250" b="0">
                 <a:solidFill>
                   <a:srgbClr val="49616A"/>
@@ -4218,6 +4325,7 @@
           </a:p>
           <a:p xmlns:a="http://schemas.openxmlformats.org/drawingml/2006/main">
             <a:pPr>
+              <a:buNone/>
               <a:defRPr sz="2250" b="0">
                 <a:solidFill>
                   <a:srgbClr val="49616A"/>
@@ -4241,6 +4349,7 @@
           </a:p>
           <a:p xmlns:a="http://schemas.openxmlformats.org/drawingml/2006/main">
             <a:pPr>
+              <a:buNone/>
               <a:defRPr sz="2250" b="0">
                 <a:solidFill>
                   <a:srgbClr val="49616A"/>
@@ -4264,6 +4373,7 @@
           </a:p>
           <a:p xmlns:a="http://schemas.openxmlformats.org/drawingml/2006/main">
             <a:pPr>
+              <a:buNone/>
               <a:defRPr sz="2250" b="0">
                 <a:solidFill>
                   <a:srgbClr val="49616A"/>
@@ -4331,6 +4441,7 @@
           </a:lstStyle>
           <a:p xmlns:a="http://schemas.openxmlformats.org/drawingml/2006/main">
             <a:pPr>
+              <a:buNone/>
               <a:defRPr sz="2100" b="0">
                 <a:solidFill>
                   <a:srgbClr val="132E38"/>
@@ -4427,6 +4538,7 @@
           </a:lstStyle>
           <a:p xmlns:a="http://schemas.openxmlformats.org/drawingml/2006/main">
             <a:pPr>
+              <a:buNone/>
               <a:defRPr sz="1350" b="1">
                 <a:solidFill>
                   <a:srgbClr val="157D80"/>
@@ -4494,6 +4606,7 @@
           </a:lstStyle>
           <a:p xmlns:a="http://schemas.openxmlformats.org/drawingml/2006/main">
             <a:pPr>
+              <a:buNone/>
               <a:defRPr sz="3450" b="1">
                 <a:solidFill>
                   <a:srgbClr val="132E38"/>
@@ -4561,6 +4674,7 @@
           </a:lstStyle>
           <a:p xmlns:a="http://schemas.openxmlformats.org/drawingml/2006/main">
             <a:pPr>
+              <a:buNone/>
               <a:defRPr sz="1800" b="0">
                 <a:solidFill>
                   <a:srgbClr val="49616A"/>
@@ -4659,6 +4773,7 @@
           </a:lstStyle>
           <a:p xmlns:a="http://schemas.openxmlformats.org/drawingml/2006/main">
             <a:pPr>
+              <a:buNone/>
               <a:defRPr sz="1275" b="0">
                 <a:solidFill>
                   <a:srgbClr val="49616A"/>
@@ -4677,7 +4792,7 @@
                 <a:ea typeface="Aptos"/>
                 <a:cs typeface="Aptos"/>
               </a:rPr>
-              <a:t>INERTIA-2026-10-23-r8 · 23 October 2026 · Autonomous build</a:t>
+              <a:t>INERTIA-2026-10-23-r9 · 23 October 2026 · Autonomous build</a:t>
             </a:r>
           </a:p>
         </p:txBody>
@@ -4726,6 +4841,7 @@
           </a:lstStyle>
           <a:p xmlns:a="http://schemas.openxmlformats.org/drawingml/2006/main">
             <a:pPr>
+              <a:buNone/>
               <a:defRPr sz="1800" b="1">
                 <a:solidFill>
                   <a:srgbClr val="157D80"/>
@@ -4826,6 +4942,7 @@
           </a:lstStyle>
           <a:p xmlns:a="http://schemas.openxmlformats.org/drawingml/2006/main">
             <a:pPr>
+              <a:buNone/>
               <a:defRPr sz="1875" b="1">
                 <a:solidFill>
                   <a:srgbClr val="157D80"/>
@@ -4893,6 +5010,7 @@
           </a:lstStyle>
           <a:p xmlns:a="http://schemas.openxmlformats.org/drawingml/2006/main">
             <a:pPr>
+              <a:buNone/>
               <a:defRPr sz="2250" b="0">
                 <a:solidFill>
                   <a:srgbClr val="49616A"/>
@@ -4916,6 +5034,7 @@
           </a:p>
           <a:p xmlns:a="http://schemas.openxmlformats.org/drawingml/2006/main">
             <a:pPr>
+              <a:buNone/>
               <a:defRPr sz="2250" b="0">
                 <a:solidFill>
                   <a:srgbClr val="49616A"/>
@@ -4939,6 +5058,7 @@
           </a:p>
           <a:p xmlns:a="http://schemas.openxmlformats.org/drawingml/2006/main">
             <a:pPr>
+              <a:buNone/>
               <a:defRPr sz="2250" b="0">
                 <a:solidFill>
                   <a:srgbClr val="49616A"/>
@@ -4962,6 +5082,7 @@
           </a:p>
           <a:p xmlns:a="http://schemas.openxmlformats.org/drawingml/2006/main">
             <a:pPr>
+              <a:buNone/>
               <a:defRPr sz="2250" b="0">
                 <a:solidFill>
                   <a:srgbClr val="49616A"/>
@@ -5062,6 +5183,7 @@
           </a:lstStyle>
           <a:p xmlns:a="http://schemas.openxmlformats.org/drawingml/2006/main">
             <a:pPr>
+              <a:buNone/>
               <a:defRPr sz="1875" b="1">
                 <a:solidFill>
                   <a:srgbClr val="157D80"/>
@@ -5129,6 +5251,7 @@
           </a:lstStyle>
           <a:p xmlns:a="http://schemas.openxmlformats.org/drawingml/2006/main">
             <a:pPr>
+              <a:buNone/>
               <a:defRPr sz="2250" b="0">
                 <a:solidFill>
                   <a:srgbClr val="49616A"/>
@@ -5147,11 +5270,12 @@
                 <a:ea typeface="Aptos"/>
                 <a:cs typeface="Aptos"/>
               </a:rPr>
-              <a:t>Signed requests and identity</a:t>
-            </a:r>
-          </a:p>
-          <a:p xmlns:a="http://schemas.openxmlformats.org/drawingml/2006/main">
-            <a:pPr>
+              <a:t>Signed requests</a:t>
+            </a:r>
+          </a:p>
+          <a:p xmlns:a="http://schemas.openxmlformats.org/drawingml/2006/main">
+            <a:pPr>
+              <a:buNone/>
               <a:defRPr sz="2250" b="0">
                 <a:solidFill>
                   <a:srgbClr val="49616A"/>
@@ -5170,11 +5294,12 @@
                 <a:ea typeface="Aptos"/>
                 <a:cs typeface="Aptos"/>
               </a:rPr>
-              <a:t>Existing native task IDs</a:t>
-            </a:r>
-          </a:p>
-          <a:p xmlns:a="http://schemas.openxmlformats.org/drawingml/2006/main">
-            <a:pPr>
+              <a:t>Identity and native task IDs</a:t>
+            </a:r>
+          </a:p>
+          <a:p xmlns:a="http://schemas.openxmlformats.org/drawingml/2006/main">
+            <a:pPr>
+              <a:buNone/>
               <a:defRPr sz="2250" b="0">
                 <a:solidFill>
                   <a:srgbClr val="49616A"/>
@@ -5193,11 +5318,12 @@
                 <a:ea typeface="Aptos"/>
                 <a:cs typeface="Aptos"/>
               </a:rPr>
-              <a:t>Shared decisions and receipts</a:t>
-            </a:r>
-          </a:p>
-          <a:p xmlns:a="http://schemas.openxmlformats.org/drawingml/2006/main">
-            <a:pPr>
+              <a:t>Native decisions</a:t>
+            </a:r>
+          </a:p>
+          <a:p xmlns:a="http://schemas.openxmlformats.org/drawingml/2006/main">
+            <a:pPr>
+              <a:buNone/>
               <a:defRPr sz="2250" b="0">
                 <a:solidFill>
                   <a:srgbClr val="49616A"/>
@@ -5298,6 +5424,7 @@
           </a:lstStyle>
           <a:p xmlns:a="http://schemas.openxmlformats.org/drawingml/2006/main">
             <a:pPr>
+              <a:buNone/>
               <a:defRPr sz="1875" b="1">
                 <a:solidFill>
                   <a:srgbClr val="157D80"/>
@@ -5365,6 +5492,7 @@
           </a:lstStyle>
           <a:p xmlns:a="http://schemas.openxmlformats.org/drawingml/2006/main">
             <a:pPr>
+              <a:buNone/>
               <a:defRPr sz="2250" b="0">
                 <a:solidFill>
                   <a:srgbClr val="49616A"/>
@@ -5383,11 +5511,12 @@
                 <a:ea typeface="Aptos"/>
                 <a:cs typeface="Aptos"/>
               </a:rPr>
-              <a:t>Qualified hardened provider</a:t>
-            </a:r>
-          </a:p>
-          <a:p xmlns:a="http://schemas.openxmlformats.org/drawingml/2006/main">
-            <a:pPr>
+              <a:t>Existing hardened provider</a:t>
+            </a:r>
+          </a:p>
+          <a:p xmlns:a="http://schemas.openxmlformats.org/drawingml/2006/main">
+            <a:pPr>
+              <a:buNone/>
               <a:defRPr sz="2250" b="0">
                 <a:solidFill>
                   <a:srgbClr val="49616A"/>
@@ -5406,11 +5535,12 @@
                 <a:ea typeface="Aptos"/>
                 <a:cs typeface="Aptos"/>
               </a:rPr>
-              <a:t>Client-side task isolation</a:t>
-            </a:r>
-          </a:p>
-          <a:p xmlns:a="http://schemas.openxmlformats.org/drawingml/2006/main">
-            <a:pPr>
+              <a:t>Isolation qualification pending</a:t>
+            </a:r>
+          </a:p>
+          <a:p xmlns:a="http://schemas.openxmlformats.org/drawingml/2006/main">
+            <a:pPr>
+              <a:buNone/>
               <a:defRPr sz="2250" b="0">
                 <a:solidFill>
                   <a:srgbClr val="49616A"/>
@@ -5434,6 +5564,7 @@
           </a:p>
           <a:p xmlns:a="http://schemas.openxmlformats.org/drawingml/2006/main">
             <a:pPr>
+              <a:buNone/>
               <a:defRPr sz="2250" b="0">
                 <a:solidFill>
                   <a:srgbClr val="49616A"/>
@@ -5501,6 +5632,7 @@
           </a:lstStyle>
           <a:p xmlns:a="http://schemas.openxmlformats.org/drawingml/2006/main">
             <a:pPr>
+              <a:buNone/>
               <a:defRPr sz="2100" b="0">
                 <a:solidFill>
                   <a:srgbClr val="132E38"/>
@@ -5597,6 +5729,7 @@
           </a:lstStyle>
           <a:p xmlns:a="http://schemas.openxmlformats.org/drawingml/2006/main">
             <a:pPr>
+              <a:buNone/>
               <a:defRPr sz="1350" b="1">
                 <a:solidFill>
                   <a:srgbClr val="157D80"/>
@@ -5664,6 +5797,7 @@
           </a:lstStyle>
           <a:p xmlns:a="http://schemas.openxmlformats.org/drawingml/2006/main">
             <a:pPr>
+              <a:buNone/>
               <a:defRPr sz="3450" b="1">
                 <a:solidFill>
                   <a:srgbClr val="132E38"/>
@@ -5731,6 +5865,7 @@
           </a:lstStyle>
           <a:p xmlns:a="http://schemas.openxmlformats.org/drawingml/2006/main">
             <a:pPr>
+              <a:buNone/>
               <a:defRPr sz="1800" b="0">
                 <a:solidFill>
                   <a:srgbClr val="49616A"/>
@@ -5749,7 +5884,7 @@
                 <a:ea typeface="Aptos"/>
                 <a:cs typeface="Aptos"/>
               </a:rPr>
-              <a:t>Meet recording and Gemini processing feed the organization’s Drive folder.</a:t>
+              <a:t>Target: authorized Meet/Gemini output in Drive, then members-only portal publication.</a:t>
             </a:r>
           </a:p>
         </p:txBody>
@@ -5829,6 +5964,7 @@
           </a:lstStyle>
           <a:p xmlns:a="http://schemas.openxmlformats.org/drawingml/2006/main">
             <a:pPr>
+              <a:buNone/>
               <a:defRPr sz="1275" b="0">
                 <a:solidFill>
                   <a:srgbClr val="49616A"/>
@@ -5847,7 +5983,7 @@
                 <a:ea typeface="Aptos"/>
                 <a:cs typeface="Aptos"/>
               </a:rPr>
-              <a:t>INERTIA-2026-10-23-r8 · 23 October 2026 · Autonomous build</a:t>
+              <a:t>INERTIA-2026-10-23-r9 · 23 October 2026 · Autonomous build</a:t>
             </a:r>
           </a:p>
         </p:txBody>
@@ -5896,6 +6032,7 @@
           </a:lstStyle>
           <a:p xmlns:a="http://schemas.openxmlformats.org/drawingml/2006/main">
             <a:pPr>
+              <a:buNone/>
               <a:defRPr sz="1800" b="1">
                 <a:solidFill>
                   <a:srgbClr val="157D80"/>
@@ -5996,6 +6133,7 @@
           </a:lstStyle>
           <a:p xmlns:a="http://schemas.openxmlformats.org/drawingml/2006/main">
             <a:pPr>
+              <a:buNone/>
               <a:defRPr sz="1875" b="1">
                 <a:solidFill>
                   <a:srgbClr val="157D80"/>
@@ -6063,6 +6201,7 @@
           </a:lstStyle>
           <a:p xmlns:a="http://schemas.openxmlformats.org/drawingml/2006/main">
             <a:pPr>
+              <a:buNone/>
               <a:defRPr sz="2250" b="0">
                 <a:solidFill>
                   <a:srgbClr val="49616A"/>
@@ -6086,6 +6225,7 @@
           </a:p>
           <a:p xmlns:a="http://schemas.openxmlformats.org/drawingml/2006/main">
             <a:pPr>
+              <a:buNone/>
               <a:defRPr sz="2250" b="0">
                 <a:solidFill>
                   <a:srgbClr val="49616A"/>
@@ -6109,6 +6249,7 @@
           </a:p>
           <a:p xmlns:a="http://schemas.openxmlformats.org/drawingml/2006/main">
             <a:pPr>
+              <a:buNone/>
               <a:defRPr sz="2250" b="0">
                 <a:solidFill>
                   <a:srgbClr val="49616A"/>
@@ -6132,6 +6273,7 @@
           </a:p>
           <a:p xmlns:a="http://schemas.openxmlformats.org/drawingml/2006/main">
             <a:pPr>
+              <a:buNone/>
               <a:defRPr sz="2250" b="0">
                 <a:solidFill>
                   <a:srgbClr val="49616A"/>
@@ -6232,6 +6374,7 @@
           </a:lstStyle>
           <a:p xmlns:a="http://schemas.openxmlformats.org/drawingml/2006/main">
             <a:pPr>
+              <a:buNone/>
               <a:defRPr sz="1875" b="1">
                 <a:solidFill>
                   <a:srgbClr val="157D80"/>
@@ -6299,6 +6442,7 @@
           </a:lstStyle>
           <a:p xmlns:a="http://schemas.openxmlformats.org/drawingml/2006/main">
             <a:pPr>
+              <a:buNone/>
               <a:defRPr sz="2250" b="0">
                 <a:solidFill>
                   <a:srgbClr val="49616A"/>
@@ -6317,11 +6461,12 @@
                 <a:ea typeface="Aptos"/>
                 <a:cs typeface="Aptos"/>
               </a:rPr>
-              <a:t>Separate transcript and notes</a:t>
-            </a:r>
-          </a:p>
-          <a:p xmlns:a="http://schemas.openxmlformats.org/drawingml/2006/main">
-            <a:pPr>
+              <a:t>Transcript plus notes</a:t>
+            </a:r>
+          </a:p>
+          <a:p xmlns:a="http://schemas.openxmlformats.org/drawingml/2006/main">
+            <a:pPr>
+              <a:buNone/>
               <a:defRPr sz="2250" b="0">
                 <a:solidFill>
                   <a:srgbClr val="49616A"/>
@@ -6340,11 +6485,12 @@
                 <a:ea typeface="Aptos"/>
                 <a:cs typeface="Aptos"/>
               </a:rPr>
-              <a:t>Cite source for action items</a:t>
-            </a:r>
-          </a:p>
-          <a:p xmlns:a="http://schemas.openxmlformats.org/drawingml/2006/main">
-            <a:pPr>
+              <a:t>Cite each action item</a:t>
+            </a:r>
+          </a:p>
+          <a:p xmlns:a="http://schemas.openxmlformats.org/drawingml/2006/main">
+            <a:pPr>
+              <a:buNone/>
               <a:defRPr sz="2250" b="0">
                 <a:solidFill>
                   <a:srgbClr val="49616A"/>
@@ -6368,6 +6514,7 @@
           </a:p>
           <a:p xmlns:a="http://schemas.openxmlformats.org/drawingml/2006/main">
             <a:pPr>
+              <a:buNone/>
               <a:defRPr sz="2250" b="0">
                 <a:solidFill>
                   <a:srgbClr val="49616A"/>
@@ -6468,6 +6615,7 @@
           </a:lstStyle>
           <a:p xmlns:a="http://schemas.openxmlformats.org/drawingml/2006/main">
             <a:pPr>
+              <a:buNone/>
               <a:defRPr sz="1875" b="1">
                 <a:solidFill>
                   <a:srgbClr val="157D80"/>
@@ -6535,6 +6683,7 @@
           </a:lstStyle>
           <a:p xmlns:a="http://schemas.openxmlformats.org/drawingml/2006/main">
             <a:pPr>
+              <a:buNone/>
               <a:defRPr sz="2250" b="0">
                 <a:solidFill>
                   <a:srgbClr val="49616A"/>
@@ -6553,11 +6702,12 @@
                 <a:ea typeface="Aptos"/>
                 <a:cs typeface="Aptos"/>
               </a:rPr>
-              <a:t>Upsert the website record</a:t>
-            </a:r>
-          </a:p>
-          <a:p xmlns:a="http://schemas.openxmlformats.org/drawingml/2006/main">
-            <a:pPr>
+              <a:t>Caller contract-tested</a:t>
+            </a:r>
+          </a:p>
+          <a:p xmlns:a="http://schemas.openxmlformats.org/drawingml/2006/main">
+            <a:pPr>
+              <a:buNone/>
               <a:defRPr sz="2250" b="0">
                 <a:solidFill>
                   <a:srgbClr val="49616A"/>
@@ -6576,11 +6726,36 @@
                 <a:ea typeface="Aptos"/>
                 <a:cs typeface="Aptos"/>
               </a:rPr>
+              <a:t>Exact persisted request bytes</a:t>
+            </a:r>
+          </a:p>
+          <a:p xmlns:a="http://schemas.openxmlformats.org/drawingml/2006/main">
+            <a:pPr>
+              <a:buNone/>
+              <a:defRPr sz="2250" b="0">
+                <a:solidFill>
+                  <a:srgbClr val="49616A"/>
+                </a:solidFill>
+                <a:latin typeface="Aptos"/>
+                <a:ea typeface="Aptos"/>
+                <a:cs typeface="Aptos"/>
+              </a:defRPr>
+            </a:pPr>
+            <a:r>
+              <a:rPr sz="2250" b="0">
+                <a:solidFill>
+                  <a:srgbClr val="49616A"/>
+                </a:solidFill>
+                <a:latin typeface="Aptos"/>
+                <a:ea typeface="Aptos"/>
+                <a:cs typeface="Aptos"/>
+              </a:rPr>
               <a:t>Verify content and audience</a:t>
             </a:r>
           </a:p>
           <a:p xmlns:a="http://schemas.openxmlformats.org/drawingml/2006/main">
             <a:pPr>
+              <a:buNone/>
               <a:defRPr sz="2250" b="0">
                 <a:solidFill>
                   <a:srgbClr val="49616A"/>
@@ -6599,30 +6774,7 @@
                 <a:ea typeface="Aptos"/>
                 <a:cs typeface="Aptos"/>
               </a:rPr>
-              <a:t>Return the published URLs</a:t>
-            </a:r>
-          </a:p>
-          <a:p xmlns:a="http://schemas.openxmlformats.org/drawingml/2006/main">
-            <a:pPr>
-              <a:defRPr sz="2250" b="0">
-                <a:solidFill>
-                  <a:srgbClr val="49616A"/>
-                </a:solidFill>
-                <a:latin typeface="Aptos"/>
-                <a:ea typeface="Aptos"/>
-                <a:cs typeface="Aptos"/>
-              </a:defRPr>
-            </a:pPr>
-            <a:r>
-              <a:rPr sz="2250" b="0">
-                <a:solidFill>
-                  <a:srgbClr val="49616A"/>
-                </a:solidFill>
-                <a:latin typeface="Aptos"/>
-                <a:ea typeface="Aptos"/>
-                <a:cs typeface="Aptos"/>
-              </a:rPr>
-              <a:t>Reconcile corrections and retries</a:t>
+              <a:t>Server rollout still pending</a:t>
             </a:r>
           </a:p>
         </p:txBody>
@@ -6671,6 +6823,7 @@
           </a:lstStyle>
           <a:p xmlns:a="http://schemas.openxmlformats.org/drawingml/2006/main">
             <a:pPr>
+              <a:buNone/>
               <a:defRPr sz="2100" b="0">
                 <a:solidFill>
                   <a:srgbClr val="132E38"/>
@@ -6689,7 +6842,7 @@
                 <a:ea typeface="Aptos"/>
                 <a:cs typeface="Aptos"/>
               </a:rPr>
-              <a:t>After one-time setup, routine publication runs automatically. Exceptions name the precise action needed.</a:t>
+              <a:t>Proposed v1.1 contract keeps v1 hashing. Metadata-only correction needs a new codec. Source and job wiring remain pending.</a:t>
             </a:r>
           </a:p>
         </p:txBody>
@@ -6767,6 +6920,7 @@
           </a:lstStyle>
           <a:p xmlns:a="http://schemas.openxmlformats.org/drawingml/2006/main">
             <a:pPr>
+              <a:buNone/>
               <a:defRPr sz="1350" b="1">
                 <a:solidFill>
                   <a:srgbClr val="157D80"/>
@@ -6834,6 +6988,7 @@
           </a:lstStyle>
           <a:p xmlns:a="http://schemas.openxmlformats.org/drawingml/2006/main">
             <a:pPr>
+              <a:buNone/>
               <a:defRPr sz="3450" b="1">
                 <a:solidFill>
                   <a:srgbClr val="132E38"/>
@@ -6901,6 +7056,7 @@
           </a:lstStyle>
           <a:p xmlns:a="http://schemas.openxmlformats.org/drawingml/2006/main">
             <a:pPr>
+              <a:buNone/>
               <a:defRPr sz="1800" b="0">
                 <a:solidFill>
                   <a:srgbClr val="49616A"/>
@@ -6999,6 +7155,7 @@
           </a:lstStyle>
           <a:p xmlns:a="http://schemas.openxmlformats.org/drawingml/2006/main">
             <a:pPr>
+              <a:buNone/>
               <a:defRPr sz="1275" b="0">
                 <a:solidFill>
                   <a:srgbClr val="49616A"/>
@@ -7017,7 +7174,7 @@
                 <a:ea typeface="Aptos"/>
                 <a:cs typeface="Aptos"/>
               </a:rPr>
-              <a:t>INERTIA-2026-10-23-r8 · 23 October 2026 · Autonomous build</a:t>
+              <a:t>INERTIA-2026-10-23-r9 · 23 October 2026 · Autonomous build</a:t>
             </a:r>
           </a:p>
         </p:txBody>
@@ -7066,6 +7223,7 @@
           </a:lstStyle>
           <a:p xmlns:a="http://schemas.openxmlformats.org/drawingml/2006/main">
             <a:pPr>
+              <a:buNone/>
               <a:defRPr sz="1800" b="1">
                 <a:solidFill>
                   <a:srgbClr val="157D80"/>
@@ -7166,6 +7324,7 @@
           </a:lstStyle>
           <a:p xmlns:a="http://schemas.openxmlformats.org/drawingml/2006/main">
             <a:pPr>
+              <a:buNone/>
               <a:defRPr sz="1875" b="1">
                 <a:solidFill>
                   <a:srgbClr val="157D80"/>
@@ -7233,6 +7392,7 @@
           </a:lstStyle>
           <a:p xmlns:a="http://schemas.openxmlformats.org/drawingml/2006/main">
             <a:pPr>
+              <a:buNone/>
               <a:defRPr sz="2250" b="0">
                 <a:solidFill>
                   <a:srgbClr val="49616A"/>
@@ -7256,6 +7416,7 @@
           </a:p>
           <a:p xmlns:a="http://schemas.openxmlformats.org/drawingml/2006/main">
             <a:pPr>
+              <a:buNone/>
               <a:defRPr sz="2250" b="0">
                 <a:solidFill>
                   <a:srgbClr val="49616A"/>
@@ -7274,11 +7435,12 @@
                 <a:ea typeface="Aptos"/>
                 <a:cs typeface="Aptos"/>
               </a:rPr>
-              <a:t>Retrieve authorized DAO facts</a:t>
-            </a:r>
-          </a:p>
-          <a:p xmlns:a="http://schemas.openxmlformats.org/drawingml/2006/main">
-            <a:pPr>
+              <a:t>Use cited DAO draft facts</a:t>
+            </a:r>
+          </a:p>
+          <a:p xmlns:a="http://schemas.openxmlformats.org/drawingml/2006/main">
+            <a:pPr>
+              <a:buNone/>
               <a:defRPr sz="2250" b="0">
                 <a:solidFill>
                   <a:srgbClr val="49616A"/>
@@ -7297,11 +7459,12 @@
                 <a:ea typeface="Aptos"/>
                 <a:cs typeface="Aptos"/>
               </a:rPr>
-              <a:t>Build a cited, eligible packet</a:t>
-            </a:r>
-          </a:p>
-          <a:p xmlns:a="http://schemas.openxmlformats.org/drawingml/2006/main">
-            <a:pPr>
+              <a:t>Verify legal/tax eligibility</a:t>
+            </a:r>
+          </a:p>
+          <a:p xmlns:a="http://schemas.openxmlformats.org/drawingml/2006/main">
+            <a:pPr>
+              <a:buNone/>
               <a:defRPr sz="2250" b="0">
                 <a:solidFill>
                   <a:srgbClr val="49616A"/>
@@ -7402,6 +7565,7 @@
           </a:lstStyle>
           <a:p xmlns:a="http://schemas.openxmlformats.org/drawingml/2006/main">
             <a:pPr>
+              <a:buNone/>
               <a:defRPr sz="1875" b="1">
                 <a:solidFill>
                   <a:srgbClr val="157D80"/>
@@ -7469,6 +7633,7 @@
           </a:lstStyle>
           <a:p xmlns:a="http://schemas.openxmlformats.org/drawingml/2006/main">
             <a:pPr>
+              <a:buNone/>
               <a:defRPr sz="2250" b="0">
                 <a:solidFill>
                   <a:srgbClr val="49616A"/>
@@ -7492,6 +7657,7 @@
           </a:p>
           <a:p xmlns:a="http://schemas.openxmlformats.org/drawingml/2006/main">
             <a:pPr>
+              <a:buNone/>
               <a:defRPr sz="2250" b="0">
                 <a:solidFill>
                   <a:srgbClr val="49616A"/>
@@ -7515,6 +7681,7 @@
           </a:p>
           <a:p xmlns:a="http://schemas.openxmlformats.org/drawingml/2006/main">
             <a:pPr>
+              <a:buNone/>
               <a:defRPr sz="2250" b="0">
                 <a:solidFill>
                   <a:srgbClr val="49616A"/>
@@ -7538,6 +7705,7 @@
           </a:p>
           <a:p xmlns:a="http://schemas.openxmlformats.org/drawingml/2006/main">
             <a:pPr>
+              <a:buNone/>
               <a:defRPr sz="2250" b="0">
                 <a:solidFill>
                   <a:srgbClr val="49616A"/>
@@ -7638,6 +7806,7 @@
           </a:lstStyle>
           <a:p xmlns:a="http://schemas.openxmlformats.org/drawingml/2006/main">
             <a:pPr>
+              <a:buNone/>
               <a:defRPr sz="1875" b="1">
                 <a:solidFill>
                   <a:srgbClr val="157D80"/>
@@ -7705,6 +7874,7 @@
           </a:lstStyle>
           <a:p xmlns:a="http://schemas.openxmlformats.org/drawingml/2006/main">
             <a:pPr>
+              <a:buNone/>
               <a:defRPr sz="2250" b="0">
                 <a:solidFill>
                   <a:srgbClr val="49616A"/>
@@ -7728,6 +7898,7 @@
           </a:p>
           <a:p xmlns:a="http://schemas.openxmlformats.org/drawingml/2006/main">
             <a:pPr>
+              <a:buNone/>
               <a:defRPr sz="2250" b="0">
                 <a:solidFill>
                   <a:srgbClr val="49616A"/>
@@ -7751,6 +7922,7 @@
           </a:p>
           <a:p xmlns:a="http://schemas.openxmlformats.org/drawingml/2006/main">
             <a:pPr>
+              <a:buNone/>
               <a:defRPr sz="2250" b="0">
                 <a:solidFill>
                   <a:srgbClr val="49616A"/>
@@ -7774,6 +7946,7 @@
           </a:p>
           <a:p xmlns:a="http://schemas.openxmlformats.org/drawingml/2006/main">
             <a:pPr>
+              <a:buNone/>
               <a:defRPr sz="2250" b="0">
                 <a:solidFill>
                   <a:srgbClr val="49616A"/>
@@ -7841,6 +8014,7 @@
           </a:lstStyle>
           <a:p xmlns:a="http://schemas.openxmlformats.org/drawingml/2006/main">
             <a:pPr>
+              <a:buNone/>
               <a:defRPr sz="2100" b="0">
                 <a:solidFill>
                   <a:srgbClr val="132E38"/>
@@ -7859,7 +8033,7 @@
                 <a:ea typeface="Aptos"/>
                 <a:cs typeface="Aptos"/>
               </a:rPr>
-              <a:t>The demo demonstrates the ratified packet. Actual funder submission remains a separately authorized action.</a:t>
+              <a:t>The synthetic demo binds a packet to fixture vote evidence. Operative governance and live verification remain pending.</a:t>
             </a:r>
           </a:p>
         </p:txBody>
@@ -7937,6 +8111,7 @@
           </a:lstStyle>
           <a:p xmlns:a="http://schemas.openxmlformats.org/drawingml/2006/main">
             <a:pPr>
+              <a:buNone/>
               <a:defRPr sz="1350" b="1">
                 <a:solidFill>
                   <a:srgbClr val="157D80"/>
@@ -8004,6 +8179,7 @@
           </a:lstStyle>
           <a:p xmlns:a="http://schemas.openxmlformats.org/drawingml/2006/main">
             <a:pPr>
+              <a:buNone/>
               <a:defRPr sz="3450" b="1">
                 <a:solidFill>
                   <a:srgbClr val="132E38"/>
@@ -8071,6 +8247,7 @@
           </a:lstStyle>
           <a:p xmlns:a="http://schemas.openxmlformats.org/drawingml/2006/main">
             <a:pPr>
+              <a:buNone/>
               <a:defRPr sz="1800" b="0">
                 <a:solidFill>
                   <a:srgbClr val="49616A"/>
@@ -8089,7 +8266,7 @@
                 <a:ea typeface="Aptos"/>
                 <a:cs typeface="Aptos"/>
               </a:rPr>
-              <a:t>An enrolled member’s agent contributes from its own isolated execution environment.</a:t>
+              <a:t>Target: an enrolled member’s agent contributes from its own isolated execution environment.</a:t>
             </a:r>
           </a:p>
         </p:txBody>
@@ -8169,6 +8346,7 @@
           </a:lstStyle>
           <a:p xmlns:a="http://schemas.openxmlformats.org/drawingml/2006/main">
             <a:pPr>
+              <a:buNone/>
               <a:defRPr sz="1275" b="0">
                 <a:solidFill>
                   <a:srgbClr val="49616A"/>
@@ -8187,7 +8365,7 @@
                 <a:ea typeface="Aptos"/>
                 <a:cs typeface="Aptos"/>
               </a:rPr>
-              <a:t>INERTIA-2026-10-23-r8 · 23 October 2026 · Autonomous build</a:t>
+              <a:t>INERTIA-2026-10-23-r9 · 23 October 2026 · Autonomous build</a:t>
             </a:r>
           </a:p>
         </p:txBody>
@@ -8236,6 +8414,7 @@
           </a:lstStyle>
           <a:p xmlns:a="http://schemas.openxmlformats.org/drawingml/2006/main">
             <a:pPr>
+              <a:buNone/>
               <a:defRPr sz="1800" b="1">
                 <a:solidFill>
                   <a:srgbClr val="157D80"/>
@@ -8336,6 +8515,7 @@
           </a:lstStyle>
           <a:p xmlns:a="http://schemas.openxmlformats.org/drawingml/2006/main">
             <a:pPr>
+              <a:buNone/>
               <a:defRPr sz="1875" b="1">
                 <a:solidFill>
                   <a:srgbClr val="157D80"/>
@@ -8403,6 +8583,7 @@
           </a:lstStyle>
           <a:p xmlns:a="http://schemas.openxmlformats.org/drawingml/2006/main">
             <a:pPr>
+              <a:buNone/>
               <a:defRPr sz="2250" b="0">
                 <a:solidFill>
                   <a:srgbClr val="49616A"/>
@@ -8421,11 +8602,12 @@
                 <a:ea typeface="Aptos"/>
                 <a:cs typeface="Aptos"/>
               </a:rPr>
-              <a:t>Native CEO delegates work</a:t>
-            </a:r>
-          </a:p>
-          <a:p xmlns:a="http://schemas.openxmlformats.org/drawingml/2006/main">
-            <a:pPr>
+              <a:t>Assigned CEO intake mandate</a:t>
+            </a:r>
+          </a:p>
+          <a:p xmlns:a="http://schemas.openxmlformats.org/drawingml/2006/main">
+            <a:pPr>
+              <a:buNone/>
               <a:defRPr sz="2250" b="0">
                 <a:solidFill>
                   <a:srgbClr val="49616A"/>
@@ -8444,11 +8626,12 @@
                 <a:ea typeface="Aptos"/>
                 <a:cs typeface="Aptos"/>
               </a:rPr>
-              <a:t>Agent selects eligible tasks</a:t>
-            </a:r>
-          </a:p>
-          <a:p xmlns:a="http://schemas.openxmlformats.org/drawingml/2006/main">
-            <a:pPr>
+              <a:t>Scoped eligible work</a:t>
+            </a:r>
+          </a:p>
+          <a:p xmlns:a="http://schemas.openxmlformats.org/drawingml/2006/main">
+            <a:pPr>
+              <a:buNone/>
               <a:defRPr sz="2250" b="0">
                 <a:solidFill>
                   <a:srgbClr val="49616A"/>
@@ -8472,6 +8655,7 @@
           </a:p>
           <a:p xmlns:a="http://schemas.openxmlformats.org/drawingml/2006/main">
             <a:pPr>
+              <a:buNone/>
               <a:defRPr sz="2250" b="0">
                 <a:solidFill>
                   <a:srgbClr val="49616A"/>
@@ -8572,6 +8756,7 @@
           </a:lstStyle>
           <a:p xmlns:a="http://schemas.openxmlformats.org/drawingml/2006/main">
             <a:pPr>
+              <a:buNone/>
               <a:defRPr sz="1875" b="1">
                 <a:solidFill>
                   <a:srgbClr val="157D80"/>
@@ -8639,6 +8824,7 @@
           </a:lstStyle>
           <a:p xmlns:a="http://schemas.openxmlformats.org/drawingml/2006/main">
             <a:pPr>
+              <a:buNone/>
               <a:defRPr sz="2250" b="0">
                 <a:solidFill>
                   <a:srgbClr val="49616A"/>
@@ -8662,6 +8848,7 @@
           </a:p>
           <a:p xmlns:a="http://schemas.openxmlformats.org/drawingml/2006/main">
             <a:pPr>
+              <a:buNone/>
               <a:defRPr sz="2250" b="0">
                 <a:solidFill>
                   <a:srgbClr val="49616A"/>
@@ -8680,11 +8867,12 @@
                 <a:ea typeface="Aptos"/>
                 <a:cs typeface="Aptos"/>
               </a:rPr>
-              <a:t>Sandbox and isolated worktree</a:t>
-            </a:r>
-          </a:p>
-          <a:p xmlns:a="http://schemas.openxmlformats.org/drawingml/2006/main">
-            <a:pPr>
+              <a:t>Sandbox and isolated files</a:t>
+            </a:r>
+          </a:p>
+          <a:p xmlns:a="http://schemas.openxmlformats.org/drawingml/2006/main">
+            <a:pPr>
+              <a:buNone/>
               <a:defRPr sz="2250" b="0">
                 <a:solidFill>
                   <a:srgbClr val="49616A"/>
@@ -8708,6 +8896,7 @@
           </a:p>
           <a:p xmlns:a="http://schemas.openxmlformats.org/drawingml/2006/main">
             <a:pPr>
+              <a:buNone/>
               <a:defRPr sz="2250" b="0">
                 <a:solidFill>
                   <a:srgbClr val="49616A"/>
@@ -8726,7 +8915,7 @@
                 <a:ea typeface="Aptos"/>
                 <a:cs typeface="Aptos"/>
               </a:rPr>
-              <a:t>No shared publisher credentials</a:t>
+              <a:t>No publisher credentials</a:t>
             </a:r>
           </a:p>
         </p:txBody>
@@ -8808,6 +8997,7 @@
           </a:lstStyle>
           <a:p xmlns:a="http://schemas.openxmlformats.org/drawingml/2006/main">
             <a:pPr>
+              <a:buNone/>
               <a:defRPr sz="1875" b="1">
                 <a:solidFill>
                   <a:srgbClr val="157D80"/>
@@ -8875,6 +9065,7 @@
           </a:lstStyle>
           <a:p xmlns:a="http://schemas.openxmlformats.org/drawingml/2006/main">
             <a:pPr>
+              <a:buNone/>
               <a:defRPr sz="2250" b="0">
                 <a:solidFill>
                   <a:srgbClr val="49616A"/>
@@ -8898,6 +9089,7 @@
           </a:p>
           <a:p xmlns:a="http://schemas.openxmlformats.org/drawingml/2006/main">
             <a:pPr>
+              <a:buNone/>
               <a:defRPr sz="2250" b="0">
                 <a:solidFill>
                   <a:srgbClr val="49616A"/>
@@ -8921,6 +9113,7 @@
           </a:p>
           <a:p xmlns:a="http://schemas.openxmlformats.org/drawingml/2006/main">
             <a:pPr>
+              <a:buNone/>
               <a:defRPr sz="2250" b="0">
                 <a:solidFill>
                   <a:srgbClr val="49616A"/>
@@ -8944,6 +9137,7 @@
           </a:p>
           <a:p xmlns:a="http://schemas.openxmlformats.org/drawingml/2006/main">
             <a:pPr>
+              <a:buNone/>
               <a:defRPr sz="2250" b="0">
                 <a:solidFill>
                   <a:srgbClr val="49616A"/>
@@ -9011,6 +9205,7 @@
           </a:lstStyle>
           <a:p xmlns:a="http://schemas.openxmlformats.org/drawingml/2006/main">
             <a:pPr>
+              <a:buNone/>
               <a:defRPr sz="2100" b="0">
                 <a:solidFill>
                   <a:srgbClr val="132E38"/>
@@ -9107,6 +9302,7 @@
           </a:lstStyle>
           <a:p xmlns:a="http://schemas.openxmlformats.org/drawingml/2006/main">
             <a:pPr>
+              <a:buNone/>
               <a:defRPr sz="1350" b="1">
                 <a:solidFill>
                   <a:srgbClr val="157D80"/>
@@ -9174,6 +9370,7 @@
           </a:lstStyle>
           <a:p xmlns:a="http://schemas.openxmlformats.org/drawingml/2006/main">
             <a:pPr>
+              <a:buNone/>
               <a:defRPr sz="3450" b="1">
                 <a:solidFill>
                   <a:srgbClr val="132E38"/>
@@ -9241,6 +9438,7 @@
           </a:lstStyle>
           <a:p xmlns:a="http://schemas.openxmlformats.org/drawingml/2006/main">
             <a:pPr>
+              <a:buNone/>
               <a:defRPr sz="1800" b="0">
                 <a:solidFill>
                   <a:srgbClr val="49616A"/>
@@ -9339,6 +9537,7 @@
           </a:lstStyle>
           <a:p xmlns:a="http://schemas.openxmlformats.org/drawingml/2006/main">
             <a:pPr>
+              <a:buNone/>
               <a:defRPr sz="1275" b="0">
                 <a:solidFill>
                   <a:srgbClr val="49616A"/>
@@ -9357,7 +9556,7 @@
                 <a:ea typeface="Aptos"/>
                 <a:cs typeface="Aptos"/>
               </a:rPr>
-              <a:t>INERTIA-2026-10-23-r8 · 23 October 2026 · Autonomous build</a:t>
+              <a:t>INERTIA-2026-10-23-r9 · 23 October 2026 · Autonomous build</a:t>
             </a:r>
           </a:p>
         </p:txBody>
@@ -9406,6 +9605,7 @@
           </a:lstStyle>
           <a:p xmlns:a="http://schemas.openxmlformats.org/drawingml/2006/main">
             <a:pPr>
+              <a:buNone/>
               <a:defRPr sz="1800" b="1">
                 <a:solidFill>
                   <a:srgbClr val="157D80"/>
@@ -9506,6 +9706,7 @@
           </a:lstStyle>
           <a:p xmlns:a="http://schemas.openxmlformats.org/drawingml/2006/main">
             <a:pPr>
+              <a:buNone/>
               <a:defRPr sz="1875" b="1">
                 <a:solidFill>
                   <a:srgbClr val="157D80"/>
@@ -9573,6 +9774,7 @@
           </a:lstStyle>
           <a:p xmlns:a="http://schemas.openxmlformats.org/drawingml/2006/main">
             <a:pPr>
+              <a:buNone/>
               <a:defRPr sz="2250" b="0">
                 <a:solidFill>
                   <a:srgbClr val="49616A"/>
@@ -9591,11 +9793,12 @@
                 <a:ea typeface="Aptos"/>
                 <a:cs typeface="Aptos"/>
               </a:rPr>
-              <a:t>Install verified archive</a:t>
-            </a:r>
-          </a:p>
-          <a:p xmlns:a="http://schemas.openxmlformats.org/drawingml/2006/main">
-            <a:pPr>
+              <a:t>Private authenticated host</a:t>
+            </a:r>
+          </a:p>
+          <a:p xmlns:a="http://schemas.openxmlformats.org/drawingml/2006/main">
+            <a:pPr>
+              <a:buNone/>
               <a:defRPr sz="2250" b="0">
                 <a:solidFill>
                   <a:srgbClr val="49616A"/>
@@ -9614,11 +9817,12 @@
                 <a:ea typeface="Aptos"/>
                 <a:cs typeface="Aptos"/>
               </a:rPr>
-              <a:t>Use Node 24.11 or newer</a:t>
-            </a:r>
-          </a:p>
-          <a:p xmlns:a="http://schemas.openxmlformats.org/drawingml/2006/main">
-            <a:pPr>
+              <a:t>Durable database and backups</a:t>
+            </a:r>
+          </a:p>
+          <a:p xmlns:a="http://schemas.openxmlformats.org/drawingml/2006/main">
+            <a:pPr>
+              <a:buNone/>
               <a:defRPr sz="2250" b="0">
                 <a:solidFill>
                   <a:srgbClr val="49616A"/>
@@ -9637,11 +9841,12 @@
                 <a:ea typeface="Aptos"/>
                 <a:cs typeface="Aptos"/>
               </a:rPr>
-              <a:t>Fill disabled configuration</a:t>
-            </a:r>
-          </a:p>
-          <a:p xmlns:a="http://schemas.openxmlformats.org/drawingml/2006/main">
-            <a:pPr>
+              <a:t>Approved relay and pairing</a:t>
+            </a:r>
+          </a:p>
+          <a:p xmlns:a="http://schemas.openxmlformats.org/drawingml/2006/main">
+            <a:pPr>
+              <a:buNone/>
               <a:defRPr sz="2250" b="0">
                 <a:solidFill>
                   <a:srgbClr val="49616A"/>
@@ -9660,7 +9865,7 @@
                 <a:ea typeface="Aptos"/>
                 <a:cs typeface="Aptos"/>
               </a:rPr>
-              <a:t>Validate, pair and enable</a:t>
+              <a:t>Validate while disabled</a:t>
             </a:r>
           </a:p>
         </p:txBody>
@@ -9742,6 +9947,7 @@
           </a:lstStyle>
           <a:p xmlns:a="http://schemas.openxmlformats.org/drawingml/2006/main">
             <a:pPr>
+              <a:buNone/>
               <a:defRPr sz="1875" b="1">
                 <a:solidFill>
                   <a:srgbClr val="157D80"/>
@@ -9809,6 +10015,7 @@
           </a:lstStyle>
           <a:p xmlns:a="http://schemas.openxmlformats.org/drawingml/2006/main">
             <a:pPr>
+              <a:buNone/>
               <a:defRPr sz="2250" b="0">
                 <a:solidFill>
                   <a:srgbClr val="49616A"/>
@@ -9832,6 +10039,7 @@
           </a:p>
           <a:p xmlns:a="http://schemas.openxmlformats.org/drawingml/2006/main">
             <a:pPr>
+              <a:buNone/>
               <a:defRPr sz="2250" b="0">
                 <a:solidFill>
                   <a:srgbClr val="49616A"/>
@@ -9855,6 +10063,7 @@
           </a:p>
           <a:p xmlns:a="http://schemas.openxmlformats.org/drawingml/2006/main">
             <a:pPr>
+              <a:buNone/>
               <a:defRPr sz="2250" b="0">
                 <a:solidFill>
                   <a:srgbClr val="49616A"/>
@@ -9878,6 +10087,7 @@
           </a:p>
           <a:p xmlns:a="http://schemas.openxmlformats.org/drawingml/2006/main">
             <a:pPr>
+              <a:buNone/>
               <a:defRPr sz="2250" b="0">
                 <a:solidFill>
                   <a:srgbClr val="49616A"/>
@@ -9978,6 +10188,7 @@
           </a:lstStyle>
           <a:p xmlns:a="http://schemas.openxmlformats.org/drawingml/2006/main">
             <a:pPr>
+              <a:buNone/>
               <a:defRPr sz="1875" b="1">
                 <a:solidFill>
                   <a:srgbClr val="157D80"/>
@@ -10045,6 +10256,7 @@
           </a:lstStyle>
           <a:p xmlns:a="http://schemas.openxmlformats.org/drawingml/2006/main">
             <a:pPr>
+              <a:buNone/>
               <a:defRPr sz="2250" b="0">
                 <a:solidFill>
                   <a:srgbClr val="49616A"/>
@@ -10068,6 +10280,7 @@
           </a:p>
           <a:p xmlns:a="http://schemas.openxmlformats.org/drawingml/2006/main">
             <a:pPr>
+              <a:buNone/>
               <a:defRPr sz="2250" b="0">
                 <a:solidFill>
                   <a:srgbClr val="49616A"/>
@@ -10091,6 +10304,7 @@
           </a:p>
           <a:p xmlns:a="http://schemas.openxmlformats.org/drawingml/2006/main">
             <a:pPr>
+              <a:buNone/>
               <a:defRPr sz="2250" b="0">
                 <a:solidFill>
                   <a:srgbClr val="49616A"/>
@@ -10114,6 +10328,7 @@
           </a:p>
           <a:p xmlns:a="http://schemas.openxmlformats.org/drawingml/2006/main">
             <a:pPr>
+              <a:buNone/>
               <a:defRPr sz="2250" b="0">
                 <a:solidFill>
                   <a:srgbClr val="49616A"/>
@@ -10181,6 +10396,7 @@
           </a:lstStyle>
           <a:p xmlns:a="http://schemas.openxmlformats.org/drawingml/2006/main">
             <a:pPr>
+              <a:buNone/>
               <a:defRPr sz="2100" b="0">
                 <a:solidFill>
                   <a:srgbClr val="132E38"/>
@@ -10199,7 +10415,7 @@
                 <a:ea typeface="Aptos"/>
                 <a:cs typeface="Aptos"/>
               </a:rPr>
-              <a:t>Source text cannot grant authority. Current host permissions govern every human-attributed native action.</a:t>
+              <a:t>Native comments stay default-off, audience-approved and history-bounded. Uncertain claims need stopped-worker recovery.</a:t>
             </a:r>
           </a:p>
         </p:txBody>
@@ -10277,6 +10493,7 @@
           </a:lstStyle>
           <a:p xmlns:a="http://schemas.openxmlformats.org/drawingml/2006/main">
             <a:pPr>
+              <a:buNone/>
               <a:defRPr sz="1350" b="1">
                 <a:solidFill>
                   <a:srgbClr val="157D80"/>
@@ -10344,6 +10561,7 @@
           </a:lstStyle>
           <a:p xmlns:a="http://schemas.openxmlformats.org/drawingml/2006/main">
             <a:pPr>
+              <a:buNone/>
               <a:defRPr sz="3450" b="1">
                 <a:solidFill>
                   <a:srgbClr val="132E38"/>
@@ -10411,6 +10629,7 @@
           </a:lstStyle>
           <a:p xmlns:a="http://schemas.openxmlformats.org/drawingml/2006/main">
             <a:pPr>
+              <a:buNone/>
               <a:defRPr sz="1800" b="0">
                 <a:solidFill>
                   <a:srgbClr val="49616A"/>
@@ -10429,7 +10648,7 @@
                 <a:ea typeface="Aptos"/>
                 <a:cs typeface="Aptos"/>
               </a:rPr>
-              <a:t>A reproducible source-checkout rehearsal joins the meeting, signed bridge and grant cores.</a:t>
+              <a:t>PR 17 is merged into develop. The exact runtime archive passed native-service qualification.</a:t>
             </a:r>
           </a:p>
         </p:txBody>
@@ -10509,6 +10728,7 @@
           </a:lstStyle>
           <a:p xmlns:a="http://schemas.openxmlformats.org/drawingml/2006/main">
             <a:pPr>
+              <a:buNone/>
               <a:defRPr sz="1275" b="0">
                 <a:solidFill>
                   <a:srgbClr val="49616A"/>
@@ -10527,7 +10747,7 @@
                 <a:ea typeface="Aptos"/>
                 <a:cs typeface="Aptos"/>
               </a:rPr>
-              <a:t>INERTIA-2026-10-23-r8 · 23 October 2026 · Autonomous build</a:t>
+              <a:t>INERTIA-2026-10-23-r9 · 23 October 2026 · Autonomous build</a:t>
             </a:r>
           </a:p>
         </p:txBody>
@@ -10576,6 +10796,7 @@
           </a:lstStyle>
           <a:p xmlns:a="http://schemas.openxmlformats.org/drawingml/2006/main">
             <a:pPr>
+              <a:buNone/>
               <a:defRPr sz="1800" b="1">
                 <a:solidFill>
                   <a:srgbClr val="157D80"/>
@@ -10676,6 +10897,7 @@
           </a:lstStyle>
           <a:p xmlns:a="http://schemas.openxmlformats.org/drawingml/2006/main">
             <a:pPr>
+              <a:buNone/>
               <a:defRPr sz="1875" b="1">
                 <a:solidFill>
                   <a:srgbClr val="157D80"/>
@@ -10694,7 +10916,7 @@
                 <a:ea typeface="Aptos"/>
                 <a:cs typeface="Aptos"/>
               </a:rPr>
-              <a:t>Merged foundation</a:t>
+              <a:t>Reviewed foundation</a:t>
             </a:r>
           </a:p>
         </p:txBody>
@@ -10743,6 +10965,7 @@
           </a:lstStyle>
           <a:p xmlns:a="http://schemas.openxmlformats.org/drawingml/2006/main">
             <a:pPr>
+              <a:buNone/>
               <a:defRPr sz="2250" b="0">
                 <a:solidFill>
                   <a:srgbClr val="49616A"/>
@@ -10766,6 +10989,7 @@
           </a:p>
           <a:p xmlns:a="http://schemas.openxmlformats.org/drawingml/2006/main">
             <a:pPr>
+              <a:buNone/>
               <a:defRPr sz="2250" b="0">
                 <a:solidFill>
                   <a:srgbClr val="49616A"/>
@@ -10784,11 +11008,12 @@
                 <a:ea typeface="Aptos"/>
                 <a:cs typeface="Aptos"/>
               </a:rPr>
-              <a:t>Connected bridge: 85 tests</a:t>
-            </a:r>
-          </a:p>
-          <a:p xmlns:a="http://schemas.openxmlformats.org/drawingml/2006/main">
-            <a:pPr>
+              <a:t>Roundtable source/hash core</a:t>
+            </a:r>
+          </a:p>
+          <a:p xmlns:a="http://schemas.openxmlformats.org/drawingml/2006/main">
+            <a:pPr>
+              <a:buNone/>
               <a:defRPr sz="2250" b="0">
                 <a:solidFill>
                   <a:srgbClr val="49616A"/>
@@ -10807,11 +11032,12 @@
                 <a:ea typeface="Aptos"/>
                 <a:cs typeface="Aptos"/>
               </a:rPr>
-              <a:t>Roundtable core: 23 tests</a:t>
-            </a:r>
-          </a:p>
-          <a:p xmlns:a="http://schemas.openxmlformats.org/drawingml/2006/main">
-            <a:pPr>
+              <a:t>Website caller contract-tested</a:t>
+            </a:r>
+          </a:p>
+          <a:p xmlns:a="http://schemas.openxmlformats.org/drawingml/2006/main">
+            <a:pPr>
+              <a:buNone/>
               <a:defRPr sz="2250" b="0">
                 <a:solidFill>
                   <a:srgbClr val="49616A"/>
@@ -10830,7 +11056,7 @@
                 <a:ea typeface="Aptos"/>
                 <a:cs typeface="Aptos"/>
               </a:rPr>
-              <a:t>Actual website publisher pending</a:t>
+              <a:t>Server and live wiring pending</a:t>
             </a:r>
           </a:p>
         </p:txBody>
@@ -10912,6 +11138,7 @@
           </a:lstStyle>
           <a:p xmlns:a="http://schemas.openxmlformats.org/drawingml/2006/main">
             <a:pPr>
+              <a:buNone/>
               <a:defRPr sz="1875" b="1">
                 <a:solidFill>
                   <a:srgbClr val="157D80"/>
@@ -10930,7 +11157,7 @@
                 <a:ea typeface="Aptos"/>
                 <a:cs typeface="Aptos"/>
               </a:rPr>
-              <a:t>Grant packet binding</a:t>
+              <a:t>Grant and DAO evidence</a:t>
             </a:r>
           </a:p>
         </p:txBody>
@@ -10979,6 +11206,7 @@
           </a:lstStyle>
           <a:p xmlns:a="http://schemas.openxmlformats.org/drawingml/2006/main">
             <a:pPr>
+              <a:buNone/>
               <a:defRPr sz="2250" b="0">
                 <a:solidFill>
                   <a:srgbClr val="49616A"/>
@@ -10997,11 +11225,12 @@
                 <a:ea typeface="Aptos"/>
                 <a:cs typeface="Aptos"/>
               </a:rPr>
-              <a:t>PR 7 grant core: 37 tests</a:t>
-            </a:r>
-          </a:p>
-          <a:p xmlns:a="http://schemas.openxmlformats.org/drawingml/2006/main">
-            <a:pPr>
+              <a:t>Packet, review and vote binding</a:t>
+            </a:r>
+          </a:p>
+          <a:p xmlns:a="http://schemas.openxmlformats.org/drawingml/2006/main">
+            <a:pPr>
+              <a:buNone/>
               <a:defRPr sz="2250" b="0">
                 <a:solidFill>
                   <a:srgbClr val="49616A"/>
@@ -11020,11 +11249,12 @@
                 <a:ea typeface="Aptos"/>
                 <a:cs typeface="Aptos"/>
               </a:rPr>
-              <a:t>Packet, review and vote binding</a:t>
-            </a:r>
-          </a:p>
-          <a:p xmlns:a="http://schemas.openxmlformats.org/drawingml/2006/main">
-            <a:pPr>
+              <a:t>Cited public DAO facts</a:t>
+            </a:r>
+          </a:p>
+          <a:p xmlns:a="http://schemas.openxmlformats.org/drawingml/2006/main">
+            <a:pPr>
+              <a:buNone/>
               <a:defRPr sz="2250" b="0">
                 <a:solidFill>
                   <a:srgbClr val="49616A"/>
@@ -11043,11 +11273,12 @@
                 <a:ea typeface="Aptos"/>
                 <a:cs typeface="Aptos"/>
               </a:rPr>
-              <a:t>Source freshness and replay</a:t>
-            </a:r>
-          </a:p>
-          <a:p xmlns:a="http://schemas.openxmlformats.org/drawingml/2006/main">
-            <a:pPr>
+              <a:t>Eligibility remains unverified</a:t>
+            </a:r>
+          </a:p>
+          <a:p xmlns:a="http://schemas.openxmlformats.org/drawingml/2006/main">
+            <a:pPr>
+              <a:buNone/>
               <a:defRPr sz="2250" b="0">
                 <a:solidFill>
                   <a:srgbClr val="49616A"/>
@@ -11066,7 +11297,7 @@
                 <a:ea typeface="Aptos"/>
                 <a:cs typeface="Aptos"/>
               </a:rPr>
-              <a:t>Production adapters next</a:t>
+              <a:t>Live governance adapter pending</a:t>
             </a:r>
           </a:p>
         </p:txBody>
@@ -11148,6 +11379,7 @@
           </a:lstStyle>
           <a:p xmlns:a="http://schemas.openxmlformats.org/drawingml/2006/main">
             <a:pPr>
+              <a:buNone/>
               <a:defRPr sz="1875" b="1">
                 <a:solidFill>
                   <a:srgbClr val="157D80"/>
@@ -11166,7 +11398,7 @@
                 <a:ea typeface="Aptos"/>
                 <a:cs typeface="Aptos"/>
               </a:rPr>
-              <a:t>Connected walkthrough</a:t>
+              <a:t>Qualification boundary</a:t>
             </a:r>
           </a:p>
         </p:txBody>
@@ -11215,6 +11447,7 @@
           </a:lstStyle>
           <a:p xmlns:a="http://schemas.openxmlformats.org/drawingml/2006/main">
             <a:pPr>
+              <a:buNone/>
               <a:defRPr sz="2250" b="0">
                 <a:solidFill>
                   <a:srgbClr val="49616A"/>
@@ -11233,11 +11466,12 @@
                 <a:ea typeface="Aptos"/>
                 <a:cs typeface="Aptos"/>
               </a:rPr>
-              <a:t>152 tests and five demos pass</a:t>
-            </a:r>
-          </a:p>
-          <a:p xmlns:a="http://schemas.openxmlformats.org/drawingml/2006/main">
-            <a:pPr>
+              <a:t>248 combined tests pass</a:t>
+            </a:r>
+          </a:p>
+          <a:p xmlns:a="http://schemas.openxmlformats.org/drawingml/2006/main">
+            <a:pPr>
+              <a:buNone/>
               <a:defRPr sz="2250" b="0">
                 <a:solidFill>
                   <a:srgbClr val="49616A"/>
@@ -11256,11 +11490,12 @@
                 <a:ea typeface="Aptos"/>
                 <a:cs typeface="Aptos"/>
               </a:rPr>
-              <a:t>One connected workflow command</a:t>
-            </a:r>
-          </a:p>
-          <a:p xmlns:a="http://schemas.openxmlformats.org/drawingml/2006/main">
-            <a:pPr>
+              <a:t>6 migrations, 3 native jobs</a:t>
+            </a:r>
+          </a:p>
+          <a:p xmlns:a="http://schemas.openxmlformats.org/drawingml/2006/main">
+            <a:pPr>
+              <a:buNone/>
               <a:defRPr sz="2250" b="0">
                 <a:solidFill>
                   <a:srgbClr val="49616A"/>
@@ -11279,11 +11514,12 @@
                 <a:ea typeface="Aptos"/>
                 <a:cs typeface="Aptos"/>
               </a:rPr>
-              <a:t>Deterministic journey receipt</a:t>
-            </a:r>
-          </a:p>
-          <a:p xmlns:a="http://schemas.openxmlformats.org/drawingml/2006/main">
-            <a:pPr>
+              <a:t>Exact artifact native pass</a:t>
+            </a:r>
+          </a:p>
+          <a:p xmlns:a="http://schemas.openxmlformats.org/drawingml/2006/main">
+            <a:pPr>
+              <a:buNone/>
               <a:defRPr sz="2250" b="0">
                 <a:solidFill>
                   <a:srgbClr val="49616A"/>
@@ -11302,7 +11538,7 @@
                 <a:ea typeface="Aptos"/>
                 <a:cs typeface="Aptos"/>
               </a:rPr>
-              <a:t>Native services and HTTP verified</a:t>
+              <a:t>Full HTTP check historical</a:t>
             </a:r>
           </a:p>
         </p:txBody>
@@ -11351,6 +11587,7 @@
           </a:lstStyle>
           <a:p xmlns:a="http://schemas.openxmlformats.org/drawingml/2006/main">
             <a:pPr>
+              <a:buNone/>
               <a:defRPr sz="2100" b="0">
                 <a:solidFill>
                   <a:srgbClr val="132E38"/>
@@ -11369,7 +11606,7 @@
                 <a:ea typeface="Aptos"/>
                 <a:cs typeface="Aptos"/>
               </a:rPr>
-              <a:t>Native services and isolated Docker HTTP/API checks passed. External integrations and live deployment remain pending.</a:t>
+              <a:t>Merge is complete; live setup remains pending. CEO intake needs an assigned mandate. Status mirroring remains future.</a:t>
             </a:r>
           </a:p>
         </p:txBody>
@@ -11447,6 +11684,7 @@
           </a:lstStyle>
           <a:p xmlns:a="http://schemas.openxmlformats.org/drawingml/2006/main">
             <a:pPr>
+              <a:buNone/>
               <a:defRPr sz="1350" b="1">
                 <a:solidFill>
                   <a:srgbClr val="157D80"/>
@@ -11514,6 +11752,7 @@
           </a:lstStyle>
           <a:p xmlns:a="http://schemas.openxmlformats.org/drawingml/2006/main">
             <a:pPr>
+              <a:buNone/>
               <a:defRPr sz="3450" b="1">
                 <a:solidFill>
                   <a:srgbClr val="132E38"/>
@@ -11581,6 +11820,7 @@
           </a:lstStyle>
           <a:p xmlns:a="http://schemas.openxmlformats.org/drawingml/2006/main">
             <a:pPr>
+              <a:buNone/>
               <a:defRPr sz="1800" b="0">
                 <a:solidFill>
                   <a:srgbClr val="49616A"/>
@@ -11679,6 +11919,7 @@
           </a:lstStyle>
           <a:p xmlns:a="http://schemas.openxmlformats.org/drawingml/2006/main">
             <a:pPr>
+              <a:buNone/>
               <a:defRPr sz="1275" b="0">
                 <a:solidFill>
                   <a:srgbClr val="49616A"/>
@@ -11697,7 +11938,7 @@
                 <a:ea typeface="Aptos"/>
                 <a:cs typeface="Aptos"/>
               </a:rPr>
-              <a:t>INERTIA-2026-10-23-r8 · 23 October 2026 · Autonomous build</a:t>
+              <a:t>INERTIA-2026-10-23-r9 · 23 October 2026 · Autonomous build</a:t>
             </a:r>
           </a:p>
         </p:txBody>
@@ -11746,6 +11987,7 @@
           </a:lstStyle>
           <a:p xmlns:a="http://schemas.openxmlformats.org/drawingml/2006/main">
             <a:pPr>
+              <a:buNone/>
               <a:defRPr sz="1800" b="1">
                 <a:solidFill>
                   <a:srgbClr val="157D80"/>
@@ -11846,6 +12088,7 @@
           </a:lstStyle>
           <a:p xmlns:a="http://schemas.openxmlformats.org/drawingml/2006/main">
             <a:pPr>
+              <a:buNone/>
               <a:defRPr sz="1875" b="1">
                 <a:solidFill>
                   <a:srgbClr val="157D80"/>
@@ -11913,6 +12156,7 @@
           </a:lstStyle>
           <a:p xmlns:a="http://schemas.openxmlformats.org/drawingml/2006/main">
             <a:pPr>
+              <a:buNone/>
               <a:defRPr sz="2250" b="0">
                 <a:solidFill>
                   <a:srgbClr val="49616A"/>
@@ -11931,11 +12175,12 @@
                 <a:ea typeface="Aptos"/>
                 <a:cs typeface="Aptos"/>
               </a:rPr>
-              <a:t>Bridge and domain cores merged</a:t>
-            </a:r>
-          </a:p>
-          <a:p xmlns:a="http://schemas.openxmlformats.org/drawingml/2006/main">
-            <a:pPr>
+              <a:t>Website caller merged</a:t>
+            </a:r>
+          </a:p>
+          <a:p xmlns:a="http://schemas.openxmlformats.org/drawingml/2006/main">
+            <a:pPr>
+              <a:buNone/>
               <a:defRPr sz="2250" b="0">
                 <a:solidFill>
                   <a:srgbClr val="49616A"/>
@@ -11954,11 +12199,12 @@
                 <a:ea typeface="Aptos"/>
                 <a:cs typeface="Aptos"/>
               </a:rPr>
-              <a:t>Plugin archive qualified</a:t>
-            </a:r>
-          </a:p>
-          <a:p xmlns:a="http://schemas.openxmlformats.org/drawingml/2006/main">
-            <a:pPr>
+              <a:t>CEO checklist merged</a:t>
+            </a:r>
+          </a:p>
+          <a:p xmlns:a="http://schemas.openxmlformats.org/drawingml/2006/main">
+            <a:pPr>
+              <a:buNone/>
               <a:defRPr sz="2250" b="0">
                 <a:solidFill>
                   <a:srgbClr val="49616A"/>
@@ -11977,11 +12223,12 @@
                 <a:ea typeface="Aptos"/>
                 <a:cs typeface="Aptos"/>
               </a:rPr>
-              <a:t>Website publisher pending</a:t>
-            </a:r>
-          </a:p>
-          <a:p xmlns:a="http://schemas.openxmlformats.org/drawingml/2006/main">
-            <a:pPr>
+              <a:t>Native comments merged</a:t>
+            </a:r>
+          </a:p>
+          <a:p xmlns:a="http://schemas.openxmlformats.org/drawingml/2006/main">
+            <a:pPr>
+              <a:buNone/>
               <a:defRPr sz="2250" b="0">
                 <a:solidFill>
                   <a:srgbClr val="49616A"/>
@@ -12000,7 +12247,7 @@
                 <a:ea typeface="Aptos"/>
                 <a:cs typeface="Aptos"/>
               </a:rPr>
-              <a:t>Keep artifacts aligned</a:t>
+              <a:t>Live setup remains pending</a:t>
             </a:r>
           </a:p>
         </p:txBody>
@@ -12082,6 +12329,7 @@
           </a:lstStyle>
           <a:p xmlns:a="http://schemas.openxmlformats.org/drawingml/2006/main">
             <a:pPr>
+              <a:buNone/>
               <a:defRPr sz="1875" b="1">
                 <a:solidFill>
                   <a:srgbClr val="157D80"/>
@@ -12149,6 +12397,7 @@
           </a:lstStyle>
           <a:p xmlns:a="http://schemas.openxmlformats.org/drawingml/2006/main">
             <a:pPr>
+              <a:buNone/>
               <a:defRPr sz="2250" b="0">
                 <a:solidFill>
                   <a:srgbClr val="49616A"/>
@@ -12167,11 +12416,12 @@
                 <a:ea typeface="Aptos"/>
                 <a:cs typeface="Aptos"/>
               </a:rPr>
-              <a:t>Complete domain adapters</a:t>
-            </a:r>
-          </a:p>
-          <a:p xmlns:a="http://schemas.openxmlformats.org/drawingml/2006/main">
-            <a:pPr>
+              <a:t>Finish live adapters</a:t>
+            </a:r>
+          </a:p>
+          <a:p xmlns:a="http://schemas.openxmlformats.org/drawingml/2006/main">
+            <a:pPr>
+              <a:buNone/>
               <a:defRPr sz="2250" b="0">
                 <a:solidFill>
                   <a:srgbClr val="49616A"/>
@@ -12195,6 +12445,7 @@
           </a:p>
           <a:p xmlns:a="http://schemas.openxmlformats.org/drawingml/2006/main">
             <a:pPr>
+              <a:buNone/>
               <a:defRPr sz="2250" b="0">
                 <a:solidFill>
                   <a:srgbClr val="49616A"/>
@@ -12213,11 +12464,12 @@
                 <a:ea typeface="Aptos"/>
                 <a:cs typeface="Aptos"/>
               </a:rPr>
-              <a:t>Exercise member contribution</a:t>
-            </a:r>
-          </a:p>
-          <a:p xmlns:a="http://schemas.openxmlformats.org/drawingml/2006/main">
-            <a:pPr>
+              <a:t>Test member contribution</a:t>
+            </a:r>
+          </a:p>
+          <a:p xmlns:a="http://schemas.openxmlformats.org/drawingml/2006/main">
+            <a:pPr>
+              <a:buNone/>
               <a:defRPr sz="2250" b="0">
                 <a:solidFill>
                   <a:srgbClr val="49616A"/>
@@ -12236,7 +12488,7 @@
                 <a:ea typeface="Aptos"/>
                 <a:cs typeface="Aptos"/>
               </a:rPr>
-              <a:t>Test backup-based recovery</a:t>
+              <a:t>Test backup recovery</a:t>
             </a:r>
           </a:p>
         </p:txBody>
@@ -12318,6 +12570,7 @@
           </a:lstStyle>
           <a:p xmlns:a="http://schemas.openxmlformats.org/drawingml/2006/main">
             <a:pPr>
+              <a:buNone/>
               <a:defRPr sz="1875" b="1">
                 <a:solidFill>
                   <a:srgbClr val="157D80"/>
@@ -12385,6 +12638,7 @@
           </a:lstStyle>
           <a:p xmlns:a="http://schemas.openxmlformats.org/drawingml/2006/main">
             <a:pPr>
+              <a:buNone/>
               <a:defRPr sz="2250" b="0">
                 <a:solidFill>
                   <a:srgbClr val="49616A"/>
@@ -12403,11 +12657,12 @@
                 <a:ea typeface="Aptos"/>
                 <a:cs typeface="Aptos"/>
               </a:rPr>
-              <a:t>Recovery and isolation tests</a:t>
-            </a:r>
-          </a:p>
-          <a:p xmlns:a="http://schemas.openxmlformats.org/drawingml/2006/main">
-            <a:pPr>
+              <a:t>Test recovery and isolation</a:t>
+            </a:r>
+          </a:p>
+          <a:p xmlns:a="http://schemas.openxmlformats.org/drawingml/2006/main">
+            <a:pPr>
+              <a:buNone/>
               <a:defRPr sz="2250" b="0">
                 <a:solidFill>
                   <a:srgbClr val="49616A"/>
@@ -12431,6 +12686,7 @@
           </a:p>
           <a:p xmlns:a="http://schemas.openxmlformats.org/drawingml/2006/main">
             <a:pPr>
+              <a:buNone/>
               <a:defRPr sz="2250" b="0">
                 <a:solidFill>
                   <a:srgbClr val="49616A"/>
@@ -12454,6 +12710,7 @@
           </a:p>
           <a:p xmlns:a="http://schemas.openxmlformats.org/drawingml/2006/main">
             <a:pPr>
+              <a:buNone/>
               <a:defRPr sz="2250" b="0">
                 <a:solidFill>
                   <a:srgbClr val="49616A"/>
@@ -12521,6 +12778,7 @@
           </a:lstStyle>
           <a:p xmlns:a="http://schemas.openxmlformats.org/drawingml/2006/main">
             <a:pPr>
+              <a:buNone/>
               <a:defRPr sz="2100" b="0">
                 <a:solidFill>
                   <a:srgbClr val="132E38"/>
@@ -12539,7 +12797,7 @@
                 <a:ea typeface="Aptos"/>
                 <a:cs typeface="Aptos"/>
               </a:rPr>
-              <a:t>Cloud-first execution. Laptop fallback only for a specific blocker. Main and the runtime archive stay unchanged.</a:t>
+              <a:t>Cloud-first execution. No live deployment or new credentials in this work. Keep the five artifacts aligned before delivery.</a:t>
             </a:r>
           </a:p>
         </p:txBody>

</xml_diff>

<commit_message>
docs: synchronize r9 artifacts and exact native qualification (#18)
</commit_message>
<xml_diff>
--- a/Inertia-Architecture.pptx
+++ b/Inertia-Architecture.pptx
@@ -2,20 +2,20 @@
 <file path=ppt/presentation.xml><?xml version="1.0" encoding="utf-8"?>
 <p:presentation xmlns:p="http://schemas.openxmlformats.org/presentationml/2006/main">
   <p:sldMasterIdLst>
-    <p:sldMasterId xmlns:r="http://schemas.openxmlformats.org/officeDocument/2006/relationships" id="2147483648" r:id="Re63ac91880a5454e"/>
+    <p:sldMasterId xmlns:r="http://schemas.openxmlformats.org/officeDocument/2006/relationships" id="2147483648" r:id="R0dd9cb7e71e0443a"/>
   </p:sldMasterIdLst>
   <p:notesMasterIdLst>
-    <p:notesMasterId xmlns:r="http://schemas.openxmlformats.org/officeDocument/2006/relationships" r:id="R565c0f89eef14973"/>
+    <p:notesMasterId xmlns:r="http://schemas.openxmlformats.org/officeDocument/2006/relationships" r:id="R30529ac607664801"/>
   </p:notesMasterIdLst>
   <p:sldIdLst>
-    <p:sldId xmlns:r="http://schemas.openxmlformats.org/officeDocument/2006/relationships" id="256" r:id="R61af3860cbfb4f76"/>
-    <p:sldId xmlns:r="http://schemas.openxmlformats.org/officeDocument/2006/relationships" id="257" r:id="Rb9391e72b1374f46"/>
-    <p:sldId xmlns:r="http://schemas.openxmlformats.org/officeDocument/2006/relationships" id="258" r:id="R93e9e8d68d904378"/>
-    <p:sldId xmlns:r="http://schemas.openxmlformats.org/officeDocument/2006/relationships" id="259" r:id="R15d2ec525f2e449e"/>
-    <p:sldId xmlns:r="http://schemas.openxmlformats.org/officeDocument/2006/relationships" id="260" r:id="Rc7df1c9c7fd3442e"/>
-    <p:sldId xmlns:r="http://schemas.openxmlformats.org/officeDocument/2006/relationships" id="261" r:id="R24343b718bcc40f3"/>
-    <p:sldId xmlns:r="http://schemas.openxmlformats.org/officeDocument/2006/relationships" id="262" r:id="R0472f160c43c4b11"/>
-    <p:sldId xmlns:r="http://schemas.openxmlformats.org/officeDocument/2006/relationships" id="263" r:id="Rb14ba0e698bb42a9"/>
+    <p:sldId xmlns:r="http://schemas.openxmlformats.org/officeDocument/2006/relationships" id="256" r:id="R07a014b80ee4408a"/>
+    <p:sldId xmlns:r="http://schemas.openxmlformats.org/officeDocument/2006/relationships" id="257" r:id="Rf7b5ddd0aa9b4179"/>
+    <p:sldId xmlns:r="http://schemas.openxmlformats.org/officeDocument/2006/relationships" id="258" r:id="Rae6958e684c04eb4"/>
+    <p:sldId xmlns:r="http://schemas.openxmlformats.org/officeDocument/2006/relationships" id="259" r:id="R7d00e6ce59aa47a4"/>
+    <p:sldId xmlns:r="http://schemas.openxmlformats.org/officeDocument/2006/relationships" id="260" r:id="Rb61e31e4dc4c417d"/>
+    <p:sldId xmlns:r="http://schemas.openxmlformats.org/officeDocument/2006/relationships" id="261" r:id="R65564fd8bbce4a04"/>
+    <p:sldId xmlns:r="http://schemas.openxmlformats.org/officeDocument/2006/relationships" id="262" r:id="R6cb958f3a90e4e84"/>
+    <p:sldId xmlns:r="http://schemas.openxmlformats.org/officeDocument/2006/relationships" id="263" r:id="R1939777d3fd44cc9"/>
   </p:sldIdLst>
   <p:sldSz cx="15240000" cy="8572500"/>
   <p:notesSz cx="6858000" cy="9144000"/>
@@ -449,7 +449,7 @@
           <a:lstStyle xmlns:a="http://schemas.openxmlformats.org/drawingml/2006/main"/>
           <a:p xmlns:a="http://schemas.openxmlformats.org/drawingml/2006/main">
             <a:r>
-              <a:t>INERTIA-2026-10-23-r8. Sources: spec.md, testing.md, decisions.md, plan.md. Merged baseline https://github.com/NetRxn/Inertia/commit/ec26c1b850e7937a9d5b1561c1a27b43d06394de; PR 2 https://github.com/NetRxn/Inertia/pull/2; PR 3 https://github.com/NetRxn/Inertia/pull/3. Paperclip selected public release v2026.1012.0, bba6a45f0d364cfd962ac59b3bdf2426a8222adb. Buzz dc25198d530acc6237a0320b697365f29daf0ea6. PR 4 https://github.com/NetRxn/Inertia/pull/4 and PR 5 https://github.com/NetRxn/Inertia/pull/5 merged. PR 7 https://github.com/NetRxn/Inertia/pull/7 merged with 37 grant tests. PR 8 https://github.com/NetRxn/Inertia/pull/8 merged with packaging f68e8bb98df0bb05f9a946340d885e0bcfc6e188 independently reviewed; 149 combined tests, typecheck, build, fresh production install and native JSON-RPC worker handshake passed at PR8. PR10 https://github.com/NetRxn/Inertia/pull/10 adds the connected workflow: 152 total tests and five demos pass. External I/O and native work seeding are fixtures. See docs/implementation/live-handoff-checklist.md and docs/qualification/native-services.md. Actual pinned native services passed using PostgreSQL18.1; cloud HTTP startup was blocked by interface enumeration; the authorized isolated Docker fallback subsequently passed full HTTP/API qualification without shims. Latest published host/SDK remain 2026.1012.0 as of 23 October. PR11 https://github.com/NetRxn/Inertia/pull/11 upgrade workflow has 12 focused tests and isolated 152-test/package qualification. DAO organizational facts come from authorized website retrieval with citations and restricted audiences. No private execution-provider source included.</a:t>
+              <a:t>INERTIA-2026-10-23-r9. Source baseline: https://github.com/NetRxn/Inertia/commit/4841f7ade1510acf93e43ce1dbd16b91ae7bcd88. Architecture target and implementation status are distinct. PR13 authenticated private cloud handoff: https://github.com/NetRxn/Inertia/pull/13. PR14 caller-side website adapter and proposed v1.1 clarification: https://github.com/NetRxn/Inertia/pull/14, final reviewed 216 tests including four concurrency regressions added after initial 212. Wire roundtable-publication-v1 and extractive-v1 unchanged. Metadata-only correction unsupported. Website server rollout, authorized Drive source and single-owner native job wiring remain pending; demos still use pendingDaoPublisher. PR15 public DAO grounding: https://github.com/NetRxn/Inertia/pull/15; public legal/tax claims remain provisional and conflicting governance needs canonical ratification evidence. PR17 https://github.com/NetRxn/Inertia/pull/17 head 2a90ce24e16a72f446a7402560bd53d22f00ca38 was independently reviewed/tested and merged at 2026-10-23T11:12:50Z as 4841f7ade1510acf93e43ce1dbd16b91ae7bcd88. The merged source bytes equal the reviewed head. This documentation tree is distinct from the exact runtime qualification hashes below. 248 combined tests in 16 files, typecheck/build and package verification: 54 files, 6 migrations. First-publication native comment mirroring only, default-off, explicit per-binding audience acknowledgment and history cutoff, existing outbox/reconciler. No edit/delete propagation or retraction. Non-expiring publication claims expose inFlightPublications; token-matched administrative recovery requires all prior workers proved stopped, never timeout/automatic expiry. Exact candidate archive SHA256 19e67c88a8de52404412e49312cebfd6db42c462de3378cf3397966250add76c, source tree 8039b3e5f54e49c302b4751445f382403381ab91, passed actual unmodified native services with PostgreSQL18.1: six migrations, eight tables, three disabled job RPCs, expected health, SQL binding/company isolation, clean lifecycle. A real host array-binding regression was fixed before this pass. No new full-HTTP qualification. See docs/qualification/combined-native-services/. PR16 native CEO operator checklist merged: https://github.com/NetRxn/Inertia/pull/16. Preparation only, no live setup or custom bootstrap engine. No automatic scan of unassigned work by default; configure an assigned intake mandate and heartbeat. General status mirroring remains future. Existing native/HTTP and package receipts qualify historical recorded baselines, not every new runtime artifact. No live deployment, credentials or member publication performed. See synchronized spec.md, testing.md, decisions.md, plan.md and public integration references.</a:t>
             </a:r>
           </a:p>
         </p:txBody>
@@ -519,7 +519,7 @@
           <a:lstStyle xmlns:a="http://schemas.openxmlformats.org/drawingml/2006/main"/>
           <a:p xmlns:a="http://schemas.openxmlformats.org/drawingml/2006/main">
             <a:r>
-              <a:t>INERTIA-2026-10-23-r8. Sources: spec.md, testing.md, decisions.md, plan.md. Merged baseline https://github.com/NetRxn/Inertia/commit/ec26c1b850e7937a9d5b1561c1a27b43d06394de; PR 2 https://github.com/NetRxn/Inertia/pull/2; PR 3 https://github.com/NetRxn/Inertia/pull/3. Paperclip selected public release v2026.1012.0, bba6a45f0d364cfd962ac59b3bdf2426a8222adb. Buzz dc25198d530acc6237a0320b697365f29daf0ea6. PR 4 https://github.com/NetRxn/Inertia/pull/4 and PR 5 https://github.com/NetRxn/Inertia/pull/5 merged. PR 7 https://github.com/NetRxn/Inertia/pull/7 merged with 37 grant tests. PR 8 https://github.com/NetRxn/Inertia/pull/8 merged with packaging f68e8bb98df0bb05f9a946340d885e0bcfc6e188 independently reviewed; 149 combined tests, typecheck, build, fresh production install and native JSON-RPC worker handshake passed at PR8. PR10 https://github.com/NetRxn/Inertia/pull/10 adds the connected workflow: 152 total tests and five demos pass. External I/O and native work seeding are fixtures. See docs/implementation/live-handoff-checklist.md and docs/qualification/native-services.md. Actual pinned native services passed using PostgreSQL18.1; cloud HTTP startup was blocked by interface enumeration; the authorized isolated Docker fallback subsequently passed full HTTP/API qualification without shims. Latest published host/SDK remain 2026.1012.0 as of 23 October. PR11 https://github.com/NetRxn/Inertia/pull/11 upgrade workflow has 12 focused tests and isolated 152-test/package qualification. DAO organizational facts come from authorized website retrieval with citations and restricted audiences. No private execution-provider source included.</a:t>
+              <a:t>INERTIA-2026-10-23-r9. Source baseline: https://github.com/NetRxn/Inertia/commit/4841f7ade1510acf93e43ce1dbd16b91ae7bcd88. Architecture target and implementation status are distinct. PR13 authenticated private cloud handoff: https://github.com/NetRxn/Inertia/pull/13. PR14 caller-side website adapter and proposed v1.1 clarification: https://github.com/NetRxn/Inertia/pull/14, final reviewed 216 tests including four concurrency regressions added after initial 212. Wire roundtable-publication-v1 and extractive-v1 unchanged. Metadata-only correction unsupported. Website server rollout, authorized Drive source and single-owner native job wiring remain pending; demos still use pendingDaoPublisher. PR15 public DAO grounding: https://github.com/NetRxn/Inertia/pull/15; public legal/tax claims remain provisional and conflicting governance needs canonical ratification evidence. PR17 https://github.com/NetRxn/Inertia/pull/17 head 2a90ce24e16a72f446a7402560bd53d22f00ca38 was independently reviewed/tested and merged at 2026-10-23T11:12:50Z as 4841f7ade1510acf93e43ce1dbd16b91ae7bcd88. The merged source bytes equal the reviewed head. This documentation tree is distinct from the exact runtime qualification hashes below. 248 combined tests in 16 files, typecheck/build and package verification: 54 files, 6 migrations. First-publication native comment mirroring only, default-off, explicit per-binding audience acknowledgment and history cutoff, existing outbox/reconciler. No edit/delete propagation or retraction. Non-expiring publication claims expose inFlightPublications; token-matched administrative recovery requires all prior workers proved stopped, never timeout/automatic expiry. Exact candidate archive SHA256 19e67c88a8de52404412e49312cebfd6db42c462de3378cf3397966250add76c, source tree 8039b3e5f54e49c302b4751445f382403381ab91, passed actual unmodified native services with PostgreSQL18.1: six migrations, eight tables, three disabled job RPCs, expected health, SQL binding/company isolation, clean lifecycle. A real host array-binding regression was fixed before this pass. No new full-HTTP qualification. See docs/qualification/combined-native-services/. PR16 native CEO operator checklist merged: https://github.com/NetRxn/Inertia/pull/16. Preparation only, no live setup or custom bootstrap engine. No automatic scan of unassigned work by default; configure an assigned intake mandate and heartbeat. General status mirroring remains future. Existing native/HTTP and package receipts qualify historical recorded baselines, not every new runtime artifact. No live deployment, credentials or member publication performed. See synchronized spec.md, testing.md, decisions.md, plan.md and public integration references.</a:t>
             </a:r>
           </a:p>
         </p:txBody>
@@ -589,7 +589,7 @@
           <a:lstStyle xmlns:a="http://schemas.openxmlformats.org/drawingml/2006/main"/>
           <a:p xmlns:a="http://schemas.openxmlformats.org/drawingml/2006/main">
             <a:r>
-              <a:t>INERTIA-2026-10-23-r8. Sources: spec.md, testing.md, decisions.md, plan.md. Merged baseline https://github.com/NetRxn/Inertia/commit/ec26c1b850e7937a9d5b1561c1a27b43d06394de; PR 2 https://github.com/NetRxn/Inertia/pull/2; PR 3 https://github.com/NetRxn/Inertia/pull/3. Paperclip selected public release v2026.1012.0, bba6a45f0d364cfd962ac59b3bdf2426a8222adb. Buzz dc25198d530acc6237a0320b697365f29daf0ea6. PR 4 https://github.com/NetRxn/Inertia/pull/4 and PR 5 https://github.com/NetRxn/Inertia/pull/5 merged. PR 7 https://github.com/NetRxn/Inertia/pull/7 merged with 37 grant tests. PR 8 https://github.com/NetRxn/Inertia/pull/8 merged with packaging f68e8bb98df0bb05f9a946340d885e0bcfc6e188 independently reviewed; 149 combined tests, typecheck, build, fresh production install and native JSON-RPC worker handshake passed at PR8. PR10 https://github.com/NetRxn/Inertia/pull/10 adds the connected workflow: 152 total tests and five demos pass. External I/O and native work seeding are fixtures. See docs/implementation/live-handoff-checklist.md and docs/qualification/native-services.md. Actual pinned native services passed using PostgreSQL18.1; cloud HTTP startup was blocked by interface enumeration; the authorized isolated Docker fallback subsequently passed full HTTP/API qualification without shims. Latest published host/SDK remain 2026.1012.0 as of 23 October. PR11 https://github.com/NetRxn/Inertia/pull/11 upgrade workflow has 12 focused tests and isolated 152-test/package qualification. DAO organizational facts come from authorized website retrieval with citations and restricted audiences. No private execution-provider source included.</a:t>
+              <a:t>INERTIA-2026-10-23-r9. Source baseline: https://github.com/NetRxn/Inertia/commit/4841f7ade1510acf93e43ce1dbd16b91ae7bcd88. Architecture target and implementation status are distinct. PR13 authenticated private cloud handoff: https://github.com/NetRxn/Inertia/pull/13. PR14 caller-side website adapter and proposed v1.1 clarification: https://github.com/NetRxn/Inertia/pull/14, final reviewed 216 tests including four concurrency regressions added after initial 212. Wire roundtable-publication-v1 and extractive-v1 unchanged. Metadata-only correction unsupported. Website server rollout, authorized Drive source and single-owner native job wiring remain pending; demos still use pendingDaoPublisher. PR15 public DAO grounding: https://github.com/NetRxn/Inertia/pull/15; public legal/tax claims remain provisional and conflicting governance needs canonical ratification evidence. PR17 https://github.com/NetRxn/Inertia/pull/17 head 2a90ce24e16a72f446a7402560bd53d22f00ca38 was independently reviewed/tested and merged at 2026-10-23T11:12:50Z as 4841f7ade1510acf93e43ce1dbd16b91ae7bcd88. The merged source bytes equal the reviewed head. This documentation tree is distinct from the exact runtime qualification hashes below. 248 combined tests in 16 files, typecheck/build and package verification: 54 files, 6 migrations. First-publication native comment mirroring only, default-off, explicit per-binding audience acknowledgment and history cutoff, existing outbox/reconciler. No edit/delete propagation or retraction. Non-expiring publication claims expose inFlightPublications; token-matched administrative recovery requires all prior workers proved stopped, never timeout/automatic expiry. Exact candidate archive SHA256 19e67c88a8de52404412e49312cebfd6db42c462de3378cf3397966250add76c, source tree 8039b3e5f54e49c302b4751445f382403381ab91, passed actual unmodified native services with PostgreSQL18.1: six migrations, eight tables, three disabled job RPCs, expected health, SQL binding/company isolation, clean lifecycle. A real host array-binding regression was fixed before this pass. No new full-HTTP qualification. See docs/qualification/combined-native-services/. PR16 native CEO operator checklist merged: https://github.com/NetRxn/Inertia/pull/16. Preparation only, no live setup or custom bootstrap engine. No automatic scan of unassigned work by default; configure an assigned intake mandate and heartbeat. General status mirroring remains future. Existing native/HTTP and package receipts qualify historical recorded baselines, not every new runtime artifact. No live deployment, credentials or member publication performed. See synchronized spec.md, testing.md, decisions.md, plan.md and public integration references.</a:t>
             </a:r>
           </a:p>
         </p:txBody>
@@ -659,7 +659,7 @@
           <a:lstStyle xmlns:a="http://schemas.openxmlformats.org/drawingml/2006/main"/>
           <a:p xmlns:a="http://schemas.openxmlformats.org/drawingml/2006/main">
             <a:r>
-              <a:t>INERTIA-2026-10-23-r8. Sources: spec.md, testing.md, decisions.md, plan.md. Merged baseline https://github.com/NetRxn/Inertia/commit/ec26c1b850e7937a9d5b1561c1a27b43d06394de; PR 2 https://github.com/NetRxn/Inertia/pull/2; PR 3 https://github.com/NetRxn/Inertia/pull/3. Paperclip selected public release v2026.1012.0, bba6a45f0d364cfd962ac59b3bdf2426a8222adb. Buzz dc25198d530acc6237a0320b697365f29daf0ea6. PR 4 https://github.com/NetRxn/Inertia/pull/4 and PR 5 https://github.com/NetRxn/Inertia/pull/5 merged. PR 7 https://github.com/NetRxn/Inertia/pull/7 merged with 37 grant tests. PR 8 https://github.com/NetRxn/Inertia/pull/8 merged with packaging f68e8bb98df0bb05f9a946340d885e0bcfc6e188 independently reviewed; 149 combined tests, typecheck, build, fresh production install and native JSON-RPC worker handshake passed at PR8. PR10 https://github.com/NetRxn/Inertia/pull/10 adds the connected workflow: 152 total tests and five demos pass. External I/O and native work seeding are fixtures. See docs/implementation/live-handoff-checklist.md and docs/qualification/native-services.md. Actual pinned native services passed using PostgreSQL18.1; cloud HTTP startup was blocked by interface enumeration; the authorized isolated Docker fallback subsequently passed full HTTP/API qualification without shims. Latest published host/SDK remain 2026.1012.0 as of 23 October. PR11 https://github.com/NetRxn/Inertia/pull/11 upgrade workflow has 12 focused tests and isolated 152-test/package qualification. DAO organizational facts come from authorized website retrieval with citations and restricted audiences. No private execution-provider source included.</a:t>
+              <a:t>INERTIA-2026-10-23-r9. Source baseline: https://github.com/NetRxn/Inertia/commit/4841f7ade1510acf93e43ce1dbd16b91ae7bcd88. Architecture target and implementation status are distinct. PR13 authenticated private cloud handoff: https://github.com/NetRxn/Inertia/pull/13. PR14 caller-side website adapter and proposed v1.1 clarification: https://github.com/NetRxn/Inertia/pull/14, final reviewed 216 tests including four concurrency regressions added after initial 212. Wire roundtable-publication-v1 and extractive-v1 unchanged. Metadata-only correction unsupported. Website server rollout, authorized Drive source and single-owner native job wiring remain pending; demos still use pendingDaoPublisher. PR15 public DAO grounding: https://github.com/NetRxn/Inertia/pull/15; public legal/tax claims remain provisional and conflicting governance needs canonical ratification evidence. PR17 https://github.com/NetRxn/Inertia/pull/17 head 2a90ce24e16a72f446a7402560bd53d22f00ca38 was independently reviewed/tested and merged at 2026-10-23T11:12:50Z as 4841f7ade1510acf93e43ce1dbd16b91ae7bcd88. The merged source bytes equal the reviewed head. This documentation tree is distinct from the exact runtime qualification hashes below. 248 combined tests in 16 files, typecheck/build and package verification: 54 files, 6 migrations. First-publication native comment mirroring only, default-off, explicit per-binding audience acknowledgment and history cutoff, existing outbox/reconciler. No edit/delete propagation or retraction. Non-expiring publication claims expose inFlightPublications; token-matched administrative recovery requires all prior workers proved stopped, never timeout/automatic expiry. Exact candidate archive SHA256 19e67c88a8de52404412e49312cebfd6db42c462de3378cf3397966250add76c, source tree 8039b3e5f54e49c302b4751445f382403381ab91, passed actual unmodified native services with PostgreSQL18.1: six migrations, eight tables, three disabled job RPCs, expected health, SQL binding/company isolation, clean lifecycle. A real host array-binding regression was fixed before this pass. No new full-HTTP qualification. See docs/qualification/combined-native-services/. PR16 native CEO operator checklist merged: https://github.com/NetRxn/Inertia/pull/16. Preparation only, no live setup or custom bootstrap engine. No automatic scan of unassigned work by default; configure an assigned intake mandate and heartbeat. General status mirroring remains future. Existing native/HTTP and package receipts qualify historical recorded baselines, not every new runtime artifact. No live deployment, credentials or member publication performed. See synchronized spec.md, testing.md, decisions.md, plan.md and public integration references.</a:t>
             </a:r>
           </a:p>
         </p:txBody>
@@ -729,7 +729,7 @@
           <a:lstStyle xmlns:a="http://schemas.openxmlformats.org/drawingml/2006/main"/>
           <a:p xmlns:a="http://schemas.openxmlformats.org/drawingml/2006/main">
             <a:r>
-              <a:t>INERTIA-2026-10-23-r8. Sources: spec.md, testing.md, decisions.md, plan.md. Merged baseline https://github.com/NetRxn/Inertia/commit/ec26c1b850e7937a9d5b1561c1a27b43d06394de; PR 2 https://github.com/NetRxn/Inertia/pull/2; PR 3 https://github.com/NetRxn/Inertia/pull/3. Paperclip selected public release v2026.1012.0, bba6a45f0d364cfd962ac59b3bdf2426a8222adb. Buzz dc25198d530acc6237a0320b697365f29daf0ea6. PR 4 https://github.com/NetRxn/Inertia/pull/4 and PR 5 https://github.com/NetRxn/Inertia/pull/5 merged. PR 7 https://github.com/NetRxn/Inertia/pull/7 merged with 37 grant tests. PR 8 https://github.com/NetRxn/Inertia/pull/8 merged with packaging f68e8bb98df0bb05f9a946340d885e0bcfc6e188 independently reviewed; 149 combined tests, typecheck, build, fresh production install and native JSON-RPC worker handshake passed at PR8. PR10 https://github.com/NetRxn/Inertia/pull/10 adds the connected workflow: 152 total tests and five demos pass. External I/O and native work seeding are fixtures. See docs/implementation/live-handoff-checklist.md and docs/qualification/native-services.md. Actual pinned native services passed using PostgreSQL18.1; cloud HTTP startup was blocked by interface enumeration; the authorized isolated Docker fallback subsequently passed full HTTP/API qualification without shims. Latest published host/SDK remain 2026.1012.0 as of 23 October. PR11 https://github.com/NetRxn/Inertia/pull/11 upgrade workflow has 12 focused tests and isolated 152-test/package qualification. DAO organizational facts come from authorized website retrieval with citations and restricted audiences. No private execution-provider source included.</a:t>
+              <a:t>INERTIA-2026-10-23-r9. Source baseline: https://github.com/NetRxn/Inertia/commit/4841f7ade1510acf93e43ce1dbd16b91ae7bcd88. Architecture target and implementation status are distinct. PR13 authenticated private cloud handoff: https://github.com/NetRxn/Inertia/pull/13. PR14 caller-side website adapter and proposed v1.1 clarification: https://github.com/NetRxn/Inertia/pull/14, final reviewed 216 tests including four concurrency regressions added after initial 212. Wire roundtable-publication-v1 and extractive-v1 unchanged. Metadata-only correction unsupported. Website server rollout, authorized Drive source and single-owner native job wiring remain pending; demos still use pendingDaoPublisher. PR15 public DAO grounding: https://github.com/NetRxn/Inertia/pull/15; public legal/tax claims remain provisional and conflicting governance needs canonical ratification evidence. PR17 https://github.com/NetRxn/Inertia/pull/17 head 2a90ce24e16a72f446a7402560bd53d22f00ca38 was independently reviewed/tested and merged at 2026-10-23T11:12:50Z as 4841f7ade1510acf93e43ce1dbd16b91ae7bcd88. The merged source bytes equal the reviewed head. This documentation tree is distinct from the exact runtime qualification hashes below. 248 combined tests in 16 files, typecheck/build and package verification: 54 files, 6 migrations. First-publication native comment mirroring only, default-off, explicit per-binding audience acknowledgment and history cutoff, existing outbox/reconciler. No edit/delete propagation or retraction. Non-expiring publication claims expose inFlightPublications; token-matched administrative recovery requires all prior workers proved stopped, never timeout/automatic expiry. Exact candidate archive SHA256 19e67c88a8de52404412e49312cebfd6db42c462de3378cf3397966250add76c, source tree 8039b3e5f54e49c302b4751445f382403381ab91, passed actual unmodified native services with PostgreSQL18.1: six migrations, eight tables, three disabled job RPCs, expected health, SQL binding/company isolation, clean lifecycle. A real host array-binding regression was fixed before this pass. No new full-HTTP qualification. See docs/qualification/combined-native-services/. PR16 native CEO operator checklist merged: https://github.com/NetRxn/Inertia/pull/16. Preparation only, no live setup or custom bootstrap engine. No automatic scan of unassigned work by default; configure an assigned intake mandate and heartbeat. General status mirroring remains future. Existing native/HTTP and package receipts qualify historical recorded baselines, not every new runtime artifact. No live deployment, credentials or member publication performed. See synchronized spec.md, testing.md, decisions.md, plan.md and public integration references.</a:t>
             </a:r>
           </a:p>
         </p:txBody>
@@ -799,7 +799,7 @@
           <a:lstStyle xmlns:a="http://schemas.openxmlformats.org/drawingml/2006/main"/>
           <a:p xmlns:a="http://schemas.openxmlformats.org/drawingml/2006/main">
             <a:r>
-              <a:t>INERTIA-2026-10-23-r8. Sources: spec.md, testing.md, decisions.md, plan.md. Merged baseline https://github.com/NetRxn/Inertia/commit/ec26c1b850e7937a9d5b1561c1a27b43d06394de; PR 2 https://github.com/NetRxn/Inertia/pull/2; PR 3 https://github.com/NetRxn/Inertia/pull/3. Paperclip selected public release v2026.1012.0, bba6a45f0d364cfd962ac59b3bdf2426a8222adb. Buzz dc25198d530acc6237a0320b697365f29daf0ea6. PR 4 https://github.com/NetRxn/Inertia/pull/4 and PR 5 https://github.com/NetRxn/Inertia/pull/5 merged. PR 7 https://github.com/NetRxn/Inertia/pull/7 merged with 37 grant tests. PR 8 https://github.com/NetRxn/Inertia/pull/8 merged with packaging f68e8bb98df0bb05f9a946340d885e0bcfc6e188 independently reviewed; 149 combined tests, typecheck, build, fresh production install and native JSON-RPC worker handshake passed at PR8. PR10 https://github.com/NetRxn/Inertia/pull/10 adds the connected workflow: 152 total tests and five demos pass. External I/O and native work seeding are fixtures. See docs/implementation/live-handoff-checklist.md and docs/qualification/native-services.md. Actual pinned native services passed using PostgreSQL18.1; cloud HTTP startup was blocked by interface enumeration; the authorized isolated Docker fallback subsequently passed full HTTP/API qualification without shims. Latest published host/SDK remain 2026.1012.0 as of 23 October. PR11 https://github.com/NetRxn/Inertia/pull/11 upgrade workflow has 12 focused tests and isolated 152-test/package qualification. DAO organizational facts come from authorized website retrieval with citations and restricted audiences. No private execution-provider source included.</a:t>
+              <a:t>INERTIA-2026-10-23-r9. Source baseline: https://github.com/NetRxn/Inertia/commit/4841f7ade1510acf93e43ce1dbd16b91ae7bcd88. Architecture target and implementation status are distinct. PR13 authenticated private cloud handoff: https://github.com/NetRxn/Inertia/pull/13. PR14 caller-side website adapter and proposed v1.1 clarification: https://github.com/NetRxn/Inertia/pull/14, final reviewed 216 tests including four concurrency regressions added after initial 212. Wire roundtable-publication-v1 and extractive-v1 unchanged. Metadata-only correction unsupported. Website server rollout, authorized Drive source and single-owner native job wiring remain pending; demos still use pendingDaoPublisher. PR15 public DAO grounding: https://github.com/NetRxn/Inertia/pull/15; public legal/tax claims remain provisional and conflicting governance needs canonical ratification evidence. PR17 https://github.com/NetRxn/Inertia/pull/17 head 2a90ce24e16a72f446a7402560bd53d22f00ca38 was independently reviewed/tested and merged at 2026-10-23T11:12:50Z as 4841f7ade1510acf93e43ce1dbd16b91ae7bcd88. The merged source bytes equal the reviewed head. This documentation tree is distinct from the exact runtime qualification hashes below. 248 combined tests in 16 files, typecheck/build and package verification: 54 files, 6 migrations. First-publication native comment mirroring only, default-off, explicit per-binding audience acknowledgment and history cutoff, existing outbox/reconciler. No edit/delete propagation or retraction. Non-expiring publication claims expose inFlightPublications; token-matched administrative recovery requires all prior workers proved stopped, never timeout/automatic expiry. Exact candidate archive SHA256 19e67c88a8de52404412e49312cebfd6db42c462de3378cf3397966250add76c, source tree 8039b3e5f54e49c302b4751445f382403381ab91, passed actual unmodified native services with PostgreSQL18.1: six migrations, eight tables, three disabled job RPCs, expected health, SQL binding/company isolation, clean lifecycle. A real host array-binding regression was fixed before this pass. No new full-HTTP qualification. See docs/qualification/combined-native-services/. PR16 native CEO operator checklist merged: https://github.com/NetRxn/Inertia/pull/16. Preparation only, no live setup or custom bootstrap engine. No automatic scan of unassigned work by default; configure an assigned intake mandate and heartbeat. General status mirroring remains future. Existing native/HTTP and package receipts qualify historical recorded baselines, not every new runtime artifact. No live deployment, credentials or member publication performed. See synchronized spec.md, testing.md, decisions.md, plan.md and public integration references.</a:t>
             </a:r>
           </a:p>
         </p:txBody>
@@ -869,7 +869,7 @@
           <a:lstStyle xmlns:a="http://schemas.openxmlformats.org/drawingml/2006/main"/>
           <a:p xmlns:a="http://schemas.openxmlformats.org/drawingml/2006/main">
             <a:r>
-              <a:t>INERTIA-2026-10-23-r8. Sources: spec.md, testing.md, decisions.md, plan.md. Merged baseline https://github.com/NetRxn/Inertia/commit/ec26c1b850e7937a9d5b1561c1a27b43d06394de; PR 2 https://github.com/NetRxn/Inertia/pull/2; PR 3 https://github.com/NetRxn/Inertia/pull/3. Paperclip selected public release v2026.1012.0, bba6a45f0d364cfd962ac59b3bdf2426a8222adb. Buzz dc25198d530acc6237a0320b697365f29daf0ea6. PR 4 https://github.com/NetRxn/Inertia/pull/4 and PR 5 https://github.com/NetRxn/Inertia/pull/5 merged. PR 7 https://github.com/NetRxn/Inertia/pull/7 merged with 37 grant tests. PR 8 https://github.com/NetRxn/Inertia/pull/8 merged with packaging f68e8bb98df0bb05f9a946340d885e0bcfc6e188 independently reviewed; 149 combined tests, typecheck, build, fresh production install and native JSON-RPC worker handshake passed at PR8. PR10 https://github.com/NetRxn/Inertia/pull/10 adds the connected workflow: 152 total tests and five demos pass. External I/O and native work seeding are fixtures. See docs/implementation/live-handoff-checklist.md and docs/qualification/native-services.md. Actual pinned native services passed using PostgreSQL18.1; cloud HTTP startup was blocked by interface enumeration; the authorized isolated Docker fallback subsequently passed full HTTP/API qualification without shims. Latest published host/SDK remain 2026.1012.0 as of 23 October. PR11 https://github.com/NetRxn/Inertia/pull/11 upgrade workflow has 12 focused tests and isolated 152-test/package qualification. DAO organizational facts come from authorized website retrieval with citations and restricted audiences. No private execution-provider source included.</a:t>
+              <a:t>INERTIA-2026-10-23-r9. Source baseline: https://github.com/NetRxn/Inertia/commit/4841f7ade1510acf93e43ce1dbd16b91ae7bcd88. Architecture target and implementation status are distinct. PR13 authenticated private cloud handoff: https://github.com/NetRxn/Inertia/pull/13. PR14 caller-side website adapter and proposed v1.1 clarification: https://github.com/NetRxn/Inertia/pull/14, final reviewed 216 tests including four concurrency regressions added after initial 212. Wire roundtable-publication-v1 and extractive-v1 unchanged. Metadata-only correction unsupported. Website server rollout, authorized Drive source and single-owner native job wiring remain pending; demos still use pendingDaoPublisher. PR15 public DAO grounding: https://github.com/NetRxn/Inertia/pull/15; public legal/tax claims remain provisional and conflicting governance needs canonical ratification evidence. PR17 https://github.com/NetRxn/Inertia/pull/17 head 2a90ce24e16a72f446a7402560bd53d22f00ca38 was independently reviewed/tested and merged at 2026-10-23T11:12:50Z as 4841f7ade1510acf93e43ce1dbd16b91ae7bcd88. The merged source bytes equal the reviewed head. This documentation tree is distinct from the exact runtime qualification hashes below. 248 combined tests in 16 files, typecheck/build and package verification: 54 files, 6 migrations. First-publication native comment mirroring only, default-off, explicit per-binding audience acknowledgment and history cutoff, existing outbox/reconciler. No edit/delete propagation or retraction. Non-expiring publication claims expose inFlightPublications; token-matched administrative recovery requires all prior workers proved stopped, never timeout/automatic expiry. Exact candidate archive SHA256 19e67c88a8de52404412e49312cebfd6db42c462de3378cf3397966250add76c, source tree 8039b3e5f54e49c302b4751445f382403381ab91, passed actual unmodified native services with PostgreSQL18.1: six migrations, eight tables, three disabled job RPCs, expected health, SQL binding/company isolation, clean lifecycle. A real host array-binding regression was fixed before this pass. No new full-HTTP qualification. See docs/qualification/combined-native-services/. PR16 native CEO operator checklist merged: https://github.com/NetRxn/Inertia/pull/16. Preparation only, no live setup or custom bootstrap engine. No automatic scan of unassigned work by default; configure an assigned intake mandate and heartbeat. General status mirroring remains future. Existing native/HTTP and package receipts qualify historical recorded baselines, not every new runtime artifact. No live deployment, credentials or member publication performed. See synchronized spec.md, testing.md, decisions.md, plan.md and public integration references.</a:t>
             </a:r>
           </a:p>
         </p:txBody>
@@ -939,7 +939,7 @@
           <a:lstStyle xmlns:a="http://schemas.openxmlformats.org/drawingml/2006/main"/>
           <a:p xmlns:a="http://schemas.openxmlformats.org/drawingml/2006/main">
             <a:r>
-              <a:t>INERTIA-2026-10-23-r8. Sources: spec.md, testing.md, decisions.md, plan.md. Merged baseline https://github.com/NetRxn/Inertia/commit/ec26c1b850e7937a9d5b1561c1a27b43d06394de; PR 2 https://github.com/NetRxn/Inertia/pull/2; PR 3 https://github.com/NetRxn/Inertia/pull/3. Paperclip selected public release v2026.1012.0, bba6a45f0d364cfd962ac59b3bdf2426a8222adb. Buzz dc25198d530acc6237a0320b697365f29daf0ea6. PR 4 https://github.com/NetRxn/Inertia/pull/4 and PR 5 https://github.com/NetRxn/Inertia/pull/5 merged. PR 7 https://github.com/NetRxn/Inertia/pull/7 merged with 37 grant tests. PR 8 https://github.com/NetRxn/Inertia/pull/8 merged with packaging f68e8bb98df0bb05f9a946340d885e0bcfc6e188 independently reviewed; 149 combined tests, typecheck, build, fresh production install and native JSON-RPC worker handshake passed at PR8. PR10 https://github.com/NetRxn/Inertia/pull/10 adds the connected workflow: 152 total tests and five demos pass. External I/O and native work seeding are fixtures. See docs/implementation/live-handoff-checklist.md and docs/qualification/native-services.md. Actual pinned native services passed using PostgreSQL18.1; cloud HTTP startup was blocked by interface enumeration; the authorized isolated Docker fallback subsequently passed full HTTP/API qualification without shims. Latest published host/SDK remain 2026.1012.0 as of 23 October. PR11 https://github.com/NetRxn/Inertia/pull/11 upgrade workflow has 12 focused tests and isolated 152-test/package qualification. DAO organizational facts come from authorized website retrieval with citations and restricted audiences. No private execution-provider source included.</a:t>
+              <a:t>INERTIA-2026-10-23-r9. Source baseline: https://github.com/NetRxn/Inertia/commit/4841f7ade1510acf93e43ce1dbd16b91ae7bcd88. Architecture target and implementation status are distinct. PR13 authenticated private cloud handoff: https://github.com/NetRxn/Inertia/pull/13. PR14 caller-side website adapter and proposed v1.1 clarification: https://github.com/NetRxn/Inertia/pull/14, final reviewed 216 tests including four concurrency regressions added after initial 212. Wire roundtable-publication-v1 and extractive-v1 unchanged. Metadata-only correction unsupported. Website server rollout, authorized Drive source and single-owner native job wiring remain pending; demos still use pendingDaoPublisher. PR15 public DAO grounding: https://github.com/NetRxn/Inertia/pull/15; public legal/tax claims remain provisional and conflicting governance needs canonical ratification evidence. PR17 https://github.com/NetRxn/Inertia/pull/17 head 2a90ce24e16a72f446a7402560bd53d22f00ca38 was independently reviewed/tested and merged at 2026-10-23T11:12:50Z as 4841f7ade1510acf93e43ce1dbd16b91ae7bcd88. The merged source bytes equal the reviewed head. This documentation tree is distinct from the exact runtime qualification hashes below. 248 combined tests in 16 files, typecheck/build and package verification: 54 files, 6 migrations. First-publication native comment mirroring only, default-off, explicit per-binding audience acknowledgment and history cutoff, existing outbox/reconciler. No edit/delete propagation or retraction. Non-expiring publication claims expose inFlightPublications; token-matched administrative recovery requires all prior workers proved stopped, never timeout/automatic expiry. Exact candidate archive SHA256 19e67c88a8de52404412e49312cebfd6db42c462de3378cf3397966250add76c, source tree 8039b3e5f54e49c302b4751445f382403381ab91, passed actual unmodified native services with PostgreSQL18.1: six migrations, eight tables, three disabled job RPCs, expected health, SQL binding/company isolation, clean lifecycle. A real host array-binding regression was fixed before this pass. No new full-HTTP qualification. See docs/qualification/combined-native-services/. PR16 native CEO operator checklist merged: https://github.com/NetRxn/Inertia/pull/16. Preparation only, no live setup or custom bootstrap engine. No automatic scan of unassigned work by default; configure an assigned intake mandate and heartbeat. General status mirroring remains future. Existing native/HTTP and package receipts qualify historical recorded baselines, not every new runtime artifact. No live deployment, credentials or member publication performed. See synchronized spec.md, testing.md, decisions.md, plan.md and public integration references.</a:t>
             </a:r>
           </a:p>
         </p:txBody>
@@ -1037,6 +1037,7 @@
                 <a:spcPts val="0"/>
               </a:spcAft>
               <a:buNone/>
+              <a:defRPr/>
             </a:lvl1pPr>
             <a:lvl2pPr marL="0" indent="0">
               <a:lnSpc>
@@ -1049,6 +1050,7 @@
                 <a:spcPts val="0"/>
               </a:spcAft>
               <a:buNone/>
+              <a:defRPr/>
             </a:lvl2pPr>
             <a:lvl3pPr marL="0" indent="0">
               <a:lnSpc>
@@ -1061,6 +1063,7 @@
                 <a:spcPts val="0"/>
               </a:spcAft>
               <a:buNone/>
+              <a:defRPr/>
             </a:lvl3pPr>
             <a:lvl4pPr marL="0" indent="0">
               <a:lnSpc>
@@ -1073,6 +1076,7 @@
                 <a:spcPts val="0"/>
               </a:spcAft>
               <a:buNone/>
+              <a:defRPr/>
             </a:lvl4pPr>
             <a:lvl5pPr marL="0" indent="0">
               <a:lnSpc>
@@ -1085,6 +1089,7 @@
                 <a:spcPts val="0"/>
               </a:spcAft>
               <a:buNone/>
+              <a:defRPr/>
             </a:lvl5pPr>
             <a:lvl6pPr marL="0" indent="0">
               <a:lnSpc>
@@ -1097,6 +1102,7 @@
                 <a:spcPts val="0"/>
               </a:spcAft>
               <a:buNone/>
+              <a:defRPr/>
             </a:lvl6pPr>
             <a:lvl7pPr marL="0" indent="0">
               <a:lnSpc>
@@ -1109,6 +1115,7 @@
                 <a:spcPts val="0"/>
               </a:spcAft>
               <a:buNone/>
+              <a:defRPr/>
             </a:lvl7pPr>
             <a:lvl8pPr marL="0" indent="0">
               <a:lnSpc>
@@ -1121,6 +1128,7 @@
                 <a:spcPts val="0"/>
               </a:spcAft>
               <a:buNone/>
+              <a:defRPr/>
             </a:lvl8pPr>
             <a:lvl9pPr marL="0" indent="0">
               <a:lnSpc>
@@ -1133,6 +1141,7 @@
                 <a:spcPts val="0"/>
               </a:spcAft>
               <a:buNone/>
+              <a:defRPr/>
             </a:lvl9pPr>
           </a:lstStyle>
           <a:p xmlns:a="http://schemas.openxmlformats.org/drawingml/2006/main"/>
@@ -1194,6 +1203,7 @@
                 <a:spcPts val="0"/>
               </a:spcAft>
               <a:buNone/>
+              <a:defRPr/>
             </a:lvl1pPr>
             <a:lvl2pPr marL="0" indent="0">
               <a:lnSpc>
@@ -1206,6 +1216,7 @@
                 <a:spcPts val="0"/>
               </a:spcAft>
               <a:buNone/>
+              <a:defRPr/>
             </a:lvl2pPr>
             <a:lvl3pPr marL="0" indent="0">
               <a:lnSpc>
@@ -1218,6 +1229,7 @@
                 <a:spcPts val="0"/>
               </a:spcAft>
               <a:buNone/>
+              <a:defRPr/>
             </a:lvl3pPr>
             <a:lvl4pPr marL="0" indent="0">
               <a:lnSpc>
@@ -1230,6 +1242,7 @@
                 <a:spcPts val="0"/>
               </a:spcAft>
               <a:buNone/>
+              <a:defRPr/>
             </a:lvl4pPr>
             <a:lvl5pPr marL="0" indent="0">
               <a:lnSpc>
@@ -1242,6 +1255,7 @@
                 <a:spcPts val="0"/>
               </a:spcAft>
               <a:buNone/>
+              <a:defRPr/>
             </a:lvl5pPr>
             <a:lvl6pPr marL="0" indent="0">
               <a:lnSpc>
@@ -1254,6 +1268,7 @@
                 <a:spcPts val="0"/>
               </a:spcAft>
               <a:buNone/>
+              <a:defRPr/>
             </a:lvl6pPr>
             <a:lvl7pPr marL="0" indent="0">
               <a:lnSpc>
@@ -1266,6 +1281,7 @@
                 <a:spcPts val="0"/>
               </a:spcAft>
               <a:buNone/>
+              <a:defRPr/>
             </a:lvl7pPr>
             <a:lvl8pPr marL="0" indent="0">
               <a:lnSpc>
@@ -1278,6 +1294,7 @@
                 <a:spcPts val="0"/>
               </a:spcAft>
               <a:buNone/>
+              <a:defRPr/>
             </a:lvl8pPr>
             <a:lvl9pPr marL="0" indent="0">
               <a:lnSpc>
@@ -1290,6 +1307,7 @@
                 <a:spcPts val="0"/>
               </a:spcAft>
               <a:buNone/>
+              <a:defRPr/>
             </a:lvl9pPr>
           </a:lstStyle>
           <a:p xmlns:a="http://schemas.openxmlformats.org/drawingml/2006/main"/>
@@ -1368,6 +1386,7 @@
                 <a:spcPts val="0"/>
               </a:spcAft>
               <a:buNone/>
+              <a:defRPr/>
             </a:lvl1pPr>
             <a:lvl2pPr marL="0" indent="0">
               <a:lnSpc>
@@ -1380,6 +1399,7 @@
                 <a:spcPts val="0"/>
               </a:spcAft>
               <a:buNone/>
+              <a:defRPr/>
             </a:lvl2pPr>
             <a:lvl3pPr marL="0" indent="0">
               <a:lnSpc>
@@ -1392,6 +1412,7 @@
                 <a:spcPts val="0"/>
               </a:spcAft>
               <a:buNone/>
+              <a:defRPr/>
             </a:lvl3pPr>
             <a:lvl4pPr marL="0" indent="0">
               <a:lnSpc>
@@ -1404,6 +1425,7 @@
                 <a:spcPts val="0"/>
               </a:spcAft>
               <a:buNone/>
+              <a:defRPr/>
             </a:lvl4pPr>
             <a:lvl5pPr marL="0" indent="0">
               <a:lnSpc>
@@ -1416,6 +1438,7 @@
                 <a:spcPts val="0"/>
               </a:spcAft>
               <a:buNone/>
+              <a:defRPr/>
             </a:lvl5pPr>
             <a:lvl6pPr marL="0" indent="0">
               <a:lnSpc>
@@ -1428,6 +1451,7 @@
                 <a:spcPts val="0"/>
               </a:spcAft>
               <a:buNone/>
+              <a:defRPr/>
             </a:lvl6pPr>
             <a:lvl7pPr marL="0" indent="0">
               <a:lnSpc>
@@ -1440,6 +1464,7 @@
                 <a:spcPts val="0"/>
               </a:spcAft>
               <a:buNone/>
+              <a:defRPr/>
             </a:lvl7pPr>
             <a:lvl8pPr marL="0" indent="0">
               <a:lnSpc>
@@ -1452,6 +1477,7 @@
                 <a:spcPts val="0"/>
               </a:spcAft>
               <a:buNone/>
+              <a:defRPr/>
             </a:lvl8pPr>
             <a:lvl9pPr marL="0" indent="0">
               <a:lnSpc>
@@ -1464,6 +1490,7 @@
                 <a:spcPts val="0"/>
               </a:spcAft>
               <a:buNone/>
+              <a:defRPr/>
             </a:lvl9pPr>
           </a:lstStyle>
           <a:p xmlns:a="http://schemas.openxmlformats.org/drawingml/2006/main"/>
@@ -1542,6 +1569,7 @@
                 <a:spcPts val="0"/>
               </a:spcAft>
               <a:buNone/>
+              <a:defRPr/>
             </a:lvl1pPr>
             <a:lvl2pPr marL="0" indent="0">
               <a:lnSpc>
@@ -1554,6 +1582,7 @@
                 <a:spcPts val="0"/>
               </a:spcAft>
               <a:buNone/>
+              <a:defRPr/>
             </a:lvl2pPr>
             <a:lvl3pPr marL="0" indent="0">
               <a:lnSpc>
@@ -1566,6 +1595,7 @@
                 <a:spcPts val="0"/>
               </a:spcAft>
               <a:buNone/>
+              <a:defRPr/>
             </a:lvl3pPr>
             <a:lvl4pPr marL="0" indent="0">
               <a:lnSpc>
@@ -1578,6 +1608,7 @@
                 <a:spcPts val="0"/>
               </a:spcAft>
               <a:buNone/>
+              <a:defRPr/>
             </a:lvl4pPr>
             <a:lvl5pPr marL="0" indent="0">
               <a:lnSpc>
@@ -1590,6 +1621,7 @@
                 <a:spcPts val="0"/>
               </a:spcAft>
               <a:buNone/>
+              <a:defRPr/>
             </a:lvl5pPr>
             <a:lvl6pPr marL="0" indent="0">
               <a:lnSpc>
@@ -1602,6 +1634,7 @@
                 <a:spcPts val="0"/>
               </a:spcAft>
               <a:buNone/>
+              <a:defRPr/>
             </a:lvl6pPr>
             <a:lvl7pPr marL="0" indent="0">
               <a:lnSpc>
@@ -1614,6 +1647,7 @@
                 <a:spcPts val="0"/>
               </a:spcAft>
               <a:buNone/>
+              <a:defRPr/>
             </a:lvl7pPr>
             <a:lvl8pPr marL="0" indent="0">
               <a:lnSpc>
@@ -1626,6 +1660,7 @@
                 <a:spcPts val="0"/>
               </a:spcAft>
               <a:buNone/>
+              <a:defRPr/>
             </a:lvl8pPr>
             <a:lvl9pPr marL="0" indent="0">
               <a:lnSpc>
@@ -1638,6 +1673,7 @@
                 <a:spcPts val="0"/>
               </a:spcAft>
               <a:buNone/>
+              <a:defRPr/>
             </a:lvl9pPr>
           </a:lstStyle>
           <a:p xmlns:a="http://schemas.openxmlformats.org/drawingml/2006/main"/>
@@ -1699,6 +1735,7 @@
                 <a:spcPts val="1500"/>
               </a:spcAft>
               <a:buChar char="•"/>
+              <a:defRPr/>
             </a:lvl1pPr>
             <a:lvl2pPr marL="666750" indent="-285750">
               <a:lnSpc>
@@ -1711,6 +1748,7 @@
                 <a:spcPts val="1500"/>
               </a:spcAft>
               <a:buChar char="•"/>
+              <a:defRPr/>
             </a:lvl2pPr>
             <a:lvl3pPr marL="1047750" indent="-285750">
               <a:lnSpc>
@@ -1723,6 +1761,7 @@
                 <a:spcPts val="1500"/>
               </a:spcAft>
               <a:buChar char="•"/>
+              <a:defRPr/>
             </a:lvl3pPr>
             <a:lvl4pPr marL="1428750" indent="-285750">
               <a:lnSpc>
@@ -1735,6 +1774,7 @@
                 <a:spcPts val="1500"/>
               </a:spcAft>
               <a:buChar char="•"/>
+              <a:defRPr/>
             </a:lvl4pPr>
             <a:lvl5pPr marL="1809750" indent="-285750">
               <a:lnSpc>
@@ -1747,6 +1787,7 @@
                 <a:spcPts val="1500"/>
               </a:spcAft>
               <a:buChar char="•"/>
+              <a:defRPr/>
             </a:lvl5pPr>
             <a:lvl6pPr marL="2190750" indent="-285750">
               <a:lnSpc>
@@ -1759,6 +1800,7 @@
                 <a:spcPts val="1500"/>
               </a:spcAft>
               <a:buChar char="•"/>
+              <a:defRPr/>
             </a:lvl6pPr>
             <a:lvl7pPr marL="2571750" indent="-285750">
               <a:lnSpc>
@@ -1771,6 +1813,7 @@
                 <a:spcPts val="1500"/>
               </a:spcAft>
               <a:buChar char="•"/>
+              <a:defRPr/>
             </a:lvl7pPr>
             <a:lvl8pPr marL="2952750" indent="-285750">
               <a:lnSpc>
@@ -1783,6 +1826,7 @@
                 <a:spcPts val="1500"/>
               </a:spcAft>
               <a:buChar char="•"/>
+              <a:defRPr/>
             </a:lvl8pPr>
             <a:lvl9pPr marL="3333750" indent="-285750">
               <a:lnSpc>
@@ -1795,6 +1839,7 @@
                 <a:spcPts val="1500"/>
               </a:spcAft>
               <a:buChar char="•"/>
+              <a:defRPr/>
             </a:lvl9pPr>
           </a:lstStyle>
           <a:p xmlns:a="http://schemas.openxmlformats.org/drawingml/2006/main"/>
@@ -1873,6 +1918,7 @@
                 <a:spcPts val="0"/>
               </a:spcAft>
               <a:buNone/>
+              <a:defRPr/>
             </a:lvl1pPr>
             <a:lvl2pPr marL="0" indent="0">
               <a:lnSpc>
@@ -1885,6 +1931,7 @@
                 <a:spcPts val="0"/>
               </a:spcAft>
               <a:buNone/>
+              <a:defRPr/>
             </a:lvl2pPr>
             <a:lvl3pPr marL="0" indent="0">
               <a:lnSpc>
@@ -1897,6 +1944,7 @@
                 <a:spcPts val="0"/>
               </a:spcAft>
               <a:buNone/>
+              <a:defRPr/>
             </a:lvl3pPr>
             <a:lvl4pPr marL="0" indent="0">
               <a:lnSpc>
@@ -1909,6 +1957,7 @@
                 <a:spcPts val="0"/>
               </a:spcAft>
               <a:buNone/>
+              <a:defRPr/>
             </a:lvl4pPr>
             <a:lvl5pPr marL="0" indent="0">
               <a:lnSpc>
@@ -1921,6 +1970,7 @@
                 <a:spcPts val="0"/>
               </a:spcAft>
               <a:buNone/>
+              <a:defRPr/>
             </a:lvl5pPr>
             <a:lvl6pPr marL="0" indent="0">
               <a:lnSpc>
@@ -1933,6 +1983,7 @@
                 <a:spcPts val="0"/>
               </a:spcAft>
               <a:buNone/>
+              <a:defRPr/>
             </a:lvl6pPr>
             <a:lvl7pPr marL="0" indent="0">
               <a:lnSpc>
@@ -1945,6 +1996,7 @@
                 <a:spcPts val="0"/>
               </a:spcAft>
               <a:buNone/>
+              <a:defRPr/>
             </a:lvl7pPr>
             <a:lvl8pPr marL="0" indent="0">
               <a:lnSpc>
@@ -1957,6 +2009,7 @@
                 <a:spcPts val="0"/>
               </a:spcAft>
               <a:buNone/>
+              <a:defRPr/>
             </a:lvl8pPr>
             <a:lvl9pPr marL="0" indent="0">
               <a:lnSpc>
@@ -1969,6 +2022,7 @@
                 <a:spcPts val="0"/>
               </a:spcAft>
               <a:buNone/>
+              <a:defRPr/>
             </a:lvl9pPr>
           </a:lstStyle>
           <a:p xmlns:a="http://schemas.openxmlformats.org/drawingml/2006/main"/>
@@ -2030,6 +2084,7 @@
                 <a:spcPts val="1500"/>
               </a:spcAft>
               <a:buChar char="•"/>
+              <a:defRPr/>
             </a:lvl1pPr>
             <a:lvl2pPr marL="666750" indent="-285750">
               <a:lnSpc>
@@ -2042,6 +2097,7 @@
                 <a:spcPts val="1500"/>
               </a:spcAft>
               <a:buChar char="•"/>
+              <a:defRPr/>
             </a:lvl2pPr>
             <a:lvl3pPr marL="1047750" indent="-285750">
               <a:lnSpc>
@@ -2054,6 +2110,7 @@
                 <a:spcPts val="1500"/>
               </a:spcAft>
               <a:buChar char="•"/>
+              <a:defRPr/>
             </a:lvl3pPr>
             <a:lvl4pPr marL="1428750" indent="-285750">
               <a:lnSpc>
@@ -2066,6 +2123,7 @@
                 <a:spcPts val="1500"/>
               </a:spcAft>
               <a:buChar char="•"/>
+              <a:defRPr/>
             </a:lvl4pPr>
             <a:lvl5pPr marL="1809750" indent="-285750">
               <a:lnSpc>
@@ -2078,6 +2136,7 @@
                 <a:spcPts val="1500"/>
               </a:spcAft>
               <a:buChar char="•"/>
+              <a:defRPr/>
             </a:lvl5pPr>
             <a:lvl6pPr marL="2190750" indent="-285750">
               <a:lnSpc>
@@ -2090,6 +2149,7 @@
                 <a:spcPts val="1500"/>
               </a:spcAft>
               <a:buChar char="•"/>
+              <a:defRPr/>
             </a:lvl6pPr>
             <a:lvl7pPr marL="2571750" indent="-285750">
               <a:lnSpc>
@@ -2102,6 +2162,7 @@
                 <a:spcPts val="1500"/>
               </a:spcAft>
               <a:buChar char="•"/>
+              <a:defRPr/>
             </a:lvl7pPr>
             <a:lvl8pPr marL="2952750" indent="-285750">
               <a:lnSpc>
@@ -2114,6 +2175,7 @@
                 <a:spcPts val="1500"/>
               </a:spcAft>
               <a:buChar char="•"/>
+              <a:defRPr/>
             </a:lvl8pPr>
             <a:lvl9pPr marL="3333750" indent="-285750">
               <a:lnSpc>
@@ -2126,6 +2188,7 @@
                 <a:spcPts val="1500"/>
               </a:spcAft>
               <a:buChar char="•"/>
+              <a:defRPr/>
             </a:lvl9pPr>
           </a:lstStyle>
           <a:p xmlns:a="http://schemas.openxmlformats.org/drawingml/2006/main"/>
@@ -2187,6 +2250,7 @@
                 <a:spcPts val="1500"/>
               </a:spcAft>
               <a:buChar char="•"/>
+              <a:defRPr/>
             </a:lvl1pPr>
             <a:lvl2pPr marL="666750" indent="-285750">
               <a:lnSpc>
@@ -2199,6 +2263,7 @@
                 <a:spcPts val="1500"/>
               </a:spcAft>
               <a:buChar char="•"/>
+              <a:defRPr/>
             </a:lvl2pPr>
             <a:lvl3pPr marL="1047750" indent="-285750">
               <a:lnSpc>
@@ -2211,6 +2276,7 @@
                 <a:spcPts val="1500"/>
               </a:spcAft>
               <a:buChar char="•"/>
+              <a:defRPr/>
             </a:lvl3pPr>
             <a:lvl4pPr marL="1428750" indent="-285750">
               <a:lnSpc>
@@ -2223,6 +2289,7 @@
                 <a:spcPts val="1500"/>
               </a:spcAft>
               <a:buChar char="•"/>
+              <a:defRPr/>
             </a:lvl4pPr>
             <a:lvl5pPr marL="1809750" indent="-285750">
               <a:lnSpc>
@@ -2235,6 +2302,7 @@
                 <a:spcPts val="1500"/>
               </a:spcAft>
               <a:buChar char="•"/>
+              <a:defRPr/>
             </a:lvl5pPr>
             <a:lvl6pPr marL="2190750" indent="-285750">
               <a:lnSpc>
@@ -2247,6 +2315,7 @@
                 <a:spcPts val="1500"/>
               </a:spcAft>
               <a:buChar char="•"/>
+              <a:defRPr/>
             </a:lvl6pPr>
             <a:lvl7pPr marL="2571750" indent="-285750">
               <a:lnSpc>
@@ -2259,6 +2328,7 @@
                 <a:spcPts val="1500"/>
               </a:spcAft>
               <a:buChar char="•"/>
+              <a:defRPr/>
             </a:lvl7pPr>
             <a:lvl8pPr marL="2952750" indent="-285750">
               <a:lnSpc>
@@ -2271,6 +2341,7 @@
                 <a:spcPts val="1500"/>
               </a:spcAft>
               <a:buChar char="•"/>
+              <a:defRPr/>
             </a:lvl8pPr>
             <a:lvl9pPr marL="3333750" indent="-285750">
               <a:lnSpc>
@@ -2283,6 +2354,7 @@
                 <a:spcPts val="1500"/>
               </a:spcAft>
               <a:buChar char="•"/>
+              <a:defRPr/>
             </a:lvl9pPr>
           </a:lstStyle>
           <a:p xmlns:a="http://schemas.openxmlformats.org/drawingml/2006/main"/>
@@ -2361,6 +2433,7 @@
                 <a:spcPts val="0"/>
               </a:spcAft>
               <a:buNone/>
+              <a:defRPr/>
             </a:lvl1pPr>
             <a:lvl2pPr marL="0" indent="0">
               <a:lnSpc>
@@ -2373,6 +2446,7 @@
                 <a:spcPts val="0"/>
               </a:spcAft>
               <a:buNone/>
+              <a:defRPr/>
             </a:lvl2pPr>
             <a:lvl3pPr marL="0" indent="0">
               <a:lnSpc>
@@ -2385,6 +2459,7 @@
                 <a:spcPts val="0"/>
               </a:spcAft>
               <a:buNone/>
+              <a:defRPr/>
             </a:lvl3pPr>
             <a:lvl4pPr marL="0" indent="0">
               <a:lnSpc>
@@ -2397,6 +2472,7 @@
                 <a:spcPts val="0"/>
               </a:spcAft>
               <a:buNone/>
+              <a:defRPr/>
             </a:lvl4pPr>
             <a:lvl5pPr marL="0" indent="0">
               <a:lnSpc>
@@ -2409,6 +2485,7 @@
                 <a:spcPts val="0"/>
               </a:spcAft>
               <a:buNone/>
+              <a:defRPr/>
             </a:lvl5pPr>
             <a:lvl6pPr marL="0" indent="0">
               <a:lnSpc>
@@ -2421,6 +2498,7 @@
                 <a:spcPts val="0"/>
               </a:spcAft>
               <a:buNone/>
+              <a:defRPr/>
             </a:lvl6pPr>
             <a:lvl7pPr marL="0" indent="0">
               <a:lnSpc>
@@ -2433,6 +2511,7 @@
                 <a:spcPts val="0"/>
               </a:spcAft>
               <a:buNone/>
+              <a:defRPr/>
             </a:lvl7pPr>
             <a:lvl8pPr marL="0" indent="0">
               <a:lnSpc>
@@ -2445,6 +2524,7 @@
                 <a:spcPts val="0"/>
               </a:spcAft>
               <a:buNone/>
+              <a:defRPr/>
             </a:lvl8pPr>
             <a:lvl9pPr marL="0" indent="0">
               <a:lnSpc>
@@ -2457,6 +2537,7 @@
                 <a:spcPts val="0"/>
               </a:spcAft>
               <a:buNone/>
+              <a:defRPr/>
             </a:lvl9pPr>
           </a:lstStyle>
           <a:p xmlns:a="http://schemas.openxmlformats.org/drawingml/2006/main"/>
@@ -2518,6 +2599,7 @@
                 <a:spcPts val="1500"/>
               </a:spcAft>
               <a:buChar char="•"/>
+              <a:defRPr/>
             </a:lvl1pPr>
             <a:lvl2pPr marL="666750" indent="-285750">
               <a:lnSpc>
@@ -2530,6 +2612,7 @@
                 <a:spcPts val="1500"/>
               </a:spcAft>
               <a:buChar char="•"/>
+              <a:defRPr/>
             </a:lvl2pPr>
             <a:lvl3pPr marL="1047750" indent="-285750">
               <a:lnSpc>
@@ -2542,6 +2625,7 @@
                 <a:spcPts val="1500"/>
               </a:spcAft>
               <a:buChar char="•"/>
+              <a:defRPr/>
             </a:lvl3pPr>
             <a:lvl4pPr marL="1428750" indent="-285750">
               <a:lnSpc>
@@ -2554,6 +2638,7 @@
                 <a:spcPts val="1500"/>
               </a:spcAft>
               <a:buChar char="•"/>
+              <a:defRPr/>
             </a:lvl4pPr>
             <a:lvl5pPr marL="1809750" indent="-285750">
               <a:lnSpc>
@@ -2566,6 +2651,7 @@
                 <a:spcPts val="1500"/>
               </a:spcAft>
               <a:buChar char="•"/>
+              <a:defRPr/>
             </a:lvl5pPr>
             <a:lvl6pPr marL="2190750" indent="-285750">
               <a:lnSpc>
@@ -2578,6 +2664,7 @@
                 <a:spcPts val="1500"/>
               </a:spcAft>
               <a:buChar char="•"/>
+              <a:defRPr/>
             </a:lvl6pPr>
             <a:lvl7pPr marL="2571750" indent="-285750">
               <a:lnSpc>
@@ -2590,6 +2677,7 @@
                 <a:spcPts val="1500"/>
               </a:spcAft>
               <a:buChar char="•"/>
+              <a:defRPr/>
             </a:lvl7pPr>
             <a:lvl8pPr marL="2952750" indent="-285750">
               <a:lnSpc>
@@ -2602,6 +2690,7 @@
                 <a:spcPts val="1500"/>
               </a:spcAft>
               <a:buChar char="•"/>
+              <a:defRPr/>
             </a:lvl8pPr>
             <a:lvl9pPr marL="3333750" indent="-285750">
               <a:lnSpc>
@@ -2614,6 +2703,7 @@
                 <a:spcPts val="1500"/>
               </a:spcAft>
               <a:buChar char="•"/>
+              <a:defRPr/>
             </a:lvl9pPr>
           </a:lstStyle>
           <a:p xmlns:a="http://schemas.openxmlformats.org/drawingml/2006/main"/>
@@ -2662,12 +2752,12 @@
   </p:cSld>
   <p:clrMap bg1="lt1" tx1="dk1" bg2="lt2" tx2="dk2" accent1="accent1" accent2="accent2" accent3="accent3" accent4="accent4" accent5="accent5" accent6="accent6" hlink="hlink" folHlink="folHlink"/>
   <p:sldLayoutIdLst>
-    <p:sldLayoutId xmlns:r="http://schemas.openxmlformats.org/officeDocument/2006/relationships" id="2147483649" r:id="R6846bf5a52784031"/>
-    <p:sldLayoutId xmlns:r="http://schemas.openxmlformats.org/officeDocument/2006/relationships" id="2147483650" r:id="R27b90192727d4b6f"/>
-    <p:sldLayoutId xmlns:r="http://schemas.openxmlformats.org/officeDocument/2006/relationships" id="2147483651" r:id="R86f2907a34264d91"/>
-    <p:sldLayoutId xmlns:r="http://schemas.openxmlformats.org/officeDocument/2006/relationships" id="2147483652" r:id="R8696eeb5e57b422f"/>
-    <p:sldLayoutId xmlns:r="http://schemas.openxmlformats.org/officeDocument/2006/relationships" id="2147483653" r:id="Rccc8d6c9a01c44f9"/>
-    <p:sldLayoutId xmlns:r="http://schemas.openxmlformats.org/officeDocument/2006/relationships" id="2147483654" r:id="R9643191b62a84ca2"/>
+    <p:sldLayoutId xmlns:r="http://schemas.openxmlformats.org/officeDocument/2006/relationships" id="2147483649" r:id="R0d3f59da63fc4a30"/>
+    <p:sldLayoutId xmlns:r="http://schemas.openxmlformats.org/officeDocument/2006/relationships" id="2147483650" r:id="Rbdb54d6e67da4e5e"/>
+    <p:sldLayoutId xmlns:r="http://schemas.openxmlformats.org/officeDocument/2006/relationships" id="2147483651" r:id="Rcf6337a96f0643ae"/>
+    <p:sldLayoutId xmlns:r="http://schemas.openxmlformats.org/officeDocument/2006/relationships" id="2147483652" r:id="R8f6e8b350d544ab5"/>
+    <p:sldLayoutId xmlns:r="http://schemas.openxmlformats.org/officeDocument/2006/relationships" id="2147483653" r:id="Rcd953509fd854bab"/>
+    <p:sldLayoutId xmlns:r="http://schemas.openxmlformats.org/officeDocument/2006/relationships" id="2147483654" r:id="R81ca42f7981f4aad"/>
   </p:sldLayoutIdLst>
   <p:txStyles>
     <p:titleStyle>
@@ -3257,6 +3347,7 @@
           </a:lstStyle>
           <a:p xmlns:a="http://schemas.openxmlformats.org/drawingml/2006/main">
             <a:pPr>
+              <a:buNone/>
               <a:defRPr sz="1350" b="1">
                 <a:solidFill>
                   <a:srgbClr val="157D80"/>
@@ -3324,6 +3415,7 @@
           </a:lstStyle>
           <a:p xmlns:a="http://schemas.openxmlformats.org/drawingml/2006/main">
             <a:pPr>
+              <a:buNone/>
               <a:defRPr sz="3450" b="1">
                 <a:solidFill>
                   <a:srgbClr val="132E38"/>
@@ -3391,6 +3483,7 @@
           </a:lstStyle>
           <a:p xmlns:a="http://schemas.openxmlformats.org/drawingml/2006/main">
             <a:pPr>
+              <a:buNone/>
               <a:defRPr sz="1800" b="0">
                 <a:solidFill>
                   <a:srgbClr val="49616A"/>
@@ -3409,7 +3502,7 @@
                 <a:ea typeface="Aptos"/>
                 <a:cs typeface="Aptos"/>
               </a:rPr>
-              <a:t>One shared work system, with Buzz and the Paperclip dashboard as equal entry points.</a:t>
+              <a:t>Target experience: one work system, with Buzz and the Paperclip dashboard as entry points.</a:t>
             </a:r>
           </a:p>
         </p:txBody>
@@ -3489,6 +3582,7 @@
           </a:lstStyle>
           <a:p xmlns:a="http://schemas.openxmlformats.org/drawingml/2006/main">
             <a:pPr>
+              <a:buNone/>
               <a:defRPr sz="1275" b="0">
                 <a:solidFill>
                   <a:srgbClr val="49616A"/>
@@ -3507,7 +3601,7 @@
                 <a:ea typeface="Aptos"/>
                 <a:cs typeface="Aptos"/>
               </a:rPr>
-              <a:t>INERTIA-2026-10-23-r8 · 23 October 2026 · Autonomous build</a:t>
+              <a:t>INERTIA-2026-10-23-r9 · 23 October 2026 · Autonomous build</a:t>
             </a:r>
           </a:p>
         </p:txBody>
@@ -3556,6 +3650,7 @@
           </a:lstStyle>
           <a:p xmlns:a="http://schemas.openxmlformats.org/drawingml/2006/main">
             <a:pPr>
+              <a:buNone/>
               <a:defRPr sz="1800" b="1">
                 <a:solidFill>
                   <a:srgbClr val="157D80"/>
@@ -3656,6 +3751,7 @@
           </a:lstStyle>
           <a:p xmlns:a="http://schemas.openxmlformats.org/drawingml/2006/main">
             <a:pPr>
+              <a:buNone/>
               <a:defRPr sz="1875" b="1">
                 <a:solidFill>
                   <a:srgbClr val="157D80"/>
@@ -3723,6 +3819,7 @@
           </a:lstStyle>
           <a:p xmlns:a="http://schemas.openxmlformats.org/drawingml/2006/main">
             <a:pPr>
+              <a:buNone/>
               <a:defRPr sz="2250" b="0">
                 <a:solidFill>
                   <a:srgbClr val="49616A"/>
@@ -3746,6 +3843,7 @@
           </a:p>
           <a:p xmlns:a="http://schemas.openxmlformats.org/drawingml/2006/main">
             <a:pPr>
+              <a:buNone/>
               <a:defRPr sz="2250" b="0">
                 <a:solidFill>
                   <a:srgbClr val="49616A"/>
@@ -3769,6 +3867,7 @@
           </a:p>
           <a:p xmlns:a="http://schemas.openxmlformats.org/drawingml/2006/main">
             <a:pPr>
+              <a:buNone/>
               <a:defRPr sz="2250" b="0">
                 <a:solidFill>
                   <a:srgbClr val="49616A"/>
@@ -3792,6 +3891,7 @@
           </a:p>
           <a:p xmlns:a="http://schemas.openxmlformats.org/drawingml/2006/main">
             <a:pPr>
+              <a:buNone/>
               <a:defRPr sz="2250" b="0">
                 <a:solidFill>
                   <a:srgbClr val="49616A"/>
@@ -3892,6 +3992,7 @@
           </a:lstStyle>
           <a:p xmlns:a="http://schemas.openxmlformats.org/drawingml/2006/main">
             <a:pPr>
+              <a:buNone/>
               <a:defRPr sz="1875" b="1">
                 <a:solidFill>
                   <a:srgbClr val="157D80"/>
@@ -3959,6 +4060,7 @@
           </a:lstStyle>
           <a:p xmlns:a="http://schemas.openxmlformats.org/drawingml/2006/main">
             <a:pPr>
+              <a:buNone/>
               <a:defRPr sz="2250" b="0">
                 <a:solidFill>
                   <a:srgbClr val="49616A"/>
@@ -3982,6 +4084,7 @@
           </a:p>
           <a:p xmlns:a="http://schemas.openxmlformats.org/drawingml/2006/main">
             <a:pPr>
+              <a:buNone/>
               <a:defRPr sz="2250" b="0">
                 <a:solidFill>
                   <a:srgbClr val="49616A"/>
@@ -4005,6 +4108,7 @@
           </a:p>
           <a:p xmlns:a="http://schemas.openxmlformats.org/drawingml/2006/main">
             <a:pPr>
+              <a:buNone/>
               <a:defRPr sz="2250" b="0">
                 <a:solidFill>
                   <a:srgbClr val="49616A"/>
@@ -4028,6 +4132,7 @@
           </a:p>
           <a:p xmlns:a="http://schemas.openxmlformats.org/drawingml/2006/main">
             <a:pPr>
+              <a:buNone/>
               <a:defRPr sz="2250" b="0">
                 <a:solidFill>
                   <a:srgbClr val="49616A"/>
@@ -4128,6 +4233,7 @@
           </a:lstStyle>
           <a:p xmlns:a="http://schemas.openxmlformats.org/drawingml/2006/main">
             <a:pPr>
+              <a:buNone/>
               <a:defRPr sz="1875" b="1">
                 <a:solidFill>
                   <a:srgbClr val="157D80"/>
@@ -4195,6 +4301,7 @@
           </a:lstStyle>
           <a:p xmlns:a="http://schemas.openxmlformats.org/drawingml/2006/main">
             <a:pPr>
+              <a:buNone/>
               <a:defRPr sz="2250" b="0">
                 <a:solidFill>
                   <a:srgbClr val="49616A"/>
@@ -4218,6 +4325,7 @@
           </a:p>
           <a:p xmlns:a="http://schemas.openxmlformats.org/drawingml/2006/main">
             <a:pPr>
+              <a:buNone/>
               <a:defRPr sz="2250" b="0">
                 <a:solidFill>
                   <a:srgbClr val="49616A"/>
@@ -4241,6 +4349,7 @@
           </a:p>
           <a:p xmlns:a="http://schemas.openxmlformats.org/drawingml/2006/main">
             <a:pPr>
+              <a:buNone/>
               <a:defRPr sz="2250" b="0">
                 <a:solidFill>
                   <a:srgbClr val="49616A"/>
@@ -4264,6 +4373,7 @@
           </a:p>
           <a:p xmlns:a="http://schemas.openxmlformats.org/drawingml/2006/main">
             <a:pPr>
+              <a:buNone/>
               <a:defRPr sz="2250" b="0">
                 <a:solidFill>
                   <a:srgbClr val="49616A"/>
@@ -4331,6 +4441,7 @@
           </a:lstStyle>
           <a:p xmlns:a="http://schemas.openxmlformats.org/drawingml/2006/main">
             <a:pPr>
+              <a:buNone/>
               <a:defRPr sz="2100" b="0">
                 <a:solidFill>
                   <a:srgbClr val="132E38"/>
@@ -4427,6 +4538,7 @@
           </a:lstStyle>
           <a:p xmlns:a="http://schemas.openxmlformats.org/drawingml/2006/main">
             <a:pPr>
+              <a:buNone/>
               <a:defRPr sz="1350" b="1">
                 <a:solidFill>
                   <a:srgbClr val="157D80"/>
@@ -4494,6 +4606,7 @@
           </a:lstStyle>
           <a:p xmlns:a="http://schemas.openxmlformats.org/drawingml/2006/main">
             <a:pPr>
+              <a:buNone/>
               <a:defRPr sz="3450" b="1">
                 <a:solidFill>
                   <a:srgbClr val="132E38"/>
@@ -4561,6 +4674,7 @@
           </a:lstStyle>
           <a:p xmlns:a="http://schemas.openxmlformats.org/drawingml/2006/main">
             <a:pPr>
+              <a:buNone/>
               <a:defRPr sz="1800" b="0">
                 <a:solidFill>
                   <a:srgbClr val="49616A"/>
@@ -4659,6 +4773,7 @@
           </a:lstStyle>
           <a:p xmlns:a="http://schemas.openxmlformats.org/drawingml/2006/main">
             <a:pPr>
+              <a:buNone/>
               <a:defRPr sz="1275" b="0">
                 <a:solidFill>
                   <a:srgbClr val="49616A"/>
@@ -4677,7 +4792,7 @@
                 <a:ea typeface="Aptos"/>
                 <a:cs typeface="Aptos"/>
               </a:rPr>
-              <a:t>INERTIA-2026-10-23-r8 · 23 October 2026 · Autonomous build</a:t>
+              <a:t>INERTIA-2026-10-23-r9 · 23 October 2026 · Autonomous build</a:t>
             </a:r>
           </a:p>
         </p:txBody>
@@ -4726,6 +4841,7 @@
           </a:lstStyle>
           <a:p xmlns:a="http://schemas.openxmlformats.org/drawingml/2006/main">
             <a:pPr>
+              <a:buNone/>
               <a:defRPr sz="1800" b="1">
                 <a:solidFill>
                   <a:srgbClr val="157D80"/>
@@ -4826,6 +4942,7 @@
           </a:lstStyle>
           <a:p xmlns:a="http://schemas.openxmlformats.org/drawingml/2006/main">
             <a:pPr>
+              <a:buNone/>
               <a:defRPr sz="1875" b="1">
                 <a:solidFill>
                   <a:srgbClr val="157D80"/>
@@ -4893,6 +5010,7 @@
           </a:lstStyle>
           <a:p xmlns:a="http://schemas.openxmlformats.org/drawingml/2006/main">
             <a:pPr>
+              <a:buNone/>
               <a:defRPr sz="2250" b="0">
                 <a:solidFill>
                   <a:srgbClr val="49616A"/>
@@ -4916,6 +5034,7 @@
           </a:p>
           <a:p xmlns:a="http://schemas.openxmlformats.org/drawingml/2006/main">
             <a:pPr>
+              <a:buNone/>
               <a:defRPr sz="2250" b="0">
                 <a:solidFill>
                   <a:srgbClr val="49616A"/>
@@ -4939,6 +5058,7 @@
           </a:p>
           <a:p xmlns:a="http://schemas.openxmlformats.org/drawingml/2006/main">
             <a:pPr>
+              <a:buNone/>
               <a:defRPr sz="2250" b="0">
                 <a:solidFill>
                   <a:srgbClr val="49616A"/>
@@ -4962,6 +5082,7 @@
           </a:p>
           <a:p xmlns:a="http://schemas.openxmlformats.org/drawingml/2006/main">
             <a:pPr>
+              <a:buNone/>
               <a:defRPr sz="2250" b="0">
                 <a:solidFill>
                   <a:srgbClr val="49616A"/>
@@ -5062,6 +5183,7 @@
           </a:lstStyle>
           <a:p xmlns:a="http://schemas.openxmlformats.org/drawingml/2006/main">
             <a:pPr>
+              <a:buNone/>
               <a:defRPr sz="1875" b="1">
                 <a:solidFill>
                   <a:srgbClr val="157D80"/>
@@ -5129,6 +5251,7 @@
           </a:lstStyle>
           <a:p xmlns:a="http://schemas.openxmlformats.org/drawingml/2006/main">
             <a:pPr>
+              <a:buNone/>
               <a:defRPr sz="2250" b="0">
                 <a:solidFill>
                   <a:srgbClr val="49616A"/>
@@ -5147,11 +5270,12 @@
                 <a:ea typeface="Aptos"/>
                 <a:cs typeface="Aptos"/>
               </a:rPr>
-              <a:t>Signed requests and identity</a:t>
-            </a:r>
-          </a:p>
-          <a:p xmlns:a="http://schemas.openxmlformats.org/drawingml/2006/main">
-            <a:pPr>
+              <a:t>Signed requests</a:t>
+            </a:r>
+          </a:p>
+          <a:p xmlns:a="http://schemas.openxmlformats.org/drawingml/2006/main">
+            <a:pPr>
+              <a:buNone/>
               <a:defRPr sz="2250" b="0">
                 <a:solidFill>
                   <a:srgbClr val="49616A"/>
@@ -5170,11 +5294,12 @@
                 <a:ea typeface="Aptos"/>
                 <a:cs typeface="Aptos"/>
               </a:rPr>
-              <a:t>Existing native task IDs</a:t>
-            </a:r>
-          </a:p>
-          <a:p xmlns:a="http://schemas.openxmlformats.org/drawingml/2006/main">
-            <a:pPr>
+              <a:t>Identity and native task IDs</a:t>
+            </a:r>
+          </a:p>
+          <a:p xmlns:a="http://schemas.openxmlformats.org/drawingml/2006/main">
+            <a:pPr>
+              <a:buNone/>
               <a:defRPr sz="2250" b="0">
                 <a:solidFill>
                   <a:srgbClr val="49616A"/>
@@ -5193,11 +5318,12 @@
                 <a:ea typeface="Aptos"/>
                 <a:cs typeface="Aptos"/>
               </a:rPr>
-              <a:t>Shared decisions and receipts</a:t>
-            </a:r>
-          </a:p>
-          <a:p xmlns:a="http://schemas.openxmlformats.org/drawingml/2006/main">
-            <a:pPr>
+              <a:t>Native decisions</a:t>
+            </a:r>
+          </a:p>
+          <a:p xmlns:a="http://schemas.openxmlformats.org/drawingml/2006/main">
+            <a:pPr>
+              <a:buNone/>
               <a:defRPr sz="2250" b="0">
                 <a:solidFill>
                   <a:srgbClr val="49616A"/>
@@ -5298,6 +5424,7 @@
           </a:lstStyle>
           <a:p xmlns:a="http://schemas.openxmlformats.org/drawingml/2006/main">
             <a:pPr>
+              <a:buNone/>
               <a:defRPr sz="1875" b="1">
                 <a:solidFill>
                   <a:srgbClr val="157D80"/>
@@ -5365,6 +5492,7 @@
           </a:lstStyle>
           <a:p xmlns:a="http://schemas.openxmlformats.org/drawingml/2006/main">
             <a:pPr>
+              <a:buNone/>
               <a:defRPr sz="2250" b="0">
                 <a:solidFill>
                   <a:srgbClr val="49616A"/>
@@ -5383,11 +5511,12 @@
                 <a:ea typeface="Aptos"/>
                 <a:cs typeface="Aptos"/>
               </a:rPr>
-              <a:t>Qualified hardened provider</a:t>
-            </a:r>
-          </a:p>
-          <a:p xmlns:a="http://schemas.openxmlformats.org/drawingml/2006/main">
-            <a:pPr>
+              <a:t>Existing hardened provider</a:t>
+            </a:r>
+          </a:p>
+          <a:p xmlns:a="http://schemas.openxmlformats.org/drawingml/2006/main">
+            <a:pPr>
+              <a:buNone/>
               <a:defRPr sz="2250" b="0">
                 <a:solidFill>
                   <a:srgbClr val="49616A"/>
@@ -5406,11 +5535,12 @@
                 <a:ea typeface="Aptos"/>
                 <a:cs typeface="Aptos"/>
               </a:rPr>
-              <a:t>Client-side task isolation</a:t>
-            </a:r>
-          </a:p>
-          <a:p xmlns:a="http://schemas.openxmlformats.org/drawingml/2006/main">
-            <a:pPr>
+              <a:t>Isolation qualification pending</a:t>
+            </a:r>
+          </a:p>
+          <a:p xmlns:a="http://schemas.openxmlformats.org/drawingml/2006/main">
+            <a:pPr>
+              <a:buNone/>
               <a:defRPr sz="2250" b="0">
                 <a:solidFill>
                   <a:srgbClr val="49616A"/>
@@ -5434,6 +5564,7 @@
           </a:p>
           <a:p xmlns:a="http://schemas.openxmlformats.org/drawingml/2006/main">
             <a:pPr>
+              <a:buNone/>
               <a:defRPr sz="2250" b="0">
                 <a:solidFill>
                   <a:srgbClr val="49616A"/>
@@ -5501,6 +5632,7 @@
           </a:lstStyle>
           <a:p xmlns:a="http://schemas.openxmlformats.org/drawingml/2006/main">
             <a:pPr>
+              <a:buNone/>
               <a:defRPr sz="2100" b="0">
                 <a:solidFill>
                   <a:srgbClr val="132E38"/>
@@ -5597,6 +5729,7 @@
           </a:lstStyle>
           <a:p xmlns:a="http://schemas.openxmlformats.org/drawingml/2006/main">
             <a:pPr>
+              <a:buNone/>
               <a:defRPr sz="1350" b="1">
                 <a:solidFill>
                   <a:srgbClr val="157D80"/>
@@ -5664,6 +5797,7 @@
           </a:lstStyle>
           <a:p xmlns:a="http://schemas.openxmlformats.org/drawingml/2006/main">
             <a:pPr>
+              <a:buNone/>
               <a:defRPr sz="3450" b="1">
                 <a:solidFill>
                   <a:srgbClr val="132E38"/>
@@ -5731,6 +5865,7 @@
           </a:lstStyle>
           <a:p xmlns:a="http://schemas.openxmlformats.org/drawingml/2006/main">
             <a:pPr>
+              <a:buNone/>
               <a:defRPr sz="1800" b="0">
                 <a:solidFill>
                   <a:srgbClr val="49616A"/>
@@ -5749,7 +5884,7 @@
                 <a:ea typeface="Aptos"/>
                 <a:cs typeface="Aptos"/>
               </a:rPr>
-              <a:t>Meet recording and Gemini processing feed the organization’s Drive folder.</a:t>
+              <a:t>Target: authorized Meet/Gemini output in Drive, then members-only portal publication.</a:t>
             </a:r>
           </a:p>
         </p:txBody>
@@ -5829,6 +5964,7 @@
           </a:lstStyle>
           <a:p xmlns:a="http://schemas.openxmlformats.org/drawingml/2006/main">
             <a:pPr>
+              <a:buNone/>
               <a:defRPr sz="1275" b="0">
                 <a:solidFill>
                   <a:srgbClr val="49616A"/>
@@ -5847,7 +5983,7 @@
                 <a:ea typeface="Aptos"/>
                 <a:cs typeface="Aptos"/>
               </a:rPr>
-              <a:t>INERTIA-2026-10-23-r8 · 23 October 2026 · Autonomous build</a:t>
+              <a:t>INERTIA-2026-10-23-r9 · 23 October 2026 · Autonomous build</a:t>
             </a:r>
           </a:p>
         </p:txBody>
@@ -5896,6 +6032,7 @@
           </a:lstStyle>
           <a:p xmlns:a="http://schemas.openxmlformats.org/drawingml/2006/main">
             <a:pPr>
+              <a:buNone/>
               <a:defRPr sz="1800" b="1">
                 <a:solidFill>
                   <a:srgbClr val="157D80"/>
@@ -5996,6 +6133,7 @@
           </a:lstStyle>
           <a:p xmlns:a="http://schemas.openxmlformats.org/drawingml/2006/main">
             <a:pPr>
+              <a:buNone/>
               <a:defRPr sz="1875" b="1">
                 <a:solidFill>
                   <a:srgbClr val="157D80"/>
@@ -6063,6 +6201,7 @@
           </a:lstStyle>
           <a:p xmlns:a="http://schemas.openxmlformats.org/drawingml/2006/main">
             <a:pPr>
+              <a:buNone/>
               <a:defRPr sz="2250" b="0">
                 <a:solidFill>
                   <a:srgbClr val="49616A"/>
@@ -6086,6 +6225,7 @@
           </a:p>
           <a:p xmlns:a="http://schemas.openxmlformats.org/drawingml/2006/main">
             <a:pPr>
+              <a:buNone/>
               <a:defRPr sz="2250" b="0">
                 <a:solidFill>
                   <a:srgbClr val="49616A"/>
@@ -6109,6 +6249,7 @@
           </a:p>
           <a:p xmlns:a="http://schemas.openxmlformats.org/drawingml/2006/main">
             <a:pPr>
+              <a:buNone/>
               <a:defRPr sz="2250" b="0">
                 <a:solidFill>
                   <a:srgbClr val="49616A"/>
@@ -6132,6 +6273,7 @@
           </a:p>
           <a:p xmlns:a="http://schemas.openxmlformats.org/drawingml/2006/main">
             <a:pPr>
+              <a:buNone/>
               <a:defRPr sz="2250" b="0">
                 <a:solidFill>
                   <a:srgbClr val="49616A"/>
@@ -6232,6 +6374,7 @@
           </a:lstStyle>
           <a:p xmlns:a="http://schemas.openxmlformats.org/drawingml/2006/main">
             <a:pPr>
+              <a:buNone/>
               <a:defRPr sz="1875" b="1">
                 <a:solidFill>
                   <a:srgbClr val="157D80"/>
@@ -6299,6 +6442,7 @@
           </a:lstStyle>
           <a:p xmlns:a="http://schemas.openxmlformats.org/drawingml/2006/main">
             <a:pPr>
+              <a:buNone/>
               <a:defRPr sz="2250" b="0">
                 <a:solidFill>
                   <a:srgbClr val="49616A"/>
@@ -6317,11 +6461,12 @@
                 <a:ea typeface="Aptos"/>
                 <a:cs typeface="Aptos"/>
               </a:rPr>
-              <a:t>Separate transcript and notes</a:t>
-            </a:r>
-          </a:p>
-          <a:p xmlns:a="http://schemas.openxmlformats.org/drawingml/2006/main">
-            <a:pPr>
+              <a:t>Transcript plus notes</a:t>
+            </a:r>
+          </a:p>
+          <a:p xmlns:a="http://schemas.openxmlformats.org/drawingml/2006/main">
+            <a:pPr>
+              <a:buNone/>
               <a:defRPr sz="2250" b="0">
                 <a:solidFill>
                   <a:srgbClr val="49616A"/>
@@ -6340,11 +6485,12 @@
                 <a:ea typeface="Aptos"/>
                 <a:cs typeface="Aptos"/>
               </a:rPr>
-              <a:t>Cite source for action items</a:t>
-            </a:r>
-          </a:p>
-          <a:p xmlns:a="http://schemas.openxmlformats.org/drawingml/2006/main">
-            <a:pPr>
+              <a:t>Cite each action item</a:t>
+            </a:r>
+          </a:p>
+          <a:p xmlns:a="http://schemas.openxmlformats.org/drawingml/2006/main">
+            <a:pPr>
+              <a:buNone/>
               <a:defRPr sz="2250" b="0">
                 <a:solidFill>
                   <a:srgbClr val="49616A"/>
@@ -6368,6 +6514,7 @@
           </a:p>
           <a:p xmlns:a="http://schemas.openxmlformats.org/drawingml/2006/main">
             <a:pPr>
+              <a:buNone/>
               <a:defRPr sz="2250" b="0">
                 <a:solidFill>
                   <a:srgbClr val="49616A"/>
@@ -6468,6 +6615,7 @@
           </a:lstStyle>
           <a:p xmlns:a="http://schemas.openxmlformats.org/drawingml/2006/main">
             <a:pPr>
+              <a:buNone/>
               <a:defRPr sz="1875" b="1">
                 <a:solidFill>
                   <a:srgbClr val="157D80"/>
@@ -6535,6 +6683,7 @@
           </a:lstStyle>
           <a:p xmlns:a="http://schemas.openxmlformats.org/drawingml/2006/main">
             <a:pPr>
+              <a:buNone/>
               <a:defRPr sz="2250" b="0">
                 <a:solidFill>
                   <a:srgbClr val="49616A"/>
@@ -6553,11 +6702,12 @@
                 <a:ea typeface="Aptos"/>
                 <a:cs typeface="Aptos"/>
               </a:rPr>
-              <a:t>Upsert the website record</a:t>
-            </a:r>
-          </a:p>
-          <a:p xmlns:a="http://schemas.openxmlformats.org/drawingml/2006/main">
-            <a:pPr>
+              <a:t>Caller contract-tested</a:t>
+            </a:r>
+          </a:p>
+          <a:p xmlns:a="http://schemas.openxmlformats.org/drawingml/2006/main">
+            <a:pPr>
+              <a:buNone/>
               <a:defRPr sz="2250" b="0">
                 <a:solidFill>
                   <a:srgbClr val="49616A"/>
@@ -6576,11 +6726,36 @@
                 <a:ea typeface="Aptos"/>
                 <a:cs typeface="Aptos"/>
               </a:rPr>
+              <a:t>Exact persisted request bytes</a:t>
+            </a:r>
+          </a:p>
+          <a:p xmlns:a="http://schemas.openxmlformats.org/drawingml/2006/main">
+            <a:pPr>
+              <a:buNone/>
+              <a:defRPr sz="2250" b="0">
+                <a:solidFill>
+                  <a:srgbClr val="49616A"/>
+                </a:solidFill>
+                <a:latin typeface="Aptos"/>
+                <a:ea typeface="Aptos"/>
+                <a:cs typeface="Aptos"/>
+              </a:defRPr>
+            </a:pPr>
+            <a:r>
+              <a:rPr sz="2250" b="0">
+                <a:solidFill>
+                  <a:srgbClr val="49616A"/>
+                </a:solidFill>
+                <a:latin typeface="Aptos"/>
+                <a:ea typeface="Aptos"/>
+                <a:cs typeface="Aptos"/>
+              </a:rPr>
               <a:t>Verify content and audience</a:t>
             </a:r>
           </a:p>
           <a:p xmlns:a="http://schemas.openxmlformats.org/drawingml/2006/main">
             <a:pPr>
+              <a:buNone/>
               <a:defRPr sz="2250" b="0">
                 <a:solidFill>
                   <a:srgbClr val="49616A"/>
@@ -6599,30 +6774,7 @@
                 <a:ea typeface="Aptos"/>
                 <a:cs typeface="Aptos"/>
               </a:rPr>
-              <a:t>Return the published URLs</a:t>
-            </a:r>
-          </a:p>
-          <a:p xmlns:a="http://schemas.openxmlformats.org/drawingml/2006/main">
-            <a:pPr>
-              <a:defRPr sz="2250" b="0">
-                <a:solidFill>
-                  <a:srgbClr val="49616A"/>
-                </a:solidFill>
-                <a:latin typeface="Aptos"/>
-                <a:ea typeface="Aptos"/>
-                <a:cs typeface="Aptos"/>
-              </a:defRPr>
-            </a:pPr>
-            <a:r>
-              <a:rPr sz="2250" b="0">
-                <a:solidFill>
-                  <a:srgbClr val="49616A"/>
-                </a:solidFill>
-                <a:latin typeface="Aptos"/>
-                <a:ea typeface="Aptos"/>
-                <a:cs typeface="Aptos"/>
-              </a:rPr>
-              <a:t>Reconcile corrections and retries</a:t>
+              <a:t>Server rollout still pending</a:t>
             </a:r>
           </a:p>
         </p:txBody>
@@ -6671,6 +6823,7 @@
           </a:lstStyle>
           <a:p xmlns:a="http://schemas.openxmlformats.org/drawingml/2006/main">
             <a:pPr>
+              <a:buNone/>
               <a:defRPr sz="2100" b="0">
                 <a:solidFill>
                   <a:srgbClr val="132E38"/>
@@ -6689,7 +6842,7 @@
                 <a:ea typeface="Aptos"/>
                 <a:cs typeface="Aptos"/>
               </a:rPr>
-              <a:t>After one-time setup, routine publication runs automatically. Exceptions name the precise action needed.</a:t>
+              <a:t>Proposed v1.1 contract keeps v1 hashing. Metadata-only correction needs a new codec. Source and job wiring remain pending.</a:t>
             </a:r>
           </a:p>
         </p:txBody>
@@ -6767,6 +6920,7 @@
           </a:lstStyle>
           <a:p xmlns:a="http://schemas.openxmlformats.org/drawingml/2006/main">
             <a:pPr>
+              <a:buNone/>
               <a:defRPr sz="1350" b="1">
                 <a:solidFill>
                   <a:srgbClr val="157D80"/>
@@ -6834,6 +6988,7 @@
           </a:lstStyle>
           <a:p xmlns:a="http://schemas.openxmlformats.org/drawingml/2006/main">
             <a:pPr>
+              <a:buNone/>
               <a:defRPr sz="3450" b="1">
                 <a:solidFill>
                   <a:srgbClr val="132E38"/>
@@ -6901,6 +7056,7 @@
           </a:lstStyle>
           <a:p xmlns:a="http://schemas.openxmlformats.org/drawingml/2006/main">
             <a:pPr>
+              <a:buNone/>
               <a:defRPr sz="1800" b="0">
                 <a:solidFill>
                   <a:srgbClr val="49616A"/>
@@ -6999,6 +7155,7 @@
           </a:lstStyle>
           <a:p xmlns:a="http://schemas.openxmlformats.org/drawingml/2006/main">
             <a:pPr>
+              <a:buNone/>
               <a:defRPr sz="1275" b="0">
                 <a:solidFill>
                   <a:srgbClr val="49616A"/>
@@ -7017,7 +7174,7 @@
                 <a:ea typeface="Aptos"/>
                 <a:cs typeface="Aptos"/>
               </a:rPr>
-              <a:t>INERTIA-2026-10-23-r8 · 23 October 2026 · Autonomous build</a:t>
+              <a:t>INERTIA-2026-10-23-r9 · 23 October 2026 · Autonomous build</a:t>
             </a:r>
           </a:p>
         </p:txBody>
@@ -7066,6 +7223,7 @@
           </a:lstStyle>
           <a:p xmlns:a="http://schemas.openxmlformats.org/drawingml/2006/main">
             <a:pPr>
+              <a:buNone/>
               <a:defRPr sz="1800" b="1">
                 <a:solidFill>
                   <a:srgbClr val="157D80"/>
@@ -7166,6 +7324,7 @@
           </a:lstStyle>
           <a:p xmlns:a="http://schemas.openxmlformats.org/drawingml/2006/main">
             <a:pPr>
+              <a:buNone/>
               <a:defRPr sz="1875" b="1">
                 <a:solidFill>
                   <a:srgbClr val="157D80"/>
@@ -7233,6 +7392,7 @@
           </a:lstStyle>
           <a:p xmlns:a="http://schemas.openxmlformats.org/drawingml/2006/main">
             <a:pPr>
+              <a:buNone/>
               <a:defRPr sz="2250" b="0">
                 <a:solidFill>
                   <a:srgbClr val="49616A"/>
@@ -7256,6 +7416,7 @@
           </a:p>
           <a:p xmlns:a="http://schemas.openxmlformats.org/drawingml/2006/main">
             <a:pPr>
+              <a:buNone/>
               <a:defRPr sz="2250" b="0">
                 <a:solidFill>
                   <a:srgbClr val="49616A"/>
@@ -7274,11 +7435,12 @@
                 <a:ea typeface="Aptos"/>
                 <a:cs typeface="Aptos"/>
               </a:rPr>
-              <a:t>Retrieve authorized DAO facts</a:t>
-            </a:r>
-          </a:p>
-          <a:p xmlns:a="http://schemas.openxmlformats.org/drawingml/2006/main">
-            <a:pPr>
+              <a:t>Use cited DAO draft facts</a:t>
+            </a:r>
+          </a:p>
+          <a:p xmlns:a="http://schemas.openxmlformats.org/drawingml/2006/main">
+            <a:pPr>
+              <a:buNone/>
               <a:defRPr sz="2250" b="0">
                 <a:solidFill>
                   <a:srgbClr val="49616A"/>
@@ -7297,11 +7459,12 @@
                 <a:ea typeface="Aptos"/>
                 <a:cs typeface="Aptos"/>
               </a:rPr>
-              <a:t>Build a cited, eligible packet</a:t>
-            </a:r>
-          </a:p>
-          <a:p xmlns:a="http://schemas.openxmlformats.org/drawingml/2006/main">
-            <a:pPr>
+              <a:t>Verify legal/tax eligibility</a:t>
+            </a:r>
+          </a:p>
+          <a:p xmlns:a="http://schemas.openxmlformats.org/drawingml/2006/main">
+            <a:pPr>
+              <a:buNone/>
               <a:defRPr sz="2250" b="0">
                 <a:solidFill>
                   <a:srgbClr val="49616A"/>
@@ -7402,6 +7565,7 @@
           </a:lstStyle>
           <a:p xmlns:a="http://schemas.openxmlformats.org/drawingml/2006/main">
             <a:pPr>
+              <a:buNone/>
               <a:defRPr sz="1875" b="1">
                 <a:solidFill>
                   <a:srgbClr val="157D80"/>
@@ -7469,6 +7633,7 @@
           </a:lstStyle>
           <a:p xmlns:a="http://schemas.openxmlformats.org/drawingml/2006/main">
             <a:pPr>
+              <a:buNone/>
               <a:defRPr sz="2250" b="0">
                 <a:solidFill>
                   <a:srgbClr val="49616A"/>
@@ -7492,6 +7657,7 @@
           </a:p>
           <a:p xmlns:a="http://schemas.openxmlformats.org/drawingml/2006/main">
             <a:pPr>
+              <a:buNone/>
               <a:defRPr sz="2250" b="0">
                 <a:solidFill>
                   <a:srgbClr val="49616A"/>
@@ -7515,6 +7681,7 @@
           </a:p>
           <a:p xmlns:a="http://schemas.openxmlformats.org/drawingml/2006/main">
             <a:pPr>
+              <a:buNone/>
               <a:defRPr sz="2250" b="0">
                 <a:solidFill>
                   <a:srgbClr val="49616A"/>
@@ -7538,6 +7705,7 @@
           </a:p>
           <a:p xmlns:a="http://schemas.openxmlformats.org/drawingml/2006/main">
             <a:pPr>
+              <a:buNone/>
               <a:defRPr sz="2250" b="0">
                 <a:solidFill>
                   <a:srgbClr val="49616A"/>
@@ -7638,6 +7806,7 @@
           </a:lstStyle>
           <a:p xmlns:a="http://schemas.openxmlformats.org/drawingml/2006/main">
             <a:pPr>
+              <a:buNone/>
               <a:defRPr sz="1875" b="1">
                 <a:solidFill>
                   <a:srgbClr val="157D80"/>
@@ -7705,6 +7874,7 @@
           </a:lstStyle>
           <a:p xmlns:a="http://schemas.openxmlformats.org/drawingml/2006/main">
             <a:pPr>
+              <a:buNone/>
               <a:defRPr sz="2250" b="0">
                 <a:solidFill>
                   <a:srgbClr val="49616A"/>
@@ -7728,6 +7898,7 @@
           </a:p>
           <a:p xmlns:a="http://schemas.openxmlformats.org/drawingml/2006/main">
             <a:pPr>
+              <a:buNone/>
               <a:defRPr sz="2250" b="0">
                 <a:solidFill>
                   <a:srgbClr val="49616A"/>
@@ -7751,6 +7922,7 @@
           </a:p>
           <a:p xmlns:a="http://schemas.openxmlformats.org/drawingml/2006/main">
             <a:pPr>
+              <a:buNone/>
               <a:defRPr sz="2250" b="0">
                 <a:solidFill>
                   <a:srgbClr val="49616A"/>
@@ -7774,6 +7946,7 @@
           </a:p>
           <a:p xmlns:a="http://schemas.openxmlformats.org/drawingml/2006/main">
             <a:pPr>
+              <a:buNone/>
               <a:defRPr sz="2250" b="0">
                 <a:solidFill>
                   <a:srgbClr val="49616A"/>
@@ -7841,6 +8014,7 @@
           </a:lstStyle>
           <a:p xmlns:a="http://schemas.openxmlformats.org/drawingml/2006/main">
             <a:pPr>
+              <a:buNone/>
               <a:defRPr sz="2100" b="0">
                 <a:solidFill>
                   <a:srgbClr val="132E38"/>
@@ -7859,7 +8033,7 @@
                 <a:ea typeface="Aptos"/>
                 <a:cs typeface="Aptos"/>
               </a:rPr>
-              <a:t>The demo demonstrates the ratified packet. Actual funder submission remains a separately authorized action.</a:t>
+              <a:t>The synthetic demo binds a packet to fixture vote evidence. Operative governance and live verification remain pending.</a:t>
             </a:r>
           </a:p>
         </p:txBody>
@@ -7937,6 +8111,7 @@
           </a:lstStyle>
           <a:p xmlns:a="http://schemas.openxmlformats.org/drawingml/2006/main">
             <a:pPr>
+              <a:buNone/>
               <a:defRPr sz="1350" b="1">
                 <a:solidFill>
                   <a:srgbClr val="157D80"/>
@@ -8004,6 +8179,7 @@
           </a:lstStyle>
           <a:p xmlns:a="http://schemas.openxmlformats.org/drawingml/2006/main">
             <a:pPr>
+              <a:buNone/>
               <a:defRPr sz="3450" b="1">
                 <a:solidFill>
                   <a:srgbClr val="132E38"/>
@@ -8071,6 +8247,7 @@
           </a:lstStyle>
           <a:p xmlns:a="http://schemas.openxmlformats.org/drawingml/2006/main">
             <a:pPr>
+              <a:buNone/>
               <a:defRPr sz="1800" b="0">
                 <a:solidFill>
                   <a:srgbClr val="49616A"/>
@@ -8089,7 +8266,7 @@
                 <a:ea typeface="Aptos"/>
                 <a:cs typeface="Aptos"/>
               </a:rPr>
-              <a:t>An enrolled member’s agent contributes from its own isolated execution environment.</a:t>
+              <a:t>Target: an enrolled member’s agent contributes from its own isolated execution environment.</a:t>
             </a:r>
           </a:p>
         </p:txBody>
@@ -8169,6 +8346,7 @@
           </a:lstStyle>
           <a:p xmlns:a="http://schemas.openxmlformats.org/drawingml/2006/main">
             <a:pPr>
+              <a:buNone/>
               <a:defRPr sz="1275" b="0">
                 <a:solidFill>
                   <a:srgbClr val="49616A"/>
@@ -8187,7 +8365,7 @@
                 <a:ea typeface="Aptos"/>
                 <a:cs typeface="Aptos"/>
               </a:rPr>
-              <a:t>INERTIA-2026-10-23-r8 · 23 October 2026 · Autonomous build</a:t>
+              <a:t>INERTIA-2026-10-23-r9 · 23 October 2026 · Autonomous build</a:t>
             </a:r>
           </a:p>
         </p:txBody>
@@ -8236,6 +8414,7 @@
           </a:lstStyle>
           <a:p xmlns:a="http://schemas.openxmlformats.org/drawingml/2006/main">
             <a:pPr>
+              <a:buNone/>
               <a:defRPr sz="1800" b="1">
                 <a:solidFill>
                   <a:srgbClr val="157D80"/>
@@ -8336,6 +8515,7 @@
           </a:lstStyle>
           <a:p xmlns:a="http://schemas.openxmlformats.org/drawingml/2006/main">
             <a:pPr>
+              <a:buNone/>
               <a:defRPr sz="1875" b="1">
                 <a:solidFill>
                   <a:srgbClr val="157D80"/>
@@ -8403,6 +8583,7 @@
           </a:lstStyle>
           <a:p xmlns:a="http://schemas.openxmlformats.org/drawingml/2006/main">
             <a:pPr>
+              <a:buNone/>
               <a:defRPr sz="2250" b="0">
                 <a:solidFill>
                   <a:srgbClr val="49616A"/>
@@ -8421,11 +8602,12 @@
                 <a:ea typeface="Aptos"/>
                 <a:cs typeface="Aptos"/>
               </a:rPr>
-              <a:t>Native CEO delegates work</a:t>
-            </a:r>
-          </a:p>
-          <a:p xmlns:a="http://schemas.openxmlformats.org/drawingml/2006/main">
-            <a:pPr>
+              <a:t>Assigned CEO intake mandate</a:t>
+            </a:r>
+          </a:p>
+          <a:p xmlns:a="http://schemas.openxmlformats.org/drawingml/2006/main">
+            <a:pPr>
+              <a:buNone/>
               <a:defRPr sz="2250" b="0">
                 <a:solidFill>
                   <a:srgbClr val="49616A"/>
@@ -8444,11 +8626,12 @@
                 <a:ea typeface="Aptos"/>
                 <a:cs typeface="Aptos"/>
               </a:rPr>
-              <a:t>Agent selects eligible tasks</a:t>
-            </a:r>
-          </a:p>
-          <a:p xmlns:a="http://schemas.openxmlformats.org/drawingml/2006/main">
-            <a:pPr>
+              <a:t>Scoped eligible work</a:t>
+            </a:r>
+          </a:p>
+          <a:p xmlns:a="http://schemas.openxmlformats.org/drawingml/2006/main">
+            <a:pPr>
+              <a:buNone/>
               <a:defRPr sz="2250" b="0">
                 <a:solidFill>
                   <a:srgbClr val="49616A"/>
@@ -8472,6 +8655,7 @@
           </a:p>
           <a:p xmlns:a="http://schemas.openxmlformats.org/drawingml/2006/main">
             <a:pPr>
+              <a:buNone/>
               <a:defRPr sz="2250" b="0">
                 <a:solidFill>
                   <a:srgbClr val="49616A"/>
@@ -8572,6 +8756,7 @@
           </a:lstStyle>
           <a:p xmlns:a="http://schemas.openxmlformats.org/drawingml/2006/main">
             <a:pPr>
+              <a:buNone/>
               <a:defRPr sz="1875" b="1">
                 <a:solidFill>
                   <a:srgbClr val="157D80"/>
@@ -8639,6 +8824,7 @@
           </a:lstStyle>
           <a:p xmlns:a="http://schemas.openxmlformats.org/drawingml/2006/main">
             <a:pPr>
+              <a:buNone/>
               <a:defRPr sz="2250" b="0">
                 <a:solidFill>
                   <a:srgbClr val="49616A"/>
@@ -8662,6 +8848,7 @@
           </a:p>
           <a:p xmlns:a="http://schemas.openxmlformats.org/drawingml/2006/main">
             <a:pPr>
+              <a:buNone/>
               <a:defRPr sz="2250" b="0">
                 <a:solidFill>
                   <a:srgbClr val="49616A"/>
@@ -8680,11 +8867,12 @@
                 <a:ea typeface="Aptos"/>
                 <a:cs typeface="Aptos"/>
               </a:rPr>
-              <a:t>Sandbox and isolated worktree</a:t>
-            </a:r>
-          </a:p>
-          <a:p xmlns:a="http://schemas.openxmlformats.org/drawingml/2006/main">
-            <a:pPr>
+              <a:t>Sandbox and isolated files</a:t>
+            </a:r>
+          </a:p>
+          <a:p xmlns:a="http://schemas.openxmlformats.org/drawingml/2006/main">
+            <a:pPr>
+              <a:buNone/>
               <a:defRPr sz="2250" b="0">
                 <a:solidFill>
                   <a:srgbClr val="49616A"/>
@@ -8708,6 +8896,7 @@
           </a:p>
           <a:p xmlns:a="http://schemas.openxmlformats.org/drawingml/2006/main">
             <a:pPr>
+              <a:buNone/>
               <a:defRPr sz="2250" b="0">
                 <a:solidFill>
                   <a:srgbClr val="49616A"/>
@@ -8726,7 +8915,7 @@
                 <a:ea typeface="Aptos"/>
                 <a:cs typeface="Aptos"/>
               </a:rPr>
-              <a:t>No shared publisher credentials</a:t>
+              <a:t>No publisher credentials</a:t>
             </a:r>
           </a:p>
         </p:txBody>
@@ -8808,6 +8997,7 @@
           </a:lstStyle>
           <a:p xmlns:a="http://schemas.openxmlformats.org/drawingml/2006/main">
             <a:pPr>
+              <a:buNone/>
               <a:defRPr sz="1875" b="1">
                 <a:solidFill>
                   <a:srgbClr val="157D80"/>
@@ -8875,6 +9065,7 @@
           </a:lstStyle>
           <a:p xmlns:a="http://schemas.openxmlformats.org/drawingml/2006/main">
             <a:pPr>
+              <a:buNone/>
               <a:defRPr sz="2250" b="0">
                 <a:solidFill>
                   <a:srgbClr val="49616A"/>
@@ -8898,6 +9089,7 @@
           </a:p>
           <a:p xmlns:a="http://schemas.openxmlformats.org/drawingml/2006/main">
             <a:pPr>
+              <a:buNone/>
               <a:defRPr sz="2250" b="0">
                 <a:solidFill>
                   <a:srgbClr val="49616A"/>
@@ -8921,6 +9113,7 @@
           </a:p>
           <a:p xmlns:a="http://schemas.openxmlformats.org/drawingml/2006/main">
             <a:pPr>
+              <a:buNone/>
               <a:defRPr sz="2250" b="0">
                 <a:solidFill>
                   <a:srgbClr val="49616A"/>
@@ -8944,6 +9137,7 @@
           </a:p>
           <a:p xmlns:a="http://schemas.openxmlformats.org/drawingml/2006/main">
             <a:pPr>
+              <a:buNone/>
               <a:defRPr sz="2250" b="0">
                 <a:solidFill>
                   <a:srgbClr val="49616A"/>
@@ -9011,6 +9205,7 @@
           </a:lstStyle>
           <a:p xmlns:a="http://schemas.openxmlformats.org/drawingml/2006/main">
             <a:pPr>
+              <a:buNone/>
               <a:defRPr sz="2100" b="0">
                 <a:solidFill>
                   <a:srgbClr val="132E38"/>
@@ -9107,6 +9302,7 @@
           </a:lstStyle>
           <a:p xmlns:a="http://schemas.openxmlformats.org/drawingml/2006/main">
             <a:pPr>
+              <a:buNone/>
               <a:defRPr sz="1350" b="1">
                 <a:solidFill>
                   <a:srgbClr val="157D80"/>
@@ -9174,6 +9370,7 @@
           </a:lstStyle>
           <a:p xmlns:a="http://schemas.openxmlformats.org/drawingml/2006/main">
             <a:pPr>
+              <a:buNone/>
               <a:defRPr sz="3450" b="1">
                 <a:solidFill>
                   <a:srgbClr val="132E38"/>
@@ -9241,6 +9438,7 @@
           </a:lstStyle>
           <a:p xmlns:a="http://schemas.openxmlformats.org/drawingml/2006/main">
             <a:pPr>
+              <a:buNone/>
               <a:defRPr sz="1800" b="0">
                 <a:solidFill>
                   <a:srgbClr val="49616A"/>
@@ -9339,6 +9537,7 @@
           </a:lstStyle>
           <a:p xmlns:a="http://schemas.openxmlformats.org/drawingml/2006/main">
             <a:pPr>
+              <a:buNone/>
               <a:defRPr sz="1275" b="0">
                 <a:solidFill>
                   <a:srgbClr val="49616A"/>
@@ -9357,7 +9556,7 @@
                 <a:ea typeface="Aptos"/>
                 <a:cs typeface="Aptos"/>
               </a:rPr>
-              <a:t>INERTIA-2026-10-23-r8 · 23 October 2026 · Autonomous build</a:t>
+              <a:t>INERTIA-2026-10-23-r9 · 23 October 2026 · Autonomous build</a:t>
             </a:r>
           </a:p>
         </p:txBody>
@@ -9406,6 +9605,7 @@
           </a:lstStyle>
           <a:p xmlns:a="http://schemas.openxmlformats.org/drawingml/2006/main">
             <a:pPr>
+              <a:buNone/>
               <a:defRPr sz="1800" b="1">
                 <a:solidFill>
                   <a:srgbClr val="157D80"/>
@@ -9506,6 +9706,7 @@
           </a:lstStyle>
           <a:p xmlns:a="http://schemas.openxmlformats.org/drawingml/2006/main">
             <a:pPr>
+              <a:buNone/>
               <a:defRPr sz="1875" b="1">
                 <a:solidFill>
                   <a:srgbClr val="157D80"/>
@@ -9573,6 +9774,7 @@
           </a:lstStyle>
           <a:p xmlns:a="http://schemas.openxmlformats.org/drawingml/2006/main">
             <a:pPr>
+              <a:buNone/>
               <a:defRPr sz="2250" b="0">
                 <a:solidFill>
                   <a:srgbClr val="49616A"/>
@@ -9591,11 +9793,12 @@
                 <a:ea typeface="Aptos"/>
                 <a:cs typeface="Aptos"/>
               </a:rPr>
-              <a:t>Install verified archive</a:t>
-            </a:r>
-          </a:p>
-          <a:p xmlns:a="http://schemas.openxmlformats.org/drawingml/2006/main">
-            <a:pPr>
+              <a:t>Private authenticated host</a:t>
+            </a:r>
+          </a:p>
+          <a:p xmlns:a="http://schemas.openxmlformats.org/drawingml/2006/main">
+            <a:pPr>
+              <a:buNone/>
               <a:defRPr sz="2250" b="0">
                 <a:solidFill>
                   <a:srgbClr val="49616A"/>
@@ -9614,11 +9817,12 @@
                 <a:ea typeface="Aptos"/>
                 <a:cs typeface="Aptos"/>
               </a:rPr>
-              <a:t>Use Node 24.11 or newer</a:t>
-            </a:r>
-          </a:p>
-          <a:p xmlns:a="http://schemas.openxmlformats.org/drawingml/2006/main">
-            <a:pPr>
+              <a:t>Durable database and backups</a:t>
+            </a:r>
+          </a:p>
+          <a:p xmlns:a="http://schemas.openxmlformats.org/drawingml/2006/main">
+            <a:pPr>
+              <a:buNone/>
               <a:defRPr sz="2250" b="0">
                 <a:solidFill>
                   <a:srgbClr val="49616A"/>
@@ -9637,11 +9841,12 @@
                 <a:ea typeface="Aptos"/>
                 <a:cs typeface="Aptos"/>
               </a:rPr>
-              <a:t>Fill disabled configuration</a:t>
-            </a:r>
-          </a:p>
-          <a:p xmlns:a="http://schemas.openxmlformats.org/drawingml/2006/main">
-            <a:pPr>
+              <a:t>Approved relay and pairing</a:t>
+            </a:r>
+          </a:p>
+          <a:p xmlns:a="http://schemas.openxmlformats.org/drawingml/2006/main">
+            <a:pPr>
+              <a:buNone/>
               <a:defRPr sz="2250" b="0">
                 <a:solidFill>
                   <a:srgbClr val="49616A"/>
@@ -9660,7 +9865,7 @@
                 <a:ea typeface="Aptos"/>
                 <a:cs typeface="Aptos"/>
               </a:rPr>
-              <a:t>Validate, pair and enable</a:t>
+              <a:t>Validate while disabled</a:t>
             </a:r>
           </a:p>
         </p:txBody>
@@ -9742,6 +9947,7 @@
           </a:lstStyle>
           <a:p xmlns:a="http://schemas.openxmlformats.org/drawingml/2006/main">
             <a:pPr>
+              <a:buNone/>
               <a:defRPr sz="1875" b="1">
                 <a:solidFill>
                   <a:srgbClr val="157D80"/>
@@ -9809,6 +10015,7 @@
           </a:lstStyle>
           <a:p xmlns:a="http://schemas.openxmlformats.org/drawingml/2006/main">
             <a:pPr>
+              <a:buNone/>
               <a:defRPr sz="2250" b="0">
                 <a:solidFill>
                   <a:srgbClr val="49616A"/>
@@ -9832,6 +10039,7 @@
           </a:p>
           <a:p xmlns:a="http://schemas.openxmlformats.org/drawingml/2006/main">
             <a:pPr>
+              <a:buNone/>
               <a:defRPr sz="2250" b="0">
                 <a:solidFill>
                   <a:srgbClr val="49616A"/>
@@ -9855,6 +10063,7 @@
           </a:p>
           <a:p xmlns:a="http://schemas.openxmlformats.org/drawingml/2006/main">
             <a:pPr>
+              <a:buNone/>
               <a:defRPr sz="2250" b="0">
                 <a:solidFill>
                   <a:srgbClr val="49616A"/>
@@ -9878,6 +10087,7 @@
           </a:p>
           <a:p xmlns:a="http://schemas.openxmlformats.org/drawingml/2006/main">
             <a:pPr>
+              <a:buNone/>
               <a:defRPr sz="2250" b="0">
                 <a:solidFill>
                   <a:srgbClr val="49616A"/>
@@ -9978,6 +10188,7 @@
           </a:lstStyle>
           <a:p xmlns:a="http://schemas.openxmlformats.org/drawingml/2006/main">
             <a:pPr>
+              <a:buNone/>
               <a:defRPr sz="1875" b="1">
                 <a:solidFill>
                   <a:srgbClr val="157D80"/>
@@ -10045,6 +10256,7 @@
           </a:lstStyle>
           <a:p xmlns:a="http://schemas.openxmlformats.org/drawingml/2006/main">
             <a:pPr>
+              <a:buNone/>
               <a:defRPr sz="2250" b="0">
                 <a:solidFill>
                   <a:srgbClr val="49616A"/>
@@ -10068,6 +10280,7 @@
           </a:p>
           <a:p xmlns:a="http://schemas.openxmlformats.org/drawingml/2006/main">
             <a:pPr>
+              <a:buNone/>
               <a:defRPr sz="2250" b="0">
                 <a:solidFill>
                   <a:srgbClr val="49616A"/>
@@ -10091,6 +10304,7 @@
           </a:p>
           <a:p xmlns:a="http://schemas.openxmlformats.org/drawingml/2006/main">
             <a:pPr>
+              <a:buNone/>
               <a:defRPr sz="2250" b="0">
                 <a:solidFill>
                   <a:srgbClr val="49616A"/>
@@ -10114,6 +10328,7 @@
           </a:p>
           <a:p xmlns:a="http://schemas.openxmlformats.org/drawingml/2006/main">
             <a:pPr>
+              <a:buNone/>
               <a:defRPr sz="2250" b="0">
                 <a:solidFill>
                   <a:srgbClr val="49616A"/>
@@ -10181,6 +10396,7 @@
           </a:lstStyle>
           <a:p xmlns:a="http://schemas.openxmlformats.org/drawingml/2006/main">
             <a:pPr>
+              <a:buNone/>
               <a:defRPr sz="2100" b="0">
                 <a:solidFill>
                   <a:srgbClr val="132E38"/>
@@ -10199,7 +10415,7 @@
                 <a:ea typeface="Aptos"/>
                 <a:cs typeface="Aptos"/>
               </a:rPr>
-              <a:t>Source text cannot grant authority. Current host permissions govern every human-attributed native action.</a:t>
+              <a:t>Native comments stay default-off, audience-approved and history-bounded. Uncertain claims need stopped-worker recovery.</a:t>
             </a:r>
           </a:p>
         </p:txBody>
@@ -10277,6 +10493,7 @@
           </a:lstStyle>
           <a:p xmlns:a="http://schemas.openxmlformats.org/drawingml/2006/main">
             <a:pPr>
+              <a:buNone/>
               <a:defRPr sz="1350" b="1">
                 <a:solidFill>
                   <a:srgbClr val="157D80"/>
@@ -10344,6 +10561,7 @@
           </a:lstStyle>
           <a:p xmlns:a="http://schemas.openxmlformats.org/drawingml/2006/main">
             <a:pPr>
+              <a:buNone/>
               <a:defRPr sz="3450" b="1">
                 <a:solidFill>
                   <a:srgbClr val="132E38"/>
@@ -10411,6 +10629,7 @@
           </a:lstStyle>
           <a:p xmlns:a="http://schemas.openxmlformats.org/drawingml/2006/main">
             <a:pPr>
+              <a:buNone/>
               <a:defRPr sz="1800" b="0">
                 <a:solidFill>
                   <a:srgbClr val="49616A"/>
@@ -10429,7 +10648,7 @@
                 <a:ea typeface="Aptos"/>
                 <a:cs typeface="Aptos"/>
               </a:rPr>
-              <a:t>A reproducible source-checkout rehearsal joins the meeting, signed bridge and grant cores.</a:t>
+              <a:t>PR 17 is merged into develop. The exact runtime archive passed native-service qualification.</a:t>
             </a:r>
           </a:p>
         </p:txBody>
@@ -10509,6 +10728,7 @@
           </a:lstStyle>
           <a:p xmlns:a="http://schemas.openxmlformats.org/drawingml/2006/main">
             <a:pPr>
+              <a:buNone/>
               <a:defRPr sz="1275" b="0">
                 <a:solidFill>
                   <a:srgbClr val="49616A"/>
@@ -10527,7 +10747,7 @@
                 <a:ea typeface="Aptos"/>
                 <a:cs typeface="Aptos"/>
               </a:rPr>
-              <a:t>INERTIA-2026-10-23-r8 · 23 October 2026 · Autonomous build</a:t>
+              <a:t>INERTIA-2026-10-23-r9 · 23 October 2026 · Autonomous build</a:t>
             </a:r>
           </a:p>
         </p:txBody>
@@ -10576,6 +10796,7 @@
           </a:lstStyle>
           <a:p xmlns:a="http://schemas.openxmlformats.org/drawingml/2006/main">
             <a:pPr>
+              <a:buNone/>
               <a:defRPr sz="1800" b="1">
                 <a:solidFill>
                   <a:srgbClr val="157D80"/>
@@ -10676,6 +10897,7 @@
           </a:lstStyle>
           <a:p xmlns:a="http://schemas.openxmlformats.org/drawingml/2006/main">
             <a:pPr>
+              <a:buNone/>
               <a:defRPr sz="1875" b="1">
                 <a:solidFill>
                   <a:srgbClr val="157D80"/>
@@ -10694,7 +10916,7 @@
                 <a:ea typeface="Aptos"/>
                 <a:cs typeface="Aptos"/>
               </a:rPr>
-              <a:t>Merged foundation</a:t>
+              <a:t>Reviewed foundation</a:t>
             </a:r>
           </a:p>
         </p:txBody>
@@ -10743,6 +10965,7 @@
           </a:lstStyle>
           <a:p xmlns:a="http://schemas.openxmlformats.org/drawingml/2006/main">
             <a:pPr>
+              <a:buNone/>
               <a:defRPr sz="2250" b="0">
                 <a:solidFill>
                   <a:srgbClr val="49616A"/>
@@ -10766,6 +10989,7 @@
           </a:p>
           <a:p xmlns:a="http://schemas.openxmlformats.org/drawingml/2006/main">
             <a:pPr>
+              <a:buNone/>
               <a:defRPr sz="2250" b="0">
                 <a:solidFill>
                   <a:srgbClr val="49616A"/>
@@ -10784,11 +11008,12 @@
                 <a:ea typeface="Aptos"/>
                 <a:cs typeface="Aptos"/>
               </a:rPr>
-              <a:t>Connected bridge: 85 tests</a:t>
-            </a:r>
-          </a:p>
-          <a:p xmlns:a="http://schemas.openxmlformats.org/drawingml/2006/main">
-            <a:pPr>
+              <a:t>Roundtable source/hash core</a:t>
+            </a:r>
+          </a:p>
+          <a:p xmlns:a="http://schemas.openxmlformats.org/drawingml/2006/main">
+            <a:pPr>
+              <a:buNone/>
               <a:defRPr sz="2250" b="0">
                 <a:solidFill>
                   <a:srgbClr val="49616A"/>
@@ -10807,11 +11032,12 @@
                 <a:ea typeface="Aptos"/>
                 <a:cs typeface="Aptos"/>
               </a:rPr>
-              <a:t>Roundtable core: 23 tests</a:t>
-            </a:r>
-          </a:p>
-          <a:p xmlns:a="http://schemas.openxmlformats.org/drawingml/2006/main">
-            <a:pPr>
+              <a:t>Website caller contract-tested</a:t>
+            </a:r>
+          </a:p>
+          <a:p xmlns:a="http://schemas.openxmlformats.org/drawingml/2006/main">
+            <a:pPr>
+              <a:buNone/>
               <a:defRPr sz="2250" b="0">
                 <a:solidFill>
                   <a:srgbClr val="49616A"/>
@@ -10830,7 +11056,7 @@
                 <a:ea typeface="Aptos"/>
                 <a:cs typeface="Aptos"/>
               </a:rPr>
-              <a:t>Actual website publisher pending</a:t>
+              <a:t>Server and live wiring pending</a:t>
             </a:r>
           </a:p>
         </p:txBody>
@@ -10912,6 +11138,7 @@
           </a:lstStyle>
           <a:p xmlns:a="http://schemas.openxmlformats.org/drawingml/2006/main">
             <a:pPr>
+              <a:buNone/>
               <a:defRPr sz="1875" b="1">
                 <a:solidFill>
                   <a:srgbClr val="157D80"/>
@@ -10930,7 +11157,7 @@
                 <a:ea typeface="Aptos"/>
                 <a:cs typeface="Aptos"/>
               </a:rPr>
-              <a:t>Grant packet binding</a:t>
+              <a:t>Grant and DAO evidence</a:t>
             </a:r>
           </a:p>
         </p:txBody>
@@ -10979,6 +11206,7 @@
           </a:lstStyle>
           <a:p xmlns:a="http://schemas.openxmlformats.org/drawingml/2006/main">
             <a:pPr>
+              <a:buNone/>
               <a:defRPr sz="2250" b="0">
                 <a:solidFill>
                   <a:srgbClr val="49616A"/>
@@ -10997,11 +11225,12 @@
                 <a:ea typeface="Aptos"/>
                 <a:cs typeface="Aptos"/>
               </a:rPr>
-              <a:t>PR 7 grant core: 37 tests</a:t>
-            </a:r>
-          </a:p>
-          <a:p xmlns:a="http://schemas.openxmlformats.org/drawingml/2006/main">
-            <a:pPr>
+              <a:t>Packet, review and vote binding</a:t>
+            </a:r>
+          </a:p>
+          <a:p xmlns:a="http://schemas.openxmlformats.org/drawingml/2006/main">
+            <a:pPr>
+              <a:buNone/>
               <a:defRPr sz="2250" b="0">
                 <a:solidFill>
                   <a:srgbClr val="49616A"/>
@@ -11020,11 +11249,12 @@
                 <a:ea typeface="Aptos"/>
                 <a:cs typeface="Aptos"/>
               </a:rPr>
-              <a:t>Packet, review and vote binding</a:t>
-            </a:r>
-          </a:p>
-          <a:p xmlns:a="http://schemas.openxmlformats.org/drawingml/2006/main">
-            <a:pPr>
+              <a:t>Cited public DAO facts</a:t>
+            </a:r>
+          </a:p>
+          <a:p xmlns:a="http://schemas.openxmlformats.org/drawingml/2006/main">
+            <a:pPr>
+              <a:buNone/>
               <a:defRPr sz="2250" b="0">
                 <a:solidFill>
                   <a:srgbClr val="49616A"/>
@@ -11043,11 +11273,12 @@
                 <a:ea typeface="Aptos"/>
                 <a:cs typeface="Aptos"/>
               </a:rPr>
-              <a:t>Source freshness and replay</a:t>
-            </a:r>
-          </a:p>
-          <a:p xmlns:a="http://schemas.openxmlformats.org/drawingml/2006/main">
-            <a:pPr>
+              <a:t>Eligibility remains unverified</a:t>
+            </a:r>
+          </a:p>
+          <a:p xmlns:a="http://schemas.openxmlformats.org/drawingml/2006/main">
+            <a:pPr>
+              <a:buNone/>
               <a:defRPr sz="2250" b="0">
                 <a:solidFill>
                   <a:srgbClr val="49616A"/>
@@ -11066,7 +11297,7 @@
                 <a:ea typeface="Aptos"/>
                 <a:cs typeface="Aptos"/>
               </a:rPr>
-              <a:t>Production adapters next</a:t>
+              <a:t>Live governance adapter pending</a:t>
             </a:r>
           </a:p>
         </p:txBody>
@@ -11148,6 +11379,7 @@
           </a:lstStyle>
           <a:p xmlns:a="http://schemas.openxmlformats.org/drawingml/2006/main">
             <a:pPr>
+              <a:buNone/>
               <a:defRPr sz="1875" b="1">
                 <a:solidFill>
                   <a:srgbClr val="157D80"/>
@@ -11166,7 +11398,7 @@
                 <a:ea typeface="Aptos"/>
                 <a:cs typeface="Aptos"/>
               </a:rPr>
-              <a:t>Connected walkthrough</a:t>
+              <a:t>Qualification boundary</a:t>
             </a:r>
           </a:p>
         </p:txBody>
@@ -11215,6 +11447,7 @@
           </a:lstStyle>
           <a:p xmlns:a="http://schemas.openxmlformats.org/drawingml/2006/main">
             <a:pPr>
+              <a:buNone/>
               <a:defRPr sz="2250" b="0">
                 <a:solidFill>
                   <a:srgbClr val="49616A"/>
@@ -11233,11 +11466,12 @@
                 <a:ea typeface="Aptos"/>
                 <a:cs typeface="Aptos"/>
               </a:rPr>
-              <a:t>152 tests and five demos pass</a:t>
-            </a:r>
-          </a:p>
-          <a:p xmlns:a="http://schemas.openxmlformats.org/drawingml/2006/main">
-            <a:pPr>
+              <a:t>248 combined tests pass</a:t>
+            </a:r>
+          </a:p>
+          <a:p xmlns:a="http://schemas.openxmlformats.org/drawingml/2006/main">
+            <a:pPr>
+              <a:buNone/>
               <a:defRPr sz="2250" b="0">
                 <a:solidFill>
                   <a:srgbClr val="49616A"/>
@@ -11256,11 +11490,12 @@
                 <a:ea typeface="Aptos"/>
                 <a:cs typeface="Aptos"/>
               </a:rPr>
-              <a:t>One connected workflow command</a:t>
-            </a:r>
-          </a:p>
-          <a:p xmlns:a="http://schemas.openxmlformats.org/drawingml/2006/main">
-            <a:pPr>
+              <a:t>6 migrations, 3 native jobs</a:t>
+            </a:r>
+          </a:p>
+          <a:p xmlns:a="http://schemas.openxmlformats.org/drawingml/2006/main">
+            <a:pPr>
+              <a:buNone/>
               <a:defRPr sz="2250" b="0">
                 <a:solidFill>
                   <a:srgbClr val="49616A"/>
@@ -11279,11 +11514,12 @@
                 <a:ea typeface="Aptos"/>
                 <a:cs typeface="Aptos"/>
               </a:rPr>
-              <a:t>Deterministic journey receipt</a:t>
-            </a:r>
-          </a:p>
-          <a:p xmlns:a="http://schemas.openxmlformats.org/drawingml/2006/main">
-            <a:pPr>
+              <a:t>Exact artifact native pass</a:t>
+            </a:r>
+          </a:p>
+          <a:p xmlns:a="http://schemas.openxmlformats.org/drawingml/2006/main">
+            <a:pPr>
+              <a:buNone/>
               <a:defRPr sz="2250" b="0">
                 <a:solidFill>
                   <a:srgbClr val="49616A"/>
@@ -11302,7 +11538,7 @@
                 <a:ea typeface="Aptos"/>
                 <a:cs typeface="Aptos"/>
               </a:rPr>
-              <a:t>Native services and HTTP verified</a:t>
+              <a:t>Full HTTP check historical</a:t>
             </a:r>
           </a:p>
         </p:txBody>
@@ -11351,6 +11587,7 @@
           </a:lstStyle>
           <a:p xmlns:a="http://schemas.openxmlformats.org/drawingml/2006/main">
             <a:pPr>
+              <a:buNone/>
               <a:defRPr sz="2100" b="0">
                 <a:solidFill>
                   <a:srgbClr val="132E38"/>
@@ -11369,7 +11606,7 @@
                 <a:ea typeface="Aptos"/>
                 <a:cs typeface="Aptos"/>
               </a:rPr>
-              <a:t>Native services and isolated Docker HTTP/API checks passed. External integrations and live deployment remain pending.</a:t>
+              <a:t>Merge is complete; live setup remains pending. CEO intake needs an assigned mandate. Status mirroring remains future.</a:t>
             </a:r>
           </a:p>
         </p:txBody>
@@ -11447,6 +11684,7 @@
           </a:lstStyle>
           <a:p xmlns:a="http://schemas.openxmlformats.org/drawingml/2006/main">
             <a:pPr>
+              <a:buNone/>
               <a:defRPr sz="1350" b="1">
                 <a:solidFill>
                   <a:srgbClr val="157D80"/>
@@ -11514,6 +11752,7 @@
           </a:lstStyle>
           <a:p xmlns:a="http://schemas.openxmlformats.org/drawingml/2006/main">
             <a:pPr>
+              <a:buNone/>
               <a:defRPr sz="3450" b="1">
                 <a:solidFill>
                   <a:srgbClr val="132E38"/>
@@ -11581,6 +11820,7 @@
           </a:lstStyle>
           <a:p xmlns:a="http://schemas.openxmlformats.org/drawingml/2006/main">
             <a:pPr>
+              <a:buNone/>
               <a:defRPr sz="1800" b="0">
                 <a:solidFill>
                   <a:srgbClr val="49616A"/>
@@ -11679,6 +11919,7 @@
           </a:lstStyle>
           <a:p xmlns:a="http://schemas.openxmlformats.org/drawingml/2006/main">
             <a:pPr>
+              <a:buNone/>
               <a:defRPr sz="1275" b="0">
                 <a:solidFill>
                   <a:srgbClr val="49616A"/>
@@ -11697,7 +11938,7 @@
                 <a:ea typeface="Aptos"/>
                 <a:cs typeface="Aptos"/>
               </a:rPr>
-              <a:t>INERTIA-2026-10-23-r8 · 23 October 2026 · Autonomous build</a:t>
+              <a:t>INERTIA-2026-10-23-r9 · 23 October 2026 · Autonomous build</a:t>
             </a:r>
           </a:p>
         </p:txBody>
@@ -11746,6 +11987,7 @@
           </a:lstStyle>
           <a:p xmlns:a="http://schemas.openxmlformats.org/drawingml/2006/main">
             <a:pPr>
+              <a:buNone/>
               <a:defRPr sz="1800" b="1">
                 <a:solidFill>
                   <a:srgbClr val="157D80"/>
@@ -11846,6 +12088,7 @@
           </a:lstStyle>
           <a:p xmlns:a="http://schemas.openxmlformats.org/drawingml/2006/main">
             <a:pPr>
+              <a:buNone/>
               <a:defRPr sz="1875" b="1">
                 <a:solidFill>
                   <a:srgbClr val="157D80"/>
@@ -11913,6 +12156,7 @@
           </a:lstStyle>
           <a:p xmlns:a="http://schemas.openxmlformats.org/drawingml/2006/main">
             <a:pPr>
+              <a:buNone/>
               <a:defRPr sz="2250" b="0">
                 <a:solidFill>
                   <a:srgbClr val="49616A"/>
@@ -11931,11 +12175,12 @@
                 <a:ea typeface="Aptos"/>
                 <a:cs typeface="Aptos"/>
               </a:rPr>
-              <a:t>Bridge and domain cores merged</a:t>
-            </a:r>
-          </a:p>
-          <a:p xmlns:a="http://schemas.openxmlformats.org/drawingml/2006/main">
-            <a:pPr>
+              <a:t>Website caller merged</a:t>
+            </a:r>
+          </a:p>
+          <a:p xmlns:a="http://schemas.openxmlformats.org/drawingml/2006/main">
+            <a:pPr>
+              <a:buNone/>
               <a:defRPr sz="2250" b="0">
                 <a:solidFill>
                   <a:srgbClr val="49616A"/>
@@ -11954,11 +12199,12 @@
                 <a:ea typeface="Aptos"/>
                 <a:cs typeface="Aptos"/>
               </a:rPr>
-              <a:t>Plugin archive qualified</a:t>
-            </a:r>
-          </a:p>
-          <a:p xmlns:a="http://schemas.openxmlformats.org/drawingml/2006/main">
-            <a:pPr>
+              <a:t>CEO checklist merged</a:t>
+            </a:r>
+          </a:p>
+          <a:p xmlns:a="http://schemas.openxmlformats.org/drawingml/2006/main">
+            <a:pPr>
+              <a:buNone/>
               <a:defRPr sz="2250" b="0">
                 <a:solidFill>
                   <a:srgbClr val="49616A"/>
@@ -11977,11 +12223,12 @@
                 <a:ea typeface="Aptos"/>
                 <a:cs typeface="Aptos"/>
               </a:rPr>
-              <a:t>Website publisher pending</a:t>
-            </a:r>
-          </a:p>
-          <a:p xmlns:a="http://schemas.openxmlformats.org/drawingml/2006/main">
-            <a:pPr>
+              <a:t>Native comments merged</a:t>
+            </a:r>
+          </a:p>
+          <a:p xmlns:a="http://schemas.openxmlformats.org/drawingml/2006/main">
+            <a:pPr>
+              <a:buNone/>
               <a:defRPr sz="2250" b="0">
                 <a:solidFill>
                   <a:srgbClr val="49616A"/>
@@ -12000,7 +12247,7 @@
                 <a:ea typeface="Aptos"/>
                 <a:cs typeface="Aptos"/>
               </a:rPr>
-              <a:t>Keep artifacts aligned</a:t>
+              <a:t>Live setup remains pending</a:t>
             </a:r>
           </a:p>
         </p:txBody>
@@ -12082,6 +12329,7 @@
           </a:lstStyle>
           <a:p xmlns:a="http://schemas.openxmlformats.org/drawingml/2006/main">
             <a:pPr>
+              <a:buNone/>
               <a:defRPr sz="1875" b="1">
                 <a:solidFill>
                   <a:srgbClr val="157D80"/>
@@ -12149,6 +12397,7 @@
           </a:lstStyle>
           <a:p xmlns:a="http://schemas.openxmlformats.org/drawingml/2006/main">
             <a:pPr>
+              <a:buNone/>
               <a:defRPr sz="2250" b="0">
                 <a:solidFill>
                   <a:srgbClr val="49616A"/>
@@ -12167,11 +12416,12 @@
                 <a:ea typeface="Aptos"/>
                 <a:cs typeface="Aptos"/>
               </a:rPr>
-              <a:t>Complete domain adapters</a:t>
-            </a:r>
-          </a:p>
-          <a:p xmlns:a="http://schemas.openxmlformats.org/drawingml/2006/main">
-            <a:pPr>
+              <a:t>Finish live adapters</a:t>
+            </a:r>
+          </a:p>
+          <a:p xmlns:a="http://schemas.openxmlformats.org/drawingml/2006/main">
+            <a:pPr>
+              <a:buNone/>
               <a:defRPr sz="2250" b="0">
                 <a:solidFill>
                   <a:srgbClr val="49616A"/>
@@ -12195,6 +12445,7 @@
           </a:p>
           <a:p xmlns:a="http://schemas.openxmlformats.org/drawingml/2006/main">
             <a:pPr>
+              <a:buNone/>
               <a:defRPr sz="2250" b="0">
                 <a:solidFill>
                   <a:srgbClr val="49616A"/>
@@ -12213,11 +12464,12 @@
                 <a:ea typeface="Aptos"/>
                 <a:cs typeface="Aptos"/>
               </a:rPr>
-              <a:t>Exercise member contribution</a:t>
-            </a:r>
-          </a:p>
-          <a:p xmlns:a="http://schemas.openxmlformats.org/drawingml/2006/main">
-            <a:pPr>
+              <a:t>Test member contribution</a:t>
+            </a:r>
+          </a:p>
+          <a:p xmlns:a="http://schemas.openxmlformats.org/drawingml/2006/main">
+            <a:pPr>
+              <a:buNone/>
               <a:defRPr sz="2250" b="0">
                 <a:solidFill>
                   <a:srgbClr val="49616A"/>
@@ -12236,7 +12488,7 @@
                 <a:ea typeface="Aptos"/>
                 <a:cs typeface="Aptos"/>
               </a:rPr>
-              <a:t>Test backup-based recovery</a:t>
+              <a:t>Test backup recovery</a:t>
             </a:r>
           </a:p>
         </p:txBody>
@@ -12318,6 +12570,7 @@
           </a:lstStyle>
           <a:p xmlns:a="http://schemas.openxmlformats.org/drawingml/2006/main">
             <a:pPr>
+              <a:buNone/>
               <a:defRPr sz="1875" b="1">
                 <a:solidFill>
                   <a:srgbClr val="157D80"/>
@@ -12385,6 +12638,7 @@
           </a:lstStyle>
           <a:p xmlns:a="http://schemas.openxmlformats.org/drawingml/2006/main">
             <a:pPr>
+              <a:buNone/>
               <a:defRPr sz="2250" b="0">
                 <a:solidFill>
                   <a:srgbClr val="49616A"/>
@@ -12403,11 +12657,12 @@
                 <a:ea typeface="Aptos"/>
                 <a:cs typeface="Aptos"/>
               </a:rPr>
-              <a:t>Recovery and isolation tests</a:t>
-            </a:r>
-          </a:p>
-          <a:p xmlns:a="http://schemas.openxmlformats.org/drawingml/2006/main">
-            <a:pPr>
+              <a:t>Test recovery and isolation</a:t>
+            </a:r>
+          </a:p>
+          <a:p xmlns:a="http://schemas.openxmlformats.org/drawingml/2006/main">
+            <a:pPr>
+              <a:buNone/>
               <a:defRPr sz="2250" b="0">
                 <a:solidFill>
                   <a:srgbClr val="49616A"/>
@@ -12431,6 +12686,7 @@
           </a:p>
           <a:p xmlns:a="http://schemas.openxmlformats.org/drawingml/2006/main">
             <a:pPr>
+              <a:buNone/>
               <a:defRPr sz="2250" b="0">
                 <a:solidFill>
                   <a:srgbClr val="49616A"/>
@@ -12454,6 +12710,7 @@
           </a:p>
           <a:p xmlns:a="http://schemas.openxmlformats.org/drawingml/2006/main">
             <a:pPr>
+              <a:buNone/>
               <a:defRPr sz="2250" b="0">
                 <a:solidFill>
                   <a:srgbClr val="49616A"/>
@@ -12521,6 +12778,7 @@
           </a:lstStyle>
           <a:p xmlns:a="http://schemas.openxmlformats.org/drawingml/2006/main">
             <a:pPr>
+              <a:buNone/>
               <a:defRPr sz="2100" b="0">
                 <a:solidFill>
                   <a:srgbClr val="132E38"/>
@@ -12539,7 +12797,7 @@
                 <a:ea typeface="Aptos"/>
                 <a:cs typeface="Aptos"/>
               </a:rPr>
-              <a:t>Cloud-first execution. Laptop fallback only for a specific blocker. Main and the runtime archive stay unchanged.</a:t>
+              <a:t>Cloud-first execution. No live deployment or new credentials in this work. Keep the five artifacts aligned before delivery.</a:t>
             </a:r>
           </a:p>
         </p:txBody>

</xml_diff>

<commit_message>
docs: consolidate DAO PostgreSQL and Helix data architecture (r12)
</commit_message>
<xml_diff>
--- a/Inertia-Architecture.pptx
+++ b/Inertia-Architecture.pptx
@@ -449,7 +449,7 @@
           <a:lstStyle xmlns:a="http://schemas.openxmlformats.org/drawingml/2006/main"/>
           <a:p xmlns:a="http://schemas.openxmlformats.org/drawingml/2006/main">
             <a:r>
-              <a:t>Paperclip owns identity/hierarchy, issues, dependencies, assignment, run admission, checkout, workflow decisions, documents, budgets and audit. Buzz uses the same native IDs via signed transport. Trusted domain adapters hold scoped external-write credentials. Paperclip PostgreSQL stores work state; DAO PlanetScale PostgreSQL and the funding domain store remain their respective sources of record. Native Paperclip agents run the shared grant skills and CLI/MCP using task-scoped data. Funding persistence retains evidence, proposals, immutable packets and review audit. A trusted decision adapter is planned, not a current MCP capability. A specialist funding UI is optional, not an export prerequisite. Cloudflare hosting/access/transport is optional. Live integration acceptance is pending.</a:t>
+              <a:t>Paperclip owns identity/hierarchy, issues, dependencies, assignment, run admission, checkout, workflow decisions, documents, budgets and audit. Buzz uses the same native IDs via signed transport. Trusted domain adapters hold scoped external-write credentials. Paperclip keeps its independent native PostgreSQL database. The target reuses one existing DAO managed PostgreSQL relational database for funding and meeting information alongside organization facts, with isolated domain schemas and least-privilege service roles, subject to provider capability verification. Logical backend ownership does not imply separate database servers. Helix is ultimately a separate, specialized graph/vector projection across funding, 990 and Y2. Projections must be rebuildable, provenance- and version-aware, and access-filtered. Helix is never the authority for facts, transactions, reviews, approvals or governance. Include Helix in a demo only if needed, with no new critical-path dependency. This design update changes no runtime or migrations. Native Paperclip agents run the shared grant skills and CLI/MCP using task-scoped data. Funding persistence retains evidence, proposals, immutable packets and review audit. A trusted decision adapter is planned, not a current MCP capability. A specialist funding UI is optional, not an export prerequisite. Cloudflare hosting/access/transport is optional. Live integration acceptance is pending.</a:t>
             </a:r>
           </a:p>
           <a:p xmlns:a="http://schemas.openxmlformats.org/drawingml/2006/main">
@@ -465,6 +465,11 @@
           <a:p xmlns:a="http://schemas.openxmlformats.org/drawingml/2006/main">
             <a:r>
               <a:t>https://github.com/NetRxn/Inertia/blob/778996e94ce3b79480b5e06a5bb1b6fbe4eb4a60/docs/bridge-state-contract.md</a:t>
+            </a:r>
+          </a:p>
+          <a:p xmlns:a="http://schemas.openxmlformats.org/drawingml/2006/main">
+            <a:r>
+              <a:t>Local r12 storage contract: docs/development/dao-data-consolidation.md</a:t>
             </a:r>
           </a:p>
         </p:txBody>
@@ -642,6 +647,11 @@
               <a:t>https://github.com/NetRxn/Inertia/blob/778996e94ce3b79480b5e06a5bb1b6fbe4eb4a60/docs/integrations/dao-website-publication-v1.1-clarifications.md</a:t>
             </a:r>
           </a:p>
+          <a:p xmlns:a="http://schemas.openxmlformats.org/drawingml/2006/main">
+            <a:r>
+              <a:t>Storage target: meeting records remain behind the DAO website backend and member authorization, persisted in isolated domain schemas in the existing DAO PostgreSQL database shared with funding data. Verify provider support for schema and least-privilege role isolation before rollout. This is logical backend ownership, not a separate physical database requirement. Local r12 source: docs/development/dao-data-consolidation.md.</a:t>
+            </a:r>
+          </a:p>
         </p:txBody>
       </p:sp>
       <p:sp>
@@ -752,6 +762,11 @@
               <a:t>https://github.com/paperclipai/paperclip/blob/bba6a45f0d364cfd962ac59b3bdf2426a8222adb/server/src/services/issue-thread-interaction-resolution.ts</a:t>
             </a:r>
           </a:p>
+          <a:p xmlns:a="http://schemas.openxmlformats.org/drawingml/2006/main">
+            <a:r>
+              <a:t>The funding backend retains evidence, proposals, immutable packets, validation and review audit as logical domain responsibilities. Target placement is an isolated funding schema in the existing DAO PostgreSQL database also used for meetings, behind a least-privilege funding service role. Verify provider capability before rollout. Paperclip remains separate. Helix is a derived access-filtered projection, never a review, approval, transaction or fact authority. No native grant decision adapter, runtime or migration change is implied. Local r12 source: docs/development/dao-data-consolidation.md.</a:t>
+            </a:r>
+          </a:p>
         </p:txBody>
       </p:sp>
       <p:sp>
@@ -1069,7 +1084,7 @@
           <a:lstStyle xmlns:a="http://schemas.openxmlformats.org/drawingml/2006/main"/>
           <a:p xmlns:a="http://schemas.openxmlformats.org/drawingml/2006/main">
             <a:r>
-              <a:t>Live host setup, credentials, authorized relay/company/thread pairing and domain admission remain pending. Grant gates: configure reviewer identities and roles, exercise one real native-card packet with a correction cycle, scope member evidence/tools, implement trusted decision adapter and replay handling. Deny agent approval, wrong addressee, cross-applicant access, stale revisions/artifacts, duplicate application and invalid partner N/A. Require exact-packet governance evidence and no submission side effects. Website server changes are a proposal for owner rollout. Qualify newer Paperclip releases through compatibility, clean package install, native and full-host checks plus backup-based database recovery. Target the latest release that passes qualification. Synthetic workflow rehearsal remains available with npm run demo:workflow. Proposed Oct29 rehearsal buffer precedes Oct30 owner submission handoff. Form990 enrichment is stretch and Helix is deprioritized.</a:t>
+              <a:t>Live host setup, credentials, authorized relay/company/thread pairing and domain admission remain pending. Grant gates: configure reviewer identities and roles, exercise one real native-card packet with a correction cycle, scope member evidence/tools, implement trusted decision adapter and replay handling. Deny agent approval, wrong addressee, cross-applicant access, stale revisions/artifacts, duplicate application and invalid partner N/A. Require exact-packet governance evidence and no submission side effects. Website server changes are a proposal for owner rollout. Qualify newer Paperclip releases through compatibility, clean package install, native and full-host checks plus backup-based database recovery. Target the latest release that passes qualification. Synthetic workflow rehearsal remains available with npm run demo:workflow. Proposed Oct29 rehearsal buffer precedes Oct30 owner submission handoff. Form990 enrichment remains stretch. Helix is the eventual separate graph/vector projection across funding, 990 and Y2. It is optional for the demo only if needed and must not introduce a new critical path. Qualify isolated domain schemas and least-privilege service roles on the existing DAO PostgreSQL provider before the shared funding/meeting placement rolls out. No runtime or migration changes are part of this design revision.</a:t>
             </a:r>
           </a:p>
           <a:p xmlns:a="http://schemas.openxmlformats.org/drawingml/2006/main">
@@ -1090,6 +1105,11 @@
           <a:p xmlns:a="http://schemas.openxmlformats.org/drawingml/2006/main">
             <a:r>
               <a:t>https://github.com/NetRxn/Inertia/blob/778996e94ce3b79480b5e06a5bb1b6fbe4eb4a60/plan.md</a:t>
+            </a:r>
+          </a:p>
+          <a:p xmlns:a="http://schemas.openxmlformats.org/drawingml/2006/main">
+            <a:r>
+              <a:t>Local r12 source: docs/development/dao-data-consolidation.md.</a:t>
             </a:r>
           </a:p>
         </p:txBody>
@@ -3368,23 +3388,26 @@
           <p:cNvPr id="28" name="">
             <a:extLst xmlns:a="http://schemas.openxmlformats.org/drawingml/2006/main">
               <a:ext uri="{FF2B5EF4-FFF2-40B4-BE49-F238E27FC236}">
-                <a16:creationId xmlns:a16="http://schemas.microsoft.com/office/drawing/2014/main" id="{1A0771D5-04A9-4E92-9CFB-0FDDDA889AD2}"/>
+                <a16:creationId xmlns:a16="http://schemas.microsoft.com/office/drawing/2014/main" id="{40A686DD-7253-4C85-B711-E46E1E9716C2}"/>
               </a:ext>
             </a:extLst>
           </p:cNvPr>
           <p:cNvCxnSpPr>
-            <a:stCxn xmlns:a="http://schemas.openxmlformats.org/drawingml/2006/main" id="21" idx="1"/>
-            <a:endCxn xmlns:a="http://schemas.openxmlformats.org/drawingml/2006/main" id="25" idx="3"/>
+            <a:stCxn xmlns:a="http://schemas.openxmlformats.org/drawingml/2006/main" id="12" idx="2"/>
+            <a:endCxn xmlns:a="http://schemas.openxmlformats.org/drawingml/2006/main" id="17" idx="0"/>
           </p:cNvCxnSpPr>
           <p:nvPr/>
         </p:nvCxnSpPr>
         <p:spPr>
           <a:xfrm xmlns:a="http://schemas.openxmlformats.org/drawingml/2006/main" flipH="1">
-            <a:off x="3657600" y="6038850"/>
-            <a:ext cx="952500" cy="0"/>
-          </a:xfrm>
-          <a:prstGeom xmlns:a="http://schemas.openxmlformats.org/drawingml/2006/main" prst="straightConnector1">
-            <a:avLst/>
+            <a:off x="2371725" y="3657600"/>
+            <a:ext cx="9439275" cy="1524000"/>
+          </a:xfrm>
+          <a:prstGeom xmlns:a="http://schemas.openxmlformats.org/drawingml/2006/main" prst="bentConnector4">
+            <a:avLst>
+              <a:gd name="adj1" fmla="val 0"/>
+              <a:gd name="adj2" fmla="val 15000"/>
+            </a:avLst>
           </a:prstGeom>
           <a:ln xmlns:a="http://schemas.openxmlformats.org/drawingml/2006/main" w="23813">
             <a:solidFill>
@@ -3397,59 +3420,55 @@
       </p:cxnSp>
       <p:cxnSp>
         <p:nvCxnSpPr>
-          <p:cNvPr id="24" name="">
-            <a:extLst xmlns:a="http://schemas.openxmlformats.org/drawingml/2006/main">
-              <a:ext uri="{FF2B5EF4-FFF2-40B4-BE49-F238E27FC236}">
-                <a16:creationId xmlns:a16="http://schemas.microsoft.com/office/drawing/2014/main" id="{32183993-58D1-4C71-8BD8-E978D63ADEFF}"/>
+          <p:cNvPr id="27" name="">
+            <a:extLst xmlns:a="http://schemas.openxmlformats.org/drawingml/2006/main">
+              <a:ext uri="{FF2B5EF4-FFF2-40B4-BE49-F238E27FC236}">
+                <a16:creationId xmlns:a16="http://schemas.microsoft.com/office/drawing/2014/main" id="{8745630D-5214-40ED-91DB-D6F0736009C1}"/>
               </a:ext>
             </a:extLst>
           </p:cNvPr>
           <p:cNvCxnSpPr>
-            <a:stCxn xmlns:a="http://schemas.openxmlformats.org/drawingml/2006/main" id="12" idx="2"/>
-            <a:endCxn xmlns:a="http://schemas.openxmlformats.org/drawingml/2006/main" id="21" idx="3"/>
+            <a:stCxn xmlns:a="http://schemas.openxmlformats.org/drawingml/2006/main" id="20" idx="3"/>
+            <a:endCxn xmlns:a="http://schemas.openxmlformats.org/drawingml/2006/main" id="23" idx="1"/>
           </p:cNvCxnSpPr>
           <p:nvPr/>
         </p:nvCxnSpPr>
         <p:spPr>
-          <a:xfrm xmlns:a="http://schemas.openxmlformats.org/drawingml/2006/main" flipH="1">
-            <a:off x="8039100" y="3657600"/>
-            <a:ext cx="3771900" cy="2381250"/>
-          </a:xfrm>
-          <a:prstGeom xmlns:a="http://schemas.openxmlformats.org/drawingml/2006/main" prst="bentConnector5">
-            <a:avLst>
-              <a:gd name="adj1" fmla="val 0"/>
-              <a:gd name="adj2" fmla="val 9600"/>
-              <a:gd name="adj3" fmla="val 93939"/>
-            </a:avLst>
+          <a:xfrm xmlns:a="http://schemas.openxmlformats.org/drawingml/2006/main">
+            <a:off x="9944100" y="5810250"/>
+            <a:ext cx="952500" cy="0"/>
+          </a:xfrm>
+          <a:prstGeom xmlns:a="http://schemas.openxmlformats.org/drawingml/2006/main" prst="straightConnector1">
+            <a:avLst/>
           </a:prstGeom>
           <a:ln xmlns:a="http://schemas.openxmlformats.org/drawingml/2006/main" w="23813">
             <a:solidFill>
               <a:srgbClr val="157D80"/>
             </a:solidFill>
-            <a:prstDash val="solid"/>
+            <a:prstDash val="dash"/>
             <a:tailEnd type="triangle" w="med" len="med"/>
           </a:ln>
         </p:spPr>
       </p:cxnSp>
       <p:cxnSp>
         <p:nvCxnSpPr>
-          <p:cNvPr id="20" name="">
-            <a:extLst xmlns:a="http://schemas.openxmlformats.org/drawingml/2006/main">
-              <a:ext uri="{FF2B5EF4-FFF2-40B4-BE49-F238E27FC236}">
-                <a16:creationId xmlns:a16="http://schemas.microsoft.com/office/drawing/2014/main" id="{F71AC2B8-ADC6-4DF9-9FCB-068F8825DBDB}"/>
+          <p:cNvPr id="26" name="">
+            <a:extLst xmlns:a="http://schemas.openxmlformats.org/drawingml/2006/main">
+              <a:ext uri="{FF2B5EF4-FFF2-40B4-BE49-F238E27FC236}">
+                <a16:creationId xmlns:a16="http://schemas.microsoft.com/office/drawing/2014/main" id="{51D59A5D-797E-479B-A2EE-4C57729CA61C}"/>
               </a:ext>
             </a:extLst>
           </p:cNvPr>
           <p:cNvCxnSpPr>
-            <a:stCxn xmlns:a="http://schemas.openxmlformats.org/drawingml/2006/main" id="17" idx="0"/>
-            <a:endCxn xmlns:a="http://schemas.openxmlformats.org/drawingml/2006/main" id="12" idx="2"/>
+            <a:stCxn xmlns:a="http://schemas.openxmlformats.org/drawingml/2006/main" id="17" idx="3"/>
+            <a:endCxn xmlns:a="http://schemas.openxmlformats.org/drawingml/2006/main" id="20" idx="1"/>
           </p:cNvCxnSpPr>
           <p:nvPr/>
         </p:nvCxnSpPr>
         <p:spPr>
-          <a:xfrm xmlns:a="http://schemas.openxmlformats.org/drawingml/2006/main" flipV="1">
-            <a:off x="11811000" y="3657600"/>
-            <a:ext cx="0" cy="1752600"/>
+          <a:xfrm xmlns:a="http://schemas.openxmlformats.org/drawingml/2006/main">
+            <a:off x="4133850" y="5810250"/>
+            <a:ext cx="952500" cy="0"/>
           </a:xfrm>
           <a:prstGeom xmlns:a="http://schemas.openxmlformats.org/drawingml/2006/main" prst="straightConnector1">
             <a:avLst/>
@@ -3468,7 +3487,7 @@
           <p:cNvPr id="16" name="">
             <a:extLst xmlns:a="http://schemas.openxmlformats.org/drawingml/2006/main">
               <a:ext uri="{FF2B5EF4-FFF2-40B4-BE49-F238E27FC236}">
-                <a16:creationId xmlns:a16="http://schemas.microsoft.com/office/drawing/2014/main" id="{C5852C42-5182-4E4D-923C-3A22303E06E9}"/>
+                <a16:creationId xmlns:a16="http://schemas.microsoft.com/office/drawing/2014/main" id="{2A3622E6-210C-4849-BC84-950579D417BD}"/>
               </a:ext>
             </a:extLst>
           </p:cNvPr>
@@ -3500,7 +3519,7 @@
           <p:cNvPr id="15" name="">
             <a:extLst xmlns:a="http://schemas.openxmlformats.org/drawingml/2006/main">
               <a:ext uri="{FF2B5EF4-FFF2-40B4-BE49-F238E27FC236}">
-                <a16:creationId xmlns:a16="http://schemas.microsoft.com/office/drawing/2014/main" id="{6A6A23BC-6B80-4F37-9E5F-0F465F478C54}"/>
+                <a16:creationId xmlns:a16="http://schemas.microsoft.com/office/drawing/2014/main" id="{3BB65394-A0C7-4ABE-B311-AB5230F70540}"/>
               </a:ext>
             </a:extLst>
           </p:cNvPr>
@@ -3529,10 +3548,10 @@
       </p:cxnSp>
       <p:sp>
         <p:nvSpPr>
-          <p:cNvPr id="31" name="text-0">
-            <a:extLst xmlns:a="http://schemas.openxmlformats.org/drawingml/2006/main">
-              <a:ext uri="{FF2B5EF4-FFF2-40B4-BE49-F238E27FC236}">
-                <a16:creationId xmlns:a16="http://schemas.microsoft.com/office/drawing/2014/main" id="{F338829B-2735-4A17-9211-BBEB4A33C807}"/>
+          <p:cNvPr id="34" name="revised-text-0">
+            <a:extLst xmlns:a="http://schemas.openxmlformats.org/drawingml/2006/main">
+              <a:ext uri="{FF2B5EF4-FFF2-40B4-BE49-F238E27FC236}">
+                <a16:creationId xmlns:a16="http://schemas.microsoft.com/office/drawing/2014/main" id="{451A6B52-AC17-4636-99CF-D42CE0E6E65C}"/>
               </a:ext>
             </a:extLst>
           </p:cNvPr>
@@ -3596,10 +3615,10 @@
       </p:sp>
       <p:sp>
         <p:nvSpPr>
-          <p:cNvPr id="2" name="text-1">
-            <a:extLst xmlns:a="http://schemas.openxmlformats.org/drawingml/2006/main">
-              <a:ext uri="{FF2B5EF4-FFF2-40B4-BE49-F238E27FC236}">
-                <a16:creationId xmlns:a16="http://schemas.microsoft.com/office/drawing/2014/main" id="{98B30851-B510-46DB-A5FE-B99A2A61E05A}"/>
+          <p:cNvPr id="2" name="revised-text-1">
+            <a:extLst xmlns:a="http://schemas.openxmlformats.org/drawingml/2006/main">
+              <a:ext uri="{FF2B5EF4-FFF2-40B4-BE49-F238E27FC236}">
+                <a16:creationId xmlns:a16="http://schemas.microsoft.com/office/drawing/2014/main" id="{601278BC-DD09-40A8-8C55-A3A40D0BB76D}"/>
               </a:ext>
             </a:extLst>
           </p:cNvPr>
@@ -3656,7 +3675,7 @@
                 <a:ea typeface="Aptos"/>
                 <a:cs typeface="Aptos"/>
               </a:rPr>
-              <a:t>Architecture target</a:t>
+              <a:t>Storage target · shared DAO data, independent Paperclip database</a:t>
             </a:r>
           </a:p>
         </p:txBody>
@@ -3666,7 +3685,7 @@
           <p:cNvPr id="3" name="">
             <a:extLst xmlns:a="http://schemas.openxmlformats.org/drawingml/2006/main">
               <a:ext uri="{FF2B5EF4-FFF2-40B4-BE49-F238E27FC236}">
-                <a16:creationId xmlns:a16="http://schemas.microsoft.com/office/drawing/2014/main" id="{F5A0C751-6B71-4A23-AF26-A60024636BE4}"/>
+                <a16:creationId xmlns:a16="http://schemas.microsoft.com/office/drawing/2014/main" id="{D0A68C2B-F3FF-47B1-9257-9F48EA299097}"/>
               </a:ext>
             </a:extLst>
           </p:cNvPr>
@@ -3693,10 +3712,10 @@
       </p:sp>
       <p:sp>
         <p:nvSpPr>
-          <p:cNvPr id="4" name="text-2">
-            <a:extLst xmlns:a="http://schemas.openxmlformats.org/drawingml/2006/main">
-              <a:ext uri="{FF2B5EF4-FFF2-40B4-BE49-F238E27FC236}">
-                <a16:creationId xmlns:a16="http://schemas.microsoft.com/office/drawing/2014/main" id="{AB6B971A-12BD-4EF5-AC08-3A887F5346B1}"/>
+          <p:cNvPr id="4" name="revised-text-2">
+            <a:extLst xmlns:a="http://schemas.openxmlformats.org/drawingml/2006/main">
+              <a:ext uri="{FF2B5EF4-FFF2-40B4-BE49-F238E27FC236}">
+                <a16:creationId xmlns:a16="http://schemas.microsoft.com/office/drawing/2014/main" id="{D1464888-C311-4DB3-9C18-9E30A9E6CC7D}"/>
               </a:ext>
             </a:extLst>
           </p:cNvPr>
@@ -3753,17 +3772,17 @@
                 <a:ea typeface="Aptos"/>
                 <a:cs typeface="Aptos"/>
               </a:rPr>
-              <a:t>Inertia architecture · r11 · 23 October 2026</a:t>
-            </a:r>
-          </a:p>
-        </p:txBody>
-      </p:sp>
-      <p:sp>
-        <p:nvSpPr>
-          <p:cNvPr id="5" name="text-3">
-            <a:extLst xmlns:a="http://schemas.openxmlformats.org/drawingml/2006/main">
-              <a:ext uri="{FF2B5EF4-FFF2-40B4-BE49-F238E27FC236}">
-                <a16:creationId xmlns:a16="http://schemas.microsoft.com/office/drawing/2014/main" id="{6E0C023B-80DC-47FB-A443-AFCF22AD0838}"/>
+              <a:t>Inertia architecture · r12 · 23 October 2026</a:t>
+            </a:r>
+          </a:p>
+        </p:txBody>
+      </p:sp>
+      <p:sp>
+        <p:nvSpPr>
+          <p:cNvPr id="5" name="revised-text-3">
+            <a:extLst xmlns:a="http://schemas.openxmlformats.org/drawingml/2006/main">
+              <a:ext uri="{FF2B5EF4-FFF2-40B4-BE49-F238E27FC236}">
+                <a16:creationId xmlns:a16="http://schemas.microsoft.com/office/drawing/2014/main" id="{419EEE86-A4C1-4878-87E7-5BFCD1F5190B}"/>
               </a:ext>
             </a:extLst>
           </p:cNvPr>
@@ -3827,10 +3846,10 @@
       </p:sp>
       <p:sp>
         <p:nvSpPr>
-          <p:cNvPr id="6" name="node-4">
-            <a:extLst xmlns:a="http://schemas.openxmlformats.org/drawingml/2006/main">
-              <a:ext uri="{FF2B5EF4-FFF2-40B4-BE49-F238E27FC236}">
-                <a16:creationId xmlns:a16="http://schemas.microsoft.com/office/drawing/2014/main" id="{D40EE361-D12D-448F-B9AA-753A41F651D5}"/>
+          <p:cNvPr id="6" name="revised-node-4">
+            <a:extLst xmlns:a="http://schemas.openxmlformats.org/drawingml/2006/main">
+              <a:ext uri="{FF2B5EF4-FFF2-40B4-BE49-F238E27FC236}">
+                <a16:creationId xmlns:a16="http://schemas.microsoft.com/office/drawing/2014/main" id="{1282C594-EE68-45A0-8A9D-C320038639B6}"/>
               </a:ext>
             </a:extLst>
           </p:cNvPr>
@@ -3860,10 +3879,10 @@
       </p:sp>
       <p:sp>
         <p:nvSpPr>
-          <p:cNvPr id="7" name="text-5">
-            <a:extLst xmlns:a="http://schemas.openxmlformats.org/drawingml/2006/main">
-              <a:ext uri="{FF2B5EF4-FFF2-40B4-BE49-F238E27FC236}">
-                <a16:creationId xmlns:a16="http://schemas.microsoft.com/office/drawing/2014/main" id="{57FAA9B2-9ACE-4EA1-B11C-52A739900D76}"/>
+          <p:cNvPr id="7" name="revised-text-5">
+            <a:extLst xmlns:a="http://schemas.openxmlformats.org/drawingml/2006/main">
+              <a:ext uri="{FF2B5EF4-FFF2-40B4-BE49-F238E27FC236}">
+                <a16:creationId xmlns:a16="http://schemas.microsoft.com/office/drawing/2014/main" id="{2D43F8BE-9AA7-4CE2-BB2D-086F2B34AD44}"/>
               </a:ext>
             </a:extLst>
           </p:cNvPr>
@@ -3927,10 +3946,10 @@
       </p:sp>
       <p:sp>
         <p:nvSpPr>
-          <p:cNvPr id="8" name="text-6">
-            <a:extLst xmlns:a="http://schemas.openxmlformats.org/drawingml/2006/main">
-              <a:ext uri="{FF2B5EF4-FFF2-40B4-BE49-F238E27FC236}">
-                <a16:creationId xmlns:a16="http://schemas.microsoft.com/office/drawing/2014/main" id="{D1709342-03D6-4291-B11A-983541517BEB}"/>
+          <p:cNvPr id="8" name="revised-text-6">
+            <a:extLst xmlns:a="http://schemas.openxmlformats.org/drawingml/2006/main">
+              <a:ext uri="{FF2B5EF4-FFF2-40B4-BE49-F238E27FC236}">
+                <a16:creationId xmlns:a16="http://schemas.microsoft.com/office/drawing/2014/main" id="{9349FA75-6DA3-4D6C-8458-C74CB8CE6AF0}"/>
               </a:ext>
             </a:extLst>
           </p:cNvPr>
@@ -3994,10 +4013,10 @@
       </p:sp>
       <p:sp>
         <p:nvSpPr>
-          <p:cNvPr id="9" name="node-7">
-            <a:extLst xmlns:a="http://schemas.openxmlformats.org/drawingml/2006/main">
-              <a:ext uri="{FF2B5EF4-FFF2-40B4-BE49-F238E27FC236}">
-                <a16:creationId xmlns:a16="http://schemas.microsoft.com/office/drawing/2014/main" id="{4D68A38C-E50A-4C92-BF4E-4E976916C4C0}"/>
+          <p:cNvPr id="9" name="revised-node-7">
+            <a:extLst xmlns:a="http://schemas.openxmlformats.org/drawingml/2006/main">
+              <a:ext uri="{FF2B5EF4-FFF2-40B4-BE49-F238E27FC236}">
+                <a16:creationId xmlns:a16="http://schemas.microsoft.com/office/drawing/2014/main" id="{3369E68E-CE07-492A-96BF-908C06950821}"/>
               </a:ext>
             </a:extLst>
           </p:cNvPr>
@@ -4027,10 +4046,10 @@
       </p:sp>
       <p:sp>
         <p:nvSpPr>
-          <p:cNvPr id="10" name="text-8">
-            <a:extLst xmlns:a="http://schemas.openxmlformats.org/drawingml/2006/main">
-              <a:ext uri="{FF2B5EF4-FFF2-40B4-BE49-F238E27FC236}">
-                <a16:creationId xmlns:a16="http://schemas.microsoft.com/office/drawing/2014/main" id="{09E6C6C1-236F-4B7C-823D-45267C123351}"/>
+          <p:cNvPr id="10" name="revised-text-8">
+            <a:extLst xmlns:a="http://schemas.openxmlformats.org/drawingml/2006/main">
+              <a:ext uri="{FF2B5EF4-FFF2-40B4-BE49-F238E27FC236}">
+                <a16:creationId xmlns:a16="http://schemas.microsoft.com/office/drawing/2014/main" id="{88384E24-B42E-4F41-9B08-B14618BB23DF}"/>
               </a:ext>
             </a:extLst>
           </p:cNvPr>
@@ -4094,10 +4113,10 @@
       </p:sp>
       <p:sp>
         <p:nvSpPr>
-          <p:cNvPr id="11" name="text-9">
-            <a:extLst xmlns:a="http://schemas.openxmlformats.org/drawingml/2006/main">
-              <a:ext uri="{FF2B5EF4-FFF2-40B4-BE49-F238E27FC236}">
-                <a16:creationId xmlns:a16="http://schemas.microsoft.com/office/drawing/2014/main" id="{AD09C499-0220-4144-BCA1-FAF6B93A9B92}"/>
+          <p:cNvPr id="11" name="revised-text-9">
+            <a:extLst xmlns:a="http://schemas.openxmlformats.org/drawingml/2006/main">
+              <a:ext uri="{FF2B5EF4-FFF2-40B4-BE49-F238E27FC236}">
+                <a16:creationId xmlns:a16="http://schemas.microsoft.com/office/drawing/2014/main" id="{0E152F7C-C020-46FF-B842-E881FAE88EF6}"/>
               </a:ext>
             </a:extLst>
           </p:cNvPr>
@@ -4161,10 +4180,10 @@
       </p:sp>
       <p:sp>
         <p:nvSpPr>
-          <p:cNvPr id="12" name="node-10">
-            <a:extLst xmlns:a="http://schemas.openxmlformats.org/drawingml/2006/main">
-              <a:ext uri="{FF2B5EF4-FFF2-40B4-BE49-F238E27FC236}">
-                <a16:creationId xmlns:a16="http://schemas.microsoft.com/office/drawing/2014/main" id="{86D85CD9-0912-4636-83E2-C2344A550DF0}"/>
+          <p:cNvPr id="12" name="revised-node-10">
+            <a:extLst xmlns:a="http://schemas.openxmlformats.org/drawingml/2006/main">
+              <a:ext uri="{FF2B5EF4-FFF2-40B4-BE49-F238E27FC236}">
+                <a16:creationId xmlns:a16="http://schemas.microsoft.com/office/drawing/2014/main" id="{15AE83C7-DF5C-4763-AE31-BA9932A8C242}"/>
               </a:ext>
             </a:extLst>
           </p:cNvPr>
@@ -4194,10 +4213,10 @@
       </p:sp>
       <p:sp>
         <p:nvSpPr>
-          <p:cNvPr id="13" name="text-11">
-            <a:extLst xmlns:a="http://schemas.openxmlformats.org/drawingml/2006/main">
-              <a:ext uri="{FF2B5EF4-FFF2-40B4-BE49-F238E27FC236}">
-                <a16:creationId xmlns:a16="http://schemas.microsoft.com/office/drawing/2014/main" id="{B464BA17-0D0F-4423-BA24-E0E4887A74D1}"/>
+          <p:cNvPr id="13" name="revised-text-11">
+            <a:extLst xmlns:a="http://schemas.openxmlformats.org/drawingml/2006/main">
+              <a:ext uri="{FF2B5EF4-FFF2-40B4-BE49-F238E27FC236}">
+                <a16:creationId xmlns:a16="http://schemas.microsoft.com/office/drawing/2014/main" id="{59D338F1-72F2-442F-9493-EFD5F20CBA79}"/>
               </a:ext>
             </a:extLst>
           </p:cNvPr>
@@ -4261,10 +4280,10 @@
       </p:sp>
       <p:sp>
         <p:nvSpPr>
-          <p:cNvPr id="14" name="text-12">
-            <a:extLst xmlns:a="http://schemas.openxmlformats.org/drawingml/2006/main">
-              <a:ext uri="{FF2B5EF4-FFF2-40B4-BE49-F238E27FC236}">
-                <a16:creationId xmlns:a16="http://schemas.microsoft.com/office/drawing/2014/main" id="{A6CA7E7E-54AF-4F84-974F-45E811EB04E2}"/>
+          <p:cNvPr id="14" name="revised-text-12">
+            <a:extLst xmlns:a="http://schemas.openxmlformats.org/drawingml/2006/main">
+              <a:ext uri="{FF2B5EF4-FFF2-40B4-BE49-F238E27FC236}">
+                <a16:creationId xmlns:a16="http://schemas.microsoft.com/office/drawing/2014/main" id="{FDDF2989-E5D2-42DB-8CA9-240B07A1165E}"/>
               </a:ext>
             </a:extLst>
           </p:cNvPr>
@@ -4321,29 +4340,29 @@
                 <a:ea typeface="Aptos"/>
                 <a:cs typeface="Aptos"/>
               </a:rPr>
-              <a:t>Work state + authority</a:t>
-            </a:r>
-          </a:p>
-        </p:txBody>
-      </p:sp>
-      <p:sp>
-        <p:nvSpPr>
-          <p:cNvPr id="17" name="node-13">
-            <a:extLst xmlns:a="http://schemas.openxmlformats.org/drawingml/2006/main">
-              <a:ext uri="{FF2B5EF4-FFF2-40B4-BE49-F238E27FC236}">
-                <a16:creationId xmlns:a16="http://schemas.microsoft.com/office/drawing/2014/main" id="{4529C4A9-D7C9-4892-A39E-6824BF7461E6}"/>
-              </a:ext>
-            </a:extLst>
-          </p:cNvPr>
-          <p:cNvSpPr>
-            <a:spLocks xmlns:a="http://schemas.openxmlformats.org/drawingml/2006/main" noGrp="1"/>
-          </p:cNvSpPr>
-          <p:nvPr/>
-        </p:nvSpPr>
-        <p:spPr>
-          <a:xfrm xmlns:a="http://schemas.openxmlformats.org/drawingml/2006/main">
-            <a:off x="8991600" y="5410200"/>
-            <a:ext cx="5638800" cy="1257300"/>
+              <a:t>Native work + independent DB</a:t>
+            </a:r>
+          </a:p>
+        </p:txBody>
+      </p:sp>
+      <p:sp>
+        <p:nvSpPr>
+          <p:cNvPr id="17" name="revised-node-13">
+            <a:extLst xmlns:a="http://schemas.openxmlformats.org/drawingml/2006/main">
+              <a:ext uri="{FF2B5EF4-FFF2-40B4-BE49-F238E27FC236}">
+                <a16:creationId xmlns:a16="http://schemas.microsoft.com/office/drawing/2014/main" id="{50194603-9019-4EDD-9848-E65EBF1288F2}"/>
+              </a:ext>
+            </a:extLst>
+          </p:cNvPr>
+          <p:cNvSpPr>
+            <a:spLocks xmlns:a="http://schemas.openxmlformats.org/drawingml/2006/main" noGrp="1"/>
+          </p:cNvSpPr>
+          <p:nvPr/>
+        </p:nvSpPr>
+        <p:spPr>
+          <a:xfrm xmlns:a="http://schemas.openxmlformats.org/drawingml/2006/main">
+            <a:off x="609600" y="5181600"/>
+            <a:ext cx="3524250" cy="1257300"/>
           </a:xfrm>
           <a:prstGeom xmlns:a="http://schemas.openxmlformats.org/drawingml/2006/main" prst="rect">
             <a:avLst/>
@@ -4361,22 +4380,22 @@
       </p:sp>
       <p:sp>
         <p:nvSpPr>
-          <p:cNvPr id="18" name="text-14">
-            <a:extLst xmlns:a="http://schemas.openxmlformats.org/drawingml/2006/main">
-              <a:ext uri="{FF2B5EF4-FFF2-40B4-BE49-F238E27FC236}">
-                <a16:creationId xmlns:a16="http://schemas.microsoft.com/office/drawing/2014/main" id="{8428794F-A1D8-4E00-81FF-6ACDF9979745}"/>
-              </a:ext>
-            </a:extLst>
-          </p:cNvPr>
-          <p:cNvSpPr>
-            <a:spLocks xmlns:a="http://schemas.openxmlformats.org/drawingml/2006/main" noGrp="1"/>
-          </p:cNvSpPr>
-          <p:nvPr/>
-        </p:nvSpPr>
-        <p:spPr>
-          <a:xfrm xmlns:a="http://schemas.openxmlformats.org/drawingml/2006/main">
-            <a:off x="9182100" y="5581650"/>
-            <a:ext cx="5257800" cy="400050"/>
+          <p:cNvPr id="18" name="revised-text-14">
+            <a:extLst xmlns:a="http://schemas.openxmlformats.org/drawingml/2006/main">
+              <a:ext uri="{FF2B5EF4-FFF2-40B4-BE49-F238E27FC236}">
+                <a16:creationId xmlns:a16="http://schemas.microsoft.com/office/drawing/2014/main" id="{46314449-F06E-489F-885E-56E66BD1D7F7}"/>
+              </a:ext>
+            </a:extLst>
+          </p:cNvPr>
+          <p:cNvSpPr>
+            <a:spLocks xmlns:a="http://schemas.openxmlformats.org/drawingml/2006/main" noGrp="1"/>
+          </p:cNvSpPr>
+          <p:nvPr/>
+        </p:nvSpPr>
+        <p:spPr>
+          <a:xfrm xmlns:a="http://schemas.openxmlformats.org/drawingml/2006/main">
+            <a:off x="800100" y="5353050"/>
+            <a:ext cx="3143250" cy="400050"/>
           </a:xfrm>
           <a:prstGeom xmlns:a="http://schemas.openxmlformats.org/drawingml/2006/main" prst="rect">
             <a:avLst/>
@@ -4421,29 +4440,29 @@
                 <a:ea typeface="Aptos"/>
                 <a:cs typeface="Aptos"/>
               </a:rPr>
-              <a:t>Paperclip dashboard</a:t>
-            </a:r>
-          </a:p>
-        </p:txBody>
-      </p:sp>
-      <p:sp>
-        <p:nvSpPr>
-          <p:cNvPr id="19" name="text-15">
-            <a:extLst xmlns:a="http://schemas.openxmlformats.org/drawingml/2006/main">
-              <a:ext uri="{FF2B5EF4-FFF2-40B4-BE49-F238E27FC236}">
-                <a16:creationId xmlns:a16="http://schemas.microsoft.com/office/drawing/2014/main" id="{8C268D16-EE47-4A1E-9856-BCBE9AA8E4E4}"/>
-              </a:ext>
-            </a:extLst>
-          </p:cNvPr>
-          <p:cNvSpPr>
-            <a:spLocks xmlns:a="http://schemas.openxmlformats.org/drawingml/2006/main" noGrp="1"/>
-          </p:cNvSpPr>
-          <p:nvPr/>
-        </p:nvSpPr>
-        <p:spPr>
-          <a:xfrm xmlns:a="http://schemas.openxmlformats.org/drawingml/2006/main">
-            <a:off x="9182100" y="6019800"/>
-            <a:ext cx="5257800" cy="533400"/>
+              <a:t>DAO backends</a:t>
+            </a:r>
+          </a:p>
+        </p:txBody>
+      </p:sp>
+      <p:sp>
+        <p:nvSpPr>
+          <p:cNvPr id="19" name="revised-text-15">
+            <a:extLst xmlns:a="http://schemas.openxmlformats.org/drawingml/2006/main">
+              <a:ext uri="{FF2B5EF4-FFF2-40B4-BE49-F238E27FC236}">
+                <a16:creationId xmlns:a16="http://schemas.microsoft.com/office/drawing/2014/main" id="{8A3A3403-C79A-40F2-A606-2F26BDBD889C}"/>
+              </a:ext>
+            </a:extLst>
+          </p:cNvPr>
+          <p:cNvSpPr>
+            <a:spLocks xmlns:a="http://schemas.openxmlformats.org/drawingml/2006/main" noGrp="1"/>
+          </p:cNvSpPr>
+          <p:nvPr/>
+        </p:nvSpPr>
+        <p:spPr>
+          <a:xfrm xmlns:a="http://schemas.openxmlformats.org/drawingml/2006/main">
+            <a:off x="800100" y="5791200"/>
+            <a:ext cx="3143250" cy="533400"/>
           </a:xfrm>
           <a:prstGeom xmlns:a="http://schemas.openxmlformats.org/drawingml/2006/main" prst="rect">
             <a:avLst/>
@@ -4488,29 +4507,29 @@
                 <a:ea typeface="Aptos"/>
                 <a:cs typeface="Aptos"/>
               </a:rPr>
-              <a:t>Native docs + human-only review cards</a:t>
-            </a:r>
-          </a:p>
-        </p:txBody>
-      </p:sp>
-      <p:sp>
-        <p:nvSpPr>
-          <p:cNvPr id="21" name="node-16">
-            <a:extLst xmlns:a="http://schemas.openxmlformats.org/drawingml/2006/main">
-              <a:ext uri="{FF2B5EF4-FFF2-40B4-BE49-F238E27FC236}">
-                <a16:creationId xmlns:a16="http://schemas.microsoft.com/office/drawing/2014/main" id="{0EE133AB-F20B-4C7C-B89D-41D38EDE4596}"/>
-              </a:ext>
-            </a:extLst>
-          </p:cNvPr>
-          <p:cNvSpPr>
-            <a:spLocks xmlns:a="http://schemas.openxmlformats.org/drawingml/2006/main" noGrp="1"/>
-          </p:cNvSpPr>
-          <p:nvPr/>
-        </p:nvSpPr>
-        <p:spPr>
-          <a:xfrm xmlns:a="http://schemas.openxmlformats.org/drawingml/2006/main">
-            <a:off x="4610100" y="5410200"/>
-            <a:ext cx="3429000" cy="1257300"/>
+              <a:t>Funding + meetings</a:t>
+            </a:r>
+          </a:p>
+        </p:txBody>
+      </p:sp>
+      <p:sp>
+        <p:nvSpPr>
+          <p:cNvPr id="20" name="revised-node-16">
+            <a:extLst xmlns:a="http://schemas.openxmlformats.org/drawingml/2006/main">
+              <a:ext uri="{FF2B5EF4-FFF2-40B4-BE49-F238E27FC236}">
+                <a16:creationId xmlns:a16="http://schemas.microsoft.com/office/drawing/2014/main" id="{DA5642D2-0DA3-49A7-B836-CED795D58472}"/>
+              </a:ext>
+            </a:extLst>
+          </p:cNvPr>
+          <p:cNvSpPr>
+            <a:spLocks xmlns:a="http://schemas.openxmlformats.org/drawingml/2006/main" noGrp="1"/>
+          </p:cNvSpPr>
+          <p:nvPr/>
+        </p:nvSpPr>
+        <p:spPr>
+          <a:xfrm xmlns:a="http://schemas.openxmlformats.org/drawingml/2006/main">
+            <a:off x="5086350" y="5181600"/>
+            <a:ext cx="4857750" cy="1257300"/>
           </a:xfrm>
           <a:prstGeom xmlns:a="http://schemas.openxmlformats.org/drawingml/2006/main" prst="rect">
             <a:avLst/>
@@ -4528,22 +4547,22 @@
       </p:sp>
       <p:sp>
         <p:nvSpPr>
-          <p:cNvPr id="22" name="text-17">
-            <a:extLst xmlns:a="http://schemas.openxmlformats.org/drawingml/2006/main">
-              <a:ext uri="{FF2B5EF4-FFF2-40B4-BE49-F238E27FC236}">
-                <a16:creationId xmlns:a16="http://schemas.microsoft.com/office/drawing/2014/main" id="{509DA9BE-D649-4653-8427-5C32E9318574}"/>
-              </a:ext>
-            </a:extLst>
-          </p:cNvPr>
-          <p:cNvSpPr>
-            <a:spLocks xmlns:a="http://schemas.openxmlformats.org/drawingml/2006/main" noGrp="1"/>
-          </p:cNvSpPr>
-          <p:nvPr/>
-        </p:nvSpPr>
-        <p:spPr>
-          <a:xfrm xmlns:a="http://schemas.openxmlformats.org/drawingml/2006/main">
-            <a:off x="4800600" y="5581650"/>
-            <a:ext cx="3048000" cy="400050"/>
+          <p:cNvPr id="21" name="revised-text-17">
+            <a:extLst xmlns:a="http://schemas.openxmlformats.org/drawingml/2006/main">
+              <a:ext uri="{FF2B5EF4-FFF2-40B4-BE49-F238E27FC236}">
+                <a16:creationId xmlns:a16="http://schemas.microsoft.com/office/drawing/2014/main" id="{F12C52C4-7210-4568-B314-CAED6ABF0C71}"/>
+              </a:ext>
+            </a:extLst>
+          </p:cNvPr>
+          <p:cNvSpPr>
+            <a:spLocks xmlns:a="http://schemas.openxmlformats.org/drawingml/2006/main" noGrp="1"/>
+          </p:cNvSpPr>
+          <p:nvPr/>
+        </p:nvSpPr>
+        <p:spPr>
+          <a:xfrm xmlns:a="http://schemas.openxmlformats.org/drawingml/2006/main">
+            <a:off x="5276850" y="5353050"/>
+            <a:ext cx="4476750" cy="400050"/>
           </a:xfrm>
           <a:prstGeom xmlns:a="http://schemas.openxmlformats.org/drawingml/2006/main" prst="rect">
             <a:avLst/>
@@ -4588,29 +4607,29 @@
                 <a:ea typeface="Aptos"/>
                 <a:cs typeface="Aptos"/>
               </a:rPr>
-              <a:t>Trusted adapters</a:t>
-            </a:r>
-          </a:p>
-        </p:txBody>
-      </p:sp>
-      <p:sp>
-        <p:nvSpPr>
-          <p:cNvPr id="23" name="text-18">
-            <a:extLst xmlns:a="http://schemas.openxmlformats.org/drawingml/2006/main">
-              <a:ext uri="{FF2B5EF4-FFF2-40B4-BE49-F238E27FC236}">
-                <a16:creationId xmlns:a16="http://schemas.microsoft.com/office/drawing/2014/main" id="{04F299F8-404D-4AF2-8E78-04A3DDA318C3}"/>
-              </a:ext>
-            </a:extLst>
-          </p:cNvPr>
-          <p:cNvSpPr>
-            <a:spLocks xmlns:a="http://schemas.openxmlformats.org/drawingml/2006/main" noGrp="1"/>
-          </p:cNvSpPr>
-          <p:nvPr/>
-        </p:nvSpPr>
-        <p:spPr>
-          <a:xfrm xmlns:a="http://schemas.openxmlformats.org/drawingml/2006/main">
-            <a:off x="4800600" y="6019800"/>
-            <a:ext cx="3048000" cy="533400"/>
+              <a:t>Existing DAO PostgreSQL</a:t>
+            </a:r>
+          </a:p>
+        </p:txBody>
+      </p:sp>
+      <p:sp>
+        <p:nvSpPr>
+          <p:cNvPr id="22" name="revised-text-18">
+            <a:extLst xmlns:a="http://schemas.openxmlformats.org/drawingml/2006/main">
+              <a:ext uri="{FF2B5EF4-FFF2-40B4-BE49-F238E27FC236}">
+                <a16:creationId xmlns:a16="http://schemas.microsoft.com/office/drawing/2014/main" id="{E4906A4F-0FBE-4CD5-B187-CFE192A29C6D}"/>
+              </a:ext>
+            </a:extLst>
+          </p:cNvPr>
+          <p:cNvSpPr>
+            <a:spLocks xmlns:a="http://schemas.openxmlformats.org/drawingml/2006/main" noGrp="1"/>
+          </p:cNvSpPr>
+          <p:nvPr/>
+        </p:nvSpPr>
+        <p:spPr>
+          <a:xfrm xmlns:a="http://schemas.openxmlformats.org/drawingml/2006/main">
+            <a:off x="5276850" y="5791200"/>
+            <a:ext cx="4476750" cy="533400"/>
           </a:xfrm>
           <a:prstGeom xmlns:a="http://schemas.openxmlformats.org/drawingml/2006/main" prst="rect">
             <a:avLst/>
@@ -4655,29 +4674,29 @@
                 <a:ea typeface="Aptos"/>
                 <a:cs typeface="Aptos"/>
               </a:rPr>
-              <a:t>Validate + publish</a:t>
-            </a:r>
-          </a:p>
-        </p:txBody>
-      </p:sp>
-      <p:sp>
-        <p:nvSpPr>
-          <p:cNvPr id="25" name="node-19">
-            <a:extLst xmlns:a="http://schemas.openxmlformats.org/drawingml/2006/main">
-              <a:ext uri="{FF2B5EF4-FFF2-40B4-BE49-F238E27FC236}">
-                <a16:creationId xmlns:a16="http://schemas.microsoft.com/office/drawing/2014/main" id="{1657C0E3-C316-4CB9-8429-70DC796949A6}"/>
-              </a:ext>
-            </a:extLst>
-          </p:cNvPr>
-          <p:cNvSpPr>
-            <a:spLocks xmlns:a="http://schemas.openxmlformats.org/drawingml/2006/main" noGrp="1"/>
-          </p:cNvSpPr>
-          <p:nvPr/>
-        </p:nvSpPr>
-        <p:spPr>
-          <a:xfrm xmlns:a="http://schemas.openxmlformats.org/drawingml/2006/main">
-            <a:off x="609600" y="5410200"/>
-            <a:ext cx="3048000" cy="1257300"/>
+              <a:t>Isolated schemas + scoped roles</a:t>
+            </a:r>
+          </a:p>
+        </p:txBody>
+      </p:sp>
+      <p:sp>
+        <p:nvSpPr>
+          <p:cNvPr id="23" name="revised-node-19">
+            <a:extLst xmlns:a="http://schemas.openxmlformats.org/drawingml/2006/main">
+              <a:ext uri="{FF2B5EF4-FFF2-40B4-BE49-F238E27FC236}">
+                <a16:creationId xmlns:a16="http://schemas.microsoft.com/office/drawing/2014/main" id="{B8DE59ED-0601-43B1-80AB-18A768C9A3CA}"/>
+              </a:ext>
+            </a:extLst>
+          </p:cNvPr>
+          <p:cNvSpPr>
+            <a:spLocks xmlns:a="http://schemas.openxmlformats.org/drawingml/2006/main" noGrp="1"/>
+          </p:cNvSpPr>
+          <p:nvPr/>
+        </p:nvSpPr>
+        <p:spPr>
+          <a:xfrm xmlns:a="http://schemas.openxmlformats.org/drawingml/2006/main">
+            <a:off x="10896600" y="5181600"/>
+            <a:ext cx="3733800" cy="1257300"/>
           </a:xfrm>
           <a:prstGeom xmlns:a="http://schemas.openxmlformats.org/drawingml/2006/main" prst="rect">
             <a:avLst/>
@@ -4695,22 +4714,22 @@
       </p:sp>
       <p:sp>
         <p:nvSpPr>
-          <p:cNvPr id="26" name="text-20">
-            <a:extLst xmlns:a="http://schemas.openxmlformats.org/drawingml/2006/main">
-              <a:ext uri="{FF2B5EF4-FFF2-40B4-BE49-F238E27FC236}">
-                <a16:creationId xmlns:a16="http://schemas.microsoft.com/office/drawing/2014/main" id="{7E4DD7EB-D6F0-46A3-B373-9C6C61B0D5B8}"/>
-              </a:ext>
-            </a:extLst>
-          </p:cNvPr>
-          <p:cNvSpPr>
-            <a:spLocks xmlns:a="http://schemas.openxmlformats.org/drawingml/2006/main" noGrp="1"/>
-          </p:cNvSpPr>
-          <p:nvPr/>
-        </p:nvSpPr>
-        <p:spPr>
-          <a:xfrm xmlns:a="http://schemas.openxmlformats.org/drawingml/2006/main">
-            <a:off x="800100" y="5581650"/>
-            <a:ext cx="2667000" cy="400050"/>
+          <p:cNvPr id="24" name="revised-text-20">
+            <a:extLst xmlns:a="http://schemas.openxmlformats.org/drawingml/2006/main">
+              <a:ext uri="{FF2B5EF4-FFF2-40B4-BE49-F238E27FC236}">
+                <a16:creationId xmlns:a16="http://schemas.microsoft.com/office/drawing/2014/main" id="{E4CD66CA-A769-4D18-AFB6-182604305961}"/>
+              </a:ext>
+            </a:extLst>
+          </p:cNvPr>
+          <p:cNvSpPr>
+            <a:spLocks xmlns:a="http://schemas.openxmlformats.org/drawingml/2006/main" noGrp="1"/>
+          </p:cNvSpPr>
+          <p:nvPr/>
+        </p:nvSpPr>
+        <p:spPr>
+          <a:xfrm xmlns:a="http://schemas.openxmlformats.org/drawingml/2006/main">
+            <a:off x="11087100" y="5353050"/>
+            <a:ext cx="3352800" cy="400050"/>
           </a:xfrm>
           <a:prstGeom xmlns:a="http://schemas.openxmlformats.org/drawingml/2006/main" prst="rect">
             <a:avLst/>
@@ -4755,29 +4774,29 @@
                 <a:ea typeface="Aptos"/>
                 <a:cs typeface="Aptos"/>
               </a:rPr>
-              <a:t>DAO integrations</a:t>
-            </a:r>
-          </a:p>
-        </p:txBody>
-      </p:sp>
-      <p:sp>
-        <p:nvSpPr>
-          <p:cNvPr id="27" name="text-21">
-            <a:extLst xmlns:a="http://schemas.openxmlformats.org/drawingml/2006/main">
-              <a:ext uri="{FF2B5EF4-FFF2-40B4-BE49-F238E27FC236}">
-                <a16:creationId xmlns:a16="http://schemas.microsoft.com/office/drawing/2014/main" id="{A272E028-333A-40CC-A4A0-CA87EDB18518}"/>
-              </a:ext>
-            </a:extLst>
-          </p:cNvPr>
-          <p:cNvSpPr>
-            <a:spLocks xmlns:a="http://schemas.openxmlformats.org/drawingml/2006/main" noGrp="1"/>
-          </p:cNvSpPr>
-          <p:nvPr/>
-        </p:nvSpPr>
-        <p:spPr>
-          <a:xfrm xmlns:a="http://schemas.openxmlformats.org/drawingml/2006/main">
-            <a:off x="800100" y="6019800"/>
-            <a:ext cx="2667000" cy="533400"/>
+              <a:t>Helix · planned</a:t>
+            </a:r>
+          </a:p>
+        </p:txBody>
+      </p:sp>
+      <p:sp>
+        <p:nvSpPr>
+          <p:cNvPr id="25" name="revised-text-21">
+            <a:extLst xmlns:a="http://schemas.openxmlformats.org/drawingml/2006/main">
+              <a:ext uri="{FF2B5EF4-FFF2-40B4-BE49-F238E27FC236}">
+                <a16:creationId xmlns:a16="http://schemas.microsoft.com/office/drawing/2014/main" id="{A359C726-4F89-4E5B-8386-BF5A0158D67A}"/>
+              </a:ext>
+            </a:extLst>
+          </p:cNvPr>
+          <p:cNvSpPr>
+            <a:spLocks xmlns:a="http://schemas.openxmlformats.org/drawingml/2006/main" noGrp="1"/>
+          </p:cNvSpPr>
+          <p:nvPr/>
+        </p:nvSpPr>
+        <p:spPr>
+          <a:xfrm xmlns:a="http://schemas.openxmlformats.org/drawingml/2006/main">
+            <a:off x="11087100" y="5791200"/>
+            <a:ext cx="3352800" cy="533400"/>
           </a:xfrm>
           <a:prstGeom xmlns:a="http://schemas.openxmlformats.org/drawingml/2006/main" prst="rect">
             <a:avLst/>
@@ -4822,29 +4841,29 @@
                 <a:ea typeface="Aptos"/>
                 <a:cs typeface="Aptos"/>
               </a:rPr>
-              <a:t>Website · grants · Y2</a:t>
-            </a:r>
-          </a:p>
-        </p:txBody>
-      </p:sp>
-      <p:sp>
-        <p:nvSpPr>
-          <p:cNvPr id="29" name="text-22">
-            <a:extLst xmlns:a="http://schemas.openxmlformats.org/drawingml/2006/main">
-              <a:ext uri="{FF2B5EF4-FFF2-40B4-BE49-F238E27FC236}">
-                <a16:creationId xmlns:a16="http://schemas.microsoft.com/office/drawing/2014/main" id="{7587C5C6-AF3C-438D-A79E-EF65919D32F7}"/>
-              </a:ext>
-            </a:extLst>
-          </p:cNvPr>
-          <p:cNvSpPr>
-            <a:spLocks xmlns:a="http://schemas.openxmlformats.org/drawingml/2006/main" noGrp="1"/>
-          </p:cNvSpPr>
-          <p:nvPr/>
-        </p:nvSpPr>
-        <p:spPr>
-          <a:xfrm xmlns:a="http://schemas.openxmlformats.org/drawingml/2006/main">
-            <a:off x="4610100" y="6858000"/>
-            <a:ext cx="3429000" cy="571500"/>
+              <a:t>Graph / vector projection</a:t>
+            </a:r>
+          </a:p>
+        </p:txBody>
+      </p:sp>
+      <p:sp>
+        <p:nvSpPr>
+          <p:cNvPr id="29" name="revised-text-22">
+            <a:extLst xmlns:a="http://schemas.openxmlformats.org/drawingml/2006/main">
+              <a:ext uri="{FF2B5EF4-FFF2-40B4-BE49-F238E27FC236}">
+                <a16:creationId xmlns:a16="http://schemas.microsoft.com/office/drawing/2014/main" id="{BAAD6C4B-4045-4D0B-8CBF-343783D884A7}"/>
+              </a:ext>
+            </a:extLst>
+          </p:cNvPr>
+          <p:cNvSpPr>
+            <a:spLocks xmlns:a="http://schemas.openxmlformats.org/drawingml/2006/main" noGrp="1"/>
+          </p:cNvSpPr>
+          <p:nvPr/>
+        </p:nvSpPr>
+        <p:spPr>
+          <a:xfrm xmlns:a="http://schemas.openxmlformats.org/drawingml/2006/main">
+            <a:off x="5086350" y="4467225"/>
+            <a:ext cx="6667500" cy="381000"/>
           </a:xfrm>
           <a:prstGeom xmlns:a="http://schemas.openxmlformats.org/drawingml/2006/main" prst="rect">
             <a:avLst/>
@@ -4889,29 +4908,29 @@
                 <a:ea typeface="Aptos"/>
                 <a:cs typeface="Aptos"/>
               </a:rPr>
-              <a:t>Scoped credentials</a:t>
-            </a:r>
-          </a:p>
-        </p:txBody>
-      </p:sp>
-      <p:sp>
-        <p:nvSpPr>
-          <p:cNvPr id="30" name="text-23">
-            <a:extLst xmlns:a="http://schemas.openxmlformats.org/drawingml/2006/main">
-              <a:ext uri="{FF2B5EF4-FFF2-40B4-BE49-F238E27FC236}">
-                <a16:creationId xmlns:a16="http://schemas.microsoft.com/office/drawing/2014/main" id="{84E2A371-A402-4CFF-B989-551B211A3998}"/>
-              </a:ext>
-            </a:extLst>
-          </p:cNvPr>
-          <p:cNvSpPr>
-            <a:spLocks xmlns:a="http://schemas.openxmlformats.org/drawingml/2006/main" noGrp="1"/>
-          </p:cNvSpPr>
-          <p:nvPr/>
-        </p:nvSpPr>
-        <p:spPr>
-          <a:xfrm xmlns:a="http://schemas.openxmlformats.org/drawingml/2006/main">
-            <a:off x="8991600" y="6858000"/>
-            <a:ext cx="5638800" cy="571500"/>
+              <a:t>Trusted adapters · scoped service access</a:t>
+            </a:r>
+          </a:p>
+        </p:txBody>
+      </p:sp>
+      <p:sp>
+        <p:nvSpPr>
+          <p:cNvPr id="30" name="revised-text-23">
+            <a:extLst xmlns:a="http://schemas.openxmlformats.org/drawingml/2006/main">
+              <a:ext uri="{FF2B5EF4-FFF2-40B4-BE49-F238E27FC236}">
+                <a16:creationId xmlns:a16="http://schemas.microsoft.com/office/drawing/2014/main" id="{35EC8245-B221-4F2C-BECD-363B393832AA}"/>
+              </a:ext>
+            </a:extLst>
+          </p:cNvPr>
+          <p:cNvSpPr>
+            <a:spLocks xmlns:a="http://schemas.openxmlformats.org/drawingml/2006/main" noGrp="1"/>
+          </p:cNvSpPr>
+          <p:nvPr/>
+        </p:nvSpPr>
+        <p:spPr>
+          <a:xfrm xmlns:a="http://schemas.openxmlformats.org/drawingml/2006/main">
+            <a:off x="609600" y="6629400"/>
+            <a:ext cx="4095750" cy="571500"/>
           </a:xfrm>
           <a:prstGeom xmlns:a="http://schemas.openxmlformats.org/drawingml/2006/main" prst="rect">
             <a:avLst/>
@@ -4956,7 +4975,277 @@
                 <a:ea typeface="Aptos"/>
                 <a:cs typeface="Aptos"/>
               </a:rPr>
-              <a:t>Grant specialist UI: optional</a:t>
+              <a:t>Logical ownership</a:t>
+            </a:r>
+          </a:p>
+          <a:p xmlns:a="http://schemas.openxmlformats.org/drawingml/2006/main">
+            <a:pPr>
+              <a:defRPr sz="1725" b="0">
+                <a:solidFill>
+                  <a:srgbClr val="49616A"/>
+                </a:solidFill>
+                <a:latin typeface="Aptos"/>
+                <a:ea typeface="Aptos"/>
+                <a:cs typeface="Aptos"/>
+              </a:defRPr>
+            </a:pPr>
+            <a:r>
+              <a:rPr sz="1725" b="0">
+                <a:solidFill>
+                  <a:srgbClr val="49616A"/>
+                </a:solidFill>
+                <a:latin typeface="Aptos"/>
+                <a:ea typeface="Aptos"/>
+                <a:cs typeface="Aptos"/>
+              </a:rPr>
+              <a:t>No separate DB servers implied</a:t>
+            </a:r>
+          </a:p>
+        </p:txBody>
+      </p:sp>
+      <p:sp>
+        <p:nvSpPr>
+          <p:cNvPr id="31" name="revised-text-24">
+            <a:extLst xmlns:a="http://schemas.openxmlformats.org/drawingml/2006/main">
+              <a:ext uri="{FF2B5EF4-FFF2-40B4-BE49-F238E27FC236}">
+                <a16:creationId xmlns:a16="http://schemas.microsoft.com/office/drawing/2014/main" id="{C578EEF8-D73B-469E-8DE6-325FA4AFCB3D}"/>
+              </a:ext>
+            </a:extLst>
+          </p:cNvPr>
+          <p:cNvSpPr>
+            <a:spLocks xmlns:a="http://schemas.openxmlformats.org/drawingml/2006/main" noGrp="1"/>
+          </p:cNvSpPr>
+          <p:nvPr/>
+        </p:nvSpPr>
+        <p:spPr>
+          <a:xfrm xmlns:a="http://schemas.openxmlformats.org/drawingml/2006/main">
+            <a:off x="5086350" y="6629400"/>
+            <a:ext cx="4857750" cy="571500"/>
+          </a:xfrm>
+          <a:prstGeom xmlns:a="http://schemas.openxmlformats.org/drawingml/2006/main" prst="rect">
+            <a:avLst/>
+          </a:prstGeom>
+          <a:noFill xmlns:a="http://schemas.openxmlformats.org/drawingml/2006/main"/>
+          <a:ln xmlns:a="http://schemas.openxmlformats.org/drawingml/2006/main" w="0">
+            <a:noFill/>
+            <a:prstDash val="solid"/>
+          </a:ln>
+        </p:spPr>
+        <p:txBody>
+          <a:bodyPr xmlns:a="http://schemas.openxmlformats.org/drawingml/2006/main" lIns="0" tIns="0" rIns="0" bIns="0" anchor="t"/>
+          <a:lstStyle xmlns:a="http://schemas.openxmlformats.org/drawingml/2006/main">
+            <a:defPPr>
+              <a:defRPr sz="1725" b="0">
+                <a:solidFill>
+                  <a:srgbClr val="49616A"/>
+                </a:solidFill>
+                <a:latin typeface="Aptos"/>
+                <a:ea typeface="Aptos"/>
+                <a:cs typeface="Aptos"/>
+              </a:defRPr>
+            </a:defPPr>
+          </a:lstStyle>
+          <a:p xmlns:a="http://schemas.openxmlformats.org/drawingml/2006/main">
+            <a:pPr>
+              <a:defRPr sz="1725" b="0">
+                <a:solidFill>
+                  <a:srgbClr val="49616A"/>
+                </a:solidFill>
+                <a:latin typeface="Aptos"/>
+                <a:ea typeface="Aptos"/>
+                <a:cs typeface="Aptos"/>
+              </a:defRPr>
+            </a:pPr>
+            <a:r>
+              <a:rPr sz="1725" b="0">
+                <a:solidFill>
+                  <a:srgbClr val="49616A"/>
+                </a:solidFill>
+                <a:latin typeface="Aptos"/>
+                <a:ea typeface="Aptos"/>
+                <a:cs typeface="Aptos"/>
+              </a:rPr>
+              <a:t>Provider capabilities: verify</a:t>
+            </a:r>
+          </a:p>
+          <a:p xmlns:a="http://schemas.openxmlformats.org/drawingml/2006/main">
+            <a:pPr>
+              <a:defRPr sz="1725" b="0">
+                <a:solidFill>
+                  <a:srgbClr val="49616A"/>
+                </a:solidFill>
+                <a:latin typeface="Aptos"/>
+                <a:ea typeface="Aptos"/>
+                <a:cs typeface="Aptos"/>
+              </a:defRPr>
+            </a:pPr>
+            <a:r>
+              <a:rPr sz="1725" b="0">
+                <a:solidFill>
+                  <a:srgbClr val="49616A"/>
+                </a:solidFill>
+                <a:latin typeface="Aptos"/>
+                <a:ea typeface="Aptos"/>
+                <a:cs typeface="Aptos"/>
+              </a:rPr>
+              <a:t>Funding + meeting domain schemas</a:t>
+            </a:r>
+          </a:p>
+        </p:txBody>
+      </p:sp>
+      <p:sp>
+        <p:nvSpPr>
+          <p:cNvPr id="32" name="revised-text-25">
+            <a:extLst xmlns:a="http://schemas.openxmlformats.org/drawingml/2006/main">
+              <a:ext uri="{FF2B5EF4-FFF2-40B4-BE49-F238E27FC236}">
+                <a16:creationId xmlns:a16="http://schemas.microsoft.com/office/drawing/2014/main" id="{C1889348-5DED-4CBE-AD66-010223BD8730}"/>
+              </a:ext>
+            </a:extLst>
+          </p:cNvPr>
+          <p:cNvSpPr>
+            <a:spLocks xmlns:a="http://schemas.openxmlformats.org/drawingml/2006/main" noGrp="1"/>
+          </p:cNvSpPr>
+          <p:nvPr/>
+        </p:nvSpPr>
+        <p:spPr>
+          <a:xfrm xmlns:a="http://schemas.openxmlformats.org/drawingml/2006/main">
+            <a:off x="10896600" y="6629400"/>
+            <a:ext cx="3733800" cy="571500"/>
+          </a:xfrm>
+          <a:prstGeom xmlns:a="http://schemas.openxmlformats.org/drawingml/2006/main" prst="rect">
+            <a:avLst/>
+          </a:prstGeom>
+          <a:noFill xmlns:a="http://schemas.openxmlformats.org/drawingml/2006/main"/>
+          <a:ln xmlns:a="http://schemas.openxmlformats.org/drawingml/2006/main" w="0">
+            <a:noFill/>
+            <a:prstDash val="solid"/>
+          </a:ln>
+        </p:spPr>
+        <p:txBody>
+          <a:bodyPr xmlns:a="http://schemas.openxmlformats.org/drawingml/2006/main" lIns="0" tIns="0" rIns="0" bIns="0" anchor="t"/>
+          <a:lstStyle xmlns:a="http://schemas.openxmlformats.org/drawingml/2006/main">
+            <a:defPPr>
+              <a:defRPr sz="1575" b="0">
+                <a:solidFill>
+                  <a:srgbClr val="49616A"/>
+                </a:solidFill>
+                <a:latin typeface="Aptos"/>
+                <a:ea typeface="Aptos"/>
+                <a:cs typeface="Aptos"/>
+              </a:defRPr>
+            </a:defPPr>
+          </a:lstStyle>
+          <a:p xmlns:a="http://schemas.openxmlformats.org/drawingml/2006/main">
+            <a:pPr>
+              <a:defRPr sz="1575" b="0">
+                <a:solidFill>
+                  <a:srgbClr val="49616A"/>
+                </a:solidFill>
+                <a:latin typeface="Aptos"/>
+                <a:ea typeface="Aptos"/>
+                <a:cs typeface="Aptos"/>
+              </a:defRPr>
+            </a:pPr>
+            <a:r>
+              <a:rPr sz="1575" b="0">
+                <a:solidFill>
+                  <a:srgbClr val="49616A"/>
+                </a:solidFill>
+                <a:latin typeface="Aptos"/>
+                <a:ea typeface="Aptos"/>
+                <a:cs typeface="Aptos"/>
+              </a:rPr>
+              <a:t>Funding / 990 / Y2</a:t>
+            </a:r>
+          </a:p>
+          <a:p xmlns:a="http://schemas.openxmlformats.org/drawingml/2006/main">
+            <a:pPr>
+              <a:defRPr sz="1575" b="0">
+                <a:solidFill>
+                  <a:srgbClr val="49616A"/>
+                </a:solidFill>
+                <a:latin typeface="Aptos"/>
+                <a:ea typeface="Aptos"/>
+                <a:cs typeface="Aptos"/>
+              </a:defRPr>
+            </a:pPr>
+            <a:r>
+              <a:rPr sz="1575" b="0">
+                <a:solidFill>
+                  <a:srgbClr val="49616A"/>
+                </a:solidFill>
+                <a:latin typeface="Aptos"/>
+                <a:ea typeface="Aptos"/>
+                <a:cs typeface="Aptos"/>
+              </a:rPr>
+              <a:t>Provenance + version + access filters</a:t>
+            </a:r>
+          </a:p>
+        </p:txBody>
+      </p:sp>
+      <p:sp>
+        <p:nvSpPr>
+          <p:cNvPr id="33" name="revised-text-26">
+            <a:extLst xmlns:a="http://schemas.openxmlformats.org/drawingml/2006/main">
+              <a:ext uri="{FF2B5EF4-FFF2-40B4-BE49-F238E27FC236}">
+                <a16:creationId xmlns:a16="http://schemas.microsoft.com/office/drawing/2014/main" id="{DC17FBDE-4347-494A-8CD6-C92D761F6CCE}"/>
+              </a:ext>
+            </a:extLst>
+          </p:cNvPr>
+          <p:cNvSpPr>
+            <a:spLocks xmlns:a="http://schemas.openxmlformats.org/drawingml/2006/main" noGrp="1"/>
+          </p:cNvSpPr>
+          <p:nvPr/>
+        </p:nvSpPr>
+        <p:spPr>
+          <a:xfrm xmlns:a="http://schemas.openxmlformats.org/drawingml/2006/main">
+            <a:off x="609600" y="7429500"/>
+            <a:ext cx="14020800" cy="323850"/>
+          </a:xfrm>
+          <a:prstGeom xmlns:a="http://schemas.openxmlformats.org/drawingml/2006/main" prst="rect">
+            <a:avLst/>
+          </a:prstGeom>
+          <a:noFill xmlns:a="http://schemas.openxmlformats.org/drawingml/2006/main"/>
+          <a:ln xmlns:a="http://schemas.openxmlformats.org/drawingml/2006/main" w="0">
+            <a:noFill/>
+            <a:prstDash val="solid"/>
+          </a:ln>
+        </p:spPr>
+        <p:txBody>
+          <a:bodyPr xmlns:a="http://schemas.openxmlformats.org/drawingml/2006/main" lIns="0" tIns="0" rIns="0" bIns="0" anchor="t"/>
+          <a:lstStyle xmlns:a="http://schemas.openxmlformats.org/drawingml/2006/main">
+            <a:defPPr>
+              <a:defRPr sz="1875" b="0">
+                <a:solidFill>
+                  <a:srgbClr val="916011"/>
+                </a:solidFill>
+                <a:latin typeface="Aptos"/>
+                <a:ea typeface="Aptos"/>
+                <a:cs typeface="Aptos"/>
+              </a:defRPr>
+            </a:defPPr>
+          </a:lstStyle>
+          <a:p xmlns:a="http://schemas.openxmlformats.org/drawingml/2006/main">
+            <a:pPr>
+              <a:defRPr sz="1875" b="0">
+                <a:solidFill>
+                  <a:srgbClr val="916011"/>
+                </a:solidFill>
+                <a:latin typeface="Aptos"/>
+                <a:ea typeface="Aptos"/>
+                <a:cs typeface="Aptos"/>
+              </a:defRPr>
+            </a:pPr>
+            <a:r>
+              <a:rPr sz="1875" b="0">
+                <a:solidFill>
+                  <a:srgbClr val="916011"/>
+                </a:solidFill>
+                <a:latin typeface="Aptos"/>
+                <a:ea typeface="Aptos"/>
+                <a:cs typeface="Aptos"/>
+              </a:rPr>
+              <a:t>Helix: optional demo projection. No fact, transaction, review or approval authority.</a:t>
             </a:r>
           </a:p>
         </p:txBody>
@@ -5347,7 +5636,7 @@
                 <a:ea typeface="Aptos"/>
                 <a:cs typeface="Aptos"/>
               </a:rPr>
-              <a:t>Inertia architecture · r11 · 23 October 2026</a:t>
+              <a:t>Inertia architecture · r12 · 23 October 2026</a:t>
             </a:r>
           </a:p>
         </p:txBody>
@@ -6556,7 +6845,7 @@
           <p:cNvPr id="28" name="">
             <a:extLst xmlns:a="http://schemas.openxmlformats.org/drawingml/2006/main">
               <a:ext uri="{FF2B5EF4-FFF2-40B4-BE49-F238E27FC236}">
-                <a16:creationId xmlns:a16="http://schemas.microsoft.com/office/drawing/2014/main" id="{4E1055AF-31A2-41C7-B11A-E380465E5EEF}"/>
+                <a16:creationId xmlns:a16="http://schemas.microsoft.com/office/drawing/2014/main" id="{980C90E1-8F7E-455E-BD51-05BEA4449865}"/>
               </a:ext>
             </a:extLst>
           </p:cNvPr>
@@ -6588,7 +6877,7 @@
           <p:cNvPr id="27" name="">
             <a:extLst xmlns:a="http://schemas.openxmlformats.org/drawingml/2006/main">
               <a:ext uri="{FF2B5EF4-FFF2-40B4-BE49-F238E27FC236}">
-                <a16:creationId xmlns:a16="http://schemas.microsoft.com/office/drawing/2014/main" id="{3C361D32-C11E-4C3D-8E08-F851AE586B25}"/>
+                <a16:creationId xmlns:a16="http://schemas.microsoft.com/office/drawing/2014/main" id="{782470C3-5B53-4B8D-999B-8D757B543B4C}"/>
               </a:ext>
             </a:extLst>
           </p:cNvPr>
@@ -6620,7 +6909,7 @@
           <p:cNvPr id="26" name="">
             <a:extLst xmlns:a="http://schemas.openxmlformats.org/drawingml/2006/main">
               <a:ext uri="{FF2B5EF4-FFF2-40B4-BE49-F238E27FC236}">
-                <a16:creationId xmlns:a16="http://schemas.microsoft.com/office/drawing/2014/main" id="{DB041CD1-F659-4594-9738-787D8D75C825}"/>
+                <a16:creationId xmlns:a16="http://schemas.microsoft.com/office/drawing/2014/main" id="{3CA08E8E-F0D5-425C-8EEC-3F2BB471DF49}"/>
               </a:ext>
             </a:extLst>
           </p:cNvPr>
@@ -6652,7 +6941,7 @@
           <p:cNvPr id="16" name="">
             <a:extLst xmlns:a="http://schemas.openxmlformats.org/drawingml/2006/main">
               <a:ext uri="{FF2B5EF4-FFF2-40B4-BE49-F238E27FC236}">
-                <a16:creationId xmlns:a16="http://schemas.microsoft.com/office/drawing/2014/main" id="{B05935B4-87A8-45C1-BBF0-B500B4D729D8}"/>
+                <a16:creationId xmlns:a16="http://schemas.microsoft.com/office/drawing/2014/main" id="{34B34925-812D-46B5-A647-E619D3AAE082}"/>
               </a:ext>
             </a:extLst>
           </p:cNvPr>
@@ -6684,7 +6973,7 @@
           <p:cNvPr id="15" name="">
             <a:extLst xmlns:a="http://schemas.openxmlformats.org/drawingml/2006/main">
               <a:ext uri="{FF2B5EF4-FFF2-40B4-BE49-F238E27FC236}">
-                <a16:creationId xmlns:a16="http://schemas.microsoft.com/office/drawing/2014/main" id="{34FCBDD2-046D-4E18-8ACC-D5CBD66984B2}"/>
+                <a16:creationId xmlns:a16="http://schemas.microsoft.com/office/drawing/2014/main" id="{8ED717A1-C84A-4660-861B-1FD5EC9657E6}"/>
               </a:ext>
             </a:extLst>
           </p:cNvPr>
@@ -6755,6 +7044,7 @@
           </a:lstStyle>
           <a:p xmlns:a="http://schemas.openxmlformats.org/drawingml/2006/main">
             <a:pPr>
+              <a:buNone/>
               <a:defRPr sz="3600" b="1">
                 <a:solidFill>
                   <a:srgbClr val="132E38"/>
@@ -6822,6 +7112,7 @@
           </a:lstStyle>
           <a:p xmlns:a="http://schemas.openxmlformats.org/drawingml/2006/main">
             <a:pPr>
+              <a:buNone/>
               <a:defRPr sz="2025" b="0">
                 <a:solidFill>
                   <a:srgbClr val="49616A"/>
@@ -6840,7 +7131,7 @@
                 <a:ea typeface="Aptos"/>
                 <a:cs typeface="Aptos"/>
               </a:rPr>
-              <a:t>Target flow</a:t>
+              <a:t>Target flow · existing DAO PostgreSQL / meeting schema</a:t>
             </a:r>
           </a:p>
         </p:txBody>
@@ -6919,6 +7210,7 @@
           </a:lstStyle>
           <a:p xmlns:a="http://schemas.openxmlformats.org/drawingml/2006/main">
             <a:pPr>
+              <a:buNone/>
               <a:defRPr sz="1350" b="0">
                 <a:solidFill>
                   <a:srgbClr val="49616A"/>
@@ -6937,7 +7229,7 @@
                 <a:ea typeface="Aptos"/>
                 <a:cs typeface="Aptos"/>
               </a:rPr>
-              <a:t>Inertia architecture · r11 · 23 October 2026</a:t>
+              <a:t>Inertia architecture · r12 · 23 October 2026</a:t>
             </a:r>
           </a:p>
         </p:txBody>
@@ -6986,6 +7278,7 @@
           </a:lstStyle>
           <a:p xmlns:a="http://schemas.openxmlformats.org/drawingml/2006/main">
             <a:pPr>
+              <a:buNone/>
               <a:defRPr sz="1650" b="1">
                 <a:solidFill>
                   <a:srgbClr val="157D80"/>
@@ -7086,6 +7379,7 @@
           </a:lstStyle>
           <a:p xmlns:a="http://schemas.openxmlformats.org/drawingml/2006/main">
             <a:pPr>
+              <a:buNone/>
               <a:defRPr sz="2250" b="1">
                 <a:solidFill>
                   <a:srgbClr val="132E38"/>
@@ -7153,6 +7447,7 @@
           </a:lstStyle>
           <a:p xmlns:a="http://schemas.openxmlformats.org/drawingml/2006/main">
             <a:pPr>
+              <a:buNone/>
               <a:defRPr sz="1875" b="0">
                 <a:solidFill>
                   <a:srgbClr val="49616A"/>
@@ -7253,6 +7548,7 @@
           </a:lstStyle>
           <a:p xmlns:a="http://schemas.openxmlformats.org/drawingml/2006/main">
             <a:pPr>
+              <a:buNone/>
               <a:defRPr sz="2250" b="1">
                 <a:solidFill>
                   <a:srgbClr val="157D80"/>
@@ -7320,6 +7616,7 @@
           </a:lstStyle>
           <a:p xmlns:a="http://schemas.openxmlformats.org/drawingml/2006/main">
             <a:pPr>
+              <a:buNone/>
               <a:defRPr sz="1875" b="0">
                 <a:solidFill>
                   <a:srgbClr val="49616A"/>
@@ -7420,6 +7717,7 @@
           </a:lstStyle>
           <a:p xmlns:a="http://schemas.openxmlformats.org/drawingml/2006/main">
             <a:pPr>
+              <a:buNone/>
               <a:defRPr sz="2250" b="1">
                 <a:solidFill>
                   <a:srgbClr val="132E38"/>
@@ -7487,6 +7785,7 @@
           </a:lstStyle>
           <a:p xmlns:a="http://schemas.openxmlformats.org/drawingml/2006/main">
             <a:pPr>
+              <a:buNone/>
               <a:defRPr sz="1875" b="0">
                 <a:solidFill>
                   <a:srgbClr val="49616A"/>
@@ -7587,6 +7886,7 @@
           </a:lstStyle>
           <a:p xmlns:a="http://schemas.openxmlformats.org/drawingml/2006/main">
             <a:pPr>
+              <a:buNone/>
               <a:defRPr sz="2250" b="1">
                 <a:solidFill>
                   <a:srgbClr val="157D80"/>
@@ -7654,6 +7954,7 @@
           </a:lstStyle>
           <a:p xmlns:a="http://schemas.openxmlformats.org/drawingml/2006/main">
             <a:pPr>
+              <a:buNone/>
               <a:defRPr sz="1875" b="0">
                 <a:solidFill>
                   <a:srgbClr val="49616A"/>
@@ -7754,6 +8055,7 @@
           </a:lstStyle>
           <a:p xmlns:a="http://schemas.openxmlformats.org/drawingml/2006/main">
             <a:pPr>
+              <a:buNone/>
               <a:defRPr sz="2250" b="1">
                 <a:solidFill>
                   <a:srgbClr val="132E38"/>
@@ -7821,6 +8123,7 @@
           </a:lstStyle>
           <a:p xmlns:a="http://schemas.openxmlformats.org/drawingml/2006/main">
             <a:pPr>
+              <a:buNone/>
               <a:defRPr sz="1875" b="0">
                 <a:solidFill>
                   <a:srgbClr val="49616A"/>
@@ -7839,7 +8142,7 @@
                 <a:ea typeface="Aptos"/>
                 <a:cs typeface="Aptos"/>
               </a:rPr>
-              <a:t>Active-membership authorization</a:t>
+              <a:t>Member ACL + meeting schema target</a:t>
             </a:r>
           </a:p>
         </p:txBody>
@@ -7921,6 +8224,7 @@
           </a:lstStyle>
           <a:p xmlns:a="http://schemas.openxmlformats.org/drawingml/2006/main">
             <a:pPr>
+              <a:buNone/>
               <a:defRPr sz="2250" b="1">
                 <a:solidFill>
                   <a:srgbClr val="132E38"/>
@@ -7988,6 +8292,7 @@
           </a:lstStyle>
           <a:p xmlns:a="http://schemas.openxmlformats.org/drawingml/2006/main">
             <a:pPr>
+              <a:buNone/>
               <a:defRPr sz="1875" b="0">
                 <a:solidFill>
                   <a:srgbClr val="49616A"/>
@@ -8055,6 +8360,7 @@
           </a:lstStyle>
           <a:p xmlns:a="http://schemas.openxmlformats.org/drawingml/2006/main">
             <a:pPr>
+              <a:buNone/>
               <a:defRPr sz="1725" b="0">
                 <a:solidFill>
                   <a:srgbClr val="49616A"/>
@@ -8112,7 +8418,7 @@
           <p:cNvPr id="31" name="">
             <a:extLst xmlns:a="http://schemas.openxmlformats.org/drawingml/2006/main">
               <a:ext uri="{FF2B5EF4-FFF2-40B4-BE49-F238E27FC236}">
-                <a16:creationId xmlns:a16="http://schemas.microsoft.com/office/drawing/2014/main" id="{C653D1C8-7E09-4C7D-9481-8CC3FCA81A52}"/>
+                <a16:creationId xmlns:a16="http://schemas.microsoft.com/office/drawing/2014/main" id="{E04CA699-12DE-4EB3-A909-FB245B95BDD5}"/>
               </a:ext>
             </a:extLst>
           </p:cNvPr>
@@ -8144,7 +8450,7 @@
           <p:cNvPr id="30" name="">
             <a:extLst xmlns:a="http://schemas.openxmlformats.org/drawingml/2006/main">
               <a:ext uri="{FF2B5EF4-FFF2-40B4-BE49-F238E27FC236}">
-                <a16:creationId xmlns:a16="http://schemas.microsoft.com/office/drawing/2014/main" id="{5C41840E-98F7-41B9-B187-802DF2A53EB2}"/>
+                <a16:creationId xmlns:a16="http://schemas.microsoft.com/office/drawing/2014/main" id="{5394FC92-4FC0-4564-BAED-A2B6274A82DA}"/>
               </a:ext>
             </a:extLst>
           </p:cNvPr>
@@ -8176,7 +8482,7 @@
           <p:cNvPr id="29" name="">
             <a:extLst xmlns:a="http://schemas.openxmlformats.org/drawingml/2006/main">
               <a:ext uri="{FF2B5EF4-FFF2-40B4-BE49-F238E27FC236}">
-                <a16:creationId xmlns:a16="http://schemas.microsoft.com/office/drawing/2014/main" id="{6ABB7A19-96AC-4CA6-8A20-0A2823048D97}"/>
+                <a16:creationId xmlns:a16="http://schemas.microsoft.com/office/drawing/2014/main" id="{8C7059F8-1D98-4019-A990-C648261D160F}"/>
               </a:ext>
             </a:extLst>
           </p:cNvPr>
@@ -8208,7 +8514,7 @@
           <p:cNvPr id="16" name="">
             <a:extLst xmlns:a="http://schemas.openxmlformats.org/drawingml/2006/main">
               <a:ext uri="{FF2B5EF4-FFF2-40B4-BE49-F238E27FC236}">
-                <a16:creationId xmlns:a16="http://schemas.microsoft.com/office/drawing/2014/main" id="{F04BF26C-4A08-4773-B43B-E56C0DDF3D5B}"/>
+                <a16:creationId xmlns:a16="http://schemas.microsoft.com/office/drawing/2014/main" id="{DD07D8A8-748F-4F3B-8965-2AE6FAA170A0}"/>
               </a:ext>
             </a:extLst>
           </p:cNvPr>
@@ -8240,7 +8546,7 @@
           <p:cNvPr id="15" name="">
             <a:extLst xmlns:a="http://schemas.openxmlformats.org/drawingml/2006/main">
               <a:ext uri="{FF2B5EF4-FFF2-40B4-BE49-F238E27FC236}">
-                <a16:creationId xmlns:a16="http://schemas.microsoft.com/office/drawing/2014/main" id="{DFFCB739-67CF-4827-916B-49EA2CC13DE1}"/>
+                <a16:creationId xmlns:a16="http://schemas.microsoft.com/office/drawing/2014/main" id="{1ED811AC-047E-4D52-B3B5-AD7369AB142B}"/>
               </a:ext>
             </a:extLst>
           </p:cNvPr>
@@ -8311,6 +8617,7 @@
           </a:lstStyle>
           <a:p xmlns:a="http://schemas.openxmlformats.org/drawingml/2006/main">
             <a:pPr>
+              <a:buNone/>
               <a:defRPr sz="3600" b="1">
                 <a:solidFill>
                   <a:srgbClr val="132E38"/>
@@ -8378,6 +8685,7 @@
           </a:lstStyle>
           <a:p xmlns:a="http://schemas.openxmlformats.org/drawingml/2006/main">
             <a:pPr>
+              <a:buNone/>
               <a:defRPr sz="2025" b="0">
                 <a:solidFill>
                   <a:srgbClr val="49616A"/>
@@ -8475,6 +8783,7 @@
           </a:lstStyle>
           <a:p xmlns:a="http://schemas.openxmlformats.org/drawingml/2006/main">
             <a:pPr>
+              <a:buNone/>
               <a:defRPr sz="1350" b="0">
                 <a:solidFill>
                   <a:srgbClr val="49616A"/>
@@ -8493,7 +8802,7 @@
                 <a:ea typeface="Aptos"/>
                 <a:cs typeface="Aptos"/>
               </a:rPr>
-              <a:t>Inertia architecture · r11 · 23 October 2026</a:t>
+              <a:t>Inertia architecture · r12 · 23 October 2026</a:t>
             </a:r>
           </a:p>
         </p:txBody>
@@ -8542,6 +8851,7 @@
           </a:lstStyle>
           <a:p xmlns:a="http://schemas.openxmlformats.org/drawingml/2006/main">
             <a:pPr>
+              <a:buNone/>
               <a:defRPr sz="1650" b="1">
                 <a:solidFill>
                   <a:srgbClr val="157D80"/>
@@ -8642,6 +8952,7 @@
           </a:lstStyle>
           <a:p xmlns:a="http://schemas.openxmlformats.org/drawingml/2006/main">
             <a:pPr>
+              <a:buNone/>
               <a:defRPr sz="2250" b="1">
                 <a:solidFill>
                   <a:srgbClr val="132E38"/>
@@ -8709,6 +9020,7 @@
           </a:lstStyle>
           <a:p xmlns:a="http://schemas.openxmlformats.org/drawingml/2006/main">
             <a:pPr>
+              <a:buNone/>
               <a:defRPr sz="1875" b="0">
                 <a:solidFill>
                   <a:srgbClr val="49616A"/>
@@ -8809,6 +9121,7 @@
           </a:lstStyle>
           <a:p xmlns:a="http://schemas.openxmlformats.org/drawingml/2006/main">
             <a:pPr>
+              <a:buNone/>
               <a:defRPr sz="2250" b="1">
                 <a:solidFill>
                   <a:srgbClr val="157D80"/>
@@ -8876,6 +9189,7 @@
           </a:lstStyle>
           <a:p xmlns:a="http://schemas.openxmlformats.org/drawingml/2006/main">
             <a:pPr>
+              <a:buNone/>
               <a:defRPr sz="1875" b="0">
                 <a:solidFill>
                   <a:srgbClr val="49616A"/>
@@ -8976,6 +9290,7 @@
           </a:lstStyle>
           <a:p xmlns:a="http://schemas.openxmlformats.org/drawingml/2006/main">
             <a:pPr>
+              <a:buNone/>
               <a:defRPr sz="2250" b="1">
                 <a:solidFill>
                   <a:srgbClr val="132E38"/>
@@ -9043,6 +9358,7 @@
           </a:lstStyle>
           <a:p xmlns:a="http://schemas.openxmlformats.org/drawingml/2006/main">
             <a:pPr>
+              <a:buNone/>
               <a:defRPr sz="1875" b="0">
                 <a:solidFill>
                   <a:srgbClr val="49616A"/>
@@ -9110,6 +9426,7 @@
           </a:lstStyle>
           <a:p xmlns:a="http://schemas.openxmlformats.org/drawingml/2006/main">
             <a:pPr>
+              <a:buNone/>
               <a:defRPr sz="1725" b="0">
                 <a:solidFill>
                   <a:srgbClr val="49616A"/>
@@ -9177,6 +9494,7 @@
           </a:lstStyle>
           <a:p xmlns:a="http://schemas.openxmlformats.org/drawingml/2006/main">
             <a:pPr>
+              <a:buNone/>
               <a:defRPr sz="1725" b="0">
                 <a:solidFill>
                   <a:srgbClr val="49616A"/>
@@ -9244,6 +9562,7 @@
           </a:lstStyle>
           <a:p xmlns:a="http://schemas.openxmlformats.org/drawingml/2006/main">
             <a:pPr>
+              <a:buNone/>
               <a:defRPr sz="1725" b="0">
                 <a:solidFill>
                   <a:srgbClr val="49616A"/>
@@ -9267,6 +9586,7 @@
           </a:p>
           <a:p xmlns:a="http://schemas.openxmlformats.org/drawingml/2006/main">
             <a:pPr>
+              <a:buNone/>
               <a:defRPr sz="1725" b="0">
                 <a:solidFill>
                   <a:srgbClr val="49616A"/>
@@ -9367,6 +9687,7 @@
           </a:lstStyle>
           <a:p xmlns:a="http://schemas.openxmlformats.org/drawingml/2006/main">
             <a:pPr>
+              <a:buNone/>
               <a:defRPr sz="2250" b="1">
                 <a:solidFill>
                   <a:srgbClr val="132E38"/>
@@ -9385,7 +9706,7 @@
                 <a:ea typeface="Aptos"/>
                 <a:cs typeface="Aptos"/>
               </a:rPr>
-              <a:t>Funding domain</a:t>
+              <a:t>Funding backend</a:t>
             </a:r>
           </a:p>
         </p:txBody>
@@ -9434,6 +9755,7 @@
           </a:lstStyle>
           <a:p xmlns:a="http://schemas.openxmlformats.org/drawingml/2006/main">
             <a:pPr>
+              <a:buNone/>
               <a:defRPr sz="1875" b="0">
                 <a:solidFill>
                   <a:srgbClr val="49616A"/>
@@ -9452,7 +9774,7 @@
                 <a:ea typeface="Aptos"/>
                 <a:cs typeface="Aptos"/>
               </a:rPr>
-              <a:t>Evidence + proposals + audit</a:t>
+              <a:t>DAO funding schema · target</a:t>
             </a:r>
           </a:p>
         </p:txBody>
@@ -9534,6 +9856,7 @@
           </a:lstStyle>
           <a:p xmlns:a="http://schemas.openxmlformats.org/drawingml/2006/main">
             <a:pPr>
+              <a:buNone/>
               <a:defRPr sz="2250" b="1">
                 <a:solidFill>
                   <a:srgbClr val="157D80"/>
@@ -9601,6 +9924,7 @@
           </a:lstStyle>
           <a:p xmlns:a="http://schemas.openxmlformats.org/drawingml/2006/main">
             <a:pPr>
+              <a:buNone/>
               <a:defRPr sz="1875" b="0">
                 <a:solidFill>
                   <a:srgbClr val="49616A"/>
@@ -9624,6 +9948,7 @@
           </a:p>
           <a:p xmlns:a="http://schemas.openxmlformats.org/drawingml/2006/main">
             <a:pPr>
+              <a:buNone/>
               <a:defRPr sz="1875" b="0">
                 <a:solidFill>
                   <a:srgbClr val="49616A"/>
@@ -9724,6 +10049,7 @@
           </a:lstStyle>
           <a:p xmlns:a="http://schemas.openxmlformats.org/drawingml/2006/main">
             <a:pPr>
+              <a:buNone/>
               <a:defRPr sz="2250" b="1">
                 <a:solidFill>
                   <a:srgbClr val="157D80"/>
@@ -9791,6 +10117,7 @@
           </a:lstStyle>
           <a:p xmlns:a="http://schemas.openxmlformats.org/drawingml/2006/main">
             <a:pPr>
+              <a:buNone/>
               <a:defRPr sz="1875" b="0">
                 <a:solidFill>
                   <a:srgbClr val="49616A"/>
@@ -9858,6 +10185,7 @@
           </a:lstStyle>
           <a:p xmlns:a="http://schemas.openxmlformats.org/drawingml/2006/main">
             <a:pPr>
+              <a:buNone/>
               <a:defRPr sz="2025" b="0">
                 <a:solidFill>
                   <a:srgbClr val="916011"/>
@@ -10264,7 +10592,7 @@
                 <a:ea typeface="Aptos"/>
                 <a:cs typeface="Aptos"/>
               </a:rPr>
-              <a:t>Inertia architecture · r11 · 23 October 2026</a:t>
+              <a:t>Inertia architecture · r12 · 23 October 2026</a:t>
             </a:r>
           </a:p>
         </p:txBody>
@@ -11810,7 +12138,7 @@
                 <a:ea typeface="Aptos"/>
                 <a:cs typeface="Aptos"/>
               </a:rPr>
-              <a:t>Inertia architecture · r11 · 23 October 2026</a:t>
+              <a:t>Inertia architecture · r12 · 23 October 2026</a:t>
             </a:r>
           </a:p>
         </p:txBody>
@@ -13270,7 +13598,7 @@
                 <a:ea typeface="Aptos"/>
                 <a:cs typeface="Aptos"/>
               </a:rPr>
-              <a:t>Inertia architecture · r11 · 23 October 2026</a:t>
+              <a:t>Inertia architecture · r12 · 23 October 2026</a:t>
             </a:r>
           </a:p>
         </p:txBody>
@@ -14443,7 +14771,7 @@
           <p:cNvPr id="16" name="">
             <a:extLst xmlns:a="http://schemas.openxmlformats.org/drawingml/2006/main">
               <a:ext uri="{FF2B5EF4-FFF2-40B4-BE49-F238E27FC236}">
-                <a16:creationId xmlns:a16="http://schemas.microsoft.com/office/drawing/2014/main" id="{43BB7F43-259C-4F8C-B78A-02E88EB30B03}"/>
+                <a16:creationId xmlns:a16="http://schemas.microsoft.com/office/drawing/2014/main" id="{AADE179F-57CD-456F-993E-74C07E53BE47}"/>
               </a:ext>
             </a:extLst>
           </p:cNvPr>
@@ -14475,7 +14803,7 @@
           <p:cNvPr id="15" name="">
             <a:extLst xmlns:a="http://schemas.openxmlformats.org/drawingml/2006/main">
               <a:ext uri="{FF2B5EF4-FFF2-40B4-BE49-F238E27FC236}">
-                <a16:creationId xmlns:a16="http://schemas.microsoft.com/office/drawing/2014/main" id="{FA033646-FF1C-405B-B290-7854A24C2A6E}"/>
+                <a16:creationId xmlns:a16="http://schemas.microsoft.com/office/drawing/2014/main" id="{78841D45-5CB9-4501-B161-7E58798E405D}"/>
               </a:ext>
             </a:extLst>
           </p:cNvPr>
@@ -14546,6 +14874,7 @@
           </a:lstStyle>
           <a:p xmlns:a="http://schemas.openxmlformats.org/drawingml/2006/main">
             <a:pPr>
+              <a:buNone/>
               <a:defRPr sz="3600" b="1">
                 <a:solidFill>
                   <a:srgbClr val="132E38"/>
@@ -14613,6 +14942,7 @@
           </a:lstStyle>
           <a:p xmlns:a="http://schemas.openxmlformats.org/drawingml/2006/main">
             <a:pPr>
+              <a:buNone/>
               <a:defRPr sz="2025" b="0">
                 <a:solidFill>
                   <a:srgbClr val="49616A"/>
@@ -14631,7 +14961,7 @@
                 <a:ea typeface="Aptos"/>
                 <a:cs typeface="Aptos"/>
               </a:rPr>
-              <a:t>Pending acceptance</a:t>
+              <a:t>Pending acceptance · Helix remains optional</a:t>
             </a:r>
           </a:p>
         </p:txBody>
@@ -14710,6 +15040,7 @@
           </a:lstStyle>
           <a:p xmlns:a="http://schemas.openxmlformats.org/drawingml/2006/main">
             <a:pPr>
+              <a:buNone/>
               <a:defRPr sz="1350" b="0">
                 <a:solidFill>
                   <a:srgbClr val="49616A"/>
@@ -14728,7 +15059,7 @@
                 <a:ea typeface="Aptos"/>
                 <a:cs typeface="Aptos"/>
               </a:rPr>
-              <a:t>Inertia architecture · r11 · 23 October 2026</a:t>
+              <a:t>Inertia architecture · r12 · 23 October 2026</a:t>
             </a:r>
           </a:p>
         </p:txBody>
@@ -14777,6 +15108,7 @@
           </a:lstStyle>
           <a:p xmlns:a="http://schemas.openxmlformats.org/drawingml/2006/main">
             <a:pPr>
+              <a:buNone/>
               <a:defRPr sz="1650" b="1">
                 <a:solidFill>
                   <a:srgbClr val="157D80"/>
@@ -14877,6 +15209,7 @@
           </a:lstStyle>
           <a:p xmlns:a="http://schemas.openxmlformats.org/drawingml/2006/main">
             <a:pPr>
+              <a:buNone/>
               <a:defRPr sz="2250" b="1">
                 <a:solidFill>
                   <a:srgbClr val="132E38"/>
@@ -14944,6 +15277,7 @@
           </a:lstStyle>
           <a:p xmlns:a="http://schemas.openxmlformats.org/drawingml/2006/main">
             <a:pPr>
+              <a:buNone/>
               <a:defRPr sz="1875" b="0">
                 <a:solidFill>
                   <a:srgbClr val="49616A"/>
@@ -14962,7 +15296,7 @@
                 <a:ea typeface="Aptos"/>
                 <a:cs typeface="Aptos"/>
               </a:rPr>
-              <a:t>Database + backup recovery</a:t>
+              <a:t>Paperclip DB + backup recovery</a:t>
             </a:r>
           </a:p>
         </p:txBody>
@@ -15044,6 +15378,7 @@
           </a:lstStyle>
           <a:p xmlns:a="http://schemas.openxmlformats.org/drawingml/2006/main">
             <a:pPr>
+              <a:buNone/>
               <a:defRPr sz="2250" b="1">
                 <a:solidFill>
                   <a:srgbClr val="132E38"/>
@@ -15111,6 +15446,7 @@
           </a:lstStyle>
           <a:p xmlns:a="http://schemas.openxmlformats.org/drawingml/2006/main">
             <a:pPr>
+              <a:buNone/>
               <a:defRPr sz="1875" b="0">
                 <a:solidFill>
                   <a:srgbClr val="49616A"/>
@@ -15211,6 +15547,7 @@
           </a:lstStyle>
           <a:p xmlns:a="http://schemas.openxmlformats.org/drawingml/2006/main">
             <a:pPr>
+              <a:buNone/>
               <a:defRPr sz="2250" b="1">
                 <a:solidFill>
                   <a:srgbClr val="132E38"/>
@@ -15278,6 +15615,7 @@
           </a:lstStyle>
           <a:p xmlns:a="http://schemas.openxmlformats.org/drawingml/2006/main">
             <a:pPr>
+              <a:buNone/>
               <a:defRPr sz="1875" b="0">
                 <a:solidFill>
                   <a:srgbClr val="49616A"/>
@@ -15375,6 +15713,7 @@
           </a:lstStyle>
           <a:p xmlns:a="http://schemas.openxmlformats.org/drawingml/2006/main">
             <a:pPr>
+              <a:buNone/>
               <a:defRPr sz="2025" b="1">
                 <a:solidFill>
                   <a:srgbClr val="157D80"/>
@@ -15442,6 +15781,7 @@
           </a:lstStyle>
           <a:p xmlns:a="http://schemas.openxmlformats.org/drawingml/2006/main">
             <a:pPr>
+              <a:buNone/>
               <a:defRPr sz="2025" b="1">
                 <a:solidFill>
                   <a:srgbClr val="157D80"/>
@@ -15509,6 +15849,7 @@
           </a:lstStyle>
           <a:p xmlns:a="http://schemas.openxmlformats.org/drawingml/2006/main">
             <a:pPr>
+              <a:buNone/>
               <a:defRPr sz="2025" b="1">
                 <a:solidFill>
                   <a:srgbClr val="132E38"/>
@@ -15576,6 +15917,7 @@
           </a:lstStyle>
           <a:p xmlns:a="http://schemas.openxmlformats.org/drawingml/2006/main">
             <a:pPr>
+              <a:buNone/>
               <a:defRPr sz="2025" b="0">
                 <a:solidFill>
                   <a:srgbClr val="132E38"/>
@@ -15643,6 +15985,7 @@
           </a:lstStyle>
           <a:p xmlns:a="http://schemas.openxmlformats.org/drawingml/2006/main">
             <a:pPr>
+              <a:buNone/>
               <a:defRPr sz="2025" b="1">
                 <a:solidFill>
                   <a:srgbClr val="132E38"/>
@@ -15710,6 +16053,7 @@
           </a:lstStyle>
           <a:p xmlns:a="http://schemas.openxmlformats.org/drawingml/2006/main">
             <a:pPr>
+              <a:buNone/>
               <a:defRPr sz="2025" b="0">
                 <a:solidFill>
                   <a:srgbClr val="132E38"/>
@@ -15777,6 +16121,7 @@
           </a:lstStyle>
           <a:p xmlns:a="http://schemas.openxmlformats.org/drawingml/2006/main">
             <a:pPr>
+              <a:buNone/>
               <a:defRPr sz="2025" b="1">
                 <a:solidFill>
                   <a:srgbClr val="132E38"/>
@@ -15844,6 +16189,7 @@
           </a:lstStyle>
           <a:p xmlns:a="http://schemas.openxmlformats.org/drawingml/2006/main">
             <a:pPr>
+              <a:buNone/>
               <a:defRPr sz="2025" b="0">
                 <a:solidFill>
                   <a:srgbClr val="132E38"/>
@@ -15911,6 +16257,7 @@
           </a:lstStyle>
           <a:p xmlns:a="http://schemas.openxmlformats.org/drawingml/2006/main">
             <a:pPr>
+              <a:buNone/>
               <a:defRPr sz="2025" b="1">
                 <a:solidFill>
                   <a:srgbClr val="132E38"/>
@@ -15978,6 +16325,7 @@
           </a:lstStyle>
           <a:p xmlns:a="http://schemas.openxmlformats.org/drawingml/2006/main">
             <a:pPr>
+              <a:buNone/>
               <a:defRPr sz="2025" b="0">
                 <a:solidFill>
                   <a:srgbClr val="132E38"/>
@@ -15997,6 +16345,73 @@
                 <a:cs typeface="Aptos"/>
               </a:rPr>
               <a:t>Interest mapping and deduplicated follow-up</a:t>
+            </a:r>
+          </a:p>
+        </p:txBody>
+      </p:sp>
+      <p:sp>
+        <p:nvSpPr>
+          <p:cNvPr id="29" name="revised-text-27">
+            <a:extLst xmlns:a="http://schemas.openxmlformats.org/drawingml/2006/main">
+              <a:ext uri="{FF2B5EF4-FFF2-40B4-BE49-F238E27FC236}">
+                <a16:creationId xmlns:a16="http://schemas.microsoft.com/office/drawing/2014/main" id="{E2A23C23-C15B-4ACE-A9EA-033C6234DA84}"/>
+              </a:ext>
+            </a:extLst>
+          </p:cNvPr>
+          <p:cNvSpPr>
+            <a:spLocks xmlns:a="http://schemas.openxmlformats.org/drawingml/2006/main" noGrp="1"/>
+          </p:cNvSpPr>
+          <p:nvPr/>
+        </p:nvSpPr>
+        <p:spPr>
+          <a:xfrm xmlns:a="http://schemas.openxmlformats.org/drawingml/2006/main">
+            <a:off x="609600" y="7600950"/>
+            <a:ext cx="14020800" cy="257175"/>
+          </a:xfrm>
+          <a:prstGeom xmlns:a="http://schemas.openxmlformats.org/drawingml/2006/main" prst="rect">
+            <a:avLst/>
+          </a:prstGeom>
+          <a:noFill xmlns:a="http://schemas.openxmlformats.org/drawingml/2006/main"/>
+          <a:ln xmlns:a="http://schemas.openxmlformats.org/drawingml/2006/main" w="0">
+            <a:noFill/>
+            <a:prstDash val="solid"/>
+          </a:ln>
+        </p:spPr>
+        <p:txBody>
+          <a:bodyPr xmlns:a="http://schemas.openxmlformats.org/drawingml/2006/main" lIns="0" tIns="0" rIns="0" bIns="0" anchor="t"/>
+          <a:lstStyle xmlns:a="http://schemas.openxmlformats.org/drawingml/2006/main">
+            <a:defPPr>
+              <a:defRPr sz="1575" b="0">
+                <a:solidFill>
+                  <a:srgbClr val="49616A"/>
+                </a:solidFill>
+                <a:latin typeface="Aptos"/>
+                <a:ea typeface="Aptos"/>
+                <a:cs typeface="Aptos"/>
+              </a:defRPr>
+            </a:defPPr>
+          </a:lstStyle>
+          <a:p xmlns:a="http://schemas.openxmlformats.org/drawingml/2006/main">
+            <a:pPr>
+              <a:defRPr sz="1575" b="0">
+                <a:solidFill>
+                  <a:srgbClr val="49616A"/>
+                </a:solidFill>
+                <a:latin typeface="Aptos"/>
+                <a:ea typeface="Aptos"/>
+                <a:cs typeface="Aptos"/>
+              </a:defRPr>
+            </a:pPr>
+            <a:r>
+              <a:rPr sz="1575" b="0">
+                <a:solidFill>
+                  <a:srgbClr val="49616A"/>
+                </a:solidFill>
+                <a:latin typeface="Aptos"/>
+                <a:ea typeface="Aptos"/>
+                <a:cs typeface="Aptos"/>
+              </a:rPr>
+              <a:t>DAO schemas + roles: verify provider support. Helix adds no demo dependency.</a:t>
             </a:r>
           </a:p>
         </p:txBody>

</xml_diff>

<commit_message>
docs: consolidate DAO PostgreSQL and Helix data architecture (r12) (#22)
</commit_message>
<xml_diff>
--- a/Inertia-Architecture.pptx
+++ b/Inertia-Architecture.pptx
@@ -449,7 +449,7 @@
           <a:lstStyle xmlns:a="http://schemas.openxmlformats.org/drawingml/2006/main"/>
           <a:p xmlns:a="http://schemas.openxmlformats.org/drawingml/2006/main">
             <a:r>
-              <a:t>Paperclip owns identity/hierarchy, issues, dependencies, assignment, run admission, checkout, workflow decisions, documents, budgets and audit. Buzz uses the same native IDs via signed transport. Trusted domain adapters hold scoped external-write credentials. Paperclip PostgreSQL stores work state; DAO PlanetScale PostgreSQL and the funding domain store remain their respective sources of record. Native Paperclip agents run the shared grant skills and CLI/MCP using task-scoped data. Funding persistence retains evidence, proposals, immutable packets and review audit. A trusted decision adapter is planned, not a current MCP capability. A specialist funding UI is optional, not an export prerequisite. Cloudflare hosting/access/transport is optional. Live integration acceptance is pending.</a:t>
+              <a:t>Paperclip owns identity/hierarchy, issues, dependencies, assignment, run admission, checkout, workflow decisions, documents, budgets and audit. Buzz uses the same native IDs via signed transport. Trusted domain adapters hold scoped external-write credentials. Paperclip keeps its independent native PostgreSQL database. The target reuses one existing DAO managed PostgreSQL relational database for funding and meeting information alongside organization facts, with isolated domain schemas and least-privilege service roles, subject to provider capability verification. Logical backend ownership does not imply separate database servers. Helix is ultimately a separate, specialized graph/vector projection across funding, 990 and Y2. Projections must be rebuildable, provenance- and version-aware, and access-filtered. Helix is never the authority for facts, transactions, reviews, approvals or governance. Include Helix in a demo only if needed, with no new critical-path dependency. This design update changes no runtime or migrations. Native Paperclip agents run the shared grant skills and CLI/MCP using task-scoped data. Funding persistence retains evidence, proposals, immutable packets and review audit. A trusted decision adapter is planned, not a current MCP capability. A specialist funding UI is optional, not an export prerequisite. Cloudflare hosting/access/transport is optional. Live integration acceptance is pending.</a:t>
             </a:r>
           </a:p>
           <a:p xmlns:a="http://schemas.openxmlformats.org/drawingml/2006/main">
@@ -465,6 +465,11 @@
           <a:p xmlns:a="http://schemas.openxmlformats.org/drawingml/2006/main">
             <a:r>
               <a:t>https://github.com/NetRxn/Inertia/blob/778996e94ce3b79480b5e06a5bb1b6fbe4eb4a60/docs/bridge-state-contract.md</a:t>
+            </a:r>
+          </a:p>
+          <a:p xmlns:a="http://schemas.openxmlformats.org/drawingml/2006/main">
+            <a:r>
+              <a:t>Local r12 storage contract: docs/development/dao-data-consolidation.md</a:t>
             </a:r>
           </a:p>
         </p:txBody>
@@ -642,6 +647,11 @@
               <a:t>https://github.com/NetRxn/Inertia/blob/778996e94ce3b79480b5e06a5bb1b6fbe4eb4a60/docs/integrations/dao-website-publication-v1.1-clarifications.md</a:t>
             </a:r>
           </a:p>
+          <a:p xmlns:a="http://schemas.openxmlformats.org/drawingml/2006/main">
+            <a:r>
+              <a:t>Storage target: meeting records remain behind the DAO website backend and member authorization, persisted in isolated domain schemas in the existing DAO PostgreSQL database shared with funding data. Verify provider support for schema and least-privilege role isolation before rollout. This is logical backend ownership, not a separate physical database requirement. Local r12 source: docs/development/dao-data-consolidation.md.</a:t>
+            </a:r>
+          </a:p>
         </p:txBody>
       </p:sp>
       <p:sp>
@@ -752,6 +762,11 @@
               <a:t>https://github.com/paperclipai/paperclip/blob/bba6a45f0d364cfd962ac59b3bdf2426a8222adb/server/src/services/issue-thread-interaction-resolution.ts</a:t>
             </a:r>
           </a:p>
+          <a:p xmlns:a="http://schemas.openxmlformats.org/drawingml/2006/main">
+            <a:r>
+              <a:t>The funding backend retains evidence, proposals, immutable packets, validation and review audit as logical domain responsibilities. Target placement is an isolated funding schema in the existing DAO PostgreSQL database also used for meetings, behind a least-privilege funding service role. Verify provider capability before rollout. Paperclip remains separate. Helix is a derived access-filtered projection, never a review, approval, transaction or fact authority. No native grant decision adapter, runtime or migration change is implied. Local r12 source: docs/development/dao-data-consolidation.md.</a:t>
+            </a:r>
+          </a:p>
         </p:txBody>
       </p:sp>
       <p:sp>
@@ -1069,7 +1084,7 @@
           <a:lstStyle xmlns:a="http://schemas.openxmlformats.org/drawingml/2006/main"/>
           <a:p xmlns:a="http://schemas.openxmlformats.org/drawingml/2006/main">
             <a:r>
-              <a:t>Live host setup, credentials, authorized relay/company/thread pairing and domain admission remain pending. Grant gates: configure reviewer identities and roles, exercise one real native-card packet with a correction cycle, scope member evidence/tools, implement trusted decision adapter and replay handling. Deny agent approval, wrong addressee, cross-applicant access, stale revisions/artifacts, duplicate application and invalid partner N/A. Require exact-packet governance evidence and no submission side effects. Website server changes are a proposal for owner rollout. Qualify newer Paperclip releases through compatibility, clean package install, native and full-host checks plus backup-based database recovery. Target the latest release that passes qualification. Synthetic workflow rehearsal remains available with npm run demo:workflow. Proposed Oct29 rehearsal buffer precedes Oct30 owner submission handoff. Form990 enrichment is stretch and Helix is deprioritized.</a:t>
+              <a:t>Live host setup, credentials, authorized relay/company/thread pairing and domain admission remain pending. Grant gates: configure reviewer identities and roles, exercise one real native-card packet with a correction cycle, scope member evidence/tools, implement trusted decision adapter and replay handling. Deny agent approval, wrong addressee, cross-applicant access, stale revisions/artifacts, duplicate application and invalid partner N/A. Require exact-packet governance evidence and no submission side effects. Website server changes are a proposal for owner rollout. Qualify newer Paperclip releases through compatibility, clean package install, native and full-host checks plus backup-based database recovery. Target the latest release that passes qualification. Synthetic workflow rehearsal remains available with npm run demo:workflow. Proposed Oct29 rehearsal buffer precedes Oct30 owner submission handoff. Form990 enrichment remains stretch. Helix is the eventual separate graph/vector projection across funding, 990 and Y2. It is optional for the demo only if needed and must not introduce a new critical path. Qualify isolated domain schemas and least-privilege service roles on the existing DAO PostgreSQL provider before the shared funding/meeting placement rolls out. No runtime or migration changes are part of this design revision.</a:t>
             </a:r>
           </a:p>
           <a:p xmlns:a="http://schemas.openxmlformats.org/drawingml/2006/main">
@@ -1090,6 +1105,11 @@
           <a:p xmlns:a="http://schemas.openxmlformats.org/drawingml/2006/main">
             <a:r>
               <a:t>https://github.com/NetRxn/Inertia/blob/778996e94ce3b79480b5e06a5bb1b6fbe4eb4a60/plan.md</a:t>
+            </a:r>
+          </a:p>
+          <a:p xmlns:a="http://schemas.openxmlformats.org/drawingml/2006/main">
+            <a:r>
+              <a:t>Local r12 source: docs/development/dao-data-consolidation.md.</a:t>
             </a:r>
           </a:p>
         </p:txBody>
@@ -3368,23 +3388,26 @@
           <p:cNvPr id="28" name="">
             <a:extLst xmlns:a="http://schemas.openxmlformats.org/drawingml/2006/main">
               <a:ext uri="{FF2B5EF4-FFF2-40B4-BE49-F238E27FC236}">
-                <a16:creationId xmlns:a16="http://schemas.microsoft.com/office/drawing/2014/main" id="{1A0771D5-04A9-4E92-9CFB-0FDDDA889AD2}"/>
+                <a16:creationId xmlns:a16="http://schemas.microsoft.com/office/drawing/2014/main" id="{40A686DD-7253-4C85-B711-E46E1E9716C2}"/>
               </a:ext>
             </a:extLst>
           </p:cNvPr>
           <p:cNvCxnSpPr>
-            <a:stCxn xmlns:a="http://schemas.openxmlformats.org/drawingml/2006/main" id="21" idx="1"/>
-            <a:endCxn xmlns:a="http://schemas.openxmlformats.org/drawingml/2006/main" id="25" idx="3"/>
+            <a:stCxn xmlns:a="http://schemas.openxmlformats.org/drawingml/2006/main" id="12" idx="2"/>
+            <a:endCxn xmlns:a="http://schemas.openxmlformats.org/drawingml/2006/main" id="17" idx="0"/>
           </p:cNvCxnSpPr>
           <p:nvPr/>
         </p:nvCxnSpPr>
         <p:spPr>
           <a:xfrm xmlns:a="http://schemas.openxmlformats.org/drawingml/2006/main" flipH="1">
-            <a:off x="3657600" y="6038850"/>
-            <a:ext cx="952500" cy="0"/>
-          </a:xfrm>
-          <a:prstGeom xmlns:a="http://schemas.openxmlformats.org/drawingml/2006/main" prst="straightConnector1">
-            <a:avLst/>
+            <a:off x="2371725" y="3657600"/>
+            <a:ext cx="9439275" cy="1524000"/>
+          </a:xfrm>
+          <a:prstGeom xmlns:a="http://schemas.openxmlformats.org/drawingml/2006/main" prst="bentConnector4">
+            <a:avLst>
+              <a:gd name="adj1" fmla="val 0"/>
+              <a:gd name="adj2" fmla="val 15000"/>
+            </a:avLst>
           </a:prstGeom>
           <a:ln xmlns:a="http://schemas.openxmlformats.org/drawingml/2006/main" w="23813">
             <a:solidFill>
@@ -3397,59 +3420,55 @@
       </p:cxnSp>
       <p:cxnSp>
         <p:nvCxnSpPr>
-          <p:cNvPr id="24" name="">
-            <a:extLst xmlns:a="http://schemas.openxmlformats.org/drawingml/2006/main">
-              <a:ext uri="{FF2B5EF4-FFF2-40B4-BE49-F238E27FC236}">
-                <a16:creationId xmlns:a16="http://schemas.microsoft.com/office/drawing/2014/main" id="{32183993-58D1-4C71-8BD8-E978D63ADEFF}"/>
+          <p:cNvPr id="27" name="">
+            <a:extLst xmlns:a="http://schemas.openxmlformats.org/drawingml/2006/main">
+              <a:ext uri="{FF2B5EF4-FFF2-40B4-BE49-F238E27FC236}">
+                <a16:creationId xmlns:a16="http://schemas.microsoft.com/office/drawing/2014/main" id="{8745630D-5214-40ED-91DB-D6F0736009C1}"/>
               </a:ext>
             </a:extLst>
           </p:cNvPr>
           <p:cNvCxnSpPr>
-            <a:stCxn xmlns:a="http://schemas.openxmlformats.org/drawingml/2006/main" id="12" idx="2"/>
-            <a:endCxn xmlns:a="http://schemas.openxmlformats.org/drawingml/2006/main" id="21" idx="3"/>
+            <a:stCxn xmlns:a="http://schemas.openxmlformats.org/drawingml/2006/main" id="20" idx="3"/>
+            <a:endCxn xmlns:a="http://schemas.openxmlformats.org/drawingml/2006/main" id="23" idx="1"/>
           </p:cNvCxnSpPr>
           <p:nvPr/>
         </p:nvCxnSpPr>
         <p:spPr>
-          <a:xfrm xmlns:a="http://schemas.openxmlformats.org/drawingml/2006/main" flipH="1">
-            <a:off x="8039100" y="3657600"/>
-            <a:ext cx="3771900" cy="2381250"/>
-          </a:xfrm>
-          <a:prstGeom xmlns:a="http://schemas.openxmlformats.org/drawingml/2006/main" prst="bentConnector5">
-            <a:avLst>
-              <a:gd name="adj1" fmla="val 0"/>
-              <a:gd name="adj2" fmla="val 9600"/>
-              <a:gd name="adj3" fmla="val 93939"/>
-            </a:avLst>
+          <a:xfrm xmlns:a="http://schemas.openxmlformats.org/drawingml/2006/main">
+            <a:off x="9944100" y="5810250"/>
+            <a:ext cx="952500" cy="0"/>
+          </a:xfrm>
+          <a:prstGeom xmlns:a="http://schemas.openxmlformats.org/drawingml/2006/main" prst="straightConnector1">
+            <a:avLst/>
           </a:prstGeom>
           <a:ln xmlns:a="http://schemas.openxmlformats.org/drawingml/2006/main" w="23813">
             <a:solidFill>
               <a:srgbClr val="157D80"/>
             </a:solidFill>
-            <a:prstDash val="solid"/>
+            <a:prstDash val="dash"/>
             <a:tailEnd type="triangle" w="med" len="med"/>
           </a:ln>
         </p:spPr>
       </p:cxnSp>
       <p:cxnSp>
         <p:nvCxnSpPr>
-          <p:cNvPr id="20" name="">
-            <a:extLst xmlns:a="http://schemas.openxmlformats.org/drawingml/2006/main">
-              <a:ext uri="{FF2B5EF4-FFF2-40B4-BE49-F238E27FC236}">
-                <a16:creationId xmlns:a16="http://schemas.microsoft.com/office/drawing/2014/main" id="{F71AC2B8-ADC6-4DF9-9FCB-068F8825DBDB}"/>
+          <p:cNvPr id="26" name="">
+            <a:extLst xmlns:a="http://schemas.openxmlformats.org/drawingml/2006/main">
+              <a:ext uri="{FF2B5EF4-FFF2-40B4-BE49-F238E27FC236}">
+                <a16:creationId xmlns:a16="http://schemas.microsoft.com/office/drawing/2014/main" id="{51D59A5D-797E-479B-A2EE-4C57729CA61C}"/>
               </a:ext>
             </a:extLst>
           </p:cNvPr>
           <p:cNvCxnSpPr>
-            <a:stCxn xmlns:a="http://schemas.openxmlformats.org/drawingml/2006/main" id="17" idx="0"/>
-            <a:endCxn xmlns:a="http://schemas.openxmlformats.org/drawingml/2006/main" id="12" idx="2"/>
+            <a:stCxn xmlns:a="http://schemas.openxmlformats.org/drawingml/2006/main" id="17" idx="3"/>
+            <a:endCxn xmlns:a="http://schemas.openxmlformats.org/drawingml/2006/main" id="20" idx="1"/>
           </p:cNvCxnSpPr>
           <p:nvPr/>
         </p:nvCxnSpPr>
         <p:spPr>
-          <a:xfrm xmlns:a="http://schemas.openxmlformats.org/drawingml/2006/main" flipV="1">
-            <a:off x="11811000" y="3657600"/>
-            <a:ext cx="0" cy="1752600"/>
+          <a:xfrm xmlns:a="http://schemas.openxmlformats.org/drawingml/2006/main">
+            <a:off x="4133850" y="5810250"/>
+            <a:ext cx="952500" cy="0"/>
           </a:xfrm>
           <a:prstGeom xmlns:a="http://schemas.openxmlformats.org/drawingml/2006/main" prst="straightConnector1">
             <a:avLst/>
@@ -3468,7 +3487,7 @@
           <p:cNvPr id="16" name="">
             <a:extLst xmlns:a="http://schemas.openxmlformats.org/drawingml/2006/main">
               <a:ext uri="{FF2B5EF4-FFF2-40B4-BE49-F238E27FC236}">
-                <a16:creationId xmlns:a16="http://schemas.microsoft.com/office/drawing/2014/main" id="{C5852C42-5182-4E4D-923C-3A22303E06E9}"/>
+                <a16:creationId xmlns:a16="http://schemas.microsoft.com/office/drawing/2014/main" id="{2A3622E6-210C-4849-BC84-950579D417BD}"/>
               </a:ext>
             </a:extLst>
           </p:cNvPr>
@@ -3500,7 +3519,7 @@
           <p:cNvPr id="15" name="">
             <a:extLst xmlns:a="http://schemas.openxmlformats.org/drawingml/2006/main">
               <a:ext uri="{FF2B5EF4-FFF2-40B4-BE49-F238E27FC236}">
-                <a16:creationId xmlns:a16="http://schemas.microsoft.com/office/drawing/2014/main" id="{6A6A23BC-6B80-4F37-9E5F-0F465F478C54}"/>
+                <a16:creationId xmlns:a16="http://schemas.microsoft.com/office/drawing/2014/main" id="{3BB65394-A0C7-4ABE-B311-AB5230F70540}"/>
               </a:ext>
             </a:extLst>
           </p:cNvPr>
@@ -3529,10 +3548,10 @@
       </p:cxnSp>
       <p:sp>
         <p:nvSpPr>
-          <p:cNvPr id="31" name="text-0">
-            <a:extLst xmlns:a="http://schemas.openxmlformats.org/drawingml/2006/main">
-              <a:ext uri="{FF2B5EF4-FFF2-40B4-BE49-F238E27FC236}">
-                <a16:creationId xmlns:a16="http://schemas.microsoft.com/office/drawing/2014/main" id="{F338829B-2735-4A17-9211-BBEB4A33C807}"/>
+          <p:cNvPr id="34" name="revised-text-0">
+            <a:extLst xmlns:a="http://schemas.openxmlformats.org/drawingml/2006/main">
+              <a:ext uri="{FF2B5EF4-FFF2-40B4-BE49-F238E27FC236}">
+                <a16:creationId xmlns:a16="http://schemas.microsoft.com/office/drawing/2014/main" id="{451A6B52-AC17-4636-99CF-D42CE0E6E65C}"/>
               </a:ext>
             </a:extLst>
           </p:cNvPr>
@@ -3596,10 +3615,10 @@
       </p:sp>
       <p:sp>
         <p:nvSpPr>
-          <p:cNvPr id="2" name="text-1">
-            <a:extLst xmlns:a="http://schemas.openxmlformats.org/drawingml/2006/main">
-              <a:ext uri="{FF2B5EF4-FFF2-40B4-BE49-F238E27FC236}">
-                <a16:creationId xmlns:a16="http://schemas.microsoft.com/office/drawing/2014/main" id="{98B30851-B510-46DB-A5FE-B99A2A61E05A}"/>
+          <p:cNvPr id="2" name="revised-text-1">
+            <a:extLst xmlns:a="http://schemas.openxmlformats.org/drawingml/2006/main">
+              <a:ext uri="{FF2B5EF4-FFF2-40B4-BE49-F238E27FC236}">
+                <a16:creationId xmlns:a16="http://schemas.microsoft.com/office/drawing/2014/main" id="{601278BC-DD09-40A8-8C55-A3A40D0BB76D}"/>
               </a:ext>
             </a:extLst>
           </p:cNvPr>
@@ -3656,7 +3675,7 @@
                 <a:ea typeface="Aptos"/>
                 <a:cs typeface="Aptos"/>
               </a:rPr>
-              <a:t>Architecture target</a:t>
+              <a:t>Storage target · shared DAO data, independent Paperclip database</a:t>
             </a:r>
           </a:p>
         </p:txBody>
@@ -3666,7 +3685,7 @@
           <p:cNvPr id="3" name="">
             <a:extLst xmlns:a="http://schemas.openxmlformats.org/drawingml/2006/main">
               <a:ext uri="{FF2B5EF4-FFF2-40B4-BE49-F238E27FC236}">
-                <a16:creationId xmlns:a16="http://schemas.microsoft.com/office/drawing/2014/main" id="{F5A0C751-6B71-4A23-AF26-A60024636BE4}"/>
+                <a16:creationId xmlns:a16="http://schemas.microsoft.com/office/drawing/2014/main" id="{D0A68C2B-F3FF-47B1-9257-9F48EA299097}"/>
               </a:ext>
             </a:extLst>
           </p:cNvPr>
@@ -3693,10 +3712,10 @@
       </p:sp>
       <p:sp>
         <p:nvSpPr>
-          <p:cNvPr id="4" name="text-2">
-            <a:extLst xmlns:a="http://schemas.openxmlformats.org/drawingml/2006/main">
-              <a:ext uri="{FF2B5EF4-FFF2-40B4-BE49-F238E27FC236}">
-                <a16:creationId xmlns:a16="http://schemas.microsoft.com/office/drawing/2014/main" id="{AB6B971A-12BD-4EF5-AC08-3A887F5346B1}"/>
+          <p:cNvPr id="4" name="revised-text-2">
+            <a:extLst xmlns:a="http://schemas.openxmlformats.org/drawingml/2006/main">
+              <a:ext uri="{FF2B5EF4-FFF2-40B4-BE49-F238E27FC236}">
+                <a16:creationId xmlns:a16="http://schemas.microsoft.com/office/drawing/2014/main" id="{D1464888-C311-4DB3-9C18-9E30A9E6CC7D}"/>
               </a:ext>
             </a:extLst>
           </p:cNvPr>
@@ -3753,17 +3772,17 @@
                 <a:ea typeface="Aptos"/>
                 <a:cs typeface="Aptos"/>
               </a:rPr>
-              <a:t>Inertia architecture · r11 · 23 October 2026</a:t>
-            </a:r>
-          </a:p>
-        </p:txBody>
-      </p:sp>
-      <p:sp>
-        <p:nvSpPr>
-          <p:cNvPr id="5" name="text-3">
-            <a:extLst xmlns:a="http://schemas.openxmlformats.org/drawingml/2006/main">
-              <a:ext uri="{FF2B5EF4-FFF2-40B4-BE49-F238E27FC236}">
-                <a16:creationId xmlns:a16="http://schemas.microsoft.com/office/drawing/2014/main" id="{6E0C023B-80DC-47FB-A443-AFCF22AD0838}"/>
+              <a:t>Inertia architecture · r12 · 23 October 2026</a:t>
+            </a:r>
+          </a:p>
+        </p:txBody>
+      </p:sp>
+      <p:sp>
+        <p:nvSpPr>
+          <p:cNvPr id="5" name="revised-text-3">
+            <a:extLst xmlns:a="http://schemas.openxmlformats.org/drawingml/2006/main">
+              <a:ext uri="{FF2B5EF4-FFF2-40B4-BE49-F238E27FC236}">
+                <a16:creationId xmlns:a16="http://schemas.microsoft.com/office/drawing/2014/main" id="{419EEE86-A4C1-4878-87E7-5BFCD1F5190B}"/>
               </a:ext>
             </a:extLst>
           </p:cNvPr>
@@ -3827,10 +3846,10 @@
       </p:sp>
       <p:sp>
         <p:nvSpPr>
-          <p:cNvPr id="6" name="node-4">
-            <a:extLst xmlns:a="http://schemas.openxmlformats.org/drawingml/2006/main">
-              <a:ext uri="{FF2B5EF4-FFF2-40B4-BE49-F238E27FC236}">
-                <a16:creationId xmlns:a16="http://schemas.microsoft.com/office/drawing/2014/main" id="{D40EE361-D12D-448F-B9AA-753A41F651D5}"/>
+          <p:cNvPr id="6" name="revised-node-4">
+            <a:extLst xmlns:a="http://schemas.openxmlformats.org/drawingml/2006/main">
+              <a:ext uri="{FF2B5EF4-FFF2-40B4-BE49-F238E27FC236}">
+                <a16:creationId xmlns:a16="http://schemas.microsoft.com/office/drawing/2014/main" id="{1282C594-EE68-45A0-8A9D-C320038639B6}"/>
               </a:ext>
             </a:extLst>
           </p:cNvPr>
@@ -3860,10 +3879,10 @@
       </p:sp>
       <p:sp>
         <p:nvSpPr>
-          <p:cNvPr id="7" name="text-5">
-            <a:extLst xmlns:a="http://schemas.openxmlformats.org/drawingml/2006/main">
-              <a:ext uri="{FF2B5EF4-FFF2-40B4-BE49-F238E27FC236}">
-                <a16:creationId xmlns:a16="http://schemas.microsoft.com/office/drawing/2014/main" id="{57FAA9B2-9ACE-4EA1-B11C-52A739900D76}"/>
+          <p:cNvPr id="7" name="revised-text-5">
+            <a:extLst xmlns:a="http://schemas.openxmlformats.org/drawingml/2006/main">
+              <a:ext uri="{FF2B5EF4-FFF2-40B4-BE49-F238E27FC236}">
+                <a16:creationId xmlns:a16="http://schemas.microsoft.com/office/drawing/2014/main" id="{2D43F8BE-9AA7-4CE2-BB2D-086F2B34AD44}"/>
               </a:ext>
             </a:extLst>
           </p:cNvPr>
@@ -3927,10 +3946,10 @@
       </p:sp>
       <p:sp>
         <p:nvSpPr>
-          <p:cNvPr id="8" name="text-6">
-            <a:extLst xmlns:a="http://schemas.openxmlformats.org/drawingml/2006/main">
-              <a:ext uri="{FF2B5EF4-FFF2-40B4-BE49-F238E27FC236}">
-                <a16:creationId xmlns:a16="http://schemas.microsoft.com/office/drawing/2014/main" id="{D1709342-03D6-4291-B11A-983541517BEB}"/>
+          <p:cNvPr id="8" name="revised-text-6">
+            <a:extLst xmlns:a="http://schemas.openxmlformats.org/drawingml/2006/main">
+              <a:ext uri="{FF2B5EF4-FFF2-40B4-BE49-F238E27FC236}">
+                <a16:creationId xmlns:a16="http://schemas.microsoft.com/office/drawing/2014/main" id="{9349FA75-6DA3-4D6C-8458-C74CB8CE6AF0}"/>
               </a:ext>
             </a:extLst>
           </p:cNvPr>
@@ -3994,10 +4013,10 @@
       </p:sp>
       <p:sp>
         <p:nvSpPr>
-          <p:cNvPr id="9" name="node-7">
-            <a:extLst xmlns:a="http://schemas.openxmlformats.org/drawingml/2006/main">
-              <a:ext uri="{FF2B5EF4-FFF2-40B4-BE49-F238E27FC236}">
-                <a16:creationId xmlns:a16="http://schemas.microsoft.com/office/drawing/2014/main" id="{4D68A38C-E50A-4C92-BF4E-4E976916C4C0}"/>
+          <p:cNvPr id="9" name="revised-node-7">
+            <a:extLst xmlns:a="http://schemas.openxmlformats.org/drawingml/2006/main">
+              <a:ext uri="{FF2B5EF4-FFF2-40B4-BE49-F238E27FC236}">
+                <a16:creationId xmlns:a16="http://schemas.microsoft.com/office/drawing/2014/main" id="{3369E68E-CE07-492A-96BF-908C06950821}"/>
               </a:ext>
             </a:extLst>
           </p:cNvPr>
@@ -4027,10 +4046,10 @@
       </p:sp>
       <p:sp>
         <p:nvSpPr>
-          <p:cNvPr id="10" name="text-8">
-            <a:extLst xmlns:a="http://schemas.openxmlformats.org/drawingml/2006/main">
-              <a:ext uri="{FF2B5EF4-FFF2-40B4-BE49-F238E27FC236}">
-                <a16:creationId xmlns:a16="http://schemas.microsoft.com/office/drawing/2014/main" id="{09E6C6C1-236F-4B7C-823D-45267C123351}"/>
+          <p:cNvPr id="10" name="revised-text-8">
+            <a:extLst xmlns:a="http://schemas.openxmlformats.org/drawingml/2006/main">
+              <a:ext uri="{FF2B5EF4-FFF2-40B4-BE49-F238E27FC236}">
+                <a16:creationId xmlns:a16="http://schemas.microsoft.com/office/drawing/2014/main" id="{88384E24-B42E-4F41-9B08-B14618BB23DF}"/>
               </a:ext>
             </a:extLst>
           </p:cNvPr>
@@ -4094,10 +4113,10 @@
       </p:sp>
       <p:sp>
         <p:nvSpPr>
-          <p:cNvPr id="11" name="text-9">
-            <a:extLst xmlns:a="http://schemas.openxmlformats.org/drawingml/2006/main">
-              <a:ext uri="{FF2B5EF4-FFF2-40B4-BE49-F238E27FC236}">
-                <a16:creationId xmlns:a16="http://schemas.microsoft.com/office/drawing/2014/main" id="{AD09C499-0220-4144-BCA1-FAF6B93A9B92}"/>
+          <p:cNvPr id="11" name="revised-text-9">
+            <a:extLst xmlns:a="http://schemas.openxmlformats.org/drawingml/2006/main">
+              <a:ext uri="{FF2B5EF4-FFF2-40B4-BE49-F238E27FC236}">
+                <a16:creationId xmlns:a16="http://schemas.microsoft.com/office/drawing/2014/main" id="{0E152F7C-C020-46FF-B842-E881FAE88EF6}"/>
               </a:ext>
             </a:extLst>
           </p:cNvPr>
@@ -4161,10 +4180,10 @@
       </p:sp>
       <p:sp>
         <p:nvSpPr>
-          <p:cNvPr id="12" name="node-10">
-            <a:extLst xmlns:a="http://schemas.openxmlformats.org/drawingml/2006/main">
-              <a:ext uri="{FF2B5EF4-FFF2-40B4-BE49-F238E27FC236}">
-                <a16:creationId xmlns:a16="http://schemas.microsoft.com/office/drawing/2014/main" id="{86D85CD9-0912-4636-83E2-C2344A550DF0}"/>
+          <p:cNvPr id="12" name="revised-node-10">
+            <a:extLst xmlns:a="http://schemas.openxmlformats.org/drawingml/2006/main">
+              <a:ext uri="{FF2B5EF4-FFF2-40B4-BE49-F238E27FC236}">
+                <a16:creationId xmlns:a16="http://schemas.microsoft.com/office/drawing/2014/main" id="{15AE83C7-DF5C-4763-AE31-BA9932A8C242}"/>
               </a:ext>
             </a:extLst>
           </p:cNvPr>
@@ -4194,10 +4213,10 @@
       </p:sp>
       <p:sp>
         <p:nvSpPr>
-          <p:cNvPr id="13" name="text-11">
-            <a:extLst xmlns:a="http://schemas.openxmlformats.org/drawingml/2006/main">
-              <a:ext uri="{FF2B5EF4-FFF2-40B4-BE49-F238E27FC236}">
-                <a16:creationId xmlns:a16="http://schemas.microsoft.com/office/drawing/2014/main" id="{B464BA17-0D0F-4423-BA24-E0E4887A74D1}"/>
+          <p:cNvPr id="13" name="revised-text-11">
+            <a:extLst xmlns:a="http://schemas.openxmlformats.org/drawingml/2006/main">
+              <a:ext uri="{FF2B5EF4-FFF2-40B4-BE49-F238E27FC236}">
+                <a16:creationId xmlns:a16="http://schemas.microsoft.com/office/drawing/2014/main" id="{59D338F1-72F2-442F-9493-EFD5F20CBA79}"/>
               </a:ext>
             </a:extLst>
           </p:cNvPr>
@@ -4261,10 +4280,10 @@
       </p:sp>
       <p:sp>
         <p:nvSpPr>
-          <p:cNvPr id="14" name="text-12">
-            <a:extLst xmlns:a="http://schemas.openxmlformats.org/drawingml/2006/main">
-              <a:ext uri="{FF2B5EF4-FFF2-40B4-BE49-F238E27FC236}">
-                <a16:creationId xmlns:a16="http://schemas.microsoft.com/office/drawing/2014/main" id="{A6CA7E7E-54AF-4F84-974F-45E811EB04E2}"/>
+          <p:cNvPr id="14" name="revised-text-12">
+            <a:extLst xmlns:a="http://schemas.openxmlformats.org/drawingml/2006/main">
+              <a:ext uri="{FF2B5EF4-FFF2-40B4-BE49-F238E27FC236}">
+                <a16:creationId xmlns:a16="http://schemas.microsoft.com/office/drawing/2014/main" id="{FDDF2989-E5D2-42DB-8CA9-240B07A1165E}"/>
               </a:ext>
             </a:extLst>
           </p:cNvPr>
@@ -4321,29 +4340,29 @@
                 <a:ea typeface="Aptos"/>
                 <a:cs typeface="Aptos"/>
               </a:rPr>
-              <a:t>Work state + authority</a:t>
-            </a:r>
-          </a:p>
-        </p:txBody>
-      </p:sp>
-      <p:sp>
-        <p:nvSpPr>
-          <p:cNvPr id="17" name="node-13">
-            <a:extLst xmlns:a="http://schemas.openxmlformats.org/drawingml/2006/main">
-              <a:ext uri="{FF2B5EF4-FFF2-40B4-BE49-F238E27FC236}">
-                <a16:creationId xmlns:a16="http://schemas.microsoft.com/office/drawing/2014/main" id="{4529C4A9-D7C9-4892-A39E-6824BF7461E6}"/>
-              </a:ext>
-            </a:extLst>
-          </p:cNvPr>
-          <p:cNvSpPr>
-            <a:spLocks xmlns:a="http://schemas.openxmlformats.org/drawingml/2006/main" noGrp="1"/>
-          </p:cNvSpPr>
-          <p:nvPr/>
-        </p:nvSpPr>
-        <p:spPr>
-          <a:xfrm xmlns:a="http://schemas.openxmlformats.org/drawingml/2006/main">
-            <a:off x="8991600" y="5410200"/>
-            <a:ext cx="5638800" cy="1257300"/>
+              <a:t>Native work + independent DB</a:t>
+            </a:r>
+          </a:p>
+        </p:txBody>
+      </p:sp>
+      <p:sp>
+        <p:nvSpPr>
+          <p:cNvPr id="17" name="revised-node-13">
+            <a:extLst xmlns:a="http://schemas.openxmlformats.org/drawingml/2006/main">
+              <a:ext uri="{FF2B5EF4-FFF2-40B4-BE49-F238E27FC236}">
+                <a16:creationId xmlns:a16="http://schemas.microsoft.com/office/drawing/2014/main" id="{50194603-9019-4EDD-9848-E65EBF1288F2}"/>
+              </a:ext>
+            </a:extLst>
+          </p:cNvPr>
+          <p:cNvSpPr>
+            <a:spLocks xmlns:a="http://schemas.openxmlformats.org/drawingml/2006/main" noGrp="1"/>
+          </p:cNvSpPr>
+          <p:nvPr/>
+        </p:nvSpPr>
+        <p:spPr>
+          <a:xfrm xmlns:a="http://schemas.openxmlformats.org/drawingml/2006/main">
+            <a:off x="609600" y="5181600"/>
+            <a:ext cx="3524250" cy="1257300"/>
           </a:xfrm>
           <a:prstGeom xmlns:a="http://schemas.openxmlformats.org/drawingml/2006/main" prst="rect">
             <a:avLst/>
@@ -4361,22 +4380,22 @@
       </p:sp>
       <p:sp>
         <p:nvSpPr>
-          <p:cNvPr id="18" name="text-14">
-            <a:extLst xmlns:a="http://schemas.openxmlformats.org/drawingml/2006/main">
-              <a:ext uri="{FF2B5EF4-FFF2-40B4-BE49-F238E27FC236}">
-                <a16:creationId xmlns:a16="http://schemas.microsoft.com/office/drawing/2014/main" id="{8428794F-A1D8-4E00-81FF-6ACDF9979745}"/>
-              </a:ext>
-            </a:extLst>
-          </p:cNvPr>
-          <p:cNvSpPr>
-            <a:spLocks xmlns:a="http://schemas.openxmlformats.org/drawingml/2006/main" noGrp="1"/>
-          </p:cNvSpPr>
-          <p:nvPr/>
-        </p:nvSpPr>
-        <p:spPr>
-          <a:xfrm xmlns:a="http://schemas.openxmlformats.org/drawingml/2006/main">
-            <a:off x="9182100" y="5581650"/>
-            <a:ext cx="5257800" cy="400050"/>
+          <p:cNvPr id="18" name="revised-text-14">
+            <a:extLst xmlns:a="http://schemas.openxmlformats.org/drawingml/2006/main">
+              <a:ext uri="{FF2B5EF4-FFF2-40B4-BE49-F238E27FC236}">
+                <a16:creationId xmlns:a16="http://schemas.microsoft.com/office/drawing/2014/main" id="{46314449-F06E-489F-885E-56E66BD1D7F7}"/>
+              </a:ext>
+            </a:extLst>
+          </p:cNvPr>
+          <p:cNvSpPr>
+            <a:spLocks xmlns:a="http://schemas.openxmlformats.org/drawingml/2006/main" noGrp="1"/>
+          </p:cNvSpPr>
+          <p:nvPr/>
+        </p:nvSpPr>
+        <p:spPr>
+          <a:xfrm xmlns:a="http://schemas.openxmlformats.org/drawingml/2006/main">
+            <a:off x="800100" y="5353050"/>
+            <a:ext cx="3143250" cy="400050"/>
           </a:xfrm>
           <a:prstGeom xmlns:a="http://schemas.openxmlformats.org/drawingml/2006/main" prst="rect">
             <a:avLst/>
@@ -4421,29 +4440,29 @@
                 <a:ea typeface="Aptos"/>
                 <a:cs typeface="Aptos"/>
               </a:rPr>
-              <a:t>Paperclip dashboard</a:t>
-            </a:r>
-          </a:p>
-        </p:txBody>
-      </p:sp>
-      <p:sp>
-        <p:nvSpPr>
-          <p:cNvPr id="19" name="text-15">
-            <a:extLst xmlns:a="http://schemas.openxmlformats.org/drawingml/2006/main">
-              <a:ext uri="{FF2B5EF4-FFF2-40B4-BE49-F238E27FC236}">
-                <a16:creationId xmlns:a16="http://schemas.microsoft.com/office/drawing/2014/main" id="{8C268D16-EE47-4A1E-9856-BCBE9AA8E4E4}"/>
-              </a:ext>
-            </a:extLst>
-          </p:cNvPr>
-          <p:cNvSpPr>
-            <a:spLocks xmlns:a="http://schemas.openxmlformats.org/drawingml/2006/main" noGrp="1"/>
-          </p:cNvSpPr>
-          <p:nvPr/>
-        </p:nvSpPr>
-        <p:spPr>
-          <a:xfrm xmlns:a="http://schemas.openxmlformats.org/drawingml/2006/main">
-            <a:off x="9182100" y="6019800"/>
-            <a:ext cx="5257800" cy="533400"/>
+              <a:t>DAO backends</a:t>
+            </a:r>
+          </a:p>
+        </p:txBody>
+      </p:sp>
+      <p:sp>
+        <p:nvSpPr>
+          <p:cNvPr id="19" name="revised-text-15">
+            <a:extLst xmlns:a="http://schemas.openxmlformats.org/drawingml/2006/main">
+              <a:ext uri="{FF2B5EF4-FFF2-40B4-BE49-F238E27FC236}">
+                <a16:creationId xmlns:a16="http://schemas.microsoft.com/office/drawing/2014/main" id="{8A3A3403-C79A-40F2-A606-2F26BDBD889C}"/>
+              </a:ext>
+            </a:extLst>
+          </p:cNvPr>
+          <p:cNvSpPr>
+            <a:spLocks xmlns:a="http://schemas.openxmlformats.org/drawingml/2006/main" noGrp="1"/>
+          </p:cNvSpPr>
+          <p:nvPr/>
+        </p:nvSpPr>
+        <p:spPr>
+          <a:xfrm xmlns:a="http://schemas.openxmlformats.org/drawingml/2006/main">
+            <a:off x="800100" y="5791200"/>
+            <a:ext cx="3143250" cy="533400"/>
           </a:xfrm>
           <a:prstGeom xmlns:a="http://schemas.openxmlformats.org/drawingml/2006/main" prst="rect">
             <a:avLst/>
@@ -4488,29 +4507,29 @@
                 <a:ea typeface="Aptos"/>
                 <a:cs typeface="Aptos"/>
               </a:rPr>
-              <a:t>Native docs + human-only review cards</a:t>
-            </a:r>
-          </a:p>
-        </p:txBody>
-      </p:sp>
-      <p:sp>
-        <p:nvSpPr>
-          <p:cNvPr id="21" name="node-16">
-            <a:extLst xmlns:a="http://schemas.openxmlformats.org/drawingml/2006/main">
-              <a:ext uri="{FF2B5EF4-FFF2-40B4-BE49-F238E27FC236}">
-                <a16:creationId xmlns:a16="http://schemas.microsoft.com/office/drawing/2014/main" id="{0EE133AB-F20B-4C7C-B89D-41D38EDE4596}"/>
-              </a:ext>
-            </a:extLst>
-          </p:cNvPr>
-          <p:cNvSpPr>
-            <a:spLocks xmlns:a="http://schemas.openxmlformats.org/drawingml/2006/main" noGrp="1"/>
-          </p:cNvSpPr>
-          <p:nvPr/>
-        </p:nvSpPr>
-        <p:spPr>
-          <a:xfrm xmlns:a="http://schemas.openxmlformats.org/drawingml/2006/main">
-            <a:off x="4610100" y="5410200"/>
-            <a:ext cx="3429000" cy="1257300"/>
+              <a:t>Funding + meetings</a:t>
+            </a:r>
+          </a:p>
+        </p:txBody>
+      </p:sp>
+      <p:sp>
+        <p:nvSpPr>
+          <p:cNvPr id="20" name="revised-node-16">
+            <a:extLst xmlns:a="http://schemas.openxmlformats.org/drawingml/2006/main">
+              <a:ext uri="{FF2B5EF4-FFF2-40B4-BE49-F238E27FC236}">
+                <a16:creationId xmlns:a16="http://schemas.microsoft.com/office/drawing/2014/main" id="{DA5642D2-0DA3-49A7-B836-CED795D58472}"/>
+              </a:ext>
+            </a:extLst>
+          </p:cNvPr>
+          <p:cNvSpPr>
+            <a:spLocks xmlns:a="http://schemas.openxmlformats.org/drawingml/2006/main" noGrp="1"/>
+          </p:cNvSpPr>
+          <p:nvPr/>
+        </p:nvSpPr>
+        <p:spPr>
+          <a:xfrm xmlns:a="http://schemas.openxmlformats.org/drawingml/2006/main">
+            <a:off x="5086350" y="5181600"/>
+            <a:ext cx="4857750" cy="1257300"/>
           </a:xfrm>
           <a:prstGeom xmlns:a="http://schemas.openxmlformats.org/drawingml/2006/main" prst="rect">
             <a:avLst/>
@@ -4528,22 +4547,22 @@
       </p:sp>
       <p:sp>
         <p:nvSpPr>
-          <p:cNvPr id="22" name="text-17">
-            <a:extLst xmlns:a="http://schemas.openxmlformats.org/drawingml/2006/main">
-              <a:ext uri="{FF2B5EF4-FFF2-40B4-BE49-F238E27FC236}">
-                <a16:creationId xmlns:a16="http://schemas.microsoft.com/office/drawing/2014/main" id="{509DA9BE-D649-4653-8427-5C32E9318574}"/>
-              </a:ext>
-            </a:extLst>
-          </p:cNvPr>
-          <p:cNvSpPr>
-            <a:spLocks xmlns:a="http://schemas.openxmlformats.org/drawingml/2006/main" noGrp="1"/>
-          </p:cNvSpPr>
-          <p:nvPr/>
-        </p:nvSpPr>
-        <p:spPr>
-          <a:xfrm xmlns:a="http://schemas.openxmlformats.org/drawingml/2006/main">
-            <a:off x="4800600" y="5581650"/>
-            <a:ext cx="3048000" cy="400050"/>
+          <p:cNvPr id="21" name="revised-text-17">
+            <a:extLst xmlns:a="http://schemas.openxmlformats.org/drawingml/2006/main">
+              <a:ext uri="{FF2B5EF4-FFF2-40B4-BE49-F238E27FC236}">
+                <a16:creationId xmlns:a16="http://schemas.microsoft.com/office/drawing/2014/main" id="{F12C52C4-7210-4568-B314-CAED6ABF0C71}"/>
+              </a:ext>
+            </a:extLst>
+          </p:cNvPr>
+          <p:cNvSpPr>
+            <a:spLocks xmlns:a="http://schemas.openxmlformats.org/drawingml/2006/main" noGrp="1"/>
+          </p:cNvSpPr>
+          <p:nvPr/>
+        </p:nvSpPr>
+        <p:spPr>
+          <a:xfrm xmlns:a="http://schemas.openxmlformats.org/drawingml/2006/main">
+            <a:off x="5276850" y="5353050"/>
+            <a:ext cx="4476750" cy="400050"/>
           </a:xfrm>
           <a:prstGeom xmlns:a="http://schemas.openxmlformats.org/drawingml/2006/main" prst="rect">
             <a:avLst/>
@@ -4588,29 +4607,29 @@
                 <a:ea typeface="Aptos"/>
                 <a:cs typeface="Aptos"/>
               </a:rPr>
-              <a:t>Trusted adapters</a:t>
-            </a:r>
-          </a:p>
-        </p:txBody>
-      </p:sp>
-      <p:sp>
-        <p:nvSpPr>
-          <p:cNvPr id="23" name="text-18">
-            <a:extLst xmlns:a="http://schemas.openxmlformats.org/drawingml/2006/main">
-              <a:ext uri="{FF2B5EF4-FFF2-40B4-BE49-F238E27FC236}">
-                <a16:creationId xmlns:a16="http://schemas.microsoft.com/office/drawing/2014/main" id="{04F299F8-404D-4AF2-8E78-04A3DDA318C3}"/>
-              </a:ext>
-            </a:extLst>
-          </p:cNvPr>
-          <p:cNvSpPr>
-            <a:spLocks xmlns:a="http://schemas.openxmlformats.org/drawingml/2006/main" noGrp="1"/>
-          </p:cNvSpPr>
-          <p:nvPr/>
-        </p:nvSpPr>
-        <p:spPr>
-          <a:xfrm xmlns:a="http://schemas.openxmlformats.org/drawingml/2006/main">
-            <a:off x="4800600" y="6019800"/>
-            <a:ext cx="3048000" cy="533400"/>
+              <a:t>Existing DAO PostgreSQL</a:t>
+            </a:r>
+          </a:p>
+        </p:txBody>
+      </p:sp>
+      <p:sp>
+        <p:nvSpPr>
+          <p:cNvPr id="22" name="revised-text-18">
+            <a:extLst xmlns:a="http://schemas.openxmlformats.org/drawingml/2006/main">
+              <a:ext uri="{FF2B5EF4-FFF2-40B4-BE49-F238E27FC236}">
+                <a16:creationId xmlns:a16="http://schemas.microsoft.com/office/drawing/2014/main" id="{E4906A4F-0FBE-4CD5-B187-CFE192A29C6D}"/>
+              </a:ext>
+            </a:extLst>
+          </p:cNvPr>
+          <p:cNvSpPr>
+            <a:spLocks xmlns:a="http://schemas.openxmlformats.org/drawingml/2006/main" noGrp="1"/>
+          </p:cNvSpPr>
+          <p:nvPr/>
+        </p:nvSpPr>
+        <p:spPr>
+          <a:xfrm xmlns:a="http://schemas.openxmlformats.org/drawingml/2006/main">
+            <a:off x="5276850" y="5791200"/>
+            <a:ext cx="4476750" cy="533400"/>
           </a:xfrm>
           <a:prstGeom xmlns:a="http://schemas.openxmlformats.org/drawingml/2006/main" prst="rect">
             <a:avLst/>
@@ -4655,29 +4674,29 @@
                 <a:ea typeface="Aptos"/>
                 <a:cs typeface="Aptos"/>
               </a:rPr>
-              <a:t>Validate + publish</a:t>
-            </a:r>
-          </a:p>
-        </p:txBody>
-      </p:sp>
-      <p:sp>
-        <p:nvSpPr>
-          <p:cNvPr id="25" name="node-19">
-            <a:extLst xmlns:a="http://schemas.openxmlformats.org/drawingml/2006/main">
-              <a:ext uri="{FF2B5EF4-FFF2-40B4-BE49-F238E27FC236}">
-                <a16:creationId xmlns:a16="http://schemas.microsoft.com/office/drawing/2014/main" id="{1657C0E3-C316-4CB9-8429-70DC796949A6}"/>
-              </a:ext>
-            </a:extLst>
-          </p:cNvPr>
-          <p:cNvSpPr>
-            <a:spLocks xmlns:a="http://schemas.openxmlformats.org/drawingml/2006/main" noGrp="1"/>
-          </p:cNvSpPr>
-          <p:nvPr/>
-        </p:nvSpPr>
-        <p:spPr>
-          <a:xfrm xmlns:a="http://schemas.openxmlformats.org/drawingml/2006/main">
-            <a:off x="609600" y="5410200"/>
-            <a:ext cx="3048000" cy="1257300"/>
+              <a:t>Isolated schemas + scoped roles</a:t>
+            </a:r>
+          </a:p>
+        </p:txBody>
+      </p:sp>
+      <p:sp>
+        <p:nvSpPr>
+          <p:cNvPr id="23" name="revised-node-19">
+            <a:extLst xmlns:a="http://schemas.openxmlformats.org/drawingml/2006/main">
+              <a:ext uri="{FF2B5EF4-FFF2-40B4-BE49-F238E27FC236}">
+                <a16:creationId xmlns:a16="http://schemas.microsoft.com/office/drawing/2014/main" id="{B8DE59ED-0601-43B1-80AB-18A768C9A3CA}"/>
+              </a:ext>
+            </a:extLst>
+          </p:cNvPr>
+          <p:cNvSpPr>
+            <a:spLocks xmlns:a="http://schemas.openxmlformats.org/drawingml/2006/main" noGrp="1"/>
+          </p:cNvSpPr>
+          <p:nvPr/>
+        </p:nvSpPr>
+        <p:spPr>
+          <a:xfrm xmlns:a="http://schemas.openxmlformats.org/drawingml/2006/main">
+            <a:off x="10896600" y="5181600"/>
+            <a:ext cx="3733800" cy="1257300"/>
           </a:xfrm>
           <a:prstGeom xmlns:a="http://schemas.openxmlformats.org/drawingml/2006/main" prst="rect">
             <a:avLst/>
@@ -4695,22 +4714,22 @@
       </p:sp>
       <p:sp>
         <p:nvSpPr>
-          <p:cNvPr id="26" name="text-20">
-            <a:extLst xmlns:a="http://schemas.openxmlformats.org/drawingml/2006/main">
-              <a:ext uri="{FF2B5EF4-FFF2-40B4-BE49-F238E27FC236}">
-                <a16:creationId xmlns:a16="http://schemas.microsoft.com/office/drawing/2014/main" id="{7E4DD7EB-D6F0-46A3-B373-9C6C61B0D5B8}"/>
-              </a:ext>
-            </a:extLst>
-          </p:cNvPr>
-          <p:cNvSpPr>
-            <a:spLocks xmlns:a="http://schemas.openxmlformats.org/drawingml/2006/main" noGrp="1"/>
-          </p:cNvSpPr>
-          <p:nvPr/>
-        </p:nvSpPr>
-        <p:spPr>
-          <a:xfrm xmlns:a="http://schemas.openxmlformats.org/drawingml/2006/main">
-            <a:off x="800100" y="5581650"/>
-            <a:ext cx="2667000" cy="400050"/>
+          <p:cNvPr id="24" name="revised-text-20">
+            <a:extLst xmlns:a="http://schemas.openxmlformats.org/drawingml/2006/main">
+              <a:ext uri="{FF2B5EF4-FFF2-40B4-BE49-F238E27FC236}">
+                <a16:creationId xmlns:a16="http://schemas.microsoft.com/office/drawing/2014/main" id="{E4CD66CA-A769-4D18-AFB6-182604305961}"/>
+              </a:ext>
+            </a:extLst>
+          </p:cNvPr>
+          <p:cNvSpPr>
+            <a:spLocks xmlns:a="http://schemas.openxmlformats.org/drawingml/2006/main" noGrp="1"/>
+          </p:cNvSpPr>
+          <p:nvPr/>
+        </p:nvSpPr>
+        <p:spPr>
+          <a:xfrm xmlns:a="http://schemas.openxmlformats.org/drawingml/2006/main">
+            <a:off x="11087100" y="5353050"/>
+            <a:ext cx="3352800" cy="400050"/>
           </a:xfrm>
           <a:prstGeom xmlns:a="http://schemas.openxmlformats.org/drawingml/2006/main" prst="rect">
             <a:avLst/>
@@ -4755,29 +4774,29 @@
                 <a:ea typeface="Aptos"/>
                 <a:cs typeface="Aptos"/>
               </a:rPr>
-              <a:t>DAO integrations</a:t>
-            </a:r>
-          </a:p>
-        </p:txBody>
-      </p:sp>
-      <p:sp>
-        <p:nvSpPr>
-          <p:cNvPr id="27" name="text-21">
-            <a:extLst xmlns:a="http://schemas.openxmlformats.org/drawingml/2006/main">
-              <a:ext uri="{FF2B5EF4-FFF2-40B4-BE49-F238E27FC236}">
-                <a16:creationId xmlns:a16="http://schemas.microsoft.com/office/drawing/2014/main" id="{A272E028-333A-40CC-A4A0-CA87EDB18518}"/>
-              </a:ext>
-            </a:extLst>
-          </p:cNvPr>
-          <p:cNvSpPr>
-            <a:spLocks xmlns:a="http://schemas.openxmlformats.org/drawingml/2006/main" noGrp="1"/>
-          </p:cNvSpPr>
-          <p:nvPr/>
-        </p:nvSpPr>
-        <p:spPr>
-          <a:xfrm xmlns:a="http://schemas.openxmlformats.org/drawingml/2006/main">
-            <a:off x="800100" y="6019800"/>
-            <a:ext cx="2667000" cy="533400"/>
+              <a:t>Helix · planned</a:t>
+            </a:r>
+          </a:p>
+        </p:txBody>
+      </p:sp>
+      <p:sp>
+        <p:nvSpPr>
+          <p:cNvPr id="25" name="revised-text-21">
+            <a:extLst xmlns:a="http://schemas.openxmlformats.org/drawingml/2006/main">
+              <a:ext uri="{FF2B5EF4-FFF2-40B4-BE49-F238E27FC236}">
+                <a16:creationId xmlns:a16="http://schemas.microsoft.com/office/drawing/2014/main" id="{A359C726-4F89-4E5B-8386-BF5A0158D67A}"/>
+              </a:ext>
+            </a:extLst>
+          </p:cNvPr>
+          <p:cNvSpPr>
+            <a:spLocks xmlns:a="http://schemas.openxmlformats.org/drawingml/2006/main" noGrp="1"/>
+          </p:cNvSpPr>
+          <p:nvPr/>
+        </p:nvSpPr>
+        <p:spPr>
+          <a:xfrm xmlns:a="http://schemas.openxmlformats.org/drawingml/2006/main">
+            <a:off x="11087100" y="5791200"/>
+            <a:ext cx="3352800" cy="533400"/>
           </a:xfrm>
           <a:prstGeom xmlns:a="http://schemas.openxmlformats.org/drawingml/2006/main" prst="rect">
             <a:avLst/>
@@ -4822,29 +4841,29 @@
                 <a:ea typeface="Aptos"/>
                 <a:cs typeface="Aptos"/>
               </a:rPr>
-              <a:t>Website · grants · Y2</a:t>
-            </a:r>
-          </a:p>
-        </p:txBody>
-      </p:sp>
-      <p:sp>
-        <p:nvSpPr>
-          <p:cNvPr id="29" name="text-22">
-            <a:extLst xmlns:a="http://schemas.openxmlformats.org/drawingml/2006/main">
-              <a:ext uri="{FF2B5EF4-FFF2-40B4-BE49-F238E27FC236}">
-                <a16:creationId xmlns:a16="http://schemas.microsoft.com/office/drawing/2014/main" id="{7587C5C6-AF3C-438D-A79E-EF65919D32F7}"/>
-              </a:ext>
-            </a:extLst>
-          </p:cNvPr>
-          <p:cNvSpPr>
-            <a:spLocks xmlns:a="http://schemas.openxmlformats.org/drawingml/2006/main" noGrp="1"/>
-          </p:cNvSpPr>
-          <p:nvPr/>
-        </p:nvSpPr>
-        <p:spPr>
-          <a:xfrm xmlns:a="http://schemas.openxmlformats.org/drawingml/2006/main">
-            <a:off x="4610100" y="6858000"/>
-            <a:ext cx="3429000" cy="571500"/>
+              <a:t>Graph / vector projection</a:t>
+            </a:r>
+          </a:p>
+        </p:txBody>
+      </p:sp>
+      <p:sp>
+        <p:nvSpPr>
+          <p:cNvPr id="29" name="revised-text-22">
+            <a:extLst xmlns:a="http://schemas.openxmlformats.org/drawingml/2006/main">
+              <a:ext uri="{FF2B5EF4-FFF2-40B4-BE49-F238E27FC236}">
+                <a16:creationId xmlns:a16="http://schemas.microsoft.com/office/drawing/2014/main" id="{BAAD6C4B-4045-4D0B-8CBF-343783D884A7}"/>
+              </a:ext>
+            </a:extLst>
+          </p:cNvPr>
+          <p:cNvSpPr>
+            <a:spLocks xmlns:a="http://schemas.openxmlformats.org/drawingml/2006/main" noGrp="1"/>
+          </p:cNvSpPr>
+          <p:nvPr/>
+        </p:nvSpPr>
+        <p:spPr>
+          <a:xfrm xmlns:a="http://schemas.openxmlformats.org/drawingml/2006/main">
+            <a:off x="5086350" y="4467225"/>
+            <a:ext cx="6667500" cy="381000"/>
           </a:xfrm>
           <a:prstGeom xmlns:a="http://schemas.openxmlformats.org/drawingml/2006/main" prst="rect">
             <a:avLst/>
@@ -4889,29 +4908,29 @@
                 <a:ea typeface="Aptos"/>
                 <a:cs typeface="Aptos"/>
               </a:rPr>
-              <a:t>Scoped credentials</a:t>
-            </a:r>
-          </a:p>
-        </p:txBody>
-      </p:sp>
-      <p:sp>
-        <p:nvSpPr>
-          <p:cNvPr id="30" name="text-23">
-            <a:extLst xmlns:a="http://schemas.openxmlformats.org/drawingml/2006/main">
-              <a:ext uri="{FF2B5EF4-FFF2-40B4-BE49-F238E27FC236}">
-                <a16:creationId xmlns:a16="http://schemas.microsoft.com/office/drawing/2014/main" id="{84E2A371-A402-4CFF-B989-551B211A3998}"/>
-              </a:ext>
-            </a:extLst>
-          </p:cNvPr>
-          <p:cNvSpPr>
-            <a:spLocks xmlns:a="http://schemas.openxmlformats.org/drawingml/2006/main" noGrp="1"/>
-          </p:cNvSpPr>
-          <p:nvPr/>
-        </p:nvSpPr>
-        <p:spPr>
-          <a:xfrm xmlns:a="http://schemas.openxmlformats.org/drawingml/2006/main">
-            <a:off x="8991600" y="6858000"/>
-            <a:ext cx="5638800" cy="571500"/>
+              <a:t>Trusted adapters · scoped service access</a:t>
+            </a:r>
+          </a:p>
+        </p:txBody>
+      </p:sp>
+      <p:sp>
+        <p:nvSpPr>
+          <p:cNvPr id="30" name="revised-text-23">
+            <a:extLst xmlns:a="http://schemas.openxmlformats.org/drawingml/2006/main">
+              <a:ext uri="{FF2B5EF4-FFF2-40B4-BE49-F238E27FC236}">
+                <a16:creationId xmlns:a16="http://schemas.microsoft.com/office/drawing/2014/main" id="{35EC8245-B221-4F2C-BECD-363B393832AA}"/>
+              </a:ext>
+            </a:extLst>
+          </p:cNvPr>
+          <p:cNvSpPr>
+            <a:spLocks xmlns:a="http://schemas.openxmlformats.org/drawingml/2006/main" noGrp="1"/>
+          </p:cNvSpPr>
+          <p:nvPr/>
+        </p:nvSpPr>
+        <p:spPr>
+          <a:xfrm xmlns:a="http://schemas.openxmlformats.org/drawingml/2006/main">
+            <a:off x="609600" y="6629400"/>
+            <a:ext cx="4095750" cy="571500"/>
           </a:xfrm>
           <a:prstGeom xmlns:a="http://schemas.openxmlformats.org/drawingml/2006/main" prst="rect">
             <a:avLst/>
@@ -4956,7 +4975,277 @@
                 <a:ea typeface="Aptos"/>
                 <a:cs typeface="Aptos"/>
               </a:rPr>
-              <a:t>Grant specialist UI: optional</a:t>
+              <a:t>Logical ownership</a:t>
+            </a:r>
+          </a:p>
+          <a:p xmlns:a="http://schemas.openxmlformats.org/drawingml/2006/main">
+            <a:pPr>
+              <a:defRPr sz="1725" b="0">
+                <a:solidFill>
+                  <a:srgbClr val="49616A"/>
+                </a:solidFill>
+                <a:latin typeface="Aptos"/>
+                <a:ea typeface="Aptos"/>
+                <a:cs typeface="Aptos"/>
+              </a:defRPr>
+            </a:pPr>
+            <a:r>
+              <a:rPr sz="1725" b="0">
+                <a:solidFill>
+                  <a:srgbClr val="49616A"/>
+                </a:solidFill>
+                <a:latin typeface="Aptos"/>
+                <a:ea typeface="Aptos"/>
+                <a:cs typeface="Aptos"/>
+              </a:rPr>
+              <a:t>No separate DB servers implied</a:t>
+            </a:r>
+          </a:p>
+        </p:txBody>
+      </p:sp>
+      <p:sp>
+        <p:nvSpPr>
+          <p:cNvPr id="31" name="revised-text-24">
+            <a:extLst xmlns:a="http://schemas.openxmlformats.org/drawingml/2006/main">
+              <a:ext uri="{FF2B5EF4-FFF2-40B4-BE49-F238E27FC236}">
+                <a16:creationId xmlns:a16="http://schemas.microsoft.com/office/drawing/2014/main" id="{C578EEF8-D73B-469E-8DE6-325FA4AFCB3D}"/>
+              </a:ext>
+            </a:extLst>
+          </p:cNvPr>
+          <p:cNvSpPr>
+            <a:spLocks xmlns:a="http://schemas.openxmlformats.org/drawingml/2006/main" noGrp="1"/>
+          </p:cNvSpPr>
+          <p:nvPr/>
+        </p:nvSpPr>
+        <p:spPr>
+          <a:xfrm xmlns:a="http://schemas.openxmlformats.org/drawingml/2006/main">
+            <a:off x="5086350" y="6629400"/>
+            <a:ext cx="4857750" cy="571500"/>
+          </a:xfrm>
+          <a:prstGeom xmlns:a="http://schemas.openxmlformats.org/drawingml/2006/main" prst="rect">
+            <a:avLst/>
+          </a:prstGeom>
+          <a:noFill xmlns:a="http://schemas.openxmlformats.org/drawingml/2006/main"/>
+          <a:ln xmlns:a="http://schemas.openxmlformats.org/drawingml/2006/main" w="0">
+            <a:noFill/>
+            <a:prstDash val="solid"/>
+          </a:ln>
+        </p:spPr>
+        <p:txBody>
+          <a:bodyPr xmlns:a="http://schemas.openxmlformats.org/drawingml/2006/main" lIns="0" tIns="0" rIns="0" bIns="0" anchor="t"/>
+          <a:lstStyle xmlns:a="http://schemas.openxmlformats.org/drawingml/2006/main">
+            <a:defPPr>
+              <a:defRPr sz="1725" b="0">
+                <a:solidFill>
+                  <a:srgbClr val="49616A"/>
+                </a:solidFill>
+                <a:latin typeface="Aptos"/>
+                <a:ea typeface="Aptos"/>
+                <a:cs typeface="Aptos"/>
+              </a:defRPr>
+            </a:defPPr>
+          </a:lstStyle>
+          <a:p xmlns:a="http://schemas.openxmlformats.org/drawingml/2006/main">
+            <a:pPr>
+              <a:defRPr sz="1725" b="0">
+                <a:solidFill>
+                  <a:srgbClr val="49616A"/>
+                </a:solidFill>
+                <a:latin typeface="Aptos"/>
+                <a:ea typeface="Aptos"/>
+                <a:cs typeface="Aptos"/>
+              </a:defRPr>
+            </a:pPr>
+            <a:r>
+              <a:rPr sz="1725" b="0">
+                <a:solidFill>
+                  <a:srgbClr val="49616A"/>
+                </a:solidFill>
+                <a:latin typeface="Aptos"/>
+                <a:ea typeface="Aptos"/>
+                <a:cs typeface="Aptos"/>
+              </a:rPr>
+              <a:t>Provider capabilities: verify</a:t>
+            </a:r>
+          </a:p>
+          <a:p xmlns:a="http://schemas.openxmlformats.org/drawingml/2006/main">
+            <a:pPr>
+              <a:defRPr sz="1725" b="0">
+                <a:solidFill>
+                  <a:srgbClr val="49616A"/>
+                </a:solidFill>
+                <a:latin typeface="Aptos"/>
+                <a:ea typeface="Aptos"/>
+                <a:cs typeface="Aptos"/>
+              </a:defRPr>
+            </a:pPr>
+            <a:r>
+              <a:rPr sz="1725" b="0">
+                <a:solidFill>
+                  <a:srgbClr val="49616A"/>
+                </a:solidFill>
+                <a:latin typeface="Aptos"/>
+                <a:ea typeface="Aptos"/>
+                <a:cs typeface="Aptos"/>
+              </a:rPr>
+              <a:t>Funding + meeting domain schemas</a:t>
+            </a:r>
+          </a:p>
+        </p:txBody>
+      </p:sp>
+      <p:sp>
+        <p:nvSpPr>
+          <p:cNvPr id="32" name="revised-text-25">
+            <a:extLst xmlns:a="http://schemas.openxmlformats.org/drawingml/2006/main">
+              <a:ext uri="{FF2B5EF4-FFF2-40B4-BE49-F238E27FC236}">
+                <a16:creationId xmlns:a16="http://schemas.microsoft.com/office/drawing/2014/main" id="{C1889348-5DED-4CBE-AD66-010223BD8730}"/>
+              </a:ext>
+            </a:extLst>
+          </p:cNvPr>
+          <p:cNvSpPr>
+            <a:spLocks xmlns:a="http://schemas.openxmlformats.org/drawingml/2006/main" noGrp="1"/>
+          </p:cNvSpPr>
+          <p:nvPr/>
+        </p:nvSpPr>
+        <p:spPr>
+          <a:xfrm xmlns:a="http://schemas.openxmlformats.org/drawingml/2006/main">
+            <a:off x="10896600" y="6629400"/>
+            <a:ext cx="3733800" cy="571500"/>
+          </a:xfrm>
+          <a:prstGeom xmlns:a="http://schemas.openxmlformats.org/drawingml/2006/main" prst="rect">
+            <a:avLst/>
+          </a:prstGeom>
+          <a:noFill xmlns:a="http://schemas.openxmlformats.org/drawingml/2006/main"/>
+          <a:ln xmlns:a="http://schemas.openxmlformats.org/drawingml/2006/main" w="0">
+            <a:noFill/>
+            <a:prstDash val="solid"/>
+          </a:ln>
+        </p:spPr>
+        <p:txBody>
+          <a:bodyPr xmlns:a="http://schemas.openxmlformats.org/drawingml/2006/main" lIns="0" tIns="0" rIns="0" bIns="0" anchor="t"/>
+          <a:lstStyle xmlns:a="http://schemas.openxmlformats.org/drawingml/2006/main">
+            <a:defPPr>
+              <a:defRPr sz="1575" b="0">
+                <a:solidFill>
+                  <a:srgbClr val="49616A"/>
+                </a:solidFill>
+                <a:latin typeface="Aptos"/>
+                <a:ea typeface="Aptos"/>
+                <a:cs typeface="Aptos"/>
+              </a:defRPr>
+            </a:defPPr>
+          </a:lstStyle>
+          <a:p xmlns:a="http://schemas.openxmlformats.org/drawingml/2006/main">
+            <a:pPr>
+              <a:defRPr sz="1575" b="0">
+                <a:solidFill>
+                  <a:srgbClr val="49616A"/>
+                </a:solidFill>
+                <a:latin typeface="Aptos"/>
+                <a:ea typeface="Aptos"/>
+                <a:cs typeface="Aptos"/>
+              </a:defRPr>
+            </a:pPr>
+            <a:r>
+              <a:rPr sz="1575" b="0">
+                <a:solidFill>
+                  <a:srgbClr val="49616A"/>
+                </a:solidFill>
+                <a:latin typeface="Aptos"/>
+                <a:ea typeface="Aptos"/>
+                <a:cs typeface="Aptos"/>
+              </a:rPr>
+              <a:t>Funding / 990 / Y2</a:t>
+            </a:r>
+          </a:p>
+          <a:p xmlns:a="http://schemas.openxmlformats.org/drawingml/2006/main">
+            <a:pPr>
+              <a:defRPr sz="1575" b="0">
+                <a:solidFill>
+                  <a:srgbClr val="49616A"/>
+                </a:solidFill>
+                <a:latin typeface="Aptos"/>
+                <a:ea typeface="Aptos"/>
+                <a:cs typeface="Aptos"/>
+              </a:defRPr>
+            </a:pPr>
+            <a:r>
+              <a:rPr sz="1575" b="0">
+                <a:solidFill>
+                  <a:srgbClr val="49616A"/>
+                </a:solidFill>
+                <a:latin typeface="Aptos"/>
+                <a:ea typeface="Aptos"/>
+                <a:cs typeface="Aptos"/>
+              </a:rPr>
+              <a:t>Provenance + version + access filters</a:t>
+            </a:r>
+          </a:p>
+        </p:txBody>
+      </p:sp>
+      <p:sp>
+        <p:nvSpPr>
+          <p:cNvPr id="33" name="revised-text-26">
+            <a:extLst xmlns:a="http://schemas.openxmlformats.org/drawingml/2006/main">
+              <a:ext uri="{FF2B5EF4-FFF2-40B4-BE49-F238E27FC236}">
+                <a16:creationId xmlns:a16="http://schemas.microsoft.com/office/drawing/2014/main" id="{DC17FBDE-4347-494A-8CD6-C92D761F6CCE}"/>
+              </a:ext>
+            </a:extLst>
+          </p:cNvPr>
+          <p:cNvSpPr>
+            <a:spLocks xmlns:a="http://schemas.openxmlformats.org/drawingml/2006/main" noGrp="1"/>
+          </p:cNvSpPr>
+          <p:nvPr/>
+        </p:nvSpPr>
+        <p:spPr>
+          <a:xfrm xmlns:a="http://schemas.openxmlformats.org/drawingml/2006/main">
+            <a:off x="609600" y="7429500"/>
+            <a:ext cx="14020800" cy="323850"/>
+          </a:xfrm>
+          <a:prstGeom xmlns:a="http://schemas.openxmlformats.org/drawingml/2006/main" prst="rect">
+            <a:avLst/>
+          </a:prstGeom>
+          <a:noFill xmlns:a="http://schemas.openxmlformats.org/drawingml/2006/main"/>
+          <a:ln xmlns:a="http://schemas.openxmlformats.org/drawingml/2006/main" w="0">
+            <a:noFill/>
+            <a:prstDash val="solid"/>
+          </a:ln>
+        </p:spPr>
+        <p:txBody>
+          <a:bodyPr xmlns:a="http://schemas.openxmlformats.org/drawingml/2006/main" lIns="0" tIns="0" rIns="0" bIns="0" anchor="t"/>
+          <a:lstStyle xmlns:a="http://schemas.openxmlformats.org/drawingml/2006/main">
+            <a:defPPr>
+              <a:defRPr sz="1875" b="0">
+                <a:solidFill>
+                  <a:srgbClr val="916011"/>
+                </a:solidFill>
+                <a:latin typeface="Aptos"/>
+                <a:ea typeface="Aptos"/>
+                <a:cs typeface="Aptos"/>
+              </a:defRPr>
+            </a:defPPr>
+          </a:lstStyle>
+          <a:p xmlns:a="http://schemas.openxmlformats.org/drawingml/2006/main">
+            <a:pPr>
+              <a:defRPr sz="1875" b="0">
+                <a:solidFill>
+                  <a:srgbClr val="916011"/>
+                </a:solidFill>
+                <a:latin typeface="Aptos"/>
+                <a:ea typeface="Aptos"/>
+                <a:cs typeface="Aptos"/>
+              </a:defRPr>
+            </a:pPr>
+            <a:r>
+              <a:rPr sz="1875" b="0">
+                <a:solidFill>
+                  <a:srgbClr val="916011"/>
+                </a:solidFill>
+                <a:latin typeface="Aptos"/>
+                <a:ea typeface="Aptos"/>
+                <a:cs typeface="Aptos"/>
+              </a:rPr>
+              <a:t>Helix: optional demo projection. No fact, transaction, review or approval authority.</a:t>
             </a:r>
           </a:p>
         </p:txBody>
@@ -5347,7 +5636,7 @@
                 <a:ea typeface="Aptos"/>
                 <a:cs typeface="Aptos"/>
               </a:rPr>
-              <a:t>Inertia architecture · r11 · 23 October 2026</a:t>
+              <a:t>Inertia architecture · r12 · 23 October 2026</a:t>
             </a:r>
           </a:p>
         </p:txBody>
@@ -6556,7 +6845,7 @@
           <p:cNvPr id="28" name="">
             <a:extLst xmlns:a="http://schemas.openxmlformats.org/drawingml/2006/main">
               <a:ext uri="{FF2B5EF4-FFF2-40B4-BE49-F238E27FC236}">
-                <a16:creationId xmlns:a16="http://schemas.microsoft.com/office/drawing/2014/main" id="{4E1055AF-31A2-41C7-B11A-E380465E5EEF}"/>
+                <a16:creationId xmlns:a16="http://schemas.microsoft.com/office/drawing/2014/main" id="{980C90E1-8F7E-455E-BD51-05BEA4449865}"/>
               </a:ext>
             </a:extLst>
           </p:cNvPr>
@@ -6588,7 +6877,7 @@
           <p:cNvPr id="27" name="">
             <a:extLst xmlns:a="http://schemas.openxmlformats.org/drawingml/2006/main">
               <a:ext uri="{FF2B5EF4-FFF2-40B4-BE49-F238E27FC236}">
-                <a16:creationId xmlns:a16="http://schemas.microsoft.com/office/drawing/2014/main" id="{3C361D32-C11E-4C3D-8E08-F851AE586B25}"/>
+                <a16:creationId xmlns:a16="http://schemas.microsoft.com/office/drawing/2014/main" id="{782470C3-5B53-4B8D-999B-8D757B543B4C}"/>
               </a:ext>
             </a:extLst>
           </p:cNvPr>
@@ -6620,7 +6909,7 @@
           <p:cNvPr id="26" name="">
             <a:extLst xmlns:a="http://schemas.openxmlformats.org/drawingml/2006/main">
               <a:ext uri="{FF2B5EF4-FFF2-40B4-BE49-F238E27FC236}">
-                <a16:creationId xmlns:a16="http://schemas.microsoft.com/office/drawing/2014/main" id="{DB041CD1-F659-4594-9738-787D8D75C825}"/>
+                <a16:creationId xmlns:a16="http://schemas.microsoft.com/office/drawing/2014/main" id="{3CA08E8E-F0D5-425C-8EEC-3F2BB471DF49}"/>
               </a:ext>
             </a:extLst>
           </p:cNvPr>
@@ -6652,7 +6941,7 @@
           <p:cNvPr id="16" name="">
             <a:extLst xmlns:a="http://schemas.openxmlformats.org/drawingml/2006/main">
               <a:ext uri="{FF2B5EF4-FFF2-40B4-BE49-F238E27FC236}">
-                <a16:creationId xmlns:a16="http://schemas.microsoft.com/office/drawing/2014/main" id="{B05935B4-87A8-45C1-BBF0-B500B4D729D8}"/>
+                <a16:creationId xmlns:a16="http://schemas.microsoft.com/office/drawing/2014/main" id="{34B34925-812D-46B5-A647-E619D3AAE082}"/>
               </a:ext>
             </a:extLst>
           </p:cNvPr>
@@ -6684,7 +6973,7 @@
           <p:cNvPr id="15" name="">
             <a:extLst xmlns:a="http://schemas.openxmlformats.org/drawingml/2006/main">
               <a:ext uri="{FF2B5EF4-FFF2-40B4-BE49-F238E27FC236}">
-                <a16:creationId xmlns:a16="http://schemas.microsoft.com/office/drawing/2014/main" id="{34FCBDD2-046D-4E18-8ACC-D5CBD66984B2}"/>
+                <a16:creationId xmlns:a16="http://schemas.microsoft.com/office/drawing/2014/main" id="{8ED717A1-C84A-4660-861B-1FD5EC9657E6}"/>
               </a:ext>
             </a:extLst>
           </p:cNvPr>
@@ -6755,6 +7044,7 @@
           </a:lstStyle>
           <a:p xmlns:a="http://schemas.openxmlformats.org/drawingml/2006/main">
             <a:pPr>
+              <a:buNone/>
               <a:defRPr sz="3600" b="1">
                 <a:solidFill>
                   <a:srgbClr val="132E38"/>
@@ -6822,6 +7112,7 @@
           </a:lstStyle>
           <a:p xmlns:a="http://schemas.openxmlformats.org/drawingml/2006/main">
             <a:pPr>
+              <a:buNone/>
               <a:defRPr sz="2025" b="0">
                 <a:solidFill>
                   <a:srgbClr val="49616A"/>
@@ -6840,7 +7131,7 @@
                 <a:ea typeface="Aptos"/>
                 <a:cs typeface="Aptos"/>
               </a:rPr>
-              <a:t>Target flow</a:t>
+              <a:t>Target flow · existing DAO PostgreSQL / meeting schema</a:t>
             </a:r>
           </a:p>
         </p:txBody>
@@ -6919,6 +7210,7 @@
           </a:lstStyle>
           <a:p xmlns:a="http://schemas.openxmlformats.org/drawingml/2006/main">
             <a:pPr>
+              <a:buNone/>
               <a:defRPr sz="1350" b="0">
                 <a:solidFill>
                   <a:srgbClr val="49616A"/>
@@ -6937,7 +7229,7 @@
                 <a:ea typeface="Aptos"/>
                 <a:cs typeface="Aptos"/>
               </a:rPr>
-              <a:t>Inertia architecture · r11 · 23 October 2026</a:t>
+              <a:t>Inertia architecture · r12 · 23 October 2026</a:t>
             </a:r>
           </a:p>
         </p:txBody>
@@ -6986,6 +7278,7 @@
           </a:lstStyle>
           <a:p xmlns:a="http://schemas.openxmlformats.org/drawingml/2006/main">
             <a:pPr>
+              <a:buNone/>
               <a:defRPr sz="1650" b="1">
                 <a:solidFill>
                   <a:srgbClr val="157D80"/>
@@ -7086,6 +7379,7 @@
           </a:lstStyle>
           <a:p xmlns:a="http://schemas.openxmlformats.org/drawingml/2006/main">
             <a:pPr>
+              <a:buNone/>
               <a:defRPr sz="2250" b="1">
                 <a:solidFill>
                   <a:srgbClr val="132E38"/>
@@ -7153,6 +7447,7 @@
           </a:lstStyle>
           <a:p xmlns:a="http://schemas.openxmlformats.org/drawingml/2006/main">
             <a:pPr>
+              <a:buNone/>
               <a:defRPr sz="1875" b="0">
                 <a:solidFill>
                   <a:srgbClr val="49616A"/>
@@ -7253,6 +7548,7 @@
           </a:lstStyle>
           <a:p xmlns:a="http://schemas.openxmlformats.org/drawingml/2006/main">
             <a:pPr>
+              <a:buNone/>
               <a:defRPr sz="2250" b="1">
                 <a:solidFill>
                   <a:srgbClr val="157D80"/>
@@ -7320,6 +7616,7 @@
           </a:lstStyle>
           <a:p xmlns:a="http://schemas.openxmlformats.org/drawingml/2006/main">
             <a:pPr>
+              <a:buNone/>
               <a:defRPr sz="1875" b="0">
                 <a:solidFill>
                   <a:srgbClr val="49616A"/>
@@ -7420,6 +7717,7 @@
           </a:lstStyle>
           <a:p xmlns:a="http://schemas.openxmlformats.org/drawingml/2006/main">
             <a:pPr>
+              <a:buNone/>
               <a:defRPr sz="2250" b="1">
                 <a:solidFill>
                   <a:srgbClr val="132E38"/>
@@ -7487,6 +7785,7 @@
           </a:lstStyle>
           <a:p xmlns:a="http://schemas.openxmlformats.org/drawingml/2006/main">
             <a:pPr>
+              <a:buNone/>
               <a:defRPr sz="1875" b="0">
                 <a:solidFill>
                   <a:srgbClr val="49616A"/>
@@ -7587,6 +7886,7 @@
           </a:lstStyle>
           <a:p xmlns:a="http://schemas.openxmlformats.org/drawingml/2006/main">
             <a:pPr>
+              <a:buNone/>
               <a:defRPr sz="2250" b="1">
                 <a:solidFill>
                   <a:srgbClr val="157D80"/>
@@ -7654,6 +7954,7 @@
           </a:lstStyle>
           <a:p xmlns:a="http://schemas.openxmlformats.org/drawingml/2006/main">
             <a:pPr>
+              <a:buNone/>
               <a:defRPr sz="1875" b="0">
                 <a:solidFill>
                   <a:srgbClr val="49616A"/>
@@ -7754,6 +8055,7 @@
           </a:lstStyle>
           <a:p xmlns:a="http://schemas.openxmlformats.org/drawingml/2006/main">
             <a:pPr>
+              <a:buNone/>
               <a:defRPr sz="2250" b="1">
                 <a:solidFill>
                   <a:srgbClr val="132E38"/>
@@ -7821,6 +8123,7 @@
           </a:lstStyle>
           <a:p xmlns:a="http://schemas.openxmlformats.org/drawingml/2006/main">
             <a:pPr>
+              <a:buNone/>
               <a:defRPr sz="1875" b="0">
                 <a:solidFill>
                   <a:srgbClr val="49616A"/>
@@ -7839,7 +8142,7 @@
                 <a:ea typeface="Aptos"/>
                 <a:cs typeface="Aptos"/>
               </a:rPr>
-              <a:t>Active-membership authorization</a:t>
+              <a:t>Member ACL + meeting schema target</a:t>
             </a:r>
           </a:p>
         </p:txBody>
@@ -7921,6 +8224,7 @@
           </a:lstStyle>
           <a:p xmlns:a="http://schemas.openxmlformats.org/drawingml/2006/main">
             <a:pPr>
+              <a:buNone/>
               <a:defRPr sz="2250" b="1">
                 <a:solidFill>
                   <a:srgbClr val="132E38"/>
@@ -7988,6 +8292,7 @@
           </a:lstStyle>
           <a:p xmlns:a="http://schemas.openxmlformats.org/drawingml/2006/main">
             <a:pPr>
+              <a:buNone/>
               <a:defRPr sz="1875" b="0">
                 <a:solidFill>
                   <a:srgbClr val="49616A"/>
@@ -8055,6 +8360,7 @@
           </a:lstStyle>
           <a:p xmlns:a="http://schemas.openxmlformats.org/drawingml/2006/main">
             <a:pPr>
+              <a:buNone/>
               <a:defRPr sz="1725" b="0">
                 <a:solidFill>
                   <a:srgbClr val="49616A"/>
@@ -8112,7 +8418,7 @@
           <p:cNvPr id="31" name="">
             <a:extLst xmlns:a="http://schemas.openxmlformats.org/drawingml/2006/main">
               <a:ext uri="{FF2B5EF4-FFF2-40B4-BE49-F238E27FC236}">
-                <a16:creationId xmlns:a16="http://schemas.microsoft.com/office/drawing/2014/main" id="{C653D1C8-7E09-4C7D-9481-8CC3FCA81A52}"/>
+                <a16:creationId xmlns:a16="http://schemas.microsoft.com/office/drawing/2014/main" id="{E04CA699-12DE-4EB3-A909-FB245B95BDD5}"/>
               </a:ext>
             </a:extLst>
           </p:cNvPr>
@@ -8144,7 +8450,7 @@
           <p:cNvPr id="30" name="">
             <a:extLst xmlns:a="http://schemas.openxmlformats.org/drawingml/2006/main">
               <a:ext uri="{FF2B5EF4-FFF2-40B4-BE49-F238E27FC236}">
-                <a16:creationId xmlns:a16="http://schemas.microsoft.com/office/drawing/2014/main" id="{5C41840E-98F7-41B9-B187-802DF2A53EB2}"/>
+                <a16:creationId xmlns:a16="http://schemas.microsoft.com/office/drawing/2014/main" id="{5394FC92-4FC0-4564-BAED-A2B6274A82DA}"/>
               </a:ext>
             </a:extLst>
           </p:cNvPr>
@@ -8176,7 +8482,7 @@
           <p:cNvPr id="29" name="">
             <a:extLst xmlns:a="http://schemas.openxmlformats.org/drawingml/2006/main">
               <a:ext uri="{FF2B5EF4-FFF2-40B4-BE49-F238E27FC236}">
-                <a16:creationId xmlns:a16="http://schemas.microsoft.com/office/drawing/2014/main" id="{6ABB7A19-96AC-4CA6-8A20-0A2823048D97}"/>
+                <a16:creationId xmlns:a16="http://schemas.microsoft.com/office/drawing/2014/main" id="{8C7059F8-1D98-4019-A990-C648261D160F}"/>
               </a:ext>
             </a:extLst>
           </p:cNvPr>
@@ -8208,7 +8514,7 @@
           <p:cNvPr id="16" name="">
             <a:extLst xmlns:a="http://schemas.openxmlformats.org/drawingml/2006/main">
               <a:ext uri="{FF2B5EF4-FFF2-40B4-BE49-F238E27FC236}">
-                <a16:creationId xmlns:a16="http://schemas.microsoft.com/office/drawing/2014/main" id="{F04BF26C-4A08-4773-B43B-E56C0DDF3D5B}"/>
+                <a16:creationId xmlns:a16="http://schemas.microsoft.com/office/drawing/2014/main" id="{DD07D8A8-748F-4F3B-8965-2AE6FAA170A0}"/>
               </a:ext>
             </a:extLst>
           </p:cNvPr>
@@ -8240,7 +8546,7 @@
           <p:cNvPr id="15" name="">
             <a:extLst xmlns:a="http://schemas.openxmlformats.org/drawingml/2006/main">
               <a:ext uri="{FF2B5EF4-FFF2-40B4-BE49-F238E27FC236}">
-                <a16:creationId xmlns:a16="http://schemas.microsoft.com/office/drawing/2014/main" id="{DFFCB739-67CF-4827-916B-49EA2CC13DE1}"/>
+                <a16:creationId xmlns:a16="http://schemas.microsoft.com/office/drawing/2014/main" id="{1ED811AC-047E-4D52-B3B5-AD7369AB142B}"/>
               </a:ext>
             </a:extLst>
           </p:cNvPr>
@@ -8311,6 +8617,7 @@
           </a:lstStyle>
           <a:p xmlns:a="http://schemas.openxmlformats.org/drawingml/2006/main">
             <a:pPr>
+              <a:buNone/>
               <a:defRPr sz="3600" b="1">
                 <a:solidFill>
                   <a:srgbClr val="132E38"/>
@@ -8378,6 +8685,7 @@
           </a:lstStyle>
           <a:p xmlns:a="http://schemas.openxmlformats.org/drawingml/2006/main">
             <a:pPr>
+              <a:buNone/>
               <a:defRPr sz="2025" b="0">
                 <a:solidFill>
                   <a:srgbClr val="49616A"/>
@@ -8475,6 +8783,7 @@
           </a:lstStyle>
           <a:p xmlns:a="http://schemas.openxmlformats.org/drawingml/2006/main">
             <a:pPr>
+              <a:buNone/>
               <a:defRPr sz="1350" b="0">
                 <a:solidFill>
                   <a:srgbClr val="49616A"/>
@@ -8493,7 +8802,7 @@
                 <a:ea typeface="Aptos"/>
                 <a:cs typeface="Aptos"/>
               </a:rPr>
-              <a:t>Inertia architecture · r11 · 23 October 2026</a:t>
+              <a:t>Inertia architecture · r12 · 23 October 2026</a:t>
             </a:r>
           </a:p>
         </p:txBody>
@@ -8542,6 +8851,7 @@
           </a:lstStyle>
           <a:p xmlns:a="http://schemas.openxmlformats.org/drawingml/2006/main">
             <a:pPr>
+              <a:buNone/>
               <a:defRPr sz="1650" b="1">
                 <a:solidFill>
                   <a:srgbClr val="157D80"/>
@@ -8642,6 +8952,7 @@
           </a:lstStyle>
           <a:p xmlns:a="http://schemas.openxmlformats.org/drawingml/2006/main">
             <a:pPr>
+              <a:buNone/>
               <a:defRPr sz="2250" b="1">
                 <a:solidFill>
                   <a:srgbClr val="132E38"/>
@@ -8709,6 +9020,7 @@
           </a:lstStyle>
           <a:p xmlns:a="http://schemas.openxmlformats.org/drawingml/2006/main">
             <a:pPr>
+              <a:buNone/>
               <a:defRPr sz="1875" b="0">
                 <a:solidFill>
                   <a:srgbClr val="49616A"/>
@@ -8809,6 +9121,7 @@
           </a:lstStyle>
           <a:p xmlns:a="http://schemas.openxmlformats.org/drawingml/2006/main">
             <a:pPr>
+              <a:buNone/>
               <a:defRPr sz="2250" b="1">
                 <a:solidFill>
                   <a:srgbClr val="157D80"/>
@@ -8876,6 +9189,7 @@
           </a:lstStyle>
           <a:p xmlns:a="http://schemas.openxmlformats.org/drawingml/2006/main">
             <a:pPr>
+              <a:buNone/>
               <a:defRPr sz="1875" b="0">
                 <a:solidFill>
                   <a:srgbClr val="49616A"/>
@@ -8976,6 +9290,7 @@
           </a:lstStyle>
           <a:p xmlns:a="http://schemas.openxmlformats.org/drawingml/2006/main">
             <a:pPr>
+              <a:buNone/>
               <a:defRPr sz="2250" b="1">
                 <a:solidFill>
                   <a:srgbClr val="132E38"/>
@@ -9043,6 +9358,7 @@
           </a:lstStyle>
           <a:p xmlns:a="http://schemas.openxmlformats.org/drawingml/2006/main">
             <a:pPr>
+              <a:buNone/>
               <a:defRPr sz="1875" b="0">
                 <a:solidFill>
                   <a:srgbClr val="49616A"/>
@@ -9110,6 +9426,7 @@
           </a:lstStyle>
           <a:p xmlns:a="http://schemas.openxmlformats.org/drawingml/2006/main">
             <a:pPr>
+              <a:buNone/>
               <a:defRPr sz="1725" b="0">
                 <a:solidFill>
                   <a:srgbClr val="49616A"/>
@@ -9177,6 +9494,7 @@
           </a:lstStyle>
           <a:p xmlns:a="http://schemas.openxmlformats.org/drawingml/2006/main">
             <a:pPr>
+              <a:buNone/>
               <a:defRPr sz="1725" b="0">
                 <a:solidFill>
                   <a:srgbClr val="49616A"/>
@@ -9244,6 +9562,7 @@
           </a:lstStyle>
           <a:p xmlns:a="http://schemas.openxmlformats.org/drawingml/2006/main">
             <a:pPr>
+              <a:buNone/>
               <a:defRPr sz="1725" b="0">
                 <a:solidFill>
                   <a:srgbClr val="49616A"/>
@@ -9267,6 +9586,7 @@
           </a:p>
           <a:p xmlns:a="http://schemas.openxmlformats.org/drawingml/2006/main">
             <a:pPr>
+              <a:buNone/>
               <a:defRPr sz="1725" b="0">
                 <a:solidFill>
                   <a:srgbClr val="49616A"/>
@@ -9367,6 +9687,7 @@
           </a:lstStyle>
           <a:p xmlns:a="http://schemas.openxmlformats.org/drawingml/2006/main">
             <a:pPr>
+              <a:buNone/>
               <a:defRPr sz="2250" b="1">
                 <a:solidFill>
                   <a:srgbClr val="132E38"/>
@@ -9385,7 +9706,7 @@
                 <a:ea typeface="Aptos"/>
                 <a:cs typeface="Aptos"/>
               </a:rPr>
-              <a:t>Funding domain</a:t>
+              <a:t>Funding backend</a:t>
             </a:r>
           </a:p>
         </p:txBody>
@@ -9434,6 +9755,7 @@
           </a:lstStyle>
           <a:p xmlns:a="http://schemas.openxmlformats.org/drawingml/2006/main">
             <a:pPr>
+              <a:buNone/>
               <a:defRPr sz="1875" b="0">
                 <a:solidFill>
                   <a:srgbClr val="49616A"/>
@@ -9452,7 +9774,7 @@
                 <a:ea typeface="Aptos"/>
                 <a:cs typeface="Aptos"/>
               </a:rPr>
-              <a:t>Evidence + proposals + audit</a:t>
+              <a:t>DAO funding schema · target</a:t>
             </a:r>
           </a:p>
         </p:txBody>
@@ -9534,6 +9856,7 @@
           </a:lstStyle>
           <a:p xmlns:a="http://schemas.openxmlformats.org/drawingml/2006/main">
             <a:pPr>
+              <a:buNone/>
               <a:defRPr sz="2250" b="1">
                 <a:solidFill>
                   <a:srgbClr val="157D80"/>
@@ -9601,6 +9924,7 @@
           </a:lstStyle>
           <a:p xmlns:a="http://schemas.openxmlformats.org/drawingml/2006/main">
             <a:pPr>
+              <a:buNone/>
               <a:defRPr sz="1875" b="0">
                 <a:solidFill>
                   <a:srgbClr val="49616A"/>
@@ -9624,6 +9948,7 @@
           </a:p>
           <a:p xmlns:a="http://schemas.openxmlformats.org/drawingml/2006/main">
             <a:pPr>
+              <a:buNone/>
               <a:defRPr sz="1875" b="0">
                 <a:solidFill>
                   <a:srgbClr val="49616A"/>
@@ -9724,6 +10049,7 @@
           </a:lstStyle>
           <a:p xmlns:a="http://schemas.openxmlformats.org/drawingml/2006/main">
             <a:pPr>
+              <a:buNone/>
               <a:defRPr sz="2250" b="1">
                 <a:solidFill>
                   <a:srgbClr val="157D80"/>
@@ -9791,6 +10117,7 @@
           </a:lstStyle>
           <a:p xmlns:a="http://schemas.openxmlformats.org/drawingml/2006/main">
             <a:pPr>
+              <a:buNone/>
               <a:defRPr sz="1875" b="0">
                 <a:solidFill>
                   <a:srgbClr val="49616A"/>
@@ -9858,6 +10185,7 @@
           </a:lstStyle>
           <a:p xmlns:a="http://schemas.openxmlformats.org/drawingml/2006/main">
             <a:pPr>
+              <a:buNone/>
               <a:defRPr sz="2025" b="0">
                 <a:solidFill>
                   <a:srgbClr val="916011"/>
@@ -10264,7 +10592,7 @@
                 <a:ea typeface="Aptos"/>
                 <a:cs typeface="Aptos"/>
               </a:rPr>
-              <a:t>Inertia architecture · r11 · 23 October 2026</a:t>
+              <a:t>Inertia architecture · r12 · 23 October 2026</a:t>
             </a:r>
           </a:p>
         </p:txBody>
@@ -11810,7 +12138,7 @@
                 <a:ea typeface="Aptos"/>
                 <a:cs typeface="Aptos"/>
               </a:rPr>
-              <a:t>Inertia architecture · r11 · 23 October 2026</a:t>
+              <a:t>Inertia architecture · r12 · 23 October 2026</a:t>
             </a:r>
           </a:p>
         </p:txBody>
@@ -13270,7 +13598,7 @@
                 <a:ea typeface="Aptos"/>
                 <a:cs typeface="Aptos"/>
               </a:rPr>
-              <a:t>Inertia architecture · r11 · 23 October 2026</a:t>
+              <a:t>Inertia architecture · r12 · 23 October 2026</a:t>
             </a:r>
           </a:p>
         </p:txBody>
@@ -14443,7 +14771,7 @@
           <p:cNvPr id="16" name="">
             <a:extLst xmlns:a="http://schemas.openxmlformats.org/drawingml/2006/main">
               <a:ext uri="{FF2B5EF4-FFF2-40B4-BE49-F238E27FC236}">
-                <a16:creationId xmlns:a16="http://schemas.microsoft.com/office/drawing/2014/main" id="{43BB7F43-259C-4F8C-B78A-02E88EB30B03}"/>
+                <a16:creationId xmlns:a16="http://schemas.microsoft.com/office/drawing/2014/main" id="{AADE179F-57CD-456F-993E-74C07E53BE47}"/>
               </a:ext>
             </a:extLst>
           </p:cNvPr>
@@ -14475,7 +14803,7 @@
           <p:cNvPr id="15" name="">
             <a:extLst xmlns:a="http://schemas.openxmlformats.org/drawingml/2006/main">
               <a:ext uri="{FF2B5EF4-FFF2-40B4-BE49-F238E27FC236}">
-                <a16:creationId xmlns:a16="http://schemas.microsoft.com/office/drawing/2014/main" id="{FA033646-FF1C-405B-B290-7854A24C2A6E}"/>
+                <a16:creationId xmlns:a16="http://schemas.microsoft.com/office/drawing/2014/main" id="{78841D45-5CB9-4501-B161-7E58798E405D}"/>
               </a:ext>
             </a:extLst>
           </p:cNvPr>
@@ -14546,6 +14874,7 @@
           </a:lstStyle>
           <a:p xmlns:a="http://schemas.openxmlformats.org/drawingml/2006/main">
             <a:pPr>
+              <a:buNone/>
               <a:defRPr sz="3600" b="1">
                 <a:solidFill>
                   <a:srgbClr val="132E38"/>
@@ -14613,6 +14942,7 @@
           </a:lstStyle>
           <a:p xmlns:a="http://schemas.openxmlformats.org/drawingml/2006/main">
             <a:pPr>
+              <a:buNone/>
               <a:defRPr sz="2025" b="0">
                 <a:solidFill>
                   <a:srgbClr val="49616A"/>
@@ -14631,7 +14961,7 @@
                 <a:ea typeface="Aptos"/>
                 <a:cs typeface="Aptos"/>
               </a:rPr>
-              <a:t>Pending acceptance</a:t>
+              <a:t>Pending acceptance · Helix remains optional</a:t>
             </a:r>
           </a:p>
         </p:txBody>
@@ -14710,6 +15040,7 @@
           </a:lstStyle>
           <a:p xmlns:a="http://schemas.openxmlformats.org/drawingml/2006/main">
             <a:pPr>
+              <a:buNone/>
               <a:defRPr sz="1350" b="0">
                 <a:solidFill>
                   <a:srgbClr val="49616A"/>
@@ -14728,7 +15059,7 @@
                 <a:ea typeface="Aptos"/>
                 <a:cs typeface="Aptos"/>
               </a:rPr>
-              <a:t>Inertia architecture · r11 · 23 October 2026</a:t>
+              <a:t>Inertia architecture · r12 · 23 October 2026</a:t>
             </a:r>
           </a:p>
         </p:txBody>
@@ -14777,6 +15108,7 @@
           </a:lstStyle>
           <a:p xmlns:a="http://schemas.openxmlformats.org/drawingml/2006/main">
             <a:pPr>
+              <a:buNone/>
               <a:defRPr sz="1650" b="1">
                 <a:solidFill>
                   <a:srgbClr val="157D80"/>
@@ -14877,6 +15209,7 @@
           </a:lstStyle>
           <a:p xmlns:a="http://schemas.openxmlformats.org/drawingml/2006/main">
             <a:pPr>
+              <a:buNone/>
               <a:defRPr sz="2250" b="1">
                 <a:solidFill>
                   <a:srgbClr val="132E38"/>
@@ -14944,6 +15277,7 @@
           </a:lstStyle>
           <a:p xmlns:a="http://schemas.openxmlformats.org/drawingml/2006/main">
             <a:pPr>
+              <a:buNone/>
               <a:defRPr sz="1875" b="0">
                 <a:solidFill>
                   <a:srgbClr val="49616A"/>
@@ -14962,7 +15296,7 @@
                 <a:ea typeface="Aptos"/>
                 <a:cs typeface="Aptos"/>
               </a:rPr>
-              <a:t>Database + backup recovery</a:t>
+              <a:t>Paperclip DB + backup recovery</a:t>
             </a:r>
           </a:p>
         </p:txBody>
@@ -15044,6 +15378,7 @@
           </a:lstStyle>
           <a:p xmlns:a="http://schemas.openxmlformats.org/drawingml/2006/main">
             <a:pPr>
+              <a:buNone/>
               <a:defRPr sz="2250" b="1">
                 <a:solidFill>
                   <a:srgbClr val="132E38"/>
@@ -15111,6 +15446,7 @@
           </a:lstStyle>
           <a:p xmlns:a="http://schemas.openxmlformats.org/drawingml/2006/main">
             <a:pPr>
+              <a:buNone/>
               <a:defRPr sz="1875" b="0">
                 <a:solidFill>
                   <a:srgbClr val="49616A"/>
@@ -15211,6 +15547,7 @@
           </a:lstStyle>
           <a:p xmlns:a="http://schemas.openxmlformats.org/drawingml/2006/main">
             <a:pPr>
+              <a:buNone/>
               <a:defRPr sz="2250" b="1">
                 <a:solidFill>
                   <a:srgbClr val="132E38"/>
@@ -15278,6 +15615,7 @@
           </a:lstStyle>
           <a:p xmlns:a="http://schemas.openxmlformats.org/drawingml/2006/main">
             <a:pPr>
+              <a:buNone/>
               <a:defRPr sz="1875" b="0">
                 <a:solidFill>
                   <a:srgbClr val="49616A"/>
@@ -15375,6 +15713,7 @@
           </a:lstStyle>
           <a:p xmlns:a="http://schemas.openxmlformats.org/drawingml/2006/main">
             <a:pPr>
+              <a:buNone/>
               <a:defRPr sz="2025" b="1">
                 <a:solidFill>
                   <a:srgbClr val="157D80"/>
@@ -15442,6 +15781,7 @@
           </a:lstStyle>
           <a:p xmlns:a="http://schemas.openxmlformats.org/drawingml/2006/main">
             <a:pPr>
+              <a:buNone/>
               <a:defRPr sz="2025" b="1">
                 <a:solidFill>
                   <a:srgbClr val="157D80"/>
@@ -15509,6 +15849,7 @@
           </a:lstStyle>
           <a:p xmlns:a="http://schemas.openxmlformats.org/drawingml/2006/main">
             <a:pPr>
+              <a:buNone/>
               <a:defRPr sz="2025" b="1">
                 <a:solidFill>
                   <a:srgbClr val="132E38"/>
@@ -15576,6 +15917,7 @@
           </a:lstStyle>
           <a:p xmlns:a="http://schemas.openxmlformats.org/drawingml/2006/main">
             <a:pPr>
+              <a:buNone/>
               <a:defRPr sz="2025" b="0">
                 <a:solidFill>
                   <a:srgbClr val="132E38"/>
@@ -15643,6 +15985,7 @@
           </a:lstStyle>
           <a:p xmlns:a="http://schemas.openxmlformats.org/drawingml/2006/main">
             <a:pPr>
+              <a:buNone/>
               <a:defRPr sz="2025" b="1">
                 <a:solidFill>
                   <a:srgbClr val="132E38"/>
@@ -15710,6 +16053,7 @@
           </a:lstStyle>
           <a:p xmlns:a="http://schemas.openxmlformats.org/drawingml/2006/main">
             <a:pPr>
+              <a:buNone/>
               <a:defRPr sz="2025" b="0">
                 <a:solidFill>
                   <a:srgbClr val="132E38"/>
@@ -15777,6 +16121,7 @@
           </a:lstStyle>
           <a:p xmlns:a="http://schemas.openxmlformats.org/drawingml/2006/main">
             <a:pPr>
+              <a:buNone/>
               <a:defRPr sz="2025" b="1">
                 <a:solidFill>
                   <a:srgbClr val="132E38"/>
@@ -15844,6 +16189,7 @@
           </a:lstStyle>
           <a:p xmlns:a="http://schemas.openxmlformats.org/drawingml/2006/main">
             <a:pPr>
+              <a:buNone/>
               <a:defRPr sz="2025" b="0">
                 <a:solidFill>
                   <a:srgbClr val="132E38"/>
@@ -15911,6 +16257,7 @@
           </a:lstStyle>
           <a:p xmlns:a="http://schemas.openxmlformats.org/drawingml/2006/main">
             <a:pPr>
+              <a:buNone/>
               <a:defRPr sz="2025" b="1">
                 <a:solidFill>
                   <a:srgbClr val="132E38"/>
@@ -15978,6 +16325,7 @@
           </a:lstStyle>
           <a:p xmlns:a="http://schemas.openxmlformats.org/drawingml/2006/main">
             <a:pPr>
+              <a:buNone/>
               <a:defRPr sz="2025" b="0">
                 <a:solidFill>
                   <a:srgbClr val="132E38"/>
@@ -15997,6 +16345,73 @@
                 <a:cs typeface="Aptos"/>
               </a:rPr>
               <a:t>Interest mapping and deduplicated follow-up</a:t>
+            </a:r>
+          </a:p>
+        </p:txBody>
+      </p:sp>
+      <p:sp>
+        <p:nvSpPr>
+          <p:cNvPr id="29" name="revised-text-27">
+            <a:extLst xmlns:a="http://schemas.openxmlformats.org/drawingml/2006/main">
+              <a:ext uri="{FF2B5EF4-FFF2-40B4-BE49-F238E27FC236}">
+                <a16:creationId xmlns:a16="http://schemas.microsoft.com/office/drawing/2014/main" id="{E2A23C23-C15B-4ACE-A9EA-033C6234DA84}"/>
+              </a:ext>
+            </a:extLst>
+          </p:cNvPr>
+          <p:cNvSpPr>
+            <a:spLocks xmlns:a="http://schemas.openxmlformats.org/drawingml/2006/main" noGrp="1"/>
+          </p:cNvSpPr>
+          <p:nvPr/>
+        </p:nvSpPr>
+        <p:spPr>
+          <a:xfrm xmlns:a="http://schemas.openxmlformats.org/drawingml/2006/main">
+            <a:off x="609600" y="7600950"/>
+            <a:ext cx="14020800" cy="257175"/>
+          </a:xfrm>
+          <a:prstGeom xmlns:a="http://schemas.openxmlformats.org/drawingml/2006/main" prst="rect">
+            <a:avLst/>
+          </a:prstGeom>
+          <a:noFill xmlns:a="http://schemas.openxmlformats.org/drawingml/2006/main"/>
+          <a:ln xmlns:a="http://schemas.openxmlformats.org/drawingml/2006/main" w="0">
+            <a:noFill/>
+            <a:prstDash val="solid"/>
+          </a:ln>
+        </p:spPr>
+        <p:txBody>
+          <a:bodyPr xmlns:a="http://schemas.openxmlformats.org/drawingml/2006/main" lIns="0" tIns="0" rIns="0" bIns="0" anchor="t"/>
+          <a:lstStyle xmlns:a="http://schemas.openxmlformats.org/drawingml/2006/main">
+            <a:defPPr>
+              <a:defRPr sz="1575" b="0">
+                <a:solidFill>
+                  <a:srgbClr val="49616A"/>
+                </a:solidFill>
+                <a:latin typeface="Aptos"/>
+                <a:ea typeface="Aptos"/>
+                <a:cs typeface="Aptos"/>
+              </a:defRPr>
+            </a:defPPr>
+          </a:lstStyle>
+          <a:p xmlns:a="http://schemas.openxmlformats.org/drawingml/2006/main">
+            <a:pPr>
+              <a:defRPr sz="1575" b="0">
+                <a:solidFill>
+                  <a:srgbClr val="49616A"/>
+                </a:solidFill>
+                <a:latin typeface="Aptos"/>
+                <a:ea typeface="Aptos"/>
+                <a:cs typeface="Aptos"/>
+              </a:defRPr>
+            </a:pPr>
+            <a:r>
+              <a:rPr sz="1575" b="0">
+                <a:solidFill>
+                  <a:srgbClr val="49616A"/>
+                </a:solidFill>
+                <a:latin typeface="Aptos"/>
+                <a:ea typeface="Aptos"/>
+                <a:cs typeface="Aptos"/>
+              </a:rPr>
+              <a:t>DAO schemas + roles: verify provider support. Helix adds no demo dependency.</a:t>
             </a:r>
           </a:p>
         </p:txBody>

</xml_diff>

<commit_message>
docs: synchronize architecture and funding delivery status
</commit_message>
<xml_diff>
--- a/Inertia-Architecture.pptx
+++ b/Inertia-Architecture.pptx
@@ -2,21 +2,21 @@
 <file path=ppt/presentation.xml><?xml version="1.0" encoding="utf-8"?>
 <p:presentation xmlns:p="http://schemas.openxmlformats.org/presentationml/2006/main">
   <p:sldMasterIdLst>
-    <p:sldMasterId xmlns:r="http://schemas.openxmlformats.org/officeDocument/2006/relationships" id="2147483648" r:id="Re7ddbcfda06747ab"/>
+    <p:sldMasterId xmlns:r="http://schemas.openxmlformats.org/officeDocument/2006/relationships" id="2147483648" r:id="R7b1feba4ebac42cb"/>
   </p:sldMasterIdLst>
   <p:notesMasterIdLst>
-    <p:notesMasterId xmlns:r="http://schemas.openxmlformats.org/officeDocument/2006/relationships" r:id="R1471660a58144325"/>
+    <p:notesMasterId xmlns:r="http://schemas.openxmlformats.org/officeDocument/2006/relationships" r:id="R0af0acd9638049c7"/>
   </p:notesMasterIdLst>
   <p:sldIdLst>
-    <p:sldId xmlns:r="http://schemas.openxmlformats.org/officeDocument/2006/relationships" id="256" r:id="Rfb5b696808f94886"/>
-    <p:sldId xmlns:r="http://schemas.openxmlformats.org/officeDocument/2006/relationships" id="257" r:id="R88a131d998e348d4"/>
-    <p:sldId xmlns:r="http://schemas.openxmlformats.org/officeDocument/2006/relationships" id="258" r:id="R9b898905b5484359"/>
-    <p:sldId xmlns:r="http://schemas.openxmlformats.org/officeDocument/2006/relationships" id="259" r:id="Rb95b11312fed4fb1"/>
-    <p:sldId xmlns:r="http://schemas.openxmlformats.org/officeDocument/2006/relationships" id="260" r:id="Rd7f2a2ed4dd64ff8"/>
-    <p:sldId xmlns:r="http://schemas.openxmlformats.org/officeDocument/2006/relationships" id="261" r:id="Rd979f7c227ed4c85"/>
-    <p:sldId xmlns:r="http://schemas.openxmlformats.org/officeDocument/2006/relationships" id="262" r:id="R9530d9a3c9144107"/>
-    <p:sldId xmlns:r="http://schemas.openxmlformats.org/officeDocument/2006/relationships" id="263" r:id="Rf34e13d35cb345e1"/>
-    <p:sldId xmlns:r="http://schemas.openxmlformats.org/officeDocument/2006/relationships" id="264" r:id="R4633fd83b2404ec3"/>
+    <p:sldId xmlns:r="http://schemas.openxmlformats.org/officeDocument/2006/relationships" id="256" r:id="R13a96eea91d94d13"/>
+    <p:sldId xmlns:r="http://schemas.openxmlformats.org/officeDocument/2006/relationships" id="257" r:id="R79cdbf9129b141da"/>
+    <p:sldId xmlns:r="http://schemas.openxmlformats.org/officeDocument/2006/relationships" id="258" r:id="R0562286197ca4413"/>
+    <p:sldId xmlns:r="http://schemas.openxmlformats.org/officeDocument/2006/relationships" id="259" r:id="R18506465cf3d46fc"/>
+    <p:sldId xmlns:r="http://schemas.openxmlformats.org/officeDocument/2006/relationships" id="260" r:id="R6636fe5d18c847ab"/>
+    <p:sldId xmlns:r="http://schemas.openxmlformats.org/officeDocument/2006/relationships" id="261" r:id="Rb5b967b1d91b4e79"/>
+    <p:sldId xmlns:r="http://schemas.openxmlformats.org/officeDocument/2006/relationships" id="262" r:id="R0ada181589494b2a"/>
+    <p:sldId xmlns:r="http://schemas.openxmlformats.org/officeDocument/2006/relationships" id="263" r:id="Ra4be38fd0b524b61"/>
+    <p:sldId xmlns:r="http://schemas.openxmlformats.org/officeDocument/2006/relationships" id="264" r:id="Rc62e5fd86aa44a33"/>
   </p:sldIdLst>
   <p:sldSz cx="15240000" cy="8572500"/>
   <p:notesSz cx="6858000" cy="9144000"/>
@@ -470,7 +470,7 @@
           </a:p>
           <a:p xmlns:a="http://schemas.openxmlformats.org/drawingml/2006/main">
             <a:r>
-              <a:t>Next connections: live host/relay pairing, general intake, runtime enrollment and domain adapters. Dashed lines mark connections awaiting integration.</a:t>
+              <a:t>Next connections: live host/relay pairing, trusted intake sources, runtime enrollment and domain adapters. Dashed lines mark connections awaiting integration.</a:t>
             </a:r>
           </a:p>
         </p:txBody>
@@ -650,7 +650,7 @@
           </a:p>
           <a:p xmlns:a="http://schemas.openxmlformats.org/drawingml/2006/main">
             <a:r>
-              <a:t>Next: connect authorized Drive readiness, website membership/publication, action intake and the trusted importer/admission policy.</a:t>
+              <a:t>The objective intake/link/brief core is merged. Next: connect authorized Drive readiness, website membership/publication, action sources and trusted admission policy.</a:t>
             </a:r>
           </a:p>
         </p:txBody>
@@ -750,7 +750,7 @@
           </a:p>
           <a:p xmlns:a="http://schemas.openxmlformats.org/drawingml/2006/main">
             <a:r>
-              <a:t>Next: connect trusted human review and live final-vote verification.</a:t>
+              <a:t>The merged native adapter remains disabled. The approved model records durable authority for an exact version at human acceptance, so disconnect alone leaves that approval valid. Activation requires implemented acceptance receipts, funding-service-confirmed cancellation and rejection of changed funding evidence. Grant submission and live final-vote verification retain their separate authority steps.</a:t>
             </a:r>
           </a:p>
         </p:txBody>
@@ -940,7 +940,7 @@
           </a:p>
           <a:p xmlns:a="http://schemas.openxmlformats.org/drawingml/2006/main">
             <a:r>
-              <a:t>Next: qualify domain/schema isolation, PG concurrency and graph integration. Financial inputs retain period, accounting basis, currency and provenance. Production QuickBooks compatibility, cash evidence and spending authority require separate qualification. Broader 990 and semantic enrichment follow the core graph.</a:t>
+              <a:t>Disposable cloud PostgreSQL and PG-to-embedded-Helix rehearsal passed. Next: wire trusted sources, admit the inventory/backfill and qualify deployed graph services. Financial inputs retain period, accounting basis, currency and provenance. Production QuickBooks compatibility, cash evidence and spending authority require separate qualification. Broader 990 and semantic enrichment follow the core graph.</a:t>
             </a:r>
           </a:p>
         </p:txBody>
@@ -1060,7 +1060,7 @@
           </a:p>
           <a:p xmlns:a="http://schemas.openxmlformats.org/drawingml/2006/main">
             <a:r>
-              <a:t>Next: complete typed assertions, writeback, projector and scoped queries, then qualify ongoing refresh, correction/revocation and end-to-end reuse.</a:t>
+              <a:t>Next: connect trusted source adapters, admit the inventory/backfill and qualify deployed graph refresh. The operational discovery loop reuses this research contract with bounded public search, official evidence capture and due rechecks.</a:t>
             </a:r>
           </a:p>
         </p:txBody>
@@ -1220,7 +1220,7 @@
           <a:lstStyle xmlns:a="http://schemas.openxmlformats.org/drawingml/2006/main"/>
           <a:p xmlns:a="http://schemas.openxmlformats.org/drawingml/2006/main">
             <a:r>
-              <a:t>Sources: Inertia spec.md §1, plan.md and testing.md; Reusable DAO knowledge and financial snapshots implementation report; Operational DAO partner graph design; https://github.com/NetRxn/DFW-Gov-Fund/pull/42; https://github.com/NetRxn/DFW-Gov-Fund/actions/runs/40027003050. Status: 23 October 2026.</a:t>
+              <a:t>Sources: Inertia spec.md, plan.md and testing.md; docs/development/funding-enhancement/discovery-loop.md; docs/development/objective-intake.md; scripts/cloud-rehearsal/README.md; https://github.com/NetRxn/Inertia/pull/25; https://github.com/NetRxn/Inertia/pull/26; https://github.com/NetRxn/Inertia/pull/27; https://github.com/NetRxn/Inertia/pull/28; https://github.com/NetRxn/DFW-Gov-Fund/pull/44; https://github.com/NetRxn/DFW-Gov-Fund/pull/45; https://github.com/NetRxn/DFW-Gov-Fund/pull/46; https://github.com/NetRxn/DFW-Gov-Fund/pull/47. Status: 24 October 2026.</a:t>
             </a:r>
           </a:p>
           <a:p xmlns:a="http://schemas.openxmlformats.org/drawingml/2006/main">
@@ -1230,7 +1230,7 @@
           </a:p>
           <a:p xmlns:a="http://schemas.openxmlformats.org/drawingml/2006/main">
             <a:r>
-              <a:t>Merged cores: Buzz bridge/plugin, Roundtable core/publication client, grant packet/vote binding, funding candidate/route review and portable skills 3.4.1. Reviewed public drafting, saved partner preparation and independent gap review await release qualification.</a:t>
+              <a:t>Merged cores now include drafting/gap preparation, scoped evidence and sanitized financial contracts, partner graph/research reuse, objective intake/links/briefs and cloud rehearsal tooling. The bounded October scout is complete. Its confidence overlay and separate July/manual/replay provenance are retained.</a:t>
             </a:r>
           </a:p>
           <a:p xmlns:a="http://schemas.openxmlformats.org/drawingml/2006/main">
@@ -1240,7 +1240,7 @@
           </a:p>
           <a:p xmlns:a="http://schemas.openxmlformats.org/drawingml/2006/main">
             <a:r>
-              <a:t>Evidence/SQL reuse and the sanitized USD financial-fixture contract are locally implemented and independently approved, unpublished and not live. Trusted importer policy, real PostgreSQL concurrency/schema qualification and production financial-provider compatibility remain next steps.</a:t>
+              <a:t>Independent cloud rehearsal passed real domain PostgreSQL/PostGIS, native PostgreSQL service/membership/checkout/crash behavior and PG-to-embedded-Helix reuse. The actual-service synthetic meeting-answer-to-revised-brief workflow passed. npm audit and clean-package checks passed. Full HTTP/UI rehearsal needs an environment with working network-interface enumeration. Actual VPS/PPC2 enrollment and production deployment remain next work.</a:t>
             </a:r>
           </a:p>
           <a:p xmlns:a="http://schemas.openxmlformats.org/drawingml/2006/main">
@@ -1250,7 +1250,7 @@
           </a:p>
           <a:p xmlns:a="http://schemas.openxmlformats.org/drawingml/2006/main">
             <a:r>
-              <a:t>Discovery repairs are published as draft PR 42 on discovery/2026-10-23-refresh at head a342ab1cd38e2e6f65a98c2c582b14d70fa5adae. Source-qualification receipts from run 40027003050 are in review. The dated live scout is next after accepted qualification. July cases remain historical. Manual research and private replay retain separate provenance. The proposed knowledge delta awaits authorized ingestion.</a:t>
+              <a:t>The native adapter is merged and disabled; the reviewed funding transaction service is in CI. The approved exact-version authority-at-acceptance model requires implementation and production writer-fence integration before activation. Live final-vote verification retains its separate gate.</a:t>
             </a:r>
           </a:p>
           <a:p xmlns:a="http://schemas.openxmlformats.org/drawingml/2006/main">
@@ -1260,7 +1260,7 @@
           </a:p>
           <a:p xmlns:a="http://schemas.openxmlformats.org/drawingml/2006/main">
             <a:r>
-              <a:t>Core graph implementation is underway. Official Helix TypeScript SDK 3.1.0 and embedded runtime 0.3.3 are installed, and a real embedded query passed. Full typed relationship/writeback, projector and end-to-end behavior await acceptance. Next gates cover ongoing refresh, scoped retrieval, correction/revocation, replay and real PG/Helix operation. Broader 990 enrichment and optional semantic/vector search follow separately.</a:t>
+              <a:t>The planned discovery loop queries saved knowledge, researches coverage gaps, validates official evidence, saves useful findings and produces prioritized briefs or deduplicated urgent alerts. Native tasks retain due rechecks and failed coverage. The daily profile remains disabled until actual agent/tool wiring, end-to-end rehearsal and recurring cadence approval. Broader 990 and optional semantic/vector enrichment follow separately.</a:t>
             </a:r>
           </a:p>
           <a:p xmlns:a="http://schemas.openxmlformats.org/drawingml/2006/main">
@@ -1270,7 +1270,7 @@
           </a:p>
           <a:p xmlns:a="http://schemas.openxmlformats.org/drawingml/2006/main">
             <a:r>
-              <a:t>Connected demo acceptance: automatic member-site meeting publication, a human-reviewed direct-application packet and required final vote with a verified manual-submission transition, known partner evidence reused and new useful research retrieved on a later run, and an accepted second-member agent contribution. Live source/tool connections and benchmark/quality assessment remain part of rehearsal.</a:t>
+              <a:t>Connected demo outcomes remain website meeting publication, a reviewed direct-application packet with its required final vote, an accepted second-member contribution and research reused on a later run. Production financial-provider compatibility and trusted admission policy require qualification.</a:t>
             </a:r>
           </a:p>
         </p:txBody>
@@ -3083,12 +3083,12 @@
   </p:cSld>
   <p:clrMap bg1="lt1" tx1="dk1" bg2="lt2" tx2="dk2" accent1="accent1" accent2="accent2" accent3="accent3" accent4="accent4" accent5="accent5" accent6="accent6" hlink="hlink" folHlink="folHlink"/>
   <p:sldLayoutIdLst>
-    <p:sldLayoutId xmlns:r="http://schemas.openxmlformats.org/officeDocument/2006/relationships" id="2147483649" r:id="R616afb358831442e"/>
-    <p:sldLayoutId xmlns:r="http://schemas.openxmlformats.org/officeDocument/2006/relationships" id="2147483650" r:id="Rfde21c57e53542b3"/>
-    <p:sldLayoutId xmlns:r="http://schemas.openxmlformats.org/officeDocument/2006/relationships" id="2147483651" r:id="R7f862b9ad23c48f8"/>
-    <p:sldLayoutId xmlns:r="http://schemas.openxmlformats.org/officeDocument/2006/relationships" id="2147483652" r:id="R118090782d914de2"/>
-    <p:sldLayoutId xmlns:r="http://schemas.openxmlformats.org/officeDocument/2006/relationships" id="2147483653" r:id="R8b61cb293b1a4343"/>
-    <p:sldLayoutId xmlns:r="http://schemas.openxmlformats.org/officeDocument/2006/relationships" id="2147483654" r:id="R3f6b22852b3d4e56"/>
+    <p:sldLayoutId xmlns:r="http://schemas.openxmlformats.org/officeDocument/2006/relationships" id="2147483649" r:id="R36c050df87df4dfb"/>
+    <p:sldLayoutId xmlns:r="http://schemas.openxmlformats.org/officeDocument/2006/relationships" id="2147483650" r:id="R4826580c941b4dfb"/>
+    <p:sldLayoutId xmlns:r="http://schemas.openxmlformats.org/officeDocument/2006/relationships" id="2147483651" r:id="R1ef15abf51b948a7"/>
+    <p:sldLayoutId xmlns:r="http://schemas.openxmlformats.org/officeDocument/2006/relationships" id="2147483652" r:id="R13a461ceefae4590"/>
+    <p:sldLayoutId xmlns:r="http://schemas.openxmlformats.org/officeDocument/2006/relationships" id="2147483653" r:id="R72511b6ee2d846d2"/>
+    <p:sldLayoutId xmlns:r="http://schemas.openxmlformats.org/officeDocument/2006/relationships" id="2147483654" r:id="R79585679f8734e86"/>
   </p:sldLayoutIdLst>
   <p:txStyles>
     <p:titleStyle>
@@ -3639,7 +3639,7 @@
           <p:cNvPr id="39" name="">
             <a:extLst xmlns:a="http://schemas.openxmlformats.org/drawingml/2006/main">
               <a:ext uri="{FF2B5EF4-FFF2-40B4-BE49-F238E27FC236}">
-                <a16:creationId xmlns:a16="http://schemas.microsoft.com/office/drawing/2014/main" id="{2638FB43-5EF1-4133-9489-D42BD6A1F3AB}"/>
+                <a16:creationId xmlns:a16="http://schemas.microsoft.com/office/drawing/2014/main" id="{D412FE0C-6DAC-45C6-B0D0-763C63607A56}"/>
               </a:ext>
             </a:extLst>
           </p:cNvPr>
@@ -3672,7 +3672,7 @@
           <p:cNvPr id="32" name="">
             <a:extLst xmlns:a="http://schemas.openxmlformats.org/drawingml/2006/main">
               <a:ext uri="{FF2B5EF4-FFF2-40B4-BE49-F238E27FC236}">
-                <a16:creationId xmlns:a16="http://schemas.microsoft.com/office/drawing/2014/main" id="{B4313EE5-5C53-43D7-99BE-F29F673E49A5}"/>
+                <a16:creationId xmlns:a16="http://schemas.microsoft.com/office/drawing/2014/main" id="{C7A66388-0418-4A12-AB11-536B1935AB16}"/>
               </a:ext>
             </a:extLst>
           </p:cNvPr>
@@ -3704,7 +3704,7 @@
           <p:cNvPr id="29" name="">
             <a:extLst xmlns:a="http://schemas.openxmlformats.org/drawingml/2006/main">
               <a:ext uri="{FF2B5EF4-FFF2-40B4-BE49-F238E27FC236}">
-                <a16:creationId xmlns:a16="http://schemas.microsoft.com/office/drawing/2014/main" id="{7E5DFC84-48BC-4F9F-B5D0-4970391E5749}"/>
+                <a16:creationId xmlns:a16="http://schemas.microsoft.com/office/drawing/2014/main" id="{793CDB02-24F2-4EA8-A861-9337AB15E01C}"/>
               </a:ext>
             </a:extLst>
           </p:cNvPr>
@@ -5497,7 +5497,7 @@
           <p:cNvPr id="30" name="flow-29">
             <a:extLst xmlns:a="http://schemas.openxmlformats.org/drawingml/2006/main">
               <a:ext uri="{FF2B5EF4-FFF2-40B4-BE49-F238E27FC236}">
-                <a16:creationId xmlns:a16="http://schemas.microsoft.com/office/drawing/2014/main" id="{55BD9632-CE50-4111-9B2D-333D49A6FCE7}"/>
+                <a16:creationId xmlns:a16="http://schemas.microsoft.com/office/drawing/2014/main" id="{116D73A4-DE0C-4746-865A-5A0861F91418}"/>
               </a:ext>
             </a:extLst>
           </p:cNvPr>
@@ -5527,7 +5527,7 @@
           <p:cNvPr id="31" name="flow-30">
             <a:extLst xmlns:a="http://schemas.openxmlformats.org/drawingml/2006/main">
               <a:ext uri="{FF2B5EF4-FFF2-40B4-BE49-F238E27FC236}">
-                <a16:creationId xmlns:a16="http://schemas.microsoft.com/office/drawing/2014/main" id="{D2300CCC-0612-4D12-9CBF-D8DCB3D96768}"/>
+                <a16:creationId xmlns:a16="http://schemas.microsoft.com/office/drawing/2014/main" id="{3731771A-875E-48B2-92BE-DF2D6BA903C8}"/>
               </a:ext>
             </a:extLst>
           </p:cNvPr>
@@ -5627,7 +5627,7 @@
           <p:cNvPr id="34" name="flow-32">
             <a:extLst xmlns:a="http://schemas.openxmlformats.org/drawingml/2006/main">
               <a:ext uri="{FF2B5EF4-FFF2-40B4-BE49-F238E27FC236}">
-                <a16:creationId xmlns:a16="http://schemas.microsoft.com/office/drawing/2014/main" id="{AC985D5E-77DF-4B76-9B8D-72BE0CC090A2}"/>
+                <a16:creationId xmlns:a16="http://schemas.microsoft.com/office/drawing/2014/main" id="{FF943156-514E-4F21-943D-31A37277F58A}"/>
               </a:ext>
             </a:extLst>
           </p:cNvPr>
@@ -5656,7 +5656,7 @@
           <p:cNvPr id="35" name="flow-33">
             <a:extLst xmlns:a="http://schemas.openxmlformats.org/drawingml/2006/main">
               <a:ext uri="{FF2B5EF4-FFF2-40B4-BE49-F238E27FC236}">
-                <a16:creationId xmlns:a16="http://schemas.microsoft.com/office/drawing/2014/main" id="{A7CAAAC6-3736-488A-A448-04C82E9ACE30}"/>
+                <a16:creationId xmlns:a16="http://schemas.microsoft.com/office/drawing/2014/main" id="{7E0A8387-7E26-400F-BFD0-C0A25DBD9924}"/>
               </a:ext>
             </a:extLst>
           </p:cNvPr>
@@ -5684,7 +5684,7 @@
           <p:cNvPr id="36" name="flow-34">
             <a:extLst xmlns:a="http://schemas.openxmlformats.org/drawingml/2006/main">
               <a:ext uri="{FF2B5EF4-FFF2-40B4-BE49-F238E27FC236}">
-                <a16:creationId xmlns:a16="http://schemas.microsoft.com/office/drawing/2014/main" id="{89BD5D39-1F2D-4203-84F0-727A2A44DE0E}"/>
+                <a16:creationId xmlns:a16="http://schemas.microsoft.com/office/drawing/2014/main" id="{573B7FFE-DD48-4608-B172-19C12DC02C38}"/>
               </a:ext>
             </a:extLst>
           </p:cNvPr>
@@ -5783,7 +5783,7 @@
           <p:cNvPr id="38" name="flow-36">
             <a:extLst xmlns:a="http://schemas.openxmlformats.org/drawingml/2006/main">
               <a:ext uri="{FF2B5EF4-FFF2-40B4-BE49-F238E27FC236}">
-                <a16:creationId xmlns:a16="http://schemas.microsoft.com/office/drawing/2014/main" id="{ECE64A28-95CE-4E64-A43D-F044FB1CE7E2}"/>
+                <a16:creationId xmlns:a16="http://schemas.microsoft.com/office/drawing/2014/main" id="{BD9D8EE3-DFBC-4002-ABEE-92865AC73C45}"/>
               </a:ext>
             </a:extLst>
           </p:cNvPr>
@@ -5912,7 +5912,7 @@
           <p:cNvPr id="35" name="">
             <a:extLst xmlns:a="http://schemas.openxmlformats.org/drawingml/2006/main">
               <a:ext uri="{FF2B5EF4-FFF2-40B4-BE49-F238E27FC236}">
-                <a16:creationId xmlns:a16="http://schemas.microsoft.com/office/drawing/2014/main" id="{57DBA162-4F9E-40B1-96DF-AD08BB0F3A30}"/>
+                <a16:creationId xmlns:a16="http://schemas.microsoft.com/office/drawing/2014/main" id="{822164ED-A4E6-40BD-8309-9D150FF51E10}"/>
               </a:ext>
             </a:extLst>
           </p:cNvPr>
@@ -5944,7 +5944,7 @@
           <p:cNvPr id="21" name="">
             <a:extLst xmlns:a="http://schemas.openxmlformats.org/drawingml/2006/main">
               <a:ext uri="{FF2B5EF4-FFF2-40B4-BE49-F238E27FC236}">
-                <a16:creationId xmlns:a16="http://schemas.microsoft.com/office/drawing/2014/main" id="{F7EF065C-7E51-4463-8E1D-0396E8E27B6E}"/>
+                <a16:creationId xmlns:a16="http://schemas.microsoft.com/office/drawing/2014/main" id="{D6F5A60F-60D8-4C4B-810A-23C53C987B2E}"/>
               </a:ext>
             </a:extLst>
           </p:cNvPr>
@@ -5976,7 +5976,7 @@
           <p:cNvPr id="20" name="">
             <a:extLst xmlns:a="http://schemas.openxmlformats.org/drawingml/2006/main">
               <a:ext uri="{FF2B5EF4-FFF2-40B4-BE49-F238E27FC236}">
-                <a16:creationId xmlns:a16="http://schemas.microsoft.com/office/drawing/2014/main" id="{8960E32D-97B0-4005-B9D4-5BF3BA84F1B2}"/>
+                <a16:creationId xmlns:a16="http://schemas.microsoft.com/office/drawing/2014/main" id="{10466ABD-73A2-4146-BC7F-9539242ECCF7}"/>
               </a:ext>
             </a:extLst>
           </p:cNvPr>
@@ -6008,7 +6008,7 @@
           <p:cNvPr id="19" name="">
             <a:extLst xmlns:a="http://schemas.openxmlformats.org/drawingml/2006/main">
               <a:ext uri="{FF2B5EF4-FFF2-40B4-BE49-F238E27FC236}">
-                <a16:creationId xmlns:a16="http://schemas.microsoft.com/office/drawing/2014/main" id="{9F7F184F-EF9A-47F9-ACF3-BA72750A3A9C}"/>
+                <a16:creationId xmlns:a16="http://schemas.microsoft.com/office/drawing/2014/main" id="{9900C5D9-787C-4CDD-B375-24D5E3656DDA}"/>
               </a:ext>
             </a:extLst>
           </p:cNvPr>
@@ -6040,7 +6040,7 @@
           <p:cNvPr id="18" name="">
             <a:extLst xmlns:a="http://schemas.openxmlformats.org/drawingml/2006/main">
               <a:ext uri="{FF2B5EF4-FFF2-40B4-BE49-F238E27FC236}">
-                <a16:creationId xmlns:a16="http://schemas.microsoft.com/office/drawing/2014/main" id="{81B91D6E-DBAD-4E1F-BBFE-BB9FCE6059F3}"/>
+                <a16:creationId xmlns:a16="http://schemas.microsoft.com/office/drawing/2014/main" id="{173E04A9-03BD-4611-B3D2-7A62AE51AFE4}"/>
               </a:ext>
             </a:extLst>
           </p:cNvPr>
@@ -7615,7 +7615,7 @@
           <p:cNvPr id="28" name="flow-61">
             <a:extLst xmlns:a="http://schemas.openxmlformats.org/drawingml/2006/main">
               <a:ext uri="{FF2B5EF4-FFF2-40B4-BE49-F238E27FC236}">
-                <a16:creationId xmlns:a16="http://schemas.microsoft.com/office/drawing/2014/main" id="{4F7933A1-DDAF-4E19-9A3D-0A281E0AA09C}"/>
+                <a16:creationId xmlns:a16="http://schemas.microsoft.com/office/drawing/2014/main" id="{E567EE97-38F1-4317-9A67-B52EB3F8B70E}"/>
               </a:ext>
             </a:extLst>
           </p:cNvPr>
@@ -7714,7 +7714,7 @@
           <p:cNvPr id="30" name="flow-63">
             <a:extLst xmlns:a="http://schemas.openxmlformats.org/drawingml/2006/main">
               <a:ext uri="{FF2B5EF4-FFF2-40B4-BE49-F238E27FC236}">
-                <a16:creationId xmlns:a16="http://schemas.microsoft.com/office/drawing/2014/main" id="{A0121C05-1693-4001-A6E9-55DF94F5CFB1}"/>
+                <a16:creationId xmlns:a16="http://schemas.microsoft.com/office/drawing/2014/main" id="{FDB526CF-4730-4F7E-ACDD-55EBE7014C5B}"/>
               </a:ext>
             </a:extLst>
           </p:cNvPr>
@@ -7742,7 +7742,7 @@
           <p:cNvPr id="31" name="flow-64">
             <a:extLst xmlns:a="http://schemas.openxmlformats.org/drawingml/2006/main">
               <a:ext uri="{FF2B5EF4-FFF2-40B4-BE49-F238E27FC236}">
-                <a16:creationId xmlns:a16="http://schemas.microsoft.com/office/drawing/2014/main" id="{36BE4576-19F2-4EA2-A78A-12DF2CB3DFAB}"/>
+                <a16:creationId xmlns:a16="http://schemas.microsoft.com/office/drawing/2014/main" id="{437323D9-BDDE-49FD-B876-B365128356E5}"/>
               </a:ext>
             </a:extLst>
           </p:cNvPr>
@@ -7770,7 +7770,7 @@
           <p:cNvPr id="32" name="flow-65">
             <a:extLst xmlns:a="http://schemas.openxmlformats.org/drawingml/2006/main">
               <a:ext uri="{FF2B5EF4-FFF2-40B4-BE49-F238E27FC236}">
-                <a16:creationId xmlns:a16="http://schemas.microsoft.com/office/drawing/2014/main" id="{96D484F1-5763-4E92-9576-324ACE1FDFCC}"/>
+                <a16:creationId xmlns:a16="http://schemas.microsoft.com/office/drawing/2014/main" id="{92FC9F92-495A-4D8E-98E4-8609C71708BE}"/>
               </a:ext>
             </a:extLst>
           </p:cNvPr>
@@ -7798,7 +7798,7 @@
           <p:cNvPr id="33" name="flow-66">
             <a:extLst xmlns:a="http://schemas.openxmlformats.org/drawingml/2006/main">
               <a:ext uri="{FF2B5EF4-FFF2-40B4-BE49-F238E27FC236}">
-                <a16:creationId xmlns:a16="http://schemas.microsoft.com/office/drawing/2014/main" id="{113C177D-76DB-4104-AE45-4F2070F6C1F1}"/>
+                <a16:creationId xmlns:a16="http://schemas.microsoft.com/office/drawing/2014/main" id="{27E92EDE-C8F0-4BA6-A8FD-FB94225210FB}"/>
               </a:ext>
             </a:extLst>
           </p:cNvPr>
@@ -8066,7 +8066,7 @@
           <p:cNvPr id="18" name="">
             <a:extLst xmlns:a="http://schemas.openxmlformats.org/drawingml/2006/main">
               <a:ext uri="{FF2B5EF4-FFF2-40B4-BE49-F238E27FC236}">
-                <a16:creationId xmlns:a16="http://schemas.microsoft.com/office/drawing/2014/main" id="{F810E6E3-E78D-4F3C-95D5-1DCB732BAEE7}"/>
+                <a16:creationId xmlns:a16="http://schemas.microsoft.com/office/drawing/2014/main" id="{DECA0952-A5AE-4EF1-BC35-188518497DDE}"/>
               </a:ext>
             </a:extLst>
           </p:cNvPr>
@@ -9269,7 +9269,7 @@
           <p:cNvPr id="20" name="flow-88">
             <a:extLst xmlns:a="http://schemas.openxmlformats.org/drawingml/2006/main">
               <a:ext uri="{FF2B5EF4-FFF2-40B4-BE49-F238E27FC236}">
-                <a16:creationId xmlns:a16="http://schemas.microsoft.com/office/drawing/2014/main" id="{FA700758-6063-4BD3-9145-558DA36A1A8B}"/>
+                <a16:creationId xmlns:a16="http://schemas.microsoft.com/office/drawing/2014/main" id="{9BADED30-1D23-447C-9A14-4A0047A4507E}"/>
               </a:ext>
             </a:extLst>
           </p:cNvPr>
@@ -9297,7 +9297,7 @@
           <p:cNvPr id="21" name="flow-89">
             <a:extLst xmlns:a="http://schemas.openxmlformats.org/drawingml/2006/main">
               <a:ext uri="{FF2B5EF4-FFF2-40B4-BE49-F238E27FC236}">
-                <a16:creationId xmlns:a16="http://schemas.microsoft.com/office/drawing/2014/main" id="{2A320953-D319-41AF-BADC-83004547950E}"/>
+                <a16:creationId xmlns:a16="http://schemas.microsoft.com/office/drawing/2014/main" id="{17F6B08D-AB40-4300-88BA-A58AB8F7B8A7}"/>
               </a:ext>
             </a:extLst>
           </p:cNvPr>
@@ -9325,7 +9325,7 @@
           <p:cNvPr id="22" name="flow-90">
             <a:extLst xmlns:a="http://schemas.openxmlformats.org/drawingml/2006/main">
               <a:ext uri="{FF2B5EF4-FFF2-40B4-BE49-F238E27FC236}">
-                <a16:creationId xmlns:a16="http://schemas.microsoft.com/office/drawing/2014/main" id="{73C3075B-DC33-4479-8183-A2C8285BDD7C}"/>
+                <a16:creationId xmlns:a16="http://schemas.microsoft.com/office/drawing/2014/main" id="{1A4C0FAB-1733-45A1-B19E-E20BC73A8DA4}"/>
               </a:ext>
             </a:extLst>
           </p:cNvPr>
@@ -9448,7 +9448,7 @@
           <p:cNvPr id="24" name="flow-92">
             <a:extLst xmlns:a="http://schemas.openxmlformats.org/drawingml/2006/main">
               <a:ext uri="{FF2B5EF4-FFF2-40B4-BE49-F238E27FC236}">
-                <a16:creationId xmlns:a16="http://schemas.microsoft.com/office/drawing/2014/main" id="{CFB5CA8C-F69E-4513-B917-F6458810358E}"/>
+                <a16:creationId xmlns:a16="http://schemas.microsoft.com/office/drawing/2014/main" id="{353F0194-201E-4415-B09A-B947DD491531}"/>
               </a:ext>
             </a:extLst>
           </p:cNvPr>
@@ -9476,7 +9476,7 @@
           <p:cNvPr id="25" name="flow-93">
             <a:extLst xmlns:a="http://schemas.openxmlformats.org/drawingml/2006/main">
               <a:ext uri="{FF2B5EF4-FFF2-40B4-BE49-F238E27FC236}">
-                <a16:creationId xmlns:a16="http://schemas.microsoft.com/office/drawing/2014/main" id="{5A3BD616-5C6C-4A0A-9E8D-29036374F8AC}"/>
+                <a16:creationId xmlns:a16="http://schemas.microsoft.com/office/drawing/2014/main" id="{4D0DDC02-9908-4199-BEB1-12E90958EA04}"/>
               </a:ext>
             </a:extLst>
           </p:cNvPr>
@@ -9504,7 +9504,7 @@
           <p:cNvPr id="26" name="flow-94">
             <a:extLst xmlns:a="http://schemas.openxmlformats.org/drawingml/2006/main">
               <a:ext uri="{FF2B5EF4-FFF2-40B4-BE49-F238E27FC236}">
-                <a16:creationId xmlns:a16="http://schemas.microsoft.com/office/drawing/2014/main" id="{AD06838F-FD01-4EA1-8BF5-8DFCDBCD7E18}"/>
+                <a16:creationId xmlns:a16="http://schemas.microsoft.com/office/drawing/2014/main" id="{BBB48D46-F608-4E32-B988-9555A3F71873}"/>
               </a:ext>
             </a:extLst>
           </p:cNvPr>
@@ -9617,7 +9617,7 @@
                 <a:ea typeface="Aptos"/>
                 <a:cs typeface="Aptos"/>
               </a:rPr>
-              <a:t>planned</a:t>
+              <a:t>wiring next</a:t>
             </a:r>
           </a:p>
         </p:txBody>
@@ -9627,7 +9627,7 @@
           <p:cNvPr id="28" name="flow-96">
             <a:extLst xmlns:a="http://schemas.openxmlformats.org/drawingml/2006/main">
               <a:ext uri="{FF2B5EF4-FFF2-40B4-BE49-F238E27FC236}">
-                <a16:creationId xmlns:a16="http://schemas.microsoft.com/office/drawing/2014/main" id="{6789951C-FDDA-4651-AA1A-4DA39B360C44}"/>
+                <a16:creationId xmlns:a16="http://schemas.microsoft.com/office/drawing/2014/main" id="{608359F2-D64F-4389-A83B-0BCF4A5ED334}"/>
               </a:ext>
             </a:extLst>
           </p:cNvPr>
@@ -9655,7 +9655,7 @@
           <p:cNvPr id="29" name="flow-97">
             <a:extLst xmlns:a="http://schemas.openxmlformats.org/drawingml/2006/main">
               <a:ext uri="{FF2B5EF4-FFF2-40B4-BE49-F238E27FC236}">
-                <a16:creationId xmlns:a16="http://schemas.microsoft.com/office/drawing/2014/main" id="{C91615A6-F80E-4775-B6FA-C8148A91202C}"/>
+                <a16:creationId xmlns:a16="http://schemas.microsoft.com/office/drawing/2014/main" id="{286DFED1-7A34-4E76-A237-DE581A3B9BB5}"/>
               </a:ext>
             </a:extLst>
           </p:cNvPr>
@@ -10041,7 +10041,7 @@
           <p:cNvPr id="35" name="">
             <a:extLst xmlns:a="http://schemas.openxmlformats.org/drawingml/2006/main">
               <a:ext uri="{FF2B5EF4-FFF2-40B4-BE49-F238E27FC236}">
-                <a16:creationId xmlns:a16="http://schemas.microsoft.com/office/drawing/2014/main" id="{670EB22F-B434-4F3E-AA16-6D5BB4F4815B}"/>
+                <a16:creationId xmlns:a16="http://schemas.microsoft.com/office/drawing/2014/main" id="{6753F9C8-ABA5-4BDB-8451-0AA031A374BF}"/>
               </a:ext>
             </a:extLst>
           </p:cNvPr>
@@ -10073,7 +10073,7 @@
           <p:cNvPr id="34" name="">
             <a:extLst xmlns:a="http://schemas.openxmlformats.org/drawingml/2006/main">
               <a:ext uri="{FF2B5EF4-FFF2-40B4-BE49-F238E27FC236}">
-                <a16:creationId xmlns:a16="http://schemas.microsoft.com/office/drawing/2014/main" id="{25F21FFC-C3C4-4100-9C29-D400CC78BA54}"/>
+                <a16:creationId xmlns:a16="http://schemas.microsoft.com/office/drawing/2014/main" id="{A8520DE8-0FEE-4F46-975D-A25F3FBAB3A1}"/>
               </a:ext>
             </a:extLst>
           </p:cNvPr>
@@ -10105,7 +10105,7 @@
           <p:cNvPr id="33" name="">
             <a:extLst xmlns:a="http://schemas.openxmlformats.org/drawingml/2006/main">
               <a:ext uri="{FF2B5EF4-FFF2-40B4-BE49-F238E27FC236}">
-                <a16:creationId xmlns:a16="http://schemas.microsoft.com/office/drawing/2014/main" id="{FF476E01-7BAD-4739-851E-7239EB3B493A}"/>
+                <a16:creationId xmlns:a16="http://schemas.microsoft.com/office/drawing/2014/main" id="{8A0B3494-667D-4A5E-BB7E-8F1CEE1290E5}"/>
               </a:ext>
             </a:extLst>
           </p:cNvPr>
@@ -10137,7 +10137,7 @@
           <p:cNvPr id="13" name="">
             <a:extLst xmlns:a="http://schemas.openxmlformats.org/drawingml/2006/main">
               <a:ext uri="{FF2B5EF4-FFF2-40B4-BE49-F238E27FC236}">
-                <a16:creationId xmlns:a16="http://schemas.microsoft.com/office/drawing/2014/main" id="{746BA64D-1DD3-4212-BCAF-1C2DEE7ECBCE}"/>
+                <a16:creationId xmlns:a16="http://schemas.microsoft.com/office/drawing/2014/main" id="{734540C0-A867-4344-AD26-ADA92C7351DB}"/>
               </a:ext>
             </a:extLst>
           </p:cNvPr>
@@ -10169,7 +10169,7 @@
           <p:cNvPr id="12" name="">
             <a:extLst xmlns:a="http://schemas.openxmlformats.org/drawingml/2006/main">
               <a:ext uri="{FF2B5EF4-FFF2-40B4-BE49-F238E27FC236}">
-                <a16:creationId xmlns:a16="http://schemas.microsoft.com/office/drawing/2014/main" id="{ABA18AAD-31DA-4632-B57B-6CAE2E53E3C1}"/>
+                <a16:creationId xmlns:a16="http://schemas.microsoft.com/office/drawing/2014/main" id="{0271DA71-397E-4917-84A5-B7F45DCE205E}"/>
               </a:ext>
             </a:extLst>
           </p:cNvPr>
@@ -10956,7 +10956,7 @@
           <p:cNvPr id="14" name="flow-113">
             <a:extLst xmlns:a="http://schemas.openxmlformats.org/drawingml/2006/main">
               <a:ext uri="{FF2B5EF4-FFF2-40B4-BE49-F238E27FC236}">
-                <a16:creationId xmlns:a16="http://schemas.microsoft.com/office/drawing/2014/main" id="{3D895D1F-E1AC-46AF-9A66-7DDFF958D5B5}"/>
+                <a16:creationId xmlns:a16="http://schemas.microsoft.com/office/drawing/2014/main" id="{6F8A72F4-BEE7-4011-9708-227AE07F042B}"/>
               </a:ext>
             </a:extLst>
           </p:cNvPr>
@@ -10984,7 +10984,7 @@
           <p:cNvPr id="15" name="flow-114">
             <a:extLst xmlns:a="http://schemas.openxmlformats.org/drawingml/2006/main">
               <a:ext uri="{FF2B5EF4-FFF2-40B4-BE49-F238E27FC236}">
-                <a16:creationId xmlns:a16="http://schemas.microsoft.com/office/drawing/2014/main" id="{CA573C54-30A4-4F82-9748-CE79A7ABDC67}"/>
+                <a16:creationId xmlns:a16="http://schemas.microsoft.com/office/drawing/2014/main" id="{B5616EFD-998E-498A-BF67-6D075C725D74}"/>
               </a:ext>
             </a:extLst>
           </p:cNvPr>
@@ -11012,7 +11012,7 @@
           <p:cNvPr id="16" name="flow-115">
             <a:extLst xmlns:a="http://schemas.openxmlformats.org/drawingml/2006/main">
               <a:ext uri="{FF2B5EF4-FFF2-40B4-BE49-F238E27FC236}">
-                <a16:creationId xmlns:a16="http://schemas.microsoft.com/office/drawing/2014/main" id="{5E971FB2-9958-45D0-B937-9F6314D4AFFE}"/>
+                <a16:creationId xmlns:a16="http://schemas.microsoft.com/office/drawing/2014/main" id="{98188FFB-72F2-4E38-8187-7EE474F358D1}"/>
               </a:ext>
             </a:extLst>
           </p:cNvPr>
@@ -11040,7 +11040,7 @@
           <p:cNvPr id="17" name="flow-116">
             <a:extLst xmlns:a="http://schemas.openxmlformats.org/drawingml/2006/main">
               <a:ext uri="{FF2B5EF4-FFF2-40B4-BE49-F238E27FC236}">
-                <a16:creationId xmlns:a16="http://schemas.microsoft.com/office/drawing/2014/main" id="{61E7A2FA-0034-4C56-8EE9-30274A1110E3}"/>
+                <a16:creationId xmlns:a16="http://schemas.microsoft.com/office/drawing/2014/main" id="{62A00B62-5A5D-4618-A879-B0B288AA08F8}"/>
               </a:ext>
             </a:extLst>
           </p:cNvPr>
@@ -11927,7 +11927,7 @@
           <p:cNvPr id="31" name="flow-130">
             <a:extLst xmlns:a="http://schemas.openxmlformats.org/drawingml/2006/main">
               <a:ext uri="{FF2B5EF4-FFF2-40B4-BE49-F238E27FC236}">
-                <a16:creationId xmlns:a16="http://schemas.microsoft.com/office/drawing/2014/main" id="{049B9C67-71EE-4471-BFC9-4AC6862DB69B}"/>
+                <a16:creationId xmlns:a16="http://schemas.microsoft.com/office/drawing/2014/main" id="{4E4A780B-08C1-4041-B576-E66AFA728FFD}"/>
               </a:ext>
             </a:extLst>
           </p:cNvPr>
@@ -12414,7 +12414,7 @@
                 <a:ea typeface="Aptos"/>
                 <a:cs typeface="Aptos"/>
               </a:rPr>
-              <a:t>Human review adapter planned</a:t>
+              <a:t>Human review adapter disabled</a:t>
             </a:r>
           </a:p>
         </p:txBody>
@@ -12518,7 +12518,7 @@
           <p:cNvPr id="43" name="partner-flow-1">
             <a:extLst xmlns:a="http://schemas.openxmlformats.org/drawingml/2006/main">
               <a:ext uri="{FF2B5EF4-FFF2-40B4-BE49-F238E27FC236}">
-                <a16:creationId xmlns:a16="http://schemas.microsoft.com/office/drawing/2014/main" id="{1A38321E-E1EB-4CAF-B356-7BED01AE15A1}"/>
+                <a16:creationId xmlns:a16="http://schemas.microsoft.com/office/drawing/2014/main" id="{6FEE8CDB-EF48-4810-85A4-F875D5170719}"/>
               </a:ext>
             </a:extLst>
           </p:cNvPr>
@@ -12546,7 +12546,7 @@
           <p:cNvPr id="44" name="partner-flow-2">
             <a:extLst xmlns:a="http://schemas.openxmlformats.org/drawingml/2006/main">
               <a:ext uri="{FF2B5EF4-FFF2-40B4-BE49-F238E27FC236}">
-                <a16:creationId xmlns:a16="http://schemas.microsoft.com/office/drawing/2014/main" id="{A1120644-599B-423D-A4B6-C56A314D7F8F}"/>
+                <a16:creationId xmlns:a16="http://schemas.microsoft.com/office/drawing/2014/main" id="{13B3A6DD-17DC-428E-8FED-0E69723DB0B1}"/>
               </a:ext>
             </a:extLst>
           </p:cNvPr>
@@ -12574,7 +12574,7 @@
           <p:cNvPr id="45" name="partner-flow-3">
             <a:extLst xmlns:a="http://schemas.openxmlformats.org/drawingml/2006/main">
               <a:ext uri="{FF2B5EF4-FFF2-40B4-BE49-F238E27FC236}">
-                <a16:creationId xmlns:a16="http://schemas.microsoft.com/office/drawing/2014/main" id="{78FF0AD2-FBEC-4A90-9698-F346F30E7C41}"/>
+                <a16:creationId xmlns:a16="http://schemas.microsoft.com/office/drawing/2014/main" id="{0CA005FF-DD34-41CA-9592-F3CA1EEB98B7}"/>
               </a:ext>
             </a:extLst>
           </p:cNvPr>
@@ -12602,7 +12602,7 @@
           <p:cNvPr id="46" name="partner-flow-4">
             <a:extLst xmlns:a="http://schemas.openxmlformats.org/drawingml/2006/main">
               <a:ext uri="{FF2B5EF4-FFF2-40B4-BE49-F238E27FC236}">
-                <a16:creationId xmlns:a16="http://schemas.microsoft.com/office/drawing/2014/main" id="{53C0AD1F-EBD7-4788-9359-67A2199371CE}"/>
+                <a16:creationId xmlns:a16="http://schemas.microsoft.com/office/drawing/2014/main" id="{A7B26F48-7BBB-4A2C-81F8-784473F4FF36}"/>
               </a:ext>
             </a:extLst>
           </p:cNvPr>
@@ -12660,7 +12660,7 @@
           <p:cNvPr id="25" name="">
             <a:extLst xmlns:a="http://schemas.openxmlformats.org/drawingml/2006/main">
               <a:ext uri="{FF2B5EF4-FFF2-40B4-BE49-F238E27FC236}">
-                <a16:creationId xmlns:a16="http://schemas.microsoft.com/office/drawing/2014/main" id="{286E0D5B-0D11-4AE2-ABDB-4C813938E4C9}"/>
+                <a16:creationId xmlns:a16="http://schemas.microsoft.com/office/drawing/2014/main" id="{CE648481-E213-4766-B725-664F04AE8B56}"/>
               </a:ext>
             </a:extLst>
           </p:cNvPr>
@@ -12972,7 +12972,7 @@
           <p:cNvPr id="5" name="flow-142">
             <a:extLst xmlns:a="http://schemas.openxmlformats.org/drawingml/2006/main">
               <a:ext uri="{FF2B5EF4-FFF2-40B4-BE49-F238E27FC236}">
-                <a16:creationId xmlns:a16="http://schemas.microsoft.com/office/drawing/2014/main" id="{0DFBB74F-F8C9-42D6-B5DF-20C60B8F9C48}"/>
+                <a16:creationId xmlns:a16="http://schemas.microsoft.com/office/drawing/2014/main" id="{F77D2F70-7348-482F-82EA-24538E7012AA}"/>
               </a:ext>
             </a:extLst>
           </p:cNvPr>
@@ -13889,7 +13889,7 @@
           <p:cNvPr id="21" name="flow-158">
             <a:extLst xmlns:a="http://schemas.openxmlformats.org/drawingml/2006/main">
               <a:ext uri="{FF2B5EF4-FFF2-40B4-BE49-F238E27FC236}">
-                <a16:creationId xmlns:a16="http://schemas.microsoft.com/office/drawing/2014/main" id="{ED8E69CD-E219-4AA4-9C4B-1EB28573B5EB}"/>
+                <a16:creationId xmlns:a16="http://schemas.microsoft.com/office/drawing/2014/main" id="{E8132D6A-DF5C-4820-9BD1-577386387945}"/>
               </a:ext>
             </a:extLst>
           </p:cNvPr>
@@ -14160,7 +14160,7 @@
           <p:cNvPr id="27" name="flow-163">
             <a:extLst xmlns:a="http://schemas.openxmlformats.org/drawingml/2006/main">
               <a:ext uri="{FF2B5EF4-FFF2-40B4-BE49-F238E27FC236}">
-                <a16:creationId xmlns:a16="http://schemas.microsoft.com/office/drawing/2014/main" id="{07186538-AC0C-4BA2-BD68-836076D97BD2}"/>
+                <a16:creationId xmlns:a16="http://schemas.microsoft.com/office/drawing/2014/main" id="{7DAC9C2F-F2BC-4466-9246-2038A6F8CA60}"/>
               </a:ext>
             </a:extLst>
           </p:cNvPr>
@@ -14188,7 +14188,7 @@
           <p:cNvPr id="28" name="flow-164">
             <a:extLst xmlns:a="http://schemas.openxmlformats.org/drawingml/2006/main">
               <a:ext uri="{FF2B5EF4-FFF2-40B4-BE49-F238E27FC236}">
-                <a16:creationId xmlns:a16="http://schemas.microsoft.com/office/drawing/2014/main" id="{DF25C412-6D69-4639-993E-711457200F59}"/>
+                <a16:creationId xmlns:a16="http://schemas.microsoft.com/office/drawing/2014/main" id="{63D8DB00-EDD4-4C04-AF3C-8B2376467571}"/>
               </a:ext>
             </a:extLst>
           </p:cNvPr>
@@ -14216,7 +14216,7 @@
           <p:cNvPr id="29" name="flow-165">
             <a:extLst xmlns:a="http://schemas.openxmlformats.org/drawingml/2006/main">
               <a:ext uri="{FF2B5EF4-FFF2-40B4-BE49-F238E27FC236}">
-                <a16:creationId xmlns:a16="http://schemas.microsoft.com/office/drawing/2014/main" id="{DCD4D9EB-BABB-4E37-BCF8-F349A17CC9EE}"/>
+                <a16:creationId xmlns:a16="http://schemas.microsoft.com/office/drawing/2014/main" id="{7F810F66-A750-4E84-A297-124DE9FF9B95}"/>
               </a:ext>
             </a:extLst>
           </p:cNvPr>
@@ -14315,7 +14315,7 @@
           <p:cNvPr id="31" name="flow-167">
             <a:extLst xmlns:a="http://schemas.openxmlformats.org/drawingml/2006/main">
               <a:ext uri="{FF2B5EF4-FFF2-40B4-BE49-F238E27FC236}">
-                <a16:creationId xmlns:a16="http://schemas.microsoft.com/office/drawing/2014/main" id="{3385FABC-651D-47EB-AA21-9B353C5E4B77}"/>
+                <a16:creationId xmlns:a16="http://schemas.microsoft.com/office/drawing/2014/main" id="{39173D0C-1C64-40F2-BCC9-0281AD3DF8BF}"/>
               </a:ext>
             </a:extLst>
           </p:cNvPr>
@@ -14414,7 +14414,7 @@
           <p:cNvPr id="33" name="flow-169">
             <a:extLst xmlns:a="http://schemas.openxmlformats.org/drawingml/2006/main">
               <a:ext uri="{FF2B5EF4-FFF2-40B4-BE49-F238E27FC236}">
-                <a16:creationId xmlns:a16="http://schemas.microsoft.com/office/drawing/2014/main" id="{24D4DF4C-D145-4C8B-A36B-230ED19E3EEC}"/>
+                <a16:creationId xmlns:a16="http://schemas.microsoft.com/office/drawing/2014/main" id="{D9240F99-73AB-449F-9BA9-95007E36EBC8}"/>
               </a:ext>
             </a:extLst>
           </p:cNvPr>
@@ -14513,7 +14513,7 @@
           <p:cNvPr id="35" name="flow-171">
             <a:extLst xmlns:a="http://schemas.openxmlformats.org/drawingml/2006/main">
               <a:ext uri="{FF2B5EF4-FFF2-40B4-BE49-F238E27FC236}">
-                <a16:creationId xmlns:a16="http://schemas.microsoft.com/office/drawing/2014/main" id="{36CA03A4-9878-41D3-A477-E97F50A5AC3F}"/>
+                <a16:creationId xmlns:a16="http://schemas.microsoft.com/office/drawing/2014/main" id="{92399F74-D275-4F65-AF64-A9B84735129B}"/>
               </a:ext>
             </a:extLst>
           </p:cNvPr>
@@ -14541,7 +14541,7 @@
           <p:cNvPr id="36" name="flow-172">
             <a:extLst xmlns:a="http://schemas.openxmlformats.org/drawingml/2006/main">
               <a:ext uri="{FF2B5EF4-FFF2-40B4-BE49-F238E27FC236}">
-                <a16:creationId xmlns:a16="http://schemas.microsoft.com/office/drawing/2014/main" id="{5119A357-8D1A-4815-AC4D-CD7EBF871278}"/>
+                <a16:creationId xmlns:a16="http://schemas.microsoft.com/office/drawing/2014/main" id="{F0BA96DC-3A62-432E-A9B6-C98F9A217455}"/>
               </a:ext>
             </a:extLst>
           </p:cNvPr>
@@ -14569,7 +14569,7 @@
           <p:cNvPr id="37" name="flow-173">
             <a:extLst xmlns:a="http://schemas.openxmlformats.org/drawingml/2006/main">
               <a:ext uri="{FF2B5EF4-FFF2-40B4-BE49-F238E27FC236}">
-                <a16:creationId xmlns:a16="http://schemas.microsoft.com/office/drawing/2014/main" id="{3DD446E9-6528-4799-B2CA-DC935A5E1F63}"/>
+                <a16:creationId xmlns:a16="http://schemas.microsoft.com/office/drawing/2014/main" id="{BCFB4E87-782C-4E00-B162-0F824ABD4131}"/>
               </a:ext>
             </a:extLst>
           </p:cNvPr>
@@ -14668,7 +14668,7 @@
           <p:cNvPr id="39" name="flow-175">
             <a:extLst xmlns:a="http://schemas.openxmlformats.org/drawingml/2006/main">
               <a:ext uri="{FF2B5EF4-FFF2-40B4-BE49-F238E27FC236}">
-                <a16:creationId xmlns:a16="http://schemas.microsoft.com/office/drawing/2014/main" id="{52A5DB60-B059-41CF-982C-3C7B29F9A8AD}"/>
+                <a16:creationId xmlns:a16="http://schemas.microsoft.com/office/drawing/2014/main" id="{D679E7C8-0F3E-4417-8481-1E324B2D9A58}"/>
               </a:ext>
             </a:extLst>
           </p:cNvPr>
@@ -14696,7 +14696,7 @@
           <p:cNvPr id="40" name="flow-176">
             <a:extLst xmlns:a="http://schemas.openxmlformats.org/drawingml/2006/main">
               <a:ext uri="{FF2B5EF4-FFF2-40B4-BE49-F238E27FC236}">
-                <a16:creationId xmlns:a16="http://schemas.microsoft.com/office/drawing/2014/main" id="{E5B99704-AAAF-4468-A8D0-D3F5C71BBC77}"/>
+                <a16:creationId xmlns:a16="http://schemas.microsoft.com/office/drawing/2014/main" id="{62FD829B-4DB9-41CE-ABDD-308A873DFBF0}"/>
               </a:ext>
             </a:extLst>
           </p:cNvPr>
@@ -14724,7 +14724,7 @@
           <p:cNvPr id="41" name="flow-177">
             <a:extLst xmlns:a="http://schemas.openxmlformats.org/drawingml/2006/main">
               <a:ext uri="{FF2B5EF4-FFF2-40B4-BE49-F238E27FC236}">
-                <a16:creationId xmlns:a16="http://schemas.microsoft.com/office/drawing/2014/main" id="{2A7C89C5-427A-45CC-8C72-011EB982683A}"/>
+                <a16:creationId xmlns:a16="http://schemas.microsoft.com/office/drawing/2014/main" id="{CD2C4D8B-0EB3-4070-881B-DB0D682C8B99}"/>
               </a:ext>
             </a:extLst>
           </p:cNvPr>
@@ -14752,7 +14752,7 @@
           <p:cNvPr id="42" name="flow-178">
             <a:extLst xmlns:a="http://schemas.openxmlformats.org/drawingml/2006/main">
               <a:ext uri="{FF2B5EF4-FFF2-40B4-BE49-F238E27FC236}">
-                <a16:creationId xmlns:a16="http://schemas.microsoft.com/office/drawing/2014/main" id="{1ADF78AC-68EE-490C-A55A-DC2799DA43C6}"/>
+                <a16:creationId xmlns:a16="http://schemas.microsoft.com/office/drawing/2014/main" id="{27B7E246-FD78-4935-8380-92471A373CDD}"/>
               </a:ext>
             </a:extLst>
           </p:cNvPr>
@@ -15371,7 +15371,7 @@
                 <a:ea typeface="Aptos"/>
                 <a:cs typeface="Aptos"/>
               </a:rPr>
-              <a:t>Evidence reuse prepared locally</a:t>
+              <a:t>Evidence and graph cores merged</a:t>
             </a:r>
           </a:p>
           <a:p xmlns:a="http://schemas.openxmlformats.org/drawingml/2006/main">
@@ -15395,7 +15395,7 @@
                 <a:ea typeface="Aptos"/>
                 <a:cs typeface="Aptos"/>
               </a:rPr>
-              <a:t>Graph implementation underway</a:t>
+              <a:t>Production integration next</a:t>
             </a:r>
           </a:p>
         </p:txBody>
@@ -15626,7 +15626,7 @@
           <p:cNvPr id="10" name="partner-flow-14">
             <a:extLst xmlns:a="http://schemas.openxmlformats.org/drawingml/2006/main">
               <a:ext uri="{FF2B5EF4-FFF2-40B4-BE49-F238E27FC236}">
-                <a16:creationId xmlns:a16="http://schemas.microsoft.com/office/drawing/2014/main" id="{5300CD4C-3B1B-496E-B251-56F8314EF966}"/>
+                <a16:creationId xmlns:a16="http://schemas.microsoft.com/office/drawing/2014/main" id="{51DA2BF7-A7AC-4CB3-91DD-AA026B46E8E7}"/>
               </a:ext>
             </a:extLst>
           </p:cNvPr>
@@ -15971,7 +15971,7 @@
           <p:cNvPr id="15" name="partner-flow-19">
             <a:extLst xmlns:a="http://schemas.openxmlformats.org/drawingml/2006/main">
               <a:ext uri="{FF2B5EF4-FFF2-40B4-BE49-F238E27FC236}">
-                <a16:creationId xmlns:a16="http://schemas.microsoft.com/office/drawing/2014/main" id="{0C9DE46F-57F3-4A00-B3D1-DAF663DBC8D8}"/>
+                <a16:creationId xmlns:a16="http://schemas.microsoft.com/office/drawing/2014/main" id="{8A225777-A9F9-4487-A78F-9871F07B4557}"/>
               </a:ext>
             </a:extLst>
           </p:cNvPr>
@@ -16267,7 +16267,7 @@
           <p:cNvPr id="20" name="partner-flow-24">
             <a:extLst xmlns:a="http://schemas.openxmlformats.org/drawingml/2006/main">
               <a:ext uri="{FF2B5EF4-FFF2-40B4-BE49-F238E27FC236}">
-                <a16:creationId xmlns:a16="http://schemas.microsoft.com/office/drawing/2014/main" id="{2AE5785C-6AD3-4DBE-B650-0396CAF3AB8D}"/>
+                <a16:creationId xmlns:a16="http://schemas.microsoft.com/office/drawing/2014/main" id="{8EBC962B-A53D-47DF-A8BC-73378EF45E19}"/>
               </a:ext>
             </a:extLst>
           </p:cNvPr>
@@ -16295,7 +16295,7 @@
           <p:cNvPr id="21" name="partner-flow-25">
             <a:extLst xmlns:a="http://schemas.openxmlformats.org/drawingml/2006/main">
               <a:ext uri="{FF2B5EF4-FFF2-40B4-BE49-F238E27FC236}">
-                <a16:creationId xmlns:a16="http://schemas.microsoft.com/office/drawing/2014/main" id="{6C00FA56-CFE8-42B6-AE19-C27787CE15F1}"/>
+                <a16:creationId xmlns:a16="http://schemas.microsoft.com/office/drawing/2014/main" id="{B2AE613A-5FD9-4122-98CF-EDECD6E43EB9}"/>
               </a:ext>
             </a:extLst>
           </p:cNvPr>
@@ -16323,7 +16323,7 @@
           <p:cNvPr id="22" name="partner-flow-26">
             <a:extLst xmlns:a="http://schemas.openxmlformats.org/drawingml/2006/main">
               <a:ext uri="{FF2B5EF4-FFF2-40B4-BE49-F238E27FC236}">
-                <a16:creationId xmlns:a16="http://schemas.microsoft.com/office/drawing/2014/main" id="{487C54BA-BF13-478C-A353-5A5964BE385B}"/>
+                <a16:creationId xmlns:a16="http://schemas.microsoft.com/office/drawing/2014/main" id="{E275A90E-92B8-41AB-9E96-DED585E6BAA8}"/>
               </a:ext>
             </a:extLst>
           </p:cNvPr>
@@ -16624,7 +16624,7 @@
                 <a:ea typeface="Aptos"/>
                 <a:cs typeface="Aptos"/>
               </a:rPr>
-              <a:t>Required core, implementation underway</a:t>
+              <a:t>Merged core, live integration next</a:t>
             </a:r>
           </a:p>
         </p:txBody>
@@ -16863,7 +16863,7 @@
                 <a:ea typeface="Aptos"/>
                 <a:cs typeface="Aptos"/>
               </a:rPr>
-              <a:t>Required operational core, implementation underway</a:t>
+              <a:t>Merged core, live integration next</a:t>
             </a:r>
           </a:p>
         </p:txBody>
@@ -17757,7 +17757,7 @@
           <p:cNvPr id="16" name="partner-flow-45">
             <a:extLst xmlns:a="http://schemas.openxmlformats.org/drawingml/2006/main">
               <a:ext uri="{FF2B5EF4-FFF2-40B4-BE49-F238E27FC236}">
-                <a16:creationId xmlns:a16="http://schemas.microsoft.com/office/drawing/2014/main" id="{077D55D7-8C44-47B6-A7F0-8D24966C3C88}"/>
+                <a16:creationId xmlns:a16="http://schemas.microsoft.com/office/drawing/2014/main" id="{FF1704F4-A287-4A95-9010-AB47A24D486B}"/>
               </a:ext>
             </a:extLst>
           </p:cNvPr>
@@ -17786,7 +17786,7 @@
           <p:cNvPr id="17" name="partner-flow-46">
             <a:extLst xmlns:a="http://schemas.openxmlformats.org/drawingml/2006/main">
               <a:ext uri="{FF2B5EF4-FFF2-40B4-BE49-F238E27FC236}">
-                <a16:creationId xmlns:a16="http://schemas.microsoft.com/office/drawing/2014/main" id="{B6F31B79-795E-4754-B829-85408678509A}"/>
+                <a16:creationId xmlns:a16="http://schemas.microsoft.com/office/drawing/2014/main" id="{CB2D629C-83A8-4F52-9FF0-E2F6B8B25335}"/>
               </a:ext>
             </a:extLst>
           </p:cNvPr>
@@ -17815,7 +17815,7 @@
           <p:cNvPr id="18" name="partner-flow-47">
             <a:extLst xmlns:a="http://schemas.openxmlformats.org/drawingml/2006/main">
               <a:ext uri="{FF2B5EF4-FFF2-40B4-BE49-F238E27FC236}">
-                <a16:creationId xmlns:a16="http://schemas.microsoft.com/office/drawing/2014/main" id="{88C95FEA-A772-44A8-8A60-6C6B76B3CAF8}"/>
+                <a16:creationId xmlns:a16="http://schemas.microsoft.com/office/drawing/2014/main" id="{E3BD4EE7-BE1F-482D-AFB4-1C4C88F936C3}"/>
               </a:ext>
             </a:extLst>
           </p:cNvPr>
@@ -17844,7 +17844,7 @@
           <p:cNvPr id="19" name="partner-flow-48">
             <a:extLst xmlns:a="http://schemas.openxmlformats.org/drawingml/2006/main">
               <a:ext uri="{FF2B5EF4-FFF2-40B4-BE49-F238E27FC236}">
-                <a16:creationId xmlns:a16="http://schemas.microsoft.com/office/drawing/2014/main" id="{5CC0505A-ADEB-4B11-9B9F-977AA1D9CEA2}"/>
+                <a16:creationId xmlns:a16="http://schemas.microsoft.com/office/drawing/2014/main" id="{7A6E6096-9326-449A-9966-D3D9DE760418}"/>
               </a:ext>
             </a:extLst>
           </p:cNvPr>
@@ -17872,7 +17872,7 @@
           <p:cNvPr id="20" name="partner-flow-49">
             <a:extLst xmlns:a="http://schemas.openxmlformats.org/drawingml/2006/main">
               <a:ext uri="{FF2B5EF4-FFF2-40B4-BE49-F238E27FC236}">
-                <a16:creationId xmlns:a16="http://schemas.microsoft.com/office/drawing/2014/main" id="{00DF08F0-EA0B-40BA-BC9B-F80F785106E3}"/>
+                <a16:creationId xmlns:a16="http://schemas.microsoft.com/office/drawing/2014/main" id="{8FED495E-C14A-47D9-B65C-348E3E6D689E}"/>
               </a:ext>
             </a:extLst>
           </p:cNvPr>
@@ -17900,7 +17900,7 @@
           <p:cNvPr id="21" name="partner-flow-50">
             <a:extLst xmlns:a="http://schemas.openxmlformats.org/drawingml/2006/main">
               <a:ext uri="{FF2B5EF4-FFF2-40B4-BE49-F238E27FC236}">
-                <a16:creationId xmlns:a16="http://schemas.microsoft.com/office/drawing/2014/main" id="{7CECE425-485C-43CA-9018-071BB0AAA583}"/>
+                <a16:creationId xmlns:a16="http://schemas.microsoft.com/office/drawing/2014/main" id="{35BAE54A-E32D-43BA-92A8-193280A0CFA8}"/>
               </a:ext>
             </a:extLst>
           </p:cNvPr>
@@ -17999,7 +17999,7 @@
           <p:cNvPr id="23" name="partner-flow-52">
             <a:extLst xmlns:a="http://schemas.openxmlformats.org/drawingml/2006/main">
               <a:ext uri="{FF2B5EF4-FFF2-40B4-BE49-F238E27FC236}">
-                <a16:creationId xmlns:a16="http://schemas.microsoft.com/office/drawing/2014/main" id="{908746F7-0514-456D-BF58-6643BDA17079}"/>
+                <a16:creationId xmlns:a16="http://schemas.microsoft.com/office/drawing/2014/main" id="{9CFC6A98-F4EC-4506-890F-DA0361A5B47A}"/>
               </a:ext>
             </a:extLst>
           </p:cNvPr>
@@ -18027,7 +18027,7 @@
           <p:cNvPr id="24" name="partner-flow-53">
             <a:extLst xmlns:a="http://schemas.openxmlformats.org/drawingml/2006/main">
               <a:ext uri="{FF2B5EF4-FFF2-40B4-BE49-F238E27FC236}">
-                <a16:creationId xmlns:a16="http://schemas.microsoft.com/office/drawing/2014/main" id="{B2869B2A-46B8-45D2-B9C4-22FBB777CD08}"/>
+                <a16:creationId xmlns:a16="http://schemas.microsoft.com/office/drawing/2014/main" id="{B328E4D9-D7C4-45E3-9241-5BCD6E9F9986}"/>
               </a:ext>
             </a:extLst>
           </p:cNvPr>
@@ -18055,7 +18055,7 @@
           <p:cNvPr id="25" name="partner-flow-54">
             <a:extLst xmlns:a="http://schemas.openxmlformats.org/drawingml/2006/main">
               <a:ext uri="{FF2B5EF4-FFF2-40B4-BE49-F238E27FC236}">
-                <a16:creationId xmlns:a16="http://schemas.microsoft.com/office/drawing/2014/main" id="{A3EEEA01-AF3F-442A-A0D1-8C0359D97D98}"/>
+                <a16:creationId xmlns:a16="http://schemas.microsoft.com/office/drawing/2014/main" id="{5E5279C2-EB2C-4D7C-A11F-AEE1697580F5}"/>
               </a:ext>
             </a:extLst>
           </p:cNvPr>
@@ -18571,6 +18571,7 @@
           </a:lstStyle>
           <a:p xmlns:a="http://schemas.openxmlformats.org/drawingml/2006/main">
             <a:pPr algn="ctr">
+              <a:buNone/>
               <a:defRPr sz="1725" b="0">
                 <a:solidFill>
                   <a:srgbClr val="4A6572"/>
@@ -18599,7 +18600,7 @@
           <p:cNvPr id="33" name="changed-assertions-edge-label-leader">
             <a:extLst xmlns:a="http://schemas.openxmlformats.org/drawingml/2006/main">
               <a:ext uri="{FF2B5EF4-FFF2-40B4-BE49-F238E27FC236}">
-                <a16:creationId xmlns:a16="http://schemas.microsoft.com/office/drawing/2014/main" id="{C9C8D566-7E3C-4AC0-856F-FBE2DA639772}"/>
+                <a16:creationId xmlns:a16="http://schemas.microsoft.com/office/drawing/2014/main" id="{311F23B3-966B-4218-A455-38A550029C31}"/>
               </a:ext>
             </a:extLst>
           </p:cNvPr>
@@ -18796,7 +18797,7 @@
           <p:cNvPr id="5" name="">
             <a:extLst xmlns:a="http://schemas.openxmlformats.org/drawingml/2006/main">
               <a:ext uri="{FF2B5EF4-FFF2-40B4-BE49-F238E27FC236}">
-                <a16:creationId xmlns:a16="http://schemas.microsoft.com/office/drawing/2014/main" id="{73BC365C-3DD6-48C6-AB89-388A0C17CCB4}"/>
+                <a16:creationId xmlns:a16="http://schemas.microsoft.com/office/drawing/2014/main" id="{EB1581A9-0A51-43E8-ABB6-6FAA73131D38}"/>
               </a:ext>
             </a:extLst>
           </p:cNvPr>
@@ -19447,7 +19448,7 @@
                           <a:ea typeface="Aptos"/>
                           <a:cs typeface="Aptos"/>
                         </a:rPr>
-                        <a:t>Connect the human review adapter</a:t>
+                        <a:t>Implement accepted review authority</a:t>
                       </a:r>
                     </a:p>
                     <a:p>
@@ -19582,7 +19583,7 @@
                           <a:ea typeface="Aptos"/>
                           <a:cs typeface="Aptos"/>
                         </a:rPr>
-                        <a:t>Build the projector and scoped queries</a:t>
+                        <a:t>Connect trusted source adapters</a:t>
                       </a:r>
                     </a:p>
                     <a:p>
@@ -19595,7 +19596,7 @@
                           <a:ea typeface="Aptos"/>
                           <a:cs typeface="Aptos"/>
                         </a:rPr>
-                        <a:t>Qualify PG, Helix and ongoing refresh</a:t>
+                        <a:t>Qualify production PG and services</a:t>
                       </a:r>
                     </a:p>
                   </a:txBody>
@@ -20170,7 +20171,7 @@
                 <a:ea typeface="Aptos"/>
                 <a:cs typeface="Aptos"/>
               </a:rPr>
-              <a:t>Prepared changes</a:t>
+              <a:t>Newly merged</a:t>
             </a:r>
           </a:p>
         </p:txBody>
@@ -20380,7 +20381,7 @@
                 <a:ea typeface="Aptos"/>
                 <a:cs typeface="Aptos"/>
               </a:rPr>
-              <a:t>Reviewed, awaiting release</a:t>
+              <a:t>Core services and adapters</a:t>
             </a:r>
           </a:p>
         </p:txBody>
@@ -20460,7 +20461,7 @@
           <p:cNvPr id="9" name="flow-217">
             <a:extLst xmlns:a="http://schemas.openxmlformats.org/drawingml/2006/main">
               <a:ext uri="{FF2B5EF4-FFF2-40B4-BE49-F238E27FC236}">
-                <a16:creationId xmlns:a16="http://schemas.microsoft.com/office/drawing/2014/main" id="{23288824-3A00-4FD8-8BC0-EE3336BC2206}"/>
+                <a16:creationId xmlns:a16="http://schemas.microsoft.com/office/drawing/2014/main" id="{7D5F8869-42BF-4EC6-A3B2-D345359AD627}"/>
               </a:ext>
             </a:extLst>
           </p:cNvPr>
@@ -20489,7 +20490,7 @@
           <p:cNvPr id="10" name="flow-218">
             <a:extLst xmlns:a="http://schemas.openxmlformats.org/drawingml/2006/main">
               <a:ext uri="{FF2B5EF4-FFF2-40B4-BE49-F238E27FC236}">
-                <a16:creationId xmlns:a16="http://schemas.microsoft.com/office/drawing/2014/main" id="{6FE9D5EA-1DF4-435F-8ECB-757E16333E27}"/>
+                <a16:creationId xmlns:a16="http://schemas.microsoft.com/office/drawing/2014/main" id="{6637023A-B417-4A8D-98FF-165F80707F68}"/>
               </a:ext>
             </a:extLst>
           </p:cNvPr>
@@ -20650,7 +20651,7 @@
                 <a:ea typeface="Aptos"/>
                 <a:cs typeface="Aptos"/>
               </a:rPr>
-              <a:t>Funding candidates and route review</a:t>
+              <a:t>Funding candidates and routes</a:t>
             </a:r>
           </a:p>
           <a:p xmlns:a="http://schemas.openxmlformats.org/drawingml/2006/main">
@@ -20675,6 +20676,30 @@
                 <a:cs typeface="Aptos"/>
               </a:rPr>
               <a:t>Portable skills</a:t>
+            </a:r>
+          </a:p>
+          <a:p xmlns:a="http://schemas.openxmlformats.org/drawingml/2006/main">
+            <a:pPr algn="l">
+              <a:buNone/>
+              <a:defRPr sz="2025" b="0">
+                <a:solidFill>
+                  <a:srgbClr val="132E38"/>
+                </a:solidFill>
+                <a:latin typeface="Aptos"/>
+                <a:ea typeface="Aptos"/>
+                <a:cs typeface="Aptos"/>
+              </a:defRPr>
+            </a:pPr>
+            <a:r>
+              <a:rPr sz="2025" b="0">
+                <a:solidFill>
+                  <a:srgbClr val="132E38"/>
+                </a:solidFill>
+                <a:latin typeface="Aptos"/>
+                <a:ea typeface="Aptos"/>
+                <a:cs typeface="Aptos"/>
+              </a:rPr>
+              <a:t>October discovery and scout</a:t>
             </a:r>
           </a:p>
         </p:txBody>
@@ -20768,7 +20793,7 @@
                 <a:ea typeface="Aptos"/>
                 <a:cs typeface="Aptos"/>
               </a:rPr>
-              <a:t>Saved partner preparation</a:t>
+              <a:t>Evidence and financial contracts</a:t>
             </a:r>
           </a:p>
           <a:p xmlns:a="http://schemas.openxmlformats.org/drawingml/2006/main">
@@ -20792,7 +20817,7 @@
                 <a:ea typeface="Aptos"/>
                 <a:cs typeface="Aptos"/>
               </a:rPr>
-              <a:t>Evidence and SQL reuse</a:t>
+              <a:t>Helix graph and research reuse</a:t>
             </a:r>
           </a:p>
           <a:p xmlns:a="http://schemas.openxmlformats.org/drawingml/2006/main">
@@ -20816,7 +20841,7 @@
                 <a:ea typeface="Aptos"/>
                 <a:cs typeface="Aptos"/>
               </a:rPr>
-              <a:t>Sanitized financial contract</a:t>
+              <a:t>Objective intake and briefs</a:t>
             </a:r>
           </a:p>
           <a:p xmlns:a="http://schemas.openxmlformats.org/drawingml/2006/main">
@@ -20840,7 +20865,7 @@
                 <a:ea typeface="Aptos"/>
                 <a:cs typeface="Aptos"/>
               </a:rPr>
-              <a:t>October discovery redesign</a:t>
+              <a:t>Cloud rehearsal tooling</a:t>
             </a:r>
           </a:p>
         </p:txBody>
@@ -20910,7 +20935,7 @@
                 <a:ea typeface="Aptos"/>
                 <a:cs typeface="Aptos"/>
               </a:rPr>
-              <a:t>Publish and qualify local changes</a:t>
+              <a:t>Trusted host and source wiring</a:t>
             </a:r>
           </a:p>
           <a:p xmlns:a="http://schemas.openxmlformats.org/drawingml/2006/main">
@@ -20934,7 +20959,7 @@
                 <a:ea typeface="Aptos"/>
                 <a:cs typeface="Aptos"/>
               </a:rPr>
-              <a:t>Fresh October scout</a:t>
+              <a:t>Operational discovery and alerts</a:t>
             </a:r>
           </a:p>
           <a:p xmlns:a="http://schemas.openxmlformats.org/drawingml/2006/main">
@@ -20958,7 +20983,7 @@
                 <a:ea typeface="Aptos"/>
                 <a:cs typeface="Aptos"/>
               </a:rPr>
-              <a:t>Helix graph and research writeback</a:t>
+              <a:t>Production PG and graph backfill</a:t>
             </a:r>
           </a:p>
           <a:p xmlns:a="http://schemas.openxmlformats.org/drawingml/2006/main">
@@ -21030,7 +21055,7 @@
                 <a:ea typeface="Aptos"/>
                 <a:cs typeface="Aptos"/>
               </a:rPr>
-              <a:t>Bounty intake and funding links</a:t>
+              <a:t>Live models and member enrollment</a:t>
             </a:r>
           </a:p>
           <a:p xmlns:a="http://schemas.openxmlformats.org/drawingml/2006/main">
@@ -21054,7 +21079,7 @@
                 <a:ea typeface="Aptos"/>
                 <a:cs typeface="Aptos"/>
               </a:rPr>
-              <a:t>Live tools, member agents and Y2</a:t>
+              <a:t>Deployment and Y2 integration</a:t>
             </a:r>
           </a:p>
         </p:txBody>
@@ -21064,7 +21089,7 @@
           <p:cNvPr id="14" name="flow-222">
             <a:extLst xmlns:a="http://schemas.openxmlformats.org/drawingml/2006/main">
               <a:ext uri="{FF2B5EF4-FFF2-40B4-BE49-F238E27FC236}">
-                <a16:creationId xmlns:a16="http://schemas.microsoft.com/office/drawing/2014/main" id="{C3F90B23-18D6-4ABE-ADFE-F8107FC7C79E}"/>
+                <a16:creationId xmlns:a16="http://schemas.microsoft.com/office/drawing/2014/main" id="{4A45CBC6-953F-4B50-A26C-F0D8872A2F99}"/>
               </a:ext>
             </a:extLst>
           </p:cNvPr>

</xml_diff>

<commit_message>
docs: synchronize architecture and funding delivery status (#30)
</commit_message>
<xml_diff>
--- a/Inertia-Architecture.pptx
+++ b/Inertia-Architecture.pptx
@@ -2,21 +2,21 @@
 <file path=ppt/presentation.xml><?xml version="1.0" encoding="utf-8"?>
 <p:presentation xmlns:p="http://schemas.openxmlformats.org/presentationml/2006/main">
   <p:sldMasterIdLst>
-    <p:sldMasterId xmlns:r="http://schemas.openxmlformats.org/officeDocument/2006/relationships" id="2147483648" r:id="Re7ddbcfda06747ab"/>
+    <p:sldMasterId xmlns:r="http://schemas.openxmlformats.org/officeDocument/2006/relationships" id="2147483648" r:id="R7b1feba4ebac42cb"/>
   </p:sldMasterIdLst>
   <p:notesMasterIdLst>
-    <p:notesMasterId xmlns:r="http://schemas.openxmlformats.org/officeDocument/2006/relationships" r:id="R1471660a58144325"/>
+    <p:notesMasterId xmlns:r="http://schemas.openxmlformats.org/officeDocument/2006/relationships" r:id="R0af0acd9638049c7"/>
   </p:notesMasterIdLst>
   <p:sldIdLst>
-    <p:sldId xmlns:r="http://schemas.openxmlformats.org/officeDocument/2006/relationships" id="256" r:id="Rfb5b696808f94886"/>
-    <p:sldId xmlns:r="http://schemas.openxmlformats.org/officeDocument/2006/relationships" id="257" r:id="R88a131d998e348d4"/>
-    <p:sldId xmlns:r="http://schemas.openxmlformats.org/officeDocument/2006/relationships" id="258" r:id="R9b898905b5484359"/>
-    <p:sldId xmlns:r="http://schemas.openxmlformats.org/officeDocument/2006/relationships" id="259" r:id="Rb95b11312fed4fb1"/>
-    <p:sldId xmlns:r="http://schemas.openxmlformats.org/officeDocument/2006/relationships" id="260" r:id="Rd7f2a2ed4dd64ff8"/>
-    <p:sldId xmlns:r="http://schemas.openxmlformats.org/officeDocument/2006/relationships" id="261" r:id="Rd979f7c227ed4c85"/>
-    <p:sldId xmlns:r="http://schemas.openxmlformats.org/officeDocument/2006/relationships" id="262" r:id="R9530d9a3c9144107"/>
-    <p:sldId xmlns:r="http://schemas.openxmlformats.org/officeDocument/2006/relationships" id="263" r:id="Rf34e13d35cb345e1"/>
-    <p:sldId xmlns:r="http://schemas.openxmlformats.org/officeDocument/2006/relationships" id="264" r:id="R4633fd83b2404ec3"/>
+    <p:sldId xmlns:r="http://schemas.openxmlformats.org/officeDocument/2006/relationships" id="256" r:id="R13a96eea91d94d13"/>
+    <p:sldId xmlns:r="http://schemas.openxmlformats.org/officeDocument/2006/relationships" id="257" r:id="R79cdbf9129b141da"/>
+    <p:sldId xmlns:r="http://schemas.openxmlformats.org/officeDocument/2006/relationships" id="258" r:id="R0562286197ca4413"/>
+    <p:sldId xmlns:r="http://schemas.openxmlformats.org/officeDocument/2006/relationships" id="259" r:id="R18506465cf3d46fc"/>
+    <p:sldId xmlns:r="http://schemas.openxmlformats.org/officeDocument/2006/relationships" id="260" r:id="R6636fe5d18c847ab"/>
+    <p:sldId xmlns:r="http://schemas.openxmlformats.org/officeDocument/2006/relationships" id="261" r:id="Rb5b967b1d91b4e79"/>
+    <p:sldId xmlns:r="http://schemas.openxmlformats.org/officeDocument/2006/relationships" id="262" r:id="R0ada181589494b2a"/>
+    <p:sldId xmlns:r="http://schemas.openxmlformats.org/officeDocument/2006/relationships" id="263" r:id="Ra4be38fd0b524b61"/>
+    <p:sldId xmlns:r="http://schemas.openxmlformats.org/officeDocument/2006/relationships" id="264" r:id="Rc62e5fd86aa44a33"/>
   </p:sldIdLst>
   <p:sldSz cx="15240000" cy="8572500"/>
   <p:notesSz cx="6858000" cy="9144000"/>
@@ -470,7 +470,7 @@
           </a:p>
           <a:p xmlns:a="http://schemas.openxmlformats.org/drawingml/2006/main">
             <a:r>
-              <a:t>Next connections: live host/relay pairing, general intake, runtime enrollment and domain adapters. Dashed lines mark connections awaiting integration.</a:t>
+              <a:t>Next connections: live host/relay pairing, trusted intake sources, runtime enrollment and domain adapters. Dashed lines mark connections awaiting integration.</a:t>
             </a:r>
           </a:p>
         </p:txBody>
@@ -650,7 +650,7 @@
           </a:p>
           <a:p xmlns:a="http://schemas.openxmlformats.org/drawingml/2006/main">
             <a:r>
-              <a:t>Next: connect authorized Drive readiness, website membership/publication, action intake and the trusted importer/admission policy.</a:t>
+              <a:t>The objective intake/link/brief core is merged. Next: connect authorized Drive readiness, website membership/publication, action sources and trusted admission policy.</a:t>
             </a:r>
           </a:p>
         </p:txBody>
@@ -750,7 +750,7 @@
           </a:p>
           <a:p xmlns:a="http://schemas.openxmlformats.org/drawingml/2006/main">
             <a:r>
-              <a:t>Next: connect trusted human review and live final-vote verification.</a:t>
+              <a:t>The merged native adapter remains disabled. The approved model records durable authority for an exact version at human acceptance, so disconnect alone leaves that approval valid. Activation requires implemented acceptance receipts, funding-service-confirmed cancellation and rejection of changed funding evidence. Grant submission and live final-vote verification retain their separate authority steps.</a:t>
             </a:r>
           </a:p>
         </p:txBody>
@@ -940,7 +940,7 @@
           </a:p>
           <a:p xmlns:a="http://schemas.openxmlformats.org/drawingml/2006/main">
             <a:r>
-              <a:t>Next: qualify domain/schema isolation, PG concurrency and graph integration. Financial inputs retain period, accounting basis, currency and provenance. Production QuickBooks compatibility, cash evidence and spending authority require separate qualification. Broader 990 and semantic enrichment follow the core graph.</a:t>
+              <a:t>Disposable cloud PostgreSQL and PG-to-embedded-Helix rehearsal passed. Next: wire trusted sources, admit the inventory/backfill and qualify deployed graph services. Financial inputs retain period, accounting basis, currency and provenance. Production QuickBooks compatibility, cash evidence and spending authority require separate qualification. Broader 990 and semantic enrichment follow the core graph.</a:t>
             </a:r>
           </a:p>
         </p:txBody>
@@ -1060,7 +1060,7 @@
           </a:p>
           <a:p xmlns:a="http://schemas.openxmlformats.org/drawingml/2006/main">
             <a:r>
-              <a:t>Next: complete typed assertions, writeback, projector and scoped queries, then qualify ongoing refresh, correction/revocation and end-to-end reuse.</a:t>
+              <a:t>Next: connect trusted source adapters, admit the inventory/backfill and qualify deployed graph refresh. The operational discovery loop reuses this research contract with bounded public search, official evidence capture and due rechecks.</a:t>
             </a:r>
           </a:p>
         </p:txBody>
@@ -1220,7 +1220,7 @@
           <a:lstStyle xmlns:a="http://schemas.openxmlformats.org/drawingml/2006/main"/>
           <a:p xmlns:a="http://schemas.openxmlformats.org/drawingml/2006/main">
             <a:r>
-              <a:t>Sources: Inertia spec.md §1, plan.md and testing.md; Reusable DAO knowledge and financial snapshots implementation report; Operational DAO partner graph design; https://github.com/NetRxn/DFW-Gov-Fund/pull/42; https://github.com/NetRxn/DFW-Gov-Fund/actions/runs/40027003050. Status: 23 October 2026.</a:t>
+              <a:t>Sources: Inertia spec.md, plan.md and testing.md; docs/development/funding-enhancement/discovery-loop.md; docs/development/objective-intake.md; scripts/cloud-rehearsal/README.md; https://github.com/NetRxn/Inertia/pull/25; https://github.com/NetRxn/Inertia/pull/26; https://github.com/NetRxn/Inertia/pull/27; https://github.com/NetRxn/Inertia/pull/28; https://github.com/NetRxn/DFW-Gov-Fund/pull/44; https://github.com/NetRxn/DFW-Gov-Fund/pull/45; https://github.com/NetRxn/DFW-Gov-Fund/pull/46; https://github.com/NetRxn/DFW-Gov-Fund/pull/47. Status: 24 October 2026.</a:t>
             </a:r>
           </a:p>
           <a:p xmlns:a="http://schemas.openxmlformats.org/drawingml/2006/main">
@@ -1230,7 +1230,7 @@
           </a:p>
           <a:p xmlns:a="http://schemas.openxmlformats.org/drawingml/2006/main">
             <a:r>
-              <a:t>Merged cores: Buzz bridge/plugin, Roundtable core/publication client, grant packet/vote binding, funding candidate/route review and portable skills 3.4.1. Reviewed public drafting, saved partner preparation and independent gap review await release qualification.</a:t>
+              <a:t>Merged cores now include drafting/gap preparation, scoped evidence and sanitized financial contracts, partner graph/research reuse, objective intake/links/briefs and cloud rehearsal tooling. The bounded October scout is complete. Its confidence overlay and separate July/manual/replay provenance are retained.</a:t>
             </a:r>
           </a:p>
           <a:p xmlns:a="http://schemas.openxmlformats.org/drawingml/2006/main">
@@ -1240,7 +1240,7 @@
           </a:p>
           <a:p xmlns:a="http://schemas.openxmlformats.org/drawingml/2006/main">
             <a:r>
-              <a:t>Evidence/SQL reuse and the sanitized USD financial-fixture contract are locally implemented and independently approved, unpublished and not live. Trusted importer policy, real PostgreSQL concurrency/schema qualification and production financial-provider compatibility remain next steps.</a:t>
+              <a:t>Independent cloud rehearsal passed real domain PostgreSQL/PostGIS, native PostgreSQL service/membership/checkout/crash behavior and PG-to-embedded-Helix reuse. The actual-service synthetic meeting-answer-to-revised-brief workflow passed. npm audit and clean-package checks passed. Full HTTP/UI rehearsal needs an environment with working network-interface enumeration. Actual VPS/PPC2 enrollment and production deployment remain next work.</a:t>
             </a:r>
           </a:p>
           <a:p xmlns:a="http://schemas.openxmlformats.org/drawingml/2006/main">
@@ -1250,7 +1250,7 @@
           </a:p>
           <a:p xmlns:a="http://schemas.openxmlformats.org/drawingml/2006/main">
             <a:r>
-              <a:t>Discovery repairs are published as draft PR 42 on discovery/2026-10-23-refresh at head a342ab1cd38e2e6f65a98c2c582b14d70fa5adae. Source-qualification receipts from run 40027003050 are in review. The dated live scout is next after accepted qualification. July cases remain historical. Manual research and private replay retain separate provenance. The proposed knowledge delta awaits authorized ingestion.</a:t>
+              <a:t>The native adapter is merged and disabled; the reviewed funding transaction service is in CI. The approved exact-version authority-at-acceptance model requires implementation and production writer-fence integration before activation. Live final-vote verification retains its separate gate.</a:t>
             </a:r>
           </a:p>
           <a:p xmlns:a="http://schemas.openxmlformats.org/drawingml/2006/main">
@@ -1260,7 +1260,7 @@
           </a:p>
           <a:p xmlns:a="http://schemas.openxmlformats.org/drawingml/2006/main">
             <a:r>
-              <a:t>Core graph implementation is underway. Official Helix TypeScript SDK 3.1.0 and embedded runtime 0.3.3 are installed, and a real embedded query passed. Full typed relationship/writeback, projector and end-to-end behavior await acceptance. Next gates cover ongoing refresh, scoped retrieval, correction/revocation, replay and real PG/Helix operation. Broader 990 enrichment and optional semantic/vector search follow separately.</a:t>
+              <a:t>The planned discovery loop queries saved knowledge, researches coverage gaps, validates official evidence, saves useful findings and produces prioritized briefs or deduplicated urgent alerts. Native tasks retain due rechecks and failed coverage. The daily profile remains disabled until actual agent/tool wiring, end-to-end rehearsal and recurring cadence approval. Broader 990 and optional semantic/vector enrichment follow separately.</a:t>
             </a:r>
           </a:p>
           <a:p xmlns:a="http://schemas.openxmlformats.org/drawingml/2006/main">
@@ -1270,7 +1270,7 @@
           </a:p>
           <a:p xmlns:a="http://schemas.openxmlformats.org/drawingml/2006/main">
             <a:r>
-              <a:t>Connected demo acceptance: automatic member-site meeting publication, a human-reviewed direct-application packet and required final vote with a verified manual-submission transition, known partner evidence reused and new useful research retrieved on a later run, and an accepted second-member agent contribution. Live source/tool connections and benchmark/quality assessment remain part of rehearsal.</a:t>
+              <a:t>Connected demo outcomes remain website meeting publication, a reviewed direct-application packet with its required final vote, an accepted second-member contribution and research reused on a later run. Production financial-provider compatibility and trusted admission policy require qualification.</a:t>
             </a:r>
           </a:p>
         </p:txBody>
@@ -3083,12 +3083,12 @@
   </p:cSld>
   <p:clrMap bg1="lt1" tx1="dk1" bg2="lt2" tx2="dk2" accent1="accent1" accent2="accent2" accent3="accent3" accent4="accent4" accent5="accent5" accent6="accent6" hlink="hlink" folHlink="folHlink"/>
   <p:sldLayoutIdLst>
-    <p:sldLayoutId xmlns:r="http://schemas.openxmlformats.org/officeDocument/2006/relationships" id="2147483649" r:id="R616afb358831442e"/>
-    <p:sldLayoutId xmlns:r="http://schemas.openxmlformats.org/officeDocument/2006/relationships" id="2147483650" r:id="Rfde21c57e53542b3"/>
-    <p:sldLayoutId xmlns:r="http://schemas.openxmlformats.org/officeDocument/2006/relationships" id="2147483651" r:id="R7f862b9ad23c48f8"/>
-    <p:sldLayoutId xmlns:r="http://schemas.openxmlformats.org/officeDocument/2006/relationships" id="2147483652" r:id="R118090782d914de2"/>
-    <p:sldLayoutId xmlns:r="http://schemas.openxmlformats.org/officeDocument/2006/relationships" id="2147483653" r:id="R8b61cb293b1a4343"/>
-    <p:sldLayoutId xmlns:r="http://schemas.openxmlformats.org/officeDocument/2006/relationships" id="2147483654" r:id="R3f6b22852b3d4e56"/>
+    <p:sldLayoutId xmlns:r="http://schemas.openxmlformats.org/officeDocument/2006/relationships" id="2147483649" r:id="R36c050df87df4dfb"/>
+    <p:sldLayoutId xmlns:r="http://schemas.openxmlformats.org/officeDocument/2006/relationships" id="2147483650" r:id="R4826580c941b4dfb"/>
+    <p:sldLayoutId xmlns:r="http://schemas.openxmlformats.org/officeDocument/2006/relationships" id="2147483651" r:id="R1ef15abf51b948a7"/>
+    <p:sldLayoutId xmlns:r="http://schemas.openxmlformats.org/officeDocument/2006/relationships" id="2147483652" r:id="R13a461ceefae4590"/>
+    <p:sldLayoutId xmlns:r="http://schemas.openxmlformats.org/officeDocument/2006/relationships" id="2147483653" r:id="R72511b6ee2d846d2"/>
+    <p:sldLayoutId xmlns:r="http://schemas.openxmlformats.org/officeDocument/2006/relationships" id="2147483654" r:id="R79585679f8734e86"/>
   </p:sldLayoutIdLst>
   <p:txStyles>
     <p:titleStyle>
@@ -3639,7 +3639,7 @@
           <p:cNvPr id="39" name="">
             <a:extLst xmlns:a="http://schemas.openxmlformats.org/drawingml/2006/main">
               <a:ext uri="{FF2B5EF4-FFF2-40B4-BE49-F238E27FC236}">
-                <a16:creationId xmlns:a16="http://schemas.microsoft.com/office/drawing/2014/main" id="{2638FB43-5EF1-4133-9489-D42BD6A1F3AB}"/>
+                <a16:creationId xmlns:a16="http://schemas.microsoft.com/office/drawing/2014/main" id="{D412FE0C-6DAC-45C6-B0D0-763C63607A56}"/>
               </a:ext>
             </a:extLst>
           </p:cNvPr>
@@ -3672,7 +3672,7 @@
           <p:cNvPr id="32" name="">
             <a:extLst xmlns:a="http://schemas.openxmlformats.org/drawingml/2006/main">
               <a:ext uri="{FF2B5EF4-FFF2-40B4-BE49-F238E27FC236}">
-                <a16:creationId xmlns:a16="http://schemas.microsoft.com/office/drawing/2014/main" id="{B4313EE5-5C53-43D7-99BE-F29F673E49A5}"/>
+                <a16:creationId xmlns:a16="http://schemas.microsoft.com/office/drawing/2014/main" id="{C7A66388-0418-4A12-AB11-536B1935AB16}"/>
               </a:ext>
             </a:extLst>
           </p:cNvPr>
@@ -3704,7 +3704,7 @@
           <p:cNvPr id="29" name="">
             <a:extLst xmlns:a="http://schemas.openxmlformats.org/drawingml/2006/main">
               <a:ext uri="{FF2B5EF4-FFF2-40B4-BE49-F238E27FC236}">
-                <a16:creationId xmlns:a16="http://schemas.microsoft.com/office/drawing/2014/main" id="{7E5DFC84-48BC-4F9F-B5D0-4970391E5749}"/>
+                <a16:creationId xmlns:a16="http://schemas.microsoft.com/office/drawing/2014/main" id="{793CDB02-24F2-4EA8-A861-9337AB15E01C}"/>
               </a:ext>
             </a:extLst>
           </p:cNvPr>
@@ -5497,7 +5497,7 @@
           <p:cNvPr id="30" name="flow-29">
             <a:extLst xmlns:a="http://schemas.openxmlformats.org/drawingml/2006/main">
               <a:ext uri="{FF2B5EF4-FFF2-40B4-BE49-F238E27FC236}">
-                <a16:creationId xmlns:a16="http://schemas.microsoft.com/office/drawing/2014/main" id="{55BD9632-CE50-4111-9B2D-333D49A6FCE7}"/>
+                <a16:creationId xmlns:a16="http://schemas.microsoft.com/office/drawing/2014/main" id="{116D73A4-DE0C-4746-865A-5A0861F91418}"/>
               </a:ext>
             </a:extLst>
           </p:cNvPr>
@@ -5527,7 +5527,7 @@
           <p:cNvPr id="31" name="flow-30">
             <a:extLst xmlns:a="http://schemas.openxmlformats.org/drawingml/2006/main">
               <a:ext uri="{FF2B5EF4-FFF2-40B4-BE49-F238E27FC236}">
-                <a16:creationId xmlns:a16="http://schemas.microsoft.com/office/drawing/2014/main" id="{D2300CCC-0612-4D12-9CBF-D8DCB3D96768}"/>
+                <a16:creationId xmlns:a16="http://schemas.microsoft.com/office/drawing/2014/main" id="{3731771A-875E-48B2-92BE-DF2D6BA903C8}"/>
               </a:ext>
             </a:extLst>
           </p:cNvPr>
@@ -5627,7 +5627,7 @@
           <p:cNvPr id="34" name="flow-32">
             <a:extLst xmlns:a="http://schemas.openxmlformats.org/drawingml/2006/main">
               <a:ext uri="{FF2B5EF4-FFF2-40B4-BE49-F238E27FC236}">
-                <a16:creationId xmlns:a16="http://schemas.microsoft.com/office/drawing/2014/main" id="{AC985D5E-77DF-4B76-9B8D-72BE0CC090A2}"/>
+                <a16:creationId xmlns:a16="http://schemas.microsoft.com/office/drawing/2014/main" id="{FF943156-514E-4F21-943D-31A37277F58A}"/>
               </a:ext>
             </a:extLst>
           </p:cNvPr>
@@ -5656,7 +5656,7 @@
           <p:cNvPr id="35" name="flow-33">
             <a:extLst xmlns:a="http://schemas.openxmlformats.org/drawingml/2006/main">
               <a:ext uri="{FF2B5EF4-FFF2-40B4-BE49-F238E27FC236}">
-                <a16:creationId xmlns:a16="http://schemas.microsoft.com/office/drawing/2014/main" id="{A7CAAAC6-3736-488A-A448-04C82E9ACE30}"/>
+                <a16:creationId xmlns:a16="http://schemas.microsoft.com/office/drawing/2014/main" id="{7E0A8387-7E26-400F-BFD0-C0A25DBD9924}"/>
               </a:ext>
             </a:extLst>
           </p:cNvPr>
@@ -5684,7 +5684,7 @@
           <p:cNvPr id="36" name="flow-34">
             <a:extLst xmlns:a="http://schemas.openxmlformats.org/drawingml/2006/main">
               <a:ext uri="{FF2B5EF4-FFF2-40B4-BE49-F238E27FC236}">
-                <a16:creationId xmlns:a16="http://schemas.microsoft.com/office/drawing/2014/main" id="{89BD5D39-1F2D-4203-84F0-727A2A44DE0E}"/>
+                <a16:creationId xmlns:a16="http://schemas.microsoft.com/office/drawing/2014/main" id="{573B7FFE-DD48-4608-B172-19C12DC02C38}"/>
               </a:ext>
             </a:extLst>
           </p:cNvPr>
@@ -5783,7 +5783,7 @@
           <p:cNvPr id="38" name="flow-36">
             <a:extLst xmlns:a="http://schemas.openxmlformats.org/drawingml/2006/main">
               <a:ext uri="{FF2B5EF4-FFF2-40B4-BE49-F238E27FC236}">
-                <a16:creationId xmlns:a16="http://schemas.microsoft.com/office/drawing/2014/main" id="{ECE64A28-95CE-4E64-A43D-F044FB1CE7E2}"/>
+                <a16:creationId xmlns:a16="http://schemas.microsoft.com/office/drawing/2014/main" id="{BD9D8EE3-DFBC-4002-ABEE-92865AC73C45}"/>
               </a:ext>
             </a:extLst>
           </p:cNvPr>
@@ -5912,7 +5912,7 @@
           <p:cNvPr id="35" name="">
             <a:extLst xmlns:a="http://schemas.openxmlformats.org/drawingml/2006/main">
               <a:ext uri="{FF2B5EF4-FFF2-40B4-BE49-F238E27FC236}">
-                <a16:creationId xmlns:a16="http://schemas.microsoft.com/office/drawing/2014/main" id="{57DBA162-4F9E-40B1-96DF-AD08BB0F3A30}"/>
+                <a16:creationId xmlns:a16="http://schemas.microsoft.com/office/drawing/2014/main" id="{822164ED-A4E6-40BD-8309-9D150FF51E10}"/>
               </a:ext>
             </a:extLst>
           </p:cNvPr>
@@ -5944,7 +5944,7 @@
           <p:cNvPr id="21" name="">
             <a:extLst xmlns:a="http://schemas.openxmlformats.org/drawingml/2006/main">
               <a:ext uri="{FF2B5EF4-FFF2-40B4-BE49-F238E27FC236}">
-                <a16:creationId xmlns:a16="http://schemas.microsoft.com/office/drawing/2014/main" id="{F7EF065C-7E51-4463-8E1D-0396E8E27B6E}"/>
+                <a16:creationId xmlns:a16="http://schemas.microsoft.com/office/drawing/2014/main" id="{D6F5A60F-60D8-4C4B-810A-23C53C987B2E}"/>
               </a:ext>
             </a:extLst>
           </p:cNvPr>
@@ -5976,7 +5976,7 @@
           <p:cNvPr id="20" name="">
             <a:extLst xmlns:a="http://schemas.openxmlformats.org/drawingml/2006/main">
               <a:ext uri="{FF2B5EF4-FFF2-40B4-BE49-F238E27FC236}">
-                <a16:creationId xmlns:a16="http://schemas.microsoft.com/office/drawing/2014/main" id="{8960E32D-97B0-4005-B9D4-5BF3BA84F1B2}"/>
+                <a16:creationId xmlns:a16="http://schemas.microsoft.com/office/drawing/2014/main" id="{10466ABD-73A2-4146-BC7F-9539242ECCF7}"/>
               </a:ext>
             </a:extLst>
           </p:cNvPr>
@@ -6008,7 +6008,7 @@
           <p:cNvPr id="19" name="">
             <a:extLst xmlns:a="http://schemas.openxmlformats.org/drawingml/2006/main">
               <a:ext uri="{FF2B5EF4-FFF2-40B4-BE49-F238E27FC236}">
-                <a16:creationId xmlns:a16="http://schemas.microsoft.com/office/drawing/2014/main" id="{9F7F184F-EF9A-47F9-ACF3-BA72750A3A9C}"/>
+                <a16:creationId xmlns:a16="http://schemas.microsoft.com/office/drawing/2014/main" id="{9900C5D9-787C-4CDD-B375-24D5E3656DDA}"/>
               </a:ext>
             </a:extLst>
           </p:cNvPr>
@@ -6040,7 +6040,7 @@
           <p:cNvPr id="18" name="">
             <a:extLst xmlns:a="http://schemas.openxmlformats.org/drawingml/2006/main">
               <a:ext uri="{FF2B5EF4-FFF2-40B4-BE49-F238E27FC236}">
-                <a16:creationId xmlns:a16="http://schemas.microsoft.com/office/drawing/2014/main" id="{81B91D6E-DBAD-4E1F-BBFE-BB9FCE6059F3}"/>
+                <a16:creationId xmlns:a16="http://schemas.microsoft.com/office/drawing/2014/main" id="{173E04A9-03BD-4611-B3D2-7A62AE51AFE4}"/>
               </a:ext>
             </a:extLst>
           </p:cNvPr>
@@ -7615,7 +7615,7 @@
           <p:cNvPr id="28" name="flow-61">
             <a:extLst xmlns:a="http://schemas.openxmlformats.org/drawingml/2006/main">
               <a:ext uri="{FF2B5EF4-FFF2-40B4-BE49-F238E27FC236}">
-                <a16:creationId xmlns:a16="http://schemas.microsoft.com/office/drawing/2014/main" id="{4F7933A1-DDAF-4E19-9A3D-0A281E0AA09C}"/>
+                <a16:creationId xmlns:a16="http://schemas.microsoft.com/office/drawing/2014/main" id="{E567EE97-38F1-4317-9A67-B52EB3F8B70E}"/>
               </a:ext>
             </a:extLst>
           </p:cNvPr>
@@ -7714,7 +7714,7 @@
           <p:cNvPr id="30" name="flow-63">
             <a:extLst xmlns:a="http://schemas.openxmlformats.org/drawingml/2006/main">
               <a:ext uri="{FF2B5EF4-FFF2-40B4-BE49-F238E27FC236}">
-                <a16:creationId xmlns:a16="http://schemas.microsoft.com/office/drawing/2014/main" id="{A0121C05-1693-4001-A6E9-55DF94F5CFB1}"/>
+                <a16:creationId xmlns:a16="http://schemas.microsoft.com/office/drawing/2014/main" id="{FDB526CF-4730-4F7E-ACDD-55EBE7014C5B}"/>
               </a:ext>
             </a:extLst>
           </p:cNvPr>
@@ -7742,7 +7742,7 @@
           <p:cNvPr id="31" name="flow-64">
             <a:extLst xmlns:a="http://schemas.openxmlformats.org/drawingml/2006/main">
               <a:ext uri="{FF2B5EF4-FFF2-40B4-BE49-F238E27FC236}">
-                <a16:creationId xmlns:a16="http://schemas.microsoft.com/office/drawing/2014/main" id="{36BE4576-19F2-4EA2-A78A-12DF2CB3DFAB}"/>
+                <a16:creationId xmlns:a16="http://schemas.microsoft.com/office/drawing/2014/main" id="{437323D9-BDDE-49FD-B876-B365128356E5}"/>
               </a:ext>
             </a:extLst>
           </p:cNvPr>
@@ -7770,7 +7770,7 @@
           <p:cNvPr id="32" name="flow-65">
             <a:extLst xmlns:a="http://schemas.openxmlformats.org/drawingml/2006/main">
               <a:ext uri="{FF2B5EF4-FFF2-40B4-BE49-F238E27FC236}">
-                <a16:creationId xmlns:a16="http://schemas.microsoft.com/office/drawing/2014/main" id="{96D484F1-5763-4E92-9576-324ACE1FDFCC}"/>
+                <a16:creationId xmlns:a16="http://schemas.microsoft.com/office/drawing/2014/main" id="{92FC9F92-495A-4D8E-98E4-8609C71708BE}"/>
               </a:ext>
             </a:extLst>
           </p:cNvPr>
@@ -7798,7 +7798,7 @@
           <p:cNvPr id="33" name="flow-66">
             <a:extLst xmlns:a="http://schemas.openxmlformats.org/drawingml/2006/main">
               <a:ext uri="{FF2B5EF4-FFF2-40B4-BE49-F238E27FC236}">
-                <a16:creationId xmlns:a16="http://schemas.microsoft.com/office/drawing/2014/main" id="{113C177D-76DB-4104-AE45-4F2070F6C1F1}"/>
+                <a16:creationId xmlns:a16="http://schemas.microsoft.com/office/drawing/2014/main" id="{27E92EDE-C8F0-4BA6-A8FD-FB94225210FB}"/>
               </a:ext>
             </a:extLst>
           </p:cNvPr>
@@ -8066,7 +8066,7 @@
           <p:cNvPr id="18" name="">
             <a:extLst xmlns:a="http://schemas.openxmlformats.org/drawingml/2006/main">
               <a:ext uri="{FF2B5EF4-FFF2-40B4-BE49-F238E27FC236}">
-                <a16:creationId xmlns:a16="http://schemas.microsoft.com/office/drawing/2014/main" id="{F810E6E3-E78D-4F3C-95D5-1DCB732BAEE7}"/>
+                <a16:creationId xmlns:a16="http://schemas.microsoft.com/office/drawing/2014/main" id="{DECA0952-A5AE-4EF1-BC35-188518497DDE}"/>
               </a:ext>
             </a:extLst>
           </p:cNvPr>
@@ -9269,7 +9269,7 @@
           <p:cNvPr id="20" name="flow-88">
             <a:extLst xmlns:a="http://schemas.openxmlformats.org/drawingml/2006/main">
               <a:ext uri="{FF2B5EF4-FFF2-40B4-BE49-F238E27FC236}">
-                <a16:creationId xmlns:a16="http://schemas.microsoft.com/office/drawing/2014/main" id="{FA700758-6063-4BD3-9145-558DA36A1A8B}"/>
+                <a16:creationId xmlns:a16="http://schemas.microsoft.com/office/drawing/2014/main" id="{9BADED30-1D23-447C-9A14-4A0047A4507E}"/>
               </a:ext>
             </a:extLst>
           </p:cNvPr>
@@ -9297,7 +9297,7 @@
           <p:cNvPr id="21" name="flow-89">
             <a:extLst xmlns:a="http://schemas.openxmlformats.org/drawingml/2006/main">
               <a:ext uri="{FF2B5EF4-FFF2-40B4-BE49-F238E27FC236}">
-                <a16:creationId xmlns:a16="http://schemas.microsoft.com/office/drawing/2014/main" id="{2A320953-D319-41AF-BADC-83004547950E}"/>
+                <a16:creationId xmlns:a16="http://schemas.microsoft.com/office/drawing/2014/main" id="{17F6B08D-AB40-4300-88BA-A58AB8F7B8A7}"/>
               </a:ext>
             </a:extLst>
           </p:cNvPr>
@@ -9325,7 +9325,7 @@
           <p:cNvPr id="22" name="flow-90">
             <a:extLst xmlns:a="http://schemas.openxmlformats.org/drawingml/2006/main">
               <a:ext uri="{FF2B5EF4-FFF2-40B4-BE49-F238E27FC236}">
-                <a16:creationId xmlns:a16="http://schemas.microsoft.com/office/drawing/2014/main" id="{73C3075B-DC33-4479-8183-A2C8285BDD7C}"/>
+                <a16:creationId xmlns:a16="http://schemas.microsoft.com/office/drawing/2014/main" id="{1A4C0FAB-1733-45A1-B19E-E20BC73A8DA4}"/>
               </a:ext>
             </a:extLst>
           </p:cNvPr>
@@ -9448,7 +9448,7 @@
           <p:cNvPr id="24" name="flow-92">
             <a:extLst xmlns:a="http://schemas.openxmlformats.org/drawingml/2006/main">
               <a:ext uri="{FF2B5EF4-FFF2-40B4-BE49-F238E27FC236}">
-                <a16:creationId xmlns:a16="http://schemas.microsoft.com/office/drawing/2014/main" id="{CFB5CA8C-F69E-4513-B917-F6458810358E}"/>
+                <a16:creationId xmlns:a16="http://schemas.microsoft.com/office/drawing/2014/main" id="{353F0194-201E-4415-B09A-B947DD491531}"/>
               </a:ext>
             </a:extLst>
           </p:cNvPr>
@@ -9476,7 +9476,7 @@
           <p:cNvPr id="25" name="flow-93">
             <a:extLst xmlns:a="http://schemas.openxmlformats.org/drawingml/2006/main">
               <a:ext uri="{FF2B5EF4-FFF2-40B4-BE49-F238E27FC236}">
-                <a16:creationId xmlns:a16="http://schemas.microsoft.com/office/drawing/2014/main" id="{5A3BD616-5C6C-4A0A-9E8D-29036374F8AC}"/>
+                <a16:creationId xmlns:a16="http://schemas.microsoft.com/office/drawing/2014/main" id="{4D0DDC02-9908-4199-BEB1-12E90958EA04}"/>
               </a:ext>
             </a:extLst>
           </p:cNvPr>
@@ -9504,7 +9504,7 @@
           <p:cNvPr id="26" name="flow-94">
             <a:extLst xmlns:a="http://schemas.openxmlformats.org/drawingml/2006/main">
               <a:ext uri="{FF2B5EF4-FFF2-40B4-BE49-F238E27FC236}">
-                <a16:creationId xmlns:a16="http://schemas.microsoft.com/office/drawing/2014/main" id="{AD06838F-FD01-4EA1-8BF5-8DFCDBCD7E18}"/>
+                <a16:creationId xmlns:a16="http://schemas.microsoft.com/office/drawing/2014/main" id="{BBB48D46-F608-4E32-B988-9555A3F71873}"/>
               </a:ext>
             </a:extLst>
           </p:cNvPr>
@@ -9617,7 +9617,7 @@
                 <a:ea typeface="Aptos"/>
                 <a:cs typeface="Aptos"/>
               </a:rPr>
-              <a:t>planned</a:t>
+              <a:t>wiring next</a:t>
             </a:r>
           </a:p>
         </p:txBody>
@@ -9627,7 +9627,7 @@
           <p:cNvPr id="28" name="flow-96">
             <a:extLst xmlns:a="http://schemas.openxmlformats.org/drawingml/2006/main">
               <a:ext uri="{FF2B5EF4-FFF2-40B4-BE49-F238E27FC236}">
-                <a16:creationId xmlns:a16="http://schemas.microsoft.com/office/drawing/2014/main" id="{6789951C-FDDA-4651-AA1A-4DA39B360C44}"/>
+                <a16:creationId xmlns:a16="http://schemas.microsoft.com/office/drawing/2014/main" id="{608359F2-D64F-4389-A83B-0BCF4A5ED334}"/>
               </a:ext>
             </a:extLst>
           </p:cNvPr>
@@ -9655,7 +9655,7 @@
           <p:cNvPr id="29" name="flow-97">
             <a:extLst xmlns:a="http://schemas.openxmlformats.org/drawingml/2006/main">
               <a:ext uri="{FF2B5EF4-FFF2-40B4-BE49-F238E27FC236}">
-                <a16:creationId xmlns:a16="http://schemas.microsoft.com/office/drawing/2014/main" id="{C91615A6-F80E-4775-B6FA-C8148A91202C}"/>
+                <a16:creationId xmlns:a16="http://schemas.microsoft.com/office/drawing/2014/main" id="{286DFED1-7A34-4E76-A237-DE581A3B9BB5}"/>
               </a:ext>
             </a:extLst>
           </p:cNvPr>
@@ -10041,7 +10041,7 @@
           <p:cNvPr id="35" name="">
             <a:extLst xmlns:a="http://schemas.openxmlformats.org/drawingml/2006/main">
               <a:ext uri="{FF2B5EF4-FFF2-40B4-BE49-F238E27FC236}">
-                <a16:creationId xmlns:a16="http://schemas.microsoft.com/office/drawing/2014/main" id="{670EB22F-B434-4F3E-AA16-6D5BB4F4815B}"/>
+                <a16:creationId xmlns:a16="http://schemas.microsoft.com/office/drawing/2014/main" id="{6753F9C8-ABA5-4BDB-8451-0AA031A374BF}"/>
               </a:ext>
             </a:extLst>
           </p:cNvPr>
@@ -10073,7 +10073,7 @@
           <p:cNvPr id="34" name="">
             <a:extLst xmlns:a="http://schemas.openxmlformats.org/drawingml/2006/main">
               <a:ext uri="{FF2B5EF4-FFF2-40B4-BE49-F238E27FC236}">
-                <a16:creationId xmlns:a16="http://schemas.microsoft.com/office/drawing/2014/main" id="{25F21FFC-C3C4-4100-9C29-D400CC78BA54}"/>
+                <a16:creationId xmlns:a16="http://schemas.microsoft.com/office/drawing/2014/main" id="{A8520DE8-0FEE-4F46-975D-A25F3FBAB3A1}"/>
               </a:ext>
             </a:extLst>
           </p:cNvPr>
@@ -10105,7 +10105,7 @@
           <p:cNvPr id="33" name="">
             <a:extLst xmlns:a="http://schemas.openxmlformats.org/drawingml/2006/main">
               <a:ext uri="{FF2B5EF4-FFF2-40B4-BE49-F238E27FC236}">
-                <a16:creationId xmlns:a16="http://schemas.microsoft.com/office/drawing/2014/main" id="{FF476E01-7BAD-4739-851E-7239EB3B493A}"/>
+                <a16:creationId xmlns:a16="http://schemas.microsoft.com/office/drawing/2014/main" id="{8A0B3494-667D-4A5E-BB7E-8F1CEE1290E5}"/>
               </a:ext>
             </a:extLst>
           </p:cNvPr>
@@ -10137,7 +10137,7 @@
           <p:cNvPr id="13" name="">
             <a:extLst xmlns:a="http://schemas.openxmlformats.org/drawingml/2006/main">
               <a:ext uri="{FF2B5EF4-FFF2-40B4-BE49-F238E27FC236}">
-                <a16:creationId xmlns:a16="http://schemas.microsoft.com/office/drawing/2014/main" id="{746BA64D-1DD3-4212-BCAF-1C2DEE7ECBCE}"/>
+                <a16:creationId xmlns:a16="http://schemas.microsoft.com/office/drawing/2014/main" id="{734540C0-A867-4344-AD26-ADA92C7351DB}"/>
               </a:ext>
             </a:extLst>
           </p:cNvPr>
@@ -10169,7 +10169,7 @@
           <p:cNvPr id="12" name="">
             <a:extLst xmlns:a="http://schemas.openxmlformats.org/drawingml/2006/main">
               <a:ext uri="{FF2B5EF4-FFF2-40B4-BE49-F238E27FC236}">
-                <a16:creationId xmlns:a16="http://schemas.microsoft.com/office/drawing/2014/main" id="{ABA18AAD-31DA-4632-B57B-6CAE2E53E3C1}"/>
+                <a16:creationId xmlns:a16="http://schemas.microsoft.com/office/drawing/2014/main" id="{0271DA71-397E-4917-84A5-B7F45DCE205E}"/>
               </a:ext>
             </a:extLst>
           </p:cNvPr>
@@ -10956,7 +10956,7 @@
           <p:cNvPr id="14" name="flow-113">
             <a:extLst xmlns:a="http://schemas.openxmlformats.org/drawingml/2006/main">
               <a:ext uri="{FF2B5EF4-FFF2-40B4-BE49-F238E27FC236}">
-                <a16:creationId xmlns:a16="http://schemas.microsoft.com/office/drawing/2014/main" id="{3D895D1F-E1AC-46AF-9A66-7DDFF958D5B5}"/>
+                <a16:creationId xmlns:a16="http://schemas.microsoft.com/office/drawing/2014/main" id="{6F8A72F4-BEE7-4011-9708-227AE07F042B}"/>
               </a:ext>
             </a:extLst>
           </p:cNvPr>
@@ -10984,7 +10984,7 @@
           <p:cNvPr id="15" name="flow-114">
             <a:extLst xmlns:a="http://schemas.openxmlformats.org/drawingml/2006/main">
               <a:ext uri="{FF2B5EF4-FFF2-40B4-BE49-F238E27FC236}">
-                <a16:creationId xmlns:a16="http://schemas.microsoft.com/office/drawing/2014/main" id="{CA573C54-30A4-4F82-9748-CE79A7ABDC67}"/>
+                <a16:creationId xmlns:a16="http://schemas.microsoft.com/office/drawing/2014/main" id="{B5616EFD-998E-498A-BF67-6D075C725D74}"/>
               </a:ext>
             </a:extLst>
           </p:cNvPr>
@@ -11012,7 +11012,7 @@
           <p:cNvPr id="16" name="flow-115">
             <a:extLst xmlns:a="http://schemas.openxmlformats.org/drawingml/2006/main">
               <a:ext uri="{FF2B5EF4-FFF2-40B4-BE49-F238E27FC236}">
-                <a16:creationId xmlns:a16="http://schemas.microsoft.com/office/drawing/2014/main" id="{5E971FB2-9958-45D0-B937-9F6314D4AFFE}"/>
+                <a16:creationId xmlns:a16="http://schemas.microsoft.com/office/drawing/2014/main" id="{98188FFB-72F2-4E38-8187-7EE474F358D1}"/>
               </a:ext>
             </a:extLst>
           </p:cNvPr>
@@ -11040,7 +11040,7 @@
           <p:cNvPr id="17" name="flow-116">
             <a:extLst xmlns:a="http://schemas.openxmlformats.org/drawingml/2006/main">
               <a:ext uri="{FF2B5EF4-FFF2-40B4-BE49-F238E27FC236}">
-                <a16:creationId xmlns:a16="http://schemas.microsoft.com/office/drawing/2014/main" id="{61E7A2FA-0034-4C56-8EE9-30274A1110E3}"/>
+                <a16:creationId xmlns:a16="http://schemas.microsoft.com/office/drawing/2014/main" id="{62A00B62-5A5D-4618-A879-B0B288AA08F8}"/>
               </a:ext>
             </a:extLst>
           </p:cNvPr>
@@ -11927,7 +11927,7 @@
           <p:cNvPr id="31" name="flow-130">
             <a:extLst xmlns:a="http://schemas.openxmlformats.org/drawingml/2006/main">
               <a:ext uri="{FF2B5EF4-FFF2-40B4-BE49-F238E27FC236}">
-                <a16:creationId xmlns:a16="http://schemas.microsoft.com/office/drawing/2014/main" id="{049B9C67-71EE-4471-BFC9-4AC6862DB69B}"/>
+                <a16:creationId xmlns:a16="http://schemas.microsoft.com/office/drawing/2014/main" id="{4E4A780B-08C1-4041-B576-E66AFA728FFD}"/>
               </a:ext>
             </a:extLst>
           </p:cNvPr>
@@ -12414,7 +12414,7 @@
                 <a:ea typeface="Aptos"/>
                 <a:cs typeface="Aptos"/>
               </a:rPr>
-              <a:t>Human review adapter planned</a:t>
+              <a:t>Human review adapter disabled</a:t>
             </a:r>
           </a:p>
         </p:txBody>
@@ -12518,7 +12518,7 @@
           <p:cNvPr id="43" name="partner-flow-1">
             <a:extLst xmlns:a="http://schemas.openxmlformats.org/drawingml/2006/main">
               <a:ext uri="{FF2B5EF4-FFF2-40B4-BE49-F238E27FC236}">
-                <a16:creationId xmlns:a16="http://schemas.microsoft.com/office/drawing/2014/main" id="{1A38321E-E1EB-4CAF-B356-7BED01AE15A1}"/>
+                <a16:creationId xmlns:a16="http://schemas.microsoft.com/office/drawing/2014/main" id="{6FEE8CDB-EF48-4810-85A4-F875D5170719}"/>
               </a:ext>
             </a:extLst>
           </p:cNvPr>
@@ -12546,7 +12546,7 @@
           <p:cNvPr id="44" name="partner-flow-2">
             <a:extLst xmlns:a="http://schemas.openxmlformats.org/drawingml/2006/main">
               <a:ext uri="{FF2B5EF4-FFF2-40B4-BE49-F238E27FC236}">
-                <a16:creationId xmlns:a16="http://schemas.microsoft.com/office/drawing/2014/main" id="{A1120644-599B-423D-A4B6-C56A314D7F8F}"/>
+                <a16:creationId xmlns:a16="http://schemas.microsoft.com/office/drawing/2014/main" id="{13B3A6DD-17DC-428E-8FED-0E69723DB0B1}"/>
               </a:ext>
             </a:extLst>
           </p:cNvPr>
@@ -12574,7 +12574,7 @@
           <p:cNvPr id="45" name="partner-flow-3">
             <a:extLst xmlns:a="http://schemas.openxmlformats.org/drawingml/2006/main">
               <a:ext uri="{FF2B5EF4-FFF2-40B4-BE49-F238E27FC236}">
-                <a16:creationId xmlns:a16="http://schemas.microsoft.com/office/drawing/2014/main" id="{78FF0AD2-FBEC-4A90-9698-F346F30E7C41}"/>
+                <a16:creationId xmlns:a16="http://schemas.microsoft.com/office/drawing/2014/main" id="{0CA005FF-DD34-41CA-9592-F3CA1EEB98B7}"/>
               </a:ext>
             </a:extLst>
           </p:cNvPr>
@@ -12602,7 +12602,7 @@
           <p:cNvPr id="46" name="partner-flow-4">
             <a:extLst xmlns:a="http://schemas.openxmlformats.org/drawingml/2006/main">
               <a:ext uri="{FF2B5EF4-FFF2-40B4-BE49-F238E27FC236}">
-                <a16:creationId xmlns:a16="http://schemas.microsoft.com/office/drawing/2014/main" id="{53C0AD1F-EBD7-4788-9359-67A2199371CE}"/>
+                <a16:creationId xmlns:a16="http://schemas.microsoft.com/office/drawing/2014/main" id="{A7B26F48-7BBB-4A2C-81F8-784473F4FF36}"/>
               </a:ext>
             </a:extLst>
           </p:cNvPr>
@@ -12660,7 +12660,7 @@
           <p:cNvPr id="25" name="">
             <a:extLst xmlns:a="http://schemas.openxmlformats.org/drawingml/2006/main">
               <a:ext uri="{FF2B5EF4-FFF2-40B4-BE49-F238E27FC236}">
-                <a16:creationId xmlns:a16="http://schemas.microsoft.com/office/drawing/2014/main" id="{286E0D5B-0D11-4AE2-ABDB-4C813938E4C9}"/>
+                <a16:creationId xmlns:a16="http://schemas.microsoft.com/office/drawing/2014/main" id="{CE648481-E213-4766-B725-664F04AE8B56}"/>
               </a:ext>
             </a:extLst>
           </p:cNvPr>
@@ -12972,7 +12972,7 @@
           <p:cNvPr id="5" name="flow-142">
             <a:extLst xmlns:a="http://schemas.openxmlformats.org/drawingml/2006/main">
               <a:ext uri="{FF2B5EF4-FFF2-40B4-BE49-F238E27FC236}">
-                <a16:creationId xmlns:a16="http://schemas.microsoft.com/office/drawing/2014/main" id="{0DFBB74F-F8C9-42D6-B5DF-20C60B8F9C48}"/>
+                <a16:creationId xmlns:a16="http://schemas.microsoft.com/office/drawing/2014/main" id="{F77D2F70-7348-482F-82EA-24538E7012AA}"/>
               </a:ext>
             </a:extLst>
           </p:cNvPr>
@@ -13889,7 +13889,7 @@
           <p:cNvPr id="21" name="flow-158">
             <a:extLst xmlns:a="http://schemas.openxmlformats.org/drawingml/2006/main">
               <a:ext uri="{FF2B5EF4-FFF2-40B4-BE49-F238E27FC236}">
-                <a16:creationId xmlns:a16="http://schemas.microsoft.com/office/drawing/2014/main" id="{ED8E69CD-E219-4AA4-9C4B-1EB28573B5EB}"/>
+                <a16:creationId xmlns:a16="http://schemas.microsoft.com/office/drawing/2014/main" id="{E8132D6A-DF5C-4820-9BD1-577386387945}"/>
               </a:ext>
             </a:extLst>
           </p:cNvPr>
@@ -14160,7 +14160,7 @@
           <p:cNvPr id="27" name="flow-163">
             <a:extLst xmlns:a="http://schemas.openxmlformats.org/drawingml/2006/main">
               <a:ext uri="{FF2B5EF4-FFF2-40B4-BE49-F238E27FC236}">
-                <a16:creationId xmlns:a16="http://schemas.microsoft.com/office/drawing/2014/main" id="{07186538-AC0C-4BA2-BD68-836076D97BD2}"/>
+                <a16:creationId xmlns:a16="http://schemas.microsoft.com/office/drawing/2014/main" id="{7DAC9C2F-F2BC-4466-9246-2038A6F8CA60}"/>
               </a:ext>
             </a:extLst>
           </p:cNvPr>
@@ -14188,7 +14188,7 @@
           <p:cNvPr id="28" name="flow-164">
             <a:extLst xmlns:a="http://schemas.openxmlformats.org/drawingml/2006/main">
               <a:ext uri="{FF2B5EF4-FFF2-40B4-BE49-F238E27FC236}">
-                <a16:creationId xmlns:a16="http://schemas.microsoft.com/office/drawing/2014/main" id="{DF25C412-6D69-4639-993E-711457200F59}"/>
+                <a16:creationId xmlns:a16="http://schemas.microsoft.com/office/drawing/2014/main" id="{63D8DB00-EDD4-4C04-AF3C-8B2376467571}"/>
               </a:ext>
             </a:extLst>
           </p:cNvPr>
@@ -14216,7 +14216,7 @@
           <p:cNvPr id="29" name="flow-165">
             <a:extLst xmlns:a="http://schemas.openxmlformats.org/drawingml/2006/main">
               <a:ext uri="{FF2B5EF4-FFF2-40B4-BE49-F238E27FC236}">
-                <a16:creationId xmlns:a16="http://schemas.microsoft.com/office/drawing/2014/main" id="{DCD4D9EB-BABB-4E37-BCF8-F349A17CC9EE}"/>
+                <a16:creationId xmlns:a16="http://schemas.microsoft.com/office/drawing/2014/main" id="{7F810F66-A750-4E84-A297-124DE9FF9B95}"/>
               </a:ext>
             </a:extLst>
           </p:cNvPr>
@@ -14315,7 +14315,7 @@
           <p:cNvPr id="31" name="flow-167">
             <a:extLst xmlns:a="http://schemas.openxmlformats.org/drawingml/2006/main">
               <a:ext uri="{FF2B5EF4-FFF2-40B4-BE49-F238E27FC236}">
-                <a16:creationId xmlns:a16="http://schemas.microsoft.com/office/drawing/2014/main" id="{3385FABC-651D-47EB-AA21-9B353C5E4B77}"/>
+                <a16:creationId xmlns:a16="http://schemas.microsoft.com/office/drawing/2014/main" id="{39173D0C-1C64-40F2-BCC9-0281AD3DF8BF}"/>
               </a:ext>
             </a:extLst>
           </p:cNvPr>
@@ -14414,7 +14414,7 @@
           <p:cNvPr id="33" name="flow-169">
             <a:extLst xmlns:a="http://schemas.openxmlformats.org/drawingml/2006/main">
               <a:ext uri="{FF2B5EF4-FFF2-40B4-BE49-F238E27FC236}">
-                <a16:creationId xmlns:a16="http://schemas.microsoft.com/office/drawing/2014/main" id="{24D4DF4C-D145-4C8B-A36B-230ED19E3EEC}"/>
+                <a16:creationId xmlns:a16="http://schemas.microsoft.com/office/drawing/2014/main" id="{D9240F99-73AB-449F-9BA9-95007E36EBC8}"/>
               </a:ext>
             </a:extLst>
           </p:cNvPr>
@@ -14513,7 +14513,7 @@
           <p:cNvPr id="35" name="flow-171">
             <a:extLst xmlns:a="http://schemas.openxmlformats.org/drawingml/2006/main">
               <a:ext uri="{FF2B5EF4-FFF2-40B4-BE49-F238E27FC236}">
-                <a16:creationId xmlns:a16="http://schemas.microsoft.com/office/drawing/2014/main" id="{36CA03A4-9878-41D3-A477-E97F50A5AC3F}"/>
+                <a16:creationId xmlns:a16="http://schemas.microsoft.com/office/drawing/2014/main" id="{92399F74-D275-4F65-AF64-A9B84735129B}"/>
               </a:ext>
             </a:extLst>
           </p:cNvPr>
@@ -14541,7 +14541,7 @@
           <p:cNvPr id="36" name="flow-172">
             <a:extLst xmlns:a="http://schemas.openxmlformats.org/drawingml/2006/main">
               <a:ext uri="{FF2B5EF4-FFF2-40B4-BE49-F238E27FC236}">
-                <a16:creationId xmlns:a16="http://schemas.microsoft.com/office/drawing/2014/main" id="{5119A357-8D1A-4815-AC4D-CD7EBF871278}"/>
+                <a16:creationId xmlns:a16="http://schemas.microsoft.com/office/drawing/2014/main" id="{F0BA96DC-3A62-432E-A9B6-C98F9A217455}"/>
               </a:ext>
             </a:extLst>
           </p:cNvPr>
@@ -14569,7 +14569,7 @@
           <p:cNvPr id="37" name="flow-173">
             <a:extLst xmlns:a="http://schemas.openxmlformats.org/drawingml/2006/main">
               <a:ext uri="{FF2B5EF4-FFF2-40B4-BE49-F238E27FC236}">
-                <a16:creationId xmlns:a16="http://schemas.microsoft.com/office/drawing/2014/main" id="{3DD446E9-6528-4799-B2CA-DC935A5E1F63}"/>
+                <a16:creationId xmlns:a16="http://schemas.microsoft.com/office/drawing/2014/main" id="{BCFB4E87-782C-4E00-B162-0F824ABD4131}"/>
               </a:ext>
             </a:extLst>
           </p:cNvPr>
@@ -14668,7 +14668,7 @@
           <p:cNvPr id="39" name="flow-175">
             <a:extLst xmlns:a="http://schemas.openxmlformats.org/drawingml/2006/main">
               <a:ext uri="{FF2B5EF4-FFF2-40B4-BE49-F238E27FC236}">
-                <a16:creationId xmlns:a16="http://schemas.microsoft.com/office/drawing/2014/main" id="{52A5DB60-B059-41CF-982C-3C7B29F9A8AD}"/>
+                <a16:creationId xmlns:a16="http://schemas.microsoft.com/office/drawing/2014/main" id="{D679E7C8-0F3E-4417-8481-1E324B2D9A58}"/>
               </a:ext>
             </a:extLst>
           </p:cNvPr>
@@ -14696,7 +14696,7 @@
           <p:cNvPr id="40" name="flow-176">
             <a:extLst xmlns:a="http://schemas.openxmlformats.org/drawingml/2006/main">
               <a:ext uri="{FF2B5EF4-FFF2-40B4-BE49-F238E27FC236}">
-                <a16:creationId xmlns:a16="http://schemas.microsoft.com/office/drawing/2014/main" id="{E5B99704-AAAF-4468-A8D0-D3F5C71BBC77}"/>
+                <a16:creationId xmlns:a16="http://schemas.microsoft.com/office/drawing/2014/main" id="{62FD829B-4DB9-41CE-ABDD-308A873DFBF0}"/>
               </a:ext>
             </a:extLst>
           </p:cNvPr>
@@ -14724,7 +14724,7 @@
           <p:cNvPr id="41" name="flow-177">
             <a:extLst xmlns:a="http://schemas.openxmlformats.org/drawingml/2006/main">
               <a:ext uri="{FF2B5EF4-FFF2-40B4-BE49-F238E27FC236}">
-                <a16:creationId xmlns:a16="http://schemas.microsoft.com/office/drawing/2014/main" id="{2A7C89C5-427A-45CC-8C72-011EB982683A}"/>
+                <a16:creationId xmlns:a16="http://schemas.microsoft.com/office/drawing/2014/main" id="{CD2C4D8B-0EB3-4070-881B-DB0D682C8B99}"/>
               </a:ext>
             </a:extLst>
           </p:cNvPr>
@@ -14752,7 +14752,7 @@
           <p:cNvPr id="42" name="flow-178">
             <a:extLst xmlns:a="http://schemas.openxmlformats.org/drawingml/2006/main">
               <a:ext uri="{FF2B5EF4-FFF2-40B4-BE49-F238E27FC236}">
-                <a16:creationId xmlns:a16="http://schemas.microsoft.com/office/drawing/2014/main" id="{1ADF78AC-68EE-490C-A55A-DC2799DA43C6}"/>
+                <a16:creationId xmlns:a16="http://schemas.microsoft.com/office/drawing/2014/main" id="{27B7E246-FD78-4935-8380-92471A373CDD}"/>
               </a:ext>
             </a:extLst>
           </p:cNvPr>
@@ -15371,7 +15371,7 @@
                 <a:ea typeface="Aptos"/>
                 <a:cs typeface="Aptos"/>
               </a:rPr>
-              <a:t>Evidence reuse prepared locally</a:t>
+              <a:t>Evidence and graph cores merged</a:t>
             </a:r>
           </a:p>
           <a:p xmlns:a="http://schemas.openxmlformats.org/drawingml/2006/main">
@@ -15395,7 +15395,7 @@
                 <a:ea typeface="Aptos"/>
                 <a:cs typeface="Aptos"/>
               </a:rPr>
-              <a:t>Graph implementation underway</a:t>
+              <a:t>Production integration next</a:t>
             </a:r>
           </a:p>
         </p:txBody>
@@ -15626,7 +15626,7 @@
           <p:cNvPr id="10" name="partner-flow-14">
             <a:extLst xmlns:a="http://schemas.openxmlformats.org/drawingml/2006/main">
               <a:ext uri="{FF2B5EF4-FFF2-40B4-BE49-F238E27FC236}">
-                <a16:creationId xmlns:a16="http://schemas.microsoft.com/office/drawing/2014/main" id="{5300CD4C-3B1B-496E-B251-56F8314EF966}"/>
+                <a16:creationId xmlns:a16="http://schemas.microsoft.com/office/drawing/2014/main" id="{51DA2BF7-A7AC-4CB3-91DD-AA026B46E8E7}"/>
               </a:ext>
             </a:extLst>
           </p:cNvPr>
@@ -15971,7 +15971,7 @@
           <p:cNvPr id="15" name="partner-flow-19">
             <a:extLst xmlns:a="http://schemas.openxmlformats.org/drawingml/2006/main">
               <a:ext uri="{FF2B5EF4-FFF2-40B4-BE49-F238E27FC236}">
-                <a16:creationId xmlns:a16="http://schemas.microsoft.com/office/drawing/2014/main" id="{0C9DE46F-57F3-4A00-B3D1-DAF663DBC8D8}"/>
+                <a16:creationId xmlns:a16="http://schemas.microsoft.com/office/drawing/2014/main" id="{8A225777-A9F9-4487-A78F-9871F07B4557}"/>
               </a:ext>
             </a:extLst>
           </p:cNvPr>
@@ -16267,7 +16267,7 @@
           <p:cNvPr id="20" name="partner-flow-24">
             <a:extLst xmlns:a="http://schemas.openxmlformats.org/drawingml/2006/main">
               <a:ext uri="{FF2B5EF4-FFF2-40B4-BE49-F238E27FC236}">
-                <a16:creationId xmlns:a16="http://schemas.microsoft.com/office/drawing/2014/main" id="{2AE5785C-6AD3-4DBE-B650-0396CAF3AB8D}"/>
+                <a16:creationId xmlns:a16="http://schemas.microsoft.com/office/drawing/2014/main" id="{8EBC962B-A53D-47DF-A8BC-73378EF45E19}"/>
               </a:ext>
             </a:extLst>
           </p:cNvPr>
@@ -16295,7 +16295,7 @@
           <p:cNvPr id="21" name="partner-flow-25">
             <a:extLst xmlns:a="http://schemas.openxmlformats.org/drawingml/2006/main">
               <a:ext uri="{FF2B5EF4-FFF2-40B4-BE49-F238E27FC236}">
-                <a16:creationId xmlns:a16="http://schemas.microsoft.com/office/drawing/2014/main" id="{6C00FA56-CFE8-42B6-AE19-C27787CE15F1}"/>
+                <a16:creationId xmlns:a16="http://schemas.microsoft.com/office/drawing/2014/main" id="{B2AE613A-5FD9-4122-98CF-EDECD6E43EB9}"/>
               </a:ext>
             </a:extLst>
           </p:cNvPr>
@@ -16323,7 +16323,7 @@
           <p:cNvPr id="22" name="partner-flow-26">
             <a:extLst xmlns:a="http://schemas.openxmlformats.org/drawingml/2006/main">
               <a:ext uri="{FF2B5EF4-FFF2-40B4-BE49-F238E27FC236}">
-                <a16:creationId xmlns:a16="http://schemas.microsoft.com/office/drawing/2014/main" id="{487C54BA-BF13-478C-A353-5A5964BE385B}"/>
+                <a16:creationId xmlns:a16="http://schemas.microsoft.com/office/drawing/2014/main" id="{E275A90E-92B8-41AB-9E96-DED585E6BAA8}"/>
               </a:ext>
             </a:extLst>
           </p:cNvPr>
@@ -16624,7 +16624,7 @@
                 <a:ea typeface="Aptos"/>
                 <a:cs typeface="Aptos"/>
               </a:rPr>
-              <a:t>Required core, implementation underway</a:t>
+              <a:t>Merged core, live integration next</a:t>
             </a:r>
           </a:p>
         </p:txBody>
@@ -16863,7 +16863,7 @@
                 <a:ea typeface="Aptos"/>
                 <a:cs typeface="Aptos"/>
               </a:rPr>
-              <a:t>Required operational core, implementation underway</a:t>
+              <a:t>Merged core, live integration next</a:t>
             </a:r>
           </a:p>
         </p:txBody>
@@ -17757,7 +17757,7 @@
           <p:cNvPr id="16" name="partner-flow-45">
             <a:extLst xmlns:a="http://schemas.openxmlformats.org/drawingml/2006/main">
               <a:ext uri="{FF2B5EF4-FFF2-40B4-BE49-F238E27FC236}">
-                <a16:creationId xmlns:a16="http://schemas.microsoft.com/office/drawing/2014/main" id="{077D55D7-8C44-47B6-A7F0-8D24966C3C88}"/>
+                <a16:creationId xmlns:a16="http://schemas.microsoft.com/office/drawing/2014/main" id="{FF1704F4-A287-4A95-9010-AB47A24D486B}"/>
               </a:ext>
             </a:extLst>
           </p:cNvPr>
@@ -17786,7 +17786,7 @@
           <p:cNvPr id="17" name="partner-flow-46">
             <a:extLst xmlns:a="http://schemas.openxmlformats.org/drawingml/2006/main">
               <a:ext uri="{FF2B5EF4-FFF2-40B4-BE49-F238E27FC236}">
-                <a16:creationId xmlns:a16="http://schemas.microsoft.com/office/drawing/2014/main" id="{B6F31B79-795E-4754-B829-85408678509A}"/>
+                <a16:creationId xmlns:a16="http://schemas.microsoft.com/office/drawing/2014/main" id="{CB2D629C-83A8-4F52-9FF0-E2F6B8B25335}"/>
               </a:ext>
             </a:extLst>
           </p:cNvPr>
@@ -17815,7 +17815,7 @@
           <p:cNvPr id="18" name="partner-flow-47">
             <a:extLst xmlns:a="http://schemas.openxmlformats.org/drawingml/2006/main">
               <a:ext uri="{FF2B5EF4-FFF2-40B4-BE49-F238E27FC236}">
-                <a16:creationId xmlns:a16="http://schemas.microsoft.com/office/drawing/2014/main" id="{88C95FEA-A772-44A8-8A60-6C6B76B3CAF8}"/>
+                <a16:creationId xmlns:a16="http://schemas.microsoft.com/office/drawing/2014/main" id="{E3BD4EE7-BE1F-482D-AFB4-1C4C88F936C3}"/>
               </a:ext>
             </a:extLst>
           </p:cNvPr>
@@ -17844,7 +17844,7 @@
           <p:cNvPr id="19" name="partner-flow-48">
             <a:extLst xmlns:a="http://schemas.openxmlformats.org/drawingml/2006/main">
               <a:ext uri="{FF2B5EF4-FFF2-40B4-BE49-F238E27FC236}">
-                <a16:creationId xmlns:a16="http://schemas.microsoft.com/office/drawing/2014/main" id="{5CC0505A-ADEB-4B11-9B9F-977AA1D9CEA2}"/>
+                <a16:creationId xmlns:a16="http://schemas.microsoft.com/office/drawing/2014/main" id="{7A6E6096-9326-449A-9966-D3D9DE760418}"/>
               </a:ext>
             </a:extLst>
           </p:cNvPr>
@@ -17872,7 +17872,7 @@
           <p:cNvPr id="20" name="partner-flow-49">
             <a:extLst xmlns:a="http://schemas.openxmlformats.org/drawingml/2006/main">
               <a:ext uri="{FF2B5EF4-FFF2-40B4-BE49-F238E27FC236}">
-                <a16:creationId xmlns:a16="http://schemas.microsoft.com/office/drawing/2014/main" id="{00DF08F0-EA0B-40BA-BC9B-F80F785106E3}"/>
+                <a16:creationId xmlns:a16="http://schemas.microsoft.com/office/drawing/2014/main" id="{8FED495E-C14A-47D9-B65C-348E3E6D689E}"/>
               </a:ext>
             </a:extLst>
           </p:cNvPr>
@@ -17900,7 +17900,7 @@
           <p:cNvPr id="21" name="partner-flow-50">
             <a:extLst xmlns:a="http://schemas.openxmlformats.org/drawingml/2006/main">
               <a:ext uri="{FF2B5EF4-FFF2-40B4-BE49-F238E27FC236}">
-                <a16:creationId xmlns:a16="http://schemas.microsoft.com/office/drawing/2014/main" id="{7CECE425-485C-43CA-9018-071BB0AAA583}"/>
+                <a16:creationId xmlns:a16="http://schemas.microsoft.com/office/drawing/2014/main" id="{35BAE54A-E32D-43BA-92A8-193280A0CFA8}"/>
               </a:ext>
             </a:extLst>
           </p:cNvPr>
@@ -17999,7 +17999,7 @@
           <p:cNvPr id="23" name="partner-flow-52">
             <a:extLst xmlns:a="http://schemas.openxmlformats.org/drawingml/2006/main">
               <a:ext uri="{FF2B5EF4-FFF2-40B4-BE49-F238E27FC236}">
-                <a16:creationId xmlns:a16="http://schemas.microsoft.com/office/drawing/2014/main" id="{908746F7-0514-456D-BF58-6643BDA17079}"/>
+                <a16:creationId xmlns:a16="http://schemas.microsoft.com/office/drawing/2014/main" id="{9CFC6A98-F4EC-4506-890F-DA0361A5B47A}"/>
               </a:ext>
             </a:extLst>
           </p:cNvPr>
@@ -18027,7 +18027,7 @@
           <p:cNvPr id="24" name="partner-flow-53">
             <a:extLst xmlns:a="http://schemas.openxmlformats.org/drawingml/2006/main">
               <a:ext uri="{FF2B5EF4-FFF2-40B4-BE49-F238E27FC236}">
-                <a16:creationId xmlns:a16="http://schemas.microsoft.com/office/drawing/2014/main" id="{B2869B2A-46B8-45D2-B9C4-22FBB777CD08}"/>
+                <a16:creationId xmlns:a16="http://schemas.microsoft.com/office/drawing/2014/main" id="{B328E4D9-D7C4-45E3-9241-5BCD6E9F9986}"/>
               </a:ext>
             </a:extLst>
           </p:cNvPr>
@@ -18055,7 +18055,7 @@
           <p:cNvPr id="25" name="partner-flow-54">
             <a:extLst xmlns:a="http://schemas.openxmlformats.org/drawingml/2006/main">
               <a:ext uri="{FF2B5EF4-FFF2-40B4-BE49-F238E27FC236}">
-                <a16:creationId xmlns:a16="http://schemas.microsoft.com/office/drawing/2014/main" id="{A3EEEA01-AF3F-442A-A0D1-8C0359D97D98}"/>
+                <a16:creationId xmlns:a16="http://schemas.microsoft.com/office/drawing/2014/main" id="{5E5279C2-EB2C-4D7C-A11F-AEE1697580F5}"/>
               </a:ext>
             </a:extLst>
           </p:cNvPr>
@@ -18571,6 +18571,7 @@
           </a:lstStyle>
           <a:p xmlns:a="http://schemas.openxmlformats.org/drawingml/2006/main">
             <a:pPr algn="ctr">
+              <a:buNone/>
               <a:defRPr sz="1725" b="0">
                 <a:solidFill>
                   <a:srgbClr val="4A6572"/>
@@ -18599,7 +18600,7 @@
           <p:cNvPr id="33" name="changed-assertions-edge-label-leader">
             <a:extLst xmlns:a="http://schemas.openxmlformats.org/drawingml/2006/main">
               <a:ext uri="{FF2B5EF4-FFF2-40B4-BE49-F238E27FC236}">
-                <a16:creationId xmlns:a16="http://schemas.microsoft.com/office/drawing/2014/main" id="{C9C8D566-7E3C-4AC0-856F-FBE2DA639772}"/>
+                <a16:creationId xmlns:a16="http://schemas.microsoft.com/office/drawing/2014/main" id="{311F23B3-966B-4218-A455-38A550029C31}"/>
               </a:ext>
             </a:extLst>
           </p:cNvPr>
@@ -18796,7 +18797,7 @@
           <p:cNvPr id="5" name="">
             <a:extLst xmlns:a="http://schemas.openxmlformats.org/drawingml/2006/main">
               <a:ext uri="{FF2B5EF4-FFF2-40B4-BE49-F238E27FC236}">
-                <a16:creationId xmlns:a16="http://schemas.microsoft.com/office/drawing/2014/main" id="{73BC365C-3DD6-48C6-AB89-388A0C17CCB4}"/>
+                <a16:creationId xmlns:a16="http://schemas.microsoft.com/office/drawing/2014/main" id="{EB1581A9-0A51-43E8-ABB6-6FAA73131D38}"/>
               </a:ext>
             </a:extLst>
           </p:cNvPr>
@@ -19447,7 +19448,7 @@
                           <a:ea typeface="Aptos"/>
                           <a:cs typeface="Aptos"/>
                         </a:rPr>
-                        <a:t>Connect the human review adapter</a:t>
+                        <a:t>Implement accepted review authority</a:t>
                       </a:r>
                     </a:p>
                     <a:p>
@@ -19582,7 +19583,7 @@
                           <a:ea typeface="Aptos"/>
                           <a:cs typeface="Aptos"/>
                         </a:rPr>
-                        <a:t>Build the projector and scoped queries</a:t>
+                        <a:t>Connect trusted source adapters</a:t>
                       </a:r>
                     </a:p>
                     <a:p>
@@ -19595,7 +19596,7 @@
                           <a:ea typeface="Aptos"/>
                           <a:cs typeface="Aptos"/>
                         </a:rPr>
-                        <a:t>Qualify PG, Helix and ongoing refresh</a:t>
+                        <a:t>Qualify production PG and services</a:t>
                       </a:r>
                     </a:p>
                   </a:txBody>
@@ -20170,7 +20171,7 @@
                 <a:ea typeface="Aptos"/>
                 <a:cs typeface="Aptos"/>
               </a:rPr>
-              <a:t>Prepared changes</a:t>
+              <a:t>Newly merged</a:t>
             </a:r>
           </a:p>
         </p:txBody>
@@ -20380,7 +20381,7 @@
                 <a:ea typeface="Aptos"/>
                 <a:cs typeface="Aptos"/>
               </a:rPr>
-              <a:t>Reviewed, awaiting release</a:t>
+              <a:t>Core services and adapters</a:t>
             </a:r>
           </a:p>
         </p:txBody>
@@ -20460,7 +20461,7 @@
           <p:cNvPr id="9" name="flow-217">
             <a:extLst xmlns:a="http://schemas.openxmlformats.org/drawingml/2006/main">
               <a:ext uri="{FF2B5EF4-FFF2-40B4-BE49-F238E27FC236}">
-                <a16:creationId xmlns:a16="http://schemas.microsoft.com/office/drawing/2014/main" id="{23288824-3A00-4FD8-8BC0-EE3336BC2206}"/>
+                <a16:creationId xmlns:a16="http://schemas.microsoft.com/office/drawing/2014/main" id="{7D5F8869-42BF-4EC6-A3B2-D345359AD627}"/>
               </a:ext>
             </a:extLst>
           </p:cNvPr>
@@ -20489,7 +20490,7 @@
           <p:cNvPr id="10" name="flow-218">
             <a:extLst xmlns:a="http://schemas.openxmlformats.org/drawingml/2006/main">
               <a:ext uri="{FF2B5EF4-FFF2-40B4-BE49-F238E27FC236}">
-                <a16:creationId xmlns:a16="http://schemas.microsoft.com/office/drawing/2014/main" id="{6FE9D5EA-1DF4-435F-8ECB-757E16333E27}"/>
+                <a16:creationId xmlns:a16="http://schemas.microsoft.com/office/drawing/2014/main" id="{6637023A-B417-4A8D-98FF-165F80707F68}"/>
               </a:ext>
             </a:extLst>
           </p:cNvPr>
@@ -20650,7 +20651,7 @@
                 <a:ea typeface="Aptos"/>
                 <a:cs typeface="Aptos"/>
               </a:rPr>
-              <a:t>Funding candidates and route review</a:t>
+              <a:t>Funding candidates and routes</a:t>
             </a:r>
           </a:p>
           <a:p xmlns:a="http://schemas.openxmlformats.org/drawingml/2006/main">
@@ -20675,6 +20676,30 @@
                 <a:cs typeface="Aptos"/>
               </a:rPr>
               <a:t>Portable skills</a:t>
+            </a:r>
+          </a:p>
+          <a:p xmlns:a="http://schemas.openxmlformats.org/drawingml/2006/main">
+            <a:pPr algn="l">
+              <a:buNone/>
+              <a:defRPr sz="2025" b="0">
+                <a:solidFill>
+                  <a:srgbClr val="132E38"/>
+                </a:solidFill>
+                <a:latin typeface="Aptos"/>
+                <a:ea typeface="Aptos"/>
+                <a:cs typeface="Aptos"/>
+              </a:defRPr>
+            </a:pPr>
+            <a:r>
+              <a:rPr sz="2025" b="0">
+                <a:solidFill>
+                  <a:srgbClr val="132E38"/>
+                </a:solidFill>
+                <a:latin typeface="Aptos"/>
+                <a:ea typeface="Aptos"/>
+                <a:cs typeface="Aptos"/>
+              </a:rPr>
+              <a:t>October discovery and scout</a:t>
             </a:r>
           </a:p>
         </p:txBody>
@@ -20768,7 +20793,7 @@
                 <a:ea typeface="Aptos"/>
                 <a:cs typeface="Aptos"/>
               </a:rPr>
-              <a:t>Saved partner preparation</a:t>
+              <a:t>Evidence and financial contracts</a:t>
             </a:r>
           </a:p>
           <a:p xmlns:a="http://schemas.openxmlformats.org/drawingml/2006/main">
@@ -20792,7 +20817,7 @@
                 <a:ea typeface="Aptos"/>
                 <a:cs typeface="Aptos"/>
               </a:rPr>
-              <a:t>Evidence and SQL reuse</a:t>
+              <a:t>Helix graph and research reuse</a:t>
             </a:r>
           </a:p>
           <a:p xmlns:a="http://schemas.openxmlformats.org/drawingml/2006/main">
@@ -20816,7 +20841,7 @@
                 <a:ea typeface="Aptos"/>
                 <a:cs typeface="Aptos"/>
               </a:rPr>
-              <a:t>Sanitized financial contract</a:t>
+              <a:t>Objective intake and briefs</a:t>
             </a:r>
           </a:p>
           <a:p xmlns:a="http://schemas.openxmlformats.org/drawingml/2006/main">
@@ -20840,7 +20865,7 @@
                 <a:ea typeface="Aptos"/>
                 <a:cs typeface="Aptos"/>
               </a:rPr>
-              <a:t>October discovery redesign</a:t>
+              <a:t>Cloud rehearsal tooling</a:t>
             </a:r>
           </a:p>
         </p:txBody>
@@ -20910,7 +20935,7 @@
                 <a:ea typeface="Aptos"/>
                 <a:cs typeface="Aptos"/>
               </a:rPr>
-              <a:t>Publish and qualify local changes</a:t>
+              <a:t>Trusted host and source wiring</a:t>
             </a:r>
           </a:p>
           <a:p xmlns:a="http://schemas.openxmlformats.org/drawingml/2006/main">
@@ -20934,7 +20959,7 @@
                 <a:ea typeface="Aptos"/>
                 <a:cs typeface="Aptos"/>
               </a:rPr>
-              <a:t>Fresh October scout</a:t>
+              <a:t>Operational discovery and alerts</a:t>
             </a:r>
           </a:p>
           <a:p xmlns:a="http://schemas.openxmlformats.org/drawingml/2006/main">
@@ -20958,7 +20983,7 @@
                 <a:ea typeface="Aptos"/>
                 <a:cs typeface="Aptos"/>
               </a:rPr>
-              <a:t>Helix graph and research writeback</a:t>
+              <a:t>Production PG and graph backfill</a:t>
             </a:r>
           </a:p>
           <a:p xmlns:a="http://schemas.openxmlformats.org/drawingml/2006/main">
@@ -21030,7 +21055,7 @@
                 <a:ea typeface="Aptos"/>
                 <a:cs typeface="Aptos"/>
               </a:rPr>
-              <a:t>Bounty intake and funding links</a:t>
+              <a:t>Live models and member enrollment</a:t>
             </a:r>
           </a:p>
           <a:p xmlns:a="http://schemas.openxmlformats.org/drawingml/2006/main">
@@ -21054,7 +21079,7 @@
                 <a:ea typeface="Aptos"/>
                 <a:cs typeface="Aptos"/>
               </a:rPr>
-              <a:t>Live tools, member agents and Y2</a:t>
+              <a:t>Deployment and Y2 integration</a:t>
             </a:r>
           </a:p>
         </p:txBody>
@@ -21064,7 +21089,7 @@
           <p:cNvPr id="14" name="flow-222">
             <a:extLst xmlns:a="http://schemas.openxmlformats.org/drawingml/2006/main">
               <a:ext uri="{FF2B5EF4-FFF2-40B4-BE49-F238E27FC236}">
-                <a16:creationId xmlns:a16="http://schemas.microsoft.com/office/drawing/2014/main" id="{C3F90B23-18D6-4ABE-ADFE-F8107FC7C79E}"/>
+                <a16:creationId xmlns:a16="http://schemas.microsoft.com/office/drawing/2014/main" id="{4A45CBC6-953F-4B50-A26C-F0D8872A2F99}"/>
               </a:ext>
             </a:extLst>
           </p:cNvPr>

</xml_diff>

<commit_message>
docs: synchronize durable review completion and activation requirements
</commit_message>
<xml_diff>
--- a/Inertia-Architecture.pptx
+++ b/Inertia-Architecture.pptx
@@ -2,21 +2,21 @@
 <file path=ppt/presentation.xml><?xml version="1.0" encoding="utf-8"?>
 <p:presentation xmlns:p="http://schemas.openxmlformats.org/presentationml/2006/main">
   <p:sldMasterIdLst>
-    <p:sldMasterId xmlns:r="http://schemas.openxmlformats.org/officeDocument/2006/relationships" id="2147483648" r:id="R7b1feba4ebac42cb"/>
+    <p:sldMasterId xmlns:r="http://schemas.openxmlformats.org/officeDocument/2006/relationships" id="2147483648" r:id="Re67716fdfb124d9f"/>
   </p:sldMasterIdLst>
   <p:notesMasterIdLst>
-    <p:notesMasterId xmlns:r="http://schemas.openxmlformats.org/officeDocument/2006/relationships" r:id="R0af0acd9638049c7"/>
+    <p:notesMasterId xmlns:r="http://schemas.openxmlformats.org/officeDocument/2006/relationships" r:id="Rb0e20b83594f454a"/>
   </p:notesMasterIdLst>
   <p:sldIdLst>
-    <p:sldId xmlns:r="http://schemas.openxmlformats.org/officeDocument/2006/relationships" id="256" r:id="R13a96eea91d94d13"/>
-    <p:sldId xmlns:r="http://schemas.openxmlformats.org/officeDocument/2006/relationships" id="257" r:id="R79cdbf9129b141da"/>
-    <p:sldId xmlns:r="http://schemas.openxmlformats.org/officeDocument/2006/relationships" id="258" r:id="R0562286197ca4413"/>
-    <p:sldId xmlns:r="http://schemas.openxmlformats.org/officeDocument/2006/relationships" id="259" r:id="R18506465cf3d46fc"/>
-    <p:sldId xmlns:r="http://schemas.openxmlformats.org/officeDocument/2006/relationships" id="260" r:id="R6636fe5d18c847ab"/>
-    <p:sldId xmlns:r="http://schemas.openxmlformats.org/officeDocument/2006/relationships" id="261" r:id="Rb5b967b1d91b4e79"/>
-    <p:sldId xmlns:r="http://schemas.openxmlformats.org/officeDocument/2006/relationships" id="262" r:id="R0ada181589494b2a"/>
-    <p:sldId xmlns:r="http://schemas.openxmlformats.org/officeDocument/2006/relationships" id="263" r:id="Ra4be38fd0b524b61"/>
-    <p:sldId xmlns:r="http://schemas.openxmlformats.org/officeDocument/2006/relationships" id="264" r:id="Rc62e5fd86aa44a33"/>
+    <p:sldId xmlns:r="http://schemas.openxmlformats.org/officeDocument/2006/relationships" id="256" r:id="R03eae314aa414ed0"/>
+    <p:sldId xmlns:r="http://schemas.openxmlformats.org/officeDocument/2006/relationships" id="257" r:id="R676bf51815974a42"/>
+    <p:sldId xmlns:r="http://schemas.openxmlformats.org/officeDocument/2006/relationships" id="258" r:id="Re773d7e86bd74a4d"/>
+    <p:sldId xmlns:r="http://schemas.openxmlformats.org/officeDocument/2006/relationships" id="259" r:id="R9f0b67c8f5ea44e0"/>
+    <p:sldId xmlns:r="http://schemas.openxmlformats.org/officeDocument/2006/relationships" id="260" r:id="Rd220d56f4e4d4fdc"/>
+    <p:sldId xmlns:r="http://schemas.openxmlformats.org/officeDocument/2006/relationships" id="261" r:id="Rc6f1a977eefc4f00"/>
+    <p:sldId xmlns:r="http://schemas.openxmlformats.org/officeDocument/2006/relationships" id="262" r:id="R936733b4d6944b04"/>
+    <p:sldId xmlns:r="http://schemas.openxmlformats.org/officeDocument/2006/relationships" id="263" r:id="Rd103217cf543416a"/>
+    <p:sldId xmlns:r="http://schemas.openxmlformats.org/officeDocument/2006/relationships" id="264" r:id="R114e4421ef5c4ec8"/>
   </p:sldIdLst>
   <p:sldSz cx="15240000" cy="8572500"/>
   <p:notesSz cx="6858000" cy="9144000"/>
@@ -720,7 +720,7 @@
           <a:lstStyle xmlns:a="http://schemas.openxmlformats.org/drawingml/2006/main"/>
           <a:p xmlns:a="http://schemas.openxmlformats.org/drawingml/2006/main">
             <a:r>
-              <a:t>Sources: Inertia spec.md R-G01–R-G04 and R-F01–R-F08; docs/development/funding-enhancement/spec.md; docs/development/native-grant-workflow.md.</a:t>
+              <a:t>Sources: Inertia spec.md R-G01–R-G04 and R-F01–R-F08; docs/development/funding-enhancement/spec.md; docs/development/native-grant-workflow.md; host-composition/paperclip-durable-funding-review/ACTIVATION-CONTRACT.md.</a:t>
             </a:r>
           </a:p>
           <a:p xmlns:a="http://schemas.openxmlformats.org/drawingml/2006/main">
@@ -750,7 +750,7 @@
           </a:p>
           <a:p xmlns:a="http://schemas.openxmlformats.org/drawingml/2006/main">
             <a:r>
-              <a:t>The merged native adapter remains disabled. The approved model records durable authority for an exact version at human acceptance, so disconnect alone leaves that approval valid. Activation requires implemented acceptance receipts, funding-service-confirmed cancellation and rejection of changed funding evidence. Grant submission and live final-vote verification retain their separate authority steps.</a:t>
+              <a:t>Durable capture and the funding service implement exact-version authority accepted with the human verdict. Approval survives disconnect and later native changes. DFW confirms cancellation and rejects stale funding evidence. Production activation needs authenticated transport, receipt retention/archival, scoped roles/source access, qualified writer fencing and a real correction/cancel walkthrough. Grant submission and final-vote verification retain their separate authority steps.</a:t>
             </a:r>
           </a:p>
         </p:txBody>
@@ -1220,7 +1220,7 @@
           <a:lstStyle xmlns:a="http://schemas.openxmlformats.org/drawingml/2006/main"/>
           <a:p xmlns:a="http://schemas.openxmlformats.org/drawingml/2006/main">
             <a:r>
-              <a:t>Sources: Inertia spec.md, plan.md and testing.md; docs/development/funding-enhancement/discovery-loop.md; docs/development/objective-intake.md; scripts/cloud-rehearsal/README.md; https://github.com/NetRxn/Inertia/pull/25; https://github.com/NetRxn/Inertia/pull/26; https://github.com/NetRxn/Inertia/pull/27; https://github.com/NetRxn/Inertia/pull/28; https://github.com/NetRxn/DFW-Gov-Fund/pull/44; https://github.com/NetRxn/DFW-Gov-Fund/pull/45; https://github.com/NetRxn/DFW-Gov-Fund/pull/46; https://github.com/NetRxn/DFW-Gov-Fund/pull/47. Status: 24 October 2026.</a:t>
+              <a:t>Sources: Inertia spec.md, plan.md and testing.md; docs/development/funding-enhancement/discovery-loop.md; docs/development/objective-intake.md; scripts/cloud-rehearsal/README.md; https://github.com/NetRxn/Inertia/pull/25; https://github.com/NetRxn/Inertia/pull/26; https://github.com/NetRxn/Inertia/pull/27; https://github.com/NetRxn/Inertia/pull/28; https://github.com/NetRxn/DFW-Gov-Fund/pull/44; https://github.com/NetRxn/DFW-Gov-Fund/pull/45; https://github.com/NetRxn/DFW-Gov-Fund/pull/46; https://github.com/NetRxn/DFW-Gov-Fund/pull/47; https://github.com/NetRxn/DFW-Gov-Fund/pull/49; https://github.com/NetRxn/DFW-Gov-Fund/pull/50; host-composition/paperclip-durable-funding-review/ACTIVATION-CONTRACT.md. Status: 24 October 2026.</a:t>
             </a:r>
           </a:p>
           <a:p xmlns:a="http://schemas.openxmlformats.org/drawingml/2006/main">
@@ -1250,7 +1250,7 @@
           </a:p>
           <a:p xmlns:a="http://schemas.openxmlformats.org/drawingml/2006/main">
             <a:r>
-              <a:t>The native adapter is merged and disabled; the reviewed funding transaction service is in CI. The approved exact-version authority-at-acceptance model requires implementation and production writer-fence integration before activation. Live final-vote verification retains its separate gate.</a:t>
+              <a:t>Durable human acceptance and funding-service cancellation are implemented and independently qualified in isolated rehearsal. Real native PostgreSQL capture and DFW PostgreSQL behavior passed separately. Cross-service rehearsals used actual native transactions, synthetic file transport and DFW SQLite. Production transport, retention/archival, scoped permissions/source access and the human walkthrough remain activation gates. The composition stays disabled until those gates pass. Live final-vote verification retains its separate gate.</a:t>
             </a:r>
           </a:p>
           <a:p xmlns:a="http://schemas.openxmlformats.org/drawingml/2006/main">
@@ -3083,12 +3083,12 @@
   </p:cSld>
   <p:clrMap bg1="lt1" tx1="dk1" bg2="lt2" tx2="dk2" accent1="accent1" accent2="accent2" accent3="accent3" accent4="accent4" accent5="accent5" accent6="accent6" hlink="hlink" folHlink="folHlink"/>
   <p:sldLayoutIdLst>
-    <p:sldLayoutId xmlns:r="http://schemas.openxmlformats.org/officeDocument/2006/relationships" id="2147483649" r:id="R36c050df87df4dfb"/>
-    <p:sldLayoutId xmlns:r="http://schemas.openxmlformats.org/officeDocument/2006/relationships" id="2147483650" r:id="R4826580c941b4dfb"/>
-    <p:sldLayoutId xmlns:r="http://schemas.openxmlformats.org/officeDocument/2006/relationships" id="2147483651" r:id="R1ef15abf51b948a7"/>
-    <p:sldLayoutId xmlns:r="http://schemas.openxmlformats.org/officeDocument/2006/relationships" id="2147483652" r:id="R13a461ceefae4590"/>
-    <p:sldLayoutId xmlns:r="http://schemas.openxmlformats.org/officeDocument/2006/relationships" id="2147483653" r:id="R72511b6ee2d846d2"/>
-    <p:sldLayoutId xmlns:r="http://schemas.openxmlformats.org/officeDocument/2006/relationships" id="2147483654" r:id="R79585679f8734e86"/>
+    <p:sldLayoutId xmlns:r="http://schemas.openxmlformats.org/officeDocument/2006/relationships" id="2147483649" r:id="R20b38ba70eb342b3"/>
+    <p:sldLayoutId xmlns:r="http://schemas.openxmlformats.org/officeDocument/2006/relationships" id="2147483650" r:id="Rd11476e6f4db4f52"/>
+    <p:sldLayoutId xmlns:r="http://schemas.openxmlformats.org/officeDocument/2006/relationships" id="2147483651" r:id="R5af7774cad524477"/>
+    <p:sldLayoutId xmlns:r="http://schemas.openxmlformats.org/officeDocument/2006/relationships" id="2147483652" r:id="Rd9c9b7a06dc94447"/>
+    <p:sldLayoutId xmlns:r="http://schemas.openxmlformats.org/officeDocument/2006/relationships" id="2147483653" r:id="Rf4e31d95c4da4466"/>
+    <p:sldLayoutId xmlns:r="http://schemas.openxmlformats.org/officeDocument/2006/relationships" id="2147483654" r:id="R91de7841eb0a44ac"/>
   </p:sldLayoutIdLst>
   <p:txStyles>
     <p:titleStyle>
@@ -3639,7 +3639,7 @@
           <p:cNvPr id="39" name="">
             <a:extLst xmlns:a="http://schemas.openxmlformats.org/drawingml/2006/main">
               <a:ext uri="{FF2B5EF4-FFF2-40B4-BE49-F238E27FC236}">
-                <a16:creationId xmlns:a16="http://schemas.microsoft.com/office/drawing/2014/main" id="{D412FE0C-6DAC-45C6-B0D0-763C63607A56}"/>
+                <a16:creationId xmlns:a16="http://schemas.microsoft.com/office/drawing/2014/main" id="{C3120CBA-2826-44C8-94CB-F07348FEA7CB}"/>
               </a:ext>
             </a:extLst>
           </p:cNvPr>
@@ -3672,7 +3672,7 @@
           <p:cNvPr id="32" name="">
             <a:extLst xmlns:a="http://schemas.openxmlformats.org/drawingml/2006/main">
               <a:ext uri="{FF2B5EF4-FFF2-40B4-BE49-F238E27FC236}">
-                <a16:creationId xmlns:a16="http://schemas.microsoft.com/office/drawing/2014/main" id="{C7A66388-0418-4A12-AB11-536B1935AB16}"/>
+                <a16:creationId xmlns:a16="http://schemas.microsoft.com/office/drawing/2014/main" id="{A6DE5ED5-9A3C-4374-86AD-43A47E7004C6}"/>
               </a:ext>
             </a:extLst>
           </p:cNvPr>
@@ -3704,7 +3704,7 @@
           <p:cNvPr id="29" name="">
             <a:extLst xmlns:a="http://schemas.openxmlformats.org/drawingml/2006/main">
               <a:ext uri="{FF2B5EF4-FFF2-40B4-BE49-F238E27FC236}">
-                <a16:creationId xmlns:a16="http://schemas.microsoft.com/office/drawing/2014/main" id="{793CDB02-24F2-4EA8-A861-9337AB15E01C}"/>
+                <a16:creationId xmlns:a16="http://schemas.microsoft.com/office/drawing/2014/main" id="{01B70731-45E5-470D-B4BB-F16F8402D9E0}"/>
               </a:ext>
             </a:extLst>
           </p:cNvPr>
@@ -5497,7 +5497,7 @@
           <p:cNvPr id="30" name="flow-29">
             <a:extLst xmlns:a="http://schemas.openxmlformats.org/drawingml/2006/main">
               <a:ext uri="{FF2B5EF4-FFF2-40B4-BE49-F238E27FC236}">
-                <a16:creationId xmlns:a16="http://schemas.microsoft.com/office/drawing/2014/main" id="{116D73A4-DE0C-4746-865A-5A0861F91418}"/>
+                <a16:creationId xmlns:a16="http://schemas.microsoft.com/office/drawing/2014/main" id="{8C091B80-C622-42DA-A009-93FF036A1267}"/>
               </a:ext>
             </a:extLst>
           </p:cNvPr>
@@ -5527,7 +5527,7 @@
           <p:cNvPr id="31" name="flow-30">
             <a:extLst xmlns:a="http://schemas.openxmlformats.org/drawingml/2006/main">
               <a:ext uri="{FF2B5EF4-FFF2-40B4-BE49-F238E27FC236}">
-                <a16:creationId xmlns:a16="http://schemas.microsoft.com/office/drawing/2014/main" id="{3731771A-875E-48B2-92BE-DF2D6BA903C8}"/>
+                <a16:creationId xmlns:a16="http://schemas.microsoft.com/office/drawing/2014/main" id="{9054FC2C-0002-4E13-A51A-7222044C9807}"/>
               </a:ext>
             </a:extLst>
           </p:cNvPr>
@@ -5627,7 +5627,7 @@
           <p:cNvPr id="34" name="flow-32">
             <a:extLst xmlns:a="http://schemas.openxmlformats.org/drawingml/2006/main">
               <a:ext uri="{FF2B5EF4-FFF2-40B4-BE49-F238E27FC236}">
-                <a16:creationId xmlns:a16="http://schemas.microsoft.com/office/drawing/2014/main" id="{FF943156-514E-4F21-943D-31A37277F58A}"/>
+                <a16:creationId xmlns:a16="http://schemas.microsoft.com/office/drawing/2014/main" id="{F42CA512-4975-4C1A-B259-B46282BE7931}"/>
               </a:ext>
             </a:extLst>
           </p:cNvPr>
@@ -5656,7 +5656,7 @@
           <p:cNvPr id="35" name="flow-33">
             <a:extLst xmlns:a="http://schemas.openxmlformats.org/drawingml/2006/main">
               <a:ext uri="{FF2B5EF4-FFF2-40B4-BE49-F238E27FC236}">
-                <a16:creationId xmlns:a16="http://schemas.microsoft.com/office/drawing/2014/main" id="{7E0A8387-7E26-400F-BFD0-C0A25DBD9924}"/>
+                <a16:creationId xmlns:a16="http://schemas.microsoft.com/office/drawing/2014/main" id="{3E3CF51B-F479-43FF-8544-3E0DE3B5B813}"/>
               </a:ext>
             </a:extLst>
           </p:cNvPr>
@@ -5684,7 +5684,7 @@
           <p:cNvPr id="36" name="flow-34">
             <a:extLst xmlns:a="http://schemas.openxmlformats.org/drawingml/2006/main">
               <a:ext uri="{FF2B5EF4-FFF2-40B4-BE49-F238E27FC236}">
-                <a16:creationId xmlns:a16="http://schemas.microsoft.com/office/drawing/2014/main" id="{573B7FFE-DD48-4608-B172-19C12DC02C38}"/>
+                <a16:creationId xmlns:a16="http://schemas.microsoft.com/office/drawing/2014/main" id="{17507772-98B2-4512-B4A7-E4A0D3371618}"/>
               </a:ext>
             </a:extLst>
           </p:cNvPr>
@@ -5783,7 +5783,7 @@
           <p:cNvPr id="38" name="flow-36">
             <a:extLst xmlns:a="http://schemas.openxmlformats.org/drawingml/2006/main">
               <a:ext uri="{FF2B5EF4-FFF2-40B4-BE49-F238E27FC236}">
-                <a16:creationId xmlns:a16="http://schemas.microsoft.com/office/drawing/2014/main" id="{BD9D8EE3-DFBC-4002-ABEE-92865AC73C45}"/>
+                <a16:creationId xmlns:a16="http://schemas.microsoft.com/office/drawing/2014/main" id="{FC620AFA-6BA6-43F0-91CD-C3EA0574AE65}"/>
               </a:ext>
             </a:extLst>
           </p:cNvPr>
@@ -5912,7 +5912,7 @@
           <p:cNvPr id="35" name="">
             <a:extLst xmlns:a="http://schemas.openxmlformats.org/drawingml/2006/main">
               <a:ext uri="{FF2B5EF4-FFF2-40B4-BE49-F238E27FC236}">
-                <a16:creationId xmlns:a16="http://schemas.microsoft.com/office/drawing/2014/main" id="{822164ED-A4E6-40BD-8309-9D150FF51E10}"/>
+                <a16:creationId xmlns:a16="http://schemas.microsoft.com/office/drawing/2014/main" id="{D4F599FF-97B5-43B6-8F99-180E2FC82611}"/>
               </a:ext>
             </a:extLst>
           </p:cNvPr>
@@ -5944,7 +5944,7 @@
           <p:cNvPr id="21" name="">
             <a:extLst xmlns:a="http://schemas.openxmlformats.org/drawingml/2006/main">
               <a:ext uri="{FF2B5EF4-FFF2-40B4-BE49-F238E27FC236}">
-                <a16:creationId xmlns:a16="http://schemas.microsoft.com/office/drawing/2014/main" id="{D6F5A60F-60D8-4C4B-810A-23C53C987B2E}"/>
+                <a16:creationId xmlns:a16="http://schemas.microsoft.com/office/drawing/2014/main" id="{3AB93786-CD66-4B1E-A32D-851B001657D5}"/>
               </a:ext>
             </a:extLst>
           </p:cNvPr>
@@ -5976,7 +5976,7 @@
           <p:cNvPr id="20" name="">
             <a:extLst xmlns:a="http://schemas.openxmlformats.org/drawingml/2006/main">
               <a:ext uri="{FF2B5EF4-FFF2-40B4-BE49-F238E27FC236}">
-                <a16:creationId xmlns:a16="http://schemas.microsoft.com/office/drawing/2014/main" id="{10466ABD-73A2-4146-BC7F-9539242ECCF7}"/>
+                <a16:creationId xmlns:a16="http://schemas.microsoft.com/office/drawing/2014/main" id="{EED3E3F1-CF60-4F28-BE2F-7B8037750AC2}"/>
               </a:ext>
             </a:extLst>
           </p:cNvPr>
@@ -6008,7 +6008,7 @@
           <p:cNvPr id="19" name="">
             <a:extLst xmlns:a="http://schemas.openxmlformats.org/drawingml/2006/main">
               <a:ext uri="{FF2B5EF4-FFF2-40B4-BE49-F238E27FC236}">
-                <a16:creationId xmlns:a16="http://schemas.microsoft.com/office/drawing/2014/main" id="{9900C5D9-787C-4CDD-B375-24D5E3656DDA}"/>
+                <a16:creationId xmlns:a16="http://schemas.microsoft.com/office/drawing/2014/main" id="{A5953D26-8AEE-4417-838F-CCAFCA89F157}"/>
               </a:ext>
             </a:extLst>
           </p:cNvPr>
@@ -6040,7 +6040,7 @@
           <p:cNvPr id="18" name="">
             <a:extLst xmlns:a="http://schemas.openxmlformats.org/drawingml/2006/main">
               <a:ext uri="{FF2B5EF4-FFF2-40B4-BE49-F238E27FC236}">
-                <a16:creationId xmlns:a16="http://schemas.microsoft.com/office/drawing/2014/main" id="{173E04A9-03BD-4611-B3D2-7A62AE51AFE4}"/>
+                <a16:creationId xmlns:a16="http://schemas.microsoft.com/office/drawing/2014/main" id="{68A424AA-DEEA-4C0D-9DD3-B8307F9A089B}"/>
               </a:ext>
             </a:extLst>
           </p:cNvPr>
@@ -7615,7 +7615,7 @@
           <p:cNvPr id="28" name="flow-61">
             <a:extLst xmlns:a="http://schemas.openxmlformats.org/drawingml/2006/main">
               <a:ext uri="{FF2B5EF4-FFF2-40B4-BE49-F238E27FC236}">
-                <a16:creationId xmlns:a16="http://schemas.microsoft.com/office/drawing/2014/main" id="{E567EE97-38F1-4317-9A67-B52EB3F8B70E}"/>
+                <a16:creationId xmlns:a16="http://schemas.microsoft.com/office/drawing/2014/main" id="{7E77EE6A-D4D8-40F7-A95F-1DC37AB7A59D}"/>
               </a:ext>
             </a:extLst>
           </p:cNvPr>
@@ -7714,7 +7714,7 @@
           <p:cNvPr id="30" name="flow-63">
             <a:extLst xmlns:a="http://schemas.openxmlformats.org/drawingml/2006/main">
               <a:ext uri="{FF2B5EF4-FFF2-40B4-BE49-F238E27FC236}">
-                <a16:creationId xmlns:a16="http://schemas.microsoft.com/office/drawing/2014/main" id="{FDB526CF-4730-4F7E-ACDD-55EBE7014C5B}"/>
+                <a16:creationId xmlns:a16="http://schemas.microsoft.com/office/drawing/2014/main" id="{52FDB377-D333-44DF-A914-1CFE5000735D}"/>
               </a:ext>
             </a:extLst>
           </p:cNvPr>
@@ -7742,7 +7742,7 @@
           <p:cNvPr id="31" name="flow-64">
             <a:extLst xmlns:a="http://schemas.openxmlformats.org/drawingml/2006/main">
               <a:ext uri="{FF2B5EF4-FFF2-40B4-BE49-F238E27FC236}">
-                <a16:creationId xmlns:a16="http://schemas.microsoft.com/office/drawing/2014/main" id="{437323D9-BDDE-49FD-B876-B365128356E5}"/>
+                <a16:creationId xmlns:a16="http://schemas.microsoft.com/office/drawing/2014/main" id="{42DCDD48-F720-41BE-8CA4-47E67C4031C2}"/>
               </a:ext>
             </a:extLst>
           </p:cNvPr>
@@ -7770,7 +7770,7 @@
           <p:cNvPr id="32" name="flow-65">
             <a:extLst xmlns:a="http://schemas.openxmlformats.org/drawingml/2006/main">
               <a:ext uri="{FF2B5EF4-FFF2-40B4-BE49-F238E27FC236}">
-                <a16:creationId xmlns:a16="http://schemas.microsoft.com/office/drawing/2014/main" id="{92FC9F92-495A-4D8E-98E4-8609C71708BE}"/>
+                <a16:creationId xmlns:a16="http://schemas.microsoft.com/office/drawing/2014/main" id="{FC0B672E-8C0B-463B-84AC-547B4A21A1F1}"/>
               </a:ext>
             </a:extLst>
           </p:cNvPr>
@@ -7798,7 +7798,7 @@
           <p:cNvPr id="33" name="flow-66">
             <a:extLst xmlns:a="http://schemas.openxmlformats.org/drawingml/2006/main">
               <a:ext uri="{FF2B5EF4-FFF2-40B4-BE49-F238E27FC236}">
-                <a16:creationId xmlns:a16="http://schemas.microsoft.com/office/drawing/2014/main" id="{27E92EDE-C8F0-4BA6-A8FD-FB94225210FB}"/>
+                <a16:creationId xmlns:a16="http://schemas.microsoft.com/office/drawing/2014/main" id="{B640F174-F1E0-497D-9292-886BDA9A4790}"/>
               </a:ext>
             </a:extLst>
           </p:cNvPr>
@@ -8066,7 +8066,7 @@
           <p:cNvPr id="18" name="">
             <a:extLst xmlns:a="http://schemas.openxmlformats.org/drawingml/2006/main">
               <a:ext uri="{FF2B5EF4-FFF2-40B4-BE49-F238E27FC236}">
-                <a16:creationId xmlns:a16="http://schemas.microsoft.com/office/drawing/2014/main" id="{DECA0952-A5AE-4EF1-BC35-188518497DDE}"/>
+                <a16:creationId xmlns:a16="http://schemas.microsoft.com/office/drawing/2014/main" id="{317B2169-A795-454D-A65B-7120C58EE562}"/>
               </a:ext>
             </a:extLst>
           </p:cNvPr>
@@ -9269,7 +9269,7 @@
           <p:cNvPr id="20" name="flow-88">
             <a:extLst xmlns:a="http://schemas.openxmlformats.org/drawingml/2006/main">
               <a:ext uri="{FF2B5EF4-FFF2-40B4-BE49-F238E27FC236}">
-                <a16:creationId xmlns:a16="http://schemas.microsoft.com/office/drawing/2014/main" id="{9BADED30-1D23-447C-9A14-4A0047A4507E}"/>
+                <a16:creationId xmlns:a16="http://schemas.microsoft.com/office/drawing/2014/main" id="{7D9B7B94-4EBB-4DF0-85DD-066C6DE5CD32}"/>
               </a:ext>
             </a:extLst>
           </p:cNvPr>
@@ -9297,7 +9297,7 @@
           <p:cNvPr id="21" name="flow-89">
             <a:extLst xmlns:a="http://schemas.openxmlformats.org/drawingml/2006/main">
               <a:ext uri="{FF2B5EF4-FFF2-40B4-BE49-F238E27FC236}">
-                <a16:creationId xmlns:a16="http://schemas.microsoft.com/office/drawing/2014/main" id="{17F6B08D-AB40-4300-88BA-A58AB8F7B8A7}"/>
+                <a16:creationId xmlns:a16="http://schemas.microsoft.com/office/drawing/2014/main" id="{B9C2B235-21EC-4B3A-8BEC-3075251078FD}"/>
               </a:ext>
             </a:extLst>
           </p:cNvPr>
@@ -9325,7 +9325,7 @@
           <p:cNvPr id="22" name="flow-90">
             <a:extLst xmlns:a="http://schemas.openxmlformats.org/drawingml/2006/main">
               <a:ext uri="{FF2B5EF4-FFF2-40B4-BE49-F238E27FC236}">
-                <a16:creationId xmlns:a16="http://schemas.microsoft.com/office/drawing/2014/main" id="{1A4C0FAB-1733-45A1-B19E-E20BC73A8DA4}"/>
+                <a16:creationId xmlns:a16="http://schemas.microsoft.com/office/drawing/2014/main" id="{1B55A4BE-0C7C-4C4D-88A0-6E5F6208D871}"/>
               </a:ext>
             </a:extLst>
           </p:cNvPr>
@@ -9448,7 +9448,7 @@
           <p:cNvPr id="24" name="flow-92">
             <a:extLst xmlns:a="http://schemas.openxmlformats.org/drawingml/2006/main">
               <a:ext uri="{FF2B5EF4-FFF2-40B4-BE49-F238E27FC236}">
-                <a16:creationId xmlns:a16="http://schemas.microsoft.com/office/drawing/2014/main" id="{353F0194-201E-4415-B09A-B947DD491531}"/>
+                <a16:creationId xmlns:a16="http://schemas.microsoft.com/office/drawing/2014/main" id="{A7E9E000-2FBE-4EC2-BE5E-8CA255134ECA}"/>
               </a:ext>
             </a:extLst>
           </p:cNvPr>
@@ -9476,7 +9476,7 @@
           <p:cNvPr id="25" name="flow-93">
             <a:extLst xmlns:a="http://schemas.openxmlformats.org/drawingml/2006/main">
               <a:ext uri="{FF2B5EF4-FFF2-40B4-BE49-F238E27FC236}">
-                <a16:creationId xmlns:a16="http://schemas.microsoft.com/office/drawing/2014/main" id="{4D0DDC02-9908-4199-BEB1-12E90958EA04}"/>
+                <a16:creationId xmlns:a16="http://schemas.microsoft.com/office/drawing/2014/main" id="{B6651FB7-F8F9-4373-9196-184B622A2782}"/>
               </a:ext>
             </a:extLst>
           </p:cNvPr>
@@ -9504,7 +9504,7 @@
           <p:cNvPr id="26" name="flow-94">
             <a:extLst xmlns:a="http://schemas.openxmlformats.org/drawingml/2006/main">
               <a:ext uri="{FF2B5EF4-FFF2-40B4-BE49-F238E27FC236}">
-                <a16:creationId xmlns:a16="http://schemas.microsoft.com/office/drawing/2014/main" id="{BBB48D46-F608-4E32-B988-9555A3F71873}"/>
+                <a16:creationId xmlns:a16="http://schemas.microsoft.com/office/drawing/2014/main" id="{743C0879-2E0E-42EC-902E-E9E36EB928B3}"/>
               </a:ext>
             </a:extLst>
           </p:cNvPr>
@@ -9627,7 +9627,7 @@
           <p:cNvPr id="28" name="flow-96">
             <a:extLst xmlns:a="http://schemas.openxmlformats.org/drawingml/2006/main">
               <a:ext uri="{FF2B5EF4-FFF2-40B4-BE49-F238E27FC236}">
-                <a16:creationId xmlns:a16="http://schemas.microsoft.com/office/drawing/2014/main" id="{608359F2-D64F-4389-A83B-0BCF4A5ED334}"/>
+                <a16:creationId xmlns:a16="http://schemas.microsoft.com/office/drawing/2014/main" id="{507793A7-002C-4DD6-B579-DDBBCD316DDF}"/>
               </a:ext>
             </a:extLst>
           </p:cNvPr>
@@ -9655,7 +9655,7 @@
           <p:cNvPr id="29" name="flow-97">
             <a:extLst xmlns:a="http://schemas.openxmlformats.org/drawingml/2006/main">
               <a:ext uri="{FF2B5EF4-FFF2-40B4-BE49-F238E27FC236}">
-                <a16:creationId xmlns:a16="http://schemas.microsoft.com/office/drawing/2014/main" id="{286DFED1-7A34-4E76-A237-DE581A3B9BB5}"/>
+                <a16:creationId xmlns:a16="http://schemas.microsoft.com/office/drawing/2014/main" id="{D7F4B9D6-8C49-4324-B5C3-735A4C88913C}"/>
               </a:ext>
             </a:extLst>
           </p:cNvPr>
@@ -10041,7 +10041,7 @@
           <p:cNvPr id="35" name="">
             <a:extLst xmlns:a="http://schemas.openxmlformats.org/drawingml/2006/main">
               <a:ext uri="{FF2B5EF4-FFF2-40B4-BE49-F238E27FC236}">
-                <a16:creationId xmlns:a16="http://schemas.microsoft.com/office/drawing/2014/main" id="{6753F9C8-ABA5-4BDB-8451-0AA031A374BF}"/>
+                <a16:creationId xmlns:a16="http://schemas.microsoft.com/office/drawing/2014/main" id="{3D1A79F3-E5EF-471C-8386-0A47F0BBCBA8}"/>
               </a:ext>
             </a:extLst>
           </p:cNvPr>
@@ -10073,7 +10073,7 @@
           <p:cNvPr id="34" name="">
             <a:extLst xmlns:a="http://schemas.openxmlformats.org/drawingml/2006/main">
               <a:ext uri="{FF2B5EF4-FFF2-40B4-BE49-F238E27FC236}">
-                <a16:creationId xmlns:a16="http://schemas.microsoft.com/office/drawing/2014/main" id="{A8520DE8-0FEE-4F46-975D-A25F3FBAB3A1}"/>
+                <a16:creationId xmlns:a16="http://schemas.microsoft.com/office/drawing/2014/main" id="{81BBABB7-3B1E-49A6-AAF3-2B11F74EB344}"/>
               </a:ext>
             </a:extLst>
           </p:cNvPr>
@@ -10105,7 +10105,7 @@
           <p:cNvPr id="33" name="">
             <a:extLst xmlns:a="http://schemas.openxmlformats.org/drawingml/2006/main">
               <a:ext uri="{FF2B5EF4-FFF2-40B4-BE49-F238E27FC236}">
-                <a16:creationId xmlns:a16="http://schemas.microsoft.com/office/drawing/2014/main" id="{8A0B3494-667D-4A5E-BB7E-8F1CEE1290E5}"/>
+                <a16:creationId xmlns:a16="http://schemas.microsoft.com/office/drawing/2014/main" id="{7427B4A4-47C9-42B7-9B79-6271F3458A25}"/>
               </a:ext>
             </a:extLst>
           </p:cNvPr>
@@ -10137,7 +10137,7 @@
           <p:cNvPr id="13" name="">
             <a:extLst xmlns:a="http://schemas.openxmlformats.org/drawingml/2006/main">
               <a:ext uri="{FF2B5EF4-FFF2-40B4-BE49-F238E27FC236}">
-                <a16:creationId xmlns:a16="http://schemas.microsoft.com/office/drawing/2014/main" id="{734540C0-A867-4344-AD26-ADA92C7351DB}"/>
+                <a16:creationId xmlns:a16="http://schemas.microsoft.com/office/drawing/2014/main" id="{ABCFD886-BD86-4E86-8609-8A068D05BDB0}"/>
               </a:ext>
             </a:extLst>
           </p:cNvPr>
@@ -10169,7 +10169,7 @@
           <p:cNvPr id="12" name="">
             <a:extLst xmlns:a="http://schemas.openxmlformats.org/drawingml/2006/main">
               <a:ext uri="{FF2B5EF4-FFF2-40B4-BE49-F238E27FC236}">
-                <a16:creationId xmlns:a16="http://schemas.microsoft.com/office/drawing/2014/main" id="{0271DA71-397E-4917-84A5-B7F45DCE205E}"/>
+                <a16:creationId xmlns:a16="http://schemas.microsoft.com/office/drawing/2014/main" id="{8ACDD802-0FEA-4DEA-89E9-4BA6734ABAAA}"/>
               </a:ext>
             </a:extLst>
           </p:cNvPr>
@@ -10956,7 +10956,7 @@
           <p:cNvPr id="14" name="flow-113">
             <a:extLst xmlns:a="http://schemas.openxmlformats.org/drawingml/2006/main">
               <a:ext uri="{FF2B5EF4-FFF2-40B4-BE49-F238E27FC236}">
-                <a16:creationId xmlns:a16="http://schemas.microsoft.com/office/drawing/2014/main" id="{6F8A72F4-BEE7-4011-9708-227AE07F042B}"/>
+                <a16:creationId xmlns:a16="http://schemas.microsoft.com/office/drawing/2014/main" id="{46BF9B33-9CCB-49BB-9D7C-871116C5E191}"/>
               </a:ext>
             </a:extLst>
           </p:cNvPr>
@@ -10984,7 +10984,7 @@
           <p:cNvPr id="15" name="flow-114">
             <a:extLst xmlns:a="http://schemas.openxmlformats.org/drawingml/2006/main">
               <a:ext uri="{FF2B5EF4-FFF2-40B4-BE49-F238E27FC236}">
-                <a16:creationId xmlns:a16="http://schemas.microsoft.com/office/drawing/2014/main" id="{B5616EFD-998E-498A-BF67-6D075C725D74}"/>
+                <a16:creationId xmlns:a16="http://schemas.microsoft.com/office/drawing/2014/main" id="{E47135E9-968E-44B3-9C3F-4F0333EB123D}"/>
               </a:ext>
             </a:extLst>
           </p:cNvPr>
@@ -11012,7 +11012,7 @@
           <p:cNvPr id="16" name="flow-115">
             <a:extLst xmlns:a="http://schemas.openxmlformats.org/drawingml/2006/main">
               <a:ext uri="{FF2B5EF4-FFF2-40B4-BE49-F238E27FC236}">
-                <a16:creationId xmlns:a16="http://schemas.microsoft.com/office/drawing/2014/main" id="{98188FFB-72F2-4E38-8187-7EE474F358D1}"/>
+                <a16:creationId xmlns:a16="http://schemas.microsoft.com/office/drawing/2014/main" id="{5314AF79-BAEF-4D59-82B7-ECEAA3EDADD6}"/>
               </a:ext>
             </a:extLst>
           </p:cNvPr>
@@ -11040,7 +11040,7 @@
           <p:cNvPr id="17" name="flow-116">
             <a:extLst xmlns:a="http://schemas.openxmlformats.org/drawingml/2006/main">
               <a:ext uri="{FF2B5EF4-FFF2-40B4-BE49-F238E27FC236}">
-                <a16:creationId xmlns:a16="http://schemas.microsoft.com/office/drawing/2014/main" id="{62A00B62-5A5D-4618-A879-B0B288AA08F8}"/>
+                <a16:creationId xmlns:a16="http://schemas.microsoft.com/office/drawing/2014/main" id="{8B112F7F-2A59-4D7C-B48F-8FE0200477BB}"/>
               </a:ext>
             </a:extLst>
           </p:cNvPr>
@@ -11927,7 +11927,7 @@
           <p:cNvPr id="31" name="flow-130">
             <a:extLst xmlns:a="http://schemas.openxmlformats.org/drawingml/2006/main">
               <a:ext uri="{FF2B5EF4-FFF2-40B4-BE49-F238E27FC236}">
-                <a16:creationId xmlns:a16="http://schemas.microsoft.com/office/drawing/2014/main" id="{4E4A780B-08C1-4041-B576-E66AFA728FFD}"/>
+                <a16:creationId xmlns:a16="http://schemas.microsoft.com/office/drawing/2014/main" id="{37AE7F39-04A1-44E8-A668-EFB1DA347DFE}"/>
               </a:ext>
             </a:extLst>
           </p:cNvPr>
@@ -12518,7 +12518,7 @@
           <p:cNvPr id="43" name="partner-flow-1">
             <a:extLst xmlns:a="http://schemas.openxmlformats.org/drawingml/2006/main">
               <a:ext uri="{FF2B5EF4-FFF2-40B4-BE49-F238E27FC236}">
-                <a16:creationId xmlns:a16="http://schemas.microsoft.com/office/drawing/2014/main" id="{6FEE8CDB-EF48-4810-85A4-F875D5170719}"/>
+                <a16:creationId xmlns:a16="http://schemas.microsoft.com/office/drawing/2014/main" id="{8C50AE15-C344-4114-8408-E3D463D49815}"/>
               </a:ext>
             </a:extLst>
           </p:cNvPr>
@@ -12546,7 +12546,7 @@
           <p:cNvPr id="44" name="partner-flow-2">
             <a:extLst xmlns:a="http://schemas.openxmlformats.org/drawingml/2006/main">
               <a:ext uri="{FF2B5EF4-FFF2-40B4-BE49-F238E27FC236}">
-                <a16:creationId xmlns:a16="http://schemas.microsoft.com/office/drawing/2014/main" id="{13B3A6DD-17DC-428E-8FED-0E69723DB0B1}"/>
+                <a16:creationId xmlns:a16="http://schemas.microsoft.com/office/drawing/2014/main" id="{F847D156-086C-4D76-BD6A-0D204D87C04C}"/>
               </a:ext>
             </a:extLst>
           </p:cNvPr>
@@ -12574,7 +12574,7 @@
           <p:cNvPr id="45" name="partner-flow-3">
             <a:extLst xmlns:a="http://schemas.openxmlformats.org/drawingml/2006/main">
               <a:ext uri="{FF2B5EF4-FFF2-40B4-BE49-F238E27FC236}">
-                <a16:creationId xmlns:a16="http://schemas.microsoft.com/office/drawing/2014/main" id="{0CA005FF-DD34-41CA-9592-F3CA1EEB98B7}"/>
+                <a16:creationId xmlns:a16="http://schemas.microsoft.com/office/drawing/2014/main" id="{3E2F194F-C69A-41A1-83DF-C3C6881A3D7E}"/>
               </a:ext>
             </a:extLst>
           </p:cNvPr>
@@ -12602,7 +12602,7 @@
           <p:cNvPr id="46" name="partner-flow-4">
             <a:extLst xmlns:a="http://schemas.openxmlformats.org/drawingml/2006/main">
               <a:ext uri="{FF2B5EF4-FFF2-40B4-BE49-F238E27FC236}">
-                <a16:creationId xmlns:a16="http://schemas.microsoft.com/office/drawing/2014/main" id="{A7B26F48-7BBB-4A2C-81F8-784473F4FF36}"/>
+                <a16:creationId xmlns:a16="http://schemas.microsoft.com/office/drawing/2014/main" id="{455FBE7F-8646-43FE-ABA5-462DDEEBEBF1}"/>
               </a:ext>
             </a:extLst>
           </p:cNvPr>
@@ -12660,7 +12660,7 @@
           <p:cNvPr id="25" name="">
             <a:extLst xmlns:a="http://schemas.openxmlformats.org/drawingml/2006/main">
               <a:ext uri="{FF2B5EF4-FFF2-40B4-BE49-F238E27FC236}">
-                <a16:creationId xmlns:a16="http://schemas.microsoft.com/office/drawing/2014/main" id="{CE648481-E213-4766-B725-664F04AE8B56}"/>
+                <a16:creationId xmlns:a16="http://schemas.microsoft.com/office/drawing/2014/main" id="{A1859A7E-8DE6-4351-A350-0C242B9D0073}"/>
               </a:ext>
             </a:extLst>
           </p:cNvPr>
@@ -12972,7 +12972,7 @@
           <p:cNvPr id="5" name="flow-142">
             <a:extLst xmlns:a="http://schemas.openxmlformats.org/drawingml/2006/main">
               <a:ext uri="{FF2B5EF4-FFF2-40B4-BE49-F238E27FC236}">
-                <a16:creationId xmlns:a16="http://schemas.microsoft.com/office/drawing/2014/main" id="{F77D2F70-7348-482F-82EA-24538E7012AA}"/>
+                <a16:creationId xmlns:a16="http://schemas.microsoft.com/office/drawing/2014/main" id="{D18FAB8B-9B1D-4CFC-B596-E9B959C813D2}"/>
               </a:ext>
             </a:extLst>
           </p:cNvPr>
@@ -13889,7 +13889,7 @@
           <p:cNvPr id="21" name="flow-158">
             <a:extLst xmlns:a="http://schemas.openxmlformats.org/drawingml/2006/main">
               <a:ext uri="{FF2B5EF4-FFF2-40B4-BE49-F238E27FC236}">
-                <a16:creationId xmlns:a16="http://schemas.microsoft.com/office/drawing/2014/main" id="{E8132D6A-DF5C-4820-9BD1-577386387945}"/>
+                <a16:creationId xmlns:a16="http://schemas.microsoft.com/office/drawing/2014/main" id="{66349483-5A50-40B0-B266-21302A63AFCB}"/>
               </a:ext>
             </a:extLst>
           </p:cNvPr>
@@ -14160,7 +14160,7 @@
           <p:cNvPr id="27" name="flow-163">
             <a:extLst xmlns:a="http://schemas.openxmlformats.org/drawingml/2006/main">
               <a:ext uri="{FF2B5EF4-FFF2-40B4-BE49-F238E27FC236}">
-                <a16:creationId xmlns:a16="http://schemas.microsoft.com/office/drawing/2014/main" id="{7DAC9C2F-F2BC-4466-9246-2038A6F8CA60}"/>
+                <a16:creationId xmlns:a16="http://schemas.microsoft.com/office/drawing/2014/main" id="{8C9A3D5C-7BE3-4AF8-9C40-FB51EDBAD22C}"/>
               </a:ext>
             </a:extLst>
           </p:cNvPr>
@@ -14188,7 +14188,7 @@
           <p:cNvPr id="28" name="flow-164">
             <a:extLst xmlns:a="http://schemas.openxmlformats.org/drawingml/2006/main">
               <a:ext uri="{FF2B5EF4-FFF2-40B4-BE49-F238E27FC236}">
-                <a16:creationId xmlns:a16="http://schemas.microsoft.com/office/drawing/2014/main" id="{63D8DB00-EDD4-4C04-AF3C-8B2376467571}"/>
+                <a16:creationId xmlns:a16="http://schemas.microsoft.com/office/drawing/2014/main" id="{41AC155E-C29D-4FBE-9125-71875122CF68}"/>
               </a:ext>
             </a:extLst>
           </p:cNvPr>
@@ -14216,7 +14216,7 @@
           <p:cNvPr id="29" name="flow-165">
             <a:extLst xmlns:a="http://schemas.openxmlformats.org/drawingml/2006/main">
               <a:ext uri="{FF2B5EF4-FFF2-40B4-BE49-F238E27FC236}">
-                <a16:creationId xmlns:a16="http://schemas.microsoft.com/office/drawing/2014/main" id="{7F810F66-A750-4E84-A297-124DE9FF9B95}"/>
+                <a16:creationId xmlns:a16="http://schemas.microsoft.com/office/drawing/2014/main" id="{46B354BC-263C-4A31-AB01-93B52D5100DC}"/>
               </a:ext>
             </a:extLst>
           </p:cNvPr>
@@ -14315,7 +14315,7 @@
           <p:cNvPr id="31" name="flow-167">
             <a:extLst xmlns:a="http://schemas.openxmlformats.org/drawingml/2006/main">
               <a:ext uri="{FF2B5EF4-FFF2-40B4-BE49-F238E27FC236}">
-                <a16:creationId xmlns:a16="http://schemas.microsoft.com/office/drawing/2014/main" id="{39173D0C-1C64-40F2-BCC9-0281AD3DF8BF}"/>
+                <a16:creationId xmlns:a16="http://schemas.microsoft.com/office/drawing/2014/main" id="{6E9984F7-475E-4988-8BD3-A0D2C5175F98}"/>
               </a:ext>
             </a:extLst>
           </p:cNvPr>
@@ -14414,7 +14414,7 @@
           <p:cNvPr id="33" name="flow-169">
             <a:extLst xmlns:a="http://schemas.openxmlformats.org/drawingml/2006/main">
               <a:ext uri="{FF2B5EF4-FFF2-40B4-BE49-F238E27FC236}">
-                <a16:creationId xmlns:a16="http://schemas.microsoft.com/office/drawing/2014/main" id="{D9240F99-73AB-449F-9BA9-95007E36EBC8}"/>
+                <a16:creationId xmlns:a16="http://schemas.microsoft.com/office/drawing/2014/main" id="{FF5185BC-DC54-4EE1-B87B-EC47F60BD949}"/>
               </a:ext>
             </a:extLst>
           </p:cNvPr>
@@ -14513,7 +14513,7 @@
           <p:cNvPr id="35" name="flow-171">
             <a:extLst xmlns:a="http://schemas.openxmlformats.org/drawingml/2006/main">
               <a:ext uri="{FF2B5EF4-FFF2-40B4-BE49-F238E27FC236}">
-                <a16:creationId xmlns:a16="http://schemas.microsoft.com/office/drawing/2014/main" id="{92399F74-D275-4F65-AF64-A9B84735129B}"/>
+                <a16:creationId xmlns:a16="http://schemas.microsoft.com/office/drawing/2014/main" id="{B64E98BC-F4C7-4173-9032-9C1E8C8381CC}"/>
               </a:ext>
             </a:extLst>
           </p:cNvPr>
@@ -14541,7 +14541,7 @@
           <p:cNvPr id="36" name="flow-172">
             <a:extLst xmlns:a="http://schemas.openxmlformats.org/drawingml/2006/main">
               <a:ext uri="{FF2B5EF4-FFF2-40B4-BE49-F238E27FC236}">
-                <a16:creationId xmlns:a16="http://schemas.microsoft.com/office/drawing/2014/main" id="{F0BA96DC-3A62-432E-A9B6-C98F9A217455}"/>
+                <a16:creationId xmlns:a16="http://schemas.microsoft.com/office/drawing/2014/main" id="{92BA4FDE-B06D-4423-8C76-41FB57E367FF}"/>
               </a:ext>
             </a:extLst>
           </p:cNvPr>
@@ -14569,7 +14569,7 @@
           <p:cNvPr id="37" name="flow-173">
             <a:extLst xmlns:a="http://schemas.openxmlformats.org/drawingml/2006/main">
               <a:ext uri="{FF2B5EF4-FFF2-40B4-BE49-F238E27FC236}">
-                <a16:creationId xmlns:a16="http://schemas.microsoft.com/office/drawing/2014/main" id="{BCFB4E87-782C-4E00-B162-0F824ABD4131}"/>
+                <a16:creationId xmlns:a16="http://schemas.microsoft.com/office/drawing/2014/main" id="{EB283368-94A3-45DC-B582-7DF3AEAEB353}"/>
               </a:ext>
             </a:extLst>
           </p:cNvPr>
@@ -14668,7 +14668,7 @@
           <p:cNvPr id="39" name="flow-175">
             <a:extLst xmlns:a="http://schemas.openxmlformats.org/drawingml/2006/main">
               <a:ext uri="{FF2B5EF4-FFF2-40B4-BE49-F238E27FC236}">
-                <a16:creationId xmlns:a16="http://schemas.microsoft.com/office/drawing/2014/main" id="{D679E7C8-0F3E-4417-8481-1E324B2D9A58}"/>
+                <a16:creationId xmlns:a16="http://schemas.microsoft.com/office/drawing/2014/main" id="{AE8BA6A1-1C3B-49E0-A662-A56C3AABA7F2}"/>
               </a:ext>
             </a:extLst>
           </p:cNvPr>
@@ -14696,7 +14696,7 @@
           <p:cNvPr id="40" name="flow-176">
             <a:extLst xmlns:a="http://schemas.openxmlformats.org/drawingml/2006/main">
               <a:ext uri="{FF2B5EF4-FFF2-40B4-BE49-F238E27FC236}">
-                <a16:creationId xmlns:a16="http://schemas.microsoft.com/office/drawing/2014/main" id="{62FD829B-4DB9-41CE-ABDD-308A873DFBF0}"/>
+                <a16:creationId xmlns:a16="http://schemas.microsoft.com/office/drawing/2014/main" id="{600CE152-AE3D-46D4-A504-B5F6D7534253}"/>
               </a:ext>
             </a:extLst>
           </p:cNvPr>
@@ -14724,7 +14724,7 @@
           <p:cNvPr id="41" name="flow-177">
             <a:extLst xmlns:a="http://schemas.openxmlformats.org/drawingml/2006/main">
               <a:ext uri="{FF2B5EF4-FFF2-40B4-BE49-F238E27FC236}">
-                <a16:creationId xmlns:a16="http://schemas.microsoft.com/office/drawing/2014/main" id="{CD2C4D8B-0EB3-4070-881B-DB0D682C8B99}"/>
+                <a16:creationId xmlns:a16="http://schemas.microsoft.com/office/drawing/2014/main" id="{C726FAEB-C2E6-4AA7-AFFC-1499C7D9E3D7}"/>
               </a:ext>
             </a:extLst>
           </p:cNvPr>
@@ -14752,7 +14752,7 @@
           <p:cNvPr id="42" name="flow-178">
             <a:extLst xmlns:a="http://schemas.openxmlformats.org/drawingml/2006/main">
               <a:ext uri="{FF2B5EF4-FFF2-40B4-BE49-F238E27FC236}">
-                <a16:creationId xmlns:a16="http://schemas.microsoft.com/office/drawing/2014/main" id="{27B7E246-FD78-4935-8380-92471A373CDD}"/>
+                <a16:creationId xmlns:a16="http://schemas.microsoft.com/office/drawing/2014/main" id="{D1A4B1E5-77BC-4442-A91F-5D31790F5FF1}"/>
               </a:ext>
             </a:extLst>
           </p:cNvPr>
@@ -15626,7 +15626,7 @@
           <p:cNvPr id="10" name="partner-flow-14">
             <a:extLst xmlns:a="http://schemas.openxmlformats.org/drawingml/2006/main">
               <a:ext uri="{FF2B5EF4-FFF2-40B4-BE49-F238E27FC236}">
-                <a16:creationId xmlns:a16="http://schemas.microsoft.com/office/drawing/2014/main" id="{51DA2BF7-A7AC-4CB3-91DD-AA026B46E8E7}"/>
+                <a16:creationId xmlns:a16="http://schemas.microsoft.com/office/drawing/2014/main" id="{7053BFAA-4CC8-4864-BFDF-5911A6EB9E33}"/>
               </a:ext>
             </a:extLst>
           </p:cNvPr>
@@ -15971,7 +15971,7 @@
           <p:cNvPr id="15" name="partner-flow-19">
             <a:extLst xmlns:a="http://schemas.openxmlformats.org/drawingml/2006/main">
               <a:ext uri="{FF2B5EF4-FFF2-40B4-BE49-F238E27FC236}">
-                <a16:creationId xmlns:a16="http://schemas.microsoft.com/office/drawing/2014/main" id="{8A225777-A9F9-4487-A78F-9871F07B4557}"/>
+                <a16:creationId xmlns:a16="http://schemas.microsoft.com/office/drawing/2014/main" id="{3C810182-40BC-457E-98DE-F040AB5F0D8D}"/>
               </a:ext>
             </a:extLst>
           </p:cNvPr>
@@ -16267,7 +16267,7 @@
           <p:cNvPr id="20" name="partner-flow-24">
             <a:extLst xmlns:a="http://schemas.openxmlformats.org/drawingml/2006/main">
               <a:ext uri="{FF2B5EF4-FFF2-40B4-BE49-F238E27FC236}">
-                <a16:creationId xmlns:a16="http://schemas.microsoft.com/office/drawing/2014/main" id="{8EBC962B-A53D-47DF-A8BC-73378EF45E19}"/>
+                <a16:creationId xmlns:a16="http://schemas.microsoft.com/office/drawing/2014/main" id="{2FF0F711-F536-4B8A-AD68-D7346A2A1B1B}"/>
               </a:ext>
             </a:extLst>
           </p:cNvPr>
@@ -16295,7 +16295,7 @@
           <p:cNvPr id="21" name="partner-flow-25">
             <a:extLst xmlns:a="http://schemas.openxmlformats.org/drawingml/2006/main">
               <a:ext uri="{FF2B5EF4-FFF2-40B4-BE49-F238E27FC236}">
-                <a16:creationId xmlns:a16="http://schemas.microsoft.com/office/drawing/2014/main" id="{B2AE613A-5FD9-4122-98CF-EDECD6E43EB9}"/>
+                <a16:creationId xmlns:a16="http://schemas.microsoft.com/office/drawing/2014/main" id="{CE6CCB48-8545-4F96-91F8-28E517050973}"/>
               </a:ext>
             </a:extLst>
           </p:cNvPr>
@@ -16323,7 +16323,7 @@
           <p:cNvPr id="22" name="partner-flow-26">
             <a:extLst xmlns:a="http://schemas.openxmlformats.org/drawingml/2006/main">
               <a:ext uri="{FF2B5EF4-FFF2-40B4-BE49-F238E27FC236}">
-                <a16:creationId xmlns:a16="http://schemas.microsoft.com/office/drawing/2014/main" id="{E275A90E-92B8-41AB-9E96-DED585E6BAA8}"/>
+                <a16:creationId xmlns:a16="http://schemas.microsoft.com/office/drawing/2014/main" id="{846A3AF9-44FE-4F69-8C01-7767FB217587}"/>
               </a:ext>
             </a:extLst>
           </p:cNvPr>
@@ -17757,7 +17757,7 @@
           <p:cNvPr id="16" name="partner-flow-45">
             <a:extLst xmlns:a="http://schemas.openxmlformats.org/drawingml/2006/main">
               <a:ext uri="{FF2B5EF4-FFF2-40B4-BE49-F238E27FC236}">
-                <a16:creationId xmlns:a16="http://schemas.microsoft.com/office/drawing/2014/main" id="{FF1704F4-A287-4A95-9010-AB47A24D486B}"/>
+                <a16:creationId xmlns:a16="http://schemas.microsoft.com/office/drawing/2014/main" id="{A9B15B4F-E453-4BE4-B5B7-DB41D0C47AA4}"/>
               </a:ext>
             </a:extLst>
           </p:cNvPr>
@@ -17786,7 +17786,7 @@
           <p:cNvPr id="17" name="partner-flow-46">
             <a:extLst xmlns:a="http://schemas.openxmlformats.org/drawingml/2006/main">
               <a:ext uri="{FF2B5EF4-FFF2-40B4-BE49-F238E27FC236}">
-                <a16:creationId xmlns:a16="http://schemas.microsoft.com/office/drawing/2014/main" id="{CB2D629C-83A8-4F52-9FF0-E2F6B8B25335}"/>
+                <a16:creationId xmlns:a16="http://schemas.microsoft.com/office/drawing/2014/main" id="{213E47D0-76F3-43CA-ACA0-3BE813120F9E}"/>
               </a:ext>
             </a:extLst>
           </p:cNvPr>
@@ -17815,7 +17815,7 @@
           <p:cNvPr id="18" name="partner-flow-47">
             <a:extLst xmlns:a="http://schemas.openxmlformats.org/drawingml/2006/main">
               <a:ext uri="{FF2B5EF4-FFF2-40B4-BE49-F238E27FC236}">
-                <a16:creationId xmlns:a16="http://schemas.microsoft.com/office/drawing/2014/main" id="{E3BD4EE7-BE1F-482D-AFB4-1C4C88F936C3}"/>
+                <a16:creationId xmlns:a16="http://schemas.microsoft.com/office/drawing/2014/main" id="{F39F82FC-2DA1-4CB9-9D10-51547946F5F3}"/>
               </a:ext>
             </a:extLst>
           </p:cNvPr>
@@ -17844,7 +17844,7 @@
           <p:cNvPr id="19" name="partner-flow-48">
             <a:extLst xmlns:a="http://schemas.openxmlformats.org/drawingml/2006/main">
               <a:ext uri="{FF2B5EF4-FFF2-40B4-BE49-F238E27FC236}">
-                <a16:creationId xmlns:a16="http://schemas.microsoft.com/office/drawing/2014/main" id="{7A6E6096-9326-449A-9966-D3D9DE760418}"/>
+                <a16:creationId xmlns:a16="http://schemas.microsoft.com/office/drawing/2014/main" id="{823279A2-F902-45C2-BED8-927CC8DB361E}"/>
               </a:ext>
             </a:extLst>
           </p:cNvPr>
@@ -17872,7 +17872,7 @@
           <p:cNvPr id="20" name="partner-flow-49">
             <a:extLst xmlns:a="http://schemas.openxmlformats.org/drawingml/2006/main">
               <a:ext uri="{FF2B5EF4-FFF2-40B4-BE49-F238E27FC236}">
-                <a16:creationId xmlns:a16="http://schemas.microsoft.com/office/drawing/2014/main" id="{8FED495E-C14A-47D9-B65C-348E3E6D689E}"/>
+                <a16:creationId xmlns:a16="http://schemas.microsoft.com/office/drawing/2014/main" id="{BC3B5E22-C13A-4C15-B730-9AA440AE21F6}"/>
               </a:ext>
             </a:extLst>
           </p:cNvPr>
@@ -17900,7 +17900,7 @@
           <p:cNvPr id="21" name="partner-flow-50">
             <a:extLst xmlns:a="http://schemas.openxmlformats.org/drawingml/2006/main">
               <a:ext uri="{FF2B5EF4-FFF2-40B4-BE49-F238E27FC236}">
-                <a16:creationId xmlns:a16="http://schemas.microsoft.com/office/drawing/2014/main" id="{35BAE54A-E32D-43BA-92A8-193280A0CFA8}"/>
+                <a16:creationId xmlns:a16="http://schemas.microsoft.com/office/drawing/2014/main" id="{A0698FFB-354A-4754-9FDD-48431269D798}"/>
               </a:ext>
             </a:extLst>
           </p:cNvPr>
@@ -17999,7 +17999,7 @@
           <p:cNvPr id="23" name="partner-flow-52">
             <a:extLst xmlns:a="http://schemas.openxmlformats.org/drawingml/2006/main">
               <a:ext uri="{FF2B5EF4-FFF2-40B4-BE49-F238E27FC236}">
-                <a16:creationId xmlns:a16="http://schemas.microsoft.com/office/drawing/2014/main" id="{9CFC6A98-F4EC-4506-890F-DA0361A5B47A}"/>
+                <a16:creationId xmlns:a16="http://schemas.microsoft.com/office/drawing/2014/main" id="{31AECDA0-1654-4C82-A21C-14E41BCEC69C}"/>
               </a:ext>
             </a:extLst>
           </p:cNvPr>
@@ -18027,7 +18027,7 @@
           <p:cNvPr id="24" name="partner-flow-53">
             <a:extLst xmlns:a="http://schemas.openxmlformats.org/drawingml/2006/main">
               <a:ext uri="{FF2B5EF4-FFF2-40B4-BE49-F238E27FC236}">
-                <a16:creationId xmlns:a16="http://schemas.microsoft.com/office/drawing/2014/main" id="{B328E4D9-D7C4-45E3-9241-5BCD6E9F9986}"/>
+                <a16:creationId xmlns:a16="http://schemas.microsoft.com/office/drawing/2014/main" id="{3A00E6D0-35AF-4C68-B73B-0E7B68940C86}"/>
               </a:ext>
             </a:extLst>
           </p:cNvPr>
@@ -18055,7 +18055,7 @@
           <p:cNvPr id="25" name="partner-flow-54">
             <a:extLst xmlns:a="http://schemas.openxmlformats.org/drawingml/2006/main">
               <a:ext uri="{FF2B5EF4-FFF2-40B4-BE49-F238E27FC236}">
-                <a16:creationId xmlns:a16="http://schemas.microsoft.com/office/drawing/2014/main" id="{5E5279C2-EB2C-4D7C-A11F-AEE1697580F5}"/>
+                <a16:creationId xmlns:a16="http://schemas.microsoft.com/office/drawing/2014/main" id="{B24AFD93-EFCA-4EBC-AFC1-6B1E5A6028B5}"/>
               </a:ext>
             </a:extLst>
           </p:cNvPr>
@@ -18600,7 +18600,7 @@
           <p:cNvPr id="33" name="changed-assertions-edge-label-leader">
             <a:extLst xmlns:a="http://schemas.openxmlformats.org/drawingml/2006/main">
               <a:ext uri="{FF2B5EF4-FFF2-40B4-BE49-F238E27FC236}">
-                <a16:creationId xmlns:a16="http://schemas.microsoft.com/office/drawing/2014/main" id="{311F23B3-966B-4218-A455-38A550029C31}"/>
+                <a16:creationId xmlns:a16="http://schemas.microsoft.com/office/drawing/2014/main" id="{3BACE6B9-C148-453B-B8BE-FE0D77EF2323}"/>
               </a:ext>
             </a:extLst>
           </p:cNvPr>
@@ -18797,7 +18797,7 @@
           <p:cNvPr id="5" name="">
             <a:extLst xmlns:a="http://schemas.openxmlformats.org/drawingml/2006/main">
               <a:ext uri="{FF2B5EF4-FFF2-40B4-BE49-F238E27FC236}">
-                <a16:creationId xmlns:a16="http://schemas.microsoft.com/office/drawing/2014/main" id="{EB1581A9-0A51-43E8-ABB6-6FAA73131D38}"/>
+                <a16:creationId xmlns:a16="http://schemas.microsoft.com/office/drawing/2014/main" id="{FA08A9B3-066A-4F3F-A7DE-375642552566}"/>
               </a:ext>
             </a:extLst>
           </p:cNvPr>
@@ -19448,7 +19448,7 @@
                           <a:ea typeface="Aptos"/>
                           <a:cs typeface="Aptos"/>
                         </a:rPr>
-                        <a:t>Implement accepted review authority</a:t>
+                        <a:t>Connect production review transport</a:t>
                       </a:r>
                     </a:p>
                     <a:p>
@@ -20461,7 +20461,7 @@
           <p:cNvPr id="9" name="flow-217">
             <a:extLst xmlns:a="http://schemas.openxmlformats.org/drawingml/2006/main">
               <a:ext uri="{FF2B5EF4-FFF2-40B4-BE49-F238E27FC236}">
-                <a16:creationId xmlns:a16="http://schemas.microsoft.com/office/drawing/2014/main" id="{7D5F8869-42BF-4EC6-A3B2-D345359AD627}"/>
+                <a16:creationId xmlns:a16="http://schemas.microsoft.com/office/drawing/2014/main" id="{447003AE-9C1A-415B-8FFF-4148B3BA88B6}"/>
               </a:ext>
             </a:extLst>
           </p:cNvPr>
@@ -20490,7 +20490,7 @@
           <p:cNvPr id="10" name="flow-218">
             <a:extLst xmlns:a="http://schemas.openxmlformats.org/drawingml/2006/main">
               <a:ext uri="{FF2B5EF4-FFF2-40B4-BE49-F238E27FC236}">
-                <a16:creationId xmlns:a16="http://schemas.microsoft.com/office/drawing/2014/main" id="{6637023A-B417-4A8D-98FF-165F80707F68}"/>
+                <a16:creationId xmlns:a16="http://schemas.microsoft.com/office/drawing/2014/main" id="{23E22D28-C01A-4B8F-A184-0E16FE5BC9A9}"/>
               </a:ext>
             </a:extLst>
           </p:cNvPr>
@@ -20868,6 +20868,30 @@
               <a:t>Cloud rehearsal tooling</a:t>
             </a:r>
           </a:p>
+          <a:p xmlns:a="http://schemas.openxmlformats.org/drawingml/2006/main">
+            <a:pPr algn="l">
+              <a:buNone/>
+              <a:defRPr sz="2025" b="0">
+                <a:solidFill>
+                  <a:srgbClr val="132E38"/>
+                </a:solidFill>
+                <a:latin typeface="Aptos"/>
+                <a:ea typeface="Aptos"/>
+                <a:cs typeface="Aptos"/>
+              </a:defRPr>
+            </a:pPr>
+            <a:r>
+              <a:rPr sz="2025" b="0">
+                <a:solidFill>
+                  <a:srgbClr val="132E38"/>
+                </a:solidFill>
+                <a:latin typeface="Aptos"/>
+                <a:ea typeface="Aptos"/>
+                <a:cs typeface="Aptos"/>
+              </a:rPr>
+              <a:t>Durable review and cancellation</a:t>
+            </a:r>
+          </a:p>
         </p:txBody>
       </p:sp>
       <p:sp>
@@ -21089,7 +21113,7 @@
           <p:cNvPr id="14" name="flow-222">
             <a:extLst xmlns:a="http://schemas.openxmlformats.org/drawingml/2006/main">
               <a:ext uri="{FF2B5EF4-FFF2-40B4-BE49-F238E27FC236}">
-                <a16:creationId xmlns:a16="http://schemas.microsoft.com/office/drawing/2014/main" id="{4A45CBC6-953F-4B50-A26C-F0D8872A2F99}"/>
+                <a16:creationId xmlns:a16="http://schemas.microsoft.com/office/drawing/2014/main" id="{7082CDD1-641A-4414-9749-37D6EC064BD7}"/>
               </a:ext>
             </a:extLst>
           </p:cNvPr>

</xml_diff>

<commit_message>
docs: synchronize durable review completion and activation requirements (#32)
</commit_message>
<xml_diff>
--- a/Inertia-Architecture.pptx
+++ b/Inertia-Architecture.pptx
@@ -2,21 +2,21 @@
 <file path=ppt/presentation.xml><?xml version="1.0" encoding="utf-8"?>
 <p:presentation xmlns:p="http://schemas.openxmlformats.org/presentationml/2006/main">
   <p:sldMasterIdLst>
-    <p:sldMasterId xmlns:r="http://schemas.openxmlformats.org/officeDocument/2006/relationships" id="2147483648" r:id="R7b1feba4ebac42cb"/>
+    <p:sldMasterId xmlns:r="http://schemas.openxmlformats.org/officeDocument/2006/relationships" id="2147483648" r:id="Re67716fdfb124d9f"/>
   </p:sldMasterIdLst>
   <p:notesMasterIdLst>
-    <p:notesMasterId xmlns:r="http://schemas.openxmlformats.org/officeDocument/2006/relationships" r:id="R0af0acd9638049c7"/>
+    <p:notesMasterId xmlns:r="http://schemas.openxmlformats.org/officeDocument/2006/relationships" r:id="Rb0e20b83594f454a"/>
   </p:notesMasterIdLst>
   <p:sldIdLst>
-    <p:sldId xmlns:r="http://schemas.openxmlformats.org/officeDocument/2006/relationships" id="256" r:id="R13a96eea91d94d13"/>
-    <p:sldId xmlns:r="http://schemas.openxmlformats.org/officeDocument/2006/relationships" id="257" r:id="R79cdbf9129b141da"/>
-    <p:sldId xmlns:r="http://schemas.openxmlformats.org/officeDocument/2006/relationships" id="258" r:id="R0562286197ca4413"/>
-    <p:sldId xmlns:r="http://schemas.openxmlformats.org/officeDocument/2006/relationships" id="259" r:id="R18506465cf3d46fc"/>
-    <p:sldId xmlns:r="http://schemas.openxmlformats.org/officeDocument/2006/relationships" id="260" r:id="R6636fe5d18c847ab"/>
-    <p:sldId xmlns:r="http://schemas.openxmlformats.org/officeDocument/2006/relationships" id="261" r:id="Rb5b967b1d91b4e79"/>
-    <p:sldId xmlns:r="http://schemas.openxmlformats.org/officeDocument/2006/relationships" id="262" r:id="R0ada181589494b2a"/>
-    <p:sldId xmlns:r="http://schemas.openxmlformats.org/officeDocument/2006/relationships" id="263" r:id="Ra4be38fd0b524b61"/>
-    <p:sldId xmlns:r="http://schemas.openxmlformats.org/officeDocument/2006/relationships" id="264" r:id="Rc62e5fd86aa44a33"/>
+    <p:sldId xmlns:r="http://schemas.openxmlformats.org/officeDocument/2006/relationships" id="256" r:id="R03eae314aa414ed0"/>
+    <p:sldId xmlns:r="http://schemas.openxmlformats.org/officeDocument/2006/relationships" id="257" r:id="R676bf51815974a42"/>
+    <p:sldId xmlns:r="http://schemas.openxmlformats.org/officeDocument/2006/relationships" id="258" r:id="Re773d7e86bd74a4d"/>
+    <p:sldId xmlns:r="http://schemas.openxmlformats.org/officeDocument/2006/relationships" id="259" r:id="R9f0b67c8f5ea44e0"/>
+    <p:sldId xmlns:r="http://schemas.openxmlformats.org/officeDocument/2006/relationships" id="260" r:id="Rd220d56f4e4d4fdc"/>
+    <p:sldId xmlns:r="http://schemas.openxmlformats.org/officeDocument/2006/relationships" id="261" r:id="Rc6f1a977eefc4f00"/>
+    <p:sldId xmlns:r="http://schemas.openxmlformats.org/officeDocument/2006/relationships" id="262" r:id="R936733b4d6944b04"/>
+    <p:sldId xmlns:r="http://schemas.openxmlformats.org/officeDocument/2006/relationships" id="263" r:id="Rd103217cf543416a"/>
+    <p:sldId xmlns:r="http://schemas.openxmlformats.org/officeDocument/2006/relationships" id="264" r:id="R114e4421ef5c4ec8"/>
   </p:sldIdLst>
   <p:sldSz cx="15240000" cy="8572500"/>
   <p:notesSz cx="6858000" cy="9144000"/>
@@ -720,7 +720,7 @@
           <a:lstStyle xmlns:a="http://schemas.openxmlformats.org/drawingml/2006/main"/>
           <a:p xmlns:a="http://schemas.openxmlformats.org/drawingml/2006/main">
             <a:r>
-              <a:t>Sources: Inertia spec.md R-G01–R-G04 and R-F01–R-F08; docs/development/funding-enhancement/spec.md; docs/development/native-grant-workflow.md.</a:t>
+              <a:t>Sources: Inertia spec.md R-G01–R-G04 and R-F01–R-F08; docs/development/funding-enhancement/spec.md; docs/development/native-grant-workflow.md; host-composition/paperclip-durable-funding-review/ACTIVATION-CONTRACT.md.</a:t>
             </a:r>
           </a:p>
           <a:p xmlns:a="http://schemas.openxmlformats.org/drawingml/2006/main">
@@ -750,7 +750,7 @@
           </a:p>
           <a:p xmlns:a="http://schemas.openxmlformats.org/drawingml/2006/main">
             <a:r>
-              <a:t>The merged native adapter remains disabled. The approved model records durable authority for an exact version at human acceptance, so disconnect alone leaves that approval valid. Activation requires implemented acceptance receipts, funding-service-confirmed cancellation and rejection of changed funding evidence. Grant submission and live final-vote verification retain their separate authority steps.</a:t>
+              <a:t>Durable capture and the funding service implement exact-version authority accepted with the human verdict. Approval survives disconnect and later native changes. DFW confirms cancellation and rejects stale funding evidence. Production activation needs authenticated transport, receipt retention/archival, scoped roles/source access, qualified writer fencing and a real correction/cancel walkthrough. Grant submission and final-vote verification retain their separate authority steps.</a:t>
             </a:r>
           </a:p>
         </p:txBody>
@@ -1220,7 +1220,7 @@
           <a:lstStyle xmlns:a="http://schemas.openxmlformats.org/drawingml/2006/main"/>
           <a:p xmlns:a="http://schemas.openxmlformats.org/drawingml/2006/main">
             <a:r>
-              <a:t>Sources: Inertia spec.md, plan.md and testing.md; docs/development/funding-enhancement/discovery-loop.md; docs/development/objective-intake.md; scripts/cloud-rehearsal/README.md; https://github.com/NetRxn/Inertia/pull/25; https://github.com/NetRxn/Inertia/pull/26; https://github.com/NetRxn/Inertia/pull/27; https://github.com/NetRxn/Inertia/pull/28; https://github.com/NetRxn/DFW-Gov-Fund/pull/44; https://github.com/NetRxn/DFW-Gov-Fund/pull/45; https://github.com/NetRxn/DFW-Gov-Fund/pull/46; https://github.com/NetRxn/DFW-Gov-Fund/pull/47. Status: 24 October 2026.</a:t>
+              <a:t>Sources: Inertia spec.md, plan.md and testing.md; docs/development/funding-enhancement/discovery-loop.md; docs/development/objective-intake.md; scripts/cloud-rehearsal/README.md; https://github.com/NetRxn/Inertia/pull/25; https://github.com/NetRxn/Inertia/pull/26; https://github.com/NetRxn/Inertia/pull/27; https://github.com/NetRxn/Inertia/pull/28; https://github.com/NetRxn/DFW-Gov-Fund/pull/44; https://github.com/NetRxn/DFW-Gov-Fund/pull/45; https://github.com/NetRxn/DFW-Gov-Fund/pull/46; https://github.com/NetRxn/DFW-Gov-Fund/pull/47; https://github.com/NetRxn/DFW-Gov-Fund/pull/49; https://github.com/NetRxn/DFW-Gov-Fund/pull/50; host-composition/paperclip-durable-funding-review/ACTIVATION-CONTRACT.md. Status: 24 October 2026.</a:t>
             </a:r>
           </a:p>
           <a:p xmlns:a="http://schemas.openxmlformats.org/drawingml/2006/main">
@@ -1250,7 +1250,7 @@
           </a:p>
           <a:p xmlns:a="http://schemas.openxmlformats.org/drawingml/2006/main">
             <a:r>
-              <a:t>The native adapter is merged and disabled; the reviewed funding transaction service is in CI. The approved exact-version authority-at-acceptance model requires implementation and production writer-fence integration before activation. Live final-vote verification retains its separate gate.</a:t>
+              <a:t>Durable human acceptance and funding-service cancellation are implemented and independently qualified in isolated rehearsal. Real native PostgreSQL capture and DFW PostgreSQL behavior passed separately. Cross-service rehearsals used actual native transactions, synthetic file transport and DFW SQLite. Production transport, retention/archival, scoped permissions/source access and the human walkthrough remain activation gates. The composition stays disabled until those gates pass. Live final-vote verification retains its separate gate.</a:t>
             </a:r>
           </a:p>
           <a:p xmlns:a="http://schemas.openxmlformats.org/drawingml/2006/main">
@@ -3083,12 +3083,12 @@
   </p:cSld>
   <p:clrMap bg1="lt1" tx1="dk1" bg2="lt2" tx2="dk2" accent1="accent1" accent2="accent2" accent3="accent3" accent4="accent4" accent5="accent5" accent6="accent6" hlink="hlink" folHlink="folHlink"/>
   <p:sldLayoutIdLst>
-    <p:sldLayoutId xmlns:r="http://schemas.openxmlformats.org/officeDocument/2006/relationships" id="2147483649" r:id="R36c050df87df4dfb"/>
-    <p:sldLayoutId xmlns:r="http://schemas.openxmlformats.org/officeDocument/2006/relationships" id="2147483650" r:id="R4826580c941b4dfb"/>
-    <p:sldLayoutId xmlns:r="http://schemas.openxmlformats.org/officeDocument/2006/relationships" id="2147483651" r:id="R1ef15abf51b948a7"/>
-    <p:sldLayoutId xmlns:r="http://schemas.openxmlformats.org/officeDocument/2006/relationships" id="2147483652" r:id="R13a461ceefae4590"/>
-    <p:sldLayoutId xmlns:r="http://schemas.openxmlformats.org/officeDocument/2006/relationships" id="2147483653" r:id="R72511b6ee2d846d2"/>
-    <p:sldLayoutId xmlns:r="http://schemas.openxmlformats.org/officeDocument/2006/relationships" id="2147483654" r:id="R79585679f8734e86"/>
+    <p:sldLayoutId xmlns:r="http://schemas.openxmlformats.org/officeDocument/2006/relationships" id="2147483649" r:id="R20b38ba70eb342b3"/>
+    <p:sldLayoutId xmlns:r="http://schemas.openxmlformats.org/officeDocument/2006/relationships" id="2147483650" r:id="Rd11476e6f4db4f52"/>
+    <p:sldLayoutId xmlns:r="http://schemas.openxmlformats.org/officeDocument/2006/relationships" id="2147483651" r:id="R5af7774cad524477"/>
+    <p:sldLayoutId xmlns:r="http://schemas.openxmlformats.org/officeDocument/2006/relationships" id="2147483652" r:id="Rd9c9b7a06dc94447"/>
+    <p:sldLayoutId xmlns:r="http://schemas.openxmlformats.org/officeDocument/2006/relationships" id="2147483653" r:id="Rf4e31d95c4da4466"/>
+    <p:sldLayoutId xmlns:r="http://schemas.openxmlformats.org/officeDocument/2006/relationships" id="2147483654" r:id="R91de7841eb0a44ac"/>
   </p:sldLayoutIdLst>
   <p:txStyles>
     <p:titleStyle>
@@ -3639,7 +3639,7 @@
           <p:cNvPr id="39" name="">
             <a:extLst xmlns:a="http://schemas.openxmlformats.org/drawingml/2006/main">
               <a:ext uri="{FF2B5EF4-FFF2-40B4-BE49-F238E27FC236}">
-                <a16:creationId xmlns:a16="http://schemas.microsoft.com/office/drawing/2014/main" id="{D412FE0C-6DAC-45C6-B0D0-763C63607A56}"/>
+                <a16:creationId xmlns:a16="http://schemas.microsoft.com/office/drawing/2014/main" id="{C3120CBA-2826-44C8-94CB-F07348FEA7CB}"/>
               </a:ext>
             </a:extLst>
           </p:cNvPr>
@@ -3672,7 +3672,7 @@
           <p:cNvPr id="32" name="">
             <a:extLst xmlns:a="http://schemas.openxmlformats.org/drawingml/2006/main">
               <a:ext uri="{FF2B5EF4-FFF2-40B4-BE49-F238E27FC236}">
-                <a16:creationId xmlns:a16="http://schemas.microsoft.com/office/drawing/2014/main" id="{C7A66388-0418-4A12-AB11-536B1935AB16}"/>
+                <a16:creationId xmlns:a16="http://schemas.microsoft.com/office/drawing/2014/main" id="{A6DE5ED5-9A3C-4374-86AD-43A47E7004C6}"/>
               </a:ext>
             </a:extLst>
           </p:cNvPr>
@@ -3704,7 +3704,7 @@
           <p:cNvPr id="29" name="">
             <a:extLst xmlns:a="http://schemas.openxmlformats.org/drawingml/2006/main">
               <a:ext uri="{FF2B5EF4-FFF2-40B4-BE49-F238E27FC236}">
-                <a16:creationId xmlns:a16="http://schemas.microsoft.com/office/drawing/2014/main" id="{793CDB02-24F2-4EA8-A861-9337AB15E01C}"/>
+                <a16:creationId xmlns:a16="http://schemas.microsoft.com/office/drawing/2014/main" id="{01B70731-45E5-470D-B4BB-F16F8402D9E0}"/>
               </a:ext>
             </a:extLst>
           </p:cNvPr>
@@ -5497,7 +5497,7 @@
           <p:cNvPr id="30" name="flow-29">
             <a:extLst xmlns:a="http://schemas.openxmlformats.org/drawingml/2006/main">
               <a:ext uri="{FF2B5EF4-FFF2-40B4-BE49-F238E27FC236}">
-                <a16:creationId xmlns:a16="http://schemas.microsoft.com/office/drawing/2014/main" id="{116D73A4-DE0C-4746-865A-5A0861F91418}"/>
+                <a16:creationId xmlns:a16="http://schemas.microsoft.com/office/drawing/2014/main" id="{8C091B80-C622-42DA-A009-93FF036A1267}"/>
               </a:ext>
             </a:extLst>
           </p:cNvPr>
@@ -5527,7 +5527,7 @@
           <p:cNvPr id="31" name="flow-30">
             <a:extLst xmlns:a="http://schemas.openxmlformats.org/drawingml/2006/main">
               <a:ext uri="{FF2B5EF4-FFF2-40B4-BE49-F238E27FC236}">
-                <a16:creationId xmlns:a16="http://schemas.microsoft.com/office/drawing/2014/main" id="{3731771A-875E-48B2-92BE-DF2D6BA903C8}"/>
+                <a16:creationId xmlns:a16="http://schemas.microsoft.com/office/drawing/2014/main" id="{9054FC2C-0002-4E13-A51A-7222044C9807}"/>
               </a:ext>
             </a:extLst>
           </p:cNvPr>
@@ -5627,7 +5627,7 @@
           <p:cNvPr id="34" name="flow-32">
             <a:extLst xmlns:a="http://schemas.openxmlformats.org/drawingml/2006/main">
               <a:ext uri="{FF2B5EF4-FFF2-40B4-BE49-F238E27FC236}">
-                <a16:creationId xmlns:a16="http://schemas.microsoft.com/office/drawing/2014/main" id="{FF943156-514E-4F21-943D-31A37277F58A}"/>
+                <a16:creationId xmlns:a16="http://schemas.microsoft.com/office/drawing/2014/main" id="{F42CA512-4975-4C1A-B259-B46282BE7931}"/>
               </a:ext>
             </a:extLst>
           </p:cNvPr>
@@ -5656,7 +5656,7 @@
           <p:cNvPr id="35" name="flow-33">
             <a:extLst xmlns:a="http://schemas.openxmlformats.org/drawingml/2006/main">
               <a:ext uri="{FF2B5EF4-FFF2-40B4-BE49-F238E27FC236}">
-                <a16:creationId xmlns:a16="http://schemas.microsoft.com/office/drawing/2014/main" id="{7E0A8387-7E26-400F-BFD0-C0A25DBD9924}"/>
+                <a16:creationId xmlns:a16="http://schemas.microsoft.com/office/drawing/2014/main" id="{3E3CF51B-F479-43FF-8544-3E0DE3B5B813}"/>
               </a:ext>
             </a:extLst>
           </p:cNvPr>
@@ -5684,7 +5684,7 @@
           <p:cNvPr id="36" name="flow-34">
             <a:extLst xmlns:a="http://schemas.openxmlformats.org/drawingml/2006/main">
               <a:ext uri="{FF2B5EF4-FFF2-40B4-BE49-F238E27FC236}">
-                <a16:creationId xmlns:a16="http://schemas.microsoft.com/office/drawing/2014/main" id="{573B7FFE-DD48-4608-B172-19C12DC02C38}"/>
+                <a16:creationId xmlns:a16="http://schemas.microsoft.com/office/drawing/2014/main" id="{17507772-98B2-4512-B4A7-E4A0D3371618}"/>
               </a:ext>
             </a:extLst>
           </p:cNvPr>
@@ -5783,7 +5783,7 @@
           <p:cNvPr id="38" name="flow-36">
             <a:extLst xmlns:a="http://schemas.openxmlformats.org/drawingml/2006/main">
               <a:ext uri="{FF2B5EF4-FFF2-40B4-BE49-F238E27FC236}">
-                <a16:creationId xmlns:a16="http://schemas.microsoft.com/office/drawing/2014/main" id="{BD9D8EE3-DFBC-4002-ABEE-92865AC73C45}"/>
+                <a16:creationId xmlns:a16="http://schemas.microsoft.com/office/drawing/2014/main" id="{FC620AFA-6BA6-43F0-91CD-C3EA0574AE65}"/>
               </a:ext>
             </a:extLst>
           </p:cNvPr>
@@ -5912,7 +5912,7 @@
           <p:cNvPr id="35" name="">
             <a:extLst xmlns:a="http://schemas.openxmlformats.org/drawingml/2006/main">
               <a:ext uri="{FF2B5EF4-FFF2-40B4-BE49-F238E27FC236}">
-                <a16:creationId xmlns:a16="http://schemas.microsoft.com/office/drawing/2014/main" id="{822164ED-A4E6-40BD-8309-9D150FF51E10}"/>
+                <a16:creationId xmlns:a16="http://schemas.microsoft.com/office/drawing/2014/main" id="{D4F599FF-97B5-43B6-8F99-180E2FC82611}"/>
               </a:ext>
             </a:extLst>
           </p:cNvPr>
@@ -5944,7 +5944,7 @@
           <p:cNvPr id="21" name="">
             <a:extLst xmlns:a="http://schemas.openxmlformats.org/drawingml/2006/main">
               <a:ext uri="{FF2B5EF4-FFF2-40B4-BE49-F238E27FC236}">
-                <a16:creationId xmlns:a16="http://schemas.microsoft.com/office/drawing/2014/main" id="{D6F5A60F-60D8-4C4B-810A-23C53C987B2E}"/>
+                <a16:creationId xmlns:a16="http://schemas.microsoft.com/office/drawing/2014/main" id="{3AB93786-CD66-4B1E-A32D-851B001657D5}"/>
               </a:ext>
             </a:extLst>
           </p:cNvPr>
@@ -5976,7 +5976,7 @@
           <p:cNvPr id="20" name="">
             <a:extLst xmlns:a="http://schemas.openxmlformats.org/drawingml/2006/main">
               <a:ext uri="{FF2B5EF4-FFF2-40B4-BE49-F238E27FC236}">
-                <a16:creationId xmlns:a16="http://schemas.microsoft.com/office/drawing/2014/main" id="{10466ABD-73A2-4146-BC7F-9539242ECCF7}"/>
+                <a16:creationId xmlns:a16="http://schemas.microsoft.com/office/drawing/2014/main" id="{EED3E3F1-CF60-4F28-BE2F-7B8037750AC2}"/>
               </a:ext>
             </a:extLst>
           </p:cNvPr>
@@ -6008,7 +6008,7 @@
           <p:cNvPr id="19" name="">
             <a:extLst xmlns:a="http://schemas.openxmlformats.org/drawingml/2006/main">
               <a:ext uri="{FF2B5EF4-FFF2-40B4-BE49-F238E27FC236}">
-                <a16:creationId xmlns:a16="http://schemas.microsoft.com/office/drawing/2014/main" id="{9900C5D9-787C-4CDD-B375-24D5E3656DDA}"/>
+                <a16:creationId xmlns:a16="http://schemas.microsoft.com/office/drawing/2014/main" id="{A5953D26-8AEE-4417-838F-CCAFCA89F157}"/>
               </a:ext>
             </a:extLst>
           </p:cNvPr>
@@ -6040,7 +6040,7 @@
           <p:cNvPr id="18" name="">
             <a:extLst xmlns:a="http://schemas.openxmlformats.org/drawingml/2006/main">
               <a:ext uri="{FF2B5EF4-FFF2-40B4-BE49-F238E27FC236}">
-                <a16:creationId xmlns:a16="http://schemas.microsoft.com/office/drawing/2014/main" id="{173E04A9-03BD-4611-B3D2-7A62AE51AFE4}"/>
+                <a16:creationId xmlns:a16="http://schemas.microsoft.com/office/drawing/2014/main" id="{68A424AA-DEEA-4C0D-9DD3-B8307F9A089B}"/>
               </a:ext>
             </a:extLst>
           </p:cNvPr>
@@ -7615,7 +7615,7 @@
           <p:cNvPr id="28" name="flow-61">
             <a:extLst xmlns:a="http://schemas.openxmlformats.org/drawingml/2006/main">
               <a:ext uri="{FF2B5EF4-FFF2-40B4-BE49-F238E27FC236}">
-                <a16:creationId xmlns:a16="http://schemas.microsoft.com/office/drawing/2014/main" id="{E567EE97-38F1-4317-9A67-B52EB3F8B70E}"/>
+                <a16:creationId xmlns:a16="http://schemas.microsoft.com/office/drawing/2014/main" id="{7E77EE6A-D4D8-40F7-A95F-1DC37AB7A59D}"/>
               </a:ext>
             </a:extLst>
           </p:cNvPr>
@@ -7714,7 +7714,7 @@
           <p:cNvPr id="30" name="flow-63">
             <a:extLst xmlns:a="http://schemas.openxmlformats.org/drawingml/2006/main">
               <a:ext uri="{FF2B5EF4-FFF2-40B4-BE49-F238E27FC236}">
-                <a16:creationId xmlns:a16="http://schemas.microsoft.com/office/drawing/2014/main" id="{FDB526CF-4730-4F7E-ACDD-55EBE7014C5B}"/>
+                <a16:creationId xmlns:a16="http://schemas.microsoft.com/office/drawing/2014/main" id="{52FDB377-D333-44DF-A914-1CFE5000735D}"/>
               </a:ext>
             </a:extLst>
           </p:cNvPr>
@@ -7742,7 +7742,7 @@
           <p:cNvPr id="31" name="flow-64">
             <a:extLst xmlns:a="http://schemas.openxmlformats.org/drawingml/2006/main">
               <a:ext uri="{FF2B5EF4-FFF2-40B4-BE49-F238E27FC236}">
-                <a16:creationId xmlns:a16="http://schemas.microsoft.com/office/drawing/2014/main" id="{437323D9-BDDE-49FD-B876-B365128356E5}"/>
+                <a16:creationId xmlns:a16="http://schemas.microsoft.com/office/drawing/2014/main" id="{42DCDD48-F720-41BE-8CA4-47E67C4031C2}"/>
               </a:ext>
             </a:extLst>
           </p:cNvPr>
@@ -7770,7 +7770,7 @@
           <p:cNvPr id="32" name="flow-65">
             <a:extLst xmlns:a="http://schemas.openxmlformats.org/drawingml/2006/main">
               <a:ext uri="{FF2B5EF4-FFF2-40B4-BE49-F238E27FC236}">
-                <a16:creationId xmlns:a16="http://schemas.microsoft.com/office/drawing/2014/main" id="{92FC9F92-495A-4D8E-98E4-8609C71708BE}"/>
+                <a16:creationId xmlns:a16="http://schemas.microsoft.com/office/drawing/2014/main" id="{FC0B672E-8C0B-463B-84AC-547B4A21A1F1}"/>
               </a:ext>
             </a:extLst>
           </p:cNvPr>
@@ -7798,7 +7798,7 @@
           <p:cNvPr id="33" name="flow-66">
             <a:extLst xmlns:a="http://schemas.openxmlformats.org/drawingml/2006/main">
               <a:ext uri="{FF2B5EF4-FFF2-40B4-BE49-F238E27FC236}">
-                <a16:creationId xmlns:a16="http://schemas.microsoft.com/office/drawing/2014/main" id="{27E92EDE-C8F0-4BA6-A8FD-FB94225210FB}"/>
+                <a16:creationId xmlns:a16="http://schemas.microsoft.com/office/drawing/2014/main" id="{B640F174-F1E0-497D-9292-886BDA9A4790}"/>
               </a:ext>
             </a:extLst>
           </p:cNvPr>
@@ -8066,7 +8066,7 @@
           <p:cNvPr id="18" name="">
             <a:extLst xmlns:a="http://schemas.openxmlformats.org/drawingml/2006/main">
               <a:ext uri="{FF2B5EF4-FFF2-40B4-BE49-F238E27FC236}">
-                <a16:creationId xmlns:a16="http://schemas.microsoft.com/office/drawing/2014/main" id="{DECA0952-A5AE-4EF1-BC35-188518497DDE}"/>
+                <a16:creationId xmlns:a16="http://schemas.microsoft.com/office/drawing/2014/main" id="{317B2169-A795-454D-A65B-7120C58EE562}"/>
               </a:ext>
             </a:extLst>
           </p:cNvPr>
@@ -9269,7 +9269,7 @@
           <p:cNvPr id="20" name="flow-88">
             <a:extLst xmlns:a="http://schemas.openxmlformats.org/drawingml/2006/main">
               <a:ext uri="{FF2B5EF4-FFF2-40B4-BE49-F238E27FC236}">
-                <a16:creationId xmlns:a16="http://schemas.microsoft.com/office/drawing/2014/main" id="{9BADED30-1D23-447C-9A14-4A0047A4507E}"/>
+                <a16:creationId xmlns:a16="http://schemas.microsoft.com/office/drawing/2014/main" id="{7D9B7B94-4EBB-4DF0-85DD-066C6DE5CD32}"/>
               </a:ext>
             </a:extLst>
           </p:cNvPr>
@@ -9297,7 +9297,7 @@
           <p:cNvPr id="21" name="flow-89">
             <a:extLst xmlns:a="http://schemas.openxmlformats.org/drawingml/2006/main">
               <a:ext uri="{FF2B5EF4-FFF2-40B4-BE49-F238E27FC236}">
-                <a16:creationId xmlns:a16="http://schemas.microsoft.com/office/drawing/2014/main" id="{17F6B08D-AB40-4300-88BA-A58AB8F7B8A7}"/>
+                <a16:creationId xmlns:a16="http://schemas.microsoft.com/office/drawing/2014/main" id="{B9C2B235-21EC-4B3A-8BEC-3075251078FD}"/>
               </a:ext>
             </a:extLst>
           </p:cNvPr>
@@ -9325,7 +9325,7 @@
           <p:cNvPr id="22" name="flow-90">
             <a:extLst xmlns:a="http://schemas.openxmlformats.org/drawingml/2006/main">
               <a:ext uri="{FF2B5EF4-FFF2-40B4-BE49-F238E27FC236}">
-                <a16:creationId xmlns:a16="http://schemas.microsoft.com/office/drawing/2014/main" id="{1A4C0FAB-1733-45A1-B19E-E20BC73A8DA4}"/>
+                <a16:creationId xmlns:a16="http://schemas.microsoft.com/office/drawing/2014/main" id="{1B55A4BE-0C7C-4C4D-88A0-6E5F6208D871}"/>
               </a:ext>
             </a:extLst>
           </p:cNvPr>
@@ -9448,7 +9448,7 @@
           <p:cNvPr id="24" name="flow-92">
             <a:extLst xmlns:a="http://schemas.openxmlformats.org/drawingml/2006/main">
               <a:ext uri="{FF2B5EF4-FFF2-40B4-BE49-F238E27FC236}">
-                <a16:creationId xmlns:a16="http://schemas.microsoft.com/office/drawing/2014/main" id="{353F0194-201E-4415-B09A-B947DD491531}"/>
+                <a16:creationId xmlns:a16="http://schemas.microsoft.com/office/drawing/2014/main" id="{A7E9E000-2FBE-4EC2-BE5E-8CA255134ECA}"/>
               </a:ext>
             </a:extLst>
           </p:cNvPr>
@@ -9476,7 +9476,7 @@
           <p:cNvPr id="25" name="flow-93">
             <a:extLst xmlns:a="http://schemas.openxmlformats.org/drawingml/2006/main">
               <a:ext uri="{FF2B5EF4-FFF2-40B4-BE49-F238E27FC236}">
-                <a16:creationId xmlns:a16="http://schemas.microsoft.com/office/drawing/2014/main" id="{4D0DDC02-9908-4199-BEB1-12E90958EA04}"/>
+                <a16:creationId xmlns:a16="http://schemas.microsoft.com/office/drawing/2014/main" id="{B6651FB7-F8F9-4373-9196-184B622A2782}"/>
               </a:ext>
             </a:extLst>
           </p:cNvPr>
@@ -9504,7 +9504,7 @@
           <p:cNvPr id="26" name="flow-94">
             <a:extLst xmlns:a="http://schemas.openxmlformats.org/drawingml/2006/main">
               <a:ext uri="{FF2B5EF4-FFF2-40B4-BE49-F238E27FC236}">
-                <a16:creationId xmlns:a16="http://schemas.microsoft.com/office/drawing/2014/main" id="{BBB48D46-F608-4E32-B988-9555A3F71873}"/>
+                <a16:creationId xmlns:a16="http://schemas.microsoft.com/office/drawing/2014/main" id="{743C0879-2E0E-42EC-902E-E9E36EB928B3}"/>
               </a:ext>
             </a:extLst>
           </p:cNvPr>
@@ -9627,7 +9627,7 @@
           <p:cNvPr id="28" name="flow-96">
             <a:extLst xmlns:a="http://schemas.openxmlformats.org/drawingml/2006/main">
               <a:ext uri="{FF2B5EF4-FFF2-40B4-BE49-F238E27FC236}">
-                <a16:creationId xmlns:a16="http://schemas.microsoft.com/office/drawing/2014/main" id="{608359F2-D64F-4389-A83B-0BCF4A5ED334}"/>
+                <a16:creationId xmlns:a16="http://schemas.microsoft.com/office/drawing/2014/main" id="{507793A7-002C-4DD6-B579-DDBBCD316DDF}"/>
               </a:ext>
             </a:extLst>
           </p:cNvPr>
@@ -9655,7 +9655,7 @@
           <p:cNvPr id="29" name="flow-97">
             <a:extLst xmlns:a="http://schemas.openxmlformats.org/drawingml/2006/main">
               <a:ext uri="{FF2B5EF4-FFF2-40B4-BE49-F238E27FC236}">
-                <a16:creationId xmlns:a16="http://schemas.microsoft.com/office/drawing/2014/main" id="{286DFED1-7A34-4E76-A237-DE581A3B9BB5}"/>
+                <a16:creationId xmlns:a16="http://schemas.microsoft.com/office/drawing/2014/main" id="{D7F4B9D6-8C49-4324-B5C3-735A4C88913C}"/>
               </a:ext>
             </a:extLst>
           </p:cNvPr>
@@ -10041,7 +10041,7 @@
           <p:cNvPr id="35" name="">
             <a:extLst xmlns:a="http://schemas.openxmlformats.org/drawingml/2006/main">
               <a:ext uri="{FF2B5EF4-FFF2-40B4-BE49-F238E27FC236}">
-                <a16:creationId xmlns:a16="http://schemas.microsoft.com/office/drawing/2014/main" id="{6753F9C8-ABA5-4BDB-8451-0AA031A374BF}"/>
+                <a16:creationId xmlns:a16="http://schemas.microsoft.com/office/drawing/2014/main" id="{3D1A79F3-E5EF-471C-8386-0A47F0BBCBA8}"/>
               </a:ext>
             </a:extLst>
           </p:cNvPr>
@@ -10073,7 +10073,7 @@
           <p:cNvPr id="34" name="">
             <a:extLst xmlns:a="http://schemas.openxmlformats.org/drawingml/2006/main">
               <a:ext uri="{FF2B5EF4-FFF2-40B4-BE49-F238E27FC236}">
-                <a16:creationId xmlns:a16="http://schemas.microsoft.com/office/drawing/2014/main" id="{A8520DE8-0FEE-4F46-975D-A25F3FBAB3A1}"/>
+                <a16:creationId xmlns:a16="http://schemas.microsoft.com/office/drawing/2014/main" id="{81BBABB7-3B1E-49A6-AAF3-2B11F74EB344}"/>
               </a:ext>
             </a:extLst>
           </p:cNvPr>
@@ -10105,7 +10105,7 @@
           <p:cNvPr id="33" name="">
             <a:extLst xmlns:a="http://schemas.openxmlformats.org/drawingml/2006/main">
               <a:ext uri="{FF2B5EF4-FFF2-40B4-BE49-F238E27FC236}">
-                <a16:creationId xmlns:a16="http://schemas.microsoft.com/office/drawing/2014/main" id="{8A0B3494-667D-4A5E-BB7E-8F1CEE1290E5}"/>
+                <a16:creationId xmlns:a16="http://schemas.microsoft.com/office/drawing/2014/main" id="{7427B4A4-47C9-42B7-9B79-6271F3458A25}"/>
               </a:ext>
             </a:extLst>
           </p:cNvPr>
@@ -10137,7 +10137,7 @@
           <p:cNvPr id="13" name="">
             <a:extLst xmlns:a="http://schemas.openxmlformats.org/drawingml/2006/main">
               <a:ext uri="{FF2B5EF4-FFF2-40B4-BE49-F238E27FC236}">
-                <a16:creationId xmlns:a16="http://schemas.microsoft.com/office/drawing/2014/main" id="{734540C0-A867-4344-AD26-ADA92C7351DB}"/>
+                <a16:creationId xmlns:a16="http://schemas.microsoft.com/office/drawing/2014/main" id="{ABCFD886-BD86-4E86-8609-8A068D05BDB0}"/>
               </a:ext>
             </a:extLst>
           </p:cNvPr>
@@ -10169,7 +10169,7 @@
           <p:cNvPr id="12" name="">
             <a:extLst xmlns:a="http://schemas.openxmlformats.org/drawingml/2006/main">
               <a:ext uri="{FF2B5EF4-FFF2-40B4-BE49-F238E27FC236}">
-                <a16:creationId xmlns:a16="http://schemas.microsoft.com/office/drawing/2014/main" id="{0271DA71-397E-4917-84A5-B7F45DCE205E}"/>
+                <a16:creationId xmlns:a16="http://schemas.microsoft.com/office/drawing/2014/main" id="{8ACDD802-0FEA-4DEA-89E9-4BA6734ABAAA}"/>
               </a:ext>
             </a:extLst>
           </p:cNvPr>
@@ -10956,7 +10956,7 @@
           <p:cNvPr id="14" name="flow-113">
             <a:extLst xmlns:a="http://schemas.openxmlformats.org/drawingml/2006/main">
               <a:ext uri="{FF2B5EF4-FFF2-40B4-BE49-F238E27FC236}">
-                <a16:creationId xmlns:a16="http://schemas.microsoft.com/office/drawing/2014/main" id="{6F8A72F4-BEE7-4011-9708-227AE07F042B}"/>
+                <a16:creationId xmlns:a16="http://schemas.microsoft.com/office/drawing/2014/main" id="{46BF9B33-9CCB-49BB-9D7C-871116C5E191}"/>
               </a:ext>
             </a:extLst>
           </p:cNvPr>
@@ -10984,7 +10984,7 @@
           <p:cNvPr id="15" name="flow-114">
             <a:extLst xmlns:a="http://schemas.openxmlformats.org/drawingml/2006/main">
               <a:ext uri="{FF2B5EF4-FFF2-40B4-BE49-F238E27FC236}">
-                <a16:creationId xmlns:a16="http://schemas.microsoft.com/office/drawing/2014/main" id="{B5616EFD-998E-498A-BF67-6D075C725D74}"/>
+                <a16:creationId xmlns:a16="http://schemas.microsoft.com/office/drawing/2014/main" id="{E47135E9-968E-44B3-9C3F-4F0333EB123D}"/>
               </a:ext>
             </a:extLst>
           </p:cNvPr>
@@ -11012,7 +11012,7 @@
           <p:cNvPr id="16" name="flow-115">
             <a:extLst xmlns:a="http://schemas.openxmlformats.org/drawingml/2006/main">
               <a:ext uri="{FF2B5EF4-FFF2-40B4-BE49-F238E27FC236}">
-                <a16:creationId xmlns:a16="http://schemas.microsoft.com/office/drawing/2014/main" id="{98188FFB-72F2-4E38-8187-7EE474F358D1}"/>
+                <a16:creationId xmlns:a16="http://schemas.microsoft.com/office/drawing/2014/main" id="{5314AF79-BAEF-4D59-82B7-ECEAA3EDADD6}"/>
               </a:ext>
             </a:extLst>
           </p:cNvPr>
@@ -11040,7 +11040,7 @@
           <p:cNvPr id="17" name="flow-116">
             <a:extLst xmlns:a="http://schemas.openxmlformats.org/drawingml/2006/main">
               <a:ext uri="{FF2B5EF4-FFF2-40B4-BE49-F238E27FC236}">
-                <a16:creationId xmlns:a16="http://schemas.microsoft.com/office/drawing/2014/main" id="{62A00B62-5A5D-4618-A879-B0B288AA08F8}"/>
+                <a16:creationId xmlns:a16="http://schemas.microsoft.com/office/drawing/2014/main" id="{8B112F7F-2A59-4D7C-B48F-8FE0200477BB}"/>
               </a:ext>
             </a:extLst>
           </p:cNvPr>
@@ -11927,7 +11927,7 @@
           <p:cNvPr id="31" name="flow-130">
             <a:extLst xmlns:a="http://schemas.openxmlformats.org/drawingml/2006/main">
               <a:ext uri="{FF2B5EF4-FFF2-40B4-BE49-F238E27FC236}">
-                <a16:creationId xmlns:a16="http://schemas.microsoft.com/office/drawing/2014/main" id="{4E4A780B-08C1-4041-B576-E66AFA728FFD}"/>
+                <a16:creationId xmlns:a16="http://schemas.microsoft.com/office/drawing/2014/main" id="{37AE7F39-04A1-44E8-A668-EFB1DA347DFE}"/>
               </a:ext>
             </a:extLst>
           </p:cNvPr>
@@ -12518,7 +12518,7 @@
           <p:cNvPr id="43" name="partner-flow-1">
             <a:extLst xmlns:a="http://schemas.openxmlformats.org/drawingml/2006/main">
               <a:ext uri="{FF2B5EF4-FFF2-40B4-BE49-F238E27FC236}">
-                <a16:creationId xmlns:a16="http://schemas.microsoft.com/office/drawing/2014/main" id="{6FEE8CDB-EF48-4810-85A4-F875D5170719}"/>
+                <a16:creationId xmlns:a16="http://schemas.microsoft.com/office/drawing/2014/main" id="{8C50AE15-C344-4114-8408-E3D463D49815}"/>
               </a:ext>
             </a:extLst>
           </p:cNvPr>
@@ -12546,7 +12546,7 @@
           <p:cNvPr id="44" name="partner-flow-2">
             <a:extLst xmlns:a="http://schemas.openxmlformats.org/drawingml/2006/main">
               <a:ext uri="{FF2B5EF4-FFF2-40B4-BE49-F238E27FC236}">
-                <a16:creationId xmlns:a16="http://schemas.microsoft.com/office/drawing/2014/main" id="{13B3A6DD-17DC-428E-8FED-0E69723DB0B1}"/>
+                <a16:creationId xmlns:a16="http://schemas.microsoft.com/office/drawing/2014/main" id="{F847D156-086C-4D76-BD6A-0D204D87C04C}"/>
               </a:ext>
             </a:extLst>
           </p:cNvPr>
@@ -12574,7 +12574,7 @@
           <p:cNvPr id="45" name="partner-flow-3">
             <a:extLst xmlns:a="http://schemas.openxmlformats.org/drawingml/2006/main">
               <a:ext uri="{FF2B5EF4-FFF2-40B4-BE49-F238E27FC236}">
-                <a16:creationId xmlns:a16="http://schemas.microsoft.com/office/drawing/2014/main" id="{0CA005FF-DD34-41CA-9592-F3CA1EEB98B7}"/>
+                <a16:creationId xmlns:a16="http://schemas.microsoft.com/office/drawing/2014/main" id="{3E2F194F-C69A-41A1-83DF-C3C6881A3D7E}"/>
               </a:ext>
             </a:extLst>
           </p:cNvPr>
@@ -12602,7 +12602,7 @@
           <p:cNvPr id="46" name="partner-flow-4">
             <a:extLst xmlns:a="http://schemas.openxmlformats.org/drawingml/2006/main">
               <a:ext uri="{FF2B5EF4-FFF2-40B4-BE49-F238E27FC236}">
-                <a16:creationId xmlns:a16="http://schemas.microsoft.com/office/drawing/2014/main" id="{A7B26F48-7BBB-4A2C-81F8-784473F4FF36}"/>
+                <a16:creationId xmlns:a16="http://schemas.microsoft.com/office/drawing/2014/main" id="{455FBE7F-8646-43FE-ABA5-462DDEEBEBF1}"/>
               </a:ext>
             </a:extLst>
           </p:cNvPr>
@@ -12660,7 +12660,7 @@
           <p:cNvPr id="25" name="">
             <a:extLst xmlns:a="http://schemas.openxmlformats.org/drawingml/2006/main">
               <a:ext uri="{FF2B5EF4-FFF2-40B4-BE49-F238E27FC236}">
-                <a16:creationId xmlns:a16="http://schemas.microsoft.com/office/drawing/2014/main" id="{CE648481-E213-4766-B725-664F04AE8B56}"/>
+                <a16:creationId xmlns:a16="http://schemas.microsoft.com/office/drawing/2014/main" id="{A1859A7E-8DE6-4351-A350-0C242B9D0073}"/>
               </a:ext>
             </a:extLst>
           </p:cNvPr>
@@ -12972,7 +12972,7 @@
           <p:cNvPr id="5" name="flow-142">
             <a:extLst xmlns:a="http://schemas.openxmlformats.org/drawingml/2006/main">
               <a:ext uri="{FF2B5EF4-FFF2-40B4-BE49-F238E27FC236}">
-                <a16:creationId xmlns:a16="http://schemas.microsoft.com/office/drawing/2014/main" id="{F77D2F70-7348-482F-82EA-24538E7012AA}"/>
+                <a16:creationId xmlns:a16="http://schemas.microsoft.com/office/drawing/2014/main" id="{D18FAB8B-9B1D-4CFC-B596-E9B959C813D2}"/>
               </a:ext>
             </a:extLst>
           </p:cNvPr>
@@ -13889,7 +13889,7 @@
           <p:cNvPr id="21" name="flow-158">
             <a:extLst xmlns:a="http://schemas.openxmlformats.org/drawingml/2006/main">
               <a:ext uri="{FF2B5EF4-FFF2-40B4-BE49-F238E27FC236}">
-                <a16:creationId xmlns:a16="http://schemas.microsoft.com/office/drawing/2014/main" id="{E8132D6A-DF5C-4820-9BD1-577386387945}"/>
+                <a16:creationId xmlns:a16="http://schemas.microsoft.com/office/drawing/2014/main" id="{66349483-5A50-40B0-B266-21302A63AFCB}"/>
               </a:ext>
             </a:extLst>
           </p:cNvPr>
@@ -14160,7 +14160,7 @@
           <p:cNvPr id="27" name="flow-163">
             <a:extLst xmlns:a="http://schemas.openxmlformats.org/drawingml/2006/main">
               <a:ext uri="{FF2B5EF4-FFF2-40B4-BE49-F238E27FC236}">
-                <a16:creationId xmlns:a16="http://schemas.microsoft.com/office/drawing/2014/main" id="{7DAC9C2F-F2BC-4466-9246-2038A6F8CA60}"/>
+                <a16:creationId xmlns:a16="http://schemas.microsoft.com/office/drawing/2014/main" id="{8C9A3D5C-7BE3-4AF8-9C40-FB51EDBAD22C}"/>
               </a:ext>
             </a:extLst>
           </p:cNvPr>
@@ -14188,7 +14188,7 @@
           <p:cNvPr id="28" name="flow-164">
             <a:extLst xmlns:a="http://schemas.openxmlformats.org/drawingml/2006/main">
               <a:ext uri="{FF2B5EF4-FFF2-40B4-BE49-F238E27FC236}">
-                <a16:creationId xmlns:a16="http://schemas.microsoft.com/office/drawing/2014/main" id="{63D8DB00-EDD4-4C04-AF3C-8B2376467571}"/>
+                <a16:creationId xmlns:a16="http://schemas.microsoft.com/office/drawing/2014/main" id="{41AC155E-C29D-4FBE-9125-71875122CF68}"/>
               </a:ext>
             </a:extLst>
           </p:cNvPr>
@@ -14216,7 +14216,7 @@
           <p:cNvPr id="29" name="flow-165">
             <a:extLst xmlns:a="http://schemas.openxmlformats.org/drawingml/2006/main">
               <a:ext uri="{FF2B5EF4-FFF2-40B4-BE49-F238E27FC236}">
-                <a16:creationId xmlns:a16="http://schemas.microsoft.com/office/drawing/2014/main" id="{7F810F66-A750-4E84-A297-124DE9FF9B95}"/>
+                <a16:creationId xmlns:a16="http://schemas.microsoft.com/office/drawing/2014/main" id="{46B354BC-263C-4A31-AB01-93B52D5100DC}"/>
               </a:ext>
             </a:extLst>
           </p:cNvPr>
@@ -14315,7 +14315,7 @@
           <p:cNvPr id="31" name="flow-167">
             <a:extLst xmlns:a="http://schemas.openxmlformats.org/drawingml/2006/main">
               <a:ext uri="{FF2B5EF4-FFF2-40B4-BE49-F238E27FC236}">
-                <a16:creationId xmlns:a16="http://schemas.microsoft.com/office/drawing/2014/main" id="{39173D0C-1C64-40F2-BCC9-0281AD3DF8BF}"/>
+                <a16:creationId xmlns:a16="http://schemas.microsoft.com/office/drawing/2014/main" id="{6E9984F7-475E-4988-8BD3-A0D2C5175F98}"/>
               </a:ext>
             </a:extLst>
           </p:cNvPr>
@@ -14414,7 +14414,7 @@
           <p:cNvPr id="33" name="flow-169">
             <a:extLst xmlns:a="http://schemas.openxmlformats.org/drawingml/2006/main">
               <a:ext uri="{FF2B5EF4-FFF2-40B4-BE49-F238E27FC236}">
-                <a16:creationId xmlns:a16="http://schemas.microsoft.com/office/drawing/2014/main" id="{D9240F99-73AB-449F-9BA9-95007E36EBC8}"/>
+                <a16:creationId xmlns:a16="http://schemas.microsoft.com/office/drawing/2014/main" id="{FF5185BC-DC54-4EE1-B87B-EC47F60BD949}"/>
               </a:ext>
             </a:extLst>
           </p:cNvPr>
@@ -14513,7 +14513,7 @@
           <p:cNvPr id="35" name="flow-171">
             <a:extLst xmlns:a="http://schemas.openxmlformats.org/drawingml/2006/main">
               <a:ext uri="{FF2B5EF4-FFF2-40B4-BE49-F238E27FC236}">
-                <a16:creationId xmlns:a16="http://schemas.microsoft.com/office/drawing/2014/main" id="{92399F74-D275-4F65-AF64-A9B84735129B}"/>
+                <a16:creationId xmlns:a16="http://schemas.microsoft.com/office/drawing/2014/main" id="{B64E98BC-F4C7-4173-9032-9C1E8C8381CC}"/>
               </a:ext>
             </a:extLst>
           </p:cNvPr>
@@ -14541,7 +14541,7 @@
           <p:cNvPr id="36" name="flow-172">
             <a:extLst xmlns:a="http://schemas.openxmlformats.org/drawingml/2006/main">
               <a:ext uri="{FF2B5EF4-FFF2-40B4-BE49-F238E27FC236}">
-                <a16:creationId xmlns:a16="http://schemas.microsoft.com/office/drawing/2014/main" id="{F0BA96DC-3A62-432E-A9B6-C98F9A217455}"/>
+                <a16:creationId xmlns:a16="http://schemas.microsoft.com/office/drawing/2014/main" id="{92BA4FDE-B06D-4423-8C76-41FB57E367FF}"/>
               </a:ext>
             </a:extLst>
           </p:cNvPr>
@@ -14569,7 +14569,7 @@
           <p:cNvPr id="37" name="flow-173">
             <a:extLst xmlns:a="http://schemas.openxmlformats.org/drawingml/2006/main">
               <a:ext uri="{FF2B5EF4-FFF2-40B4-BE49-F238E27FC236}">
-                <a16:creationId xmlns:a16="http://schemas.microsoft.com/office/drawing/2014/main" id="{BCFB4E87-782C-4E00-B162-0F824ABD4131}"/>
+                <a16:creationId xmlns:a16="http://schemas.microsoft.com/office/drawing/2014/main" id="{EB283368-94A3-45DC-B582-7DF3AEAEB353}"/>
               </a:ext>
             </a:extLst>
           </p:cNvPr>
@@ -14668,7 +14668,7 @@
           <p:cNvPr id="39" name="flow-175">
             <a:extLst xmlns:a="http://schemas.openxmlformats.org/drawingml/2006/main">
               <a:ext uri="{FF2B5EF4-FFF2-40B4-BE49-F238E27FC236}">
-                <a16:creationId xmlns:a16="http://schemas.microsoft.com/office/drawing/2014/main" id="{D679E7C8-0F3E-4417-8481-1E324B2D9A58}"/>
+                <a16:creationId xmlns:a16="http://schemas.microsoft.com/office/drawing/2014/main" id="{AE8BA6A1-1C3B-49E0-A662-A56C3AABA7F2}"/>
               </a:ext>
             </a:extLst>
           </p:cNvPr>
@@ -14696,7 +14696,7 @@
           <p:cNvPr id="40" name="flow-176">
             <a:extLst xmlns:a="http://schemas.openxmlformats.org/drawingml/2006/main">
               <a:ext uri="{FF2B5EF4-FFF2-40B4-BE49-F238E27FC236}">
-                <a16:creationId xmlns:a16="http://schemas.microsoft.com/office/drawing/2014/main" id="{62FD829B-4DB9-41CE-ABDD-308A873DFBF0}"/>
+                <a16:creationId xmlns:a16="http://schemas.microsoft.com/office/drawing/2014/main" id="{600CE152-AE3D-46D4-A504-B5F6D7534253}"/>
               </a:ext>
             </a:extLst>
           </p:cNvPr>
@@ -14724,7 +14724,7 @@
           <p:cNvPr id="41" name="flow-177">
             <a:extLst xmlns:a="http://schemas.openxmlformats.org/drawingml/2006/main">
               <a:ext uri="{FF2B5EF4-FFF2-40B4-BE49-F238E27FC236}">
-                <a16:creationId xmlns:a16="http://schemas.microsoft.com/office/drawing/2014/main" id="{CD2C4D8B-0EB3-4070-881B-DB0D682C8B99}"/>
+                <a16:creationId xmlns:a16="http://schemas.microsoft.com/office/drawing/2014/main" id="{C726FAEB-C2E6-4AA7-AFFC-1499C7D9E3D7}"/>
               </a:ext>
             </a:extLst>
           </p:cNvPr>
@@ -14752,7 +14752,7 @@
           <p:cNvPr id="42" name="flow-178">
             <a:extLst xmlns:a="http://schemas.openxmlformats.org/drawingml/2006/main">
               <a:ext uri="{FF2B5EF4-FFF2-40B4-BE49-F238E27FC236}">
-                <a16:creationId xmlns:a16="http://schemas.microsoft.com/office/drawing/2014/main" id="{27B7E246-FD78-4935-8380-92471A373CDD}"/>
+                <a16:creationId xmlns:a16="http://schemas.microsoft.com/office/drawing/2014/main" id="{D1A4B1E5-77BC-4442-A91F-5D31790F5FF1}"/>
               </a:ext>
             </a:extLst>
           </p:cNvPr>
@@ -15626,7 +15626,7 @@
           <p:cNvPr id="10" name="partner-flow-14">
             <a:extLst xmlns:a="http://schemas.openxmlformats.org/drawingml/2006/main">
               <a:ext uri="{FF2B5EF4-FFF2-40B4-BE49-F238E27FC236}">
-                <a16:creationId xmlns:a16="http://schemas.microsoft.com/office/drawing/2014/main" id="{51DA2BF7-A7AC-4CB3-91DD-AA026B46E8E7}"/>
+                <a16:creationId xmlns:a16="http://schemas.microsoft.com/office/drawing/2014/main" id="{7053BFAA-4CC8-4864-BFDF-5911A6EB9E33}"/>
               </a:ext>
             </a:extLst>
           </p:cNvPr>
@@ -15971,7 +15971,7 @@
           <p:cNvPr id="15" name="partner-flow-19">
             <a:extLst xmlns:a="http://schemas.openxmlformats.org/drawingml/2006/main">
               <a:ext uri="{FF2B5EF4-FFF2-40B4-BE49-F238E27FC236}">
-                <a16:creationId xmlns:a16="http://schemas.microsoft.com/office/drawing/2014/main" id="{8A225777-A9F9-4487-A78F-9871F07B4557}"/>
+                <a16:creationId xmlns:a16="http://schemas.microsoft.com/office/drawing/2014/main" id="{3C810182-40BC-457E-98DE-F040AB5F0D8D}"/>
               </a:ext>
             </a:extLst>
           </p:cNvPr>
@@ -16267,7 +16267,7 @@
           <p:cNvPr id="20" name="partner-flow-24">
             <a:extLst xmlns:a="http://schemas.openxmlformats.org/drawingml/2006/main">
               <a:ext uri="{FF2B5EF4-FFF2-40B4-BE49-F238E27FC236}">
-                <a16:creationId xmlns:a16="http://schemas.microsoft.com/office/drawing/2014/main" id="{8EBC962B-A53D-47DF-A8BC-73378EF45E19}"/>
+                <a16:creationId xmlns:a16="http://schemas.microsoft.com/office/drawing/2014/main" id="{2FF0F711-F536-4B8A-AD68-D7346A2A1B1B}"/>
               </a:ext>
             </a:extLst>
           </p:cNvPr>
@@ -16295,7 +16295,7 @@
           <p:cNvPr id="21" name="partner-flow-25">
             <a:extLst xmlns:a="http://schemas.openxmlformats.org/drawingml/2006/main">
               <a:ext uri="{FF2B5EF4-FFF2-40B4-BE49-F238E27FC236}">
-                <a16:creationId xmlns:a16="http://schemas.microsoft.com/office/drawing/2014/main" id="{B2AE613A-5FD9-4122-98CF-EDECD6E43EB9}"/>
+                <a16:creationId xmlns:a16="http://schemas.microsoft.com/office/drawing/2014/main" id="{CE6CCB48-8545-4F96-91F8-28E517050973}"/>
               </a:ext>
             </a:extLst>
           </p:cNvPr>
@@ -16323,7 +16323,7 @@
           <p:cNvPr id="22" name="partner-flow-26">
             <a:extLst xmlns:a="http://schemas.openxmlformats.org/drawingml/2006/main">
               <a:ext uri="{FF2B5EF4-FFF2-40B4-BE49-F238E27FC236}">
-                <a16:creationId xmlns:a16="http://schemas.microsoft.com/office/drawing/2014/main" id="{E275A90E-92B8-41AB-9E96-DED585E6BAA8}"/>
+                <a16:creationId xmlns:a16="http://schemas.microsoft.com/office/drawing/2014/main" id="{846A3AF9-44FE-4F69-8C01-7767FB217587}"/>
               </a:ext>
             </a:extLst>
           </p:cNvPr>
@@ -17757,7 +17757,7 @@
           <p:cNvPr id="16" name="partner-flow-45">
             <a:extLst xmlns:a="http://schemas.openxmlformats.org/drawingml/2006/main">
               <a:ext uri="{FF2B5EF4-FFF2-40B4-BE49-F238E27FC236}">
-                <a16:creationId xmlns:a16="http://schemas.microsoft.com/office/drawing/2014/main" id="{FF1704F4-A287-4A95-9010-AB47A24D486B}"/>
+                <a16:creationId xmlns:a16="http://schemas.microsoft.com/office/drawing/2014/main" id="{A9B15B4F-E453-4BE4-B5B7-DB41D0C47AA4}"/>
               </a:ext>
             </a:extLst>
           </p:cNvPr>
@@ -17786,7 +17786,7 @@
           <p:cNvPr id="17" name="partner-flow-46">
             <a:extLst xmlns:a="http://schemas.openxmlformats.org/drawingml/2006/main">
               <a:ext uri="{FF2B5EF4-FFF2-40B4-BE49-F238E27FC236}">
-                <a16:creationId xmlns:a16="http://schemas.microsoft.com/office/drawing/2014/main" id="{CB2D629C-83A8-4F52-9FF0-E2F6B8B25335}"/>
+                <a16:creationId xmlns:a16="http://schemas.microsoft.com/office/drawing/2014/main" id="{213E47D0-76F3-43CA-ACA0-3BE813120F9E}"/>
               </a:ext>
             </a:extLst>
           </p:cNvPr>
@@ -17815,7 +17815,7 @@
           <p:cNvPr id="18" name="partner-flow-47">
             <a:extLst xmlns:a="http://schemas.openxmlformats.org/drawingml/2006/main">
               <a:ext uri="{FF2B5EF4-FFF2-40B4-BE49-F238E27FC236}">
-                <a16:creationId xmlns:a16="http://schemas.microsoft.com/office/drawing/2014/main" id="{E3BD4EE7-BE1F-482D-AFB4-1C4C88F936C3}"/>
+                <a16:creationId xmlns:a16="http://schemas.microsoft.com/office/drawing/2014/main" id="{F39F82FC-2DA1-4CB9-9D10-51547946F5F3}"/>
               </a:ext>
             </a:extLst>
           </p:cNvPr>
@@ -17844,7 +17844,7 @@
           <p:cNvPr id="19" name="partner-flow-48">
             <a:extLst xmlns:a="http://schemas.openxmlformats.org/drawingml/2006/main">
               <a:ext uri="{FF2B5EF4-FFF2-40B4-BE49-F238E27FC236}">
-                <a16:creationId xmlns:a16="http://schemas.microsoft.com/office/drawing/2014/main" id="{7A6E6096-9326-449A-9966-D3D9DE760418}"/>
+                <a16:creationId xmlns:a16="http://schemas.microsoft.com/office/drawing/2014/main" id="{823279A2-F902-45C2-BED8-927CC8DB361E}"/>
               </a:ext>
             </a:extLst>
           </p:cNvPr>
@@ -17872,7 +17872,7 @@
           <p:cNvPr id="20" name="partner-flow-49">
             <a:extLst xmlns:a="http://schemas.openxmlformats.org/drawingml/2006/main">
               <a:ext uri="{FF2B5EF4-FFF2-40B4-BE49-F238E27FC236}">
-                <a16:creationId xmlns:a16="http://schemas.microsoft.com/office/drawing/2014/main" id="{8FED495E-C14A-47D9-B65C-348E3E6D689E}"/>
+                <a16:creationId xmlns:a16="http://schemas.microsoft.com/office/drawing/2014/main" id="{BC3B5E22-C13A-4C15-B730-9AA440AE21F6}"/>
               </a:ext>
             </a:extLst>
           </p:cNvPr>
@@ -17900,7 +17900,7 @@
           <p:cNvPr id="21" name="partner-flow-50">
             <a:extLst xmlns:a="http://schemas.openxmlformats.org/drawingml/2006/main">
               <a:ext uri="{FF2B5EF4-FFF2-40B4-BE49-F238E27FC236}">
-                <a16:creationId xmlns:a16="http://schemas.microsoft.com/office/drawing/2014/main" id="{35BAE54A-E32D-43BA-92A8-193280A0CFA8}"/>
+                <a16:creationId xmlns:a16="http://schemas.microsoft.com/office/drawing/2014/main" id="{A0698FFB-354A-4754-9FDD-48431269D798}"/>
               </a:ext>
             </a:extLst>
           </p:cNvPr>
@@ -17999,7 +17999,7 @@
           <p:cNvPr id="23" name="partner-flow-52">
             <a:extLst xmlns:a="http://schemas.openxmlformats.org/drawingml/2006/main">
               <a:ext uri="{FF2B5EF4-FFF2-40B4-BE49-F238E27FC236}">
-                <a16:creationId xmlns:a16="http://schemas.microsoft.com/office/drawing/2014/main" id="{9CFC6A98-F4EC-4506-890F-DA0361A5B47A}"/>
+                <a16:creationId xmlns:a16="http://schemas.microsoft.com/office/drawing/2014/main" id="{31AECDA0-1654-4C82-A21C-14E41BCEC69C}"/>
               </a:ext>
             </a:extLst>
           </p:cNvPr>
@@ -18027,7 +18027,7 @@
           <p:cNvPr id="24" name="partner-flow-53">
             <a:extLst xmlns:a="http://schemas.openxmlformats.org/drawingml/2006/main">
               <a:ext uri="{FF2B5EF4-FFF2-40B4-BE49-F238E27FC236}">
-                <a16:creationId xmlns:a16="http://schemas.microsoft.com/office/drawing/2014/main" id="{B328E4D9-D7C4-45E3-9241-5BCD6E9F9986}"/>
+                <a16:creationId xmlns:a16="http://schemas.microsoft.com/office/drawing/2014/main" id="{3A00E6D0-35AF-4C68-B73B-0E7B68940C86}"/>
               </a:ext>
             </a:extLst>
           </p:cNvPr>
@@ -18055,7 +18055,7 @@
           <p:cNvPr id="25" name="partner-flow-54">
             <a:extLst xmlns:a="http://schemas.openxmlformats.org/drawingml/2006/main">
               <a:ext uri="{FF2B5EF4-FFF2-40B4-BE49-F238E27FC236}">
-                <a16:creationId xmlns:a16="http://schemas.microsoft.com/office/drawing/2014/main" id="{5E5279C2-EB2C-4D7C-A11F-AEE1697580F5}"/>
+                <a16:creationId xmlns:a16="http://schemas.microsoft.com/office/drawing/2014/main" id="{B24AFD93-EFCA-4EBC-AFC1-6B1E5A6028B5}"/>
               </a:ext>
             </a:extLst>
           </p:cNvPr>
@@ -18600,7 +18600,7 @@
           <p:cNvPr id="33" name="changed-assertions-edge-label-leader">
             <a:extLst xmlns:a="http://schemas.openxmlformats.org/drawingml/2006/main">
               <a:ext uri="{FF2B5EF4-FFF2-40B4-BE49-F238E27FC236}">
-                <a16:creationId xmlns:a16="http://schemas.microsoft.com/office/drawing/2014/main" id="{311F23B3-966B-4218-A455-38A550029C31}"/>
+                <a16:creationId xmlns:a16="http://schemas.microsoft.com/office/drawing/2014/main" id="{3BACE6B9-C148-453B-B8BE-FE0D77EF2323}"/>
               </a:ext>
             </a:extLst>
           </p:cNvPr>
@@ -18797,7 +18797,7 @@
           <p:cNvPr id="5" name="">
             <a:extLst xmlns:a="http://schemas.openxmlformats.org/drawingml/2006/main">
               <a:ext uri="{FF2B5EF4-FFF2-40B4-BE49-F238E27FC236}">
-                <a16:creationId xmlns:a16="http://schemas.microsoft.com/office/drawing/2014/main" id="{EB1581A9-0A51-43E8-ABB6-6FAA73131D38}"/>
+                <a16:creationId xmlns:a16="http://schemas.microsoft.com/office/drawing/2014/main" id="{FA08A9B3-066A-4F3F-A7DE-375642552566}"/>
               </a:ext>
             </a:extLst>
           </p:cNvPr>
@@ -19448,7 +19448,7 @@
                           <a:ea typeface="Aptos"/>
                           <a:cs typeface="Aptos"/>
                         </a:rPr>
-                        <a:t>Implement accepted review authority</a:t>
+                        <a:t>Connect production review transport</a:t>
                       </a:r>
                     </a:p>
                     <a:p>
@@ -20461,7 +20461,7 @@
           <p:cNvPr id="9" name="flow-217">
             <a:extLst xmlns:a="http://schemas.openxmlformats.org/drawingml/2006/main">
               <a:ext uri="{FF2B5EF4-FFF2-40B4-BE49-F238E27FC236}">
-                <a16:creationId xmlns:a16="http://schemas.microsoft.com/office/drawing/2014/main" id="{7D5F8869-42BF-4EC6-A3B2-D345359AD627}"/>
+                <a16:creationId xmlns:a16="http://schemas.microsoft.com/office/drawing/2014/main" id="{447003AE-9C1A-415B-8FFF-4148B3BA88B6}"/>
               </a:ext>
             </a:extLst>
           </p:cNvPr>
@@ -20490,7 +20490,7 @@
           <p:cNvPr id="10" name="flow-218">
             <a:extLst xmlns:a="http://schemas.openxmlformats.org/drawingml/2006/main">
               <a:ext uri="{FF2B5EF4-FFF2-40B4-BE49-F238E27FC236}">
-                <a16:creationId xmlns:a16="http://schemas.microsoft.com/office/drawing/2014/main" id="{6637023A-B417-4A8D-98FF-165F80707F68}"/>
+                <a16:creationId xmlns:a16="http://schemas.microsoft.com/office/drawing/2014/main" id="{23E22D28-C01A-4B8F-A184-0E16FE5BC9A9}"/>
               </a:ext>
             </a:extLst>
           </p:cNvPr>
@@ -20868,6 +20868,30 @@
               <a:t>Cloud rehearsal tooling</a:t>
             </a:r>
           </a:p>
+          <a:p xmlns:a="http://schemas.openxmlformats.org/drawingml/2006/main">
+            <a:pPr algn="l">
+              <a:buNone/>
+              <a:defRPr sz="2025" b="0">
+                <a:solidFill>
+                  <a:srgbClr val="132E38"/>
+                </a:solidFill>
+                <a:latin typeface="Aptos"/>
+                <a:ea typeface="Aptos"/>
+                <a:cs typeface="Aptos"/>
+              </a:defRPr>
+            </a:pPr>
+            <a:r>
+              <a:rPr sz="2025" b="0">
+                <a:solidFill>
+                  <a:srgbClr val="132E38"/>
+                </a:solidFill>
+                <a:latin typeface="Aptos"/>
+                <a:ea typeface="Aptos"/>
+                <a:cs typeface="Aptos"/>
+              </a:rPr>
+              <a:t>Durable review and cancellation</a:t>
+            </a:r>
+          </a:p>
         </p:txBody>
       </p:sp>
       <p:sp>
@@ -21089,7 +21113,7 @@
           <p:cNvPr id="14" name="flow-222">
             <a:extLst xmlns:a="http://schemas.openxmlformats.org/drawingml/2006/main">
               <a:ext uri="{FF2B5EF4-FFF2-40B4-BE49-F238E27FC236}">
-                <a16:creationId xmlns:a16="http://schemas.microsoft.com/office/drawing/2014/main" id="{4A45CBC6-953F-4B50-A26C-F0D8872A2F99}"/>
+                <a16:creationId xmlns:a16="http://schemas.microsoft.com/office/drawing/2014/main" id="{7082CDD1-641A-4414-9749-37D6EC064BD7}"/>
               </a:ext>
             </a:extLst>
           </p:cNvPr>

</xml_diff>

<commit_message>
docs: synchronize meeting discovery and member candidate status
</commit_message>
<xml_diff>
--- a/Inertia-Architecture.pptx
+++ b/Inertia-Architecture.pptx
@@ -2,21 +2,21 @@
 <file path=ppt/presentation.xml><?xml version="1.0" encoding="utf-8"?>
 <p:presentation xmlns:p="http://schemas.openxmlformats.org/presentationml/2006/main">
   <p:sldMasterIdLst>
-    <p:sldMasterId xmlns:r="http://schemas.openxmlformats.org/officeDocument/2006/relationships" id="2147483648" r:id="Re67716fdfb124d9f"/>
+    <p:sldMasterId xmlns:r="http://schemas.openxmlformats.org/officeDocument/2006/relationships" id="2147483648" r:id="R5e3ce0d235b54432"/>
   </p:sldMasterIdLst>
   <p:notesMasterIdLst>
-    <p:notesMasterId xmlns:r="http://schemas.openxmlformats.org/officeDocument/2006/relationships" r:id="Rb0e20b83594f454a"/>
+    <p:notesMasterId xmlns:r="http://schemas.openxmlformats.org/officeDocument/2006/relationships" r:id="R4de93270790644b3"/>
   </p:notesMasterIdLst>
   <p:sldIdLst>
-    <p:sldId xmlns:r="http://schemas.openxmlformats.org/officeDocument/2006/relationships" id="256" r:id="R03eae314aa414ed0"/>
-    <p:sldId xmlns:r="http://schemas.openxmlformats.org/officeDocument/2006/relationships" id="257" r:id="R676bf51815974a42"/>
-    <p:sldId xmlns:r="http://schemas.openxmlformats.org/officeDocument/2006/relationships" id="258" r:id="Re773d7e86bd74a4d"/>
-    <p:sldId xmlns:r="http://schemas.openxmlformats.org/officeDocument/2006/relationships" id="259" r:id="R9f0b67c8f5ea44e0"/>
-    <p:sldId xmlns:r="http://schemas.openxmlformats.org/officeDocument/2006/relationships" id="260" r:id="Rd220d56f4e4d4fdc"/>
-    <p:sldId xmlns:r="http://schemas.openxmlformats.org/officeDocument/2006/relationships" id="261" r:id="Rc6f1a977eefc4f00"/>
-    <p:sldId xmlns:r="http://schemas.openxmlformats.org/officeDocument/2006/relationships" id="262" r:id="R936733b4d6944b04"/>
-    <p:sldId xmlns:r="http://schemas.openxmlformats.org/officeDocument/2006/relationships" id="263" r:id="Rd103217cf543416a"/>
-    <p:sldId xmlns:r="http://schemas.openxmlformats.org/officeDocument/2006/relationships" id="264" r:id="R114e4421ef5c4ec8"/>
+    <p:sldId xmlns:r="http://schemas.openxmlformats.org/officeDocument/2006/relationships" id="256" r:id="R2732d204445748e9"/>
+    <p:sldId xmlns:r="http://schemas.openxmlformats.org/officeDocument/2006/relationships" id="257" r:id="R26731a1f10484fa6"/>
+    <p:sldId xmlns:r="http://schemas.openxmlformats.org/officeDocument/2006/relationships" id="258" r:id="Rc0a8e38ce5f6436b"/>
+    <p:sldId xmlns:r="http://schemas.openxmlformats.org/officeDocument/2006/relationships" id="259" r:id="R826a7a3dcd1b4353"/>
+    <p:sldId xmlns:r="http://schemas.openxmlformats.org/officeDocument/2006/relationships" id="260" r:id="Rb6f8ee8409774d33"/>
+    <p:sldId xmlns:r="http://schemas.openxmlformats.org/officeDocument/2006/relationships" id="261" r:id="R46af81d8aaf94481"/>
+    <p:sldId xmlns:r="http://schemas.openxmlformats.org/officeDocument/2006/relationships" id="262" r:id="Re7326f7df2f14630"/>
+    <p:sldId xmlns:r="http://schemas.openxmlformats.org/officeDocument/2006/relationships" id="263" r:id="R488cb08c01dd4e34"/>
+    <p:sldId xmlns:r="http://schemas.openxmlformats.org/officeDocument/2006/relationships" id="264" r:id="Rbf421dd28b304bef"/>
   </p:sldIdLst>
   <p:sldSz cx="15240000" cy="8572500"/>
   <p:notesSz cx="6858000" cy="9144000"/>
@@ -630,7 +630,7 @@
           <a:lstStyle xmlns:a="http://schemas.openxmlformats.org/drawingml/2006/main"/>
           <a:p xmlns:a="http://schemas.openxmlformats.org/drawingml/2006/main">
             <a:r>
-              <a:t>Sources: Inertia spec.md R-M01–R-M04 and R-F04; docs/integrations/dao-website-member-publication-proposal.md; dao-website-publication-v1.1-clarifications.md.</a:t>
+              <a:t>Sources: Inertia spec.md R-M01–R-M04 and R-F04; docs/development/meeting-source-native-composition.md; docs/integrations/dao-website-member-publication-proposal.md; dao-website-publication-v1.1-clarifications.md; Needed-from-team.md NTF01, NTF03 and NTF05.</a:t>
             </a:r>
           </a:p>
           <a:p xmlns:a="http://schemas.openxmlformats.org/drawingml/2006/main">
@@ -640,7 +640,7 @@
           </a:p>
           <a:p xmlns:a="http://schemas.openxmlformats.org/drawingml/2006/main">
             <a:r>
-              <a:t>Roundtable preserves original meeting sources, prepares a cleaned transcript and separate notes, and extracts source-linked candidates. Summary-only material produces notes and a missing-transcript task. Trusted admission retains exact evidence, revisions, audience and project/opportunity scope. Decisions and commitments require an authorized decision record. Published links return to the Paperclip task and Buzz thread.</a:t>
+              <a:t>The merged source job verifies Meet readiness and Drive identity/version before preparing a transcript and separate notes. It saves exact publication operations, reconciles uncertain outcomes and applies corrections through the existing website contract. New and corrected publications update one reference-only native follow-up. Summary-only sources retain a protected Drive reference and create missing-transcript work. Notes-only website output requires an approved server contract.</a:t>
             </a:r>
           </a:p>
           <a:p xmlns:a="http://schemas.openxmlformats.org/drawingml/2006/main">
@@ -650,7 +650,17 @@
           </a:p>
           <a:p xmlns:a="http://schemas.openxmlformats.org/drawingml/2006/main">
             <a:r>
-              <a:t>The objective intake/link/brief core is merged. Next: connect authorized Drive readiness, website membership/publication, action sources and trusted admission policy.</a:t>
+              <a:t>Actual pinned native PostgreSQL qualification passed ownership, source/correction flow, native issue and website acknowledgment recovery, and WAL restart preservation. Source and website responses were synthetic. The job stays disabled until approved Drive/website access, installation capabilities, source retention, transport limits and a staging canary are qualified.</a:t>
+            </a:r>
+          </a:p>
+          <a:p xmlns:a="http://schemas.openxmlformats.org/drawingml/2006/main">
+            <a:r>
+              <a:t/>
+            </a:r>
+          </a:p>
+          <a:p xmlns:a="http://schemas.openxmlformats.org/drawingml/2006/main">
+            <a:r>
+              <a:t>Trusted knowledge admission retains exact evidence, revisions, audience and project/opportunity scope. Decisions and commitments require an authorized decision record. Published links return to shared Paperclip work and its Buzz view.</a:t>
             </a:r>
           </a:p>
         </p:txBody>
@@ -820,7 +830,7 @@
           <a:lstStyle xmlns:a="http://schemas.openxmlformats.org/drawingml/2006/main"/>
           <a:p xmlns:a="http://schemas.openxmlformats.org/drawingml/2006/main">
             <a:r>
-              <a:t>Sources: Inertia spec.md §2 and R-C01–R-C05; docs/implementation/live-handoff-checklist.md.</a:t>
+              <a:t>Sources: Inertia spec.md R-C01–R-C05; docs/development/member-contribution-boundary.md; Needed-from-team.md NTF11.</a:t>
             </a:r>
           </a:p>
           <a:p xmlns:a="http://schemas.openxmlformats.org/drawingml/2006/main">
@@ -830,7 +840,7 @@
           </a:p>
           <a:p xmlns:a="http://schemas.openxmlformats.org/drawingml/2006/main">
             <a:r>
-              <a:t>An enrolled member agent receives an assigned task, authorized evidence and scoped tools in a sandbox and isolated worktree. It returns candidate evidence. Trusted services validate identity, task revision and source scope, then apply required reviews and accept the task update. A designated human supplies authenticated decisions when required. Database, admin and publisher credentials stay in trusted services.</a:t>
+              <a:t>The candidate library checks the authenticated member, exact execution attempt, enrollment, task revision, native run/checkout and artifact policy. It releases only server-curated inputs and stages immutable, untrusted candidate receipts. Exact retries converge and uncertain writes reconcile before returning a receipt. Actual pinned native services qualified candidate staging, revocation and recovery while tasks remained in progress.</a:t>
             </a:r>
           </a:p>
           <a:p xmlns:a="http://schemas.openxmlformats.org/drawingml/2006/main">
@@ -840,7 +850,7 @@
           </a:p>
           <a:p xmlns:a="http://schemas.openxmlformats.org/drawingml/2006/main">
             <a:r>
-              <a:t>Next: qualify member enrollment, live runtime isolation and contribution adapters.</a:t>
+              <a:t>Engineering must provide authenticated ingress and a fresh, non-reusable authority for each execution attempt. It also owns provider/sandbox qualification, native review handoff and final acceptance with current authority checks in the owning native transaction. The team supplies the willing participant, chosen runtime, membership reference and approved task/data scope. Database and publisher credentials stay in trusted services.</a:t>
             </a:r>
           </a:p>
         </p:txBody>
@@ -1060,7 +1070,7 @@
           </a:p>
           <a:p xmlns:a="http://schemas.openxmlformats.org/drawingml/2006/main">
             <a:r>
-              <a:t>Next: connect trusted source adapters, admit the inventory/backfill and qualify deployed graph refresh. The operational discovery loop reuses this research contract with bounded public search, official evidence capture and due rechecks.</a:t>
+              <a:t>Next: connect trusted source adapters, admit the inventory/backfill and qualify deployed graph refresh. The merged discovery foundation reuses this research contract with bounded source capture and due rechecks. Qualify the assigned research tools, admitted sources and live service path before activation.</a:t>
             </a:r>
           </a:p>
         </p:txBody>
@@ -1150,7 +1160,27 @@
           </a:p>
           <a:p xmlns:a="http://schemas.openxmlformats.org/drawingml/2006/main">
             <a:r>
-              <a:t>Next connections and component responsibilities appear in the table.</a:t>
+              <a:t>The source job and native meeting follow-up are merged. Confirm approved Drive examples/access, scoped issue capabilities and source retention, then qualify the real website/source path. Team inputs are tracked in Needed-from-team.md.</a:t>
+            </a:r>
+          </a:p>
+          <a:p xmlns:a="http://schemas.openxmlformats.org/drawingml/2006/main">
+            <a:r>
+              <a:t/>
+            </a:r>
+          </a:p>
+          <a:p xmlns:a="http://schemas.openxmlformats.org/drawingml/2006/main">
+            <a:r>
+              <a:t>Discovery uses the existing scout/diligence tasks and signed Buzz outbox. Its assigned issues need a host-resolvable active responsible member for native wake policy. NTF05 and NTF14 track runtime/tool access, scoped principals, the human audience and pilot budgets.</a:t>
+            </a:r>
+          </a:p>
+          <a:p xmlns:a="http://schemas.openxmlformats.org/drawingml/2006/main">
+            <a:r>
+              <a:t/>
+            </a:r>
+          </a:p>
+          <a:p xmlns:a="http://schemas.openxmlformats.org/drawingml/2006/main">
+            <a:r>
+              <a:t>Member candidate validation and immutable receipts are implemented. Trusted ingress, attempt-authority issuance, provider/sandbox qualification and native review/acceptance remain engineering work; NTF11 retains the participant and approved scope handoff.</a:t>
             </a:r>
           </a:p>
         </p:txBody>
@@ -1220,7 +1250,7 @@
           <a:lstStyle xmlns:a="http://schemas.openxmlformats.org/drawingml/2006/main"/>
           <a:p xmlns:a="http://schemas.openxmlformats.org/drawingml/2006/main">
             <a:r>
-              <a:t>Sources: Inertia spec.md, plan.md and testing.md; docs/development/funding-enhancement/discovery-loop.md; docs/development/objective-intake.md; scripts/cloud-rehearsal/README.md; https://github.com/NetRxn/Inertia/pull/25; https://github.com/NetRxn/Inertia/pull/26; https://github.com/NetRxn/Inertia/pull/27; https://github.com/NetRxn/Inertia/pull/28; https://github.com/NetRxn/DFW-Gov-Fund/pull/44; https://github.com/NetRxn/DFW-Gov-Fund/pull/45; https://github.com/NetRxn/DFW-Gov-Fund/pull/46; https://github.com/NetRxn/DFW-Gov-Fund/pull/47; https://github.com/NetRxn/DFW-Gov-Fund/pull/49; https://github.com/NetRxn/DFW-Gov-Fund/pull/50; host-composition/paperclip-durable-funding-review/ACTIVATION-CONTRACT.md. Status: 24 October 2026.</a:t>
+              <a:t>Sources: Inertia spec.md, plan.md and testing.md; docs/development/funding-enhancement/discovery-loop.md; docs/development/funding-enhancement/discovery-host-composition.md; Needed-from-team.md; docs/development/objective-intake.md; scripts/cloud-rehearsal/README.md; https://github.com/NetRxn/Inertia/pull/25; https://github.com/NetRxn/Inertia/pull/26; https://github.com/NetRxn/Inertia/pull/27; https://github.com/NetRxn/Inertia/pull/28; https://github.com/NetRxn/DFW-Gov-Fund/pull/44; https://github.com/NetRxn/DFW-Gov-Fund/pull/45; https://github.com/NetRxn/DFW-Gov-Fund/pull/46; https://github.com/NetRxn/DFW-Gov-Fund/pull/47; https://github.com/NetRxn/DFW-Gov-Fund/pull/49; https://github.com/NetRxn/DFW-Gov-Fund/pull/50; host-composition/paperclip-durable-funding-review/ACTIVATION-CONTRACT.md; docs/development/member-contribution-boundary.md. Status: 24 October 2026.</a:t>
             </a:r>
           </a:p>
           <a:p xmlns:a="http://schemas.openxmlformats.org/drawingml/2006/main">
@@ -1230,7 +1260,7 @@
           </a:p>
           <a:p xmlns:a="http://schemas.openxmlformats.org/drawingml/2006/main">
             <a:r>
-              <a:t>Merged cores now include drafting/gap preparation, scoped evidence and sanitized financial contracts, partner graph/research reuse, objective intake/links/briefs and cloud rehearsal tooling. The bounded October scout is complete. Its confidence overlay and separate July/manual/replay provenance are retained.</a:t>
+              <a:t>Merged cores now include meeting source/native follow-up, drafting/gap preparation, scoped evidence and sanitized financial contracts, partner graph/research reuse, objective intake/links/briefs and cloud rehearsal tooling. The bounded October scout is complete. Its confidence overlay and separate July/manual/replay provenance are retained.</a:t>
             </a:r>
           </a:p>
           <a:p xmlns:a="http://schemas.openxmlformats.org/drawingml/2006/main">
@@ -1240,7 +1270,7 @@
           </a:p>
           <a:p xmlns:a="http://schemas.openxmlformats.org/drawingml/2006/main">
             <a:r>
-              <a:t>Independent cloud rehearsal passed real domain PostgreSQL/PostGIS, native PostgreSQL service/membership/checkout/crash behavior and PG-to-embedded-Helix reuse. The actual-service synthetic meeting-answer-to-revised-brief workflow passed. npm audit and clean-package checks passed. Full HTTP/UI rehearsal needs an environment with working network-interface enumeration. Actual VPS/PPC2 enrollment and production deployment remain next work.</a:t>
+              <a:t>Independent cloud rehearsal passed real domain PostgreSQL/PostGIS, native PostgreSQL service/membership/checkout/crash behavior and PG-to-embedded-Helix reuse. The actual-service synthetic meeting-answer-to-revised-brief workflow passed. Meeting source/native composition also passed actual pinned native PostgreSQL recovery and WAL qualification with synthetic source/website responses. Real Drive/website access, scoped capabilities, retention and notes-only website behavior remain integration work. npm audit and clean-package checks passed. Full HTTP/UI rehearsal needs an environment with working network-interface enumeration. Actual VPS/PPC2 enrollment and production deployment remain next work.</a:t>
             </a:r>
           </a:p>
           <a:p xmlns:a="http://schemas.openxmlformats.org/drawingml/2006/main">
@@ -1260,7 +1290,7 @@
           </a:p>
           <a:p xmlns:a="http://schemas.openxmlformats.org/drawingml/2006/main">
             <a:r>
-              <a:t>The planned discovery loop queries saved knowledge, researches coverage gaps, validates official evidence, saves useful findings and produces prioritized briefs or deduplicated urgent alerts. Native tasks retain due rechecks and failed coverage. The daily profile remains disabled until actual agent/tool wiring, end-to-end rehearsal and recurring cadence approval. Broader 990 and optional semantic/vector enrichment follow separately.</a:t>
+              <a:t>The merged discovery foundation queries saved knowledge, captures official sources and produces preliminary briefs and date alerts for qualified sources before packet signoff. New sponsors enter quarantine and independent exact-source identity review. Independent reviewers now submit complete current source quotes for deadline and benefit assessment. Conditional briefs preserve unknown cutoff, eligibility and fit; unresolved evidence stays with agent diligence. Urgent transport uses the configured Buzz audience and signed outbox; relay acceptance records transport acknowledgment. Actual-native and cold-DFW rehearsal passed with synthetic sources and relay. Activation needs real browser/model/tool qualification, active responsible-member mappings, source/runtime access and approved audience/budgets. Recurrence remains disabled pending measured rehearsal and cadence approval. Broader 990 and semantic enrichment follow separately.</a:t>
             </a:r>
           </a:p>
           <a:p xmlns:a="http://schemas.openxmlformats.org/drawingml/2006/main">
@@ -1271,6 +1301,16 @@
           <a:p xmlns:a="http://schemas.openxmlformats.org/drawingml/2006/main">
             <a:r>
               <a:t>Connected demo outcomes remain website meeting publication, a reviewed direct-application packet with its required final vote, an accepted second-member contribution and research reused on a later run. Production financial-provider compatibility and trusted admission policy require qualification.</a:t>
+            </a:r>
+          </a:p>
+          <a:p xmlns:a="http://schemas.openxmlformats.org/drawingml/2006/main">
+            <a:r>
+              <a:t/>
+            </a:r>
+          </a:p>
+          <a:p xmlns:a="http://schemas.openxmlformats.org/drawingml/2006/main">
+            <a:r>
+              <a:t>Member candidate validation and replay are implemented and independently qualified on the combined native build. Engineering next connects authenticated ingress, non-reusable attempt authority, live provider execution and native review/acceptance. The second-member demonstration remains an activation goal.</a:t>
             </a:r>
           </a:p>
         </p:txBody>
@@ -3083,12 +3123,12 @@
   </p:cSld>
   <p:clrMap bg1="lt1" tx1="dk1" bg2="lt2" tx2="dk2" accent1="accent1" accent2="accent2" accent3="accent3" accent4="accent4" accent5="accent5" accent6="accent6" hlink="hlink" folHlink="folHlink"/>
   <p:sldLayoutIdLst>
-    <p:sldLayoutId xmlns:r="http://schemas.openxmlformats.org/officeDocument/2006/relationships" id="2147483649" r:id="R20b38ba70eb342b3"/>
-    <p:sldLayoutId xmlns:r="http://schemas.openxmlformats.org/officeDocument/2006/relationships" id="2147483650" r:id="Rd11476e6f4db4f52"/>
-    <p:sldLayoutId xmlns:r="http://schemas.openxmlformats.org/officeDocument/2006/relationships" id="2147483651" r:id="R5af7774cad524477"/>
-    <p:sldLayoutId xmlns:r="http://schemas.openxmlformats.org/officeDocument/2006/relationships" id="2147483652" r:id="Rd9c9b7a06dc94447"/>
-    <p:sldLayoutId xmlns:r="http://schemas.openxmlformats.org/officeDocument/2006/relationships" id="2147483653" r:id="Rf4e31d95c4da4466"/>
-    <p:sldLayoutId xmlns:r="http://schemas.openxmlformats.org/officeDocument/2006/relationships" id="2147483654" r:id="R91de7841eb0a44ac"/>
+    <p:sldLayoutId xmlns:r="http://schemas.openxmlformats.org/officeDocument/2006/relationships" id="2147483649" r:id="Rd13a80fc66ce4090"/>
+    <p:sldLayoutId xmlns:r="http://schemas.openxmlformats.org/officeDocument/2006/relationships" id="2147483650" r:id="Rd64e45b425b44dae"/>
+    <p:sldLayoutId xmlns:r="http://schemas.openxmlformats.org/officeDocument/2006/relationships" id="2147483651" r:id="R0f85ddb51d4f4209"/>
+    <p:sldLayoutId xmlns:r="http://schemas.openxmlformats.org/officeDocument/2006/relationships" id="2147483652" r:id="Rf56581445579435f"/>
+    <p:sldLayoutId xmlns:r="http://schemas.openxmlformats.org/officeDocument/2006/relationships" id="2147483653" r:id="R0a78effee79b4a6f"/>
+    <p:sldLayoutId xmlns:r="http://schemas.openxmlformats.org/officeDocument/2006/relationships" id="2147483654" r:id="R60495d1cb8444f3c"/>
   </p:sldLayoutIdLst>
   <p:txStyles>
     <p:titleStyle>
@@ -3639,7 +3679,7 @@
           <p:cNvPr id="39" name="">
             <a:extLst xmlns:a="http://schemas.openxmlformats.org/drawingml/2006/main">
               <a:ext uri="{FF2B5EF4-FFF2-40B4-BE49-F238E27FC236}">
-                <a16:creationId xmlns:a16="http://schemas.microsoft.com/office/drawing/2014/main" id="{C3120CBA-2826-44C8-94CB-F07348FEA7CB}"/>
+                <a16:creationId xmlns:a16="http://schemas.microsoft.com/office/drawing/2014/main" id="{F2CC556C-2FBD-49FA-97AC-2CDC1E921185}"/>
               </a:ext>
             </a:extLst>
           </p:cNvPr>
@@ -3672,7 +3712,7 @@
           <p:cNvPr id="32" name="">
             <a:extLst xmlns:a="http://schemas.openxmlformats.org/drawingml/2006/main">
               <a:ext uri="{FF2B5EF4-FFF2-40B4-BE49-F238E27FC236}">
-                <a16:creationId xmlns:a16="http://schemas.microsoft.com/office/drawing/2014/main" id="{A6DE5ED5-9A3C-4374-86AD-43A47E7004C6}"/>
+                <a16:creationId xmlns:a16="http://schemas.microsoft.com/office/drawing/2014/main" id="{9308FDB0-5972-48A6-B22A-34E8C4F8EA2A}"/>
               </a:ext>
             </a:extLst>
           </p:cNvPr>
@@ -3704,7 +3744,7 @@
           <p:cNvPr id="29" name="">
             <a:extLst xmlns:a="http://schemas.openxmlformats.org/drawingml/2006/main">
               <a:ext uri="{FF2B5EF4-FFF2-40B4-BE49-F238E27FC236}">
-                <a16:creationId xmlns:a16="http://schemas.microsoft.com/office/drawing/2014/main" id="{01B70731-45E5-470D-B4BB-F16F8402D9E0}"/>
+                <a16:creationId xmlns:a16="http://schemas.microsoft.com/office/drawing/2014/main" id="{EC7741F9-488D-4101-A888-E3261CB92D49}"/>
               </a:ext>
             </a:extLst>
           </p:cNvPr>
@@ -5497,7 +5537,7 @@
           <p:cNvPr id="30" name="flow-29">
             <a:extLst xmlns:a="http://schemas.openxmlformats.org/drawingml/2006/main">
               <a:ext uri="{FF2B5EF4-FFF2-40B4-BE49-F238E27FC236}">
-                <a16:creationId xmlns:a16="http://schemas.microsoft.com/office/drawing/2014/main" id="{8C091B80-C622-42DA-A009-93FF036A1267}"/>
+                <a16:creationId xmlns:a16="http://schemas.microsoft.com/office/drawing/2014/main" id="{CC551E53-B51A-413F-B10F-A026A982F66B}"/>
               </a:ext>
             </a:extLst>
           </p:cNvPr>
@@ -5527,7 +5567,7 @@
           <p:cNvPr id="31" name="flow-30">
             <a:extLst xmlns:a="http://schemas.openxmlformats.org/drawingml/2006/main">
               <a:ext uri="{FF2B5EF4-FFF2-40B4-BE49-F238E27FC236}">
-                <a16:creationId xmlns:a16="http://schemas.microsoft.com/office/drawing/2014/main" id="{9054FC2C-0002-4E13-A51A-7222044C9807}"/>
+                <a16:creationId xmlns:a16="http://schemas.microsoft.com/office/drawing/2014/main" id="{1216BD79-AD2E-4D0A-8BF5-796D9D002A17}"/>
               </a:ext>
             </a:extLst>
           </p:cNvPr>
@@ -5627,7 +5667,7 @@
           <p:cNvPr id="34" name="flow-32">
             <a:extLst xmlns:a="http://schemas.openxmlformats.org/drawingml/2006/main">
               <a:ext uri="{FF2B5EF4-FFF2-40B4-BE49-F238E27FC236}">
-                <a16:creationId xmlns:a16="http://schemas.microsoft.com/office/drawing/2014/main" id="{F42CA512-4975-4C1A-B259-B46282BE7931}"/>
+                <a16:creationId xmlns:a16="http://schemas.microsoft.com/office/drawing/2014/main" id="{D7F93970-F225-4598-A42C-A4B92C616A17}"/>
               </a:ext>
             </a:extLst>
           </p:cNvPr>
@@ -5656,7 +5696,7 @@
           <p:cNvPr id="35" name="flow-33">
             <a:extLst xmlns:a="http://schemas.openxmlformats.org/drawingml/2006/main">
               <a:ext uri="{FF2B5EF4-FFF2-40B4-BE49-F238E27FC236}">
-                <a16:creationId xmlns:a16="http://schemas.microsoft.com/office/drawing/2014/main" id="{3E3CF51B-F479-43FF-8544-3E0DE3B5B813}"/>
+                <a16:creationId xmlns:a16="http://schemas.microsoft.com/office/drawing/2014/main" id="{116FBAE3-6DE7-4724-9FB6-74463C44399D}"/>
               </a:ext>
             </a:extLst>
           </p:cNvPr>
@@ -5684,7 +5724,7 @@
           <p:cNvPr id="36" name="flow-34">
             <a:extLst xmlns:a="http://schemas.openxmlformats.org/drawingml/2006/main">
               <a:ext uri="{FF2B5EF4-FFF2-40B4-BE49-F238E27FC236}">
-                <a16:creationId xmlns:a16="http://schemas.microsoft.com/office/drawing/2014/main" id="{17507772-98B2-4512-B4A7-E4A0D3371618}"/>
+                <a16:creationId xmlns:a16="http://schemas.microsoft.com/office/drawing/2014/main" id="{95586601-9CB6-4A86-A16C-73D2852D00EF}"/>
               </a:ext>
             </a:extLst>
           </p:cNvPr>
@@ -5783,7 +5823,7 @@
           <p:cNvPr id="38" name="flow-36">
             <a:extLst xmlns:a="http://schemas.openxmlformats.org/drawingml/2006/main">
               <a:ext uri="{FF2B5EF4-FFF2-40B4-BE49-F238E27FC236}">
-                <a16:creationId xmlns:a16="http://schemas.microsoft.com/office/drawing/2014/main" id="{FC620AFA-6BA6-43F0-91CD-C3EA0574AE65}"/>
+                <a16:creationId xmlns:a16="http://schemas.microsoft.com/office/drawing/2014/main" id="{57797733-D8CA-4958-808F-A0726DE98AA3}"/>
               </a:ext>
             </a:extLst>
           </p:cNvPr>
@@ -5912,7 +5952,7 @@
           <p:cNvPr id="35" name="">
             <a:extLst xmlns:a="http://schemas.openxmlformats.org/drawingml/2006/main">
               <a:ext uri="{FF2B5EF4-FFF2-40B4-BE49-F238E27FC236}">
-                <a16:creationId xmlns:a16="http://schemas.microsoft.com/office/drawing/2014/main" id="{D4F599FF-97B5-43B6-8F99-180E2FC82611}"/>
+                <a16:creationId xmlns:a16="http://schemas.microsoft.com/office/drawing/2014/main" id="{10287671-85DE-4E27-A357-47342C93EA06}"/>
               </a:ext>
             </a:extLst>
           </p:cNvPr>
@@ -5944,7 +5984,7 @@
           <p:cNvPr id="21" name="">
             <a:extLst xmlns:a="http://schemas.openxmlformats.org/drawingml/2006/main">
               <a:ext uri="{FF2B5EF4-FFF2-40B4-BE49-F238E27FC236}">
-                <a16:creationId xmlns:a16="http://schemas.microsoft.com/office/drawing/2014/main" id="{3AB93786-CD66-4B1E-A32D-851B001657D5}"/>
+                <a16:creationId xmlns:a16="http://schemas.microsoft.com/office/drawing/2014/main" id="{ECAFA72F-B794-498D-BF27-3BB175101A45}"/>
               </a:ext>
             </a:extLst>
           </p:cNvPr>
@@ -5976,7 +6016,7 @@
           <p:cNvPr id="20" name="">
             <a:extLst xmlns:a="http://schemas.openxmlformats.org/drawingml/2006/main">
               <a:ext uri="{FF2B5EF4-FFF2-40B4-BE49-F238E27FC236}">
-                <a16:creationId xmlns:a16="http://schemas.microsoft.com/office/drawing/2014/main" id="{EED3E3F1-CF60-4F28-BE2F-7B8037750AC2}"/>
+                <a16:creationId xmlns:a16="http://schemas.microsoft.com/office/drawing/2014/main" id="{C7652AB2-D035-4D5E-8530-1682B3CEAD3C}"/>
               </a:ext>
             </a:extLst>
           </p:cNvPr>
@@ -6008,7 +6048,7 @@
           <p:cNvPr id="19" name="">
             <a:extLst xmlns:a="http://schemas.openxmlformats.org/drawingml/2006/main">
               <a:ext uri="{FF2B5EF4-FFF2-40B4-BE49-F238E27FC236}">
-                <a16:creationId xmlns:a16="http://schemas.microsoft.com/office/drawing/2014/main" id="{A5953D26-8AEE-4417-838F-CCAFCA89F157}"/>
+                <a16:creationId xmlns:a16="http://schemas.microsoft.com/office/drawing/2014/main" id="{A4E66A3D-BD1E-410C-8C84-3591655EDAD1}"/>
               </a:ext>
             </a:extLst>
           </p:cNvPr>
@@ -6040,7 +6080,7 @@
           <p:cNvPr id="18" name="">
             <a:extLst xmlns:a="http://schemas.openxmlformats.org/drawingml/2006/main">
               <a:ext uri="{FF2B5EF4-FFF2-40B4-BE49-F238E27FC236}">
-                <a16:creationId xmlns:a16="http://schemas.microsoft.com/office/drawing/2014/main" id="{68A424AA-DEEA-4C0D-9DD3-B8307F9A089B}"/>
+                <a16:creationId xmlns:a16="http://schemas.microsoft.com/office/drawing/2014/main" id="{925C269E-0BA9-486D-AA23-C8FDA489F7AD}"/>
               </a:ext>
             </a:extLst>
           </p:cNvPr>
@@ -7615,7 +7655,7 @@
           <p:cNvPr id="28" name="flow-61">
             <a:extLst xmlns:a="http://schemas.openxmlformats.org/drawingml/2006/main">
               <a:ext uri="{FF2B5EF4-FFF2-40B4-BE49-F238E27FC236}">
-                <a16:creationId xmlns:a16="http://schemas.microsoft.com/office/drawing/2014/main" id="{7E77EE6A-D4D8-40F7-A95F-1DC37AB7A59D}"/>
+                <a16:creationId xmlns:a16="http://schemas.microsoft.com/office/drawing/2014/main" id="{3DB5733C-5FB3-4B68-A04E-DEE2F220C191}"/>
               </a:ext>
             </a:extLst>
           </p:cNvPr>
@@ -7714,7 +7754,7 @@
           <p:cNvPr id="30" name="flow-63">
             <a:extLst xmlns:a="http://schemas.openxmlformats.org/drawingml/2006/main">
               <a:ext uri="{FF2B5EF4-FFF2-40B4-BE49-F238E27FC236}">
-                <a16:creationId xmlns:a16="http://schemas.microsoft.com/office/drawing/2014/main" id="{52FDB377-D333-44DF-A914-1CFE5000735D}"/>
+                <a16:creationId xmlns:a16="http://schemas.microsoft.com/office/drawing/2014/main" id="{08668D5E-A6BE-4962-BA85-2B397B52594E}"/>
               </a:ext>
             </a:extLst>
           </p:cNvPr>
@@ -7742,7 +7782,7 @@
           <p:cNvPr id="31" name="flow-64">
             <a:extLst xmlns:a="http://schemas.openxmlformats.org/drawingml/2006/main">
               <a:ext uri="{FF2B5EF4-FFF2-40B4-BE49-F238E27FC236}">
-                <a16:creationId xmlns:a16="http://schemas.microsoft.com/office/drawing/2014/main" id="{42DCDD48-F720-41BE-8CA4-47E67C4031C2}"/>
+                <a16:creationId xmlns:a16="http://schemas.microsoft.com/office/drawing/2014/main" id="{B75F1FD4-C02A-44C5-9E64-05EC4EA99E6A}"/>
               </a:ext>
             </a:extLst>
           </p:cNvPr>
@@ -7770,7 +7810,7 @@
           <p:cNvPr id="32" name="flow-65">
             <a:extLst xmlns:a="http://schemas.openxmlformats.org/drawingml/2006/main">
               <a:ext uri="{FF2B5EF4-FFF2-40B4-BE49-F238E27FC236}">
-                <a16:creationId xmlns:a16="http://schemas.microsoft.com/office/drawing/2014/main" id="{FC0B672E-8C0B-463B-84AC-547B4A21A1F1}"/>
+                <a16:creationId xmlns:a16="http://schemas.microsoft.com/office/drawing/2014/main" id="{FF36DB5C-928D-4444-9A6D-6880C45134B2}"/>
               </a:ext>
             </a:extLst>
           </p:cNvPr>
@@ -7798,7 +7838,7 @@
           <p:cNvPr id="33" name="flow-66">
             <a:extLst xmlns:a="http://schemas.openxmlformats.org/drawingml/2006/main">
               <a:ext uri="{FF2B5EF4-FFF2-40B4-BE49-F238E27FC236}">
-                <a16:creationId xmlns:a16="http://schemas.microsoft.com/office/drawing/2014/main" id="{B640F174-F1E0-497D-9292-886BDA9A4790}"/>
+                <a16:creationId xmlns:a16="http://schemas.microsoft.com/office/drawing/2014/main" id="{CDEF0BF4-6CAD-4ABC-9B95-6147440D2B48}"/>
               </a:ext>
             </a:extLst>
           </p:cNvPr>
@@ -8066,7 +8106,7 @@
           <p:cNvPr id="18" name="">
             <a:extLst xmlns:a="http://schemas.openxmlformats.org/drawingml/2006/main">
               <a:ext uri="{FF2B5EF4-FFF2-40B4-BE49-F238E27FC236}">
-                <a16:creationId xmlns:a16="http://schemas.microsoft.com/office/drawing/2014/main" id="{317B2169-A795-454D-A65B-7120C58EE562}"/>
+                <a16:creationId xmlns:a16="http://schemas.microsoft.com/office/drawing/2014/main" id="{FDBF6BE9-C935-4884-8826-CCE7C39D491F}"/>
               </a:ext>
             </a:extLst>
           </p:cNvPr>
@@ -8968,7 +9008,7 @@
                 <a:ea typeface="Aptos"/>
                 <a:cs typeface="Aptos"/>
               </a:rPr>
-              <a:t>Proposed actions + sources</a:t>
+              <a:t>Source-linked follow-up</a:t>
             </a:r>
           </a:p>
         </p:txBody>
@@ -9235,7 +9275,7 @@
                 <a:ea typeface="Aptos"/>
                 <a:cs typeface="Aptos"/>
               </a:rPr>
-              <a:t>Source job</a:t>
+              <a:t>Drive access</a:t>
             </a:r>
           </a:p>
           <a:p xmlns:a="http://schemas.openxmlformats.org/drawingml/2006/main">
@@ -9259,7 +9299,7 @@
                 <a:ea typeface="Aptos"/>
                 <a:cs typeface="Aptos"/>
               </a:rPr>
-              <a:t>pending</a:t>
+              <a:t>needed</a:t>
             </a:r>
           </a:p>
         </p:txBody>
@@ -9269,7 +9309,7 @@
           <p:cNvPr id="20" name="flow-88">
             <a:extLst xmlns:a="http://schemas.openxmlformats.org/drawingml/2006/main">
               <a:ext uri="{FF2B5EF4-FFF2-40B4-BE49-F238E27FC236}">
-                <a16:creationId xmlns:a16="http://schemas.microsoft.com/office/drawing/2014/main" id="{7D9B7B94-4EBB-4DF0-85DD-066C6DE5CD32}"/>
+                <a16:creationId xmlns:a16="http://schemas.microsoft.com/office/drawing/2014/main" id="{90FD3FC6-D090-407E-9927-AB70A50120E1}"/>
               </a:ext>
             </a:extLst>
           </p:cNvPr>
@@ -9297,7 +9337,7 @@
           <p:cNvPr id="21" name="flow-89">
             <a:extLst xmlns:a="http://schemas.openxmlformats.org/drawingml/2006/main">
               <a:ext uri="{FF2B5EF4-FFF2-40B4-BE49-F238E27FC236}">
-                <a16:creationId xmlns:a16="http://schemas.microsoft.com/office/drawing/2014/main" id="{B9C2B235-21EC-4B3A-8BEC-3075251078FD}"/>
+                <a16:creationId xmlns:a16="http://schemas.microsoft.com/office/drawing/2014/main" id="{9D414016-4AE9-4DF8-91ED-449A34E6FF8B}"/>
               </a:ext>
             </a:extLst>
           </p:cNvPr>
@@ -9325,7 +9365,7 @@
           <p:cNvPr id="22" name="flow-90">
             <a:extLst xmlns:a="http://schemas.openxmlformats.org/drawingml/2006/main">
               <a:ext uri="{FF2B5EF4-FFF2-40B4-BE49-F238E27FC236}">
-                <a16:creationId xmlns:a16="http://schemas.microsoft.com/office/drawing/2014/main" id="{1B55A4BE-0C7C-4C4D-88A0-6E5F6208D871}"/>
+                <a16:creationId xmlns:a16="http://schemas.microsoft.com/office/drawing/2014/main" id="{171425A0-10D7-4922-885A-01D6996630A6}"/>
               </a:ext>
             </a:extLst>
           </p:cNvPr>
@@ -9448,7 +9488,7 @@
           <p:cNvPr id="24" name="flow-92">
             <a:extLst xmlns:a="http://schemas.openxmlformats.org/drawingml/2006/main">
               <a:ext uri="{FF2B5EF4-FFF2-40B4-BE49-F238E27FC236}">
-                <a16:creationId xmlns:a16="http://schemas.microsoft.com/office/drawing/2014/main" id="{A7E9E000-2FBE-4EC2-BE5E-8CA255134ECA}"/>
+                <a16:creationId xmlns:a16="http://schemas.microsoft.com/office/drawing/2014/main" id="{D996C47B-D5F6-4ABB-98C2-6CAEE001E309}"/>
               </a:ext>
             </a:extLst>
           </p:cNvPr>
@@ -9467,7 +9507,7 @@
             <a:solidFill>
               <a:srgbClr val="157D80"/>
             </a:solidFill>
-            <a:prstDash val="dash"/>
+            <a:prstDash val="solid"/>
           </a:ln>
         </p:spPr>
       </p:cxnSp>
@@ -9476,7 +9516,7 @@
           <p:cNvPr id="25" name="flow-93">
             <a:extLst xmlns:a="http://schemas.openxmlformats.org/drawingml/2006/main">
               <a:ext uri="{FF2B5EF4-FFF2-40B4-BE49-F238E27FC236}">
-                <a16:creationId xmlns:a16="http://schemas.microsoft.com/office/drawing/2014/main" id="{B6651FB7-F8F9-4373-9196-184B622A2782}"/>
+                <a16:creationId xmlns:a16="http://schemas.microsoft.com/office/drawing/2014/main" id="{CEC7B0CC-B168-42B5-8327-7285BD73004B}"/>
               </a:ext>
             </a:extLst>
           </p:cNvPr>
@@ -9495,7 +9535,7 @@
             <a:solidFill>
               <a:srgbClr val="157D80"/>
             </a:solidFill>
-            <a:prstDash val="dash"/>
+            <a:prstDash val="solid"/>
           </a:ln>
         </p:spPr>
       </p:cxnSp>
@@ -9504,7 +9544,7 @@
           <p:cNvPr id="26" name="flow-94">
             <a:extLst xmlns:a="http://schemas.openxmlformats.org/drawingml/2006/main">
               <a:ext uri="{FF2B5EF4-FFF2-40B4-BE49-F238E27FC236}">
-                <a16:creationId xmlns:a16="http://schemas.microsoft.com/office/drawing/2014/main" id="{743C0879-2E0E-42EC-902E-E9E36EB928B3}"/>
+                <a16:creationId xmlns:a16="http://schemas.microsoft.com/office/drawing/2014/main" id="{0D442C91-6D28-4718-88A5-365345CFE4CA}"/>
               </a:ext>
             </a:extLst>
           </p:cNvPr>
@@ -9523,7 +9563,7 @@
             <a:solidFill>
               <a:srgbClr val="157D80"/>
             </a:solidFill>
-            <a:prstDash val="dash"/>
+            <a:prstDash val="solid"/>
             <a:tailEnd type="triangle" w="med" len="med"/>
           </a:ln>
         </p:spPr>
@@ -9593,7 +9633,7 @@
                 <a:ea typeface="Aptos"/>
                 <a:cs typeface="Aptos"/>
               </a:rPr>
-              <a:t>Action intake</a:t>
+              <a:t>Native follow-up</a:t>
             </a:r>
           </a:p>
           <a:p xmlns:a="http://schemas.openxmlformats.org/drawingml/2006/main">
@@ -9617,7 +9657,7 @@
                 <a:ea typeface="Aptos"/>
                 <a:cs typeface="Aptos"/>
               </a:rPr>
-              <a:t>wiring next</a:t>
+              <a:t>implemented</a:t>
             </a:r>
           </a:p>
         </p:txBody>
@@ -9627,7 +9667,7 @@
           <p:cNvPr id="28" name="flow-96">
             <a:extLst xmlns:a="http://schemas.openxmlformats.org/drawingml/2006/main">
               <a:ext uri="{FF2B5EF4-FFF2-40B4-BE49-F238E27FC236}">
-                <a16:creationId xmlns:a16="http://schemas.microsoft.com/office/drawing/2014/main" id="{507793A7-002C-4DD6-B579-DDBBCD316DDF}"/>
+                <a16:creationId xmlns:a16="http://schemas.microsoft.com/office/drawing/2014/main" id="{25A284C1-6226-4F55-81E6-2631C0C43E12}"/>
               </a:ext>
             </a:extLst>
           </p:cNvPr>
@@ -9655,7 +9695,7 @@
           <p:cNvPr id="29" name="flow-97">
             <a:extLst xmlns:a="http://schemas.openxmlformats.org/drawingml/2006/main">
               <a:ext uri="{FF2B5EF4-FFF2-40B4-BE49-F238E27FC236}">
-                <a16:creationId xmlns:a16="http://schemas.microsoft.com/office/drawing/2014/main" id="{D7F4B9D6-8C49-4324-B5C3-735A4C88913C}"/>
+                <a16:creationId xmlns:a16="http://schemas.microsoft.com/office/drawing/2014/main" id="{033F1FD7-724C-4024-80F2-357B094C2B4F}"/>
               </a:ext>
             </a:extLst>
           </p:cNvPr>
@@ -9908,7 +9948,7 @@
                 <a:ea typeface="Aptos"/>
                 <a:cs typeface="Aptos"/>
               </a:rPr>
-              <a:t>Core and publication client merged</a:t>
+              <a:t>Source and native follow-up merged</a:t>
             </a:r>
           </a:p>
         </p:txBody>
@@ -10041,7 +10081,7 @@
           <p:cNvPr id="35" name="">
             <a:extLst xmlns:a="http://schemas.openxmlformats.org/drawingml/2006/main">
               <a:ext uri="{FF2B5EF4-FFF2-40B4-BE49-F238E27FC236}">
-                <a16:creationId xmlns:a16="http://schemas.microsoft.com/office/drawing/2014/main" id="{3D1A79F3-E5EF-471C-8386-0A47F0BBCBA8}"/>
+                <a16:creationId xmlns:a16="http://schemas.microsoft.com/office/drawing/2014/main" id="{4976A6EF-CB1D-4713-AA4C-7A07885C3206}"/>
               </a:ext>
             </a:extLst>
           </p:cNvPr>
@@ -10073,7 +10113,7 @@
           <p:cNvPr id="34" name="">
             <a:extLst xmlns:a="http://schemas.openxmlformats.org/drawingml/2006/main">
               <a:ext uri="{FF2B5EF4-FFF2-40B4-BE49-F238E27FC236}">
-                <a16:creationId xmlns:a16="http://schemas.microsoft.com/office/drawing/2014/main" id="{81BBABB7-3B1E-49A6-AAF3-2B11F74EB344}"/>
+                <a16:creationId xmlns:a16="http://schemas.microsoft.com/office/drawing/2014/main" id="{6B19A4DE-2240-4C60-8ED2-C92C52FC628F}"/>
               </a:ext>
             </a:extLst>
           </p:cNvPr>
@@ -10105,7 +10145,7 @@
           <p:cNvPr id="33" name="">
             <a:extLst xmlns:a="http://schemas.openxmlformats.org/drawingml/2006/main">
               <a:ext uri="{FF2B5EF4-FFF2-40B4-BE49-F238E27FC236}">
-                <a16:creationId xmlns:a16="http://schemas.microsoft.com/office/drawing/2014/main" id="{7427B4A4-47C9-42B7-9B79-6271F3458A25}"/>
+                <a16:creationId xmlns:a16="http://schemas.microsoft.com/office/drawing/2014/main" id="{1E391E25-C876-4B35-96F8-59EB7204988A}"/>
               </a:ext>
             </a:extLst>
           </p:cNvPr>
@@ -10137,7 +10177,7 @@
           <p:cNvPr id="13" name="">
             <a:extLst xmlns:a="http://schemas.openxmlformats.org/drawingml/2006/main">
               <a:ext uri="{FF2B5EF4-FFF2-40B4-BE49-F238E27FC236}">
-                <a16:creationId xmlns:a16="http://schemas.microsoft.com/office/drawing/2014/main" id="{ABCFD886-BD86-4E86-8609-8A068D05BDB0}"/>
+                <a16:creationId xmlns:a16="http://schemas.microsoft.com/office/drawing/2014/main" id="{19130EEE-A3E3-49C6-B192-A2BAADA80B64}"/>
               </a:ext>
             </a:extLst>
           </p:cNvPr>
@@ -10169,7 +10209,7 @@
           <p:cNvPr id="12" name="">
             <a:extLst xmlns:a="http://schemas.openxmlformats.org/drawingml/2006/main">
               <a:ext uri="{FF2B5EF4-FFF2-40B4-BE49-F238E27FC236}">
-                <a16:creationId xmlns:a16="http://schemas.microsoft.com/office/drawing/2014/main" id="{8ACDD802-0FEA-4DEA-89E9-4BA6734ABAAA}"/>
+                <a16:creationId xmlns:a16="http://schemas.microsoft.com/office/drawing/2014/main" id="{CC00D0D6-B04E-404B-A8D7-578C96BD7DE9}"/>
               </a:ext>
             </a:extLst>
           </p:cNvPr>
@@ -10956,7 +10996,7 @@
           <p:cNvPr id="14" name="flow-113">
             <a:extLst xmlns:a="http://schemas.openxmlformats.org/drawingml/2006/main">
               <a:ext uri="{FF2B5EF4-FFF2-40B4-BE49-F238E27FC236}">
-                <a16:creationId xmlns:a16="http://schemas.microsoft.com/office/drawing/2014/main" id="{46BF9B33-9CCB-49BB-9D7C-871116C5E191}"/>
+                <a16:creationId xmlns:a16="http://schemas.microsoft.com/office/drawing/2014/main" id="{148BD751-8735-4D9D-9351-7F40335BCF03}"/>
               </a:ext>
             </a:extLst>
           </p:cNvPr>
@@ -10984,7 +11024,7 @@
           <p:cNvPr id="15" name="flow-114">
             <a:extLst xmlns:a="http://schemas.openxmlformats.org/drawingml/2006/main">
               <a:ext uri="{FF2B5EF4-FFF2-40B4-BE49-F238E27FC236}">
-                <a16:creationId xmlns:a16="http://schemas.microsoft.com/office/drawing/2014/main" id="{E47135E9-968E-44B3-9C3F-4F0333EB123D}"/>
+                <a16:creationId xmlns:a16="http://schemas.microsoft.com/office/drawing/2014/main" id="{61C4F464-9138-46BA-909E-F8BD8B858762}"/>
               </a:ext>
             </a:extLst>
           </p:cNvPr>
@@ -11012,7 +11052,7 @@
           <p:cNvPr id="16" name="flow-115">
             <a:extLst xmlns:a="http://schemas.openxmlformats.org/drawingml/2006/main">
               <a:ext uri="{FF2B5EF4-FFF2-40B4-BE49-F238E27FC236}">
-                <a16:creationId xmlns:a16="http://schemas.microsoft.com/office/drawing/2014/main" id="{5314AF79-BAEF-4D59-82B7-ECEAA3EDADD6}"/>
+                <a16:creationId xmlns:a16="http://schemas.microsoft.com/office/drawing/2014/main" id="{71E53580-7331-4B8D-9B55-A66F1AE093A2}"/>
               </a:ext>
             </a:extLst>
           </p:cNvPr>
@@ -11040,7 +11080,7 @@
           <p:cNvPr id="17" name="flow-116">
             <a:extLst xmlns:a="http://schemas.openxmlformats.org/drawingml/2006/main">
               <a:ext uri="{FF2B5EF4-FFF2-40B4-BE49-F238E27FC236}">
-                <a16:creationId xmlns:a16="http://schemas.microsoft.com/office/drawing/2014/main" id="{8B112F7F-2A59-4D7C-B48F-8FE0200477BB}"/>
+                <a16:creationId xmlns:a16="http://schemas.microsoft.com/office/drawing/2014/main" id="{7DDD52AF-6783-4F79-9DC1-999B31A3B1B5}"/>
               </a:ext>
             </a:extLst>
           </p:cNvPr>
@@ -11927,7 +11967,7 @@
           <p:cNvPr id="31" name="flow-130">
             <a:extLst xmlns:a="http://schemas.openxmlformats.org/drawingml/2006/main">
               <a:ext uri="{FF2B5EF4-FFF2-40B4-BE49-F238E27FC236}">
-                <a16:creationId xmlns:a16="http://schemas.microsoft.com/office/drawing/2014/main" id="{37AE7F39-04A1-44E8-A668-EFB1DA347DFE}"/>
+                <a16:creationId xmlns:a16="http://schemas.microsoft.com/office/drawing/2014/main" id="{9AE42BFD-C926-4708-99C5-D5BF4F77B9B2}"/>
               </a:ext>
             </a:extLst>
           </p:cNvPr>
@@ -12518,7 +12558,7 @@
           <p:cNvPr id="43" name="partner-flow-1">
             <a:extLst xmlns:a="http://schemas.openxmlformats.org/drawingml/2006/main">
               <a:ext uri="{FF2B5EF4-FFF2-40B4-BE49-F238E27FC236}">
-                <a16:creationId xmlns:a16="http://schemas.microsoft.com/office/drawing/2014/main" id="{8C50AE15-C344-4114-8408-E3D463D49815}"/>
+                <a16:creationId xmlns:a16="http://schemas.microsoft.com/office/drawing/2014/main" id="{2EE74050-9140-4D98-9195-7222082EF0A5}"/>
               </a:ext>
             </a:extLst>
           </p:cNvPr>
@@ -12546,7 +12586,7 @@
           <p:cNvPr id="44" name="partner-flow-2">
             <a:extLst xmlns:a="http://schemas.openxmlformats.org/drawingml/2006/main">
               <a:ext uri="{FF2B5EF4-FFF2-40B4-BE49-F238E27FC236}">
-                <a16:creationId xmlns:a16="http://schemas.microsoft.com/office/drawing/2014/main" id="{F847D156-086C-4D76-BD6A-0D204D87C04C}"/>
+                <a16:creationId xmlns:a16="http://schemas.microsoft.com/office/drawing/2014/main" id="{739D2C01-9424-44CD-A648-01F678C8463E}"/>
               </a:ext>
             </a:extLst>
           </p:cNvPr>
@@ -12574,7 +12614,7 @@
           <p:cNvPr id="45" name="partner-flow-3">
             <a:extLst xmlns:a="http://schemas.openxmlformats.org/drawingml/2006/main">
               <a:ext uri="{FF2B5EF4-FFF2-40B4-BE49-F238E27FC236}">
-                <a16:creationId xmlns:a16="http://schemas.microsoft.com/office/drawing/2014/main" id="{3E2F194F-C69A-41A1-83DF-C3C6881A3D7E}"/>
+                <a16:creationId xmlns:a16="http://schemas.microsoft.com/office/drawing/2014/main" id="{C4BC747C-25CD-4B47-A9CB-A56979A7A092}"/>
               </a:ext>
             </a:extLst>
           </p:cNvPr>
@@ -12602,7 +12642,7 @@
           <p:cNvPr id="46" name="partner-flow-4">
             <a:extLst xmlns:a="http://schemas.openxmlformats.org/drawingml/2006/main">
               <a:ext uri="{FF2B5EF4-FFF2-40B4-BE49-F238E27FC236}">
-                <a16:creationId xmlns:a16="http://schemas.microsoft.com/office/drawing/2014/main" id="{455FBE7F-8646-43FE-ABA5-462DDEEBEBF1}"/>
+                <a16:creationId xmlns:a16="http://schemas.microsoft.com/office/drawing/2014/main" id="{4C6DD1CF-E478-447E-99C5-D3FE43C59AD6}"/>
               </a:ext>
             </a:extLst>
           </p:cNvPr>
@@ -12660,7 +12700,7 @@
           <p:cNvPr id="25" name="">
             <a:extLst xmlns:a="http://schemas.openxmlformats.org/drawingml/2006/main">
               <a:ext uri="{FF2B5EF4-FFF2-40B4-BE49-F238E27FC236}">
-                <a16:creationId xmlns:a16="http://schemas.microsoft.com/office/drawing/2014/main" id="{A1859A7E-8DE6-4351-A350-0C242B9D0073}"/>
+                <a16:creationId xmlns:a16="http://schemas.microsoft.com/office/drawing/2014/main" id="{86E81405-94C6-423B-B2C0-5BDA496A6AD7}"/>
               </a:ext>
             </a:extLst>
           </p:cNvPr>
@@ -12972,7 +13012,7 @@
           <p:cNvPr id="5" name="flow-142">
             <a:extLst xmlns:a="http://schemas.openxmlformats.org/drawingml/2006/main">
               <a:ext uri="{FF2B5EF4-FFF2-40B4-BE49-F238E27FC236}">
-                <a16:creationId xmlns:a16="http://schemas.microsoft.com/office/drawing/2014/main" id="{D18FAB8B-9B1D-4CFC-B596-E9B959C813D2}"/>
+                <a16:creationId xmlns:a16="http://schemas.microsoft.com/office/drawing/2014/main" id="{859AE66F-A02D-45D5-807B-5735957AAC1C}"/>
               </a:ext>
             </a:extLst>
           </p:cNvPr>
@@ -13364,13 +13404,13 @@
             <a:avLst/>
           </a:prstGeom>
           <a:solidFill xmlns:a="http://schemas.openxmlformats.org/drawingml/2006/main">
-            <a:srgbClr val="E7F1EE"/>
+            <a:srgbClr val="FFFAF0"/>
           </a:solidFill>
           <a:ln xmlns:a="http://schemas.openxmlformats.org/drawingml/2006/main" w="17145">
             <a:solidFill>
-              <a:srgbClr val="157D80"/>
+              <a:srgbClr val="B1853E"/>
             </a:solidFill>
-            <a:prstDash val="solid"/>
+            <a:prstDash val="dash"/>
           </a:ln>
         </p:spPr>
       </p:sp>
@@ -13533,7 +13573,7 @@
                 <a:ea typeface="Aptos"/>
                 <a:cs typeface="Aptos"/>
               </a:rPr>
-              <a:t>Task-scoped evidence and tools</a:t>
+              <a:t>Live enrollment and execution next</a:t>
             </a:r>
           </a:p>
         </p:txBody>
@@ -13556,6 +13596,380 @@
           <a:xfrm xmlns:a="http://schemas.openxmlformats.org/drawingml/2006/main">
             <a:off x="8667750" y="4000500"/>
             <a:ext cx="5962650" cy="1238250"/>
+          </a:xfrm>
+          <a:prstGeom xmlns:a="http://schemas.openxmlformats.org/drawingml/2006/main" prst="rect">
+            <a:avLst/>
+          </a:prstGeom>
+          <a:solidFill xmlns:a="http://schemas.openxmlformats.org/drawingml/2006/main">
+            <a:srgbClr val="E7F1EE"/>
+          </a:solidFill>
+          <a:ln xmlns:a="http://schemas.openxmlformats.org/drawingml/2006/main" w="17145">
+            <a:solidFill>
+              <a:srgbClr val="157D80"/>
+            </a:solidFill>
+            <a:prstDash val="solid"/>
+          </a:ln>
+        </p:spPr>
+      </p:sp>
+      <p:sp>
+        <p:nvSpPr>
+          <p:cNvPr id="16" name="text-153">
+            <a:extLst xmlns:a="http://schemas.openxmlformats.org/drawingml/2006/main">
+              <a:ext uri="{FF2B5EF4-FFF2-40B4-BE49-F238E27FC236}">
+                <a16:creationId xmlns:a16="http://schemas.microsoft.com/office/drawing/2014/main" id="{25BAE476-D051-4A95-BC6B-956ECA4478E2}"/>
+              </a:ext>
+            </a:extLst>
+          </p:cNvPr>
+          <p:cNvSpPr>
+            <a:spLocks xmlns:a="http://schemas.openxmlformats.org/drawingml/2006/main" noGrp="1"/>
+          </p:cNvSpPr>
+          <p:nvPr/>
+        </p:nvSpPr>
+        <p:spPr>
+          <a:xfrm xmlns:a="http://schemas.openxmlformats.org/drawingml/2006/main">
+            <a:off x="8858250" y="4162425"/>
+            <a:ext cx="5581650" cy="386715"/>
+          </a:xfrm>
+          <a:prstGeom xmlns:a="http://schemas.openxmlformats.org/drawingml/2006/main" prst="rect">
+            <a:avLst/>
+          </a:prstGeom>
+          <a:noFill xmlns:a="http://schemas.openxmlformats.org/drawingml/2006/main"/>
+          <a:ln xmlns:a="http://schemas.openxmlformats.org/drawingml/2006/main" w="0">
+            <a:noFill/>
+            <a:prstDash val="solid"/>
+          </a:ln>
+        </p:spPr>
+        <p:txBody>
+          <a:bodyPr xmlns:a="http://schemas.openxmlformats.org/drawingml/2006/main" wrap="square" lIns="0" tIns="0" rIns="0" bIns="0" anchor="t">
+            <a:noAutofit/>
+          </a:bodyPr>
+          <a:lstStyle xmlns:a="http://schemas.openxmlformats.org/drawingml/2006/main">
+            <a:defPPr algn="l">
+              <a:defRPr sz="2250" b="1">
+                <a:solidFill>
+                  <a:srgbClr val="132E38"/>
+                </a:solidFill>
+                <a:latin typeface="Aptos"/>
+                <a:ea typeface="Aptos"/>
+                <a:cs typeface="Aptos"/>
+              </a:defRPr>
+            </a:defPPr>
+          </a:lstStyle>
+          <a:p xmlns:a="http://schemas.openxmlformats.org/drawingml/2006/main">
+            <a:pPr algn="l">
+              <a:buNone/>
+              <a:defRPr sz="2250" b="1">
+                <a:solidFill>
+                  <a:srgbClr val="132E38"/>
+                </a:solidFill>
+                <a:latin typeface="Aptos"/>
+                <a:ea typeface="Aptos"/>
+                <a:cs typeface="Aptos"/>
+              </a:defRPr>
+            </a:pPr>
+            <a:r>
+              <a:rPr sz="2250" b="1">
+                <a:solidFill>
+                  <a:srgbClr val="132E38"/>
+                </a:solidFill>
+                <a:latin typeface="Aptos"/>
+                <a:ea typeface="Aptos"/>
+                <a:cs typeface="Aptos"/>
+              </a:rPr>
+              <a:t>Candidate validation</a:t>
+            </a:r>
+          </a:p>
+        </p:txBody>
+      </p:sp>
+      <p:sp>
+        <p:nvSpPr>
+          <p:cNvPr id="17" name="text-154">
+            <a:extLst xmlns:a="http://schemas.openxmlformats.org/drawingml/2006/main">
+              <a:ext uri="{FF2B5EF4-FFF2-40B4-BE49-F238E27FC236}">
+                <a16:creationId xmlns:a16="http://schemas.microsoft.com/office/drawing/2014/main" id="{F11BB3A0-ECF0-41B5-B3CD-BC71552C93EB}"/>
+              </a:ext>
+            </a:extLst>
+          </p:cNvPr>
+          <p:cNvSpPr>
+            <a:spLocks xmlns:a="http://schemas.openxmlformats.org/drawingml/2006/main" noGrp="1"/>
+          </p:cNvSpPr>
+          <p:nvPr/>
+        </p:nvSpPr>
+        <p:spPr>
+          <a:xfrm xmlns:a="http://schemas.openxmlformats.org/drawingml/2006/main">
+            <a:off x="8858250" y="4558665"/>
+            <a:ext cx="5581650" cy="340233"/>
+          </a:xfrm>
+          <a:prstGeom xmlns:a="http://schemas.openxmlformats.org/drawingml/2006/main" prst="rect">
+            <a:avLst/>
+          </a:prstGeom>
+          <a:noFill xmlns:a="http://schemas.openxmlformats.org/drawingml/2006/main"/>
+          <a:ln xmlns:a="http://schemas.openxmlformats.org/drawingml/2006/main" w="0">
+            <a:noFill/>
+            <a:prstDash val="solid"/>
+          </a:ln>
+        </p:spPr>
+        <p:txBody>
+          <a:bodyPr xmlns:a="http://schemas.openxmlformats.org/drawingml/2006/main" wrap="square" lIns="0" tIns="0" rIns="0" bIns="0" anchor="t">
+            <a:noAutofit/>
+          </a:bodyPr>
+          <a:lstStyle xmlns:a="http://schemas.openxmlformats.org/drawingml/2006/main">
+            <a:defPPr algn="l">
+              <a:defRPr sz="1950" b="0">
+                <a:solidFill>
+                  <a:srgbClr val="4A6572"/>
+                </a:solidFill>
+                <a:latin typeface="Aptos"/>
+                <a:ea typeface="Aptos"/>
+                <a:cs typeface="Aptos"/>
+              </a:defRPr>
+            </a:defPPr>
+          </a:lstStyle>
+          <a:p xmlns:a="http://schemas.openxmlformats.org/drawingml/2006/main">
+            <a:pPr algn="l">
+              <a:buNone/>
+              <a:defRPr sz="1950" b="0">
+                <a:solidFill>
+                  <a:srgbClr val="4A6572"/>
+                </a:solidFill>
+                <a:latin typeface="Aptos"/>
+                <a:ea typeface="Aptos"/>
+                <a:cs typeface="Aptos"/>
+              </a:defRPr>
+            </a:pPr>
+            <a:r>
+              <a:rPr sz="1950" b="0">
+                <a:solidFill>
+                  <a:srgbClr val="4A6572"/>
+                </a:solidFill>
+                <a:latin typeface="Aptos"/>
+                <a:ea typeface="Aptos"/>
+                <a:cs typeface="Aptos"/>
+              </a:rPr>
+              <a:t>Identity, attempt, task and artifact checks</a:t>
+            </a:r>
+          </a:p>
+        </p:txBody>
+      </p:sp>
+      <p:sp>
+        <p:nvSpPr>
+          <p:cNvPr id="18" name="node-155">
+            <a:extLst xmlns:a="http://schemas.openxmlformats.org/drawingml/2006/main">
+              <a:ext uri="{FF2B5EF4-FFF2-40B4-BE49-F238E27FC236}">
+                <a16:creationId xmlns:a16="http://schemas.microsoft.com/office/drawing/2014/main" id="{D21E1D51-8C9A-47B9-B1E4-DB9FC38BEA0C}"/>
+              </a:ext>
+            </a:extLst>
+          </p:cNvPr>
+          <p:cNvSpPr>
+            <a:spLocks xmlns:a="http://schemas.openxmlformats.org/drawingml/2006/main" noGrp="1"/>
+          </p:cNvSpPr>
+          <p:nvPr/>
+        </p:nvSpPr>
+        <p:spPr>
+          <a:xfrm xmlns:a="http://schemas.openxmlformats.org/drawingml/2006/main">
+            <a:off x="8667750" y="6286500"/>
+            <a:ext cx="5962650" cy="1333500"/>
+          </a:xfrm>
+          <a:prstGeom xmlns:a="http://schemas.openxmlformats.org/drawingml/2006/main" prst="rect">
+            <a:avLst/>
+          </a:prstGeom>
+          <a:solidFill xmlns:a="http://schemas.openxmlformats.org/drawingml/2006/main">
+            <a:srgbClr val="FFFAF0"/>
+          </a:solidFill>
+          <a:ln xmlns:a="http://schemas.openxmlformats.org/drawingml/2006/main" w="17145">
+            <a:solidFill>
+              <a:srgbClr val="B1853E"/>
+            </a:solidFill>
+            <a:prstDash val="dash"/>
+          </a:ln>
+        </p:spPr>
+      </p:sp>
+      <p:sp>
+        <p:nvSpPr>
+          <p:cNvPr id="19" name="text-156">
+            <a:extLst xmlns:a="http://schemas.openxmlformats.org/drawingml/2006/main">
+              <a:ext uri="{FF2B5EF4-FFF2-40B4-BE49-F238E27FC236}">
+                <a16:creationId xmlns:a16="http://schemas.microsoft.com/office/drawing/2014/main" id="{AFCF249E-1085-4474-8A12-407CBA559FDA}"/>
+              </a:ext>
+            </a:extLst>
+          </p:cNvPr>
+          <p:cNvSpPr>
+            <a:spLocks xmlns:a="http://schemas.openxmlformats.org/drawingml/2006/main" noGrp="1"/>
+          </p:cNvSpPr>
+          <p:nvPr/>
+        </p:nvSpPr>
+        <p:spPr>
+          <a:xfrm xmlns:a="http://schemas.openxmlformats.org/drawingml/2006/main">
+            <a:off x="8858250" y="6448425"/>
+            <a:ext cx="5581650" cy="386715"/>
+          </a:xfrm>
+          <a:prstGeom xmlns:a="http://schemas.openxmlformats.org/drawingml/2006/main" prst="rect">
+            <a:avLst/>
+          </a:prstGeom>
+          <a:noFill xmlns:a="http://schemas.openxmlformats.org/drawingml/2006/main"/>
+          <a:ln xmlns:a="http://schemas.openxmlformats.org/drawingml/2006/main" w="0">
+            <a:noFill/>
+            <a:prstDash val="solid"/>
+          </a:ln>
+        </p:spPr>
+        <p:txBody>
+          <a:bodyPr xmlns:a="http://schemas.openxmlformats.org/drawingml/2006/main" wrap="square" lIns="0" tIns="0" rIns="0" bIns="0" anchor="t">
+            <a:noAutofit/>
+          </a:bodyPr>
+          <a:lstStyle xmlns:a="http://schemas.openxmlformats.org/drawingml/2006/main">
+            <a:defPPr algn="l">
+              <a:defRPr sz="2250" b="1">
+                <a:solidFill>
+                  <a:srgbClr val="157D80"/>
+                </a:solidFill>
+                <a:latin typeface="Aptos"/>
+                <a:ea typeface="Aptos"/>
+                <a:cs typeface="Aptos"/>
+              </a:defRPr>
+            </a:defPPr>
+          </a:lstStyle>
+          <a:p xmlns:a="http://schemas.openxmlformats.org/drawingml/2006/main">
+            <a:pPr algn="l">
+              <a:buNone/>
+              <a:defRPr sz="2250" b="1">
+                <a:solidFill>
+                  <a:srgbClr val="157D80"/>
+                </a:solidFill>
+                <a:latin typeface="Aptos"/>
+                <a:ea typeface="Aptos"/>
+                <a:cs typeface="Aptos"/>
+              </a:defRPr>
+            </a:pPr>
+            <a:r>
+              <a:rPr sz="2250" b="1">
+                <a:solidFill>
+                  <a:srgbClr val="157D80"/>
+                </a:solidFill>
+                <a:latin typeface="Aptos"/>
+                <a:ea typeface="Aptos"/>
+                <a:cs typeface="Aptos"/>
+              </a:rPr>
+              <a:t>Review and acceptance</a:t>
+            </a:r>
+          </a:p>
+        </p:txBody>
+      </p:sp>
+      <p:sp>
+        <p:nvSpPr>
+          <p:cNvPr id="20" name="text-157">
+            <a:extLst xmlns:a="http://schemas.openxmlformats.org/drawingml/2006/main">
+              <a:ext uri="{FF2B5EF4-FFF2-40B4-BE49-F238E27FC236}">
+                <a16:creationId xmlns:a16="http://schemas.microsoft.com/office/drawing/2014/main" id="{A480B314-118F-4395-B774-59C14B986408}"/>
+              </a:ext>
+            </a:extLst>
+          </p:cNvPr>
+          <p:cNvSpPr>
+            <a:spLocks xmlns:a="http://schemas.openxmlformats.org/drawingml/2006/main" noGrp="1"/>
+          </p:cNvSpPr>
+          <p:nvPr/>
+        </p:nvSpPr>
+        <p:spPr>
+          <a:xfrm xmlns:a="http://schemas.openxmlformats.org/drawingml/2006/main">
+            <a:off x="8858250" y="6844665"/>
+            <a:ext cx="5581650" cy="340233"/>
+          </a:xfrm>
+          <a:prstGeom xmlns:a="http://schemas.openxmlformats.org/drawingml/2006/main" prst="rect">
+            <a:avLst/>
+          </a:prstGeom>
+          <a:noFill xmlns:a="http://schemas.openxmlformats.org/drawingml/2006/main"/>
+          <a:ln xmlns:a="http://schemas.openxmlformats.org/drawingml/2006/main" w="0">
+            <a:noFill/>
+            <a:prstDash val="solid"/>
+          </a:ln>
+        </p:spPr>
+        <p:txBody>
+          <a:bodyPr xmlns:a="http://schemas.openxmlformats.org/drawingml/2006/main" wrap="square" lIns="0" tIns="0" rIns="0" bIns="0" anchor="t">
+            <a:noAutofit/>
+          </a:bodyPr>
+          <a:lstStyle xmlns:a="http://schemas.openxmlformats.org/drawingml/2006/main">
+            <a:defPPr algn="l">
+              <a:defRPr sz="1950" b="0">
+                <a:solidFill>
+                  <a:srgbClr val="4A6572"/>
+                </a:solidFill>
+                <a:latin typeface="Aptos"/>
+                <a:ea typeface="Aptos"/>
+                <a:cs typeface="Aptos"/>
+              </a:defRPr>
+            </a:defPPr>
+          </a:lstStyle>
+          <a:p xmlns:a="http://schemas.openxmlformats.org/drawingml/2006/main">
+            <a:pPr algn="l">
+              <a:buNone/>
+              <a:defRPr sz="1950" b="0">
+                <a:solidFill>
+                  <a:srgbClr val="4A6572"/>
+                </a:solidFill>
+                <a:latin typeface="Aptos"/>
+                <a:ea typeface="Aptos"/>
+                <a:cs typeface="Aptos"/>
+              </a:defRPr>
+            </a:pPr>
+            <a:r>
+              <a:rPr sz="1950" b="0">
+                <a:solidFill>
+                  <a:srgbClr val="4A6572"/>
+                </a:solidFill>
+                <a:latin typeface="Aptos"/>
+                <a:ea typeface="Aptos"/>
+                <a:cs typeface="Aptos"/>
+              </a:rPr>
+              <a:t>Native integration next</a:t>
+            </a:r>
+          </a:p>
+        </p:txBody>
+      </p:sp>
+      <p:cxnSp>
+        <p:nvCxnSpPr>
+          <p:cNvPr id="21" name="flow-158">
+            <a:extLst xmlns:a="http://schemas.openxmlformats.org/drawingml/2006/main">
+              <a:ext uri="{FF2B5EF4-FFF2-40B4-BE49-F238E27FC236}">
+                <a16:creationId xmlns:a16="http://schemas.microsoft.com/office/drawing/2014/main" id="{D0A4EEFB-8808-47DF-9BE4-A6EFA9E58FB5}"/>
+              </a:ext>
+            </a:extLst>
+          </p:cNvPr>
+          <p:cNvCxnSpPr/>
+          <p:nvPr/>
+        </p:nvCxnSpPr>
+        <p:spPr>
+          <a:xfrm xmlns:a="http://schemas.openxmlformats.org/drawingml/2006/main" flipH="0" flipV="0">
+            <a:off x="609600" y="6477000"/>
+            <a:ext cx="5334000" cy="0"/>
+          </a:xfrm>
+          <a:prstGeom xmlns:a="http://schemas.openxmlformats.org/drawingml/2006/main" prst="straightConnector1">
+            <a:avLst/>
+          </a:prstGeom>
+          <a:ln xmlns:a="http://schemas.openxmlformats.org/drawingml/2006/main" w="14288">
+            <a:solidFill>
+              <a:srgbClr val="B8CACC"/>
+            </a:solidFill>
+            <a:prstDash val="solid"/>
+          </a:ln>
+        </p:spPr>
+      </p:cxnSp>
+      <p:sp>
+        <p:nvSpPr>
+          <p:cNvPr id="22" name="node-159">
+            <a:extLst xmlns:a="http://schemas.openxmlformats.org/drawingml/2006/main">
+              <a:ext uri="{FF2B5EF4-FFF2-40B4-BE49-F238E27FC236}">
+                <a16:creationId xmlns:a16="http://schemas.microsoft.com/office/drawing/2014/main" id="{3F5888FB-B549-4744-94BD-55682478694E}"/>
+              </a:ext>
+            </a:extLst>
+          </p:cNvPr>
+          <p:cNvSpPr>
+            <a:spLocks xmlns:a="http://schemas.openxmlformats.org/drawingml/2006/main" noGrp="1"/>
+          </p:cNvSpPr>
+          <p:nvPr/>
+        </p:nvSpPr>
+        <p:spPr>
+          <a:xfrm xmlns:a="http://schemas.openxmlformats.org/drawingml/2006/main">
+            <a:off x="609600" y="6858000"/>
+            <a:ext cx="5334000" cy="952500"/>
           </a:xfrm>
           <a:prstGeom xmlns:a="http://schemas.openxmlformats.org/drawingml/2006/main" prst="rect">
             <a:avLst/>
@@ -13573,22 +13987,22 @@
       </p:sp>
       <p:sp>
         <p:nvSpPr>
-          <p:cNvPr id="16" name="text-153">
-            <a:extLst xmlns:a="http://schemas.openxmlformats.org/drawingml/2006/main">
-              <a:ext uri="{FF2B5EF4-FFF2-40B4-BE49-F238E27FC236}">
-                <a16:creationId xmlns:a16="http://schemas.microsoft.com/office/drawing/2014/main" id="{25BAE476-D051-4A95-BC6B-956ECA4478E2}"/>
-              </a:ext>
-            </a:extLst>
-          </p:cNvPr>
-          <p:cNvSpPr>
-            <a:spLocks xmlns:a="http://schemas.openxmlformats.org/drawingml/2006/main" noGrp="1"/>
-          </p:cNvSpPr>
-          <p:nvPr/>
-        </p:nvSpPr>
-        <p:spPr>
-          <a:xfrm xmlns:a="http://schemas.openxmlformats.org/drawingml/2006/main">
-            <a:off x="8858250" y="4162425"/>
-            <a:ext cx="5581650" cy="386715"/>
+          <p:cNvPr id="23" name="text-160">
+            <a:extLst xmlns:a="http://schemas.openxmlformats.org/drawingml/2006/main">
+              <a:ext uri="{FF2B5EF4-FFF2-40B4-BE49-F238E27FC236}">
+                <a16:creationId xmlns:a16="http://schemas.microsoft.com/office/drawing/2014/main" id="{3174332F-933D-4987-A5E2-7FD7CE8CCE5B}"/>
+              </a:ext>
+            </a:extLst>
+          </p:cNvPr>
+          <p:cNvSpPr>
+            <a:spLocks xmlns:a="http://schemas.openxmlformats.org/drawingml/2006/main" noGrp="1"/>
+          </p:cNvSpPr>
+          <p:nvPr/>
+        </p:nvSpPr>
+        <p:spPr>
+          <a:xfrm xmlns:a="http://schemas.openxmlformats.org/drawingml/2006/main">
+            <a:off x="800100" y="7019925"/>
+            <a:ext cx="4953000" cy="386715"/>
           </a:xfrm>
           <a:prstGeom xmlns:a="http://schemas.openxmlformats.org/drawingml/2006/main" prst="rect">
             <a:avLst/>
@@ -13636,380 +14050,6 @@
                 <a:ea typeface="Aptos"/>
                 <a:cs typeface="Aptos"/>
               </a:rPr>
-              <a:t>Server validation</a:t>
-            </a:r>
-          </a:p>
-        </p:txBody>
-      </p:sp>
-      <p:sp>
-        <p:nvSpPr>
-          <p:cNvPr id="17" name="text-154">
-            <a:extLst xmlns:a="http://schemas.openxmlformats.org/drawingml/2006/main">
-              <a:ext uri="{FF2B5EF4-FFF2-40B4-BE49-F238E27FC236}">
-                <a16:creationId xmlns:a16="http://schemas.microsoft.com/office/drawing/2014/main" id="{F11BB3A0-ECF0-41B5-B3CD-BC71552C93EB}"/>
-              </a:ext>
-            </a:extLst>
-          </p:cNvPr>
-          <p:cNvSpPr>
-            <a:spLocks xmlns:a="http://schemas.openxmlformats.org/drawingml/2006/main" noGrp="1"/>
-          </p:cNvSpPr>
-          <p:nvPr/>
-        </p:nvSpPr>
-        <p:spPr>
-          <a:xfrm xmlns:a="http://schemas.openxmlformats.org/drawingml/2006/main">
-            <a:off x="8858250" y="4558665"/>
-            <a:ext cx="5581650" cy="340233"/>
-          </a:xfrm>
-          <a:prstGeom xmlns:a="http://schemas.openxmlformats.org/drawingml/2006/main" prst="rect">
-            <a:avLst/>
-          </a:prstGeom>
-          <a:noFill xmlns:a="http://schemas.openxmlformats.org/drawingml/2006/main"/>
-          <a:ln xmlns:a="http://schemas.openxmlformats.org/drawingml/2006/main" w="0">
-            <a:noFill/>
-            <a:prstDash val="solid"/>
-          </a:ln>
-        </p:spPr>
-        <p:txBody>
-          <a:bodyPr xmlns:a="http://schemas.openxmlformats.org/drawingml/2006/main" wrap="square" lIns="0" tIns="0" rIns="0" bIns="0" anchor="t">
-            <a:noAutofit/>
-          </a:bodyPr>
-          <a:lstStyle xmlns:a="http://schemas.openxmlformats.org/drawingml/2006/main">
-            <a:defPPr algn="l">
-              <a:defRPr sz="1950" b="0">
-                <a:solidFill>
-                  <a:srgbClr val="4A6572"/>
-                </a:solidFill>
-                <a:latin typeface="Aptos"/>
-                <a:ea typeface="Aptos"/>
-                <a:cs typeface="Aptos"/>
-              </a:defRPr>
-            </a:defPPr>
-          </a:lstStyle>
-          <a:p xmlns:a="http://schemas.openxmlformats.org/drawingml/2006/main">
-            <a:pPr algn="l">
-              <a:buNone/>
-              <a:defRPr sz="1950" b="0">
-                <a:solidFill>
-                  <a:srgbClr val="4A6572"/>
-                </a:solidFill>
-                <a:latin typeface="Aptos"/>
-                <a:ea typeface="Aptos"/>
-                <a:cs typeface="Aptos"/>
-              </a:defRPr>
-            </a:pPr>
-            <a:r>
-              <a:rPr sz="1950" b="0">
-                <a:solidFill>
-                  <a:srgbClr val="4A6572"/>
-                </a:solidFill>
-                <a:latin typeface="Aptos"/>
-                <a:ea typeface="Aptos"/>
-                <a:cs typeface="Aptos"/>
-              </a:rPr>
-              <a:t>Identity, task revision and source checks</a:t>
-            </a:r>
-          </a:p>
-        </p:txBody>
-      </p:sp>
-      <p:sp>
-        <p:nvSpPr>
-          <p:cNvPr id="18" name="node-155">
-            <a:extLst xmlns:a="http://schemas.openxmlformats.org/drawingml/2006/main">
-              <a:ext uri="{FF2B5EF4-FFF2-40B4-BE49-F238E27FC236}">
-                <a16:creationId xmlns:a16="http://schemas.microsoft.com/office/drawing/2014/main" id="{D21E1D51-8C9A-47B9-B1E4-DB9FC38BEA0C}"/>
-              </a:ext>
-            </a:extLst>
-          </p:cNvPr>
-          <p:cNvSpPr>
-            <a:spLocks xmlns:a="http://schemas.openxmlformats.org/drawingml/2006/main" noGrp="1"/>
-          </p:cNvSpPr>
-          <p:nvPr/>
-        </p:nvSpPr>
-        <p:spPr>
-          <a:xfrm xmlns:a="http://schemas.openxmlformats.org/drawingml/2006/main">
-            <a:off x="8667750" y="6286500"/>
-            <a:ext cx="5962650" cy="1333500"/>
-          </a:xfrm>
-          <a:prstGeom xmlns:a="http://schemas.openxmlformats.org/drawingml/2006/main" prst="rect">
-            <a:avLst/>
-          </a:prstGeom>
-          <a:solidFill xmlns:a="http://schemas.openxmlformats.org/drawingml/2006/main">
-            <a:srgbClr val="E7F1EE"/>
-          </a:solidFill>
-          <a:ln xmlns:a="http://schemas.openxmlformats.org/drawingml/2006/main" w="17145">
-            <a:solidFill>
-              <a:srgbClr val="157D80"/>
-            </a:solidFill>
-            <a:prstDash val="solid"/>
-          </a:ln>
-        </p:spPr>
-      </p:sp>
-      <p:sp>
-        <p:nvSpPr>
-          <p:cNvPr id="19" name="text-156">
-            <a:extLst xmlns:a="http://schemas.openxmlformats.org/drawingml/2006/main">
-              <a:ext uri="{FF2B5EF4-FFF2-40B4-BE49-F238E27FC236}">
-                <a16:creationId xmlns:a16="http://schemas.microsoft.com/office/drawing/2014/main" id="{AFCF249E-1085-4474-8A12-407CBA559FDA}"/>
-              </a:ext>
-            </a:extLst>
-          </p:cNvPr>
-          <p:cNvSpPr>
-            <a:spLocks xmlns:a="http://schemas.openxmlformats.org/drawingml/2006/main" noGrp="1"/>
-          </p:cNvSpPr>
-          <p:nvPr/>
-        </p:nvSpPr>
-        <p:spPr>
-          <a:xfrm xmlns:a="http://schemas.openxmlformats.org/drawingml/2006/main">
-            <a:off x="8858250" y="6448425"/>
-            <a:ext cx="5581650" cy="386715"/>
-          </a:xfrm>
-          <a:prstGeom xmlns:a="http://schemas.openxmlformats.org/drawingml/2006/main" prst="rect">
-            <a:avLst/>
-          </a:prstGeom>
-          <a:noFill xmlns:a="http://schemas.openxmlformats.org/drawingml/2006/main"/>
-          <a:ln xmlns:a="http://schemas.openxmlformats.org/drawingml/2006/main" w="0">
-            <a:noFill/>
-            <a:prstDash val="solid"/>
-          </a:ln>
-        </p:spPr>
-        <p:txBody>
-          <a:bodyPr xmlns:a="http://schemas.openxmlformats.org/drawingml/2006/main" wrap="square" lIns="0" tIns="0" rIns="0" bIns="0" anchor="t">
-            <a:noAutofit/>
-          </a:bodyPr>
-          <a:lstStyle xmlns:a="http://schemas.openxmlformats.org/drawingml/2006/main">
-            <a:defPPr algn="l">
-              <a:defRPr sz="2250" b="1">
-                <a:solidFill>
-                  <a:srgbClr val="157D80"/>
-                </a:solidFill>
-                <a:latin typeface="Aptos"/>
-                <a:ea typeface="Aptos"/>
-                <a:cs typeface="Aptos"/>
-              </a:defRPr>
-            </a:defPPr>
-          </a:lstStyle>
-          <a:p xmlns:a="http://schemas.openxmlformats.org/drawingml/2006/main">
-            <a:pPr algn="l">
-              <a:buNone/>
-              <a:defRPr sz="2250" b="1">
-                <a:solidFill>
-                  <a:srgbClr val="157D80"/>
-                </a:solidFill>
-                <a:latin typeface="Aptos"/>
-                <a:ea typeface="Aptos"/>
-                <a:cs typeface="Aptos"/>
-              </a:defRPr>
-            </a:pPr>
-            <a:r>
-              <a:rPr sz="2250" b="1">
-                <a:solidFill>
-                  <a:srgbClr val="157D80"/>
-                </a:solidFill>
-                <a:latin typeface="Aptos"/>
-                <a:ea typeface="Aptos"/>
-                <a:cs typeface="Aptos"/>
-              </a:rPr>
-              <a:t>Review and acceptance</a:t>
-            </a:r>
-          </a:p>
-        </p:txBody>
-      </p:sp>
-      <p:sp>
-        <p:nvSpPr>
-          <p:cNvPr id="20" name="text-157">
-            <a:extLst xmlns:a="http://schemas.openxmlformats.org/drawingml/2006/main">
-              <a:ext uri="{FF2B5EF4-FFF2-40B4-BE49-F238E27FC236}">
-                <a16:creationId xmlns:a16="http://schemas.microsoft.com/office/drawing/2014/main" id="{A480B314-118F-4395-B774-59C14B986408}"/>
-              </a:ext>
-            </a:extLst>
-          </p:cNvPr>
-          <p:cNvSpPr>
-            <a:spLocks xmlns:a="http://schemas.openxmlformats.org/drawingml/2006/main" noGrp="1"/>
-          </p:cNvSpPr>
-          <p:nvPr/>
-        </p:nvSpPr>
-        <p:spPr>
-          <a:xfrm xmlns:a="http://schemas.openxmlformats.org/drawingml/2006/main">
-            <a:off x="8858250" y="6844665"/>
-            <a:ext cx="5581650" cy="340233"/>
-          </a:xfrm>
-          <a:prstGeom xmlns:a="http://schemas.openxmlformats.org/drawingml/2006/main" prst="rect">
-            <a:avLst/>
-          </a:prstGeom>
-          <a:noFill xmlns:a="http://schemas.openxmlformats.org/drawingml/2006/main"/>
-          <a:ln xmlns:a="http://schemas.openxmlformats.org/drawingml/2006/main" w="0">
-            <a:noFill/>
-            <a:prstDash val="solid"/>
-          </a:ln>
-        </p:spPr>
-        <p:txBody>
-          <a:bodyPr xmlns:a="http://schemas.openxmlformats.org/drawingml/2006/main" wrap="square" lIns="0" tIns="0" rIns="0" bIns="0" anchor="t">
-            <a:noAutofit/>
-          </a:bodyPr>
-          <a:lstStyle xmlns:a="http://schemas.openxmlformats.org/drawingml/2006/main">
-            <a:defPPr algn="l">
-              <a:defRPr sz="1950" b="0">
-                <a:solidFill>
-                  <a:srgbClr val="4A6572"/>
-                </a:solidFill>
-                <a:latin typeface="Aptos"/>
-                <a:ea typeface="Aptos"/>
-                <a:cs typeface="Aptos"/>
-              </a:defRPr>
-            </a:defPPr>
-          </a:lstStyle>
-          <a:p xmlns:a="http://schemas.openxmlformats.org/drawingml/2006/main">
-            <a:pPr algn="l">
-              <a:buNone/>
-              <a:defRPr sz="1950" b="0">
-                <a:solidFill>
-                  <a:srgbClr val="4A6572"/>
-                </a:solidFill>
-                <a:latin typeface="Aptos"/>
-                <a:ea typeface="Aptos"/>
-                <a:cs typeface="Aptos"/>
-              </a:defRPr>
-            </a:pPr>
-            <a:r>
-              <a:rPr sz="1950" b="0">
-                <a:solidFill>
-                  <a:srgbClr val="4A6572"/>
-                </a:solidFill>
-                <a:latin typeface="Aptos"/>
-                <a:ea typeface="Aptos"/>
-                <a:cs typeface="Aptos"/>
-              </a:rPr>
-              <a:t>Authorized task update</a:t>
-            </a:r>
-          </a:p>
-        </p:txBody>
-      </p:sp>
-      <p:cxnSp>
-        <p:nvCxnSpPr>
-          <p:cNvPr id="21" name="flow-158">
-            <a:extLst xmlns:a="http://schemas.openxmlformats.org/drawingml/2006/main">
-              <a:ext uri="{FF2B5EF4-FFF2-40B4-BE49-F238E27FC236}">
-                <a16:creationId xmlns:a16="http://schemas.microsoft.com/office/drawing/2014/main" id="{66349483-5A50-40B0-B266-21302A63AFCB}"/>
-              </a:ext>
-            </a:extLst>
-          </p:cNvPr>
-          <p:cNvCxnSpPr/>
-          <p:nvPr/>
-        </p:nvCxnSpPr>
-        <p:spPr>
-          <a:xfrm xmlns:a="http://schemas.openxmlformats.org/drawingml/2006/main" flipH="0" flipV="0">
-            <a:off x="609600" y="6477000"/>
-            <a:ext cx="5334000" cy="0"/>
-          </a:xfrm>
-          <a:prstGeom xmlns:a="http://schemas.openxmlformats.org/drawingml/2006/main" prst="straightConnector1">
-            <a:avLst/>
-          </a:prstGeom>
-          <a:ln xmlns:a="http://schemas.openxmlformats.org/drawingml/2006/main" w="14288">
-            <a:solidFill>
-              <a:srgbClr val="B8CACC"/>
-            </a:solidFill>
-            <a:prstDash val="solid"/>
-          </a:ln>
-        </p:spPr>
-      </p:cxnSp>
-      <p:sp>
-        <p:nvSpPr>
-          <p:cNvPr id="22" name="node-159">
-            <a:extLst xmlns:a="http://schemas.openxmlformats.org/drawingml/2006/main">
-              <a:ext uri="{FF2B5EF4-FFF2-40B4-BE49-F238E27FC236}">
-                <a16:creationId xmlns:a16="http://schemas.microsoft.com/office/drawing/2014/main" id="{3F5888FB-B549-4744-94BD-55682478694E}"/>
-              </a:ext>
-            </a:extLst>
-          </p:cNvPr>
-          <p:cNvSpPr>
-            <a:spLocks xmlns:a="http://schemas.openxmlformats.org/drawingml/2006/main" noGrp="1"/>
-          </p:cNvSpPr>
-          <p:nvPr/>
-        </p:nvSpPr>
-        <p:spPr>
-          <a:xfrm xmlns:a="http://schemas.openxmlformats.org/drawingml/2006/main">
-            <a:off x="609600" y="6858000"/>
-            <a:ext cx="5334000" cy="952500"/>
-          </a:xfrm>
-          <a:prstGeom xmlns:a="http://schemas.openxmlformats.org/drawingml/2006/main" prst="rect">
-            <a:avLst/>
-          </a:prstGeom>
-          <a:solidFill xmlns:a="http://schemas.openxmlformats.org/drawingml/2006/main">
-            <a:srgbClr val="FFFFFF"/>
-          </a:solidFill>
-          <a:ln xmlns:a="http://schemas.openxmlformats.org/drawingml/2006/main" w="17145">
-            <a:solidFill>
-              <a:srgbClr val="B8CACC"/>
-            </a:solidFill>
-            <a:prstDash val="solid"/>
-          </a:ln>
-        </p:spPr>
-      </p:sp>
-      <p:sp>
-        <p:nvSpPr>
-          <p:cNvPr id="23" name="text-160">
-            <a:extLst xmlns:a="http://schemas.openxmlformats.org/drawingml/2006/main">
-              <a:ext uri="{FF2B5EF4-FFF2-40B4-BE49-F238E27FC236}">
-                <a16:creationId xmlns:a16="http://schemas.microsoft.com/office/drawing/2014/main" id="{3174332F-933D-4987-A5E2-7FD7CE8CCE5B}"/>
-              </a:ext>
-            </a:extLst>
-          </p:cNvPr>
-          <p:cNvSpPr>
-            <a:spLocks xmlns:a="http://schemas.openxmlformats.org/drawingml/2006/main" noGrp="1"/>
-          </p:cNvSpPr>
-          <p:nvPr/>
-        </p:nvSpPr>
-        <p:spPr>
-          <a:xfrm xmlns:a="http://schemas.openxmlformats.org/drawingml/2006/main">
-            <a:off x="800100" y="7019925"/>
-            <a:ext cx="4953000" cy="386715"/>
-          </a:xfrm>
-          <a:prstGeom xmlns:a="http://schemas.openxmlformats.org/drawingml/2006/main" prst="rect">
-            <a:avLst/>
-          </a:prstGeom>
-          <a:noFill xmlns:a="http://schemas.openxmlformats.org/drawingml/2006/main"/>
-          <a:ln xmlns:a="http://schemas.openxmlformats.org/drawingml/2006/main" w="0">
-            <a:noFill/>
-            <a:prstDash val="solid"/>
-          </a:ln>
-        </p:spPr>
-        <p:txBody>
-          <a:bodyPr xmlns:a="http://schemas.openxmlformats.org/drawingml/2006/main" wrap="square" lIns="0" tIns="0" rIns="0" bIns="0" anchor="t">
-            <a:noAutofit/>
-          </a:bodyPr>
-          <a:lstStyle xmlns:a="http://schemas.openxmlformats.org/drawingml/2006/main">
-            <a:defPPr algn="l">
-              <a:defRPr sz="2250" b="1">
-                <a:solidFill>
-                  <a:srgbClr val="132E38"/>
-                </a:solidFill>
-                <a:latin typeface="Aptos"/>
-                <a:ea typeface="Aptos"/>
-                <a:cs typeface="Aptos"/>
-              </a:defRPr>
-            </a:defPPr>
-          </a:lstStyle>
-          <a:p xmlns:a="http://schemas.openxmlformats.org/drawingml/2006/main">
-            <a:pPr algn="l">
-              <a:buNone/>
-              <a:defRPr sz="2250" b="1">
-                <a:solidFill>
-                  <a:srgbClr val="132E38"/>
-                </a:solidFill>
-                <a:latin typeface="Aptos"/>
-                <a:ea typeface="Aptos"/>
-                <a:cs typeface="Aptos"/>
-              </a:defRPr>
-            </a:pPr>
-            <a:r>
-              <a:rPr sz="2250" b="1">
-                <a:solidFill>
-                  <a:srgbClr val="132E38"/>
-                </a:solidFill>
-                <a:latin typeface="Aptos"/>
-                <a:ea typeface="Aptos"/>
-                <a:cs typeface="Aptos"/>
-              </a:rPr>
               <a:t>Authorized human reviewer</a:t>
             </a:r>
           </a:p>
@@ -14160,7 +14200,7 @@
           <p:cNvPr id="27" name="flow-163">
             <a:extLst xmlns:a="http://schemas.openxmlformats.org/drawingml/2006/main">
               <a:ext uri="{FF2B5EF4-FFF2-40B4-BE49-F238E27FC236}">
-                <a16:creationId xmlns:a16="http://schemas.microsoft.com/office/drawing/2014/main" id="{8C9A3D5C-7BE3-4AF8-9C40-FB51EDBAD22C}"/>
+                <a16:creationId xmlns:a16="http://schemas.microsoft.com/office/drawing/2014/main" id="{E861DA4B-4845-48E9-B9A1-73275C411058}"/>
               </a:ext>
             </a:extLst>
           </p:cNvPr>
@@ -14188,7 +14228,7 @@
           <p:cNvPr id="28" name="flow-164">
             <a:extLst xmlns:a="http://schemas.openxmlformats.org/drawingml/2006/main">
               <a:ext uri="{FF2B5EF4-FFF2-40B4-BE49-F238E27FC236}">
-                <a16:creationId xmlns:a16="http://schemas.microsoft.com/office/drawing/2014/main" id="{41AC155E-C29D-4FBE-9125-71875122CF68}"/>
+                <a16:creationId xmlns:a16="http://schemas.microsoft.com/office/drawing/2014/main" id="{F5A2EB2C-855D-4850-A35B-5E581775762E}"/>
               </a:ext>
             </a:extLst>
           </p:cNvPr>
@@ -14216,7 +14256,7 @@
           <p:cNvPr id="29" name="flow-165">
             <a:extLst xmlns:a="http://schemas.openxmlformats.org/drawingml/2006/main">
               <a:ext uri="{FF2B5EF4-FFF2-40B4-BE49-F238E27FC236}">
-                <a16:creationId xmlns:a16="http://schemas.microsoft.com/office/drawing/2014/main" id="{46B354BC-263C-4A31-AB01-93B52D5100DC}"/>
+                <a16:creationId xmlns:a16="http://schemas.microsoft.com/office/drawing/2014/main" id="{4FFAE719-4C77-4766-B766-C76BBAA07764}"/>
               </a:ext>
             </a:extLst>
           </p:cNvPr>
@@ -14315,7 +14355,7 @@
           <p:cNvPr id="31" name="flow-167">
             <a:extLst xmlns:a="http://schemas.openxmlformats.org/drawingml/2006/main">
               <a:ext uri="{FF2B5EF4-FFF2-40B4-BE49-F238E27FC236}">
-                <a16:creationId xmlns:a16="http://schemas.microsoft.com/office/drawing/2014/main" id="{6E9984F7-475E-4988-8BD3-A0D2C5175F98}"/>
+                <a16:creationId xmlns:a16="http://schemas.microsoft.com/office/drawing/2014/main" id="{4F4A29F4-5A75-4A9A-ACAD-5FE523567CDD}"/>
               </a:ext>
             </a:extLst>
           </p:cNvPr>
@@ -14414,7 +14454,7 @@
           <p:cNvPr id="33" name="flow-169">
             <a:extLst xmlns:a="http://schemas.openxmlformats.org/drawingml/2006/main">
               <a:ext uri="{FF2B5EF4-FFF2-40B4-BE49-F238E27FC236}">
-                <a16:creationId xmlns:a16="http://schemas.microsoft.com/office/drawing/2014/main" id="{FF5185BC-DC54-4EE1-B87B-EC47F60BD949}"/>
+                <a16:creationId xmlns:a16="http://schemas.microsoft.com/office/drawing/2014/main" id="{EC7DDB2E-1145-4C66-9470-0A8E3BE6190D}"/>
               </a:ext>
             </a:extLst>
           </p:cNvPr>
@@ -14433,7 +14473,7 @@
             <a:solidFill>
               <a:srgbClr val="157D80"/>
             </a:solidFill>
-            <a:prstDash val="solid"/>
+            <a:prstDash val="dash"/>
             <a:tailEnd type="triangle" w="med" len="med"/>
           </a:ln>
         </p:spPr>
@@ -14503,7 +14543,31 @@
                 <a:ea typeface="Aptos"/>
                 <a:cs typeface="Aptos"/>
               </a:rPr>
-              <a:t>Validated evidence</a:t>
+              <a:t>Saved candidate</a:t>
+            </a:r>
+          </a:p>
+          <a:p xmlns:a="http://schemas.openxmlformats.org/drawingml/2006/main">
+            <a:pPr algn="ctr">
+              <a:buNone/>
+              <a:defRPr sz="1725" b="0">
+                <a:solidFill>
+                  <a:srgbClr val="4A6572"/>
+                </a:solidFill>
+                <a:latin typeface="Aptos"/>
+                <a:ea typeface="Aptos"/>
+                <a:cs typeface="Aptos"/>
+              </a:defRPr>
+            </a:pPr>
+            <a:r>
+              <a:rPr sz="1725" b="0">
+                <a:solidFill>
+                  <a:srgbClr val="4A6572"/>
+                </a:solidFill>
+                <a:latin typeface="Aptos"/>
+                <a:ea typeface="Aptos"/>
+                <a:cs typeface="Aptos"/>
+              </a:rPr>
+              <a:t>Review handoff next</a:t>
             </a:r>
           </a:p>
         </p:txBody>
@@ -14513,7 +14577,7 @@
           <p:cNvPr id="35" name="flow-171">
             <a:extLst xmlns:a="http://schemas.openxmlformats.org/drawingml/2006/main">
               <a:ext uri="{FF2B5EF4-FFF2-40B4-BE49-F238E27FC236}">
-                <a16:creationId xmlns:a16="http://schemas.microsoft.com/office/drawing/2014/main" id="{B64E98BC-F4C7-4173-9032-9C1E8C8381CC}"/>
+                <a16:creationId xmlns:a16="http://schemas.microsoft.com/office/drawing/2014/main" id="{9743F637-A6A5-4226-A24E-BE9DF8D49AF9}"/>
               </a:ext>
             </a:extLst>
           </p:cNvPr>
@@ -14541,7 +14605,7 @@
           <p:cNvPr id="36" name="flow-172">
             <a:extLst xmlns:a="http://schemas.openxmlformats.org/drawingml/2006/main">
               <a:ext uri="{FF2B5EF4-FFF2-40B4-BE49-F238E27FC236}">
-                <a16:creationId xmlns:a16="http://schemas.microsoft.com/office/drawing/2014/main" id="{92BA4FDE-B06D-4423-8C76-41FB57E367FF}"/>
+                <a16:creationId xmlns:a16="http://schemas.microsoft.com/office/drawing/2014/main" id="{0487D37B-C33D-419E-9B91-8F3BE9DF6DF9}"/>
               </a:ext>
             </a:extLst>
           </p:cNvPr>
@@ -14569,7 +14633,7 @@
           <p:cNvPr id="37" name="flow-173">
             <a:extLst xmlns:a="http://schemas.openxmlformats.org/drawingml/2006/main">
               <a:ext uri="{FF2B5EF4-FFF2-40B4-BE49-F238E27FC236}">
-                <a16:creationId xmlns:a16="http://schemas.microsoft.com/office/drawing/2014/main" id="{EB283368-94A3-45DC-B582-7DF3AEAEB353}"/>
+                <a16:creationId xmlns:a16="http://schemas.microsoft.com/office/drawing/2014/main" id="{9245F350-9661-41C5-A84A-EAABE9D2D4F0}"/>
               </a:ext>
             </a:extLst>
           </p:cNvPr>
@@ -14668,7 +14732,7 @@
           <p:cNvPr id="39" name="flow-175">
             <a:extLst xmlns:a="http://schemas.openxmlformats.org/drawingml/2006/main">
               <a:ext uri="{FF2B5EF4-FFF2-40B4-BE49-F238E27FC236}">
-                <a16:creationId xmlns:a16="http://schemas.microsoft.com/office/drawing/2014/main" id="{AE8BA6A1-1C3B-49E0-A662-A56C3AABA7F2}"/>
+                <a16:creationId xmlns:a16="http://schemas.microsoft.com/office/drawing/2014/main" id="{990AC02A-23C9-427A-BC76-D4F6DBD93D6F}"/>
               </a:ext>
             </a:extLst>
           </p:cNvPr>
@@ -14696,7 +14760,7 @@
           <p:cNvPr id="40" name="flow-176">
             <a:extLst xmlns:a="http://schemas.openxmlformats.org/drawingml/2006/main">
               <a:ext uri="{FF2B5EF4-FFF2-40B4-BE49-F238E27FC236}">
-                <a16:creationId xmlns:a16="http://schemas.microsoft.com/office/drawing/2014/main" id="{600CE152-AE3D-46D4-A504-B5F6D7534253}"/>
+                <a16:creationId xmlns:a16="http://schemas.microsoft.com/office/drawing/2014/main" id="{85DFC6C0-B1F4-44ED-A008-6808345A3073}"/>
               </a:ext>
             </a:extLst>
           </p:cNvPr>
@@ -14724,7 +14788,7 @@
           <p:cNvPr id="41" name="flow-177">
             <a:extLst xmlns:a="http://schemas.openxmlformats.org/drawingml/2006/main">
               <a:ext uri="{FF2B5EF4-FFF2-40B4-BE49-F238E27FC236}">
-                <a16:creationId xmlns:a16="http://schemas.microsoft.com/office/drawing/2014/main" id="{C726FAEB-C2E6-4AA7-AFFC-1499C7D9E3D7}"/>
+                <a16:creationId xmlns:a16="http://schemas.microsoft.com/office/drawing/2014/main" id="{BB981CBA-718D-40B5-A2A6-1E5120660BE8}"/>
               </a:ext>
             </a:extLst>
           </p:cNvPr>
@@ -14752,7 +14816,7 @@
           <p:cNvPr id="42" name="flow-178">
             <a:extLst xmlns:a="http://schemas.openxmlformats.org/drawingml/2006/main">
               <a:ext uri="{FF2B5EF4-FFF2-40B4-BE49-F238E27FC236}">
-                <a16:creationId xmlns:a16="http://schemas.microsoft.com/office/drawing/2014/main" id="{D1A4B1E5-77BC-4442-A91F-5D31790F5FF1}"/>
+                <a16:creationId xmlns:a16="http://schemas.microsoft.com/office/drawing/2014/main" id="{97FCC60A-03AE-4FF5-9195-199D77EA3064}"/>
               </a:ext>
             </a:extLst>
           </p:cNvPr>
@@ -15626,7 +15690,7 @@
           <p:cNvPr id="10" name="partner-flow-14">
             <a:extLst xmlns:a="http://schemas.openxmlformats.org/drawingml/2006/main">
               <a:ext uri="{FF2B5EF4-FFF2-40B4-BE49-F238E27FC236}">
-                <a16:creationId xmlns:a16="http://schemas.microsoft.com/office/drawing/2014/main" id="{7053BFAA-4CC8-4864-BFDF-5911A6EB9E33}"/>
+                <a16:creationId xmlns:a16="http://schemas.microsoft.com/office/drawing/2014/main" id="{C1FB5187-2091-4B2F-B26A-FF2429B1FA00}"/>
               </a:ext>
             </a:extLst>
           </p:cNvPr>
@@ -15971,7 +16035,7 @@
           <p:cNvPr id="15" name="partner-flow-19">
             <a:extLst xmlns:a="http://schemas.openxmlformats.org/drawingml/2006/main">
               <a:ext uri="{FF2B5EF4-FFF2-40B4-BE49-F238E27FC236}">
-                <a16:creationId xmlns:a16="http://schemas.microsoft.com/office/drawing/2014/main" id="{3C810182-40BC-457E-98DE-F040AB5F0D8D}"/>
+                <a16:creationId xmlns:a16="http://schemas.microsoft.com/office/drawing/2014/main" id="{C6D5B310-1D15-45BE-BFE7-6709B47B9A84}"/>
               </a:ext>
             </a:extLst>
           </p:cNvPr>
@@ -16267,7 +16331,7 @@
           <p:cNvPr id="20" name="partner-flow-24">
             <a:extLst xmlns:a="http://schemas.openxmlformats.org/drawingml/2006/main">
               <a:ext uri="{FF2B5EF4-FFF2-40B4-BE49-F238E27FC236}">
-                <a16:creationId xmlns:a16="http://schemas.microsoft.com/office/drawing/2014/main" id="{2FF0F711-F536-4B8A-AD68-D7346A2A1B1B}"/>
+                <a16:creationId xmlns:a16="http://schemas.microsoft.com/office/drawing/2014/main" id="{688DCCBC-6817-4A75-95D4-22D8396A0E54}"/>
               </a:ext>
             </a:extLst>
           </p:cNvPr>
@@ -16295,7 +16359,7 @@
           <p:cNvPr id="21" name="partner-flow-25">
             <a:extLst xmlns:a="http://schemas.openxmlformats.org/drawingml/2006/main">
               <a:ext uri="{FF2B5EF4-FFF2-40B4-BE49-F238E27FC236}">
-                <a16:creationId xmlns:a16="http://schemas.microsoft.com/office/drawing/2014/main" id="{CE6CCB48-8545-4F96-91F8-28E517050973}"/>
+                <a16:creationId xmlns:a16="http://schemas.microsoft.com/office/drawing/2014/main" id="{C52DC936-70A5-4C5F-A32D-7D31CD24644C}"/>
               </a:ext>
             </a:extLst>
           </p:cNvPr>
@@ -16323,7 +16387,7 @@
           <p:cNvPr id="22" name="partner-flow-26">
             <a:extLst xmlns:a="http://schemas.openxmlformats.org/drawingml/2006/main">
               <a:ext uri="{FF2B5EF4-FFF2-40B4-BE49-F238E27FC236}">
-                <a16:creationId xmlns:a16="http://schemas.microsoft.com/office/drawing/2014/main" id="{846A3AF9-44FE-4F69-8C01-7767FB217587}"/>
+                <a16:creationId xmlns:a16="http://schemas.microsoft.com/office/drawing/2014/main" id="{BD26B45E-DFC7-485C-A8C8-8E005339C3C1}"/>
               </a:ext>
             </a:extLst>
           </p:cNvPr>
@@ -17757,7 +17821,7 @@
           <p:cNvPr id="16" name="partner-flow-45">
             <a:extLst xmlns:a="http://schemas.openxmlformats.org/drawingml/2006/main">
               <a:ext uri="{FF2B5EF4-FFF2-40B4-BE49-F238E27FC236}">
-                <a16:creationId xmlns:a16="http://schemas.microsoft.com/office/drawing/2014/main" id="{A9B15B4F-E453-4BE4-B5B7-DB41D0C47AA4}"/>
+                <a16:creationId xmlns:a16="http://schemas.microsoft.com/office/drawing/2014/main" id="{97E60165-6DBA-4CE5-ADB4-8F5BC04CB5C4}"/>
               </a:ext>
             </a:extLst>
           </p:cNvPr>
@@ -17786,7 +17850,7 @@
           <p:cNvPr id="17" name="partner-flow-46">
             <a:extLst xmlns:a="http://schemas.openxmlformats.org/drawingml/2006/main">
               <a:ext uri="{FF2B5EF4-FFF2-40B4-BE49-F238E27FC236}">
-                <a16:creationId xmlns:a16="http://schemas.microsoft.com/office/drawing/2014/main" id="{213E47D0-76F3-43CA-ACA0-3BE813120F9E}"/>
+                <a16:creationId xmlns:a16="http://schemas.microsoft.com/office/drawing/2014/main" id="{AA8592C8-2180-44A1-93B2-F1157510F9F1}"/>
               </a:ext>
             </a:extLst>
           </p:cNvPr>
@@ -17815,7 +17879,7 @@
           <p:cNvPr id="18" name="partner-flow-47">
             <a:extLst xmlns:a="http://schemas.openxmlformats.org/drawingml/2006/main">
               <a:ext uri="{FF2B5EF4-FFF2-40B4-BE49-F238E27FC236}">
-                <a16:creationId xmlns:a16="http://schemas.microsoft.com/office/drawing/2014/main" id="{F39F82FC-2DA1-4CB9-9D10-51547946F5F3}"/>
+                <a16:creationId xmlns:a16="http://schemas.microsoft.com/office/drawing/2014/main" id="{EB3D61D6-5EF2-4322-8A24-2B2DF5A8E929}"/>
               </a:ext>
             </a:extLst>
           </p:cNvPr>
@@ -17844,7 +17908,7 @@
           <p:cNvPr id="19" name="partner-flow-48">
             <a:extLst xmlns:a="http://schemas.openxmlformats.org/drawingml/2006/main">
               <a:ext uri="{FF2B5EF4-FFF2-40B4-BE49-F238E27FC236}">
-                <a16:creationId xmlns:a16="http://schemas.microsoft.com/office/drawing/2014/main" id="{823279A2-F902-45C2-BED8-927CC8DB361E}"/>
+                <a16:creationId xmlns:a16="http://schemas.microsoft.com/office/drawing/2014/main" id="{B3EBBFBE-5872-42F2-A644-D5B19C4266F2}"/>
               </a:ext>
             </a:extLst>
           </p:cNvPr>
@@ -17872,7 +17936,7 @@
           <p:cNvPr id="20" name="partner-flow-49">
             <a:extLst xmlns:a="http://schemas.openxmlformats.org/drawingml/2006/main">
               <a:ext uri="{FF2B5EF4-FFF2-40B4-BE49-F238E27FC236}">
-                <a16:creationId xmlns:a16="http://schemas.microsoft.com/office/drawing/2014/main" id="{BC3B5E22-C13A-4C15-B730-9AA440AE21F6}"/>
+                <a16:creationId xmlns:a16="http://schemas.microsoft.com/office/drawing/2014/main" id="{45B82E9C-590A-4E53-820E-09B6CEEF26C8}"/>
               </a:ext>
             </a:extLst>
           </p:cNvPr>
@@ -17900,7 +17964,7 @@
           <p:cNvPr id="21" name="partner-flow-50">
             <a:extLst xmlns:a="http://schemas.openxmlformats.org/drawingml/2006/main">
               <a:ext uri="{FF2B5EF4-FFF2-40B4-BE49-F238E27FC236}">
-                <a16:creationId xmlns:a16="http://schemas.microsoft.com/office/drawing/2014/main" id="{A0698FFB-354A-4754-9FDD-48431269D798}"/>
+                <a16:creationId xmlns:a16="http://schemas.microsoft.com/office/drawing/2014/main" id="{42F21023-ABDD-4F0B-826B-389A5A2339DB}"/>
               </a:ext>
             </a:extLst>
           </p:cNvPr>
@@ -17999,7 +18063,7 @@
           <p:cNvPr id="23" name="partner-flow-52">
             <a:extLst xmlns:a="http://schemas.openxmlformats.org/drawingml/2006/main">
               <a:ext uri="{FF2B5EF4-FFF2-40B4-BE49-F238E27FC236}">
-                <a16:creationId xmlns:a16="http://schemas.microsoft.com/office/drawing/2014/main" id="{31AECDA0-1654-4C82-A21C-14E41BCEC69C}"/>
+                <a16:creationId xmlns:a16="http://schemas.microsoft.com/office/drawing/2014/main" id="{C7AFD679-8C94-4545-8C92-F4DA78B526B7}"/>
               </a:ext>
             </a:extLst>
           </p:cNvPr>
@@ -18027,7 +18091,7 @@
           <p:cNvPr id="24" name="partner-flow-53">
             <a:extLst xmlns:a="http://schemas.openxmlformats.org/drawingml/2006/main">
               <a:ext uri="{FF2B5EF4-FFF2-40B4-BE49-F238E27FC236}">
-                <a16:creationId xmlns:a16="http://schemas.microsoft.com/office/drawing/2014/main" id="{3A00E6D0-35AF-4C68-B73B-0E7B68940C86}"/>
+                <a16:creationId xmlns:a16="http://schemas.microsoft.com/office/drawing/2014/main" id="{4373D710-8140-4F15-BBE9-4E83C451CF47}"/>
               </a:ext>
             </a:extLst>
           </p:cNvPr>
@@ -18055,7 +18119,7 @@
           <p:cNvPr id="25" name="partner-flow-54">
             <a:extLst xmlns:a="http://schemas.openxmlformats.org/drawingml/2006/main">
               <a:ext uri="{FF2B5EF4-FFF2-40B4-BE49-F238E27FC236}">
-                <a16:creationId xmlns:a16="http://schemas.microsoft.com/office/drawing/2014/main" id="{B24AFD93-EFCA-4EBC-AFC1-6B1E5A6028B5}"/>
+                <a16:creationId xmlns:a16="http://schemas.microsoft.com/office/drawing/2014/main" id="{187BF84D-1085-4C66-A9CF-ED6A4F7838B2}"/>
               </a:ext>
             </a:extLst>
           </p:cNvPr>
@@ -18600,7 +18664,7 @@
           <p:cNvPr id="33" name="changed-assertions-edge-label-leader">
             <a:extLst xmlns:a="http://schemas.openxmlformats.org/drawingml/2006/main">
               <a:ext uri="{FF2B5EF4-FFF2-40B4-BE49-F238E27FC236}">
-                <a16:creationId xmlns:a16="http://schemas.microsoft.com/office/drawing/2014/main" id="{3BACE6B9-C148-453B-B8BE-FE0D77EF2323}"/>
+                <a16:creationId xmlns:a16="http://schemas.microsoft.com/office/drawing/2014/main" id="{12734BAE-6D6B-40BA-B926-14249190C5C4}"/>
               </a:ext>
             </a:extLst>
           </p:cNvPr>
@@ -18797,7 +18861,7 @@
           <p:cNvPr id="5" name="">
             <a:extLst xmlns:a="http://schemas.openxmlformats.org/drawingml/2006/main">
               <a:ext uri="{FF2B5EF4-FFF2-40B4-BE49-F238E27FC236}">
-                <a16:creationId xmlns:a16="http://schemas.microsoft.com/office/drawing/2014/main" id="{FA08A9B3-066A-4F3F-A7DE-375642552566}"/>
+                <a16:creationId xmlns:a16="http://schemas.microsoft.com/office/drawing/2014/main" id="{66340D06-6D3F-4F49-9CBF-76D471DBD0CF}"/>
               </a:ext>
             </a:extLst>
           </p:cNvPr>
@@ -19056,7 +19120,7 @@
                           <a:ea typeface="Aptos"/>
                           <a:cs typeface="Aptos"/>
                         </a:rPr>
-                        <a:t>Confirm Drive source access</a:t>
+                        <a:t>Confirm Drive sources and access</a:t>
                       </a:r>
                     </a:p>
                     <a:p>
@@ -19069,7 +19133,7 @@
                           <a:ea typeface="Aptos"/>
                           <a:cs typeface="Aptos"/>
                         </a:rPr>
-                        <a:t>Connect the source job</a:t>
+                        <a:t>Qualify the live source job</a:t>
                       </a:r>
                     </a:p>
                   </a:txBody>
@@ -19840,6 +19904,19 @@
                           <a:ea typeface="Aptos"/>
                           <a:cs typeface="Aptos"/>
                         </a:rPr>
+                        <a:t>Implement trusted submission and review</a:t>
+                      </a:r>
+                    </a:p>
+                    <a:p>
+                      <a:r>
+                        <a:rPr sz="1875" b="0">
+                          <a:solidFill>
+                            <a:srgbClr val="132E38"/>
+                          </a:solidFill>
+                          <a:latin typeface="Aptos"/>
+                          <a:ea typeface="Aptos"/>
+                          <a:cs typeface="Aptos"/>
+                        </a:rPr>
                         <a:t>Enroll and qualify a second contributor</a:t>
                       </a:r>
                     </a:p>
@@ -20461,7 +20538,7 @@
           <p:cNvPr id="9" name="flow-217">
             <a:extLst xmlns:a="http://schemas.openxmlformats.org/drawingml/2006/main">
               <a:ext uri="{FF2B5EF4-FFF2-40B4-BE49-F238E27FC236}">
-                <a16:creationId xmlns:a16="http://schemas.microsoft.com/office/drawing/2014/main" id="{447003AE-9C1A-415B-8FFF-4148B3BA88B6}"/>
+                <a16:creationId xmlns:a16="http://schemas.microsoft.com/office/drawing/2014/main" id="{B5A08364-19E8-490E-84FB-00264A8B600D}"/>
               </a:ext>
             </a:extLst>
           </p:cNvPr>
@@ -20490,7 +20567,7 @@
           <p:cNvPr id="10" name="flow-218">
             <a:extLst xmlns:a="http://schemas.openxmlformats.org/drawingml/2006/main">
               <a:ext uri="{FF2B5EF4-FFF2-40B4-BE49-F238E27FC236}">
-                <a16:creationId xmlns:a16="http://schemas.microsoft.com/office/drawing/2014/main" id="{23E22D28-C01A-4B8F-A184-0E16FE5BC9A9}"/>
+                <a16:creationId xmlns:a16="http://schemas.microsoft.com/office/drawing/2014/main" id="{78E21F28-8046-4B61-8154-B2D469F4D881}"/>
               </a:ext>
             </a:extLst>
           </p:cNvPr>
@@ -20603,7 +20680,7 @@
                 <a:ea typeface="Aptos"/>
                 <a:cs typeface="Aptos"/>
               </a:rPr>
-              <a:t>Roundtable core and client</a:t>
+              <a:t>Meeting sources and follow-up</a:t>
             </a:r>
           </a:p>
           <a:p xmlns:a="http://schemas.openxmlformats.org/drawingml/2006/main">
@@ -20865,7 +20942,7 @@
                 <a:ea typeface="Aptos"/>
                 <a:cs typeface="Aptos"/>
               </a:rPr>
-              <a:t>Cloud rehearsal tooling</a:t>
+              <a:t>Durable review and cancellation</a:t>
             </a:r>
           </a:p>
           <a:p xmlns:a="http://schemas.openxmlformats.org/drawingml/2006/main">
@@ -20889,7 +20966,31 @@
                 <a:ea typeface="Aptos"/>
                 <a:cs typeface="Aptos"/>
               </a:rPr>
-              <a:t>Durable review and cancellation</a:t>
+              <a:t>Discovery and alert routing</a:t>
+            </a:r>
+          </a:p>
+          <a:p xmlns:a="http://schemas.openxmlformats.org/drawingml/2006/main">
+            <a:pPr algn="l">
+              <a:buNone/>
+              <a:defRPr sz="2025" b="0">
+                <a:solidFill>
+                  <a:srgbClr val="132E38"/>
+                </a:solidFill>
+                <a:latin typeface="Aptos"/>
+                <a:ea typeface="Aptos"/>
+                <a:cs typeface="Aptos"/>
+              </a:defRPr>
+            </a:pPr>
+            <a:r>
+              <a:rPr sz="2025" b="0">
+                <a:solidFill>
+                  <a:srgbClr val="132E38"/>
+                </a:solidFill>
+                <a:latin typeface="Aptos"/>
+                <a:ea typeface="Aptos"/>
+                <a:cs typeface="Aptos"/>
+              </a:rPr>
+              <a:t>Member candidate validation</a:t>
             </a:r>
           </a:p>
         </p:txBody>
@@ -20983,7 +21084,7 @@
                 <a:ea typeface="Aptos"/>
                 <a:cs typeface="Aptos"/>
               </a:rPr>
-              <a:t>Operational discovery and alerts</a:t>
+              <a:t>Live research and alert qualification</a:t>
             </a:r>
           </a:p>
           <a:p xmlns:a="http://schemas.openxmlformats.org/drawingml/2006/main">
@@ -21113,7 +21214,7 @@
           <p:cNvPr id="14" name="flow-222">
             <a:extLst xmlns:a="http://schemas.openxmlformats.org/drawingml/2006/main">
               <a:ext uri="{FF2B5EF4-FFF2-40B4-BE49-F238E27FC236}">
-                <a16:creationId xmlns:a16="http://schemas.microsoft.com/office/drawing/2014/main" id="{7082CDD1-641A-4414-9749-37D6EC064BD7}"/>
+                <a16:creationId xmlns:a16="http://schemas.microsoft.com/office/drawing/2014/main" id="{31ED6B22-2C8A-497A-A492-99526EE4161B}"/>
               </a:ext>
             </a:extLst>
           </p:cNvPr>

</xml_diff>

<commit_message>
docs: synchronize meeting, discovery and member candidate status (#38)
</commit_message>
<xml_diff>
--- a/Inertia-Architecture.pptx
+++ b/Inertia-Architecture.pptx
@@ -2,21 +2,21 @@
 <file path=ppt/presentation.xml><?xml version="1.0" encoding="utf-8"?>
 <p:presentation xmlns:p="http://schemas.openxmlformats.org/presentationml/2006/main">
   <p:sldMasterIdLst>
-    <p:sldMasterId xmlns:r="http://schemas.openxmlformats.org/officeDocument/2006/relationships" id="2147483648" r:id="Re67716fdfb124d9f"/>
+    <p:sldMasterId xmlns:r="http://schemas.openxmlformats.org/officeDocument/2006/relationships" id="2147483648" r:id="R5e3ce0d235b54432"/>
   </p:sldMasterIdLst>
   <p:notesMasterIdLst>
-    <p:notesMasterId xmlns:r="http://schemas.openxmlformats.org/officeDocument/2006/relationships" r:id="Rb0e20b83594f454a"/>
+    <p:notesMasterId xmlns:r="http://schemas.openxmlformats.org/officeDocument/2006/relationships" r:id="R4de93270790644b3"/>
   </p:notesMasterIdLst>
   <p:sldIdLst>
-    <p:sldId xmlns:r="http://schemas.openxmlformats.org/officeDocument/2006/relationships" id="256" r:id="R03eae314aa414ed0"/>
-    <p:sldId xmlns:r="http://schemas.openxmlformats.org/officeDocument/2006/relationships" id="257" r:id="R676bf51815974a42"/>
-    <p:sldId xmlns:r="http://schemas.openxmlformats.org/officeDocument/2006/relationships" id="258" r:id="Re773d7e86bd74a4d"/>
-    <p:sldId xmlns:r="http://schemas.openxmlformats.org/officeDocument/2006/relationships" id="259" r:id="R9f0b67c8f5ea44e0"/>
-    <p:sldId xmlns:r="http://schemas.openxmlformats.org/officeDocument/2006/relationships" id="260" r:id="Rd220d56f4e4d4fdc"/>
-    <p:sldId xmlns:r="http://schemas.openxmlformats.org/officeDocument/2006/relationships" id="261" r:id="Rc6f1a977eefc4f00"/>
-    <p:sldId xmlns:r="http://schemas.openxmlformats.org/officeDocument/2006/relationships" id="262" r:id="R936733b4d6944b04"/>
-    <p:sldId xmlns:r="http://schemas.openxmlformats.org/officeDocument/2006/relationships" id="263" r:id="Rd103217cf543416a"/>
-    <p:sldId xmlns:r="http://schemas.openxmlformats.org/officeDocument/2006/relationships" id="264" r:id="R114e4421ef5c4ec8"/>
+    <p:sldId xmlns:r="http://schemas.openxmlformats.org/officeDocument/2006/relationships" id="256" r:id="R2732d204445748e9"/>
+    <p:sldId xmlns:r="http://schemas.openxmlformats.org/officeDocument/2006/relationships" id="257" r:id="R26731a1f10484fa6"/>
+    <p:sldId xmlns:r="http://schemas.openxmlformats.org/officeDocument/2006/relationships" id="258" r:id="Rc0a8e38ce5f6436b"/>
+    <p:sldId xmlns:r="http://schemas.openxmlformats.org/officeDocument/2006/relationships" id="259" r:id="R826a7a3dcd1b4353"/>
+    <p:sldId xmlns:r="http://schemas.openxmlformats.org/officeDocument/2006/relationships" id="260" r:id="Rb6f8ee8409774d33"/>
+    <p:sldId xmlns:r="http://schemas.openxmlformats.org/officeDocument/2006/relationships" id="261" r:id="R46af81d8aaf94481"/>
+    <p:sldId xmlns:r="http://schemas.openxmlformats.org/officeDocument/2006/relationships" id="262" r:id="Re7326f7df2f14630"/>
+    <p:sldId xmlns:r="http://schemas.openxmlformats.org/officeDocument/2006/relationships" id="263" r:id="R488cb08c01dd4e34"/>
+    <p:sldId xmlns:r="http://schemas.openxmlformats.org/officeDocument/2006/relationships" id="264" r:id="Rbf421dd28b304bef"/>
   </p:sldIdLst>
   <p:sldSz cx="15240000" cy="8572500"/>
   <p:notesSz cx="6858000" cy="9144000"/>
@@ -630,7 +630,7 @@
           <a:lstStyle xmlns:a="http://schemas.openxmlformats.org/drawingml/2006/main"/>
           <a:p xmlns:a="http://schemas.openxmlformats.org/drawingml/2006/main">
             <a:r>
-              <a:t>Sources: Inertia spec.md R-M01–R-M04 and R-F04; docs/integrations/dao-website-member-publication-proposal.md; dao-website-publication-v1.1-clarifications.md.</a:t>
+              <a:t>Sources: Inertia spec.md R-M01–R-M04 and R-F04; docs/development/meeting-source-native-composition.md; docs/integrations/dao-website-member-publication-proposal.md; dao-website-publication-v1.1-clarifications.md; Needed-from-team.md NTF01, NTF03 and NTF05.</a:t>
             </a:r>
           </a:p>
           <a:p xmlns:a="http://schemas.openxmlformats.org/drawingml/2006/main">
@@ -640,7 +640,7 @@
           </a:p>
           <a:p xmlns:a="http://schemas.openxmlformats.org/drawingml/2006/main">
             <a:r>
-              <a:t>Roundtable preserves original meeting sources, prepares a cleaned transcript and separate notes, and extracts source-linked candidates. Summary-only material produces notes and a missing-transcript task. Trusted admission retains exact evidence, revisions, audience and project/opportunity scope. Decisions and commitments require an authorized decision record. Published links return to the Paperclip task and Buzz thread.</a:t>
+              <a:t>The merged source job verifies Meet readiness and Drive identity/version before preparing a transcript and separate notes. It saves exact publication operations, reconciles uncertain outcomes and applies corrections through the existing website contract. New and corrected publications update one reference-only native follow-up. Summary-only sources retain a protected Drive reference and create missing-transcript work. Notes-only website output requires an approved server contract.</a:t>
             </a:r>
           </a:p>
           <a:p xmlns:a="http://schemas.openxmlformats.org/drawingml/2006/main">
@@ -650,7 +650,17 @@
           </a:p>
           <a:p xmlns:a="http://schemas.openxmlformats.org/drawingml/2006/main">
             <a:r>
-              <a:t>The objective intake/link/brief core is merged. Next: connect authorized Drive readiness, website membership/publication, action sources and trusted admission policy.</a:t>
+              <a:t>Actual pinned native PostgreSQL qualification passed ownership, source/correction flow, native issue and website acknowledgment recovery, and WAL restart preservation. Source and website responses were synthetic. The job stays disabled until approved Drive/website access, installation capabilities, source retention, transport limits and a staging canary are qualified.</a:t>
+            </a:r>
+          </a:p>
+          <a:p xmlns:a="http://schemas.openxmlformats.org/drawingml/2006/main">
+            <a:r>
+              <a:t/>
+            </a:r>
+          </a:p>
+          <a:p xmlns:a="http://schemas.openxmlformats.org/drawingml/2006/main">
+            <a:r>
+              <a:t>Trusted knowledge admission retains exact evidence, revisions, audience and project/opportunity scope. Decisions and commitments require an authorized decision record. Published links return to shared Paperclip work and its Buzz view.</a:t>
             </a:r>
           </a:p>
         </p:txBody>
@@ -820,7 +830,7 @@
           <a:lstStyle xmlns:a="http://schemas.openxmlformats.org/drawingml/2006/main"/>
           <a:p xmlns:a="http://schemas.openxmlformats.org/drawingml/2006/main">
             <a:r>
-              <a:t>Sources: Inertia spec.md §2 and R-C01–R-C05; docs/implementation/live-handoff-checklist.md.</a:t>
+              <a:t>Sources: Inertia spec.md R-C01–R-C05; docs/development/member-contribution-boundary.md; Needed-from-team.md NTF11.</a:t>
             </a:r>
           </a:p>
           <a:p xmlns:a="http://schemas.openxmlformats.org/drawingml/2006/main">
@@ -830,7 +840,7 @@
           </a:p>
           <a:p xmlns:a="http://schemas.openxmlformats.org/drawingml/2006/main">
             <a:r>
-              <a:t>An enrolled member agent receives an assigned task, authorized evidence and scoped tools in a sandbox and isolated worktree. It returns candidate evidence. Trusted services validate identity, task revision and source scope, then apply required reviews and accept the task update. A designated human supplies authenticated decisions when required. Database, admin and publisher credentials stay in trusted services.</a:t>
+              <a:t>The candidate library checks the authenticated member, exact execution attempt, enrollment, task revision, native run/checkout and artifact policy. It releases only server-curated inputs and stages immutable, untrusted candidate receipts. Exact retries converge and uncertain writes reconcile before returning a receipt. Actual pinned native services qualified candidate staging, revocation and recovery while tasks remained in progress.</a:t>
             </a:r>
           </a:p>
           <a:p xmlns:a="http://schemas.openxmlformats.org/drawingml/2006/main">
@@ -840,7 +850,7 @@
           </a:p>
           <a:p xmlns:a="http://schemas.openxmlformats.org/drawingml/2006/main">
             <a:r>
-              <a:t>Next: qualify member enrollment, live runtime isolation and contribution adapters.</a:t>
+              <a:t>Engineering must provide authenticated ingress and a fresh, non-reusable authority for each execution attempt. It also owns provider/sandbox qualification, native review handoff and final acceptance with current authority checks in the owning native transaction. The team supplies the willing participant, chosen runtime, membership reference and approved task/data scope. Database and publisher credentials stay in trusted services.</a:t>
             </a:r>
           </a:p>
         </p:txBody>
@@ -1060,7 +1070,7 @@
           </a:p>
           <a:p xmlns:a="http://schemas.openxmlformats.org/drawingml/2006/main">
             <a:r>
-              <a:t>Next: connect trusted source adapters, admit the inventory/backfill and qualify deployed graph refresh. The operational discovery loop reuses this research contract with bounded public search, official evidence capture and due rechecks.</a:t>
+              <a:t>Next: connect trusted source adapters, admit the inventory/backfill and qualify deployed graph refresh. The merged discovery foundation reuses this research contract with bounded source capture and due rechecks. Qualify the assigned research tools, admitted sources and live service path before activation.</a:t>
             </a:r>
           </a:p>
         </p:txBody>
@@ -1150,7 +1160,27 @@
           </a:p>
           <a:p xmlns:a="http://schemas.openxmlformats.org/drawingml/2006/main">
             <a:r>
-              <a:t>Next connections and component responsibilities appear in the table.</a:t>
+              <a:t>The source job and native meeting follow-up are merged. Confirm approved Drive examples/access, scoped issue capabilities and source retention, then qualify the real website/source path. Team inputs are tracked in Needed-from-team.md.</a:t>
+            </a:r>
+          </a:p>
+          <a:p xmlns:a="http://schemas.openxmlformats.org/drawingml/2006/main">
+            <a:r>
+              <a:t/>
+            </a:r>
+          </a:p>
+          <a:p xmlns:a="http://schemas.openxmlformats.org/drawingml/2006/main">
+            <a:r>
+              <a:t>Discovery uses the existing scout/diligence tasks and signed Buzz outbox. Its assigned issues need a host-resolvable active responsible member for native wake policy. NTF05 and NTF14 track runtime/tool access, scoped principals, the human audience and pilot budgets.</a:t>
+            </a:r>
+          </a:p>
+          <a:p xmlns:a="http://schemas.openxmlformats.org/drawingml/2006/main">
+            <a:r>
+              <a:t/>
+            </a:r>
+          </a:p>
+          <a:p xmlns:a="http://schemas.openxmlformats.org/drawingml/2006/main">
+            <a:r>
+              <a:t>Member candidate validation and immutable receipts are implemented. Trusted ingress, attempt-authority issuance, provider/sandbox qualification and native review/acceptance remain engineering work; NTF11 retains the participant and approved scope handoff.</a:t>
             </a:r>
           </a:p>
         </p:txBody>
@@ -1220,7 +1250,7 @@
           <a:lstStyle xmlns:a="http://schemas.openxmlformats.org/drawingml/2006/main"/>
           <a:p xmlns:a="http://schemas.openxmlformats.org/drawingml/2006/main">
             <a:r>
-              <a:t>Sources: Inertia spec.md, plan.md and testing.md; docs/development/funding-enhancement/discovery-loop.md; docs/development/objective-intake.md; scripts/cloud-rehearsal/README.md; https://github.com/NetRxn/Inertia/pull/25; https://github.com/NetRxn/Inertia/pull/26; https://github.com/NetRxn/Inertia/pull/27; https://github.com/NetRxn/Inertia/pull/28; https://github.com/NetRxn/DFW-Gov-Fund/pull/44; https://github.com/NetRxn/DFW-Gov-Fund/pull/45; https://github.com/NetRxn/DFW-Gov-Fund/pull/46; https://github.com/NetRxn/DFW-Gov-Fund/pull/47; https://github.com/NetRxn/DFW-Gov-Fund/pull/49; https://github.com/NetRxn/DFW-Gov-Fund/pull/50; host-composition/paperclip-durable-funding-review/ACTIVATION-CONTRACT.md. Status: 24 October 2026.</a:t>
+              <a:t>Sources: Inertia spec.md, plan.md and testing.md; docs/development/funding-enhancement/discovery-loop.md; docs/development/funding-enhancement/discovery-host-composition.md; Needed-from-team.md; docs/development/objective-intake.md; scripts/cloud-rehearsal/README.md; https://github.com/NetRxn/Inertia/pull/25; https://github.com/NetRxn/Inertia/pull/26; https://github.com/NetRxn/Inertia/pull/27; https://github.com/NetRxn/Inertia/pull/28; https://github.com/NetRxn/DFW-Gov-Fund/pull/44; https://github.com/NetRxn/DFW-Gov-Fund/pull/45; https://github.com/NetRxn/DFW-Gov-Fund/pull/46; https://github.com/NetRxn/DFW-Gov-Fund/pull/47; https://github.com/NetRxn/DFW-Gov-Fund/pull/49; https://github.com/NetRxn/DFW-Gov-Fund/pull/50; host-composition/paperclip-durable-funding-review/ACTIVATION-CONTRACT.md; docs/development/member-contribution-boundary.md. Status: 24 October 2026.</a:t>
             </a:r>
           </a:p>
           <a:p xmlns:a="http://schemas.openxmlformats.org/drawingml/2006/main">
@@ -1230,7 +1260,7 @@
           </a:p>
           <a:p xmlns:a="http://schemas.openxmlformats.org/drawingml/2006/main">
             <a:r>
-              <a:t>Merged cores now include drafting/gap preparation, scoped evidence and sanitized financial contracts, partner graph/research reuse, objective intake/links/briefs and cloud rehearsal tooling. The bounded October scout is complete. Its confidence overlay and separate July/manual/replay provenance are retained.</a:t>
+              <a:t>Merged cores now include meeting source/native follow-up, drafting/gap preparation, scoped evidence and sanitized financial contracts, partner graph/research reuse, objective intake/links/briefs and cloud rehearsal tooling. The bounded October scout is complete. Its confidence overlay and separate July/manual/replay provenance are retained.</a:t>
             </a:r>
           </a:p>
           <a:p xmlns:a="http://schemas.openxmlformats.org/drawingml/2006/main">
@@ -1240,7 +1270,7 @@
           </a:p>
           <a:p xmlns:a="http://schemas.openxmlformats.org/drawingml/2006/main">
             <a:r>
-              <a:t>Independent cloud rehearsal passed real domain PostgreSQL/PostGIS, native PostgreSQL service/membership/checkout/crash behavior and PG-to-embedded-Helix reuse. The actual-service synthetic meeting-answer-to-revised-brief workflow passed. npm audit and clean-package checks passed. Full HTTP/UI rehearsal needs an environment with working network-interface enumeration. Actual VPS/PPC2 enrollment and production deployment remain next work.</a:t>
+              <a:t>Independent cloud rehearsal passed real domain PostgreSQL/PostGIS, native PostgreSQL service/membership/checkout/crash behavior and PG-to-embedded-Helix reuse. The actual-service synthetic meeting-answer-to-revised-brief workflow passed. Meeting source/native composition also passed actual pinned native PostgreSQL recovery and WAL qualification with synthetic source/website responses. Real Drive/website access, scoped capabilities, retention and notes-only website behavior remain integration work. npm audit and clean-package checks passed. Full HTTP/UI rehearsal needs an environment with working network-interface enumeration. Actual VPS/PPC2 enrollment and production deployment remain next work.</a:t>
             </a:r>
           </a:p>
           <a:p xmlns:a="http://schemas.openxmlformats.org/drawingml/2006/main">
@@ -1260,7 +1290,7 @@
           </a:p>
           <a:p xmlns:a="http://schemas.openxmlformats.org/drawingml/2006/main">
             <a:r>
-              <a:t>The planned discovery loop queries saved knowledge, researches coverage gaps, validates official evidence, saves useful findings and produces prioritized briefs or deduplicated urgent alerts. Native tasks retain due rechecks and failed coverage. The daily profile remains disabled until actual agent/tool wiring, end-to-end rehearsal and recurring cadence approval. Broader 990 and optional semantic/vector enrichment follow separately.</a:t>
+              <a:t>The merged discovery foundation queries saved knowledge, captures official sources and produces preliminary briefs and date alerts for qualified sources before packet signoff. New sponsors enter quarantine and independent exact-source identity review. Independent reviewers now submit complete current source quotes for deadline and benefit assessment. Conditional briefs preserve unknown cutoff, eligibility and fit; unresolved evidence stays with agent diligence. Urgent transport uses the configured Buzz audience and signed outbox; relay acceptance records transport acknowledgment. Actual-native and cold-DFW rehearsal passed with synthetic sources and relay. Activation needs real browser/model/tool qualification, active responsible-member mappings, source/runtime access and approved audience/budgets. Recurrence remains disabled pending measured rehearsal and cadence approval. Broader 990 and semantic enrichment follow separately.</a:t>
             </a:r>
           </a:p>
           <a:p xmlns:a="http://schemas.openxmlformats.org/drawingml/2006/main">
@@ -1271,6 +1301,16 @@
           <a:p xmlns:a="http://schemas.openxmlformats.org/drawingml/2006/main">
             <a:r>
               <a:t>Connected demo outcomes remain website meeting publication, a reviewed direct-application packet with its required final vote, an accepted second-member contribution and research reused on a later run. Production financial-provider compatibility and trusted admission policy require qualification.</a:t>
+            </a:r>
+          </a:p>
+          <a:p xmlns:a="http://schemas.openxmlformats.org/drawingml/2006/main">
+            <a:r>
+              <a:t/>
+            </a:r>
+          </a:p>
+          <a:p xmlns:a="http://schemas.openxmlformats.org/drawingml/2006/main">
+            <a:r>
+              <a:t>Member candidate validation and replay are implemented and independently qualified on the combined native build. Engineering next connects authenticated ingress, non-reusable attempt authority, live provider execution and native review/acceptance. The second-member demonstration remains an activation goal.</a:t>
             </a:r>
           </a:p>
         </p:txBody>
@@ -3083,12 +3123,12 @@
   </p:cSld>
   <p:clrMap bg1="lt1" tx1="dk1" bg2="lt2" tx2="dk2" accent1="accent1" accent2="accent2" accent3="accent3" accent4="accent4" accent5="accent5" accent6="accent6" hlink="hlink" folHlink="folHlink"/>
   <p:sldLayoutIdLst>
-    <p:sldLayoutId xmlns:r="http://schemas.openxmlformats.org/officeDocument/2006/relationships" id="2147483649" r:id="R20b38ba70eb342b3"/>
-    <p:sldLayoutId xmlns:r="http://schemas.openxmlformats.org/officeDocument/2006/relationships" id="2147483650" r:id="Rd11476e6f4db4f52"/>
-    <p:sldLayoutId xmlns:r="http://schemas.openxmlformats.org/officeDocument/2006/relationships" id="2147483651" r:id="R5af7774cad524477"/>
-    <p:sldLayoutId xmlns:r="http://schemas.openxmlformats.org/officeDocument/2006/relationships" id="2147483652" r:id="Rd9c9b7a06dc94447"/>
-    <p:sldLayoutId xmlns:r="http://schemas.openxmlformats.org/officeDocument/2006/relationships" id="2147483653" r:id="Rf4e31d95c4da4466"/>
-    <p:sldLayoutId xmlns:r="http://schemas.openxmlformats.org/officeDocument/2006/relationships" id="2147483654" r:id="R91de7841eb0a44ac"/>
+    <p:sldLayoutId xmlns:r="http://schemas.openxmlformats.org/officeDocument/2006/relationships" id="2147483649" r:id="Rd13a80fc66ce4090"/>
+    <p:sldLayoutId xmlns:r="http://schemas.openxmlformats.org/officeDocument/2006/relationships" id="2147483650" r:id="Rd64e45b425b44dae"/>
+    <p:sldLayoutId xmlns:r="http://schemas.openxmlformats.org/officeDocument/2006/relationships" id="2147483651" r:id="R0f85ddb51d4f4209"/>
+    <p:sldLayoutId xmlns:r="http://schemas.openxmlformats.org/officeDocument/2006/relationships" id="2147483652" r:id="Rf56581445579435f"/>
+    <p:sldLayoutId xmlns:r="http://schemas.openxmlformats.org/officeDocument/2006/relationships" id="2147483653" r:id="R0a78effee79b4a6f"/>
+    <p:sldLayoutId xmlns:r="http://schemas.openxmlformats.org/officeDocument/2006/relationships" id="2147483654" r:id="R60495d1cb8444f3c"/>
   </p:sldLayoutIdLst>
   <p:txStyles>
     <p:titleStyle>
@@ -3639,7 +3679,7 @@
           <p:cNvPr id="39" name="">
             <a:extLst xmlns:a="http://schemas.openxmlformats.org/drawingml/2006/main">
               <a:ext uri="{FF2B5EF4-FFF2-40B4-BE49-F238E27FC236}">
-                <a16:creationId xmlns:a16="http://schemas.microsoft.com/office/drawing/2014/main" id="{C3120CBA-2826-44C8-94CB-F07348FEA7CB}"/>
+                <a16:creationId xmlns:a16="http://schemas.microsoft.com/office/drawing/2014/main" id="{F2CC556C-2FBD-49FA-97AC-2CDC1E921185}"/>
               </a:ext>
             </a:extLst>
           </p:cNvPr>
@@ -3672,7 +3712,7 @@
           <p:cNvPr id="32" name="">
             <a:extLst xmlns:a="http://schemas.openxmlformats.org/drawingml/2006/main">
               <a:ext uri="{FF2B5EF4-FFF2-40B4-BE49-F238E27FC236}">
-                <a16:creationId xmlns:a16="http://schemas.microsoft.com/office/drawing/2014/main" id="{A6DE5ED5-9A3C-4374-86AD-43A47E7004C6}"/>
+                <a16:creationId xmlns:a16="http://schemas.microsoft.com/office/drawing/2014/main" id="{9308FDB0-5972-48A6-B22A-34E8C4F8EA2A}"/>
               </a:ext>
             </a:extLst>
           </p:cNvPr>
@@ -3704,7 +3744,7 @@
           <p:cNvPr id="29" name="">
             <a:extLst xmlns:a="http://schemas.openxmlformats.org/drawingml/2006/main">
               <a:ext uri="{FF2B5EF4-FFF2-40B4-BE49-F238E27FC236}">
-                <a16:creationId xmlns:a16="http://schemas.microsoft.com/office/drawing/2014/main" id="{01B70731-45E5-470D-B4BB-F16F8402D9E0}"/>
+                <a16:creationId xmlns:a16="http://schemas.microsoft.com/office/drawing/2014/main" id="{EC7741F9-488D-4101-A888-E3261CB92D49}"/>
               </a:ext>
             </a:extLst>
           </p:cNvPr>
@@ -5497,7 +5537,7 @@
           <p:cNvPr id="30" name="flow-29">
             <a:extLst xmlns:a="http://schemas.openxmlformats.org/drawingml/2006/main">
               <a:ext uri="{FF2B5EF4-FFF2-40B4-BE49-F238E27FC236}">
-                <a16:creationId xmlns:a16="http://schemas.microsoft.com/office/drawing/2014/main" id="{8C091B80-C622-42DA-A009-93FF036A1267}"/>
+                <a16:creationId xmlns:a16="http://schemas.microsoft.com/office/drawing/2014/main" id="{CC551E53-B51A-413F-B10F-A026A982F66B}"/>
               </a:ext>
             </a:extLst>
           </p:cNvPr>
@@ -5527,7 +5567,7 @@
           <p:cNvPr id="31" name="flow-30">
             <a:extLst xmlns:a="http://schemas.openxmlformats.org/drawingml/2006/main">
               <a:ext uri="{FF2B5EF4-FFF2-40B4-BE49-F238E27FC236}">
-                <a16:creationId xmlns:a16="http://schemas.microsoft.com/office/drawing/2014/main" id="{9054FC2C-0002-4E13-A51A-7222044C9807}"/>
+                <a16:creationId xmlns:a16="http://schemas.microsoft.com/office/drawing/2014/main" id="{1216BD79-AD2E-4D0A-8BF5-796D9D002A17}"/>
               </a:ext>
             </a:extLst>
           </p:cNvPr>
@@ -5627,7 +5667,7 @@
           <p:cNvPr id="34" name="flow-32">
             <a:extLst xmlns:a="http://schemas.openxmlformats.org/drawingml/2006/main">
               <a:ext uri="{FF2B5EF4-FFF2-40B4-BE49-F238E27FC236}">
-                <a16:creationId xmlns:a16="http://schemas.microsoft.com/office/drawing/2014/main" id="{F42CA512-4975-4C1A-B259-B46282BE7931}"/>
+                <a16:creationId xmlns:a16="http://schemas.microsoft.com/office/drawing/2014/main" id="{D7F93970-F225-4598-A42C-A4B92C616A17}"/>
               </a:ext>
             </a:extLst>
           </p:cNvPr>
@@ -5656,7 +5696,7 @@
           <p:cNvPr id="35" name="flow-33">
             <a:extLst xmlns:a="http://schemas.openxmlformats.org/drawingml/2006/main">
               <a:ext uri="{FF2B5EF4-FFF2-40B4-BE49-F238E27FC236}">
-                <a16:creationId xmlns:a16="http://schemas.microsoft.com/office/drawing/2014/main" id="{3E3CF51B-F479-43FF-8544-3E0DE3B5B813}"/>
+                <a16:creationId xmlns:a16="http://schemas.microsoft.com/office/drawing/2014/main" id="{116FBAE3-6DE7-4724-9FB6-74463C44399D}"/>
               </a:ext>
             </a:extLst>
           </p:cNvPr>
@@ -5684,7 +5724,7 @@
           <p:cNvPr id="36" name="flow-34">
             <a:extLst xmlns:a="http://schemas.openxmlformats.org/drawingml/2006/main">
               <a:ext uri="{FF2B5EF4-FFF2-40B4-BE49-F238E27FC236}">
-                <a16:creationId xmlns:a16="http://schemas.microsoft.com/office/drawing/2014/main" id="{17507772-98B2-4512-B4A7-E4A0D3371618}"/>
+                <a16:creationId xmlns:a16="http://schemas.microsoft.com/office/drawing/2014/main" id="{95586601-9CB6-4A86-A16C-73D2852D00EF}"/>
               </a:ext>
             </a:extLst>
           </p:cNvPr>
@@ -5783,7 +5823,7 @@
           <p:cNvPr id="38" name="flow-36">
             <a:extLst xmlns:a="http://schemas.openxmlformats.org/drawingml/2006/main">
               <a:ext uri="{FF2B5EF4-FFF2-40B4-BE49-F238E27FC236}">
-                <a16:creationId xmlns:a16="http://schemas.microsoft.com/office/drawing/2014/main" id="{FC620AFA-6BA6-43F0-91CD-C3EA0574AE65}"/>
+                <a16:creationId xmlns:a16="http://schemas.microsoft.com/office/drawing/2014/main" id="{57797733-D8CA-4958-808F-A0726DE98AA3}"/>
               </a:ext>
             </a:extLst>
           </p:cNvPr>
@@ -5912,7 +5952,7 @@
           <p:cNvPr id="35" name="">
             <a:extLst xmlns:a="http://schemas.openxmlformats.org/drawingml/2006/main">
               <a:ext uri="{FF2B5EF4-FFF2-40B4-BE49-F238E27FC236}">
-                <a16:creationId xmlns:a16="http://schemas.microsoft.com/office/drawing/2014/main" id="{D4F599FF-97B5-43B6-8F99-180E2FC82611}"/>
+                <a16:creationId xmlns:a16="http://schemas.microsoft.com/office/drawing/2014/main" id="{10287671-85DE-4E27-A357-47342C93EA06}"/>
               </a:ext>
             </a:extLst>
           </p:cNvPr>
@@ -5944,7 +5984,7 @@
           <p:cNvPr id="21" name="">
             <a:extLst xmlns:a="http://schemas.openxmlformats.org/drawingml/2006/main">
               <a:ext uri="{FF2B5EF4-FFF2-40B4-BE49-F238E27FC236}">
-                <a16:creationId xmlns:a16="http://schemas.microsoft.com/office/drawing/2014/main" id="{3AB93786-CD66-4B1E-A32D-851B001657D5}"/>
+                <a16:creationId xmlns:a16="http://schemas.microsoft.com/office/drawing/2014/main" id="{ECAFA72F-B794-498D-BF27-3BB175101A45}"/>
               </a:ext>
             </a:extLst>
           </p:cNvPr>
@@ -5976,7 +6016,7 @@
           <p:cNvPr id="20" name="">
             <a:extLst xmlns:a="http://schemas.openxmlformats.org/drawingml/2006/main">
               <a:ext uri="{FF2B5EF4-FFF2-40B4-BE49-F238E27FC236}">
-                <a16:creationId xmlns:a16="http://schemas.microsoft.com/office/drawing/2014/main" id="{EED3E3F1-CF60-4F28-BE2F-7B8037750AC2}"/>
+                <a16:creationId xmlns:a16="http://schemas.microsoft.com/office/drawing/2014/main" id="{C7652AB2-D035-4D5E-8530-1682B3CEAD3C}"/>
               </a:ext>
             </a:extLst>
           </p:cNvPr>
@@ -6008,7 +6048,7 @@
           <p:cNvPr id="19" name="">
             <a:extLst xmlns:a="http://schemas.openxmlformats.org/drawingml/2006/main">
               <a:ext uri="{FF2B5EF4-FFF2-40B4-BE49-F238E27FC236}">
-                <a16:creationId xmlns:a16="http://schemas.microsoft.com/office/drawing/2014/main" id="{A5953D26-8AEE-4417-838F-CCAFCA89F157}"/>
+                <a16:creationId xmlns:a16="http://schemas.microsoft.com/office/drawing/2014/main" id="{A4E66A3D-BD1E-410C-8C84-3591655EDAD1}"/>
               </a:ext>
             </a:extLst>
           </p:cNvPr>
@@ -6040,7 +6080,7 @@
           <p:cNvPr id="18" name="">
             <a:extLst xmlns:a="http://schemas.openxmlformats.org/drawingml/2006/main">
               <a:ext uri="{FF2B5EF4-FFF2-40B4-BE49-F238E27FC236}">
-                <a16:creationId xmlns:a16="http://schemas.microsoft.com/office/drawing/2014/main" id="{68A424AA-DEEA-4C0D-9DD3-B8307F9A089B}"/>
+                <a16:creationId xmlns:a16="http://schemas.microsoft.com/office/drawing/2014/main" id="{925C269E-0BA9-486D-AA23-C8FDA489F7AD}"/>
               </a:ext>
             </a:extLst>
           </p:cNvPr>
@@ -7615,7 +7655,7 @@
           <p:cNvPr id="28" name="flow-61">
             <a:extLst xmlns:a="http://schemas.openxmlformats.org/drawingml/2006/main">
               <a:ext uri="{FF2B5EF4-FFF2-40B4-BE49-F238E27FC236}">
-                <a16:creationId xmlns:a16="http://schemas.microsoft.com/office/drawing/2014/main" id="{7E77EE6A-D4D8-40F7-A95F-1DC37AB7A59D}"/>
+                <a16:creationId xmlns:a16="http://schemas.microsoft.com/office/drawing/2014/main" id="{3DB5733C-5FB3-4B68-A04E-DEE2F220C191}"/>
               </a:ext>
             </a:extLst>
           </p:cNvPr>
@@ -7714,7 +7754,7 @@
           <p:cNvPr id="30" name="flow-63">
             <a:extLst xmlns:a="http://schemas.openxmlformats.org/drawingml/2006/main">
               <a:ext uri="{FF2B5EF4-FFF2-40B4-BE49-F238E27FC236}">
-                <a16:creationId xmlns:a16="http://schemas.microsoft.com/office/drawing/2014/main" id="{52FDB377-D333-44DF-A914-1CFE5000735D}"/>
+                <a16:creationId xmlns:a16="http://schemas.microsoft.com/office/drawing/2014/main" id="{08668D5E-A6BE-4962-BA85-2B397B52594E}"/>
               </a:ext>
             </a:extLst>
           </p:cNvPr>
@@ -7742,7 +7782,7 @@
           <p:cNvPr id="31" name="flow-64">
             <a:extLst xmlns:a="http://schemas.openxmlformats.org/drawingml/2006/main">
               <a:ext uri="{FF2B5EF4-FFF2-40B4-BE49-F238E27FC236}">
-                <a16:creationId xmlns:a16="http://schemas.microsoft.com/office/drawing/2014/main" id="{42DCDD48-F720-41BE-8CA4-47E67C4031C2}"/>
+                <a16:creationId xmlns:a16="http://schemas.microsoft.com/office/drawing/2014/main" id="{B75F1FD4-C02A-44C5-9E64-05EC4EA99E6A}"/>
               </a:ext>
             </a:extLst>
           </p:cNvPr>
@@ -7770,7 +7810,7 @@
           <p:cNvPr id="32" name="flow-65">
             <a:extLst xmlns:a="http://schemas.openxmlformats.org/drawingml/2006/main">
               <a:ext uri="{FF2B5EF4-FFF2-40B4-BE49-F238E27FC236}">
-                <a16:creationId xmlns:a16="http://schemas.microsoft.com/office/drawing/2014/main" id="{FC0B672E-8C0B-463B-84AC-547B4A21A1F1}"/>
+                <a16:creationId xmlns:a16="http://schemas.microsoft.com/office/drawing/2014/main" id="{FF36DB5C-928D-4444-9A6D-6880C45134B2}"/>
               </a:ext>
             </a:extLst>
           </p:cNvPr>
@@ -7798,7 +7838,7 @@
           <p:cNvPr id="33" name="flow-66">
             <a:extLst xmlns:a="http://schemas.openxmlformats.org/drawingml/2006/main">
               <a:ext uri="{FF2B5EF4-FFF2-40B4-BE49-F238E27FC236}">
-                <a16:creationId xmlns:a16="http://schemas.microsoft.com/office/drawing/2014/main" id="{B640F174-F1E0-497D-9292-886BDA9A4790}"/>
+                <a16:creationId xmlns:a16="http://schemas.microsoft.com/office/drawing/2014/main" id="{CDEF0BF4-6CAD-4ABC-9B95-6147440D2B48}"/>
               </a:ext>
             </a:extLst>
           </p:cNvPr>
@@ -8066,7 +8106,7 @@
           <p:cNvPr id="18" name="">
             <a:extLst xmlns:a="http://schemas.openxmlformats.org/drawingml/2006/main">
               <a:ext uri="{FF2B5EF4-FFF2-40B4-BE49-F238E27FC236}">
-                <a16:creationId xmlns:a16="http://schemas.microsoft.com/office/drawing/2014/main" id="{317B2169-A795-454D-A65B-7120C58EE562}"/>
+                <a16:creationId xmlns:a16="http://schemas.microsoft.com/office/drawing/2014/main" id="{FDBF6BE9-C935-4884-8826-CCE7C39D491F}"/>
               </a:ext>
             </a:extLst>
           </p:cNvPr>
@@ -8968,7 +9008,7 @@
                 <a:ea typeface="Aptos"/>
                 <a:cs typeface="Aptos"/>
               </a:rPr>
-              <a:t>Proposed actions + sources</a:t>
+              <a:t>Source-linked follow-up</a:t>
             </a:r>
           </a:p>
         </p:txBody>
@@ -9235,7 +9275,7 @@
                 <a:ea typeface="Aptos"/>
                 <a:cs typeface="Aptos"/>
               </a:rPr>
-              <a:t>Source job</a:t>
+              <a:t>Drive access</a:t>
             </a:r>
           </a:p>
           <a:p xmlns:a="http://schemas.openxmlformats.org/drawingml/2006/main">
@@ -9259,7 +9299,7 @@
                 <a:ea typeface="Aptos"/>
                 <a:cs typeface="Aptos"/>
               </a:rPr>
-              <a:t>pending</a:t>
+              <a:t>needed</a:t>
             </a:r>
           </a:p>
         </p:txBody>
@@ -9269,7 +9309,7 @@
           <p:cNvPr id="20" name="flow-88">
             <a:extLst xmlns:a="http://schemas.openxmlformats.org/drawingml/2006/main">
               <a:ext uri="{FF2B5EF4-FFF2-40B4-BE49-F238E27FC236}">
-                <a16:creationId xmlns:a16="http://schemas.microsoft.com/office/drawing/2014/main" id="{7D9B7B94-4EBB-4DF0-85DD-066C6DE5CD32}"/>
+                <a16:creationId xmlns:a16="http://schemas.microsoft.com/office/drawing/2014/main" id="{90FD3FC6-D090-407E-9927-AB70A50120E1}"/>
               </a:ext>
             </a:extLst>
           </p:cNvPr>
@@ -9297,7 +9337,7 @@
           <p:cNvPr id="21" name="flow-89">
             <a:extLst xmlns:a="http://schemas.openxmlformats.org/drawingml/2006/main">
               <a:ext uri="{FF2B5EF4-FFF2-40B4-BE49-F238E27FC236}">
-                <a16:creationId xmlns:a16="http://schemas.microsoft.com/office/drawing/2014/main" id="{B9C2B235-21EC-4B3A-8BEC-3075251078FD}"/>
+                <a16:creationId xmlns:a16="http://schemas.microsoft.com/office/drawing/2014/main" id="{9D414016-4AE9-4DF8-91ED-449A34E6FF8B}"/>
               </a:ext>
             </a:extLst>
           </p:cNvPr>
@@ -9325,7 +9365,7 @@
           <p:cNvPr id="22" name="flow-90">
             <a:extLst xmlns:a="http://schemas.openxmlformats.org/drawingml/2006/main">
               <a:ext uri="{FF2B5EF4-FFF2-40B4-BE49-F238E27FC236}">
-                <a16:creationId xmlns:a16="http://schemas.microsoft.com/office/drawing/2014/main" id="{1B55A4BE-0C7C-4C4D-88A0-6E5F6208D871}"/>
+                <a16:creationId xmlns:a16="http://schemas.microsoft.com/office/drawing/2014/main" id="{171425A0-10D7-4922-885A-01D6996630A6}"/>
               </a:ext>
             </a:extLst>
           </p:cNvPr>
@@ -9448,7 +9488,7 @@
           <p:cNvPr id="24" name="flow-92">
             <a:extLst xmlns:a="http://schemas.openxmlformats.org/drawingml/2006/main">
               <a:ext uri="{FF2B5EF4-FFF2-40B4-BE49-F238E27FC236}">
-                <a16:creationId xmlns:a16="http://schemas.microsoft.com/office/drawing/2014/main" id="{A7E9E000-2FBE-4EC2-BE5E-8CA255134ECA}"/>
+                <a16:creationId xmlns:a16="http://schemas.microsoft.com/office/drawing/2014/main" id="{D996C47B-D5F6-4ABB-98C2-6CAEE001E309}"/>
               </a:ext>
             </a:extLst>
           </p:cNvPr>
@@ -9467,7 +9507,7 @@
             <a:solidFill>
               <a:srgbClr val="157D80"/>
             </a:solidFill>
-            <a:prstDash val="dash"/>
+            <a:prstDash val="solid"/>
           </a:ln>
         </p:spPr>
       </p:cxnSp>
@@ -9476,7 +9516,7 @@
           <p:cNvPr id="25" name="flow-93">
             <a:extLst xmlns:a="http://schemas.openxmlformats.org/drawingml/2006/main">
               <a:ext uri="{FF2B5EF4-FFF2-40B4-BE49-F238E27FC236}">
-                <a16:creationId xmlns:a16="http://schemas.microsoft.com/office/drawing/2014/main" id="{B6651FB7-F8F9-4373-9196-184B622A2782}"/>
+                <a16:creationId xmlns:a16="http://schemas.microsoft.com/office/drawing/2014/main" id="{CEC7B0CC-B168-42B5-8327-7285BD73004B}"/>
               </a:ext>
             </a:extLst>
           </p:cNvPr>
@@ -9495,7 +9535,7 @@
             <a:solidFill>
               <a:srgbClr val="157D80"/>
             </a:solidFill>
-            <a:prstDash val="dash"/>
+            <a:prstDash val="solid"/>
           </a:ln>
         </p:spPr>
       </p:cxnSp>
@@ -9504,7 +9544,7 @@
           <p:cNvPr id="26" name="flow-94">
             <a:extLst xmlns:a="http://schemas.openxmlformats.org/drawingml/2006/main">
               <a:ext uri="{FF2B5EF4-FFF2-40B4-BE49-F238E27FC236}">
-                <a16:creationId xmlns:a16="http://schemas.microsoft.com/office/drawing/2014/main" id="{743C0879-2E0E-42EC-902E-E9E36EB928B3}"/>
+                <a16:creationId xmlns:a16="http://schemas.microsoft.com/office/drawing/2014/main" id="{0D442C91-6D28-4718-88A5-365345CFE4CA}"/>
               </a:ext>
             </a:extLst>
           </p:cNvPr>
@@ -9523,7 +9563,7 @@
             <a:solidFill>
               <a:srgbClr val="157D80"/>
             </a:solidFill>
-            <a:prstDash val="dash"/>
+            <a:prstDash val="solid"/>
             <a:tailEnd type="triangle" w="med" len="med"/>
           </a:ln>
         </p:spPr>
@@ -9593,7 +9633,7 @@
                 <a:ea typeface="Aptos"/>
                 <a:cs typeface="Aptos"/>
               </a:rPr>
-              <a:t>Action intake</a:t>
+              <a:t>Native follow-up</a:t>
             </a:r>
           </a:p>
           <a:p xmlns:a="http://schemas.openxmlformats.org/drawingml/2006/main">
@@ -9617,7 +9657,7 @@
                 <a:ea typeface="Aptos"/>
                 <a:cs typeface="Aptos"/>
               </a:rPr>
-              <a:t>wiring next</a:t>
+              <a:t>implemented</a:t>
             </a:r>
           </a:p>
         </p:txBody>
@@ -9627,7 +9667,7 @@
           <p:cNvPr id="28" name="flow-96">
             <a:extLst xmlns:a="http://schemas.openxmlformats.org/drawingml/2006/main">
               <a:ext uri="{FF2B5EF4-FFF2-40B4-BE49-F238E27FC236}">
-                <a16:creationId xmlns:a16="http://schemas.microsoft.com/office/drawing/2014/main" id="{507793A7-002C-4DD6-B579-DDBBCD316DDF}"/>
+                <a16:creationId xmlns:a16="http://schemas.microsoft.com/office/drawing/2014/main" id="{25A284C1-6226-4F55-81E6-2631C0C43E12}"/>
               </a:ext>
             </a:extLst>
           </p:cNvPr>
@@ -9655,7 +9695,7 @@
           <p:cNvPr id="29" name="flow-97">
             <a:extLst xmlns:a="http://schemas.openxmlformats.org/drawingml/2006/main">
               <a:ext uri="{FF2B5EF4-FFF2-40B4-BE49-F238E27FC236}">
-                <a16:creationId xmlns:a16="http://schemas.microsoft.com/office/drawing/2014/main" id="{D7F4B9D6-8C49-4324-B5C3-735A4C88913C}"/>
+                <a16:creationId xmlns:a16="http://schemas.microsoft.com/office/drawing/2014/main" id="{033F1FD7-724C-4024-80F2-357B094C2B4F}"/>
               </a:ext>
             </a:extLst>
           </p:cNvPr>
@@ -9908,7 +9948,7 @@
                 <a:ea typeface="Aptos"/>
                 <a:cs typeface="Aptos"/>
               </a:rPr>
-              <a:t>Core and publication client merged</a:t>
+              <a:t>Source and native follow-up merged</a:t>
             </a:r>
           </a:p>
         </p:txBody>
@@ -10041,7 +10081,7 @@
           <p:cNvPr id="35" name="">
             <a:extLst xmlns:a="http://schemas.openxmlformats.org/drawingml/2006/main">
               <a:ext uri="{FF2B5EF4-FFF2-40B4-BE49-F238E27FC236}">
-                <a16:creationId xmlns:a16="http://schemas.microsoft.com/office/drawing/2014/main" id="{3D1A79F3-E5EF-471C-8386-0A47F0BBCBA8}"/>
+                <a16:creationId xmlns:a16="http://schemas.microsoft.com/office/drawing/2014/main" id="{4976A6EF-CB1D-4713-AA4C-7A07885C3206}"/>
               </a:ext>
             </a:extLst>
           </p:cNvPr>
@@ -10073,7 +10113,7 @@
           <p:cNvPr id="34" name="">
             <a:extLst xmlns:a="http://schemas.openxmlformats.org/drawingml/2006/main">
               <a:ext uri="{FF2B5EF4-FFF2-40B4-BE49-F238E27FC236}">
-                <a16:creationId xmlns:a16="http://schemas.microsoft.com/office/drawing/2014/main" id="{81BBABB7-3B1E-49A6-AAF3-2B11F74EB344}"/>
+                <a16:creationId xmlns:a16="http://schemas.microsoft.com/office/drawing/2014/main" id="{6B19A4DE-2240-4C60-8ED2-C92C52FC628F}"/>
               </a:ext>
             </a:extLst>
           </p:cNvPr>
@@ -10105,7 +10145,7 @@
           <p:cNvPr id="33" name="">
             <a:extLst xmlns:a="http://schemas.openxmlformats.org/drawingml/2006/main">
               <a:ext uri="{FF2B5EF4-FFF2-40B4-BE49-F238E27FC236}">
-                <a16:creationId xmlns:a16="http://schemas.microsoft.com/office/drawing/2014/main" id="{7427B4A4-47C9-42B7-9B79-6271F3458A25}"/>
+                <a16:creationId xmlns:a16="http://schemas.microsoft.com/office/drawing/2014/main" id="{1E391E25-C876-4B35-96F8-59EB7204988A}"/>
               </a:ext>
             </a:extLst>
           </p:cNvPr>
@@ -10137,7 +10177,7 @@
           <p:cNvPr id="13" name="">
             <a:extLst xmlns:a="http://schemas.openxmlformats.org/drawingml/2006/main">
               <a:ext uri="{FF2B5EF4-FFF2-40B4-BE49-F238E27FC236}">
-                <a16:creationId xmlns:a16="http://schemas.microsoft.com/office/drawing/2014/main" id="{ABCFD886-BD86-4E86-8609-8A068D05BDB0}"/>
+                <a16:creationId xmlns:a16="http://schemas.microsoft.com/office/drawing/2014/main" id="{19130EEE-A3E3-49C6-B192-A2BAADA80B64}"/>
               </a:ext>
             </a:extLst>
           </p:cNvPr>
@@ -10169,7 +10209,7 @@
           <p:cNvPr id="12" name="">
             <a:extLst xmlns:a="http://schemas.openxmlformats.org/drawingml/2006/main">
               <a:ext uri="{FF2B5EF4-FFF2-40B4-BE49-F238E27FC236}">
-                <a16:creationId xmlns:a16="http://schemas.microsoft.com/office/drawing/2014/main" id="{8ACDD802-0FEA-4DEA-89E9-4BA6734ABAAA}"/>
+                <a16:creationId xmlns:a16="http://schemas.microsoft.com/office/drawing/2014/main" id="{CC00D0D6-B04E-404B-A8D7-578C96BD7DE9}"/>
               </a:ext>
             </a:extLst>
           </p:cNvPr>
@@ -10956,7 +10996,7 @@
           <p:cNvPr id="14" name="flow-113">
             <a:extLst xmlns:a="http://schemas.openxmlformats.org/drawingml/2006/main">
               <a:ext uri="{FF2B5EF4-FFF2-40B4-BE49-F238E27FC236}">
-                <a16:creationId xmlns:a16="http://schemas.microsoft.com/office/drawing/2014/main" id="{46BF9B33-9CCB-49BB-9D7C-871116C5E191}"/>
+                <a16:creationId xmlns:a16="http://schemas.microsoft.com/office/drawing/2014/main" id="{148BD751-8735-4D9D-9351-7F40335BCF03}"/>
               </a:ext>
             </a:extLst>
           </p:cNvPr>
@@ -10984,7 +11024,7 @@
           <p:cNvPr id="15" name="flow-114">
             <a:extLst xmlns:a="http://schemas.openxmlformats.org/drawingml/2006/main">
               <a:ext uri="{FF2B5EF4-FFF2-40B4-BE49-F238E27FC236}">
-                <a16:creationId xmlns:a16="http://schemas.microsoft.com/office/drawing/2014/main" id="{E47135E9-968E-44B3-9C3F-4F0333EB123D}"/>
+                <a16:creationId xmlns:a16="http://schemas.microsoft.com/office/drawing/2014/main" id="{61C4F464-9138-46BA-909E-F8BD8B858762}"/>
               </a:ext>
             </a:extLst>
           </p:cNvPr>
@@ -11012,7 +11052,7 @@
           <p:cNvPr id="16" name="flow-115">
             <a:extLst xmlns:a="http://schemas.openxmlformats.org/drawingml/2006/main">
               <a:ext uri="{FF2B5EF4-FFF2-40B4-BE49-F238E27FC236}">
-                <a16:creationId xmlns:a16="http://schemas.microsoft.com/office/drawing/2014/main" id="{5314AF79-BAEF-4D59-82B7-ECEAA3EDADD6}"/>
+                <a16:creationId xmlns:a16="http://schemas.microsoft.com/office/drawing/2014/main" id="{71E53580-7331-4B8D-9B55-A66F1AE093A2}"/>
               </a:ext>
             </a:extLst>
           </p:cNvPr>
@@ -11040,7 +11080,7 @@
           <p:cNvPr id="17" name="flow-116">
             <a:extLst xmlns:a="http://schemas.openxmlformats.org/drawingml/2006/main">
               <a:ext uri="{FF2B5EF4-FFF2-40B4-BE49-F238E27FC236}">
-                <a16:creationId xmlns:a16="http://schemas.microsoft.com/office/drawing/2014/main" id="{8B112F7F-2A59-4D7C-B48F-8FE0200477BB}"/>
+                <a16:creationId xmlns:a16="http://schemas.microsoft.com/office/drawing/2014/main" id="{7DDD52AF-6783-4F79-9DC1-999B31A3B1B5}"/>
               </a:ext>
             </a:extLst>
           </p:cNvPr>
@@ -11927,7 +11967,7 @@
           <p:cNvPr id="31" name="flow-130">
             <a:extLst xmlns:a="http://schemas.openxmlformats.org/drawingml/2006/main">
               <a:ext uri="{FF2B5EF4-FFF2-40B4-BE49-F238E27FC236}">
-                <a16:creationId xmlns:a16="http://schemas.microsoft.com/office/drawing/2014/main" id="{37AE7F39-04A1-44E8-A668-EFB1DA347DFE}"/>
+                <a16:creationId xmlns:a16="http://schemas.microsoft.com/office/drawing/2014/main" id="{9AE42BFD-C926-4708-99C5-D5BF4F77B9B2}"/>
               </a:ext>
             </a:extLst>
           </p:cNvPr>
@@ -12518,7 +12558,7 @@
           <p:cNvPr id="43" name="partner-flow-1">
             <a:extLst xmlns:a="http://schemas.openxmlformats.org/drawingml/2006/main">
               <a:ext uri="{FF2B5EF4-FFF2-40B4-BE49-F238E27FC236}">
-                <a16:creationId xmlns:a16="http://schemas.microsoft.com/office/drawing/2014/main" id="{8C50AE15-C344-4114-8408-E3D463D49815}"/>
+                <a16:creationId xmlns:a16="http://schemas.microsoft.com/office/drawing/2014/main" id="{2EE74050-9140-4D98-9195-7222082EF0A5}"/>
               </a:ext>
             </a:extLst>
           </p:cNvPr>
@@ -12546,7 +12586,7 @@
           <p:cNvPr id="44" name="partner-flow-2">
             <a:extLst xmlns:a="http://schemas.openxmlformats.org/drawingml/2006/main">
               <a:ext uri="{FF2B5EF4-FFF2-40B4-BE49-F238E27FC236}">
-                <a16:creationId xmlns:a16="http://schemas.microsoft.com/office/drawing/2014/main" id="{F847D156-086C-4D76-BD6A-0D204D87C04C}"/>
+                <a16:creationId xmlns:a16="http://schemas.microsoft.com/office/drawing/2014/main" id="{739D2C01-9424-44CD-A648-01F678C8463E}"/>
               </a:ext>
             </a:extLst>
           </p:cNvPr>
@@ -12574,7 +12614,7 @@
           <p:cNvPr id="45" name="partner-flow-3">
             <a:extLst xmlns:a="http://schemas.openxmlformats.org/drawingml/2006/main">
               <a:ext uri="{FF2B5EF4-FFF2-40B4-BE49-F238E27FC236}">
-                <a16:creationId xmlns:a16="http://schemas.microsoft.com/office/drawing/2014/main" id="{3E2F194F-C69A-41A1-83DF-C3C6881A3D7E}"/>
+                <a16:creationId xmlns:a16="http://schemas.microsoft.com/office/drawing/2014/main" id="{C4BC747C-25CD-4B47-A9CB-A56979A7A092}"/>
               </a:ext>
             </a:extLst>
           </p:cNvPr>
@@ -12602,7 +12642,7 @@
           <p:cNvPr id="46" name="partner-flow-4">
             <a:extLst xmlns:a="http://schemas.openxmlformats.org/drawingml/2006/main">
               <a:ext uri="{FF2B5EF4-FFF2-40B4-BE49-F238E27FC236}">
-                <a16:creationId xmlns:a16="http://schemas.microsoft.com/office/drawing/2014/main" id="{455FBE7F-8646-43FE-ABA5-462DDEEBEBF1}"/>
+                <a16:creationId xmlns:a16="http://schemas.microsoft.com/office/drawing/2014/main" id="{4C6DD1CF-E478-447E-99C5-D3FE43C59AD6}"/>
               </a:ext>
             </a:extLst>
           </p:cNvPr>
@@ -12660,7 +12700,7 @@
           <p:cNvPr id="25" name="">
             <a:extLst xmlns:a="http://schemas.openxmlformats.org/drawingml/2006/main">
               <a:ext uri="{FF2B5EF4-FFF2-40B4-BE49-F238E27FC236}">
-                <a16:creationId xmlns:a16="http://schemas.microsoft.com/office/drawing/2014/main" id="{A1859A7E-8DE6-4351-A350-0C242B9D0073}"/>
+                <a16:creationId xmlns:a16="http://schemas.microsoft.com/office/drawing/2014/main" id="{86E81405-94C6-423B-B2C0-5BDA496A6AD7}"/>
               </a:ext>
             </a:extLst>
           </p:cNvPr>
@@ -12972,7 +13012,7 @@
           <p:cNvPr id="5" name="flow-142">
             <a:extLst xmlns:a="http://schemas.openxmlformats.org/drawingml/2006/main">
               <a:ext uri="{FF2B5EF4-FFF2-40B4-BE49-F238E27FC236}">
-                <a16:creationId xmlns:a16="http://schemas.microsoft.com/office/drawing/2014/main" id="{D18FAB8B-9B1D-4CFC-B596-E9B959C813D2}"/>
+                <a16:creationId xmlns:a16="http://schemas.microsoft.com/office/drawing/2014/main" id="{859AE66F-A02D-45D5-807B-5735957AAC1C}"/>
               </a:ext>
             </a:extLst>
           </p:cNvPr>
@@ -13364,13 +13404,13 @@
             <a:avLst/>
           </a:prstGeom>
           <a:solidFill xmlns:a="http://schemas.openxmlformats.org/drawingml/2006/main">
-            <a:srgbClr val="E7F1EE"/>
+            <a:srgbClr val="FFFAF0"/>
           </a:solidFill>
           <a:ln xmlns:a="http://schemas.openxmlformats.org/drawingml/2006/main" w="17145">
             <a:solidFill>
-              <a:srgbClr val="157D80"/>
+              <a:srgbClr val="B1853E"/>
             </a:solidFill>
-            <a:prstDash val="solid"/>
+            <a:prstDash val="dash"/>
           </a:ln>
         </p:spPr>
       </p:sp>
@@ -13533,7 +13573,7 @@
                 <a:ea typeface="Aptos"/>
                 <a:cs typeface="Aptos"/>
               </a:rPr>
-              <a:t>Task-scoped evidence and tools</a:t>
+              <a:t>Live enrollment and execution next</a:t>
             </a:r>
           </a:p>
         </p:txBody>
@@ -13556,6 +13596,380 @@
           <a:xfrm xmlns:a="http://schemas.openxmlformats.org/drawingml/2006/main">
             <a:off x="8667750" y="4000500"/>
             <a:ext cx="5962650" cy="1238250"/>
+          </a:xfrm>
+          <a:prstGeom xmlns:a="http://schemas.openxmlformats.org/drawingml/2006/main" prst="rect">
+            <a:avLst/>
+          </a:prstGeom>
+          <a:solidFill xmlns:a="http://schemas.openxmlformats.org/drawingml/2006/main">
+            <a:srgbClr val="E7F1EE"/>
+          </a:solidFill>
+          <a:ln xmlns:a="http://schemas.openxmlformats.org/drawingml/2006/main" w="17145">
+            <a:solidFill>
+              <a:srgbClr val="157D80"/>
+            </a:solidFill>
+            <a:prstDash val="solid"/>
+          </a:ln>
+        </p:spPr>
+      </p:sp>
+      <p:sp>
+        <p:nvSpPr>
+          <p:cNvPr id="16" name="text-153">
+            <a:extLst xmlns:a="http://schemas.openxmlformats.org/drawingml/2006/main">
+              <a:ext uri="{FF2B5EF4-FFF2-40B4-BE49-F238E27FC236}">
+                <a16:creationId xmlns:a16="http://schemas.microsoft.com/office/drawing/2014/main" id="{25BAE476-D051-4A95-BC6B-956ECA4478E2}"/>
+              </a:ext>
+            </a:extLst>
+          </p:cNvPr>
+          <p:cNvSpPr>
+            <a:spLocks xmlns:a="http://schemas.openxmlformats.org/drawingml/2006/main" noGrp="1"/>
+          </p:cNvSpPr>
+          <p:nvPr/>
+        </p:nvSpPr>
+        <p:spPr>
+          <a:xfrm xmlns:a="http://schemas.openxmlformats.org/drawingml/2006/main">
+            <a:off x="8858250" y="4162425"/>
+            <a:ext cx="5581650" cy="386715"/>
+          </a:xfrm>
+          <a:prstGeom xmlns:a="http://schemas.openxmlformats.org/drawingml/2006/main" prst="rect">
+            <a:avLst/>
+          </a:prstGeom>
+          <a:noFill xmlns:a="http://schemas.openxmlformats.org/drawingml/2006/main"/>
+          <a:ln xmlns:a="http://schemas.openxmlformats.org/drawingml/2006/main" w="0">
+            <a:noFill/>
+            <a:prstDash val="solid"/>
+          </a:ln>
+        </p:spPr>
+        <p:txBody>
+          <a:bodyPr xmlns:a="http://schemas.openxmlformats.org/drawingml/2006/main" wrap="square" lIns="0" tIns="0" rIns="0" bIns="0" anchor="t">
+            <a:noAutofit/>
+          </a:bodyPr>
+          <a:lstStyle xmlns:a="http://schemas.openxmlformats.org/drawingml/2006/main">
+            <a:defPPr algn="l">
+              <a:defRPr sz="2250" b="1">
+                <a:solidFill>
+                  <a:srgbClr val="132E38"/>
+                </a:solidFill>
+                <a:latin typeface="Aptos"/>
+                <a:ea typeface="Aptos"/>
+                <a:cs typeface="Aptos"/>
+              </a:defRPr>
+            </a:defPPr>
+          </a:lstStyle>
+          <a:p xmlns:a="http://schemas.openxmlformats.org/drawingml/2006/main">
+            <a:pPr algn="l">
+              <a:buNone/>
+              <a:defRPr sz="2250" b="1">
+                <a:solidFill>
+                  <a:srgbClr val="132E38"/>
+                </a:solidFill>
+                <a:latin typeface="Aptos"/>
+                <a:ea typeface="Aptos"/>
+                <a:cs typeface="Aptos"/>
+              </a:defRPr>
+            </a:pPr>
+            <a:r>
+              <a:rPr sz="2250" b="1">
+                <a:solidFill>
+                  <a:srgbClr val="132E38"/>
+                </a:solidFill>
+                <a:latin typeface="Aptos"/>
+                <a:ea typeface="Aptos"/>
+                <a:cs typeface="Aptos"/>
+              </a:rPr>
+              <a:t>Candidate validation</a:t>
+            </a:r>
+          </a:p>
+        </p:txBody>
+      </p:sp>
+      <p:sp>
+        <p:nvSpPr>
+          <p:cNvPr id="17" name="text-154">
+            <a:extLst xmlns:a="http://schemas.openxmlformats.org/drawingml/2006/main">
+              <a:ext uri="{FF2B5EF4-FFF2-40B4-BE49-F238E27FC236}">
+                <a16:creationId xmlns:a16="http://schemas.microsoft.com/office/drawing/2014/main" id="{F11BB3A0-ECF0-41B5-B3CD-BC71552C93EB}"/>
+              </a:ext>
+            </a:extLst>
+          </p:cNvPr>
+          <p:cNvSpPr>
+            <a:spLocks xmlns:a="http://schemas.openxmlformats.org/drawingml/2006/main" noGrp="1"/>
+          </p:cNvSpPr>
+          <p:nvPr/>
+        </p:nvSpPr>
+        <p:spPr>
+          <a:xfrm xmlns:a="http://schemas.openxmlformats.org/drawingml/2006/main">
+            <a:off x="8858250" y="4558665"/>
+            <a:ext cx="5581650" cy="340233"/>
+          </a:xfrm>
+          <a:prstGeom xmlns:a="http://schemas.openxmlformats.org/drawingml/2006/main" prst="rect">
+            <a:avLst/>
+          </a:prstGeom>
+          <a:noFill xmlns:a="http://schemas.openxmlformats.org/drawingml/2006/main"/>
+          <a:ln xmlns:a="http://schemas.openxmlformats.org/drawingml/2006/main" w="0">
+            <a:noFill/>
+            <a:prstDash val="solid"/>
+          </a:ln>
+        </p:spPr>
+        <p:txBody>
+          <a:bodyPr xmlns:a="http://schemas.openxmlformats.org/drawingml/2006/main" wrap="square" lIns="0" tIns="0" rIns="0" bIns="0" anchor="t">
+            <a:noAutofit/>
+          </a:bodyPr>
+          <a:lstStyle xmlns:a="http://schemas.openxmlformats.org/drawingml/2006/main">
+            <a:defPPr algn="l">
+              <a:defRPr sz="1950" b="0">
+                <a:solidFill>
+                  <a:srgbClr val="4A6572"/>
+                </a:solidFill>
+                <a:latin typeface="Aptos"/>
+                <a:ea typeface="Aptos"/>
+                <a:cs typeface="Aptos"/>
+              </a:defRPr>
+            </a:defPPr>
+          </a:lstStyle>
+          <a:p xmlns:a="http://schemas.openxmlformats.org/drawingml/2006/main">
+            <a:pPr algn="l">
+              <a:buNone/>
+              <a:defRPr sz="1950" b="0">
+                <a:solidFill>
+                  <a:srgbClr val="4A6572"/>
+                </a:solidFill>
+                <a:latin typeface="Aptos"/>
+                <a:ea typeface="Aptos"/>
+                <a:cs typeface="Aptos"/>
+              </a:defRPr>
+            </a:pPr>
+            <a:r>
+              <a:rPr sz="1950" b="0">
+                <a:solidFill>
+                  <a:srgbClr val="4A6572"/>
+                </a:solidFill>
+                <a:latin typeface="Aptos"/>
+                <a:ea typeface="Aptos"/>
+                <a:cs typeface="Aptos"/>
+              </a:rPr>
+              <a:t>Identity, attempt, task and artifact checks</a:t>
+            </a:r>
+          </a:p>
+        </p:txBody>
+      </p:sp>
+      <p:sp>
+        <p:nvSpPr>
+          <p:cNvPr id="18" name="node-155">
+            <a:extLst xmlns:a="http://schemas.openxmlformats.org/drawingml/2006/main">
+              <a:ext uri="{FF2B5EF4-FFF2-40B4-BE49-F238E27FC236}">
+                <a16:creationId xmlns:a16="http://schemas.microsoft.com/office/drawing/2014/main" id="{D21E1D51-8C9A-47B9-B1E4-DB9FC38BEA0C}"/>
+              </a:ext>
+            </a:extLst>
+          </p:cNvPr>
+          <p:cNvSpPr>
+            <a:spLocks xmlns:a="http://schemas.openxmlformats.org/drawingml/2006/main" noGrp="1"/>
+          </p:cNvSpPr>
+          <p:nvPr/>
+        </p:nvSpPr>
+        <p:spPr>
+          <a:xfrm xmlns:a="http://schemas.openxmlformats.org/drawingml/2006/main">
+            <a:off x="8667750" y="6286500"/>
+            <a:ext cx="5962650" cy="1333500"/>
+          </a:xfrm>
+          <a:prstGeom xmlns:a="http://schemas.openxmlformats.org/drawingml/2006/main" prst="rect">
+            <a:avLst/>
+          </a:prstGeom>
+          <a:solidFill xmlns:a="http://schemas.openxmlformats.org/drawingml/2006/main">
+            <a:srgbClr val="FFFAF0"/>
+          </a:solidFill>
+          <a:ln xmlns:a="http://schemas.openxmlformats.org/drawingml/2006/main" w="17145">
+            <a:solidFill>
+              <a:srgbClr val="B1853E"/>
+            </a:solidFill>
+            <a:prstDash val="dash"/>
+          </a:ln>
+        </p:spPr>
+      </p:sp>
+      <p:sp>
+        <p:nvSpPr>
+          <p:cNvPr id="19" name="text-156">
+            <a:extLst xmlns:a="http://schemas.openxmlformats.org/drawingml/2006/main">
+              <a:ext uri="{FF2B5EF4-FFF2-40B4-BE49-F238E27FC236}">
+                <a16:creationId xmlns:a16="http://schemas.microsoft.com/office/drawing/2014/main" id="{AFCF249E-1085-4474-8A12-407CBA559FDA}"/>
+              </a:ext>
+            </a:extLst>
+          </p:cNvPr>
+          <p:cNvSpPr>
+            <a:spLocks xmlns:a="http://schemas.openxmlformats.org/drawingml/2006/main" noGrp="1"/>
+          </p:cNvSpPr>
+          <p:nvPr/>
+        </p:nvSpPr>
+        <p:spPr>
+          <a:xfrm xmlns:a="http://schemas.openxmlformats.org/drawingml/2006/main">
+            <a:off x="8858250" y="6448425"/>
+            <a:ext cx="5581650" cy="386715"/>
+          </a:xfrm>
+          <a:prstGeom xmlns:a="http://schemas.openxmlformats.org/drawingml/2006/main" prst="rect">
+            <a:avLst/>
+          </a:prstGeom>
+          <a:noFill xmlns:a="http://schemas.openxmlformats.org/drawingml/2006/main"/>
+          <a:ln xmlns:a="http://schemas.openxmlformats.org/drawingml/2006/main" w="0">
+            <a:noFill/>
+            <a:prstDash val="solid"/>
+          </a:ln>
+        </p:spPr>
+        <p:txBody>
+          <a:bodyPr xmlns:a="http://schemas.openxmlformats.org/drawingml/2006/main" wrap="square" lIns="0" tIns="0" rIns="0" bIns="0" anchor="t">
+            <a:noAutofit/>
+          </a:bodyPr>
+          <a:lstStyle xmlns:a="http://schemas.openxmlformats.org/drawingml/2006/main">
+            <a:defPPr algn="l">
+              <a:defRPr sz="2250" b="1">
+                <a:solidFill>
+                  <a:srgbClr val="157D80"/>
+                </a:solidFill>
+                <a:latin typeface="Aptos"/>
+                <a:ea typeface="Aptos"/>
+                <a:cs typeface="Aptos"/>
+              </a:defRPr>
+            </a:defPPr>
+          </a:lstStyle>
+          <a:p xmlns:a="http://schemas.openxmlformats.org/drawingml/2006/main">
+            <a:pPr algn="l">
+              <a:buNone/>
+              <a:defRPr sz="2250" b="1">
+                <a:solidFill>
+                  <a:srgbClr val="157D80"/>
+                </a:solidFill>
+                <a:latin typeface="Aptos"/>
+                <a:ea typeface="Aptos"/>
+                <a:cs typeface="Aptos"/>
+              </a:defRPr>
+            </a:pPr>
+            <a:r>
+              <a:rPr sz="2250" b="1">
+                <a:solidFill>
+                  <a:srgbClr val="157D80"/>
+                </a:solidFill>
+                <a:latin typeface="Aptos"/>
+                <a:ea typeface="Aptos"/>
+                <a:cs typeface="Aptos"/>
+              </a:rPr>
+              <a:t>Review and acceptance</a:t>
+            </a:r>
+          </a:p>
+        </p:txBody>
+      </p:sp>
+      <p:sp>
+        <p:nvSpPr>
+          <p:cNvPr id="20" name="text-157">
+            <a:extLst xmlns:a="http://schemas.openxmlformats.org/drawingml/2006/main">
+              <a:ext uri="{FF2B5EF4-FFF2-40B4-BE49-F238E27FC236}">
+                <a16:creationId xmlns:a16="http://schemas.microsoft.com/office/drawing/2014/main" id="{A480B314-118F-4395-B774-59C14B986408}"/>
+              </a:ext>
+            </a:extLst>
+          </p:cNvPr>
+          <p:cNvSpPr>
+            <a:spLocks xmlns:a="http://schemas.openxmlformats.org/drawingml/2006/main" noGrp="1"/>
+          </p:cNvSpPr>
+          <p:nvPr/>
+        </p:nvSpPr>
+        <p:spPr>
+          <a:xfrm xmlns:a="http://schemas.openxmlformats.org/drawingml/2006/main">
+            <a:off x="8858250" y="6844665"/>
+            <a:ext cx="5581650" cy="340233"/>
+          </a:xfrm>
+          <a:prstGeom xmlns:a="http://schemas.openxmlformats.org/drawingml/2006/main" prst="rect">
+            <a:avLst/>
+          </a:prstGeom>
+          <a:noFill xmlns:a="http://schemas.openxmlformats.org/drawingml/2006/main"/>
+          <a:ln xmlns:a="http://schemas.openxmlformats.org/drawingml/2006/main" w="0">
+            <a:noFill/>
+            <a:prstDash val="solid"/>
+          </a:ln>
+        </p:spPr>
+        <p:txBody>
+          <a:bodyPr xmlns:a="http://schemas.openxmlformats.org/drawingml/2006/main" wrap="square" lIns="0" tIns="0" rIns="0" bIns="0" anchor="t">
+            <a:noAutofit/>
+          </a:bodyPr>
+          <a:lstStyle xmlns:a="http://schemas.openxmlformats.org/drawingml/2006/main">
+            <a:defPPr algn="l">
+              <a:defRPr sz="1950" b="0">
+                <a:solidFill>
+                  <a:srgbClr val="4A6572"/>
+                </a:solidFill>
+                <a:latin typeface="Aptos"/>
+                <a:ea typeface="Aptos"/>
+                <a:cs typeface="Aptos"/>
+              </a:defRPr>
+            </a:defPPr>
+          </a:lstStyle>
+          <a:p xmlns:a="http://schemas.openxmlformats.org/drawingml/2006/main">
+            <a:pPr algn="l">
+              <a:buNone/>
+              <a:defRPr sz="1950" b="0">
+                <a:solidFill>
+                  <a:srgbClr val="4A6572"/>
+                </a:solidFill>
+                <a:latin typeface="Aptos"/>
+                <a:ea typeface="Aptos"/>
+                <a:cs typeface="Aptos"/>
+              </a:defRPr>
+            </a:pPr>
+            <a:r>
+              <a:rPr sz="1950" b="0">
+                <a:solidFill>
+                  <a:srgbClr val="4A6572"/>
+                </a:solidFill>
+                <a:latin typeface="Aptos"/>
+                <a:ea typeface="Aptos"/>
+                <a:cs typeface="Aptos"/>
+              </a:rPr>
+              <a:t>Native integration next</a:t>
+            </a:r>
+          </a:p>
+        </p:txBody>
+      </p:sp>
+      <p:cxnSp>
+        <p:nvCxnSpPr>
+          <p:cNvPr id="21" name="flow-158">
+            <a:extLst xmlns:a="http://schemas.openxmlformats.org/drawingml/2006/main">
+              <a:ext uri="{FF2B5EF4-FFF2-40B4-BE49-F238E27FC236}">
+                <a16:creationId xmlns:a16="http://schemas.microsoft.com/office/drawing/2014/main" id="{D0A4EEFB-8808-47DF-9BE4-A6EFA9E58FB5}"/>
+              </a:ext>
+            </a:extLst>
+          </p:cNvPr>
+          <p:cNvCxnSpPr/>
+          <p:nvPr/>
+        </p:nvCxnSpPr>
+        <p:spPr>
+          <a:xfrm xmlns:a="http://schemas.openxmlformats.org/drawingml/2006/main" flipH="0" flipV="0">
+            <a:off x="609600" y="6477000"/>
+            <a:ext cx="5334000" cy="0"/>
+          </a:xfrm>
+          <a:prstGeom xmlns:a="http://schemas.openxmlformats.org/drawingml/2006/main" prst="straightConnector1">
+            <a:avLst/>
+          </a:prstGeom>
+          <a:ln xmlns:a="http://schemas.openxmlformats.org/drawingml/2006/main" w="14288">
+            <a:solidFill>
+              <a:srgbClr val="B8CACC"/>
+            </a:solidFill>
+            <a:prstDash val="solid"/>
+          </a:ln>
+        </p:spPr>
+      </p:cxnSp>
+      <p:sp>
+        <p:nvSpPr>
+          <p:cNvPr id="22" name="node-159">
+            <a:extLst xmlns:a="http://schemas.openxmlformats.org/drawingml/2006/main">
+              <a:ext uri="{FF2B5EF4-FFF2-40B4-BE49-F238E27FC236}">
+                <a16:creationId xmlns:a16="http://schemas.microsoft.com/office/drawing/2014/main" id="{3F5888FB-B549-4744-94BD-55682478694E}"/>
+              </a:ext>
+            </a:extLst>
+          </p:cNvPr>
+          <p:cNvSpPr>
+            <a:spLocks xmlns:a="http://schemas.openxmlformats.org/drawingml/2006/main" noGrp="1"/>
+          </p:cNvSpPr>
+          <p:nvPr/>
+        </p:nvSpPr>
+        <p:spPr>
+          <a:xfrm xmlns:a="http://schemas.openxmlformats.org/drawingml/2006/main">
+            <a:off x="609600" y="6858000"/>
+            <a:ext cx="5334000" cy="952500"/>
           </a:xfrm>
           <a:prstGeom xmlns:a="http://schemas.openxmlformats.org/drawingml/2006/main" prst="rect">
             <a:avLst/>
@@ -13573,22 +13987,22 @@
       </p:sp>
       <p:sp>
         <p:nvSpPr>
-          <p:cNvPr id="16" name="text-153">
-            <a:extLst xmlns:a="http://schemas.openxmlformats.org/drawingml/2006/main">
-              <a:ext uri="{FF2B5EF4-FFF2-40B4-BE49-F238E27FC236}">
-                <a16:creationId xmlns:a16="http://schemas.microsoft.com/office/drawing/2014/main" id="{25BAE476-D051-4A95-BC6B-956ECA4478E2}"/>
-              </a:ext>
-            </a:extLst>
-          </p:cNvPr>
-          <p:cNvSpPr>
-            <a:spLocks xmlns:a="http://schemas.openxmlformats.org/drawingml/2006/main" noGrp="1"/>
-          </p:cNvSpPr>
-          <p:nvPr/>
-        </p:nvSpPr>
-        <p:spPr>
-          <a:xfrm xmlns:a="http://schemas.openxmlformats.org/drawingml/2006/main">
-            <a:off x="8858250" y="4162425"/>
-            <a:ext cx="5581650" cy="386715"/>
+          <p:cNvPr id="23" name="text-160">
+            <a:extLst xmlns:a="http://schemas.openxmlformats.org/drawingml/2006/main">
+              <a:ext uri="{FF2B5EF4-FFF2-40B4-BE49-F238E27FC236}">
+                <a16:creationId xmlns:a16="http://schemas.microsoft.com/office/drawing/2014/main" id="{3174332F-933D-4987-A5E2-7FD7CE8CCE5B}"/>
+              </a:ext>
+            </a:extLst>
+          </p:cNvPr>
+          <p:cNvSpPr>
+            <a:spLocks xmlns:a="http://schemas.openxmlformats.org/drawingml/2006/main" noGrp="1"/>
+          </p:cNvSpPr>
+          <p:nvPr/>
+        </p:nvSpPr>
+        <p:spPr>
+          <a:xfrm xmlns:a="http://schemas.openxmlformats.org/drawingml/2006/main">
+            <a:off x="800100" y="7019925"/>
+            <a:ext cx="4953000" cy="386715"/>
           </a:xfrm>
           <a:prstGeom xmlns:a="http://schemas.openxmlformats.org/drawingml/2006/main" prst="rect">
             <a:avLst/>
@@ -13636,380 +14050,6 @@
                 <a:ea typeface="Aptos"/>
                 <a:cs typeface="Aptos"/>
               </a:rPr>
-              <a:t>Server validation</a:t>
-            </a:r>
-          </a:p>
-        </p:txBody>
-      </p:sp>
-      <p:sp>
-        <p:nvSpPr>
-          <p:cNvPr id="17" name="text-154">
-            <a:extLst xmlns:a="http://schemas.openxmlformats.org/drawingml/2006/main">
-              <a:ext uri="{FF2B5EF4-FFF2-40B4-BE49-F238E27FC236}">
-                <a16:creationId xmlns:a16="http://schemas.microsoft.com/office/drawing/2014/main" id="{F11BB3A0-ECF0-41B5-B3CD-BC71552C93EB}"/>
-              </a:ext>
-            </a:extLst>
-          </p:cNvPr>
-          <p:cNvSpPr>
-            <a:spLocks xmlns:a="http://schemas.openxmlformats.org/drawingml/2006/main" noGrp="1"/>
-          </p:cNvSpPr>
-          <p:nvPr/>
-        </p:nvSpPr>
-        <p:spPr>
-          <a:xfrm xmlns:a="http://schemas.openxmlformats.org/drawingml/2006/main">
-            <a:off x="8858250" y="4558665"/>
-            <a:ext cx="5581650" cy="340233"/>
-          </a:xfrm>
-          <a:prstGeom xmlns:a="http://schemas.openxmlformats.org/drawingml/2006/main" prst="rect">
-            <a:avLst/>
-          </a:prstGeom>
-          <a:noFill xmlns:a="http://schemas.openxmlformats.org/drawingml/2006/main"/>
-          <a:ln xmlns:a="http://schemas.openxmlformats.org/drawingml/2006/main" w="0">
-            <a:noFill/>
-            <a:prstDash val="solid"/>
-          </a:ln>
-        </p:spPr>
-        <p:txBody>
-          <a:bodyPr xmlns:a="http://schemas.openxmlformats.org/drawingml/2006/main" wrap="square" lIns="0" tIns="0" rIns="0" bIns="0" anchor="t">
-            <a:noAutofit/>
-          </a:bodyPr>
-          <a:lstStyle xmlns:a="http://schemas.openxmlformats.org/drawingml/2006/main">
-            <a:defPPr algn="l">
-              <a:defRPr sz="1950" b="0">
-                <a:solidFill>
-                  <a:srgbClr val="4A6572"/>
-                </a:solidFill>
-                <a:latin typeface="Aptos"/>
-                <a:ea typeface="Aptos"/>
-                <a:cs typeface="Aptos"/>
-              </a:defRPr>
-            </a:defPPr>
-          </a:lstStyle>
-          <a:p xmlns:a="http://schemas.openxmlformats.org/drawingml/2006/main">
-            <a:pPr algn="l">
-              <a:buNone/>
-              <a:defRPr sz="1950" b="0">
-                <a:solidFill>
-                  <a:srgbClr val="4A6572"/>
-                </a:solidFill>
-                <a:latin typeface="Aptos"/>
-                <a:ea typeface="Aptos"/>
-                <a:cs typeface="Aptos"/>
-              </a:defRPr>
-            </a:pPr>
-            <a:r>
-              <a:rPr sz="1950" b="0">
-                <a:solidFill>
-                  <a:srgbClr val="4A6572"/>
-                </a:solidFill>
-                <a:latin typeface="Aptos"/>
-                <a:ea typeface="Aptos"/>
-                <a:cs typeface="Aptos"/>
-              </a:rPr>
-              <a:t>Identity, task revision and source checks</a:t>
-            </a:r>
-          </a:p>
-        </p:txBody>
-      </p:sp>
-      <p:sp>
-        <p:nvSpPr>
-          <p:cNvPr id="18" name="node-155">
-            <a:extLst xmlns:a="http://schemas.openxmlformats.org/drawingml/2006/main">
-              <a:ext uri="{FF2B5EF4-FFF2-40B4-BE49-F238E27FC236}">
-                <a16:creationId xmlns:a16="http://schemas.microsoft.com/office/drawing/2014/main" id="{D21E1D51-8C9A-47B9-B1E4-DB9FC38BEA0C}"/>
-              </a:ext>
-            </a:extLst>
-          </p:cNvPr>
-          <p:cNvSpPr>
-            <a:spLocks xmlns:a="http://schemas.openxmlformats.org/drawingml/2006/main" noGrp="1"/>
-          </p:cNvSpPr>
-          <p:nvPr/>
-        </p:nvSpPr>
-        <p:spPr>
-          <a:xfrm xmlns:a="http://schemas.openxmlformats.org/drawingml/2006/main">
-            <a:off x="8667750" y="6286500"/>
-            <a:ext cx="5962650" cy="1333500"/>
-          </a:xfrm>
-          <a:prstGeom xmlns:a="http://schemas.openxmlformats.org/drawingml/2006/main" prst="rect">
-            <a:avLst/>
-          </a:prstGeom>
-          <a:solidFill xmlns:a="http://schemas.openxmlformats.org/drawingml/2006/main">
-            <a:srgbClr val="E7F1EE"/>
-          </a:solidFill>
-          <a:ln xmlns:a="http://schemas.openxmlformats.org/drawingml/2006/main" w="17145">
-            <a:solidFill>
-              <a:srgbClr val="157D80"/>
-            </a:solidFill>
-            <a:prstDash val="solid"/>
-          </a:ln>
-        </p:spPr>
-      </p:sp>
-      <p:sp>
-        <p:nvSpPr>
-          <p:cNvPr id="19" name="text-156">
-            <a:extLst xmlns:a="http://schemas.openxmlformats.org/drawingml/2006/main">
-              <a:ext uri="{FF2B5EF4-FFF2-40B4-BE49-F238E27FC236}">
-                <a16:creationId xmlns:a16="http://schemas.microsoft.com/office/drawing/2014/main" id="{AFCF249E-1085-4474-8A12-407CBA559FDA}"/>
-              </a:ext>
-            </a:extLst>
-          </p:cNvPr>
-          <p:cNvSpPr>
-            <a:spLocks xmlns:a="http://schemas.openxmlformats.org/drawingml/2006/main" noGrp="1"/>
-          </p:cNvSpPr>
-          <p:nvPr/>
-        </p:nvSpPr>
-        <p:spPr>
-          <a:xfrm xmlns:a="http://schemas.openxmlformats.org/drawingml/2006/main">
-            <a:off x="8858250" y="6448425"/>
-            <a:ext cx="5581650" cy="386715"/>
-          </a:xfrm>
-          <a:prstGeom xmlns:a="http://schemas.openxmlformats.org/drawingml/2006/main" prst="rect">
-            <a:avLst/>
-          </a:prstGeom>
-          <a:noFill xmlns:a="http://schemas.openxmlformats.org/drawingml/2006/main"/>
-          <a:ln xmlns:a="http://schemas.openxmlformats.org/drawingml/2006/main" w="0">
-            <a:noFill/>
-            <a:prstDash val="solid"/>
-          </a:ln>
-        </p:spPr>
-        <p:txBody>
-          <a:bodyPr xmlns:a="http://schemas.openxmlformats.org/drawingml/2006/main" wrap="square" lIns="0" tIns="0" rIns="0" bIns="0" anchor="t">
-            <a:noAutofit/>
-          </a:bodyPr>
-          <a:lstStyle xmlns:a="http://schemas.openxmlformats.org/drawingml/2006/main">
-            <a:defPPr algn="l">
-              <a:defRPr sz="2250" b="1">
-                <a:solidFill>
-                  <a:srgbClr val="157D80"/>
-                </a:solidFill>
-                <a:latin typeface="Aptos"/>
-                <a:ea typeface="Aptos"/>
-                <a:cs typeface="Aptos"/>
-              </a:defRPr>
-            </a:defPPr>
-          </a:lstStyle>
-          <a:p xmlns:a="http://schemas.openxmlformats.org/drawingml/2006/main">
-            <a:pPr algn="l">
-              <a:buNone/>
-              <a:defRPr sz="2250" b="1">
-                <a:solidFill>
-                  <a:srgbClr val="157D80"/>
-                </a:solidFill>
-                <a:latin typeface="Aptos"/>
-                <a:ea typeface="Aptos"/>
-                <a:cs typeface="Aptos"/>
-              </a:defRPr>
-            </a:pPr>
-            <a:r>
-              <a:rPr sz="2250" b="1">
-                <a:solidFill>
-                  <a:srgbClr val="157D80"/>
-                </a:solidFill>
-                <a:latin typeface="Aptos"/>
-                <a:ea typeface="Aptos"/>
-                <a:cs typeface="Aptos"/>
-              </a:rPr>
-              <a:t>Review and acceptance</a:t>
-            </a:r>
-          </a:p>
-        </p:txBody>
-      </p:sp>
-      <p:sp>
-        <p:nvSpPr>
-          <p:cNvPr id="20" name="text-157">
-            <a:extLst xmlns:a="http://schemas.openxmlformats.org/drawingml/2006/main">
-              <a:ext uri="{FF2B5EF4-FFF2-40B4-BE49-F238E27FC236}">
-                <a16:creationId xmlns:a16="http://schemas.microsoft.com/office/drawing/2014/main" id="{A480B314-118F-4395-B774-59C14B986408}"/>
-              </a:ext>
-            </a:extLst>
-          </p:cNvPr>
-          <p:cNvSpPr>
-            <a:spLocks xmlns:a="http://schemas.openxmlformats.org/drawingml/2006/main" noGrp="1"/>
-          </p:cNvSpPr>
-          <p:nvPr/>
-        </p:nvSpPr>
-        <p:spPr>
-          <a:xfrm xmlns:a="http://schemas.openxmlformats.org/drawingml/2006/main">
-            <a:off x="8858250" y="6844665"/>
-            <a:ext cx="5581650" cy="340233"/>
-          </a:xfrm>
-          <a:prstGeom xmlns:a="http://schemas.openxmlformats.org/drawingml/2006/main" prst="rect">
-            <a:avLst/>
-          </a:prstGeom>
-          <a:noFill xmlns:a="http://schemas.openxmlformats.org/drawingml/2006/main"/>
-          <a:ln xmlns:a="http://schemas.openxmlformats.org/drawingml/2006/main" w="0">
-            <a:noFill/>
-            <a:prstDash val="solid"/>
-          </a:ln>
-        </p:spPr>
-        <p:txBody>
-          <a:bodyPr xmlns:a="http://schemas.openxmlformats.org/drawingml/2006/main" wrap="square" lIns="0" tIns="0" rIns="0" bIns="0" anchor="t">
-            <a:noAutofit/>
-          </a:bodyPr>
-          <a:lstStyle xmlns:a="http://schemas.openxmlformats.org/drawingml/2006/main">
-            <a:defPPr algn="l">
-              <a:defRPr sz="1950" b="0">
-                <a:solidFill>
-                  <a:srgbClr val="4A6572"/>
-                </a:solidFill>
-                <a:latin typeface="Aptos"/>
-                <a:ea typeface="Aptos"/>
-                <a:cs typeface="Aptos"/>
-              </a:defRPr>
-            </a:defPPr>
-          </a:lstStyle>
-          <a:p xmlns:a="http://schemas.openxmlformats.org/drawingml/2006/main">
-            <a:pPr algn="l">
-              <a:buNone/>
-              <a:defRPr sz="1950" b="0">
-                <a:solidFill>
-                  <a:srgbClr val="4A6572"/>
-                </a:solidFill>
-                <a:latin typeface="Aptos"/>
-                <a:ea typeface="Aptos"/>
-                <a:cs typeface="Aptos"/>
-              </a:defRPr>
-            </a:pPr>
-            <a:r>
-              <a:rPr sz="1950" b="0">
-                <a:solidFill>
-                  <a:srgbClr val="4A6572"/>
-                </a:solidFill>
-                <a:latin typeface="Aptos"/>
-                <a:ea typeface="Aptos"/>
-                <a:cs typeface="Aptos"/>
-              </a:rPr>
-              <a:t>Authorized task update</a:t>
-            </a:r>
-          </a:p>
-        </p:txBody>
-      </p:sp>
-      <p:cxnSp>
-        <p:nvCxnSpPr>
-          <p:cNvPr id="21" name="flow-158">
-            <a:extLst xmlns:a="http://schemas.openxmlformats.org/drawingml/2006/main">
-              <a:ext uri="{FF2B5EF4-FFF2-40B4-BE49-F238E27FC236}">
-                <a16:creationId xmlns:a16="http://schemas.microsoft.com/office/drawing/2014/main" id="{66349483-5A50-40B0-B266-21302A63AFCB}"/>
-              </a:ext>
-            </a:extLst>
-          </p:cNvPr>
-          <p:cNvCxnSpPr/>
-          <p:nvPr/>
-        </p:nvCxnSpPr>
-        <p:spPr>
-          <a:xfrm xmlns:a="http://schemas.openxmlformats.org/drawingml/2006/main" flipH="0" flipV="0">
-            <a:off x="609600" y="6477000"/>
-            <a:ext cx="5334000" cy="0"/>
-          </a:xfrm>
-          <a:prstGeom xmlns:a="http://schemas.openxmlformats.org/drawingml/2006/main" prst="straightConnector1">
-            <a:avLst/>
-          </a:prstGeom>
-          <a:ln xmlns:a="http://schemas.openxmlformats.org/drawingml/2006/main" w="14288">
-            <a:solidFill>
-              <a:srgbClr val="B8CACC"/>
-            </a:solidFill>
-            <a:prstDash val="solid"/>
-          </a:ln>
-        </p:spPr>
-      </p:cxnSp>
-      <p:sp>
-        <p:nvSpPr>
-          <p:cNvPr id="22" name="node-159">
-            <a:extLst xmlns:a="http://schemas.openxmlformats.org/drawingml/2006/main">
-              <a:ext uri="{FF2B5EF4-FFF2-40B4-BE49-F238E27FC236}">
-                <a16:creationId xmlns:a16="http://schemas.microsoft.com/office/drawing/2014/main" id="{3F5888FB-B549-4744-94BD-55682478694E}"/>
-              </a:ext>
-            </a:extLst>
-          </p:cNvPr>
-          <p:cNvSpPr>
-            <a:spLocks xmlns:a="http://schemas.openxmlformats.org/drawingml/2006/main" noGrp="1"/>
-          </p:cNvSpPr>
-          <p:nvPr/>
-        </p:nvSpPr>
-        <p:spPr>
-          <a:xfrm xmlns:a="http://schemas.openxmlformats.org/drawingml/2006/main">
-            <a:off x="609600" y="6858000"/>
-            <a:ext cx="5334000" cy="952500"/>
-          </a:xfrm>
-          <a:prstGeom xmlns:a="http://schemas.openxmlformats.org/drawingml/2006/main" prst="rect">
-            <a:avLst/>
-          </a:prstGeom>
-          <a:solidFill xmlns:a="http://schemas.openxmlformats.org/drawingml/2006/main">
-            <a:srgbClr val="FFFFFF"/>
-          </a:solidFill>
-          <a:ln xmlns:a="http://schemas.openxmlformats.org/drawingml/2006/main" w="17145">
-            <a:solidFill>
-              <a:srgbClr val="B8CACC"/>
-            </a:solidFill>
-            <a:prstDash val="solid"/>
-          </a:ln>
-        </p:spPr>
-      </p:sp>
-      <p:sp>
-        <p:nvSpPr>
-          <p:cNvPr id="23" name="text-160">
-            <a:extLst xmlns:a="http://schemas.openxmlformats.org/drawingml/2006/main">
-              <a:ext uri="{FF2B5EF4-FFF2-40B4-BE49-F238E27FC236}">
-                <a16:creationId xmlns:a16="http://schemas.microsoft.com/office/drawing/2014/main" id="{3174332F-933D-4987-A5E2-7FD7CE8CCE5B}"/>
-              </a:ext>
-            </a:extLst>
-          </p:cNvPr>
-          <p:cNvSpPr>
-            <a:spLocks xmlns:a="http://schemas.openxmlformats.org/drawingml/2006/main" noGrp="1"/>
-          </p:cNvSpPr>
-          <p:nvPr/>
-        </p:nvSpPr>
-        <p:spPr>
-          <a:xfrm xmlns:a="http://schemas.openxmlformats.org/drawingml/2006/main">
-            <a:off x="800100" y="7019925"/>
-            <a:ext cx="4953000" cy="386715"/>
-          </a:xfrm>
-          <a:prstGeom xmlns:a="http://schemas.openxmlformats.org/drawingml/2006/main" prst="rect">
-            <a:avLst/>
-          </a:prstGeom>
-          <a:noFill xmlns:a="http://schemas.openxmlformats.org/drawingml/2006/main"/>
-          <a:ln xmlns:a="http://schemas.openxmlformats.org/drawingml/2006/main" w="0">
-            <a:noFill/>
-            <a:prstDash val="solid"/>
-          </a:ln>
-        </p:spPr>
-        <p:txBody>
-          <a:bodyPr xmlns:a="http://schemas.openxmlformats.org/drawingml/2006/main" wrap="square" lIns="0" tIns="0" rIns="0" bIns="0" anchor="t">
-            <a:noAutofit/>
-          </a:bodyPr>
-          <a:lstStyle xmlns:a="http://schemas.openxmlformats.org/drawingml/2006/main">
-            <a:defPPr algn="l">
-              <a:defRPr sz="2250" b="1">
-                <a:solidFill>
-                  <a:srgbClr val="132E38"/>
-                </a:solidFill>
-                <a:latin typeface="Aptos"/>
-                <a:ea typeface="Aptos"/>
-                <a:cs typeface="Aptos"/>
-              </a:defRPr>
-            </a:defPPr>
-          </a:lstStyle>
-          <a:p xmlns:a="http://schemas.openxmlformats.org/drawingml/2006/main">
-            <a:pPr algn="l">
-              <a:buNone/>
-              <a:defRPr sz="2250" b="1">
-                <a:solidFill>
-                  <a:srgbClr val="132E38"/>
-                </a:solidFill>
-                <a:latin typeface="Aptos"/>
-                <a:ea typeface="Aptos"/>
-                <a:cs typeface="Aptos"/>
-              </a:defRPr>
-            </a:pPr>
-            <a:r>
-              <a:rPr sz="2250" b="1">
-                <a:solidFill>
-                  <a:srgbClr val="132E38"/>
-                </a:solidFill>
-                <a:latin typeface="Aptos"/>
-                <a:ea typeface="Aptos"/>
-                <a:cs typeface="Aptos"/>
-              </a:rPr>
               <a:t>Authorized human reviewer</a:t>
             </a:r>
           </a:p>
@@ -14160,7 +14200,7 @@
           <p:cNvPr id="27" name="flow-163">
             <a:extLst xmlns:a="http://schemas.openxmlformats.org/drawingml/2006/main">
               <a:ext uri="{FF2B5EF4-FFF2-40B4-BE49-F238E27FC236}">
-                <a16:creationId xmlns:a16="http://schemas.microsoft.com/office/drawing/2014/main" id="{8C9A3D5C-7BE3-4AF8-9C40-FB51EDBAD22C}"/>
+                <a16:creationId xmlns:a16="http://schemas.microsoft.com/office/drawing/2014/main" id="{E861DA4B-4845-48E9-B9A1-73275C411058}"/>
               </a:ext>
             </a:extLst>
           </p:cNvPr>
@@ -14188,7 +14228,7 @@
           <p:cNvPr id="28" name="flow-164">
             <a:extLst xmlns:a="http://schemas.openxmlformats.org/drawingml/2006/main">
               <a:ext uri="{FF2B5EF4-FFF2-40B4-BE49-F238E27FC236}">
-                <a16:creationId xmlns:a16="http://schemas.microsoft.com/office/drawing/2014/main" id="{41AC155E-C29D-4FBE-9125-71875122CF68}"/>
+                <a16:creationId xmlns:a16="http://schemas.microsoft.com/office/drawing/2014/main" id="{F5A2EB2C-855D-4850-A35B-5E581775762E}"/>
               </a:ext>
             </a:extLst>
           </p:cNvPr>
@@ -14216,7 +14256,7 @@
           <p:cNvPr id="29" name="flow-165">
             <a:extLst xmlns:a="http://schemas.openxmlformats.org/drawingml/2006/main">
               <a:ext uri="{FF2B5EF4-FFF2-40B4-BE49-F238E27FC236}">
-                <a16:creationId xmlns:a16="http://schemas.microsoft.com/office/drawing/2014/main" id="{46B354BC-263C-4A31-AB01-93B52D5100DC}"/>
+                <a16:creationId xmlns:a16="http://schemas.microsoft.com/office/drawing/2014/main" id="{4FFAE719-4C77-4766-B766-C76BBAA07764}"/>
               </a:ext>
             </a:extLst>
           </p:cNvPr>
@@ -14315,7 +14355,7 @@
           <p:cNvPr id="31" name="flow-167">
             <a:extLst xmlns:a="http://schemas.openxmlformats.org/drawingml/2006/main">
               <a:ext uri="{FF2B5EF4-FFF2-40B4-BE49-F238E27FC236}">
-                <a16:creationId xmlns:a16="http://schemas.microsoft.com/office/drawing/2014/main" id="{6E9984F7-475E-4988-8BD3-A0D2C5175F98}"/>
+                <a16:creationId xmlns:a16="http://schemas.microsoft.com/office/drawing/2014/main" id="{4F4A29F4-5A75-4A9A-ACAD-5FE523567CDD}"/>
               </a:ext>
             </a:extLst>
           </p:cNvPr>
@@ -14414,7 +14454,7 @@
           <p:cNvPr id="33" name="flow-169">
             <a:extLst xmlns:a="http://schemas.openxmlformats.org/drawingml/2006/main">
               <a:ext uri="{FF2B5EF4-FFF2-40B4-BE49-F238E27FC236}">
-                <a16:creationId xmlns:a16="http://schemas.microsoft.com/office/drawing/2014/main" id="{FF5185BC-DC54-4EE1-B87B-EC47F60BD949}"/>
+                <a16:creationId xmlns:a16="http://schemas.microsoft.com/office/drawing/2014/main" id="{EC7DDB2E-1145-4C66-9470-0A8E3BE6190D}"/>
               </a:ext>
             </a:extLst>
           </p:cNvPr>
@@ -14433,7 +14473,7 @@
             <a:solidFill>
               <a:srgbClr val="157D80"/>
             </a:solidFill>
-            <a:prstDash val="solid"/>
+            <a:prstDash val="dash"/>
             <a:tailEnd type="triangle" w="med" len="med"/>
           </a:ln>
         </p:spPr>
@@ -14503,7 +14543,31 @@
                 <a:ea typeface="Aptos"/>
                 <a:cs typeface="Aptos"/>
               </a:rPr>
-              <a:t>Validated evidence</a:t>
+              <a:t>Saved candidate</a:t>
+            </a:r>
+          </a:p>
+          <a:p xmlns:a="http://schemas.openxmlformats.org/drawingml/2006/main">
+            <a:pPr algn="ctr">
+              <a:buNone/>
+              <a:defRPr sz="1725" b="0">
+                <a:solidFill>
+                  <a:srgbClr val="4A6572"/>
+                </a:solidFill>
+                <a:latin typeface="Aptos"/>
+                <a:ea typeface="Aptos"/>
+                <a:cs typeface="Aptos"/>
+              </a:defRPr>
+            </a:pPr>
+            <a:r>
+              <a:rPr sz="1725" b="0">
+                <a:solidFill>
+                  <a:srgbClr val="4A6572"/>
+                </a:solidFill>
+                <a:latin typeface="Aptos"/>
+                <a:ea typeface="Aptos"/>
+                <a:cs typeface="Aptos"/>
+              </a:rPr>
+              <a:t>Review handoff next</a:t>
             </a:r>
           </a:p>
         </p:txBody>
@@ -14513,7 +14577,7 @@
           <p:cNvPr id="35" name="flow-171">
             <a:extLst xmlns:a="http://schemas.openxmlformats.org/drawingml/2006/main">
               <a:ext uri="{FF2B5EF4-FFF2-40B4-BE49-F238E27FC236}">
-                <a16:creationId xmlns:a16="http://schemas.microsoft.com/office/drawing/2014/main" id="{B64E98BC-F4C7-4173-9032-9C1E8C8381CC}"/>
+                <a16:creationId xmlns:a16="http://schemas.microsoft.com/office/drawing/2014/main" id="{9743F637-A6A5-4226-A24E-BE9DF8D49AF9}"/>
               </a:ext>
             </a:extLst>
           </p:cNvPr>
@@ -14541,7 +14605,7 @@
           <p:cNvPr id="36" name="flow-172">
             <a:extLst xmlns:a="http://schemas.openxmlformats.org/drawingml/2006/main">
               <a:ext uri="{FF2B5EF4-FFF2-40B4-BE49-F238E27FC236}">
-                <a16:creationId xmlns:a16="http://schemas.microsoft.com/office/drawing/2014/main" id="{92BA4FDE-B06D-4423-8C76-41FB57E367FF}"/>
+                <a16:creationId xmlns:a16="http://schemas.microsoft.com/office/drawing/2014/main" id="{0487D37B-C33D-419E-9B91-8F3BE9DF6DF9}"/>
               </a:ext>
             </a:extLst>
           </p:cNvPr>
@@ -14569,7 +14633,7 @@
           <p:cNvPr id="37" name="flow-173">
             <a:extLst xmlns:a="http://schemas.openxmlformats.org/drawingml/2006/main">
               <a:ext uri="{FF2B5EF4-FFF2-40B4-BE49-F238E27FC236}">
-                <a16:creationId xmlns:a16="http://schemas.microsoft.com/office/drawing/2014/main" id="{EB283368-94A3-45DC-B582-7DF3AEAEB353}"/>
+                <a16:creationId xmlns:a16="http://schemas.microsoft.com/office/drawing/2014/main" id="{9245F350-9661-41C5-A84A-EAABE9D2D4F0}"/>
               </a:ext>
             </a:extLst>
           </p:cNvPr>
@@ -14668,7 +14732,7 @@
           <p:cNvPr id="39" name="flow-175">
             <a:extLst xmlns:a="http://schemas.openxmlformats.org/drawingml/2006/main">
               <a:ext uri="{FF2B5EF4-FFF2-40B4-BE49-F238E27FC236}">
-                <a16:creationId xmlns:a16="http://schemas.microsoft.com/office/drawing/2014/main" id="{AE8BA6A1-1C3B-49E0-A662-A56C3AABA7F2}"/>
+                <a16:creationId xmlns:a16="http://schemas.microsoft.com/office/drawing/2014/main" id="{990AC02A-23C9-427A-BC76-D4F6DBD93D6F}"/>
               </a:ext>
             </a:extLst>
           </p:cNvPr>
@@ -14696,7 +14760,7 @@
           <p:cNvPr id="40" name="flow-176">
             <a:extLst xmlns:a="http://schemas.openxmlformats.org/drawingml/2006/main">
               <a:ext uri="{FF2B5EF4-FFF2-40B4-BE49-F238E27FC236}">
-                <a16:creationId xmlns:a16="http://schemas.microsoft.com/office/drawing/2014/main" id="{600CE152-AE3D-46D4-A504-B5F6D7534253}"/>
+                <a16:creationId xmlns:a16="http://schemas.microsoft.com/office/drawing/2014/main" id="{85DFC6C0-B1F4-44ED-A008-6808345A3073}"/>
               </a:ext>
             </a:extLst>
           </p:cNvPr>
@@ -14724,7 +14788,7 @@
           <p:cNvPr id="41" name="flow-177">
             <a:extLst xmlns:a="http://schemas.openxmlformats.org/drawingml/2006/main">
               <a:ext uri="{FF2B5EF4-FFF2-40B4-BE49-F238E27FC236}">
-                <a16:creationId xmlns:a16="http://schemas.microsoft.com/office/drawing/2014/main" id="{C726FAEB-C2E6-4AA7-AFFC-1499C7D9E3D7}"/>
+                <a16:creationId xmlns:a16="http://schemas.microsoft.com/office/drawing/2014/main" id="{BB981CBA-718D-40B5-A2A6-1E5120660BE8}"/>
               </a:ext>
             </a:extLst>
           </p:cNvPr>
@@ -14752,7 +14816,7 @@
           <p:cNvPr id="42" name="flow-178">
             <a:extLst xmlns:a="http://schemas.openxmlformats.org/drawingml/2006/main">
               <a:ext uri="{FF2B5EF4-FFF2-40B4-BE49-F238E27FC236}">
-                <a16:creationId xmlns:a16="http://schemas.microsoft.com/office/drawing/2014/main" id="{D1A4B1E5-77BC-4442-A91F-5D31790F5FF1}"/>
+                <a16:creationId xmlns:a16="http://schemas.microsoft.com/office/drawing/2014/main" id="{97FCC60A-03AE-4FF5-9195-199D77EA3064}"/>
               </a:ext>
             </a:extLst>
           </p:cNvPr>
@@ -15626,7 +15690,7 @@
           <p:cNvPr id="10" name="partner-flow-14">
             <a:extLst xmlns:a="http://schemas.openxmlformats.org/drawingml/2006/main">
               <a:ext uri="{FF2B5EF4-FFF2-40B4-BE49-F238E27FC236}">
-                <a16:creationId xmlns:a16="http://schemas.microsoft.com/office/drawing/2014/main" id="{7053BFAA-4CC8-4864-BFDF-5911A6EB9E33}"/>
+                <a16:creationId xmlns:a16="http://schemas.microsoft.com/office/drawing/2014/main" id="{C1FB5187-2091-4B2F-B26A-FF2429B1FA00}"/>
               </a:ext>
             </a:extLst>
           </p:cNvPr>
@@ -15971,7 +16035,7 @@
           <p:cNvPr id="15" name="partner-flow-19">
             <a:extLst xmlns:a="http://schemas.openxmlformats.org/drawingml/2006/main">
               <a:ext uri="{FF2B5EF4-FFF2-40B4-BE49-F238E27FC236}">
-                <a16:creationId xmlns:a16="http://schemas.microsoft.com/office/drawing/2014/main" id="{3C810182-40BC-457E-98DE-F040AB5F0D8D}"/>
+                <a16:creationId xmlns:a16="http://schemas.microsoft.com/office/drawing/2014/main" id="{C6D5B310-1D15-45BE-BFE7-6709B47B9A84}"/>
               </a:ext>
             </a:extLst>
           </p:cNvPr>
@@ -16267,7 +16331,7 @@
           <p:cNvPr id="20" name="partner-flow-24">
             <a:extLst xmlns:a="http://schemas.openxmlformats.org/drawingml/2006/main">
               <a:ext uri="{FF2B5EF4-FFF2-40B4-BE49-F238E27FC236}">
-                <a16:creationId xmlns:a16="http://schemas.microsoft.com/office/drawing/2014/main" id="{2FF0F711-F536-4B8A-AD68-D7346A2A1B1B}"/>
+                <a16:creationId xmlns:a16="http://schemas.microsoft.com/office/drawing/2014/main" id="{688DCCBC-6817-4A75-95D4-22D8396A0E54}"/>
               </a:ext>
             </a:extLst>
           </p:cNvPr>
@@ -16295,7 +16359,7 @@
           <p:cNvPr id="21" name="partner-flow-25">
             <a:extLst xmlns:a="http://schemas.openxmlformats.org/drawingml/2006/main">
               <a:ext uri="{FF2B5EF4-FFF2-40B4-BE49-F238E27FC236}">
-                <a16:creationId xmlns:a16="http://schemas.microsoft.com/office/drawing/2014/main" id="{CE6CCB48-8545-4F96-91F8-28E517050973}"/>
+                <a16:creationId xmlns:a16="http://schemas.microsoft.com/office/drawing/2014/main" id="{C52DC936-70A5-4C5F-A32D-7D31CD24644C}"/>
               </a:ext>
             </a:extLst>
           </p:cNvPr>
@@ -16323,7 +16387,7 @@
           <p:cNvPr id="22" name="partner-flow-26">
             <a:extLst xmlns:a="http://schemas.openxmlformats.org/drawingml/2006/main">
               <a:ext uri="{FF2B5EF4-FFF2-40B4-BE49-F238E27FC236}">
-                <a16:creationId xmlns:a16="http://schemas.microsoft.com/office/drawing/2014/main" id="{846A3AF9-44FE-4F69-8C01-7767FB217587}"/>
+                <a16:creationId xmlns:a16="http://schemas.microsoft.com/office/drawing/2014/main" id="{BD26B45E-DFC7-485C-A8C8-8E005339C3C1}"/>
               </a:ext>
             </a:extLst>
           </p:cNvPr>
@@ -17757,7 +17821,7 @@
           <p:cNvPr id="16" name="partner-flow-45">
             <a:extLst xmlns:a="http://schemas.openxmlformats.org/drawingml/2006/main">
               <a:ext uri="{FF2B5EF4-FFF2-40B4-BE49-F238E27FC236}">
-                <a16:creationId xmlns:a16="http://schemas.microsoft.com/office/drawing/2014/main" id="{A9B15B4F-E453-4BE4-B5B7-DB41D0C47AA4}"/>
+                <a16:creationId xmlns:a16="http://schemas.microsoft.com/office/drawing/2014/main" id="{97E60165-6DBA-4CE5-ADB4-8F5BC04CB5C4}"/>
               </a:ext>
             </a:extLst>
           </p:cNvPr>
@@ -17786,7 +17850,7 @@
           <p:cNvPr id="17" name="partner-flow-46">
             <a:extLst xmlns:a="http://schemas.openxmlformats.org/drawingml/2006/main">
               <a:ext uri="{FF2B5EF4-FFF2-40B4-BE49-F238E27FC236}">
-                <a16:creationId xmlns:a16="http://schemas.microsoft.com/office/drawing/2014/main" id="{213E47D0-76F3-43CA-ACA0-3BE813120F9E}"/>
+                <a16:creationId xmlns:a16="http://schemas.microsoft.com/office/drawing/2014/main" id="{AA8592C8-2180-44A1-93B2-F1157510F9F1}"/>
               </a:ext>
             </a:extLst>
           </p:cNvPr>
@@ -17815,7 +17879,7 @@
           <p:cNvPr id="18" name="partner-flow-47">
             <a:extLst xmlns:a="http://schemas.openxmlformats.org/drawingml/2006/main">
               <a:ext uri="{FF2B5EF4-FFF2-40B4-BE49-F238E27FC236}">
-                <a16:creationId xmlns:a16="http://schemas.microsoft.com/office/drawing/2014/main" id="{F39F82FC-2DA1-4CB9-9D10-51547946F5F3}"/>
+                <a16:creationId xmlns:a16="http://schemas.microsoft.com/office/drawing/2014/main" id="{EB3D61D6-5EF2-4322-8A24-2B2DF5A8E929}"/>
               </a:ext>
             </a:extLst>
           </p:cNvPr>
@@ -17844,7 +17908,7 @@
           <p:cNvPr id="19" name="partner-flow-48">
             <a:extLst xmlns:a="http://schemas.openxmlformats.org/drawingml/2006/main">
               <a:ext uri="{FF2B5EF4-FFF2-40B4-BE49-F238E27FC236}">
-                <a16:creationId xmlns:a16="http://schemas.microsoft.com/office/drawing/2014/main" id="{823279A2-F902-45C2-BED8-927CC8DB361E}"/>
+                <a16:creationId xmlns:a16="http://schemas.microsoft.com/office/drawing/2014/main" id="{B3EBBFBE-5872-42F2-A644-D5B19C4266F2}"/>
               </a:ext>
             </a:extLst>
           </p:cNvPr>
@@ -17872,7 +17936,7 @@
           <p:cNvPr id="20" name="partner-flow-49">
             <a:extLst xmlns:a="http://schemas.openxmlformats.org/drawingml/2006/main">
               <a:ext uri="{FF2B5EF4-FFF2-40B4-BE49-F238E27FC236}">
-                <a16:creationId xmlns:a16="http://schemas.microsoft.com/office/drawing/2014/main" id="{BC3B5E22-C13A-4C15-B730-9AA440AE21F6}"/>
+                <a16:creationId xmlns:a16="http://schemas.microsoft.com/office/drawing/2014/main" id="{45B82E9C-590A-4E53-820E-09B6CEEF26C8}"/>
               </a:ext>
             </a:extLst>
           </p:cNvPr>
@@ -17900,7 +17964,7 @@
           <p:cNvPr id="21" name="partner-flow-50">
             <a:extLst xmlns:a="http://schemas.openxmlformats.org/drawingml/2006/main">
               <a:ext uri="{FF2B5EF4-FFF2-40B4-BE49-F238E27FC236}">
-                <a16:creationId xmlns:a16="http://schemas.microsoft.com/office/drawing/2014/main" id="{A0698FFB-354A-4754-9FDD-48431269D798}"/>
+                <a16:creationId xmlns:a16="http://schemas.microsoft.com/office/drawing/2014/main" id="{42F21023-ABDD-4F0B-826B-389A5A2339DB}"/>
               </a:ext>
             </a:extLst>
           </p:cNvPr>
@@ -17999,7 +18063,7 @@
           <p:cNvPr id="23" name="partner-flow-52">
             <a:extLst xmlns:a="http://schemas.openxmlformats.org/drawingml/2006/main">
               <a:ext uri="{FF2B5EF4-FFF2-40B4-BE49-F238E27FC236}">
-                <a16:creationId xmlns:a16="http://schemas.microsoft.com/office/drawing/2014/main" id="{31AECDA0-1654-4C82-A21C-14E41BCEC69C}"/>
+                <a16:creationId xmlns:a16="http://schemas.microsoft.com/office/drawing/2014/main" id="{C7AFD679-8C94-4545-8C92-F4DA78B526B7}"/>
               </a:ext>
             </a:extLst>
           </p:cNvPr>
@@ -18027,7 +18091,7 @@
           <p:cNvPr id="24" name="partner-flow-53">
             <a:extLst xmlns:a="http://schemas.openxmlformats.org/drawingml/2006/main">
               <a:ext uri="{FF2B5EF4-FFF2-40B4-BE49-F238E27FC236}">
-                <a16:creationId xmlns:a16="http://schemas.microsoft.com/office/drawing/2014/main" id="{3A00E6D0-35AF-4C68-B73B-0E7B68940C86}"/>
+                <a16:creationId xmlns:a16="http://schemas.microsoft.com/office/drawing/2014/main" id="{4373D710-8140-4F15-BBE9-4E83C451CF47}"/>
               </a:ext>
             </a:extLst>
           </p:cNvPr>
@@ -18055,7 +18119,7 @@
           <p:cNvPr id="25" name="partner-flow-54">
             <a:extLst xmlns:a="http://schemas.openxmlformats.org/drawingml/2006/main">
               <a:ext uri="{FF2B5EF4-FFF2-40B4-BE49-F238E27FC236}">
-                <a16:creationId xmlns:a16="http://schemas.microsoft.com/office/drawing/2014/main" id="{B24AFD93-EFCA-4EBC-AFC1-6B1E5A6028B5}"/>
+                <a16:creationId xmlns:a16="http://schemas.microsoft.com/office/drawing/2014/main" id="{187BF84D-1085-4C66-A9CF-ED6A4F7838B2}"/>
               </a:ext>
             </a:extLst>
           </p:cNvPr>
@@ -18600,7 +18664,7 @@
           <p:cNvPr id="33" name="changed-assertions-edge-label-leader">
             <a:extLst xmlns:a="http://schemas.openxmlformats.org/drawingml/2006/main">
               <a:ext uri="{FF2B5EF4-FFF2-40B4-BE49-F238E27FC236}">
-                <a16:creationId xmlns:a16="http://schemas.microsoft.com/office/drawing/2014/main" id="{3BACE6B9-C148-453B-B8BE-FE0D77EF2323}"/>
+                <a16:creationId xmlns:a16="http://schemas.microsoft.com/office/drawing/2014/main" id="{12734BAE-6D6B-40BA-B926-14249190C5C4}"/>
               </a:ext>
             </a:extLst>
           </p:cNvPr>
@@ -18797,7 +18861,7 @@
           <p:cNvPr id="5" name="">
             <a:extLst xmlns:a="http://schemas.openxmlformats.org/drawingml/2006/main">
               <a:ext uri="{FF2B5EF4-FFF2-40B4-BE49-F238E27FC236}">
-                <a16:creationId xmlns:a16="http://schemas.microsoft.com/office/drawing/2014/main" id="{FA08A9B3-066A-4F3F-A7DE-375642552566}"/>
+                <a16:creationId xmlns:a16="http://schemas.microsoft.com/office/drawing/2014/main" id="{66340D06-6D3F-4F49-9CBF-76D471DBD0CF}"/>
               </a:ext>
             </a:extLst>
           </p:cNvPr>
@@ -19056,7 +19120,7 @@
                           <a:ea typeface="Aptos"/>
                           <a:cs typeface="Aptos"/>
                         </a:rPr>
-                        <a:t>Confirm Drive source access</a:t>
+                        <a:t>Confirm Drive sources and access</a:t>
                       </a:r>
                     </a:p>
                     <a:p>
@@ -19069,7 +19133,7 @@
                           <a:ea typeface="Aptos"/>
                           <a:cs typeface="Aptos"/>
                         </a:rPr>
-                        <a:t>Connect the source job</a:t>
+                        <a:t>Qualify the live source job</a:t>
                       </a:r>
                     </a:p>
                   </a:txBody>
@@ -19840,6 +19904,19 @@
                           <a:ea typeface="Aptos"/>
                           <a:cs typeface="Aptos"/>
                         </a:rPr>
+                        <a:t>Implement trusted submission and review</a:t>
+                      </a:r>
+                    </a:p>
+                    <a:p>
+                      <a:r>
+                        <a:rPr sz="1875" b="0">
+                          <a:solidFill>
+                            <a:srgbClr val="132E38"/>
+                          </a:solidFill>
+                          <a:latin typeface="Aptos"/>
+                          <a:ea typeface="Aptos"/>
+                          <a:cs typeface="Aptos"/>
+                        </a:rPr>
                         <a:t>Enroll and qualify a second contributor</a:t>
                       </a:r>
                     </a:p>
@@ -20461,7 +20538,7 @@
           <p:cNvPr id="9" name="flow-217">
             <a:extLst xmlns:a="http://schemas.openxmlformats.org/drawingml/2006/main">
               <a:ext uri="{FF2B5EF4-FFF2-40B4-BE49-F238E27FC236}">
-                <a16:creationId xmlns:a16="http://schemas.microsoft.com/office/drawing/2014/main" id="{447003AE-9C1A-415B-8FFF-4148B3BA88B6}"/>
+                <a16:creationId xmlns:a16="http://schemas.microsoft.com/office/drawing/2014/main" id="{B5A08364-19E8-490E-84FB-00264A8B600D}"/>
               </a:ext>
             </a:extLst>
           </p:cNvPr>
@@ -20490,7 +20567,7 @@
           <p:cNvPr id="10" name="flow-218">
             <a:extLst xmlns:a="http://schemas.openxmlformats.org/drawingml/2006/main">
               <a:ext uri="{FF2B5EF4-FFF2-40B4-BE49-F238E27FC236}">
-                <a16:creationId xmlns:a16="http://schemas.microsoft.com/office/drawing/2014/main" id="{23E22D28-C01A-4B8F-A184-0E16FE5BC9A9}"/>
+                <a16:creationId xmlns:a16="http://schemas.microsoft.com/office/drawing/2014/main" id="{78E21F28-8046-4B61-8154-B2D469F4D881}"/>
               </a:ext>
             </a:extLst>
           </p:cNvPr>
@@ -20603,7 +20680,7 @@
                 <a:ea typeface="Aptos"/>
                 <a:cs typeface="Aptos"/>
               </a:rPr>
-              <a:t>Roundtable core and client</a:t>
+              <a:t>Meeting sources and follow-up</a:t>
             </a:r>
           </a:p>
           <a:p xmlns:a="http://schemas.openxmlformats.org/drawingml/2006/main">
@@ -20865,7 +20942,7 @@
                 <a:ea typeface="Aptos"/>
                 <a:cs typeface="Aptos"/>
               </a:rPr>
-              <a:t>Cloud rehearsal tooling</a:t>
+              <a:t>Durable review and cancellation</a:t>
             </a:r>
           </a:p>
           <a:p xmlns:a="http://schemas.openxmlformats.org/drawingml/2006/main">
@@ -20889,7 +20966,31 @@
                 <a:ea typeface="Aptos"/>
                 <a:cs typeface="Aptos"/>
               </a:rPr>
-              <a:t>Durable review and cancellation</a:t>
+              <a:t>Discovery and alert routing</a:t>
+            </a:r>
+          </a:p>
+          <a:p xmlns:a="http://schemas.openxmlformats.org/drawingml/2006/main">
+            <a:pPr algn="l">
+              <a:buNone/>
+              <a:defRPr sz="2025" b="0">
+                <a:solidFill>
+                  <a:srgbClr val="132E38"/>
+                </a:solidFill>
+                <a:latin typeface="Aptos"/>
+                <a:ea typeface="Aptos"/>
+                <a:cs typeface="Aptos"/>
+              </a:defRPr>
+            </a:pPr>
+            <a:r>
+              <a:rPr sz="2025" b="0">
+                <a:solidFill>
+                  <a:srgbClr val="132E38"/>
+                </a:solidFill>
+                <a:latin typeface="Aptos"/>
+                <a:ea typeface="Aptos"/>
+                <a:cs typeface="Aptos"/>
+              </a:rPr>
+              <a:t>Member candidate validation</a:t>
             </a:r>
           </a:p>
         </p:txBody>
@@ -20983,7 +21084,7 @@
                 <a:ea typeface="Aptos"/>
                 <a:cs typeface="Aptos"/>
               </a:rPr>
-              <a:t>Operational discovery and alerts</a:t>
+              <a:t>Live research and alert qualification</a:t>
             </a:r>
           </a:p>
           <a:p xmlns:a="http://schemas.openxmlformats.org/drawingml/2006/main">
@@ -21113,7 +21214,7 @@
           <p:cNvPr id="14" name="flow-222">
             <a:extLst xmlns:a="http://schemas.openxmlformats.org/drawingml/2006/main">
               <a:ext uri="{FF2B5EF4-FFF2-40B4-BE49-F238E27FC236}">
-                <a16:creationId xmlns:a16="http://schemas.microsoft.com/office/drawing/2014/main" id="{7082CDD1-641A-4414-9749-37D6EC064BD7}"/>
+                <a16:creationId xmlns:a16="http://schemas.microsoft.com/office/drawing/2014/main" id="{31ED6B22-2C8A-497A-A492-99526EE4161B}"/>
               </a:ext>
             </a:extLst>
           </p:cNvPr>

</xml_diff>

<commit_message>
docs: sync merged packet core and SQL tool status
</commit_message>
<xml_diff>
--- a/Inertia-Architecture.pptx
+++ b/Inertia-Architecture.pptx
@@ -2,21 +2,21 @@
 <file path=ppt/presentation.xml><?xml version="1.0" encoding="utf-8"?>
 <p:presentation xmlns:p="http://schemas.openxmlformats.org/presentationml/2006/main">
   <p:sldMasterIdLst>
-    <p:sldMasterId xmlns:r="http://schemas.openxmlformats.org/officeDocument/2006/relationships" id="2147483648" r:id="Rfb43b6fd7fcf4b77"/>
+    <p:sldMasterId xmlns:r="http://schemas.openxmlformats.org/officeDocument/2006/relationships" id="2147483648" r:id="Ra1b673d9b34c42e8"/>
   </p:sldMasterIdLst>
   <p:notesMasterIdLst>
-    <p:notesMasterId xmlns:r="http://schemas.openxmlformats.org/officeDocument/2006/relationships" r:id="Rfbbf48d8c317414b"/>
+    <p:notesMasterId xmlns:r="http://schemas.openxmlformats.org/officeDocument/2006/relationships" r:id="Rf81cefadcc6440ad"/>
   </p:notesMasterIdLst>
   <p:sldIdLst>
-    <p:sldId xmlns:r="http://schemas.openxmlformats.org/officeDocument/2006/relationships" id="256" r:id="R33fdfd251ee04213"/>
-    <p:sldId xmlns:r="http://schemas.openxmlformats.org/officeDocument/2006/relationships" id="257" r:id="R58d0fe2a28df44f9"/>
-    <p:sldId xmlns:r="http://schemas.openxmlformats.org/officeDocument/2006/relationships" id="258" r:id="Ra46311dd605541a9"/>
-    <p:sldId xmlns:r="http://schemas.openxmlformats.org/officeDocument/2006/relationships" id="259" r:id="R208b24cd802c4ad0"/>
-    <p:sldId xmlns:r="http://schemas.openxmlformats.org/officeDocument/2006/relationships" id="260" r:id="R36df038db8c74601"/>
-    <p:sldId xmlns:r="http://schemas.openxmlformats.org/officeDocument/2006/relationships" id="261" r:id="R5db84b637f5541d3"/>
-    <p:sldId xmlns:r="http://schemas.openxmlformats.org/officeDocument/2006/relationships" id="262" r:id="R280c3796318d49fe"/>
-    <p:sldId xmlns:r="http://schemas.openxmlformats.org/officeDocument/2006/relationships" id="263" r:id="Rd7a6af5e91e04dc0"/>
-    <p:sldId xmlns:r="http://schemas.openxmlformats.org/officeDocument/2006/relationships" id="264" r:id="R3aacd62184dc4652"/>
+    <p:sldId xmlns:r="http://schemas.openxmlformats.org/officeDocument/2006/relationships" id="256" r:id="Rf94bc82259144592"/>
+    <p:sldId xmlns:r="http://schemas.openxmlformats.org/officeDocument/2006/relationships" id="257" r:id="R2d4cab23c58144c1"/>
+    <p:sldId xmlns:r="http://schemas.openxmlformats.org/officeDocument/2006/relationships" id="258" r:id="R875bcf3150f840ce"/>
+    <p:sldId xmlns:r="http://schemas.openxmlformats.org/officeDocument/2006/relationships" id="259" r:id="R13c9e85416f54c47"/>
+    <p:sldId xmlns:r="http://schemas.openxmlformats.org/officeDocument/2006/relationships" id="260" r:id="R077f40ab50434fce"/>
+    <p:sldId xmlns:r="http://schemas.openxmlformats.org/officeDocument/2006/relationships" id="261" r:id="R7693e4ab2f3b46c8"/>
+    <p:sldId xmlns:r="http://schemas.openxmlformats.org/officeDocument/2006/relationships" id="262" r:id="Rf3803cc0b6fd4648"/>
+    <p:sldId xmlns:r="http://schemas.openxmlformats.org/officeDocument/2006/relationships" id="263" r:id="R44b4aa6372a24a9d"/>
+    <p:sldId xmlns:r="http://schemas.openxmlformats.org/officeDocument/2006/relationships" id="264" r:id="Rf4b8a1f8d5f34b19"/>
   </p:sldIdLst>
   <p:sldSz cx="15240000" cy="8572500"/>
   <p:notesSz cx="6858000" cy="9144000"/>
@@ -450,7 +450,7 @@
           <a:lstStyle xmlns:a="http://schemas.openxmlformats.org/drawingml/2006/main"/>
           <a:p xmlns:a="http://schemas.openxmlformats.org/drawingml/2006/main">
             <a:r>
-              <a:t>Sources: spec.md, decisions.md and plan.md. Current public source: https://github.com/NetRxn/Inertia/pull/53.</a:t>
+              <a:t>Sources: spec.md, decisions.md and plan.md. Current public source: https://github.com/NetRxn/Inertia/pull/56, retaining PR53 host qualification.</a:t>
             </a:r>
           </a:p>
           <a:p xmlns:a="http://schemas.openxmlformats.org/drawingml/2006/main">
@@ -470,7 +470,7 @@
           </a:p>
           <a:p xmlns:a="http://schemas.openxmlformats.org/drawingml/2006/main">
             <a:r>
-              <a:t>This chosen target is not a deployed-integration claim. PR53 source-qualified default-disabled host assembly, early SDK pre-buffer byte/deadline checks, manual invocation and native state-delete reset. Actual data/source/action bindings, source-row allocation, remaining deployment/latency compatibility, approved lifecycle/authentication/network integration, writer fencing and live walkthrough remain gates. New v2 exact-version member confirmation and submission recording are in progress, not merged. Legacy v1 records remain intact.</a:t>
+              <a:t>This chosen target is not a deployed-integration claim. PR53 source-qualified default-disabled host assembly, early SDK pre-buffer byte/deadline checks, manual invocation and native state-delete reset. Actual data/source/action bindings, source-row allocation, remaining deployment/latency compatibility, approved lifecycle/authentication/network integration, writer fencing and live walkthrough remain gates. Packet-v2 contract/freeze core source is merged. Native capture is the current bounded #40 task; UI/signed-human Buzz, real current-authority resolver/transport and provider execution remain unqualified. Legacy v1 records remain intact.</a:t>
             </a:r>
           </a:p>
         </p:txBody>
@@ -560,7 +560,7 @@
           </a:p>
           <a:p xmlns:a="http://schemas.openxmlformats.org/drawingml/2006/main">
             <a:r>
-              <a:t>Any authenticated, currently verified DAO member with current application action access may confirm the exact immutable version under the chosen v2 policy. No named application owner or default five specialist human gates. V2 is in progress, not merged/deployed. Real sponsor signatures or DAO/Vocdoni governance apply only when genuinely required. Preserve exact versions, source scope, replay/conflict denial and current access checks. Reference packets and answer keys are separate from actual generated output.</a:t>
+              <a:t>Any authenticated, currently verified DAO member with current application action access may confirm the exact immutable version under the chosen v2 policy. No named application owner or default five specialist human gates. V2 packet primitives are merged; native/Buzz and real authority integration remain unqualified. Source: https://github.com/NetRxn/Inertia/pull/56. Real sponsor signatures or DAO/Vocdoni governance apply only when genuinely required. Preserve exact versions, source scope, replay/conflict denial and current access checks. Reference packets and answer keys are separate from actual generated output.</a:t>
             </a:r>
           </a:p>
         </p:txBody>
@@ -730,7 +730,7 @@
           </a:p>
           <a:p xmlns:a="http://schemas.openxmlformats.org/drawingml/2006/main">
             <a:r>
-              <a:t>This is the chosen v2 workflow, not a claim of merged/deployed v2. Agents prepare and independently critique; they never supply human approval. Any authenticated, currently verified DAO member with current application review access may confirm the exact immutable packet/version/artifact bytes. There is no named application owner or default five-specialist human ceremony. Actual sponsor signatures and DAO/Vocdoni governance apply only when the real case requires them.</a:t>
+              <a:t>The v2 packet contract/freeze core is merged in https://github.com/NetRxn/Inertia/pull/56. The native/Buzz member-action path and real authority binding remain unqualified; this diagram is not a deployment claim. Agents prepare and independently critique; they never supply human approval. Any authenticated, currently verified DAO member with current application review access may confirm the exact immutable packet/version/artifact bytes. There is no named application owner or default five-specialist human ceremony. Actual sponsor signatures and DAO/Vocdoni governance apply only when the real case requires them.</a:t>
             </a:r>
           </a:p>
           <a:p xmlns:a="http://schemas.openxmlformats.org/drawingml/2006/main">
@@ -840,7 +840,7 @@
           </a:p>
           <a:p xmlns:a="http://schemas.openxmlformats.org/drawingml/2006/main">
             <a:r>
-              <a:t>V2 member actions are in progress, not merged or deployed. Preserve original authenticated actor, exact packet/version/policy, current action rights, stale/conflict denial and authoritative readback. No named application owner or default five-specialist setup is needed.</a:t>
+              <a:t>V2 packet primitives are merged in https://github.com/NetRxn/Inertia/pull/56. Native capture is being implemented; real authorization, UI/signed-human Buzz and actual provider/human execution remain pending. Preserve original authenticated actor, exact packet/version/policy, current action rights, stale/conflict denial and authoritative readback. No named application owner or default five-specialist setup is needed.</a:t>
             </a:r>
           </a:p>
           <a:p xmlns:a="http://schemas.openxmlformats.org/drawingml/2006/main">
@@ -1053,6 +1053,16 @@
               <a:t>Helix and Y2 are deferred from Wednesday. Do not require full graph backfill, a graph migration or historical graph p95/size targets as entry gates. Future reversible adapters still need actual fencing/revision, tombstone/removal, lost-response and rebuild qualification. Measure actual current-path timing and coverage; no deployed SQL integration or unmeasured performance is claimed.</a:t>
             </a:r>
           </a:p>
+          <a:p xmlns:a="http://schemas.openxmlformats.org/drawingml/2006/main">
+            <a:r>
+              <a:t/>
+            </a:r>
+          </a:p>
+          <a:p xmlns:a="http://schemas.openxmlformats.org/drawingml/2006/main">
+            <a:r>
+              <a:t>Named owning-domain SQL knowledge tools are merged with local PostgreSQL facade qualification. Production current-authority resolver/transport, provider execution and actual system-run evidence remain unqualified; source qualification is not deployment.</a:t>
+            </a:r>
+          </a:p>
         </p:txBody>
       </p:sp>
       <p:sp>
@@ -1150,7 +1160,7 @@
           </a:p>
           <a:p xmlns:a="http://schemas.openxmlformats.org/drawingml/2006/main">
             <a:r>
-              <a:t>Engineering owns v2 guarded member action and submitted-record implementation, actual system-generated research/draft/critique, SQL writeback/reuse, runbook/video and measurements. V2 is in progress, not merged/deployed. Team contacts are operational contacts, not named application approval owners. No new permissions, deployment, deletion, account or external submission is performed.</a:t>
+              <a:t>Engineering owns the remaining native/Buzz member-action and submitted-record wiring, actual system-generated research/draft/critique, SQL writeback/reuse, runbook/video and measurements. Packet-v2 core source is merged in https://github.com/NetRxn/Inertia/pull/56. Named owning-domain SQL tools have merged source/local PostgreSQL facade qualification. Real resolver/transport/provider execution and end-to-end member action remain unqualified. Team contacts are operational contacts, not named application approval owners. No new permissions, deployment, deletion, account or external submission is performed.</a:t>
             </a:r>
           </a:p>
         </p:txBody>
@@ -1240,7 +1250,7 @@
           </a:p>
           <a:p xmlns:a="http://schemas.openxmlformats.org/drawingml/2006/main">
             <a:r>
-              <a:t>Chosen v2 allows any authenticated, currently verified DAO member with current application action access to confirm the exact immutable version, with no named owner or default five-specialist gates. Real sponsor signatures and DAO/Vocdoni governance apply only when required. Mark submitted records a selected immutable packet/date and reporter/evidence level with optional later evidence; no automatic submission or fake prior approvals. V2 is in progress, not merged or deployed; legacy v1 history remains intact.</a:t>
+              <a:t>Chosen v2 allows any authenticated, currently verified DAO member with current application action access to confirm the exact immutable version, with no named owner or default five-specialist gates. Real sponsor signatures and DAO/Vocdoni governance apply only when required. Mark submitted records a selected immutable packet/date and reporter/evidence level with optional later evidence; no automatic submission or fake prior approvals. V2 packet core source is merged in https://github.com/NetRxn/Inertia/pull/56; native/Buzz and real authority integration remain unqualified, with legacy v1 intact.</a:t>
             </a:r>
           </a:p>
           <a:p xmlns:a="http://schemas.openxmlformats.org/drawingml/2006/main">
@@ -3703,12 +3713,12 @@
   </p:cSld>
   <p:clrMap bg1="lt1" tx1="dk1" bg2="lt2" tx2="dk2" accent1="accent1" accent2="accent2" accent3="accent3" accent4="accent4" accent5="accent5" accent6="accent6" hlink="hlink" folHlink="folHlink"/>
   <p:sldLayoutIdLst>
-    <p:sldLayoutId xmlns:r="http://schemas.openxmlformats.org/officeDocument/2006/relationships" id="2147483649" r:id="Rd476c988b5e5496c"/>
-    <p:sldLayoutId xmlns:r="http://schemas.openxmlformats.org/officeDocument/2006/relationships" id="2147483650" r:id="Rd78ffcc91c094ec6"/>
-    <p:sldLayoutId xmlns:r="http://schemas.openxmlformats.org/officeDocument/2006/relationships" id="2147483651" r:id="R3664dc1416554e9e"/>
-    <p:sldLayoutId xmlns:r="http://schemas.openxmlformats.org/officeDocument/2006/relationships" id="2147483652" r:id="R8d7096105c8940d4"/>
-    <p:sldLayoutId xmlns:r="http://schemas.openxmlformats.org/officeDocument/2006/relationships" id="2147483653" r:id="Reba1f9e828a643ee"/>
-    <p:sldLayoutId xmlns:r="http://schemas.openxmlformats.org/officeDocument/2006/relationships" id="2147483654" r:id="Rbb07904ef3264fac"/>
+    <p:sldLayoutId xmlns:r="http://schemas.openxmlformats.org/officeDocument/2006/relationships" id="2147483649" r:id="R09d4872235fe423b"/>
+    <p:sldLayoutId xmlns:r="http://schemas.openxmlformats.org/officeDocument/2006/relationships" id="2147483650" r:id="R6015f1edee6049f5"/>
+    <p:sldLayoutId xmlns:r="http://schemas.openxmlformats.org/officeDocument/2006/relationships" id="2147483651" r:id="R7bf1df3318fc4a28"/>
+    <p:sldLayoutId xmlns:r="http://schemas.openxmlformats.org/officeDocument/2006/relationships" id="2147483652" r:id="R2f1e5d37e994467e"/>
+    <p:sldLayoutId xmlns:r="http://schemas.openxmlformats.org/officeDocument/2006/relationships" id="2147483653" r:id="R15bf2d5226be4f53"/>
+    <p:sldLayoutId xmlns:r="http://schemas.openxmlformats.org/officeDocument/2006/relationships" id="2147483654" r:id="Re9361a5eaac44684"/>
   </p:sldLayoutIdLst>
   <p:txStyles>
     <p:titleStyle>
@@ -4259,7 +4269,7 @@
           <p:cNvPr id="39" name="">
             <a:extLst xmlns:a="http://schemas.openxmlformats.org/drawingml/2006/main">
               <a:ext uri="{FF2B5EF4-FFF2-40B4-BE49-F238E27FC236}">
-                <a16:creationId xmlns:a16="http://schemas.microsoft.com/office/drawing/2014/main" id="{FD09A522-D6C1-4C0C-989A-B3048264B7DF}"/>
+                <a16:creationId xmlns:a16="http://schemas.microsoft.com/office/drawing/2014/main" id="{F6C8DEF8-8C98-417F-AE54-8D051A39DF23}"/>
               </a:ext>
             </a:extLst>
           </p:cNvPr>
@@ -4292,7 +4302,7 @@
           <p:cNvPr id="32" name="">
             <a:extLst xmlns:a="http://schemas.openxmlformats.org/drawingml/2006/main">
               <a:ext uri="{FF2B5EF4-FFF2-40B4-BE49-F238E27FC236}">
-                <a16:creationId xmlns:a16="http://schemas.microsoft.com/office/drawing/2014/main" id="{C4F86691-6C5B-4816-90A8-CA937757EB5B}"/>
+                <a16:creationId xmlns:a16="http://schemas.microsoft.com/office/drawing/2014/main" id="{09A76ACA-4B57-47D3-BC5D-66FF68038961}"/>
               </a:ext>
             </a:extLst>
           </p:cNvPr>
@@ -4324,7 +4334,7 @@
           <p:cNvPr id="29" name="">
             <a:extLst xmlns:a="http://schemas.openxmlformats.org/drawingml/2006/main">
               <a:ext uri="{FF2B5EF4-FFF2-40B4-BE49-F238E27FC236}">
-                <a16:creationId xmlns:a16="http://schemas.microsoft.com/office/drawing/2014/main" id="{BAFFA7BD-A982-4371-9699-34B3E1C268D1}"/>
+                <a16:creationId xmlns:a16="http://schemas.microsoft.com/office/drawing/2014/main" id="{FEE3A29D-3926-44EF-AA03-EE4D5F5EECBC}"/>
               </a:ext>
             </a:extLst>
           </p:cNvPr>
@@ -8097,7 +8107,7 @@
           <p:cNvPr id="30" name="flow-29">
             <a:extLst xmlns:a="http://schemas.openxmlformats.org/drawingml/2006/main">
               <a:ext uri="{FF2B5EF4-FFF2-40B4-BE49-F238E27FC236}">
-                <a16:creationId xmlns:a16="http://schemas.microsoft.com/office/drawing/2014/main" id="{DF7AC9A8-8E77-4D26-B4B3-9118E3F368E1}"/>
+                <a16:creationId xmlns:a16="http://schemas.microsoft.com/office/drawing/2014/main" id="{88B984AA-CF5E-44BD-A311-51B2FD9F90DB}"/>
               </a:ext>
             </a:extLst>
           </p:cNvPr>
@@ -8127,7 +8137,7 @@
           <p:cNvPr id="31" name="flow-30">
             <a:extLst xmlns:a="http://schemas.openxmlformats.org/drawingml/2006/main">
               <a:ext uri="{FF2B5EF4-FFF2-40B4-BE49-F238E27FC236}">
-                <a16:creationId xmlns:a16="http://schemas.microsoft.com/office/drawing/2014/main" id="{89B907E6-1E7B-4DF0-AF34-956407F687D6}"/>
+                <a16:creationId xmlns:a16="http://schemas.microsoft.com/office/drawing/2014/main" id="{328753CE-AE59-41B6-88C8-7FA6BF12759C}"/>
               </a:ext>
             </a:extLst>
           </p:cNvPr>
@@ -8326,7 +8336,7 @@
           <p:cNvPr id="34" name="flow-32">
             <a:extLst xmlns:a="http://schemas.openxmlformats.org/drawingml/2006/main">
               <a:ext uri="{FF2B5EF4-FFF2-40B4-BE49-F238E27FC236}">
-                <a16:creationId xmlns:a16="http://schemas.microsoft.com/office/drawing/2014/main" id="{3C3A702E-E064-4790-A373-D0711F8C5026}"/>
+                <a16:creationId xmlns:a16="http://schemas.microsoft.com/office/drawing/2014/main" id="{9AB9E95B-D7A4-4352-9B6A-005349D8FD92}"/>
               </a:ext>
             </a:extLst>
           </p:cNvPr>
@@ -8355,7 +8365,7 @@
           <p:cNvPr id="35" name="flow-33">
             <a:extLst xmlns:a="http://schemas.openxmlformats.org/drawingml/2006/main">
               <a:ext uri="{FF2B5EF4-FFF2-40B4-BE49-F238E27FC236}">
-                <a16:creationId xmlns:a16="http://schemas.microsoft.com/office/drawing/2014/main" id="{C2CA082E-515E-4913-B043-8DDB1BA5CC7C}"/>
+                <a16:creationId xmlns:a16="http://schemas.microsoft.com/office/drawing/2014/main" id="{2BBEC55F-4026-44BA-8CC2-4C2663B1F308}"/>
               </a:ext>
             </a:extLst>
           </p:cNvPr>
@@ -8383,7 +8393,7 @@
           <p:cNvPr id="36" name="flow-34">
             <a:extLst xmlns:a="http://schemas.openxmlformats.org/drawingml/2006/main">
               <a:ext uri="{FF2B5EF4-FFF2-40B4-BE49-F238E27FC236}">
-                <a16:creationId xmlns:a16="http://schemas.microsoft.com/office/drawing/2014/main" id="{57EDF5AA-27EB-4DA0-9A02-C23A6B412D73}"/>
+                <a16:creationId xmlns:a16="http://schemas.microsoft.com/office/drawing/2014/main" id="{4856F17C-C269-4616-86B5-7B4F3B588E5E}"/>
               </a:ext>
             </a:extLst>
           </p:cNvPr>
@@ -8581,7 +8591,7 @@
           <p:cNvPr id="38" name="flow-36">
             <a:extLst xmlns:a="http://schemas.openxmlformats.org/drawingml/2006/main">
               <a:ext uri="{FF2B5EF4-FFF2-40B4-BE49-F238E27FC236}">
-                <a16:creationId xmlns:a16="http://schemas.microsoft.com/office/drawing/2014/main" id="{1F969358-BD41-4D79-9367-FE53B3DD2A5B}"/>
+                <a16:creationId xmlns:a16="http://schemas.microsoft.com/office/drawing/2014/main" id="{EA91F5E8-40CA-4095-BA56-F2034B4F140C}"/>
               </a:ext>
             </a:extLst>
           </p:cNvPr>
@@ -8809,7 +8819,7 @@
           <p:cNvPr id="35" name="">
             <a:extLst xmlns:a="http://schemas.openxmlformats.org/drawingml/2006/main">
               <a:ext uri="{FF2B5EF4-FFF2-40B4-BE49-F238E27FC236}">
-                <a16:creationId xmlns:a16="http://schemas.microsoft.com/office/drawing/2014/main" id="{01C7B020-3DB7-4F21-B5A2-A745852CB3F3}"/>
+                <a16:creationId xmlns:a16="http://schemas.microsoft.com/office/drawing/2014/main" id="{13CD3235-D918-4830-B4EC-80965E479479}"/>
               </a:ext>
             </a:extLst>
           </p:cNvPr>
@@ -8841,7 +8851,7 @@
           <p:cNvPr id="21" name="">
             <a:extLst xmlns:a="http://schemas.openxmlformats.org/drawingml/2006/main">
               <a:ext uri="{FF2B5EF4-FFF2-40B4-BE49-F238E27FC236}">
-                <a16:creationId xmlns:a16="http://schemas.microsoft.com/office/drawing/2014/main" id="{E4965307-55E4-4480-8C24-C2296F0E2978}"/>
+                <a16:creationId xmlns:a16="http://schemas.microsoft.com/office/drawing/2014/main" id="{AD574D7C-16A2-4A12-9B77-70EB63F90D61}"/>
               </a:ext>
             </a:extLst>
           </p:cNvPr>
@@ -8873,7 +8883,7 @@
           <p:cNvPr id="20" name="">
             <a:extLst xmlns:a="http://schemas.openxmlformats.org/drawingml/2006/main">
               <a:ext uri="{FF2B5EF4-FFF2-40B4-BE49-F238E27FC236}">
-                <a16:creationId xmlns:a16="http://schemas.microsoft.com/office/drawing/2014/main" id="{35A43C7B-10EA-4D14-AC71-F6C0091F1FDB}"/>
+                <a16:creationId xmlns:a16="http://schemas.microsoft.com/office/drawing/2014/main" id="{D5115F0A-C9C2-48DF-9926-915127A59A3E}"/>
               </a:ext>
             </a:extLst>
           </p:cNvPr>
@@ -8905,7 +8915,7 @@
           <p:cNvPr id="19" name="">
             <a:extLst xmlns:a="http://schemas.openxmlformats.org/drawingml/2006/main">
               <a:ext uri="{FF2B5EF4-FFF2-40B4-BE49-F238E27FC236}">
-                <a16:creationId xmlns:a16="http://schemas.microsoft.com/office/drawing/2014/main" id="{DA955B6C-C238-40F3-A375-FF916BCB1931}"/>
+                <a16:creationId xmlns:a16="http://schemas.microsoft.com/office/drawing/2014/main" id="{7581794B-057A-4D4B-9282-62FC0E644395}"/>
               </a:ext>
             </a:extLst>
           </p:cNvPr>
@@ -8937,7 +8947,7 @@
           <p:cNvPr id="18" name="">
             <a:extLst xmlns:a="http://schemas.openxmlformats.org/drawingml/2006/main">
               <a:ext uri="{FF2B5EF4-FFF2-40B4-BE49-F238E27FC236}">
-                <a16:creationId xmlns:a16="http://schemas.microsoft.com/office/drawing/2014/main" id="{38715AE4-B61D-44C3-B623-48B75D1D244C}"/>
+                <a16:creationId xmlns:a16="http://schemas.microsoft.com/office/drawing/2014/main" id="{52410611-4E8C-4DEC-AC97-2F57559779C4}"/>
               </a:ext>
             </a:extLst>
           </p:cNvPr>
@@ -12096,7 +12106,7 @@
           <p:cNvPr id="28" name="flow-61">
             <a:extLst xmlns:a="http://schemas.openxmlformats.org/drawingml/2006/main">
               <a:ext uri="{FF2B5EF4-FFF2-40B4-BE49-F238E27FC236}">
-                <a16:creationId xmlns:a16="http://schemas.microsoft.com/office/drawing/2014/main" id="{247D777B-C72E-42D9-99F3-8D06A1D66221}"/>
+                <a16:creationId xmlns:a16="http://schemas.microsoft.com/office/drawing/2014/main" id="{944DAFBF-3248-4629-A0A4-9A1BF80530BA}"/>
               </a:ext>
             </a:extLst>
           </p:cNvPr>
@@ -12294,7 +12304,7 @@
           <p:cNvPr id="30" name="flow-63">
             <a:extLst xmlns:a="http://schemas.openxmlformats.org/drawingml/2006/main">
               <a:ext uri="{FF2B5EF4-FFF2-40B4-BE49-F238E27FC236}">
-                <a16:creationId xmlns:a16="http://schemas.microsoft.com/office/drawing/2014/main" id="{64DBC626-A94E-4391-822D-CFB76273C927}"/>
+                <a16:creationId xmlns:a16="http://schemas.microsoft.com/office/drawing/2014/main" id="{6DED72C9-6330-4F5C-8FE0-EEF303315B84}"/>
               </a:ext>
             </a:extLst>
           </p:cNvPr>
@@ -12322,7 +12332,7 @@
           <p:cNvPr id="31" name="flow-64">
             <a:extLst xmlns:a="http://schemas.openxmlformats.org/drawingml/2006/main">
               <a:ext uri="{FF2B5EF4-FFF2-40B4-BE49-F238E27FC236}">
-                <a16:creationId xmlns:a16="http://schemas.microsoft.com/office/drawing/2014/main" id="{0510EDAE-4053-41BE-87BA-85A0FE48A8BC}"/>
+                <a16:creationId xmlns:a16="http://schemas.microsoft.com/office/drawing/2014/main" id="{AE533842-3567-42A8-B2BB-D59D467D4065}"/>
               </a:ext>
             </a:extLst>
           </p:cNvPr>
@@ -12350,7 +12360,7 @@
           <p:cNvPr id="32" name="flow-65">
             <a:extLst xmlns:a="http://schemas.openxmlformats.org/drawingml/2006/main">
               <a:ext uri="{FF2B5EF4-FFF2-40B4-BE49-F238E27FC236}">
-                <a16:creationId xmlns:a16="http://schemas.microsoft.com/office/drawing/2014/main" id="{3C93F697-D383-403F-B5BE-FB22AAA503DD}"/>
+                <a16:creationId xmlns:a16="http://schemas.microsoft.com/office/drawing/2014/main" id="{97001629-AF78-4755-83C5-3237938B0278}"/>
               </a:ext>
             </a:extLst>
           </p:cNvPr>
@@ -12378,7 +12388,7 @@
           <p:cNvPr id="33" name="flow-66">
             <a:extLst xmlns:a="http://schemas.openxmlformats.org/drawingml/2006/main">
               <a:ext uri="{FF2B5EF4-FFF2-40B4-BE49-F238E27FC236}">
-                <a16:creationId xmlns:a16="http://schemas.microsoft.com/office/drawing/2014/main" id="{4D72462C-FC87-4C36-B6DF-F3C94E79C4A3}"/>
+                <a16:creationId xmlns:a16="http://schemas.microsoft.com/office/drawing/2014/main" id="{B26AF4DE-7F2D-41DC-B8E6-D6E691671532}"/>
               </a:ext>
             </a:extLst>
           </p:cNvPr>
@@ -12943,7 +12953,7 @@
           <p:cNvPr id="18" name="">
             <a:extLst xmlns:a="http://schemas.openxmlformats.org/drawingml/2006/main">
               <a:ext uri="{FF2B5EF4-FFF2-40B4-BE49-F238E27FC236}">
-                <a16:creationId xmlns:a16="http://schemas.microsoft.com/office/drawing/2014/main" id="{41C5D6B8-94F5-41AF-96F0-8EECF2E7FBCF}"/>
+                <a16:creationId xmlns:a16="http://schemas.microsoft.com/office/drawing/2014/main" id="{C2332155-AD63-44A2-A399-643CE81DB384}"/>
               </a:ext>
             </a:extLst>
           </p:cNvPr>
@@ -15433,7 +15443,7 @@
           <p:cNvPr id="20" name="flow-88">
             <a:extLst xmlns:a="http://schemas.openxmlformats.org/drawingml/2006/main">
               <a:ext uri="{FF2B5EF4-FFF2-40B4-BE49-F238E27FC236}">
-                <a16:creationId xmlns:a16="http://schemas.microsoft.com/office/drawing/2014/main" id="{1B990CD5-B5D7-4775-87C3-31080CA2DD18}"/>
+                <a16:creationId xmlns:a16="http://schemas.microsoft.com/office/drawing/2014/main" id="{0675FF83-10E9-4E15-9F4C-1A46DC56F7C0}"/>
               </a:ext>
             </a:extLst>
           </p:cNvPr>
@@ -15461,7 +15471,7 @@
           <p:cNvPr id="21" name="flow-89">
             <a:extLst xmlns:a="http://schemas.openxmlformats.org/drawingml/2006/main">
               <a:ext uri="{FF2B5EF4-FFF2-40B4-BE49-F238E27FC236}">
-                <a16:creationId xmlns:a16="http://schemas.microsoft.com/office/drawing/2014/main" id="{31E72F1E-0F3A-488F-90C9-7FF1276E0BDD}"/>
+                <a16:creationId xmlns:a16="http://schemas.microsoft.com/office/drawing/2014/main" id="{B9EDF08F-7A86-460E-A6F2-E651A8A752F1}"/>
               </a:ext>
             </a:extLst>
           </p:cNvPr>
@@ -15489,7 +15499,7 @@
           <p:cNvPr id="22" name="flow-90">
             <a:extLst xmlns:a="http://schemas.openxmlformats.org/drawingml/2006/main">
               <a:ext uri="{FF2B5EF4-FFF2-40B4-BE49-F238E27FC236}">
-                <a16:creationId xmlns:a16="http://schemas.microsoft.com/office/drawing/2014/main" id="{5BE9C458-9DFD-412D-BC63-0E2D6C477C0B}"/>
+                <a16:creationId xmlns:a16="http://schemas.microsoft.com/office/drawing/2014/main" id="{EA9A95AF-99BE-4164-A13F-1D801C6AC39C}"/>
               </a:ext>
             </a:extLst>
           </p:cNvPr>
@@ -15711,7 +15721,7 @@
           <p:cNvPr id="24" name="flow-92">
             <a:extLst xmlns:a="http://schemas.openxmlformats.org/drawingml/2006/main">
               <a:ext uri="{FF2B5EF4-FFF2-40B4-BE49-F238E27FC236}">
-                <a16:creationId xmlns:a16="http://schemas.microsoft.com/office/drawing/2014/main" id="{620F9D20-D4E1-4191-8C6D-3B229743EC14}"/>
+                <a16:creationId xmlns:a16="http://schemas.microsoft.com/office/drawing/2014/main" id="{37D90C01-0E90-4F98-9A8E-285FBAAA88C3}"/>
               </a:ext>
             </a:extLst>
           </p:cNvPr>
@@ -15739,7 +15749,7 @@
           <p:cNvPr id="25" name="flow-93">
             <a:extLst xmlns:a="http://schemas.openxmlformats.org/drawingml/2006/main">
               <a:ext uri="{FF2B5EF4-FFF2-40B4-BE49-F238E27FC236}">
-                <a16:creationId xmlns:a16="http://schemas.microsoft.com/office/drawing/2014/main" id="{52F8FFFC-B2BC-4293-82C9-8A106F67C69F}"/>
+                <a16:creationId xmlns:a16="http://schemas.microsoft.com/office/drawing/2014/main" id="{60524EB1-9AAB-49CC-9146-E8D7BCABD3CE}"/>
               </a:ext>
             </a:extLst>
           </p:cNvPr>
@@ -15767,7 +15777,7 @@
           <p:cNvPr id="26" name="flow-94">
             <a:extLst xmlns:a="http://schemas.openxmlformats.org/drawingml/2006/main">
               <a:ext uri="{FF2B5EF4-FFF2-40B4-BE49-F238E27FC236}">
-                <a16:creationId xmlns:a16="http://schemas.microsoft.com/office/drawing/2014/main" id="{67F95BB5-E114-457C-8584-0BEC8BE72014}"/>
+                <a16:creationId xmlns:a16="http://schemas.microsoft.com/office/drawing/2014/main" id="{59448AF5-8417-4086-B051-32CAC12BB397}"/>
               </a:ext>
             </a:extLst>
           </p:cNvPr>
@@ -15989,7 +15999,7 @@
           <p:cNvPr id="28" name="flow-96">
             <a:extLst xmlns:a="http://schemas.openxmlformats.org/drawingml/2006/main">
               <a:ext uri="{FF2B5EF4-FFF2-40B4-BE49-F238E27FC236}">
-                <a16:creationId xmlns:a16="http://schemas.microsoft.com/office/drawing/2014/main" id="{5315DFF0-B27A-4B7E-B96C-E0F589F2B5DE}"/>
+                <a16:creationId xmlns:a16="http://schemas.microsoft.com/office/drawing/2014/main" id="{4273A0B6-C4CE-4CD6-ABE3-6D9D43A1FA76}"/>
               </a:ext>
             </a:extLst>
           </p:cNvPr>
@@ -16017,7 +16027,7 @@
           <p:cNvPr id="29" name="flow-97">
             <a:extLst xmlns:a="http://schemas.openxmlformats.org/drawingml/2006/main">
               <a:ext uri="{FF2B5EF4-FFF2-40B4-BE49-F238E27FC236}">
-                <a16:creationId xmlns:a16="http://schemas.microsoft.com/office/drawing/2014/main" id="{1BFEE72B-81FC-4077-AE11-BA2D4C705639}"/>
+                <a16:creationId xmlns:a16="http://schemas.microsoft.com/office/drawing/2014/main" id="{EC59B536-1741-4BF0-8178-AF8895A3CCAA}"/>
               </a:ext>
             </a:extLst>
           </p:cNvPr>
@@ -16799,7 +16809,7 @@
           <p:cNvPr id="35" name="">
             <a:extLst xmlns:a="http://schemas.openxmlformats.org/drawingml/2006/main">
               <a:ext uri="{FF2B5EF4-FFF2-40B4-BE49-F238E27FC236}">
-                <a16:creationId xmlns:a16="http://schemas.microsoft.com/office/drawing/2014/main" id="{17D6293A-ECD4-400A-B4E7-48908FBCA7BC}"/>
+                <a16:creationId xmlns:a16="http://schemas.microsoft.com/office/drawing/2014/main" id="{AE660065-2521-48A5-BB55-9F993257E672}"/>
               </a:ext>
             </a:extLst>
           </p:cNvPr>
@@ -16831,7 +16841,7 @@
           <p:cNvPr id="34" name="">
             <a:extLst xmlns:a="http://schemas.openxmlformats.org/drawingml/2006/main">
               <a:ext uri="{FF2B5EF4-FFF2-40B4-BE49-F238E27FC236}">
-                <a16:creationId xmlns:a16="http://schemas.microsoft.com/office/drawing/2014/main" id="{5D4D2479-E84C-42E6-93B0-AEB04686F3CF}"/>
+                <a16:creationId xmlns:a16="http://schemas.microsoft.com/office/drawing/2014/main" id="{C05A3AB3-F594-4DB7-A431-BFAA1F2EDFF4}"/>
               </a:ext>
             </a:extLst>
           </p:cNvPr>
@@ -16863,7 +16873,7 @@
           <p:cNvPr id="33" name="">
             <a:extLst xmlns:a="http://schemas.openxmlformats.org/drawingml/2006/main">
               <a:ext uri="{FF2B5EF4-FFF2-40B4-BE49-F238E27FC236}">
-                <a16:creationId xmlns:a16="http://schemas.microsoft.com/office/drawing/2014/main" id="{E2A3C626-B522-49BF-AA16-D0642A388BE7}"/>
+                <a16:creationId xmlns:a16="http://schemas.microsoft.com/office/drawing/2014/main" id="{FAFCE76C-7C93-4061-8398-E67D560CDAB7}"/>
               </a:ext>
             </a:extLst>
           </p:cNvPr>
@@ -16895,7 +16905,7 @@
           <p:cNvPr id="13" name="">
             <a:extLst xmlns:a="http://schemas.openxmlformats.org/drawingml/2006/main">
               <a:ext uri="{FF2B5EF4-FFF2-40B4-BE49-F238E27FC236}">
-                <a16:creationId xmlns:a16="http://schemas.microsoft.com/office/drawing/2014/main" id="{3ACB45BA-735C-4C3F-BC3E-436CF7836B22}"/>
+                <a16:creationId xmlns:a16="http://schemas.microsoft.com/office/drawing/2014/main" id="{6D5B285B-C685-4F85-8EBC-6CE621429724}"/>
               </a:ext>
             </a:extLst>
           </p:cNvPr>
@@ -16927,7 +16937,7 @@
           <p:cNvPr id="12" name="">
             <a:extLst xmlns:a="http://schemas.openxmlformats.org/drawingml/2006/main">
               <a:ext uri="{FF2B5EF4-FFF2-40B4-BE49-F238E27FC236}">
-                <a16:creationId xmlns:a16="http://schemas.microsoft.com/office/drawing/2014/main" id="{EEAA9C3B-7A92-4B1D-A251-52196B99C9B6}"/>
+                <a16:creationId xmlns:a16="http://schemas.microsoft.com/office/drawing/2014/main" id="{AEA3B08F-7EA7-4ED2-A76A-2B2EF0632B15}"/>
               </a:ext>
             </a:extLst>
           </p:cNvPr>
@@ -18506,7 +18516,7 @@
           <p:cNvPr id="14" name="flow-113">
             <a:extLst xmlns:a="http://schemas.openxmlformats.org/drawingml/2006/main">
               <a:ext uri="{FF2B5EF4-FFF2-40B4-BE49-F238E27FC236}">
-                <a16:creationId xmlns:a16="http://schemas.microsoft.com/office/drawing/2014/main" id="{995D6E97-4379-4553-8187-A4CFA16FB52A}"/>
+                <a16:creationId xmlns:a16="http://schemas.microsoft.com/office/drawing/2014/main" id="{A23A146E-4459-4132-A81A-0F55AA0FEDF9}"/>
               </a:ext>
             </a:extLst>
           </p:cNvPr>
@@ -18534,7 +18544,7 @@
           <p:cNvPr id="15" name="flow-114">
             <a:extLst xmlns:a="http://schemas.openxmlformats.org/drawingml/2006/main">
               <a:ext uri="{FF2B5EF4-FFF2-40B4-BE49-F238E27FC236}">
-                <a16:creationId xmlns:a16="http://schemas.microsoft.com/office/drawing/2014/main" id="{5F82A055-C6B6-493E-AC66-559E7264E030}"/>
+                <a16:creationId xmlns:a16="http://schemas.microsoft.com/office/drawing/2014/main" id="{05282601-2835-43D7-96F6-40444A6447C3}"/>
               </a:ext>
             </a:extLst>
           </p:cNvPr>
@@ -18562,7 +18572,7 @@
           <p:cNvPr id="16" name="flow-115">
             <a:extLst xmlns:a="http://schemas.openxmlformats.org/drawingml/2006/main">
               <a:ext uri="{FF2B5EF4-FFF2-40B4-BE49-F238E27FC236}">
-                <a16:creationId xmlns:a16="http://schemas.microsoft.com/office/drawing/2014/main" id="{E16A7C41-81C4-47A9-942F-E40B2CFAE59D}"/>
+                <a16:creationId xmlns:a16="http://schemas.microsoft.com/office/drawing/2014/main" id="{D04D8537-13F6-4BEA-921C-588A990BF4A5}"/>
               </a:ext>
             </a:extLst>
           </p:cNvPr>
@@ -18590,7 +18600,7 @@
           <p:cNvPr id="17" name="flow-116">
             <a:extLst xmlns:a="http://schemas.openxmlformats.org/drawingml/2006/main">
               <a:ext uri="{FF2B5EF4-FFF2-40B4-BE49-F238E27FC236}">
-                <a16:creationId xmlns:a16="http://schemas.microsoft.com/office/drawing/2014/main" id="{CC9D29E6-E00C-47AB-8480-99516DAFB5E9}"/>
+                <a16:creationId xmlns:a16="http://schemas.microsoft.com/office/drawing/2014/main" id="{B0EEBD32-0273-40B2-B654-F68164CC1BB2}"/>
               </a:ext>
             </a:extLst>
           </p:cNvPr>
@@ -20368,7 +20378,7 @@
           <p:cNvPr id="31" name="flow-130">
             <a:extLst xmlns:a="http://schemas.openxmlformats.org/drawingml/2006/main">
               <a:ext uri="{FF2B5EF4-FFF2-40B4-BE49-F238E27FC236}">
-                <a16:creationId xmlns:a16="http://schemas.microsoft.com/office/drawing/2014/main" id="{8510615C-8274-4C74-ACBD-64D05BCB221E}"/>
+                <a16:creationId xmlns:a16="http://schemas.microsoft.com/office/drawing/2014/main" id="{086FBD1A-D57A-400F-B81C-96EF922B688D}"/>
               </a:ext>
             </a:extLst>
           </p:cNvPr>
@@ -21280,7 +21290,7 @@
                 <a:ea typeface="Aptos"/>
                 <a:cs typeface="Aptos"/>
               </a:rPr>
-              <a:t>V2 target, not yet merged</a:t>
+              <a:t>V2 core merged; wiring pending</a:t>
             </a:r>
           </a:p>
         </p:txBody>
@@ -21652,7 +21662,7 @@
           <p:cNvPr id="43" name="partner-flow-1">
             <a:extLst xmlns:a="http://schemas.openxmlformats.org/drawingml/2006/main">
               <a:ext uri="{FF2B5EF4-FFF2-40B4-BE49-F238E27FC236}">
-                <a16:creationId xmlns:a16="http://schemas.microsoft.com/office/drawing/2014/main" id="{F9296DA7-D161-49D8-8AD4-68D740194149}"/>
+                <a16:creationId xmlns:a16="http://schemas.microsoft.com/office/drawing/2014/main" id="{56F2AE85-DB6D-49EC-833D-AC05D4AFED33}"/>
               </a:ext>
             </a:extLst>
           </p:cNvPr>
@@ -21680,7 +21690,7 @@
           <p:cNvPr id="44" name="partner-flow-2">
             <a:extLst xmlns:a="http://schemas.openxmlformats.org/drawingml/2006/main">
               <a:ext uri="{FF2B5EF4-FFF2-40B4-BE49-F238E27FC236}">
-                <a16:creationId xmlns:a16="http://schemas.microsoft.com/office/drawing/2014/main" id="{6BF445A1-58DE-46A6-9DD9-443EA1292732}"/>
+                <a16:creationId xmlns:a16="http://schemas.microsoft.com/office/drawing/2014/main" id="{E74AC5FE-927D-4A84-9F57-8F98A3A77565}"/>
               </a:ext>
             </a:extLst>
           </p:cNvPr>
@@ -21708,7 +21718,7 @@
           <p:cNvPr id="45" name="partner-flow-3">
             <a:extLst xmlns:a="http://schemas.openxmlformats.org/drawingml/2006/main">
               <a:ext uri="{FF2B5EF4-FFF2-40B4-BE49-F238E27FC236}">
-                <a16:creationId xmlns:a16="http://schemas.microsoft.com/office/drawing/2014/main" id="{0D32D050-7168-418B-90C6-75EB06BF9C91}"/>
+                <a16:creationId xmlns:a16="http://schemas.microsoft.com/office/drawing/2014/main" id="{7F5A4803-B0E8-4A3C-9D12-D64CBA62DC92}"/>
               </a:ext>
             </a:extLst>
           </p:cNvPr>
@@ -21736,7 +21746,7 @@
           <p:cNvPr id="46" name="partner-flow-4">
             <a:extLst xmlns:a="http://schemas.openxmlformats.org/drawingml/2006/main">
               <a:ext uri="{FF2B5EF4-FFF2-40B4-BE49-F238E27FC236}">
-                <a16:creationId xmlns:a16="http://schemas.microsoft.com/office/drawing/2014/main" id="{6C99FA25-513C-4AAA-93E9-E389C0766836}"/>
+                <a16:creationId xmlns:a16="http://schemas.microsoft.com/office/drawing/2014/main" id="{2881DDDD-D0C7-4BBE-A883-B0FB7E7BCBAA}"/>
               </a:ext>
             </a:extLst>
           </p:cNvPr>
@@ -21794,7 +21804,7 @@
           <p:cNvPr id="25" name="">
             <a:extLst xmlns:a="http://schemas.openxmlformats.org/drawingml/2006/main">
               <a:ext uri="{FF2B5EF4-FFF2-40B4-BE49-F238E27FC236}">
-                <a16:creationId xmlns:a16="http://schemas.microsoft.com/office/drawing/2014/main" id="{E0282A97-C20F-4147-ADE1-391E58B808DD}"/>
+                <a16:creationId xmlns:a16="http://schemas.microsoft.com/office/drawing/2014/main" id="{66D3E603-504C-475E-A357-C8547DE77376}"/>
               </a:ext>
             </a:extLst>
           </p:cNvPr>
@@ -22502,7 +22512,7 @@
           <p:cNvPr id="5" name="flow-142">
             <a:extLst xmlns:a="http://schemas.openxmlformats.org/drawingml/2006/main">
               <a:ext uri="{FF2B5EF4-FFF2-40B4-BE49-F238E27FC236}">
-                <a16:creationId xmlns:a16="http://schemas.microsoft.com/office/drawing/2014/main" id="{0CB2D2EB-CDA2-4D11-B2AF-98F25C4AD661}"/>
+                <a16:creationId xmlns:a16="http://schemas.microsoft.com/office/drawing/2014/main" id="{4CF5FB71-DE37-45BC-A897-BC8B9EFBECD5}"/>
               </a:ext>
             </a:extLst>
           </p:cNvPr>
@@ -24399,7 +24409,7 @@
                 <a:ea typeface="Aptos"/>
                 <a:cs typeface="Aptos"/>
               </a:rPr>
-              <a:t>V2 in progress, not merged</a:t>
+              <a:t>V2 core merged; wiring pending</a:t>
             </a:r>
           </a:p>
         </p:txBody>
@@ -24409,7 +24419,7 @@
           <p:cNvPr id="21" name="flow-158">
             <a:extLst xmlns:a="http://schemas.openxmlformats.org/drawingml/2006/main">
               <a:ext uri="{FF2B5EF4-FFF2-40B4-BE49-F238E27FC236}">
-                <a16:creationId xmlns:a16="http://schemas.microsoft.com/office/drawing/2014/main" id="{678BEEB4-54EB-4D4C-B080-91BF4BD03E49}"/>
+                <a16:creationId xmlns:a16="http://schemas.microsoft.com/office/drawing/2014/main" id="{E290F44B-1D90-48FD-8974-A8414659C4B7}"/>
               </a:ext>
             </a:extLst>
           </p:cNvPr>
@@ -24977,7 +24987,7 @@
           <p:cNvPr id="27" name="flow-163">
             <a:extLst xmlns:a="http://schemas.openxmlformats.org/drawingml/2006/main">
               <a:ext uri="{FF2B5EF4-FFF2-40B4-BE49-F238E27FC236}">
-                <a16:creationId xmlns:a16="http://schemas.microsoft.com/office/drawing/2014/main" id="{DF118FD8-BD2C-4366-A637-64C13A86CFE3}"/>
+                <a16:creationId xmlns:a16="http://schemas.microsoft.com/office/drawing/2014/main" id="{1F51F7BE-1DB3-48D8-AA8D-C45F20634994}"/>
               </a:ext>
             </a:extLst>
           </p:cNvPr>
@@ -25005,7 +25015,7 @@
           <p:cNvPr id="28" name="flow-164">
             <a:extLst xmlns:a="http://schemas.openxmlformats.org/drawingml/2006/main">
               <a:ext uri="{FF2B5EF4-FFF2-40B4-BE49-F238E27FC236}">
-                <a16:creationId xmlns:a16="http://schemas.microsoft.com/office/drawing/2014/main" id="{CBCAF17A-AC68-49DA-83D3-A8EB3D58495E}"/>
+                <a16:creationId xmlns:a16="http://schemas.microsoft.com/office/drawing/2014/main" id="{8F9E5EC2-7958-4EE8-AB42-2E7E4F7C0DF3}"/>
               </a:ext>
             </a:extLst>
           </p:cNvPr>
@@ -25033,7 +25043,7 @@
           <p:cNvPr id="29" name="flow-165">
             <a:extLst xmlns:a="http://schemas.openxmlformats.org/drawingml/2006/main">
               <a:ext uri="{FF2B5EF4-FFF2-40B4-BE49-F238E27FC236}">
-                <a16:creationId xmlns:a16="http://schemas.microsoft.com/office/drawing/2014/main" id="{5F8FD0E7-BFC8-4D70-82FA-1BD29F1944AD}"/>
+                <a16:creationId xmlns:a16="http://schemas.microsoft.com/office/drawing/2014/main" id="{048D0C5A-0D5F-45E9-AD33-B25C62729B52}"/>
               </a:ext>
             </a:extLst>
           </p:cNvPr>
@@ -25231,7 +25241,7 @@
           <p:cNvPr id="31" name="flow-167">
             <a:extLst xmlns:a="http://schemas.openxmlformats.org/drawingml/2006/main">
               <a:ext uri="{FF2B5EF4-FFF2-40B4-BE49-F238E27FC236}">
-                <a16:creationId xmlns:a16="http://schemas.microsoft.com/office/drawing/2014/main" id="{D079C3F2-9FB0-477C-8108-BD4A669051FB}"/>
+                <a16:creationId xmlns:a16="http://schemas.microsoft.com/office/drawing/2014/main" id="{109DAE1D-49D5-4D17-9F2F-5286CAEEDD59}"/>
               </a:ext>
             </a:extLst>
           </p:cNvPr>
@@ -25429,7 +25439,7 @@
           <p:cNvPr id="33" name="flow-169">
             <a:extLst xmlns:a="http://schemas.openxmlformats.org/drawingml/2006/main">
               <a:ext uri="{FF2B5EF4-FFF2-40B4-BE49-F238E27FC236}">
-                <a16:creationId xmlns:a16="http://schemas.microsoft.com/office/drawing/2014/main" id="{2E82569A-22C6-431F-96AE-342285DFE012}"/>
+                <a16:creationId xmlns:a16="http://schemas.microsoft.com/office/drawing/2014/main" id="{BD16DDBD-B8E9-4483-9767-1632B1A113EC}"/>
               </a:ext>
             </a:extLst>
           </p:cNvPr>
@@ -25651,7 +25661,7 @@
           <p:cNvPr id="35" name="flow-171">
             <a:extLst xmlns:a="http://schemas.openxmlformats.org/drawingml/2006/main">
               <a:ext uri="{FF2B5EF4-FFF2-40B4-BE49-F238E27FC236}">
-                <a16:creationId xmlns:a16="http://schemas.microsoft.com/office/drawing/2014/main" id="{E6CD2851-EB26-49A4-8ECE-A6AB1FAE3C37}"/>
+                <a16:creationId xmlns:a16="http://schemas.microsoft.com/office/drawing/2014/main" id="{ED8F64E4-9AA2-4368-8EC2-7FD36E1AC7FE}"/>
               </a:ext>
             </a:extLst>
           </p:cNvPr>
@@ -25679,7 +25689,7 @@
           <p:cNvPr id="36" name="flow-172">
             <a:extLst xmlns:a="http://schemas.openxmlformats.org/drawingml/2006/main">
               <a:ext uri="{FF2B5EF4-FFF2-40B4-BE49-F238E27FC236}">
-                <a16:creationId xmlns:a16="http://schemas.microsoft.com/office/drawing/2014/main" id="{9293ABBF-8788-4A94-884C-89893EFBD600}"/>
+                <a16:creationId xmlns:a16="http://schemas.microsoft.com/office/drawing/2014/main" id="{8CE47179-A748-4100-89C8-F5AE18604705}"/>
               </a:ext>
             </a:extLst>
           </p:cNvPr>
@@ -25707,7 +25717,7 @@
           <p:cNvPr id="37" name="flow-173">
             <a:extLst xmlns:a="http://schemas.openxmlformats.org/drawingml/2006/main">
               <a:ext uri="{FF2B5EF4-FFF2-40B4-BE49-F238E27FC236}">
-                <a16:creationId xmlns:a16="http://schemas.microsoft.com/office/drawing/2014/main" id="{64BFD37D-E41D-465C-B719-48FC347A78E3}"/>
+                <a16:creationId xmlns:a16="http://schemas.microsoft.com/office/drawing/2014/main" id="{84BF9CD2-7AC5-4DCF-849B-8C07FEF14618}"/>
               </a:ext>
             </a:extLst>
           </p:cNvPr>
@@ -25905,7 +25915,7 @@
           <p:cNvPr id="39" name="flow-175">
             <a:extLst xmlns:a="http://schemas.openxmlformats.org/drawingml/2006/main">
               <a:ext uri="{FF2B5EF4-FFF2-40B4-BE49-F238E27FC236}">
-                <a16:creationId xmlns:a16="http://schemas.microsoft.com/office/drawing/2014/main" id="{23982865-CAA8-41FE-8757-086F3B806541}"/>
+                <a16:creationId xmlns:a16="http://schemas.microsoft.com/office/drawing/2014/main" id="{6BF49D48-2FB0-450F-862A-6A1CADC39174}"/>
               </a:ext>
             </a:extLst>
           </p:cNvPr>
@@ -25933,7 +25943,7 @@
           <p:cNvPr id="40" name="flow-176">
             <a:extLst xmlns:a="http://schemas.openxmlformats.org/drawingml/2006/main">
               <a:ext uri="{FF2B5EF4-FFF2-40B4-BE49-F238E27FC236}">
-                <a16:creationId xmlns:a16="http://schemas.microsoft.com/office/drawing/2014/main" id="{C230491F-4220-428A-B0B9-8B4C9AA3A0CF}"/>
+                <a16:creationId xmlns:a16="http://schemas.microsoft.com/office/drawing/2014/main" id="{B787F93B-95AA-4B36-9A2B-422FF9251A30}"/>
               </a:ext>
             </a:extLst>
           </p:cNvPr>
@@ -25961,7 +25971,7 @@
           <p:cNvPr id="41" name="flow-177">
             <a:extLst xmlns:a="http://schemas.openxmlformats.org/drawingml/2006/main">
               <a:ext uri="{FF2B5EF4-FFF2-40B4-BE49-F238E27FC236}">
-                <a16:creationId xmlns:a16="http://schemas.microsoft.com/office/drawing/2014/main" id="{BFB2C384-206D-4261-8233-CB92EFC245DB}"/>
+                <a16:creationId xmlns:a16="http://schemas.microsoft.com/office/drawing/2014/main" id="{4DCEC9B1-E3DC-4E5A-9A81-7FEF14068C3A}"/>
               </a:ext>
             </a:extLst>
           </p:cNvPr>
@@ -25989,7 +25999,7 @@
           <p:cNvPr id="42" name="flow-178">
             <a:extLst xmlns:a="http://schemas.openxmlformats.org/drawingml/2006/main">
               <a:ext uri="{FF2B5EF4-FFF2-40B4-BE49-F238E27FC236}">
-                <a16:creationId xmlns:a16="http://schemas.microsoft.com/office/drawing/2014/main" id="{3B90B7DB-6D49-4154-BF04-ED8B3EBD8AFB}"/>
+                <a16:creationId xmlns:a16="http://schemas.microsoft.com/office/drawing/2014/main" id="{BDABE26C-2431-4654-8346-68DA42E08E37}"/>
               </a:ext>
             </a:extLst>
           </p:cNvPr>
@@ -27730,7 +27740,7 @@
           <p:cNvPr id="10" name="partner-flow-14">
             <a:extLst xmlns:a="http://schemas.openxmlformats.org/drawingml/2006/main">
               <a:ext uri="{FF2B5EF4-FFF2-40B4-BE49-F238E27FC236}">
-                <a16:creationId xmlns:a16="http://schemas.microsoft.com/office/drawing/2014/main" id="{83978DB6-3E3C-480E-A735-F5CA5AD4E346}"/>
+                <a16:creationId xmlns:a16="http://schemas.microsoft.com/office/drawing/2014/main" id="{DE4C125C-55E4-42FF-8F82-D73F3D8670C1}"/>
               </a:ext>
             </a:extLst>
           </p:cNvPr>
@@ -28372,7 +28382,7 @@
           <p:cNvPr id="15" name="partner-flow-19">
             <a:extLst xmlns:a="http://schemas.openxmlformats.org/drawingml/2006/main">
               <a:ext uri="{FF2B5EF4-FFF2-40B4-BE49-F238E27FC236}">
-                <a16:creationId xmlns:a16="http://schemas.microsoft.com/office/drawing/2014/main" id="{3A0E436B-7717-493C-9D36-32B3CBB18FB3}"/>
+                <a16:creationId xmlns:a16="http://schemas.microsoft.com/office/drawing/2014/main" id="{7AD49FC8-603D-411F-A83A-A2717D315E84}"/>
               </a:ext>
             </a:extLst>
           </p:cNvPr>
@@ -28965,7 +28975,7 @@
           <p:cNvPr id="20" name="partner-flow-24">
             <a:extLst xmlns:a="http://schemas.openxmlformats.org/drawingml/2006/main">
               <a:ext uri="{FF2B5EF4-FFF2-40B4-BE49-F238E27FC236}">
-                <a16:creationId xmlns:a16="http://schemas.microsoft.com/office/drawing/2014/main" id="{73490B8B-AD27-4F78-B05A-C94941FB2441}"/>
+                <a16:creationId xmlns:a16="http://schemas.microsoft.com/office/drawing/2014/main" id="{B8364D9F-08D0-4C7C-B723-01E673ED449E}"/>
               </a:ext>
             </a:extLst>
           </p:cNvPr>
@@ -28993,7 +29003,7 @@
           <p:cNvPr id="21" name="partner-flow-25">
             <a:extLst xmlns:a="http://schemas.openxmlformats.org/drawingml/2006/main">
               <a:ext uri="{FF2B5EF4-FFF2-40B4-BE49-F238E27FC236}">
-                <a16:creationId xmlns:a16="http://schemas.microsoft.com/office/drawing/2014/main" id="{4B0FF8A9-5D9F-46D0-A6E6-320A898AA7E1}"/>
+                <a16:creationId xmlns:a16="http://schemas.microsoft.com/office/drawing/2014/main" id="{F071D189-F9BF-4DA5-9168-98269F5DCE54}"/>
               </a:ext>
             </a:extLst>
           </p:cNvPr>
@@ -29021,7 +29031,7 @@
           <p:cNvPr id="22" name="partner-flow-26">
             <a:extLst xmlns:a="http://schemas.openxmlformats.org/drawingml/2006/main">
               <a:ext uri="{FF2B5EF4-FFF2-40B4-BE49-F238E27FC236}">
-                <a16:creationId xmlns:a16="http://schemas.microsoft.com/office/drawing/2014/main" id="{C95D240F-17CA-4DD9-87AD-EF12673A4A85}"/>
+                <a16:creationId xmlns:a16="http://schemas.microsoft.com/office/drawing/2014/main" id="{932A0575-E41C-45C3-8213-B6082D2C17C0}"/>
               </a:ext>
             </a:extLst>
           </p:cNvPr>
@@ -31817,7 +31827,7 @@
           <p:cNvPr id="16" name="partner-flow-45">
             <a:extLst xmlns:a="http://schemas.openxmlformats.org/drawingml/2006/main">
               <a:ext uri="{FF2B5EF4-FFF2-40B4-BE49-F238E27FC236}">
-                <a16:creationId xmlns:a16="http://schemas.microsoft.com/office/drawing/2014/main" id="{C3D47E89-754E-4DDB-8C34-FB85CFAAD46A}"/>
+                <a16:creationId xmlns:a16="http://schemas.microsoft.com/office/drawing/2014/main" id="{BF0B5158-ABC9-4EB8-9137-DC205F252D5A}"/>
               </a:ext>
             </a:extLst>
           </p:cNvPr>
@@ -31846,7 +31856,7 @@
           <p:cNvPr id="17" name="partner-flow-46">
             <a:extLst xmlns:a="http://schemas.openxmlformats.org/drawingml/2006/main">
               <a:ext uri="{FF2B5EF4-FFF2-40B4-BE49-F238E27FC236}">
-                <a16:creationId xmlns:a16="http://schemas.microsoft.com/office/drawing/2014/main" id="{70AB4BE2-DB80-4A13-86BE-D026BD29C711}"/>
+                <a16:creationId xmlns:a16="http://schemas.microsoft.com/office/drawing/2014/main" id="{1F005D60-A7D1-453C-8232-55B4AA8442F2}"/>
               </a:ext>
             </a:extLst>
           </p:cNvPr>
@@ -31875,7 +31885,7 @@
           <p:cNvPr id="18" name="partner-flow-47">
             <a:extLst xmlns:a="http://schemas.openxmlformats.org/drawingml/2006/main">
               <a:ext uri="{FF2B5EF4-FFF2-40B4-BE49-F238E27FC236}">
-                <a16:creationId xmlns:a16="http://schemas.microsoft.com/office/drawing/2014/main" id="{A2C2F93C-09CC-4434-B28A-18C216133CDA}"/>
+                <a16:creationId xmlns:a16="http://schemas.microsoft.com/office/drawing/2014/main" id="{76D5BFF4-5C3E-441F-AA2B-34D9BE2114FF}"/>
               </a:ext>
             </a:extLst>
           </p:cNvPr>
@@ -31904,7 +31914,7 @@
           <p:cNvPr id="19" name="partner-flow-48">
             <a:extLst xmlns:a="http://schemas.openxmlformats.org/drawingml/2006/main">
               <a:ext uri="{FF2B5EF4-FFF2-40B4-BE49-F238E27FC236}">
-                <a16:creationId xmlns:a16="http://schemas.microsoft.com/office/drawing/2014/main" id="{38CF0282-D450-4438-B5B3-D47CA5B3B0A5}"/>
+                <a16:creationId xmlns:a16="http://schemas.microsoft.com/office/drawing/2014/main" id="{E53C3C57-4859-411F-BA78-44C22FB8C8EC}"/>
               </a:ext>
             </a:extLst>
           </p:cNvPr>
@@ -31932,7 +31942,7 @@
           <p:cNvPr id="20" name="partner-flow-49">
             <a:extLst xmlns:a="http://schemas.openxmlformats.org/drawingml/2006/main">
               <a:ext uri="{FF2B5EF4-FFF2-40B4-BE49-F238E27FC236}">
-                <a16:creationId xmlns:a16="http://schemas.microsoft.com/office/drawing/2014/main" id="{FB92964B-79E7-4E6B-A5EE-698D7DB27665}"/>
+                <a16:creationId xmlns:a16="http://schemas.microsoft.com/office/drawing/2014/main" id="{5C2F8F74-6065-493C-80C4-31BA10419B46}"/>
               </a:ext>
             </a:extLst>
           </p:cNvPr>
@@ -31960,7 +31970,7 @@
           <p:cNvPr id="21" name="partner-flow-50">
             <a:extLst xmlns:a="http://schemas.openxmlformats.org/drawingml/2006/main">
               <a:ext uri="{FF2B5EF4-FFF2-40B4-BE49-F238E27FC236}">
-                <a16:creationId xmlns:a16="http://schemas.microsoft.com/office/drawing/2014/main" id="{04ADB0C7-060D-43E6-AB9D-5D87DC7D0B83}"/>
+                <a16:creationId xmlns:a16="http://schemas.microsoft.com/office/drawing/2014/main" id="{EA390FD5-D4F3-4908-BAEC-58F3AB93CFF3}"/>
               </a:ext>
             </a:extLst>
           </p:cNvPr>
@@ -32158,7 +32168,7 @@
           <p:cNvPr id="23" name="partner-flow-52">
             <a:extLst xmlns:a="http://schemas.openxmlformats.org/drawingml/2006/main">
               <a:ext uri="{FF2B5EF4-FFF2-40B4-BE49-F238E27FC236}">
-                <a16:creationId xmlns:a16="http://schemas.microsoft.com/office/drawing/2014/main" id="{6761BCF8-3F4C-4F44-AA7D-366B9B2E8D00}"/>
+                <a16:creationId xmlns:a16="http://schemas.microsoft.com/office/drawing/2014/main" id="{CF8CFD3E-BA2F-437C-BF82-47F00E90CE76}"/>
               </a:ext>
             </a:extLst>
           </p:cNvPr>
@@ -32186,7 +32196,7 @@
           <p:cNvPr id="24" name="partner-flow-53">
             <a:extLst xmlns:a="http://schemas.openxmlformats.org/drawingml/2006/main">
               <a:ext uri="{FF2B5EF4-FFF2-40B4-BE49-F238E27FC236}">
-                <a16:creationId xmlns:a16="http://schemas.microsoft.com/office/drawing/2014/main" id="{09AD3D06-6C07-4210-9CB4-B5F032101A98}"/>
+                <a16:creationId xmlns:a16="http://schemas.microsoft.com/office/drawing/2014/main" id="{61D9FF73-67BB-4E9C-B70C-2D657C6143C5}"/>
               </a:ext>
             </a:extLst>
           </p:cNvPr>
@@ -32214,7 +32224,7 @@
           <p:cNvPr id="25" name="partner-flow-54">
             <a:extLst xmlns:a="http://schemas.openxmlformats.org/drawingml/2006/main">
               <a:ext uri="{FF2B5EF4-FFF2-40B4-BE49-F238E27FC236}">
-                <a16:creationId xmlns:a16="http://schemas.microsoft.com/office/drawing/2014/main" id="{50FCCC5E-6FE9-42D2-B750-2A164283827F}"/>
+                <a16:creationId xmlns:a16="http://schemas.microsoft.com/office/drawing/2014/main" id="{08F64F45-C65D-4E5A-B576-A44C7B6E30B0}"/>
               </a:ext>
             </a:extLst>
           </p:cNvPr>
@@ -33353,7 +33363,7 @@
           <p:cNvPr id="33" name="changed-assertions-edge-label-leader">
             <a:extLst xmlns:a="http://schemas.openxmlformats.org/drawingml/2006/main">
               <a:ext uri="{FF2B5EF4-FFF2-40B4-BE49-F238E27FC236}">
-                <a16:creationId xmlns:a16="http://schemas.microsoft.com/office/drawing/2014/main" id="{CC11C58D-4A90-4AA8-951E-0F101F82992E}"/>
+                <a16:creationId xmlns:a16="http://schemas.microsoft.com/office/drawing/2014/main" id="{63930AA4-B411-4BE7-8B3B-A9101043AE4B}"/>
               </a:ext>
             </a:extLst>
           </p:cNvPr>
@@ -33748,7 +33758,7 @@
           <p:cNvPr id="5" name="">
             <a:extLst xmlns:a="http://schemas.openxmlformats.org/drawingml/2006/main">
               <a:ext uri="{FF2B5EF4-FFF2-40B4-BE49-F238E27FC236}">
-                <a16:creationId xmlns:a16="http://schemas.microsoft.com/office/drawing/2014/main" id="{8349F4E3-FE72-45FC-AC4E-32A9327F664E}"/>
+                <a16:creationId xmlns:a16="http://schemas.microsoft.com/office/drawing/2014/main" id="{D7C7D9F5-AFF3-4125-AFC4-D0479A1B8CEB}"/>
               </a:ext>
             </a:extLst>
           </p:cNvPr>
@@ -34361,7 +34371,7 @@
                           <a:ea typeface="Aptos"/>
                           <a:cs typeface="Aptos"/>
                         </a:rPr>
-                        <a:t>Exact-version review and submitted record</a:t>
+                        <a:t>Packet-v2 contract/freeze core merged</a:t>
                       </a:r>
                     </a:p>
                   </a:txBody>
@@ -34399,7 +34409,7 @@
                           <a:ea typeface="Aptos"/>
                           <a:cs typeface="Aptos"/>
                         </a:rPr>
-                        <a:t>Implement v2 member confirmation</a:t>
+                        <a:t>Connect native capture and current access</a:t>
                       </a:r>
                     </a:p>
                     <a:p>
@@ -34496,7 +34506,7 @@
                           <a:ea typeface="Aptos"/>
                           <a:cs typeface="Aptos"/>
                         </a:rPr>
-                        <a:t>Authorized query-first reuse and writeback</a:t>
+                        <a:t>Named SQL-tool facade merged</a:t>
                       </a:r>
                     </a:p>
                   </a:txBody>
@@ -34534,7 +34544,7 @@
                           <a:ea typeface="Aptos"/>
                           <a:cs typeface="Aptos"/>
                         </a:rPr>
-                        <a:t>Qualify existing SQL/domain tools</a:t>
+                        <a:t>Qualify real resolver and provider path</a:t>
                       </a:r>
                     </a:p>
                     <a:p>
@@ -36230,7 +36240,7 @@
           <p:cNvPr id="9" name="flow-217">
             <a:extLst xmlns:a="http://schemas.openxmlformats.org/drawingml/2006/main">
               <a:ext uri="{FF2B5EF4-FFF2-40B4-BE49-F238E27FC236}">
-                <a16:creationId xmlns:a16="http://schemas.microsoft.com/office/drawing/2014/main" id="{69B0D55D-B8A5-4875-A95D-F588DC999F37}"/>
+                <a16:creationId xmlns:a16="http://schemas.microsoft.com/office/drawing/2014/main" id="{87CB30DD-4CCF-4580-B6CD-8B7A4F23DE35}"/>
               </a:ext>
             </a:extLst>
           </p:cNvPr>
@@ -36259,7 +36269,7 @@
           <p:cNvPr id="10" name="flow-218">
             <a:extLst xmlns:a="http://schemas.openxmlformats.org/drawingml/2006/main">
               <a:ext uri="{FF2B5EF4-FFF2-40B4-BE49-F238E27FC236}">
-                <a16:creationId xmlns:a16="http://schemas.microsoft.com/office/drawing/2014/main" id="{4F7F7D39-7612-44CA-864E-0BD230F2C3F0}"/>
+                <a16:creationId xmlns:a16="http://schemas.microsoft.com/office/drawing/2014/main" id="{33F0527C-7E8D-4E7D-B7BB-62E7DD49B573}"/>
               </a:ext>
             </a:extLst>
           </p:cNvPr>
@@ -36495,7 +36505,7 @@
                 <a:ea typeface="Aptos"/>
                 <a:cs typeface="Aptos"/>
               </a:rPr>
-              <a:t>Legacy packet core</a:t>
+              <a:t>V1/v2 packet source</a:t>
             </a:r>
           </a:p>
           <a:p xmlns:a="http://schemas.openxmlformats.org/drawingml/2006/main">
@@ -36543,7 +36553,7 @@
                 <a:ea typeface="Aptos"/>
                 <a:cs typeface="Aptos"/>
               </a:rPr>
-              <a:t>SQL evidence foundation</a:t>
+              <a:t>SQL tools and evidence</a:t>
             </a:r>
           </a:p>
           <a:p xmlns:a="http://schemas.openxmlformats.org/drawingml/2006/main">
@@ -37179,7 +37189,7 @@
           <p:cNvPr id="14" name="flow-222">
             <a:extLst xmlns:a="http://schemas.openxmlformats.org/drawingml/2006/main">
               <a:ext uri="{FF2B5EF4-FFF2-40B4-BE49-F238E27FC236}">
-                <a16:creationId xmlns:a16="http://schemas.microsoft.com/office/drawing/2014/main" id="{252311FD-EE71-4CB1-BE9E-6941CC4D412D}"/>
+                <a16:creationId xmlns:a16="http://schemas.microsoft.com/office/drawing/2014/main" id="{384B3AD5-7A71-453C-9CEE-63E991E2FD75}"/>
               </a:ext>
             </a:extLst>
           </p:cNvPr>

</xml_diff>

<commit_message>
docs: sync prioritized roadmap and source qualification artifacts
</commit_message>
<xml_diff>
--- a/Inertia-Architecture.pptx
+++ b/Inertia-Architecture.pptx
@@ -2,21 +2,21 @@
 <file path=ppt/presentation.xml><?xml version="1.0" encoding="utf-8"?>
 <p:presentation xmlns:p="http://schemas.openxmlformats.org/presentationml/2006/main">
   <p:sldMasterIdLst>
-    <p:sldMasterId xmlns:r="http://schemas.openxmlformats.org/officeDocument/2006/relationships" id="2147483648" r:id="Ra1b673d9b34c42e8"/>
+    <p:sldMasterId xmlns:r="http://schemas.openxmlformats.org/officeDocument/2006/relationships" id="2147483648" r:id="Re691d457a91043a0"/>
   </p:sldMasterIdLst>
   <p:notesMasterIdLst>
-    <p:notesMasterId xmlns:r="http://schemas.openxmlformats.org/officeDocument/2006/relationships" r:id="Rf81cefadcc6440ad"/>
+    <p:notesMasterId xmlns:r="http://schemas.openxmlformats.org/officeDocument/2006/relationships" r:id="R6d7917bc560d457c"/>
   </p:notesMasterIdLst>
   <p:sldIdLst>
-    <p:sldId xmlns:r="http://schemas.openxmlformats.org/officeDocument/2006/relationships" id="256" r:id="Rf94bc82259144592"/>
-    <p:sldId xmlns:r="http://schemas.openxmlformats.org/officeDocument/2006/relationships" id="257" r:id="R2d4cab23c58144c1"/>
-    <p:sldId xmlns:r="http://schemas.openxmlformats.org/officeDocument/2006/relationships" id="258" r:id="R875bcf3150f840ce"/>
-    <p:sldId xmlns:r="http://schemas.openxmlformats.org/officeDocument/2006/relationships" id="259" r:id="R13c9e85416f54c47"/>
-    <p:sldId xmlns:r="http://schemas.openxmlformats.org/officeDocument/2006/relationships" id="260" r:id="R077f40ab50434fce"/>
-    <p:sldId xmlns:r="http://schemas.openxmlformats.org/officeDocument/2006/relationships" id="261" r:id="R7693e4ab2f3b46c8"/>
-    <p:sldId xmlns:r="http://schemas.openxmlformats.org/officeDocument/2006/relationships" id="262" r:id="Rf3803cc0b6fd4648"/>
-    <p:sldId xmlns:r="http://schemas.openxmlformats.org/officeDocument/2006/relationships" id="263" r:id="R44b4aa6372a24a9d"/>
-    <p:sldId xmlns:r="http://schemas.openxmlformats.org/officeDocument/2006/relationships" id="264" r:id="Rf4b8a1f8d5f34b19"/>
+    <p:sldId xmlns:r="http://schemas.openxmlformats.org/officeDocument/2006/relationships" id="256" r:id="R0fedb4e012c341c2"/>
+    <p:sldId xmlns:r="http://schemas.openxmlformats.org/officeDocument/2006/relationships" id="257" r:id="R6a3a954ac17c488b"/>
+    <p:sldId xmlns:r="http://schemas.openxmlformats.org/officeDocument/2006/relationships" id="258" r:id="R172aafb786e7425f"/>
+    <p:sldId xmlns:r="http://schemas.openxmlformats.org/officeDocument/2006/relationships" id="259" r:id="Ra964bf0368a248da"/>
+    <p:sldId xmlns:r="http://schemas.openxmlformats.org/officeDocument/2006/relationships" id="260" r:id="R5bbb8aebe3a84b9c"/>
+    <p:sldId xmlns:r="http://schemas.openxmlformats.org/officeDocument/2006/relationships" id="261" r:id="Rf1a6a06db2da42fe"/>
+    <p:sldId xmlns:r="http://schemas.openxmlformats.org/officeDocument/2006/relationships" id="262" r:id="Rfc786949916b408b"/>
+    <p:sldId xmlns:r="http://schemas.openxmlformats.org/officeDocument/2006/relationships" id="263" r:id="R9d40d8509a514db6"/>
+    <p:sldId xmlns:r="http://schemas.openxmlformats.org/officeDocument/2006/relationships" id="264" r:id="Rd6a4bc2316e74b5f"/>
   </p:sldIdLst>
   <p:sldSz cx="15240000" cy="8572500"/>
   <p:notesSz cx="6858000" cy="9144000"/>
@@ -450,7 +450,7 @@
           <a:lstStyle xmlns:a="http://schemas.openxmlformats.org/drawingml/2006/main"/>
           <a:p xmlns:a="http://schemas.openxmlformats.org/drawingml/2006/main">
             <a:r>
-              <a:t>Sources: spec.md, decisions.md and plan.md. Current public source: https://github.com/NetRxn/Inertia/pull/56, retaining PR53 host qualification.</a:t>
+              <a:t>Sources: spec.md, decisions.md and plan.md. Current source: native exact-action capture https://github.com/NetRxn/Inertia/pull/58; Packet UI reviewed draft https://github.com/NetRxn/Inertia/pull/62. PR53 host qualification remains historical.</a:t>
             </a:r>
           </a:p>
           <a:p xmlns:a="http://schemas.openxmlformats.org/drawingml/2006/main">
@@ -470,7 +470,27 @@
           </a:p>
           <a:p xmlns:a="http://schemas.openxmlformats.org/drawingml/2006/main">
             <a:r>
-              <a:t>This chosen target is not a deployed-integration claim. PR53 source-qualified default-disabled host assembly, early SDK pre-buffer byte/deadline checks, manual invocation and native state-delete reset. Actual data/source/action bindings, source-row allocation, remaining deployment/latency compatibility, approved lifecycle/authentication/network integration, writer fencing and live walkthrough remain gates. Packet-v2 contract/freeze core source is merged. Native capture is the current bounded #40 task; UI/signed-human Buzz, real current-authority resolver/transport and provider execution remain unqualified. Legacy v1 records remain intact.</a:t>
+              <a:t>This chosen target is not a deployed-integration claim. PR53 source-qualified default-disabled host assembly, early SDK pre-buffer byte/deadline checks, manual invocation and native state-delete reset. Actual data/source/action bindings, bounded receipt-read allocation, remaining deployment/latency compatibility, approved lifecycle/authentication/network integration, writer fencing and live walkthrough remain gates. Packet-v2 contract/freeze core source is merged. Native capture source is merged with synthetic callbacks and absent authority/retention disabled. Packet UI/attestation is reviewed draft PR62, not merged/live. Browser walkthrough, mutual #48 recovery agreement and real authority/runtime/domain/Buzz remain pending. Legacy v1 records remain intact.</a:t>
+            </a:r>
+          </a:p>
+          <a:p xmlns:a="http://schemas.openxmlformats.org/drawingml/2006/main">
+            <a:r>
+              <a:t/>
+            </a:r>
+          </a:p>
+          <a:p xmlns:a="http://schemas.openxmlformats.org/drawingml/2006/main">
+            <a:r>
+              <a:t>The remaining #42 read-only assessment proposes early SQL filtering and bounded receipt projection, retaining pending identity. No generic activity acceptance-forgery path was established; no implementation or approved new page interface is claimed. https://github.com/NetRxn/Inertia/issues/42#issuecomment-6389560049</a:t>
+            </a:r>
+          </a:p>
+          <a:p xmlns:a="http://schemas.openxmlformats.org/drawingml/2006/main">
+            <a:r>
+              <a:t/>
+            </a:r>
+          </a:p>
+          <a:p xmlns:a="http://schemas.openxmlformats.org/drawingml/2006/main">
+            <a:r>
+              <a:t>Current execution clarification: provider/role assignments are configurable. Two-provider funding and general member/bounty scenarios test existing requirements. Reuse Paperclip native coordination, checkout and budgets; no new dispatcher or framework. See spec.md section 2 and testing.md, Two-provider scenarios for existing requirements.</a:t>
             </a:r>
           </a:p>
         </p:txBody>
@@ -560,7 +580,17 @@
           </a:p>
           <a:p xmlns:a="http://schemas.openxmlformats.org/drawingml/2006/main">
             <a:r>
-              <a:t>Any authenticated, currently verified DAO member with current application action access may confirm the exact immutable version under the chosen v2 policy. No named application owner or default five specialist human gates. V2 packet primitives are merged; native/Buzz and real authority integration remain unqualified. Source: https://github.com/NetRxn/Inertia/pull/56. Real sponsor signatures or DAO/Vocdoni governance apply only when genuinely required. Preserve exact versions, source scope, replay/conflict denial and current access checks. Reference packets and answer keys are separate from actual generated output.</a:t>
+              <a:t>Any authenticated, currently verified DAO member with current application action access may confirm the exact immutable version under the chosen v2 policy. No named application owner or default five specialist human gates. Packet-v2 core and native exact-action capture are merged in PR56/PR58. Packet UI is reviewed draft PR62, not merged/live; browser, mutual recovery agreement and real authority/runtime/domain/Buzz remain pending. Real sponsor signatures or DAO/Vocdoni governance apply only when genuinely required. Preserve exact versions, source scope, replay/conflict denial and current access checks. Reference packets and answer keys are separate from actual generated output.</a:t>
+            </a:r>
+          </a:p>
+          <a:p xmlns:a="http://schemas.openxmlformats.org/drawingml/2006/main">
+            <a:r>
+              <a:t/>
+            </a:r>
+          </a:p>
+          <a:p xmlns:a="http://schemas.openxmlformats.org/drawingml/2006/main">
+            <a:r>
+              <a:t>Native coordination already covers decomposition, role/capability-based acquisition, exclusive checkout, budgets, review and follow-up. Test complementary research, partner-discovery, assembly and review roles rather than fixing Codex as writer and Claude as checker. Two agents owned by John are not two independent human members.</a:t>
             </a:r>
           </a:p>
         </p:txBody>
@@ -730,7 +760,7 @@
           </a:p>
           <a:p xmlns:a="http://schemas.openxmlformats.org/drawingml/2006/main">
             <a:r>
-              <a:t>The v2 packet contract/freeze core is merged in https://github.com/NetRxn/Inertia/pull/56. The native/Buzz member-action path and real authority binding remain unqualified; this diagram is not a deployment claim. Agents prepare and independently critique; they never supply human approval. Any authenticated, currently verified DAO member with current application review access may confirm the exact immutable packet/version/artifact bytes. There is no named application owner or default five-specialist human ceremony. Actual sponsor signatures and DAO/Vocdoni governance apply only when the real case requires them.</a:t>
+              <a:t>V2 core and native exact-action capture are merged in https://github.com/NetRxn/Inertia/pull/56 and https://github.com/NetRxn/Inertia/pull/58. Packet UI/attestation is reviewed draft https://github.com/NetRxn/Inertia/pull/62, not merged/live. Browser, mutual #48 recovery agreement and real authority/runtime/domain/Buzz remain pending; this diagram is not a deployment claim. Agents prepare and independently critique; they never supply human approval. Any authenticated, currently verified DAO member with current application review access may confirm the exact immutable packet/version/artifact bytes. There is no named application owner or default five-specialist human ceremony. Actual sponsor signatures and DAO/Vocdoni governance apply only when the real case requires them.</a:t>
             </a:r>
           </a:p>
           <a:p xmlns:a="http://schemas.openxmlformats.org/drawingml/2006/main">
@@ -840,7 +870,7 @@
           </a:p>
           <a:p xmlns:a="http://schemas.openxmlformats.org/drawingml/2006/main">
             <a:r>
-              <a:t>V2 packet primitives are merged in https://github.com/NetRxn/Inertia/pull/56. Native capture is being implemented; real authorization, UI/signed-human Buzz and actual provider/human execution remain pending. Preserve original authenticated actor, exact packet/version/policy, current action rights, stale/conflict denial and authoritative readback. No named application owner or default five-specialist setup is needed.</a:t>
+              <a:t>V2 packet primitives are merged in https://github.com/NetRxn/Inertia/pull/56. Native exact-action capture is merged in PR58. Packet UI/attestation is reviewed draft PR62, not merged/live; browser, real authorization/runtime/domain/Buzz and actual provider/human execution remain pending. Preserve original authenticated actor, exact packet/version/policy, current action rights, stale/conflict denial and authoritative readback. No named application owner or default five-specialist setup is needed.</a:t>
             </a:r>
           </a:p>
           <a:p xmlns:a="http://schemas.openxmlformats.org/drawingml/2006/main">
@@ -851,6 +881,26 @@
           <a:p xmlns:a="http://schemas.openxmlformats.org/drawingml/2006/main">
             <a:r>
               <a:t>This path does not qualify full untrusted member-owned runtime isolation. PR37 only stages inert candidates; PR51 is draft/unmerged/inactive ingress/per-attempt authority. Full untrusted isolation, enrollment/provider execution and native authoritative completion remain separate unqualified work. No candidate receipt alone means completed work.</a:t>
+            </a:r>
+          </a:p>
+          <a:p xmlns:a="http://schemas.openxmlformats.org/drawingml/2006/main">
+            <a:r>
+              <a:t/>
+            </a:r>
+          </a:p>
+          <a:p xmlns:a="http://schemas.openxmlformats.org/drawingml/2006/main">
+            <a:r>
+              <a:t>The simpler same-pending-ID re-entry is a PR62 candidate awaiting mutual #48 agreement, not an adopted shared workflow. No retirement endpoint, new store or payload persistence was added.</a:t>
+            </a:r>
+          </a:p>
+          <a:p xmlns:a="http://schemas.openxmlformats.org/drawingml/2006/main">
+            <a:r>
+              <a:t/>
+            </a:r>
+          </a:p>
+          <a:p xmlns:a="http://schemas.openxmlformats.org/drawingml/2006/main">
+            <a:r>
+              <a:t>Two-provider test preparation maps funding to existing R-F01–04/R-F06–08, R-K01–08, R-C01–05 and R-O01; general member/bounty objectives map to R-I01–04, R-C01–05 and R-O01. Use existing T-K05/T-K10/T-K12 and T-C01–04. Separate workspace/history and configurable roles; no model run or successful native coordination is claimed. The owning-service member-domain adapter and Inertia result readback are merged, not activated. Full-checkout and public-package checks passed within source scope. Native event delivery, current-member authority and transport integration remain pending; no operational end-to-end or live completion is claimed. Public source: https://github.com/NetRxn/Inertia/pull/63.</a:t>
             </a:r>
           </a:p>
         </p:txBody>
@@ -1160,7 +1210,27 @@
           </a:p>
           <a:p xmlns:a="http://schemas.openxmlformats.org/drawingml/2006/main">
             <a:r>
-              <a:t>Engineering owns the remaining native/Buzz member-action and submitted-record wiring, actual system-generated research/draft/critique, SQL writeback/reuse, runbook/video and measurements. Packet-v2 core source is merged in https://github.com/NetRxn/Inertia/pull/56. Named owning-domain SQL tools have merged source/local PostgreSQL facade qualification. Real resolver/transport/provider execution and end-to-end member action remain unqualified. Team contacts are operational contacts, not named application approval owners. No new permissions, deployment, deletion, account or external submission is performed.</a:t>
+              <a:t>Engineering owns the remaining native/Buzz member-action and submitted-record wiring, actual system-generated research/draft/critique, SQL writeback/reuse, runbook/video and measurements. Packet-v2 core and native capture source are merged in PR56/PR58; Packet UI/attestation is reviewed draft https://github.com/NetRxn/Inertia/pull/62, not merged/live. Named owning-domain SQL tools have merged source/local PostgreSQL facade qualification. Real resolver/transport/provider execution and end-to-end member action remain unqualified. Team contacts are operational contacts, not named application approval owners. No new permissions, deployment, deletion, account or external submission is performed.</a:t>
+            </a:r>
+          </a:p>
+          <a:p xmlns:a="http://schemas.openxmlformats.org/drawingml/2006/main">
+            <a:r>
+              <a:t/>
+            </a:r>
+          </a:p>
+          <a:p xmlns:a="http://schemas.openxmlformats.org/drawingml/2006/main">
+            <a:r>
+              <a:t>PR59 is noncanonical discussion only. Contributor-owned PR60 passed scoped rereview but awaits their readiness/nonblocking-note choice. PR61 awaits its clarification and R-02 recovery alignment. Shared workflow adoption requires mutual agreement; contributor proposal/validator/rehearsal files are untouched. Follow #40 for live coordination.</a:t>
+            </a:r>
+          </a:p>
+          <a:p xmlns:a="http://schemas.openxmlformats.org/drawingml/2006/main">
+            <a:r>
+              <a:t/>
+            </a:r>
+          </a:p>
+          <a:p xmlns:a="http://schemas.openxmlformats.org/drawingml/2006/main">
+            <a:r>
+              <a:t>Reuse existing references; this is an interface map, not a new owner/dependency/handoff register. John plans shared runtime deployment before Wednesday. Laptop Docker is sufficient for local development with his own credentials. The cloud CLI failed at read-only Codex-home writes before authentication/model execution, not for a demonstrated API-key requirement. New sign-in requires exact approval.</a:t>
             </a:r>
           </a:p>
         </p:txBody>
@@ -1250,7 +1320,7 @@
           </a:p>
           <a:p xmlns:a="http://schemas.openxmlformats.org/drawingml/2006/main">
             <a:r>
-              <a:t>Chosen v2 allows any authenticated, currently verified DAO member with current application action access to confirm the exact immutable version, with no named owner or default five-specialist gates. Real sponsor signatures and DAO/Vocdoni governance apply only when required. Mark submitted records a selected immutable packet/date and reporter/evidence level with optional later evidence; no automatic submission or fake prior approvals. V2 packet core source is merged in https://github.com/NetRxn/Inertia/pull/56; native/Buzz and real authority integration remain unqualified, with legacy v1 intact.</a:t>
+              <a:t>Chosen v2 allows any authenticated, currently verified DAO member with current application action access to confirm the exact immutable version, with no named owner or default five-specialist gates. Real sponsor signatures and DAO/Vocdoni governance apply only when required. Mark submitted records a selected immutable packet/date and reporter/evidence level with optional later evidence; no automatic submission or fake prior approvals. V2 core and native capture are merged in PR56/PR58. Packet UI/attestation is reviewed draft https://github.com/NetRxn/Inertia/pull/62, not merged/live. Browser, mutual #48 recovery and real authority/runtime/domain/Buzz remain unqualified, with legacy v1 intact.</a:t>
             </a:r>
           </a:p>
           <a:p xmlns:a="http://schemas.openxmlformats.org/drawingml/2006/main">
@@ -1271,6 +1341,26 @@
           <a:p xmlns:a="http://schemas.openxmlformats.org/drawingml/2006/main">
             <a:r>
               <a:t>Friday event deadline is October 30, 11:00am CDT (16:00 UTC). Actual roster/talent/attendance/check-in, public tested source/video and administrator verification remain operational entry inputs. The five equal-20 judging axes are checked-in defaults, not verified live weights. No entry/account/outreach action is performed. PR53 source qualification stays default-disabled; actual source/ACL/tool/lifecycle/deployment/writer and human walkthrough gates remain explicit.</a:t>
+            </a:r>
+          </a:p>
+          <a:p xmlns:a="http://schemas.openxmlformats.org/drawingml/2006/main">
+            <a:r>
+              <a:t/>
+            </a:r>
+          </a:p>
+          <a:p xmlns:a="http://schemas.openxmlformats.org/drawingml/2006/main">
+            <a:r>
+              <a:t>PR62 source checks and an isolated full package check passed after earlier fixture timeout/relation collision and dependency-install failures. Those attempts remain evidence; their causes are not established. No actual browser walkthrough is claimed. PR59 is discussion-only; PR60/61 shared recovery/readiness remains subject to mutual alignment.</a:t>
+            </a:r>
+          </a:p>
+          <a:p xmlns:a="http://schemas.openxmlformats.org/drawingml/2006/main">
+            <a:r>
+              <a:t/>
+            </a:r>
+          </a:p>
+          <a:p xmlns:a="http://schemas.openxmlformats.org/drawingml/2006/main">
+            <a:r>
+              <a:t>Recommended Pareto ordering, not a verbatim user-authored ranking: generated funding research/draft; PostgreSQL read/admit/reuse; member review to durable outcome; autonomous meeting/bounty collaboration; meeting cleanup/publication/readback; measured rehearsal. Helix, Y2 and extra UI polish are deferred. The first two proposals are with John; hold a new external work split until his review is clear. See plan.md for the concise task list. No new requirements, contributor assignments or publication are implied.</a:t>
             </a:r>
           </a:p>
         </p:txBody>
@@ -3713,12 +3803,12 @@
   </p:cSld>
   <p:clrMap bg1="lt1" tx1="dk1" bg2="lt2" tx2="dk2" accent1="accent1" accent2="accent2" accent3="accent3" accent4="accent4" accent5="accent5" accent6="accent6" hlink="hlink" folHlink="folHlink"/>
   <p:sldLayoutIdLst>
-    <p:sldLayoutId xmlns:r="http://schemas.openxmlformats.org/officeDocument/2006/relationships" id="2147483649" r:id="R09d4872235fe423b"/>
-    <p:sldLayoutId xmlns:r="http://schemas.openxmlformats.org/officeDocument/2006/relationships" id="2147483650" r:id="R6015f1edee6049f5"/>
-    <p:sldLayoutId xmlns:r="http://schemas.openxmlformats.org/officeDocument/2006/relationships" id="2147483651" r:id="R7bf1df3318fc4a28"/>
-    <p:sldLayoutId xmlns:r="http://schemas.openxmlformats.org/officeDocument/2006/relationships" id="2147483652" r:id="R2f1e5d37e994467e"/>
-    <p:sldLayoutId xmlns:r="http://schemas.openxmlformats.org/officeDocument/2006/relationships" id="2147483653" r:id="R15bf2d5226be4f53"/>
-    <p:sldLayoutId xmlns:r="http://schemas.openxmlformats.org/officeDocument/2006/relationships" id="2147483654" r:id="Re9361a5eaac44684"/>
+    <p:sldLayoutId xmlns:r="http://schemas.openxmlformats.org/officeDocument/2006/relationships" id="2147483649" r:id="Rd8f74dfe61a848ad"/>
+    <p:sldLayoutId xmlns:r="http://schemas.openxmlformats.org/officeDocument/2006/relationships" id="2147483650" r:id="R15eb50a0fa5b4fb7"/>
+    <p:sldLayoutId xmlns:r="http://schemas.openxmlformats.org/officeDocument/2006/relationships" id="2147483651" r:id="Rd8bb0ea592f6453c"/>
+    <p:sldLayoutId xmlns:r="http://schemas.openxmlformats.org/officeDocument/2006/relationships" id="2147483652" r:id="R3def14decf4746a1"/>
+    <p:sldLayoutId xmlns:r="http://schemas.openxmlformats.org/officeDocument/2006/relationships" id="2147483653" r:id="R75e4ebea60df49f8"/>
+    <p:sldLayoutId xmlns:r="http://schemas.openxmlformats.org/officeDocument/2006/relationships" id="2147483654" r:id="Rf692c337f562415a"/>
   </p:sldLayoutIdLst>
   <p:txStyles>
     <p:titleStyle>
@@ -4269,7 +4359,7 @@
           <p:cNvPr id="39" name="">
             <a:extLst xmlns:a="http://schemas.openxmlformats.org/drawingml/2006/main">
               <a:ext uri="{FF2B5EF4-FFF2-40B4-BE49-F238E27FC236}">
-                <a16:creationId xmlns:a16="http://schemas.microsoft.com/office/drawing/2014/main" id="{F6C8DEF8-8C98-417F-AE54-8D051A39DF23}"/>
+                <a16:creationId xmlns:a16="http://schemas.microsoft.com/office/drawing/2014/main" id="{7FA8B869-90AB-49D3-8F0F-245C0D14BB0E}"/>
               </a:ext>
             </a:extLst>
           </p:cNvPr>
@@ -4302,7 +4392,7 @@
           <p:cNvPr id="32" name="">
             <a:extLst xmlns:a="http://schemas.openxmlformats.org/drawingml/2006/main">
               <a:ext uri="{FF2B5EF4-FFF2-40B4-BE49-F238E27FC236}">
-                <a16:creationId xmlns:a16="http://schemas.microsoft.com/office/drawing/2014/main" id="{09A76ACA-4B57-47D3-BC5D-66FF68038961}"/>
+                <a16:creationId xmlns:a16="http://schemas.microsoft.com/office/drawing/2014/main" id="{21A8C252-84F4-4DF4-92C5-F75301C0CFA6}"/>
               </a:ext>
             </a:extLst>
           </p:cNvPr>
@@ -4334,7 +4424,7 @@
           <p:cNvPr id="29" name="">
             <a:extLst xmlns:a="http://schemas.openxmlformats.org/drawingml/2006/main">
               <a:ext uri="{FF2B5EF4-FFF2-40B4-BE49-F238E27FC236}">
-                <a16:creationId xmlns:a16="http://schemas.microsoft.com/office/drawing/2014/main" id="{FEE3A29D-3926-44EF-AA03-EE4D5F5EECBC}"/>
+                <a16:creationId xmlns:a16="http://schemas.microsoft.com/office/drawing/2014/main" id="{F56FFB93-9D8C-4B5E-9887-7564F0A420AF}"/>
               </a:ext>
             </a:extLst>
           </p:cNvPr>
@@ -7162,7 +7252,7 @@
                 <a:ea typeface="Aptos"/>
                 <a:cs typeface="Aptos"/>
               </a:rPr>
-              <a:t>Authorized agent</a:t>
+              <a:t>Authorized agents</a:t>
             </a:r>
           </a:p>
         </p:txBody>
@@ -7331,7 +7421,7 @@
                 <a:ea typeface="Aptos"/>
                 <a:cs typeface="Aptos"/>
               </a:rPr>
-              <a:t>Existing Buzz agent</a:t>
+              <a:t>Providers and scoped roles</a:t>
             </a:r>
           </a:p>
         </p:txBody>
@@ -8107,7 +8197,7 @@
           <p:cNvPr id="30" name="flow-29">
             <a:extLst xmlns:a="http://schemas.openxmlformats.org/drawingml/2006/main">
               <a:ext uri="{FF2B5EF4-FFF2-40B4-BE49-F238E27FC236}">
-                <a16:creationId xmlns:a16="http://schemas.microsoft.com/office/drawing/2014/main" id="{88B984AA-CF5E-44BD-A311-51B2FD9F90DB}"/>
+                <a16:creationId xmlns:a16="http://schemas.microsoft.com/office/drawing/2014/main" id="{DB00AF9F-B684-4FBF-9CDB-E98EB3F66599}"/>
               </a:ext>
             </a:extLst>
           </p:cNvPr>
@@ -8137,7 +8227,7 @@
           <p:cNvPr id="31" name="flow-30">
             <a:extLst xmlns:a="http://schemas.openxmlformats.org/drawingml/2006/main">
               <a:ext uri="{FF2B5EF4-FFF2-40B4-BE49-F238E27FC236}">
-                <a16:creationId xmlns:a16="http://schemas.microsoft.com/office/drawing/2014/main" id="{328753CE-AE59-41B6-88C8-7FA6BF12759C}"/>
+                <a16:creationId xmlns:a16="http://schemas.microsoft.com/office/drawing/2014/main" id="{409058CF-2392-4715-8993-61A274F9A1B9}"/>
               </a:ext>
             </a:extLst>
           </p:cNvPr>
@@ -8336,7 +8426,7 @@
           <p:cNvPr id="34" name="flow-32">
             <a:extLst xmlns:a="http://schemas.openxmlformats.org/drawingml/2006/main">
               <a:ext uri="{FF2B5EF4-FFF2-40B4-BE49-F238E27FC236}">
-                <a16:creationId xmlns:a16="http://schemas.microsoft.com/office/drawing/2014/main" id="{9AB9E95B-D7A4-4352-9B6A-005349D8FD92}"/>
+                <a16:creationId xmlns:a16="http://schemas.microsoft.com/office/drawing/2014/main" id="{058DE65F-BB4D-495A-94BE-D7E82E5BC08A}"/>
               </a:ext>
             </a:extLst>
           </p:cNvPr>
@@ -8365,7 +8455,7 @@
           <p:cNvPr id="35" name="flow-33">
             <a:extLst xmlns:a="http://schemas.openxmlformats.org/drawingml/2006/main">
               <a:ext uri="{FF2B5EF4-FFF2-40B4-BE49-F238E27FC236}">
-                <a16:creationId xmlns:a16="http://schemas.microsoft.com/office/drawing/2014/main" id="{2BBEC55F-4026-44BA-8CC2-4C2663B1F308}"/>
+                <a16:creationId xmlns:a16="http://schemas.microsoft.com/office/drawing/2014/main" id="{F79640FF-2CDC-425F-A9A5-ECFF42FE82F9}"/>
               </a:ext>
             </a:extLst>
           </p:cNvPr>
@@ -8393,7 +8483,7 @@
           <p:cNvPr id="36" name="flow-34">
             <a:extLst xmlns:a="http://schemas.openxmlformats.org/drawingml/2006/main">
               <a:ext uri="{FF2B5EF4-FFF2-40B4-BE49-F238E27FC236}">
-                <a16:creationId xmlns:a16="http://schemas.microsoft.com/office/drawing/2014/main" id="{4856F17C-C269-4616-86B5-7B4F3B588E5E}"/>
+                <a16:creationId xmlns:a16="http://schemas.microsoft.com/office/drawing/2014/main" id="{B1CCE3CA-7FE8-4758-99EA-7DC5E3155868}"/>
               </a:ext>
             </a:extLst>
           </p:cNvPr>
@@ -8591,7 +8681,7 @@
           <p:cNvPr id="38" name="flow-36">
             <a:extLst xmlns:a="http://schemas.openxmlformats.org/drawingml/2006/main">
               <a:ext uri="{FF2B5EF4-FFF2-40B4-BE49-F238E27FC236}">
-                <a16:creationId xmlns:a16="http://schemas.microsoft.com/office/drawing/2014/main" id="{EA91F5E8-40CA-4095-BA56-F2034B4F140C}"/>
+                <a16:creationId xmlns:a16="http://schemas.microsoft.com/office/drawing/2014/main" id="{7715CF72-E735-4E2A-A356-072D5951FEAA}"/>
               </a:ext>
             </a:extLst>
           </p:cNvPr>
@@ -8819,7 +8909,7 @@
           <p:cNvPr id="35" name="">
             <a:extLst xmlns:a="http://schemas.openxmlformats.org/drawingml/2006/main">
               <a:ext uri="{FF2B5EF4-FFF2-40B4-BE49-F238E27FC236}">
-                <a16:creationId xmlns:a16="http://schemas.microsoft.com/office/drawing/2014/main" id="{13CD3235-D918-4830-B4EC-80965E479479}"/>
+                <a16:creationId xmlns:a16="http://schemas.microsoft.com/office/drawing/2014/main" id="{D75AD070-7C82-4457-97EB-1B87431A1251}"/>
               </a:ext>
             </a:extLst>
           </p:cNvPr>
@@ -8851,7 +8941,7 @@
           <p:cNvPr id="21" name="">
             <a:extLst xmlns:a="http://schemas.openxmlformats.org/drawingml/2006/main">
               <a:ext uri="{FF2B5EF4-FFF2-40B4-BE49-F238E27FC236}">
-                <a16:creationId xmlns:a16="http://schemas.microsoft.com/office/drawing/2014/main" id="{AD574D7C-16A2-4A12-9B77-70EB63F90D61}"/>
+                <a16:creationId xmlns:a16="http://schemas.microsoft.com/office/drawing/2014/main" id="{584B719B-06D0-465E-AE0B-1A1256C79427}"/>
               </a:ext>
             </a:extLst>
           </p:cNvPr>
@@ -8883,7 +8973,7 @@
           <p:cNvPr id="20" name="">
             <a:extLst xmlns:a="http://schemas.openxmlformats.org/drawingml/2006/main">
               <a:ext uri="{FF2B5EF4-FFF2-40B4-BE49-F238E27FC236}">
-                <a16:creationId xmlns:a16="http://schemas.microsoft.com/office/drawing/2014/main" id="{D5115F0A-C9C2-48DF-9926-915127A59A3E}"/>
+                <a16:creationId xmlns:a16="http://schemas.microsoft.com/office/drawing/2014/main" id="{F58F24E6-3A81-4C0E-BBAA-C07C34F50E9D}"/>
               </a:ext>
             </a:extLst>
           </p:cNvPr>
@@ -8915,7 +9005,7 @@
           <p:cNvPr id="19" name="">
             <a:extLst xmlns:a="http://schemas.openxmlformats.org/drawingml/2006/main">
               <a:ext uri="{FF2B5EF4-FFF2-40B4-BE49-F238E27FC236}">
-                <a16:creationId xmlns:a16="http://schemas.microsoft.com/office/drawing/2014/main" id="{7581794B-057A-4D4B-9282-62FC0E644395}"/>
+                <a16:creationId xmlns:a16="http://schemas.microsoft.com/office/drawing/2014/main" id="{52E2C1D4-9504-4292-8C66-306CFCE17062}"/>
               </a:ext>
             </a:extLst>
           </p:cNvPr>
@@ -8947,7 +9037,7 @@
           <p:cNvPr id="18" name="">
             <a:extLst xmlns:a="http://schemas.openxmlformats.org/drawingml/2006/main">
               <a:ext uri="{FF2B5EF4-FFF2-40B4-BE49-F238E27FC236}">
-                <a16:creationId xmlns:a16="http://schemas.microsoft.com/office/drawing/2014/main" id="{52410611-4E8C-4DEC-AC97-2F57559779C4}"/>
+                <a16:creationId xmlns:a16="http://schemas.microsoft.com/office/drawing/2014/main" id="{4EA6C6D7-B1AD-4134-9FFD-B15971681106}"/>
               </a:ext>
             </a:extLst>
           </p:cNvPr>
@@ -9928,7 +10018,7 @@
                 <a:ea typeface="Aptos"/>
                 <a:cs typeface="Aptos"/>
               </a:rPr>
-              <a:t>Assigned agent</a:t>
+              <a:t>Coordinator</a:t>
             </a:r>
           </a:p>
         </p:txBody>
@@ -10097,7 +10187,7 @@
                 <a:ea typeface="Aptos"/>
                 <a:cs typeface="Aptos"/>
               </a:rPr>
-              <a:t>Prepare</a:t>
+              <a:t>Decompose</a:t>
             </a:r>
           </a:p>
           <a:p xmlns:a="http://schemas.openxmlformats.org/drawingml/2006/main">
@@ -10911,7 +11001,7 @@
                 <a:ea typeface="Aptos"/>
                 <a:cs typeface="Aptos"/>
               </a:rPr>
-              <a:t>Authorized agent</a:t>
+              <a:t>Role-based agent</a:t>
             </a:r>
           </a:p>
           <a:p xmlns:a="http://schemas.openxmlformats.org/drawingml/2006/main">
@@ -12106,7 +12196,7 @@
           <p:cNvPr id="28" name="flow-61">
             <a:extLst xmlns:a="http://schemas.openxmlformats.org/drawingml/2006/main">
               <a:ext uri="{FF2B5EF4-FFF2-40B4-BE49-F238E27FC236}">
-                <a16:creationId xmlns:a16="http://schemas.microsoft.com/office/drawing/2014/main" id="{944DAFBF-3248-4629-A0A4-9A1BF80530BA}"/>
+                <a16:creationId xmlns:a16="http://schemas.microsoft.com/office/drawing/2014/main" id="{7BA58286-D406-4B19-8F31-AE6DB80B91F6}"/>
               </a:ext>
             </a:extLst>
           </p:cNvPr>
@@ -12304,7 +12394,7 @@
           <p:cNvPr id="30" name="flow-63">
             <a:extLst xmlns:a="http://schemas.openxmlformats.org/drawingml/2006/main">
               <a:ext uri="{FF2B5EF4-FFF2-40B4-BE49-F238E27FC236}">
-                <a16:creationId xmlns:a16="http://schemas.microsoft.com/office/drawing/2014/main" id="{6DED72C9-6330-4F5C-8FE0-EEF303315B84}"/>
+                <a16:creationId xmlns:a16="http://schemas.microsoft.com/office/drawing/2014/main" id="{D332619A-CE6F-46E1-BB3F-57BCB1BCCACC}"/>
               </a:ext>
             </a:extLst>
           </p:cNvPr>
@@ -12332,7 +12422,7 @@
           <p:cNvPr id="31" name="flow-64">
             <a:extLst xmlns:a="http://schemas.openxmlformats.org/drawingml/2006/main">
               <a:ext uri="{FF2B5EF4-FFF2-40B4-BE49-F238E27FC236}">
-                <a16:creationId xmlns:a16="http://schemas.microsoft.com/office/drawing/2014/main" id="{AE533842-3567-42A8-B2BB-D59D467D4065}"/>
+                <a16:creationId xmlns:a16="http://schemas.microsoft.com/office/drawing/2014/main" id="{D1646ACE-63CC-46CA-8658-05E2DFDE404E}"/>
               </a:ext>
             </a:extLst>
           </p:cNvPr>
@@ -12360,7 +12450,7 @@
           <p:cNvPr id="32" name="flow-65">
             <a:extLst xmlns:a="http://schemas.openxmlformats.org/drawingml/2006/main">
               <a:ext uri="{FF2B5EF4-FFF2-40B4-BE49-F238E27FC236}">
-                <a16:creationId xmlns:a16="http://schemas.microsoft.com/office/drawing/2014/main" id="{97001629-AF78-4755-83C5-3237938B0278}"/>
+                <a16:creationId xmlns:a16="http://schemas.microsoft.com/office/drawing/2014/main" id="{C34592A8-9DAC-4660-B21E-778A2A1A738E}"/>
               </a:ext>
             </a:extLst>
           </p:cNvPr>
@@ -12388,7 +12478,7 @@
           <p:cNvPr id="33" name="flow-66">
             <a:extLst xmlns:a="http://schemas.openxmlformats.org/drawingml/2006/main">
               <a:ext uri="{FF2B5EF4-FFF2-40B4-BE49-F238E27FC236}">
-                <a16:creationId xmlns:a16="http://schemas.microsoft.com/office/drawing/2014/main" id="{B26AF4DE-7F2D-41DC-B8E6-D6E691671532}"/>
+                <a16:creationId xmlns:a16="http://schemas.microsoft.com/office/drawing/2014/main" id="{1526C849-C2A1-487D-A2AB-062F507BCF8C}"/>
               </a:ext>
             </a:extLst>
           </p:cNvPr>
@@ -12953,7 +13043,7 @@
           <p:cNvPr id="18" name="">
             <a:extLst xmlns:a="http://schemas.openxmlformats.org/drawingml/2006/main">
               <a:ext uri="{FF2B5EF4-FFF2-40B4-BE49-F238E27FC236}">
-                <a16:creationId xmlns:a16="http://schemas.microsoft.com/office/drawing/2014/main" id="{C2332155-AD63-44A2-A399-643CE81DB384}"/>
+                <a16:creationId xmlns:a16="http://schemas.microsoft.com/office/drawing/2014/main" id="{2BDD1F9E-D22C-4B42-9138-BBDCD180D619}"/>
               </a:ext>
             </a:extLst>
           </p:cNvPr>
@@ -15443,7 +15533,7 @@
           <p:cNvPr id="20" name="flow-88">
             <a:extLst xmlns:a="http://schemas.openxmlformats.org/drawingml/2006/main">
               <a:ext uri="{FF2B5EF4-FFF2-40B4-BE49-F238E27FC236}">
-                <a16:creationId xmlns:a16="http://schemas.microsoft.com/office/drawing/2014/main" id="{0675FF83-10E9-4E15-9F4C-1A46DC56F7C0}"/>
+                <a16:creationId xmlns:a16="http://schemas.microsoft.com/office/drawing/2014/main" id="{B241B2D4-D64B-4BA4-BE21-226F5087281E}"/>
               </a:ext>
             </a:extLst>
           </p:cNvPr>
@@ -15471,7 +15561,7 @@
           <p:cNvPr id="21" name="flow-89">
             <a:extLst xmlns:a="http://schemas.openxmlformats.org/drawingml/2006/main">
               <a:ext uri="{FF2B5EF4-FFF2-40B4-BE49-F238E27FC236}">
-                <a16:creationId xmlns:a16="http://schemas.microsoft.com/office/drawing/2014/main" id="{B9EDF08F-7A86-460E-A6F2-E651A8A752F1}"/>
+                <a16:creationId xmlns:a16="http://schemas.microsoft.com/office/drawing/2014/main" id="{3F79E248-AE7F-43FD-9BD4-0D387EF29116}"/>
               </a:ext>
             </a:extLst>
           </p:cNvPr>
@@ -15499,7 +15589,7 @@
           <p:cNvPr id="22" name="flow-90">
             <a:extLst xmlns:a="http://schemas.openxmlformats.org/drawingml/2006/main">
               <a:ext uri="{FF2B5EF4-FFF2-40B4-BE49-F238E27FC236}">
-                <a16:creationId xmlns:a16="http://schemas.microsoft.com/office/drawing/2014/main" id="{EA9A95AF-99BE-4164-A13F-1D801C6AC39C}"/>
+                <a16:creationId xmlns:a16="http://schemas.microsoft.com/office/drawing/2014/main" id="{48CF2C92-D3FB-4A14-B29A-951309921B37}"/>
               </a:ext>
             </a:extLst>
           </p:cNvPr>
@@ -15721,7 +15811,7 @@
           <p:cNvPr id="24" name="flow-92">
             <a:extLst xmlns:a="http://schemas.openxmlformats.org/drawingml/2006/main">
               <a:ext uri="{FF2B5EF4-FFF2-40B4-BE49-F238E27FC236}">
-                <a16:creationId xmlns:a16="http://schemas.microsoft.com/office/drawing/2014/main" id="{37D90C01-0E90-4F98-9A8E-285FBAAA88C3}"/>
+                <a16:creationId xmlns:a16="http://schemas.microsoft.com/office/drawing/2014/main" id="{E0DA8A2F-9AF6-4B35-A979-475D993EFEC1}"/>
               </a:ext>
             </a:extLst>
           </p:cNvPr>
@@ -15749,7 +15839,7 @@
           <p:cNvPr id="25" name="flow-93">
             <a:extLst xmlns:a="http://schemas.openxmlformats.org/drawingml/2006/main">
               <a:ext uri="{FF2B5EF4-FFF2-40B4-BE49-F238E27FC236}">
-                <a16:creationId xmlns:a16="http://schemas.microsoft.com/office/drawing/2014/main" id="{60524EB1-9AAB-49CC-9146-E8D7BCABD3CE}"/>
+                <a16:creationId xmlns:a16="http://schemas.microsoft.com/office/drawing/2014/main" id="{43D41F70-A243-454E-A0C1-ECD149BDCFA8}"/>
               </a:ext>
             </a:extLst>
           </p:cNvPr>
@@ -15777,7 +15867,7 @@
           <p:cNvPr id="26" name="flow-94">
             <a:extLst xmlns:a="http://schemas.openxmlformats.org/drawingml/2006/main">
               <a:ext uri="{FF2B5EF4-FFF2-40B4-BE49-F238E27FC236}">
-                <a16:creationId xmlns:a16="http://schemas.microsoft.com/office/drawing/2014/main" id="{59448AF5-8417-4086-B051-32CAC12BB397}"/>
+                <a16:creationId xmlns:a16="http://schemas.microsoft.com/office/drawing/2014/main" id="{8203639C-1CE6-415C-86B2-BE81C0406C16}"/>
               </a:ext>
             </a:extLst>
           </p:cNvPr>
@@ -15999,7 +16089,7 @@
           <p:cNvPr id="28" name="flow-96">
             <a:extLst xmlns:a="http://schemas.openxmlformats.org/drawingml/2006/main">
               <a:ext uri="{FF2B5EF4-FFF2-40B4-BE49-F238E27FC236}">
-                <a16:creationId xmlns:a16="http://schemas.microsoft.com/office/drawing/2014/main" id="{4273A0B6-C4CE-4CD6-ABE3-6D9D43A1FA76}"/>
+                <a16:creationId xmlns:a16="http://schemas.microsoft.com/office/drawing/2014/main" id="{DFB4BC9B-83C5-4725-B876-0F31413B639D}"/>
               </a:ext>
             </a:extLst>
           </p:cNvPr>
@@ -16027,7 +16117,7 @@
           <p:cNvPr id="29" name="flow-97">
             <a:extLst xmlns:a="http://schemas.openxmlformats.org/drawingml/2006/main">
               <a:ext uri="{FF2B5EF4-FFF2-40B4-BE49-F238E27FC236}">
-                <a16:creationId xmlns:a16="http://schemas.microsoft.com/office/drawing/2014/main" id="{EC59B536-1741-4BF0-8178-AF8895A3CCAA}"/>
+                <a16:creationId xmlns:a16="http://schemas.microsoft.com/office/drawing/2014/main" id="{2B4D084B-7B11-4E42-A10C-26A0C0082BDA}"/>
               </a:ext>
             </a:extLst>
           </p:cNvPr>
@@ -16809,7 +16899,7 @@
           <p:cNvPr id="35" name="">
             <a:extLst xmlns:a="http://schemas.openxmlformats.org/drawingml/2006/main">
               <a:ext uri="{FF2B5EF4-FFF2-40B4-BE49-F238E27FC236}">
-                <a16:creationId xmlns:a16="http://schemas.microsoft.com/office/drawing/2014/main" id="{AE660065-2521-48A5-BB55-9F993257E672}"/>
+                <a16:creationId xmlns:a16="http://schemas.microsoft.com/office/drawing/2014/main" id="{746985A6-321D-40D3-BD63-A74A1C6E67BD}"/>
               </a:ext>
             </a:extLst>
           </p:cNvPr>
@@ -16841,7 +16931,7 @@
           <p:cNvPr id="34" name="">
             <a:extLst xmlns:a="http://schemas.openxmlformats.org/drawingml/2006/main">
               <a:ext uri="{FF2B5EF4-FFF2-40B4-BE49-F238E27FC236}">
-                <a16:creationId xmlns:a16="http://schemas.microsoft.com/office/drawing/2014/main" id="{C05A3AB3-F594-4DB7-A431-BFAA1F2EDFF4}"/>
+                <a16:creationId xmlns:a16="http://schemas.microsoft.com/office/drawing/2014/main" id="{A019DA35-5538-4BC9-8019-E8F1F98946DE}"/>
               </a:ext>
             </a:extLst>
           </p:cNvPr>
@@ -16873,7 +16963,7 @@
           <p:cNvPr id="33" name="">
             <a:extLst xmlns:a="http://schemas.openxmlformats.org/drawingml/2006/main">
               <a:ext uri="{FF2B5EF4-FFF2-40B4-BE49-F238E27FC236}">
-                <a16:creationId xmlns:a16="http://schemas.microsoft.com/office/drawing/2014/main" id="{FAFCE76C-7C93-4061-8398-E67D560CDAB7}"/>
+                <a16:creationId xmlns:a16="http://schemas.microsoft.com/office/drawing/2014/main" id="{0DC79D47-795A-4129-A380-273B4597993D}"/>
               </a:ext>
             </a:extLst>
           </p:cNvPr>
@@ -16905,7 +16995,7 @@
           <p:cNvPr id="13" name="">
             <a:extLst xmlns:a="http://schemas.openxmlformats.org/drawingml/2006/main">
               <a:ext uri="{FF2B5EF4-FFF2-40B4-BE49-F238E27FC236}">
-                <a16:creationId xmlns:a16="http://schemas.microsoft.com/office/drawing/2014/main" id="{6D5B285B-C685-4F85-8EBC-6CE621429724}"/>
+                <a16:creationId xmlns:a16="http://schemas.microsoft.com/office/drawing/2014/main" id="{C0A62017-19F8-412E-9039-CAACA2A839CE}"/>
               </a:ext>
             </a:extLst>
           </p:cNvPr>
@@ -16937,7 +17027,7 @@
           <p:cNvPr id="12" name="">
             <a:extLst xmlns:a="http://schemas.openxmlformats.org/drawingml/2006/main">
               <a:ext uri="{FF2B5EF4-FFF2-40B4-BE49-F238E27FC236}">
-                <a16:creationId xmlns:a16="http://schemas.microsoft.com/office/drawing/2014/main" id="{AEA3B08F-7EA7-4ED2-A76A-2B2EF0632B15}"/>
+                <a16:creationId xmlns:a16="http://schemas.microsoft.com/office/drawing/2014/main" id="{AFB2ADAC-96B3-48C5-96F5-A1762A43ACD8}"/>
               </a:ext>
             </a:extLst>
           </p:cNvPr>
@@ -18516,7 +18606,7 @@
           <p:cNvPr id="14" name="flow-113">
             <a:extLst xmlns:a="http://schemas.openxmlformats.org/drawingml/2006/main">
               <a:ext uri="{FF2B5EF4-FFF2-40B4-BE49-F238E27FC236}">
-                <a16:creationId xmlns:a16="http://schemas.microsoft.com/office/drawing/2014/main" id="{A23A146E-4459-4132-A81A-0F55AA0FEDF9}"/>
+                <a16:creationId xmlns:a16="http://schemas.microsoft.com/office/drawing/2014/main" id="{C048B40E-6EDD-4660-B925-C3B35DDF64C2}"/>
               </a:ext>
             </a:extLst>
           </p:cNvPr>
@@ -18544,7 +18634,7 @@
           <p:cNvPr id="15" name="flow-114">
             <a:extLst xmlns:a="http://schemas.openxmlformats.org/drawingml/2006/main">
               <a:ext uri="{FF2B5EF4-FFF2-40B4-BE49-F238E27FC236}">
-                <a16:creationId xmlns:a16="http://schemas.microsoft.com/office/drawing/2014/main" id="{05282601-2835-43D7-96F6-40444A6447C3}"/>
+                <a16:creationId xmlns:a16="http://schemas.microsoft.com/office/drawing/2014/main" id="{765D620A-B598-452B-809F-CDA209699E14}"/>
               </a:ext>
             </a:extLst>
           </p:cNvPr>
@@ -18572,7 +18662,7 @@
           <p:cNvPr id="16" name="flow-115">
             <a:extLst xmlns:a="http://schemas.openxmlformats.org/drawingml/2006/main">
               <a:ext uri="{FF2B5EF4-FFF2-40B4-BE49-F238E27FC236}">
-                <a16:creationId xmlns:a16="http://schemas.microsoft.com/office/drawing/2014/main" id="{D04D8537-13F6-4BEA-921C-588A990BF4A5}"/>
+                <a16:creationId xmlns:a16="http://schemas.microsoft.com/office/drawing/2014/main" id="{FF8B3767-335E-4386-A6D0-7FD4272FD674}"/>
               </a:ext>
             </a:extLst>
           </p:cNvPr>
@@ -18600,7 +18690,7 @@
           <p:cNvPr id="17" name="flow-116">
             <a:extLst xmlns:a="http://schemas.openxmlformats.org/drawingml/2006/main">
               <a:ext uri="{FF2B5EF4-FFF2-40B4-BE49-F238E27FC236}">
-                <a16:creationId xmlns:a16="http://schemas.microsoft.com/office/drawing/2014/main" id="{B0EEBD32-0273-40B2-B654-F68164CC1BB2}"/>
+                <a16:creationId xmlns:a16="http://schemas.microsoft.com/office/drawing/2014/main" id="{2564613A-8A2C-4DF3-BA8A-ABBECAFAA266}"/>
               </a:ext>
             </a:extLst>
           </p:cNvPr>
@@ -20378,7 +20468,7 @@
           <p:cNvPr id="31" name="flow-130">
             <a:extLst xmlns:a="http://schemas.openxmlformats.org/drawingml/2006/main">
               <a:ext uri="{FF2B5EF4-FFF2-40B4-BE49-F238E27FC236}">
-                <a16:creationId xmlns:a16="http://schemas.microsoft.com/office/drawing/2014/main" id="{086FBD1A-D57A-400F-B81C-96EF922B688D}"/>
+                <a16:creationId xmlns:a16="http://schemas.microsoft.com/office/drawing/2014/main" id="{FB0B129B-A86A-44A2-AAE4-B9BE4C4CB57D}"/>
               </a:ext>
             </a:extLst>
           </p:cNvPr>
@@ -21290,7 +21380,7 @@
                 <a:ea typeface="Aptos"/>
                 <a:cs typeface="Aptos"/>
               </a:rPr>
-              <a:t>V2 core merged; wiring pending</a:t>
+              <a:t>Capture merged; Packet UI draft</a:t>
             </a:r>
           </a:p>
         </p:txBody>
@@ -21662,7 +21752,7 @@
           <p:cNvPr id="43" name="partner-flow-1">
             <a:extLst xmlns:a="http://schemas.openxmlformats.org/drawingml/2006/main">
               <a:ext uri="{FF2B5EF4-FFF2-40B4-BE49-F238E27FC236}">
-                <a16:creationId xmlns:a16="http://schemas.microsoft.com/office/drawing/2014/main" id="{56F2AE85-DB6D-49EC-833D-AC05D4AFED33}"/>
+                <a16:creationId xmlns:a16="http://schemas.microsoft.com/office/drawing/2014/main" id="{474C57F3-FEA4-4A15-99F5-A14F448532AE}"/>
               </a:ext>
             </a:extLst>
           </p:cNvPr>
@@ -21690,7 +21780,7 @@
           <p:cNvPr id="44" name="partner-flow-2">
             <a:extLst xmlns:a="http://schemas.openxmlformats.org/drawingml/2006/main">
               <a:ext uri="{FF2B5EF4-FFF2-40B4-BE49-F238E27FC236}">
-                <a16:creationId xmlns:a16="http://schemas.microsoft.com/office/drawing/2014/main" id="{E74AC5FE-927D-4A84-9F57-8F98A3A77565}"/>
+                <a16:creationId xmlns:a16="http://schemas.microsoft.com/office/drawing/2014/main" id="{F9DDB598-75FF-48EF-8335-C0F8661E584F}"/>
               </a:ext>
             </a:extLst>
           </p:cNvPr>
@@ -21718,7 +21808,7 @@
           <p:cNvPr id="45" name="partner-flow-3">
             <a:extLst xmlns:a="http://schemas.openxmlformats.org/drawingml/2006/main">
               <a:ext uri="{FF2B5EF4-FFF2-40B4-BE49-F238E27FC236}">
-                <a16:creationId xmlns:a16="http://schemas.microsoft.com/office/drawing/2014/main" id="{7F5A4803-B0E8-4A3C-9D12-D64CBA62DC92}"/>
+                <a16:creationId xmlns:a16="http://schemas.microsoft.com/office/drawing/2014/main" id="{F1C69EBB-F099-4B9D-B38E-48C7E22FFEFA}"/>
               </a:ext>
             </a:extLst>
           </p:cNvPr>
@@ -21746,7 +21836,7 @@
           <p:cNvPr id="46" name="partner-flow-4">
             <a:extLst xmlns:a="http://schemas.openxmlformats.org/drawingml/2006/main">
               <a:ext uri="{FF2B5EF4-FFF2-40B4-BE49-F238E27FC236}">
-                <a16:creationId xmlns:a16="http://schemas.microsoft.com/office/drawing/2014/main" id="{2881DDDD-D0C7-4BBE-A883-B0FB7E7BCBAA}"/>
+                <a16:creationId xmlns:a16="http://schemas.microsoft.com/office/drawing/2014/main" id="{2F5CBEB4-37A5-4BF1-AACC-ACA976297623}"/>
               </a:ext>
             </a:extLst>
           </p:cNvPr>
@@ -21804,7 +21894,7 @@
           <p:cNvPr id="25" name="">
             <a:extLst xmlns:a="http://schemas.openxmlformats.org/drawingml/2006/main">
               <a:ext uri="{FF2B5EF4-FFF2-40B4-BE49-F238E27FC236}">
-                <a16:creationId xmlns:a16="http://schemas.microsoft.com/office/drawing/2014/main" id="{66D3E603-504C-475E-A357-C8547DE77376}"/>
+                <a16:creationId xmlns:a16="http://schemas.microsoft.com/office/drawing/2014/main" id="{BE12559E-019E-42EB-8504-0E5882CF4073}"/>
               </a:ext>
             </a:extLst>
           </p:cNvPr>
@@ -22333,7 +22423,7 @@
                 <a:ea typeface="Aptos"/>
                 <a:cs typeface="Aptos"/>
               </a:rPr>
-              <a:t>Wednesday path</a:t>
+              <a:t>Native collaboration</a:t>
             </a:r>
           </a:p>
         </p:txBody>
@@ -22512,7 +22602,7 @@
           <p:cNvPr id="5" name="flow-142">
             <a:extLst xmlns:a="http://schemas.openxmlformats.org/drawingml/2006/main">
               <a:ext uri="{FF2B5EF4-FFF2-40B4-BE49-F238E27FC236}">
-                <a16:creationId xmlns:a16="http://schemas.microsoft.com/office/drawing/2014/main" id="{4CF5FB71-DE37-45BC-A897-BC8B9EFBECD5}"/>
+                <a16:creationId xmlns:a16="http://schemas.microsoft.com/office/drawing/2014/main" id="{E430C7FB-999B-4E4A-ACD9-9BF6B3A7C9CE}"/>
               </a:ext>
             </a:extLst>
           </p:cNvPr>
@@ -23272,7 +23362,7 @@
                 <a:ea typeface="Aptos"/>
                 <a:cs typeface="Aptos"/>
               </a:rPr>
-              <a:t>Assigns the task and allowed inputs</a:t>
+              <a:t>Decomposes and assigns work</a:t>
             </a:r>
           </a:p>
         </p:txBody>
@@ -23474,7 +23564,7 @@
                 <a:ea typeface="Aptos"/>
                 <a:cs typeface="Aptos"/>
               </a:rPr>
-              <a:t>Existing Buzz agent</a:t>
+              <a:t>Configured agents</a:t>
             </a:r>
           </a:p>
         </p:txBody>
@@ -23643,7 +23733,7 @@
                 <a:ea typeface="Aptos"/>
                 <a:cs typeface="Aptos"/>
               </a:rPr>
-              <a:t>Authorized runtime and tools</a:t>
+              <a:t>Provider and role roster</a:t>
             </a:r>
           </a:p>
           <a:p xmlns:a="http://schemas.openxmlformats.org/drawingml/2006/main">
@@ -23667,7 +23757,7 @@
                 <a:ea typeface="Aptos"/>
                 <a:cs typeface="Aptos"/>
               </a:rPr>
-              <a:t>Wednesday contribution path</a:t>
+              <a:t>Scoped tools and histories</a:t>
             </a:r>
           </a:p>
         </p:txBody>
@@ -24409,7 +24499,7 @@
                 <a:ea typeface="Aptos"/>
                 <a:cs typeface="Aptos"/>
               </a:rPr>
-              <a:t>V2 core merged; wiring pending</a:t>
+              <a:t>Capture merged; Packet UI draft</a:t>
             </a:r>
           </a:p>
         </p:txBody>
@@ -24419,7 +24509,7 @@
           <p:cNvPr id="21" name="flow-158">
             <a:extLst xmlns:a="http://schemas.openxmlformats.org/drawingml/2006/main">
               <a:ext uri="{FF2B5EF4-FFF2-40B4-BE49-F238E27FC236}">
-                <a16:creationId xmlns:a16="http://schemas.microsoft.com/office/drawing/2014/main" id="{E290F44B-1D90-48FD-8974-A8414659C4B7}"/>
+                <a16:creationId xmlns:a16="http://schemas.microsoft.com/office/drawing/2014/main" id="{7D07108F-6B4A-4801-A078-6388E59B89CE}"/>
               </a:ext>
             </a:extLst>
           </p:cNvPr>
@@ -24987,7 +25077,7 @@
           <p:cNvPr id="27" name="flow-163">
             <a:extLst xmlns:a="http://schemas.openxmlformats.org/drawingml/2006/main">
               <a:ext uri="{FF2B5EF4-FFF2-40B4-BE49-F238E27FC236}">
-                <a16:creationId xmlns:a16="http://schemas.microsoft.com/office/drawing/2014/main" id="{1F51F7BE-1DB3-48D8-AA8D-C45F20634994}"/>
+                <a16:creationId xmlns:a16="http://schemas.microsoft.com/office/drawing/2014/main" id="{B6BE3F8D-4190-4F1E-B35F-35BD62206314}"/>
               </a:ext>
             </a:extLst>
           </p:cNvPr>
@@ -25015,7 +25105,7 @@
           <p:cNvPr id="28" name="flow-164">
             <a:extLst xmlns:a="http://schemas.openxmlformats.org/drawingml/2006/main">
               <a:ext uri="{FF2B5EF4-FFF2-40B4-BE49-F238E27FC236}">
-                <a16:creationId xmlns:a16="http://schemas.microsoft.com/office/drawing/2014/main" id="{8F9E5EC2-7958-4EE8-AB42-2E7E4F7C0DF3}"/>
+                <a16:creationId xmlns:a16="http://schemas.microsoft.com/office/drawing/2014/main" id="{F5B95593-3D47-45A3-AF90-377C43E69F96}"/>
               </a:ext>
             </a:extLst>
           </p:cNvPr>
@@ -25043,7 +25133,7 @@
           <p:cNvPr id="29" name="flow-165">
             <a:extLst xmlns:a="http://schemas.openxmlformats.org/drawingml/2006/main">
               <a:ext uri="{FF2B5EF4-FFF2-40B4-BE49-F238E27FC236}">
-                <a16:creationId xmlns:a16="http://schemas.microsoft.com/office/drawing/2014/main" id="{048D0C5A-0D5F-45E9-AD33-B25C62729B52}"/>
+                <a16:creationId xmlns:a16="http://schemas.microsoft.com/office/drawing/2014/main" id="{704FE7F6-F247-4AEF-B3FE-9469EF32A540}"/>
               </a:ext>
             </a:extLst>
           </p:cNvPr>
@@ -25241,7 +25331,7 @@
           <p:cNvPr id="31" name="flow-167">
             <a:extLst xmlns:a="http://schemas.openxmlformats.org/drawingml/2006/main">
               <a:ext uri="{FF2B5EF4-FFF2-40B4-BE49-F238E27FC236}">
-                <a16:creationId xmlns:a16="http://schemas.microsoft.com/office/drawing/2014/main" id="{109DAE1D-49D5-4D17-9F2F-5286CAEEDD59}"/>
+                <a16:creationId xmlns:a16="http://schemas.microsoft.com/office/drawing/2014/main" id="{2D93CC09-938A-4BDD-AA3F-48D2B250E5E7}"/>
               </a:ext>
             </a:extLst>
           </p:cNvPr>
@@ -25439,7 +25529,7 @@
           <p:cNvPr id="33" name="flow-169">
             <a:extLst xmlns:a="http://schemas.openxmlformats.org/drawingml/2006/main">
               <a:ext uri="{FF2B5EF4-FFF2-40B4-BE49-F238E27FC236}">
-                <a16:creationId xmlns:a16="http://schemas.microsoft.com/office/drawing/2014/main" id="{BD16DDBD-B8E9-4483-9767-1632B1A113EC}"/>
+                <a16:creationId xmlns:a16="http://schemas.microsoft.com/office/drawing/2014/main" id="{BB6A33C9-17D2-4ECE-AC12-BB600CDFBD54}"/>
               </a:ext>
             </a:extLst>
           </p:cNvPr>
@@ -25661,7 +25751,7 @@
           <p:cNvPr id="35" name="flow-171">
             <a:extLst xmlns:a="http://schemas.openxmlformats.org/drawingml/2006/main">
               <a:ext uri="{FF2B5EF4-FFF2-40B4-BE49-F238E27FC236}">
-                <a16:creationId xmlns:a16="http://schemas.microsoft.com/office/drawing/2014/main" id="{ED8F64E4-9AA2-4368-8EC2-7FD36E1AC7FE}"/>
+                <a16:creationId xmlns:a16="http://schemas.microsoft.com/office/drawing/2014/main" id="{EFD7CD08-0417-480B-A23A-2286373F81FD}"/>
               </a:ext>
             </a:extLst>
           </p:cNvPr>
@@ -25689,7 +25779,7 @@
           <p:cNvPr id="36" name="flow-172">
             <a:extLst xmlns:a="http://schemas.openxmlformats.org/drawingml/2006/main">
               <a:ext uri="{FF2B5EF4-FFF2-40B4-BE49-F238E27FC236}">
-                <a16:creationId xmlns:a16="http://schemas.microsoft.com/office/drawing/2014/main" id="{8CE47179-A748-4100-89C8-F5AE18604705}"/>
+                <a16:creationId xmlns:a16="http://schemas.microsoft.com/office/drawing/2014/main" id="{58D8F5E9-A2DE-47CB-B527-73EBD0DAEF01}"/>
               </a:ext>
             </a:extLst>
           </p:cNvPr>
@@ -25717,7 +25807,7 @@
           <p:cNvPr id="37" name="flow-173">
             <a:extLst xmlns:a="http://schemas.openxmlformats.org/drawingml/2006/main">
               <a:ext uri="{FF2B5EF4-FFF2-40B4-BE49-F238E27FC236}">
-                <a16:creationId xmlns:a16="http://schemas.microsoft.com/office/drawing/2014/main" id="{84BF9CD2-7AC5-4DCF-849B-8C07FEF14618}"/>
+                <a16:creationId xmlns:a16="http://schemas.microsoft.com/office/drawing/2014/main" id="{6BCBE229-CE7B-4539-800A-F6F9AA34FD2D}"/>
               </a:ext>
             </a:extLst>
           </p:cNvPr>
@@ -25915,7 +26005,7 @@
           <p:cNvPr id="39" name="flow-175">
             <a:extLst xmlns:a="http://schemas.openxmlformats.org/drawingml/2006/main">
               <a:ext uri="{FF2B5EF4-FFF2-40B4-BE49-F238E27FC236}">
-                <a16:creationId xmlns:a16="http://schemas.microsoft.com/office/drawing/2014/main" id="{6BF49D48-2FB0-450F-862A-6A1CADC39174}"/>
+                <a16:creationId xmlns:a16="http://schemas.microsoft.com/office/drawing/2014/main" id="{6252D98D-57E5-4827-ACA3-B39504372846}"/>
               </a:ext>
             </a:extLst>
           </p:cNvPr>
@@ -25943,7 +26033,7 @@
           <p:cNvPr id="40" name="flow-176">
             <a:extLst xmlns:a="http://schemas.openxmlformats.org/drawingml/2006/main">
               <a:ext uri="{FF2B5EF4-FFF2-40B4-BE49-F238E27FC236}">
-                <a16:creationId xmlns:a16="http://schemas.microsoft.com/office/drawing/2014/main" id="{B787F93B-95AA-4B36-9A2B-422FF9251A30}"/>
+                <a16:creationId xmlns:a16="http://schemas.microsoft.com/office/drawing/2014/main" id="{895A55E5-AE8F-493B-BCAB-02215E94F453}"/>
               </a:ext>
             </a:extLst>
           </p:cNvPr>
@@ -25971,7 +26061,7 @@
           <p:cNvPr id="41" name="flow-177">
             <a:extLst xmlns:a="http://schemas.openxmlformats.org/drawingml/2006/main">
               <a:ext uri="{FF2B5EF4-FFF2-40B4-BE49-F238E27FC236}">
-                <a16:creationId xmlns:a16="http://schemas.microsoft.com/office/drawing/2014/main" id="{4DCEC9B1-E3DC-4E5A-9A81-7FEF14068C3A}"/>
+                <a16:creationId xmlns:a16="http://schemas.microsoft.com/office/drawing/2014/main" id="{2818271D-823F-43B0-807E-78EDCC5E6ED6}"/>
               </a:ext>
             </a:extLst>
           </p:cNvPr>
@@ -25999,7 +26089,7 @@
           <p:cNvPr id="42" name="flow-178">
             <a:extLst xmlns:a="http://schemas.openxmlformats.org/drawingml/2006/main">
               <a:ext uri="{FF2B5EF4-FFF2-40B4-BE49-F238E27FC236}">
-                <a16:creationId xmlns:a16="http://schemas.microsoft.com/office/drawing/2014/main" id="{BDABE26C-2431-4654-8346-68DA42E08E37}"/>
+                <a16:creationId xmlns:a16="http://schemas.microsoft.com/office/drawing/2014/main" id="{554084CC-FBAD-4820-8F71-04535170EED8}"/>
               </a:ext>
             </a:extLst>
           </p:cNvPr>
@@ -27740,7 +27830,7 @@
           <p:cNvPr id="10" name="partner-flow-14">
             <a:extLst xmlns:a="http://schemas.openxmlformats.org/drawingml/2006/main">
               <a:ext uri="{FF2B5EF4-FFF2-40B4-BE49-F238E27FC236}">
-                <a16:creationId xmlns:a16="http://schemas.microsoft.com/office/drawing/2014/main" id="{DE4C125C-55E4-42FF-8F82-D73F3D8670C1}"/>
+                <a16:creationId xmlns:a16="http://schemas.microsoft.com/office/drawing/2014/main" id="{2191F705-222E-4129-A211-93FBAB4AFDB5}"/>
               </a:ext>
             </a:extLst>
           </p:cNvPr>
@@ -28382,7 +28472,7 @@
           <p:cNvPr id="15" name="partner-flow-19">
             <a:extLst xmlns:a="http://schemas.openxmlformats.org/drawingml/2006/main">
               <a:ext uri="{FF2B5EF4-FFF2-40B4-BE49-F238E27FC236}">
-                <a16:creationId xmlns:a16="http://schemas.microsoft.com/office/drawing/2014/main" id="{7AD49FC8-603D-411F-A83A-A2717D315E84}"/>
+                <a16:creationId xmlns:a16="http://schemas.microsoft.com/office/drawing/2014/main" id="{2348295F-52EF-41BF-9D8E-7FF327C8AC4B}"/>
               </a:ext>
             </a:extLst>
           </p:cNvPr>
@@ -28975,7 +29065,7 @@
           <p:cNvPr id="20" name="partner-flow-24">
             <a:extLst xmlns:a="http://schemas.openxmlformats.org/drawingml/2006/main">
               <a:ext uri="{FF2B5EF4-FFF2-40B4-BE49-F238E27FC236}">
-                <a16:creationId xmlns:a16="http://schemas.microsoft.com/office/drawing/2014/main" id="{B8364D9F-08D0-4C7C-B723-01E673ED449E}"/>
+                <a16:creationId xmlns:a16="http://schemas.microsoft.com/office/drawing/2014/main" id="{55BE9F48-850A-4719-BAD8-BB13475829BA}"/>
               </a:ext>
             </a:extLst>
           </p:cNvPr>
@@ -29003,7 +29093,7 @@
           <p:cNvPr id="21" name="partner-flow-25">
             <a:extLst xmlns:a="http://schemas.openxmlformats.org/drawingml/2006/main">
               <a:ext uri="{FF2B5EF4-FFF2-40B4-BE49-F238E27FC236}">
-                <a16:creationId xmlns:a16="http://schemas.microsoft.com/office/drawing/2014/main" id="{F071D189-F9BF-4DA5-9168-98269F5DCE54}"/>
+                <a16:creationId xmlns:a16="http://schemas.microsoft.com/office/drawing/2014/main" id="{4B82C371-FB07-4615-99C1-A8A06B45D679}"/>
               </a:ext>
             </a:extLst>
           </p:cNvPr>
@@ -29031,7 +29121,7 @@
           <p:cNvPr id="22" name="partner-flow-26">
             <a:extLst xmlns:a="http://schemas.openxmlformats.org/drawingml/2006/main">
               <a:ext uri="{FF2B5EF4-FFF2-40B4-BE49-F238E27FC236}">
-                <a16:creationId xmlns:a16="http://schemas.microsoft.com/office/drawing/2014/main" id="{932A0575-E41C-45C3-8213-B6082D2C17C0}"/>
+                <a16:creationId xmlns:a16="http://schemas.microsoft.com/office/drawing/2014/main" id="{AF833F3E-9D17-4EA9-86D6-DEBA212CEFC6}"/>
               </a:ext>
             </a:extLst>
           </p:cNvPr>
@@ -31827,7 +31917,7 @@
           <p:cNvPr id="16" name="partner-flow-45">
             <a:extLst xmlns:a="http://schemas.openxmlformats.org/drawingml/2006/main">
               <a:ext uri="{FF2B5EF4-FFF2-40B4-BE49-F238E27FC236}">
-                <a16:creationId xmlns:a16="http://schemas.microsoft.com/office/drawing/2014/main" id="{BF0B5158-ABC9-4EB8-9137-DC205F252D5A}"/>
+                <a16:creationId xmlns:a16="http://schemas.microsoft.com/office/drawing/2014/main" id="{103CC2A6-9C09-4481-B298-8FD3F0CABE7C}"/>
               </a:ext>
             </a:extLst>
           </p:cNvPr>
@@ -31856,7 +31946,7 @@
           <p:cNvPr id="17" name="partner-flow-46">
             <a:extLst xmlns:a="http://schemas.openxmlformats.org/drawingml/2006/main">
               <a:ext uri="{FF2B5EF4-FFF2-40B4-BE49-F238E27FC236}">
-                <a16:creationId xmlns:a16="http://schemas.microsoft.com/office/drawing/2014/main" id="{1F005D60-A7D1-453C-8232-55B4AA8442F2}"/>
+                <a16:creationId xmlns:a16="http://schemas.microsoft.com/office/drawing/2014/main" id="{328E6224-6DB6-47B9-887E-A8C433747DDC}"/>
               </a:ext>
             </a:extLst>
           </p:cNvPr>
@@ -31885,7 +31975,7 @@
           <p:cNvPr id="18" name="partner-flow-47">
             <a:extLst xmlns:a="http://schemas.openxmlformats.org/drawingml/2006/main">
               <a:ext uri="{FF2B5EF4-FFF2-40B4-BE49-F238E27FC236}">
-                <a16:creationId xmlns:a16="http://schemas.microsoft.com/office/drawing/2014/main" id="{76D5BFF4-5C3E-441F-AA2B-34D9BE2114FF}"/>
+                <a16:creationId xmlns:a16="http://schemas.microsoft.com/office/drawing/2014/main" id="{E2F2930F-FE5A-40BA-9D10-EF9261776194}"/>
               </a:ext>
             </a:extLst>
           </p:cNvPr>
@@ -31914,7 +32004,7 @@
           <p:cNvPr id="19" name="partner-flow-48">
             <a:extLst xmlns:a="http://schemas.openxmlformats.org/drawingml/2006/main">
               <a:ext uri="{FF2B5EF4-FFF2-40B4-BE49-F238E27FC236}">
-                <a16:creationId xmlns:a16="http://schemas.microsoft.com/office/drawing/2014/main" id="{E53C3C57-4859-411F-BA78-44C22FB8C8EC}"/>
+                <a16:creationId xmlns:a16="http://schemas.microsoft.com/office/drawing/2014/main" id="{4250851E-75DE-45DB-BF2B-3D2CEFACDAA2}"/>
               </a:ext>
             </a:extLst>
           </p:cNvPr>
@@ -31942,7 +32032,7 @@
           <p:cNvPr id="20" name="partner-flow-49">
             <a:extLst xmlns:a="http://schemas.openxmlformats.org/drawingml/2006/main">
               <a:ext uri="{FF2B5EF4-FFF2-40B4-BE49-F238E27FC236}">
-                <a16:creationId xmlns:a16="http://schemas.microsoft.com/office/drawing/2014/main" id="{5C2F8F74-6065-493C-80C4-31BA10419B46}"/>
+                <a16:creationId xmlns:a16="http://schemas.microsoft.com/office/drawing/2014/main" id="{7A3EDE25-93E7-459E-916F-546029B658FF}"/>
               </a:ext>
             </a:extLst>
           </p:cNvPr>
@@ -31970,7 +32060,7 @@
           <p:cNvPr id="21" name="partner-flow-50">
             <a:extLst xmlns:a="http://schemas.openxmlformats.org/drawingml/2006/main">
               <a:ext uri="{FF2B5EF4-FFF2-40B4-BE49-F238E27FC236}">
-                <a16:creationId xmlns:a16="http://schemas.microsoft.com/office/drawing/2014/main" id="{EA390FD5-D4F3-4908-BAEC-58F3AB93CFF3}"/>
+                <a16:creationId xmlns:a16="http://schemas.microsoft.com/office/drawing/2014/main" id="{E76EFA95-7777-4948-85FD-1938B1A1AEB0}"/>
               </a:ext>
             </a:extLst>
           </p:cNvPr>
@@ -32168,7 +32258,7 @@
           <p:cNvPr id="23" name="partner-flow-52">
             <a:extLst xmlns:a="http://schemas.openxmlformats.org/drawingml/2006/main">
               <a:ext uri="{FF2B5EF4-FFF2-40B4-BE49-F238E27FC236}">
-                <a16:creationId xmlns:a16="http://schemas.microsoft.com/office/drawing/2014/main" id="{CF8CFD3E-BA2F-437C-BF82-47F00E90CE76}"/>
+                <a16:creationId xmlns:a16="http://schemas.microsoft.com/office/drawing/2014/main" id="{533D558D-2C9F-42BB-945D-2A51DE506835}"/>
               </a:ext>
             </a:extLst>
           </p:cNvPr>
@@ -32196,7 +32286,7 @@
           <p:cNvPr id="24" name="partner-flow-53">
             <a:extLst xmlns:a="http://schemas.openxmlformats.org/drawingml/2006/main">
               <a:ext uri="{FF2B5EF4-FFF2-40B4-BE49-F238E27FC236}">
-                <a16:creationId xmlns:a16="http://schemas.microsoft.com/office/drawing/2014/main" id="{61D9FF73-67BB-4E9C-B70C-2D657C6143C5}"/>
+                <a16:creationId xmlns:a16="http://schemas.microsoft.com/office/drawing/2014/main" id="{306B542C-5136-4807-A7CE-186DDBB1C555}"/>
               </a:ext>
             </a:extLst>
           </p:cNvPr>
@@ -32224,7 +32314,7 @@
           <p:cNvPr id="25" name="partner-flow-54">
             <a:extLst xmlns:a="http://schemas.openxmlformats.org/drawingml/2006/main">
               <a:ext uri="{FF2B5EF4-FFF2-40B4-BE49-F238E27FC236}">
-                <a16:creationId xmlns:a16="http://schemas.microsoft.com/office/drawing/2014/main" id="{08F64F45-C65D-4E5A-B576-A44C7B6E30B0}"/>
+                <a16:creationId xmlns:a16="http://schemas.microsoft.com/office/drawing/2014/main" id="{E8B96621-1E68-42BC-BAD3-98CE12D32ABA}"/>
               </a:ext>
             </a:extLst>
           </p:cNvPr>
@@ -33363,7 +33453,7 @@
           <p:cNvPr id="33" name="changed-assertions-edge-label-leader">
             <a:extLst xmlns:a="http://schemas.openxmlformats.org/drawingml/2006/main">
               <a:ext uri="{FF2B5EF4-FFF2-40B4-BE49-F238E27FC236}">
-                <a16:creationId xmlns:a16="http://schemas.microsoft.com/office/drawing/2014/main" id="{63930AA4-B411-4BE7-8B3B-A9101043AE4B}"/>
+                <a16:creationId xmlns:a16="http://schemas.microsoft.com/office/drawing/2014/main" id="{DD8138AA-E52F-4D3E-B262-1AF9645ACD53}"/>
               </a:ext>
             </a:extLst>
           </p:cNvPr>
@@ -33758,7 +33848,7 @@
           <p:cNvPr id="5" name="">
             <a:extLst xmlns:a="http://schemas.openxmlformats.org/drawingml/2006/main">
               <a:ext uri="{FF2B5EF4-FFF2-40B4-BE49-F238E27FC236}">
-                <a16:creationId xmlns:a16="http://schemas.microsoft.com/office/drawing/2014/main" id="{D7C7D9F5-AFF3-4125-AFC4-D0479A1B8CEB}"/>
+                <a16:creationId xmlns:a16="http://schemas.microsoft.com/office/drawing/2014/main" id="{EBD71CBF-DD61-4D85-A7AA-687ADB0D55EE}"/>
               </a:ext>
             </a:extLst>
           </p:cNvPr>
@@ -34371,7 +34461,7 @@
                           <a:ea typeface="Aptos"/>
                           <a:cs typeface="Aptos"/>
                         </a:rPr>
-                        <a:t>Packet-v2 contract/freeze core merged</a:t>
+                        <a:t>Native exact-action capture merged</a:t>
                       </a:r>
                     </a:p>
                   </a:txBody>
@@ -34409,7 +34499,7 @@
                           <a:ea typeface="Aptos"/>
                           <a:cs typeface="Aptos"/>
                         </a:rPr>
-                        <a:t>Connect native capture and current access</a:t>
+                        <a:t>Qualify draft UI and current access</a:t>
                       </a:r>
                     </a:p>
                     <a:p>
@@ -34776,7 +34866,7 @@
                           <a:ea typeface="Aptos"/>
                           <a:cs typeface="Aptos"/>
                         </a:rPr>
-                        <a:t>Existing authorized Buzz agent</a:t>
+                        <a:t>Native roles and checkout</a:t>
                       </a:r>
                     </a:p>
                   </a:txBody>
@@ -34814,7 +34904,7 @@
                           <a:ea typeface="Aptos"/>
                           <a:cs typeface="Aptos"/>
                         </a:rPr>
-                        <a:t>Qualify actual contribution path</a:t>
+                        <a:t>Test funding and member objectives</a:t>
                       </a:r>
                     </a:p>
                     <a:p>
@@ -34827,7 +34917,7 @@
                           <a:ea typeface="Aptos"/>
                           <a:cs typeface="Aptos"/>
                         </a:rPr>
-                        <a:t>Untrusted isolation remains separate</a:t>
+                        <a:t>Human approval stays separate</a:t>
                       </a:r>
                     </a:p>
                   </a:txBody>
@@ -35554,7 +35644,7 @@
                 <a:ea typeface="Aptos"/>
                 <a:cs typeface="Aptos"/>
               </a:rPr>
-              <a:t>Current target</a:t>
+              <a:t>Priority outcomes</a:t>
             </a:r>
           </a:p>
         </p:txBody>
@@ -35723,7 +35813,7 @@
                 <a:ea typeface="Aptos"/>
                 <a:cs typeface="Aptos"/>
               </a:rPr>
-              <a:t>Integration and rehearsal</a:t>
+              <a:t>Remaining work in order</a:t>
             </a:r>
           </a:p>
         </p:txBody>
@@ -36240,7 +36330,7 @@
           <p:cNvPr id="9" name="flow-217">
             <a:extLst xmlns:a="http://schemas.openxmlformats.org/drawingml/2006/main">
               <a:ext uri="{FF2B5EF4-FFF2-40B4-BE49-F238E27FC236}">
-                <a16:creationId xmlns:a16="http://schemas.microsoft.com/office/drawing/2014/main" id="{87CB30DD-4CCF-4580-B6CD-8B7A4F23DE35}"/>
+                <a16:creationId xmlns:a16="http://schemas.microsoft.com/office/drawing/2014/main" id="{10C31AF1-B497-4BAC-906E-86EC045C4E95}"/>
               </a:ext>
             </a:extLst>
           </p:cNvPr>
@@ -36269,7 +36359,7 @@
           <p:cNvPr id="10" name="flow-218">
             <a:extLst xmlns:a="http://schemas.openxmlformats.org/drawingml/2006/main">
               <a:ext uri="{FF2B5EF4-FFF2-40B4-BE49-F238E27FC236}">
-                <a16:creationId xmlns:a16="http://schemas.microsoft.com/office/drawing/2014/main" id="{33F0527C-7E8D-4E7D-B7BB-62E7DD49B573}"/>
+                <a16:creationId xmlns:a16="http://schemas.microsoft.com/office/drawing/2014/main" id="{F3084C09-5310-4E11-B63C-FBB12BCFEA3B}"/>
               </a:ext>
             </a:extLst>
           </p:cNvPr>
@@ -36505,7 +36595,7 @@
                 <a:ea typeface="Aptos"/>
                 <a:cs typeface="Aptos"/>
               </a:rPr>
-              <a:t>V1/v2 packet source</a:t>
+              <a:t>V2 core and native capture</a:t>
             </a:r>
           </a:p>
           <a:p xmlns:a="http://schemas.openxmlformats.org/drawingml/2006/main">
@@ -37035,7 +37125,7 @@
                 <a:ea typeface="Aptos"/>
                 <a:cs typeface="Aptos"/>
               </a:rPr>
-              <a:t>Actual source and tool bindings</a:t>
+              <a:t>1 Funding research and draft</a:t>
             </a:r>
           </a:p>
           <a:p xmlns:a="http://schemas.openxmlformats.org/drawingml/2006/main">
@@ -37059,7 +37149,7 @@
                 <a:ea typeface="Aptos"/>
                 <a:cs typeface="Aptos"/>
               </a:rPr>
-              <a:t>Current member / application access</a:t>
+              <a:t>2 SQL admission and reuse</a:t>
             </a:r>
           </a:p>
           <a:p xmlns:a="http://schemas.openxmlformats.org/drawingml/2006/main">
@@ -37083,7 +37173,7 @@
                 <a:ea typeface="Aptos"/>
                 <a:cs typeface="Aptos"/>
               </a:rPr>
-              <a:t>Generated draft and measured run</a:t>
+              <a:t>3 Member review to durable result</a:t>
             </a:r>
           </a:p>
           <a:p xmlns:a="http://schemas.openxmlformats.org/drawingml/2006/main">
@@ -37107,7 +37197,7 @@
                 <a:ea typeface="Aptos"/>
                 <a:cs typeface="Aptos"/>
               </a:rPr>
-              <a:t>Correction, replay and denied action</a:t>
+              <a:t>4 Meeting / bounty collaboration</a:t>
             </a:r>
           </a:p>
           <a:p xmlns:a="http://schemas.openxmlformats.org/drawingml/2006/main">
@@ -37131,7 +37221,7 @@
                 <a:ea typeface="Aptos"/>
                 <a:cs typeface="Aptos"/>
               </a:rPr>
-              <a:t>V2 live human walkthrough</a:t>
+              <a:t>5 Meeting publish and readback</a:t>
             </a:r>
           </a:p>
           <a:p xmlns:a="http://schemas.openxmlformats.org/drawingml/2006/main">
@@ -37155,7 +37245,7 @@
                 <a:ea typeface="Aptos"/>
                 <a:cs typeface="Aptos"/>
               </a:rPr>
-              <a:t>Friday Oct 30, 11am CDT entry</a:t>
+              <a:t>6 Measured rehearsal</a:t>
             </a:r>
           </a:p>
           <a:p xmlns:a="http://schemas.openxmlformats.org/drawingml/2006/main">
@@ -37179,7 +37269,7 @@
                 <a:ea typeface="Aptos"/>
                 <a:cs typeface="Aptos"/>
               </a:rPr>
-              <a:t>Qualified recording and roster</a:t>
+              <a:t>Friday Oct 30, 11am CDT entry</a:t>
             </a:r>
           </a:p>
         </p:txBody>
@@ -37189,7 +37279,7 @@
           <p:cNvPr id="14" name="flow-222">
             <a:extLst xmlns:a="http://schemas.openxmlformats.org/drawingml/2006/main">
               <a:ext uri="{FF2B5EF4-FFF2-40B4-BE49-F238E27FC236}">
-                <a16:creationId xmlns:a16="http://schemas.microsoft.com/office/drawing/2014/main" id="{384B3AD5-7A71-453C-9CEE-63E991E2FD75}"/>
+                <a16:creationId xmlns:a16="http://schemas.microsoft.com/office/drawing/2014/main" id="{301A796B-AD0D-42EC-A506-0A5EA28BEF78}"/>
               </a:ext>
             </a:extLst>
           </p:cNvPr>

</xml_diff>

<commit_message>
docs: sync r25 native delivery and preproduction status
</commit_message>
<xml_diff>
--- a/Inertia-Architecture.pptx
+++ b/Inertia-Architecture.pptx
@@ -2,21 +2,21 @@
 <file path=ppt/presentation.xml><?xml version="1.0" encoding="utf-8"?>
 <p:presentation xmlns:p="http://schemas.openxmlformats.org/presentationml/2006/main">
   <p:sldMasterIdLst>
-    <p:sldMasterId xmlns:r="http://schemas.openxmlformats.org/officeDocument/2006/relationships" id="2147483648" r:id="Re691d457a91043a0"/>
+    <p:sldMasterId xmlns:r="http://schemas.openxmlformats.org/officeDocument/2006/relationships" id="2147483648" r:id="Ra6c45da0d57f4202"/>
   </p:sldMasterIdLst>
   <p:notesMasterIdLst>
-    <p:notesMasterId xmlns:r="http://schemas.openxmlformats.org/officeDocument/2006/relationships" r:id="R6d7917bc560d457c"/>
+    <p:notesMasterId xmlns:r="http://schemas.openxmlformats.org/officeDocument/2006/relationships" r:id="R5f5f99c8012c4c93"/>
   </p:notesMasterIdLst>
   <p:sldIdLst>
-    <p:sldId xmlns:r="http://schemas.openxmlformats.org/officeDocument/2006/relationships" id="256" r:id="R0fedb4e012c341c2"/>
-    <p:sldId xmlns:r="http://schemas.openxmlformats.org/officeDocument/2006/relationships" id="257" r:id="R6a3a954ac17c488b"/>
-    <p:sldId xmlns:r="http://schemas.openxmlformats.org/officeDocument/2006/relationships" id="258" r:id="R172aafb786e7425f"/>
-    <p:sldId xmlns:r="http://schemas.openxmlformats.org/officeDocument/2006/relationships" id="259" r:id="Ra964bf0368a248da"/>
-    <p:sldId xmlns:r="http://schemas.openxmlformats.org/officeDocument/2006/relationships" id="260" r:id="R5bbb8aebe3a84b9c"/>
-    <p:sldId xmlns:r="http://schemas.openxmlformats.org/officeDocument/2006/relationships" id="261" r:id="Rf1a6a06db2da42fe"/>
-    <p:sldId xmlns:r="http://schemas.openxmlformats.org/officeDocument/2006/relationships" id="262" r:id="Rfc786949916b408b"/>
-    <p:sldId xmlns:r="http://schemas.openxmlformats.org/officeDocument/2006/relationships" id="263" r:id="R9d40d8509a514db6"/>
-    <p:sldId xmlns:r="http://schemas.openxmlformats.org/officeDocument/2006/relationships" id="264" r:id="Rd6a4bc2316e74b5f"/>
+    <p:sldId xmlns:r="http://schemas.openxmlformats.org/officeDocument/2006/relationships" id="256" r:id="R1c59b84ea7594b57"/>
+    <p:sldId xmlns:r="http://schemas.openxmlformats.org/officeDocument/2006/relationships" id="257" r:id="Rb321bc3e704343f4"/>
+    <p:sldId xmlns:r="http://schemas.openxmlformats.org/officeDocument/2006/relationships" id="258" r:id="Ra10407449ef740b9"/>
+    <p:sldId xmlns:r="http://schemas.openxmlformats.org/officeDocument/2006/relationships" id="259" r:id="R5826496e08a64aab"/>
+    <p:sldId xmlns:r="http://schemas.openxmlformats.org/officeDocument/2006/relationships" id="260" r:id="Rbb44a07840a04c92"/>
+    <p:sldId xmlns:r="http://schemas.openxmlformats.org/officeDocument/2006/relationships" id="261" r:id="R01e37d853ab9441b"/>
+    <p:sldId xmlns:r="http://schemas.openxmlformats.org/officeDocument/2006/relationships" id="262" r:id="Ra5e98dee0aa440c1"/>
+    <p:sldId xmlns:r="http://schemas.openxmlformats.org/officeDocument/2006/relationships" id="263" r:id="R11f9065c3a044367"/>
+    <p:sldId xmlns:r="http://schemas.openxmlformats.org/officeDocument/2006/relationships" id="264" r:id="R44af1ad8029a4c83"/>
   </p:sldIdLst>
   <p:sldSz cx="15240000" cy="8572500"/>
   <p:notesSz cx="6858000" cy="9144000"/>
@@ -870,7 +870,7 @@
           </a:p>
           <a:p xmlns:a="http://schemas.openxmlformats.org/drawingml/2006/main">
             <a:r>
-              <a:t>V2 packet primitives are merged in https://github.com/NetRxn/Inertia/pull/56. Native exact-action capture is merged in PR58. Packet UI/attestation is reviewed draft PR62, not merged/live; browser, real authorization/runtime/domain/Buzz and actual provider/human execution remain pending. Preserve original authenticated actor, exact packet/version/policy, current action rights, stale/conflict denial and authoritative readback. No named application owner or default five-specialist setup is needed.</a:t>
+              <a:t>V2 packet primitives are merged in https://github.com/NetRxn/Inertia/pull/56. Native exact-action capture is merged in PR58. Packet UI/attestation is reviewed draft PR62, not merged/live; browser, real authorization/runtime/domain/Buzz and production provider/human workflow remains pending. Preserve original authenticated actor, exact packet/version/policy, current action rights, stale/conflict denial and authoritative readback. No named application owner or default five-specialist setup is needed.</a:t>
             </a:r>
           </a:p>
           <a:p xmlns:a="http://schemas.openxmlformats.org/drawingml/2006/main">
@@ -900,7 +900,7 @@
           </a:p>
           <a:p xmlns:a="http://schemas.openxmlformats.org/drawingml/2006/main">
             <a:r>
-              <a:t>Two-provider test preparation maps funding to existing R-F01–04/R-F06–08, R-K01–08, R-C01–05 and R-O01; general member/bounty objectives map to R-I01–04, R-C01–05 and R-O01. Use existing T-K05/T-K10/T-K12 and T-C01–04. Separate workspace/history and configurable roles; no model run or successful native coordination is claimed. The owning-service member-domain adapter and Inertia result readback are merged, not activated. Full-checkout and public-package checks passed within source scope. Native event delivery, current-member authority and transport integration remain pending; no operational end-to-end or live completion is claimed. Public source: https://github.com/NetRxn/Inertia/pull/63.</a:t>
+              <a:t>Two-provider test preparation maps funding to existing R-F01–04/R-F06–08, R-K01–08, R-C01–05 and R-O01; general member/bounty objectives map to R-I01–04, R-C01–05 and R-O01. Use existing T-K05/T-K10/T-K12 and T-C01–04. Separate workspace/history and configurable roles; no substantial funding run or successful multi-agent rehearsal is claimed. Native delivery and the owning-service implementation are merged, activation disabled. Connected disposable native approval and frozen Task2 submission produced real PostgreSQL effects; replay, lost-response recovery and retained readback after source-transport revocation passed with synthetic current authority. Actual original-human current DAO authority and production transport/member integration remain pending. PR62 UI remains draft; controlled evidence does not establish a production workflow. Public source: https://github.com/NetRxn/Inertia/pull/66.</a:t>
             </a:r>
           </a:p>
         </p:txBody>
@@ -1210,7 +1210,7 @@
           </a:p>
           <a:p xmlns:a="http://schemas.openxmlformats.org/drawingml/2006/main">
             <a:r>
-              <a:t>Engineering owns the remaining native/Buzz member-action and submitted-record wiring, actual system-generated research/draft/critique, SQL writeback/reuse, runbook/video and measurements. Packet-v2 core and native capture source are merged in PR56/PR58; Packet UI/attestation is reviewed draft https://github.com/NetRxn/Inertia/pull/62, not merged/live. Named owning-domain SQL tools have merged source/local PostgreSQL facade qualification. Real resolver/transport/provider execution and end-to-end member action remain unqualified. Team contacts are operational contacts, not named application approval owners. No new permissions, deployment, deletion, account or external submission is performed.</a:t>
+              <a:t>Engineering owns the remaining native/Buzz member-action and submitted-record wiring, actual system-generated research/draft/critique, SQL writeback/reuse, runbook/video and measurements. Packet-v2 core and native capture source are merged in PR56/PR58; Packet UI/attestation is reviewed draft https://github.com/NetRxn/Inertia/pull/62, not merged/live. Named owning-domain SQL tools have merged source/local PostgreSQL facade qualification. Production resolver/transport/provider execution and end-to-end member action remain unqualified. Team contacts are operational contacts, not named application approval owners. No new permissions, deployment, deletion, account or external submission is performed.</a:t>
             </a:r>
           </a:p>
           <a:p xmlns:a="http://schemas.openxmlformats.org/drawingml/2006/main">
@@ -1230,7 +1230,7 @@
           </a:p>
           <a:p xmlns:a="http://schemas.openxmlformats.org/drawingml/2006/main">
             <a:r>
-              <a:t>Reuse existing references; this is an interface map, not a new owner/dependency/handoff register. John plans shared runtime deployment before Wednesday. Laptop Docker is sufficient for local development with his own credentials. The cloud CLI failed at read-only Codex-home writes before authentication/model execution, not for a demonstrated API-key requirement. New sign-in requires exact approval.</a:t>
+              <a:t>Reuse existing references; this is an interface map, not a new owner/dependency/handoff register. John plans shared runtime deployment before Wednesday. Docker preproduction Paperclip-to-Codex subscription smoke passed with the expected short output and no API key. Single-provider workflow qualification, including substantial funding research/draft/reuse, is next. Claude CLI is installed; connection/inference waits until Monday, with the two-provider rehearsal later. Meeting/member integration remains pending.</a:t>
             </a:r>
           </a:p>
         </p:txBody>
@@ -3803,12 +3803,12 @@
   </p:cSld>
   <p:clrMap bg1="lt1" tx1="dk1" bg2="lt2" tx2="dk2" accent1="accent1" accent2="accent2" accent3="accent3" accent4="accent4" accent5="accent5" accent6="accent6" hlink="hlink" folHlink="folHlink"/>
   <p:sldLayoutIdLst>
-    <p:sldLayoutId xmlns:r="http://schemas.openxmlformats.org/officeDocument/2006/relationships" id="2147483649" r:id="Rd8f74dfe61a848ad"/>
-    <p:sldLayoutId xmlns:r="http://schemas.openxmlformats.org/officeDocument/2006/relationships" id="2147483650" r:id="R15eb50a0fa5b4fb7"/>
-    <p:sldLayoutId xmlns:r="http://schemas.openxmlformats.org/officeDocument/2006/relationships" id="2147483651" r:id="Rd8bb0ea592f6453c"/>
-    <p:sldLayoutId xmlns:r="http://schemas.openxmlformats.org/officeDocument/2006/relationships" id="2147483652" r:id="R3def14decf4746a1"/>
-    <p:sldLayoutId xmlns:r="http://schemas.openxmlformats.org/officeDocument/2006/relationships" id="2147483653" r:id="R75e4ebea60df49f8"/>
-    <p:sldLayoutId xmlns:r="http://schemas.openxmlformats.org/officeDocument/2006/relationships" id="2147483654" r:id="Rf692c337f562415a"/>
+    <p:sldLayoutId xmlns:r="http://schemas.openxmlformats.org/officeDocument/2006/relationships" id="2147483649" r:id="R9632ce175b524157"/>
+    <p:sldLayoutId xmlns:r="http://schemas.openxmlformats.org/officeDocument/2006/relationships" id="2147483650" r:id="Rb10a8c200e6747c7"/>
+    <p:sldLayoutId xmlns:r="http://schemas.openxmlformats.org/officeDocument/2006/relationships" id="2147483651" r:id="Rab8c1d763c1b4686"/>
+    <p:sldLayoutId xmlns:r="http://schemas.openxmlformats.org/officeDocument/2006/relationships" id="2147483652" r:id="R885e70f5d1344733"/>
+    <p:sldLayoutId xmlns:r="http://schemas.openxmlformats.org/officeDocument/2006/relationships" id="2147483653" r:id="R976307571e144f89"/>
+    <p:sldLayoutId xmlns:r="http://schemas.openxmlformats.org/officeDocument/2006/relationships" id="2147483654" r:id="R7c404d410d3f41b3"/>
   </p:sldLayoutIdLst>
   <p:txStyles>
     <p:titleStyle>
@@ -4359,7 +4359,7 @@
           <p:cNvPr id="39" name="">
             <a:extLst xmlns:a="http://schemas.openxmlformats.org/drawingml/2006/main">
               <a:ext uri="{FF2B5EF4-FFF2-40B4-BE49-F238E27FC236}">
-                <a16:creationId xmlns:a16="http://schemas.microsoft.com/office/drawing/2014/main" id="{7FA8B869-90AB-49D3-8F0F-245C0D14BB0E}"/>
+                <a16:creationId xmlns:a16="http://schemas.microsoft.com/office/drawing/2014/main" id="{5E0386CB-2A9C-464E-91C4-0CB2F2848F58}"/>
               </a:ext>
             </a:extLst>
           </p:cNvPr>
@@ -4392,7 +4392,7 @@
           <p:cNvPr id="32" name="">
             <a:extLst xmlns:a="http://schemas.openxmlformats.org/drawingml/2006/main">
               <a:ext uri="{FF2B5EF4-FFF2-40B4-BE49-F238E27FC236}">
-                <a16:creationId xmlns:a16="http://schemas.microsoft.com/office/drawing/2014/main" id="{21A8C252-84F4-4DF4-92C5-F75301C0CFA6}"/>
+                <a16:creationId xmlns:a16="http://schemas.microsoft.com/office/drawing/2014/main" id="{48FF9E57-53DC-466D-B56B-838E54EFF9CD}"/>
               </a:ext>
             </a:extLst>
           </p:cNvPr>
@@ -4424,7 +4424,7 @@
           <p:cNvPr id="29" name="">
             <a:extLst xmlns:a="http://schemas.openxmlformats.org/drawingml/2006/main">
               <a:ext uri="{FF2B5EF4-FFF2-40B4-BE49-F238E27FC236}">
-                <a16:creationId xmlns:a16="http://schemas.microsoft.com/office/drawing/2014/main" id="{F56FFB93-9D8C-4B5E-9887-7564F0A420AF}"/>
+                <a16:creationId xmlns:a16="http://schemas.microsoft.com/office/drawing/2014/main" id="{EF03239E-7EB2-484D-8876-421F252ED4CE}"/>
               </a:ext>
             </a:extLst>
           </p:cNvPr>
@@ -8197,7 +8197,7 @@
           <p:cNvPr id="30" name="flow-29">
             <a:extLst xmlns:a="http://schemas.openxmlformats.org/drawingml/2006/main">
               <a:ext uri="{FF2B5EF4-FFF2-40B4-BE49-F238E27FC236}">
-                <a16:creationId xmlns:a16="http://schemas.microsoft.com/office/drawing/2014/main" id="{DB00AF9F-B684-4FBF-9CDB-E98EB3F66599}"/>
+                <a16:creationId xmlns:a16="http://schemas.microsoft.com/office/drawing/2014/main" id="{6DA7E072-756B-423A-9624-B0213C3D9BC2}"/>
               </a:ext>
             </a:extLst>
           </p:cNvPr>
@@ -8227,7 +8227,7 @@
           <p:cNvPr id="31" name="flow-30">
             <a:extLst xmlns:a="http://schemas.openxmlformats.org/drawingml/2006/main">
               <a:ext uri="{FF2B5EF4-FFF2-40B4-BE49-F238E27FC236}">
-                <a16:creationId xmlns:a16="http://schemas.microsoft.com/office/drawing/2014/main" id="{409058CF-2392-4715-8993-61A274F9A1B9}"/>
+                <a16:creationId xmlns:a16="http://schemas.microsoft.com/office/drawing/2014/main" id="{87D75D4A-3345-4E3E-8231-EEE4662B3587}"/>
               </a:ext>
             </a:extLst>
           </p:cNvPr>
@@ -8426,7 +8426,7 @@
           <p:cNvPr id="34" name="flow-32">
             <a:extLst xmlns:a="http://schemas.openxmlformats.org/drawingml/2006/main">
               <a:ext uri="{FF2B5EF4-FFF2-40B4-BE49-F238E27FC236}">
-                <a16:creationId xmlns:a16="http://schemas.microsoft.com/office/drawing/2014/main" id="{058DE65F-BB4D-495A-94BE-D7E82E5BC08A}"/>
+                <a16:creationId xmlns:a16="http://schemas.microsoft.com/office/drawing/2014/main" id="{915E546F-6A24-4AB6-9EA1-3A7825EC6317}"/>
               </a:ext>
             </a:extLst>
           </p:cNvPr>
@@ -8455,7 +8455,7 @@
           <p:cNvPr id="35" name="flow-33">
             <a:extLst xmlns:a="http://schemas.openxmlformats.org/drawingml/2006/main">
               <a:ext uri="{FF2B5EF4-FFF2-40B4-BE49-F238E27FC236}">
-                <a16:creationId xmlns:a16="http://schemas.microsoft.com/office/drawing/2014/main" id="{F79640FF-2CDC-425F-A9A5-ECFF42FE82F9}"/>
+                <a16:creationId xmlns:a16="http://schemas.microsoft.com/office/drawing/2014/main" id="{FDC9A76D-39E5-495B-8F8A-13DCC5F87B2D}"/>
               </a:ext>
             </a:extLst>
           </p:cNvPr>
@@ -8483,7 +8483,7 @@
           <p:cNvPr id="36" name="flow-34">
             <a:extLst xmlns:a="http://schemas.openxmlformats.org/drawingml/2006/main">
               <a:ext uri="{FF2B5EF4-FFF2-40B4-BE49-F238E27FC236}">
-                <a16:creationId xmlns:a16="http://schemas.microsoft.com/office/drawing/2014/main" id="{B1CCE3CA-7FE8-4758-99EA-7DC5E3155868}"/>
+                <a16:creationId xmlns:a16="http://schemas.microsoft.com/office/drawing/2014/main" id="{B02C2959-310F-47B0-98D3-450003CEE6C5}"/>
               </a:ext>
             </a:extLst>
           </p:cNvPr>
@@ -8681,7 +8681,7 @@
           <p:cNvPr id="38" name="flow-36">
             <a:extLst xmlns:a="http://schemas.openxmlformats.org/drawingml/2006/main">
               <a:ext uri="{FF2B5EF4-FFF2-40B4-BE49-F238E27FC236}">
-                <a16:creationId xmlns:a16="http://schemas.microsoft.com/office/drawing/2014/main" id="{7715CF72-E735-4E2A-A356-072D5951FEAA}"/>
+                <a16:creationId xmlns:a16="http://schemas.microsoft.com/office/drawing/2014/main" id="{ED535B0E-98E0-4B41-9681-5C953289C1FA}"/>
               </a:ext>
             </a:extLst>
           </p:cNvPr>
@@ -8909,7 +8909,7 @@
           <p:cNvPr id="35" name="">
             <a:extLst xmlns:a="http://schemas.openxmlformats.org/drawingml/2006/main">
               <a:ext uri="{FF2B5EF4-FFF2-40B4-BE49-F238E27FC236}">
-                <a16:creationId xmlns:a16="http://schemas.microsoft.com/office/drawing/2014/main" id="{D75AD070-7C82-4457-97EB-1B87431A1251}"/>
+                <a16:creationId xmlns:a16="http://schemas.microsoft.com/office/drawing/2014/main" id="{7928B86D-C224-4CB6-B805-8E8E0E371440}"/>
               </a:ext>
             </a:extLst>
           </p:cNvPr>
@@ -8941,7 +8941,7 @@
           <p:cNvPr id="21" name="">
             <a:extLst xmlns:a="http://schemas.openxmlformats.org/drawingml/2006/main">
               <a:ext uri="{FF2B5EF4-FFF2-40B4-BE49-F238E27FC236}">
-                <a16:creationId xmlns:a16="http://schemas.microsoft.com/office/drawing/2014/main" id="{584B719B-06D0-465E-AE0B-1A1256C79427}"/>
+                <a16:creationId xmlns:a16="http://schemas.microsoft.com/office/drawing/2014/main" id="{E5849EFD-86E2-4D15-B649-D66743A45092}"/>
               </a:ext>
             </a:extLst>
           </p:cNvPr>
@@ -8973,7 +8973,7 @@
           <p:cNvPr id="20" name="">
             <a:extLst xmlns:a="http://schemas.openxmlformats.org/drawingml/2006/main">
               <a:ext uri="{FF2B5EF4-FFF2-40B4-BE49-F238E27FC236}">
-                <a16:creationId xmlns:a16="http://schemas.microsoft.com/office/drawing/2014/main" id="{F58F24E6-3A81-4C0E-BBAA-C07C34F50E9D}"/>
+                <a16:creationId xmlns:a16="http://schemas.microsoft.com/office/drawing/2014/main" id="{09752710-DF51-4C37-9A1C-DF20A68236F1}"/>
               </a:ext>
             </a:extLst>
           </p:cNvPr>
@@ -9005,7 +9005,7 @@
           <p:cNvPr id="19" name="">
             <a:extLst xmlns:a="http://schemas.openxmlformats.org/drawingml/2006/main">
               <a:ext uri="{FF2B5EF4-FFF2-40B4-BE49-F238E27FC236}">
-                <a16:creationId xmlns:a16="http://schemas.microsoft.com/office/drawing/2014/main" id="{52E2C1D4-9504-4292-8C66-306CFCE17062}"/>
+                <a16:creationId xmlns:a16="http://schemas.microsoft.com/office/drawing/2014/main" id="{54C9ECD6-3591-4051-9BA4-7597E06C9034}"/>
               </a:ext>
             </a:extLst>
           </p:cNvPr>
@@ -9037,7 +9037,7 @@
           <p:cNvPr id="18" name="">
             <a:extLst xmlns:a="http://schemas.openxmlformats.org/drawingml/2006/main">
               <a:ext uri="{FF2B5EF4-FFF2-40B4-BE49-F238E27FC236}">
-                <a16:creationId xmlns:a16="http://schemas.microsoft.com/office/drawing/2014/main" id="{4EA6C6D7-B1AD-4134-9FFD-B15971681106}"/>
+                <a16:creationId xmlns:a16="http://schemas.microsoft.com/office/drawing/2014/main" id="{233A2E10-6F48-4066-A163-A930135B7C45}"/>
               </a:ext>
             </a:extLst>
           </p:cNvPr>
@@ -12196,7 +12196,7 @@
           <p:cNvPr id="28" name="flow-61">
             <a:extLst xmlns:a="http://schemas.openxmlformats.org/drawingml/2006/main">
               <a:ext uri="{FF2B5EF4-FFF2-40B4-BE49-F238E27FC236}">
-                <a16:creationId xmlns:a16="http://schemas.microsoft.com/office/drawing/2014/main" id="{7BA58286-D406-4B19-8F31-AE6DB80B91F6}"/>
+                <a16:creationId xmlns:a16="http://schemas.microsoft.com/office/drawing/2014/main" id="{912882D7-4176-45A2-9FEE-781D540DCEC8}"/>
               </a:ext>
             </a:extLst>
           </p:cNvPr>
@@ -12394,7 +12394,7 @@
           <p:cNvPr id="30" name="flow-63">
             <a:extLst xmlns:a="http://schemas.openxmlformats.org/drawingml/2006/main">
               <a:ext uri="{FF2B5EF4-FFF2-40B4-BE49-F238E27FC236}">
-                <a16:creationId xmlns:a16="http://schemas.microsoft.com/office/drawing/2014/main" id="{D332619A-CE6F-46E1-BB3F-57BCB1BCCACC}"/>
+                <a16:creationId xmlns:a16="http://schemas.microsoft.com/office/drawing/2014/main" id="{171D0F8A-8F5C-48E0-84E0-3B4631DBCD3F}"/>
               </a:ext>
             </a:extLst>
           </p:cNvPr>
@@ -12422,7 +12422,7 @@
           <p:cNvPr id="31" name="flow-64">
             <a:extLst xmlns:a="http://schemas.openxmlformats.org/drawingml/2006/main">
               <a:ext uri="{FF2B5EF4-FFF2-40B4-BE49-F238E27FC236}">
-                <a16:creationId xmlns:a16="http://schemas.microsoft.com/office/drawing/2014/main" id="{D1646ACE-63CC-46CA-8658-05E2DFDE404E}"/>
+                <a16:creationId xmlns:a16="http://schemas.microsoft.com/office/drawing/2014/main" id="{165F5805-1941-4664-A9D1-F3AD9B74A63A}"/>
               </a:ext>
             </a:extLst>
           </p:cNvPr>
@@ -12450,7 +12450,7 @@
           <p:cNvPr id="32" name="flow-65">
             <a:extLst xmlns:a="http://schemas.openxmlformats.org/drawingml/2006/main">
               <a:ext uri="{FF2B5EF4-FFF2-40B4-BE49-F238E27FC236}">
-                <a16:creationId xmlns:a16="http://schemas.microsoft.com/office/drawing/2014/main" id="{C34592A8-9DAC-4660-B21E-778A2A1A738E}"/>
+                <a16:creationId xmlns:a16="http://schemas.microsoft.com/office/drawing/2014/main" id="{A207FCE3-AF5E-4BE0-835D-723C76091E10}"/>
               </a:ext>
             </a:extLst>
           </p:cNvPr>
@@ -12478,7 +12478,7 @@
           <p:cNvPr id="33" name="flow-66">
             <a:extLst xmlns:a="http://schemas.openxmlformats.org/drawingml/2006/main">
               <a:ext uri="{FF2B5EF4-FFF2-40B4-BE49-F238E27FC236}">
-                <a16:creationId xmlns:a16="http://schemas.microsoft.com/office/drawing/2014/main" id="{1526C849-C2A1-487D-A2AB-062F507BCF8C}"/>
+                <a16:creationId xmlns:a16="http://schemas.microsoft.com/office/drawing/2014/main" id="{C70491CF-03A0-4BE8-BF2B-11733C3C0089}"/>
               </a:ext>
             </a:extLst>
           </p:cNvPr>
@@ -13043,7 +13043,7 @@
           <p:cNvPr id="18" name="">
             <a:extLst xmlns:a="http://schemas.openxmlformats.org/drawingml/2006/main">
               <a:ext uri="{FF2B5EF4-FFF2-40B4-BE49-F238E27FC236}">
-                <a16:creationId xmlns:a16="http://schemas.microsoft.com/office/drawing/2014/main" id="{2BDD1F9E-D22C-4B42-9138-BBDCD180D619}"/>
+                <a16:creationId xmlns:a16="http://schemas.microsoft.com/office/drawing/2014/main" id="{42A81A05-7E6E-409F-AF49-AD50FFCAAAD2}"/>
               </a:ext>
             </a:extLst>
           </p:cNvPr>
@@ -15533,7 +15533,7 @@
           <p:cNvPr id="20" name="flow-88">
             <a:extLst xmlns:a="http://schemas.openxmlformats.org/drawingml/2006/main">
               <a:ext uri="{FF2B5EF4-FFF2-40B4-BE49-F238E27FC236}">
-                <a16:creationId xmlns:a16="http://schemas.microsoft.com/office/drawing/2014/main" id="{B241B2D4-D64B-4BA4-BE21-226F5087281E}"/>
+                <a16:creationId xmlns:a16="http://schemas.microsoft.com/office/drawing/2014/main" id="{ECBA7BA3-1981-4B0E-BC5D-32AF0B2C3A10}"/>
               </a:ext>
             </a:extLst>
           </p:cNvPr>
@@ -15561,7 +15561,7 @@
           <p:cNvPr id="21" name="flow-89">
             <a:extLst xmlns:a="http://schemas.openxmlformats.org/drawingml/2006/main">
               <a:ext uri="{FF2B5EF4-FFF2-40B4-BE49-F238E27FC236}">
-                <a16:creationId xmlns:a16="http://schemas.microsoft.com/office/drawing/2014/main" id="{3F79E248-AE7F-43FD-9BD4-0D387EF29116}"/>
+                <a16:creationId xmlns:a16="http://schemas.microsoft.com/office/drawing/2014/main" id="{E2A839E8-6546-4C9C-95CE-DAFBB2B3CFD7}"/>
               </a:ext>
             </a:extLst>
           </p:cNvPr>
@@ -15589,7 +15589,7 @@
           <p:cNvPr id="22" name="flow-90">
             <a:extLst xmlns:a="http://schemas.openxmlformats.org/drawingml/2006/main">
               <a:ext uri="{FF2B5EF4-FFF2-40B4-BE49-F238E27FC236}">
-                <a16:creationId xmlns:a16="http://schemas.microsoft.com/office/drawing/2014/main" id="{48CF2C92-D3FB-4A14-B29A-951309921B37}"/>
+                <a16:creationId xmlns:a16="http://schemas.microsoft.com/office/drawing/2014/main" id="{75AD852A-AD0F-4F8B-8E4E-874992AA8D7B}"/>
               </a:ext>
             </a:extLst>
           </p:cNvPr>
@@ -15811,7 +15811,7 @@
           <p:cNvPr id="24" name="flow-92">
             <a:extLst xmlns:a="http://schemas.openxmlformats.org/drawingml/2006/main">
               <a:ext uri="{FF2B5EF4-FFF2-40B4-BE49-F238E27FC236}">
-                <a16:creationId xmlns:a16="http://schemas.microsoft.com/office/drawing/2014/main" id="{E0DA8A2F-9AF6-4B35-A979-475D993EFEC1}"/>
+                <a16:creationId xmlns:a16="http://schemas.microsoft.com/office/drawing/2014/main" id="{FA2DC789-0826-4B6E-9C00-9E99A7AED793}"/>
               </a:ext>
             </a:extLst>
           </p:cNvPr>
@@ -15839,7 +15839,7 @@
           <p:cNvPr id="25" name="flow-93">
             <a:extLst xmlns:a="http://schemas.openxmlformats.org/drawingml/2006/main">
               <a:ext uri="{FF2B5EF4-FFF2-40B4-BE49-F238E27FC236}">
-                <a16:creationId xmlns:a16="http://schemas.microsoft.com/office/drawing/2014/main" id="{43D41F70-A243-454E-A0C1-ECD149BDCFA8}"/>
+                <a16:creationId xmlns:a16="http://schemas.microsoft.com/office/drawing/2014/main" id="{E07AB091-7A1D-4095-974E-58D9F48B9802}"/>
               </a:ext>
             </a:extLst>
           </p:cNvPr>
@@ -15867,7 +15867,7 @@
           <p:cNvPr id="26" name="flow-94">
             <a:extLst xmlns:a="http://schemas.openxmlformats.org/drawingml/2006/main">
               <a:ext uri="{FF2B5EF4-FFF2-40B4-BE49-F238E27FC236}">
-                <a16:creationId xmlns:a16="http://schemas.microsoft.com/office/drawing/2014/main" id="{8203639C-1CE6-415C-86B2-BE81C0406C16}"/>
+                <a16:creationId xmlns:a16="http://schemas.microsoft.com/office/drawing/2014/main" id="{E1D9D3EB-FFF5-4F8D-B59F-A1F03508967B}"/>
               </a:ext>
             </a:extLst>
           </p:cNvPr>
@@ -16089,7 +16089,7 @@
           <p:cNvPr id="28" name="flow-96">
             <a:extLst xmlns:a="http://schemas.openxmlformats.org/drawingml/2006/main">
               <a:ext uri="{FF2B5EF4-FFF2-40B4-BE49-F238E27FC236}">
-                <a16:creationId xmlns:a16="http://schemas.microsoft.com/office/drawing/2014/main" id="{DFB4BC9B-83C5-4725-B876-0F31413B639D}"/>
+                <a16:creationId xmlns:a16="http://schemas.microsoft.com/office/drawing/2014/main" id="{5A208F3C-C5BF-4E55-A71C-A9A66F0B9953}"/>
               </a:ext>
             </a:extLst>
           </p:cNvPr>
@@ -16117,7 +16117,7 @@
           <p:cNvPr id="29" name="flow-97">
             <a:extLst xmlns:a="http://schemas.openxmlformats.org/drawingml/2006/main">
               <a:ext uri="{FF2B5EF4-FFF2-40B4-BE49-F238E27FC236}">
-                <a16:creationId xmlns:a16="http://schemas.microsoft.com/office/drawing/2014/main" id="{2B4D084B-7B11-4E42-A10C-26A0C0082BDA}"/>
+                <a16:creationId xmlns:a16="http://schemas.microsoft.com/office/drawing/2014/main" id="{0A2E3973-5893-4A0A-99F9-E2E1B31D5AF0}"/>
               </a:ext>
             </a:extLst>
           </p:cNvPr>
@@ -16899,7 +16899,7 @@
           <p:cNvPr id="35" name="">
             <a:extLst xmlns:a="http://schemas.openxmlformats.org/drawingml/2006/main">
               <a:ext uri="{FF2B5EF4-FFF2-40B4-BE49-F238E27FC236}">
-                <a16:creationId xmlns:a16="http://schemas.microsoft.com/office/drawing/2014/main" id="{746985A6-321D-40D3-BD63-A74A1C6E67BD}"/>
+                <a16:creationId xmlns:a16="http://schemas.microsoft.com/office/drawing/2014/main" id="{E3BD5345-3BBC-4AAE-B146-EBE85BBEC941}"/>
               </a:ext>
             </a:extLst>
           </p:cNvPr>
@@ -16931,7 +16931,7 @@
           <p:cNvPr id="34" name="">
             <a:extLst xmlns:a="http://schemas.openxmlformats.org/drawingml/2006/main">
               <a:ext uri="{FF2B5EF4-FFF2-40B4-BE49-F238E27FC236}">
-                <a16:creationId xmlns:a16="http://schemas.microsoft.com/office/drawing/2014/main" id="{A019DA35-5538-4BC9-8019-E8F1F98946DE}"/>
+                <a16:creationId xmlns:a16="http://schemas.microsoft.com/office/drawing/2014/main" id="{B35B69E9-BB66-4627-8192-753F73F57ED1}"/>
               </a:ext>
             </a:extLst>
           </p:cNvPr>
@@ -16963,7 +16963,7 @@
           <p:cNvPr id="33" name="">
             <a:extLst xmlns:a="http://schemas.openxmlformats.org/drawingml/2006/main">
               <a:ext uri="{FF2B5EF4-FFF2-40B4-BE49-F238E27FC236}">
-                <a16:creationId xmlns:a16="http://schemas.microsoft.com/office/drawing/2014/main" id="{0DC79D47-795A-4129-A380-273B4597993D}"/>
+                <a16:creationId xmlns:a16="http://schemas.microsoft.com/office/drawing/2014/main" id="{5F2E91EF-40C2-4E36-8551-B70EC49452D6}"/>
               </a:ext>
             </a:extLst>
           </p:cNvPr>
@@ -16995,7 +16995,7 @@
           <p:cNvPr id="13" name="">
             <a:extLst xmlns:a="http://schemas.openxmlformats.org/drawingml/2006/main">
               <a:ext uri="{FF2B5EF4-FFF2-40B4-BE49-F238E27FC236}">
-                <a16:creationId xmlns:a16="http://schemas.microsoft.com/office/drawing/2014/main" id="{C0A62017-19F8-412E-9039-CAACA2A839CE}"/>
+                <a16:creationId xmlns:a16="http://schemas.microsoft.com/office/drawing/2014/main" id="{56BE6817-A69B-4BF8-8308-FC8412A3AB49}"/>
               </a:ext>
             </a:extLst>
           </p:cNvPr>
@@ -17027,7 +17027,7 @@
           <p:cNvPr id="12" name="">
             <a:extLst xmlns:a="http://schemas.openxmlformats.org/drawingml/2006/main">
               <a:ext uri="{FF2B5EF4-FFF2-40B4-BE49-F238E27FC236}">
-                <a16:creationId xmlns:a16="http://schemas.microsoft.com/office/drawing/2014/main" id="{AFB2ADAC-96B3-48C5-96F5-A1762A43ACD8}"/>
+                <a16:creationId xmlns:a16="http://schemas.microsoft.com/office/drawing/2014/main" id="{697B271D-53D4-4000-8ED5-39E0C5448C1C}"/>
               </a:ext>
             </a:extLst>
           </p:cNvPr>
@@ -18606,7 +18606,7 @@
           <p:cNvPr id="14" name="flow-113">
             <a:extLst xmlns:a="http://schemas.openxmlformats.org/drawingml/2006/main">
               <a:ext uri="{FF2B5EF4-FFF2-40B4-BE49-F238E27FC236}">
-                <a16:creationId xmlns:a16="http://schemas.microsoft.com/office/drawing/2014/main" id="{C048B40E-6EDD-4660-B925-C3B35DDF64C2}"/>
+                <a16:creationId xmlns:a16="http://schemas.microsoft.com/office/drawing/2014/main" id="{AE3886ED-E661-47A4-A92C-9286A6C82E3D}"/>
               </a:ext>
             </a:extLst>
           </p:cNvPr>
@@ -18634,7 +18634,7 @@
           <p:cNvPr id="15" name="flow-114">
             <a:extLst xmlns:a="http://schemas.openxmlformats.org/drawingml/2006/main">
               <a:ext uri="{FF2B5EF4-FFF2-40B4-BE49-F238E27FC236}">
-                <a16:creationId xmlns:a16="http://schemas.microsoft.com/office/drawing/2014/main" id="{765D620A-B598-452B-809F-CDA209699E14}"/>
+                <a16:creationId xmlns:a16="http://schemas.microsoft.com/office/drawing/2014/main" id="{C83F7109-F920-446C-8422-ABDA646EF561}"/>
               </a:ext>
             </a:extLst>
           </p:cNvPr>
@@ -18662,7 +18662,7 @@
           <p:cNvPr id="16" name="flow-115">
             <a:extLst xmlns:a="http://schemas.openxmlformats.org/drawingml/2006/main">
               <a:ext uri="{FF2B5EF4-FFF2-40B4-BE49-F238E27FC236}">
-                <a16:creationId xmlns:a16="http://schemas.microsoft.com/office/drawing/2014/main" id="{FF8B3767-335E-4386-A6D0-7FD4272FD674}"/>
+                <a16:creationId xmlns:a16="http://schemas.microsoft.com/office/drawing/2014/main" id="{DCCBABF4-1E0E-42C1-ACA6-08EE16738FCB}"/>
               </a:ext>
             </a:extLst>
           </p:cNvPr>
@@ -18690,7 +18690,7 @@
           <p:cNvPr id="17" name="flow-116">
             <a:extLst xmlns:a="http://schemas.openxmlformats.org/drawingml/2006/main">
               <a:ext uri="{FF2B5EF4-FFF2-40B4-BE49-F238E27FC236}">
-                <a16:creationId xmlns:a16="http://schemas.microsoft.com/office/drawing/2014/main" id="{2564613A-8A2C-4DF3-BA8A-ABBECAFAA266}"/>
+                <a16:creationId xmlns:a16="http://schemas.microsoft.com/office/drawing/2014/main" id="{5E48C0CC-6A8B-458C-B804-4DC1B9CBD6CC}"/>
               </a:ext>
             </a:extLst>
           </p:cNvPr>
@@ -20468,7 +20468,7 @@
           <p:cNvPr id="31" name="flow-130">
             <a:extLst xmlns:a="http://schemas.openxmlformats.org/drawingml/2006/main">
               <a:ext uri="{FF2B5EF4-FFF2-40B4-BE49-F238E27FC236}">
-                <a16:creationId xmlns:a16="http://schemas.microsoft.com/office/drawing/2014/main" id="{FB0B129B-A86A-44A2-AAE4-B9BE4C4CB57D}"/>
+                <a16:creationId xmlns:a16="http://schemas.microsoft.com/office/drawing/2014/main" id="{3D5D5DBA-A4CB-4AB2-8CBB-9A6E2435AFA0}"/>
               </a:ext>
             </a:extLst>
           </p:cNvPr>
@@ -21752,7 +21752,7 @@
           <p:cNvPr id="43" name="partner-flow-1">
             <a:extLst xmlns:a="http://schemas.openxmlformats.org/drawingml/2006/main">
               <a:ext uri="{FF2B5EF4-FFF2-40B4-BE49-F238E27FC236}">
-                <a16:creationId xmlns:a16="http://schemas.microsoft.com/office/drawing/2014/main" id="{474C57F3-FEA4-4A15-99F5-A14F448532AE}"/>
+                <a16:creationId xmlns:a16="http://schemas.microsoft.com/office/drawing/2014/main" id="{274546DC-7B5D-4FC9-8765-E687A476C61E}"/>
               </a:ext>
             </a:extLst>
           </p:cNvPr>
@@ -21780,7 +21780,7 @@
           <p:cNvPr id="44" name="partner-flow-2">
             <a:extLst xmlns:a="http://schemas.openxmlformats.org/drawingml/2006/main">
               <a:ext uri="{FF2B5EF4-FFF2-40B4-BE49-F238E27FC236}">
-                <a16:creationId xmlns:a16="http://schemas.microsoft.com/office/drawing/2014/main" id="{F9DDB598-75FF-48EF-8335-C0F8661E584F}"/>
+                <a16:creationId xmlns:a16="http://schemas.microsoft.com/office/drawing/2014/main" id="{4CE2A232-4EF8-4F05-B51D-EB418AEF74E7}"/>
               </a:ext>
             </a:extLst>
           </p:cNvPr>
@@ -21808,7 +21808,7 @@
           <p:cNvPr id="45" name="partner-flow-3">
             <a:extLst xmlns:a="http://schemas.openxmlformats.org/drawingml/2006/main">
               <a:ext uri="{FF2B5EF4-FFF2-40B4-BE49-F238E27FC236}">
-                <a16:creationId xmlns:a16="http://schemas.microsoft.com/office/drawing/2014/main" id="{F1C69EBB-F099-4B9D-B38E-48C7E22FFEFA}"/>
+                <a16:creationId xmlns:a16="http://schemas.microsoft.com/office/drawing/2014/main" id="{4AE1D8F4-592D-427E-98E3-5539BF666DE2}"/>
               </a:ext>
             </a:extLst>
           </p:cNvPr>
@@ -21836,7 +21836,7 @@
           <p:cNvPr id="46" name="partner-flow-4">
             <a:extLst xmlns:a="http://schemas.openxmlformats.org/drawingml/2006/main">
               <a:ext uri="{FF2B5EF4-FFF2-40B4-BE49-F238E27FC236}">
-                <a16:creationId xmlns:a16="http://schemas.microsoft.com/office/drawing/2014/main" id="{2F5CBEB4-37A5-4BF1-AACC-ACA976297623}"/>
+                <a16:creationId xmlns:a16="http://schemas.microsoft.com/office/drawing/2014/main" id="{F0A52A4D-5F28-40CE-84BD-282D3A1C4D84}"/>
               </a:ext>
             </a:extLst>
           </p:cNvPr>
@@ -21894,7 +21894,7 @@
           <p:cNvPr id="25" name="">
             <a:extLst xmlns:a="http://schemas.openxmlformats.org/drawingml/2006/main">
               <a:ext uri="{FF2B5EF4-FFF2-40B4-BE49-F238E27FC236}">
-                <a16:creationId xmlns:a16="http://schemas.microsoft.com/office/drawing/2014/main" id="{BE12559E-019E-42EB-8504-0E5882CF4073}"/>
+                <a16:creationId xmlns:a16="http://schemas.microsoft.com/office/drawing/2014/main" id="{219EC66B-E8CF-4A93-867C-F2EE32FE54D1}"/>
               </a:ext>
             </a:extLst>
           </p:cNvPr>
@@ -22602,7 +22602,7 @@
           <p:cNvPr id="5" name="flow-142">
             <a:extLst xmlns:a="http://schemas.openxmlformats.org/drawingml/2006/main">
               <a:ext uri="{FF2B5EF4-FFF2-40B4-BE49-F238E27FC236}">
-                <a16:creationId xmlns:a16="http://schemas.microsoft.com/office/drawing/2014/main" id="{E430C7FB-999B-4E4A-ACD9-9BF6B3A7C9CE}"/>
+                <a16:creationId xmlns:a16="http://schemas.microsoft.com/office/drawing/2014/main" id="{44FBBF81-096B-4BCC-B556-715456E97D33}"/>
               </a:ext>
             </a:extLst>
           </p:cNvPr>
@@ -24509,7 +24509,7 @@
           <p:cNvPr id="21" name="flow-158">
             <a:extLst xmlns:a="http://schemas.openxmlformats.org/drawingml/2006/main">
               <a:ext uri="{FF2B5EF4-FFF2-40B4-BE49-F238E27FC236}">
-                <a16:creationId xmlns:a16="http://schemas.microsoft.com/office/drawing/2014/main" id="{7D07108F-6B4A-4801-A078-6388E59B89CE}"/>
+                <a16:creationId xmlns:a16="http://schemas.microsoft.com/office/drawing/2014/main" id="{ED7C233D-F22C-4BD8-AA68-E3D1D356A837}"/>
               </a:ext>
             </a:extLst>
           </p:cNvPr>
@@ -25077,7 +25077,7 @@
           <p:cNvPr id="27" name="flow-163">
             <a:extLst xmlns:a="http://schemas.openxmlformats.org/drawingml/2006/main">
               <a:ext uri="{FF2B5EF4-FFF2-40B4-BE49-F238E27FC236}">
-                <a16:creationId xmlns:a16="http://schemas.microsoft.com/office/drawing/2014/main" id="{B6BE3F8D-4190-4F1E-B35F-35BD62206314}"/>
+                <a16:creationId xmlns:a16="http://schemas.microsoft.com/office/drawing/2014/main" id="{A0E0A54E-0054-441F-86F6-0611EA726AB8}"/>
               </a:ext>
             </a:extLst>
           </p:cNvPr>
@@ -25105,7 +25105,7 @@
           <p:cNvPr id="28" name="flow-164">
             <a:extLst xmlns:a="http://schemas.openxmlformats.org/drawingml/2006/main">
               <a:ext uri="{FF2B5EF4-FFF2-40B4-BE49-F238E27FC236}">
-                <a16:creationId xmlns:a16="http://schemas.microsoft.com/office/drawing/2014/main" id="{F5B95593-3D47-45A3-AF90-377C43E69F96}"/>
+                <a16:creationId xmlns:a16="http://schemas.microsoft.com/office/drawing/2014/main" id="{D1AF441D-DEA2-4F6D-B622-60C14AE5C157}"/>
               </a:ext>
             </a:extLst>
           </p:cNvPr>
@@ -25133,7 +25133,7 @@
           <p:cNvPr id="29" name="flow-165">
             <a:extLst xmlns:a="http://schemas.openxmlformats.org/drawingml/2006/main">
               <a:ext uri="{FF2B5EF4-FFF2-40B4-BE49-F238E27FC236}">
-                <a16:creationId xmlns:a16="http://schemas.microsoft.com/office/drawing/2014/main" id="{704FE7F6-F247-4AEF-B3FE-9469EF32A540}"/>
+                <a16:creationId xmlns:a16="http://schemas.microsoft.com/office/drawing/2014/main" id="{DD0AA757-13B1-41C3-B9D7-54CC33B07413}"/>
               </a:ext>
             </a:extLst>
           </p:cNvPr>
@@ -25331,7 +25331,7 @@
           <p:cNvPr id="31" name="flow-167">
             <a:extLst xmlns:a="http://schemas.openxmlformats.org/drawingml/2006/main">
               <a:ext uri="{FF2B5EF4-FFF2-40B4-BE49-F238E27FC236}">
-                <a16:creationId xmlns:a16="http://schemas.microsoft.com/office/drawing/2014/main" id="{2D93CC09-938A-4BDD-AA3F-48D2B250E5E7}"/>
+                <a16:creationId xmlns:a16="http://schemas.microsoft.com/office/drawing/2014/main" id="{E66F4706-1E42-4B3F-A582-2642CC768ECA}"/>
               </a:ext>
             </a:extLst>
           </p:cNvPr>
@@ -25529,7 +25529,7 @@
           <p:cNvPr id="33" name="flow-169">
             <a:extLst xmlns:a="http://schemas.openxmlformats.org/drawingml/2006/main">
               <a:ext uri="{FF2B5EF4-FFF2-40B4-BE49-F238E27FC236}">
-                <a16:creationId xmlns:a16="http://schemas.microsoft.com/office/drawing/2014/main" id="{BB6A33C9-17D2-4ECE-AC12-BB600CDFBD54}"/>
+                <a16:creationId xmlns:a16="http://schemas.microsoft.com/office/drawing/2014/main" id="{85D8F087-C22C-4D78-89ED-2097C5127108}"/>
               </a:ext>
             </a:extLst>
           </p:cNvPr>
@@ -25751,7 +25751,7 @@
           <p:cNvPr id="35" name="flow-171">
             <a:extLst xmlns:a="http://schemas.openxmlformats.org/drawingml/2006/main">
               <a:ext uri="{FF2B5EF4-FFF2-40B4-BE49-F238E27FC236}">
-                <a16:creationId xmlns:a16="http://schemas.microsoft.com/office/drawing/2014/main" id="{EFD7CD08-0417-480B-A23A-2286373F81FD}"/>
+                <a16:creationId xmlns:a16="http://schemas.microsoft.com/office/drawing/2014/main" id="{8CE9B448-9978-4F74-891A-23D8D3095BA8}"/>
               </a:ext>
             </a:extLst>
           </p:cNvPr>
@@ -25779,7 +25779,7 @@
           <p:cNvPr id="36" name="flow-172">
             <a:extLst xmlns:a="http://schemas.openxmlformats.org/drawingml/2006/main">
               <a:ext uri="{FF2B5EF4-FFF2-40B4-BE49-F238E27FC236}">
-                <a16:creationId xmlns:a16="http://schemas.microsoft.com/office/drawing/2014/main" id="{58D8F5E9-A2DE-47CB-B527-73EBD0DAEF01}"/>
+                <a16:creationId xmlns:a16="http://schemas.microsoft.com/office/drawing/2014/main" id="{5FEB6134-3E62-4E38-B3EA-BDECF20CB9C7}"/>
               </a:ext>
             </a:extLst>
           </p:cNvPr>
@@ -25807,7 +25807,7 @@
           <p:cNvPr id="37" name="flow-173">
             <a:extLst xmlns:a="http://schemas.openxmlformats.org/drawingml/2006/main">
               <a:ext uri="{FF2B5EF4-FFF2-40B4-BE49-F238E27FC236}">
-                <a16:creationId xmlns:a16="http://schemas.microsoft.com/office/drawing/2014/main" id="{6BCBE229-CE7B-4539-800A-F6F9AA34FD2D}"/>
+                <a16:creationId xmlns:a16="http://schemas.microsoft.com/office/drawing/2014/main" id="{A25EB32E-5620-4DC2-A838-9EFC9B6CB0FF}"/>
               </a:ext>
             </a:extLst>
           </p:cNvPr>
@@ -26005,7 +26005,7 @@
           <p:cNvPr id="39" name="flow-175">
             <a:extLst xmlns:a="http://schemas.openxmlformats.org/drawingml/2006/main">
               <a:ext uri="{FF2B5EF4-FFF2-40B4-BE49-F238E27FC236}">
-                <a16:creationId xmlns:a16="http://schemas.microsoft.com/office/drawing/2014/main" id="{6252D98D-57E5-4827-ACA3-B39504372846}"/>
+                <a16:creationId xmlns:a16="http://schemas.microsoft.com/office/drawing/2014/main" id="{4D33A37F-C2C4-4229-89E7-A45AA969659E}"/>
               </a:ext>
             </a:extLst>
           </p:cNvPr>
@@ -26033,7 +26033,7 @@
           <p:cNvPr id="40" name="flow-176">
             <a:extLst xmlns:a="http://schemas.openxmlformats.org/drawingml/2006/main">
               <a:ext uri="{FF2B5EF4-FFF2-40B4-BE49-F238E27FC236}">
-                <a16:creationId xmlns:a16="http://schemas.microsoft.com/office/drawing/2014/main" id="{895A55E5-AE8F-493B-BCAB-02215E94F453}"/>
+                <a16:creationId xmlns:a16="http://schemas.microsoft.com/office/drawing/2014/main" id="{E10591A8-C96A-4656-A0D5-9B8A7E3918C1}"/>
               </a:ext>
             </a:extLst>
           </p:cNvPr>
@@ -26061,7 +26061,7 @@
           <p:cNvPr id="41" name="flow-177">
             <a:extLst xmlns:a="http://schemas.openxmlformats.org/drawingml/2006/main">
               <a:ext uri="{FF2B5EF4-FFF2-40B4-BE49-F238E27FC236}">
-                <a16:creationId xmlns:a16="http://schemas.microsoft.com/office/drawing/2014/main" id="{2818271D-823F-43B0-807E-78EDCC5E6ED6}"/>
+                <a16:creationId xmlns:a16="http://schemas.microsoft.com/office/drawing/2014/main" id="{20EA0393-0629-41B1-963F-58D7BEF8AD3A}"/>
               </a:ext>
             </a:extLst>
           </p:cNvPr>
@@ -26089,7 +26089,7 @@
           <p:cNvPr id="42" name="flow-178">
             <a:extLst xmlns:a="http://schemas.openxmlformats.org/drawingml/2006/main">
               <a:ext uri="{FF2B5EF4-FFF2-40B4-BE49-F238E27FC236}">
-                <a16:creationId xmlns:a16="http://schemas.microsoft.com/office/drawing/2014/main" id="{554084CC-FBAD-4820-8F71-04535170EED8}"/>
+                <a16:creationId xmlns:a16="http://schemas.microsoft.com/office/drawing/2014/main" id="{1D08BCEA-5CF8-40AE-869B-1033C748BC19}"/>
               </a:ext>
             </a:extLst>
           </p:cNvPr>
@@ -27830,7 +27830,7 @@
           <p:cNvPr id="10" name="partner-flow-14">
             <a:extLst xmlns:a="http://schemas.openxmlformats.org/drawingml/2006/main">
               <a:ext uri="{FF2B5EF4-FFF2-40B4-BE49-F238E27FC236}">
-                <a16:creationId xmlns:a16="http://schemas.microsoft.com/office/drawing/2014/main" id="{2191F705-222E-4129-A211-93FBAB4AFDB5}"/>
+                <a16:creationId xmlns:a16="http://schemas.microsoft.com/office/drawing/2014/main" id="{62A5FA2E-22D7-4F55-8139-9047D5C04DD1}"/>
               </a:ext>
             </a:extLst>
           </p:cNvPr>
@@ -28472,7 +28472,7 @@
           <p:cNvPr id="15" name="partner-flow-19">
             <a:extLst xmlns:a="http://schemas.openxmlformats.org/drawingml/2006/main">
               <a:ext uri="{FF2B5EF4-FFF2-40B4-BE49-F238E27FC236}">
-                <a16:creationId xmlns:a16="http://schemas.microsoft.com/office/drawing/2014/main" id="{2348295F-52EF-41BF-9D8E-7FF327C8AC4B}"/>
+                <a16:creationId xmlns:a16="http://schemas.microsoft.com/office/drawing/2014/main" id="{0B270CFB-D6FD-4216-A41E-0DD9D1622806}"/>
               </a:ext>
             </a:extLst>
           </p:cNvPr>
@@ -29065,7 +29065,7 @@
           <p:cNvPr id="20" name="partner-flow-24">
             <a:extLst xmlns:a="http://schemas.openxmlformats.org/drawingml/2006/main">
               <a:ext uri="{FF2B5EF4-FFF2-40B4-BE49-F238E27FC236}">
-                <a16:creationId xmlns:a16="http://schemas.microsoft.com/office/drawing/2014/main" id="{55BE9F48-850A-4719-BAD8-BB13475829BA}"/>
+                <a16:creationId xmlns:a16="http://schemas.microsoft.com/office/drawing/2014/main" id="{F2AA690B-A5BA-4486-8959-DD0BBE79A2BA}"/>
               </a:ext>
             </a:extLst>
           </p:cNvPr>
@@ -29093,7 +29093,7 @@
           <p:cNvPr id="21" name="partner-flow-25">
             <a:extLst xmlns:a="http://schemas.openxmlformats.org/drawingml/2006/main">
               <a:ext uri="{FF2B5EF4-FFF2-40B4-BE49-F238E27FC236}">
-                <a16:creationId xmlns:a16="http://schemas.microsoft.com/office/drawing/2014/main" id="{4B82C371-FB07-4615-99C1-A8A06B45D679}"/>
+                <a16:creationId xmlns:a16="http://schemas.microsoft.com/office/drawing/2014/main" id="{5E4693A2-E0CC-42CB-973F-6B1BC7BF721C}"/>
               </a:ext>
             </a:extLst>
           </p:cNvPr>
@@ -29121,7 +29121,7 @@
           <p:cNvPr id="22" name="partner-flow-26">
             <a:extLst xmlns:a="http://schemas.openxmlformats.org/drawingml/2006/main">
               <a:ext uri="{FF2B5EF4-FFF2-40B4-BE49-F238E27FC236}">
-                <a16:creationId xmlns:a16="http://schemas.microsoft.com/office/drawing/2014/main" id="{AF833F3E-9D17-4EA9-86D6-DEBA212CEFC6}"/>
+                <a16:creationId xmlns:a16="http://schemas.microsoft.com/office/drawing/2014/main" id="{282DC3F2-D0F6-4C9F-880A-C93A7EB611AE}"/>
               </a:ext>
             </a:extLst>
           </p:cNvPr>
@@ -31917,7 +31917,7 @@
           <p:cNvPr id="16" name="partner-flow-45">
             <a:extLst xmlns:a="http://schemas.openxmlformats.org/drawingml/2006/main">
               <a:ext uri="{FF2B5EF4-FFF2-40B4-BE49-F238E27FC236}">
-                <a16:creationId xmlns:a16="http://schemas.microsoft.com/office/drawing/2014/main" id="{103CC2A6-9C09-4481-B298-8FD3F0CABE7C}"/>
+                <a16:creationId xmlns:a16="http://schemas.microsoft.com/office/drawing/2014/main" id="{81339AEE-3B1B-4E4E-AE14-8E9E0A7F375F}"/>
               </a:ext>
             </a:extLst>
           </p:cNvPr>
@@ -31946,7 +31946,7 @@
           <p:cNvPr id="17" name="partner-flow-46">
             <a:extLst xmlns:a="http://schemas.openxmlformats.org/drawingml/2006/main">
               <a:ext uri="{FF2B5EF4-FFF2-40B4-BE49-F238E27FC236}">
-                <a16:creationId xmlns:a16="http://schemas.microsoft.com/office/drawing/2014/main" id="{328E6224-6DB6-47B9-887E-A8C433747DDC}"/>
+                <a16:creationId xmlns:a16="http://schemas.microsoft.com/office/drawing/2014/main" id="{79DA3EE9-7700-40CF-B304-700D8E82116A}"/>
               </a:ext>
             </a:extLst>
           </p:cNvPr>
@@ -31975,7 +31975,7 @@
           <p:cNvPr id="18" name="partner-flow-47">
             <a:extLst xmlns:a="http://schemas.openxmlformats.org/drawingml/2006/main">
               <a:ext uri="{FF2B5EF4-FFF2-40B4-BE49-F238E27FC236}">
-                <a16:creationId xmlns:a16="http://schemas.microsoft.com/office/drawing/2014/main" id="{E2F2930F-FE5A-40BA-9D10-EF9261776194}"/>
+                <a16:creationId xmlns:a16="http://schemas.microsoft.com/office/drawing/2014/main" id="{AE26B34C-14A8-43EF-9793-61C8134261DD}"/>
               </a:ext>
             </a:extLst>
           </p:cNvPr>
@@ -32004,7 +32004,7 @@
           <p:cNvPr id="19" name="partner-flow-48">
             <a:extLst xmlns:a="http://schemas.openxmlformats.org/drawingml/2006/main">
               <a:ext uri="{FF2B5EF4-FFF2-40B4-BE49-F238E27FC236}">
-                <a16:creationId xmlns:a16="http://schemas.microsoft.com/office/drawing/2014/main" id="{4250851E-75DE-45DB-BF2B-3D2CEFACDAA2}"/>
+                <a16:creationId xmlns:a16="http://schemas.microsoft.com/office/drawing/2014/main" id="{09BDA49A-D051-4CA7-9BBA-19D05D282D72}"/>
               </a:ext>
             </a:extLst>
           </p:cNvPr>
@@ -32032,7 +32032,7 @@
           <p:cNvPr id="20" name="partner-flow-49">
             <a:extLst xmlns:a="http://schemas.openxmlformats.org/drawingml/2006/main">
               <a:ext uri="{FF2B5EF4-FFF2-40B4-BE49-F238E27FC236}">
-                <a16:creationId xmlns:a16="http://schemas.microsoft.com/office/drawing/2014/main" id="{7A3EDE25-93E7-459E-916F-546029B658FF}"/>
+                <a16:creationId xmlns:a16="http://schemas.microsoft.com/office/drawing/2014/main" id="{7BDBA942-13F4-4605-B259-8F4BE9410844}"/>
               </a:ext>
             </a:extLst>
           </p:cNvPr>
@@ -32060,7 +32060,7 @@
           <p:cNvPr id="21" name="partner-flow-50">
             <a:extLst xmlns:a="http://schemas.openxmlformats.org/drawingml/2006/main">
               <a:ext uri="{FF2B5EF4-FFF2-40B4-BE49-F238E27FC236}">
-                <a16:creationId xmlns:a16="http://schemas.microsoft.com/office/drawing/2014/main" id="{E76EFA95-7777-4948-85FD-1938B1A1AEB0}"/>
+                <a16:creationId xmlns:a16="http://schemas.microsoft.com/office/drawing/2014/main" id="{DE61B143-7DA6-4744-9990-532DE1ACCC06}"/>
               </a:ext>
             </a:extLst>
           </p:cNvPr>
@@ -32258,7 +32258,7 @@
           <p:cNvPr id="23" name="partner-flow-52">
             <a:extLst xmlns:a="http://schemas.openxmlformats.org/drawingml/2006/main">
               <a:ext uri="{FF2B5EF4-FFF2-40B4-BE49-F238E27FC236}">
-                <a16:creationId xmlns:a16="http://schemas.microsoft.com/office/drawing/2014/main" id="{533D558D-2C9F-42BB-945D-2A51DE506835}"/>
+                <a16:creationId xmlns:a16="http://schemas.microsoft.com/office/drawing/2014/main" id="{3107D102-18F0-43E5-A085-4B74015722DF}"/>
               </a:ext>
             </a:extLst>
           </p:cNvPr>
@@ -32286,7 +32286,7 @@
           <p:cNvPr id="24" name="partner-flow-53">
             <a:extLst xmlns:a="http://schemas.openxmlformats.org/drawingml/2006/main">
               <a:ext uri="{FF2B5EF4-FFF2-40B4-BE49-F238E27FC236}">
-                <a16:creationId xmlns:a16="http://schemas.microsoft.com/office/drawing/2014/main" id="{306B542C-5136-4807-A7CE-186DDBB1C555}"/>
+                <a16:creationId xmlns:a16="http://schemas.microsoft.com/office/drawing/2014/main" id="{D1C0988A-DBEF-4346-A9E6-75F35691E09F}"/>
               </a:ext>
             </a:extLst>
           </p:cNvPr>
@@ -32314,7 +32314,7 @@
           <p:cNvPr id="25" name="partner-flow-54">
             <a:extLst xmlns:a="http://schemas.openxmlformats.org/drawingml/2006/main">
               <a:ext uri="{FF2B5EF4-FFF2-40B4-BE49-F238E27FC236}">
-                <a16:creationId xmlns:a16="http://schemas.microsoft.com/office/drawing/2014/main" id="{E8B96621-1E68-42BC-BAD3-98CE12D32ABA}"/>
+                <a16:creationId xmlns:a16="http://schemas.microsoft.com/office/drawing/2014/main" id="{55278894-2AA9-4BA0-B649-5F8AC39CA834}"/>
               </a:ext>
             </a:extLst>
           </p:cNvPr>
@@ -33453,7 +33453,7 @@
           <p:cNvPr id="33" name="changed-assertions-edge-label-leader">
             <a:extLst xmlns:a="http://schemas.openxmlformats.org/drawingml/2006/main">
               <a:ext uri="{FF2B5EF4-FFF2-40B4-BE49-F238E27FC236}">
-                <a16:creationId xmlns:a16="http://schemas.microsoft.com/office/drawing/2014/main" id="{DD8138AA-E52F-4D3E-B262-1AF9645ACD53}"/>
+                <a16:creationId xmlns:a16="http://schemas.microsoft.com/office/drawing/2014/main" id="{ACD93D52-E41C-4336-B030-5B5FC26429A4}"/>
               </a:ext>
             </a:extLst>
           </p:cNvPr>
@@ -33848,7 +33848,7 @@
           <p:cNvPr id="5" name="">
             <a:extLst xmlns:a="http://schemas.openxmlformats.org/drawingml/2006/main">
               <a:ext uri="{FF2B5EF4-FFF2-40B4-BE49-F238E27FC236}">
-                <a16:creationId xmlns:a16="http://schemas.microsoft.com/office/drawing/2014/main" id="{EBD71CBF-DD61-4D85-A7AA-687ADB0D55EE}"/>
+                <a16:creationId xmlns:a16="http://schemas.microsoft.com/office/drawing/2014/main" id="{F38271FE-45AE-431B-A466-52A52EA3418A}"/>
               </a:ext>
             </a:extLst>
           </p:cNvPr>
@@ -34461,7 +34461,7 @@
                           <a:ea typeface="Aptos"/>
                           <a:cs typeface="Aptos"/>
                         </a:rPr>
-                        <a:t>Native exact-action capture merged</a:t>
+                        <a:t>Native capture and delivery merged</a:t>
                       </a:r>
                     </a:p>
                   </a:txBody>
@@ -36330,7 +36330,7 @@
           <p:cNvPr id="9" name="flow-217">
             <a:extLst xmlns:a="http://schemas.openxmlformats.org/drawingml/2006/main">
               <a:ext uri="{FF2B5EF4-FFF2-40B4-BE49-F238E27FC236}">
-                <a16:creationId xmlns:a16="http://schemas.microsoft.com/office/drawing/2014/main" id="{10C31AF1-B497-4BAC-906E-86EC045C4E95}"/>
+                <a16:creationId xmlns:a16="http://schemas.microsoft.com/office/drawing/2014/main" id="{9162338C-668C-4E97-A8D2-65D386866301}"/>
               </a:ext>
             </a:extLst>
           </p:cNvPr>
@@ -36359,7 +36359,7 @@
           <p:cNvPr id="10" name="flow-218">
             <a:extLst xmlns:a="http://schemas.openxmlformats.org/drawingml/2006/main">
               <a:ext uri="{FF2B5EF4-FFF2-40B4-BE49-F238E27FC236}">
-                <a16:creationId xmlns:a16="http://schemas.microsoft.com/office/drawing/2014/main" id="{F3084C09-5310-4E11-B63C-FBB12BCFEA3B}"/>
+                <a16:creationId xmlns:a16="http://schemas.microsoft.com/office/drawing/2014/main" id="{A8A09DA8-FCF8-46B0-A640-EFFCE3EDB027}"/>
               </a:ext>
             </a:extLst>
           </p:cNvPr>
@@ -36595,7 +36595,7 @@
                 <a:ea typeface="Aptos"/>
                 <a:cs typeface="Aptos"/>
               </a:rPr>
-              <a:t>V2 core and native capture</a:t>
+              <a:t>V2 core, capture and delivery</a:t>
             </a:r>
           </a:p>
           <a:p xmlns:a="http://schemas.openxmlformats.org/drawingml/2006/main">
@@ -37279,7 +37279,7 @@
           <p:cNvPr id="14" name="flow-222">
             <a:extLst xmlns:a="http://schemas.openxmlformats.org/drawingml/2006/main">
               <a:ext uri="{FF2B5EF4-FFF2-40B4-BE49-F238E27FC236}">
-                <a16:creationId xmlns:a16="http://schemas.microsoft.com/office/drawing/2014/main" id="{301A796B-AD0D-42EC-A506-0A5EA28BEF78}"/>
+                <a16:creationId xmlns:a16="http://schemas.microsoft.com/office/drawing/2014/main" id="{B8F002E2-1A2D-494E-A9E7-528F482C1212}"/>
               </a:ext>
             </a:extLst>
           </p:cNvPr>

</xml_diff>

<commit_message>
docs: synchronize r26 runtime and contributor status
</commit_message>
<xml_diff>
--- a/Inertia-Architecture.pptx
+++ b/Inertia-Architecture.pptx
@@ -2,21 +2,21 @@
 <file path=ppt/presentation.xml><?xml version="1.0" encoding="utf-8"?>
 <p:presentation xmlns:p="http://schemas.openxmlformats.org/presentationml/2006/main">
   <p:sldMasterIdLst>
-    <p:sldMasterId xmlns:r="http://schemas.openxmlformats.org/officeDocument/2006/relationships" id="2147483648" r:id="Ra6c45da0d57f4202"/>
+    <p:sldMasterId xmlns:r="http://schemas.openxmlformats.org/officeDocument/2006/relationships" id="2147483648" r:id="R98635c6eabc04cf4"/>
   </p:sldMasterIdLst>
   <p:notesMasterIdLst>
-    <p:notesMasterId xmlns:r="http://schemas.openxmlformats.org/officeDocument/2006/relationships" r:id="R5f5f99c8012c4c93"/>
+    <p:notesMasterId xmlns:r="http://schemas.openxmlformats.org/officeDocument/2006/relationships" r:id="Rb9dc012d16224e6b"/>
   </p:notesMasterIdLst>
   <p:sldIdLst>
-    <p:sldId xmlns:r="http://schemas.openxmlformats.org/officeDocument/2006/relationships" id="256" r:id="R1c59b84ea7594b57"/>
-    <p:sldId xmlns:r="http://schemas.openxmlformats.org/officeDocument/2006/relationships" id="257" r:id="Rb321bc3e704343f4"/>
-    <p:sldId xmlns:r="http://schemas.openxmlformats.org/officeDocument/2006/relationships" id="258" r:id="Ra10407449ef740b9"/>
-    <p:sldId xmlns:r="http://schemas.openxmlformats.org/officeDocument/2006/relationships" id="259" r:id="R5826496e08a64aab"/>
-    <p:sldId xmlns:r="http://schemas.openxmlformats.org/officeDocument/2006/relationships" id="260" r:id="Rbb44a07840a04c92"/>
-    <p:sldId xmlns:r="http://schemas.openxmlformats.org/officeDocument/2006/relationships" id="261" r:id="R01e37d853ab9441b"/>
-    <p:sldId xmlns:r="http://schemas.openxmlformats.org/officeDocument/2006/relationships" id="262" r:id="Ra5e98dee0aa440c1"/>
-    <p:sldId xmlns:r="http://schemas.openxmlformats.org/officeDocument/2006/relationships" id="263" r:id="R11f9065c3a044367"/>
-    <p:sldId xmlns:r="http://schemas.openxmlformats.org/officeDocument/2006/relationships" id="264" r:id="R44af1ad8029a4c83"/>
+    <p:sldId xmlns:r="http://schemas.openxmlformats.org/officeDocument/2006/relationships" id="256" r:id="Raef1031ea21447ce"/>
+    <p:sldId xmlns:r="http://schemas.openxmlformats.org/officeDocument/2006/relationships" id="257" r:id="R11cdba2e6a744dbc"/>
+    <p:sldId xmlns:r="http://schemas.openxmlformats.org/officeDocument/2006/relationships" id="258" r:id="Rc032a0ec448b48af"/>
+    <p:sldId xmlns:r="http://schemas.openxmlformats.org/officeDocument/2006/relationships" id="259" r:id="R964e029a6aea4e77"/>
+    <p:sldId xmlns:r="http://schemas.openxmlformats.org/officeDocument/2006/relationships" id="260" r:id="R45688cdf61694ac2"/>
+    <p:sldId xmlns:r="http://schemas.openxmlformats.org/officeDocument/2006/relationships" id="261" r:id="Rc93086e7ba15418c"/>
+    <p:sldId xmlns:r="http://schemas.openxmlformats.org/officeDocument/2006/relationships" id="262" r:id="R8e0c83482eb44baa"/>
+    <p:sldId xmlns:r="http://schemas.openxmlformats.org/officeDocument/2006/relationships" id="263" r:id="R3d695139b86742cf"/>
+    <p:sldId xmlns:r="http://schemas.openxmlformats.org/officeDocument/2006/relationships" id="264" r:id="Rad9541e618e14128"/>
   </p:sldIdLst>
   <p:sldSz cx="15240000" cy="8572500"/>
   <p:notesSz cx="6858000" cy="9144000"/>
@@ -470,7 +470,7 @@
           </a:p>
           <a:p xmlns:a="http://schemas.openxmlformats.org/drawingml/2006/main">
             <a:r>
-              <a:t>This chosen target is not a deployed-integration claim. PR53 source-qualified default-disabled host assembly, early SDK pre-buffer byte/deadline checks, manual invocation and native state-delete reset. Actual data/source/action bindings, bounded receipt-read allocation, remaining deployment/latency compatibility, approved lifecycle/authentication/network integration, writer fencing and live walkthrough remain gates. Packet-v2 contract/freeze core source is merged. Native capture source is merged with synthetic callbacks and absent authority/retention disabled. Packet UI/attestation is reviewed draft PR62, not merged/live. Browser walkthrough, mutual #48 recovery agreement and real authority/runtime/domain/Buzz remain pending. Legacy v1 records remain intact.</a:t>
+              <a:t>This chosen target is not a deployed-integration claim. PR53 source-qualified default-disabled host assembly, early SDK pre-buffer byte/deadline checks, manual invocation and native state-delete reset. Actual data/source/action bindings, bounded receipt-read allocation, remaining deployment/latency compatibility, approved lifecycle/authentication/network integration, writer fencing and live walkthrough remain gates. Packet-v2 contract/freeze core source is merged. Native capture source is merged with synthetic callbacks and absent authority/retention disabled. Packet UI/attestation is reviewed draft PR62, not merged/live. PR62 conflict reconciliation and real-browser QA are in progress. Real authority/runtime/domain/Buzz remain pending. Shared recovery alignment is resolved. Legacy v1 records remain intact.</a:t>
             </a:r>
           </a:p>
           <a:p xmlns:a="http://schemas.openxmlformats.org/drawingml/2006/main">
@@ -580,7 +580,7 @@
           </a:p>
           <a:p xmlns:a="http://schemas.openxmlformats.org/drawingml/2006/main">
             <a:r>
-              <a:t>Any authenticated, currently verified DAO member with current application action access may confirm the exact immutable version under the chosen v2 policy. No named application owner or default five specialist human gates. Packet-v2 core and native exact-action capture are merged in PR56/PR58. Packet UI is reviewed draft PR62, not merged/live; browser, mutual recovery agreement and real authority/runtime/domain/Buzz remain pending. Real sponsor signatures or DAO/Vocdoni governance apply only when genuinely required. Preserve exact versions, source scope, replay/conflict denial and current access checks. Reference packets and answer keys are separate from actual generated output.</a:t>
+              <a:t>Any authenticated, currently verified DAO member with current application action access may confirm the exact immutable version under the chosen v2 policy. No named application owner or default five specialist human gates. Packet-v2 core and native exact-action capture are merged in PR56/PR58. Packet UI is reviewed draft PR62, not merged/live; PR62 conflict reconciliation and real-browser QA are in progress. Real authority/runtime/domain/Buzz remain pending. Shared recovery alignment is resolved. Real sponsor signatures or DAO/Vocdoni governance apply only when genuinely required. Preserve exact versions, source scope, replay/conflict denial and current access checks. Reference packets and answer keys are separate from actual generated output.</a:t>
             </a:r>
           </a:p>
           <a:p xmlns:a="http://schemas.openxmlformats.org/drawingml/2006/main">
@@ -760,7 +760,7 @@
           </a:p>
           <a:p xmlns:a="http://schemas.openxmlformats.org/drawingml/2006/main">
             <a:r>
-              <a:t>V2 core and native exact-action capture are merged in https://github.com/NetRxn/Inertia/pull/56 and https://github.com/NetRxn/Inertia/pull/58. Packet UI/attestation is reviewed draft https://github.com/NetRxn/Inertia/pull/62, not merged/live. Browser, mutual #48 recovery agreement and real authority/runtime/domain/Buzz remain pending; this diagram is not a deployment claim. Agents prepare and independently critique; they never supply human approval. Any authenticated, currently verified DAO member with current application review access may confirm the exact immutable packet/version/artifact bytes. There is no named application owner or default five-specialist human ceremony. Actual sponsor signatures and DAO/Vocdoni governance apply only when the real case requires them.</a:t>
+              <a:t>V2 core and native exact-action capture are merged in https://github.com/NetRxn/Inertia/pull/56 and https://github.com/NetRxn/Inertia/pull/58. Packet UI/attestation is reviewed draft https://github.com/NetRxn/Inertia/pull/62, not merged/live. PR62 conflict reconciliation and real-browser QA are in progress. Real authority/runtime/domain/Buzz remain pending; shared recovery alignment is resolved; this diagram is not a deployment claim. Agents prepare and independently critique; they never supply human approval. Any authenticated, currently verified DAO member with current application review access may confirm the exact immutable packet/version/artifact bytes. There is no named application owner or default five-specialist human ceremony. Actual sponsor signatures and DAO/Vocdoni governance apply only when the real case requires them.</a:t>
             </a:r>
           </a:p>
           <a:p xmlns:a="http://schemas.openxmlformats.org/drawingml/2006/main">
@@ -890,7 +890,7 @@
           </a:p>
           <a:p xmlns:a="http://schemas.openxmlformats.org/drawingml/2006/main">
             <a:r>
-              <a:t>The simpler same-pending-ID re-entry is a PR62 candidate awaiting mutual #48 agreement, not an adopted shared workflow. No retirement endpoint, new store or payload persistence was added.</a:t>
+              <a:t>Shared recovery alignment is resolved: R02 retains system-run recovery and R03 the member same-request-ID path. PR62 remains draft with conflict reconciliation and real-browser QA in progress. No retirement endpoint, new store or payload persistence was added.</a:t>
             </a:r>
           </a:p>
           <a:p xmlns:a="http://schemas.openxmlformats.org/drawingml/2006/main">
@@ -1220,7 +1220,7 @@
           </a:p>
           <a:p xmlns:a="http://schemas.openxmlformats.org/drawingml/2006/main">
             <a:r>
-              <a:t>PR59 is noncanonical discussion only. Contributor-owned PR60 passed scoped rereview but awaits their readiness/nonblocking-note choice. PR61 awaits its clarification and R-02 recovery alignment. Shared workflow adoption requires mutual agreement; contributor proposal/validator/rehearsal files are untouched. Follow #40 for live coordination.</a:t>
+              <a:t>PR59 is noncanonical discussion only. Contributor PR60 validator and PR61 rehearsal are merged after mutual recovery alignment. The rehearsal is valid but NOT qualified; contributor files are untouched here. Follow #40 for live coordination.</a:t>
             </a:r>
           </a:p>
           <a:p xmlns:a="http://schemas.openxmlformats.org/drawingml/2006/main">
@@ -1230,7 +1230,7 @@
           </a:p>
           <a:p xmlns:a="http://schemas.openxmlformats.org/drawingml/2006/main">
             <a:r>
-              <a:t>Reuse existing references; this is an interface map, not a new owner/dependency/handoff register. John plans shared runtime deployment before Wednesday. Docker preproduction Paperclip-to-Codex subscription smoke passed with the expected short output and no API key. Single-provider workflow qualification, including substantial funding research/draft/reuse, is next. Claude CLI is installed; connection/inference waits until Monday, with the two-provider rehearsal later. Meeting/member integration remains pending.</a:t>
+              <a:t>Reuse existing references; this is an interface map, not a new owner/dependency/handoff register. John plans shared runtime deployment before Wednesday. Docker preproduction Paperclip-to-Codex subscription smoke passed with the expected short output and no API key. Durable preproduction and command-free drafting installation are verified. Actual funding execution has zero candidates and zero reviews; agents remain paused. The command-disable adapter repair is local-only; not yet installed. Claude CLI is installed; connection/inference waits until Monday, with the two-provider rehearsal later. Meeting/member integration remains pending.</a:t>
             </a:r>
           </a:p>
         </p:txBody>
@@ -1320,7 +1320,7 @@
           </a:p>
           <a:p xmlns:a="http://schemas.openxmlformats.org/drawingml/2006/main">
             <a:r>
-              <a:t>Chosen v2 allows any authenticated, currently verified DAO member with current application action access to confirm the exact immutable version, with no named owner or default five-specialist gates. Real sponsor signatures and DAO/Vocdoni governance apply only when required. Mark submitted records a selected immutable packet/date and reporter/evidence level with optional later evidence; no automatic submission or fake prior approvals. V2 core and native capture are merged in PR56/PR58. Packet UI/attestation is reviewed draft https://github.com/NetRxn/Inertia/pull/62, not merged/live. Browser, mutual #48 recovery and real authority/runtime/domain/Buzz remain unqualified, with legacy v1 intact.</a:t>
+              <a:t>Chosen v2 allows any authenticated, currently verified DAO member with current application action access to confirm the exact immutable version, with no named owner or default five-specialist gates. Real sponsor signatures and DAO/Vocdoni governance apply only when required. Mark submitted records a selected immutable packet/date and reporter/evidence level with optional later evidence; no automatic submission or fake prior approvals. V2 core and native capture are merged in PR56/PR58. Packet UI/attestation is reviewed draft https://github.com/NetRxn/Inertia/pull/62, not merged/live. PR62 conflict reconciliation and real-browser QA are in progress. Real authority/runtime/domain/Buzz remain open, with legacy v1 intact. Shared recovery alignment is resolved.</a:t>
             </a:r>
           </a:p>
           <a:p xmlns:a="http://schemas.openxmlformats.org/drawingml/2006/main">
@@ -1350,7 +1350,7 @@
           </a:p>
           <a:p xmlns:a="http://schemas.openxmlformats.org/drawingml/2006/main">
             <a:r>
-              <a:t>PR62 source checks and an isolated full package check passed after earlier fixture timeout/relation collision and dependency-install failures. Those attempts remain evidence; their causes are not established. No actual browser walkthrough is claimed. PR59 is discussion-only; PR60/61 shared recovery/readiness remains subject to mutual alignment.</a:t>
+              <a:t>PR62 source checks and an isolated full package check passed after earlier fixture timeout/relation collision and dependency-install failures. Those attempts remain evidence; their causes are not established. No actual browser walkthrough is claimed. PR59 is discussion-only. PR60/61 are merged after recovery alignment; the rehearsal remains NOT qualified.</a:t>
             </a:r>
           </a:p>
           <a:p xmlns:a="http://schemas.openxmlformats.org/drawingml/2006/main">
@@ -1360,7 +1360,7 @@
           </a:p>
           <a:p xmlns:a="http://schemas.openxmlformats.org/drawingml/2006/main">
             <a:r>
-              <a:t>Recommended Pareto ordering, not a verbatim user-authored ranking: generated funding research/draft; PostgreSQL read/admit/reuse; member review to durable outcome; autonomous meeting/bounty collaboration; meeting cleanup/publication/readback; measured rehearsal. Helix, Y2 and extra UI polish are deferred. The first two proposals are with John; hold a new external work split until his review is clear. See plan.md for the concise task list. No new requirements, contributor assignments or publication are implied.</a:t>
+              <a:t>Recommended Pareto ordering, not a verbatim user-authored ranking: generated funding research/draft; PostgreSQL read/admit/reuse; member review to durable outcome; autonomous meeting/bounty collaboration; meeting cleanup/publication/readback; measured rehearsal. Helix, Y2 and extra UI polish are deferred. The first two proposals are with John; hold a new external work split until his review is clear. See plan.md for the concise task list. No new requirements, contributor assignments or publication are implied. Status checkpoint 2026-10-25: PR73 command-free drafting is merged and installed in durable preproduction. The initial subscription smoke remains the only live inference proof; actual funding execution has zero candidates and zero reviews. The independently reviewed command-disable adapter repair is local-only; not yet installed. Trusted-central knowledge/review/admission changes are local-only; not yet published or activated. Member PR70/74/75 remain fixture-only drafts with preview DNS, upload buffering and old-email-token issues unresolved; PR75 fixes Unicode handling. PR62 conflict reconciliation and real-browser QA are in progress. Verification details: testing.md. Public merged source: https://github.com/NetRxn/Inertia/pull/73; contributor merges: https://github.com/NetRxn/Inertia/pull/60 and https://github.com/NetRxn/Inertia/pull/61</a:t>
             </a:r>
           </a:p>
         </p:txBody>
@@ -3803,12 +3803,12 @@
   </p:cSld>
   <p:clrMap bg1="lt1" tx1="dk1" bg2="lt2" tx2="dk2" accent1="accent1" accent2="accent2" accent3="accent3" accent4="accent4" accent5="accent5" accent6="accent6" hlink="hlink" folHlink="folHlink"/>
   <p:sldLayoutIdLst>
-    <p:sldLayoutId xmlns:r="http://schemas.openxmlformats.org/officeDocument/2006/relationships" id="2147483649" r:id="R9632ce175b524157"/>
-    <p:sldLayoutId xmlns:r="http://schemas.openxmlformats.org/officeDocument/2006/relationships" id="2147483650" r:id="Rb10a8c200e6747c7"/>
-    <p:sldLayoutId xmlns:r="http://schemas.openxmlformats.org/officeDocument/2006/relationships" id="2147483651" r:id="Rab8c1d763c1b4686"/>
-    <p:sldLayoutId xmlns:r="http://schemas.openxmlformats.org/officeDocument/2006/relationships" id="2147483652" r:id="R885e70f5d1344733"/>
-    <p:sldLayoutId xmlns:r="http://schemas.openxmlformats.org/officeDocument/2006/relationships" id="2147483653" r:id="R976307571e144f89"/>
-    <p:sldLayoutId xmlns:r="http://schemas.openxmlformats.org/officeDocument/2006/relationships" id="2147483654" r:id="R7c404d410d3f41b3"/>
+    <p:sldLayoutId xmlns:r="http://schemas.openxmlformats.org/officeDocument/2006/relationships" id="2147483649" r:id="R0387bf3db7004a61"/>
+    <p:sldLayoutId xmlns:r="http://schemas.openxmlformats.org/officeDocument/2006/relationships" id="2147483650" r:id="Ra96045877a874a84"/>
+    <p:sldLayoutId xmlns:r="http://schemas.openxmlformats.org/officeDocument/2006/relationships" id="2147483651" r:id="Ra4661739d6b242bf"/>
+    <p:sldLayoutId xmlns:r="http://schemas.openxmlformats.org/officeDocument/2006/relationships" id="2147483652" r:id="R29966871efc4481d"/>
+    <p:sldLayoutId xmlns:r="http://schemas.openxmlformats.org/officeDocument/2006/relationships" id="2147483653" r:id="Rb1da1fc0230644ac"/>
+    <p:sldLayoutId xmlns:r="http://schemas.openxmlformats.org/officeDocument/2006/relationships" id="2147483654" r:id="R0e2d554f13c2467d"/>
   </p:sldLayoutIdLst>
   <p:txStyles>
     <p:titleStyle>
@@ -4359,7 +4359,7 @@
           <p:cNvPr id="39" name="">
             <a:extLst xmlns:a="http://schemas.openxmlformats.org/drawingml/2006/main">
               <a:ext uri="{FF2B5EF4-FFF2-40B4-BE49-F238E27FC236}">
-                <a16:creationId xmlns:a16="http://schemas.microsoft.com/office/drawing/2014/main" id="{5E0386CB-2A9C-464E-91C4-0CB2F2848F58}"/>
+                <a16:creationId xmlns:a16="http://schemas.microsoft.com/office/drawing/2014/main" id="{1516662F-6161-429D-B202-6A3332857AE3}"/>
               </a:ext>
             </a:extLst>
           </p:cNvPr>
@@ -4392,7 +4392,7 @@
           <p:cNvPr id="32" name="">
             <a:extLst xmlns:a="http://schemas.openxmlformats.org/drawingml/2006/main">
               <a:ext uri="{FF2B5EF4-FFF2-40B4-BE49-F238E27FC236}">
-                <a16:creationId xmlns:a16="http://schemas.microsoft.com/office/drawing/2014/main" id="{48FF9E57-53DC-466D-B56B-838E54EFF9CD}"/>
+                <a16:creationId xmlns:a16="http://schemas.microsoft.com/office/drawing/2014/main" id="{1EA22BDC-2853-4CB5-8096-E946BBBDF7D8}"/>
               </a:ext>
             </a:extLst>
           </p:cNvPr>
@@ -4424,7 +4424,7 @@
           <p:cNvPr id="29" name="">
             <a:extLst xmlns:a="http://schemas.openxmlformats.org/drawingml/2006/main">
               <a:ext uri="{FF2B5EF4-FFF2-40B4-BE49-F238E27FC236}">
-                <a16:creationId xmlns:a16="http://schemas.microsoft.com/office/drawing/2014/main" id="{EF03239E-7EB2-484D-8876-421F252ED4CE}"/>
+                <a16:creationId xmlns:a16="http://schemas.microsoft.com/office/drawing/2014/main" id="{38956C0B-2DA1-4FB2-A608-97FE366E6873}"/>
               </a:ext>
             </a:extLst>
           </p:cNvPr>
@@ -8197,7 +8197,7 @@
           <p:cNvPr id="30" name="flow-29">
             <a:extLst xmlns:a="http://schemas.openxmlformats.org/drawingml/2006/main">
               <a:ext uri="{FF2B5EF4-FFF2-40B4-BE49-F238E27FC236}">
-                <a16:creationId xmlns:a16="http://schemas.microsoft.com/office/drawing/2014/main" id="{6DA7E072-756B-423A-9624-B0213C3D9BC2}"/>
+                <a16:creationId xmlns:a16="http://schemas.microsoft.com/office/drawing/2014/main" id="{F9497FF2-1E39-4C3F-9BDB-EF98524314BC}"/>
               </a:ext>
             </a:extLst>
           </p:cNvPr>
@@ -8227,7 +8227,7 @@
           <p:cNvPr id="31" name="flow-30">
             <a:extLst xmlns:a="http://schemas.openxmlformats.org/drawingml/2006/main">
               <a:ext uri="{FF2B5EF4-FFF2-40B4-BE49-F238E27FC236}">
-                <a16:creationId xmlns:a16="http://schemas.microsoft.com/office/drawing/2014/main" id="{87D75D4A-3345-4E3E-8231-EEE4662B3587}"/>
+                <a16:creationId xmlns:a16="http://schemas.microsoft.com/office/drawing/2014/main" id="{33E3CD49-4BED-4197-8AF2-91D159BE7FC6}"/>
               </a:ext>
             </a:extLst>
           </p:cNvPr>
@@ -8426,7 +8426,7 @@
           <p:cNvPr id="34" name="flow-32">
             <a:extLst xmlns:a="http://schemas.openxmlformats.org/drawingml/2006/main">
               <a:ext uri="{FF2B5EF4-FFF2-40B4-BE49-F238E27FC236}">
-                <a16:creationId xmlns:a16="http://schemas.microsoft.com/office/drawing/2014/main" id="{915E546F-6A24-4AB6-9EA1-3A7825EC6317}"/>
+                <a16:creationId xmlns:a16="http://schemas.microsoft.com/office/drawing/2014/main" id="{6B0F0527-24CA-4815-90F0-F5BB7F2AF783}"/>
               </a:ext>
             </a:extLst>
           </p:cNvPr>
@@ -8455,7 +8455,7 @@
           <p:cNvPr id="35" name="flow-33">
             <a:extLst xmlns:a="http://schemas.openxmlformats.org/drawingml/2006/main">
               <a:ext uri="{FF2B5EF4-FFF2-40B4-BE49-F238E27FC236}">
-                <a16:creationId xmlns:a16="http://schemas.microsoft.com/office/drawing/2014/main" id="{FDC9A76D-39E5-495B-8F8A-13DCC5F87B2D}"/>
+                <a16:creationId xmlns:a16="http://schemas.microsoft.com/office/drawing/2014/main" id="{B5127375-DF58-4A09-A551-9CE2077AC0B7}"/>
               </a:ext>
             </a:extLst>
           </p:cNvPr>
@@ -8483,7 +8483,7 @@
           <p:cNvPr id="36" name="flow-34">
             <a:extLst xmlns:a="http://schemas.openxmlformats.org/drawingml/2006/main">
               <a:ext uri="{FF2B5EF4-FFF2-40B4-BE49-F238E27FC236}">
-                <a16:creationId xmlns:a16="http://schemas.microsoft.com/office/drawing/2014/main" id="{B02C2959-310F-47B0-98D3-450003CEE6C5}"/>
+                <a16:creationId xmlns:a16="http://schemas.microsoft.com/office/drawing/2014/main" id="{102DF9CB-43AE-44F0-A301-96BB031DA1DA}"/>
               </a:ext>
             </a:extLst>
           </p:cNvPr>
@@ -8681,7 +8681,7 @@
           <p:cNvPr id="38" name="flow-36">
             <a:extLst xmlns:a="http://schemas.openxmlformats.org/drawingml/2006/main">
               <a:ext uri="{FF2B5EF4-FFF2-40B4-BE49-F238E27FC236}">
-                <a16:creationId xmlns:a16="http://schemas.microsoft.com/office/drawing/2014/main" id="{ED535B0E-98E0-4B41-9681-5C953289C1FA}"/>
+                <a16:creationId xmlns:a16="http://schemas.microsoft.com/office/drawing/2014/main" id="{30196BA5-F7FF-46D9-9490-A4BC59CCEC6F}"/>
               </a:ext>
             </a:extLst>
           </p:cNvPr>
@@ -8909,7 +8909,7 @@
           <p:cNvPr id="35" name="">
             <a:extLst xmlns:a="http://schemas.openxmlformats.org/drawingml/2006/main">
               <a:ext uri="{FF2B5EF4-FFF2-40B4-BE49-F238E27FC236}">
-                <a16:creationId xmlns:a16="http://schemas.microsoft.com/office/drawing/2014/main" id="{7928B86D-C224-4CB6-B805-8E8E0E371440}"/>
+                <a16:creationId xmlns:a16="http://schemas.microsoft.com/office/drawing/2014/main" id="{A3BBAA9B-BC1E-404E-A6DB-6AACD72FBF9F}"/>
               </a:ext>
             </a:extLst>
           </p:cNvPr>
@@ -8941,7 +8941,7 @@
           <p:cNvPr id="21" name="">
             <a:extLst xmlns:a="http://schemas.openxmlformats.org/drawingml/2006/main">
               <a:ext uri="{FF2B5EF4-FFF2-40B4-BE49-F238E27FC236}">
-                <a16:creationId xmlns:a16="http://schemas.microsoft.com/office/drawing/2014/main" id="{E5849EFD-86E2-4D15-B649-D66743A45092}"/>
+                <a16:creationId xmlns:a16="http://schemas.microsoft.com/office/drawing/2014/main" id="{03A0A2ED-466F-439F-9851-9885983D621B}"/>
               </a:ext>
             </a:extLst>
           </p:cNvPr>
@@ -8973,7 +8973,7 @@
           <p:cNvPr id="20" name="">
             <a:extLst xmlns:a="http://schemas.openxmlformats.org/drawingml/2006/main">
               <a:ext uri="{FF2B5EF4-FFF2-40B4-BE49-F238E27FC236}">
-                <a16:creationId xmlns:a16="http://schemas.microsoft.com/office/drawing/2014/main" id="{09752710-DF51-4C37-9A1C-DF20A68236F1}"/>
+                <a16:creationId xmlns:a16="http://schemas.microsoft.com/office/drawing/2014/main" id="{F9FC7D89-2346-4155-845E-3C4F335658B8}"/>
               </a:ext>
             </a:extLst>
           </p:cNvPr>
@@ -9005,7 +9005,7 @@
           <p:cNvPr id="19" name="">
             <a:extLst xmlns:a="http://schemas.openxmlformats.org/drawingml/2006/main">
               <a:ext uri="{FF2B5EF4-FFF2-40B4-BE49-F238E27FC236}">
-                <a16:creationId xmlns:a16="http://schemas.microsoft.com/office/drawing/2014/main" id="{54C9ECD6-3591-4051-9BA4-7597E06C9034}"/>
+                <a16:creationId xmlns:a16="http://schemas.microsoft.com/office/drawing/2014/main" id="{5C3994CE-F4F0-40A0-A527-A50AED2A4D85}"/>
               </a:ext>
             </a:extLst>
           </p:cNvPr>
@@ -9037,7 +9037,7 @@
           <p:cNvPr id="18" name="">
             <a:extLst xmlns:a="http://schemas.openxmlformats.org/drawingml/2006/main">
               <a:ext uri="{FF2B5EF4-FFF2-40B4-BE49-F238E27FC236}">
-                <a16:creationId xmlns:a16="http://schemas.microsoft.com/office/drawing/2014/main" id="{233A2E10-6F48-4066-A163-A930135B7C45}"/>
+                <a16:creationId xmlns:a16="http://schemas.microsoft.com/office/drawing/2014/main" id="{E88087B0-65BD-4356-9229-B84572AD8953}"/>
               </a:ext>
             </a:extLst>
           </p:cNvPr>
@@ -12196,7 +12196,7 @@
           <p:cNvPr id="28" name="flow-61">
             <a:extLst xmlns:a="http://schemas.openxmlformats.org/drawingml/2006/main">
               <a:ext uri="{FF2B5EF4-FFF2-40B4-BE49-F238E27FC236}">
-                <a16:creationId xmlns:a16="http://schemas.microsoft.com/office/drawing/2014/main" id="{912882D7-4176-45A2-9FEE-781D540DCEC8}"/>
+                <a16:creationId xmlns:a16="http://schemas.microsoft.com/office/drawing/2014/main" id="{0129ED2B-E6FD-4C4E-9298-CE4C84D985D5}"/>
               </a:ext>
             </a:extLst>
           </p:cNvPr>
@@ -12394,7 +12394,7 @@
           <p:cNvPr id="30" name="flow-63">
             <a:extLst xmlns:a="http://schemas.openxmlformats.org/drawingml/2006/main">
               <a:ext uri="{FF2B5EF4-FFF2-40B4-BE49-F238E27FC236}">
-                <a16:creationId xmlns:a16="http://schemas.microsoft.com/office/drawing/2014/main" id="{171D0F8A-8F5C-48E0-84E0-3B4631DBCD3F}"/>
+                <a16:creationId xmlns:a16="http://schemas.microsoft.com/office/drawing/2014/main" id="{86EE59E5-F208-4D76-AE1F-B2B6547A4A54}"/>
               </a:ext>
             </a:extLst>
           </p:cNvPr>
@@ -12422,7 +12422,7 @@
           <p:cNvPr id="31" name="flow-64">
             <a:extLst xmlns:a="http://schemas.openxmlformats.org/drawingml/2006/main">
               <a:ext uri="{FF2B5EF4-FFF2-40B4-BE49-F238E27FC236}">
-                <a16:creationId xmlns:a16="http://schemas.microsoft.com/office/drawing/2014/main" id="{165F5805-1941-4664-A9D1-F3AD9B74A63A}"/>
+                <a16:creationId xmlns:a16="http://schemas.microsoft.com/office/drawing/2014/main" id="{AD5184FF-4494-412D-A9C7-0C2CEE8EABCB}"/>
               </a:ext>
             </a:extLst>
           </p:cNvPr>
@@ -12450,7 +12450,7 @@
           <p:cNvPr id="32" name="flow-65">
             <a:extLst xmlns:a="http://schemas.openxmlformats.org/drawingml/2006/main">
               <a:ext uri="{FF2B5EF4-FFF2-40B4-BE49-F238E27FC236}">
-                <a16:creationId xmlns:a16="http://schemas.microsoft.com/office/drawing/2014/main" id="{A207FCE3-AF5E-4BE0-835D-723C76091E10}"/>
+                <a16:creationId xmlns:a16="http://schemas.microsoft.com/office/drawing/2014/main" id="{43511FA5-27E7-4C55-B112-A0B4BA6EAD0A}"/>
               </a:ext>
             </a:extLst>
           </p:cNvPr>
@@ -12478,7 +12478,7 @@
           <p:cNvPr id="33" name="flow-66">
             <a:extLst xmlns:a="http://schemas.openxmlformats.org/drawingml/2006/main">
               <a:ext uri="{FF2B5EF4-FFF2-40B4-BE49-F238E27FC236}">
-                <a16:creationId xmlns:a16="http://schemas.microsoft.com/office/drawing/2014/main" id="{C70491CF-03A0-4BE8-BF2B-11733C3C0089}"/>
+                <a16:creationId xmlns:a16="http://schemas.microsoft.com/office/drawing/2014/main" id="{600EF3D7-0746-477B-845D-22784F7DC016}"/>
               </a:ext>
             </a:extLst>
           </p:cNvPr>
@@ -13043,7 +13043,7 @@
           <p:cNvPr id="18" name="">
             <a:extLst xmlns:a="http://schemas.openxmlformats.org/drawingml/2006/main">
               <a:ext uri="{FF2B5EF4-FFF2-40B4-BE49-F238E27FC236}">
-                <a16:creationId xmlns:a16="http://schemas.microsoft.com/office/drawing/2014/main" id="{42A81A05-7E6E-409F-AF49-AD50FFCAAAD2}"/>
+                <a16:creationId xmlns:a16="http://schemas.microsoft.com/office/drawing/2014/main" id="{F391DE1D-F019-4060-8E9C-0C21AE73C866}"/>
               </a:ext>
             </a:extLst>
           </p:cNvPr>
@@ -15533,7 +15533,7 @@
           <p:cNvPr id="20" name="flow-88">
             <a:extLst xmlns:a="http://schemas.openxmlformats.org/drawingml/2006/main">
               <a:ext uri="{FF2B5EF4-FFF2-40B4-BE49-F238E27FC236}">
-                <a16:creationId xmlns:a16="http://schemas.microsoft.com/office/drawing/2014/main" id="{ECBA7BA3-1981-4B0E-BC5D-32AF0B2C3A10}"/>
+                <a16:creationId xmlns:a16="http://schemas.microsoft.com/office/drawing/2014/main" id="{1CF1F1D8-9820-4E1F-A2AD-87E11D62EACD}"/>
               </a:ext>
             </a:extLst>
           </p:cNvPr>
@@ -15561,7 +15561,7 @@
           <p:cNvPr id="21" name="flow-89">
             <a:extLst xmlns:a="http://schemas.openxmlformats.org/drawingml/2006/main">
               <a:ext uri="{FF2B5EF4-FFF2-40B4-BE49-F238E27FC236}">
-                <a16:creationId xmlns:a16="http://schemas.microsoft.com/office/drawing/2014/main" id="{E2A839E8-6546-4C9C-95CE-DAFBB2B3CFD7}"/>
+                <a16:creationId xmlns:a16="http://schemas.microsoft.com/office/drawing/2014/main" id="{84409A38-6E6E-4187-86F2-851571D93D81}"/>
               </a:ext>
             </a:extLst>
           </p:cNvPr>
@@ -15589,7 +15589,7 @@
           <p:cNvPr id="22" name="flow-90">
             <a:extLst xmlns:a="http://schemas.openxmlformats.org/drawingml/2006/main">
               <a:ext uri="{FF2B5EF4-FFF2-40B4-BE49-F238E27FC236}">
-                <a16:creationId xmlns:a16="http://schemas.microsoft.com/office/drawing/2014/main" id="{75AD852A-AD0F-4F8B-8E4E-874992AA8D7B}"/>
+                <a16:creationId xmlns:a16="http://schemas.microsoft.com/office/drawing/2014/main" id="{C1FB95B1-C7E5-43B8-A9F5-C5B30719C20E}"/>
               </a:ext>
             </a:extLst>
           </p:cNvPr>
@@ -15811,7 +15811,7 @@
           <p:cNvPr id="24" name="flow-92">
             <a:extLst xmlns:a="http://schemas.openxmlformats.org/drawingml/2006/main">
               <a:ext uri="{FF2B5EF4-FFF2-40B4-BE49-F238E27FC236}">
-                <a16:creationId xmlns:a16="http://schemas.microsoft.com/office/drawing/2014/main" id="{FA2DC789-0826-4B6E-9C00-9E99A7AED793}"/>
+                <a16:creationId xmlns:a16="http://schemas.microsoft.com/office/drawing/2014/main" id="{80B5C039-26A5-48A0-B198-B29C58826349}"/>
               </a:ext>
             </a:extLst>
           </p:cNvPr>
@@ -15839,7 +15839,7 @@
           <p:cNvPr id="25" name="flow-93">
             <a:extLst xmlns:a="http://schemas.openxmlformats.org/drawingml/2006/main">
               <a:ext uri="{FF2B5EF4-FFF2-40B4-BE49-F238E27FC236}">
-                <a16:creationId xmlns:a16="http://schemas.microsoft.com/office/drawing/2014/main" id="{E07AB091-7A1D-4095-974E-58D9F48B9802}"/>
+                <a16:creationId xmlns:a16="http://schemas.microsoft.com/office/drawing/2014/main" id="{4EB3F28C-57E9-4314-8CEB-CCBD54583F9E}"/>
               </a:ext>
             </a:extLst>
           </p:cNvPr>
@@ -15867,7 +15867,7 @@
           <p:cNvPr id="26" name="flow-94">
             <a:extLst xmlns:a="http://schemas.openxmlformats.org/drawingml/2006/main">
               <a:ext uri="{FF2B5EF4-FFF2-40B4-BE49-F238E27FC236}">
-                <a16:creationId xmlns:a16="http://schemas.microsoft.com/office/drawing/2014/main" id="{E1D9D3EB-FFF5-4F8D-B59F-A1F03508967B}"/>
+                <a16:creationId xmlns:a16="http://schemas.microsoft.com/office/drawing/2014/main" id="{0E1B7F72-A8F3-4559-8164-4C401F461441}"/>
               </a:ext>
             </a:extLst>
           </p:cNvPr>
@@ -16089,7 +16089,7 @@
           <p:cNvPr id="28" name="flow-96">
             <a:extLst xmlns:a="http://schemas.openxmlformats.org/drawingml/2006/main">
               <a:ext uri="{FF2B5EF4-FFF2-40B4-BE49-F238E27FC236}">
-                <a16:creationId xmlns:a16="http://schemas.microsoft.com/office/drawing/2014/main" id="{5A208F3C-C5BF-4E55-A71C-A9A66F0B9953}"/>
+                <a16:creationId xmlns:a16="http://schemas.microsoft.com/office/drawing/2014/main" id="{5FA6548F-52A2-40F8-BD62-D4B781EAB358}"/>
               </a:ext>
             </a:extLst>
           </p:cNvPr>
@@ -16117,7 +16117,7 @@
           <p:cNvPr id="29" name="flow-97">
             <a:extLst xmlns:a="http://schemas.openxmlformats.org/drawingml/2006/main">
               <a:ext uri="{FF2B5EF4-FFF2-40B4-BE49-F238E27FC236}">
-                <a16:creationId xmlns:a16="http://schemas.microsoft.com/office/drawing/2014/main" id="{0A2E3973-5893-4A0A-99F9-E2E1B31D5AF0}"/>
+                <a16:creationId xmlns:a16="http://schemas.microsoft.com/office/drawing/2014/main" id="{FCEFB35C-0450-4F79-B474-370F1B4287EC}"/>
               </a:ext>
             </a:extLst>
           </p:cNvPr>
@@ -16899,7 +16899,7 @@
           <p:cNvPr id="35" name="">
             <a:extLst xmlns:a="http://schemas.openxmlformats.org/drawingml/2006/main">
               <a:ext uri="{FF2B5EF4-FFF2-40B4-BE49-F238E27FC236}">
-                <a16:creationId xmlns:a16="http://schemas.microsoft.com/office/drawing/2014/main" id="{E3BD5345-3BBC-4AAE-B146-EBE85BBEC941}"/>
+                <a16:creationId xmlns:a16="http://schemas.microsoft.com/office/drawing/2014/main" id="{4FF351DA-7604-4A60-9F8F-BFA88069DFA7}"/>
               </a:ext>
             </a:extLst>
           </p:cNvPr>
@@ -16931,7 +16931,7 @@
           <p:cNvPr id="34" name="">
             <a:extLst xmlns:a="http://schemas.openxmlformats.org/drawingml/2006/main">
               <a:ext uri="{FF2B5EF4-FFF2-40B4-BE49-F238E27FC236}">
-                <a16:creationId xmlns:a16="http://schemas.microsoft.com/office/drawing/2014/main" id="{B35B69E9-BB66-4627-8192-753F73F57ED1}"/>
+                <a16:creationId xmlns:a16="http://schemas.microsoft.com/office/drawing/2014/main" id="{6E1556D6-5E6B-4C0A-8249-145F5FBD284C}"/>
               </a:ext>
             </a:extLst>
           </p:cNvPr>
@@ -16963,7 +16963,7 @@
           <p:cNvPr id="33" name="">
             <a:extLst xmlns:a="http://schemas.openxmlformats.org/drawingml/2006/main">
               <a:ext uri="{FF2B5EF4-FFF2-40B4-BE49-F238E27FC236}">
-                <a16:creationId xmlns:a16="http://schemas.microsoft.com/office/drawing/2014/main" id="{5F2E91EF-40C2-4E36-8551-B70EC49452D6}"/>
+                <a16:creationId xmlns:a16="http://schemas.microsoft.com/office/drawing/2014/main" id="{E4EB3B1A-2698-439C-9570-92D097B35E30}"/>
               </a:ext>
             </a:extLst>
           </p:cNvPr>
@@ -16995,7 +16995,7 @@
           <p:cNvPr id="13" name="">
             <a:extLst xmlns:a="http://schemas.openxmlformats.org/drawingml/2006/main">
               <a:ext uri="{FF2B5EF4-FFF2-40B4-BE49-F238E27FC236}">
-                <a16:creationId xmlns:a16="http://schemas.microsoft.com/office/drawing/2014/main" id="{56BE6817-A69B-4BF8-8308-FC8412A3AB49}"/>
+                <a16:creationId xmlns:a16="http://schemas.microsoft.com/office/drawing/2014/main" id="{97A35D9F-DBAD-45D4-93C7-2F88450F036A}"/>
               </a:ext>
             </a:extLst>
           </p:cNvPr>
@@ -17027,7 +17027,7 @@
           <p:cNvPr id="12" name="">
             <a:extLst xmlns:a="http://schemas.openxmlformats.org/drawingml/2006/main">
               <a:ext uri="{FF2B5EF4-FFF2-40B4-BE49-F238E27FC236}">
-                <a16:creationId xmlns:a16="http://schemas.microsoft.com/office/drawing/2014/main" id="{697B271D-53D4-4000-8ED5-39E0C5448C1C}"/>
+                <a16:creationId xmlns:a16="http://schemas.microsoft.com/office/drawing/2014/main" id="{79FF41FA-CAC6-4E18-B534-62F61905FE77}"/>
               </a:ext>
             </a:extLst>
           </p:cNvPr>
@@ -18606,7 +18606,7 @@
           <p:cNvPr id="14" name="flow-113">
             <a:extLst xmlns:a="http://schemas.openxmlformats.org/drawingml/2006/main">
               <a:ext uri="{FF2B5EF4-FFF2-40B4-BE49-F238E27FC236}">
-                <a16:creationId xmlns:a16="http://schemas.microsoft.com/office/drawing/2014/main" id="{AE3886ED-E661-47A4-A92C-9286A6C82E3D}"/>
+                <a16:creationId xmlns:a16="http://schemas.microsoft.com/office/drawing/2014/main" id="{71CDA9EA-B018-42E0-ABB6-F1731AEE133C}"/>
               </a:ext>
             </a:extLst>
           </p:cNvPr>
@@ -18634,7 +18634,7 @@
           <p:cNvPr id="15" name="flow-114">
             <a:extLst xmlns:a="http://schemas.openxmlformats.org/drawingml/2006/main">
               <a:ext uri="{FF2B5EF4-FFF2-40B4-BE49-F238E27FC236}">
-                <a16:creationId xmlns:a16="http://schemas.microsoft.com/office/drawing/2014/main" id="{C83F7109-F920-446C-8422-ABDA646EF561}"/>
+                <a16:creationId xmlns:a16="http://schemas.microsoft.com/office/drawing/2014/main" id="{BC6FA975-0FC4-4755-9FDA-7A17AE96B0C3}"/>
               </a:ext>
             </a:extLst>
           </p:cNvPr>
@@ -18662,7 +18662,7 @@
           <p:cNvPr id="16" name="flow-115">
             <a:extLst xmlns:a="http://schemas.openxmlformats.org/drawingml/2006/main">
               <a:ext uri="{FF2B5EF4-FFF2-40B4-BE49-F238E27FC236}">
-                <a16:creationId xmlns:a16="http://schemas.microsoft.com/office/drawing/2014/main" id="{DCCBABF4-1E0E-42C1-ACA6-08EE16738FCB}"/>
+                <a16:creationId xmlns:a16="http://schemas.microsoft.com/office/drawing/2014/main" id="{F5829C35-D0B9-4768-B7CF-7BBCC063BAD1}"/>
               </a:ext>
             </a:extLst>
           </p:cNvPr>
@@ -18690,7 +18690,7 @@
           <p:cNvPr id="17" name="flow-116">
             <a:extLst xmlns:a="http://schemas.openxmlformats.org/drawingml/2006/main">
               <a:ext uri="{FF2B5EF4-FFF2-40B4-BE49-F238E27FC236}">
-                <a16:creationId xmlns:a16="http://schemas.microsoft.com/office/drawing/2014/main" id="{5E48C0CC-6A8B-458C-B804-4DC1B9CBD6CC}"/>
+                <a16:creationId xmlns:a16="http://schemas.microsoft.com/office/drawing/2014/main" id="{FE1704A0-B59F-4CF2-895C-21D7C541E7BA}"/>
               </a:ext>
             </a:extLst>
           </p:cNvPr>
@@ -20468,7 +20468,7 @@
           <p:cNvPr id="31" name="flow-130">
             <a:extLst xmlns:a="http://schemas.openxmlformats.org/drawingml/2006/main">
               <a:ext uri="{FF2B5EF4-FFF2-40B4-BE49-F238E27FC236}">
-                <a16:creationId xmlns:a16="http://schemas.microsoft.com/office/drawing/2014/main" id="{3D5D5DBA-A4CB-4AB2-8CBB-9A6E2435AFA0}"/>
+                <a16:creationId xmlns:a16="http://schemas.microsoft.com/office/drawing/2014/main" id="{7E9A1E6F-630B-422C-B078-877B5CFED3A1}"/>
               </a:ext>
             </a:extLst>
           </p:cNvPr>
@@ -21752,7 +21752,7 @@
           <p:cNvPr id="43" name="partner-flow-1">
             <a:extLst xmlns:a="http://schemas.openxmlformats.org/drawingml/2006/main">
               <a:ext uri="{FF2B5EF4-FFF2-40B4-BE49-F238E27FC236}">
-                <a16:creationId xmlns:a16="http://schemas.microsoft.com/office/drawing/2014/main" id="{274546DC-7B5D-4FC9-8765-E687A476C61E}"/>
+                <a16:creationId xmlns:a16="http://schemas.microsoft.com/office/drawing/2014/main" id="{040CDE0A-1E40-4C2D-8333-11B411C2BC33}"/>
               </a:ext>
             </a:extLst>
           </p:cNvPr>
@@ -21780,7 +21780,7 @@
           <p:cNvPr id="44" name="partner-flow-2">
             <a:extLst xmlns:a="http://schemas.openxmlformats.org/drawingml/2006/main">
               <a:ext uri="{FF2B5EF4-FFF2-40B4-BE49-F238E27FC236}">
-                <a16:creationId xmlns:a16="http://schemas.microsoft.com/office/drawing/2014/main" id="{4CE2A232-4EF8-4F05-B51D-EB418AEF74E7}"/>
+                <a16:creationId xmlns:a16="http://schemas.microsoft.com/office/drawing/2014/main" id="{476CEB09-588A-4CF7-A475-3F5EDDBB627B}"/>
               </a:ext>
             </a:extLst>
           </p:cNvPr>
@@ -21808,7 +21808,7 @@
           <p:cNvPr id="45" name="partner-flow-3">
             <a:extLst xmlns:a="http://schemas.openxmlformats.org/drawingml/2006/main">
               <a:ext uri="{FF2B5EF4-FFF2-40B4-BE49-F238E27FC236}">
-                <a16:creationId xmlns:a16="http://schemas.microsoft.com/office/drawing/2014/main" id="{4AE1D8F4-592D-427E-98E3-5539BF666DE2}"/>
+                <a16:creationId xmlns:a16="http://schemas.microsoft.com/office/drawing/2014/main" id="{16509FFC-129E-45DE-91B5-8F194D95C483}"/>
               </a:ext>
             </a:extLst>
           </p:cNvPr>
@@ -21836,7 +21836,7 @@
           <p:cNvPr id="46" name="partner-flow-4">
             <a:extLst xmlns:a="http://schemas.openxmlformats.org/drawingml/2006/main">
               <a:ext uri="{FF2B5EF4-FFF2-40B4-BE49-F238E27FC236}">
-                <a16:creationId xmlns:a16="http://schemas.microsoft.com/office/drawing/2014/main" id="{F0A52A4D-5F28-40CE-84BD-282D3A1C4D84}"/>
+                <a16:creationId xmlns:a16="http://schemas.microsoft.com/office/drawing/2014/main" id="{12F9AB51-9750-4DB3-9FF3-FB1A05B6DDC6}"/>
               </a:ext>
             </a:extLst>
           </p:cNvPr>
@@ -21894,7 +21894,7 @@
           <p:cNvPr id="25" name="">
             <a:extLst xmlns:a="http://schemas.openxmlformats.org/drawingml/2006/main">
               <a:ext uri="{FF2B5EF4-FFF2-40B4-BE49-F238E27FC236}">
-                <a16:creationId xmlns:a16="http://schemas.microsoft.com/office/drawing/2014/main" id="{219EC66B-E8CF-4A93-867C-F2EE32FE54D1}"/>
+                <a16:creationId xmlns:a16="http://schemas.microsoft.com/office/drawing/2014/main" id="{8744D379-2237-4777-B57C-1D57F92327D8}"/>
               </a:ext>
             </a:extLst>
           </p:cNvPr>
@@ -22602,7 +22602,7 @@
           <p:cNvPr id="5" name="flow-142">
             <a:extLst xmlns:a="http://schemas.openxmlformats.org/drawingml/2006/main">
               <a:ext uri="{FF2B5EF4-FFF2-40B4-BE49-F238E27FC236}">
-                <a16:creationId xmlns:a16="http://schemas.microsoft.com/office/drawing/2014/main" id="{44FBBF81-096B-4BCC-B556-715456E97D33}"/>
+                <a16:creationId xmlns:a16="http://schemas.microsoft.com/office/drawing/2014/main" id="{F4137126-ED06-46C6-9687-61801A5381D1}"/>
               </a:ext>
             </a:extLst>
           </p:cNvPr>
@@ -24509,7 +24509,7 @@
           <p:cNvPr id="21" name="flow-158">
             <a:extLst xmlns:a="http://schemas.openxmlformats.org/drawingml/2006/main">
               <a:ext uri="{FF2B5EF4-FFF2-40B4-BE49-F238E27FC236}">
-                <a16:creationId xmlns:a16="http://schemas.microsoft.com/office/drawing/2014/main" id="{ED7C233D-F22C-4BD8-AA68-E3